<commit_message>
chore(deck): rebuild EN + TH against the refreshed NABC and ThaiWater data
The two data PRs that merged after the deck moved three of its numbers: seven Thai farm-gate
prices are falling year on year, not eight, and four commodities now disagree on direction
between the annual and six-month windows, not three.

Those counts are spelled out by word(), so they live in the translation KEY rather than as {}
arguments — the Thai build reported them as untranslated, which is the harvest doing its job.
Both readings are kept in the catalogue, because the count can move back. 510 strings, 0 left
English, no fit findings in either language.

Co-Authored-By: Claude Opus 5 <noreply@anthropic.com>
</commit_message>
<xml_diff>
--- a/docs/decks/mcom-2026-08-05-macro-TH.pptx
+++ b/docs/decks/mcom-2026-08-05-macro-TH.pptx
@@ -6279,7 +6279,7 @@
                 </a:solidFill>
                 <a:latin typeface="Kanit"/>
               </a:rPr>
-              <a:t>จาก 794 (16.6%) · เรียลไทม์ · 2026-08-04</a:t>
+              <a:t>จาก 795 (16.6%) · เรียลไทม์ · 2026-08-05</a:t>
             </a:r>
           </a:p>
         </p:txBody>
@@ -6405,7 +6405,7 @@
                 </a:solidFill>
                 <a:latin typeface="Kanit"/>
               </a:rPr>
-              <a:t>41</a:t>
+              <a:t>29</a:t>
             </a:r>
           </a:p>
         </p:txBody>
@@ -6444,7 +6444,7 @@
                 </a:solidFill>
                 <a:latin typeface="Kanit"/>
               </a:rPr>
-              <a:t>ค่าล่าสุดรายวัน · 2026-08-04</a:t>
+              <a:t>ค่าล่าสุดรายวัน · 2026-08-05</a:t>
             </a:r>
           </a:p>
         </p:txBody>
@@ -7882,7 +7882,7 @@
                           </a:solidFill>
                           <a:latin typeface="Kanit"/>
                         </a:rPr>
-                        <a:t>ยโสธร</a:t>
+                        <a:t>นราธิวาส</a:t>
                       </a:r>
                     </a:p>
                   </a:txBody>
@@ -7905,7 +7905,7 @@
                           </a:solidFill>
                           <a:latin typeface="Kanit"/>
                         </a:rPr>
-                        <a:t>15</a:t>
+                        <a:t>66</a:t>
                       </a:r>
                     </a:p>
                   </a:txBody>
@@ -7928,7 +7928,7 @@
                           </a:solidFill>
                           <a:latin typeface="Kanit"/>
                         </a:rPr>
-                        <a:t>98</a:t>
+                        <a:t>56</a:t>
                       </a:r>
                     </a:p>
                   </a:txBody>
@@ -7951,7 +7951,7 @@
                           </a:solidFill>
                           <a:latin typeface="Kanit"/>
                         </a:rPr>
-                        <a:t>33.3%</a:t>
+                        <a:t>4.5%</a:t>
                       </a:r>
                     </a:p>
                   </a:txBody>
@@ -7974,7 +7974,7 @@
                           </a:solidFill>
                           <a:latin typeface="Kanit"/>
                         </a:rPr>
-                        <a:t>5/6</a:t>
+                        <a:t>5/10</a:t>
                       </a:r>
                     </a:p>
                   </a:txBody>
@@ -8022,7 +8022,7 @@
                           </a:solidFill>
                           <a:latin typeface="Kanit"/>
                         </a:rPr>
-                        <a:t>นราธิวาส</a:t>
+                        <a:t>ยโสธร</a:t>
                       </a:r>
                     </a:p>
                   </a:txBody>
@@ -8045,7 +8045,7 @@
                           </a:solidFill>
                           <a:latin typeface="Kanit"/>
                         </a:rPr>
-                        <a:t>65</a:t>
+                        <a:t>16</a:t>
                       </a:r>
                     </a:p>
                   </a:txBody>
@@ -8068,7 +8068,7 @@
                           </a:solidFill>
                           <a:latin typeface="Kanit"/>
                         </a:rPr>
-                        <a:t>57</a:t>
+                        <a:t>27</a:t>
                       </a:r>
                     </a:p>
                   </a:txBody>
@@ -8087,11 +8087,11 @@
                       <a:r>
                         <a:rPr sz="900" b="1">
                           <a:solidFill>
-                            <a:srgbClr val="F5C242"/>
-                          </a:solidFill>
-                          <a:latin typeface="Kanit"/>
-                        </a:rPr>
-                        <a:t>7.7%</a:t>
+                            <a:srgbClr val="606060"/>
+                          </a:solidFill>
+                          <a:latin typeface="Kanit"/>
+                        </a:rPr>
+                        <a:t>0.0%</a:t>
                       </a:r>
                     </a:p>
                   </a:txBody>
@@ -8114,7 +8114,7 @@
                           </a:solidFill>
                           <a:latin typeface="Kanit"/>
                         </a:rPr>
-                        <a:t>5/10</a:t>
+                        <a:t>5/6</a:t>
                       </a:r>
                     </a:p>
                   </a:txBody>
@@ -8162,7 +8162,7 @@
                           </a:solidFill>
                           <a:latin typeface="Kanit"/>
                         </a:rPr>
-                        <a:t>มุกดาหาร</a:t>
+                        <a:t>บึงกาฬ</a:t>
                       </a:r>
                     </a:p>
                   </a:txBody>
@@ -8185,7 +8185,7 @@
                           </a:solidFill>
                           <a:latin typeface="Kanit"/>
                         </a:rPr>
-                        <a:t>17</a:t>
+                        <a:t>10</a:t>
                       </a:r>
                     </a:p>
                   </a:txBody>
@@ -8208,7 +8208,7 @@
                           </a:solidFill>
                           <a:latin typeface="Kanit"/>
                         </a:rPr>
-                        <a:t>97</a:t>
+                        <a:t>99</a:t>
                       </a:r>
                     </a:p>
                   </a:txBody>
@@ -8231,7 +8231,7 @@
                           </a:solidFill>
                           <a:latin typeface="Kanit"/>
                         </a:rPr>
-                        <a:t>47.1%</a:t>
+                        <a:t>90.0%</a:t>
                       </a:r>
                     </a:p>
                   </a:txBody>
@@ -8254,7 +8254,7 @@
                           </a:solidFill>
                           <a:latin typeface="Kanit"/>
                         </a:rPr>
-                        <a:t>1/2</a:t>
+                        <a:t>1/1</a:t>
                       </a:r>
                     </a:p>
                   </a:txBody>
@@ -8302,7 +8302,7 @@
                           </a:solidFill>
                           <a:latin typeface="Kanit"/>
                         </a:rPr>
-                        <a:t>บึงกาฬ</a:t>
+                        <a:t>มุกดาหาร</a:t>
                       </a:r>
                     </a:p>
                   </a:txBody>
@@ -8325,7 +8325,7 @@
                           </a:solidFill>
                           <a:latin typeface="Kanit"/>
                         </a:rPr>
-                        <a:t>11</a:t>
+                        <a:t>16</a:t>
                       </a:r>
                     </a:p>
                   </a:txBody>
@@ -8348,7 +8348,7 @@
                           </a:solidFill>
                           <a:latin typeface="Kanit"/>
                         </a:rPr>
-                        <a:t>85</a:t>
+                        <a:t>77</a:t>
                       </a:r>
                     </a:p>
                   </a:txBody>
@@ -8371,7 +8371,7 @@
                           </a:solidFill>
                           <a:latin typeface="Kanit"/>
                         </a:rPr>
-                        <a:t>45.5%</a:t>
+                        <a:t>18.8%</a:t>
                       </a:r>
                     </a:p>
                   </a:txBody>
@@ -8394,7 +8394,7 @@
                           </a:solidFill>
                           <a:latin typeface="Kanit"/>
                         </a:rPr>
-                        <a:t>1/1</a:t>
+                        <a:t>1/2</a:t>
                       </a:r>
                     </a:p>
                   </a:txBody>
@@ -8442,7 +8442,7 @@
                           </a:solidFill>
                           <a:latin typeface="Kanit"/>
                         </a:rPr>
-                        <a:t>นครพนม</a:t>
+                        <a:t>ปทุมธานี</a:t>
                       </a:r>
                     </a:p>
                   </a:txBody>
@@ -8465,7 +8465,7 @@
                           </a:solidFill>
                           <a:latin typeface="Kanit"/>
                         </a:rPr>
-                        <a:t>29</a:t>
+                        <a:t>11</a:t>
                       </a:r>
                     </a:p>
                   </a:txBody>
@@ -8488,7 +8488,7 @@
                           </a:solidFill>
                           <a:latin typeface="Kanit"/>
                         </a:rPr>
-                        <a:t>56</a:t>
+                        <a:t>43</a:t>
                       </a:r>
                     </a:p>
                   </a:txBody>
@@ -8511,7 +8511,7 @@
                           </a:solidFill>
                           <a:latin typeface="Kanit"/>
                         </a:rPr>
-                        <a:t>24.1%</a:t>
+                        <a:t>18.2%</a:t>
                       </a:r>
                     </a:p>
                   </a:txBody>
@@ -8534,7 +8534,7 @@
                           </a:solidFill>
                           <a:latin typeface="Kanit"/>
                         </a:rPr>
-                        <a:t>5/15</a:t>
+                        <a:t>2/4</a:t>
                       </a:r>
                     </a:p>
                   </a:txBody>
@@ -8582,7 +8582,7 @@
                           </a:solidFill>
                           <a:latin typeface="Kanit"/>
                         </a:rPr>
-                        <a:t>อุดรธานี</a:t>
+                        <a:t>นครพนม</a:t>
                       </a:r>
                     </a:p>
                   </a:txBody>
@@ -8605,7 +8605,7 @@
                           </a:solidFill>
                           <a:latin typeface="Kanit"/>
                         </a:rPr>
-                        <a:t>33</a:t>
+                        <a:t>29</a:t>
                       </a:r>
                     </a:p>
                   </a:txBody>
@@ -8628,7 +8628,7 @@
                           </a:solidFill>
                           <a:latin typeface="Kanit"/>
                         </a:rPr>
-                        <a:t>59</a:t>
+                        <a:t>86</a:t>
                       </a:r>
                     </a:p>
                   </a:txBody>
@@ -8651,7 +8651,7 @@
                           </a:solidFill>
                           <a:latin typeface="Kanit"/>
                         </a:rPr>
-                        <a:t>15.2%</a:t>
+                        <a:t>17.2%</a:t>
                       </a:r>
                     </a:p>
                   </a:txBody>
@@ -8674,7 +8674,7 @@
                           </a:solidFill>
                           <a:latin typeface="Kanit"/>
                         </a:rPr>
-                        <a:t>3/4</a:t>
+                        <a:t>5/15</a:t>
                       </a:r>
                     </a:p>
                   </a:txBody>
@@ -8909,7 +8909,7 @@
                 </a:solidFill>
                 <a:latin typeface="Kanit"/>
               </a:rPr>
-              <a:t>พื้นที่ปลูก วัดจริง (สศก. — ข้อมูลอำเภอ×พืช 3,295 แถว) ภัยแล้งเป็นดัชนี SPEI จาก แบบจำลอง คำนวณจากปริมาณฝนและการคายระเหย ปรับเดือนละครั้ง ดึงข้อมูล 2026-07-20 — เป็นสัญญาณที่ครอบคลุมทั้งประเทศดีที่สุดที่มี แต่ไม่มีใครลงพื้นที่ไปเดินดูอำเภอเหล่านั้น ข้อมูลฝนและระดับน้ำ วัดจริง (ThaiWater เรียลไทม์ ดึงทุกวันและสะสมไว้ — วันที่ดึงไม่สำเร็จจะเว้นเป็นช่องว่าง ไม่ใส่ค่าสมมติ) · ฝนถึง 2026-08-04, ระดับน้ำถึง 2026-08-04 ความเสี่ยงน้ำท่วมเชิงโครงสร้าง วัดจริง (สำมะโนพื้นที่ท่วมซ้ำซาก GISTDA มาตราส่วน 1:50,000 ปี 2005-2016 — เป็นบันทึกภาคพื้นดิน 12 ปี ไม่ใช่การพยากรณ์)</a:t>
+              <a:t>พื้นที่ปลูก วัดจริง (สศก. — ข้อมูลอำเภอ×พืช 3,295 แถว) ภัยแล้งเป็นดัชนี SPEI จาก แบบจำลอง คำนวณจากปริมาณฝนและการคายระเหย ปรับเดือนละครั้ง ดึงข้อมูล 2026-07-20 — เป็นสัญญาณที่ครอบคลุมทั้งประเทศดีที่สุดที่มี แต่ไม่มีใครลงพื้นที่ไปเดินดูอำเภอเหล่านั้น ข้อมูลฝนและระดับน้ำ วัดจริง (ThaiWater เรียลไทม์ ดึงทุกวันและสะสมไว้ — วันที่ดึงไม่สำเร็จจะเว้นเป็นช่องว่าง ไม่ใส่ค่าสมมติ) · ฝนถึง 2026-08-05, ระดับน้ำถึง 2026-08-05 ความเสี่ยงน้ำท่วมเชิงโครงสร้าง วัดจริง (สำมะโนพื้นที่ท่วมซ้ำซาก GISTDA มาตราส่วน 1:50,000 ปี 2005-2016 — เป็นบันทึกภาคพื้นดิน 12 ปี ไม่ใช่การพยากรณ์)</a:t>
             </a:r>
           </a:p>
         </p:txBody>
@@ -31476,7 +31476,7 @@
                 </a:solidFill>
                 <a:latin typeface="Kanit"/>
               </a:rPr>
-              <a:t>รายได้จากพืชค่ากลางเพิ่มขึ้น +15.5% แต่มีสี่จังหวัดที่ลดลง — ทั้งหมดอยู่ในแหล่งปลูกมะพร้าว โดยหนักที่สุดคือสมุทรสงครามที่ −65.2%</a:t>
+              <a:t>รายได้จากพืชค่ากลางเพิ่มขึ้น +15.6% แต่มีสี่จังหวัดที่ลดลง — ทั้งหมดอยู่ในแหล่งปลูกมะพร้าว โดยหนักที่สุดคือสมุทรสงครามที่ −64.8%</a:t>
             </a:r>
           </a:p>
         </p:txBody>
@@ -32047,7 +32047,7 @@
                 </a:solidFill>
                 <a:latin typeface="Kanit"/>
               </a:rPr>
-              <a:t>รุ่นข้อมูล — ราคาโลก 2026M06 · ราคาหน้าฟาร์มไทย 2026-08-03 · ประวัติราคาไทย 2026-08-02 · ต้นทุนการผลิตพืช สศก. ไจอัป 2568 (ปีเพาะปลูก 2568/69, ประมาณการ สศก. มี.ค. 2569) · ภัยแล้ง 2026-06-21 · เงินเฟ้อ 2026-05 · GDP 2026 ไตรมาส 1 · IMF WEO 2026 · ดัชนีราคาขายต่อ 2026-05 · ยอดจดทะเบียนถึง 2026-01 · หนี้ครัวเรือน สสช. SES 2566 · ค่าจ้าง สสช. LFS 2568 · ข้อมูลตรวจวัด 2026-08-04</a:t>
+              <a:t>รุ่นข้อมูล — ราคาโลก 2026M06 · ราคาหน้าฟาร์มไทย 2026-08-04 · ประวัติราคาไทย 2026-08-02 · ต้นทุนการผลิตพืช สศก. ไจอัป 2568 (ปีเพาะปลูก 2568/69, ประมาณการ สศก. มี.ค. 2569) · ภัยแล้ง 2026-06-21 · เงินเฟ้อ 2026-05 · GDP 2026 ไตรมาส 1 · IMF WEO 2026 · ดัชนีราคาขายต่อ 2026-05 · ยอดจดทะเบียนถึง 2026-01 · หนี้ครัวเรือน สสช. SES 2566 · ค่าจ้าง สสช. LFS 2568 · ข้อมูลตรวจวัด 2026-08-05</a:t>
             </a:r>
           </a:p>
         </p:txBody>
@@ -32544,9 +32544,9 @@
                 <a:latin typeface="Kanit"/>
               </a:rPr>
               <a:t>ไม่ใช่ถ้าดูดัชนีโลก — แต่ราคาหน้าฟาร์ม (ราคาที่เกษตรกรขายได้) บอกคนละเรื่อง
-• ราคาหน้าฟาร์มไทยแปดจากสิบเจ็ดรายการลดลงเมื่อเทียบกับปีก่อน
+• ราคาหน้าฟาร์มไทยเจ็ดจากสิบเจ็ดรายการลดลงเมื่อเทียบกับปีก่อน
 • เนื้อวัว: หน้าฟาร์ม −6.1% เทียบดัชนีโลก +11.8%
-• ส่วนต่างสำคัญกว่าราคา: ราคาขยับ 25% กลายเป็นรายได้เกษตรเหวี่ยง 80%</a:t>
+• ส่วนต่างสำคัญกว่าราคา: ราคาขยับ 25% กลายเป็นรายได้เกษตรเหวี่ยง 81%</a:t>
             </a:r>
           </a:p>
         </p:txBody>
@@ -37087,7 +37087,7 @@
                 </a:solidFill>
                 <a:latin typeface="Kanit"/>
               </a:rPr>
-              <a:t>338 จาก 928 อำเภอ · แม่น้ำเกินระดับ 132 จาก 794 สถานี</a:t>
+              <a:t>338 จาก 928 อำเภอ · แม่น้ำเกินระดับ 132 จาก 795 สถานี</a:t>
             </a:r>
           </a:p>
         </p:txBody>
@@ -37859,7 +37859,7 @@
                           </a:solidFill>
                           <a:latin typeface="Kanit"/>
                         </a:rPr>
-                        <a:t>31/158</a:t>
+                        <a:t>34/159</a:t>
                       </a:r>
                     </a:p>
                   </a:txBody>
@@ -38091,7 +38091,7 @@
                           </a:solidFill>
                           <a:latin typeface="Kanit"/>
                         </a:rPr>
-                        <a:t>26/274</a:t>
+                        <a:t>23/274</a:t>
                       </a:r>
                     </a:p>
                   </a:txBody>
@@ -38323,7 +38323,7 @@
                           </a:solidFill>
                           <a:latin typeface="Kanit"/>
                         </a:rPr>
-                        <a:t>29/168</a:t>
+                        <a:t>27/168</a:t>
                       </a:r>
                     </a:p>
                   </a:txBody>
@@ -38555,7 +38555,7 @@
                           </a:solidFill>
                           <a:latin typeface="Kanit"/>
                         </a:rPr>
-                        <a:t>7/52</a:t>
+                        <a:t>8/52</a:t>
                       </a:r>
                     </a:p>
                   </a:txBody>
@@ -38787,7 +38787,7 @@
                           </a:solidFill>
                           <a:latin typeface="Kanit"/>
                         </a:rPr>
-                        <a:t>39/142</a:t>
+                        <a:t>40/142</a:t>
                       </a:r>
                     </a:p>
                   </a:txBody>
@@ -39502,7 +39502,7 @@
                 </a:solidFill>
                 <a:latin typeface="Kanit"/>
               </a:rPr>
-              <a:t>สินค้าเกษตร 17 จากทั้งหมด 21 รายการที่เราติดตาม มีราคาหน้าฟาร์มไทยที่วัดได้จริง (ราคาที่เกษตรกรขายได้) และแปดรายการกำลังลดลงเมื่อเทียบกับปีก่อน</a:t>
+              <a:t>สินค้าเกษตร 17 จากทั้งหมด 21 รายการที่เราติดตาม มีราคาหน้าฟาร์มไทยที่วัดได้จริง (ราคาที่เกษตรกรขายได้) และเจ็ดรายการกำลังลดลงเมื่อเทียบกับปีก่อน</a:t>
             </a:r>
           </a:p>
         </p:txBody>
@@ -39673,7 +39673,7 @@
         </p:nvGraphicFramePr>
         <p:xfrm>
           <a:off x="411480" y="2033016"/>
-          <a:ext cx="11365992" cy="2362808"/>
+          <a:ext cx="11365992" cy="2108605"/>
         </p:xfrm>
         <a:graphic>
           <a:graphicData uri="http://schemas.openxmlformats.org/drawingml/2006/table">
@@ -39936,7 +39936,7 @@
                           </a:solidFill>
                           <a:latin typeface="Kanit"/>
                         </a:rPr>
-                        <a:t>−69.7%</a:t>
+                        <a:t>−69.3%</a:t>
                       </a:r>
                     </a:p>
                   </a:txBody>
@@ -40751,7 +40751,7 @@
                           </a:solidFill>
                           <a:latin typeface="Kanit"/>
                         </a:rPr>
-                        <a:t>−3.5%</a:t>
+                        <a:t>−3.2%</a:t>
                       </a:r>
                     </a:p>
                   </a:txBody>
@@ -40914,7 +40914,7 @@
                           </a:solidFill>
                           <a:latin typeface="Kanit"/>
                         </a:rPr>
-                        <a:t>−1.8%</a:t>
+                        <a:t>−1.5%</a:t>
                       </a:r>
                     </a:p>
                   </a:txBody>
@@ -40990,169 +40990,6 @@
                   <a:tcPr marL="54864" marR="54864" marT="18288" marB="18288" anchor="ctr">
                     <a:solidFill>
                       <a:srgbClr val="FFFFFF"/>
-                    </a:solidFill>
-                  </a:tcPr>
-                </a:tc>
-              </a:tr>
-              <a:tr h="254203">
-                <a:tc>
-                  <a:txBody>
-                    <a:bodyPr wrap="square"/>
-                    <a:lstStyle/>
-                    <a:p>
-                      <a:pPr algn="l"/>
-                      <a:r>
-                        <a:rPr sz="1000" b="1">
-                          <a:solidFill>
-                            <a:srgbClr val="1E2F5C"/>
-                          </a:solidFill>
-                          <a:latin typeface="Kanit"/>
-                        </a:rPr>
-                        <a:t>ไก่เนื้อ</a:t>
-                      </a:r>
-                    </a:p>
-                  </a:txBody>
-                  <a:tcPr marL="54864" marR="54864" marT="18288" marB="18288" anchor="ctr">
-                    <a:solidFill>
-                      <a:srgbClr val="F7F9FC"/>
-                    </a:solidFill>
-                  </a:tcPr>
-                </a:tc>
-                <a:tc>
-                  <a:txBody>
-                    <a:bodyPr wrap="square"/>
-                    <a:lstStyle/>
-                    <a:p>
-                      <a:pPr algn="l"/>
-                      <a:r>
-                        <a:rPr sz="1000" b="0">
-                          <a:solidFill>
-                            <a:srgbClr val="1E2F5C"/>
-                          </a:solidFill>
-                          <a:latin typeface="Kanit"/>
-                        </a:rPr>
-                        <a:t>ปศุสัตว์</a:t>
-                      </a:r>
-                    </a:p>
-                  </a:txBody>
-                  <a:tcPr marL="54864" marR="54864" marT="18288" marB="18288" anchor="ctr">
-                    <a:solidFill>
-                      <a:srgbClr val="F7F9FC"/>
-                    </a:solidFill>
-                  </a:tcPr>
-                </a:tc>
-                <a:tc>
-                  <a:txBody>
-                    <a:bodyPr wrap="square"/>
-                    <a:lstStyle/>
-                    <a:p>
-                      <a:pPr algn="l"/>
-                      <a:r>
-                        <a:rPr sz="1000" b="0">
-                          <a:solidFill>
-                            <a:srgbClr val="1E2F5C"/>
-                          </a:solidFill>
-                          <a:latin typeface="Kanit"/>
-                        </a:rPr>
-                        <a:t>กลาง · ตอ.</a:t>
-                      </a:r>
-                    </a:p>
-                  </a:txBody>
-                  <a:tcPr marL="54864" marR="54864" marT="18288" marB="18288" anchor="ctr">
-                    <a:solidFill>
-                      <a:srgbClr val="F7F9FC"/>
-                    </a:solidFill>
-                  </a:tcPr>
-                </a:tc>
-                <a:tc>
-                  <a:txBody>
-                    <a:bodyPr wrap="square"/>
-                    <a:lstStyle/>
-                    <a:p>
-                      <a:pPr algn="r"/>
-                      <a:r>
-                        <a:rPr sz="1000" b="1">
-                          <a:solidFill>
-                            <a:srgbClr val="CC0000"/>
-                          </a:solidFill>
-                          <a:latin typeface="Kanit"/>
-                        </a:rPr>
-                        <a:t>−0.1%</a:t>
-                      </a:r>
-                    </a:p>
-                  </a:txBody>
-                  <a:tcPr marL="54864" marR="54864" marT="18288" marB="18288" anchor="ctr">
-                    <a:solidFill>
-                      <a:srgbClr val="F7F9FC"/>
-                    </a:solidFill>
-                  </a:tcPr>
-                </a:tc>
-                <a:tc>
-                  <a:txBody>
-                    <a:bodyPr wrap="square"/>
-                    <a:lstStyle/>
-                    <a:p>
-                      <a:pPr algn="r"/>
-                      <a:r>
-                        <a:rPr sz="1000" b="1">
-                          <a:solidFill>
-                            <a:srgbClr val="CC0000"/>
-                          </a:solidFill>
-                          <a:latin typeface="Kanit"/>
-                        </a:rPr>
-                        <a:t>−1.9%</a:t>
-                      </a:r>
-                    </a:p>
-                  </a:txBody>
-                  <a:tcPr marL="54864" marR="54864" marT="18288" marB="18288" anchor="ctr">
-                    <a:solidFill>
-                      <a:srgbClr val="F7F9FC"/>
-                    </a:solidFill>
-                  </a:tcPr>
-                </a:tc>
-                <a:tc>
-                  <a:txBody>
-                    <a:bodyPr wrap="square"/>
-                    <a:lstStyle/>
-                    <a:p>
-                      <a:pPr algn="r"/>
-                      <a:r>
-                        <a:rPr sz="1000" b="1">
-                          <a:solidFill>
-                            <a:srgbClr val="7A4FE0"/>
-                          </a:solidFill>
-                          <a:latin typeface="Kanit"/>
-                        </a:rPr>
-                        <a:t>41,496</a:t>
-                      </a:r>
-                    </a:p>
-                  </a:txBody>
-                  <a:tcPr marL="54864" marR="54864" marT="18288" marB="18288" anchor="ctr">
-                    <a:solidFill>
-                      <a:srgbClr val="F7F9FC"/>
-                    </a:solidFill>
-                  </a:tcPr>
-                </a:tc>
-                <a:tc>
-                  <a:txBody>
-                    <a:bodyPr wrap="square"/>
-                    <a:lstStyle/>
-                    <a:p>
-                      <a:pPr algn="r"/>
-                      <a:r>
-                        <a:rPr sz="1000" b="0">
-                          <a:solidFill>
-                            <a:srgbClr val="606060"/>
-                          </a:solidFill>
-                          <a:latin typeface="Kanit"/>
-                        </a:rPr>
-                        <a:t>23%</a:t>
-                      </a:r>
-                    </a:p>
-                  </a:txBody>
-                  <a:tcPr marL="54864" marR="54864" marT="18288" marB="18288" anchor="ctr">
-                    <a:solidFill>
-                      <a:srgbClr val="F7F9FC"/>
                     </a:solidFill>
                   </a:tcPr>
                 </a:tc>
@@ -41169,7 +41006,7 @@
         </p:nvSpPr>
         <p:spPr>
           <a:xfrm>
-            <a:off x="411480" y="4523841"/>
+            <a:off x="411480" y="4269638"/>
             <a:ext cx="535747" cy="192024"/>
           </a:xfrm>
           <a:prstGeom prst="roundRect">
@@ -41215,7 +41052,7 @@
         </p:nvSpPr>
         <p:spPr>
           <a:xfrm>
-            <a:off x="411480" y="4553102"/>
+            <a:off x="411480" y="4298899"/>
             <a:ext cx="535747" cy="134112"/>
           </a:xfrm>
           <a:prstGeom prst="rect">
@@ -41254,7 +41091,7 @@
         </p:nvSpPr>
         <p:spPr>
           <a:xfrm>
-            <a:off x="1056955" y="4537557"/>
+            <a:off x="1056955" y="4283354"/>
             <a:ext cx="10720516" cy="462915"/>
           </a:xfrm>
           <a:prstGeom prst="rect">
@@ -41280,7 +41117,7 @@
                 </a:solidFill>
                 <a:latin typeface="Kanit"/>
               </a:rPr>
-              <a:t>ราคา วัดจริง — ราคาหน้าฟาร์มไทยจากราคารายวันของ NABC และราคาอ้อยประกาศของ สอน. ราคาล่าสุด 2026-08-03 การเปลี่ยนแปลงหกเดือนคำนวณจากข้อมูลรายเดือนของ NABC เอง (thai_price_history รุ่นข้อมูล 2026-08-02) พืชที่ไม่มีข้อมูลรายเดือนจะกำกับไว้ ไม่ประมาณการขึ้นมา แหล่งผลิตเป็นการอ่านแบบ ประมาณการ ว่าสินค้าแต่ละชนิดปลูกที่ไหน และแหล่งผลิตทับซ้อนกันได้ บัญชีอาชีพเกษตรเป็นข้อมูลของเราเองและ วัดจริง — บัญชีที่บันทึกอาชีพว่า เกษตร ในจังหวัดแหล่งผลิต จากฐานข้อมูล 382,735 บัญชี ณ 2026-07 ไม่เผยแพร่ช่องที่มีน้อยกว่า 30 บัญชี คนกลุ่มนี้อาศัยอยู่ในพื้นที่ที่ปลูกพืชนั้น แต่ไม่ได้ยืนยันว่าปลูกพืชนั้นเอง</a:t>
+              <a:t>ราคา วัดจริง — ราคาหน้าฟาร์มไทยจากราคารายวันของ NABC และราคาอ้อยประกาศของ สอน. ราคาล่าสุด 2026-08-04 การเปลี่ยนแปลงหกเดือนคำนวณจากข้อมูลรายเดือนของ NABC เอง (thai_price_history รุ่นข้อมูล 2026-08-02) พืชที่ไม่มีข้อมูลรายเดือนจะกำกับไว้ ไม่ประมาณการขึ้นมา แหล่งผลิตเป็นการอ่านแบบ ประมาณการ ว่าสินค้าแต่ละชนิดปลูกที่ไหน และแหล่งผลิตทับซ้อนกันได้ บัญชีอาชีพเกษตรเป็นข้อมูลของเราเองและ วัดจริง — บัญชีที่บันทึกอาชีพว่า เกษตร ในจังหวัดแหล่งผลิต จากฐานข้อมูล 382,735 บัญชี ณ 2026-07 ไม่เผยแพร่ช่องที่มีน้อยกว่า 30 บัญชี คนกลุ่มนี้อาศัยอยู่ในพื้นที่ที่ปลูกพืชนั้น แต่ไม่ได้ยืนยันว่าปลูกพืชนั้นเอง</a:t>
             </a:r>
           </a:p>
         </p:txBody>
@@ -41293,7 +41130,7 @@
         </p:nvSpPr>
         <p:spPr>
           <a:xfrm>
-            <a:off x="411480" y="5133060"/>
+            <a:off x="411480" y="4878857"/>
             <a:ext cx="11365992" cy="675767"/>
           </a:xfrm>
           <a:prstGeom prst="rect">
@@ -41337,7 +41174,7 @@
         </p:nvSpPr>
         <p:spPr>
           <a:xfrm>
-            <a:off x="411480" y="5133060"/>
+            <a:off x="411480" y="4878857"/>
             <a:ext cx="50292" cy="675767"/>
           </a:xfrm>
           <a:prstGeom prst="rect">
@@ -41381,7 +41218,7 @@
         </p:nvSpPr>
         <p:spPr>
           <a:xfrm>
-            <a:off x="630936" y="5279364"/>
+            <a:off x="630936" y="5025161"/>
             <a:ext cx="11036808" cy="158750"/>
           </a:xfrm>
           <a:prstGeom prst="rect">
@@ -41420,7 +41257,7 @@
         </p:nvSpPr>
         <p:spPr>
           <a:xfrm>
-            <a:off x="630936" y="5483834"/>
+            <a:off x="630936" y="5229631"/>
             <a:ext cx="11036808" cy="178689"/>
           </a:xfrm>
           <a:prstGeom prst="rect">
@@ -45168,7 +45005,7 @@
                 </a:solidFill>
                 <a:latin typeface="Kanit"/>
               </a:rPr>
-              <a:t>มะพร้าว −69.7% สับปะรด −18.4% อ้อย −17.9% เทียบปีก่อน</a:t>
+              <a:t>มะพร้าว −69.3% สับปะรด −18.4% อ้อย −17.9% เทียบปีก่อน</a:t>
             </a:r>
           </a:p>
         </p:txBody>
@@ -45294,7 +45131,7 @@
                 </a:solidFill>
                 <a:latin typeface="Kanit"/>
               </a:rPr>
-              <a:t>+15.5%</a:t>
+              <a:t>+15.6%</a:t>
             </a:r>
           </a:p>
         </p:txBody>
@@ -45768,7 +45605,7 @@
                           </a:solidFill>
                           <a:latin typeface="Kanit"/>
                         </a:rPr>
-                        <a:t>+5.8%</a:t>
+                        <a:t>+6.0%</a:t>
                       </a:r>
                     </a:p>
                   </a:txBody>
@@ -45837,7 +45674,7 @@
                           </a:solidFill>
                           <a:latin typeface="Kanit"/>
                         </a:rPr>
-                        <a:t>-65.2%</a:t>
+                        <a:t>-64.8%</a:t>
                       </a:r>
                     </a:p>
                   </a:txBody>
@@ -45908,7 +45745,7 @@
                           </a:solidFill>
                           <a:latin typeface="Kanit"/>
                         </a:rPr>
-                        <a:t>+14.3%</a:t>
+                        <a:t>+14.4%</a:t>
                       </a:r>
                     </a:p>
                   </a:txBody>
@@ -45977,7 +45814,7 @@
                           </a:solidFill>
                           <a:latin typeface="Kanit"/>
                         </a:rPr>
-                        <a:t>+9.2%</a:t>
+                        <a:t>+9.3%</a:t>
                       </a:r>
                     </a:p>
                   </a:txBody>
@@ -46048,7 +45885,7 @@
                           </a:solidFill>
                           <a:latin typeface="Kanit"/>
                         </a:rPr>
-                        <a:t>+15.7%</a:t>
+                        <a:t>+15.9%</a:t>
                       </a:r>
                     </a:p>
                   </a:txBody>
@@ -46117,7 +45954,7 @@
                           </a:solidFill>
                           <a:latin typeface="Kanit"/>
                         </a:rPr>
-                        <a:t>+8.0%</a:t>
+                        <a:t>+8.1%</a:t>
                       </a:r>
                     </a:p>
                   </a:txBody>
@@ -46257,7 +46094,7 @@
                           </a:solidFill>
                           <a:latin typeface="Kanit"/>
                         </a:rPr>
-                        <a:t>+9.8%</a:t>
+                        <a:t>+9.9%</a:t>
                       </a:r>
                     </a:p>
                   </a:txBody>
@@ -46328,7 +46165,7 @@
                           </a:solidFill>
                           <a:latin typeface="Kanit"/>
                         </a:rPr>
-                        <a:t>+36.4%</a:t>
+                        <a:t>+36.3%</a:t>
                       </a:r>
                     </a:p>
                   </a:txBody>
@@ -46397,7 +46234,7 @@
                           </a:solidFill>
                           <a:latin typeface="Kanit"/>
                         </a:rPr>
-                        <a:t>+29.9%</a:t>
+                        <a:t>+29.8%</a:t>
                       </a:r>
                     </a:p>
                   </a:txBody>
@@ -46573,8 +46410,8 @@
                 </a:solidFill>
                 <a:latin typeface="Kanit"/>
               </a:rPr>
-              <a:t>•  ราคาหน้าฟาร์ม: ยางพารา +41% มันสำปะหลัง +59% ปาล์ม +28% ข้าว +13% รายได้จากพืชเพิ่มขึ้นทุกภาค
-•  มีสี่จังหวัดที่ลดลง — ทั้งหมดเป็นมะพร้าว และอยู่ฝั่งอ่าวไทยตะวันตก ราคามะพร้าวลดลง 70%
+              <a:t>•  ราคาหน้าฟาร์ม: ยางพารา +41% มันสำปะหลัง +59% ปาล์ม +27% ข้าว +13% รายได้จากพืชเพิ่มขึ้นทุกภาค
+•  มีสี่จังหวัดที่ลดลง — ทั้งหมดเป็นมะพร้าว และอยู่ฝั่งอ่าวไทยตะวันตก ราคามะพร้าวลดลง 69%
 •  กำไรบนกระดาษยังไม่ใช่เงินสด — ตารางถัดไปหักราคาด้วยต้นทุน</a:t>
             </a:r>
           </a:p>
@@ -46876,7 +46713,7 @@
                           </a:solidFill>
                           <a:latin typeface="Kanit"/>
                         </a:rPr>
-                        <a:t>+15.5%</a:t>
+                        <a:t>+15.7%</a:t>
                       </a:r>
                     </a:p>
                   </a:txBody>
@@ -47039,7 +46876,7 @@
                           </a:solidFill>
                           <a:latin typeface="Kanit"/>
                         </a:rPr>
-                        <a:t>+20.1%</a:t>
+                        <a:t>+20.2%</a:t>
                       </a:r>
                     </a:p>
                   </a:txBody>
@@ -47202,7 +47039,7 @@
                           </a:solidFill>
                           <a:latin typeface="Kanit"/>
                         </a:rPr>
-                        <a:t>+10.0%</a:t>
+                        <a:t>+10.2%</a:t>
                       </a:r>
                     </a:p>
                   </a:txBody>
@@ -47365,7 +47202,7 @@
                           </a:solidFill>
                           <a:latin typeface="Kanit"/>
                         </a:rPr>
-                        <a:t>+34.9%</a:t>
+                        <a:t>+34.8%</a:t>
                       </a:r>
                     </a:p>
                   </a:txBody>
@@ -47528,7 +47365,7 @@
                           </a:solidFill>
                           <a:latin typeface="Kanit"/>
                         </a:rPr>
-                        <a:t>+15.9%</a:t>
+                        <a:t>+16.1%</a:t>
                       </a:r>
                     </a:p>
                   </a:txBody>
@@ -47691,7 +47528,7 @@
                           </a:solidFill>
                           <a:latin typeface="Kanit"/>
                         </a:rPr>
-                        <a:t>+14.8%</a:t>
+                        <a:t>+15.0%</a:t>
                       </a:r>
                     </a:p>
                   </a:txBody>
@@ -48318,7 +48155,7 @@
                 </a:solidFill>
                 <a:latin typeface="Kanit"/>
               </a:rPr>
-              <a:t>สามรายการมีทิศทางไม่ตรงกันระหว่างเทียบปีก่อนกับหกเดือน ตัวเลขรายปีเพียงตัวเดียวจึงอาจชี้ผิดทางได้</a:t>
+              <a:t>สี่รายการมีทิศทางไม่ตรงกันระหว่างเทียบปีก่อนกับหกเดือน ตัวเลขรายปีเพียงตัวเดียวจึงอาจชี้ผิดทางได้</a:t>
             </a:r>
           </a:p>
         </p:txBody>
@@ -48513,7 +48350,7 @@
                 </a:solidFill>
                 <a:latin typeface="Kanit"/>
               </a:rPr>
-              <a:t>เทียบปีก่อน −69.7%</a:t>
+              <a:t>เทียบปีก่อน −69.3%</a:t>
             </a:r>
           </a:p>
         </p:txBody>
@@ -49149,7 +48986,7 @@
                 </a:solidFill>
                 <a:latin typeface="Kanit"/>
               </a:rPr>
-              <a:t>เทียบปีก่อน −3.5%</a:t>
+              <a:t>เทียบปีก่อน −3.2%</a:t>
             </a:r>
           </a:p>
         </p:txBody>
@@ -49467,7 +49304,7 @@
                 </a:solidFill>
                 <a:latin typeface="Kanit"/>
               </a:rPr>
-              <a:t>เทียบปีก่อน −1.8%</a:t>
+              <a:t>เทียบปีก่อน −1.5%</a:t>
             </a:r>
           </a:p>
         </p:txBody>
@@ -49707,6 +49544,324 @@
                 </a:solidFill>
                 <a:latin typeface="Kanit"/>
               </a:rPr>
+              <a:t>ไข่ไก่</a:t>
+            </a:r>
+          </a:p>
+        </p:txBody>
+      </p:sp>
+      <p:sp>
+        <p:nvSpPr>
+          <p:cNvPr id="44" name="TextBox 43"/>
+          <p:cNvSpPr txBox="1"/>
+          <p:nvPr/>
+        </p:nvSpPr>
+        <p:spPr>
+          <a:xfrm>
+            <a:off x="9621316" y="2112263"/>
+            <a:ext cx="2156155" cy="125730"/>
+          </a:xfrm>
+          <a:prstGeom prst="rect">
+            <a:avLst/>
+          </a:prstGeom>
+          <a:noFill/>
+        </p:spPr>
+        <p:txBody>
+          <a:bodyPr wrap="square" lIns="0" rIns="0" tIns="0" bIns="0" anchor="t">
+            <a:noAutofit/>
+          </a:bodyPr>
+          <a:lstStyle/>
+          <a:p>
+            <a:pPr algn="l">
+              <a:lnSpc>
+                <a:spcPts val="990"/>
+              </a:lnSpc>
+            </a:pPr>
+            <a:r>
+              <a:rPr sz="750" b="0">
+                <a:solidFill>
+                  <a:srgbClr val="606060"/>
+                </a:solidFill>
+                <a:latin typeface="Kanit"/>
+              </a:rPr>
+              <a:t>฿338.24 /ร้อยฟอง · กลาง·ตอ.</a:t>
+            </a:r>
+          </a:p>
+        </p:txBody>
+      </p:sp>
+      <p:sp>
+        <p:nvSpPr>
+          <p:cNvPr id="45" name="TextBox 44"/>
+          <p:cNvSpPr txBox="1"/>
+          <p:nvPr/>
+        </p:nvSpPr>
+        <p:spPr>
+          <a:xfrm>
+            <a:off x="9621316" y="2244851"/>
+            <a:ext cx="1078077" cy="134112"/>
+          </a:xfrm>
+          <a:prstGeom prst="rect">
+            <a:avLst/>
+          </a:prstGeom>
+          <a:noFill/>
+        </p:spPr>
+        <p:txBody>
+          <a:bodyPr wrap="square" lIns="0" rIns="0" tIns="0" bIns="0" anchor="t">
+            <a:noAutofit/>
+          </a:bodyPr>
+          <a:lstStyle/>
+          <a:p>
+            <a:pPr algn="l">
+              <a:lnSpc>
+                <a:spcPts val="1056"/>
+              </a:lnSpc>
+            </a:pPr>
+            <a:r>
+              <a:rPr sz="800" b="1">
+                <a:solidFill>
+                  <a:srgbClr val="606060"/>
+                </a:solidFill>
+                <a:latin typeface="Kanit"/>
+              </a:rPr>
+              <a:t>เทียบปีก่อน +0.0%</a:t>
+            </a:r>
+          </a:p>
+        </p:txBody>
+      </p:sp>
+      <p:sp>
+        <p:nvSpPr>
+          <p:cNvPr id="46" name="TextBox 45"/>
+          <p:cNvSpPr txBox="1"/>
+          <p:nvPr/>
+        </p:nvSpPr>
+        <p:spPr>
+          <a:xfrm>
+            <a:off x="10699394" y="2244851"/>
+            <a:ext cx="1078077" cy="134112"/>
+          </a:xfrm>
+          <a:prstGeom prst="rect">
+            <a:avLst/>
+          </a:prstGeom>
+          <a:noFill/>
+        </p:spPr>
+        <p:txBody>
+          <a:bodyPr wrap="square" lIns="0" rIns="0" tIns="0" bIns="0" anchor="t">
+            <a:noAutofit/>
+          </a:bodyPr>
+          <a:lstStyle/>
+          <a:p>
+            <a:pPr algn="l">
+              <a:lnSpc>
+                <a:spcPts val="1056"/>
+              </a:lnSpc>
+            </a:pPr>
+            <a:r>
+              <a:rPr sz="800" b="1">
+                <a:solidFill>
+                  <a:srgbClr val="15795F"/>
+                </a:solidFill>
+                <a:latin typeface="Kanit"/>
+              </a:rPr>
+              <a:t>6 เดือน +5.0%</a:t>
+            </a:r>
+          </a:p>
+        </p:txBody>
+      </p:sp>
+      <p:sp>
+        <p:nvSpPr>
+          <p:cNvPr id="47" name="Rectangle 46"/>
+          <p:cNvSpPr/>
+          <p:nvPr/>
+        </p:nvSpPr>
+        <p:spPr>
+          <a:xfrm>
+            <a:off x="9621316" y="2400300"/>
+            <a:ext cx="2156155" cy="548640"/>
+          </a:xfrm>
+          <a:prstGeom prst="rect">
+            <a:avLst/>
+          </a:prstGeom>
+          <a:solidFill>
+            <a:srgbClr val="FBFCFE"/>
+          </a:solidFill>
+          <a:ln w="9525">
+            <a:solidFill>
+              <a:srgbClr val="D9DEE9"/>
+            </a:solidFill>
+          </a:ln>
+          <a:effectLst/>
+        </p:spPr>
+        <p:style>
+          <a:lnRef idx="1">
+            <a:schemeClr val="accent1"/>
+          </a:lnRef>
+          <a:fillRef idx="3">
+            <a:schemeClr val="accent1"/>
+          </a:fillRef>
+          <a:effectRef idx="2">
+            <a:schemeClr val="accent1"/>
+          </a:effectRef>
+          <a:fontRef idx="minor">
+            <a:schemeClr val="lt1"/>
+          </a:fontRef>
+        </p:style>
+        <p:txBody>
+          <a:bodyPr rtlCol="0" anchor="ctr" wrap="none"/>
+          <a:lstStyle/>
+          <a:p>
+            <a:pPr algn="ctr"/>
+          </a:p>
+        </p:txBody>
+      </p:sp>
+      <p:sp>
+        <p:nvSpPr>
+          <p:cNvPr id="48" name="Freeform 47"/>
+          <p:cNvSpPr/>
+          <p:nvPr/>
+        </p:nvSpPr>
+        <p:spPr>
+          <a:xfrm>
+            <a:off x="9667036" y="2446020"/>
+            <a:ext cx="2064715" cy="457200"/>
+          </a:xfrm>
+          <a:custGeom>
+            <a:avLst/>
+            <a:gdLst/>
+            <a:ahLst/>
+            <a:cxnLst/>
+            <a:rect l="l" t="t" r="r" b="b"/>
+            <a:pathLst>
+              <a:path w="2064715" h="457200">
+                <a:moveTo>
+                  <a:pt x="0" y="457200"/>
+                </a:moveTo>
+                <a:lnTo>
+                  <a:pt x="412943" y="391702"/>
+                </a:lnTo>
+                <a:lnTo>
+                  <a:pt x="825886" y="105409"/>
+                </a:lnTo>
+                <a:lnTo>
+                  <a:pt x="1238829" y="105409"/>
+                </a:lnTo>
+                <a:lnTo>
+                  <a:pt x="1651772" y="214144"/>
+                </a:lnTo>
+                <a:lnTo>
+                  <a:pt x="2064715" y="0"/>
+                </a:lnTo>
+              </a:path>
+            </a:pathLst>
+          </a:custGeom>
+          <a:noFill/>
+          <a:ln w="20320">
+            <a:solidFill>
+              <a:srgbClr val="15795F"/>
+            </a:solidFill>
+          </a:ln>
+          <a:effectLst/>
+        </p:spPr>
+        <p:style>
+          <a:lnRef idx="1">
+            <a:schemeClr val="accent1"/>
+          </a:lnRef>
+          <a:fillRef idx="3">
+            <a:schemeClr val="accent1"/>
+          </a:fillRef>
+          <a:effectRef idx="2">
+            <a:schemeClr val="accent1"/>
+          </a:effectRef>
+          <a:fontRef idx="minor">
+            <a:schemeClr val="lt1"/>
+          </a:fontRef>
+        </p:style>
+        <p:txBody>
+          <a:bodyPr rtlCol="0" anchor="ctr"/>
+          <a:lstStyle/>
+          <a:p>
+            <a:pPr algn="ctr"/>
+          </a:p>
+        </p:txBody>
+      </p:sp>
+      <p:sp>
+        <p:nvSpPr>
+          <p:cNvPr id="49" name="Rounded Rectangle 48"/>
+          <p:cNvSpPr/>
+          <p:nvPr/>
+        </p:nvSpPr>
+        <p:spPr>
+          <a:xfrm>
+            <a:off x="11690603" y="2404872"/>
+            <a:ext cx="82296" cy="82296"/>
+          </a:xfrm>
+          <a:prstGeom prst="roundRect">
+            <a:avLst>
+              <a:gd name="adj" fmla="val 50000"/>
+            </a:avLst>
+          </a:prstGeom>
+          <a:solidFill>
+            <a:srgbClr val="15795F"/>
+          </a:solidFill>
+          <a:ln>
+            <a:noFill/>
+          </a:ln>
+          <a:effectLst/>
+        </p:spPr>
+        <p:style>
+          <a:lnRef idx="1">
+            <a:schemeClr val="accent1"/>
+          </a:lnRef>
+          <a:fillRef idx="3">
+            <a:schemeClr val="accent1"/>
+          </a:fillRef>
+          <a:effectRef idx="2">
+            <a:schemeClr val="accent1"/>
+          </a:effectRef>
+          <a:fontRef idx="minor">
+            <a:schemeClr val="lt1"/>
+          </a:fontRef>
+        </p:style>
+        <p:txBody>
+          <a:bodyPr rtlCol="0" anchor="ctr" wrap="none"/>
+          <a:lstStyle/>
+          <a:p>
+            <a:pPr algn="ctr"/>
+          </a:p>
+        </p:txBody>
+      </p:sp>
+      <p:sp>
+        <p:nvSpPr>
+          <p:cNvPr id="50" name="TextBox 49"/>
+          <p:cNvSpPr txBox="1"/>
+          <p:nvPr/>
+        </p:nvSpPr>
+        <p:spPr>
+          <a:xfrm>
+            <a:off x="411480" y="3076956"/>
+            <a:ext cx="2156155" cy="150876"/>
+          </a:xfrm>
+          <a:prstGeom prst="rect">
+            <a:avLst/>
+          </a:prstGeom>
+          <a:noFill/>
+        </p:spPr>
+        <p:txBody>
+          <a:bodyPr wrap="square" lIns="0" rIns="0" tIns="0" bIns="0" anchor="t">
+            <a:noAutofit/>
+          </a:bodyPr>
+          <a:lstStyle/>
+          <a:p>
+            <a:pPr algn="l">
+              <a:lnSpc>
+                <a:spcPts val="1188"/>
+              </a:lnSpc>
+            </a:pPr>
+            <a:r>
+              <a:rPr sz="900" b="1">
+                <a:solidFill>
+                  <a:srgbClr val="1E2F5C"/>
+                </a:solidFill>
+                <a:latin typeface="Kanit"/>
+              </a:rPr>
               <a:t>ไก่เนื้อ</a:t>
             </a:r>
           </a:p>
@@ -49714,13 +49869,13 @@
       </p:sp>
       <p:sp>
         <p:nvSpPr>
-          <p:cNvPr id="44" name="TextBox 43"/>
+          <p:cNvPr id="51" name="TextBox 50"/>
           <p:cNvSpPr txBox="1"/>
           <p:nvPr/>
         </p:nvSpPr>
         <p:spPr>
           <a:xfrm>
-            <a:off x="9621316" y="2112263"/>
+            <a:off x="411480" y="3218687"/>
             <a:ext cx="2156155" cy="125730"/>
           </a:xfrm>
           <a:prstGeom prst="rect">
@@ -49753,13 +49908,13 @@
       </p:sp>
       <p:sp>
         <p:nvSpPr>
-          <p:cNvPr id="45" name="TextBox 44"/>
+          <p:cNvPr id="52" name="TextBox 51"/>
           <p:cNvSpPr txBox="1"/>
           <p:nvPr/>
         </p:nvSpPr>
         <p:spPr>
           <a:xfrm>
-            <a:off x="9621316" y="2244851"/>
+            <a:off x="411480" y="3351275"/>
             <a:ext cx="1078077" cy="134112"/>
           </a:xfrm>
           <a:prstGeom prst="rect">
@@ -49781,24 +49936,24 @@
             <a:r>
               <a:rPr sz="800" b="1">
                 <a:solidFill>
-                  <a:srgbClr val="CC0000"/>
+                  <a:srgbClr val="15795F"/>
                 </a:solidFill>
                 <a:latin typeface="Kanit"/>
               </a:rPr>
-              <a:t>เทียบปีก่อน −0.1%</a:t>
+              <a:t>เทียบปีก่อน +0.1%</a:t>
             </a:r>
           </a:p>
         </p:txBody>
       </p:sp>
       <p:sp>
         <p:nvSpPr>
-          <p:cNvPr id="46" name="TextBox 45"/>
+          <p:cNvPr id="53" name="TextBox 52"/>
           <p:cNvSpPr txBox="1"/>
           <p:nvPr/>
         </p:nvSpPr>
         <p:spPr>
           <a:xfrm>
-            <a:off x="10699394" y="2244851"/>
+            <a:off x="1489557" y="3351275"/>
             <a:ext cx="1078077" cy="134112"/>
           </a:xfrm>
           <a:prstGeom prst="rect">
@@ -49831,13 +49986,13 @@
       </p:sp>
       <p:sp>
         <p:nvSpPr>
-          <p:cNvPr id="47" name="Rectangle 46"/>
+          <p:cNvPr id="54" name="Rectangle 53"/>
           <p:cNvSpPr/>
           <p:nvPr/>
         </p:nvSpPr>
         <p:spPr>
           <a:xfrm>
-            <a:off x="9621316" y="2400300"/>
+            <a:off x="411480" y="3506724"/>
             <a:ext cx="2156155" cy="548640"/>
           </a:xfrm>
           <a:prstGeom prst="rect">
@@ -49877,13 +50032,13 @@
       </p:sp>
       <p:sp>
         <p:nvSpPr>
-          <p:cNvPr id="48" name="Freeform 47"/>
+          <p:cNvPr id="55" name="Freeform 54"/>
           <p:cNvSpPr/>
           <p:nvPr/>
         </p:nvSpPr>
         <p:spPr>
           <a:xfrm>
-            <a:off x="9667036" y="2446020"/>
+            <a:off x="457200" y="3552444"/>
             <a:ext cx="2064715" cy="457200"/>
           </a:xfrm>
           <a:custGeom>
@@ -49947,13 +50102,13 @@
       </p:sp>
       <p:sp>
         <p:nvSpPr>
-          <p:cNvPr id="49" name="Rounded Rectangle 48"/>
+          <p:cNvPr id="56" name="Rounded Rectangle 55"/>
           <p:cNvSpPr/>
           <p:nvPr/>
         </p:nvSpPr>
         <p:spPr>
           <a:xfrm>
-            <a:off x="11690603" y="2680208"/>
+            <a:off x="2480767" y="3786632"/>
             <a:ext cx="82296" cy="82296"/>
           </a:xfrm>
           <a:prstGeom prst="roundRect">
@@ -49993,13 +50148,13 @@
       </p:sp>
       <p:sp>
         <p:nvSpPr>
-          <p:cNvPr id="50" name="TextBox 49"/>
+          <p:cNvPr id="57" name="TextBox 56"/>
           <p:cNvSpPr txBox="1"/>
           <p:nvPr/>
         </p:nvSpPr>
         <p:spPr>
           <a:xfrm>
-            <a:off x="411480" y="3076956"/>
+            <a:off x="2713939" y="3076956"/>
             <a:ext cx="2156155" cy="150876"/>
           </a:xfrm>
           <a:prstGeom prst="rect">
@@ -50025,20 +50180,20 @@
                 </a:solidFill>
                 <a:latin typeface="Kanit"/>
               </a:rPr>
-              <a:t>ไข่ไก่</a:t>
+              <a:t>ข้าวโพดเลี้ยงสัตว์</a:t>
             </a:r>
           </a:p>
         </p:txBody>
       </p:sp>
       <p:sp>
         <p:nvSpPr>
-          <p:cNvPr id="51" name="TextBox 50"/>
+          <p:cNvPr id="58" name="TextBox 57"/>
           <p:cNvSpPr txBox="1"/>
           <p:nvPr/>
         </p:nvSpPr>
         <p:spPr>
           <a:xfrm>
-            <a:off x="411480" y="3218687"/>
+            <a:off x="2713939" y="3218687"/>
             <a:ext cx="2156155" cy="125730"/>
           </a:xfrm>
           <a:prstGeom prst="rect">
@@ -50064,59 +50219,20 @@
                 </a:solidFill>
                 <a:latin typeface="Kanit"/>
               </a:rPr>
-              <a:t>฿338.24 /ร้อยฟอง · กลาง·ตอ.</a:t>
+              <a:t>฿10.76 /กก. · เหนือ</a:t>
             </a:r>
           </a:p>
         </p:txBody>
       </p:sp>
       <p:sp>
         <p:nvSpPr>
-          <p:cNvPr id="52" name="TextBox 51"/>
+          <p:cNvPr id="59" name="TextBox 58"/>
           <p:cNvSpPr txBox="1"/>
           <p:nvPr/>
         </p:nvSpPr>
         <p:spPr>
           <a:xfrm>
-            <a:off x="411480" y="3351275"/>
-            <a:ext cx="1078077" cy="134112"/>
-          </a:xfrm>
-          <a:prstGeom prst="rect">
-            <a:avLst/>
-          </a:prstGeom>
-          <a:noFill/>
-        </p:spPr>
-        <p:txBody>
-          <a:bodyPr wrap="square" lIns="0" rIns="0" tIns="0" bIns="0" anchor="t">
-            <a:noAutofit/>
-          </a:bodyPr>
-          <a:lstStyle/>
-          <a:p>
-            <a:pPr algn="l">
-              <a:lnSpc>
-                <a:spcPts val="1056"/>
-              </a:lnSpc>
-            </a:pPr>
-            <a:r>
-              <a:rPr sz="800" b="1">
-                <a:solidFill>
-                  <a:srgbClr val="606060"/>
-                </a:solidFill>
-                <a:latin typeface="Kanit"/>
-              </a:rPr>
-              <a:t>เทียบปีก่อน +0.0%</a:t>
-            </a:r>
-          </a:p>
-        </p:txBody>
-      </p:sp>
-      <p:sp>
-        <p:nvSpPr>
-          <p:cNvPr id="53" name="TextBox 52"/>
-          <p:cNvSpPr txBox="1"/>
-          <p:nvPr/>
-        </p:nvSpPr>
-        <p:spPr>
-          <a:xfrm>
-            <a:off x="1489557" y="3351275"/>
+            <a:off x="2713939" y="3351275"/>
             <a:ext cx="1078077" cy="134112"/>
           </a:xfrm>
           <a:prstGeom prst="rect">
@@ -50142,20 +50258,59 @@
                 </a:solidFill>
                 <a:latin typeface="Kanit"/>
               </a:rPr>
-              <a:t>6 เดือน +5.0%</a:t>
+              <a:t>เทียบปีก่อน +13.3%</a:t>
             </a:r>
           </a:p>
         </p:txBody>
       </p:sp>
       <p:sp>
         <p:nvSpPr>
-          <p:cNvPr id="54" name="Rectangle 53"/>
+          <p:cNvPr id="60" name="TextBox 59"/>
+          <p:cNvSpPr txBox="1"/>
+          <p:nvPr/>
+        </p:nvSpPr>
+        <p:spPr>
+          <a:xfrm>
+            <a:off x="3792016" y="3351275"/>
+            <a:ext cx="1078077" cy="134112"/>
+          </a:xfrm>
+          <a:prstGeom prst="rect">
+            <a:avLst/>
+          </a:prstGeom>
+          <a:noFill/>
+        </p:spPr>
+        <p:txBody>
+          <a:bodyPr wrap="square" lIns="0" rIns="0" tIns="0" bIns="0" anchor="t">
+            <a:noAutofit/>
+          </a:bodyPr>
+          <a:lstStyle/>
+          <a:p>
+            <a:pPr algn="l">
+              <a:lnSpc>
+                <a:spcPts val="1056"/>
+              </a:lnSpc>
+            </a:pPr>
+            <a:r>
+              <a:rPr sz="800" b="1">
+                <a:solidFill>
+                  <a:srgbClr val="15795F"/>
+                </a:solidFill>
+                <a:latin typeface="Kanit"/>
+              </a:rPr>
+              <a:t>6 เดือน +22.1%</a:t>
+            </a:r>
+          </a:p>
+        </p:txBody>
+      </p:sp>
+      <p:sp>
+        <p:nvSpPr>
+          <p:cNvPr id="61" name="Rectangle 60"/>
           <p:cNvSpPr/>
           <p:nvPr/>
         </p:nvSpPr>
         <p:spPr>
           <a:xfrm>
-            <a:off x="411480" y="3506724"/>
+            <a:off x="2713939" y="3506724"/>
             <a:ext cx="2156155" cy="548640"/>
           </a:xfrm>
           <a:prstGeom prst="rect">
@@ -50195,13 +50350,13 @@
       </p:sp>
       <p:sp>
         <p:nvSpPr>
-          <p:cNvPr id="55" name="Freeform 54"/>
+          <p:cNvPr id="62" name="Freeform 61"/>
           <p:cNvSpPr/>
           <p:nvPr/>
         </p:nvSpPr>
         <p:spPr>
           <a:xfrm>
-            <a:off x="457200" y="3552444"/>
+            <a:off x="2759659" y="3552444"/>
             <a:ext cx="2064715" cy="457200"/>
           </a:xfrm>
           <a:custGeom>
@@ -50216,19 +50371,19 @@
                   <a:pt x="0" y="457200"/>
                 </a:moveTo>
                 <a:lnTo>
-                  <a:pt x="412943" y="391702"/>
-                </a:lnTo>
-                <a:lnTo>
-                  <a:pt x="825886" y="105409"/>
-                </a:lnTo>
-                <a:lnTo>
-                  <a:pt x="1238829" y="105409"/>
-                </a:lnTo>
-                <a:lnTo>
-                  <a:pt x="1651772" y="214144"/>
-                </a:lnTo>
-                <a:lnTo>
-                  <a:pt x="2064715" y="0"/>
+                  <a:pt x="412943" y="415234"/>
+                </a:lnTo>
+                <a:lnTo>
+                  <a:pt x="825886" y="315843"/>
+                </a:lnTo>
+                <a:lnTo>
+                  <a:pt x="1238829" y="81721"/>
+                </a:lnTo>
+                <a:lnTo>
+                  <a:pt x="1651772" y="0"/>
+                </a:lnTo>
+                <a:lnTo>
+                  <a:pt x="2064715" y="46382"/>
                 </a:lnTo>
               </a:path>
             </a:pathLst>
@@ -50265,13 +50420,13 @@
       </p:sp>
       <p:sp>
         <p:nvSpPr>
-          <p:cNvPr id="56" name="Rounded Rectangle 55"/>
+          <p:cNvPr id="63" name="Rounded Rectangle 62"/>
           <p:cNvSpPr/>
           <p:nvPr/>
         </p:nvSpPr>
         <p:spPr>
           <a:xfrm>
-            <a:off x="2480767" y="3511296"/>
+            <a:off x="4783226" y="3557678"/>
             <a:ext cx="82296" cy="82296"/>
           </a:xfrm>
           <a:prstGeom prst="roundRect">
@@ -50311,13 +50466,13 @@
       </p:sp>
       <p:sp>
         <p:nvSpPr>
-          <p:cNvPr id="57" name="TextBox 56"/>
+          <p:cNvPr id="64" name="TextBox 63"/>
           <p:cNvSpPr txBox="1"/>
           <p:nvPr/>
         </p:nvSpPr>
         <p:spPr>
           <a:xfrm>
-            <a:off x="2713939" y="3076956"/>
+            <a:off x="5016398" y="3076956"/>
             <a:ext cx="2156155" cy="150876"/>
           </a:xfrm>
           <a:prstGeom prst="rect">
@@ -50350,13 +50505,13 @@
       </p:sp>
       <p:sp>
         <p:nvSpPr>
-          <p:cNvPr id="58" name="TextBox 57"/>
+          <p:cNvPr id="65" name="TextBox 64"/>
           <p:cNvSpPr txBox="1"/>
           <p:nvPr/>
         </p:nvSpPr>
         <p:spPr>
           <a:xfrm>
-            <a:off x="2713939" y="3218687"/>
+            <a:off x="5016398" y="3218687"/>
             <a:ext cx="2156155" cy="125730"/>
           </a:xfrm>
           <a:prstGeom prst="rect">
@@ -50389,13 +50544,13 @@
       </p:sp>
       <p:sp>
         <p:nvSpPr>
-          <p:cNvPr id="59" name="TextBox 58"/>
+          <p:cNvPr id="66" name="TextBox 65"/>
           <p:cNvSpPr txBox="1"/>
           <p:nvPr/>
         </p:nvSpPr>
         <p:spPr>
           <a:xfrm>
-            <a:off x="2713939" y="3351275"/>
+            <a:off x="5016398" y="3351275"/>
             <a:ext cx="1078077" cy="134112"/>
           </a:xfrm>
           <a:prstGeom prst="rect">
@@ -50421,20 +50576,20 @@
                 </a:solidFill>
                 <a:latin typeface="Kanit"/>
               </a:rPr>
-              <a:t>เทียบปีก่อน +13.2%</a:t>
+              <a:t>เทียบปีก่อน +13.4%</a:t>
             </a:r>
           </a:p>
         </p:txBody>
       </p:sp>
       <p:sp>
         <p:nvSpPr>
-          <p:cNvPr id="60" name="TextBox 59"/>
+          <p:cNvPr id="67" name="TextBox 66"/>
           <p:cNvSpPr txBox="1"/>
           <p:nvPr/>
         </p:nvSpPr>
         <p:spPr>
           <a:xfrm>
-            <a:off x="3792016" y="3351275"/>
+            <a:off x="6094475" y="3351275"/>
             <a:ext cx="1078077" cy="134112"/>
           </a:xfrm>
           <a:prstGeom prst="rect">
@@ -50467,13 +50622,13 @@
       </p:sp>
       <p:sp>
         <p:nvSpPr>
-          <p:cNvPr id="61" name="Rectangle 60"/>
+          <p:cNvPr id="68" name="Rectangle 67"/>
           <p:cNvSpPr/>
           <p:nvPr/>
         </p:nvSpPr>
         <p:spPr>
           <a:xfrm>
-            <a:off x="2713939" y="3506724"/>
+            <a:off x="5016398" y="3506724"/>
             <a:ext cx="2156155" cy="548640"/>
           </a:xfrm>
           <a:prstGeom prst="rect">
@@ -50513,13 +50668,13 @@
       </p:sp>
       <p:sp>
         <p:nvSpPr>
-          <p:cNvPr id="62" name="Freeform 61"/>
+          <p:cNvPr id="69" name="Freeform 68"/>
           <p:cNvSpPr/>
           <p:nvPr/>
         </p:nvSpPr>
         <p:spPr>
           <a:xfrm>
-            <a:off x="2759659" y="3552444"/>
+            <a:off x="5062118" y="3552444"/>
             <a:ext cx="2064715" cy="457200"/>
           </a:xfrm>
           <a:custGeom>
@@ -50583,331 +50738,13 @@
       </p:sp>
       <p:sp>
         <p:nvSpPr>
-          <p:cNvPr id="63" name="Rounded Rectangle 62"/>
-          <p:cNvSpPr/>
-          <p:nvPr/>
-        </p:nvSpPr>
-        <p:spPr>
-          <a:xfrm>
-            <a:off x="4783226" y="3511296"/>
-            <a:ext cx="82296" cy="82296"/>
-          </a:xfrm>
-          <a:prstGeom prst="roundRect">
-            <a:avLst>
-              <a:gd name="adj" fmla="val 50000"/>
-            </a:avLst>
-          </a:prstGeom>
-          <a:solidFill>
-            <a:srgbClr val="15795F"/>
-          </a:solidFill>
-          <a:ln>
-            <a:noFill/>
-          </a:ln>
-          <a:effectLst/>
-        </p:spPr>
-        <p:style>
-          <a:lnRef idx="1">
-            <a:schemeClr val="accent1"/>
-          </a:lnRef>
-          <a:fillRef idx="3">
-            <a:schemeClr val="accent1"/>
-          </a:fillRef>
-          <a:effectRef idx="2">
-            <a:schemeClr val="accent1"/>
-          </a:effectRef>
-          <a:fontRef idx="minor">
-            <a:schemeClr val="lt1"/>
-          </a:fontRef>
-        </p:style>
-        <p:txBody>
-          <a:bodyPr rtlCol="0" anchor="ctr" wrap="none"/>
-          <a:lstStyle/>
-          <a:p>
-            <a:pPr algn="ctr"/>
-          </a:p>
-        </p:txBody>
-      </p:sp>
-      <p:sp>
-        <p:nvSpPr>
-          <p:cNvPr id="64" name="TextBox 63"/>
-          <p:cNvSpPr txBox="1"/>
-          <p:nvPr/>
-        </p:nvSpPr>
-        <p:spPr>
-          <a:xfrm>
-            <a:off x="5016398" y="3076956"/>
-            <a:ext cx="2156155" cy="150876"/>
-          </a:xfrm>
-          <a:prstGeom prst="rect">
-            <a:avLst/>
-          </a:prstGeom>
-          <a:noFill/>
-        </p:spPr>
-        <p:txBody>
-          <a:bodyPr wrap="square" lIns="0" rIns="0" tIns="0" bIns="0" anchor="t">
-            <a:noAutofit/>
-          </a:bodyPr>
-          <a:lstStyle/>
-          <a:p>
-            <a:pPr algn="l">
-              <a:lnSpc>
-                <a:spcPts val="1188"/>
-              </a:lnSpc>
-            </a:pPr>
-            <a:r>
-              <a:rPr sz="900" b="1">
-                <a:solidFill>
-                  <a:srgbClr val="1E2F5C"/>
-                </a:solidFill>
-                <a:latin typeface="Kanit"/>
-              </a:rPr>
-              <a:t>ข้าวโพดเลี้ยงสัตว์</a:t>
-            </a:r>
-          </a:p>
-        </p:txBody>
-      </p:sp>
-      <p:sp>
-        <p:nvSpPr>
-          <p:cNvPr id="65" name="TextBox 64"/>
-          <p:cNvSpPr txBox="1"/>
-          <p:nvPr/>
-        </p:nvSpPr>
-        <p:spPr>
-          <a:xfrm>
-            <a:off x="5016398" y="3218687"/>
-            <a:ext cx="2156155" cy="125730"/>
-          </a:xfrm>
-          <a:prstGeom prst="rect">
-            <a:avLst/>
-          </a:prstGeom>
-          <a:noFill/>
-        </p:spPr>
-        <p:txBody>
-          <a:bodyPr wrap="square" lIns="0" rIns="0" tIns="0" bIns="0" anchor="t">
-            <a:noAutofit/>
-          </a:bodyPr>
-          <a:lstStyle/>
-          <a:p>
-            <a:pPr algn="l">
-              <a:lnSpc>
-                <a:spcPts val="990"/>
-              </a:lnSpc>
-            </a:pPr>
-            <a:r>
-              <a:rPr sz="750" b="0">
-                <a:solidFill>
-                  <a:srgbClr val="606060"/>
-                </a:solidFill>
-                <a:latin typeface="Kanit"/>
-              </a:rPr>
-              <a:t>฿10.76 /กก. · เหนือ</a:t>
-            </a:r>
-          </a:p>
-        </p:txBody>
-      </p:sp>
-      <p:sp>
-        <p:nvSpPr>
-          <p:cNvPr id="66" name="TextBox 65"/>
-          <p:cNvSpPr txBox="1"/>
-          <p:nvPr/>
-        </p:nvSpPr>
-        <p:spPr>
-          <a:xfrm>
-            <a:off x="5016398" y="3351275"/>
-            <a:ext cx="1078077" cy="134112"/>
-          </a:xfrm>
-          <a:prstGeom prst="rect">
-            <a:avLst/>
-          </a:prstGeom>
-          <a:noFill/>
-        </p:spPr>
-        <p:txBody>
-          <a:bodyPr wrap="square" lIns="0" rIns="0" tIns="0" bIns="0" anchor="t">
-            <a:noAutofit/>
-          </a:bodyPr>
-          <a:lstStyle/>
-          <a:p>
-            <a:pPr algn="l">
-              <a:lnSpc>
-                <a:spcPts val="1056"/>
-              </a:lnSpc>
-            </a:pPr>
-            <a:r>
-              <a:rPr sz="800" b="1">
-                <a:solidFill>
-                  <a:srgbClr val="15795F"/>
-                </a:solidFill>
-                <a:latin typeface="Kanit"/>
-              </a:rPr>
-              <a:t>เทียบปีก่อน +13.4%</a:t>
-            </a:r>
-          </a:p>
-        </p:txBody>
-      </p:sp>
-      <p:sp>
-        <p:nvSpPr>
-          <p:cNvPr id="67" name="TextBox 66"/>
-          <p:cNvSpPr txBox="1"/>
-          <p:nvPr/>
-        </p:nvSpPr>
-        <p:spPr>
-          <a:xfrm>
-            <a:off x="6094475" y="3351275"/>
-            <a:ext cx="1078077" cy="134112"/>
-          </a:xfrm>
-          <a:prstGeom prst="rect">
-            <a:avLst/>
-          </a:prstGeom>
-          <a:noFill/>
-        </p:spPr>
-        <p:txBody>
-          <a:bodyPr wrap="square" lIns="0" rIns="0" tIns="0" bIns="0" anchor="t">
-            <a:noAutofit/>
-          </a:bodyPr>
-          <a:lstStyle/>
-          <a:p>
-            <a:pPr algn="l">
-              <a:lnSpc>
-                <a:spcPts val="1056"/>
-              </a:lnSpc>
-            </a:pPr>
-            <a:r>
-              <a:rPr sz="800" b="1">
-                <a:solidFill>
-                  <a:srgbClr val="15795F"/>
-                </a:solidFill>
-                <a:latin typeface="Kanit"/>
-              </a:rPr>
-              <a:t>6 เดือน +22.1%</a:t>
-            </a:r>
-          </a:p>
-        </p:txBody>
-      </p:sp>
-      <p:sp>
-        <p:nvSpPr>
-          <p:cNvPr id="68" name="Rectangle 67"/>
-          <p:cNvSpPr/>
-          <p:nvPr/>
-        </p:nvSpPr>
-        <p:spPr>
-          <a:xfrm>
-            <a:off x="5016398" y="3506724"/>
-            <a:ext cx="2156155" cy="548640"/>
-          </a:xfrm>
-          <a:prstGeom prst="rect">
-            <a:avLst/>
-          </a:prstGeom>
-          <a:solidFill>
-            <a:srgbClr val="FBFCFE"/>
-          </a:solidFill>
-          <a:ln w="9525">
-            <a:solidFill>
-              <a:srgbClr val="D9DEE9"/>
-            </a:solidFill>
-          </a:ln>
-          <a:effectLst/>
-        </p:spPr>
-        <p:style>
-          <a:lnRef idx="1">
-            <a:schemeClr val="accent1"/>
-          </a:lnRef>
-          <a:fillRef idx="3">
-            <a:schemeClr val="accent1"/>
-          </a:fillRef>
-          <a:effectRef idx="2">
-            <a:schemeClr val="accent1"/>
-          </a:effectRef>
-          <a:fontRef idx="minor">
-            <a:schemeClr val="lt1"/>
-          </a:fontRef>
-        </p:style>
-        <p:txBody>
-          <a:bodyPr rtlCol="0" anchor="ctr" wrap="none"/>
-          <a:lstStyle/>
-          <a:p>
-            <a:pPr algn="ctr"/>
-          </a:p>
-        </p:txBody>
-      </p:sp>
-      <p:sp>
-        <p:nvSpPr>
-          <p:cNvPr id="69" name="Freeform 68"/>
-          <p:cNvSpPr/>
-          <p:nvPr/>
-        </p:nvSpPr>
-        <p:spPr>
-          <a:xfrm>
-            <a:off x="5062118" y="3552444"/>
-            <a:ext cx="2064715" cy="457200"/>
-          </a:xfrm>
-          <a:custGeom>
-            <a:avLst/>
-            <a:gdLst/>
-            <a:ahLst/>
-            <a:cxnLst/>
-            <a:rect l="l" t="t" r="r" b="b"/>
-            <a:pathLst>
-              <a:path w="2064715" h="457200">
-                <a:moveTo>
-                  <a:pt x="0" y="457200"/>
-                </a:moveTo>
-                <a:lnTo>
-                  <a:pt x="412943" y="415234"/>
-                </a:lnTo>
-                <a:lnTo>
-                  <a:pt x="825886" y="315843"/>
-                </a:lnTo>
-                <a:lnTo>
-                  <a:pt x="1238829" y="81721"/>
-                </a:lnTo>
-                <a:lnTo>
-                  <a:pt x="1651772" y="0"/>
-                </a:lnTo>
-                <a:lnTo>
-                  <a:pt x="2064715" y="46382"/>
-                </a:lnTo>
-              </a:path>
-            </a:pathLst>
-          </a:custGeom>
-          <a:noFill/>
-          <a:ln w="20320">
-            <a:solidFill>
-              <a:srgbClr val="15795F"/>
-            </a:solidFill>
-          </a:ln>
-          <a:effectLst/>
-        </p:spPr>
-        <p:style>
-          <a:lnRef idx="1">
-            <a:schemeClr val="accent1"/>
-          </a:lnRef>
-          <a:fillRef idx="3">
-            <a:schemeClr val="accent1"/>
-          </a:fillRef>
-          <a:effectRef idx="2">
-            <a:schemeClr val="accent1"/>
-          </a:effectRef>
-          <a:fontRef idx="minor">
-            <a:schemeClr val="lt1"/>
-          </a:fontRef>
-        </p:style>
-        <p:txBody>
-          <a:bodyPr rtlCol="0" anchor="ctr"/>
-          <a:lstStyle/>
-          <a:p>
-            <a:pPr algn="ctr"/>
-          </a:p>
-        </p:txBody>
-      </p:sp>
-      <p:sp>
-        <p:nvSpPr>
           <p:cNvPr id="70" name="Rounded Rectangle 69"/>
           <p:cNvSpPr/>
           <p:nvPr/>
         </p:nvSpPr>
         <p:spPr>
           <a:xfrm>
-            <a:off x="7085685" y="3557678"/>
+            <a:off x="7085685" y="3511296"/>
             <a:ext cx="82296" cy="82296"/>
           </a:xfrm>
           <a:prstGeom prst="roundRect">
@@ -51057,7 +50894,7 @@
                 </a:solidFill>
                 <a:latin typeface="Kanit"/>
               </a:rPr>
-              <a:t>เทียบปีก่อน +27.5%</a:t>
+              <a:t>เทียบปีก่อน +27.3%</a:t>
             </a:r>
           </a:p>
         </p:txBody>
@@ -51375,7 +51212,7 @@
                 </a:solidFill>
                 <a:latin typeface="Kanit"/>
               </a:rPr>
-              <a:t>เทียบปีก่อน +41.2%</a:t>
+              <a:t>เทียบปีก่อน +41.1%</a:t>
             </a:r>
           </a:p>
         </p:txBody>
@@ -51693,7 +51530,7 @@
                 </a:solidFill>
                 <a:latin typeface="Kanit"/>
               </a:rPr>
-              <a:t>เทียบปีก่อน +58.8%</a:t>
+              <a:t>เทียบปีก่อน +59.3%</a:t>
             </a:r>
           </a:p>
         </p:txBody>
@@ -52011,7 +51848,7 @@
                 </a:solidFill>
                 <a:latin typeface="Kanit"/>
               </a:rPr>
-              <a:t>เทียบปีก่อน +75.6%</a:t>
+              <a:t>เทียบปีก่อน +94.7%</a:t>
             </a:r>
           </a:p>
         </p:txBody>
@@ -52375,7 +52212,7 @@
                 </a:solidFill>
                 <a:latin typeface="Kanit"/>
               </a:rPr>
-              <a:t>ราคาหน้าฟาร์ม วัดจริง — ราคารายวันของ NABC เฉลี่ยเป็นรายเดือน หน่วยเป็นบาทตามที่เผยแพร่ (ไม่มีการแปลงสกุลเงิน) ราคาล่าสุด 2026-08-03, รุ่นข้อมูลย้อนหลัง 2026-08-02 ราคาหน้าฟาร์ม (ราคาที่เกษตรกรขายได้) คือเงินที่เกษตรกรได้รับเมื่อขายครั้งแรก ก่อนพ่อค้าคนกลาง โรงสี หรือค่าขนส่งจะหักส่วนแบ่ง — ไม่ใช่ดัชนีโลก และไม่ใช่ราคาในซูเปอร์มาร์เก็ต แหล่งผลิตเป็นการอ่านแบบ ประมาณการ ว่าสินค้าแต่ละชนิดผลิตที่ไหน และทับซ้อนกันได้ น้ำตาลเป็นราคาอ้อยประกาศของ สอน. ปีละหนึ่งจุด จึงไม่มีการเปลี่ยนแปลงหกเดือนให้แสดง</a:t>
+              <a:t>ราคาหน้าฟาร์ม วัดจริง — ราคารายวันของ NABC เฉลี่ยเป็นรายเดือน หน่วยเป็นบาทตามที่เผยแพร่ (ไม่มีการแปลงสกุลเงิน) ราคาล่าสุด 2026-08-04, รุ่นข้อมูลย้อนหลัง 2026-08-02 ราคาหน้าฟาร์ม (ราคาที่เกษตรกรขายได้) คือเงินที่เกษตรกรได้รับเมื่อขายครั้งแรก ก่อนพ่อค้าคนกลาง โรงสี หรือค่าขนส่งจะหักส่วนแบ่ง — ไม่ใช่ดัชนีโลก และไม่ใช่ราคาในซูเปอร์มาร์เก็ต แหล่งผลิตเป็นการอ่านแบบ ประมาณการ ว่าสินค้าแต่ละชนิดผลิตที่ไหน และทับซ้อนกันได้ น้ำตาลเป็นราคาอ้อยประกาศของ สอน. ปีละหนึ่งจุด จึงไม่มีการเปลี่ยนแปลงหกเดือนให้แสดง</a:t>
             </a:r>
           </a:p>
         </p:txBody>

</xml_diff>

<commit_message>
chore(deck): rebuild EN + TH against the refreshed NABC and ThaiWater data (#292)
The two data PRs that merged after the deck moved three of its numbers: seven Thai farm-gate
prices are falling year on year, not eight, and four commodities now disagree on direction
between the annual and six-month windows, not three.

Those counts are spelled out by word(), so they live in the translation KEY rather than as {}
arguments — the Thai build reported them as untranslated, which is the harvest doing its job.
Both readings are kept in the catalogue, because the count can move back. 510 strings, 0 left
English, no fit findings in either language.

Co-authored-by: Claude Opus 5 <noreply@anthropic.com>
</commit_message>
<xml_diff>
--- a/docs/decks/mcom-2026-08-05-macro-TH.pptx
+++ b/docs/decks/mcom-2026-08-05-macro-TH.pptx
@@ -6279,7 +6279,7 @@
                 </a:solidFill>
                 <a:latin typeface="Kanit"/>
               </a:rPr>
-              <a:t>จาก 794 (16.6%) · เรียลไทม์ · 2026-08-04</a:t>
+              <a:t>จาก 795 (16.6%) · เรียลไทม์ · 2026-08-05</a:t>
             </a:r>
           </a:p>
         </p:txBody>
@@ -6405,7 +6405,7 @@
                 </a:solidFill>
                 <a:latin typeface="Kanit"/>
               </a:rPr>
-              <a:t>41</a:t>
+              <a:t>29</a:t>
             </a:r>
           </a:p>
         </p:txBody>
@@ -6444,7 +6444,7 @@
                 </a:solidFill>
                 <a:latin typeface="Kanit"/>
               </a:rPr>
-              <a:t>ค่าล่าสุดรายวัน · 2026-08-04</a:t>
+              <a:t>ค่าล่าสุดรายวัน · 2026-08-05</a:t>
             </a:r>
           </a:p>
         </p:txBody>
@@ -7882,7 +7882,7 @@
                           </a:solidFill>
                           <a:latin typeface="Kanit"/>
                         </a:rPr>
-                        <a:t>ยโสธร</a:t>
+                        <a:t>นราธิวาส</a:t>
                       </a:r>
                     </a:p>
                   </a:txBody>
@@ -7905,7 +7905,7 @@
                           </a:solidFill>
                           <a:latin typeface="Kanit"/>
                         </a:rPr>
-                        <a:t>15</a:t>
+                        <a:t>66</a:t>
                       </a:r>
                     </a:p>
                   </a:txBody>
@@ -7928,7 +7928,7 @@
                           </a:solidFill>
                           <a:latin typeface="Kanit"/>
                         </a:rPr>
-                        <a:t>98</a:t>
+                        <a:t>56</a:t>
                       </a:r>
                     </a:p>
                   </a:txBody>
@@ -7951,7 +7951,7 @@
                           </a:solidFill>
                           <a:latin typeface="Kanit"/>
                         </a:rPr>
-                        <a:t>33.3%</a:t>
+                        <a:t>4.5%</a:t>
                       </a:r>
                     </a:p>
                   </a:txBody>
@@ -7974,7 +7974,7 @@
                           </a:solidFill>
                           <a:latin typeface="Kanit"/>
                         </a:rPr>
-                        <a:t>5/6</a:t>
+                        <a:t>5/10</a:t>
                       </a:r>
                     </a:p>
                   </a:txBody>
@@ -8022,7 +8022,7 @@
                           </a:solidFill>
                           <a:latin typeface="Kanit"/>
                         </a:rPr>
-                        <a:t>นราธิวาส</a:t>
+                        <a:t>ยโสธร</a:t>
                       </a:r>
                     </a:p>
                   </a:txBody>
@@ -8045,7 +8045,7 @@
                           </a:solidFill>
                           <a:latin typeface="Kanit"/>
                         </a:rPr>
-                        <a:t>65</a:t>
+                        <a:t>16</a:t>
                       </a:r>
                     </a:p>
                   </a:txBody>
@@ -8068,7 +8068,7 @@
                           </a:solidFill>
                           <a:latin typeface="Kanit"/>
                         </a:rPr>
-                        <a:t>57</a:t>
+                        <a:t>27</a:t>
                       </a:r>
                     </a:p>
                   </a:txBody>
@@ -8087,11 +8087,11 @@
                       <a:r>
                         <a:rPr sz="900" b="1">
                           <a:solidFill>
-                            <a:srgbClr val="F5C242"/>
-                          </a:solidFill>
-                          <a:latin typeface="Kanit"/>
-                        </a:rPr>
-                        <a:t>7.7%</a:t>
+                            <a:srgbClr val="606060"/>
+                          </a:solidFill>
+                          <a:latin typeface="Kanit"/>
+                        </a:rPr>
+                        <a:t>0.0%</a:t>
                       </a:r>
                     </a:p>
                   </a:txBody>
@@ -8114,7 +8114,7 @@
                           </a:solidFill>
                           <a:latin typeface="Kanit"/>
                         </a:rPr>
-                        <a:t>5/10</a:t>
+                        <a:t>5/6</a:t>
                       </a:r>
                     </a:p>
                   </a:txBody>
@@ -8162,7 +8162,7 @@
                           </a:solidFill>
                           <a:latin typeface="Kanit"/>
                         </a:rPr>
-                        <a:t>มุกดาหาร</a:t>
+                        <a:t>บึงกาฬ</a:t>
                       </a:r>
                     </a:p>
                   </a:txBody>
@@ -8185,7 +8185,7 @@
                           </a:solidFill>
                           <a:latin typeface="Kanit"/>
                         </a:rPr>
-                        <a:t>17</a:t>
+                        <a:t>10</a:t>
                       </a:r>
                     </a:p>
                   </a:txBody>
@@ -8208,7 +8208,7 @@
                           </a:solidFill>
                           <a:latin typeface="Kanit"/>
                         </a:rPr>
-                        <a:t>97</a:t>
+                        <a:t>99</a:t>
                       </a:r>
                     </a:p>
                   </a:txBody>
@@ -8231,7 +8231,7 @@
                           </a:solidFill>
                           <a:latin typeface="Kanit"/>
                         </a:rPr>
-                        <a:t>47.1%</a:t>
+                        <a:t>90.0%</a:t>
                       </a:r>
                     </a:p>
                   </a:txBody>
@@ -8254,7 +8254,7 @@
                           </a:solidFill>
                           <a:latin typeface="Kanit"/>
                         </a:rPr>
-                        <a:t>1/2</a:t>
+                        <a:t>1/1</a:t>
                       </a:r>
                     </a:p>
                   </a:txBody>
@@ -8302,7 +8302,7 @@
                           </a:solidFill>
                           <a:latin typeface="Kanit"/>
                         </a:rPr>
-                        <a:t>บึงกาฬ</a:t>
+                        <a:t>มุกดาหาร</a:t>
                       </a:r>
                     </a:p>
                   </a:txBody>
@@ -8325,7 +8325,7 @@
                           </a:solidFill>
                           <a:latin typeface="Kanit"/>
                         </a:rPr>
-                        <a:t>11</a:t>
+                        <a:t>16</a:t>
                       </a:r>
                     </a:p>
                   </a:txBody>
@@ -8348,7 +8348,7 @@
                           </a:solidFill>
                           <a:latin typeface="Kanit"/>
                         </a:rPr>
-                        <a:t>85</a:t>
+                        <a:t>77</a:t>
                       </a:r>
                     </a:p>
                   </a:txBody>
@@ -8371,7 +8371,7 @@
                           </a:solidFill>
                           <a:latin typeface="Kanit"/>
                         </a:rPr>
-                        <a:t>45.5%</a:t>
+                        <a:t>18.8%</a:t>
                       </a:r>
                     </a:p>
                   </a:txBody>
@@ -8394,7 +8394,7 @@
                           </a:solidFill>
                           <a:latin typeface="Kanit"/>
                         </a:rPr>
-                        <a:t>1/1</a:t>
+                        <a:t>1/2</a:t>
                       </a:r>
                     </a:p>
                   </a:txBody>
@@ -8442,7 +8442,7 @@
                           </a:solidFill>
                           <a:latin typeface="Kanit"/>
                         </a:rPr>
-                        <a:t>นครพนม</a:t>
+                        <a:t>ปทุมธานี</a:t>
                       </a:r>
                     </a:p>
                   </a:txBody>
@@ -8465,7 +8465,7 @@
                           </a:solidFill>
                           <a:latin typeface="Kanit"/>
                         </a:rPr>
-                        <a:t>29</a:t>
+                        <a:t>11</a:t>
                       </a:r>
                     </a:p>
                   </a:txBody>
@@ -8488,7 +8488,7 @@
                           </a:solidFill>
                           <a:latin typeface="Kanit"/>
                         </a:rPr>
-                        <a:t>56</a:t>
+                        <a:t>43</a:t>
                       </a:r>
                     </a:p>
                   </a:txBody>
@@ -8511,7 +8511,7 @@
                           </a:solidFill>
                           <a:latin typeface="Kanit"/>
                         </a:rPr>
-                        <a:t>24.1%</a:t>
+                        <a:t>18.2%</a:t>
                       </a:r>
                     </a:p>
                   </a:txBody>
@@ -8534,7 +8534,7 @@
                           </a:solidFill>
                           <a:latin typeface="Kanit"/>
                         </a:rPr>
-                        <a:t>5/15</a:t>
+                        <a:t>2/4</a:t>
                       </a:r>
                     </a:p>
                   </a:txBody>
@@ -8582,7 +8582,7 @@
                           </a:solidFill>
                           <a:latin typeface="Kanit"/>
                         </a:rPr>
-                        <a:t>อุดรธานี</a:t>
+                        <a:t>นครพนม</a:t>
                       </a:r>
                     </a:p>
                   </a:txBody>
@@ -8605,7 +8605,7 @@
                           </a:solidFill>
                           <a:latin typeface="Kanit"/>
                         </a:rPr>
-                        <a:t>33</a:t>
+                        <a:t>29</a:t>
                       </a:r>
                     </a:p>
                   </a:txBody>
@@ -8628,7 +8628,7 @@
                           </a:solidFill>
                           <a:latin typeface="Kanit"/>
                         </a:rPr>
-                        <a:t>59</a:t>
+                        <a:t>86</a:t>
                       </a:r>
                     </a:p>
                   </a:txBody>
@@ -8651,7 +8651,7 @@
                           </a:solidFill>
                           <a:latin typeface="Kanit"/>
                         </a:rPr>
-                        <a:t>15.2%</a:t>
+                        <a:t>17.2%</a:t>
                       </a:r>
                     </a:p>
                   </a:txBody>
@@ -8674,7 +8674,7 @@
                           </a:solidFill>
                           <a:latin typeface="Kanit"/>
                         </a:rPr>
-                        <a:t>3/4</a:t>
+                        <a:t>5/15</a:t>
                       </a:r>
                     </a:p>
                   </a:txBody>
@@ -8909,7 +8909,7 @@
                 </a:solidFill>
                 <a:latin typeface="Kanit"/>
               </a:rPr>
-              <a:t>พื้นที่ปลูก วัดจริง (สศก. — ข้อมูลอำเภอ×พืช 3,295 แถว) ภัยแล้งเป็นดัชนี SPEI จาก แบบจำลอง คำนวณจากปริมาณฝนและการคายระเหย ปรับเดือนละครั้ง ดึงข้อมูล 2026-07-20 — เป็นสัญญาณที่ครอบคลุมทั้งประเทศดีที่สุดที่มี แต่ไม่มีใครลงพื้นที่ไปเดินดูอำเภอเหล่านั้น ข้อมูลฝนและระดับน้ำ วัดจริง (ThaiWater เรียลไทม์ ดึงทุกวันและสะสมไว้ — วันที่ดึงไม่สำเร็จจะเว้นเป็นช่องว่าง ไม่ใส่ค่าสมมติ) · ฝนถึง 2026-08-04, ระดับน้ำถึง 2026-08-04 ความเสี่ยงน้ำท่วมเชิงโครงสร้าง วัดจริง (สำมะโนพื้นที่ท่วมซ้ำซาก GISTDA มาตราส่วน 1:50,000 ปี 2005-2016 — เป็นบันทึกภาคพื้นดิน 12 ปี ไม่ใช่การพยากรณ์)</a:t>
+              <a:t>พื้นที่ปลูก วัดจริง (สศก. — ข้อมูลอำเภอ×พืช 3,295 แถว) ภัยแล้งเป็นดัชนี SPEI จาก แบบจำลอง คำนวณจากปริมาณฝนและการคายระเหย ปรับเดือนละครั้ง ดึงข้อมูล 2026-07-20 — เป็นสัญญาณที่ครอบคลุมทั้งประเทศดีที่สุดที่มี แต่ไม่มีใครลงพื้นที่ไปเดินดูอำเภอเหล่านั้น ข้อมูลฝนและระดับน้ำ วัดจริง (ThaiWater เรียลไทม์ ดึงทุกวันและสะสมไว้ — วันที่ดึงไม่สำเร็จจะเว้นเป็นช่องว่าง ไม่ใส่ค่าสมมติ) · ฝนถึง 2026-08-05, ระดับน้ำถึง 2026-08-05 ความเสี่ยงน้ำท่วมเชิงโครงสร้าง วัดจริง (สำมะโนพื้นที่ท่วมซ้ำซาก GISTDA มาตราส่วน 1:50,000 ปี 2005-2016 — เป็นบันทึกภาคพื้นดิน 12 ปี ไม่ใช่การพยากรณ์)</a:t>
             </a:r>
           </a:p>
         </p:txBody>
@@ -31476,7 +31476,7 @@
                 </a:solidFill>
                 <a:latin typeface="Kanit"/>
               </a:rPr>
-              <a:t>รายได้จากพืชค่ากลางเพิ่มขึ้น +15.5% แต่มีสี่จังหวัดที่ลดลง — ทั้งหมดอยู่ในแหล่งปลูกมะพร้าว โดยหนักที่สุดคือสมุทรสงครามที่ −65.2%</a:t>
+              <a:t>รายได้จากพืชค่ากลางเพิ่มขึ้น +15.6% แต่มีสี่จังหวัดที่ลดลง — ทั้งหมดอยู่ในแหล่งปลูกมะพร้าว โดยหนักที่สุดคือสมุทรสงครามที่ −64.8%</a:t>
             </a:r>
           </a:p>
         </p:txBody>
@@ -32047,7 +32047,7 @@
                 </a:solidFill>
                 <a:latin typeface="Kanit"/>
               </a:rPr>
-              <a:t>รุ่นข้อมูล — ราคาโลก 2026M06 · ราคาหน้าฟาร์มไทย 2026-08-03 · ประวัติราคาไทย 2026-08-02 · ต้นทุนการผลิตพืช สศก. ไจอัป 2568 (ปีเพาะปลูก 2568/69, ประมาณการ สศก. มี.ค. 2569) · ภัยแล้ง 2026-06-21 · เงินเฟ้อ 2026-05 · GDP 2026 ไตรมาส 1 · IMF WEO 2026 · ดัชนีราคาขายต่อ 2026-05 · ยอดจดทะเบียนถึง 2026-01 · หนี้ครัวเรือน สสช. SES 2566 · ค่าจ้าง สสช. LFS 2568 · ข้อมูลตรวจวัด 2026-08-04</a:t>
+              <a:t>รุ่นข้อมูล — ราคาโลก 2026M06 · ราคาหน้าฟาร์มไทย 2026-08-04 · ประวัติราคาไทย 2026-08-02 · ต้นทุนการผลิตพืช สศก. ไจอัป 2568 (ปีเพาะปลูก 2568/69, ประมาณการ สศก. มี.ค. 2569) · ภัยแล้ง 2026-06-21 · เงินเฟ้อ 2026-05 · GDP 2026 ไตรมาส 1 · IMF WEO 2026 · ดัชนีราคาขายต่อ 2026-05 · ยอดจดทะเบียนถึง 2026-01 · หนี้ครัวเรือน สสช. SES 2566 · ค่าจ้าง สสช. LFS 2568 · ข้อมูลตรวจวัด 2026-08-05</a:t>
             </a:r>
           </a:p>
         </p:txBody>
@@ -32544,9 +32544,9 @@
                 <a:latin typeface="Kanit"/>
               </a:rPr>
               <a:t>ไม่ใช่ถ้าดูดัชนีโลก — แต่ราคาหน้าฟาร์ม (ราคาที่เกษตรกรขายได้) บอกคนละเรื่อง
-• ราคาหน้าฟาร์มไทยแปดจากสิบเจ็ดรายการลดลงเมื่อเทียบกับปีก่อน
+• ราคาหน้าฟาร์มไทยเจ็ดจากสิบเจ็ดรายการลดลงเมื่อเทียบกับปีก่อน
 • เนื้อวัว: หน้าฟาร์ม −6.1% เทียบดัชนีโลก +11.8%
-• ส่วนต่างสำคัญกว่าราคา: ราคาขยับ 25% กลายเป็นรายได้เกษตรเหวี่ยง 80%</a:t>
+• ส่วนต่างสำคัญกว่าราคา: ราคาขยับ 25% กลายเป็นรายได้เกษตรเหวี่ยง 81%</a:t>
             </a:r>
           </a:p>
         </p:txBody>
@@ -37087,7 +37087,7 @@
                 </a:solidFill>
                 <a:latin typeface="Kanit"/>
               </a:rPr>
-              <a:t>338 จาก 928 อำเภอ · แม่น้ำเกินระดับ 132 จาก 794 สถานี</a:t>
+              <a:t>338 จาก 928 อำเภอ · แม่น้ำเกินระดับ 132 จาก 795 สถานี</a:t>
             </a:r>
           </a:p>
         </p:txBody>
@@ -37859,7 +37859,7 @@
                           </a:solidFill>
                           <a:latin typeface="Kanit"/>
                         </a:rPr>
-                        <a:t>31/158</a:t>
+                        <a:t>34/159</a:t>
                       </a:r>
                     </a:p>
                   </a:txBody>
@@ -38091,7 +38091,7 @@
                           </a:solidFill>
                           <a:latin typeface="Kanit"/>
                         </a:rPr>
-                        <a:t>26/274</a:t>
+                        <a:t>23/274</a:t>
                       </a:r>
                     </a:p>
                   </a:txBody>
@@ -38323,7 +38323,7 @@
                           </a:solidFill>
                           <a:latin typeface="Kanit"/>
                         </a:rPr>
-                        <a:t>29/168</a:t>
+                        <a:t>27/168</a:t>
                       </a:r>
                     </a:p>
                   </a:txBody>
@@ -38555,7 +38555,7 @@
                           </a:solidFill>
                           <a:latin typeface="Kanit"/>
                         </a:rPr>
-                        <a:t>7/52</a:t>
+                        <a:t>8/52</a:t>
                       </a:r>
                     </a:p>
                   </a:txBody>
@@ -38787,7 +38787,7 @@
                           </a:solidFill>
                           <a:latin typeface="Kanit"/>
                         </a:rPr>
-                        <a:t>39/142</a:t>
+                        <a:t>40/142</a:t>
                       </a:r>
                     </a:p>
                   </a:txBody>
@@ -39502,7 +39502,7 @@
                 </a:solidFill>
                 <a:latin typeface="Kanit"/>
               </a:rPr>
-              <a:t>สินค้าเกษตร 17 จากทั้งหมด 21 รายการที่เราติดตาม มีราคาหน้าฟาร์มไทยที่วัดได้จริง (ราคาที่เกษตรกรขายได้) และแปดรายการกำลังลดลงเมื่อเทียบกับปีก่อน</a:t>
+              <a:t>สินค้าเกษตร 17 จากทั้งหมด 21 รายการที่เราติดตาม มีราคาหน้าฟาร์มไทยที่วัดได้จริง (ราคาที่เกษตรกรขายได้) และเจ็ดรายการกำลังลดลงเมื่อเทียบกับปีก่อน</a:t>
             </a:r>
           </a:p>
         </p:txBody>
@@ -39673,7 +39673,7 @@
         </p:nvGraphicFramePr>
         <p:xfrm>
           <a:off x="411480" y="2033016"/>
-          <a:ext cx="11365992" cy="2362808"/>
+          <a:ext cx="11365992" cy="2108605"/>
         </p:xfrm>
         <a:graphic>
           <a:graphicData uri="http://schemas.openxmlformats.org/drawingml/2006/table">
@@ -39936,7 +39936,7 @@
                           </a:solidFill>
                           <a:latin typeface="Kanit"/>
                         </a:rPr>
-                        <a:t>−69.7%</a:t>
+                        <a:t>−69.3%</a:t>
                       </a:r>
                     </a:p>
                   </a:txBody>
@@ -40751,7 +40751,7 @@
                           </a:solidFill>
                           <a:latin typeface="Kanit"/>
                         </a:rPr>
-                        <a:t>−3.5%</a:t>
+                        <a:t>−3.2%</a:t>
                       </a:r>
                     </a:p>
                   </a:txBody>
@@ -40914,7 +40914,7 @@
                           </a:solidFill>
                           <a:latin typeface="Kanit"/>
                         </a:rPr>
-                        <a:t>−1.8%</a:t>
+                        <a:t>−1.5%</a:t>
                       </a:r>
                     </a:p>
                   </a:txBody>
@@ -40990,169 +40990,6 @@
                   <a:tcPr marL="54864" marR="54864" marT="18288" marB="18288" anchor="ctr">
                     <a:solidFill>
                       <a:srgbClr val="FFFFFF"/>
-                    </a:solidFill>
-                  </a:tcPr>
-                </a:tc>
-              </a:tr>
-              <a:tr h="254203">
-                <a:tc>
-                  <a:txBody>
-                    <a:bodyPr wrap="square"/>
-                    <a:lstStyle/>
-                    <a:p>
-                      <a:pPr algn="l"/>
-                      <a:r>
-                        <a:rPr sz="1000" b="1">
-                          <a:solidFill>
-                            <a:srgbClr val="1E2F5C"/>
-                          </a:solidFill>
-                          <a:latin typeface="Kanit"/>
-                        </a:rPr>
-                        <a:t>ไก่เนื้อ</a:t>
-                      </a:r>
-                    </a:p>
-                  </a:txBody>
-                  <a:tcPr marL="54864" marR="54864" marT="18288" marB="18288" anchor="ctr">
-                    <a:solidFill>
-                      <a:srgbClr val="F7F9FC"/>
-                    </a:solidFill>
-                  </a:tcPr>
-                </a:tc>
-                <a:tc>
-                  <a:txBody>
-                    <a:bodyPr wrap="square"/>
-                    <a:lstStyle/>
-                    <a:p>
-                      <a:pPr algn="l"/>
-                      <a:r>
-                        <a:rPr sz="1000" b="0">
-                          <a:solidFill>
-                            <a:srgbClr val="1E2F5C"/>
-                          </a:solidFill>
-                          <a:latin typeface="Kanit"/>
-                        </a:rPr>
-                        <a:t>ปศุสัตว์</a:t>
-                      </a:r>
-                    </a:p>
-                  </a:txBody>
-                  <a:tcPr marL="54864" marR="54864" marT="18288" marB="18288" anchor="ctr">
-                    <a:solidFill>
-                      <a:srgbClr val="F7F9FC"/>
-                    </a:solidFill>
-                  </a:tcPr>
-                </a:tc>
-                <a:tc>
-                  <a:txBody>
-                    <a:bodyPr wrap="square"/>
-                    <a:lstStyle/>
-                    <a:p>
-                      <a:pPr algn="l"/>
-                      <a:r>
-                        <a:rPr sz="1000" b="0">
-                          <a:solidFill>
-                            <a:srgbClr val="1E2F5C"/>
-                          </a:solidFill>
-                          <a:latin typeface="Kanit"/>
-                        </a:rPr>
-                        <a:t>กลาง · ตอ.</a:t>
-                      </a:r>
-                    </a:p>
-                  </a:txBody>
-                  <a:tcPr marL="54864" marR="54864" marT="18288" marB="18288" anchor="ctr">
-                    <a:solidFill>
-                      <a:srgbClr val="F7F9FC"/>
-                    </a:solidFill>
-                  </a:tcPr>
-                </a:tc>
-                <a:tc>
-                  <a:txBody>
-                    <a:bodyPr wrap="square"/>
-                    <a:lstStyle/>
-                    <a:p>
-                      <a:pPr algn="r"/>
-                      <a:r>
-                        <a:rPr sz="1000" b="1">
-                          <a:solidFill>
-                            <a:srgbClr val="CC0000"/>
-                          </a:solidFill>
-                          <a:latin typeface="Kanit"/>
-                        </a:rPr>
-                        <a:t>−0.1%</a:t>
-                      </a:r>
-                    </a:p>
-                  </a:txBody>
-                  <a:tcPr marL="54864" marR="54864" marT="18288" marB="18288" anchor="ctr">
-                    <a:solidFill>
-                      <a:srgbClr val="F7F9FC"/>
-                    </a:solidFill>
-                  </a:tcPr>
-                </a:tc>
-                <a:tc>
-                  <a:txBody>
-                    <a:bodyPr wrap="square"/>
-                    <a:lstStyle/>
-                    <a:p>
-                      <a:pPr algn="r"/>
-                      <a:r>
-                        <a:rPr sz="1000" b="1">
-                          <a:solidFill>
-                            <a:srgbClr val="CC0000"/>
-                          </a:solidFill>
-                          <a:latin typeface="Kanit"/>
-                        </a:rPr>
-                        <a:t>−1.9%</a:t>
-                      </a:r>
-                    </a:p>
-                  </a:txBody>
-                  <a:tcPr marL="54864" marR="54864" marT="18288" marB="18288" anchor="ctr">
-                    <a:solidFill>
-                      <a:srgbClr val="F7F9FC"/>
-                    </a:solidFill>
-                  </a:tcPr>
-                </a:tc>
-                <a:tc>
-                  <a:txBody>
-                    <a:bodyPr wrap="square"/>
-                    <a:lstStyle/>
-                    <a:p>
-                      <a:pPr algn="r"/>
-                      <a:r>
-                        <a:rPr sz="1000" b="1">
-                          <a:solidFill>
-                            <a:srgbClr val="7A4FE0"/>
-                          </a:solidFill>
-                          <a:latin typeface="Kanit"/>
-                        </a:rPr>
-                        <a:t>41,496</a:t>
-                      </a:r>
-                    </a:p>
-                  </a:txBody>
-                  <a:tcPr marL="54864" marR="54864" marT="18288" marB="18288" anchor="ctr">
-                    <a:solidFill>
-                      <a:srgbClr val="F7F9FC"/>
-                    </a:solidFill>
-                  </a:tcPr>
-                </a:tc>
-                <a:tc>
-                  <a:txBody>
-                    <a:bodyPr wrap="square"/>
-                    <a:lstStyle/>
-                    <a:p>
-                      <a:pPr algn="r"/>
-                      <a:r>
-                        <a:rPr sz="1000" b="0">
-                          <a:solidFill>
-                            <a:srgbClr val="606060"/>
-                          </a:solidFill>
-                          <a:latin typeface="Kanit"/>
-                        </a:rPr>
-                        <a:t>23%</a:t>
-                      </a:r>
-                    </a:p>
-                  </a:txBody>
-                  <a:tcPr marL="54864" marR="54864" marT="18288" marB="18288" anchor="ctr">
-                    <a:solidFill>
-                      <a:srgbClr val="F7F9FC"/>
                     </a:solidFill>
                   </a:tcPr>
                 </a:tc>
@@ -41169,7 +41006,7 @@
         </p:nvSpPr>
         <p:spPr>
           <a:xfrm>
-            <a:off x="411480" y="4523841"/>
+            <a:off x="411480" y="4269638"/>
             <a:ext cx="535747" cy="192024"/>
           </a:xfrm>
           <a:prstGeom prst="roundRect">
@@ -41215,7 +41052,7 @@
         </p:nvSpPr>
         <p:spPr>
           <a:xfrm>
-            <a:off x="411480" y="4553102"/>
+            <a:off x="411480" y="4298899"/>
             <a:ext cx="535747" cy="134112"/>
           </a:xfrm>
           <a:prstGeom prst="rect">
@@ -41254,7 +41091,7 @@
         </p:nvSpPr>
         <p:spPr>
           <a:xfrm>
-            <a:off x="1056955" y="4537557"/>
+            <a:off x="1056955" y="4283354"/>
             <a:ext cx="10720516" cy="462915"/>
           </a:xfrm>
           <a:prstGeom prst="rect">
@@ -41280,7 +41117,7 @@
                 </a:solidFill>
                 <a:latin typeface="Kanit"/>
               </a:rPr>
-              <a:t>ราคา วัดจริง — ราคาหน้าฟาร์มไทยจากราคารายวันของ NABC และราคาอ้อยประกาศของ สอน. ราคาล่าสุด 2026-08-03 การเปลี่ยนแปลงหกเดือนคำนวณจากข้อมูลรายเดือนของ NABC เอง (thai_price_history รุ่นข้อมูล 2026-08-02) พืชที่ไม่มีข้อมูลรายเดือนจะกำกับไว้ ไม่ประมาณการขึ้นมา แหล่งผลิตเป็นการอ่านแบบ ประมาณการ ว่าสินค้าแต่ละชนิดปลูกที่ไหน และแหล่งผลิตทับซ้อนกันได้ บัญชีอาชีพเกษตรเป็นข้อมูลของเราเองและ วัดจริง — บัญชีที่บันทึกอาชีพว่า เกษตร ในจังหวัดแหล่งผลิต จากฐานข้อมูล 382,735 บัญชี ณ 2026-07 ไม่เผยแพร่ช่องที่มีน้อยกว่า 30 บัญชี คนกลุ่มนี้อาศัยอยู่ในพื้นที่ที่ปลูกพืชนั้น แต่ไม่ได้ยืนยันว่าปลูกพืชนั้นเอง</a:t>
+              <a:t>ราคา วัดจริง — ราคาหน้าฟาร์มไทยจากราคารายวันของ NABC และราคาอ้อยประกาศของ สอน. ราคาล่าสุด 2026-08-04 การเปลี่ยนแปลงหกเดือนคำนวณจากข้อมูลรายเดือนของ NABC เอง (thai_price_history รุ่นข้อมูล 2026-08-02) พืชที่ไม่มีข้อมูลรายเดือนจะกำกับไว้ ไม่ประมาณการขึ้นมา แหล่งผลิตเป็นการอ่านแบบ ประมาณการ ว่าสินค้าแต่ละชนิดปลูกที่ไหน และแหล่งผลิตทับซ้อนกันได้ บัญชีอาชีพเกษตรเป็นข้อมูลของเราเองและ วัดจริง — บัญชีที่บันทึกอาชีพว่า เกษตร ในจังหวัดแหล่งผลิต จากฐานข้อมูล 382,735 บัญชี ณ 2026-07 ไม่เผยแพร่ช่องที่มีน้อยกว่า 30 บัญชี คนกลุ่มนี้อาศัยอยู่ในพื้นที่ที่ปลูกพืชนั้น แต่ไม่ได้ยืนยันว่าปลูกพืชนั้นเอง</a:t>
             </a:r>
           </a:p>
         </p:txBody>
@@ -41293,7 +41130,7 @@
         </p:nvSpPr>
         <p:spPr>
           <a:xfrm>
-            <a:off x="411480" y="5133060"/>
+            <a:off x="411480" y="4878857"/>
             <a:ext cx="11365992" cy="675767"/>
           </a:xfrm>
           <a:prstGeom prst="rect">
@@ -41337,7 +41174,7 @@
         </p:nvSpPr>
         <p:spPr>
           <a:xfrm>
-            <a:off x="411480" y="5133060"/>
+            <a:off x="411480" y="4878857"/>
             <a:ext cx="50292" cy="675767"/>
           </a:xfrm>
           <a:prstGeom prst="rect">
@@ -41381,7 +41218,7 @@
         </p:nvSpPr>
         <p:spPr>
           <a:xfrm>
-            <a:off x="630936" y="5279364"/>
+            <a:off x="630936" y="5025161"/>
             <a:ext cx="11036808" cy="158750"/>
           </a:xfrm>
           <a:prstGeom prst="rect">
@@ -41420,7 +41257,7 @@
         </p:nvSpPr>
         <p:spPr>
           <a:xfrm>
-            <a:off x="630936" y="5483834"/>
+            <a:off x="630936" y="5229631"/>
             <a:ext cx="11036808" cy="178689"/>
           </a:xfrm>
           <a:prstGeom prst="rect">
@@ -45168,7 +45005,7 @@
                 </a:solidFill>
                 <a:latin typeface="Kanit"/>
               </a:rPr>
-              <a:t>มะพร้าว −69.7% สับปะรด −18.4% อ้อย −17.9% เทียบปีก่อน</a:t>
+              <a:t>มะพร้าว −69.3% สับปะรด −18.4% อ้อย −17.9% เทียบปีก่อน</a:t>
             </a:r>
           </a:p>
         </p:txBody>
@@ -45294,7 +45131,7 @@
                 </a:solidFill>
                 <a:latin typeface="Kanit"/>
               </a:rPr>
-              <a:t>+15.5%</a:t>
+              <a:t>+15.6%</a:t>
             </a:r>
           </a:p>
         </p:txBody>
@@ -45768,7 +45605,7 @@
                           </a:solidFill>
                           <a:latin typeface="Kanit"/>
                         </a:rPr>
-                        <a:t>+5.8%</a:t>
+                        <a:t>+6.0%</a:t>
                       </a:r>
                     </a:p>
                   </a:txBody>
@@ -45837,7 +45674,7 @@
                           </a:solidFill>
                           <a:latin typeface="Kanit"/>
                         </a:rPr>
-                        <a:t>-65.2%</a:t>
+                        <a:t>-64.8%</a:t>
                       </a:r>
                     </a:p>
                   </a:txBody>
@@ -45908,7 +45745,7 @@
                           </a:solidFill>
                           <a:latin typeface="Kanit"/>
                         </a:rPr>
-                        <a:t>+14.3%</a:t>
+                        <a:t>+14.4%</a:t>
                       </a:r>
                     </a:p>
                   </a:txBody>
@@ -45977,7 +45814,7 @@
                           </a:solidFill>
                           <a:latin typeface="Kanit"/>
                         </a:rPr>
-                        <a:t>+9.2%</a:t>
+                        <a:t>+9.3%</a:t>
                       </a:r>
                     </a:p>
                   </a:txBody>
@@ -46048,7 +45885,7 @@
                           </a:solidFill>
                           <a:latin typeface="Kanit"/>
                         </a:rPr>
-                        <a:t>+15.7%</a:t>
+                        <a:t>+15.9%</a:t>
                       </a:r>
                     </a:p>
                   </a:txBody>
@@ -46117,7 +45954,7 @@
                           </a:solidFill>
                           <a:latin typeface="Kanit"/>
                         </a:rPr>
-                        <a:t>+8.0%</a:t>
+                        <a:t>+8.1%</a:t>
                       </a:r>
                     </a:p>
                   </a:txBody>
@@ -46257,7 +46094,7 @@
                           </a:solidFill>
                           <a:latin typeface="Kanit"/>
                         </a:rPr>
-                        <a:t>+9.8%</a:t>
+                        <a:t>+9.9%</a:t>
                       </a:r>
                     </a:p>
                   </a:txBody>
@@ -46328,7 +46165,7 @@
                           </a:solidFill>
                           <a:latin typeface="Kanit"/>
                         </a:rPr>
-                        <a:t>+36.4%</a:t>
+                        <a:t>+36.3%</a:t>
                       </a:r>
                     </a:p>
                   </a:txBody>
@@ -46397,7 +46234,7 @@
                           </a:solidFill>
                           <a:latin typeface="Kanit"/>
                         </a:rPr>
-                        <a:t>+29.9%</a:t>
+                        <a:t>+29.8%</a:t>
                       </a:r>
                     </a:p>
                   </a:txBody>
@@ -46573,8 +46410,8 @@
                 </a:solidFill>
                 <a:latin typeface="Kanit"/>
               </a:rPr>
-              <a:t>•  ราคาหน้าฟาร์ม: ยางพารา +41% มันสำปะหลัง +59% ปาล์ม +28% ข้าว +13% รายได้จากพืชเพิ่มขึ้นทุกภาค
-•  มีสี่จังหวัดที่ลดลง — ทั้งหมดเป็นมะพร้าว และอยู่ฝั่งอ่าวไทยตะวันตก ราคามะพร้าวลดลง 70%
+              <a:t>•  ราคาหน้าฟาร์ม: ยางพารา +41% มันสำปะหลัง +59% ปาล์ม +27% ข้าว +13% รายได้จากพืชเพิ่มขึ้นทุกภาค
+•  มีสี่จังหวัดที่ลดลง — ทั้งหมดเป็นมะพร้าว และอยู่ฝั่งอ่าวไทยตะวันตก ราคามะพร้าวลดลง 69%
 •  กำไรบนกระดาษยังไม่ใช่เงินสด — ตารางถัดไปหักราคาด้วยต้นทุน</a:t>
             </a:r>
           </a:p>
@@ -46876,7 +46713,7 @@
                           </a:solidFill>
                           <a:latin typeface="Kanit"/>
                         </a:rPr>
-                        <a:t>+15.5%</a:t>
+                        <a:t>+15.7%</a:t>
                       </a:r>
                     </a:p>
                   </a:txBody>
@@ -47039,7 +46876,7 @@
                           </a:solidFill>
                           <a:latin typeface="Kanit"/>
                         </a:rPr>
-                        <a:t>+20.1%</a:t>
+                        <a:t>+20.2%</a:t>
                       </a:r>
                     </a:p>
                   </a:txBody>
@@ -47202,7 +47039,7 @@
                           </a:solidFill>
                           <a:latin typeface="Kanit"/>
                         </a:rPr>
-                        <a:t>+10.0%</a:t>
+                        <a:t>+10.2%</a:t>
                       </a:r>
                     </a:p>
                   </a:txBody>
@@ -47365,7 +47202,7 @@
                           </a:solidFill>
                           <a:latin typeface="Kanit"/>
                         </a:rPr>
-                        <a:t>+34.9%</a:t>
+                        <a:t>+34.8%</a:t>
                       </a:r>
                     </a:p>
                   </a:txBody>
@@ -47528,7 +47365,7 @@
                           </a:solidFill>
                           <a:latin typeface="Kanit"/>
                         </a:rPr>
-                        <a:t>+15.9%</a:t>
+                        <a:t>+16.1%</a:t>
                       </a:r>
                     </a:p>
                   </a:txBody>
@@ -47691,7 +47528,7 @@
                           </a:solidFill>
                           <a:latin typeface="Kanit"/>
                         </a:rPr>
-                        <a:t>+14.8%</a:t>
+                        <a:t>+15.0%</a:t>
                       </a:r>
                     </a:p>
                   </a:txBody>
@@ -48318,7 +48155,7 @@
                 </a:solidFill>
                 <a:latin typeface="Kanit"/>
               </a:rPr>
-              <a:t>สามรายการมีทิศทางไม่ตรงกันระหว่างเทียบปีก่อนกับหกเดือน ตัวเลขรายปีเพียงตัวเดียวจึงอาจชี้ผิดทางได้</a:t>
+              <a:t>สี่รายการมีทิศทางไม่ตรงกันระหว่างเทียบปีก่อนกับหกเดือน ตัวเลขรายปีเพียงตัวเดียวจึงอาจชี้ผิดทางได้</a:t>
             </a:r>
           </a:p>
         </p:txBody>
@@ -48513,7 +48350,7 @@
                 </a:solidFill>
                 <a:latin typeface="Kanit"/>
               </a:rPr>
-              <a:t>เทียบปีก่อน −69.7%</a:t>
+              <a:t>เทียบปีก่อน −69.3%</a:t>
             </a:r>
           </a:p>
         </p:txBody>
@@ -49149,7 +48986,7 @@
                 </a:solidFill>
                 <a:latin typeface="Kanit"/>
               </a:rPr>
-              <a:t>เทียบปีก่อน −3.5%</a:t>
+              <a:t>เทียบปีก่อน −3.2%</a:t>
             </a:r>
           </a:p>
         </p:txBody>
@@ -49467,7 +49304,7 @@
                 </a:solidFill>
                 <a:latin typeface="Kanit"/>
               </a:rPr>
-              <a:t>เทียบปีก่อน −1.8%</a:t>
+              <a:t>เทียบปีก่อน −1.5%</a:t>
             </a:r>
           </a:p>
         </p:txBody>
@@ -49707,6 +49544,324 @@
                 </a:solidFill>
                 <a:latin typeface="Kanit"/>
               </a:rPr>
+              <a:t>ไข่ไก่</a:t>
+            </a:r>
+          </a:p>
+        </p:txBody>
+      </p:sp>
+      <p:sp>
+        <p:nvSpPr>
+          <p:cNvPr id="44" name="TextBox 43"/>
+          <p:cNvSpPr txBox="1"/>
+          <p:nvPr/>
+        </p:nvSpPr>
+        <p:spPr>
+          <a:xfrm>
+            <a:off x="9621316" y="2112263"/>
+            <a:ext cx="2156155" cy="125730"/>
+          </a:xfrm>
+          <a:prstGeom prst="rect">
+            <a:avLst/>
+          </a:prstGeom>
+          <a:noFill/>
+        </p:spPr>
+        <p:txBody>
+          <a:bodyPr wrap="square" lIns="0" rIns="0" tIns="0" bIns="0" anchor="t">
+            <a:noAutofit/>
+          </a:bodyPr>
+          <a:lstStyle/>
+          <a:p>
+            <a:pPr algn="l">
+              <a:lnSpc>
+                <a:spcPts val="990"/>
+              </a:lnSpc>
+            </a:pPr>
+            <a:r>
+              <a:rPr sz="750" b="0">
+                <a:solidFill>
+                  <a:srgbClr val="606060"/>
+                </a:solidFill>
+                <a:latin typeface="Kanit"/>
+              </a:rPr>
+              <a:t>฿338.24 /ร้อยฟอง · กลาง·ตอ.</a:t>
+            </a:r>
+          </a:p>
+        </p:txBody>
+      </p:sp>
+      <p:sp>
+        <p:nvSpPr>
+          <p:cNvPr id="45" name="TextBox 44"/>
+          <p:cNvSpPr txBox="1"/>
+          <p:nvPr/>
+        </p:nvSpPr>
+        <p:spPr>
+          <a:xfrm>
+            <a:off x="9621316" y="2244851"/>
+            <a:ext cx="1078077" cy="134112"/>
+          </a:xfrm>
+          <a:prstGeom prst="rect">
+            <a:avLst/>
+          </a:prstGeom>
+          <a:noFill/>
+        </p:spPr>
+        <p:txBody>
+          <a:bodyPr wrap="square" lIns="0" rIns="0" tIns="0" bIns="0" anchor="t">
+            <a:noAutofit/>
+          </a:bodyPr>
+          <a:lstStyle/>
+          <a:p>
+            <a:pPr algn="l">
+              <a:lnSpc>
+                <a:spcPts val="1056"/>
+              </a:lnSpc>
+            </a:pPr>
+            <a:r>
+              <a:rPr sz="800" b="1">
+                <a:solidFill>
+                  <a:srgbClr val="606060"/>
+                </a:solidFill>
+                <a:latin typeface="Kanit"/>
+              </a:rPr>
+              <a:t>เทียบปีก่อน +0.0%</a:t>
+            </a:r>
+          </a:p>
+        </p:txBody>
+      </p:sp>
+      <p:sp>
+        <p:nvSpPr>
+          <p:cNvPr id="46" name="TextBox 45"/>
+          <p:cNvSpPr txBox="1"/>
+          <p:nvPr/>
+        </p:nvSpPr>
+        <p:spPr>
+          <a:xfrm>
+            <a:off x="10699394" y="2244851"/>
+            <a:ext cx="1078077" cy="134112"/>
+          </a:xfrm>
+          <a:prstGeom prst="rect">
+            <a:avLst/>
+          </a:prstGeom>
+          <a:noFill/>
+        </p:spPr>
+        <p:txBody>
+          <a:bodyPr wrap="square" lIns="0" rIns="0" tIns="0" bIns="0" anchor="t">
+            <a:noAutofit/>
+          </a:bodyPr>
+          <a:lstStyle/>
+          <a:p>
+            <a:pPr algn="l">
+              <a:lnSpc>
+                <a:spcPts val="1056"/>
+              </a:lnSpc>
+            </a:pPr>
+            <a:r>
+              <a:rPr sz="800" b="1">
+                <a:solidFill>
+                  <a:srgbClr val="15795F"/>
+                </a:solidFill>
+                <a:latin typeface="Kanit"/>
+              </a:rPr>
+              <a:t>6 เดือน +5.0%</a:t>
+            </a:r>
+          </a:p>
+        </p:txBody>
+      </p:sp>
+      <p:sp>
+        <p:nvSpPr>
+          <p:cNvPr id="47" name="Rectangle 46"/>
+          <p:cNvSpPr/>
+          <p:nvPr/>
+        </p:nvSpPr>
+        <p:spPr>
+          <a:xfrm>
+            <a:off x="9621316" y="2400300"/>
+            <a:ext cx="2156155" cy="548640"/>
+          </a:xfrm>
+          <a:prstGeom prst="rect">
+            <a:avLst/>
+          </a:prstGeom>
+          <a:solidFill>
+            <a:srgbClr val="FBFCFE"/>
+          </a:solidFill>
+          <a:ln w="9525">
+            <a:solidFill>
+              <a:srgbClr val="D9DEE9"/>
+            </a:solidFill>
+          </a:ln>
+          <a:effectLst/>
+        </p:spPr>
+        <p:style>
+          <a:lnRef idx="1">
+            <a:schemeClr val="accent1"/>
+          </a:lnRef>
+          <a:fillRef idx="3">
+            <a:schemeClr val="accent1"/>
+          </a:fillRef>
+          <a:effectRef idx="2">
+            <a:schemeClr val="accent1"/>
+          </a:effectRef>
+          <a:fontRef idx="minor">
+            <a:schemeClr val="lt1"/>
+          </a:fontRef>
+        </p:style>
+        <p:txBody>
+          <a:bodyPr rtlCol="0" anchor="ctr" wrap="none"/>
+          <a:lstStyle/>
+          <a:p>
+            <a:pPr algn="ctr"/>
+          </a:p>
+        </p:txBody>
+      </p:sp>
+      <p:sp>
+        <p:nvSpPr>
+          <p:cNvPr id="48" name="Freeform 47"/>
+          <p:cNvSpPr/>
+          <p:nvPr/>
+        </p:nvSpPr>
+        <p:spPr>
+          <a:xfrm>
+            <a:off x="9667036" y="2446020"/>
+            <a:ext cx="2064715" cy="457200"/>
+          </a:xfrm>
+          <a:custGeom>
+            <a:avLst/>
+            <a:gdLst/>
+            <a:ahLst/>
+            <a:cxnLst/>
+            <a:rect l="l" t="t" r="r" b="b"/>
+            <a:pathLst>
+              <a:path w="2064715" h="457200">
+                <a:moveTo>
+                  <a:pt x="0" y="457200"/>
+                </a:moveTo>
+                <a:lnTo>
+                  <a:pt x="412943" y="391702"/>
+                </a:lnTo>
+                <a:lnTo>
+                  <a:pt x="825886" y="105409"/>
+                </a:lnTo>
+                <a:lnTo>
+                  <a:pt x="1238829" y="105409"/>
+                </a:lnTo>
+                <a:lnTo>
+                  <a:pt x="1651772" y="214144"/>
+                </a:lnTo>
+                <a:lnTo>
+                  <a:pt x="2064715" y="0"/>
+                </a:lnTo>
+              </a:path>
+            </a:pathLst>
+          </a:custGeom>
+          <a:noFill/>
+          <a:ln w="20320">
+            <a:solidFill>
+              <a:srgbClr val="15795F"/>
+            </a:solidFill>
+          </a:ln>
+          <a:effectLst/>
+        </p:spPr>
+        <p:style>
+          <a:lnRef idx="1">
+            <a:schemeClr val="accent1"/>
+          </a:lnRef>
+          <a:fillRef idx="3">
+            <a:schemeClr val="accent1"/>
+          </a:fillRef>
+          <a:effectRef idx="2">
+            <a:schemeClr val="accent1"/>
+          </a:effectRef>
+          <a:fontRef idx="minor">
+            <a:schemeClr val="lt1"/>
+          </a:fontRef>
+        </p:style>
+        <p:txBody>
+          <a:bodyPr rtlCol="0" anchor="ctr"/>
+          <a:lstStyle/>
+          <a:p>
+            <a:pPr algn="ctr"/>
+          </a:p>
+        </p:txBody>
+      </p:sp>
+      <p:sp>
+        <p:nvSpPr>
+          <p:cNvPr id="49" name="Rounded Rectangle 48"/>
+          <p:cNvSpPr/>
+          <p:nvPr/>
+        </p:nvSpPr>
+        <p:spPr>
+          <a:xfrm>
+            <a:off x="11690603" y="2404872"/>
+            <a:ext cx="82296" cy="82296"/>
+          </a:xfrm>
+          <a:prstGeom prst="roundRect">
+            <a:avLst>
+              <a:gd name="adj" fmla="val 50000"/>
+            </a:avLst>
+          </a:prstGeom>
+          <a:solidFill>
+            <a:srgbClr val="15795F"/>
+          </a:solidFill>
+          <a:ln>
+            <a:noFill/>
+          </a:ln>
+          <a:effectLst/>
+        </p:spPr>
+        <p:style>
+          <a:lnRef idx="1">
+            <a:schemeClr val="accent1"/>
+          </a:lnRef>
+          <a:fillRef idx="3">
+            <a:schemeClr val="accent1"/>
+          </a:fillRef>
+          <a:effectRef idx="2">
+            <a:schemeClr val="accent1"/>
+          </a:effectRef>
+          <a:fontRef idx="minor">
+            <a:schemeClr val="lt1"/>
+          </a:fontRef>
+        </p:style>
+        <p:txBody>
+          <a:bodyPr rtlCol="0" anchor="ctr" wrap="none"/>
+          <a:lstStyle/>
+          <a:p>
+            <a:pPr algn="ctr"/>
+          </a:p>
+        </p:txBody>
+      </p:sp>
+      <p:sp>
+        <p:nvSpPr>
+          <p:cNvPr id="50" name="TextBox 49"/>
+          <p:cNvSpPr txBox="1"/>
+          <p:nvPr/>
+        </p:nvSpPr>
+        <p:spPr>
+          <a:xfrm>
+            <a:off x="411480" y="3076956"/>
+            <a:ext cx="2156155" cy="150876"/>
+          </a:xfrm>
+          <a:prstGeom prst="rect">
+            <a:avLst/>
+          </a:prstGeom>
+          <a:noFill/>
+        </p:spPr>
+        <p:txBody>
+          <a:bodyPr wrap="square" lIns="0" rIns="0" tIns="0" bIns="0" anchor="t">
+            <a:noAutofit/>
+          </a:bodyPr>
+          <a:lstStyle/>
+          <a:p>
+            <a:pPr algn="l">
+              <a:lnSpc>
+                <a:spcPts val="1188"/>
+              </a:lnSpc>
+            </a:pPr>
+            <a:r>
+              <a:rPr sz="900" b="1">
+                <a:solidFill>
+                  <a:srgbClr val="1E2F5C"/>
+                </a:solidFill>
+                <a:latin typeface="Kanit"/>
+              </a:rPr>
               <a:t>ไก่เนื้อ</a:t>
             </a:r>
           </a:p>
@@ -49714,13 +49869,13 @@
       </p:sp>
       <p:sp>
         <p:nvSpPr>
-          <p:cNvPr id="44" name="TextBox 43"/>
+          <p:cNvPr id="51" name="TextBox 50"/>
           <p:cNvSpPr txBox="1"/>
           <p:nvPr/>
         </p:nvSpPr>
         <p:spPr>
           <a:xfrm>
-            <a:off x="9621316" y="2112263"/>
+            <a:off x="411480" y="3218687"/>
             <a:ext cx="2156155" cy="125730"/>
           </a:xfrm>
           <a:prstGeom prst="rect">
@@ -49753,13 +49908,13 @@
       </p:sp>
       <p:sp>
         <p:nvSpPr>
-          <p:cNvPr id="45" name="TextBox 44"/>
+          <p:cNvPr id="52" name="TextBox 51"/>
           <p:cNvSpPr txBox="1"/>
           <p:nvPr/>
         </p:nvSpPr>
         <p:spPr>
           <a:xfrm>
-            <a:off x="9621316" y="2244851"/>
+            <a:off x="411480" y="3351275"/>
             <a:ext cx="1078077" cy="134112"/>
           </a:xfrm>
           <a:prstGeom prst="rect">
@@ -49781,24 +49936,24 @@
             <a:r>
               <a:rPr sz="800" b="1">
                 <a:solidFill>
-                  <a:srgbClr val="CC0000"/>
+                  <a:srgbClr val="15795F"/>
                 </a:solidFill>
                 <a:latin typeface="Kanit"/>
               </a:rPr>
-              <a:t>เทียบปีก่อน −0.1%</a:t>
+              <a:t>เทียบปีก่อน +0.1%</a:t>
             </a:r>
           </a:p>
         </p:txBody>
       </p:sp>
       <p:sp>
         <p:nvSpPr>
-          <p:cNvPr id="46" name="TextBox 45"/>
+          <p:cNvPr id="53" name="TextBox 52"/>
           <p:cNvSpPr txBox="1"/>
           <p:nvPr/>
         </p:nvSpPr>
         <p:spPr>
           <a:xfrm>
-            <a:off x="10699394" y="2244851"/>
+            <a:off x="1489557" y="3351275"/>
             <a:ext cx="1078077" cy="134112"/>
           </a:xfrm>
           <a:prstGeom prst="rect">
@@ -49831,13 +49986,13 @@
       </p:sp>
       <p:sp>
         <p:nvSpPr>
-          <p:cNvPr id="47" name="Rectangle 46"/>
+          <p:cNvPr id="54" name="Rectangle 53"/>
           <p:cNvSpPr/>
           <p:nvPr/>
         </p:nvSpPr>
         <p:spPr>
           <a:xfrm>
-            <a:off x="9621316" y="2400300"/>
+            <a:off x="411480" y="3506724"/>
             <a:ext cx="2156155" cy="548640"/>
           </a:xfrm>
           <a:prstGeom prst="rect">
@@ -49877,13 +50032,13 @@
       </p:sp>
       <p:sp>
         <p:nvSpPr>
-          <p:cNvPr id="48" name="Freeform 47"/>
+          <p:cNvPr id="55" name="Freeform 54"/>
           <p:cNvSpPr/>
           <p:nvPr/>
         </p:nvSpPr>
         <p:spPr>
           <a:xfrm>
-            <a:off x="9667036" y="2446020"/>
+            <a:off x="457200" y="3552444"/>
             <a:ext cx="2064715" cy="457200"/>
           </a:xfrm>
           <a:custGeom>
@@ -49947,13 +50102,13 @@
       </p:sp>
       <p:sp>
         <p:nvSpPr>
-          <p:cNvPr id="49" name="Rounded Rectangle 48"/>
+          <p:cNvPr id="56" name="Rounded Rectangle 55"/>
           <p:cNvSpPr/>
           <p:nvPr/>
         </p:nvSpPr>
         <p:spPr>
           <a:xfrm>
-            <a:off x="11690603" y="2680208"/>
+            <a:off x="2480767" y="3786632"/>
             <a:ext cx="82296" cy="82296"/>
           </a:xfrm>
           <a:prstGeom prst="roundRect">
@@ -49993,13 +50148,13 @@
       </p:sp>
       <p:sp>
         <p:nvSpPr>
-          <p:cNvPr id="50" name="TextBox 49"/>
+          <p:cNvPr id="57" name="TextBox 56"/>
           <p:cNvSpPr txBox="1"/>
           <p:nvPr/>
         </p:nvSpPr>
         <p:spPr>
           <a:xfrm>
-            <a:off x="411480" y="3076956"/>
+            <a:off x="2713939" y="3076956"/>
             <a:ext cx="2156155" cy="150876"/>
           </a:xfrm>
           <a:prstGeom prst="rect">
@@ -50025,20 +50180,20 @@
                 </a:solidFill>
                 <a:latin typeface="Kanit"/>
               </a:rPr>
-              <a:t>ไข่ไก่</a:t>
+              <a:t>ข้าวโพดเลี้ยงสัตว์</a:t>
             </a:r>
           </a:p>
         </p:txBody>
       </p:sp>
       <p:sp>
         <p:nvSpPr>
-          <p:cNvPr id="51" name="TextBox 50"/>
+          <p:cNvPr id="58" name="TextBox 57"/>
           <p:cNvSpPr txBox="1"/>
           <p:nvPr/>
         </p:nvSpPr>
         <p:spPr>
           <a:xfrm>
-            <a:off x="411480" y="3218687"/>
+            <a:off x="2713939" y="3218687"/>
             <a:ext cx="2156155" cy="125730"/>
           </a:xfrm>
           <a:prstGeom prst="rect">
@@ -50064,59 +50219,20 @@
                 </a:solidFill>
                 <a:latin typeface="Kanit"/>
               </a:rPr>
-              <a:t>฿338.24 /ร้อยฟอง · กลาง·ตอ.</a:t>
+              <a:t>฿10.76 /กก. · เหนือ</a:t>
             </a:r>
           </a:p>
         </p:txBody>
       </p:sp>
       <p:sp>
         <p:nvSpPr>
-          <p:cNvPr id="52" name="TextBox 51"/>
+          <p:cNvPr id="59" name="TextBox 58"/>
           <p:cNvSpPr txBox="1"/>
           <p:nvPr/>
         </p:nvSpPr>
         <p:spPr>
           <a:xfrm>
-            <a:off x="411480" y="3351275"/>
-            <a:ext cx="1078077" cy="134112"/>
-          </a:xfrm>
-          <a:prstGeom prst="rect">
-            <a:avLst/>
-          </a:prstGeom>
-          <a:noFill/>
-        </p:spPr>
-        <p:txBody>
-          <a:bodyPr wrap="square" lIns="0" rIns="0" tIns="0" bIns="0" anchor="t">
-            <a:noAutofit/>
-          </a:bodyPr>
-          <a:lstStyle/>
-          <a:p>
-            <a:pPr algn="l">
-              <a:lnSpc>
-                <a:spcPts val="1056"/>
-              </a:lnSpc>
-            </a:pPr>
-            <a:r>
-              <a:rPr sz="800" b="1">
-                <a:solidFill>
-                  <a:srgbClr val="606060"/>
-                </a:solidFill>
-                <a:latin typeface="Kanit"/>
-              </a:rPr>
-              <a:t>เทียบปีก่อน +0.0%</a:t>
-            </a:r>
-          </a:p>
-        </p:txBody>
-      </p:sp>
-      <p:sp>
-        <p:nvSpPr>
-          <p:cNvPr id="53" name="TextBox 52"/>
-          <p:cNvSpPr txBox="1"/>
-          <p:nvPr/>
-        </p:nvSpPr>
-        <p:spPr>
-          <a:xfrm>
-            <a:off x="1489557" y="3351275"/>
+            <a:off x="2713939" y="3351275"/>
             <a:ext cx="1078077" cy="134112"/>
           </a:xfrm>
           <a:prstGeom prst="rect">
@@ -50142,20 +50258,59 @@
                 </a:solidFill>
                 <a:latin typeface="Kanit"/>
               </a:rPr>
-              <a:t>6 เดือน +5.0%</a:t>
+              <a:t>เทียบปีก่อน +13.3%</a:t>
             </a:r>
           </a:p>
         </p:txBody>
       </p:sp>
       <p:sp>
         <p:nvSpPr>
-          <p:cNvPr id="54" name="Rectangle 53"/>
+          <p:cNvPr id="60" name="TextBox 59"/>
+          <p:cNvSpPr txBox="1"/>
+          <p:nvPr/>
+        </p:nvSpPr>
+        <p:spPr>
+          <a:xfrm>
+            <a:off x="3792016" y="3351275"/>
+            <a:ext cx="1078077" cy="134112"/>
+          </a:xfrm>
+          <a:prstGeom prst="rect">
+            <a:avLst/>
+          </a:prstGeom>
+          <a:noFill/>
+        </p:spPr>
+        <p:txBody>
+          <a:bodyPr wrap="square" lIns="0" rIns="0" tIns="0" bIns="0" anchor="t">
+            <a:noAutofit/>
+          </a:bodyPr>
+          <a:lstStyle/>
+          <a:p>
+            <a:pPr algn="l">
+              <a:lnSpc>
+                <a:spcPts val="1056"/>
+              </a:lnSpc>
+            </a:pPr>
+            <a:r>
+              <a:rPr sz="800" b="1">
+                <a:solidFill>
+                  <a:srgbClr val="15795F"/>
+                </a:solidFill>
+                <a:latin typeface="Kanit"/>
+              </a:rPr>
+              <a:t>6 เดือน +22.1%</a:t>
+            </a:r>
+          </a:p>
+        </p:txBody>
+      </p:sp>
+      <p:sp>
+        <p:nvSpPr>
+          <p:cNvPr id="61" name="Rectangle 60"/>
           <p:cNvSpPr/>
           <p:nvPr/>
         </p:nvSpPr>
         <p:spPr>
           <a:xfrm>
-            <a:off x="411480" y="3506724"/>
+            <a:off x="2713939" y="3506724"/>
             <a:ext cx="2156155" cy="548640"/>
           </a:xfrm>
           <a:prstGeom prst="rect">
@@ -50195,13 +50350,13 @@
       </p:sp>
       <p:sp>
         <p:nvSpPr>
-          <p:cNvPr id="55" name="Freeform 54"/>
+          <p:cNvPr id="62" name="Freeform 61"/>
           <p:cNvSpPr/>
           <p:nvPr/>
         </p:nvSpPr>
         <p:spPr>
           <a:xfrm>
-            <a:off x="457200" y="3552444"/>
+            <a:off x="2759659" y="3552444"/>
             <a:ext cx="2064715" cy="457200"/>
           </a:xfrm>
           <a:custGeom>
@@ -50216,19 +50371,19 @@
                   <a:pt x="0" y="457200"/>
                 </a:moveTo>
                 <a:lnTo>
-                  <a:pt x="412943" y="391702"/>
-                </a:lnTo>
-                <a:lnTo>
-                  <a:pt x="825886" y="105409"/>
-                </a:lnTo>
-                <a:lnTo>
-                  <a:pt x="1238829" y="105409"/>
-                </a:lnTo>
-                <a:lnTo>
-                  <a:pt x="1651772" y="214144"/>
-                </a:lnTo>
-                <a:lnTo>
-                  <a:pt x="2064715" y="0"/>
+                  <a:pt x="412943" y="415234"/>
+                </a:lnTo>
+                <a:lnTo>
+                  <a:pt x="825886" y="315843"/>
+                </a:lnTo>
+                <a:lnTo>
+                  <a:pt x="1238829" y="81721"/>
+                </a:lnTo>
+                <a:lnTo>
+                  <a:pt x="1651772" y="0"/>
+                </a:lnTo>
+                <a:lnTo>
+                  <a:pt x="2064715" y="46382"/>
                 </a:lnTo>
               </a:path>
             </a:pathLst>
@@ -50265,13 +50420,13 @@
       </p:sp>
       <p:sp>
         <p:nvSpPr>
-          <p:cNvPr id="56" name="Rounded Rectangle 55"/>
+          <p:cNvPr id="63" name="Rounded Rectangle 62"/>
           <p:cNvSpPr/>
           <p:nvPr/>
         </p:nvSpPr>
         <p:spPr>
           <a:xfrm>
-            <a:off x="2480767" y="3511296"/>
+            <a:off x="4783226" y="3557678"/>
             <a:ext cx="82296" cy="82296"/>
           </a:xfrm>
           <a:prstGeom prst="roundRect">
@@ -50311,13 +50466,13 @@
       </p:sp>
       <p:sp>
         <p:nvSpPr>
-          <p:cNvPr id="57" name="TextBox 56"/>
+          <p:cNvPr id="64" name="TextBox 63"/>
           <p:cNvSpPr txBox="1"/>
           <p:nvPr/>
         </p:nvSpPr>
         <p:spPr>
           <a:xfrm>
-            <a:off x="2713939" y="3076956"/>
+            <a:off x="5016398" y="3076956"/>
             <a:ext cx="2156155" cy="150876"/>
           </a:xfrm>
           <a:prstGeom prst="rect">
@@ -50350,13 +50505,13 @@
       </p:sp>
       <p:sp>
         <p:nvSpPr>
-          <p:cNvPr id="58" name="TextBox 57"/>
+          <p:cNvPr id="65" name="TextBox 64"/>
           <p:cNvSpPr txBox="1"/>
           <p:nvPr/>
         </p:nvSpPr>
         <p:spPr>
           <a:xfrm>
-            <a:off x="2713939" y="3218687"/>
+            <a:off x="5016398" y="3218687"/>
             <a:ext cx="2156155" cy="125730"/>
           </a:xfrm>
           <a:prstGeom prst="rect">
@@ -50389,13 +50544,13 @@
       </p:sp>
       <p:sp>
         <p:nvSpPr>
-          <p:cNvPr id="59" name="TextBox 58"/>
+          <p:cNvPr id="66" name="TextBox 65"/>
           <p:cNvSpPr txBox="1"/>
           <p:nvPr/>
         </p:nvSpPr>
         <p:spPr>
           <a:xfrm>
-            <a:off x="2713939" y="3351275"/>
+            <a:off x="5016398" y="3351275"/>
             <a:ext cx="1078077" cy="134112"/>
           </a:xfrm>
           <a:prstGeom prst="rect">
@@ -50421,20 +50576,20 @@
                 </a:solidFill>
                 <a:latin typeface="Kanit"/>
               </a:rPr>
-              <a:t>เทียบปีก่อน +13.2%</a:t>
+              <a:t>เทียบปีก่อน +13.4%</a:t>
             </a:r>
           </a:p>
         </p:txBody>
       </p:sp>
       <p:sp>
         <p:nvSpPr>
-          <p:cNvPr id="60" name="TextBox 59"/>
+          <p:cNvPr id="67" name="TextBox 66"/>
           <p:cNvSpPr txBox="1"/>
           <p:nvPr/>
         </p:nvSpPr>
         <p:spPr>
           <a:xfrm>
-            <a:off x="3792016" y="3351275"/>
+            <a:off x="6094475" y="3351275"/>
             <a:ext cx="1078077" cy="134112"/>
           </a:xfrm>
           <a:prstGeom prst="rect">
@@ -50467,13 +50622,13 @@
       </p:sp>
       <p:sp>
         <p:nvSpPr>
-          <p:cNvPr id="61" name="Rectangle 60"/>
+          <p:cNvPr id="68" name="Rectangle 67"/>
           <p:cNvSpPr/>
           <p:nvPr/>
         </p:nvSpPr>
         <p:spPr>
           <a:xfrm>
-            <a:off x="2713939" y="3506724"/>
+            <a:off x="5016398" y="3506724"/>
             <a:ext cx="2156155" cy="548640"/>
           </a:xfrm>
           <a:prstGeom prst="rect">
@@ -50513,13 +50668,13 @@
       </p:sp>
       <p:sp>
         <p:nvSpPr>
-          <p:cNvPr id="62" name="Freeform 61"/>
+          <p:cNvPr id="69" name="Freeform 68"/>
           <p:cNvSpPr/>
           <p:nvPr/>
         </p:nvSpPr>
         <p:spPr>
           <a:xfrm>
-            <a:off x="2759659" y="3552444"/>
+            <a:off x="5062118" y="3552444"/>
             <a:ext cx="2064715" cy="457200"/>
           </a:xfrm>
           <a:custGeom>
@@ -50583,331 +50738,13 @@
       </p:sp>
       <p:sp>
         <p:nvSpPr>
-          <p:cNvPr id="63" name="Rounded Rectangle 62"/>
-          <p:cNvSpPr/>
-          <p:nvPr/>
-        </p:nvSpPr>
-        <p:spPr>
-          <a:xfrm>
-            <a:off x="4783226" y="3511296"/>
-            <a:ext cx="82296" cy="82296"/>
-          </a:xfrm>
-          <a:prstGeom prst="roundRect">
-            <a:avLst>
-              <a:gd name="adj" fmla="val 50000"/>
-            </a:avLst>
-          </a:prstGeom>
-          <a:solidFill>
-            <a:srgbClr val="15795F"/>
-          </a:solidFill>
-          <a:ln>
-            <a:noFill/>
-          </a:ln>
-          <a:effectLst/>
-        </p:spPr>
-        <p:style>
-          <a:lnRef idx="1">
-            <a:schemeClr val="accent1"/>
-          </a:lnRef>
-          <a:fillRef idx="3">
-            <a:schemeClr val="accent1"/>
-          </a:fillRef>
-          <a:effectRef idx="2">
-            <a:schemeClr val="accent1"/>
-          </a:effectRef>
-          <a:fontRef idx="minor">
-            <a:schemeClr val="lt1"/>
-          </a:fontRef>
-        </p:style>
-        <p:txBody>
-          <a:bodyPr rtlCol="0" anchor="ctr" wrap="none"/>
-          <a:lstStyle/>
-          <a:p>
-            <a:pPr algn="ctr"/>
-          </a:p>
-        </p:txBody>
-      </p:sp>
-      <p:sp>
-        <p:nvSpPr>
-          <p:cNvPr id="64" name="TextBox 63"/>
-          <p:cNvSpPr txBox="1"/>
-          <p:nvPr/>
-        </p:nvSpPr>
-        <p:spPr>
-          <a:xfrm>
-            <a:off x="5016398" y="3076956"/>
-            <a:ext cx="2156155" cy="150876"/>
-          </a:xfrm>
-          <a:prstGeom prst="rect">
-            <a:avLst/>
-          </a:prstGeom>
-          <a:noFill/>
-        </p:spPr>
-        <p:txBody>
-          <a:bodyPr wrap="square" lIns="0" rIns="0" tIns="0" bIns="0" anchor="t">
-            <a:noAutofit/>
-          </a:bodyPr>
-          <a:lstStyle/>
-          <a:p>
-            <a:pPr algn="l">
-              <a:lnSpc>
-                <a:spcPts val="1188"/>
-              </a:lnSpc>
-            </a:pPr>
-            <a:r>
-              <a:rPr sz="900" b="1">
-                <a:solidFill>
-                  <a:srgbClr val="1E2F5C"/>
-                </a:solidFill>
-                <a:latin typeface="Kanit"/>
-              </a:rPr>
-              <a:t>ข้าวโพดเลี้ยงสัตว์</a:t>
-            </a:r>
-          </a:p>
-        </p:txBody>
-      </p:sp>
-      <p:sp>
-        <p:nvSpPr>
-          <p:cNvPr id="65" name="TextBox 64"/>
-          <p:cNvSpPr txBox="1"/>
-          <p:nvPr/>
-        </p:nvSpPr>
-        <p:spPr>
-          <a:xfrm>
-            <a:off x="5016398" y="3218687"/>
-            <a:ext cx="2156155" cy="125730"/>
-          </a:xfrm>
-          <a:prstGeom prst="rect">
-            <a:avLst/>
-          </a:prstGeom>
-          <a:noFill/>
-        </p:spPr>
-        <p:txBody>
-          <a:bodyPr wrap="square" lIns="0" rIns="0" tIns="0" bIns="0" anchor="t">
-            <a:noAutofit/>
-          </a:bodyPr>
-          <a:lstStyle/>
-          <a:p>
-            <a:pPr algn="l">
-              <a:lnSpc>
-                <a:spcPts val="990"/>
-              </a:lnSpc>
-            </a:pPr>
-            <a:r>
-              <a:rPr sz="750" b="0">
-                <a:solidFill>
-                  <a:srgbClr val="606060"/>
-                </a:solidFill>
-                <a:latin typeface="Kanit"/>
-              </a:rPr>
-              <a:t>฿10.76 /กก. · เหนือ</a:t>
-            </a:r>
-          </a:p>
-        </p:txBody>
-      </p:sp>
-      <p:sp>
-        <p:nvSpPr>
-          <p:cNvPr id="66" name="TextBox 65"/>
-          <p:cNvSpPr txBox="1"/>
-          <p:nvPr/>
-        </p:nvSpPr>
-        <p:spPr>
-          <a:xfrm>
-            <a:off x="5016398" y="3351275"/>
-            <a:ext cx="1078077" cy="134112"/>
-          </a:xfrm>
-          <a:prstGeom prst="rect">
-            <a:avLst/>
-          </a:prstGeom>
-          <a:noFill/>
-        </p:spPr>
-        <p:txBody>
-          <a:bodyPr wrap="square" lIns="0" rIns="0" tIns="0" bIns="0" anchor="t">
-            <a:noAutofit/>
-          </a:bodyPr>
-          <a:lstStyle/>
-          <a:p>
-            <a:pPr algn="l">
-              <a:lnSpc>
-                <a:spcPts val="1056"/>
-              </a:lnSpc>
-            </a:pPr>
-            <a:r>
-              <a:rPr sz="800" b="1">
-                <a:solidFill>
-                  <a:srgbClr val="15795F"/>
-                </a:solidFill>
-                <a:latin typeface="Kanit"/>
-              </a:rPr>
-              <a:t>เทียบปีก่อน +13.4%</a:t>
-            </a:r>
-          </a:p>
-        </p:txBody>
-      </p:sp>
-      <p:sp>
-        <p:nvSpPr>
-          <p:cNvPr id="67" name="TextBox 66"/>
-          <p:cNvSpPr txBox="1"/>
-          <p:nvPr/>
-        </p:nvSpPr>
-        <p:spPr>
-          <a:xfrm>
-            <a:off x="6094475" y="3351275"/>
-            <a:ext cx="1078077" cy="134112"/>
-          </a:xfrm>
-          <a:prstGeom prst="rect">
-            <a:avLst/>
-          </a:prstGeom>
-          <a:noFill/>
-        </p:spPr>
-        <p:txBody>
-          <a:bodyPr wrap="square" lIns="0" rIns="0" tIns="0" bIns="0" anchor="t">
-            <a:noAutofit/>
-          </a:bodyPr>
-          <a:lstStyle/>
-          <a:p>
-            <a:pPr algn="l">
-              <a:lnSpc>
-                <a:spcPts val="1056"/>
-              </a:lnSpc>
-            </a:pPr>
-            <a:r>
-              <a:rPr sz="800" b="1">
-                <a:solidFill>
-                  <a:srgbClr val="15795F"/>
-                </a:solidFill>
-                <a:latin typeface="Kanit"/>
-              </a:rPr>
-              <a:t>6 เดือน +22.1%</a:t>
-            </a:r>
-          </a:p>
-        </p:txBody>
-      </p:sp>
-      <p:sp>
-        <p:nvSpPr>
-          <p:cNvPr id="68" name="Rectangle 67"/>
-          <p:cNvSpPr/>
-          <p:nvPr/>
-        </p:nvSpPr>
-        <p:spPr>
-          <a:xfrm>
-            <a:off x="5016398" y="3506724"/>
-            <a:ext cx="2156155" cy="548640"/>
-          </a:xfrm>
-          <a:prstGeom prst="rect">
-            <a:avLst/>
-          </a:prstGeom>
-          <a:solidFill>
-            <a:srgbClr val="FBFCFE"/>
-          </a:solidFill>
-          <a:ln w="9525">
-            <a:solidFill>
-              <a:srgbClr val="D9DEE9"/>
-            </a:solidFill>
-          </a:ln>
-          <a:effectLst/>
-        </p:spPr>
-        <p:style>
-          <a:lnRef idx="1">
-            <a:schemeClr val="accent1"/>
-          </a:lnRef>
-          <a:fillRef idx="3">
-            <a:schemeClr val="accent1"/>
-          </a:fillRef>
-          <a:effectRef idx="2">
-            <a:schemeClr val="accent1"/>
-          </a:effectRef>
-          <a:fontRef idx="minor">
-            <a:schemeClr val="lt1"/>
-          </a:fontRef>
-        </p:style>
-        <p:txBody>
-          <a:bodyPr rtlCol="0" anchor="ctr" wrap="none"/>
-          <a:lstStyle/>
-          <a:p>
-            <a:pPr algn="ctr"/>
-          </a:p>
-        </p:txBody>
-      </p:sp>
-      <p:sp>
-        <p:nvSpPr>
-          <p:cNvPr id="69" name="Freeform 68"/>
-          <p:cNvSpPr/>
-          <p:nvPr/>
-        </p:nvSpPr>
-        <p:spPr>
-          <a:xfrm>
-            <a:off x="5062118" y="3552444"/>
-            <a:ext cx="2064715" cy="457200"/>
-          </a:xfrm>
-          <a:custGeom>
-            <a:avLst/>
-            <a:gdLst/>
-            <a:ahLst/>
-            <a:cxnLst/>
-            <a:rect l="l" t="t" r="r" b="b"/>
-            <a:pathLst>
-              <a:path w="2064715" h="457200">
-                <a:moveTo>
-                  <a:pt x="0" y="457200"/>
-                </a:moveTo>
-                <a:lnTo>
-                  <a:pt x="412943" y="415234"/>
-                </a:lnTo>
-                <a:lnTo>
-                  <a:pt x="825886" y="315843"/>
-                </a:lnTo>
-                <a:lnTo>
-                  <a:pt x="1238829" y="81721"/>
-                </a:lnTo>
-                <a:lnTo>
-                  <a:pt x="1651772" y="0"/>
-                </a:lnTo>
-                <a:lnTo>
-                  <a:pt x="2064715" y="46382"/>
-                </a:lnTo>
-              </a:path>
-            </a:pathLst>
-          </a:custGeom>
-          <a:noFill/>
-          <a:ln w="20320">
-            <a:solidFill>
-              <a:srgbClr val="15795F"/>
-            </a:solidFill>
-          </a:ln>
-          <a:effectLst/>
-        </p:spPr>
-        <p:style>
-          <a:lnRef idx="1">
-            <a:schemeClr val="accent1"/>
-          </a:lnRef>
-          <a:fillRef idx="3">
-            <a:schemeClr val="accent1"/>
-          </a:fillRef>
-          <a:effectRef idx="2">
-            <a:schemeClr val="accent1"/>
-          </a:effectRef>
-          <a:fontRef idx="minor">
-            <a:schemeClr val="lt1"/>
-          </a:fontRef>
-        </p:style>
-        <p:txBody>
-          <a:bodyPr rtlCol="0" anchor="ctr"/>
-          <a:lstStyle/>
-          <a:p>
-            <a:pPr algn="ctr"/>
-          </a:p>
-        </p:txBody>
-      </p:sp>
-      <p:sp>
-        <p:nvSpPr>
           <p:cNvPr id="70" name="Rounded Rectangle 69"/>
           <p:cNvSpPr/>
           <p:nvPr/>
         </p:nvSpPr>
         <p:spPr>
           <a:xfrm>
-            <a:off x="7085685" y="3557678"/>
+            <a:off x="7085685" y="3511296"/>
             <a:ext cx="82296" cy="82296"/>
           </a:xfrm>
           <a:prstGeom prst="roundRect">
@@ -51057,7 +50894,7 @@
                 </a:solidFill>
                 <a:latin typeface="Kanit"/>
               </a:rPr>
-              <a:t>เทียบปีก่อน +27.5%</a:t>
+              <a:t>เทียบปีก่อน +27.3%</a:t>
             </a:r>
           </a:p>
         </p:txBody>
@@ -51375,7 +51212,7 @@
                 </a:solidFill>
                 <a:latin typeface="Kanit"/>
               </a:rPr>
-              <a:t>เทียบปีก่อน +41.2%</a:t>
+              <a:t>เทียบปีก่อน +41.1%</a:t>
             </a:r>
           </a:p>
         </p:txBody>
@@ -51693,7 +51530,7 @@
                 </a:solidFill>
                 <a:latin typeface="Kanit"/>
               </a:rPr>
-              <a:t>เทียบปีก่อน +58.8%</a:t>
+              <a:t>เทียบปีก่อน +59.3%</a:t>
             </a:r>
           </a:p>
         </p:txBody>
@@ -52011,7 +51848,7 @@
                 </a:solidFill>
                 <a:latin typeface="Kanit"/>
               </a:rPr>
-              <a:t>เทียบปีก่อน +75.6%</a:t>
+              <a:t>เทียบปีก่อน +94.7%</a:t>
             </a:r>
           </a:p>
         </p:txBody>
@@ -52375,7 +52212,7 @@
                 </a:solidFill>
                 <a:latin typeface="Kanit"/>
               </a:rPr>
-              <a:t>ราคาหน้าฟาร์ม วัดจริง — ราคารายวันของ NABC เฉลี่ยเป็นรายเดือน หน่วยเป็นบาทตามที่เผยแพร่ (ไม่มีการแปลงสกุลเงิน) ราคาล่าสุด 2026-08-03, รุ่นข้อมูลย้อนหลัง 2026-08-02 ราคาหน้าฟาร์ม (ราคาที่เกษตรกรขายได้) คือเงินที่เกษตรกรได้รับเมื่อขายครั้งแรก ก่อนพ่อค้าคนกลาง โรงสี หรือค่าขนส่งจะหักส่วนแบ่ง — ไม่ใช่ดัชนีโลก และไม่ใช่ราคาในซูเปอร์มาร์เก็ต แหล่งผลิตเป็นการอ่านแบบ ประมาณการ ว่าสินค้าแต่ละชนิดผลิตที่ไหน และทับซ้อนกันได้ น้ำตาลเป็นราคาอ้อยประกาศของ สอน. ปีละหนึ่งจุด จึงไม่มีการเปลี่ยนแปลงหกเดือนให้แสดง</a:t>
+              <a:t>ราคาหน้าฟาร์ม วัดจริง — ราคารายวันของ NABC เฉลี่ยเป็นรายเดือน หน่วยเป็นบาทตามที่เผยแพร่ (ไม่มีการแปลงสกุลเงิน) ราคาล่าสุด 2026-08-04, รุ่นข้อมูลย้อนหลัง 2026-08-02 ราคาหน้าฟาร์ม (ราคาที่เกษตรกรขายได้) คือเงินที่เกษตรกรได้รับเมื่อขายครั้งแรก ก่อนพ่อค้าคนกลาง โรงสี หรือค่าขนส่งจะหักส่วนแบ่ง — ไม่ใช่ดัชนีโลก และไม่ใช่ราคาในซูเปอร์มาร์เก็ต แหล่งผลิตเป็นการอ่านแบบ ประมาณการ ว่าสินค้าแต่ละชนิดผลิตที่ไหน และทับซ้อนกันได้ น้ำตาลเป็นราคาอ้อยประกาศของ สอน. ปีละหนึ่งจุด จึงไม่มีการเปลี่ยนแปลงหกเดือนให้แสดง</a:t>
             </a:r>
           </a:p>
         </p:txBody>

</xml_diff>

<commit_message>
deck(mcom): rebuild — the data moved past the committed figures (run 31487447613)
</commit_message>
<xml_diff>
--- a/docs/decks/mcom-2026-08-05-macro-TH.pptx
+++ b/docs/decks/mcom-2026-08-05-macro-TH.pptx
@@ -6240,7 +6240,7 @@
                 </a:solidFill>
                 <a:latin typeface="Kanit"/>
               </a:rPr>
-              <a:t>167</a:t>
+              <a:t>156</a:t>
             </a:r>
           </a:p>
         </p:txBody>
@@ -6279,7 +6279,7 @@
                 </a:solidFill>
                 <a:latin typeface="Kanit"/>
               </a:rPr>
-              <a:t>จาก 796 (21.0%) · เรียลไทม์ · 2026-08-09</a:t>
+              <a:t>จาก 794 (19.6%) · เรียลไทม์ · 2026-08-11</a:t>
             </a:r>
           </a:p>
         </p:txBody>
@@ -6405,7 +6405,7 @@
                 </a:solidFill>
                 <a:latin typeface="Kanit"/>
               </a:rPr>
-              <a:t>20</a:t>
+              <a:t>14</a:t>
             </a:r>
           </a:p>
         </p:txBody>
@@ -6444,7 +6444,7 @@
                 </a:solidFill>
                 <a:latin typeface="Kanit"/>
               </a:rPr>
-              <a:t>ค่าล่าสุดรายวัน · 2026-08-09</a:t>
+              <a:t>ค่าล่าสุดรายวัน · 2026-08-11</a:t>
             </a:r>
           </a:p>
         </p:txBody>
@@ -7905,7 +7905,7 @@
                           </a:solidFill>
                           <a:latin typeface="Kanit"/>
                         </a:rPr>
-                        <a:t>121</a:t>
+                        <a:t>123</a:t>
                       </a:r>
                     </a:p>
                   </a:txBody>
@@ -7928,7 +7928,7 @@
                           </a:solidFill>
                           <a:latin typeface="Kanit"/>
                         </a:rPr>
-                        <a:t>82</a:t>
+                        <a:t>105</a:t>
                       </a:r>
                     </a:p>
                   </a:txBody>
@@ -7951,7 +7951,7 @@
                           </a:solidFill>
                           <a:latin typeface="Kanit"/>
                         </a:rPr>
-                        <a:t>24.8%</a:t>
+                        <a:t>10.6%</a:t>
                       </a:r>
                     </a:p>
                   </a:txBody>
@@ -7974,7 +7974,7 @@
                           </a:solidFill>
                           <a:latin typeface="Kanit"/>
                         </a:rPr>
-                        <a:t>5/13</a:t>
+                        <a:t>4/13</a:t>
                       </a:r>
                     </a:p>
                   </a:txBody>
@@ -8022,7 +8022,7 @@
                           </a:solidFill>
                           <a:latin typeface="Kanit"/>
                         </a:rPr>
-                        <a:t>น่าน</a:t>
+                        <a:t>นราธิวาส</a:t>
                       </a:r>
                     </a:p>
                   </a:txBody>
@@ -8045,7 +8045,7 @@
                           </a:solidFill>
                           <a:latin typeface="Kanit"/>
                         </a:rPr>
-                        <a:t>221</a:t>
+                        <a:t>64</a:t>
                       </a:r>
                     </a:p>
                   </a:txBody>
@@ -8068,7 +8068,7 @@
                           </a:solidFill>
                           <a:latin typeface="Kanit"/>
                         </a:rPr>
-                        <a:t>134</a:t>
+                        <a:t>38</a:t>
                       </a:r>
                     </a:p>
                   </a:txBody>
@@ -8091,7 +8091,7 @@
                           </a:solidFill>
                           <a:latin typeface="Kanit"/>
                         </a:rPr>
-                        <a:t>23.5%</a:t>
+                        <a:t>1.6%</a:t>
                       </a:r>
                     </a:p>
                   </a:txBody>
@@ -8114,7 +8114,7 @@
                           </a:solidFill>
                           <a:latin typeface="Kanit"/>
                         </a:rPr>
-                        <a:t>10/28</a:t>
+                        <a:t>5/10</a:t>
                       </a:r>
                     </a:p>
                   </a:txBody>
@@ -8162,7 +8162,7 @@
                           </a:solidFill>
                           <a:latin typeface="Kanit"/>
                         </a:rPr>
-                        <a:t>นครพนม</a:t>
+                        <a:t>ชัยภูมิ</a:t>
                       </a:r>
                     </a:p>
                   </a:txBody>
@@ -8185,7 +8185,7 @@
                           </a:solidFill>
                           <a:latin typeface="Kanit"/>
                         </a:rPr>
-                        <a:t>29</a:t>
+                        <a:t>58</a:t>
                       </a:r>
                     </a:p>
                   </a:txBody>
@@ -8208,7 +8208,7 @@
                           </a:solidFill>
                           <a:latin typeface="Kanit"/>
                         </a:rPr>
-                        <a:t>278</a:t>
+                        <a:t>24</a:t>
                       </a:r>
                     </a:p>
                   </a:txBody>
@@ -8227,11 +8227,11 @@
                       <a:r>
                         <a:rPr sz="900" b="1">
                           <a:solidFill>
-                            <a:srgbClr val="F5C242"/>
-                          </a:solidFill>
-                          <a:latin typeface="Kanit"/>
-                        </a:rPr>
-                        <a:t>17.2%</a:t>
+                            <a:srgbClr val="606060"/>
+                          </a:solidFill>
+                          <a:latin typeface="Kanit"/>
+                        </a:rPr>
+                        <a:t>0.0%</a:t>
                       </a:r>
                     </a:p>
                   </a:txBody>
@@ -8254,7 +8254,7 @@
                           </a:solidFill>
                           <a:latin typeface="Kanit"/>
                         </a:rPr>
-                        <a:t>9/15</a:t>
+                        <a:t>1/12</a:t>
                       </a:r>
                     </a:p>
                   </a:txBody>
@@ -8302,7 +8302,7 @@
                           </a:solidFill>
                           <a:latin typeface="Kanit"/>
                         </a:rPr>
-                        <a:t>สกลนคร</a:t>
+                        <a:t>นครพนม</a:t>
                       </a:r>
                     </a:p>
                   </a:txBody>
@@ -8325,7 +8325,7 @@
                           </a:solidFill>
                           <a:latin typeface="Kanit"/>
                         </a:rPr>
-                        <a:t>36</a:t>
+                        <a:t>29</a:t>
                       </a:r>
                     </a:p>
                   </a:txBody>
@@ -8348,7 +8348,7 @@
                           </a:solidFill>
                           <a:latin typeface="Kanit"/>
                         </a:rPr>
-                        <a:t>47</a:t>
+                        <a:t>9</a:t>
                       </a:r>
                     </a:p>
                   </a:txBody>
@@ -8367,11 +8367,11 @@
                       <a:r>
                         <a:rPr sz="900" b="1">
                           <a:solidFill>
-                            <a:srgbClr val="F5C242"/>
-                          </a:solidFill>
-                          <a:latin typeface="Kanit"/>
-                        </a:rPr>
-                        <a:t>2.8%</a:t>
+                            <a:srgbClr val="606060"/>
+                          </a:solidFill>
+                          <a:latin typeface="Kanit"/>
+                        </a:rPr>
+                        <a:t>0.0%</a:t>
                       </a:r>
                     </a:p>
                   </a:txBody>
@@ -8394,7 +8394,7 @@
                           </a:solidFill>
                           <a:latin typeface="Kanit"/>
                         </a:rPr>
-                        <a:t>9/14</a:t>
+                        <a:t>9/15</a:t>
                       </a:r>
                     </a:p>
                   </a:txBody>
@@ -8442,7 +8442,7 @@
                           </a:solidFill>
                           <a:latin typeface="Kanit"/>
                         </a:rPr>
-                        <a:t>นราธิวาส</a:t>
+                        <a:t>บึงกาฬ</a:t>
                       </a:r>
                     </a:p>
                   </a:txBody>
@@ -8465,7 +8465,7 @@
                           </a:solidFill>
                           <a:latin typeface="Kanit"/>
                         </a:rPr>
-                        <a:t>64</a:t>
+                        <a:t>11</a:t>
                       </a:r>
                     </a:p>
                   </a:txBody>
@@ -8488,7 +8488,7 @@
                           </a:solidFill>
                           <a:latin typeface="Kanit"/>
                         </a:rPr>
-                        <a:t>24</a:t>
+                        <a:t>23</a:t>
                       </a:r>
                     </a:p>
                   </a:txBody>
@@ -8534,7 +8534,7 @@
                           </a:solidFill>
                           <a:latin typeface="Kanit"/>
                         </a:rPr>
-                        <a:t>5/10</a:t>
+                        <a:t>1/1</a:t>
                       </a:r>
                     </a:p>
                   </a:txBody>
@@ -8605,7 +8605,7 @@
                           </a:solidFill>
                           <a:latin typeface="Kanit"/>
                         </a:rPr>
-                        <a:t>18</a:t>
+                        <a:t>17</a:t>
                       </a:r>
                     </a:p>
                   </a:txBody>
@@ -8628,7 +8628,7 @@
                           </a:solidFill>
                           <a:latin typeface="Kanit"/>
                         </a:rPr>
-                        <a:t>22</a:t>
+                        <a:t>16</a:t>
                       </a:r>
                     </a:p>
                   </a:txBody>
@@ -8909,7 +8909,7 @@
                 </a:solidFill>
                 <a:latin typeface="Kanit"/>
               </a:rPr>
-              <a:t>พื้นที่ปลูก วัดจริง (สศก. — ข้อมูลอำเภอ×พืช 3,295 แถว) ภัยแล้งเป็นดัชนี SPEI จาก แบบจำลอง คำนวณจากปริมาณฝนและการคายระเหย ปรับเดือนละครั้ง ดึงข้อมูล 2026-07-20 — เป็นสัญญาณที่ครอบคลุมทั้งประเทศดีที่สุดที่มี แต่ไม่มีใครลงพื้นที่ไปเดินดูอำเภอเหล่านั้น ข้อมูลฝนและระดับน้ำ วัดจริง (ThaiWater เรียลไทม์ ดึงทุกวันและสะสมไว้ — วันที่ดึงไม่สำเร็จจะเว้นเป็นช่องว่าง ไม่ใส่ค่าสมมติ) · ฝนถึง 2026-08-09, ระดับน้ำถึง 2026-08-09 ความเสี่ยงน้ำท่วมเชิงโครงสร้าง วัดจริง (สำมะโนพื้นที่ท่วมซ้ำซาก GISTDA มาตราส่วน 1:50,000 ปี 2005-2016 — เป็นบันทึกภาคพื้นดิน 12 ปี ไม่ใช่การพยากรณ์)</a:t>
+              <a:t>พื้นที่ปลูก วัดจริง (สศก. — ข้อมูลอำเภอ×พืช 3,295 แถว) ภัยแล้งเป็นดัชนี SPEI จาก แบบจำลอง คำนวณจากปริมาณฝนและการคายระเหย ปรับเดือนละครั้ง ดึงข้อมูล 2026-07-20 — เป็นสัญญาณที่ครอบคลุมทั้งประเทศดีที่สุดที่มี แต่ไม่มีใครลงพื้นที่ไปเดินดูอำเภอเหล่านั้น ข้อมูลฝนและระดับน้ำ วัดจริง (ThaiWater เรียลไทม์ ดึงทุกวันและสะสมไว้ — วันที่ดึงไม่สำเร็จจะเว้นเป็นช่องว่าง ไม่ใส่ค่าสมมติ) · ฝนถึง 2026-08-11, ระดับน้ำถึง 2026-08-11 ความเสี่ยงน้ำท่วมเชิงโครงสร้าง วัดจริง (สำมะโนพื้นที่ท่วมซ้ำซาก GISTDA มาตราส่วน 1:50,000 ปี 2005-2016 — เป็นบันทึกภาคพื้นดิน 12 ปี ไม่ใช่การพยากรณ์)</a:t>
             </a:r>
           </a:p>
         </p:txBody>
@@ -31476,7 +31476,7 @@
                 </a:solidFill>
                 <a:latin typeface="Kanit"/>
               </a:rPr>
-              <a:t>รายได้จากพืชค่ากลางเพิ่มขึ้น +16.1% แต่มีสี่จังหวัดที่ลดลง — ทั้งหมดอยู่ในแหล่งปลูกมะพร้าว โดยหนักที่สุดคือสมุทรสงครามที่ −64.0%</a:t>
+              <a:t>รายได้จากพืชค่ากลางเพิ่มขึ้น +16.6% แต่มีสี่จังหวัดที่ลดลง — ทั้งหมดอยู่ในแหล่งปลูกมะพร้าว โดยหนักที่สุดคือสมุทรสงครามที่ −63.4%</a:t>
             </a:r>
           </a:p>
         </p:txBody>
@@ -32047,7 +32047,7 @@
                 </a:solidFill>
                 <a:latin typeface="Kanit"/>
               </a:rPr>
-              <a:t>รุ่นข้อมูล — ราคาโลก 2026M06 · ราคาหน้าฟาร์มไทย 2026-08-07 · ประวัติราคาไทย 2026-08-02 · ต้นทุนการผลิตพืช สศก. ไจอัป 2568 (ปีเพาะปลูก 2568/69, ประมาณการ สศก. มี.ค. 2569) · ภัยแล้ง 2026-06-21 · เงินเฟ้อ 2026-05 · GDP 2026 ไตรมาส 1 · IMF WEO 2026 · ดัชนีราคาขายต่อ 2026-05 · ยอดจดทะเบียนถึง 2026-01 · หนี้ครัวเรือน สสช. SES 2566 · ค่าจ้าง สสช. LFS 2568 · ข้อมูลตรวจวัด 2026-08-09</a:t>
+              <a:t>รุ่นข้อมูล — ราคาโลก 2026M06 · ราคาหน้าฟาร์มไทย 2026-08-11 · ประวัติราคาไทย 2026-08-02 · ต้นทุนการผลิตพืช สศก. ไจอัป 2568 (ปีเพาะปลูก 2568/69, ประมาณการ สศก. มี.ค. 2569) · ภัยแล้ง 2026-06-21 · เงินเฟ้อ 2026-05 · GDP 2026 ไตรมาส 1 · IMF WEO 2026 · ดัชนีราคาขายต่อ 2026-05 · ยอดจดทะเบียนถึง 2026-01 · หนี้ครัวเรือน สสช. SES 2566 · ค่าจ้าง สสช. LFS 2568 · ข้อมูลตรวจวัด 2026-08-11</a:t>
             </a:r>
           </a:p>
         </p:txBody>
@@ -32543,10 +32543,10 @@
                 </a:solidFill>
                 <a:latin typeface="Kanit"/>
               </a:rPr>
-              <a:t>ไม่ใช่ถ้าดูดัชนีโลก — แต่ราคาหน้าฟาร์ม (ราคาที่เกษตรกรขายได้) บอกคนละเรื่อง
-• ราคาหน้าฟาร์มไทยเจ็ดจากสิบเจ็ดรายการลดลงเมื่อเทียบกับปีก่อน
-• เนื้อวัว: หน้าฟาร์ม −6.1% เทียบดัชนีโลก +11.8%
-• ส่วนต่างสำคัญกว่าราคา: ราคาขยับ 26% กลายเป็นรายได้เกษตรเหวี่ยง 83%</a:t>
+              <a:t>Not on the world index — the farm gate (ราคาที่เกษตรกรขายได้) says otherwise.
+• Five of seventeen Thai farm-gate prices are falling year on year.
+• Beef: farm gate −6.1% vs world index +11.8%.
+• Margin over price: a 26% price move becomes an 85% swing in crop income.</a:t>
             </a:r>
           </a:p>
         </p:txBody>
@@ -37087,7 +37087,7 @@
                 </a:solidFill>
                 <a:latin typeface="Kanit"/>
               </a:rPr>
-              <a:t>338 จาก 928 อำเภอ · แม่น้ำเกินระดับ 167 จาก 796 สถานี</a:t>
+              <a:t>338 จาก 928 อำเภอ · แม่น้ำเกินระดับ 156 จาก 794 สถานี</a:t>
             </a:r>
           </a:p>
         </p:txBody>
@@ -37859,7 +37859,7 @@
                           </a:solidFill>
                           <a:latin typeface="Kanit"/>
                         </a:rPr>
-                        <a:t>40/159</a:t>
+                        <a:t>39/158</a:t>
                       </a:r>
                     </a:p>
                   </a:txBody>
@@ -38091,7 +38091,7 @@
                           </a:solidFill>
                           <a:latin typeface="Kanit"/>
                         </a:rPr>
-                        <a:t>45/274</a:t>
+                        <a:t>42/273</a:t>
                       </a:r>
                     </a:p>
                   </a:txBody>
@@ -38323,7 +38323,7 @@
                           </a:solidFill>
                           <a:latin typeface="Kanit"/>
                         </a:rPr>
-                        <a:t>27/168</a:t>
+                        <a:t>24/168</a:t>
                       </a:r>
                     </a:p>
                   </a:txBody>
@@ -38555,7 +38555,7 @@
                           </a:solidFill>
                           <a:latin typeface="Kanit"/>
                         </a:rPr>
-                        <a:t>7/52</a:t>
+                        <a:t>6/52</a:t>
                       </a:r>
                     </a:p>
                   </a:txBody>
@@ -38787,7 +38787,7 @@
                           </a:solidFill>
                           <a:latin typeface="Kanit"/>
                         </a:rPr>
-                        <a:t>48/143</a:t>
+                        <a:t>45/143</a:t>
                       </a:r>
                     </a:p>
                   </a:txBody>
@@ -39502,7 +39502,7 @@
                 </a:solidFill>
                 <a:latin typeface="Kanit"/>
               </a:rPr>
-              <a:t>สินค้าเกษตร 17 จากทั้งหมด 21 รายการที่เราติดตาม มีราคาหน้าฟาร์มไทยที่วัดได้จริง (ราคาที่เกษตรกรขายได้) และเจ็ดรายการกำลังลดลงเมื่อเทียบกับปีก่อน</a:t>
+              <a:t>Seventeen of the 21 commodities we track have a measured Thai farm-gate price (ราคาที่เกษตรกรขายได้). Five are falling year on year.</a:t>
             </a:r>
           </a:p>
         </p:txBody>
@@ -39673,7 +39673,7 @@
         </p:nvGraphicFramePr>
         <p:xfrm>
           <a:off x="411480" y="2033016"/>
-          <a:ext cx="11365992" cy="2108605"/>
+          <a:ext cx="11365992" cy="1600199"/>
         </p:xfrm>
         <a:graphic>
           <a:graphicData uri="http://schemas.openxmlformats.org/drawingml/2006/table">
@@ -39936,7 +39936,7 @@
                           </a:solidFill>
                           <a:latin typeface="Kanit"/>
                         </a:rPr>
-                        <a:t>−68.4%</a:t>
+                        <a:t>−67.8%</a:t>
                       </a:r>
                     </a:p>
                   </a:txBody>
@@ -40658,332 +40658,6 @@
                           <a:latin typeface="Kanit"/>
                         </a:rPr>
                         <a:t>23%</a:t>
-                      </a:r>
-                    </a:p>
-                  </a:txBody>
-                  <a:tcPr marL="54864" marR="54864" marT="18288" marB="18288" anchor="ctr">
-                    <a:solidFill>
-                      <a:srgbClr val="FFFFFF"/>
-                    </a:solidFill>
-                  </a:tcPr>
-                </a:tc>
-              </a:tr>
-              <a:tr h="254203">
-                <a:tc>
-                  <a:txBody>
-                    <a:bodyPr wrap="square"/>
-                    <a:lstStyle/>
-                    <a:p>
-                      <a:pPr algn="l"/>
-                      <a:r>
-                        <a:rPr sz="1000" b="1">
-                          <a:solidFill>
-                            <a:srgbClr val="1E2F5C"/>
-                          </a:solidFill>
-                          <a:latin typeface="Kanit"/>
-                        </a:rPr>
-                        <a:t>สุกร</a:t>
-                      </a:r>
-                    </a:p>
-                  </a:txBody>
-                  <a:tcPr marL="54864" marR="54864" marT="18288" marB="18288" anchor="ctr">
-                    <a:solidFill>
-                      <a:srgbClr val="F7F9FC"/>
-                    </a:solidFill>
-                  </a:tcPr>
-                </a:tc>
-                <a:tc>
-                  <a:txBody>
-                    <a:bodyPr wrap="square"/>
-                    <a:lstStyle/>
-                    <a:p>
-                      <a:pPr algn="l"/>
-                      <a:r>
-                        <a:rPr sz="1000" b="0">
-                          <a:solidFill>
-                            <a:srgbClr val="1E2F5C"/>
-                          </a:solidFill>
-                          <a:latin typeface="Kanit"/>
-                        </a:rPr>
-                        <a:t>ปศุสัตว์</a:t>
-                      </a:r>
-                    </a:p>
-                  </a:txBody>
-                  <a:tcPr marL="54864" marR="54864" marT="18288" marB="18288" anchor="ctr">
-                    <a:solidFill>
-                      <a:srgbClr val="F7F9FC"/>
-                    </a:solidFill>
-                  </a:tcPr>
-                </a:tc>
-                <a:tc>
-                  <a:txBody>
-                    <a:bodyPr wrap="square"/>
-                    <a:lstStyle/>
-                    <a:p>
-                      <a:pPr algn="l"/>
-                      <a:r>
-                        <a:rPr sz="1000" b="0">
-                          <a:solidFill>
-                            <a:srgbClr val="1E2F5C"/>
-                          </a:solidFill>
-                          <a:latin typeface="Kanit"/>
-                        </a:rPr>
-                        <a:t>กลาง · ตต. · ตอ.</a:t>
-                      </a:r>
-                    </a:p>
-                  </a:txBody>
-                  <a:tcPr marL="54864" marR="54864" marT="18288" marB="18288" anchor="ctr">
-                    <a:solidFill>
-                      <a:srgbClr val="F7F9FC"/>
-                    </a:solidFill>
-                  </a:tcPr>
-                </a:tc>
-                <a:tc>
-                  <a:txBody>
-                    <a:bodyPr wrap="square"/>
-                    <a:lstStyle/>
-                    <a:p>
-                      <a:pPr algn="r"/>
-                      <a:r>
-                        <a:rPr sz="1000" b="1">
-                          <a:solidFill>
-                            <a:srgbClr val="CC0000"/>
-                          </a:solidFill>
-                          <a:latin typeface="Kanit"/>
-                        </a:rPr>
-                        <a:t>−1.2%</a:t>
-                      </a:r>
-                    </a:p>
-                  </a:txBody>
-                  <a:tcPr marL="54864" marR="54864" marT="18288" marB="18288" anchor="ctr">
-                    <a:solidFill>
-                      <a:srgbClr val="F7F9FC"/>
-                    </a:solidFill>
-                  </a:tcPr>
-                </a:tc>
-                <a:tc>
-                  <a:txBody>
-                    <a:bodyPr wrap="square"/>
-                    <a:lstStyle/>
-                    <a:p>
-                      <a:pPr algn="r"/>
-                      <a:r>
-                        <a:rPr sz="1000" b="1">
-                          <a:solidFill>
-                            <a:srgbClr val="15795F"/>
-                          </a:solidFill>
-                          <a:latin typeface="Kanit"/>
-                        </a:rPr>
-                        <a:t>+6.1%</a:t>
-                      </a:r>
-                    </a:p>
-                  </a:txBody>
-                  <a:tcPr marL="54864" marR="54864" marT="18288" marB="18288" anchor="ctr">
-                    <a:solidFill>
-                      <a:srgbClr val="F7F9FC"/>
-                    </a:solidFill>
-                  </a:tcPr>
-                </a:tc>
-                <a:tc>
-                  <a:txBody>
-                    <a:bodyPr wrap="square"/>
-                    <a:lstStyle/>
-                    <a:p>
-                      <a:pPr algn="r"/>
-                      <a:r>
-                        <a:rPr sz="1000" b="1">
-                          <a:solidFill>
-                            <a:srgbClr val="7A4FE0"/>
-                          </a:solidFill>
-                          <a:latin typeface="Kanit"/>
-                        </a:rPr>
-                        <a:t>32,143</a:t>
-                      </a:r>
-                    </a:p>
-                  </a:txBody>
-                  <a:tcPr marL="54864" marR="54864" marT="18288" marB="18288" anchor="ctr">
-                    <a:solidFill>
-                      <a:srgbClr val="F7F9FC"/>
-                    </a:solidFill>
-                  </a:tcPr>
-                </a:tc>
-                <a:tc>
-                  <a:txBody>
-                    <a:bodyPr wrap="square"/>
-                    <a:lstStyle/>
-                    <a:p>
-                      <a:pPr algn="r"/>
-                      <a:r>
-                        <a:rPr sz="1000" b="0">
-                          <a:solidFill>
-                            <a:srgbClr val="606060"/>
-                          </a:solidFill>
-                          <a:latin typeface="Kanit"/>
-                        </a:rPr>
-                        <a:t>22%</a:t>
-                      </a:r>
-                    </a:p>
-                  </a:txBody>
-                  <a:tcPr marL="54864" marR="54864" marT="18288" marB="18288" anchor="ctr">
-                    <a:solidFill>
-                      <a:srgbClr val="F7F9FC"/>
-                    </a:solidFill>
-                  </a:tcPr>
-                </a:tc>
-              </a:tr>
-              <a:tr h="254203">
-                <a:tc>
-                  <a:txBody>
-                    <a:bodyPr wrap="square"/>
-                    <a:lstStyle/>
-                    <a:p>
-                      <a:pPr algn="l"/>
-                      <a:r>
-                        <a:rPr sz="1000" b="1">
-                          <a:solidFill>
-                            <a:srgbClr val="1E2F5C"/>
-                          </a:solidFill>
-                          <a:latin typeface="Kanit"/>
-                        </a:rPr>
-                        <a:t>กุ้งขาว</a:t>
-                      </a:r>
-                    </a:p>
-                  </a:txBody>
-                  <a:tcPr marL="54864" marR="54864" marT="18288" marB="18288" anchor="ctr">
-                    <a:solidFill>
-                      <a:srgbClr val="FFFFFF"/>
-                    </a:solidFill>
-                  </a:tcPr>
-                </a:tc>
-                <a:tc>
-                  <a:txBody>
-                    <a:bodyPr wrap="square"/>
-                    <a:lstStyle/>
-                    <a:p>
-                      <a:pPr algn="l"/>
-                      <a:r>
-                        <a:rPr sz="1000" b="0">
-                          <a:solidFill>
-                            <a:srgbClr val="1E2F5C"/>
-                          </a:solidFill>
-                          <a:latin typeface="Kanit"/>
-                        </a:rPr>
-                        <a:t>ประมง</a:t>
-                      </a:r>
-                    </a:p>
-                  </a:txBody>
-                  <a:tcPr marL="54864" marR="54864" marT="18288" marB="18288" anchor="ctr">
-                    <a:solidFill>
-                      <a:srgbClr val="FFFFFF"/>
-                    </a:solidFill>
-                  </a:tcPr>
-                </a:tc>
-                <a:tc>
-                  <a:txBody>
-                    <a:bodyPr wrap="square"/>
-                    <a:lstStyle/>
-                    <a:p>
-                      <a:pPr algn="l"/>
-                      <a:r>
-                        <a:rPr sz="1000" b="0">
-                          <a:solidFill>
-                            <a:srgbClr val="1E2F5C"/>
-                          </a:solidFill>
-                          <a:latin typeface="Kanit"/>
-                        </a:rPr>
-                        <a:t>ชายฝั่งใต้ · ตอ.</a:t>
-                      </a:r>
-                    </a:p>
-                  </a:txBody>
-                  <a:tcPr marL="54864" marR="54864" marT="18288" marB="18288" anchor="ctr">
-                    <a:solidFill>
-                      <a:srgbClr val="FFFFFF"/>
-                    </a:solidFill>
-                  </a:tcPr>
-                </a:tc>
-                <a:tc>
-                  <a:txBody>
-                    <a:bodyPr wrap="square"/>
-                    <a:lstStyle/>
-                    <a:p>
-                      <a:pPr algn="r"/>
-                      <a:r>
-                        <a:rPr sz="1000" b="1">
-                          <a:solidFill>
-                            <a:srgbClr val="CC0000"/>
-                          </a:solidFill>
-                          <a:latin typeface="Kanit"/>
-                        </a:rPr>
-                        <a:t>−0.4%</a:t>
-                      </a:r>
-                    </a:p>
-                  </a:txBody>
-                  <a:tcPr marL="54864" marR="54864" marT="18288" marB="18288" anchor="ctr">
-                    <a:solidFill>
-                      <a:srgbClr val="FFFFFF"/>
-                    </a:solidFill>
-                  </a:tcPr>
-                </a:tc>
-                <a:tc>
-                  <a:txBody>
-                    <a:bodyPr wrap="square"/>
-                    <a:lstStyle/>
-                    <a:p>
-                      <a:pPr algn="r"/>
-                      <a:r>
-                        <a:rPr sz="1000" b="1">
-                          <a:solidFill>
-                            <a:srgbClr val="CC0000"/>
-                          </a:solidFill>
-                          <a:latin typeface="Kanit"/>
-                        </a:rPr>
-                        <a:t>−15.8%</a:t>
-                      </a:r>
-                    </a:p>
-                  </a:txBody>
-                  <a:tcPr marL="54864" marR="54864" marT="18288" marB="18288" anchor="ctr">
-                    <a:solidFill>
-                      <a:srgbClr val="FFFFFF"/>
-                    </a:solidFill>
-                  </a:tcPr>
-                </a:tc>
-                <a:tc>
-                  <a:txBody>
-                    <a:bodyPr wrap="square"/>
-                    <a:lstStyle/>
-                    <a:p>
-                      <a:pPr algn="r"/>
-                      <a:r>
-                        <a:rPr sz="1000" b="1">
-                          <a:solidFill>
-                            <a:srgbClr val="7A4FE0"/>
-                          </a:solidFill>
-                          <a:latin typeface="Kanit"/>
-                        </a:rPr>
-                        <a:t>9,675</a:t>
-                      </a:r>
-                    </a:p>
-                  </a:txBody>
-                  <a:tcPr marL="54864" marR="54864" marT="18288" marB="18288" anchor="ctr">
-                    <a:solidFill>
-                      <a:srgbClr val="FFFFFF"/>
-                    </a:solidFill>
-                  </a:tcPr>
-                </a:tc>
-                <a:tc>
-                  <a:txBody>
-                    <a:bodyPr wrap="square"/>
-                    <a:lstStyle/>
-                    <a:p>
-                      <a:pPr algn="r"/>
-                      <a:r>
-                        <a:rPr sz="1000" b="0">
-                          <a:solidFill>
-                            <a:srgbClr val="606060"/>
-                          </a:solidFill>
-                          <a:latin typeface="Kanit"/>
-                        </a:rPr>
-                        <a:t>9%</a:t>
                       </a:r>
                     </a:p>
                   </a:txBody>
@@ -41006,7 +40680,7 @@
         </p:nvSpPr>
         <p:spPr>
           <a:xfrm>
-            <a:off x="411480" y="4269638"/>
+            <a:off x="411480" y="3761232"/>
             <a:ext cx="535747" cy="192024"/>
           </a:xfrm>
           <a:prstGeom prst="roundRect">
@@ -41052,7 +40726,7 @@
         </p:nvSpPr>
         <p:spPr>
           <a:xfrm>
-            <a:off x="411480" y="4298899"/>
+            <a:off x="411480" y="3790492"/>
             <a:ext cx="535747" cy="134112"/>
           </a:xfrm>
           <a:prstGeom prst="rect">
@@ -41091,7 +40765,7 @@
         </p:nvSpPr>
         <p:spPr>
           <a:xfrm>
-            <a:off x="1056955" y="4283354"/>
+            <a:off x="1056955" y="3774947"/>
             <a:ext cx="10720516" cy="462915"/>
           </a:xfrm>
           <a:prstGeom prst="rect">
@@ -41117,7 +40791,7 @@
                 </a:solidFill>
                 <a:latin typeface="Kanit"/>
               </a:rPr>
-              <a:t>ราคา วัดจริง — ราคาหน้าฟาร์มไทยจากราคารายวันของ NABC และราคาอ้อยประกาศของ สอน. ราคาล่าสุด 2026-08-07 การเปลี่ยนแปลงหกเดือนคำนวณจากข้อมูลรายเดือนของ NABC เอง (thai_price_history รุ่นข้อมูล 2026-08-02) พืชที่ไม่มีข้อมูลรายเดือนจะกำกับไว้ ไม่ประมาณการขึ้นมา แหล่งผลิตเป็นการอ่านแบบ ประมาณการ ว่าสินค้าแต่ละชนิดปลูกที่ไหน และแหล่งผลิตทับซ้อนกันได้ บัญชีอาชีพเกษตรเป็นข้อมูลของเราเองและ วัดจริง — บัญชีที่บันทึกอาชีพว่า เกษตร ในจังหวัดแหล่งผลิต จากฐานข้อมูล 382,735 บัญชี ณ 2026-07 ไม่เผยแพร่ช่องที่มีน้อยกว่า 30 บัญชี คนกลุ่มนี้อาศัยอยู่ในพื้นที่ที่ปลูกพืชนั้น แต่ไม่ได้ยืนยันว่าปลูกพืชนั้นเอง</a:t>
+              <a:t>ราคา วัดจริง — ราคาหน้าฟาร์มไทยจากราคารายวันของ NABC และราคาอ้อยประกาศของ สอน. ราคาล่าสุด 2026-08-11 การเปลี่ยนแปลงหกเดือนคำนวณจากข้อมูลรายเดือนของ NABC เอง (thai_price_history รุ่นข้อมูล 2026-08-02) พืชที่ไม่มีข้อมูลรายเดือนจะกำกับไว้ ไม่ประมาณการขึ้นมา แหล่งผลิตเป็นการอ่านแบบ ประมาณการ ว่าสินค้าแต่ละชนิดปลูกที่ไหน และแหล่งผลิตทับซ้อนกันได้ บัญชีอาชีพเกษตรเป็นข้อมูลของเราเองและ วัดจริง — บัญชีที่บันทึกอาชีพว่า เกษตร ในจังหวัดแหล่งผลิต จากฐานข้อมูล 382,735 บัญชี ณ 2026-07 ไม่เผยแพร่ช่องที่มีน้อยกว่า 30 บัญชี คนกลุ่มนี้อาศัยอยู่ในพื้นที่ที่ปลูกพืชนั้น แต่ไม่ได้ยืนยันว่าปลูกพืชนั้นเอง</a:t>
             </a:r>
           </a:p>
         </p:txBody>
@@ -41130,7 +40804,7 @@
         </p:nvSpPr>
         <p:spPr>
           <a:xfrm>
-            <a:off x="411480" y="4878857"/>
+            <a:off x="411480" y="4370451"/>
             <a:ext cx="11365992" cy="675767"/>
           </a:xfrm>
           <a:prstGeom prst="rect">
@@ -41174,7 +40848,7 @@
         </p:nvSpPr>
         <p:spPr>
           <a:xfrm>
-            <a:off x="411480" y="4878857"/>
+            <a:off x="411480" y="4370451"/>
             <a:ext cx="50292" cy="675767"/>
           </a:xfrm>
           <a:prstGeom prst="rect">
@@ -41218,7 +40892,7 @@
         </p:nvSpPr>
         <p:spPr>
           <a:xfrm>
-            <a:off x="630936" y="5025161"/>
+            <a:off x="630936" y="4516755"/>
             <a:ext cx="11036808" cy="158750"/>
           </a:xfrm>
           <a:prstGeom prst="rect">
@@ -41257,7 +40931,7 @@
         </p:nvSpPr>
         <p:spPr>
           <a:xfrm>
-            <a:off x="630936" y="5229631"/>
+            <a:off x="630936" y="4721224"/>
             <a:ext cx="11036808" cy="178689"/>
           </a:xfrm>
           <a:prstGeom prst="rect">
@@ -45005,7 +44679,7 @@
                 </a:solidFill>
                 <a:latin typeface="Kanit"/>
               </a:rPr>
-              <a:t>มะพร้าว −68.4% สับปะรด −18.4% อ้อย −17.9% เทียบปีก่อน</a:t>
+              <a:t>มะพร้าว −67.8% สับปะรด −18.4% อ้อย −17.9% เทียบปีก่อน</a:t>
             </a:r>
           </a:p>
         </p:txBody>
@@ -45131,7 +44805,7 @@
                 </a:solidFill>
                 <a:latin typeface="Kanit"/>
               </a:rPr>
-              <a:t>+16.1%</a:t>
+              <a:t>+16.6%</a:t>
             </a:r>
           </a:p>
         </p:txBody>
@@ -45605,7 +45279,7 @@
                           </a:solidFill>
                           <a:latin typeface="Kanit"/>
                         </a:rPr>
-                        <a:t>+6.1%</a:t>
+                        <a:t>+6.5%</a:t>
                       </a:r>
                     </a:p>
                   </a:txBody>
@@ -45674,7 +45348,7 @@
                           </a:solidFill>
                           <a:latin typeface="Kanit"/>
                         </a:rPr>
-                        <a:t>-64.0%</a:t>
+                        <a:t>-63.4%</a:t>
                       </a:r>
                     </a:p>
                   </a:txBody>
@@ -45745,7 +45419,7 @@
                           </a:solidFill>
                           <a:latin typeface="Kanit"/>
                         </a:rPr>
-                        <a:t>+14.9%</a:t>
+                        <a:t>+15.3%</a:t>
                       </a:r>
                     </a:p>
                   </a:txBody>
@@ -45814,7 +45488,7 @@
                           </a:solidFill>
                           <a:latin typeface="Kanit"/>
                         </a:rPr>
-                        <a:t>+9.5%</a:t>
+                        <a:t>+9.8%</a:t>
                       </a:r>
                     </a:p>
                   </a:txBody>
@@ -45885,7 +45559,7 @@
                           </a:solidFill>
                           <a:latin typeface="Kanit"/>
                         </a:rPr>
-                        <a:t>+16.2%</a:t>
+                        <a:t>+16.7%</a:t>
                       </a:r>
                     </a:p>
                   </a:txBody>
@@ -45954,7 +45628,7 @@
                           </a:solidFill>
                           <a:latin typeface="Kanit"/>
                         </a:rPr>
-                        <a:t>+8.3%</a:t>
+                        <a:t>+8.6%</a:t>
                       </a:r>
                     </a:p>
                   </a:txBody>
@@ -46025,7 +45699,7 @@
                           </a:solidFill>
                           <a:latin typeface="Kanit"/>
                         </a:rPr>
-                        <a:t>+25.5%</a:t>
+                        <a:t>+25.8%</a:t>
                       </a:r>
                     </a:p>
                   </a:txBody>
@@ -46094,7 +45768,7 @@
                           </a:solidFill>
                           <a:latin typeface="Kanit"/>
                         </a:rPr>
-                        <a:t>+10.2%</a:t>
+                        <a:t>+10.7%</a:t>
                       </a:r>
                     </a:p>
                   </a:txBody>
@@ -46165,7 +45839,7 @@
                           </a:solidFill>
                           <a:latin typeface="Kanit"/>
                         </a:rPr>
-                        <a:t>+36.3%</a:t>
+                        <a:t>+36.5%</a:t>
                       </a:r>
                     </a:p>
                   </a:txBody>
@@ -46234,7 +45908,7 @@
                           </a:solidFill>
                           <a:latin typeface="Kanit"/>
                         </a:rPr>
-                        <a:t>+28.9%</a:t>
+                        <a:t>+29.0%</a:t>
                       </a:r>
                     </a:p>
                   </a:txBody>
@@ -46410,7 +46084,7 @@
                 </a:solidFill>
                 <a:latin typeface="Kanit"/>
               </a:rPr>
-              <a:t>•  ราคาหน้าฟาร์ม: ยางพารา +42% มันสำปะหลัง +61% ปาล์ม +26% ข้าว +14% รายได้จากพืชเพิ่มขึ้นทุกภาค
+              <a:t>•  ราคาหน้าฟาร์ม: ยางพารา +42% มันสำปะหลัง +64% ปาล์ม +25% ข้าว +14% รายได้จากพืชเพิ่มขึ้นทุกภาค
 •  มีสี่จังหวัดที่ลดลง — ทั้งหมดเป็นมะพร้าว และอยู่ฝั่งอ่าวไทยตะวันตก ราคามะพร้าวลดลง 68%
 •  กำไรบนกระดาษยังไม่ใช่เงินสด — ตารางถัดไปหักราคาด้วยต้นทุน</a:t>
             </a:r>
@@ -46713,7 +46387,7 @@
                           </a:solidFill>
                           <a:latin typeface="Kanit"/>
                         </a:rPr>
-                        <a:t>+16.1%</a:t>
+                        <a:t>+16.7%</a:t>
                       </a:r>
                     </a:p>
                   </a:txBody>
@@ -46876,7 +46550,7 @@
                           </a:solidFill>
                           <a:latin typeface="Kanit"/>
                         </a:rPr>
-                        <a:t>+20.5%</a:t>
+                        <a:t>+21.1%</a:t>
                       </a:r>
                     </a:p>
                   </a:txBody>
@@ -47039,7 +46713,7 @@
                           </a:solidFill>
                           <a:latin typeface="Kanit"/>
                         </a:rPr>
-                        <a:t>+10.5%</a:t>
+                        <a:t>+10.9%</a:t>
                       </a:r>
                     </a:p>
                   </a:txBody>
@@ -47202,7 +46876,7 @@
                           </a:solidFill>
                           <a:latin typeface="Kanit"/>
                         </a:rPr>
-                        <a:t>+34.4%</a:t>
+                        <a:t>+34.5%</a:t>
                       </a:r>
                     </a:p>
                   </a:txBody>
@@ -47365,7 +47039,7 @@
                           </a:solidFill>
                           <a:latin typeface="Kanit"/>
                         </a:rPr>
-                        <a:t>+16.3%</a:t>
+                        <a:t>+16.8%</a:t>
                       </a:r>
                     </a:p>
                   </a:txBody>
@@ -47528,7 +47202,7 @@
                           </a:solidFill>
                           <a:latin typeface="Kanit"/>
                         </a:rPr>
-                        <a:t>+15.1%</a:t>
+                        <a:t>+15.5%</a:t>
                       </a:r>
                     </a:p>
                   </a:txBody>
@@ -48350,7 +48024,7 @@
                 </a:solidFill>
                 <a:latin typeface="Kanit"/>
               </a:rPr>
-              <a:t>เทียบปีก่อน −68.4%</a:t>
+              <a:t>เทียบปีก่อน −67.8%</a:t>
             </a:r>
           </a:p>
         </p:txBody>
@@ -48908,6 +48582,324 @@
                 </a:solidFill>
                 <a:latin typeface="Kanit"/>
               </a:rPr>
+              <a:t>ไข่ไก่</a:t>
+            </a:r>
+          </a:p>
+        </p:txBody>
+      </p:sp>
+      <p:sp>
+        <p:nvSpPr>
+          <p:cNvPr id="30" name="TextBox 29"/>
+          <p:cNvSpPr txBox="1"/>
+          <p:nvPr/>
+        </p:nvSpPr>
+        <p:spPr>
+          <a:xfrm>
+            <a:off x="5016398" y="2112263"/>
+            <a:ext cx="2156155" cy="125730"/>
+          </a:xfrm>
+          <a:prstGeom prst="rect">
+            <a:avLst/>
+          </a:prstGeom>
+          <a:noFill/>
+        </p:spPr>
+        <p:txBody>
+          <a:bodyPr wrap="square" lIns="0" rIns="0" tIns="0" bIns="0" anchor="t">
+            <a:noAutofit/>
+          </a:bodyPr>
+          <a:lstStyle/>
+          <a:p>
+            <a:pPr algn="l">
+              <a:lnSpc>
+                <a:spcPts val="990"/>
+              </a:lnSpc>
+            </a:pPr>
+            <a:r>
+              <a:rPr sz="750" b="0">
+                <a:solidFill>
+                  <a:srgbClr val="606060"/>
+                </a:solidFill>
+                <a:latin typeface="Kanit"/>
+              </a:rPr>
+              <a:t>฿338.24 /ร้อยฟอง · กลาง·ตอ.</a:t>
+            </a:r>
+          </a:p>
+        </p:txBody>
+      </p:sp>
+      <p:sp>
+        <p:nvSpPr>
+          <p:cNvPr id="31" name="TextBox 30"/>
+          <p:cNvSpPr txBox="1"/>
+          <p:nvPr/>
+        </p:nvSpPr>
+        <p:spPr>
+          <a:xfrm>
+            <a:off x="5016398" y="2244851"/>
+            <a:ext cx="1078077" cy="134112"/>
+          </a:xfrm>
+          <a:prstGeom prst="rect">
+            <a:avLst/>
+          </a:prstGeom>
+          <a:noFill/>
+        </p:spPr>
+        <p:txBody>
+          <a:bodyPr wrap="square" lIns="0" rIns="0" tIns="0" bIns="0" anchor="t">
+            <a:noAutofit/>
+          </a:bodyPr>
+          <a:lstStyle/>
+          <a:p>
+            <a:pPr algn="l">
+              <a:lnSpc>
+                <a:spcPts val="1056"/>
+              </a:lnSpc>
+            </a:pPr>
+            <a:r>
+              <a:rPr sz="800" b="1">
+                <a:solidFill>
+                  <a:srgbClr val="15795F"/>
+                </a:solidFill>
+                <a:latin typeface="Kanit"/>
+              </a:rPr>
+              <a:t>เทียบปีก่อน +0.3%</a:t>
+            </a:r>
+          </a:p>
+        </p:txBody>
+      </p:sp>
+      <p:sp>
+        <p:nvSpPr>
+          <p:cNvPr id="32" name="TextBox 31"/>
+          <p:cNvSpPr txBox="1"/>
+          <p:nvPr/>
+        </p:nvSpPr>
+        <p:spPr>
+          <a:xfrm>
+            <a:off x="6094475" y="2244851"/>
+            <a:ext cx="1078077" cy="134112"/>
+          </a:xfrm>
+          <a:prstGeom prst="rect">
+            <a:avLst/>
+          </a:prstGeom>
+          <a:noFill/>
+        </p:spPr>
+        <p:txBody>
+          <a:bodyPr wrap="square" lIns="0" rIns="0" tIns="0" bIns="0" anchor="t">
+            <a:noAutofit/>
+          </a:bodyPr>
+          <a:lstStyle/>
+          <a:p>
+            <a:pPr algn="l">
+              <a:lnSpc>
+                <a:spcPts val="1056"/>
+              </a:lnSpc>
+            </a:pPr>
+            <a:r>
+              <a:rPr sz="800" b="1">
+                <a:solidFill>
+                  <a:srgbClr val="15795F"/>
+                </a:solidFill>
+                <a:latin typeface="Kanit"/>
+              </a:rPr>
+              <a:t>6 เดือน +5.0%</a:t>
+            </a:r>
+          </a:p>
+        </p:txBody>
+      </p:sp>
+      <p:sp>
+        <p:nvSpPr>
+          <p:cNvPr id="33" name="Rectangle 32"/>
+          <p:cNvSpPr/>
+          <p:nvPr/>
+        </p:nvSpPr>
+        <p:spPr>
+          <a:xfrm>
+            <a:off x="5016398" y="2400300"/>
+            <a:ext cx="2156155" cy="548640"/>
+          </a:xfrm>
+          <a:prstGeom prst="rect">
+            <a:avLst/>
+          </a:prstGeom>
+          <a:solidFill>
+            <a:srgbClr val="FBFCFE"/>
+          </a:solidFill>
+          <a:ln w="9525">
+            <a:solidFill>
+              <a:srgbClr val="D9DEE9"/>
+            </a:solidFill>
+          </a:ln>
+          <a:effectLst/>
+        </p:spPr>
+        <p:style>
+          <a:lnRef idx="1">
+            <a:schemeClr val="accent1"/>
+          </a:lnRef>
+          <a:fillRef idx="3">
+            <a:schemeClr val="accent1"/>
+          </a:fillRef>
+          <a:effectRef idx="2">
+            <a:schemeClr val="accent1"/>
+          </a:effectRef>
+          <a:fontRef idx="minor">
+            <a:schemeClr val="lt1"/>
+          </a:fontRef>
+        </p:style>
+        <p:txBody>
+          <a:bodyPr rtlCol="0" anchor="ctr" wrap="none"/>
+          <a:lstStyle/>
+          <a:p>
+            <a:pPr algn="ctr"/>
+          </a:p>
+        </p:txBody>
+      </p:sp>
+      <p:sp>
+        <p:nvSpPr>
+          <p:cNvPr id="34" name="Freeform 33"/>
+          <p:cNvSpPr/>
+          <p:nvPr/>
+        </p:nvSpPr>
+        <p:spPr>
+          <a:xfrm>
+            <a:off x="5062118" y="2446020"/>
+            <a:ext cx="2064715" cy="457200"/>
+          </a:xfrm>
+          <a:custGeom>
+            <a:avLst/>
+            <a:gdLst/>
+            <a:ahLst/>
+            <a:cxnLst/>
+            <a:rect l="l" t="t" r="r" b="b"/>
+            <a:pathLst>
+              <a:path w="2064715" h="457200">
+                <a:moveTo>
+                  <a:pt x="0" y="457200"/>
+                </a:moveTo>
+                <a:lnTo>
+                  <a:pt x="412943" y="391702"/>
+                </a:lnTo>
+                <a:lnTo>
+                  <a:pt x="825886" y="105409"/>
+                </a:lnTo>
+                <a:lnTo>
+                  <a:pt x="1238829" y="105409"/>
+                </a:lnTo>
+                <a:lnTo>
+                  <a:pt x="1651772" y="214144"/>
+                </a:lnTo>
+                <a:lnTo>
+                  <a:pt x="2064715" y="0"/>
+                </a:lnTo>
+              </a:path>
+            </a:pathLst>
+          </a:custGeom>
+          <a:noFill/>
+          <a:ln w="20320">
+            <a:solidFill>
+              <a:srgbClr val="15795F"/>
+            </a:solidFill>
+          </a:ln>
+          <a:effectLst/>
+        </p:spPr>
+        <p:style>
+          <a:lnRef idx="1">
+            <a:schemeClr val="accent1"/>
+          </a:lnRef>
+          <a:fillRef idx="3">
+            <a:schemeClr val="accent1"/>
+          </a:fillRef>
+          <a:effectRef idx="2">
+            <a:schemeClr val="accent1"/>
+          </a:effectRef>
+          <a:fontRef idx="minor">
+            <a:schemeClr val="lt1"/>
+          </a:fontRef>
+        </p:style>
+        <p:txBody>
+          <a:bodyPr rtlCol="0" anchor="ctr"/>
+          <a:lstStyle/>
+          <a:p>
+            <a:pPr algn="ctr"/>
+          </a:p>
+        </p:txBody>
+      </p:sp>
+      <p:sp>
+        <p:nvSpPr>
+          <p:cNvPr id="35" name="Rounded Rectangle 34"/>
+          <p:cNvSpPr/>
+          <p:nvPr/>
+        </p:nvSpPr>
+        <p:spPr>
+          <a:xfrm>
+            <a:off x="7085685" y="2404872"/>
+            <a:ext cx="82296" cy="82296"/>
+          </a:xfrm>
+          <a:prstGeom prst="roundRect">
+            <a:avLst>
+              <a:gd name="adj" fmla="val 50000"/>
+            </a:avLst>
+          </a:prstGeom>
+          <a:solidFill>
+            <a:srgbClr val="15795F"/>
+          </a:solidFill>
+          <a:ln>
+            <a:noFill/>
+          </a:ln>
+          <a:effectLst/>
+        </p:spPr>
+        <p:style>
+          <a:lnRef idx="1">
+            <a:schemeClr val="accent1"/>
+          </a:lnRef>
+          <a:fillRef idx="3">
+            <a:schemeClr val="accent1"/>
+          </a:fillRef>
+          <a:effectRef idx="2">
+            <a:schemeClr val="accent1"/>
+          </a:effectRef>
+          <a:fontRef idx="minor">
+            <a:schemeClr val="lt1"/>
+          </a:fontRef>
+        </p:style>
+        <p:txBody>
+          <a:bodyPr rtlCol="0" anchor="ctr" wrap="none"/>
+          <a:lstStyle/>
+          <a:p>
+            <a:pPr algn="ctr"/>
+          </a:p>
+        </p:txBody>
+      </p:sp>
+      <p:sp>
+        <p:nvSpPr>
+          <p:cNvPr id="36" name="TextBox 35"/>
+          <p:cNvSpPr txBox="1"/>
+          <p:nvPr/>
+        </p:nvSpPr>
+        <p:spPr>
+          <a:xfrm>
+            <a:off x="7318857" y="1970531"/>
+            <a:ext cx="2156155" cy="150876"/>
+          </a:xfrm>
+          <a:prstGeom prst="rect">
+            <a:avLst/>
+          </a:prstGeom>
+          <a:noFill/>
+        </p:spPr>
+        <p:txBody>
+          <a:bodyPr wrap="square" lIns="0" rIns="0" tIns="0" bIns="0" anchor="t">
+            <a:noAutofit/>
+          </a:bodyPr>
+          <a:lstStyle/>
+          <a:p>
+            <a:pPr algn="l">
+              <a:lnSpc>
+                <a:spcPts val="1188"/>
+              </a:lnSpc>
+            </a:pPr>
+            <a:r>
+              <a:rPr sz="900" b="1">
+                <a:solidFill>
+                  <a:srgbClr val="1E2F5C"/>
+                </a:solidFill>
+                <a:latin typeface="Kanit"/>
+              </a:rPr>
               <a:t>สุกร</a:t>
             </a:r>
           </a:p>
@@ -48915,13 +48907,13 @@
       </p:sp>
       <p:sp>
         <p:nvSpPr>
-          <p:cNvPr id="30" name="TextBox 29"/>
+          <p:cNvPr id="37" name="TextBox 36"/>
           <p:cNvSpPr txBox="1"/>
           <p:nvPr/>
         </p:nvSpPr>
         <p:spPr>
           <a:xfrm>
-            <a:off x="5016398" y="2112263"/>
+            <a:off x="7318857" y="2112263"/>
             <a:ext cx="2156155" cy="125730"/>
           </a:xfrm>
           <a:prstGeom prst="rect">
@@ -48954,13 +48946,13 @@
       </p:sp>
       <p:sp>
         <p:nvSpPr>
-          <p:cNvPr id="31" name="TextBox 30"/>
+          <p:cNvPr id="38" name="TextBox 37"/>
           <p:cNvSpPr txBox="1"/>
           <p:nvPr/>
         </p:nvSpPr>
         <p:spPr>
           <a:xfrm>
-            <a:off x="5016398" y="2244851"/>
+            <a:off x="7318857" y="2244851"/>
             <a:ext cx="1078077" cy="134112"/>
           </a:xfrm>
           <a:prstGeom prst="rect">
@@ -48982,24 +48974,24 @@
             <a:r>
               <a:rPr sz="800" b="1">
                 <a:solidFill>
-                  <a:srgbClr val="CC0000"/>
+                  <a:srgbClr val="15795F"/>
                 </a:solidFill>
                 <a:latin typeface="Kanit"/>
               </a:rPr>
-              <a:t>เทียบปีก่อน −1.2%</a:t>
+              <a:t>เทียบปีก่อน +0.3%</a:t>
             </a:r>
           </a:p>
         </p:txBody>
       </p:sp>
       <p:sp>
         <p:nvSpPr>
-          <p:cNvPr id="32" name="TextBox 31"/>
+          <p:cNvPr id="39" name="TextBox 38"/>
           <p:cNvSpPr txBox="1"/>
           <p:nvPr/>
         </p:nvSpPr>
         <p:spPr>
           <a:xfrm>
-            <a:off x="6094475" y="2244851"/>
+            <a:off x="8396935" y="2244851"/>
             <a:ext cx="1078077" cy="134112"/>
           </a:xfrm>
           <a:prstGeom prst="rect">
@@ -49032,13 +49024,13 @@
       </p:sp>
       <p:sp>
         <p:nvSpPr>
-          <p:cNvPr id="33" name="Rectangle 32"/>
+          <p:cNvPr id="40" name="Rectangle 39"/>
           <p:cNvSpPr/>
           <p:nvPr/>
         </p:nvSpPr>
         <p:spPr>
           <a:xfrm>
-            <a:off x="5016398" y="2400300"/>
+            <a:off x="7318857" y="2400300"/>
             <a:ext cx="2156155" cy="548640"/>
           </a:xfrm>
           <a:prstGeom prst="rect">
@@ -49078,13 +49070,13 @@
       </p:sp>
       <p:sp>
         <p:nvSpPr>
-          <p:cNvPr id="34" name="Freeform 33"/>
+          <p:cNvPr id="41" name="Freeform 40"/>
           <p:cNvSpPr/>
           <p:nvPr/>
         </p:nvSpPr>
         <p:spPr>
           <a:xfrm>
-            <a:off x="5062118" y="2446020"/>
+            <a:off x="7364577" y="2446020"/>
             <a:ext cx="2064715" cy="457200"/>
           </a:xfrm>
           <a:custGeom>
@@ -49148,13 +49140,13 @@
       </p:sp>
       <p:sp>
         <p:nvSpPr>
-          <p:cNvPr id="35" name="Rounded Rectangle 34"/>
+          <p:cNvPr id="42" name="Rounded Rectangle 41"/>
           <p:cNvSpPr/>
           <p:nvPr/>
         </p:nvSpPr>
         <p:spPr>
           <a:xfrm>
-            <a:off x="7085685" y="2457891"/>
+            <a:off x="9388144" y="2457891"/>
             <a:ext cx="82296" cy="82296"/>
           </a:xfrm>
           <a:prstGeom prst="roundRect">
@@ -49194,13 +49186,13 @@
       </p:sp>
       <p:sp>
         <p:nvSpPr>
-          <p:cNvPr id="36" name="TextBox 35"/>
+          <p:cNvPr id="43" name="TextBox 42"/>
           <p:cNvSpPr txBox="1"/>
           <p:nvPr/>
         </p:nvSpPr>
         <p:spPr>
           <a:xfrm>
-            <a:off x="7318857" y="1970531"/>
+            <a:off x="9621316" y="1970531"/>
             <a:ext cx="2156155" cy="150876"/>
           </a:xfrm>
           <a:prstGeom prst="rect">
@@ -49233,13 +49225,13 @@
       </p:sp>
       <p:sp>
         <p:nvSpPr>
-          <p:cNvPr id="37" name="TextBox 36"/>
+          <p:cNvPr id="44" name="TextBox 43"/>
           <p:cNvSpPr txBox="1"/>
           <p:nvPr/>
         </p:nvSpPr>
         <p:spPr>
           <a:xfrm>
-            <a:off x="7318857" y="2112263"/>
+            <a:off x="9621316" y="2112263"/>
             <a:ext cx="2156155" cy="125730"/>
           </a:xfrm>
           <a:prstGeom prst="rect">
@@ -49272,13 +49264,13 @@
       </p:sp>
       <p:sp>
         <p:nvSpPr>
-          <p:cNvPr id="38" name="TextBox 37"/>
+          <p:cNvPr id="45" name="TextBox 44"/>
           <p:cNvSpPr txBox="1"/>
           <p:nvPr/>
         </p:nvSpPr>
         <p:spPr>
           <a:xfrm>
-            <a:off x="7318857" y="2244851"/>
+            <a:off x="9621316" y="2244851"/>
             <a:ext cx="1078077" cy="134112"/>
           </a:xfrm>
           <a:prstGeom prst="rect">
@@ -49300,24 +49292,24 @@
             <a:r>
               <a:rPr sz="800" b="1">
                 <a:solidFill>
-                  <a:srgbClr val="CC0000"/>
+                  <a:srgbClr val="15795F"/>
                 </a:solidFill>
                 <a:latin typeface="Kanit"/>
               </a:rPr>
-              <a:t>เทียบปีก่อน −0.4%</a:t>
+              <a:t>เทียบปีก่อน +0.6%</a:t>
             </a:r>
           </a:p>
         </p:txBody>
       </p:sp>
       <p:sp>
         <p:nvSpPr>
-          <p:cNvPr id="39" name="TextBox 38"/>
+          <p:cNvPr id="46" name="TextBox 45"/>
           <p:cNvSpPr txBox="1"/>
           <p:nvPr/>
         </p:nvSpPr>
         <p:spPr>
           <a:xfrm>
-            <a:off x="8396935" y="2244851"/>
+            <a:off x="10699394" y="2244851"/>
             <a:ext cx="1078077" cy="134112"/>
           </a:xfrm>
           <a:prstGeom prst="rect">
@@ -49350,13 +49342,13 @@
       </p:sp>
       <p:sp>
         <p:nvSpPr>
-          <p:cNvPr id="40" name="Rectangle 39"/>
+          <p:cNvPr id="47" name="Rectangle 46"/>
           <p:cNvSpPr/>
           <p:nvPr/>
         </p:nvSpPr>
         <p:spPr>
           <a:xfrm>
-            <a:off x="7318857" y="2400300"/>
+            <a:off x="9621316" y="2400300"/>
             <a:ext cx="2156155" cy="548640"/>
           </a:xfrm>
           <a:prstGeom prst="rect">
@@ -49396,13 +49388,13 @@
       </p:sp>
       <p:sp>
         <p:nvSpPr>
-          <p:cNvPr id="41" name="Freeform 40"/>
+          <p:cNvPr id="48" name="Freeform 47"/>
           <p:cNvSpPr/>
           <p:nvPr/>
         </p:nvSpPr>
         <p:spPr>
           <a:xfrm>
-            <a:off x="7364577" y="2446020"/>
+            <a:off x="9667036" y="2446020"/>
             <a:ext cx="2064715" cy="457200"/>
           </a:xfrm>
           <a:custGeom>
@@ -49466,13 +49458,13 @@
       </p:sp>
       <p:sp>
         <p:nvSpPr>
-          <p:cNvPr id="42" name="Rounded Rectangle 41"/>
+          <p:cNvPr id="49" name="Rounded Rectangle 48"/>
           <p:cNvSpPr/>
           <p:nvPr/>
         </p:nvSpPr>
         <p:spPr>
           <a:xfrm>
-            <a:off x="9388144" y="2628007"/>
+            <a:off x="11690603" y="2628007"/>
             <a:ext cx="82296" cy="82296"/>
           </a:xfrm>
           <a:prstGeom prst="roundRect">
@@ -49482,324 +49474,6 @@
           </a:prstGeom>
           <a:solidFill>
             <a:srgbClr val="CC0000"/>
-          </a:solidFill>
-          <a:ln>
-            <a:noFill/>
-          </a:ln>
-          <a:effectLst/>
-        </p:spPr>
-        <p:style>
-          <a:lnRef idx="1">
-            <a:schemeClr val="accent1"/>
-          </a:lnRef>
-          <a:fillRef idx="3">
-            <a:schemeClr val="accent1"/>
-          </a:fillRef>
-          <a:effectRef idx="2">
-            <a:schemeClr val="accent1"/>
-          </a:effectRef>
-          <a:fontRef idx="minor">
-            <a:schemeClr val="lt1"/>
-          </a:fontRef>
-        </p:style>
-        <p:txBody>
-          <a:bodyPr rtlCol="0" anchor="ctr" wrap="none"/>
-          <a:lstStyle/>
-          <a:p>
-            <a:pPr algn="ctr"/>
-          </a:p>
-        </p:txBody>
-      </p:sp>
-      <p:sp>
-        <p:nvSpPr>
-          <p:cNvPr id="43" name="TextBox 42"/>
-          <p:cNvSpPr txBox="1"/>
-          <p:nvPr/>
-        </p:nvSpPr>
-        <p:spPr>
-          <a:xfrm>
-            <a:off x="9621316" y="1970531"/>
-            <a:ext cx="2156155" cy="150876"/>
-          </a:xfrm>
-          <a:prstGeom prst="rect">
-            <a:avLst/>
-          </a:prstGeom>
-          <a:noFill/>
-        </p:spPr>
-        <p:txBody>
-          <a:bodyPr wrap="square" lIns="0" rIns="0" tIns="0" bIns="0" anchor="t">
-            <a:noAutofit/>
-          </a:bodyPr>
-          <a:lstStyle/>
-          <a:p>
-            <a:pPr algn="l">
-              <a:lnSpc>
-                <a:spcPts val="1188"/>
-              </a:lnSpc>
-            </a:pPr>
-            <a:r>
-              <a:rPr sz="900" b="1">
-                <a:solidFill>
-                  <a:srgbClr val="1E2F5C"/>
-                </a:solidFill>
-                <a:latin typeface="Kanit"/>
-              </a:rPr>
-              <a:t>ไข่ไก่</a:t>
-            </a:r>
-          </a:p>
-        </p:txBody>
-      </p:sp>
-      <p:sp>
-        <p:nvSpPr>
-          <p:cNvPr id="44" name="TextBox 43"/>
-          <p:cNvSpPr txBox="1"/>
-          <p:nvPr/>
-        </p:nvSpPr>
-        <p:spPr>
-          <a:xfrm>
-            <a:off x="9621316" y="2112263"/>
-            <a:ext cx="2156155" cy="125730"/>
-          </a:xfrm>
-          <a:prstGeom prst="rect">
-            <a:avLst/>
-          </a:prstGeom>
-          <a:noFill/>
-        </p:spPr>
-        <p:txBody>
-          <a:bodyPr wrap="square" lIns="0" rIns="0" tIns="0" bIns="0" anchor="t">
-            <a:noAutofit/>
-          </a:bodyPr>
-          <a:lstStyle/>
-          <a:p>
-            <a:pPr algn="l">
-              <a:lnSpc>
-                <a:spcPts val="990"/>
-              </a:lnSpc>
-            </a:pPr>
-            <a:r>
-              <a:rPr sz="750" b="0">
-                <a:solidFill>
-                  <a:srgbClr val="606060"/>
-                </a:solidFill>
-                <a:latin typeface="Kanit"/>
-              </a:rPr>
-              <a:t>฿338.24 /ร้อยฟอง · กลาง·ตอ.</a:t>
-            </a:r>
-          </a:p>
-        </p:txBody>
-      </p:sp>
-      <p:sp>
-        <p:nvSpPr>
-          <p:cNvPr id="45" name="TextBox 44"/>
-          <p:cNvSpPr txBox="1"/>
-          <p:nvPr/>
-        </p:nvSpPr>
-        <p:spPr>
-          <a:xfrm>
-            <a:off x="9621316" y="2244851"/>
-            <a:ext cx="1078077" cy="134112"/>
-          </a:xfrm>
-          <a:prstGeom prst="rect">
-            <a:avLst/>
-          </a:prstGeom>
-          <a:noFill/>
-        </p:spPr>
-        <p:txBody>
-          <a:bodyPr wrap="square" lIns="0" rIns="0" tIns="0" bIns="0" anchor="t">
-            <a:noAutofit/>
-          </a:bodyPr>
-          <a:lstStyle/>
-          <a:p>
-            <a:pPr algn="l">
-              <a:lnSpc>
-                <a:spcPts val="1056"/>
-              </a:lnSpc>
-            </a:pPr>
-            <a:r>
-              <a:rPr sz="800" b="1">
-                <a:solidFill>
-                  <a:srgbClr val="606060"/>
-                </a:solidFill>
-                <a:latin typeface="Kanit"/>
-              </a:rPr>
-              <a:t>เทียบปีก่อน +0.0%</a:t>
-            </a:r>
-          </a:p>
-        </p:txBody>
-      </p:sp>
-      <p:sp>
-        <p:nvSpPr>
-          <p:cNvPr id="46" name="TextBox 45"/>
-          <p:cNvSpPr txBox="1"/>
-          <p:nvPr/>
-        </p:nvSpPr>
-        <p:spPr>
-          <a:xfrm>
-            <a:off x="10699394" y="2244851"/>
-            <a:ext cx="1078077" cy="134112"/>
-          </a:xfrm>
-          <a:prstGeom prst="rect">
-            <a:avLst/>
-          </a:prstGeom>
-          <a:noFill/>
-        </p:spPr>
-        <p:txBody>
-          <a:bodyPr wrap="square" lIns="0" rIns="0" tIns="0" bIns="0" anchor="t">
-            <a:noAutofit/>
-          </a:bodyPr>
-          <a:lstStyle/>
-          <a:p>
-            <a:pPr algn="l">
-              <a:lnSpc>
-                <a:spcPts val="1056"/>
-              </a:lnSpc>
-            </a:pPr>
-            <a:r>
-              <a:rPr sz="800" b="1">
-                <a:solidFill>
-                  <a:srgbClr val="15795F"/>
-                </a:solidFill>
-                <a:latin typeface="Kanit"/>
-              </a:rPr>
-              <a:t>6 เดือน +5.0%</a:t>
-            </a:r>
-          </a:p>
-        </p:txBody>
-      </p:sp>
-      <p:sp>
-        <p:nvSpPr>
-          <p:cNvPr id="47" name="Rectangle 46"/>
-          <p:cNvSpPr/>
-          <p:nvPr/>
-        </p:nvSpPr>
-        <p:spPr>
-          <a:xfrm>
-            <a:off x="9621316" y="2400300"/>
-            <a:ext cx="2156155" cy="548640"/>
-          </a:xfrm>
-          <a:prstGeom prst="rect">
-            <a:avLst/>
-          </a:prstGeom>
-          <a:solidFill>
-            <a:srgbClr val="FBFCFE"/>
-          </a:solidFill>
-          <a:ln w="9525">
-            <a:solidFill>
-              <a:srgbClr val="D9DEE9"/>
-            </a:solidFill>
-          </a:ln>
-          <a:effectLst/>
-        </p:spPr>
-        <p:style>
-          <a:lnRef idx="1">
-            <a:schemeClr val="accent1"/>
-          </a:lnRef>
-          <a:fillRef idx="3">
-            <a:schemeClr val="accent1"/>
-          </a:fillRef>
-          <a:effectRef idx="2">
-            <a:schemeClr val="accent1"/>
-          </a:effectRef>
-          <a:fontRef idx="minor">
-            <a:schemeClr val="lt1"/>
-          </a:fontRef>
-        </p:style>
-        <p:txBody>
-          <a:bodyPr rtlCol="0" anchor="ctr" wrap="none"/>
-          <a:lstStyle/>
-          <a:p>
-            <a:pPr algn="ctr"/>
-          </a:p>
-        </p:txBody>
-      </p:sp>
-      <p:sp>
-        <p:nvSpPr>
-          <p:cNvPr id="48" name="Freeform 47"/>
-          <p:cNvSpPr/>
-          <p:nvPr/>
-        </p:nvSpPr>
-        <p:spPr>
-          <a:xfrm>
-            <a:off x="9667036" y="2446020"/>
-            <a:ext cx="2064715" cy="457200"/>
-          </a:xfrm>
-          <a:custGeom>
-            <a:avLst/>
-            <a:gdLst/>
-            <a:ahLst/>
-            <a:cxnLst/>
-            <a:rect l="l" t="t" r="r" b="b"/>
-            <a:pathLst>
-              <a:path w="2064715" h="457200">
-                <a:moveTo>
-                  <a:pt x="0" y="457200"/>
-                </a:moveTo>
-                <a:lnTo>
-                  <a:pt x="412943" y="391702"/>
-                </a:lnTo>
-                <a:lnTo>
-                  <a:pt x="825886" y="105409"/>
-                </a:lnTo>
-                <a:lnTo>
-                  <a:pt x="1238829" y="105409"/>
-                </a:lnTo>
-                <a:lnTo>
-                  <a:pt x="1651772" y="214144"/>
-                </a:lnTo>
-                <a:lnTo>
-                  <a:pt x="2064715" y="0"/>
-                </a:lnTo>
-              </a:path>
-            </a:pathLst>
-          </a:custGeom>
-          <a:noFill/>
-          <a:ln w="20320">
-            <a:solidFill>
-              <a:srgbClr val="15795F"/>
-            </a:solidFill>
-          </a:ln>
-          <a:effectLst/>
-        </p:spPr>
-        <p:style>
-          <a:lnRef idx="1">
-            <a:schemeClr val="accent1"/>
-          </a:lnRef>
-          <a:fillRef idx="3">
-            <a:schemeClr val="accent1"/>
-          </a:fillRef>
-          <a:effectRef idx="2">
-            <a:schemeClr val="accent1"/>
-          </a:effectRef>
-          <a:fontRef idx="minor">
-            <a:schemeClr val="lt1"/>
-          </a:fontRef>
-        </p:style>
-        <p:txBody>
-          <a:bodyPr rtlCol="0" anchor="ctr"/>
-          <a:lstStyle/>
-          <a:p>
-            <a:pPr algn="ctr"/>
-          </a:p>
-        </p:txBody>
-      </p:sp>
-      <p:sp>
-        <p:nvSpPr>
-          <p:cNvPr id="49" name="Rounded Rectangle 48"/>
-          <p:cNvSpPr/>
-          <p:nvPr/>
-        </p:nvSpPr>
-        <p:spPr>
-          <a:xfrm>
-            <a:off x="11690603" y="2404872"/>
-            <a:ext cx="82296" cy="82296"/>
-          </a:xfrm>
-          <a:prstGeom prst="roundRect">
-            <a:avLst>
-              <a:gd name="adj" fmla="val 50000"/>
-            </a:avLst>
-          </a:prstGeom>
-          <a:solidFill>
-            <a:srgbClr val="15795F"/>
           </a:solidFill>
           <a:ln>
             <a:noFill/>
@@ -49940,7 +49614,7 @@
                 </a:solidFill>
                 <a:latin typeface="Kanit"/>
               </a:rPr>
-              <a:t>เทียบปีก่อน +0.9%</a:t>
+              <a:t>เทียบปีก่อน +1.6%</a:t>
             </a:r>
           </a:p>
         </p:txBody>
@@ -50258,7 +49932,7 @@
                 </a:solidFill>
                 <a:latin typeface="Kanit"/>
               </a:rPr>
-              <a:t>เทียบปีก่อน +13.5%</a:t>
+              <a:t>เทียบปีก่อน +13.9%</a:t>
             </a:r>
           </a:p>
         </p:txBody>
@@ -50576,7 +50250,7 @@
                 </a:solidFill>
                 <a:latin typeface="Kanit"/>
               </a:rPr>
-              <a:t>เทียบปีก่อน +14.9%</a:t>
+              <a:t>เทียบปีก่อน +15.4%</a:t>
             </a:r>
           </a:p>
         </p:txBody>
@@ -50894,7 +50568,7 @@
                 </a:solidFill>
                 <a:latin typeface="Kanit"/>
               </a:rPr>
-              <a:t>เทียบปีก่อน +25.5%</a:t>
+              <a:t>เทียบปีก่อน +25.3%</a:t>
             </a:r>
           </a:p>
         </p:txBody>
@@ -51212,7 +50886,7 @@
                 </a:solidFill>
                 <a:latin typeface="Kanit"/>
               </a:rPr>
-              <a:t>เทียบปีก่อน +41.6%</a:t>
+              <a:t>เทียบปีก่อน +42.0%</a:t>
             </a:r>
           </a:p>
         </p:txBody>
@@ -51530,7 +51204,7 @@
                 </a:solidFill>
                 <a:latin typeface="Kanit"/>
               </a:rPr>
-              <a:t>เทียบปีก่อน +61.3%</a:t>
+              <a:t>เทียบปีก่อน +63.5%</a:t>
             </a:r>
           </a:p>
         </p:txBody>
@@ -51848,7 +51522,7 @@
                 </a:solidFill>
                 <a:latin typeface="Kanit"/>
               </a:rPr>
-              <a:t>เทียบปีก่อน +105.0%</a:t>
+              <a:t>เทียบปีก่อน +109.2%</a:t>
             </a:r>
           </a:p>
         </p:txBody>
@@ -52212,7 +51886,7 @@
                 </a:solidFill>
                 <a:latin typeface="Kanit"/>
               </a:rPr>
-              <a:t>ราคาหน้าฟาร์ม วัดจริง — ราคารายวันของ NABC เฉลี่ยเป็นรายเดือน หน่วยเป็นบาทตามที่เผยแพร่ (ไม่มีการแปลงสกุลเงิน) ราคาล่าสุด 2026-08-07, รุ่นข้อมูลย้อนหลัง 2026-08-02 ราคาหน้าฟาร์ม (ราคาที่เกษตรกรขายได้) คือเงินที่เกษตรกรได้รับเมื่อขายครั้งแรก ก่อนพ่อค้าคนกลาง โรงสี หรือค่าขนส่งจะหักส่วนแบ่ง — ไม่ใช่ดัชนีโลก และไม่ใช่ราคาในซูเปอร์มาร์เก็ต แหล่งผลิตเป็นการอ่านแบบ ประมาณการ ว่าสินค้าแต่ละชนิดผลิตที่ไหน และทับซ้อนกันได้ น้ำตาลเป็นราคาอ้อยประกาศของ สอน. ปีละหนึ่งจุด จึงไม่มีการเปลี่ยนแปลงหกเดือนให้แสดง</a:t>
+              <a:t>ราคาหน้าฟาร์ม วัดจริง — ราคารายวันของ NABC เฉลี่ยเป็นรายเดือน หน่วยเป็นบาทตามที่เผยแพร่ (ไม่มีการแปลงสกุลเงิน) ราคาล่าสุด 2026-08-11, รุ่นข้อมูลย้อนหลัง 2026-08-02 ราคาหน้าฟาร์ม (ราคาที่เกษตรกรขายได้) คือเงินที่เกษตรกรได้รับเมื่อขายครั้งแรก ก่อนพ่อค้าคนกลาง โรงสี หรือค่าขนส่งจะหักส่วนแบ่ง — ไม่ใช่ดัชนีโลก และไม่ใช่ราคาในซูเปอร์มาร์เก็ต แหล่งผลิตเป็นการอ่านแบบ ประมาณการ ว่าสินค้าแต่ละชนิดผลิตที่ไหน และทับซ้อนกันได้ น้ำตาลเป็นราคาอ้อยประกาศของ สอน. ปีละหนึ่งจุด จึงไม่มีการเปลี่ยนแปลงหกเดือนให้แสดง</a:t>
             </a:r>
           </a:p>
         </p:txBody>

</xml_diff>

<commit_message>
deck(mcom): rebuild — the data moved past the committed figures (run 31487447613) (#351)
</commit_message>
<xml_diff>
--- a/docs/decks/mcom-2026-08-05-macro-TH.pptx
+++ b/docs/decks/mcom-2026-08-05-macro-TH.pptx
@@ -6240,7 +6240,7 @@
                 </a:solidFill>
                 <a:latin typeface="Kanit"/>
               </a:rPr>
-              <a:t>167</a:t>
+              <a:t>156</a:t>
             </a:r>
           </a:p>
         </p:txBody>
@@ -6279,7 +6279,7 @@
                 </a:solidFill>
                 <a:latin typeface="Kanit"/>
               </a:rPr>
-              <a:t>จาก 796 (21.0%) · เรียลไทม์ · 2026-08-09</a:t>
+              <a:t>จาก 794 (19.6%) · เรียลไทม์ · 2026-08-11</a:t>
             </a:r>
           </a:p>
         </p:txBody>
@@ -6405,7 +6405,7 @@
                 </a:solidFill>
                 <a:latin typeface="Kanit"/>
               </a:rPr>
-              <a:t>20</a:t>
+              <a:t>14</a:t>
             </a:r>
           </a:p>
         </p:txBody>
@@ -6444,7 +6444,7 @@
                 </a:solidFill>
                 <a:latin typeface="Kanit"/>
               </a:rPr>
-              <a:t>ค่าล่าสุดรายวัน · 2026-08-09</a:t>
+              <a:t>ค่าล่าสุดรายวัน · 2026-08-11</a:t>
             </a:r>
           </a:p>
         </p:txBody>
@@ -7905,7 +7905,7 @@
                           </a:solidFill>
                           <a:latin typeface="Kanit"/>
                         </a:rPr>
-                        <a:t>121</a:t>
+                        <a:t>123</a:t>
                       </a:r>
                     </a:p>
                   </a:txBody>
@@ -7928,7 +7928,7 @@
                           </a:solidFill>
                           <a:latin typeface="Kanit"/>
                         </a:rPr>
-                        <a:t>82</a:t>
+                        <a:t>105</a:t>
                       </a:r>
                     </a:p>
                   </a:txBody>
@@ -7951,7 +7951,7 @@
                           </a:solidFill>
                           <a:latin typeface="Kanit"/>
                         </a:rPr>
-                        <a:t>24.8%</a:t>
+                        <a:t>10.6%</a:t>
                       </a:r>
                     </a:p>
                   </a:txBody>
@@ -7974,7 +7974,7 @@
                           </a:solidFill>
                           <a:latin typeface="Kanit"/>
                         </a:rPr>
-                        <a:t>5/13</a:t>
+                        <a:t>4/13</a:t>
                       </a:r>
                     </a:p>
                   </a:txBody>
@@ -8022,7 +8022,7 @@
                           </a:solidFill>
                           <a:latin typeface="Kanit"/>
                         </a:rPr>
-                        <a:t>น่าน</a:t>
+                        <a:t>นราธิวาส</a:t>
                       </a:r>
                     </a:p>
                   </a:txBody>
@@ -8045,7 +8045,7 @@
                           </a:solidFill>
                           <a:latin typeface="Kanit"/>
                         </a:rPr>
-                        <a:t>221</a:t>
+                        <a:t>64</a:t>
                       </a:r>
                     </a:p>
                   </a:txBody>
@@ -8068,7 +8068,7 @@
                           </a:solidFill>
                           <a:latin typeface="Kanit"/>
                         </a:rPr>
-                        <a:t>134</a:t>
+                        <a:t>38</a:t>
                       </a:r>
                     </a:p>
                   </a:txBody>
@@ -8091,7 +8091,7 @@
                           </a:solidFill>
                           <a:latin typeface="Kanit"/>
                         </a:rPr>
-                        <a:t>23.5%</a:t>
+                        <a:t>1.6%</a:t>
                       </a:r>
                     </a:p>
                   </a:txBody>
@@ -8114,7 +8114,7 @@
                           </a:solidFill>
                           <a:latin typeface="Kanit"/>
                         </a:rPr>
-                        <a:t>10/28</a:t>
+                        <a:t>5/10</a:t>
                       </a:r>
                     </a:p>
                   </a:txBody>
@@ -8162,7 +8162,7 @@
                           </a:solidFill>
                           <a:latin typeface="Kanit"/>
                         </a:rPr>
-                        <a:t>นครพนม</a:t>
+                        <a:t>ชัยภูมิ</a:t>
                       </a:r>
                     </a:p>
                   </a:txBody>
@@ -8185,7 +8185,7 @@
                           </a:solidFill>
                           <a:latin typeface="Kanit"/>
                         </a:rPr>
-                        <a:t>29</a:t>
+                        <a:t>58</a:t>
                       </a:r>
                     </a:p>
                   </a:txBody>
@@ -8208,7 +8208,7 @@
                           </a:solidFill>
                           <a:latin typeface="Kanit"/>
                         </a:rPr>
-                        <a:t>278</a:t>
+                        <a:t>24</a:t>
                       </a:r>
                     </a:p>
                   </a:txBody>
@@ -8227,11 +8227,11 @@
                       <a:r>
                         <a:rPr sz="900" b="1">
                           <a:solidFill>
-                            <a:srgbClr val="F5C242"/>
-                          </a:solidFill>
-                          <a:latin typeface="Kanit"/>
-                        </a:rPr>
-                        <a:t>17.2%</a:t>
+                            <a:srgbClr val="606060"/>
+                          </a:solidFill>
+                          <a:latin typeface="Kanit"/>
+                        </a:rPr>
+                        <a:t>0.0%</a:t>
                       </a:r>
                     </a:p>
                   </a:txBody>
@@ -8254,7 +8254,7 @@
                           </a:solidFill>
                           <a:latin typeface="Kanit"/>
                         </a:rPr>
-                        <a:t>9/15</a:t>
+                        <a:t>1/12</a:t>
                       </a:r>
                     </a:p>
                   </a:txBody>
@@ -8302,7 +8302,7 @@
                           </a:solidFill>
                           <a:latin typeface="Kanit"/>
                         </a:rPr>
-                        <a:t>สกลนคร</a:t>
+                        <a:t>นครพนม</a:t>
                       </a:r>
                     </a:p>
                   </a:txBody>
@@ -8325,7 +8325,7 @@
                           </a:solidFill>
                           <a:latin typeface="Kanit"/>
                         </a:rPr>
-                        <a:t>36</a:t>
+                        <a:t>29</a:t>
                       </a:r>
                     </a:p>
                   </a:txBody>
@@ -8348,7 +8348,7 @@
                           </a:solidFill>
                           <a:latin typeface="Kanit"/>
                         </a:rPr>
-                        <a:t>47</a:t>
+                        <a:t>9</a:t>
                       </a:r>
                     </a:p>
                   </a:txBody>
@@ -8367,11 +8367,11 @@
                       <a:r>
                         <a:rPr sz="900" b="1">
                           <a:solidFill>
-                            <a:srgbClr val="F5C242"/>
-                          </a:solidFill>
-                          <a:latin typeface="Kanit"/>
-                        </a:rPr>
-                        <a:t>2.8%</a:t>
+                            <a:srgbClr val="606060"/>
+                          </a:solidFill>
+                          <a:latin typeface="Kanit"/>
+                        </a:rPr>
+                        <a:t>0.0%</a:t>
                       </a:r>
                     </a:p>
                   </a:txBody>
@@ -8394,7 +8394,7 @@
                           </a:solidFill>
                           <a:latin typeface="Kanit"/>
                         </a:rPr>
-                        <a:t>9/14</a:t>
+                        <a:t>9/15</a:t>
                       </a:r>
                     </a:p>
                   </a:txBody>
@@ -8442,7 +8442,7 @@
                           </a:solidFill>
                           <a:latin typeface="Kanit"/>
                         </a:rPr>
-                        <a:t>นราธิวาส</a:t>
+                        <a:t>บึงกาฬ</a:t>
                       </a:r>
                     </a:p>
                   </a:txBody>
@@ -8465,7 +8465,7 @@
                           </a:solidFill>
                           <a:latin typeface="Kanit"/>
                         </a:rPr>
-                        <a:t>64</a:t>
+                        <a:t>11</a:t>
                       </a:r>
                     </a:p>
                   </a:txBody>
@@ -8488,7 +8488,7 @@
                           </a:solidFill>
                           <a:latin typeface="Kanit"/>
                         </a:rPr>
-                        <a:t>24</a:t>
+                        <a:t>23</a:t>
                       </a:r>
                     </a:p>
                   </a:txBody>
@@ -8534,7 +8534,7 @@
                           </a:solidFill>
                           <a:latin typeface="Kanit"/>
                         </a:rPr>
-                        <a:t>5/10</a:t>
+                        <a:t>1/1</a:t>
                       </a:r>
                     </a:p>
                   </a:txBody>
@@ -8605,7 +8605,7 @@
                           </a:solidFill>
                           <a:latin typeface="Kanit"/>
                         </a:rPr>
-                        <a:t>18</a:t>
+                        <a:t>17</a:t>
                       </a:r>
                     </a:p>
                   </a:txBody>
@@ -8628,7 +8628,7 @@
                           </a:solidFill>
                           <a:latin typeface="Kanit"/>
                         </a:rPr>
-                        <a:t>22</a:t>
+                        <a:t>16</a:t>
                       </a:r>
                     </a:p>
                   </a:txBody>
@@ -8909,7 +8909,7 @@
                 </a:solidFill>
                 <a:latin typeface="Kanit"/>
               </a:rPr>
-              <a:t>พื้นที่ปลูก วัดจริง (สศก. — ข้อมูลอำเภอ×พืช 3,295 แถว) ภัยแล้งเป็นดัชนี SPEI จาก แบบจำลอง คำนวณจากปริมาณฝนและการคายระเหย ปรับเดือนละครั้ง ดึงข้อมูล 2026-07-20 — เป็นสัญญาณที่ครอบคลุมทั้งประเทศดีที่สุดที่มี แต่ไม่มีใครลงพื้นที่ไปเดินดูอำเภอเหล่านั้น ข้อมูลฝนและระดับน้ำ วัดจริง (ThaiWater เรียลไทม์ ดึงทุกวันและสะสมไว้ — วันที่ดึงไม่สำเร็จจะเว้นเป็นช่องว่าง ไม่ใส่ค่าสมมติ) · ฝนถึง 2026-08-09, ระดับน้ำถึง 2026-08-09 ความเสี่ยงน้ำท่วมเชิงโครงสร้าง วัดจริง (สำมะโนพื้นที่ท่วมซ้ำซาก GISTDA มาตราส่วน 1:50,000 ปี 2005-2016 — เป็นบันทึกภาคพื้นดิน 12 ปี ไม่ใช่การพยากรณ์)</a:t>
+              <a:t>พื้นที่ปลูก วัดจริง (สศก. — ข้อมูลอำเภอ×พืช 3,295 แถว) ภัยแล้งเป็นดัชนี SPEI จาก แบบจำลอง คำนวณจากปริมาณฝนและการคายระเหย ปรับเดือนละครั้ง ดึงข้อมูล 2026-07-20 — เป็นสัญญาณที่ครอบคลุมทั้งประเทศดีที่สุดที่มี แต่ไม่มีใครลงพื้นที่ไปเดินดูอำเภอเหล่านั้น ข้อมูลฝนและระดับน้ำ วัดจริง (ThaiWater เรียลไทม์ ดึงทุกวันและสะสมไว้ — วันที่ดึงไม่สำเร็จจะเว้นเป็นช่องว่าง ไม่ใส่ค่าสมมติ) · ฝนถึง 2026-08-11, ระดับน้ำถึง 2026-08-11 ความเสี่ยงน้ำท่วมเชิงโครงสร้าง วัดจริง (สำมะโนพื้นที่ท่วมซ้ำซาก GISTDA มาตราส่วน 1:50,000 ปี 2005-2016 — เป็นบันทึกภาคพื้นดิน 12 ปี ไม่ใช่การพยากรณ์)</a:t>
             </a:r>
           </a:p>
         </p:txBody>
@@ -31476,7 +31476,7 @@
                 </a:solidFill>
                 <a:latin typeface="Kanit"/>
               </a:rPr>
-              <a:t>รายได้จากพืชค่ากลางเพิ่มขึ้น +16.1% แต่มีสี่จังหวัดที่ลดลง — ทั้งหมดอยู่ในแหล่งปลูกมะพร้าว โดยหนักที่สุดคือสมุทรสงครามที่ −64.0%</a:t>
+              <a:t>รายได้จากพืชค่ากลางเพิ่มขึ้น +16.6% แต่มีสี่จังหวัดที่ลดลง — ทั้งหมดอยู่ในแหล่งปลูกมะพร้าว โดยหนักที่สุดคือสมุทรสงครามที่ −63.4%</a:t>
             </a:r>
           </a:p>
         </p:txBody>
@@ -32047,7 +32047,7 @@
                 </a:solidFill>
                 <a:latin typeface="Kanit"/>
               </a:rPr>
-              <a:t>รุ่นข้อมูล — ราคาโลก 2026M06 · ราคาหน้าฟาร์มไทย 2026-08-07 · ประวัติราคาไทย 2026-08-02 · ต้นทุนการผลิตพืช สศก. ไจอัป 2568 (ปีเพาะปลูก 2568/69, ประมาณการ สศก. มี.ค. 2569) · ภัยแล้ง 2026-06-21 · เงินเฟ้อ 2026-05 · GDP 2026 ไตรมาส 1 · IMF WEO 2026 · ดัชนีราคาขายต่อ 2026-05 · ยอดจดทะเบียนถึง 2026-01 · หนี้ครัวเรือน สสช. SES 2566 · ค่าจ้าง สสช. LFS 2568 · ข้อมูลตรวจวัด 2026-08-09</a:t>
+              <a:t>รุ่นข้อมูล — ราคาโลก 2026M06 · ราคาหน้าฟาร์มไทย 2026-08-11 · ประวัติราคาไทย 2026-08-02 · ต้นทุนการผลิตพืช สศก. ไจอัป 2568 (ปีเพาะปลูก 2568/69, ประมาณการ สศก. มี.ค. 2569) · ภัยแล้ง 2026-06-21 · เงินเฟ้อ 2026-05 · GDP 2026 ไตรมาส 1 · IMF WEO 2026 · ดัชนีราคาขายต่อ 2026-05 · ยอดจดทะเบียนถึง 2026-01 · หนี้ครัวเรือน สสช. SES 2566 · ค่าจ้าง สสช. LFS 2568 · ข้อมูลตรวจวัด 2026-08-11</a:t>
             </a:r>
           </a:p>
         </p:txBody>
@@ -32543,10 +32543,10 @@
                 </a:solidFill>
                 <a:latin typeface="Kanit"/>
               </a:rPr>
-              <a:t>ไม่ใช่ถ้าดูดัชนีโลก — แต่ราคาหน้าฟาร์ม (ราคาที่เกษตรกรขายได้) บอกคนละเรื่อง
-• ราคาหน้าฟาร์มไทยเจ็ดจากสิบเจ็ดรายการลดลงเมื่อเทียบกับปีก่อน
-• เนื้อวัว: หน้าฟาร์ม −6.1% เทียบดัชนีโลก +11.8%
-• ส่วนต่างสำคัญกว่าราคา: ราคาขยับ 26% กลายเป็นรายได้เกษตรเหวี่ยง 83%</a:t>
+              <a:t>Not on the world index — the farm gate (ราคาที่เกษตรกรขายได้) says otherwise.
+• Five of seventeen Thai farm-gate prices are falling year on year.
+• Beef: farm gate −6.1% vs world index +11.8%.
+• Margin over price: a 26% price move becomes an 85% swing in crop income.</a:t>
             </a:r>
           </a:p>
         </p:txBody>
@@ -37087,7 +37087,7 @@
                 </a:solidFill>
                 <a:latin typeface="Kanit"/>
               </a:rPr>
-              <a:t>338 จาก 928 อำเภอ · แม่น้ำเกินระดับ 167 จาก 796 สถานี</a:t>
+              <a:t>338 จาก 928 อำเภอ · แม่น้ำเกินระดับ 156 จาก 794 สถานี</a:t>
             </a:r>
           </a:p>
         </p:txBody>
@@ -37859,7 +37859,7 @@
                           </a:solidFill>
                           <a:latin typeface="Kanit"/>
                         </a:rPr>
-                        <a:t>40/159</a:t>
+                        <a:t>39/158</a:t>
                       </a:r>
                     </a:p>
                   </a:txBody>
@@ -38091,7 +38091,7 @@
                           </a:solidFill>
                           <a:latin typeface="Kanit"/>
                         </a:rPr>
-                        <a:t>45/274</a:t>
+                        <a:t>42/273</a:t>
                       </a:r>
                     </a:p>
                   </a:txBody>
@@ -38323,7 +38323,7 @@
                           </a:solidFill>
                           <a:latin typeface="Kanit"/>
                         </a:rPr>
-                        <a:t>27/168</a:t>
+                        <a:t>24/168</a:t>
                       </a:r>
                     </a:p>
                   </a:txBody>
@@ -38555,7 +38555,7 @@
                           </a:solidFill>
                           <a:latin typeface="Kanit"/>
                         </a:rPr>
-                        <a:t>7/52</a:t>
+                        <a:t>6/52</a:t>
                       </a:r>
                     </a:p>
                   </a:txBody>
@@ -38787,7 +38787,7 @@
                           </a:solidFill>
                           <a:latin typeface="Kanit"/>
                         </a:rPr>
-                        <a:t>48/143</a:t>
+                        <a:t>45/143</a:t>
                       </a:r>
                     </a:p>
                   </a:txBody>
@@ -39502,7 +39502,7 @@
                 </a:solidFill>
                 <a:latin typeface="Kanit"/>
               </a:rPr>
-              <a:t>สินค้าเกษตร 17 จากทั้งหมด 21 รายการที่เราติดตาม มีราคาหน้าฟาร์มไทยที่วัดได้จริง (ราคาที่เกษตรกรขายได้) และเจ็ดรายการกำลังลดลงเมื่อเทียบกับปีก่อน</a:t>
+              <a:t>Seventeen of the 21 commodities we track have a measured Thai farm-gate price (ราคาที่เกษตรกรขายได้). Five are falling year on year.</a:t>
             </a:r>
           </a:p>
         </p:txBody>
@@ -39673,7 +39673,7 @@
         </p:nvGraphicFramePr>
         <p:xfrm>
           <a:off x="411480" y="2033016"/>
-          <a:ext cx="11365992" cy="2108605"/>
+          <a:ext cx="11365992" cy="1600199"/>
         </p:xfrm>
         <a:graphic>
           <a:graphicData uri="http://schemas.openxmlformats.org/drawingml/2006/table">
@@ -39936,7 +39936,7 @@
                           </a:solidFill>
                           <a:latin typeface="Kanit"/>
                         </a:rPr>
-                        <a:t>−68.4%</a:t>
+                        <a:t>−67.8%</a:t>
                       </a:r>
                     </a:p>
                   </a:txBody>
@@ -40658,332 +40658,6 @@
                           <a:latin typeface="Kanit"/>
                         </a:rPr>
                         <a:t>23%</a:t>
-                      </a:r>
-                    </a:p>
-                  </a:txBody>
-                  <a:tcPr marL="54864" marR="54864" marT="18288" marB="18288" anchor="ctr">
-                    <a:solidFill>
-                      <a:srgbClr val="FFFFFF"/>
-                    </a:solidFill>
-                  </a:tcPr>
-                </a:tc>
-              </a:tr>
-              <a:tr h="254203">
-                <a:tc>
-                  <a:txBody>
-                    <a:bodyPr wrap="square"/>
-                    <a:lstStyle/>
-                    <a:p>
-                      <a:pPr algn="l"/>
-                      <a:r>
-                        <a:rPr sz="1000" b="1">
-                          <a:solidFill>
-                            <a:srgbClr val="1E2F5C"/>
-                          </a:solidFill>
-                          <a:latin typeface="Kanit"/>
-                        </a:rPr>
-                        <a:t>สุกร</a:t>
-                      </a:r>
-                    </a:p>
-                  </a:txBody>
-                  <a:tcPr marL="54864" marR="54864" marT="18288" marB="18288" anchor="ctr">
-                    <a:solidFill>
-                      <a:srgbClr val="F7F9FC"/>
-                    </a:solidFill>
-                  </a:tcPr>
-                </a:tc>
-                <a:tc>
-                  <a:txBody>
-                    <a:bodyPr wrap="square"/>
-                    <a:lstStyle/>
-                    <a:p>
-                      <a:pPr algn="l"/>
-                      <a:r>
-                        <a:rPr sz="1000" b="0">
-                          <a:solidFill>
-                            <a:srgbClr val="1E2F5C"/>
-                          </a:solidFill>
-                          <a:latin typeface="Kanit"/>
-                        </a:rPr>
-                        <a:t>ปศุสัตว์</a:t>
-                      </a:r>
-                    </a:p>
-                  </a:txBody>
-                  <a:tcPr marL="54864" marR="54864" marT="18288" marB="18288" anchor="ctr">
-                    <a:solidFill>
-                      <a:srgbClr val="F7F9FC"/>
-                    </a:solidFill>
-                  </a:tcPr>
-                </a:tc>
-                <a:tc>
-                  <a:txBody>
-                    <a:bodyPr wrap="square"/>
-                    <a:lstStyle/>
-                    <a:p>
-                      <a:pPr algn="l"/>
-                      <a:r>
-                        <a:rPr sz="1000" b="0">
-                          <a:solidFill>
-                            <a:srgbClr val="1E2F5C"/>
-                          </a:solidFill>
-                          <a:latin typeface="Kanit"/>
-                        </a:rPr>
-                        <a:t>กลาง · ตต. · ตอ.</a:t>
-                      </a:r>
-                    </a:p>
-                  </a:txBody>
-                  <a:tcPr marL="54864" marR="54864" marT="18288" marB="18288" anchor="ctr">
-                    <a:solidFill>
-                      <a:srgbClr val="F7F9FC"/>
-                    </a:solidFill>
-                  </a:tcPr>
-                </a:tc>
-                <a:tc>
-                  <a:txBody>
-                    <a:bodyPr wrap="square"/>
-                    <a:lstStyle/>
-                    <a:p>
-                      <a:pPr algn="r"/>
-                      <a:r>
-                        <a:rPr sz="1000" b="1">
-                          <a:solidFill>
-                            <a:srgbClr val="CC0000"/>
-                          </a:solidFill>
-                          <a:latin typeface="Kanit"/>
-                        </a:rPr>
-                        <a:t>−1.2%</a:t>
-                      </a:r>
-                    </a:p>
-                  </a:txBody>
-                  <a:tcPr marL="54864" marR="54864" marT="18288" marB="18288" anchor="ctr">
-                    <a:solidFill>
-                      <a:srgbClr val="F7F9FC"/>
-                    </a:solidFill>
-                  </a:tcPr>
-                </a:tc>
-                <a:tc>
-                  <a:txBody>
-                    <a:bodyPr wrap="square"/>
-                    <a:lstStyle/>
-                    <a:p>
-                      <a:pPr algn="r"/>
-                      <a:r>
-                        <a:rPr sz="1000" b="1">
-                          <a:solidFill>
-                            <a:srgbClr val="15795F"/>
-                          </a:solidFill>
-                          <a:latin typeface="Kanit"/>
-                        </a:rPr>
-                        <a:t>+6.1%</a:t>
-                      </a:r>
-                    </a:p>
-                  </a:txBody>
-                  <a:tcPr marL="54864" marR="54864" marT="18288" marB="18288" anchor="ctr">
-                    <a:solidFill>
-                      <a:srgbClr val="F7F9FC"/>
-                    </a:solidFill>
-                  </a:tcPr>
-                </a:tc>
-                <a:tc>
-                  <a:txBody>
-                    <a:bodyPr wrap="square"/>
-                    <a:lstStyle/>
-                    <a:p>
-                      <a:pPr algn="r"/>
-                      <a:r>
-                        <a:rPr sz="1000" b="1">
-                          <a:solidFill>
-                            <a:srgbClr val="7A4FE0"/>
-                          </a:solidFill>
-                          <a:latin typeface="Kanit"/>
-                        </a:rPr>
-                        <a:t>32,143</a:t>
-                      </a:r>
-                    </a:p>
-                  </a:txBody>
-                  <a:tcPr marL="54864" marR="54864" marT="18288" marB="18288" anchor="ctr">
-                    <a:solidFill>
-                      <a:srgbClr val="F7F9FC"/>
-                    </a:solidFill>
-                  </a:tcPr>
-                </a:tc>
-                <a:tc>
-                  <a:txBody>
-                    <a:bodyPr wrap="square"/>
-                    <a:lstStyle/>
-                    <a:p>
-                      <a:pPr algn="r"/>
-                      <a:r>
-                        <a:rPr sz="1000" b="0">
-                          <a:solidFill>
-                            <a:srgbClr val="606060"/>
-                          </a:solidFill>
-                          <a:latin typeface="Kanit"/>
-                        </a:rPr>
-                        <a:t>22%</a:t>
-                      </a:r>
-                    </a:p>
-                  </a:txBody>
-                  <a:tcPr marL="54864" marR="54864" marT="18288" marB="18288" anchor="ctr">
-                    <a:solidFill>
-                      <a:srgbClr val="F7F9FC"/>
-                    </a:solidFill>
-                  </a:tcPr>
-                </a:tc>
-              </a:tr>
-              <a:tr h="254203">
-                <a:tc>
-                  <a:txBody>
-                    <a:bodyPr wrap="square"/>
-                    <a:lstStyle/>
-                    <a:p>
-                      <a:pPr algn="l"/>
-                      <a:r>
-                        <a:rPr sz="1000" b="1">
-                          <a:solidFill>
-                            <a:srgbClr val="1E2F5C"/>
-                          </a:solidFill>
-                          <a:latin typeface="Kanit"/>
-                        </a:rPr>
-                        <a:t>กุ้งขาว</a:t>
-                      </a:r>
-                    </a:p>
-                  </a:txBody>
-                  <a:tcPr marL="54864" marR="54864" marT="18288" marB="18288" anchor="ctr">
-                    <a:solidFill>
-                      <a:srgbClr val="FFFFFF"/>
-                    </a:solidFill>
-                  </a:tcPr>
-                </a:tc>
-                <a:tc>
-                  <a:txBody>
-                    <a:bodyPr wrap="square"/>
-                    <a:lstStyle/>
-                    <a:p>
-                      <a:pPr algn="l"/>
-                      <a:r>
-                        <a:rPr sz="1000" b="0">
-                          <a:solidFill>
-                            <a:srgbClr val="1E2F5C"/>
-                          </a:solidFill>
-                          <a:latin typeface="Kanit"/>
-                        </a:rPr>
-                        <a:t>ประมง</a:t>
-                      </a:r>
-                    </a:p>
-                  </a:txBody>
-                  <a:tcPr marL="54864" marR="54864" marT="18288" marB="18288" anchor="ctr">
-                    <a:solidFill>
-                      <a:srgbClr val="FFFFFF"/>
-                    </a:solidFill>
-                  </a:tcPr>
-                </a:tc>
-                <a:tc>
-                  <a:txBody>
-                    <a:bodyPr wrap="square"/>
-                    <a:lstStyle/>
-                    <a:p>
-                      <a:pPr algn="l"/>
-                      <a:r>
-                        <a:rPr sz="1000" b="0">
-                          <a:solidFill>
-                            <a:srgbClr val="1E2F5C"/>
-                          </a:solidFill>
-                          <a:latin typeface="Kanit"/>
-                        </a:rPr>
-                        <a:t>ชายฝั่งใต้ · ตอ.</a:t>
-                      </a:r>
-                    </a:p>
-                  </a:txBody>
-                  <a:tcPr marL="54864" marR="54864" marT="18288" marB="18288" anchor="ctr">
-                    <a:solidFill>
-                      <a:srgbClr val="FFFFFF"/>
-                    </a:solidFill>
-                  </a:tcPr>
-                </a:tc>
-                <a:tc>
-                  <a:txBody>
-                    <a:bodyPr wrap="square"/>
-                    <a:lstStyle/>
-                    <a:p>
-                      <a:pPr algn="r"/>
-                      <a:r>
-                        <a:rPr sz="1000" b="1">
-                          <a:solidFill>
-                            <a:srgbClr val="CC0000"/>
-                          </a:solidFill>
-                          <a:latin typeface="Kanit"/>
-                        </a:rPr>
-                        <a:t>−0.4%</a:t>
-                      </a:r>
-                    </a:p>
-                  </a:txBody>
-                  <a:tcPr marL="54864" marR="54864" marT="18288" marB="18288" anchor="ctr">
-                    <a:solidFill>
-                      <a:srgbClr val="FFFFFF"/>
-                    </a:solidFill>
-                  </a:tcPr>
-                </a:tc>
-                <a:tc>
-                  <a:txBody>
-                    <a:bodyPr wrap="square"/>
-                    <a:lstStyle/>
-                    <a:p>
-                      <a:pPr algn="r"/>
-                      <a:r>
-                        <a:rPr sz="1000" b="1">
-                          <a:solidFill>
-                            <a:srgbClr val="CC0000"/>
-                          </a:solidFill>
-                          <a:latin typeface="Kanit"/>
-                        </a:rPr>
-                        <a:t>−15.8%</a:t>
-                      </a:r>
-                    </a:p>
-                  </a:txBody>
-                  <a:tcPr marL="54864" marR="54864" marT="18288" marB="18288" anchor="ctr">
-                    <a:solidFill>
-                      <a:srgbClr val="FFFFFF"/>
-                    </a:solidFill>
-                  </a:tcPr>
-                </a:tc>
-                <a:tc>
-                  <a:txBody>
-                    <a:bodyPr wrap="square"/>
-                    <a:lstStyle/>
-                    <a:p>
-                      <a:pPr algn="r"/>
-                      <a:r>
-                        <a:rPr sz="1000" b="1">
-                          <a:solidFill>
-                            <a:srgbClr val="7A4FE0"/>
-                          </a:solidFill>
-                          <a:latin typeface="Kanit"/>
-                        </a:rPr>
-                        <a:t>9,675</a:t>
-                      </a:r>
-                    </a:p>
-                  </a:txBody>
-                  <a:tcPr marL="54864" marR="54864" marT="18288" marB="18288" anchor="ctr">
-                    <a:solidFill>
-                      <a:srgbClr val="FFFFFF"/>
-                    </a:solidFill>
-                  </a:tcPr>
-                </a:tc>
-                <a:tc>
-                  <a:txBody>
-                    <a:bodyPr wrap="square"/>
-                    <a:lstStyle/>
-                    <a:p>
-                      <a:pPr algn="r"/>
-                      <a:r>
-                        <a:rPr sz="1000" b="0">
-                          <a:solidFill>
-                            <a:srgbClr val="606060"/>
-                          </a:solidFill>
-                          <a:latin typeface="Kanit"/>
-                        </a:rPr>
-                        <a:t>9%</a:t>
                       </a:r>
                     </a:p>
                   </a:txBody>
@@ -41006,7 +40680,7 @@
         </p:nvSpPr>
         <p:spPr>
           <a:xfrm>
-            <a:off x="411480" y="4269638"/>
+            <a:off x="411480" y="3761232"/>
             <a:ext cx="535747" cy="192024"/>
           </a:xfrm>
           <a:prstGeom prst="roundRect">
@@ -41052,7 +40726,7 @@
         </p:nvSpPr>
         <p:spPr>
           <a:xfrm>
-            <a:off x="411480" y="4298899"/>
+            <a:off x="411480" y="3790492"/>
             <a:ext cx="535747" cy="134112"/>
           </a:xfrm>
           <a:prstGeom prst="rect">
@@ -41091,7 +40765,7 @@
         </p:nvSpPr>
         <p:spPr>
           <a:xfrm>
-            <a:off x="1056955" y="4283354"/>
+            <a:off x="1056955" y="3774947"/>
             <a:ext cx="10720516" cy="462915"/>
           </a:xfrm>
           <a:prstGeom prst="rect">
@@ -41117,7 +40791,7 @@
                 </a:solidFill>
                 <a:latin typeface="Kanit"/>
               </a:rPr>
-              <a:t>ราคา วัดจริง — ราคาหน้าฟาร์มไทยจากราคารายวันของ NABC และราคาอ้อยประกาศของ สอน. ราคาล่าสุด 2026-08-07 การเปลี่ยนแปลงหกเดือนคำนวณจากข้อมูลรายเดือนของ NABC เอง (thai_price_history รุ่นข้อมูล 2026-08-02) พืชที่ไม่มีข้อมูลรายเดือนจะกำกับไว้ ไม่ประมาณการขึ้นมา แหล่งผลิตเป็นการอ่านแบบ ประมาณการ ว่าสินค้าแต่ละชนิดปลูกที่ไหน และแหล่งผลิตทับซ้อนกันได้ บัญชีอาชีพเกษตรเป็นข้อมูลของเราเองและ วัดจริง — บัญชีที่บันทึกอาชีพว่า เกษตร ในจังหวัดแหล่งผลิต จากฐานข้อมูล 382,735 บัญชี ณ 2026-07 ไม่เผยแพร่ช่องที่มีน้อยกว่า 30 บัญชี คนกลุ่มนี้อาศัยอยู่ในพื้นที่ที่ปลูกพืชนั้น แต่ไม่ได้ยืนยันว่าปลูกพืชนั้นเอง</a:t>
+              <a:t>ราคา วัดจริง — ราคาหน้าฟาร์มไทยจากราคารายวันของ NABC และราคาอ้อยประกาศของ สอน. ราคาล่าสุด 2026-08-11 การเปลี่ยนแปลงหกเดือนคำนวณจากข้อมูลรายเดือนของ NABC เอง (thai_price_history รุ่นข้อมูล 2026-08-02) พืชที่ไม่มีข้อมูลรายเดือนจะกำกับไว้ ไม่ประมาณการขึ้นมา แหล่งผลิตเป็นการอ่านแบบ ประมาณการ ว่าสินค้าแต่ละชนิดปลูกที่ไหน และแหล่งผลิตทับซ้อนกันได้ บัญชีอาชีพเกษตรเป็นข้อมูลของเราเองและ วัดจริง — บัญชีที่บันทึกอาชีพว่า เกษตร ในจังหวัดแหล่งผลิต จากฐานข้อมูล 382,735 บัญชี ณ 2026-07 ไม่เผยแพร่ช่องที่มีน้อยกว่า 30 บัญชี คนกลุ่มนี้อาศัยอยู่ในพื้นที่ที่ปลูกพืชนั้น แต่ไม่ได้ยืนยันว่าปลูกพืชนั้นเอง</a:t>
             </a:r>
           </a:p>
         </p:txBody>
@@ -41130,7 +40804,7 @@
         </p:nvSpPr>
         <p:spPr>
           <a:xfrm>
-            <a:off x="411480" y="4878857"/>
+            <a:off x="411480" y="4370451"/>
             <a:ext cx="11365992" cy="675767"/>
           </a:xfrm>
           <a:prstGeom prst="rect">
@@ -41174,7 +40848,7 @@
         </p:nvSpPr>
         <p:spPr>
           <a:xfrm>
-            <a:off x="411480" y="4878857"/>
+            <a:off x="411480" y="4370451"/>
             <a:ext cx="50292" cy="675767"/>
           </a:xfrm>
           <a:prstGeom prst="rect">
@@ -41218,7 +40892,7 @@
         </p:nvSpPr>
         <p:spPr>
           <a:xfrm>
-            <a:off x="630936" y="5025161"/>
+            <a:off x="630936" y="4516755"/>
             <a:ext cx="11036808" cy="158750"/>
           </a:xfrm>
           <a:prstGeom prst="rect">
@@ -41257,7 +40931,7 @@
         </p:nvSpPr>
         <p:spPr>
           <a:xfrm>
-            <a:off x="630936" y="5229631"/>
+            <a:off x="630936" y="4721224"/>
             <a:ext cx="11036808" cy="178689"/>
           </a:xfrm>
           <a:prstGeom prst="rect">
@@ -45005,7 +44679,7 @@
                 </a:solidFill>
                 <a:latin typeface="Kanit"/>
               </a:rPr>
-              <a:t>มะพร้าว −68.4% สับปะรด −18.4% อ้อย −17.9% เทียบปีก่อน</a:t>
+              <a:t>มะพร้าว −67.8% สับปะรด −18.4% อ้อย −17.9% เทียบปีก่อน</a:t>
             </a:r>
           </a:p>
         </p:txBody>
@@ -45131,7 +44805,7 @@
                 </a:solidFill>
                 <a:latin typeface="Kanit"/>
               </a:rPr>
-              <a:t>+16.1%</a:t>
+              <a:t>+16.6%</a:t>
             </a:r>
           </a:p>
         </p:txBody>
@@ -45605,7 +45279,7 @@
                           </a:solidFill>
                           <a:latin typeface="Kanit"/>
                         </a:rPr>
-                        <a:t>+6.1%</a:t>
+                        <a:t>+6.5%</a:t>
                       </a:r>
                     </a:p>
                   </a:txBody>
@@ -45674,7 +45348,7 @@
                           </a:solidFill>
                           <a:latin typeface="Kanit"/>
                         </a:rPr>
-                        <a:t>-64.0%</a:t>
+                        <a:t>-63.4%</a:t>
                       </a:r>
                     </a:p>
                   </a:txBody>
@@ -45745,7 +45419,7 @@
                           </a:solidFill>
                           <a:latin typeface="Kanit"/>
                         </a:rPr>
-                        <a:t>+14.9%</a:t>
+                        <a:t>+15.3%</a:t>
                       </a:r>
                     </a:p>
                   </a:txBody>
@@ -45814,7 +45488,7 @@
                           </a:solidFill>
                           <a:latin typeface="Kanit"/>
                         </a:rPr>
-                        <a:t>+9.5%</a:t>
+                        <a:t>+9.8%</a:t>
                       </a:r>
                     </a:p>
                   </a:txBody>
@@ -45885,7 +45559,7 @@
                           </a:solidFill>
                           <a:latin typeface="Kanit"/>
                         </a:rPr>
-                        <a:t>+16.2%</a:t>
+                        <a:t>+16.7%</a:t>
                       </a:r>
                     </a:p>
                   </a:txBody>
@@ -45954,7 +45628,7 @@
                           </a:solidFill>
                           <a:latin typeface="Kanit"/>
                         </a:rPr>
-                        <a:t>+8.3%</a:t>
+                        <a:t>+8.6%</a:t>
                       </a:r>
                     </a:p>
                   </a:txBody>
@@ -46025,7 +45699,7 @@
                           </a:solidFill>
                           <a:latin typeface="Kanit"/>
                         </a:rPr>
-                        <a:t>+25.5%</a:t>
+                        <a:t>+25.8%</a:t>
                       </a:r>
                     </a:p>
                   </a:txBody>
@@ -46094,7 +45768,7 @@
                           </a:solidFill>
                           <a:latin typeface="Kanit"/>
                         </a:rPr>
-                        <a:t>+10.2%</a:t>
+                        <a:t>+10.7%</a:t>
                       </a:r>
                     </a:p>
                   </a:txBody>
@@ -46165,7 +45839,7 @@
                           </a:solidFill>
                           <a:latin typeface="Kanit"/>
                         </a:rPr>
-                        <a:t>+36.3%</a:t>
+                        <a:t>+36.5%</a:t>
                       </a:r>
                     </a:p>
                   </a:txBody>
@@ -46234,7 +45908,7 @@
                           </a:solidFill>
                           <a:latin typeface="Kanit"/>
                         </a:rPr>
-                        <a:t>+28.9%</a:t>
+                        <a:t>+29.0%</a:t>
                       </a:r>
                     </a:p>
                   </a:txBody>
@@ -46410,7 +46084,7 @@
                 </a:solidFill>
                 <a:latin typeface="Kanit"/>
               </a:rPr>
-              <a:t>•  ราคาหน้าฟาร์ม: ยางพารา +42% มันสำปะหลัง +61% ปาล์ม +26% ข้าว +14% รายได้จากพืชเพิ่มขึ้นทุกภาค
+              <a:t>•  ราคาหน้าฟาร์ม: ยางพารา +42% มันสำปะหลัง +64% ปาล์ม +25% ข้าว +14% รายได้จากพืชเพิ่มขึ้นทุกภาค
 •  มีสี่จังหวัดที่ลดลง — ทั้งหมดเป็นมะพร้าว และอยู่ฝั่งอ่าวไทยตะวันตก ราคามะพร้าวลดลง 68%
 •  กำไรบนกระดาษยังไม่ใช่เงินสด — ตารางถัดไปหักราคาด้วยต้นทุน</a:t>
             </a:r>
@@ -46713,7 +46387,7 @@
                           </a:solidFill>
                           <a:latin typeface="Kanit"/>
                         </a:rPr>
-                        <a:t>+16.1%</a:t>
+                        <a:t>+16.7%</a:t>
                       </a:r>
                     </a:p>
                   </a:txBody>
@@ -46876,7 +46550,7 @@
                           </a:solidFill>
                           <a:latin typeface="Kanit"/>
                         </a:rPr>
-                        <a:t>+20.5%</a:t>
+                        <a:t>+21.1%</a:t>
                       </a:r>
                     </a:p>
                   </a:txBody>
@@ -47039,7 +46713,7 @@
                           </a:solidFill>
                           <a:latin typeface="Kanit"/>
                         </a:rPr>
-                        <a:t>+10.5%</a:t>
+                        <a:t>+10.9%</a:t>
                       </a:r>
                     </a:p>
                   </a:txBody>
@@ -47202,7 +46876,7 @@
                           </a:solidFill>
                           <a:latin typeface="Kanit"/>
                         </a:rPr>
-                        <a:t>+34.4%</a:t>
+                        <a:t>+34.5%</a:t>
                       </a:r>
                     </a:p>
                   </a:txBody>
@@ -47365,7 +47039,7 @@
                           </a:solidFill>
                           <a:latin typeface="Kanit"/>
                         </a:rPr>
-                        <a:t>+16.3%</a:t>
+                        <a:t>+16.8%</a:t>
                       </a:r>
                     </a:p>
                   </a:txBody>
@@ -47528,7 +47202,7 @@
                           </a:solidFill>
                           <a:latin typeface="Kanit"/>
                         </a:rPr>
-                        <a:t>+15.1%</a:t>
+                        <a:t>+15.5%</a:t>
                       </a:r>
                     </a:p>
                   </a:txBody>
@@ -48350,7 +48024,7 @@
                 </a:solidFill>
                 <a:latin typeface="Kanit"/>
               </a:rPr>
-              <a:t>เทียบปีก่อน −68.4%</a:t>
+              <a:t>เทียบปีก่อน −67.8%</a:t>
             </a:r>
           </a:p>
         </p:txBody>
@@ -48908,6 +48582,324 @@
                 </a:solidFill>
                 <a:latin typeface="Kanit"/>
               </a:rPr>
+              <a:t>ไข่ไก่</a:t>
+            </a:r>
+          </a:p>
+        </p:txBody>
+      </p:sp>
+      <p:sp>
+        <p:nvSpPr>
+          <p:cNvPr id="30" name="TextBox 29"/>
+          <p:cNvSpPr txBox="1"/>
+          <p:nvPr/>
+        </p:nvSpPr>
+        <p:spPr>
+          <a:xfrm>
+            <a:off x="5016398" y="2112263"/>
+            <a:ext cx="2156155" cy="125730"/>
+          </a:xfrm>
+          <a:prstGeom prst="rect">
+            <a:avLst/>
+          </a:prstGeom>
+          <a:noFill/>
+        </p:spPr>
+        <p:txBody>
+          <a:bodyPr wrap="square" lIns="0" rIns="0" tIns="0" bIns="0" anchor="t">
+            <a:noAutofit/>
+          </a:bodyPr>
+          <a:lstStyle/>
+          <a:p>
+            <a:pPr algn="l">
+              <a:lnSpc>
+                <a:spcPts val="990"/>
+              </a:lnSpc>
+            </a:pPr>
+            <a:r>
+              <a:rPr sz="750" b="0">
+                <a:solidFill>
+                  <a:srgbClr val="606060"/>
+                </a:solidFill>
+                <a:latin typeface="Kanit"/>
+              </a:rPr>
+              <a:t>฿338.24 /ร้อยฟอง · กลาง·ตอ.</a:t>
+            </a:r>
+          </a:p>
+        </p:txBody>
+      </p:sp>
+      <p:sp>
+        <p:nvSpPr>
+          <p:cNvPr id="31" name="TextBox 30"/>
+          <p:cNvSpPr txBox="1"/>
+          <p:nvPr/>
+        </p:nvSpPr>
+        <p:spPr>
+          <a:xfrm>
+            <a:off x="5016398" y="2244851"/>
+            <a:ext cx="1078077" cy="134112"/>
+          </a:xfrm>
+          <a:prstGeom prst="rect">
+            <a:avLst/>
+          </a:prstGeom>
+          <a:noFill/>
+        </p:spPr>
+        <p:txBody>
+          <a:bodyPr wrap="square" lIns="0" rIns="0" tIns="0" bIns="0" anchor="t">
+            <a:noAutofit/>
+          </a:bodyPr>
+          <a:lstStyle/>
+          <a:p>
+            <a:pPr algn="l">
+              <a:lnSpc>
+                <a:spcPts val="1056"/>
+              </a:lnSpc>
+            </a:pPr>
+            <a:r>
+              <a:rPr sz="800" b="1">
+                <a:solidFill>
+                  <a:srgbClr val="15795F"/>
+                </a:solidFill>
+                <a:latin typeface="Kanit"/>
+              </a:rPr>
+              <a:t>เทียบปีก่อน +0.3%</a:t>
+            </a:r>
+          </a:p>
+        </p:txBody>
+      </p:sp>
+      <p:sp>
+        <p:nvSpPr>
+          <p:cNvPr id="32" name="TextBox 31"/>
+          <p:cNvSpPr txBox="1"/>
+          <p:nvPr/>
+        </p:nvSpPr>
+        <p:spPr>
+          <a:xfrm>
+            <a:off x="6094475" y="2244851"/>
+            <a:ext cx="1078077" cy="134112"/>
+          </a:xfrm>
+          <a:prstGeom prst="rect">
+            <a:avLst/>
+          </a:prstGeom>
+          <a:noFill/>
+        </p:spPr>
+        <p:txBody>
+          <a:bodyPr wrap="square" lIns="0" rIns="0" tIns="0" bIns="0" anchor="t">
+            <a:noAutofit/>
+          </a:bodyPr>
+          <a:lstStyle/>
+          <a:p>
+            <a:pPr algn="l">
+              <a:lnSpc>
+                <a:spcPts val="1056"/>
+              </a:lnSpc>
+            </a:pPr>
+            <a:r>
+              <a:rPr sz="800" b="1">
+                <a:solidFill>
+                  <a:srgbClr val="15795F"/>
+                </a:solidFill>
+                <a:latin typeface="Kanit"/>
+              </a:rPr>
+              <a:t>6 เดือน +5.0%</a:t>
+            </a:r>
+          </a:p>
+        </p:txBody>
+      </p:sp>
+      <p:sp>
+        <p:nvSpPr>
+          <p:cNvPr id="33" name="Rectangle 32"/>
+          <p:cNvSpPr/>
+          <p:nvPr/>
+        </p:nvSpPr>
+        <p:spPr>
+          <a:xfrm>
+            <a:off x="5016398" y="2400300"/>
+            <a:ext cx="2156155" cy="548640"/>
+          </a:xfrm>
+          <a:prstGeom prst="rect">
+            <a:avLst/>
+          </a:prstGeom>
+          <a:solidFill>
+            <a:srgbClr val="FBFCFE"/>
+          </a:solidFill>
+          <a:ln w="9525">
+            <a:solidFill>
+              <a:srgbClr val="D9DEE9"/>
+            </a:solidFill>
+          </a:ln>
+          <a:effectLst/>
+        </p:spPr>
+        <p:style>
+          <a:lnRef idx="1">
+            <a:schemeClr val="accent1"/>
+          </a:lnRef>
+          <a:fillRef idx="3">
+            <a:schemeClr val="accent1"/>
+          </a:fillRef>
+          <a:effectRef idx="2">
+            <a:schemeClr val="accent1"/>
+          </a:effectRef>
+          <a:fontRef idx="minor">
+            <a:schemeClr val="lt1"/>
+          </a:fontRef>
+        </p:style>
+        <p:txBody>
+          <a:bodyPr rtlCol="0" anchor="ctr" wrap="none"/>
+          <a:lstStyle/>
+          <a:p>
+            <a:pPr algn="ctr"/>
+          </a:p>
+        </p:txBody>
+      </p:sp>
+      <p:sp>
+        <p:nvSpPr>
+          <p:cNvPr id="34" name="Freeform 33"/>
+          <p:cNvSpPr/>
+          <p:nvPr/>
+        </p:nvSpPr>
+        <p:spPr>
+          <a:xfrm>
+            <a:off x="5062118" y="2446020"/>
+            <a:ext cx="2064715" cy="457200"/>
+          </a:xfrm>
+          <a:custGeom>
+            <a:avLst/>
+            <a:gdLst/>
+            <a:ahLst/>
+            <a:cxnLst/>
+            <a:rect l="l" t="t" r="r" b="b"/>
+            <a:pathLst>
+              <a:path w="2064715" h="457200">
+                <a:moveTo>
+                  <a:pt x="0" y="457200"/>
+                </a:moveTo>
+                <a:lnTo>
+                  <a:pt x="412943" y="391702"/>
+                </a:lnTo>
+                <a:lnTo>
+                  <a:pt x="825886" y="105409"/>
+                </a:lnTo>
+                <a:lnTo>
+                  <a:pt x="1238829" y="105409"/>
+                </a:lnTo>
+                <a:lnTo>
+                  <a:pt x="1651772" y="214144"/>
+                </a:lnTo>
+                <a:lnTo>
+                  <a:pt x="2064715" y="0"/>
+                </a:lnTo>
+              </a:path>
+            </a:pathLst>
+          </a:custGeom>
+          <a:noFill/>
+          <a:ln w="20320">
+            <a:solidFill>
+              <a:srgbClr val="15795F"/>
+            </a:solidFill>
+          </a:ln>
+          <a:effectLst/>
+        </p:spPr>
+        <p:style>
+          <a:lnRef idx="1">
+            <a:schemeClr val="accent1"/>
+          </a:lnRef>
+          <a:fillRef idx="3">
+            <a:schemeClr val="accent1"/>
+          </a:fillRef>
+          <a:effectRef idx="2">
+            <a:schemeClr val="accent1"/>
+          </a:effectRef>
+          <a:fontRef idx="minor">
+            <a:schemeClr val="lt1"/>
+          </a:fontRef>
+        </p:style>
+        <p:txBody>
+          <a:bodyPr rtlCol="0" anchor="ctr"/>
+          <a:lstStyle/>
+          <a:p>
+            <a:pPr algn="ctr"/>
+          </a:p>
+        </p:txBody>
+      </p:sp>
+      <p:sp>
+        <p:nvSpPr>
+          <p:cNvPr id="35" name="Rounded Rectangle 34"/>
+          <p:cNvSpPr/>
+          <p:nvPr/>
+        </p:nvSpPr>
+        <p:spPr>
+          <a:xfrm>
+            <a:off x="7085685" y="2404872"/>
+            <a:ext cx="82296" cy="82296"/>
+          </a:xfrm>
+          <a:prstGeom prst="roundRect">
+            <a:avLst>
+              <a:gd name="adj" fmla="val 50000"/>
+            </a:avLst>
+          </a:prstGeom>
+          <a:solidFill>
+            <a:srgbClr val="15795F"/>
+          </a:solidFill>
+          <a:ln>
+            <a:noFill/>
+          </a:ln>
+          <a:effectLst/>
+        </p:spPr>
+        <p:style>
+          <a:lnRef idx="1">
+            <a:schemeClr val="accent1"/>
+          </a:lnRef>
+          <a:fillRef idx="3">
+            <a:schemeClr val="accent1"/>
+          </a:fillRef>
+          <a:effectRef idx="2">
+            <a:schemeClr val="accent1"/>
+          </a:effectRef>
+          <a:fontRef idx="minor">
+            <a:schemeClr val="lt1"/>
+          </a:fontRef>
+        </p:style>
+        <p:txBody>
+          <a:bodyPr rtlCol="0" anchor="ctr" wrap="none"/>
+          <a:lstStyle/>
+          <a:p>
+            <a:pPr algn="ctr"/>
+          </a:p>
+        </p:txBody>
+      </p:sp>
+      <p:sp>
+        <p:nvSpPr>
+          <p:cNvPr id="36" name="TextBox 35"/>
+          <p:cNvSpPr txBox="1"/>
+          <p:nvPr/>
+        </p:nvSpPr>
+        <p:spPr>
+          <a:xfrm>
+            <a:off x="7318857" y="1970531"/>
+            <a:ext cx="2156155" cy="150876"/>
+          </a:xfrm>
+          <a:prstGeom prst="rect">
+            <a:avLst/>
+          </a:prstGeom>
+          <a:noFill/>
+        </p:spPr>
+        <p:txBody>
+          <a:bodyPr wrap="square" lIns="0" rIns="0" tIns="0" bIns="0" anchor="t">
+            <a:noAutofit/>
+          </a:bodyPr>
+          <a:lstStyle/>
+          <a:p>
+            <a:pPr algn="l">
+              <a:lnSpc>
+                <a:spcPts val="1188"/>
+              </a:lnSpc>
+            </a:pPr>
+            <a:r>
+              <a:rPr sz="900" b="1">
+                <a:solidFill>
+                  <a:srgbClr val="1E2F5C"/>
+                </a:solidFill>
+                <a:latin typeface="Kanit"/>
+              </a:rPr>
               <a:t>สุกร</a:t>
             </a:r>
           </a:p>
@@ -48915,13 +48907,13 @@
       </p:sp>
       <p:sp>
         <p:nvSpPr>
-          <p:cNvPr id="30" name="TextBox 29"/>
+          <p:cNvPr id="37" name="TextBox 36"/>
           <p:cNvSpPr txBox="1"/>
           <p:nvPr/>
         </p:nvSpPr>
         <p:spPr>
           <a:xfrm>
-            <a:off x="5016398" y="2112263"/>
+            <a:off x="7318857" y="2112263"/>
             <a:ext cx="2156155" cy="125730"/>
           </a:xfrm>
           <a:prstGeom prst="rect">
@@ -48954,13 +48946,13 @@
       </p:sp>
       <p:sp>
         <p:nvSpPr>
-          <p:cNvPr id="31" name="TextBox 30"/>
+          <p:cNvPr id="38" name="TextBox 37"/>
           <p:cNvSpPr txBox="1"/>
           <p:nvPr/>
         </p:nvSpPr>
         <p:spPr>
           <a:xfrm>
-            <a:off x="5016398" y="2244851"/>
+            <a:off x="7318857" y="2244851"/>
             <a:ext cx="1078077" cy="134112"/>
           </a:xfrm>
           <a:prstGeom prst="rect">
@@ -48982,24 +48974,24 @@
             <a:r>
               <a:rPr sz="800" b="1">
                 <a:solidFill>
-                  <a:srgbClr val="CC0000"/>
+                  <a:srgbClr val="15795F"/>
                 </a:solidFill>
                 <a:latin typeface="Kanit"/>
               </a:rPr>
-              <a:t>เทียบปีก่อน −1.2%</a:t>
+              <a:t>เทียบปีก่อน +0.3%</a:t>
             </a:r>
           </a:p>
         </p:txBody>
       </p:sp>
       <p:sp>
         <p:nvSpPr>
-          <p:cNvPr id="32" name="TextBox 31"/>
+          <p:cNvPr id="39" name="TextBox 38"/>
           <p:cNvSpPr txBox="1"/>
           <p:nvPr/>
         </p:nvSpPr>
         <p:spPr>
           <a:xfrm>
-            <a:off x="6094475" y="2244851"/>
+            <a:off x="8396935" y="2244851"/>
             <a:ext cx="1078077" cy="134112"/>
           </a:xfrm>
           <a:prstGeom prst="rect">
@@ -49032,13 +49024,13 @@
       </p:sp>
       <p:sp>
         <p:nvSpPr>
-          <p:cNvPr id="33" name="Rectangle 32"/>
+          <p:cNvPr id="40" name="Rectangle 39"/>
           <p:cNvSpPr/>
           <p:nvPr/>
         </p:nvSpPr>
         <p:spPr>
           <a:xfrm>
-            <a:off x="5016398" y="2400300"/>
+            <a:off x="7318857" y="2400300"/>
             <a:ext cx="2156155" cy="548640"/>
           </a:xfrm>
           <a:prstGeom prst="rect">
@@ -49078,13 +49070,13 @@
       </p:sp>
       <p:sp>
         <p:nvSpPr>
-          <p:cNvPr id="34" name="Freeform 33"/>
+          <p:cNvPr id="41" name="Freeform 40"/>
           <p:cNvSpPr/>
           <p:nvPr/>
         </p:nvSpPr>
         <p:spPr>
           <a:xfrm>
-            <a:off x="5062118" y="2446020"/>
+            <a:off x="7364577" y="2446020"/>
             <a:ext cx="2064715" cy="457200"/>
           </a:xfrm>
           <a:custGeom>
@@ -49148,13 +49140,13 @@
       </p:sp>
       <p:sp>
         <p:nvSpPr>
-          <p:cNvPr id="35" name="Rounded Rectangle 34"/>
+          <p:cNvPr id="42" name="Rounded Rectangle 41"/>
           <p:cNvSpPr/>
           <p:nvPr/>
         </p:nvSpPr>
         <p:spPr>
           <a:xfrm>
-            <a:off x="7085685" y="2457891"/>
+            <a:off x="9388144" y="2457891"/>
             <a:ext cx="82296" cy="82296"/>
           </a:xfrm>
           <a:prstGeom prst="roundRect">
@@ -49194,13 +49186,13 @@
       </p:sp>
       <p:sp>
         <p:nvSpPr>
-          <p:cNvPr id="36" name="TextBox 35"/>
+          <p:cNvPr id="43" name="TextBox 42"/>
           <p:cNvSpPr txBox="1"/>
           <p:nvPr/>
         </p:nvSpPr>
         <p:spPr>
           <a:xfrm>
-            <a:off x="7318857" y="1970531"/>
+            <a:off x="9621316" y="1970531"/>
             <a:ext cx="2156155" cy="150876"/>
           </a:xfrm>
           <a:prstGeom prst="rect">
@@ -49233,13 +49225,13 @@
       </p:sp>
       <p:sp>
         <p:nvSpPr>
-          <p:cNvPr id="37" name="TextBox 36"/>
+          <p:cNvPr id="44" name="TextBox 43"/>
           <p:cNvSpPr txBox="1"/>
           <p:nvPr/>
         </p:nvSpPr>
         <p:spPr>
           <a:xfrm>
-            <a:off x="7318857" y="2112263"/>
+            <a:off x="9621316" y="2112263"/>
             <a:ext cx="2156155" cy="125730"/>
           </a:xfrm>
           <a:prstGeom prst="rect">
@@ -49272,13 +49264,13 @@
       </p:sp>
       <p:sp>
         <p:nvSpPr>
-          <p:cNvPr id="38" name="TextBox 37"/>
+          <p:cNvPr id="45" name="TextBox 44"/>
           <p:cNvSpPr txBox="1"/>
           <p:nvPr/>
         </p:nvSpPr>
         <p:spPr>
           <a:xfrm>
-            <a:off x="7318857" y="2244851"/>
+            <a:off x="9621316" y="2244851"/>
             <a:ext cx="1078077" cy="134112"/>
           </a:xfrm>
           <a:prstGeom prst="rect">
@@ -49300,24 +49292,24 @@
             <a:r>
               <a:rPr sz="800" b="1">
                 <a:solidFill>
-                  <a:srgbClr val="CC0000"/>
+                  <a:srgbClr val="15795F"/>
                 </a:solidFill>
                 <a:latin typeface="Kanit"/>
               </a:rPr>
-              <a:t>เทียบปีก่อน −0.4%</a:t>
+              <a:t>เทียบปีก่อน +0.6%</a:t>
             </a:r>
           </a:p>
         </p:txBody>
       </p:sp>
       <p:sp>
         <p:nvSpPr>
-          <p:cNvPr id="39" name="TextBox 38"/>
+          <p:cNvPr id="46" name="TextBox 45"/>
           <p:cNvSpPr txBox="1"/>
           <p:nvPr/>
         </p:nvSpPr>
         <p:spPr>
           <a:xfrm>
-            <a:off x="8396935" y="2244851"/>
+            <a:off x="10699394" y="2244851"/>
             <a:ext cx="1078077" cy="134112"/>
           </a:xfrm>
           <a:prstGeom prst="rect">
@@ -49350,13 +49342,13 @@
       </p:sp>
       <p:sp>
         <p:nvSpPr>
-          <p:cNvPr id="40" name="Rectangle 39"/>
+          <p:cNvPr id="47" name="Rectangle 46"/>
           <p:cNvSpPr/>
           <p:nvPr/>
         </p:nvSpPr>
         <p:spPr>
           <a:xfrm>
-            <a:off x="7318857" y="2400300"/>
+            <a:off x="9621316" y="2400300"/>
             <a:ext cx="2156155" cy="548640"/>
           </a:xfrm>
           <a:prstGeom prst="rect">
@@ -49396,13 +49388,13 @@
       </p:sp>
       <p:sp>
         <p:nvSpPr>
-          <p:cNvPr id="41" name="Freeform 40"/>
+          <p:cNvPr id="48" name="Freeform 47"/>
           <p:cNvSpPr/>
           <p:nvPr/>
         </p:nvSpPr>
         <p:spPr>
           <a:xfrm>
-            <a:off x="7364577" y="2446020"/>
+            <a:off x="9667036" y="2446020"/>
             <a:ext cx="2064715" cy="457200"/>
           </a:xfrm>
           <a:custGeom>
@@ -49466,13 +49458,13 @@
       </p:sp>
       <p:sp>
         <p:nvSpPr>
-          <p:cNvPr id="42" name="Rounded Rectangle 41"/>
+          <p:cNvPr id="49" name="Rounded Rectangle 48"/>
           <p:cNvSpPr/>
           <p:nvPr/>
         </p:nvSpPr>
         <p:spPr>
           <a:xfrm>
-            <a:off x="9388144" y="2628007"/>
+            <a:off x="11690603" y="2628007"/>
             <a:ext cx="82296" cy="82296"/>
           </a:xfrm>
           <a:prstGeom prst="roundRect">
@@ -49482,324 +49474,6 @@
           </a:prstGeom>
           <a:solidFill>
             <a:srgbClr val="CC0000"/>
-          </a:solidFill>
-          <a:ln>
-            <a:noFill/>
-          </a:ln>
-          <a:effectLst/>
-        </p:spPr>
-        <p:style>
-          <a:lnRef idx="1">
-            <a:schemeClr val="accent1"/>
-          </a:lnRef>
-          <a:fillRef idx="3">
-            <a:schemeClr val="accent1"/>
-          </a:fillRef>
-          <a:effectRef idx="2">
-            <a:schemeClr val="accent1"/>
-          </a:effectRef>
-          <a:fontRef idx="minor">
-            <a:schemeClr val="lt1"/>
-          </a:fontRef>
-        </p:style>
-        <p:txBody>
-          <a:bodyPr rtlCol="0" anchor="ctr" wrap="none"/>
-          <a:lstStyle/>
-          <a:p>
-            <a:pPr algn="ctr"/>
-          </a:p>
-        </p:txBody>
-      </p:sp>
-      <p:sp>
-        <p:nvSpPr>
-          <p:cNvPr id="43" name="TextBox 42"/>
-          <p:cNvSpPr txBox="1"/>
-          <p:nvPr/>
-        </p:nvSpPr>
-        <p:spPr>
-          <a:xfrm>
-            <a:off x="9621316" y="1970531"/>
-            <a:ext cx="2156155" cy="150876"/>
-          </a:xfrm>
-          <a:prstGeom prst="rect">
-            <a:avLst/>
-          </a:prstGeom>
-          <a:noFill/>
-        </p:spPr>
-        <p:txBody>
-          <a:bodyPr wrap="square" lIns="0" rIns="0" tIns="0" bIns="0" anchor="t">
-            <a:noAutofit/>
-          </a:bodyPr>
-          <a:lstStyle/>
-          <a:p>
-            <a:pPr algn="l">
-              <a:lnSpc>
-                <a:spcPts val="1188"/>
-              </a:lnSpc>
-            </a:pPr>
-            <a:r>
-              <a:rPr sz="900" b="1">
-                <a:solidFill>
-                  <a:srgbClr val="1E2F5C"/>
-                </a:solidFill>
-                <a:latin typeface="Kanit"/>
-              </a:rPr>
-              <a:t>ไข่ไก่</a:t>
-            </a:r>
-          </a:p>
-        </p:txBody>
-      </p:sp>
-      <p:sp>
-        <p:nvSpPr>
-          <p:cNvPr id="44" name="TextBox 43"/>
-          <p:cNvSpPr txBox="1"/>
-          <p:nvPr/>
-        </p:nvSpPr>
-        <p:spPr>
-          <a:xfrm>
-            <a:off x="9621316" y="2112263"/>
-            <a:ext cx="2156155" cy="125730"/>
-          </a:xfrm>
-          <a:prstGeom prst="rect">
-            <a:avLst/>
-          </a:prstGeom>
-          <a:noFill/>
-        </p:spPr>
-        <p:txBody>
-          <a:bodyPr wrap="square" lIns="0" rIns="0" tIns="0" bIns="0" anchor="t">
-            <a:noAutofit/>
-          </a:bodyPr>
-          <a:lstStyle/>
-          <a:p>
-            <a:pPr algn="l">
-              <a:lnSpc>
-                <a:spcPts val="990"/>
-              </a:lnSpc>
-            </a:pPr>
-            <a:r>
-              <a:rPr sz="750" b="0">
-                <a:solidFill>
-                  <a:srgbClr val="606060"/>
-                </a:solidFill>
-                <a:latin typeface="Kanit"/>
-              </a:rPr>
-              <a:t>฿338.24 /ร้อยฟอง · กลาง·ตอ.</a:t>
-            </a:r>
-          </a:p>
-        </p:txBody>
-      </p:sp>
-      <p:sp>
-        <p:nvSpPr>
-          <p:cNvPr id="45" name="TextBox 44"/>
-          <p:cNvSpPr txBox="1"/>
-          <p:nvPr/>
-        </p:nvSpPr>
-        <p:spPr>
-          <a:xfrm>
-            <a:off x="9621316" y="2244851"/>
-            <a:ext cx="1078077" cy="134112"/>
-          </a:xfrm>
-          <a:prstGeom prst="rect">
-            <a:avLst/>
-          </a:prstGeom>
-          <a:noFill/>
-        </p:spPr>
-        <p:txBody>
-          <a:bodyPr wrap="square" lIns="0" rIns="0" tIns="0" bIns="0" anchor="t">
-            <a:noAutofit/>
-          </a:bodyPr>
-          <a:lstStyle/>
-          <a:p>
-            <a:pPr algn="l">
-              <a:lnSpc>
-                <a:spcPts val="1056"/>
-              </a:lnSpc>
-            </a:pPr>
-            <a:r>
-              <a:rPr sz="800" b="1">
-                <a:solidFill>
-                  <a:srgbClr val="606060"/>
-                </a:solidFill>
-                <a:latin typeface="Kanit"/>
-              </a:rPr>
-              <a:t>เทียบปีก่อน +0.0%</a:t>
-            </a:r>
-          </a:p>
-        </p:txBody>
-      </p:sp>
-      <p:sp>
-        <p:nvSpPr>
-          <p:cNvPr id="46" name="TextBox 45"/>
-          <p:cNvSpPr txBox="1"/>
-          <p:nvPr/>
-        </p:nvSpPr>
-        <p:spPr>
-          <a:xfrm>
-            <a:off x="10699394" y="2244851"/>
-            <a:ext cx="1078077" cy="134112"/>
-          </a:xfrm>
-          <a:prstGeom prst="rect">
-            <a:avLst/>
-          </a:prstGeom>
-          <a:noFill/>
-        </p:spPr>
-        <p:txBody>
-          <a:bodyPr wrap="square" lIns="0" rIns="0" tIns="0" bIns="0" anchor="t">
-            <a:noAutofit/>
-          </a:bodyPr>
-          <a:lstStyle/>
-          <a:p>
-            <a:pPr algn="l">
-              <a:lnSpc>
-                <a:spcPts val="1056"/>
-              </a:lnSpc>
-            </a:pPr>
-            <a:r>
-              <a:rPr sz="800" b="1">
-                <a:solidFill>
-                  <a:srgbClr val="15795F"/>
-                </a:solidFill>
-                <a:latin typeface="Kanit"/>
-              </a:rPr>
-              <a:t>6 เดือน +5.0%</a:t>
-            </a:r>
-          </a:p>
-        </p:txBody>
-      </p:sp>
-      <p:sp>
-        <p:nvSpPr>
-          <p:cNvPr id="47" name="Rectangle 46"/>
-          <p:cNvSpPr/>
-          <p:nvPr/>
-        </p:nvSpPr>
-        <p:spPr>
-          <a:xfrm>
-            <a:off x="9621316" y="2400300"/>
-            <a:ext cx="2156155" cy="548640"/>
-          </a:xfrm>
-          <a:prstGeom prst="rect">
-            <a:avLst/>
-          </a:prstGeom>
-          <a:solidFill>
-            <a:srgbClr val="FBFCFE"/>
-          </a:solidFill>
-          <a:ln w="9525">
-            <a:solidFill>
-              <a:srgbClr val="D9DEE9"/>
-            </a:solidFill>
-          </a:ln>
-          <a:effectLst/>
-        </p:spPr>
-        <p:style>
-          <a:lnRef idx="1">
-            <a:schemeClr val="accent1"/>
-          </a:lnRef>
-          <a:fillRef idx="3">
-            <a:schemeClr val="accent1"/>
-          </a:fillRef>
-          <a:effectRef idx="2">
-            <a:schemeClr val="accent1"/>
-          </a:effectRef>
-          <a:fontRef idx="minor">
-            <a:schemeClr val="lt1"/>
-          </a:fontRef>
-        </p:style>
-        <p:txBody>
-          <a:bodyPr rtlCol="0" anchor="ctr" wrap="none"/>
-          <a:lstStyle/>
-          <a:p>
-            <a:pPr algn="ctr"/>
-          </a:p>
-        </p:txBody>
-      </p:sp>
-      <p:sp>
-        <p:nvSpPr>
-          <p:cNvPr id="48" name="Freeform 47"/>
-          <p:cNvSpPr/>
-          <p:nvPr/>
-        </p:nvSpPr>
-        <p:spPr>
-          <a:xfrm>
-            <a:off x="9667036" y="2446020"/>
-            <a:ext cx="2064715" cy="457200"/>
-          </a:xfrm>
-          <a:custGeom>
-            <a:avLst/>
-            <a:gdLst/>
-            <a:ahLst/>
-            <a:cxnLst/>
-            <a:rect l="l" t="t" r="r" b="b"/>
-            <a:pathLst>
-              <a:path w="2064715" h="457200">
-                <a:moveTo>
-                  <a:pt x="0" y="457200"/>
-                </a:moveTo>
-                <a:lnTo>
-                  <a:pt x="412943" y="391702"/>
-                </a:lnTo>
-                <a:lnTo>
-                  <a:pt x="825886" y="105409"/>
-                </a:lnTo>
-                <a:lnTo>
-                  <a:pt x="1238829" y="105409"/>
-                </a:lnTo>
-                <a:lnTo>
-                  <a:pt x="1651772" y="214144"/>
-                </a:lnTo>
-                <a:lnTo>
-                  <a:pt x="2064715" y="0"/>
-                </a:lnTo>
-              </a:path>
-            </a:pathLst>
-          </a:custGeom>
-          <a:noFill/>
-          <a:ln w="20320">
-            <a:solidFill>
-              <a:srgbClr val="15795F"/>
-            </a:solidFill>
-          </a:ln>
-          <a:effectLst/>
-        </p:spPr>
-        <p:style>
-          <a:lnRef idx="1">
-            <a:schemeClr val="accent1"/>
-          </a:lnRef>
-          <a:fillRef idx="3">
-            <a:schemeClr val="accent1"/>
-          </a:fillRef>
-          <a:effectRef idx="2">
-            <a:schemeClr val="accent1"/>
-          </a:effectRef>
-          <a:fontRef idx="minor">
-            <a:schemeClr val="lt1"/>
-          </a:fontRef>
-        </p:style>
-        <p:txBody>
-          <a:bodyPr rtlCol="0" anchor="ctr"/>
-          <a:lstStyle/>
-          <a:p>
-            <a:pPr algn="ctr"/>
-          </a:p>
-        </p:txBody>
-      </p:sp>
-      <p:sp>
-        <p:nvSpPr>
-          <p:cNvPr id="49" name="Rounded Rectangle 48"/>
-          <p:cNvSpPr/>
-          <p:nvPr/>
-        </p:nvSpPr>
-        <p:spPr>
-          <a:xfrm>
-            <a:off x="11690603" y="2404872"/>
-            <a:ext cx="82296" cy="82296"/>
-          </a:xfrm>
-          <a:prstGeom prst="roundRect">
-            <a:avLst>
-              <a:gd name="adj" fmla="val 50000"/>
-            </a:avLst>
-          </a:prstGeom>
-          <a:solidFill>
-            <a:srgbClr val="15795F"/>
           </a:solidFill>
           <a:ln>
             <a:noFill/>
@@ -49940,7 +49614,7 @@
                 </a:solidFill>
                 <a:latin typeface="Kanit"/>
               </a:rPr>
-              <a:t>เทียบปีก่อน +0.9%</a:t>
+              <a:t>เทียบปีก่อน +1.6%</a:t>
             </a:r>
           </a:p>
         </p:txBody>
@@ -50258,7 +49932,7 @@
                 </a:solidFill>
                 <a:latin typeface="Kanit"/>
               </a:rPr>
-              <a:t>เทียบปีก่อน +13.5%</a:t>
+              <a:t>เทียบปีก่อน +13.9%</a:t>
             </a:r>
           </a:p>
         </p:txBody>
@@ -50576,7 +50250,7 @@
                 </a:solidFill>
                 <a:latin typeface="Kanit"/>
               </a:rPr>
-              <a:t>เทียบปีก่อน +14.9%</a:t>
+              <a:t>เทียบปีก่อน +15.4%</a:t>
             </a:r>
           </a:p>
         </p:txBody>
@@ -50894,7 +50568,7 @@
                 </a:solidFill>
                 <a:latin typeface="Kanit"/>
               </a:rPr>
-              <a:t>เทียบปีก่อน +25.5%</a:t>
+              <a:t>เทียบปีก่อน +25.3%</a:t>
             </a:r>
           </a:p>
         </p:txBody>
@@ -51212,7 +50886,7 @@
                 </a:solidFill>
                 <a:latin typeface="Kanit"/>
               </a:rPr>
-              <a:t>เทียบปีก่อน +41.6%</a:t>
+              <a:t>เทียบปีก่อน +42.0%</a:t>
             </a:r>
           </a:p>
         </p:txBody>
@@ -51530,7 +51204,7 @@
                 </a:solidFill>
                 <a:latin typeface="Kanit"/>
               </a:rPr>
-              <a:t>เทียบปีก่อน +61.3%</a:t>
+              <a:t>เทียบปีก่อน +63.5%</a:t>
             </a:r>
           </a:p>
         </p:txBody>
@@ -51848,7 +51522,7 @@
                 </a:solidFill>
                 <a:latin typeface="Kanit"/>
               </a:rPr>
-              <a:t>เทียบปีก่อน +105.0%</a:t>
+              <a:t>เทียบปีก่อน +109.2%</a:t>
             </a:r>
           </a:p>
         </p:txBody>
@@ -52212,7 +51886,7 @@
                 </a:solidFill>
                 <a:latin typeface="Kanit"/>
               </a:rPr>
-              <a:t>ราคาหน้าฟาร์ม วัดจริง — ราคารายวันของ NABC เฉลี่ยเป็นรายเดือน หน่วยเป็นบาทตามที่เผยแพร่ (ไม่มีการแปลงสกุลเงิน) ราคาล่าสุด 2026-08-07, รุ่นข้อมูลย้อนหลัง 2026-08-02 ราคาหน้าฟาร์ม (ราคาที่เกษตรกรขายได้) คือเงินที่เกษตรกรได้รับเมื่อขายครั้งแรก ก่อนพ่อค้าคนกลาง โรงสี หรือค่าขนส่งจะหักส่วนแบ่ง — ไม่ใช่ดัชนีโลก และไม่ใช่ราคาในซูเปอร์มาร์เก็ต แหล่งผลิตเป็นการอ่านแบบ ประมาณการ ว่าสินค้าแต่ละชนิดผลิตที่ไหน และทับซ้อนกันได้ น้ำตาลเป็นราคาอ้อยประกาศของ สอน. ปีละหนึ่งจุด จึงไม่มีการเปลี่ยนแปลงหกเดือนให้แสดง</a:t>
+              <a:t>ราคาหน้าฟาร์ม วัดจริง — ราคารายวันของ NABC เฉลี่ยเป็นรายเดือน หน่วยเป็นบาทตามที่เผยแพร่ (ไม่มีการแปลงสกุลเงิน) ราคาล่าสุด 2026-08-11, รุ่นข้อมูลย้อนหลัง 2026-08-02 ราคาหน้าฟาร์ม (ราคาที่เกษตรกรขายได้) คือเงินที่เกษตรกรได้รับเมื่อขายครั้งแรก ก่อนพ่อค้าคนกลาง โรงสี หรือค่าขนส่งจะหักส่วนแบ่ง — ไม่ใช่ดัชนีโลก และไม่ใช่ราคาในซูเปอร์มาร์เก็ต แหล่งผลิตเป็นการอ่านแบบ ประมาณการ ว่าสินค้าแต่ละชนิดผลิตที่ไหน และทับซ้อนกันได้ น้ำตาลเป็นราคาอ้อยประกาศของ สอน. ปีละหนึ่งจุด จึงไม่มีการเปลี่ยนแปลงหกเดือนให้แสดง</a:t>
             </a:r>
           </a:p>
         </p:txBody>

</xml_diff>

<commit_message>
deck(mcom): rebuild — the data moved past the committed figures (run 31755008036)
</commit_message>
<xml_diff>
--- a/docs/decks/mcom-2026-08-05-macro-TH.pptx
+++ b/docs/decks/mcom-2026-08-05-macro-TH.pptx
@@ -6240,7 +6240,7 @@
                 </a:solidFill>
                 <a:latin typeface="Kanit"/>
               </a:rPr>
-              <a:t>156</a:t>
+              <a:t>155</a:t>
             </a:r>
           </a:p>
         </p:txBody>
@@ -6279,7 +6279,7 @@
                 </a:solidFill>
                 <a:latin typeface="Kanit"/>
               </a:rPr>
-              <a:t>จาก 794 (19.6%) · เรียลไทม์ · 2026-08-11</a:t>
+              <a:t>จาก 794 (19.5%) · เรียลไทม์ · 2026-08-11</a:t>
             </a:r>
           </a:p>
         </p:txBody>
@@ -8022,7 +8022,7 @@
                           </a:solidFill>
                           <a:latin typeface="Kanit"/>
                         </a:rPr>
-                        <a:t>นราธิวาส</a:t>
+                        <a:t>ชัยภูมิ</a:t>
                       </a:r>
                     </a:p>
                   </a:txBody>
@@ -8045,7 +8045,7 @@
                           </a:solidFill>
                           <a:latin typeface="Kanit"/>
                         </a:rPr>
-                        <a:t>64</a:t>
+                        <a:t>58</a:t>
                       </a:r>
                     </a:p>
                   </a:txBody>
@@ -8068,7 +8068,7 @@
                           </a:solidFill>
                           <a:latin typeface="Kanit"/>
                         </a:rPr>
-                        <a:t>38</a:t>
+                        <a:t>22</a:t>
                       </a:r>
                     </a:p>
                   </a:txBody>
@@ -8087,11 +8087,11 @@
                       <a:r>
                         <a:rPr sz="900" b="1">
                           <a:solidFill>
-                            <a:srgbClr val="F5C242"/>
-                          </a:solidFill>
-                          <a:latin typeface="Kanit"/>
-                        </a:rPr>
-                        <a:t>1.6%</a:t>
+                            <a:srgbClr val="606060"/>
+                          </a:solidFill>
+                          <a:latin typeface="Kanit"/>
+                        </a:rPr>
+                        <a:t>0.0%</a:t>
                       </a:r>
                     </a:p>
                   </a:txBody>
@@ -8114,7 +8114,7 @@
                           </a:solidFill>
                           <a:latin typeface="Kanit"/>
                         </a:rPr>
-                        <a:t>5/10</a:t>
+                        <a:t>1/12</a:t>
                       </a:r>
                     </a:p>
                   </a:txBody>
@@ -8162,7 +8162,7 @@
                           </a:solidFill>
                           <a:latin typeface="Kanit"/>
                         </a:rPr>
-                        <a:t>ชัยภูมิ</a:t>
+                        <a:t>นครพนม</a:t>
                       </a:r>
                     </a:p>
                   </a:txBody>
@@ -8185,7 +8185,7 @@
                           </a:solidFill>
                           <a:latin typeface="Kanit"/>
                         </a:rPr>
-                        <a:t>58</a:t>
+                        <a:t>29</a:t>
                       </a:r>
                     </a:p>
                   </a:txBody>
@@ -8208,7 +8208,7 @@
                           </a:solidFill>
                           <a:latin typeface="Kanit"/>
                         </a:rPr>
-                        <a:t>24</a:t>
+                        <a:t>14</a:t>
                       </a:r>
                     </a:p>
                   </a:txBody>
@@ -8254,7 +8254,7 @@
                           </a:solidFill>
                           <a:latin typeface="Kanit"/>
                         </a:rPr>
-                        <a:t>1/12</a:t>
+                        <a:t>9/15</a:t>
                       </a:r>
                     </a:p>
                   </a:txBody>
@@ -8302,7 +8302,7 @@
                           </a:solidFill>
                           <a:latin typeface="Kanit"/>
                         </a:rPr>
-                        <a:t>นครพนม</a:t>
+                        <a:t>นราธิวาส</a:t>
                       </a:r>
                     </a:p>
                   </a:txBody>
@@ -8325,7 +8325,7 @@
                           </a:solidFill>
                           <a:latin typeface="Kanit"/>
                         </a:rPr>
-                        <a:t>29</a:t>
+                        <a:t>64</a:t>
                       </a:r>
                     </a:p>
                   </a:txBody>
@@ -8348,7 +8348,7 @@
                           </a:solidFill>
                           <a:latin typeface="Kanit"/>
                         </a:rPr>
-                        <a:t>9</a:t>
+                        <a:t>24</a:t>
                       </a:r>
                     </a:p>
                   </a:txBody>
@@ -8394,7 +8394,7 @@
                           </a:solidFill>
                           <a:latin typeface="Kanit"/>
                         </a:rPr>
-                        <a:t>9/15</a:t>
+                        <a:t>5/10</a:t>
                       </a:r>
                     </a:p>
                   </a:txBody>
@@ -8488,7 +8488,7 @@
                           </a:solidFill>
                           <a:latin typeface="Kanit"/>
                         </a:rPr>
-                        <a:t>23</a:t>
+                        <a:t>20</a:t>
                       </a:r>
                     </a:p>
                   </a:txBody>
@@ -8605,7 +8605,7 @@
                           </a:solidFill>
                           <a:latin typeface="Kanit"/>
                         </a:rPr>
-                        <a:t>17</a:t>
+                        <a:t>18</a:t>
                       </a:r>
                     </a:p>
                   </a:txBody>
@@ -33912,7 +33912,7 @@
                 </a:solidFill>
                 <a:latin typeface="Kanit"/>
               </a:rPr>
-              <a:t>33.05</a:t>
+              <a:t>33.01</a:t>
             </a:r>
           </a:p>
         </p:txBody>
@@ -33951,7 +33951,7 @@
                 </a:solidFill>
                 <a:latin typeface="Kanit"/>
               </a:rPr>
-              <a:t>อัตราอ้างอิง ECB · 2026-08-07</a:t>
+              <a:t>อัตราอ้างอิง ECB · 2026-08-10</a:t>
             </a:r>
           </a:p>
         </p:txBody>
@@ -35798,7 +35798,7 @@
                 </a:solidFill>
                 <a:latin typeface="Kanit"/>
               </a:rPr>
-              <a:t>สศช. 2026 ไตรมาส 1 · TPSO 2026-05 · ธนาคารแห่งประเทศไทย 2026-06 · BIS 2025 ไตรมาส 4 · ECB 2026-08-07, ทั้งหมดดึงจากหน่วยงานผู้เผยแพร่โดยตรง ตารางเทียบประเทศใช้ IMF World Economic Outlook 2026 (ดึงข้อมูล 2026-07-25) อัตรา NPL ที่ ธปท. เผยแพร่ — 4.48% ณ 2026 ไตรมาส 1, จาก 4.33% ไตรมาสก่อน เปลี่ยน +0.24 จุดใน 1 ปี และต่ำสุด 3.08% ณ 2021 ไตรมาส 1</a:t>
+              <a:t>สศช. 2026 ไตรมาส 1 · TPSO 2026-05 · ธนาคารแห่งประเทศไทย 2026-06 · BIS 2025 ไตรมาส 4 · ECB 2026-08-10, ทั้งหมดดึงจากหน่วยงานผู้เผยแพร่โดยตรง ตารางเทียบประเทศใช้ IMF World Economic Outlook 2026 (ดึงข้อมูล 2026-07-25) อัตรา NPL ที่ ธปท. เผยแพร่ — 4.48% ณ 2026 ไตรมาส 1, จาก 4.33% ไตรมาสก่อน เปลี่ยน +0.24 จุดใน 1 ปี และต่ำสุด 3.08% ณ 2021 ไตรมาส 1</a:t>
             </a:r>
           </a:p>
         </p:txBody>
@@ -37087,7 +37087,7 @@
                 </a:solidFill>
                 <a:latin typeface="Kanit"/>
               </a:rPr>
-              <a:t>338 จาก 928 อำเภอ · แม่น้ำเกินระดับ 156 จาก 794 สถานี</a:t>
+              <a:t>338 จาก 928 อำเภอ · แม่น้ำเกินระดับ 155 จาก 794 สถานี</a:t>
             </a:r>
           </a:p>
         </p:txBody>
@@ -37905,7 +37905,7 @@
                           </a:solidFill>
                           <a:latin typeface="Kanit"/>
                         </a:rPr>
-                        <a:t>0.10</a:t>
+                        <a:t>0.09</a:t>
                       </a:r>
                     </a:p>
                   </a:txBody>
@@ -38091,7 +38091,7 @@
                           </a:solidFill>
                           <a:latin typeface="Kanit"/>
                         </a:rPr>
-                        <a:t>42/273</a:t>
+                        <a:t>41/273</a:t>
                       </a:r>
                     </a:p>
                   </a:txBody>
@@ -38601,7 +38601,7 @@
                           </a:solidFill>
                           <a:latin typeface="Kanit"/>
                         </a:rPr>
-                        <a:t>0.25</a:t>
+                        <a:t>0.22</a:t>
                       </a:r>
                     </a:p>
                   </a:txBody>
@@ -38833,7 +38833,7 @@
                           </a:solidFill>
                           <a:latin typeface="Kanit"/>
                         </a:rPr>
-                        <a:t>0.27</a:t>
+                        <a:t>0.26</a:t>
                       </a:r>
                     </a:p>
                   </a:txBody>
@@ -43419,7 +43419,7 @@
                           </a:solidFill>
                           <a:latin typeface="Kanit"/>
                         </a:rPr>
-                        <a:t>94.54</a:t>
+                        <a:t>94.42</a:t>
                       </a:r>
                     </a:p>
                   </a:txBody>
@@ -43559,7 +43559,7 @@
                           </a:solidFill>
                           <a:latin typeface="Kanit"/>
                         </a:rPr>
-                        <a:t>16,329</a:t>
+                        <a:t>16,308</a:t>
                       </a:r>
                     </a:p>
                   </a:txBody>
@@ -43699,7 +43699,7 @@
                           </a:solidFill>
                           <a:latin typeface="Kanit"/>
                         </a:rPr>
-                        <a:t>36,526</a:t>
+                        <a:t>36,479</a:t>
                       </a:r>
                     </a:p>
                   </a:txBody>
@@ -43839,7 +43839,7 @@
                           </a:solidFill>
                           <a:latin typeface="Kanit"/>
                         </a:rPr>
-                        <a:t>10.58</a:t>
+                        <a:t>10.56</a:t>
                       </a:r>
                     </a:p>
                   </a:txBody>
@@ -44058,7 +44058,7 @@
                 </a:solidFill>
                 <a:latin typeface="Kanit"/>
               </a:rPr>
-              <a:t>ราคารายเดือนสกุลดอลลาร์ราคาปัจจุบันจาก World Bank Pink Sheet รุ่นข้อมูล 2026M06 (ข้อมูล 60 จุดต่อรายการ ปรับฐานเป็น 100 ณ 2021-07 เพื่อวาดกราฟ — หน่วยต่างกัน จึงใช้แกนเดียวกับระดับราคาดิบไม่ได้) แปลงเป็นบาทด้วยอัตราอ้างอิง ECB USD/THB 33.055 ณ 2026-08-07 สัดส่วนพื้นที่ปลูก วัดจริง จากสัดส่วนพืชของ สศก./กรมส่งเสริมการเกษตร (crop_mix.json) เป็นราคาปัจจุบัน ไม่ได้ปรับเงินเฟ้อ: ทุกตัวเลข ‘เทียบ 5 ปีก่อน’ มีเงินเฟ้อไทยห้าปีซ่อนอยู่ข้างใต้</a:t>
+              <a:t>ราคารายเดือนสกุลดอลลาร์ราคาปัจจุบันจาก World Bank Pink Sheet รุ่นข้อมูล 2026M06 (ข้อมูล 60 จุดต่อรายการ ปรับฐานเป็น 100 ณ 2021-07 เพื่อวาดกราฟ — หน่วยต่างกัน จึงใช้แกนเดียวกับระดับราคาดิบไม่ได้) แปลงเป็นบาทด้วยอัตราอ้างอิง ECB USD/THB 33.013 ณ 2026-08-10 สัดส่วนพื้นที่ปลูก วัดจริง จากสัดส่วนพืชของ สศก./กรมส่งเสริมการเกษตร (crop_mix.json) เป็นราคาปัจจุบัน ไม่ได้ปรับเงินเฟ้อ: ทุกตัวเลข ‘เทียบ 5 ปีก่อน’ มีเงินเฟ้อไทยห้าปีซ่อนอยู่ข้างใต้</a:t>
             </a:r>
           </a:p>
         </p:txBody>

</xml_diff>

<commit_message>
deck(mcom): rebuild — the data moved past the committed figures (run 31755008036) (#395)
Co-authored-by: github-actions[bot] <41898282+github-actions[bot]@users.noreply.github.com>
</commit_message>
<xml_diff>
--- a/docs/decks/mcom-2026-08-05-macro-TH.pptx
+++ b/docs/decks/mcom-2026-08-05-macro-TH.pptx
@@ -6240,7 +6240,7 @@
                 </a:solidFill>
                 <a:latin typeface="Kanit"/>
               </a:rPr>
-              <a:t>156</a:t>
+              <a:t>155</a:t>
             </a:r>
           </a:p>
         </p:txBody>
@@ -6279,7 +6279,7 @@
                 </a:solidFill>
                 <a:latin typeface="Kanit"/>
               </a:rPr>
-              <a:t>จาก 794 (19.6%) · เรียลไทม์ · 2026-08-11</a:t>
+              <a:t>จาก 794 (19.5%) · เรียลไทม์ · 2026-08-11</a:t>
             </a:r>
           </a:p>
         </p:txBody>
@@ -8022,7 +8022,7 @@
                           </a:solidFill>
                           <a:latin typeface="Kanit"/>
                         </a:rPr>
-                        <a:t>นราธิวาส</a:t>
+                        <a:t>ชัยภูมิ</a:t>
                       </a:r>
                     </a:p>
                   </a:txBody>
@@ -8045,7 +8045,7 @@
                           </a:solidFill>
                           <a:latin typeface="Kanit"/>
                         </a:rPr>
-                        <a:t>64</a:t>
+                        <a:t>58</a:t>
                       </a:r>
                     </a:p>
                   </a:txBody>
@@ -8068,7 +8068,7 @@
                           </a:solidFill>
                           <a:latin typeface="Kanit"/>
                         </a:rPr>
-                        <a:t>38</a:t>
+                        <a:t>22</a:t>
                       </a:r>
                     </a:p>
                   </a:txBody>
@@ -8087,11 +8087,11 @@
                       <a:r>
                         <a:rPr sz="900" b="1">
                           <a:solidFill>
-                            <a:srgbClr val="F5C242"/>
-                          </a:solidFill>
-                          <a:latin typeface="Kanit"/>
-                        </a:rPr>
-                        <a:t>1.6%</a:t>
+                            <a:srgbClr val="606060"/>
+                          </a:solidFill>
+                          <a:latin typeface="Kanit"/>
+                        </a:rPr>
+                        <a:t>0.0%</a:t>
                       </a:r>
                     </a:p>
                   </a:txBody>
@@ -8114,7 +8114,7 @@
                           </a:solidFill>
                           <a:latin typeface="Kanit"/>
                         </a:rPr>
-                        <a:t>5/10</a:t>
+                        <a:t>1/12</a:t>
                       </a:r>
                     </a:p>
                   </a:txBody>
@@ -8162,7 +8162,7 @@
                           </a:solidFill>
                           <a:latin typeface="Kanit"/>
                         </a:rPr>
-                        <a:t>ชัยภูมิ</a:t>
+                        <a:t>นครพนม</a:t>
                       </a:r>
                     </a:p>
                   </a:txBody>
@@ -8185,7 +8185,7 @@
                           </a:solidFill>
                           <a:latin typeface="Kanit"/>
                         </a:rPr>
-                        <a:t>58</a:t>
+                        <a:t>29</a:t>
                       </a:r>
                     </a:p>
                   </a:txBody>
@@ -8208,7 +8208,7 @@
                           </a:solidFill>
                           <a:latin typeface="Kanit"/>
                         </a:rPr>
-                        <a:t>24</a:t>
+                        <a:t>14</a:t>
                       </a:r>
                     </a:p>
                   </a:txBody>
@@ -8254,7 +8254,7 @@
                           </a:solidFill>
                           <a:latin typeface="Kanit"/>
                         </a:rPr>
-                        <a:t>1/12</a:t>
+                        <a:t>9/15</a:t>
                       </a:r>
                     </a:p>
                   </a:txBody>
@@ -8302,7 +8302,7 @@
                           </a:solidFill>
                           <a:latin typeface="Kanit"/>
                         </a:rPr>
-                        <a:t>นครพนม</a:t>
+                        <a:t>นราธิวาส</a:t>
                       </a:r>
                     </a:p>
                   </a:txBody>
@@ -8325,7 +8325,7 @@
                           </a:solidFill>
                           <a:latin typeface="Kanit"/>
                         </a:rPr>
-                        <a:t>29</a:t>
+                        <a:t>64</a:t>
                       </a:r>
                     </a:p>
                   </a:txBody>
@@ -8348,7 +8348,7 @@
                           </a:solidFill>
                           <a:latin typeface="Kanit"/>
                         </a:rPr>
-                        <a:t>9</a:t>
+                        <a:t>24</a:t>
                       </a:r>
                     </a:p>
                   </a:txBody>
@@ -8394,7 +8394,7 @@
                           </a:solidFill>
                           <a:latin typeface="Kanit"/>
                         </a:rPr>
-                        <a:t>9/15</a:t>
+                        <a:t>5/10</a:t>
                       </a:r>
                     </a:p>
                   </a:txBody>
@@ -8488,7 +8488,7 @@
                           </a:solidFill>
                           <a:latin typeface="Kanit"/>
                         </a:rPr>
-                        <a:t>23</a:t>
+                        <a:t>20</a:t>
                       </a:r>
                     </a:p>
                   </a:txBody>
@@ -8605,7 +8605,7 @@
                           </a:solidFill>
                           <a:latin typeface="Kanit"/>
                         </a:rPr>
-                        <a:t>17</a:t>
+                        <a:t>18</a:t>
                       </a:r>
                     </a:p>
                   </a:txBody>
@@ -33912,7 +33912,7 @@
                 </a:solidFill>
                 <a:latin typeface="Kanit"/>
               </a:rPr>
-              <a:t>33.05</a:t>
+              <a:t>33.01</a:t>
             </a:r>
           </a:p>
         </p:txBody>
@@ -33951,7 +33951,7 @@
                 </a:solidFill>
                 <a:latin typeface="Kanit"/>
               </a:rPr>
-              <a:t>อัตราอ้างอิง ECB · 2026-08-07</a:t>
+              <a:t>อัตราอ้างอิง ECB · 2026-08-10</a:t>
             </a:r>
           </a:p>
         </p:txBody>
@@ -35798,7 +35798,7 @@
                 </a:solidFill>
                 <a:latin typeface="Kanit"/>
               </a:rPr>
-              <a:t>สศช. 2026 ไตรมาส 1 · TPSO 2026-05 · ธนาคารแห่งประเทศไทย 2026-06 · BIS 2025 ไตรมาส 4 · ECB 2026-08-07, ทั้งหมดดึงจากหน่วยงานผู้เผยแพร่โดยตรง ตารางเทียบประเทศใช้ IMF World Economic Outlook 2026 (ดึงข้อมูล 2026-07-25) อัตรา NPL ที่ ธปท. เผยแพร่ — 4.48% ณ 2026 ไตรมาส 1, จาก 4.33% ไตรมาสก่อน เปลี่ยน +0.24 จุดใน 1 ปี และต่ำสุด 3.08% ณ 2021 ไตรมาส 1</a:t>
+              <a:t>สศช. 2026 ไตรมาส 1 · TPSO 2026-05 · ธนาคารแห่งประเทศไทย 2026-06 · BIS 2025 ไตรมาส 4 · ECB 2026-08-10, ทั้งหมดดึงจากหน่วยงานผู้เผยแพร่โดยตรง ตารางเทียบประเทศใช้ IMF World Economic Outlook 2026 (ดึงข้อมูล 2026-07-25) อัตรา NPL ที่ ธปท. เผยแพร่ — 4.48% ณ 2026 ไตรมาส 1, จาก 4.33% ไตรมาสก่อน เปลี่ยน +0.24 จุดใน 1 ปี และต่ำสุด 3.08% ณ 2021 ไตรมาส 1</a:t>
             </a:r>
           </a:p>
         </p:txBody>
@@ -37087,7 +37087,7 @@
                 </a:solidFill>
                 <a:latin typeface="Kanit"/>
               </a:rPr>
-              <a:t>338 จาก 928 อำเภอ · แม่น้ำเกินระดับ 156 จาก 794 สถานี</a:t>
+              <a:t>338 จาก 928 อำเภอ · แม่น้ำเกินระดับ 155 จาก 794 สถานี</a:t>
             </a:r>
           </a:p>
         </p:txBody>
@@ -37905,7 +37905,7 @@
                           </a:solidFill>
                           <a:latin typeface="Kanit"/>
                         </a:rPr>
-                        <a:t>0.10</a:t>
+                        <a:t>0.09</a:t>
                       </a:r>
                     </a:p>
                   </a:txBody>
@@ -38091,7 +38091,7 @@
                           </a:solidFill>
                           <a:latin typeface="Kanit"/>
                         </a:rPr>
-                        <a:t>42/273</a:t>
+                        <a:t>41/273</a:t>
                       </a:r>
                     </a:p>
                   </a:txBody>
@@ -38601,7 +38601,7 @@
                           </a:solidFill>
                           <a:latin typeface="Kanit"/>
                         </a:rPr>
-                        <a:t>0.25</a:t>
+                        <a:t>0.22</a:t>
                       </a:r>
                     </a:p>
                   </a:txBody>
@@ -38833,7 +38833,7 @@
                           </a:solidFill>
                           <a:latin typeface="Kanit"/>
                         </a:rPr>
-                        <a:t>0.27</a:t>
+                        <a:t>0.26</a:t>
                       </a:r>
                     </a:p>
                   </a:txBody>
@@ -43419,7 +43419,7 @@
                           </a:solidFill>
                           <a:latin typeface="Kanit"/>
                         </a:rPr>
-                        <a:t>94.54</a:t>
+                        <a:t>94.42</a:t>
                       </a:r>
                     </a:p>
                   </a:txBody>
@@ -43559,7 +43559,7 @@
                           </a:solidFill>
                           <a:latin typeface="Kanit"/>
                         </a:rPr>
-                        <a:t>16,329</a:t>
+                        <a:t>16,308</a:t>
                       </a:r>
                     </a:p>
                   </a:txBody>
@@ -43699,7 +43699,7 @@
                           </a:solidFill>
                           <a:latin typeface="Kanit"/>
                         </a:rPr>
-                        <a:t>36,526</a:t>
+                        <a:t>36,479</a:t>
                       </a:r>
                     </a:p>
                   </a:txBody>
@@ -43839,7 +43839,7 @@
                           </a:solidFill>
                           <a:latin typeface="Kanit"/>
                         </a:rPr>
-                        <a:t>10.58</a:t>
+                        <a:t>10.56</a:t>
                       </a:r>
                     </a:p>
                   </a:txBody>
@@ -44058,7 +44058,7 @@
                 </a:solidFill>
                 <a:latin typeface="Kanit"/>
               </a:rPr>
-              <a:t>ราคารายเดือนสกุลดอลลาร์ราคาปัจจุบันจาก World Bank Pink Sheet รุ่นข้อมูล 2026M06 (ข้อมูล 60 จุดต่อรายการ ปรับฐานเป็น 100 ณ 2021-07 เพื่อวาดกราฟ — หน่วยต่างกัน จึงใช้แกนเดียวกับระดับราคาดิบไม่ได้) แปลงเป็นบาทด้วยอัตราอ้างอิง ECB USD/THB 33.055 ณ 2026-08-07 สัดส่วนพื้นที่ปลูก วัดจริง จากสัดส่วนพืชของ สศก./กรมส่งเสริมการเกษตร (crop_mix.json) เป็นราคาปัจจุบัน ไม่ได้ปรับเงินเฟ้อ: ทุกตัวเลข ‘เทียบ 5 ปีก่อน’ มีเงินเฟ้อไทยห้าปีซ่อนอยู่ข้างใต้</a:t>
+              <a:t>ราคารายเดือนสกุลดอลลาร์ราคาปัจจุบันจาก World Bank Pink Sheet รุ่นข้อมูล 2026M06 (ข้อมูล 60 จุดต่อรายการ ปรับฐานเป็น 100 ณ 2021-07 เพื่อวาดกราฟ — หน่วยต่างกัน จึงใช้แกนเดียวกับระดับราคาดิบไม่ได้) แปลงเป็นบาทด้วยอัตราอ้างอิง ECB USD/THB 33.013 ณ 2026-08-10 สัดส่วนพื้นที่ปลูก วัดจริง จากสัดส่วนพืชของ สศก./กรมส่งเสริมการเกษตร (crop_mix.json) เป็นราคาปัจจุบัน ไม่ได้ปรับเงินเฟ้อ: ทุกตัวเลข ‘เทียบ 5 ปีก่อน’ มีเงินเฟ้อไทยห้าปีซ่อนอยู่ข้างใต้</a:t>
             </a:r>
           </a:p>
         </p:txBody>

</xml_diff>

<commit_message>
deck(mcom): rebuild — the data moved past the committed figures (run 31825669383)
</commit_message>
<xml_diff>
--- a/docs/decks/mcom-2026-08-05-macro-TH.pptx
+++ b/docs/decks/mcom-2026-08-05-macro-TH.pptx
@@ -6240,7 +6240,7 @@
                 </a:solidFill>
                 <a:latin typeface="Kanit"/>
               </a:rPr>
-              <a:t>155</a:t>
+              <a:t>129</a:t>
             </a:r>
           </a:p>
         </p:txBody>
@@ -6279,7 +6279,7 @@
                 </a:solidFill>
                 <a:latin typeface="Kanit"/>
               </a:rPr>
-              <a:t>จาก 794 (19.5%) · เรียลไทม์ · 2026-08-11</a:t>
+              <a:t>จาก 795 (16.2%) · เรียลไทม์ · 2026-08-14</a:t>
             </a:r>
           </a:p>
         </p:txBody>
@@ -6405,7 +6405,7 @@
                 </a:solidFill>
                 <a:latin typeface="Kanit"/>
               </a:rPr>
-              <a:t>14</a:t>
+              <a:t>24</a:t>
             </a:r>
           </a:p>
         </p:txBody>
@@ -6444,7 +6444,7 @@
                 </a:solidFill>
                 <a:latin typeface="Kanit"/>
               </a:rPr>
-              <a:t>ค่าล่าสุดรายวัน · 2026-08-11</a:t>
+              <a:t>ค่าล่าสุดรายวัน · 2026-08-14</a:t>
             </a:r>
           </a:p>
         </p:txBody>
@@ -7882,7 +7882,7 @@
                           </a:solidFill>
                           <a:latin typeface="Kanit"/>
                         </a:rPr>
-                        <a:t>พะเยา</a:t>
+                        <a:t>นครพนม</a:t>
                       </a:r>
                     </a:p>
                   </a:txBody>
@@ -7905,7 +7905,7 @@
                           </a:solidFill>
                           <a:latin typeface="Kanit"/>
                         </a:rPr>
-                        <a:t>123</a:t>
+                        <a:t>28</a:t>
                       </a:r>
                     </a:p>
                   </a:txBody>
@@ -7928,7 +7928,7 @@
                           </a:solidFill>
                           <a:latin typeface="Kanit"/>
                         </a:rPr>
-                        <a:t>105</a:t>
+                        <a:t>114</a:t>
                       </a:r>
                     </a:p>
                   </a:txBody>
@@ -7951,7 +7951,7 @@
                           </a:solidFill>
                           <a:latin typeface="Kanit"/>
                         </a:rPr>
-                        <a:t>10.6%</a:t>
+                        <a:t>46.4%</a:t>
                       </a:r>
                     </a:p>
                   </a:txBody>
@@ -7974,7 +7974,7 @@
                           </a:solidFill>
                           <a:latin typeface="Kanit"/>
                         </a:rPr>
-                        <a:t>4/13</a:t>
+                        <a:t>8/15</a:t>
                       </a:r>
                     </a:p>
                   </a:txBody>
@@ -8022,7 +8022,7 @@
                           </a:solidFill>
                           <a:latin typeface="Kanit"/>
                         </a:rPr>
-                        <a:t>ชัยภูมิ</a:t>
+                        <a:t>มุกดาหาร</a:t>
                       </a:r>
                     </a:p>
                   </a:txBody>
@@ -8045,7 +8045,7 @@
                           </a:solidFill>
                           <a:latin typeface="Kanit"/>
                         </a:rPr>
-                        <a:t>58</a:t>
+                        <a:t>18</a:t>
                       </a:r>
                     </a:p>
                   </a:txBody>
@@ -8068,7 +8068,7 @@
                           </a:solidFill>
                           <a:latin typeface="Kanit"/>
                         </a:rPr>
-                        <a:t>22</a:t>
+                        <a:t>51</a:t>
                       </a:r>
                     </a:p>
                   </a:txBody>
@@ -8087,11 +8087,11 @@
                       <a:r>
                         <a:rPr sz="900" b="1">
                           <a:solidFill>
-                            <a:srgbClr val="606060"/>
-                          </a:solidFill>
-                          <a:latin typeface="Kanit"/>
-                        </a:rPr>
-                        <a:t>0.0%</a:t>
+                            <a:srgbClr val="F5C242"/>
+                          </a:solidFill>
+                          <a:latin typeface="Kanit"/>
+                        </a:rPr>
+                        <a:t>5.6%</a:t>
                       </a:r>
                     </a:p>
                   </a:txBody>
@@ -8114,7 +8114,7 @@
                           </a:solidFill>
                           <a:latin typeface="Kanit"/>
                         </a:rPr>
-                        <a:t>1/12</a:t>
+                        <a:t>2/2</a:t>
                       </a:r>
                     </a:p>
                   </a:txBody>
@@ -8162,7 +8162,7 @@
                           </a:solidFill>
                           <a:latin typeface="Kanit"/>
                         </a:rPr>
-                        <a:t>นครพนม</a:t>
+                        <a:t>สกลนคร</a:t>
                       </a:r>
                     </a:p>
                   </a:txBody>
@@ -8185,6 +8185,29 @@
                           </a:solidFill>
                           <a:latin typeface="Kanit"/>
                         </a:rPr>
+                        <a:t>36</a:t>
+                      </a:r>
+                    </a:p>
+                  </a:txBody>
+                  <a:tcPr marL="54864" marR="54864" marT="18288" marB="18288" anchor="ctr">
+                    <a:solidFill>
+                      <a:srgbClr val="FFFFFF"/>
+                    </a:solidFill>
+                  </a:tcPr>
+                </a:tc>
+                <a:tc>
+                  <a:txBody>
+                    <a:bodyPr wrap="square"/>
+                    <a:lstStyle/>
+                    <a:p>
+                      <a:pPr algn="r"/>
+                      <a:r>
+                        <a:rPr sz="900" b="0">
+                          <a:solidFill>
+                            <a:srgbClr val="1E2F5C"/>
+                          </a:solidFill>
+                          <a:latin typeface="Kanit"/>
+                        </a:rPr>
                         <a:t>29</a:t>
                       </a:r>
                     </a:p>
@@ -8202,13 +8225,13 @@
                     <a:p>
                       <a:pPr algn="r"/>
                       <a:r>
-                        <a:rPr sz="900" b="0">
-                          <a:solidFill>
-                            <a:srgbClr val="1E2F5C"/>
-                          </a:solidFill>
-                          <a:latin typeface="Kanit"/>
-                        </a:rPr>
-                        <a:t>14</a:t>
+                        <a:rPr sz="900" b="1">
+                          <a:solidFill>
+                            <a:srgbClr val="606060"/>
+                          </a:solidFill>
+                          <a:latin typeface="Kanit"/>
+                        </a:rPr>
+                        <a:t>0.0%</a:t>
                       </a:r>
                     </a:p>
                   </a:txBody>
@@ -8227,34 +8250,11 @@
                       <a:r>
                         <a:rPr sz="900" b="1">
                           <a:solidFill>
-                            <a:srgbClr val="606060"/>
-                          </a:solidFill>
-                          <a:latin typeface="Kanit"/>
-                        </a:rPr>
-                        <a:t>0.0%</a:t>
-                      </a:r>
-                    </a:p>
-                  </a:txBody>
-                  <a:tcPr marL="54864" marR="54864" marT="18288" marB="18288" anchor="ctr">
-                    <a:solidFill>
-                      <a:srgbClr val="FFFFFF"/>
-                    </a:solidFill>
-                  </a:tcPr>
-                </a:tc>
-                <a:tc>
-                  <a:txBody>
-                    <a:bodyPr wrap="square"/>
-                    <a:lstStyle/>
-                    <a:p>
-                      <a:pPr algn="r"/>
-                      <a:r>
-                        <a:rPr sz="900" b="1">
-                          <a:solidFill>
                             <a:srgbClr val="CC0000"/>
                           </a:solidFill>
                           <a:latin typeface="Kanit"/>
                         </a:rPr>
-                        <a:t>9/15</a:t>
+                        <a:t>7/13</a:t>
                       </a:r>
                     </a:p>
                   </a:txBody>
@@ -8302,7 +8302,7 @@
                           </a:solidFill>
                           <a:latin typeface="Kanit"/>
                         </a:rPr>
-                        <a:t>นราธิวาส</a:t>
+                        <a:t>สมุทรปราการ</a:t>
                       </a:r>
                     </a:p>
                   </a:txBody>
@@ -8325,7 +8325,7 @@
                           </a:solidFill>
                           <a:latin typeface="Kanit"/>
                         </a:rPr>
-                        <a:t>64</a:t>
+                        <a:t>16</a:t>
                       </a:r>
                     </a:p>
                   </a:txBody>
@@ -8348,7 +8348,7 @@
                           </a:solidFill>
                           <a:latin typeface="Kanit"/>
                         </a:rPr>
-                        <a:t>24</a:t>
+                        <a:t>0</a:t>
                       </a:r>
                     </a:p>
                   </a:txBody>
@@ -8394,7 +8394,7 @@
                           </a:solidFill>
                           <a:latin typeface="Kanit"/>
                         </a:rPr>
-                        <a:t>5/10</a:t>
+                        <a:t>4/5</a:t>
                       </a:r>
                     </a:p>
                   </a:txBody>
@@ -8442,7 +8442,7 @@
                           </a:solidFill>
                           <a:latin typeface="Kanit"/>
                         </a:rPr>
-                        <a:t>บึงกาฬ</a:t>
+                        <a:t>เลย</a:t>
                       </a:r>
                     </a:p>
                   </a:txBody>
@@ -8465,7 +8465,7 @@
                           </a:solidFill>
                           <a:latin typeface="Kanit"/>
                         </a:rPr>
-                        <a:t>11</a:t>
+                        <a:t>101</a:t>
                       </a:r>
                     </a:p>
                   </a:txBody>
@@ -8488,7 +8488,7 @@
                           </a:solidFill>
                           <a:latin typeface="Kanit"/>
                         </a:rPr>
-                        <a:t>20</a:t>
+                        <a:t>14</a:t>
                       </a:r>
                     </a:p>
                   </a:txBody>
@@ -8534,7 +8534,7 @@
                           </a:solidFill>
                           <a:latin typeface="Kanit"/>
                         </a:rPr>
-                        <a:t>1/1</a:t>
+                        <a:t>1/8</a:t>
                       </a:r>
                     </a:p>
                   </a:txBody>
@@ -8582,7 +8582,7 @@
                           </a:solidFill>
                           <a:latin typeface="Kanit"/>
                         </a:rPr>
-                        <a:t>มุกดาหาร</a:t>
+                        <a:t>บึงกาฬ</a:t>
                       </a:r>
                     </a:p>
                   </a:txBody>
@@ -8605,7 +8605,7 @@
                           </a:solidFill>
                           <a:latin typeface="Kanit"/>
                         </a:rPr>
-                        <a:t>18</a:t>
+                        <a:t>11</a:t>
                       </a:r>
                     </a:p>
                   </a:txBody>
@@ -8628,7 +8628,7 @@
                           </a:solidFill>
                           <a:latin typeface="Kanit"/>
                         </a:rPr>
-                        <a:t>16</a:t>
+                        <a:t>48</a:t>
                       </a:r>
                     </a:p>
                   </a:txBody>
@@ -8647,11 +8647,11 @@
                       <a:r>
                         <a:rPr sz="900" b="1">
                           <a:solidFill>
-                            <a:srgbClr val="606060"/>
-                          </a:solidFill>
-                          <a:latin typeface="Kanit"/>
-                        </a:rPr>
-                        <a:t>0.0%</a:t>
+                            <a:srgbClr val="F5C242"/>
+                          </a:solidFill>
+                          <a:latin typeface="Kanit"/>
+                        </a:rPr>
+                        <a:t>36.4%</a:t>
                       </a:r>
                     </a:p>
                   </a:txBody>
@@ -8674,7 +8674,7 @@
                           </a:solidFill>
                           <a:latin typeface="Kanit"/>
                         </a:rPr>
-                        <a:t>2/2</a:t>
+                        <a:t>1/1</a:t>
                       </a:r>
                     </a:p>
                   </a:txBody>
@@ -8693,11 +8693,11 @@
                       <a:r>
                         <a:rPr sz="900" b="1">
                           <a:solidFill>
-                            <a:srgbClr val="CC0000"/>
-                          </a:solidFill>
-                          <a:latin typeface="Kanit"/>
-                        </a:rPr>
-                        <a:t>5</a:t>
+                            <a:srgbClr val="F5C242"/>
+                          </a:solidFill>
+                          <a:latin typeface="Kanit"/>
+                        </a:rPr>
+                        <a:t>4</a:t>
                       </a:r>
                     </a:p>
                   </a:txBody>
@@ -8909,7 +8909,7 @@
                 </a:solidFill>
                 <a:latin typeface="Kanit"/>
               </a:rPr>
-              <a:t>พื้นที่ปลูก วัดจริง (สศก. — ข้อมูลอำเภอ×พืช 3,295 แถว) ภัยแล้งเป็นดัชนี SPEI จาก แบบจำลอง คำนวณจากปริมาณฝนและการคายระเหย ปรับเดือนละครั้ง ดึงข้อมูล 2026-07-20 — เป็นสัญญาณที่ครอบคลุมทั้งประเทศดีที่สุดที่มี แต่ไม่มีใครลงพื้นที่ไปเดินดูอำเภอเหล่านั้น ข้อมูลฝนและระดับน้ำ วัดจริง (ThaiWater เรียลไทม์ ดึงทุกวันและสะสมไว้ — วันที่ดึงไม่สำเร็จจะเว้นเป็นช่องว่าง ไม่ใส่ค่าสมมติ) · ฝนถึง 2026-08-11, ระดับน้ำถึง 2026-08-11 ความเสี่ยงน้ำท่วมเชิงโครงสร้าง วัดจริง (สำมะโนพื้นที่ท่วมซ้ำซาก GISTDA มาตราส่วน 1:50,000 ปี 2005-2016 — เป็นบันทึกภาคพื้นดิน 12 ปี ไม่ใช่การพยากรณ์)</a:t>
+              <a:t>พื้นที่ปลูก วัดจริง (สศก. — ข้อมูลอำเภอ×พืช 3,295 แถว) ภัยแล้งเป็นดัชนี SPEI จาก แบบจำลอง คำนวณจากปริมาณฝนและการคายระเหย ปรับเดือนละครั้ง ดึงข้อมูล 2026-07-20 — เป็นสัญญาณที่ครอบคลุมทั้งประเทศดีที่สุดที่มี แต่ไม่มีใครลงพื้นที่ไปเดินดูอำเภอเหล่านั้น ข้อมูลฝนและระดับน้ำ วัดจริง (ThaiWater เรียลไทม์ ดึงทุกวันและสะสมไว้ — วันที่ดึงไม่สำเร็จจะเว้นเป็นช่องว่าง ไม่ใส่ค่าสมมติ) · ฝนถึง 2026-08-14, ระดับน้ำถึง 2026-08-14 ความเสี่ยงน้ำท่วมเชิงโครงสร้าง วัดจริง (สำมะโนพื้นที่ท่วมซ้ำซาก GISTDA มาตราส่วน 1:50,000 ปี 2005-2016 — เป็นบันทึกภาคพื้นดิน 12 ปี ไม่ใช่การพยากรณ์)</a:t>
             </a:r>
           </a:p>
         </p:txBody>
@@ -31476,7 +31476,7 @@
                 </a:solidFill>
                 <a:latin typeface="Kanit"/>
               </a:rPr>
-              <a:t>รายได้จากพืชค่ากลางเพิ่มขึ้น +16.6% แต่มีสี่จังหวัดที่ลดลง — ทั้งหมดอยู่ในแหล่งปลูกมะพร้าว โดยหนักที่สุดคือสมุทรสงครามที่ −63.4%</a:t>
+              <a:t>รายได้จากพืชค่ากลางเพิ่มขึ้น +16.9% แต่มีสี่จังหวัดที่ลดลง — ทั้งหมดอยู่ในแหล่งปลูกมะพร้าว โดยหนักที่สุดคือสมุทรสงครามที่ −63.2%</a:t>
             </a:r>
           </a:p>
         </p:txBody>
@@ -32047,7 +32047,7 @@
                 </a:solidFill>
                 <a:latin typeface="Kanit"/>
               </a:rPr>
-              <a:t>รุ่นข้อมูล — ราคาโลก 2026M06 · ราคาหน้าฟาร์มไทย 2026-08-11 · ประวัติราคาไทย 2026-08-02 · ต้นทุนการผลิตพืช สศก. ไจอัป 2568 (ปีเพาะปลูก 2568/69, ประมาณการ สศก. มี.ค. 2569) · ภัยแล้ง 2026-06-21 · เงินเฟ้อ 2026-05 · GDP 2026 ไตรมาส 1 · IMF WEO 2026 · ดัชนีราคาขายต่อ 2026-05 · ยอดจดทะเบียนถึง 2026-01 · หนี้ครัวเรือน สสช. SES 2566 · ค่าจ้าง สสช. LFS 2568 · ข้อมูลตรวจวัด 2026-08-11</a:t>
+              <a:t>รุ่นข้อมูล — ราคาโลก 2026M06 · ราคาหน้าฟาร์มไทย 2026-08-13 · ประวัติราคาไทย 2026-08-02 · ต้นทุนการผลิตพืช สศก. ไจอัป 2568 (ปีเพาะปลูก 2568/69, ประมาณการ สศก. มี.ค. 2569) · ภัยแล้ง 2026-06-21 · เงินเฟ้อ 2026-05 · GDP 2026 ไตรมาส 1 · IMF WEO 2026 · ดัชนีราคาขายต่อ 2026-05 · ยอดจดทะเบียนถึง 2026-01 · หนี้ครัวเรือน สสช. SES 2566 · ค่าจ้าง สสช. LFS 2568 · ข้อมูลตรวจวัด 2026-08-14</a:t>
             </a:r>
           </a:p>
         </p:txBody>
@@ -32546,7 +32546,7 @@
               <a:t>Not on the world index — the farm gate (ราคาที่เกษตรกรขายได้) says otherwise.
 • Five of seventeen Thai farm-gate prices are falling year on year.
 • Beef: farm gate −6.1% vs world index +11.8%.
-• Margin over price: a 26% price move becomes an 85% swing in crop income.</a:t>
+• Margin over price: a 26% price move becomes an 87% swing in crop income.</a:t>
             </a:r>
           </a:p>
         </p:txBody>
@@ -37087,7 +37087,7 @@
                 </a:solidFill>
                 <a:latin typeface="Kanit"/>
               </a:rPr>
-              <a:t>338 จาก 928 อำเภอ · แม่น้ำเกินระดับ 155 จาก 794 สถานี</a:t>
+              <a:t>338 จาก 928 อำเภอ · แม่น้ำเกินระดับ 129 จาก 795 สถานี</a:t>
             </a:r>
           </a:p>
         </p:txBody>
@@ -37859,7 +37859,7 @@
                           </a:solidFill>
                           <a:latin typeface="Kanit"/>
                         </a:rPr>
-                        <a:t>39/158</a:t>
+                        <a:t>33/157</a:t>
                       </a:r>
                     </a:p>
                   </a:txBody>
@@ -38091,7 +38091,7 @@
                           </a:solidFill>
                           <a:latin typeface="Kanit"/>
                         </a:rPr>
-                        <a:t>41/273</a:t>
+                        <a:t>23/274</a:t>
                       </a:r>
                     </a:p>
                   </a:txBody>
@@ -38323,7 +38323,7 @@
                           </a:solidFill>
                           <a:latin typeface="Kanit"/>
                         </a:rPr>
-                        <a:t>24/168</a:t>
+                        <a:t>27/168</a:t>
                       </a:r>
                     </a:p>
                   </a:txBody>
@@ -38787,7 +38787,7 @@
                           </a:solidFill>
                           <a:latin typeface="Kanit"/>
                         </a:rPr>
-                        <a:t>45/143</a:t>
+                        <a:t>40/144</a:t>
                       </a:r>
                     </a:p>
                   </a:txBody>
@@ -39936,7 +39936,7 @@
                           </a:solidFill>
                           <a:latin typeface="Kanit"/>
                         </a:rPr>
-                        <a:t>−67.8%</a:t>
+                        <a:t>−67.6%</a:t>
                       </a:r>
                     </a:p>
                   </a:txBody>
@@ -40791,7 +40791,7 @@
                 </a:solidFill>
                 <a:latin typeface="Kanit"/>
               </a:rPr>
-              <a:t>ราคา วัดจริง — ราคาหน้าฟาร์มไทยจากราคารายวันของ NABC และราคาอ้อยประกาศของ สอน. ราคาล่าสุด 2026-08-11 การเปลี่ยนแปลงหกเดือนคำนวณจากข้อมูลรายเดือนของ NABC เอง (thai_price_history รุ่นข้อมูล 2026-08-02) พืชที่ไม่มีข้อมูลรายเดือนจะกำกับไว้ ไม่ประมาณการขึ้นมา แหล่งผลิตเป็นการอ่านแบบ ประมาณการ ว่าสินค้าแต่ละชนิดปลูกที่ไหน และแหล่งผลิตทับซ้อนกันได้ บัญชีอาชีพเกษตรเป็นข้อมูลของเราเองและ วัดจริง — บัญชีที่บันทึกอาชีพว่า เกษตร ในจังหวัดแหล่งผลิต จากฐานข้อมูล 382,735 บัญชี ณ 2026-07 ไม่เผยแพร่ช่องที่มีน้อยกว่า 30 บัญชี คนกลุ่มนี้อาศัยอยู่ในพื้นที่ที่ปลูกพืชนั้น แต่ไม่ได้ยืนยันว่าปลูกพืชนั้นเอง</a:t>
+              <a:t>ราคา วัดจริง — ราคาหน้าฟาร์มไทยจากราคารายวันของ NABC และราคาอ้อยประกาศของ สอน. ราคาล่าสุด 2026-08-13 การเปลี่ยนแปลงหกเดือนคำนวณจากข้อมูลรายเดือนของ NABC เอง (thai_price_history รุ่นข้อมูล 2026-08-02) พืชที่ไม่มีข้อมูลรายเดือนจะกำกับไว้ ไม่ประมาณการขึ้นมา แหล่งผลิตเป็นการอ่านแบบ ประมาณการ ว่าสินค้าแต่ละชนิดปลูกที่ไหน และแหล่งผลิตทับซ้อนกันได้ บัญชีอาชีพเกษตรเป็นข้อมูลของเราเองและ วัดจริง — บัญชีที่บันทึกอาชีพว่า เกษตร ในจังหวัดแหล่งผลิต จากฐานข้อมูล 382,735 บัญชี ณ 2026-07 ไม่เผยแพร่ช่องที่มีน้อยกว่า 30 บัญชี คนกลุ่มนี้อาศัยอยู่ในพื้นที่ที่ปลูกพืชนั้น แต่ไม่ได้ยืนยันว่าปลูกพืชนั้นเอง</a:t>
             </a:r>
           </a:p>
         </p:txBody>
@@ -44679,7 +44679,7 @@
                 </a:solidFill>
                 <a:latin typeface="Kanit"/>
               </a:rPr>
-              <a:t>มะพร้าว −67.8% สับปะรด −18.4% อ้อย −17.9% เทียบปีก่อน</a:t>
+              <a:t>มะพร้าว −67.6% สับปะรด −18.4% อ้อย −17.9% เทียบปีก่อน</a:t>
             </a:r>
           </a:p>
         </p:txBody>
@@ -44805,7 +44805,7 @@
                 </a:solidFill>
                 <a:latin typeface="Kanit"/>
               </a:rPr>
-              <a:t>+16.6%</a:t>
+              <a:t>+16.9%</a:t>
             </a:r>
           </a:p>
         </p:txBody>
@@ -45279,7 +45279,7 @@
                           </a:solidFill>
                           <a:latin typeface="Kanit"/>
                         </a:rPr>
-                        <a:t>+6.5%</a:t>
+                        <a:t>+6.7%</a:t>
                       </a:r>
                     </a:p>
                   </a:txBody>
@@ -45348,7 +45348,7 @@
                           </a:solidFill>
                           <a:latin typeface="Kanit"/>
                         </a:rPr>
-                        <a:t>-63.4%</a:t>
+                        <a:t>-63.2%</a:t>
                       </a:r>
                     </a:p>
                   </a:txBody>
@@ -45419,7 +45419,7 @@
                           </a:solidFill>
                           <a:latin typeface="Kanit"/>
                         </a:rPr>
-                        <a:t>+15.3%</a:t>
+                        <a:t>+15.6%</a:t>
                       </a:r>
                     </a:p>
                   </a:txBody>
@@ -45488,7 +45488,7 @@
                           </a:solidFill>
                           <a:latin typeface="Kanit"/>
                         </a:rPr>
-                        <a:t>+9.8%</a:t>
+                        <a:t>+10.0%</a:t>
                       </a:r>
                     </a:p>
                   </a:txBody>
@@ -45559,7 +45559,7 @@
                           </a:solidFill>
                           <a:latin typeface="Kanit"/>
                         </a:rPr>
-                        <a:t>+16.7%</a:t>
+                        <a:t>+16.8%</a:t>
                       </a:r>
                     </a:p>
                   </a:txBody>
@@ -45628,7 +45628,7 @@
                           </a:solidFill>
                           <a:latin typeface="Kanit"/>
                         </a:rPr>
-                        <a:t>+8.6%</a:t>
+                        <a:t>+8.7%</a:t>
                       </a:r>
                     </a:p>
                   </a:txBody>
@@ -45699,7 +45699,7 @@
                           </a:solidFill>
                           <a:latin typeface="Kanit"/>
                         </a:rPr>
-                        <a:t>+25.8%</a:t>
+                        <a:t>+26.0%</a:t>
                       </a:r>
                     </a:p>
                   </a:txBody>
@@ -45768,7 +45768,7 @@
                           </a:solidFill>
                           <a:latin typeface="Kanit"/>
                         </a:rPr>
-                        <a:t>+10.7%</a:t>
+                        <a:t>+10.8%</a:t>
                       </a:r>
                     </a:p>
                   </a:txBody>
@@ -45839,7 +45839,7 @@
                           </a:solidFill>
                           <a:latin typeface="Kanit"/>
                         </a:rPr>
-                        <a:t>+36.5%</a:t>
+                        <a:t>+36.7%</a:t>
                       </a:r>
                     </a:p>
                   </a:txBody>
@@ -45908,7 +45908,7 @@
                           </a:solidFill>
                           <a:latin typeface="Kanit"/>
                         </a:rPr>
-                        <a:t>+29.0%</a:t>
+                        <a:t>+28.8%</a:t>
                       </a:r>
                     </a:p>
                   </a:txBody>
@@ -46387,7 +46387,7 @@
                           </a:solidFill>
                           <a:latin typeface="Kanit"/>
                         </a:rPr>
-                        <a:t>+16.7%</a:t>
+                        <a:t>+16.9%</a:t>
                       </a:r>
                     </a:p>
                   </a:txBody>
@@ -46550,7 +46550,7 @@
                           </a:solidFill>
                           <a:latin typeface="Kanit"/>
                         </a:rPr>
-                        <a:t>+21.1%</a:t>
+                        <a:t>+21.3%</a:t>
                       </a:r>
                     </a:p>
                   </a:txBody>
@@ -46713,7 +46713,7 @@
                           </a:solidFill>
                           <a:latin typeface="Kanit"/>
                         </a:rPr>
-                        <a:t>+10.9%</a:t>
+                        <a:t>+11.2%</a:t>
                       </a:r>
                     </a:p>
                   </a:txBody>
@@ -47039,7 +47039,7 @@
                           </a:solidFill>
                           <a:latin typeface="Kanit"/>
                         </a:rPr>
-                        <a:t>+16.8%</a:t>
+                        <a:t>+16.9%</a:t>
                       </a:r>
                     </a:p>
                   </a:txBody>
@@ -47202,7 +47202,7 @@
                           </a:solidFill>
                           <a:latin typeface="Kanit"/>
                         </a:rPr>
-                        <a:t>+15.5%</a:t>
+                        <a:t>+15.6%</a:t>
                       </a:r>
                     </a:p>
                   </a:txBody>
@@ -48024,7 +48024,7 @@
                 </a:solidFill>
                 <a:latin typeface="Kanit"/>
               </a:rPr>
-              <a:t>เทียบปีก่อน −67.8%</a:t>
+              <a:t>เทียบปีก่อน −67.6%</a:t>
             </a:r>
           </a:p>
         </p:txBody>
@@ -48660,7 +48660,7 @@
                 </a:solidFill>
                 <a:latin typeface="Kanit"/>
               </a:rPr>
-              <a:t>เทียบปีก่อน +0.3%</a:t>
+              <a:t>เทียบปีก่อน +0.7%</a:t>
             </a:r>
           </a:p>
         </p:txBody>
@@ -48900,6 +48900,324 @@
                 </a:solidFill>
                 <a:latin typeface="Kanit"/>
               </a:rPr>
+              <a:t>กุ้งขาว</a:t>
+            </a:r>
+          </a:p>
+        </p:txBody>
+      </p:sp>
+      <p:sp>
+        <p:nvSpPr>
+          <p:cNvPr id="37" name="TextBox 36"/>
+          <p:cNvSpPr txBox="1"/>
+          <p:nvPr/>
+        </p:nvSpPr>
+        <p:spPr>
+          <a:xfrm>
+            <a:off x="7318857" y="2112263"/>
+            <a:ext cx="2156155" cy="125730"/>
+          </a:xfrm>
+          <a:prstGeom prst="rect">
+            <a:avLst/>
+          </a:prstGeom>
+          <a:noFill/>
+        </p:spPr>
+        <p:txBody>
+          <a:bodyPr wrap="square" lIns="0" rIns="0" tIns="0" bIns="0" anchor="t">
+            <a:noAutofit/>
+          </a:bodyPr>
+          <a:lstStyle/>
+          <a:p>
+            <a:pPr algn="l">
+              <a:lnSpc>
+                <a:spcPts val="990"/>
+              </a:lnSpc>
+            </a:pPr>
+            <a:r>
+              <a:rPr sz="750" b="0">
+                <a:solidFill>
+                  <a:srgbClr val="606060"/>
+                </a:solidFill>
+                <a:latin typeface="Kanit"/>
+              </a:rPr>
+              <a:t>฿133.82 /กก. · ชายฝั่งใต้·ตอ.</a:t>
+            </a:r>
+          </a:p>
+        </p:txBody>
+      </p:sp>
+      <p:sp>
+        <p:nvSpPr>
+          <p:cNvPr id="38" name="TextBox 37"/>
+          <p:cNvSpPr txBox="1"/>
+          <p:nvPr/>
+        </p:nvSpPr>
+        <p:spPr>
+          <a:xfrm>
+            <a:off x="7318857" y="2244851"/>
+            <a:ext cx="1078077" cy="134112"/>
+          </a:xfrm>
+          <a:prstGeom prst="rect">
+            <a:avLst/>
+          </a:prstGeom>
+          <a:noFill/>
+        </p:spPr>
+        <p:txBody>
+          <a:bodyPr wrap="square" lIns="0" rIns="0" tIns="0" bIns="0" anchor="t">
+            <a:noAutofit/>
+          </a:bodyPr>
+          <a:lstStyle/>
+          <a:p>
+            <a:pPr algn="l">
+              <a:lnSpc>
+                <a:spcPts val="1056"/>
+              </a:lnSpc>
+            </a:pPr>
+            <a:r>
+              <a:rPr sz="800" b="1">
+                <a:solidFill>
+                  <a:srgbClr val="15795F"/>
+                </a:solidFill>
+                <a:latin typeface="Kanit"/>
+              </a:rPr>
+              <a:t>เทียบปีก่อน +1.1%</a:t>
+            </a:r>
+          </a:p>
+        </p:txBody>
+      </p:sp>
+      <p:sp>
+        <p:nvSpPr>
+          <p:cNvPr id="39" name="TextBox 38"/>
+          <p:cNvSpPr txBox="1"/>
+          <p:nvPr/>
+        </p:nvSpPr>
+        <p:spPr>
+          <a:xfrm>
+            <a:off x="8396935" y="2244851"/>
+            <a:ext cx="1078077" cy="134112"/>
+          </a:xfrm>
+          <a:prstGeom prst="rect">
+            <a:avLst/>
+          </a:prstGeom>
+          <a:noFill/>
+        </p:spPr>
+        <p:txBody>
+          <a:bodyPr wrap="square" lIns="0" rIns="0" tIns="0" bIns="0" anchor="t">
+            <a:noAutofit/>
+          </a:bodyPr>
+          <a:lstStyle/>
+          <a:p>
+            <a:pPr algn="l">
+              <a:lnSpc>
+                <a:spcPts val="1056"/>
+              </a:lnSpc>
+            </a:pPr>
+            <a:r>
+              <a:rPr sz="800" b="1">
+                <a:solidFill>
+                  <a:srgbClr val="CC0000"/>
+                </a:solidFill>
+                <a:latin typeface="Kanit"/>
+              </a:rPr>
+              <a:t>6 เดือน −15.8%</a:t>
+            </a:r>
+          </a:p>
+        </p:txBody>
+      </p:sp>
+      <p:sp>
+        <p:nvSpPr>
+          <p:cNvPr id="40" name="Rectangle 39"/>
+          <p:cNvSpPr/>
+          <p:nvPr/>
+        </p:nvSpPr>
+        <p:spPr>
+          <a:xfrm>
+            <a:off x="7318857" y="2400300"/>
+            <a:ext cx="2156155" cy="548640"/>
+          </a:xfrm>
+          <a:prstGeom prst="rect">
+            <a:avLst/>
+          </a:prstGeom>
+          <a:solidFill>
+            <a:srgbClr val="FBFCFE"/>
+          </a:solidFill>
+          <a:ln w="9525">
+            <a:solidFill>
+              <a:srgbClr val="D9DEE9"/>
+            </a:solidFill>
+          </a:ln>
+          <a:effectLst/>
+        </p:spPr>
+        <p:style>
+          <a:lnRef idx="1">
+            <a:schemeClr val="accent1"/>
+          </a:lnRef>
+          <a:fillRef idx="3">
+            <a:schemeClr val="accent1"/>
+          </a:fillRef>
+          <a:effectRef idx="2">
+            <a:schemeClr val="accent1"/>
+          </a:effectRef>
+          <a:fontRef idx="minor">
+            <a:schemeClr val="lt1"/>
+          </a:fontRef>
+        </p:style>
+        <p:txBody>
+          <a:bodyPr rtlCol="0" anchor="ctr" wrap="none"/>
+          <a:lstStyle/>
+          <a:p>
+            <a:pPr algn="ctr"/>
+          </a:p>
+        </p:txBody>
+      </p:sp>
+      <p:sp>
+        <p:nvSpPr>
+          <p:cNvPr id="41" name="Freeform 40"/>
+          <p:cNvSpPr/>
+          <p:nvPr/>
+        </p:nvSpPr>
+        <p:spPr>
+          <a:xfrm>
+            <a:off x="7364577" y="2446020"/>
+            <a:ext cx="2064715" cy="457200"/>
+          </a:xfrm>
+          <a:custGeom>
+            <a:avLst/>
+            <a:gdLst/>
+            <a:ahLst/>
+            <a:cxnLst/>
+            <a:rect l="l" t="t" r="r" b="b"/>
+            <a:pathLst>
+              <a:path w="2064715" h="457200">
+                <a:moveTo>
+                  <a:pt x="0" y="0"/>
+                </a:moveTo>
+                <a:lnTo>
+                  <a:pt x="412943" y="247179"/>
+                </a:lnTo>
+                <a:lnTo>
+                  <a:pt x="825886" y="420769"/>
+                </a:lnTo>
+                <a:lnTo>
+                  <a:pt x="1238829" y="457200"/>
+                </a:lnTo>
+                <a:lnTo>
+                  <a:pt x="1651772" y="424594"/>
+                </a:lnTo>
+                <a:lnTo>
+                  <a:pt x="2064715" y="223135"/>
+                </a:lnTo>
+              </a:path>
+            </a:pathLst>
+          </a:custGeom>
+          <a:noFill/>
+          <a:ln w="20320">
+            <a:solidFill>
+              <a:srgbClr val="CC0000"/>
+            </a:solidFill>
+          </a:ln>
+          <a:effectLst/>
+        </p:spPr>
+        <p:style>
+          <a:lnRef idx="1">
+            <a:schemeClr val="accent1"/>
+          </a:lnRef>
+          <a:fillRef idx="3">
+            <a:schemeClr val="accent1"/>
+          </a:fillRef>
+          <a:effectRef idx="2">
+            <a:schemeClr val="accent1"/>
+          </a:effectRef>
+          <a:fontRef idx="minor">
+            <a:schemeClr val="lt1"/>
+          </a:fontRef>
+        </p:style>
+        <p:txBody>
+          <a:bodyPr rtlCol="0" anchor="ctr"/>
+          <a:lstStyle/>
+          <a:p>
+            <a:pPr algn="ctr"/>
+          </a:p>
+        </p:txBody>
+      </p:sp>
+      <p:sp>
+        <p:nvSpPr>
+          <p:cNvPr id="42" name="Rounded Rectangle 41"/>
+          <p:cNvSpPr/>
+          <p:nvPr/>
+        </p:nvSpPr>
+        <p:spPr>
+          <a:xfrm>
+            <a:off x="9388144" y="2628007"/>
+            <a:ext cx="82296" cy="82296"/>
+          </a:xfrm>
+          <a:prstGeom prst="roundRect">
+            <a:avLst>
+              <a:gd name="adj" fmla="val 50000"/>
+            </a:avLst>
+          </a:prstGeom>
+          <a:solidFill>
+            <a:srgbClr val="CC0000"/>
+          </a:solidFill>
+          <a:ln>
+            <a:noFill/>
+          </a:ln>
+          <a:effectLst/>
+        </p:spPr>
+        <p:style>
+          <a:lnRef idx="1">
+            <a:schemeClr val="accent1"/>
+          </a:lnRef>
+          <a:fillRef idx="3">
+            <a:schemeClr val="accent1"/>
+          </a:fillRef>
+          <a:effectRef idx="2">
+            <a:schemeClr val="accent1"/>
+          </a:effectRef>
+          <a:fontRef idx="minor">
+            <a:schemeClr val="lt1"/>
+          </a:fontRef>
+        </p:style>
+        <p:txBody>
+          <a:bodyPr rtlCol="0" anchor="ctr" wrap="none"/>
+          <a:lstStyle/>
+          <a:p>
+            <a:pPr algn="ctr"/>
+          </a:p>
+        </p:txBody>
+      </p:sp>
+      <p:sp>
+        <p:nvSpPr>
+          <p:cNvPr id="43" name="TextBox 42"/>
+          <p:cNvSpPr txBox="1"/>
+          <p:nvPr/>
+        </p:nvSpPr>
+        <p:spPr>
+          <a:xfrm>
+            <a:off x="9621316" y="1970531"/>
+            <a:ext cx="2156155" cy="150876"/>
+          </a:xfrm>
+          <a:prstGeom prst="rect">
+            <a:avLst/>
+          </a:prstGeom>
+          <a:noFill/>
+        </p:spPr>
+        <p:txBody>
+          <a:bodyPr wrap="square" lIns="0" rIns="0" tIns="0" bIns="0" anchor="t">
+            <a:noAutofit/>
+          </a:bodyPr>
+          <a:lstStyle/>
+          <a:p>
+            <a:pPr algn="l">
+              <a:lnSpc>
+                <a:spcPts val="1188"/>
+              </a:lnSpc>
+            </a:pPr>
+            <a:r>
+              <a:rPr sz="900" b="1">
+                <a:solidFill>
+                  <a:srgbClr val="1E2F5C"/>
+                </a:solidFill>
+                <a:latin typeface="Kanit"/>
+              </a:rPr>
               <a:t>สุกร</a:t>
             </a:r>
           </a:p>
@@ -48907,13 +49225,13 @@
       </p:sp>
       <p:sp>
         <p:nvSpPr>
-          <p:cNvPr id="37" name="TextBox 36"/>
+          <p:cNvPr id="44" name="TextBox 43"/>
           <p:cNvSpPr txBox="1"/>
           <p:nvPr/>
         </p:nvSpPr>
         <p:spPr>
           <a:xfrm>
-            <a:off x="7318857" y="2112263"/>
+            <a:off x="9621316" y="2112263"/>
             <a:ext cx="2156155" cy="125730"/>
           </a:xfrm>
           <a:prstGeom prst="rect">
@@ -48946,13 +49264,13 @@
       </p:sp>
       <p:sp>
         <p:nvSpPr>
-          <p:cNvPr id="38" name="TextBox 37"/>
+          <p:cNvPr id="45" name="TextBox 44"/>
           <p:cNvSpPr txBox="1"/>
           <p:nvPr/>
         </p:nvSpPr>
         <p:spPr>
           <a:xfrm>
-            <a:off x="7318857" y="2244851"/>
+            <a:off x="9621316" y="2244851"/>
             <a:ext cx="1078077" cy="134112"/>
           </a:xfrm>
           <a:prstGeom prst="rect">
@@ -48978,20 +49296,20 @@
                 </a:solidFill>
                 <a:latin typeface="Kanit"/>
               </a:rPr>
-              <a:t>เทียบปีก่อน +0.3%</a:t>
+              <a:t>เทียบปีก่อน +1.5%</a:t>
             </a:r>
           </a:p>
         </p:txBody>
       </p:sp>
       <p:sp>
         <p:nvSpPr>
-          <p:cNvPr id="39" name="TextBox 38"/>
+          <p:cNvPr id="46" name="TextBox 45"/>
           <p:cNvSpPr txBox="1"/>
           <p:nvPr/>
         </p:nvSpPr>
         <p:spPr>
           <a:xfrm>
-            <a:off x="8396935" y="2244851"/>
+            <a:off x="10699394" y="2244851"/>
             <a:ext cx="1078077" cy="134112"/>
           </a:xfrm>
           <a:prstGeom prst="rect">
@@ -49024,13 +49342,13 @@
       </p:sp>
       <p:sp>
         <p:nvSpPr>
-          <p:cNvPr id="40" name="Rectangle 39"/>
+          <p:cNvPr id="47" name="Rectangle 46"/>
           <p:cNvSpPr/>
           <p:nvPr/>
         </p:nvSpPr>
         <p:spPr>
           <a:xfrm>
-            <a:off x="7318857" y="2400300"/>
+            <a:off x="9621316" y="2400300"/>
             <a:ext cx="2156155" cy="548640"/>
           </a:xfrm>
           <a:prstGeom prst="rect">
@@ -49070,13 +49388,13 @@
       </p:sp>
       <p:sp>
         <p:nvSpPr>
-          <p:cNvPr id="41" name="Freeform 40"/>
+          <p:cNvPr id="48" name="Freeform 47"/>
           <p:cNvSpPr/>
           <p:nvPr/>
         </p:nvSpPr>
         <p:spPr>
           <a:xfrm>
-            <a:off x="7364577" y="2446020"/>
+            <a:off x="9667036" y="2446020"/>
             <a:ext cx="2064715" cy="457200"/>
           </a:xfrm>
           <a:custGeom>
@@ -49140,13 +49458,13 @@
       </p:sp>
       <p:sp>
         <p:nvSpPr>
-          <p:cNvPr id="42" name="Rounded Rectangle 41"/>
+          <p:cNvPr id="49" name="Rounded Rectangle 48"/>
           <p:cNvSpPr/>
           <p:nvPr/>
         </p:nvSpPr>
         <p:spPr>
           <a:xfrm>
-            <a:off x="9388144" y="2457891"/>
+            <a:off x="11690603" y="2457891"/>
             <a:ext cx="82296" cy="82296"/>
           </a:xfrm>
           <a:prstGeom prst="roundRect">
@@ -49156,324 +49474,6 @@
           </a:prstGeom>
           <a:solidFill>
             <a:srgbClr val="15795F"/>
-          </a:solidFill>
-          <a:ln>
-            <a:noFill/>
-          </a:ln>
-          <a:effectLst/>
-        </p:spPr>
-        <p:style>
-          <a:lnRef idx="1">
-            <a:schemeClr val="accent1"/>
-          </a:lnRef>
-          <a:fillRef idx="3">
-            <a:schemeClr val="accent1"/>
-          </a:fillRef>
-          <a:effectRef idx="2">
-            <a:schemeClr val="accent1"/>
-          </a:effectRef>
-          <a:fontRef idx="minor">
-            <a:schemeClr val="lt1"/>
-          </a:fontRef>
-        </p:style>
-        <p:txBody>
-          <a:bodyPr rtlCol="0" anchor="ctr" wrap="none"/>
-          <a:lstStyle/>
-          <a:p>
-            <a:pPr algn="ctr"/>
-          </a:p>
-        </p:txBody>
-      </p:sp>
-      <p:sp>
-        <p:nvSpPr>
-          <p:cNvPr id="43" name="TextBox 42"/>
-          <p:cNvSpPr txBox="1"/>
-          <p:nvPr/>
-        </p:nvSpPr>
-        <p:spPr>
-          <a:xfrm>
-            <a:off x="9621316" y="1970531"/>
-            <a:ext cx="2156155" cy="150876"/>
-          </a:xfrm>
-          <a:prstGeom prst="rect">
-            <a:avLst/>
-          </a:prstGeom>
-          <a:noFill/>
-        </p:spPr>
-        <p:txBody>
-          <a:bodyPr wrap="square" lIns="0" rIns="0" tIns="0" bIns="0" anchor="t">
-            <a:noAutofit/>
-          </a:bodyPr>
-          <a:lstStyle/>
-          <a:p>
-            <a:pPr algn="l">
-              <a:lnSpc>
-                <a:spcPts val="1188"/>
-              </a:lnSpc>
-            </a:pPr>
-            <a:r>
-              <a:rPr sz="900" b="1">
-                <a:solidFill>
-                  <a:srgbClr val="1E2F5C"/>
-                </a:solidFill>
-                <a:latin typeface="Kanit"/>
-              </a:rPr>
-              <a:t>กุ้งขาว</a:t>
-            </a:r>
-          </a:p>
-        </p:txBody>
-      </p:sp>
-      <p:sp>
-        <p:nvSpPr>
-          <p:cNvPr id="44" name="TextBox 43"/>
-          <p:cNvSpPr txBox="1"/>
-          <p:nvPr/>
-        </p:nvSpPr>
-        <p:spPr>
-          <a:xfrm>
-            <a:off x="9621316" y="2112263"/>
-            <a:ext cx="2156155" cy="125730"/>
-          </a:xfrm>
-          <a:prstGeom prst="rect">
-            <a:avLst/>
-          </a:prstGeom>
-          <a:noFill/>
-        </p:spPr>
-        <p:txBody>
-          <a:bodyPr wrap="square" lIns="0" rIns="0" tIns="0" bIns="0" anchor="t">
-            <a:noAutofit/>
-          </a:bodyPr>
-          <a:lstStyle/>
-          <a:p>
-            <a:pPr algn="l">
-              <a:lnSpc>
-                <a:spcPts val="990"/>
-              </a:lnSpc>
-            </a:pPr>
-            <a:r>
-              <a:rPr sz="750" b="0">
-                <a:solidFill>
-                  <a:srgbClr val="606060"/>
-                </a:solidFill>
-                <a:latin typeface="Kanit"/>
-              </a:rPr>
-              <a:t>฿133.82 /กก. · ชายฝั่งใต้·ตอ.</a:t>
-            </a:r>
-          </a:p>
-        </p:txBody>
-      </p:sp>
-      <p:sp>
-        <p:nvSpPr>
-          <p:cNvPr id="45" name="TextBox 44"/>
-          <p:cNvSpPr txBox="1"/>
-          <p:nvPr/>
-        </p:nvSpPr>
-        <p:spPr>
-          <a:xfrm>
-            <a:off x="9621316" y="2244851"/>
-            <a:ext cx="1078077" cy="134112"/>
-          </a:xfrm>
-          <a:prstGeom prst="rect">
-            <a:avLst/>
-          </a:prstGeom>
-          <a:noFill/>
-        </p:spPr>
-        <p:txBody>
-          <a:bodyPr wrap="square" lIns="0" rIns="0" tIns="0" bIns="0" anchor="t">
-            <a:noAutofit/>
-          </a:bodyPr>
-          <a:lstStyle/>
-          <a:p>
-            <a:pPr algn="l">
-              <a:lnSpc>
-                <a:spcPts val="1056"/>
-              </a:lnSpc>
-            </a:pPr>
-            <a:r>
-              <a:rPr sz="800" b="1">
-                <a:solidFill>
-                  <a:srgbClr val="15795F"/>
-                </a:solidFill>
-                <a:latin typeface="Kanit"/>
-              </a:rPr>
-              <a:t>เทียบปีก่อน +0.6%</a:t>
-            </a:r>
-          </a:p>
-        </p:txBody>
-      </p:sp>
-      <p:sp>
-        <p:nvSpPr>
-          <p:cNvPr id="46" name="TextBox 45"/>
-          <p:cNvSpPr txBox="1"/>
-          <p:nvPr/>
-        </p:nvSpPr>
-        <p:spPr>
-          <a:xfrm>
-            <a:off x="10699394" y="2244851"/>
-            <a:ext cx="1078077" cy="134112"/>
-          </a:xfrm>
-          <a:prstGeom prst="rect">
-            <a:avLst/>
-          </a:prstGeom>
-          <a:noFill/>
-        </p:spPr>
-        <p:txBody>
-          <a:bodyPr wrap="square" lIns="0" rIns="0" tIns="0" bIns="0" anchor="t">
-            <a:noAutofit/>
-          </a:bodyPr>
-          <a:lstStyle/>
-          <a:p>
-            <a:pPr algn="l">
-              <a:lnSpc>
-                <a:spcPts val="1056"/>
-              </a:lnSpc>
-            </a:pPr>
-            <a:r>
-              <a:rPr sz="800" b="1">
-                <a:solidFill>
-                  <a:srgbClr val="CC0000"/>
-                </a:solidFill>
-                <a:latin typeface="Kanit"/>
-              </a:rPr>
-              <a:t>6 เดือน −15.8%</a:t>
-            </a:r>
-          </a:p>
-        </p:txBody>
-      </p:sp>
-      <p:sp>
-        <p:nvSpPr>
-          <p:cNvPr id="47" name="Rectangle 46"/>
-          <p:cNvSpPr/>
-          <p:nvPr/>
-        </p:nvSpPr>
-        <p:spPr>
-          <a:xfrm>
-            <a:off x="9621316" y="2400300"/>
-            <a:ext cx="2156155" cy="548640"/>
-          </a:xfrm>
-          <a:prstGeom prst="rect">
-            <a:avLst/>
-          </a:prstGeom>
-          <a:solidFill>
-            <a:srgbClr val="FBFCFE"/>
-          </a:solidFill>
-          <a:ln w="9525">
-            <a:solidFill>
-              <a:srgbClr val="D9DEE9"/>
-            </a:solidFill>
-          </a:ln>
-          <a:effectLst/>
-        </p:spPr>
-        <p:style>
-          <a:lnRef idx="1">
-            <a:schemeClr val="accent1"/>
-          </a:lnRef>
-          <a:fillRef idx="3">
-            <a:schemeClr val="accent1"/>
-          </a:fillRef>
-          <a:effectRef idx="2">
-            <a:schemeClr val="accent1"/>
-          </a:effectRef>
-          <a:fontRef idx="minor">
-            <a:schemeClr val="lt1"/>
-          </a:fontRef>
-        </p:style>
-        <p:txBody>
-          <a:bodyPr rtlCol="0" anchor="ctr" wrap="none"/>
-          <a:lstStyle/>
-          <a:p>
-            <a:pPr algn="ctr"/>
-          </a:p>
-        </p:txBody>
-      </p:sp>
-      <p:sp>
-        <p:nvSpPr>
-          <p:cNvPr id="48" name="Freeform 47"/>
-          <p:cNvSpPr/>
-          <p:nvPr/>
-        </p:nvSpPr>
-        <p:spPr>
-          <a:xfrm>
-            <a:off x="9667036" y="2446020"/>
-            <a:ext cx="2064715" cy="457200"/>
-          </a:xfrm>
-          <a:custGeom>
-            <a:avLst/>
-            <a:gdLst/>
-            <a:ahLst/>
-            <a:cxnLst/>
-            <a:rect l="l" t="t" r="r" b="b"/>
-            <a:pathLst>
-              <a:path w="2064715" h="457200">
-                <a:moveTo>
-                  <a:pt x="0" y="0"/>
-                </a:moveTo>
-                <a:lnTo>
-                  <a:pt x="412943" y="247179"/>
-                </a:lnTo>
-                <a:lnTo>
-                  <a:pt x="825886" y="420769"/>
-                </a:lnTo>
-                <a:lnTo>
-                  <a:pt x="1238829" y="457200"/>
-                </a:lnTo>
-                <a:lnTo>
-                  <a:pt x="1651772" y="424594"/>
-                </a:lnTo>
-                <a:lnTo>
-                  <a:pt x="2064715" y="223135"/>
-                </a:lnTo>
-              </a:path>
-            </a:pathLst>
-          </a:custGeom>
-          <a:noFill/>
-          <a:ln w="20320">
-            <a:solidFill>
-              <a:srgbClr val="CC0000"/>
-            </a:solidFill>
-          </a:ln>
-          <a:effectLst/>
-        </p:spPr>
-        <p:style>
-          <a:lnRef idx="1">
-            <a:schemeClr val="accent1"/>
-          </a:lnRef>
-          <a:fillRef idx="3">
-            <a:schemeClr val="accent1"/>
-          </a:fillRef>
-          <a:effectRef idx="2">
-            <a:schemeClr val="accent1"/>
-          </a:effectRef>
-          <a:fontRef idx="minor">
-            <a:schemeClr val="lt1"/>
-          </a:fontRef>
-        </p:style>
-        <p:txBody>
-          <a:bodyPr rtlCol="0" anchor="ctr"/>
-          <a:lstStyle/>
-          <a:p>
-            <a:pPr algn="ctr"/>
-          </a:p>
-        </p:txBody>
-      </p:sp>
-      <p:sp>
-        <p:nvSpPr>
-          <p:cNvPr id="49" name="Rounded Rectangle 48"/>
-          <p:cNvSpPr/>
-          <p:nvPr/>
-        </p:nvSpPr>
-        <p:spPr>
-          <a:xfrm>
-            <a:off x="11690603" y="2628007"/>
-            <a:ext cx="82296" cy="82296"/>
-          </a:xfrm>
-          <a:prstGeom prst="roundRect">
-            <a:avLst>
-              <a:gd name="adj" fmla="val 50000"/>
-            </a:avLst>
-          </a:prstGeom>
-          <a:solidFill>
-            <a:srgbClr val="CC0000"/>
           </a:solidFill>
           <a:ln>
             <a:noFill/>
@@ -49614,7 +49614,7 @@
                 </a:solidFill>
                 <a:latin typeface="Kanit"/>
               </a:rPr>
-              <a:t>เทียบปีก่อน +1.6%</a:t>
+              <a:t>เทียบปีก่อน +2.0%</a:t>
             </a:r>
           </a:p>
         </p:txBody>
@@ -49932,7 +49932,7 @@
                 </a:solidFill>
                 <a:latin typeface="Kanit"/>
               </a:rPr>
-              <a:t>เทียบปีก่อน +13.9%</a:t>
+              <a:t>เทียบปีก่อน +14.0%</a:t>
             </a:r>
           </a:p>
         </p:txBody>
@@ -50250,7 +50250,7 @@
                 </a:solidFill>
                 <a:latin typeface="Kanit"/>
               </a:rPr>
-              <a:t>เทียบปีก่อน +15.4%</a:t>
+              <a:t>เทียบปีก่อน +16.5%</a:t>
             </a:r>
           </a:p>
         </p:txBody>
@@ -50568,7 +50568,7 @@
                 </a:solidFill>
                 <a:latin typeface="Kanit"/>
               </a:rPr>
-              <a:t>เทียบปีก่อน +25.3%</a:t>
+              <a:t>เทียบปีก่อน +24.7%</a:t>
             </a:r>
           </a:p>
         </p:txBody>
@@ -50886,7 +50886,7 @@
                 </a:solidFill>
                 <a:latin typeface="Kanit"/>
               </a:rPr>
-              <a:t>เทียบปีก่อน +42.0%</a:t>
+              <a:t>เทียบปีก่อน +42.4%</a:t>
             </a:r>
           </a:p>
         </p:txBody>
@@ -51204,7 +51204,7 @@
                 </a:solidFill>
                 <a:latin typeface="Kanit"/>
               </a:rPr>
-              <a:t>เทียบปีก่อน +63.5%</a:t>
+              <a:t>เทียบปีก่อน +64.3%</a:t>
             </a:r>
           </a:p>
         </p:txBody>
@@ -51522,7 +51522,7 @@
                 </a:solidFill>
                 <a:latin typeface="Kanit"/>
               </a:rPr>
-              <a:t>เทียบปีก่อน +109.2%</a:t>
+              <a:t>เทียบปีก่อน +126.5%</a:t>
             </a:r>
           </a:p>
         </p:txBody>
@@ -51886,7 +51886,7 @@
                 </a:solidFill>
                 <a:latin typeface="Kanit"/>
               </a:rPr>
-              <a:t>ราคาหน้าฟาร์ม วัดจริง — ราคารายวันของ NABC เฉลี่ยเป็นรายเดือน หน่วยเป็นบาทตามที่เผยแพร่ (ไม่มีการแปลงสกุลเงิน) ราคาล่าสุด 2026-08-11, รุ่นข้อมูลย้อนหลัง 2026-08-02 ราคาหน้าฟาร์ม (ราคาที่เกษตรกรขายได้) คือเงินที่เกษตรกรได้รับเมื่อขายครั้งแรก ก่อนพ่อค้าคนกลาง โรงสี หรือค่าขนส่งจะหักส่วนแบ่ง — ไม่ใช่ดัชนีโลก และไม่ใช่ราคาในซูเปอร์มาร์เก็ต แหล่งผลิตเป็นการอ่านแบบ ประมาณการ ว่าสินค้าแต่ละชนิดผลิตที่ไหน และทับซ้อนกันได้ น้ำตาลเป็นราคาอ้อยประกาศของ สอน. ปีละหนึ่งจุด จึงไม่มีการเปลี่ยนแปลงหกเดือนให้แสดง</a:t>
+              <a:t>ราคาหน้าฟาร์ม วัดจริง — ราคารายวันของ NABC เฉลี่ยเป็นรายเดือน หน่วยเป็นบาทตามที่เผยแพร่ (ไม่มีการแปลงสกุลเงิน) ราคาล่าสุด 2026-08-13, รุ่นข้อมูลย้อนหลัง 2026-08-02 ราคาหน้าฟาร์ม (ราคาที่เกษตรกรขายได้) คือเงินที่เกษตรกรได้รับเมื่อขายครั้งแรก ก่อนพ่อค้าคนกลาง โรงสี หรือค่าขนส่งจะหักส่วนแบ่ง — ไม่ใช่ดัชนีโลก และไม่ใช่ราคาในซูเปอร์มาร์เก็ต แหล่งผลิตเป็นการอ่านแบบ ประมาณการ ว่าสินค้าแต่ละชนิดผลิตที่ไหน และทับซ้อนกันได้ น้ำตาลเป็นราคาอ้อยประกาศของ สอน. ปีละหนึ่งจุด จึงไม่มีการเปลี่ยนแปลงหกเดือนให้แสดง</a:t>
             </a:r>
           </a:p>
         </p:txBody>

</xml_diff>

<commit_message>
deck(mcom): rebuild — the data moved past the committed figures (run 31825669383) (#398)
Co-authored-by: github-actions[bot] <41898282+github-actions[bot]@users.noreply.github.com>
</commit_message>
<xml_diff>
--- a/docs/decks/mcom-2026-08-05-macro-TH.pptx
+++ b/docs/decks/mcom-2026-08-05-macro-TH.pptx
@@ -6240,7 +6240,7 @@
                 </a:solidFill>
                 <a:latin typeface="Kanit"/>
               </a:rPr>
-              <a:t>155</a:t>
+              <a:t>129</a:t>
             </a:r>
           </a:p>
         </p:txBody>
@@ -6279,7 +6279,7 @@
                 </a:solidFill>
                 <a:latin typeface="Kanit"/>
               </a:rPr>
-              <a:t>จาก 794 (19.5%) · เรียลไทม์ · 2026-08-11</a:t>
+              <a:t>จาก 795 (16.2%) · เรียลไทม์ · 2026-08-14</a:t>
             </a:r>
           </a:p>
         </p:txBody>
@@ -6405,7 +6405,7 @@
                 </a:solidFill>
                 <a:latin typeface="Kanit"/>
               </a:rPr>
-              <a:t>14</a:t>
+              <a:t>24</a:t>
             </a:r>
           </a:p>
         </p:txBody>
@@ -6444,7 +6444,7 @@
                 </a:solidFill>
                 <a:latin typeface="Kanit"/>
               </a:rPr>
-              <a:t>ค่าล่าสุดรายวัน · 2026-08-11</a:t>
+              <a:t>ค่าล่าสุดรายวัน · 2026-08-14</a:t>
             </a:r>
           </a:p>
         </p:txBody>
@@ -7882,7 +7882,7 @@
                           </a:solidFill>
                           <a:latin typeface="Kanit"/>
                         </a:rPr>
-                        <a:t>พะเยา</a:t>
+                        <a:t>นครพนม</a:t>
                       </a:r>
                     </a:p>
                   </a:txBody>
@@ -7905,7 +7905,7 @@
                           </a:solidFill>
                           <a:latin typeface="Kanit"/>
                         </a:rPr>
-                        <a:t>123</a:t>
+                        <a:t>28</a:t>
                       </a:r>
                     </a:p>
                   </a:txBody>
@@ -7928,7 +7928,7 @@
                           </a:solidFill>
                           <a:latin typeface="Kanit"/>
                         </a:rPr>
-                        <a:t>105</a:t>
+                        <a:t>114</a:t>
                       </a:r>
                     </a:p>
                   </a:txBody>
@@ -7951,7 +7951,7 @@
                           </a:solidFill>
                           <a:latin typeface="Kanit"/>
                         </a:rPr>
-                        <a:t>10.6%</a:t>
+                        <a:t>46.4%</a:t>
                       </a:r>
                     </a:p>
                   </a:txBody>
@@ -7974,7 +7974,7 @@
                           </a:solidFill>
                           <a:latin typeface="Kanit"/>
                         </a:rPr>
-                        <a:t>4/13</a:t>
+                        <a:t>8/15</a:t>
                       </a:r>
                     </a:p>
                   </a:txBody>
@@ -8022,7 +8022,7 @@
                           </a:solidFill>
                           <a:latin typeface="Kanit"/>
                         </a:rPr>
-                        <a:t>ชัยภูมิ</a:t>
+                        <a:t>มุกดาหาร</a:t>
                       </a:r>
                     </a:p>
                   </a:txBody>
@@ -8045,7 +8045,7 @@
                           </a:solidFill>
                           <a:latin typeface="Kanit"/>
                         </a:rPr>
-                        <a:t>58</a:t>
+                        <a:t>18</a:t>
                       </a:r>
                     </a:p>
                   </a:txBody>
@@ -8068,7 +8068,7 @@
                           </a:solidFill>
                           <a:latin typeface="Kanit"/>
                         </a:rPr>
-                        <a:t>22</a:t>
+                        <a:t>51</a:t>
                       </a:r>
                     </a:p>
                   </a:txBody>
@@ -8087,11 +8087,11 @@
                       <a:r>
                         <a:rPr sz="900" b="1">
                           <a:solidFill>
-                            <a:srgbClr val="606060"/>
-                          </a:solidFill>
-                          <a:latin typeface="Kanit"/>
-                        </a:rPr>
-                        <a:t>0.0%</a:t>
+                            <a:srgbClr val="F5C242"/>
+                          </a:solidFill>
+                          <a:latin typeface="Kanit"/>
+                        </a:rPr>
+                        <a:t>5.6%</a:t>
                       </a:r>
                     </a:p>
                   </a:txBody>
@@ -8114,7 +8114,7 @@
                           </a:solidFill>
                           <a:latin typeface="Kanit"/>
                         </a:rPr>
-                        <a:t>1/12</a:t>
+                        <a:t>2/2</a:t>
                       </a:r>
                     </a:p>
                   </a:txBody>
@@ -8162,7 +8162,7 @@
                           </a:solidFill>
                           <a:latin typeface="Kanit"/>
                         </a:rPr>
-                        <a:t>นครพนม</a:t>
+                        <a:t>สกลนคร</a:t>
                       </a:r>
                     </a:p>
                   </a:txBody>
@@ -8185,6 +8185,29 @@
                           </a:solidFill>
                           <a:latin typeface="Kanit"/>
                         </a:rPr>
+                        <a:t>36</a:t>
+                      </a:r>
+                    </a:p>
+                  </a:txBody>
+                  <a:tcPr marL="54864" marR="54864" marT="18288" marB="18288" anchor="ctr">
+                    <a:solidFill>
+                      <a:srgbClr val="FFFFFF"/>
+                    </a:solidFill>
+                  </a:tcPr>
+                </a:tc>
+                <a:tc>
+                  <a:txBody>
+                    <a:bodyPr wrap="square"/>
+                    <a:lstStyle/>
+                    <a:p>
+                      <a:pPr algn="r"/>
+                      <a:r>
+                        <a:rPr sz="900" b="0">
+                          <a:solidFill>
+                            <a:srgbClr val="1E2F5C"/>
+                          </a:solidFill>
+                          <a:latin typeface="Kanit"/>
+                        </a:rPr>
                         <a:t>29</a:t>
                       </a:r>
                     </a:p>
@@ -8202,13 +8225,13 @@
                     <a:p>
                       <a:pPr algn="r"/>
                       <a:r>
-                        <a:rPr sz="900" b="0">
-                          <a:solidFill>
-                            <a:srgbClr val="1E2F5C"/>
-                          </a:solidFill>
-                          <a:latin typeface="Kanit"/>
-                        </a:rPr>
-                        <a:t>14</a:t>
+                        <a:rPr sz="900" b="1">
+                          <a:solidFill>
+                            <a:srgbClr val="606060"/>
+                          </a:solidFill>
+                          <a:latin typeface="Kanit"/>
+                        </a:rPr>
+                        <a:t>0.0%</a:t>
                       </a:r>
                     </a:p>
                   </a:txBody>
@@ -8227,34 +8250,11 @@
                       <a:r>
                         <a:rPr sz="900" b="1">
                           <a:solidFill>
-                            <a:srgbClr val="606060"/>
-                          </a:solidFill>
-                          <a:latin typeface="Kanit"/>
-                        </a:rPr>
-                        <a:t>0.0%</a:t>
-                      </a:r>
-                    </a:p>
-                  </a:txBody>
-                  <a:tcPr marL="54864" marR="54864" marT="18288" marB="18288" anchor="ctr">
-                    <a:solidFill>
-                      <a:srgbClr val="FFFFFF"/>
-                    </a:solidFill>
-                  </a:tcPr>
-                </a:tc>
-                <a:tc>
-                  <a:txBody>
-                    <a:bodyPr wrap="square"/>
-                    <a:lstStyle/>
-                    <a:p>
-                      <a:pPr algn="r"/>
-                      <a:r>
-                        <a:rPr sz="900" b="1">
-                          <a:solidFill>
                             <a:srgbClr val="CC0000"/>
                           </a:solidFill>
                           <a:latin typeface="Kanit"/>
                         </a:rPr>
-                        <a:t>9/15</a:t>
+                        <a:t>7/13</a:t>
                       </a:r>
                     </a:p>
                   </a:txBody>
@@ -8302,7 +8302,7 @@
                           </a:solidFill>
                           <a:latin typeface="Kanit"/>
                         </a:rPr>
-                        <a:t>นราธิวาส</a:t>
+                        <a:t>สมุทรปราการ</a:t>
                       </a:r>
                     </a:p>
                   </a:txBody>
@@ -8325,7 +8325,7 @@
                           </a:solidFill>
                           <a:latin typeface="Kanit"/>
                         </a:rPr>
-                        <a:t>64</a:t>
+                        <a:t>16</a:t>
                       </a:r>
                     </a:p>
                   </a:txBody>
@@ -8348,7 +8348,7 @@
                           </a:solidFill>
                           <a:latin typeface="Kanit"/>
                         </a:rPr>
-                        <a:t>24</a:t>
+                        <a:t>0</a:t>
                       </a:r>
                     </a:p>
                   </a:txBody>
@@ -8394,7 +8394,7 @@
                           </a:solidFill>
                           <a:latin typeface="Kanit"/>
                         </a:rPr>
-                        <a:t>5/10</a:t>
+                        <a:t>4/5</a:t>
                       </a:r>
                     </a:p>
                   </a:txBody>
@@ -8442,7 +8442,7 @@
                           </a:solidFill>
                           <a:latin typeface="Kanit"/>
                         </a:rPr>
-                        <a:t>บึงกาฬ</a:t>
+                        <a:t>เลย</a:t>
                       </a:r>
                     </a:p>
                   </a:txBody>
@@ -8465,7 +8465,7 @@
                           </a:solidFill>
                           <a:latin typeface="Kanit"/>
                         </a:rPr>
-                        <a:t>11</a:t>
+                        <a:t>101</a:t>
                       </a:r>
                     </a:p>
                   </a:txBody>
@@ -8488,7 +8488,7 @@
                           </a:solidFill>
                           <a:latin typeface="Kanit"/>
                         </a:rPr>
-                        <a:t>20</a:t>
+                        <a:t>14</a:t>
                       </a:r>
                     </a:p>
                   </a:txBody>
@@ -8534,7 +8534,7 @@
                           </a:solidFill>
                           <a:latin typeface="Kanit"/>
                         </a:rPr>
-                        <a:t>1/1</a:t>
+                        <a:t>1/8</a:t>
                       </a:r>
                     </a:p>
                   </a:txBody>
@@ -8582,7 +8582,7 @@
                           </a:solidFill>
                           <a:latin typeface="Kanit"/>
                         </a:rPr>
-                        <a:t>มุกดาหาร</a:t>
+                        <a:t>บึงกาฬ</a:t>
                       </a:r>
                     </a:p>
                   </a:txBody>
@@ -8605,7 +8605,7 @@
                           </a:solidFill>
                           <a:latin typeface="Kanit"/>
                         </a:rPr>
-                        <a:t>18</a:t>
+                        <a:t>11</a:t>
                       </a:r>
                     </a:p>
                   </a:txBody>
@@ -8628,7 +8628,7 @@
                           </a:solidFill>
                           <a:latin typeface="Kanit"/>
                         </a:rPr>
-                        <a:t>16</a:t>
+                        <a:t>48</a:t>
                       </a:r>
                     </a:p>
                   </a:txBody>
@@ -8647,11 +8647,11 @@
                       <a:r>
                         <a:rPr sz="900" b="1">
                           <a:solidFill>
-                            <a:srgbClr val="606060"/>
-                          </a:solidFill>
-                          <a:latin typeface="Kanit"/>
-                        </a:rPr>
-                        <a:t>0.0%</a:t>
+                            <a:srgbClr val="F5C242"/>
+                          </a:solidFill>
+                          <a:latin typeface="Kanit"/>
+                        </a:rPr>
+                        <a:t>36.4%</a:t>
                       </a:r>
                     </a:p>
                   </a:txBody>
@@ -8674,7 +8674,7 @@
                           </a:solidFill>
                           <a:latin typeface="Kanit"/>
                         </a:rPr>
-                        <a:t>2/2</a:t>
+                        <a:t>1/1</a:t>
                       </a:r>
                     </a:p>
                   </a:txBody>
@@ -8693,11 +8693,11 @@
                       <a:r>
                         <a:rPr sz="900" b="1">
                           <a:solidFill>
-                            <a:srgbClr val="CC0000"/>
-                          </a:solidFill>
-                          <a:latin typeface="Kanit"/>
-                        </a:rPr>
-                        <a:t>5</a:t>
+                            <a:srgbClr val="F5C242"/>
+                          </a:solidFill>
+                          <a:latin typeface="Kanit"/>
+                        </a:rPr>
+                        <a:t>4</a:t>
                       </a:r>
                     </a:p>
                   </a:txBody>
@@ -8909,7 +8909,7 @@
                 </a:solidFill>
                 <a:latin typeface="Kanit"/>
               </a:rPr>
-              <a:t>พื้นที่ปลูก วัดจริง (สศก. — ข้อมูลอำเภอ×พืช 3,295 แถว) ภัยแล้งเป็นดัชนี SPEI จาก แบบจำลอง คำนวณจากปริมาณฝนและการคายระเหย ปรับเดือนละครั้ง ดึงข้อมูล 2026-07-20 — เป็นสัญญาณที่ครอบคลุมทั้งประเทศดีที่สุดที่มี แต่ไม่มีใครลงพื้นที่ไปเดินดูอำเภอเหล่านั้น ข้อมูลฝนและระดับน้ำ วัดจริง (ThaiWater เรียลไทม์ ดึงทุกวันและสะสมไว้ — วันที่ดึงไม่สำเร็จจะเว้นเป็นช่องว่าง ไม่ใส่ค่าสมมติ) · ฝนถึง 2026-08-11, ระดับน้ำถึง 2026-08-11 ความเสี่ยงน้ำท่วมเชิงโครงสร้าง วัดจริง (สำมะโนพื้นที่ท่วมซ้ำซาก GISTDA มาตราส่วน 1:50,000 ปี 2005-2016 — เป็นบันทึกภาคพื้นดิน 12 ปี ไม่ใช่การพยากรณ์)</a:t>
+              <a:t>พื้นที่ปลูก วัดจริง (สศก. — ข้อมูลอำเภอ×พืช 3,295 แถว) ภัยแล้งเป็นดัชนี SPEI จาก แบบจำลอง คำนวณจากปริมาณฝนและการคายระเหย ปรับเดือนละครั้ง ดึงข้อมูล 2026-07-20 — เป็นสัญญาณที่ครอบคลุมทั้งประเทศดีที่สุดที่มี แต่ไม่มีใครลงพื้นที่ไปเดินดูอำเภอเหล่านั้น ข้อมูลฝนและระดับน้ำ วัดจริง (ThaiWater เรียลไทม์ ดึงทุกวันและสะสมไว้ — วันที่ดึงไม่สำเร็จจะเว้นเป็นช่องว่าง ไม่ใส่ค่าสมมติ) · ฝนถึง 2026-08-14, ระดับน้ำถึง 2026-08-14 ความเสี่ยงน้ำท่วมเชิงโครงสร้าง วัดจริง (สำมะโนพื้นที่ท่วมซ้ำซาก GISTDA มาตราส่วน 1:50,000 ปี 2005-2016 — เป็นบันทึกภาคพื้นดิน 12 ปี ไม่ใช่การพยากรณ์)</a:t>
             </a:r>
           </a:p>
         </p:txBody>
@@ -31476,7 +31476,7 @@
                 </a:solidFill>
                 <a:latin typeface="Kanit"/>
               </a:rPr>
-              <a:t>รายได้จากพืชค่ากลางเพิ่มขึ้น +16.6% แต่มีสี่จังหวัดที่ลดลง — ทั้งหมดอยู่ในแหล่งปลูกมะพร้าว โดยหนักที่สุดคือสมุทรสงครามที่ −63.4%</a:t>
+              <a:t>รายได้จากพืชค่ากลางเพิ่มขึ้น +16.9% แต่มีสี่จังหวัดที่ลดลง — ทั้งหมดอยู่ในแหล่งปลูกมะพร้าว โดยหนักที่สุดคือสมุทรสงครามที่ −63.2%</a:t>
             </a:r>
           </a:p>
         </p:txBody>
@@ -32047,7 +32047,7 @@
                 </a:solidFill>
                 <a:latin typeface="Kanit"/>
               </a:rPr>
-              <a:t>รุ่นข้อมูล — ราคาโลก 2026M06 · ราคาหน้าฟาร์มไทย 2026-08-11 · ประวัติราคาไทย 2026-08-02 · ต้นทุนการผลิตพืช สศก. ไจอัป 2568 (ปีเพาะปลูก 2568/69, ประมาณการ สศก. มี.ค. 2569) · ภัยแล้ง 2026-06-21 · เงินเฟ้อ 2026-05 · GDP 2026 ไตรมาส 1 · IMF WEO 2026 · ดัชนีราคาขายต่อ 2026-05 · ยอดจดทะเบียนถึง 2026-01 · หนี้ครัวเรือน สสช. SES 2566 · ค่าจ้าง สสช. LFS 2568 · ข้อมูลตรวจวัด 2026-08-11</a:t>
+              <a:t>รุ่นข้อมูล — ราคาโลก 2026M06 · ราคาหน้าฟาร์มไทย 2026-08-13 · ประวัติราคาไทย 2026-08-02 · ต้นทุนการผลิตพืช สศก. ไจอัป 2568 (ปีเพาะปลูก 2568/69, ประมาณการ สศก. มี.ค. 2569) · ภัยแล้ง 2026-06-21 · เงินเฟ้อ 2026-05 · GDP 2026 ไตรมาส 1 · IMF WEO 2026 · ดัชนีราคาขายต่อ 2026-05 · ยอดจดทะเบียนถึง 2026-01 · หนี้ครัวเรือน สสช. SES 2566 · ค่าจ้าง สสช. LFS 2568 · ข้อมูลตรวจวัด 2026-08-14</a:t>
             </a:r>
           </a:p>
         </p:txBody>
@@ -32546,7 +32546,7 @@
               <a:t>Not on the world index — the farm gate (ราคาที่เกษตรกรขายได้) says otherwise.
 • Five of seventeen Thai farm-gate prices are falling year on year.
 • Beef: farm gate −6.1% vs world index +11.8%.
-• Margin over price: a 26% price move becomes an 85% swing in crop income.</a:t>
+• Margin over price: a 26% price move becomes an 87% swing in crop income.</a:t>
             </a:r>
           </a:p>
         </p:txBody>
@@ -37087,7 +37087,7 @@
                 </a:solidFill>
                 <a:latin typeface="Kanit"/>
               </a:rPr>
-              <a:t>338 จาก 928 อำเภอ · แม่น้ำเกินระดับ 155 จาก 794 สถานี</a:t>
+              <a:t>338 จาก 928 อำเภอ · แม่น้ำเกินระดับ 129 จาก 795 สถานี</a:t>
             </a:r>
           </a:p>
         </p:txBody>
@@ -37859,7 +37859,7 @@
                           </a:solidFill>
                           <a:latin typeface="Kanit"/>
                         </a:rPr>
-                        <a:t>39/158</a:t>
+                        <a:t>33/157</a:t>
                       </a:r>
                     </a:p>
                   </a:txBody>
@@ -38091,7 +38091,7 @@
                           </a:solidFill>
                           <a:latin typeface="Kanit"/>
                         </a:rPr>
-                        <a:t>41/273</a:t>
+                        <a:t>23/274</a:t>
                       </a:r>
                     </a:p>
                   </a:txBody>
@@ -38323,7 +38323,7 @@
                           </a:solidFill>
                           <a:latin typeface="Kanit"/>
                         </a:rPr>
-                        <a:t>24/168</a:t>
+                        <a:t>27/168</a:t>
                       </a:r>
                     </a:p>
                   </a:txBody>
@@ -38787,7 +38787,7 @@
                           </a:solidFill>
                           <a:latin typeface="Kanit"/>
                         </a:rPr>
-                        <a:t>45/143</a:t>
+                        <a:t>40/144</a:t>
                       </a:r>
                     </a:p>
                   </a:txBody>
@@ -39936,7 +39936,7 @@
                           </a:solidFill>
                           <a:latin typeface="Kanit"/>
                         </a:rPr>
-                        <a:t>−67.8%</a:t>
+                        <a:t>−67.6%</a:t>
                       </a:r>
                     </a:p>
                   </a:txBody>
@@ -40791,7 +40791,7 @@
                 </a:solidFill>
                 <a:latin typeface="Kanit"/>
               </a:rPr>
-              <a:t>ราคา วัดจริง — ราคาหน้าฟาร์มไทยจากราคารายวันของ NABC และราคาอ้อยประกาศของ สอน. ราคาล่าสุด 2026-08-11 การเปลี่ยนแปลงหกเดือนคำนวณจากข้อมูลรายเดือนของ NABC เอง (thai_price_history รุ่นข้อมูล 2026-08-02) พืชที่ไม่มีข้อมูลรายเดือนจะกำกับไว้ ไม่ประมาณการขึ้นมา แหล่งผลิตเป็นการอ่านแบบ ประมาณการ ว่าสินค้าแต่ละชนิดปลูกที่ไหน และแหล่งผลิตทับซ้อนกันได้ บัญชีอาชีพเกษตรเป็นข้อมูลของเราเองและ วัดจริง — บัญชีที่บันทึกอาชีพว่า เกษตร ในจังหวัดแหล่งผลิต จากฐานข้อมูล 382,735 บัญชี ณ 2026-07 ไม่เผยแพร่ช่องที่มีน้อยกว่า 30 บัญชี คนกลุ่มนี้อาศัยอยู่ในพื้นที่ที่ปลูกพืชนั้น แต่ไม่ได้ยืนยันว่าปลูกพืชนั้นเอง</a:t>
+              <a:t>ราคา วัดจริง — ราคาหน้าฟาร์มไทยจากราคารายวันของ NABC และราคาอ้อยประกาศของ สอน. ราคาล่าสุด 2026-08-13 การเปลี่ยนแปลงหกเดือนคำนวณจากข้อมูลรายเดือนของ NABC เอง (thai_price_history รุ่นข้อมูล 2026-08-02) พืชที่ไม่มีข้อมูลรายเดือนจะกำกับไว้ ไม่ประมาณการขึ้นมา แหล่งผลิตเป็นการอ่านแบบ ประมาณการ ว่าสินค้าแต่ละชนิดปลูกที่ไหน และแหล่งผลิตทับซ้อนกันได้ บัญชีอาชีพเกษตรเป็นข้อมูลของเราเองและ วัดจริง — บัญชีที่บันทึกอาชีพว่า เกษตร ในจังหวัดแหล่งผลิต จากฐานข้อมูล 382,735 บัญชี ณ 2026-07 ไม่เผยแพร่ช่องที่มีน้อยกว่า 30 บัญชี คนกลุ่มนี้อาศัยอยู่ในพื้นที่ที่ปลูกพืชนั้น แต่ไม่ได้ยืนยันว่าปลูกพืชนั้นเอง</a:t>
             </a:r>
           </a:p>
         </p:txBody>
@@ -44679,7 +44679,7 @@
                 </a:solidFill>
                 <a:latin typeface="Kanit"/>
               </a:rPr>
-              <a:t>มะพร้าว −67.8% สับปะรด −18.4% อ้อย −17.9% เทียบปีก่อน</a:t>
+              <a:t>มะพร้าว −67.6% สับปะรด −18.4% อ้อย −17.9% เทียบปีก่อน</a:t>
             </a:r>
           </a:p>
         </p:txBody>
@@ -44805,7 +44805,7 @@
                 </a:solidFill>
                 <a:latin typeface="Kanit"/>
               </a:rPr>
-              <a:t>+16.6%</a:t>
+              <a:t>+16.9%</a:t>
             </a:r>
           </a:p>
         </p:txBody>
@@ -45279,7 +45279,7 @@
                           </a:solidFill>
                           <a:latin typeface="Kanit"/>
                         </a:rPr>
-                        <a:t>+6.5%</a:t>
+                        <a:t>+6.7%</a:t>
                       </a:r>
                     </a:p>
                   </a:txBody>
@@ -45348,7 +45348,7 @@
                           </a:solidFill>
                           <a:latin typeface="Kanit"/>
                         </a:rPr>
-                        <a:t>-63.4%</a:t>
+                        <a:t>-63.2%</a:t>
                       </a:r>
                     </a:p>
                   </a:txBody>
@@ -45419,7 +45419,7 @@
                           </a:solidFill>
                           <a:latin typeface="Kanit"/>
                         </a:rPr>
-                        <a:t>+15.3%</a:t>
+                        <a:t>+15.6%</a:t>
                       </a:r>
                     </a:p>
                   </a:txBody>
@@ -45488,7 +45488,7 @@
                           </a:solidFill>
                           <a:latin typeface="Kanit"/>
                         </a:rPr>
-                        <a:t>+9.8%</a:t>
+                        <a:t>+10.0%</a:t>
                       </a:r>
                     </a:p>
                   </a:txBody>
@@ -45559,7 +45559,7 @@
                           </a:solidFill>
                           <a:latin typeface="Kanit"/>
                         </a:rPr>
-                        <a:t>+16.7%</a:t>
+                        <a:t>+16.8%</a:t>
                       </a:r>
                     </a:p>
                   </a:txBody>
@@ -45628,7 +45628,7 @@
                           </a:solidFill>
                           <a:latin typeface="Kanit"/>
                         </a:rPr>
-                        <a:t>+8.6%</a:t>
+                        <a:t>+8.7%</a:t>
                       </a:r>
                     </a:p>
                   </a:txBody>
@@ -45699,7 +45699,7 @@
                           </a:solidFill>
                           <a:latin typeface="Kanit"/>
                         </a:rPr>
-                        <a:t>+25.8%</a:t>
+                        <a:t>+26.0%</a:t>
                       </a:r>
                     </a:p>
                   </a:txBody>
@@ -45768,7 +45768,7 @@
                           </a:solidFill>
                           <a:latin typeface="Kanit"/>
                         </a:rPr>
-                        <a:t>+10.7%</a:t>
+                        <a:t>+10.8%</a:t>
                       </a:r>
                     </a:p>
                   </a:txBody>
@@ -45839,7 +45839,7 @@
                           </a:solidFill>
                           <a:latin typeface="Kanit"/>
                         </a:rPr>
-                        <a:t>+36.5%</a:t>
+                        <a:t>+36.7%</a:t>
                       </a:r>
                     </a:p>
                   </a:txBody>
@@ -45908,7 +45908,7 @@
                           </a:solidFill>
                           <a:latin typeface="Kanit"/>
                         </a:rPr>
-                        <a:t>+29.0%</a:t>
+                        <a:t>+28.8%</a:t>
                       </a:r>
                     </a:p>
                   </a:txBody>
@@ -46387,7 +46387,7 @@
                           </a:solidFill>
                           <a:latin typeface="Kanit"/>
                         </a:rPr>
-                        <a:t>+16.7%</a:t>
+                        <a:t>+16.9%</a:t>
                       </a:r>
                     </a:p>
                   </a:txBody>
@@ -46550,7 +46550,7 @@
                           </a:solidFill>
                           <a:latin typeface="Kanit"/>
                         </a:rPr>
-                        <a:t>+21.1%</a:t>
+                        <a:t>+21.3%</a:t>
                       </a:r>
                     </a:p>
                   </a:txBody>
@@ -46713,7 +46713,7 @@
                           </a:solidFill>
                           <a:latin typeface="Kanit"/>
                         </a:rPr>
-                        <a:t>+10.9%</a:t>
+                        <a:t>+11.2%</a:t>
                       </a:r>
                     </a:p>
                   </a:txBody>
@@ -47039,7 +47039,7 @@
                           </a:solidFill>
                           <a:latin typeface="Kanit"/>
                         </a:rPr>
-                        <a:t>+16.8%</a:t>
+                        <a:t>+16.9%</a:t>
                       </a:r>
                     </a:p>
                   </a:txBody>
@@ -47202,7 +47202,7 @@
                           </a:solidFill>
                           <a:latin typeface="Kanit"/>
                         </a:rPr>
-                        <a:t>+15.5%</a:t>
+                        <a:t>+15.6%</a:t>
                       </a:r>
                     </a:p>
                   </a:txBody>
@@ -48024,7 +48024,7 @@
                 </a:solidFill>
                 <a:latin typeface="Kanit"/>
               </a:rPr>
-              <a:t>เทียบปีก่อน −67.8%</a:t>
+              <a:t>เทียบปีก่อน −67.6%</a:t>
             </a:r>
           </a:p>
         </p:txBody>
@@ -48660,7 +48660,7 @@
                 </a:solidFill>
                 <a:latin typeface="Kanit"/>
               </a:rPr>
-              <a:t>เทียบปีก่อน +0.3%</a:t>
+              <a:t>เทียบปีก่อน +0.7%</a:t>
             </a:r>
           </a:p>
         </p:txBody>
@@ -48900,6 +48900,324 @@
                 </a:solidFill>
                 <a:latin typeface="Kanit"/>
               </a:rPr>
+              <a:t>กุ้งขาว</a:t>
+            </a:r>
+          </a:p>
+        </p:txBody>
+      </p:sp>
+      <p:sp>
+        <p:nvSpPr>
+          <p:cNvPr id="37" name="TextBox 36"/>
+          <p:cNvSpPr txBox="1"/>
+          <p:nvPr/>
+        </p:nvSpPr>
+        <p:spPr>
+          <a:xfrm>
+            <a:off x="7318857" y="2112263"/>
+            <a:ext cx="2156155" cy="125730"/>
+          </a:xfrm>
+          <a:prstGeom prst="rect">
+            <a:avLst/>
+          </a:prstGeom>
+          <a:noFill/>
+        </p:spPr>
+        <p:txBody>
+          <a:bodyPr wrap="square" lIns="0" rIns="0" tIns="0" bIns="0" anchor="t">
+            <a:noAutofit/>
+          </a:bodyPr>
+          <a:lstStyle/>
+          <a:p>
+            <a:pPr algn="l">
+              <a:lnSpc>
+                <a:spcPts val="990"/>
+              </a:lnSpc>
+            </a:pPr>
+            <a:r>
+              <a:rPr sz="750" b="0">
+                <a:solidFill>
+                  <a:srgbClr val="606060"/>
+                </a:solidFill>
+                <a:latin typeface="Kanit"/>
+              </a:rPr>
+              <a:t>฿133.82 /กก. · ชายฝั่งใต้·ตอ.</a:t>
+            </a:r>
+          </a:p>
+        </p:txBody>
+      </p:sp>
+      <p:sp>
+        <p:nvSpPr>
+          <p:cNvPr id="38" name="TextBox 37"/>
+          <p:cNvSpPr txBox="1"/>
+          <p:nvPr/>
+        </p:nvSpPr>
+        <p:spPr>
+          <a:xfrm>
+            <a:off x="7318857" y="2244851"/>
+            <a:ext cx="1078077" cy="134112"/>
+          </a:xfrm>
+          <a:prstGeom prst="rect">
+            <a:avLst/>
+          </a:prstGeom>
+          <a:noFill/>
+        </p:spPr>
+        <p:txBody>
+          <a:bodyPr wrap="square" lIns="0" rIns="0" tIns="0" bIns="0" anchor="t">
+            <a:noAutofit/>
+          </a:bodyPr>
+          <a:lstStyle/>
+          <a:p>
+            <a:pPr algn="l">
+              <a:lnSpc>
+                <a:spcPts val="1056"/>
+              </a:lnSpc>
+            </a:pPr>
+            <a:r>
+              <a:rPr sz="800" b="1">
+                <a:solidFill>
+                  <a:srgbClr val="15795F"/>
+                </a:solidFill>
+                <a:latin typeface="Kanit"/>
+              </a:rPr>
+              <a:t>เทียบปีก่อน +1.1%</a:t>
+            </a:r>
+          </a:p>
+        </p:txBody>
+      </p:sp>
+      <p:sp>
+        <p:nvSpPr>
+          <p:cNvPr id="39" name="TextBox 38"/>
+          <p:cNvSpPr txBox="1"/>
+          <p:nvPr/>
+        </p:nvSpPr>
+        <p:spPr>
+          <a:xfrm>
+            <a:off x="8396935" y="2244851"/>
+            <a:ext cx="1078077" cy="134112"/>
+          </a:xfrm>
+          <a:prstGeom prst="rect">
+            <a:avLst/>
+          </a:prstGeom>
+          <a:noFill/>
+        </p:spPr>
+        <p:txBody>
+          <a:bodyPr wrap="square" lIns="0" rIns="0" tIns="0" bIns="0" anchor="t">
+            <a:noAutofit/>
+          </a:bodyPr>
+          <a:lstStyle/>
+          <a:p>
+            <a:pPr algn="l">
+              <a:lnSpc>
+                <a:spcPts val="1056"/>
+              </a:lnSpc>
+            </a:pPr>
+            <a:r>
+              <a:rPr sz="800" b="1">
+                <a:solidFill>
+                  <a:srgbClr val="CC0000"/>
+                </a:solidFill>
+                <a:latin typeface="Kanit"/>
+              </a:rPr>
+              <a:t>6 เดือน −15.8%</a:t>
+            </a:r>
+          </a:p>
+        </p:txBody>
+      </p:sp>
+      <p:sp>
+        <p:nvSpPr>
+          <p:cNvPr id="40" name="Rectangle 39"/>
+          <p:cNvSpPr/>
+          <p:nvPr/>
+        </p:nvSpPr>
+        <p:spPr>
+          <a:xfrm>
+            <a:off x="7318857" y="2400300"/>
+            <a:ext cx="2156155" cy="548640"/>
+          </a:xfrm>
+          <a:prstGeom prst="rect">
+            <a:avLst/>
+          </a:prstGeom>
+          <a:solidFill>
+            <a:srgbClr val="FBFCFE"/>
+          </a:solidFill>
+          <a:ln w="9525">
+            <a:solidFill>
+              <a:srgbClr val="D9DEE9"/>
+            </a:solidFill>
+          </a:ln>
+          <a:effectLst/>
+        </p:spPr>
+        <p:style>
+          <a:lnRef idx="1">
+            <a:schemeClr val="accent1"/>
+          </a:lnRef>
+          <a:fillRef idx="3">
+            <a:schemeClr val="accent1"/>
+          </a:fillRef>
+          <a:effectRef idx="2">
+            <a:schemeClr val="accent1"/>
+          </a:effectRef>
+          <a:fontRef idx="minor">
+            <a:schemeClr val="lt1"/>
+          </a:fontRef>
+        </p:style>
+        <p:txBody>
+          <a:bodyPr rtlCol="0" anchor="ctr" wrap="none"/>
+          <a:lstStyle/>
+          <a:p>
+            <a:pPr algn="ctr"/>
+          </a:p>
+        </p:txBody>
+      </p:sp>
+      <p:sp>
+        <p:nvSpPr>
+          <p:cNvPr id="41" name="Freeform 40"/>
+          <p:cNvSpPr/>
+          <p:nvPr/>
+        </p:nvSpPr>
+        <p:spPr>
+          <a:xfrm>
+            <a:off x="7364577" y="2446020"/>
+            <a:ext cx="2064715" cy="457200"/>
+          </a:xfrm>
+          <a:custGeom>
+            <a:avLst/>
+            <a:gdLst/>
+            <a:ahLst/>
+            <a:cxnLst/>
+            <a:rect l="l" t="t" r="r" b="b"/>
+            <a:pathLst>
+              <a:path w="2064715" h="457200">
+                <a:moveTo>
+                  <a:pt x="0" y="0"/>
+                </a:moveTo>
+                <a:lnTo>
+                  <a:pt x="412943" y="247179"/>
+                </a:lnTo>
+                <a:lnTo>
+                  <a:pt x="825886" y="420769"/>
+                </a:lnTo>
+                <a:lnTo>
+                  <a:pt x="1238829" y="457200"/>
+                </a:lnTo>
+                <a:lnTo>
+                  <a:pt x="1651772" y="424594"/>
+                </a:lnTo>
+                <a:lnTo>
+                  <a:pt x="2064715" y="223135"/>
+                </a:lnTo>
+              </a:path>
+            </a:pathLst>
+          </a:custGeom>
+          <a:noFill/>
+          <a:ln w="20320">
+            <a:solidFill>
+              <a:srgbClr val="CC0000"/>
+            </a:solidFill>
+          </a:ln>
+          <a:effectLst/>
+        </p:spPr>
+        <p:style>
+          <a:lnRef idx="1">
+            <a:schemeClr val="accent1"/>
+          </a:lnRef>
+          <a:fillRef idx="3">
+            <a:schemeClr val="accent1"/>
+          </a:fillRef>
+          <a:effectRef idx="2">
+            <a:schemeClr val="accent1"/>
+          </a:effectRef>
+          <a:fontRef idx="minor">
+            <a:schemeClr val="lt1"/>
+          </a:fontRef>
+        </p:style>
+        <p:txBody>
+          <a:bodyPr rtlCol="0" anchor="ctr"/>
+          <a:lstStyle/>
+          <a:p>
+            <a:pPr algn="ctr"/>
+          </a:p>
+        </p:txBody>
+      </p:sp>
+      <p:sp>
+        <p:nvSpPr>
+          <p:cNvPr id="42" name="Rounded Rectangle 41"/>
+          <p:cNvSpPr/>
+          <p:nvPr/>
+        </p:nvSpPr>
+        <p:spPr>
+          <a:xfrm>
+            <a:off x="9388144" y="2628007"/>
+            <a:ext cx="82296" cy="82296"/>
+          </a:xfrm>
+          <a:prstGeom prst="roundRect">
+            <a:avLst>
+              <a:gd name="adj" fmla="val 50000"/>
+            </a:avLst>
+          </a:prstGeom>
+          <a:solidFill>
+            <a:srgbClr val="CC0000"/>
+          </a:solidFill>
+          <a:ln>
+            <a:noFill/>
+          </a:ln>
+          <a:effectLst/>
+        </p:spPr>
+        <p:style>
+          <a:lnRef idx="1">
+            <a:schemeClr val="accent1"/>
+          </a:lnRef>
+          <a:fillRef idx="3">
+            <a:schemeClr val="accent1"/>
+          </a:fillRef>
+          <a:effectRef idx="2">
+            <a:schemeClr val="accent1"/>
+          </a:effectRef>
+          <a:fontRef idx="minor">
+            <a:schemeClr val="lt1"/>
+          </a:fontRef>
+        </p:style>
+        <p:txBody>
+          <a:bodyPr rtlCol="0" anchor="ctr" wrap="none"/>
+          <a:lstStyle/>
+          <a:p>
+            <a:pPr algn="ctr"/>
+          </a:p>
+        </p:txBody>
+      </p:sp>
+      <p:sp>
+        <p:nvSpPr>
+          <p:cNvPr id="43" name="TextBox 42"/>
+          <p:cNvSpPr txBox="1"/>
+          <p:nvPr/>
+        </p:nvSpPr>
+        <p:spPr>
+          <a:xfrm>
+            <a:off x="9621316" y="1970531"/>
+            <a:ext cx="2156155" cy="150876"/>
+          </a:xfrm>
+          <a:prstGeom prst="rect">
+            <a:avLst/>
+          </a:prstGeom>
+          <a:noFill/>
+        </p:spPr>
+        <p:txBody>
+          <a:bodyPr wrap="square" lIns="0" rIns="0" tIns="0" bIns="0" anchor="t">
+            <a:noAutofit/>
+          </a:bodyPr>
+          <a:lstStyle/>
+          <a:p>
+            <a:pPr algn="l">
+              <a:lnSpc>
+                <a:spcPts val="1188"/>
+              </a:lnSpc>
+            </a:pPr>
+            <a:r>
+              <a:rPr sz="900" b="1">
+                <a:solidFill>
+                  <a:srgbClr val="1E2F5C"/>
+                </a:solidFill>
+                <a:latin typeface="Kanit"/>
+              </a:rPr>
               <a:t>สุกร</a:t>
             </a:r>
           </a:p>
@@ -48907,13 +49225,13 @@
       </p:sp>
       <p:sp>
         <p:nvSpPr>
-          <p:cNvPr id="37" name="TextBox 36"/>
+          <p:cNvPr id="44" name="TextBox 43"/>
           <p:cNvSpPr txBox="1"/>
           <p:nvPr/>
         </p:nvSpPr>
         <p:spPr>
           <a:xfrm>
-            <a:off x="7318857" y="2112263"/>
+            <a:off x="9621316" y="2112263"/>
             <a:ext cx="2156155" cy="125730"/>
           </a:xfrm>
           <a:prstGeom prst="rect">
@@ -48946,13 +49264,13 @@
       </p:sp>
       <p:sp>
         <p:nvSpPr>
-          <p:cNvPr id="38" name="TextBox 37"/>
+          <p:cNvPr id="45" name="TextBox 44"/>
           <p:cNvSpPr txBox="1"/>
           <p:nvPr/>
         </p:nvSpPr>
         <p:spPr>
           <a:xfrm>
-            <a:off x="7318857" y="2244851"/>
+            <a:off x="9621316" y="2244851"/>
             <a:ext cx="1078077" cy="134112"/>
           </a:xfrm>
           <a:prstGeom prst="rect">
@@ -48978,20 +49296,20 @@
                 </a:solidFill>
                 <a:latin typeface="Kanit"/>
               </a:rPr>
-              <a:t>เทียบปีก่อน +0.3%</a:t>
+              <a:t>เทียบปีก่อน +1.5%</a:t>
             </a:r>
           </a:p>
         </p:txBody>
       </p:sp>
       <p:sp>
         <p:nvSpPr>
-          <p:cNvPr id="39" name="TextBox 38"/>
+          <p:cNvPr id="46" name="TextBox 45"/>
           <p:cNvSpPr txBox="1"/>
           <p:nvPr/>
         </p:nvSpPr>
         <p:spPr>
           <a:xfrm>
-            <a:off x="8396935" y="2244851"/>
+            <a:off x="10699394" y="2244851"/>
             <a:ext cx="1078077" cy="134112"/>
           </a:xfrm>
           <a:prstGeom prst="rect">
@@ -49024,13 +49342,13 @@
       </p:sp>
       <p:sp>
         <p:nvSpPr>
-          <p:cNvPr id="40" name="Rectangle 39"/>
+          <p:cNvPr id="47" name="Rectangle 46"/>
           <p:cNvSpPr/>
           <p:nvPr/>
         </p:nvSpPr>
         <p:spPr>
           <a:xfrm>
-            <a:off x="7318857" y="2400300"/>
+            <a:off x="9621316" y="2400300"/>
             <a:ext cx="2156155" cy="548640"/>
           </a:xfrm>
           <a:prstGeom prst="rect">
@@ -49070,13 +49388,13 @@
       </p:sp>
       <p:sp>
         <p:nvSpPr>
-          <p:cNvPr id="41" name="Freeform 40"/>
+          <p:cNvPr id="48" name="Freeform 47"/>
           <p:cNvSpPr/>
           <p:nvPr/>
         </p:nvSpPr>
         <p:spPr>
           <a:xfrm>
-            <a:off x="7364577" y="2446020"/>
+            <a:off x="9667036" y="2446020"/>
             <a:ext cx="2064715" cy="457200"/>
           </a:xfrm>
           <a:custGeom>
@@ -49140,13 +49458,13 @@
       </p:sp>
       <p:sp>
         <p:nvSpPr>
-          <p:cNvPr id="42" name="Rounded Rectangle 41"/>
+          <p:cNvPr id="49" name="Rounded Rectangle 48"/>
           <p:cNvSpPr/>
           <p:nvPr/>
         </p:nvSpPr>
         <p:spPr>
           <a:xfrm>
-            <a:off x="9388144" y="2457891"/>
+            <a:off x="11690603" y="2457891"/>
             <a:ext cx="82296" cy="82296"/>
           </a:xfrm>
           <a:prstGeom prst="roundRect">
@@ -49156,324 +49474,6 @@
           </a:prstGeom>
           <a:solidFill>
             <a:srgbClr val="15795F"/>
-          </a:solidFill>
-          <a:ln>
-            <a:noFill/>
-          </a:ln>
-          <a:effectLst/>
-        </p:spPr>
-        <p:style>
-          <a:lnRef idx="1">
-            <a:schemeClr val="accent1"/>
-          </a:lnRef>
-          <a:fillRef idx="3">
-            <a:schemeClr val="accent1"/>
-          </a:fillRef>
-          <a:effectRef idx="2">
-            <a:schemeClr val="accent1"/>
-          </a:effectRef>
-          <a:fontRef idx="minor">
-            <a:schemeClr val="lt1"/>
-          </a:fontRef>
-        </p:style>
-        <p:txBody>
-          <a:bodyPr rtlCol="0" anchor="ctr" wrap="none"/>
-          <a:lstStyle/>
-          <a:p>
-            <a:pPr algn="ctr"/>
-          </a:p>
-        </p:txBody>
-      </p:sp>
-      <p:sp>
-        <p:nvSpPr>
-          <p:cNvPr id="43" name="TextBox 42"/>
-          <p:cNvSpPr txBox="1"/>
-          <p:nvPr/>
-        </p:nvSpPr>
-        <p:spPr>
-          <a:xfrm>
-            <a:off x="9621316" y="1970531"/>
-            <a:ext cx="2156155" cy="150876"/>
-          </a:xfrm>
-          <a:prstGeom prst="rect">
-            <a:avLst/>
-          </a:prstGeom>
-          <a:noFill/>
-        </p:spPr>
-        <p:txBody>
-          <a:bodyPr wrap="square" lIns="0" rIns="0" tIns="0" bIns="0" anchor="t">
-            <a:noAutofit/>
-          </a:bodyPr>
-          <a:lstStyle/>
-          <a:p>
-            <a:pPr algn="l">
-              <a:lnSpc>
-                <a:spcPts val="1188"/>
-              </a:lnSpc>
-            </a:pPr>
-            <a:r>
-              <a:rPr sz="900" b="1">
-                <a:solidFill>
-                  <a:srgbClr val="1E2F5C"/>
-                </a:solidFill>
-                <a:latin typeface="Kanit"/>
-              </a:rPr>
-              <a:t>กุ้งขาว</a:t>
-            </a:r>
-          </a:p>
-        </p:txBody>
-      </p:sp>
-      <p:sp>
-        <p:nvSpPr>
-          <p:cNvPr id="44" name="TextBox 43"/>
-          <p:cNvSpPr txBox="1"/>
-          <p:nvPr/>
-        </p:nvSpPr>
-        <p:spPr>
-          <a:xfrm>
-            <a:off x="9621316" y="2112263"/>
-            <a:ext cx="2156155" cy="125730"/>
-          </a:xfrm>
-          <a:prstGeom prst="rect">
-            <a:avLst/>
-          </a:prstGeom>
-          <a:noFill/>
-        </p:spPr>
-        <p:txBody>
-          <a:bodyPr wrap="square" lIns="0" rIns="0" tIns="0" bIns="0" anchor="t">
-            <a:noAutofit/>
-          </a:bodyPr>
-          <a:lstStyle/>
-          <a:p>
-            <a:pPr algn="l">
-              <a:lnSpc>
-                <a:spcPts val="990"/>
-              </a:lnSpc>
-            </a:pPr>
-            <a:r>
-              <a:rPr sz="750" b="0">
-                <a:solidFill>
-                  <a:srgbClr val="606060"/>
-                </a:solidFill>
-                <a:latin typeface="Kanit"/>
-              </a:rPr>
-              <a:t>฿133.82 /กก. · ชายฝั่งใต้·ตอ.</a:t>
-            </a:r>
-          </a:p>
-        </p:txBody>
-      </p:sp>
-      <p:sp>
-        <p:nvSpPr>
-          <p:cNvPr id="45" name="TextBox 44"/>
-          <p:cNvSpPr txBox="1"/>
-          <p:nvPr/>
-        </p:nvSpPr>
-        <p:spPr>
-          <a:xfrm>
-            <a:off x="9621316" y="2244851"/>
-            <a:ext cx="1078077" cy="134112"/>
-          </a:xfrm>
-          <a:prstGeom prst="rect">
-            <a:avLst/>
-          </a:prstGeom>
-          <a:noFill/>
-        </p:spPr>
-        <p:txBody>
-          <a:bodyPr wrap="square" lIns="0" rIns="0" tIns="0" bIns="0" anchor="t">
-            <a:noAutofit/>
-          </a:bodyPr>
-          <a:lstStyle/>
-          <a:p>
-            <a:pPr algn="l">
-              <a:lnSpc>
-                <a:spcPts val="1056"/>
-              </a:lnSpc>
-            </a:pPr>
-            <a:r>
-              <a:rPr sz="800" b="1">
-                <a:solidFill>
-                  <a:srgbClr val="15795F"/>
-                </a:solidFill>
-                <a:latin typeface="Kanit"/>
-              </a:rPr>
-              <a:t>เทียบปีก่อน +0.6%</a:t>
-            </a:r>
-          </a:p>
-        </p:txBody>
-      </p:sp>
-      <p:sp>
-        <p:nvSpPr>
-          <p:cNvPr id="46" name="TextBox 45"/>
-          <p:cNvSpPr txBox="1"/>
-          <p:nvPr/>
-        </p:nvSpPr>
-        <p:spPr>
-          <a:xfrm>
-            <a:off x="10699394" y="2244851"/>
-            <a:ext cx="1078077" cy="134112"/>
-          </a:xfrm>
-          <a:prstGeom prst="rect">
-            <a:avLst/>
-          </a:prstGeom>
-          <a:noFill/>
-        </p:spPr>
-        <p:txBody>
-          <a:bodyPr wrap="square" lIns="0" rIns="0" tIns="0" bIns="0" anchor="t">
-            <a:noAutofit/>
-          </a:bodyPr>
-          <a:lstStyle/>
-          <a:p>
-            <a:pPr algn="l">
-              <a:lnSpc>
-                <a:spcPts val="1056"/>
-              </a:lnSpc>
-            </a:pPr>
-            <a:r>
-              <a:rPr sz="800" b="1">
-                <a:solidFill>
-                  <a:srgbClr val="CC0000"/>
-                </a:solidFill>
-                <a:latin typeface="Kanit"/>
-              </a:rPr>
-              <a:t>6 เดือน −15.8%</a:t>
-            </a:r>
-          </a:p>
-        </p:txBody>
-      </p:sp>
-      <p:sp>
-        <p:nvSpPr>
-          <p:cNvPr id="47" name="Rectangle 46"/>
-          <p:cNvSpPr/>
-          <p:nvPr/>
-        </p:nvSpPr>
-        <p:spPr>
-          <a:xfrm>
-            <a:off x="9621316" y="2400300"/>
-            <a:ext cx="2156155" cy="548640"/>
-          </a:xfrm>
-          <a:prstGeom prst="rect">
-            <a:avLst/>
-          </a:prstGeom>
-          <a:solidFill>
-            <a:srgbClr val="FBFCFE"/>
-          </a:solidFill>
-          <a:ln w="9525">
-            <a:solidFill>
-              <a:srgbClr val="D9DEE9"/>
-            </a:solidFill>
-          </a:ln>
-          <a:effectLst/>
-        </p:spPr>
-        <p:style>
-          <a:lnRef idx="1">
-            <a:schemeClr val="accent1"/>
-          </a:lnRef>
-          <a:fillRef idx="3">
-            <a:schemeClr val="accent1"/>
-          </a:fillRef>
-          <a:effectRef idx="2">
-            <a:schemeClr val="accent1"/>
-          </a:effectRef>
-          <a:fontRef idx="minor">
-            <a:schemeClr val="lt1"/>
-          </a:fontRef>
-        </p:style>
-        <p:txBody>
-          <a:bodyPr rtlCol="0" anchor="ctr" wrap="none"/>
-          <a:lstStyle/>
-          <a:p>
-            <a:pPr algn="ctr"/>
-          </a:p>
-        </p:txBody>
-      </p:sp>
-      <p:sp>
-        <p:nvSpPr>
-          <p:cNvPr id="48" name="Freeform 47"/>
-          <p:cNvSpPr/>
-          <p:nvPr/>
-        </p:nvSpPr>
-        <p:spPr>
-          <a:xfrm>
-            <a:off x="9667036" y="2446020"/>
-            <a:ext cx="2064715" cy="457200"/>
-          </a:xfrm>
-          <a:custGeom>
-            <a:avLst/>
-            <a:gdLst/>
-            <a:ahLst/>
-            <a:cxnLst/>
-            <a:rect l="l" t="t" r="r" b="b"/>
-            <a:pathLst>
-              <a:path w="2064715" h="457200">
-                <a:moveTo>
-                  <a:pt x="0" y="0"/>
-                </a:moveTo>
-                <a:lnTo>
-                  <a:pt x="412943" y="247179"/>
-                </a:lnTo>
-                <a:lnTo>
-                  <a:pt x="825886" y="420769"/>
-                </a:lnTo>
-                <a:lnTo>
-                  <a:pt x="1238829" y="457200"/>
-                </a:lnTo>
-                <a:lnTo>
-                  <a:pt x="1651772" y="424594"/>
-                </a:lnTo>
-                <a:lnTo>
-                  <a:pt x="2064715" y="223135"/>
-                </a:lnTo>
-              </a:path>
-            </a:pathLst>
-          </a:custGeom>
-          <a:noFill/>
-          <a:ln w="20320">
-            <a:solidFill>
-              <a:srgbClr val="CC0000"/>
-            </a:solidFill>
-          </a:ln>
-          <a:effectLst/>
-        </p:spPr>
-        <p:style>
-          <a:lnRef idx="1">
-            <a:schemeClr val="accent1"/>
-          </a:lnRef>
-          <a:fillRef idx="3">
-            <a:schemeClr val="accent1"/>
-          </a:fillRef>
-          <a:effectRef idx="2">
-            <a:schemeClr val="accent1"/>
-          </a:effectRef>
-          <a:fontRef idx="minor">
-            <a:schemeClr val="lt1"/>
-          </a:fontRef>
-        </p:style>
-        <p:txBody>
-          <a:bodyPr rtlCol="0" anchor="ctr"/>
-          <a:lstStyle/>
-          <a:p>
-            <a:pPr algn="ctr"/>
-          </a:p>
-        </p:txBody>
-      </p:sp>
-      <p:sp>
-        <p:nvSpPr>
-          <p:cNvPr id="49" name="Rounded Rectangle 48"/>
-          <p:cNvSpPr/>
-          <p:nvPr/>
-        </p:nvSpPr>
-        <p:spPr>
-          <a:xfrm>
-            <a:off x="11690603" y="2628007"/>
-            <a:ext cx="82296" cy="82296"/>
-          </a:xfrm>
-          <a:prstGeom prst="roundRect">
-            <a:avLst>
-              <a:gd name="adj" fmla="val 50000"/>
-            </a:avLst>
-          </a:prstGeom>
-          <a:solidFill>
-            <a:srgbClr val="CC0000"/>
           </a:solidFill>
           <a:ln>
             <a:noFill/>
@@ -49614,7 +49614,7 @@
                 </a:solidFill>
                 <a:latin typeface="Kanit"/>
               </a:rPr>
-              <a:t>เทียบปีก่อน +1.6%</a:t>
+              <a:t>เทียบปีก่อน +2.0%</a:t>
             </a:r>
           </a:p>
         </p:txBody>
@@ -49932,7 +49932,7 @@
                 </a:solidFill>
                 <a:latin typeface="Kanit"/>
               </a:rPr>
-              <a:t>เทียบปีก่อน +13.9%</a:t>
+              <a:t>เทียบปีก่อน +14.0%</a:t>
             </a:r>
           </a:p>
         </p:txBody>
@@ -50250,7 +50250,7 @@
                 </a:solidFill>
                 <a:latin typeface="Kanit"/>
               </a:rPr>
-              <a:t>เทียบปีก่อน +15.4%</a:t>
+              <a:t>เทียบปีก่อน +16.5%</a:t>
             </a:r>
           </a:p>
         </p:txBody>
@@ -50568,7 +50568,7 @@
                 </a:solidFill>
                 <a:latin typeface="Kanit"/>
               </a:rPr>
-              <a:t>เทียบปีก่อน +25.3%</a:t>
+              <a:t>เทียบปีก่อน +24.7%</a:t>
             </a:r>
           </a:p>
         </p:txBody>
@@ -50886,7 +50886,7 @@
                 </a:solidFill>
                 <a:latin typeface="Kanit"/>
               </a:rPr>
-              <a:t>เทียบปีก่อน +42.0%</a:t>
+              <a:t>เทียบปีก่อน +42.4%</a:t>
             </a:r>
           </a:p>
         </p:txBody>
@@ -51204,7 +51204,7 @@
                 </a:solidFill>
                 <a:latin typeface="Kanit"/>
               </a:rPr>
-              <a:t>เทียบปีก่อน +63.5%</a:t>
+              <a:t>เทียบปีก่อน +64.3%</a:t>
             </a:r>
           </a:p>
         </p:txBody>
@@ -51522,7 +51522,7 @@
                 </a:solidFill>
                 <a:latin typeface="Kanit"/>
               </a:rPr>
-              <a:t>เทียบปีก่อน +109.2%</a:t>
+              <a:t>เทียบปีก่อน +126.5%</a:t>
             </a:r>
           </a:p>
         </p:txBody>
@@ -51886,7 +51886,7 @@
                 </a:solidFill>
                 <a:latin typeface="Kanit"/>
               </a:rPr>
-              <a:t>ราคาหน้าฟาร์ม วัดจริง — ราคารายวันของ NABC เฉลี่ยเป็นรายเดือน หน่วยเป็นบาทตามที่เผยแพร่ (ไม่มีการแปลงสกุลเงิน) ราคาล่าสุด 2026-08-11, รุ่นข้อมูลย้อนหลัง 2026-08-02 ราคาหน้าฟาร์ม (ราคาที่เกษตรกรขายได้) คือเงินที่เกษตรกรได้รับเมื่อขายครั้งแรก ก่อนพ่อค้าคนกลาง โรงสี หรือค่าขนส่งจะหักส่วนแบ่ง — ไม่ใช่ดัชนีโลก และไม่ใช่ราคาในซูเปอร์มาร์เก็ต แหล่งผลิตเป็นการอ่านแบบ ประมาณการ ว่าสินค้าแต่ละชนิดผลิตที่ไหน และทับซ้อนกันได้ น้ำตาลเป็นราคาอ้อยประกาศของ สอน. ปีละหนึ่งจุด จึงไม่มีการเปลี่ยนแปลงหกเดือนให้แสดง</a:t>
+              <a:t>ราคาหน้าฟาร์ม วัดจริง — ราคารายวันของ NABC เฉลี่ยเป็นรายเดือน หน่วยเป็นบาทตามที่เผยแพร่ (ไม่มีการแปลงสกุลเงิน) ราคาล่าสุด 2026-08-13, รุ่นข้อมูลย้อนหลัง 2026-08-02 ราคาหน้าฟาร์ม (ราคาที่เกษตรกรขายได้) คือเงินที่เกษตรกรได้รับเมื่อขายครั้งแรก ก่อนพ่อค้าคนกลาง โรงสี หรือค่าขนส่งจะหักส่วนแบ่ง — ไม่ใช่ดัชนีโลก และไม่ใช่ราคาในซูเปอร์มาร์เก็ต แหล่งผลิตเป็นการอ่านแบบ ประมาณการ ว่าสินค้าแต่ละชนิดผลิตที่ไหน และทับซ้อนกันได้ น้ำตาลเป็นราคาอ้อยประกาศของ สอน. ปีละหนึ่งจุด จึงไม่มีการเปลี่ยนแปลงหกเดือนให้แสดง</a:t>
             </a:r>
           </a:p>
         </p:txBody>

</xml_diff>

<commit_message>
deck(mcom): rebuild — the data moved past the committed figures (run 31862364669)
</commit_message>
<xml_diff>
--- a/docs/decks/mcom-2026-08-05-macro-TH.pptx
+++ b/docs/decks/mcom-2026-08-05-macro-TH.pptx
@@ -6240,7 +6240,7 @@
                 </a:solidFill>
                 <a:latin typeface="Kanit"/>
               </a:rPr>
-              <a:t>129</a:t>
+              <a:t>133</a:t>
             </a:r>
           </a:p>
         </p:txBody>
@@ -6279,7 +6279,7 @@
                 </a:solidFill>
                 <a:latin typeface="Kanit"/>
               </a:rPr>
-              <a:t>จาก 795 (16.2%) · เรียลไทม์ · 2026-08-14</a:t>
+              <a:t>จาก 795 (16.7%) · เรียลไทม์ · 2026-08-15</a:t>
             </a:r>
           </a:p>
         </p:txBody>
@@ -6405,7 +6405,7 @@
                 </a:solidFill>
                 <a:latin typeface="Kanit"/>
               </a:rPr>
-              <a:t>24</a:t>
+              <a:t>26</a:t>
             </a:r>
           </a:p>
         </p:txBody>
@@ -6444,7 +6444,7 @@
                 </a:solidFill>
                 <a:latin typeface="Kanit"/>
               </a:rPr>
-              <a:t>ค่าล่าสุดรายวัน · 2026-08-14</a:t>
+              <a:t>ค่าล่าสุดรายวัน · 2026-08-15</a:t>
             </a:r>
           </a:p>
         </p:txBody>
@@ -7928,7 +7928,7 @@
                           </a:solidFill>
                           <a:latin typeface="Kanit"/>
                         </a:rPr>
-                        <a:t>114</a:t>
+                        <a:t>84</a:t>
                       </a:r>
                     </a:p>
                   </a:txBody>
@@ -7951,7 +7951,7 @@
                           </a:solidFill>
                           <a:latin typeface="Kanit"/>
                         </a:rPr>
-                        <a:t>46.4%</a:t>
+                        <a:t>60.7%</a:t>
                       </a:r>
                     </a:p>
                   </a:txBody>
@@ -8022,7 +8022,7 @@
                           </a:solidFill>
                           <a:latin typeface="Kanit"/>
                         </a:rPr>
-                        <a:t>มุกดาหาร</a:t>
+                        <a:t>สกลนคร</a:t>
                       </a:r>
                     </a:p>
                   </a:txBody>
@@ -8045,7 +8045,7 @@
                           </a:solidFill>
                           <a:latin typeface="Kanit"/>
                         </a:rPr>
-                        <a:t>18</a:t>
+                        <a:t>36</a:t>
                       </a:r>
                     </a:p>
                   </a:txBody>
@@ -8068,7 +8068,7 @@
                           </a:solidFill>
                           <a:latin typeface="Kanit"/>
                         </a:rPr>
-                        <a:t>51</a:t>
+                        <a:t>42</a:t>
                       </a:r>
                     </a:p>
                   </a:txBody>
@@ -8091,7 +8091,7 @@
                           </a:solidFill>
                           <a:latin typeface="Kanit"/>
                         </a:rPr>
-                        <a:t>5.6%</a:t>
+                        <a:t>8.3%</a:t>
                       </a:r>
                     </a:p>
                   </a:txBody>
@@ -8114,7 +8114,7 @@
                           </a:solidFill>
                           <a:latin typeface="Kanit"/>
                         </a:rPr>
-                        <a:t>2/2</a:t>
+                        <a:t>7/13</a:t>
                       </a:r>
                     </a:p>
                   </a:txBody>
@@ -8162,7 +8162,7 @@
                           </a:solidFill>
                           <a:latin typeface="Kanit"/>
                         </a:rPr>
-                        <a:t>สกลนคร</a:t>
+                        <a:t>มุกดาหาร</a:t>
                       </a:r>
                     </a:p>
                   </a:txBody>
@@ -8185,7 +8185,7 @@
                           </a:solidFill>
                           <a:latin typeface="Kanit"/>
                         </a:rPr>
-                        <a:t>36</a:t>
+                        <a:t>17</a:t>
                       </a:r>
                     </a:p>
                   </a:txBody>
@@ -8208,7 +8208,7 @@
                           </a:solidFill>
                           <a:latin typeface="Kanit"/>
                         </a:rPr>
-                        <a:t>29</a:t>
+                        <a:t>51</a:t>
                       </a:r>
                     </a:p>
                   </a:txBody>
@@ -8227,11 +8227,11 @@
                       <a:r>
                         <a:rPr sz="900" b="1">
                           <a:solidFill>
-                            <a:srgbClr val="606060"/>
-                          </a:solidFill>
-                          <a:latin typeface="Kanit"/>
-                        </a:rPr>
-                        <a:t>0.0%</a:t>
+                            <a:srgbClr val="F5C242"/>
+                          </a:solidFill>
+                          <a:latin typeface="Kanit"/>
+                        </a:rPr>
+                        <a:t>5.9%</a:t>
                       </a:r>
                     </a:p>
                   </a:txBody>
@@ -8254,7 +8254,7 @@
                           </a:solidFill>
                           <a:latin typeface="Kanit"/>
                         </a:rPr>
-                        <a:t>7/13</a:t>
+                        <a:t>2/2</a:t>
                       </a:r>
                     </a:p>
                   </a:txBody>
@@ -8302,7 +8302,7 @@
                           </a:solidFill>
                           <a:latin typeface="Kanit"/>
                         </a:rPr>
-                        <a:t>สมุทรปราการ</a:t>
+                        <a:t>เลย</a:t>
                       </a:r>
                     </a:p>
                   </a:txBody>
@@ -8325,7 +8325,7 @@
                           </a:solidFill>
                           <a:latin typeface="Kanit"/>
                         </a:rPr>
-                        <a:t>16</a:t>
+                        <a:t>101</a:t>
                       </a:r>
                     </a:p>
                   </a:txBody>
@@ -8348,7 +8348,7 @@
                           </a:solidFill>
                           <a:latin typeface="Kanit"/>
                         </a:rPr>
-                        <a:t>0</a:t>
+                        <a:t>14</a:t>
                       </a:r>
                     </a:p>
                   </a:txBody>
@@ -8394,7 +8394,7 @@
                           </a:solidFill>
                           <a:latin typeface="Kanit"/>
                         </a:rPr>
-                        <a:t>4/5</a:t>
+                        <a:t>1/8</a:t>
                       </a:r>
                     </a:p>
                   </a:txBody>
@@ -8442,7 +8442,7 @@
                           </a:solidFill>
                           <a:latin typeface="Kanit"/>
                         </a:rPr>
-                        <a:t>เลย</a:t>
+                        <a:t>บึงกาฬ</a:t>
                       </a:r>
                     </a:p>
                   </a:txBody>
@@ -8465,7 +8465,7 @@
                           </a:solidFill>
                           <a:latin typeface="Kanit"/>
                         </a:rPr>
-                        <a:t>101</a:t>
+                        <a:t>11</a:t>
                       </a:r>
                     </a:p>
                   </a:txBody>
@@ -8488,7 +8488,7 @@
                           </a:solidFill>
                           <a:latin typeface="Kanit"/>
                         </a:rPr>
-                        <a:t>14</a:t>
+                        <a:t>45</a:t>
                       </a:r>
                     </a:p>
                   </a:txBody>
@@ -8507,11 +8507,11 @@
                       <a:r>
                         <a:rPr sz="900" b="1">
                           <a:solidFill>
-                            <a:srgbClr val="606060"/>
-                          </a:solidFill>
-                          <a:latin typeface="Kanit"/>
-                        </a:rPr>
-                        <a:t>0.0%</a:t>
+                            <a:srgbClr val="F5C242"/>
+                          </a:solidFill>
+                          <a:latin typeface="Kanit"/>
+                        </a:rPr>
+                        <a:t>27.3%</a:t>
                       </a:r>
                     </a:p>
                   </a:txBody>
@@ -8534,7 +8534,7 @@
                           </a:solidFill>
                           <a:latin typeface="Kanit"/>
                         </a:rPr>
-                        <a:t>1/8</a:t>
+                        <a:t>1/1</a:t>
                       </a:r>
                     </a:p>
                   </a:txBody>
@@ -8553,11 +8553,11 @@
                       <a:r>
                         <a:rPr sz="900" b="1">
                           <a:solidFill>
-                            <a:srgbClr val="CC0000"/>
-                          </a:solidFill>
-                          <a:latin typeface="Kanit"/>
-                        </a:rPr>
-                        <a:t>5</a:t>
+                            <a:srgbClr val="F5C242"/>
+                          </a:solidFill>
+                          <a:latin typeface="Kanit"/>
+                        </a:rPr>
+                        <a:t>4</a:t>
                       </a:r>
                     </a:p>
                   </a:txBody>
@@ -8582,7 +8582,7 @@
                           </a:solidFill>
                           <a:latin typeface="Kanit"/>
                         </a:rPr>
-                        <a:t>บึงกาฬ</a:t>
+                        <a:t>นครนายก</a:t>
                       </a:r>
                     </a:p>
                   </a:txBody>
@@ -8605,7 +8605,7 @@
                           </a:solidFill>
                           <a:latin typeface="Kanit"/>
                         </a:rPr>
-                        <a:t>11</a:t>
+                        <a:t>26</a:t>
                       </a:r>
                     </a:p>
                   </a:txBody>
@@ -8628,7 +8628,7 @@
                           </a:solidFill>
                           <a:latin typeface="Kanit"/>
                         </a:rPr>
-                        <a:t>48</a:t>
+                        <a:t>96</a:t>
                       </a:r>
                     </a:p>
                   </a:txBody>
@@ -8651,7 +8651,7 @@
                           </a:solidFill>
                           <a:latin typeface="Kanit"/>
                         </a:rPr>
-                        <a:t>36.4%</a:t>
+                        <a:t>23.1%</a:t>
                       </a:r>
                     </a:p>
                   </a:txBody>
@@ -8674,7 +8674,7 @@
                           </a:solidFill>
                           <a:latin typeface="Kanit"/>
                         </a:rPr>
-                        <a:t>1/1</a:t>
+                        <a:t>2/6</a:t>
                       </a:r>
                     </a:p>
                   </a:txBody>
@@ -8909,7 +8909,7 @@
                 </a:solidFill>
                 <a:latin typeface="Kanit"/>
               </a:rPr>
-              <a:t>พื้นที่ปลูก วัดจริง (สศก. — ข้อมูลอำเภอ×พืช 3,295 แถว) ภัยแล้งเป็นดัชนี SPEI จาก แบบจำลอง คำนวณจากปริมาณฝนและการคายระเหย ปรับเดือนละครั้ง ดึงข้อมูล 2026-07-20 — เป็นสัญญาณที่ครอบคลุมทั้งประเทศดีที่สุดที่มี แต่ไม่มีใครลงพื้นที่ไปเดินดูอำเภอเหล่านั้น ข้อมูลฝนและระดับน้ำ วัดจริง (ThaiWater เรียลไทม์ ดึงทุกวันและสะสมไว้ — วันที่ดึงไม่สำเร็จจะเว้นเป็นช่องว่าง ไม่ใส่ค่าสมมติ) · ฝนถึง 2026-08-14, ระดับน้ำถึง 2026-08-14 ความเสี่ยงน้ำท่วมเชิงโครงสร้าง วัดจริง (สำมะโนพื้นที่ท่วมซ้ำซาก GISTDA มาตราส่วน 1:50,000 ปี 2005-2016 — เป็นบันทึกภาคพื้นดิน 12 ปี ไม่ใช่การพยากรณ์)</a:t>
+              <a:t>พื้นที่ปลูก วัดจริง (สศก. — ข้อมูลอำเภอ×พืช 3,295 แถว) ภัยแล้งเป็นดัชนี SPEI จาก แบบจำลอง คำนวณจากปริมาณฝนและการคายระเหย ปรับเดือนละครั้ง ดึงข้อมูล 2026-07-20 — เป็นสัญญาณที่ครอบคลุมทั้งประเทศดีที่สุดที่มี แต่ไม่มีใครลงพื้นที่ไปเดินดูอำเภอเหล่านั้น ข้อมูลฝนและระดับน้ำ วัดจริง (ThaiWater เรียลไทม์ ดึงทุกวันและสะสมไว้ — วันที่ดึงไม่สำเร็จจะเว้นเป็นช่องว่าง ไม่ใส่ค่าสมมติ) · ฝนถึง 2026-08-15, ระดับน้ำถึง 2026-08-15 ความเสี่ยงน้ำท่วมเชิงโครงสร้าง วัดจริง (สำมะโนพื้นที่ท่วมซ้ำซาก GISTDA มาตราส่วน 1:50,000 ปี 2005-2016 — เป็นบันทึกภาคพื้นดิน 12 ปี ไม่ใช่การพยากรณ์)</a:t>
             </a:r>
           </a:p>
         </p:txBody>
@@ -32047,7 +32047,7 @@
                 </a:solidFill>
                 <a:latin typeface="Kanit"/>
               </a:rPr>
-              <a:t>รุ่นข้อมูล — ราคาโลก 2026M06 · ราคาหน้าฟาร์มไทย 2026-08-13 · ประวัติราคาไทย 2026-08-02 · ต้นทุนการผลิตพืช สศก. ไจอัป 2568 (ปีเพาะปลูก 2568/69, ประมาณการ สศก. มี.ค. 2569) · ภัยแล้ง 2026-06-21 · เงินเฟ้อ 2026-05 · GDP 2026 ไตรมาส 1 · IMF WEO 2026 · ดัชนีราคาขายต่อ 2026-05 · ยอดจดทะเบียนถึง 2026-01 · หนี้ครัวเรือน สสช. SES 2566 · ค่าจ้าง สสช. LFS 2568 · ข้อมูลตรวจวัด 2026-08-14</a:t>
+              <a:t>รุ่นข้อมูล — ราคาโลก 2026M06 · ราคาหน้าฟาร์มไทย 2026-08-13 · ประวัติราคาไทย 2026-08-02 · ต้นทุนการผลิตพืช สศก. ไจอัป 2568 (ปีเพาะปลูก 2568/69, ประมาณการ สศก. มี.ค. 2569) · ภัยแล้ง 2026-06-21 · เงินเฟ้อ 2026-05 · GDP 2026 ไตรมาส 1 · IMF WEO 2026 · ดัชนีราคาขายต่อ 2026-05 · ยอดจดทะเบียนถึง 2026-01 · หนี้ครัวเรือน สสช. SES 2566 · ค่าจ้าง สสช. LFS 2568 · ข้อมูลตรวจวัด 2026-08-15</a:t>
             </a:r>
           </a:p>
         </p:txBody>
@@ -37087,7 +37087,7 @@
                 </a:solidFill>
                 <a:latin typeface="Kanit"/>
               </a:rPr>
-              <a:t>338 จาก 928 อำเภอ · แม่น้ำเกินระดับ 129 จาก 795 สถานี</a:t>
+              <a:t>338 จาก 928 อำเภอ · แม่น้ำเกินระดับ 133 จาก 795 สถานี</a:t>
             </a:r>
           </a:p>
         </p:txBody>
@@ -38091,7 +38091,7 @@
                           </a:solidFill>
                           <a:latin typeface="Kanit"/>
                         </a:rPr>
-                        <a:t>23/274</a:t>
+                        <a:t>24/274</a:t>
                       </a:r>
                     </a:p>
                   </a:txBody>
@@ -38323,7 +38323,7 @@
                           </a:solidFill>
                           <a:latin typeface="Kanit"/>
                         </a:rPr>
-                        <a:t>27/168</a:t>
+                        <a:t>29/168</a:t>
                       </a:r>
                     </a:p>
                   </a:txBody>
@@ -38787,7 +38787,7 @@
                           </a:solidFill>
                           <a:latin typeface="Kanit"/>
                         </a:rPr>
-                        <a:t>40/144</a:t>
+                        <a:t>41/144</a:t>
                       </a:r>
                     </a:p>
                   </a:txBody>

</xml_diff>

<commit_message>
deck(mcom): rebuild — the data moved past the committed figures (run 31862364669) (#408)
Co-authored-by: github-actions[bot] <41898282+github-actions[bot]@users.noreply.github.com>
</commit_message>
<xml_diff>
--- a/docs/decks/mcom-2026-08-05-macro-TH.pptx
+++ b/docs/decks/mcom-2026-08-05-macro-TH.pptx
@@ -6240,7 +6240,7 @@
                 </a:solidFill>
                 <a:latin typeface="Kanit"/>
               </a:rPr>
-              <a:t>129</a:t>
+              <a:t>133</a:t>
             </a:r>
           </a:p>
         </p:txBody>
@@ -6279,7 +6279,7 @@
                 </a:solidFill>
                 <a:latin typeface="Kanit"/>
               </a:rPr>
-              <a:t>จาก 795 (16.2%) · เรียลไทม์ · 2026-08-14</a:t>
+              <a:t>จาก 795 (16.7%) · เรียลไทม์ · 2026-08-15</a:t>
             </a:r>
           </a:p>
         </p:txBody>
@@ -6405,7 +6405,7 @@
                 </a:solidFill>
                 <a:latin typeface="Kanit"/>
               </a:rPr>
-              <a:t>24</a:t>
+              <a:t>26</a:t>
             </a:r>
           </a:p>
         </p:txBody>
@@ -6444,7 +6444,7 @@
                 </a:solidFill>
                 <a:latin typeface="Kanit"/>
               </a:rPr>
-              <a:t>ค่าล่าสุดรายวัน · 2026-08-14</a:t>
+              <a:t>ค่าล่าสุดรายวัน · 2026-08-15</a:t>
             </a:r>
           </a:p>
         </p:txBody>
@@ -7928,7 +7928,7 @@
                           </a:solidFill>
                           <a:latin typeface="Kanit"/>
                         </a:rPr>
-                        <a:t>114</a:t>
+                        <a:t>84</a:t>
                       </a:r>
                     </a:p>
                   </a:txBody>
@@ -7951,7 +7951,7 @@
                           </a:solidFill>
                           <a:latin typeface="Kanit"/>
                         </a:rPr>
-                        <a:t>46.4%</a:t>
+                        <a:t>60.7%</a:t>
                       </a:r>
                     </a:p>
                   </a:txBody>
@@ -8022,7 +8022,7 @@
                           </a:solidFill>
                           <a:latin typeface="Kanit"/>
                         </a:rPr>
-                        <a:t>มุกดาหาร</a:t>
+                        <a:t>สกลนคร</a:t>
                       </a:r>
                     </a:p>
                   </a:txBody>
@@ -8045,7 +8045,7 @@
                           </a:solidFill>
                           <a:latin typeface="Kanit"/>
                         </a:rPr>
-                        <a:t>18</a:t>
+                        <a:t>36</a:t>
                       </a:r>
                     </a:p>
                   </a:txBody>
@@ -8068,7 +8068,7 @@
                           </a:solidFill>
                           <a:latin typeface="Kanit"/>
                         </a:rPr>
-                        <a:t>51</a:t>
+                        <a:t>42</a:t>
                       </a:r>
                     </a:p>
                   </a:txBody>
@@ -8091,7 +8091,7 @@
                           </a:solidFill>
                           <a:latin typeface="Kanit"/>
                         </a:rPr>
-                        <a:t>5.6%</a:t>
+                        <a:t>8.3%</a:t>
                       </a:r>
                     </a:p>
                   </a:txBody>
@@ -8114,7 +8114,7 @@
                           </a:solidFill>
                           <a:latin typeface="Kanit"/>
                         </a:rPr>
-                        <a:t>2/2</a:t>
+                        <a:t>7/13</a:t>
                       </a:r>
                     </a:p>
                   </a:txBody>
@@ -8162,7 +8162,7 @@
                           </a:solidFill>
                           <a:latin typeface="Kanit"/>
                         </a:rPr>
-                        <a:t>สกลนคร</a:t>
+                        <a:t>มุกดาหาร</a:t>
                       </a:r>
                     </a:p>
                   </a:txBody>
@@ -8185,7 +8185,7 @@
                           </a:solidFill>
                           <a:latin typeface="Kanit"/>
                         </a:rPr>
-                        <a:t>36</a:t>
+                        <a:t>17</a:t>
                       </a:r>
                     </a:p>
                   </a:txBody>
@@ -8208,7 +8208,7 @@
                           </a:solidFill>
                           <a:latin typeface="Kanit"/>
                         </a:rPr>
-                        <a:t>29</a:t>
+                        <a:t>51</a:t>
                       </a:r>
                     </a:p>
                   </a:txBody>
@@ -8227,11 +8227,11 @@
                       <a:r>
                         <a:rPr sz="900" b="1">
                           <a:solidFill>
-                            <a:srgbClr val="606060"/>
-                          </a:solidFill>
-                          <a:latin typeface="Kanit"/>
-                        </a:rPr>
-                        <a:t>0.0%</a:t>
+                            <a:srgbClr val="F5C242"/>
+                          </a:solidFill>
+                          <a:latin typeface="Kanit"/>
+                        </a:rPr>
+                        <a:t>5.9%</a:t>
                       </a:r>
                     </a:p>
                   </a:txBody>
@@ -8254,7 +8254,7 @@
                           </a:solidFill>
                           <a:latin typeface="Kanit"/>
                         </a:rPr>
-                        <a:t>7/13</a:t>
+                        <a:t>2/2</a:t>
                       </a:r>
                     </a:p>
                   </a:txBody>
@@ -8302,7 +8302,7 @@
                           </a:solidFill>
                           <a:latin typeface="Kanit"/>
                         </a:rPr>
-                        <a:t>สมุทรปราการ</a:t>
+                        <a:t>เลย</a:t>
                       </a:r>
                     </a:p>
                   </a:txBody>
@@ -8325,7 +8325,7 @@
                           </a:solidFill>
                           <a:latin typeface="Kanit"/>
                         </a:rPr>
-                        <a:t>16</a:t>
+                        <a:t>101</a:t>
                       </a:r>
                     </a:p>
                   </a:txBody>
@@ -8348,7 +8348,7 @@
                           </a:solidFill>
                           <a:latin typeface="Kanit"/>
                         </a:rPr>
-                        <a:t>0</a:t>
+                        <a:t>14</a:t>
                       </a:r>
                     </a:p>
                   </a:txBody>
@@ -8394,7 +8394,7 @@
                           </a:solidFill>
                           <a:latin typeface="Kanit"/>
                         </a:rPr>
-                        <a:t>4/5</a:t>
+                        <a:t>1/8</a:t>
                       </a:r>
                     </a:p>
                   </a:txBody>
@@ -8442,7 +8442,7 @@
                           </a:solidFill>
                           <a:latin typeface="Kanit"/>
                         </a:rPr>
-                        <a:t>เลย</a:t>
+                        <a:t>บึงกาฬ</a:t>
                       </a:r>
                     </a:p>
                   </a:txBody>
@@ -8465,7 +8465,7 @@
                           </a:solidFill>
                           <a:latin typeface="Kanit"/>
                         </a:rPr>
-                        <a:t>101</a:t>
+                        <a:t>11</a:t>
                       </a:r>
                     </a:p>
                   </a:txBody>
@@ -8488,7 +8488,7 @@
                           </a:solidFill>
                           <a:latin typeface="Kanit"/>
                         </a:rPr>
-                        <a:t>14</a:t>
+                        <a:t>45</a:t>
                       </a:r>
                     </a:p>
                   </a:txBody>
@@ -8507,11 +8507,11 @@
                       <a:r>
                         <a:rPr sz="900" b="1">
                           <a:solidFill>
-                            <a:srgbClr val="606060"/>
-                          </a:solidFill>
-                          <a:latin typeface="Kanit"/>
-                        </a:rPr>
-                        <a:t>0.0%</a:t>
+                            <a:srgbClr val="F5C242"/>
+                          </a:solidFill>
+                          <a:latin typeface="Kanit"/>
+                        </a:rPr>
+                        <a:t>27.3%</a:t>
                       </a:r>
                     </a:p>
                   </a:txBody>
@@ -8534,7 +8534,7 @@
                           </a:solidFill>
                           <a:latin typeface="Kanit"/>
                         </a:rPr>
-                        <a:t>1/8</a:t>
+                        <a:t>1/1</a:t>
                       </a:r>
                     </a:p>
                   </a:txBody>
@@ -8553,11 +8553,11 @@
                       <a:r>
                         <a:rPr sz="900" b="1">
                           <a:solidFill>
-                            <a:srgbClr val="CC0000"/>
-                          </a:solidFill>
-                          <a:latin typeface="Kanit"/>
-                        </a:rPr>
-                        <a:t>5</a:t>
+                            <a:srgbClr val="F5C242"/>
+                          </a:solidFill>
+                          <a:latin typeface="Kanit"/>
+                        </a:rPr>
+                        <a:t>4</a:t>
                       </a:r>
                     </a:p>
                   </a:txBody>
@@ -8582,7 +8582,7 @@
                           </a:solidFill>
                           <a:latin typeface="Kanit"/>
                         </a:rPr>
-                        <a:t>บึงกาฬ</a:t>
+                        <a:t>นครนายก</a:t>
                       </a:r>
                     </a:p>
                   </a:txBody>
@@ -8605,7 +8605,7 @@
                           </a:solidFill>
                           <a:latin typeface="Kanit"/>
                         </a:rPr>
-                        <a:t>11</a:t>
+                        <a:t>26</a:t>
                       </a:r>
                     </a:p>
                   </a:txBody>
@@ -8628,7 +8628,7 @@
                           </a:solidFill>
                           <a:latin typeface="Kanit"/>
                         </a:rPr>
-                        <a:t>48</a:t>
+                        <a:t>96</a:t>
                       </a:r>
                     </a:p>
                   </a:txBody>
@@ -8651,7 +8651,7 @@
                           </a:solidFill>
                           <a:latin typeface="Kanit"/>
                         </a:rPr>
-                        <a:t>36.4%</a:t>
+                        <a:t>23.1%</a:t>
                       </a:r>
                     </a:p>
                   </a:txBody>
@@ -8674,7 +8674,7 @@
                           </a:solidFill>
                           <a:latin typeface="Kanit"/>
                         </a:rPr>
-                        <a:t>1/1</a:t>
+                        <a:t>2/6</a:t>
                       </a:r>
                     </a:p>
                   </a:txBody>
@@ -8909,7 +8909,7 @@
                 </a:solidFill>
                 <a:latin typeface="Kanit"/>
               </a:rPr>
-              <a:t>พื้นที่ปลูก วัดจริง (สศก. — ข้อมูลอำเภอ×พืช 3,295 แถว) ภัยแล้งเป็นดัชนี SPEI จาก แบบจำลอง คำนวณจากปริมาณฝนและการคายระเหย ปรับเดือนละครั้ง ดึงข้อมูล 2026-07-20 — เป็นสัญญาณที่ครอบคลุมทั้งประเทศดีที่สุดที่มี แต่ไม่มีใครลงพื้นที่ไปเดินดูอำเภอเหล่านั้น ข้อมูลฝนและระดับน้ำ วัดจริง (ThaiWater เรียลไทม์ ดึงทุกวันและสะสมไว้ — วันที่ดึงไม่สำเร็จจะเว้นเป็นช่องว่าง ไม่ใส่ค่าสมมติ) · ฝนถึง 2026-08-14, ระดับน้ำถึง 2026-08-14 ความเสี่ยงน้ำท่วมเชิงโครงสร้าง วัดจริง (สำมะโนพื้นที่ท่วมซ้ำซาก GISTDA มาตราส่วน 1:50,000 ปี 2005-2016 — เป็นบันทึกภาคพื้นดิน 12 ปี ไม่ใช่การพยากรณ์)</a:t>
+              <a:t>พื้นที่ปลูก วัดจริง (สศก. — ข้อมูลอำเภอ×พืช 3,295 แถว) ภัยแล้งเป็นดัชนี SPEI จาก แบบจำลอง คำนวณจากปริมาณฝนและการคายระเหย ปรับเดือนละครั้ง ดึงข้อมูล 2026-07-20 — เป็นสัญญาณที่ครอบคลุมทั้งประเทศดีที่สุดที่มี แต่ไม่มีใครลงพื้นที่ไปเดินดูอำเภอเหล่านั้น ข้อมูลฝนและระดับน้ำ วัดจริง (ThaiWater เรียลไทม์ ดึงทุกวันและสะสมไว้ — วันที่ดึงไม่สำเร็จจะเว้นเป็นช่องว่าง ไม่ใส่ค่าสมมติ) · ฝนถึง 2026-08-15, ระดับน้ำถึง 2026-08-15 ความเสี่ยงน้ำท่วมเชิงโครงสร้าง วัดจริง (สำมะโนพื้นที่ท่วมซ้ำซาก GISTDA มาตราส่วน 1:50,000 ปี 2005-2016 — เป็นบันทึกภาคพื้นดิน 12 ปี ไม่ใช่การพยากรณ์)</a:t>
             </a:r>
           </a:p>
         </p:txBody>
@@ -32047,7 +32047,7 @@
                 </a:solidFill>
                 <a:latin typeface="Kanit"/>
               </a:rPr>
-              <a:t>รุ่นข้อมูล — ราคาโลก 2026M06 · ราคาหน้าฟาร์มไทย 2026-08-13 · ประวัติราคาไทย 2026-08-02 · ต้นทุนการผลิตพืช สศก. ไจอัป 2568 (ปีเพาะปลูก 2568/69, ประมาณการ สศก. มี.ค. 2569) · ภัยแล้ง 2026-06-21 · เงินเฟ้อ 2026-05 · GDP 2026 ไตรมาส 1 · IMF WEO 2026 · ดัชนีราคาขายต่อ 2026-05 · ยอดจดทะเบียนถึง 2026-01 · หนี้ครัวเรือน สสช. SES 2566 · ค่าจ้าง สสช. LFS 2568 · ข้อมูลตรวจวัด 2026-08-14</a:t>
+              <a:t>รุ่นข้อมูล — ราคาโลก 2026M06 · ราคาหน้าฟาร์มไทย 2026-08-13 · ประวัติราคาไทย 2026-08-02 · ต้นทุนการผลิตพืช สศก. ไจอัป 2568 (ปีเพาะปลูก 2568/69, ประมาณการ สศก. มี.ค. 2569) · ภัยแล้ง 2026-06-21 · เงินเฟ้อ 2026-05 · GDP 2026 ไตรมาส 1 · IMF WEO 2026 · ดัชนีราคาขายต่อ 2026-05 · ยอดจดทะเบียนถึง 2026-01 · หนี้ครัวเรือน สสช. SES 2566 · ค่าจ้าง สสช. LFS 2568 · ข้อมูลตรวจวัด 2026-08-15</a:t>
             </a:r>
           </a:p>
         </p:txBody>
@@ -37087,7 +37087,7 @@
                 </a:solidFill>
                 <a:latin typeface="Kanit"/>
               </a:rPr>
-              <a:t>338 จาก 928 อำเภอ · แม่น้ำเกินระดับ 129 จาก 795 สถานี</a:t>
+              <a:t>338 จาก 928 อำเภอ · แม่น้ำเกินระดับ 133 จาก 795 สถานี</a:t>
             </a:r>
           </a:p>
         </p:txBody>
@@ -38091,7 +38091,7 @@
                           </a:solidFill>
                           <a:latin typeface="Kanit"/>
                         </a:rPr>
-                        <a:t>23/274</a:t>
+                        <a:t>24/274</a:t>
                       </a:r>
                     </a:p>
                   </a:txBody>
@@ -38323,7 +38323,7 @@
                           </a:solidFill>
                           <a:latin typeface="Kanit"/>
                         </a:rPr>
-                        <a:t>27/168</a:t>
+                        <a:t>29/168</a:t>
                       </a:r>
                     </a:p>
                   </a:txBody>
@@ -38787,7 +38787,7 @@
                           </a:solidFill>
                           <a:latin typeface="Kanit"/>
                         </a:rPr>
-                        <a:t>40/144</a:t>
+                        <a:t>41/144</a:t>
                       </a:r>
                     </a:p>
                   </a:txBody>

</xml_diff>

<commit_message>
deck(mcom): rebuild — the data moved past the committed figures (run 31952455765)
</commit_message>
<xml_diff>
--- a/docs/decks/mcom-2026-08-05-macro-TH.pptx
+++ b/docs/decks/mcom-2026-08-05-macro-TH.pptx
@@ -6240,7 +6240,7 @@
                 </a:solidFill>
                 <a:latin typeface="Kanit"/>
               </a:rPr>
-              <a:t>133</a:t>
+              <a:t>123</a:t>
             </a:r>
           </a:p>
         </p:txBody>
@@ -6279,7 +6279,7 @@
                 </a:solidFill>
                 <a:latin typeface="Kanit"/>
               </a:rPr>
-              <a:t>จาก 795 (16.7%) · เรียลไทม์ · 2026-08-15</a:t>
+              <a:t>จาก 796 (15.5%) · เรียลไทม์ · 2026-08-16</a:t>
             </a:r>
           </a:p>
         </p:txBody>
@@ -6405,7 +6405,7 @@
                 </a:solidFill>
                 <a:latin typeface="Kanit"/>
               </a:rPr>
-              <a:t>26</a:t>
+              <a:t>18</a:t>
             </a:r>
           </a:p>
         </p:txBody>
@@ -6444,7 +6444,7 @@
                 </a:solidFill>
                 <a:latin typeface="Kanit"/>
               </a:rPr>
-              <a:t>ค่าล่าสุดรายวัน · 2026-08-15</a:t>
+              <a:t>ค่าล่าสุดรายวัน · 2026-08-16</a:t>
             </a:r>
           </a:p>
         </p:txBody>
@@ -7928,7 +7928,7 @@
                           </a:solidFill>
                           <a:latin typeface="Kanit"/>
                         </a:rPr>
-                        <a:t>84</a:t>
+                        <a:t>24</a:t>
                       </a:r>
                     </a:p>
                   </a:txBody>
@@ -7947,11 +7947,11 @@
                       <a:r>
                         <a:rPr sz="900" b="1">
                           <a:solidFill>
-                            <a:srgbClr val="F5C242"/>
-                          </a:solidFill>
-                          <a:latin typeface="Kanit"/>
-                        </a:rPr>
-                        <a:t>60.7%</a:t>
+                            <a:srgbClr val="606060"/>
+                          </a:solidFill>
+                          <a:latin typeface="Kanit"/>
+                        </a:rPr>
+                        <a:t>0.0%</a:t>
                       </a:r>
                     </a:p>
                   </a:txBody>
@@ -8022,7 +8022,7 @@
                           </a:solidFill>
                           <a:latin typeface="Kanit"/>
                         </a:rPr>
-                        <a:t>สกลนคร</a:t>
+                        <a:t>มุกดาหาร</a:t>
                       </a:r>
                     </a:p>
                   </a:txBody>
@@ -8045,7 +8045,7 @@
                           </a:solidFill>
                           <a:latin typeface="Kanit"/>
                         </a:rPr>
-                        <a:t>36</a:t>
+                        <a:t>17</a:t>
                       </a:r>
                     </a:p>
                   </a:txBody>
@@ -8068,7 +8068,7 @@
                           </a:solidFill>
                           <a:latin typeface="Kanit"/>
                         </a:rPr>
-                        <a:t>42</a:t>
+                        <a:t>7</a:t>
                       </a:r>
                     </a:p>
                   </a:txBody>
@@ -8087,11 +8087,11 @@
                       <a:r>
                         <a:rPr sz="900" b="1">
                           <a:solidFill>
-                            <a:srgbClr val="F5C242"/>
-                          </a:solidFill>
-                          <a:latin typeface="Kanit"/>
-                        </a:rPr>
-                        <a:t>8.3%</a:t>
+                            <a:srgbClr val="606060"/>
+                          </a:solidFill>
+                          <a:latin typeface="Kanit"/>
+                        </a:rPr>
+                        <a:t>0.0%</a:t>
                       </a:r>
                     </a:p>
                   </a:txBody>
@@ -8114,7 +8114,7 @@
                           </a:solidFill>
                           <a:latin typeface="Kanit"/>
                         </a:rPr>
-                        <a:t>7/13</a:t>
+                        <a:t>2/2</a:t>
                       </a:r>
                     </a:p>
                   </a:txBody>
@@ -8162,7 +8162,7 @@
                           </a:solidFill>
                           <a:latin typeface="Kanit"/>
                         </a:rPr>
-                        <a:t>มุกดาหาร</a:t>
+                        <a:t>สกลนคร</a:t>
                       </a:r>
                     </a:p>
                   </a:txBody>
@@ -8185,7 +8185,7 @@
                           </a:solidFill>
                           <a:latin typeface="Kanit"/>
                         </a:rPr>
-                        <a:t>17</a:t>
+                        <a:t>35</a:t>
                       </a:r>
                     </a:p>
                   </a:txBody>
@@ -8208,7 +8208,7 @@
                           </a:solidFill>
                           <a:latin typeface="Kanit"/>
                         </a:rPr>
-                        <a:t>51</a:t>
+                        <a:t>5</a:t>
                       </a:r>
                     </a:p>
                   </a:txBody>
@@ -8227,11 +8227,11 @@
                       <a:r>
                         <a:rPr sz="900" b="1">
                           <a:solidFill>
-                            <a:srgbClr val="F5C242"/>
-                          </a:solidFill>
-                          <a:latin typeface="Kanit"/>
-                        </a:rPr>
-                        <a:t>5.9%</a:t>
+                            <a:srgbClr val="606060"/>
+                          </a:solidFill>
+                          <a:latin typeface="Kanit"/>
+                        </a:rPr>
+                        <a:t>0.0%</a:t>
                       </a:r>
                     </a:p>
                   </a:txBody>
@@ -8254,7 +8254,7 @@
                           </a:solidFill>
                           <a:latin typeface="Kanit"/>
                         </a:rPr>
-                        <a:t>2/2</a:t>
+                        <a:t>7/13</a:t>
                       </a:r>
                     </a:p>
                   </a:txBody>
@@ -8302,7 +8302,7 @@
                           </a:solidFill>
                           <a:latin typeface="Kanit"/>
                         </a:rPr>
-                        <a:t>เลย</a:t>
+                        <a:t>บึงกาฬ</a:t>
                       </a:r>
                     </a:p>
                   </a:txBody>
@@ -8325,7 +8325,7 @@
                           </a:solidFill>
                           <a:latin typeface="Kanit"/>
                         </a:rPr>
-                        <a:t>101</a:t>
+                        <a:t>10</a:t>
                       </a:r>
                     </a:p>
                   </a:txBody>
@@ -8348,7 +8348,7 @@
                           </a:solidFill>
                           <a:latin typeface="Kanit"/>
                         </a:rPr>
-                        <a:t>14</a:t>
+                        <a:t>110</a:t>
                       </a:r>
                     </a:p>
                   </a:txBody>
@@ -8367,11 +8367,11 @@
                       <a:r>
                         <a:rPr sz="900" b="1">
                           <a:solidFill>
-                            <a:srgbClr val="606060"/>
-                          </a:solidFill>
-                          <a:latin typeface="Kanit"/>
-                        </a:rPr>
-                        <a:t>0.0%</a:t>
+                            <a:srgbClr val="F5C242"/>
+                          </a:solidFill>
+                          <a:latin typeface="Kanit"/>
+                        </a:rPr>
+                        <a:t>30.0%</a:t>
                       </a:r>
                     </a:p>
                   </a:txBody>
@@ -8394,7 +8394,7 @@
                           </a:solidFill>
                           <a:latin typeface="Kanit"/>
                         </a:rPr>
-                        <a:t>1/8</a:t>
+                        <a:t>1/1</a:t>
                       </a:r>
                     </a:p>
                   </a:txBody>
@@ -8413,11 +8413,11 @@
                       <a:r>
                         <a:rPr sz="900" b="1">
                           <a:solidFill>
-                            <a:srgbClr val="CC0000"/>
-                          </a:solidFill>
-                          <a:latin typeface="Kanit"/>
-                        </a:rPr>
-                        <a:t>5</a:t>
+                            <a:srgbClr val="F5C242"/>
+                          </a:solidFill>
+                          <a:latin typeface="Kanit"/>
+                        </a:rPr>
+                        <a:t>4</a:t>
                       </a:r>
                     </a:p>
                   </a:txBody>
@@ -8442,7 +8442,7 @@
                           </a:solidFill>
                           <a:latin typeface="Kanit"/>
                         </a:rPr>
-                        <a:t>บึงกาฬ</a:t>
+                        <a:t>สตูล</a:t>
                       </a:r>
                     </a:p>
                   </a:txBody>
@@ -8465,7 +8465,7 @@
                           </a:solidFill>
                           <a:latin typeface="Kanit"/>
                         </a:rPr>
-                        <a:t>11</a:t>
+                        <a:t>33</a:t>
                       </a:r>
                     </a:p>
                   </a:txBody>
@@ -8488,7 +8488,7 @@
                           </a:solidFill>
                           <a:latin typeface="Kanit"/>
                         </a:rPr>
-                        <a:t>45</a:t>
+                        <a:t>70</a:t>
                       </a:r>
                     </a:p>
                   </a:txBody>
@@ -8511,7 +8511,7 @@
                           </a:solidFill>
                           <a:latin typeface="Kanit"/>
                         </a:rPr>
-                        <a:t>27.3%</a:t>
+                        <a:t>24.2%</a:t>
                       </a:r>
                     </a:p>
                   </a:txBody>
@@ -8534,7 +8534,7 @@
                           </a:solidFill>
                           <a:latin typeface="Kanit"/>
                         </a:rPr>
-                        <a:t>1/1</a:t>
+                        <a:t>1/8</a:t>
                       </a:r>
                     </a:p>
                   </a:txBody>
@@ -8582,7 +8582,7 @@
                           </a:solidFill>
                           <a:latin typeface="Kanit"/>
                         </a:rPr>
-                        <a:t>นครนายก</a:t>
+                        <a:t>ฉะเชิงเทรา</a:t>
                       </a:r>
                     </a:p>
                   </a:txBody>
@@ -8605,7 +8605,7 @@
                           </a:solidFill>
                           <a:latin typeface="Kanit"/>
                         </a:rPr>
-                        <a:t>26</a:t>
+                        <a:t>18</a:t>
                       </a:r>
                     </a:p>
                   </a:txBody>
@@ -8628,7 +8628,7 @@
                           </a:solidFill>
                           <a:latin typeface="Kanit"/>
                         </a:rPr>
-                        <a:t>96</a:t>
+                        <a:t>46</a:t>
                       </a:r>
                     </a:p>
                   </a:txBody>
@@ -8651,7 +8651,7 @@
                           </a:solidFill>
                           <a:latin typeface="Kanit"/>
                         </a:rPr>
-                        <a:t>23.1%</a:t>
+                        <a:t>11.1%</a:t>
                       </a:r>
                     </a:p>
                   </a:txBody>
@@ -8674,7 +8674,7 @@
                           </a:solidFill>
                           <a:latin typeface="Kanit"/>
                         </a:rPr>
-                        <a:t>2/6</a:t>
+                        <a:t>2/4</a:t>
                       </a:r>
                     </a:p>
                   </a:txBody>
@@ -8909,7 +8909,7 @@
                 </a:solidFill>
                 <a:latin typeface="Kanit"/>
               </a:rPr>
-              <a:t>พื้นที่ปลูก วัดจริง (สศก. — ข้อมูลอำเภอ×พืช 3,295 แถว) ภัยแล้งเป็นดัชนี SPEI จาก แบบจำลอง คำนวณจากปริมาณฝนและการคายระเหย ปรับเดือนละครั้ง ดึงข้อมูล 2026-07-20 — เป็นสัญญาณที่ครอบคลุมทั้งประเทศดีที่สุดที่มี แต่ไม่มีใครลงพื้นที่ไปเดินดูอำเภอเหล่านั้น ข้อมูลฝนและระดับน้ำ วัดจริง (ThaiWater เรียลไทม์ ดึงทุกวันและสะสมไว้ — วันที่ดึงไม่สำเร็จจะเว้นเป็นช่องว่าง ไม่ใส่ค่าสมมติ) · ฝนถึง 2026-08-15, ระดับน้ำถึง 2026-08-15 ความเสี่ยงน้ำท่วมเชิงโครงสร้าง วัดจริง (สำมะโนพื้นที่ท่วมซ้ำซาก GISTDA มาตราส่วน 1:50,000 ปี 2005-2016 — เป็นบันทึกภาคพื้นดิน 12 ปี ไม่ใช่การพยากรณ์)</a:t>
+              <a:t>พื้นที่ปลูก วัดจริง (สศก. — ข้อมูลอำเภอ×พืช 3,295 แถว) ภัยแล้งเป็นดัชนี SPEI จาก แบบจำลอง คำนวณจากปริมาณฝนและการคายระเหย ปรับเดือนละครั้ง ดึงข้อมูล 2026-07-20 — เป็นสัญญาณที่ครอบคลุมทั้งประเทศดีที่สุดที่มี แต่ไม่มีใครลงพื้นที่ไปเดินดูอำเภอเหล่านั้น ข้อมูลฝนและระดับน้ำ วัดจริง (ThaiWater เรียลไทม์ ดึงทุกวันและสะสมไว้ — วันที่ดึงไม่สำเร็จจะเว้นเป็นช่องว่าง ไม่ใส่ค่าสมมติ) · ฝนถึง 2026-08-16, ระดับน้ำถึง 2026-08-16 ความเสี่ยงน้ำท่วมเชิงโครงสร้าง วัดจริง (สำมะโนพื้นที่ท่วมซ้ำซาก GISTDA มาตราส่วน 1:50,000 ปี 2005-2016 — เป็นบันทึกภาคพื้นดิน 12 ปี ไม่ใช่การพยากรณ์)</a:t>
             </a:r>
           </a:p>
         </p:txBody>
@@ -32047,7 +32047,7 @@
                 </a:solidFill>
                 <a:latin typeface="Kanit"/>
               </a:rPr>
-              <a:t>รุ่นข้อมูล — ราคาโลก 2026M06 · ราคาหน้าฟาร์มไทย 2026-08-13 · ประวัติราคาไทย 2026-08-02 · ต้นทุนการผลิตพืช สศก. ไจอัป 2568 (ปีเพาะปลูก 2568/69, ประมาณการ สศก. มี.ค. 2569) · ภัยแล้ง 2026-06-21 · เงินเฟ้อ 2026-05 · GDP 2026 ไตรมาส 1 · IMF WEO 2026 · ดัชนีราคาขายต่อ 2026-05 · ยอดจดทะเบียนถึง 2026-01 · หนี้ครัวเรือน สสช. SES 2566 · ค่าจ้าง สสช. LFS 2568 · ข้อมูลตรวจวัด 2026-08-15</a:t>
+              <a:t>รุ่นข้อมูล — ราคาโลก 2026M06 · ราคาหน้าฟาร์มไทย 2026-08-13 · ประวัติราคาไทย 2026-08-02 · ต้นทุนการผลิตพืช สศก. ไจอัป 2568 (ปีเพาะปลูก 2568/69, ประมาณการ สศก. มี.ค. 2569) · ภัยแล้ง 2026-06-21 · เงินเฟ้อ 2026-05 · GDP 2026 ไตรมาส 1 · IMF WEO 2026 · ดัชนีราคาขายต่อ 2026-05 · ยอดจดทะเบียนถึง 2026-01 · หนี้ครัวเรือน สสช. SES 2566 · ค่าจ้าง สสช. LFS 2568 · ข้อมูลตรวจวัด 2026-08-16</a:t>
             </a:r>
           </a:p>
         </p:txBody>
@@ -33912,7 +33912,7 @@
                 </a:solidFill>
                 <a:latin typeface="Kanit"/>
               </a:rPr>
-              <a:t>33.01</a:t>
+              <a:t>33.12</a:t>
             </a:r>
           </a:p>
         </p:txBody>
@@ -33951,7 +33951,7 @@
                 </a:solidFill>
                 <a:latin typeface="Kanit"/>
               </a:rPr>
-              <a:t>อัตราอ้างอิง ECB · 2026-08-10</a:t>
+              <a:t>อัตราอ้างอิง ECB · 2026-08-14</a:t>
             </a:r>
           </a:p>
         </p:txBody>
@@ -35798,7 +35798,7 @@
                 </a:solidFill>
                 <a:latin typeface="Kanit"/>
               </a:rPr>
-              <a:t>สศช. 2026 ไตรมาส 1 · TPSO 2026-05 · ธนาคารแห่งประเทศไทย 2026-06 · BIS 2025 ไตรมาส 4 · ECB 2026-08-10, ทั้งหมดดึงจากหน่วยงานผู้เผยแพร่โดยตรง ตารางเทียบประเทศใช้ IMF World Economic Outlook 2026 (ดึงข้อมูล 2026-07-25) อัตรา NPL ที่ ธปท. เผยแพร่ — 4.48% ณ 2026 ไตรมาส 1, จาก 4.33% ไตรมาสก่อน เปลี่ยน +0.24 จุดใน 1 ปี และต่ำสุด 3.08% ณ 2021 ไตรมาส 1</a:t>
+              <a:t>สศช. 2026 ไตรมาส 1 · TPSO 2026-05 · ธนาคารแห่งประเทศไทย 2026-06 · BIS 2025 ไตรมาส 4 · ECB 2026-08-14, ทั้งหมดดึงจากหน่วยงานผู้เผยแพร่โดยตรง ตารางเทียบประเทศใช้ IMF World Economic Outlook 2026 (ดึงข้อมูล 2026-07-25) อัตรา NPL ที่ ธปท. เผยแพร่ — 4.48% ณ 2026 ไตรมาส 1, จาก 4.33% ไตรมาสก่อน เปลี่ยน +0.24 จุดใน 1 ปี และต่ำสุด 3.08% ณ 2021 ไตรมาส 1</a:t>
             </a:r>
           </a:p>
         </p:txBody>
@@ -37087,7 +37087,7 @@
                 </a:solidFill>
                 <a:latin typeface="Kanit"/>
               </a:rPr>
-              <a:t>338 จาก 928 อำเภอ · แม่น้ำเกินระดับ 133 จาก 795 สถานี</a:t>
+              <a:t>338 จาก 928 อำเภอ · แม่น้ำเกินระดับ 123 จาก 796 สถานี</a:t>
             </a:r>
           </a:p>
         </p:txBody>
@@ -37859,7 +37859,7 @@
                           </a:solidFill>
                           <a:latin typeface="Kanit"/>
                         </a:rPr>
-                        <a:t>33/157</a:t>
+                        <a:t>29/157</a:t>
                       </a:r>
                     </a:p>
                   </a:txBody>
@@ -38091,7 +38091,7 @@
                           </a:solidFill>
                           <a:latin typeface="Kanit"/>
                         </a:rPr>
-                        <a:t>24/274</a:t>
+                        <a:t>21/274</a:t>
                       </a:r>
                     </a:p>
                   </a:txBody>
@@ -38323,7 +38323,7 @@
                           </a:solidFill>
                           <a:latin typeface="Kanit"/>
                         </a:rPr>
-                        <a:t>29/168</a:t>
+                        <a:t>26/168</a:t>
                       </a:r>
                     </a:p>
                   </a:txBody>
@@ -38787,7 +38787,7 @@
                           </a:solidFill>
                           <a:latin typeface="Kanit"/>
                         </a:rPr>
-                        <a:t>41/144</a:t>
+                        <a:t>41/145</a:t>
                       </a:r>
                     </a:p>
                   </a:txBody>
@@ -43419,7 +43419,7 @@
                           </a:solidFill>
                           <a:latin typeface="Kanit"/>
                         </a:rPr>
-                        <a:t>94.42</a:t>
+                        <a:t>94.74</a:t>
                       </a:r>
                     </a:p>
                   </a:txBody>
@@ -43559,7 +43559,7 @@
                           </a:solidFill>
                           <a:latin typeface="Kanit"/>
                         </a:rPr>
-                        <a:t>16,308</a:t>
+                        <a:t>16,364</a:t>
                       </a:r>
                     </a:p>
                   </a:txBody>
@@ -43699,7 +43699,7 @@
                           </a:solidFill>
                           <a:latin typeface="Kanit"/>
                         </a:rPr>
-                        <a:t>36,479</a:t>
+                        <a:t>36,603</a:t>
                       </a:r>
                     </a:p>
                   </a:txBody>
@@ -43839,7 +43839,7 @@
                           </a:solidFill>
                           <a:latin typeface="Kanit"/>
                         </a:rPr>
-                        <a:t>10.56</a:t>
+                        <a:t>10.60</a:t>
                       </a:r>
                     </a:p>
                   </a:txBody>
@@ -44058,7 +44058,7 @@
                 </a:solidFill>
                 <a:latin typeface="Kanit"/>
               </a:rPr>
-              <a:t>ราคารายเดือนสกุลดอลลาร์ราคาปัจจุบันจาก World Bank Pink Sheet รุ่นข้อมูล 2026M06 (ข้อมูล 60 จุดต่อรายการ ปรับฐานเป็น 100 ณ 2021-07 เพื่อวาดกราฟ — หน่วยต่างกัน จึงใช้แกนเดียวกับระดับราคาดิบไม่ได้) แปลงเป็นบาทด้วยอัตราอ้างอิง ECB USD/THB 33.013 ณ 2026-08-10 สัดส่วนพื้นที่ปลูก วัดจริง จากสัดส่วนพืชของ สศก./กรมส่งเสริมการเกษตร (crop_mix.json) เป็นราคาปัจจุบัน ไม่ได้ปรับเงินเฟ้อ: ทุกตัวเลข ‘เทียบ 5 ปีก่อน’ มีเงินเฟ้อไทยห้าปีซ่อนอยู่ข้างใต้</a:t>
+              <a:t>ราคารายเดือนสกุลดอลลาร์ราคาปัจจุบันจาก World Bank Pink Sheet รุ่นข้อมูล 2026M06 (ข้อมูล 60 จุดต่อรายการ ปรับฐานเป็น 100 ณ 2021-07 เพื่อวาดกราฟ — หน่วยต่างกัน จึงใช้แกนเดียวกับระดับราคาดิบไม่ได้) แปลงเป็นบาทด้วยอัตราอ้างอิง ECB USD/THB 33.125 ณ 2026-08-14 สัดส่วนพื้นที่ปลูก วัดจริง จากสัดส่วนพืชของ สศก./กรมส่งเสริมการเกษตร (crop_mix.json) เป็นราคาปัจจุบัน ไม่ได้ปรับเงินเฟ้อ: ทุกตัวเลข ‘เทียบ 5 ปีก่อน’ มีเงินเฟ้อไทยห้าปีซ่อนอยู่ข้างใต้</a:t>
             </a:r>
           </a:p>
         </p:txBody>

</xml_diff>

<commit_message>
deck(mcom): rebuild — the data moved past the committed figures (run 31952455765) (#458)
Co-authored-by: github-actions[bot] <41898282+github-actions[bot]@users.noreply.github.com>
</commit_message>
<xml_diff>
--- a/docs/decks/mcom-2026-08-05-macro-TH.pptx
+++ b/docs/decks/mcom-2026-08-05-macro-TH.pptx
@@ -6240,7 +6240,7 @@
                 </a:solidFill>
                 <a:latin typeface="Kanit"/>
               </a:rPr>
-              <a:t>133</a:t>
+              <a:t>123</a:t>
             </a:r>
           </a:p>
         </p:txBody>
@@ -6279,7 +6279,7 @@
                 </a:solidFill>
                 <a:latin typeface="Kanit"/>
               </a:rPr>
-              <a:t>จาก 795 (16.7%) · เรียลไทม์ · 2026-08-15</a:t>
+              <a:t>จาก 796 (15.5%) · เรียลไทม์ · 2026-08-16</a:t>
             </a:r>
           </a:p>
         </p:txBody>
@@ -6405,7 +6405,7 @@
                 </a:solidFill>
                 <a:latin typeface="Kanit"/>
               </a:rPr>
-              <a:t>26</a:t>
+              <a:t>18</a:t>
             </a:r>
           </a:p>
         </p:txBody>
@@ -6444,7 +6444,7 @@
                 </a:solidFill>
                 <a:latin typeface="Kanit"/>
               </a:rPr>
-              <a:t>ค่าล่าสุดรายวัน · 2026-08-15</a:t>
+              <a:t>ค่าล่าสุดรายวัน · 2026-08-16</a:t>
             </a:r>
           </a:p>
         </p:txBody>
@@ -7928,7 +7928,7 @@
                           </a:solidFill>
                           <a:latin typeface="Kanit"/>
                         </a:rPr>
-                        <a:t>84</a:t>
+                        <a:t>24</a:t>
                       </a:r>
                     </a:p>
                   </a:txBody>
@@ -7947,11 +7947,11 @@
                       <a:r>
                         <a:rPr sz="900" b="1">
                           <a:solidFill>
-                            <a:srgbClr val="F5C242"/>
-                          </a:solidFill>
-                          <a:latin typeface="Kanit"/>
-                        </a:rPr>
-                        <a:t>60.7%</a:t>
+                            <a:srgbClr val="606060"/>
+                          </a:solidFill>
+                          <a:latin typeface="Kanit"/>
+                        </a:rPr>
+                        <a:t>0.0%</a:t>
                       </a:r>
                     </a:p>
                   </a:txBody>
@@ -8022,7 +8022,7 @@
                           </a:solidFill>
                           <a:latin typeface="Kanit"/>
                         </a:rPr>
-                        <a:t>สกลนคร</a:t>
+                        <a:t>มุกดาหาร</a:t>
                       </a:r>
                     </a:p>
                   </a:txBody>
@@ -8045,7 +8045,7 @@
                           </a:solidFill>
                           <a:latin typeface="Kanit"/>
                         </a:rPr>
-                        <a:t>36</a:t>
+                        <a:t>17</a:t>
                       </a:r>
                     </a:p>
                   </a:txBody>
@@ -8068,7 +8068,7 @@
                           </a:solidFill>
                           <a:latin typeface="Kanit"/>
                         </a:rPr>
-                        <a:t>42</a:t>
+                        <a:t>7</a:t>
                       </a:r>
                     </a:p>
                   </a:txBody>
@@ -8087,11 +8087,11 @@
                       <a:r>
                         <a:rPr sz="900" b="1">
                           <a:solidFill>
-                            <a:srgbClr val="F5C242"/>
-                          </a:solidFill>
-                          <a:latin typeface="Kanit"/>
-                        </a:rPr>
-                        <a:t>8.3%</a:t>
+                            <a:srgbClr val="606060"/>
+                          </a:solidFill>
+                          <a:latin typeface="Kanit"/>
+                        </a:rPr>
+                        <a:t>0.0%</a:t>
                       </a:r>
                     </a:p>
                   </a:txBody>
@@ -8114,7 +8114,7 @@
                           </a:solidFill>
                           <a:latin typeface="Kanit"/>
                         </a:rPr>
-                        <a:t>7/13</a:t>
+                        <a:t>2/2</a:t>
                       </a:r>
                     </a:p>
                   </a:txBody>
@@ -8162,7 +8162,7 @@
                           </a:solidFill>
                           <a:latin typeface="Kanit"/>
                         </a:rPr>
-                        <a:t>มุกดาหาร</a:t>
+                        <a:t>สกลนคร</a:t>
                       </a:r>
                     </a:p>
                   </a:txBody>
@@ -8185,7 +8185,7 @@
                           </a:solidFill>
                           <a:latin typeface="Kanit"/>
                         </a:rPr>
-                        <a:t>17</a:t>
+                        <a:t>35</a:t>
                       </a:r>
                     </a:p>
                   </a:txBody>
@@ -8208,7 +8208,7 @@
                           </a:solidFill>
                           <a:latin typeface="Kanit"/>
                         </a:rPr>
-                        <a:t>51</a:t>
+                        <a:t>5</a:t>
                       </a:r>
                     </a:p>
                   </a:txBody>
@@ -8227,11 +8227,11 @@
                       <a:r>
                         <a:rPr sz="900" b="1">
                           <a:solidFill>
-                            <a:srgbClr val="F5C242"/>
-                          </a:solidFill>
-                          <a:latin typeface="Kanit"/>
-                        </a:rPr>
-                        <a:t>5.9%</a:t>
+                            <a:srgbClr val="606060"/>
+                          </a:solidFill>
+                          <a:latin typeface="Kanit"/>
+                        </a:rPr>
+                        <a:t>0.0%</a:t>
                       </a:r>
                     </a:p>
                   </a:txBody>
@@ -8254,7 +8254,7 @@
                           </a:solidFill>
                           <a:latin typeface="Kanit"/>
                         </a:rPr>
-                        <a:t>2/2</a:t>
+                        <a:t>7/13</a:t>
                       </a:r>
                     </a:p>
                   </a:txBody>
@@ -8302,7 +8302,7 @@
                           </a:solidFill>
                           <a:latin typeface="Kanit"/>
                         </a:rPr>
-                        <a:t>เลย</a:t>
+                        <a:t>บึงกาฬ</a:t>
                       </a:r>
                     </a:p>
                   </a:txBody>
@@ -8325,7 +8325,7 @@
                           </a:solidFill>
                           <a:latin typeface="Kanit"/>
                         </a:rPr>
-                        <a:t>101</a:t>
+                        <a:t>10</a:t>
                       </a:r>
                     </a:p>
                   </a:txBody>
@@ -8348,7 +8348,7 @@
                           </a:solidFill>
                           <a:latin typeface="Kanit"/>
                         </a:rPr>
-                        <a:t>14</a:t>
+                        <a:t>110</a:t>
                       </a:r>
                     </a:p>
                   </a:txBody>
@@ -8367,11 +8367,11 @@
                       <a:r>
                         <a:rPr sz="900" b="1">
                           <a:solidFill>
-                            <a:srgbClr val="606060"/>
-                          </a:solidFill>
-                          <a:latin typeface="Kanit"/>
-                        </a:rPr>
-                        <a:t>0.0%</a:t>
+                            <a:srgbClr val="F5C242"/>
+                          </a:solidFill>
+                          <a:latin typeface="Kanit"/>
+                        </a:rPr>
+                        <a:t>30.0%</a:t>
                       </a:r>
                     </a:p>
                   </a:txBody>
@@ -8394,7 +8394,7 @@
                           </a:solidFill>
                           <a:latin typeface="Kanit"/>
                         </a:rPr>
-                        <a:t>1/8</a:t>
+                        <a:t>1/1</a:t>
                       </a:r>
                     </a:p>
                   </a:txBody>
@@ -8413,11 +8413,11 @@
                       <a:r>
                         <a:rPr sz="900" b="1">
                           <a:solidFill>
-                            <a:srgbClr val="CC0000"/>
-                          </a:solidFill>
-                          <a:latin typeface="Kanit"/>
-                        </a:rPr>
-                        <a:t>5</a:t>
+                            <a:srgbClr val="F5C242"/>
+                          </a:solidFill>
+                          <a:latin typeface="Kanit"/>
+                        </a:rPr>
+                        <a:t>4</a:t>
                       </a:r>
                     </a:p>
                   </a:txBody>
@@ -8442,7 +8442,7 @@
                           </a:solidFill>
                           <a:latin typeface="Kanit"/>
                         </a:rPr>
-                        <a:t>บึงกาฬ</a:t>
+                        <a:t>สตูล</a:t>
                       </a:r>
                     </a:p>
                   </a:txBody>
@@ -8465,7 +8465,7 @@
                           </a:solidFill>
                           <a:latin typeface="Kanit"/>
                         </a:rPr>
-                        <a:t>11</a:t>
+                        <a:t>33</a:t>
                       </a:r>
                     </a:p>
                   </a:txBody>
@@ -8488,7 +8488,7 @@
                           </a:solidFill>
                           <a:latin typeface="Kanit"/>
                         </a:rPr>
-                        <a:t>45</a:t>
+                        <a:t>70</a:t>
                       </a:r>
                     </a:p>
                   </a:txBody>
@@ -8511,7 +8511,7 @@
                           </a:solidFill>
                           <a:latin typeface="Kanit"/>
                         </a:rPr>
-                        <a:t>27.3%</a:t>
+                        <a:t>24.2%</a:t>
                       </a:r>
                     </a:p>
                   </a:txBody>
@@ -8534,7 +8534,7 @@
                           </a:solidFill>
                           <a:latin typeface="Kanit"/>
                         </a:rPr>
-                        <a:t>1/1</a:t>
+                        <a:t>1/8</a:t>
                       </a:r>
                     </a:p>
                   </a:txBody>
@@ -8582,7 +8582,7 @@
                           </a:solidFill>
                           <a:latin typeface="Kanit"/>
                         </a:rPr>
-                        <a:t>นครนายก</a:t>
+                        <a:t>ฉะเชิงเทรา</a:t>
                       </a:r>
                     </a:p>
                   </a:txBody>
@@ -8605,7 +8605,7 @@
                           </a:solidFill>
                           <a:latin typeface="Kanit"/>
                         </a:rPr>
-                        <a:t>26</a:t>
+                        <a:t>18</a:t>
                       </a:r>
                     </a:p>
                   </a:txBody>
@@ -8628,7 +8628,7 @@
                           </a:solidFill>
                           <a:latin typeface="Kanit"/>
                         </a:rPr>
-                        <a:t>96</a:t>
+                        <a:t>46</a:t>
                       </a:r>
                     </a:p>
                   </a:txBody>
@@ -8651,7 +8651,7 @@
                           </a:solidFill>
                           <a:latin typeface="Kanit"/>
                         </a:rPr>
-                        <a:t>23.1%</a:t>
+                        <a:t>11.1%</a:t>
                       </a:r>
                     </a:p>
                   </a:txBody>
@@ -8674,7 +8674,7 @@
                           </a:solidFill>
                           <a:latin typeface="Kanit"/>
                         </a:rPr>
-                        <a:t>2/6</a:t>
+                        <a:t>2/4</a:t>
                       </a:r>
                     </a:p>
                   </a:txBody>
@@ -8909,7 +8909,7 @@
                 </a:solidFill>
                 <a:latin typeface="Kanit"/>
               </a:rPr>
-              <a:t>พื้นที่ปลูก วัดจริง (สศก. — ข้อมูลอำเภอ×พืช 3,295 แถว) ภัยแล้งเป็นดัชนี SPEI จาก แบบจำลอง คำนวณจากปริมาณฝนและการคายระเหย ปรับเดือนละครั้ง ดึงข้อมูล 2026-07-20 — เป็นสัญญาณที่ครอบคลุมทั้งประเทศดีที่สุดที่มี แต่ไม่มีใครลงพื้นที่ไปเดินดูอำเภอเหล่านั้น ข้อมูลฝนและระดับน้ำ วัดจริง (ThaiWater เรียลไทม์ ดึงทุกวันและสะสมไว้ — วันที่ดึงไม่สำเร็จจะเว้นเป็นช่องว่าง ไม่ใส่ค่าสมมติ) · ฝนถึง 2026-08-15, ระดับน้ำถึง 2026-08-15 ความเสี่ยงน้ำท่วมเชิงโครงสร้าง วัดจริง (สำมะโนพื้นที่ท่วมซ้ำซาก GISTDA มาตราส่วน 1:50,000 ปี 2005-2016 — เป็นบันทึกภาคพื้นดิน 12 ปี ไม่ใช่การพยากรณ์)</a:t>
+              <a:t>พื้นที่ปลูก วัดจริง (สศก. — ข้อมูลอำเภอ×พืช 3,295 แถว) ภัยแล้งเป็นดัชนี SPEI จาก แบบจำลอง คำนวณจากปริมาณฝนและการคายระเหย ปรับเดือนละครั้ง ดึงข้อมูล 2026-07-20 — เป็นสัญญาณที่ครอบคลุมทั้งประเทศดีที่สุดที่มี แต่ไม่มีใครลงพื้นที่ไปเดินดูอำเภอเหล่านั้น ข้อมูลฝนและระดับน้ำ วัดจริง (ThaiWater เรียลไทม์ ดึงทุกวันและสะสมไว้ — วันที่ดึงไม่สำเร็จจะเว้นเป็นช่องว่าง ไม่ใส่ค่าสมมติ) · ฝนถึง 2026-08-16, ระดับน้ำถึง 2026-08-16 ความเสี่ยงน้ำท่วมเชิงโครงสร้าง วัดจริง (สำมะโนพื้นที่ท่วมซ้ำซาก GISTDA มาตราส่วน 1:50,000 ปี 2005-2016 — เป็นบันทึกภาคพื้นดิน 12 ปี ไม่ใช่การพยากรณ์)</a:t>
             </a:r>
           </a:p>
         </p:txBody>
@@ -32047,7 +32047,7 @@
                 </a:solidFill>
                 <a:latin typeface="Kanit"/>
               </a:rPr>
-              <a:t>รุ่นข้อมูล — ราคาโลก 2026M06 · ราคาหน้าฟาร์มไทย 2026-08-13 · ประวัติราคาไทย 2026-08-02 · ต้นทุนการผลิตพืช สศก. ไจอัป 2568 (ปีเพาะปลูก 2568/69, ประมาณการ สศก. มี.ค. 2569) · ภัยแล้ง 2026-06-21 · เงินเฟ้อ 2026-05 · GDP 2026 ไตรมาส 1 · IMF WEO 2026 · ดัชนีราคาขายต่อ 2026-05 · ยอดจดทะเบียนถึง 2026-01 · หนี้ครัวเรือน สสช. SES 2566 · ค่าจ้าง สสช. LFS 2568 · ข้อมูลตรวจวัด 2026-08-15</a:t>
+              <a:t>รุ่นข้อมูล — ราคาโลก 2026M06 · ราคาหน้าฟาร์มไทย 2026-08-13 · ประวัติราคาไทย 2026-08-02 · ต้นทุนการผลิตพืช สศก. ไจอัป 2568 (ปีเพาะปลูก 2568/69, ประมาณการ สศก. มี.ค. 2569) · ภัยแล้ง 2026-06-21 · เงินเฟ้อ 2026-05 · GDP 2026 ไตรมาส 1 · IMF WEO 2026 · ดัชนีราคาขายต่อ 2026-05 · ยอดจดทะเบียนถึง 2026-01 · หนี้ครัวเรือน สสช. SES 2566 · ค่าจ้าง สสช. LFS 2568 · ข้อมูลตรวจวัด 2026-08-16</a:t>
             </a:r>
           </a:p>
         </p:txBody>
@@ -33912,7 +33912,7 @@
                 </a:solidFill>
                 <a:latin typeface="Kanit"/>
               </a:rPr>
-              <a:t>33.01</a:t>
+              <a:t>33.12</a:t>
             </a:r>
           </a:p>
         </p:txBody>
@@ -33951,7 +33951,7 @@
                 </a:solidFill>
                 <a:latin typeface="Kanit"/>
               </a:rPr>
-              <a:t>อัตราอ้างอิง ECB · 2026-08-10</a:t>
+              <a:t>อัตราอ้างอิง ECB · 2026-08-14</a:t>
             </a:r>
           </a:p>
         </p:txBody>
@@ -35798,7 +35798,7 @@
                 </a:solidFill>
                 <a:latin typeface="Kanit"/>
               </a:rPr>
-              <a:t>สศช. 2026 ไตรมาส 1 · TPSO 2026-05 · ธนาคารแห่งประเทศไทย 2026-06 · BIS 2025 ไตรมาส 4 · ECB 2026-08-10, ทั้งหมดดึงจากหน่วยงานผู้เผยแพร่โดยตรง ตารางเทียบประเทศใช้ IMF World Economic Outlook 2026 (ดึงข้อมูล 2026-07-25) อัตรา NPL ที่ ธปท. เผยแพร่ — 4.48% ณ 2026 ไตรมาส 1, จาก 4.33% ไตรมาสก่อน เปลี่ยน +0.24 จุดใน 1 ปี และต่ำสุด 3.08% ณ 2021 ไตรมาส 1</a:t>
+              <a:t>สศช. 2026 ไตรมาส 1 · TPSO 2026-05 · ธนาคารแห่งประเทศไทย 2026-06 · BIS 2025 ไตรมาส 4 · ECB 2026-08-14, ทั้งหมดดึงจากหน่วยงานผู้เผยแพร่โดยตรง ตารางเทียบประเทศใช้ IMF World Economic Outlook 2026 (ดึงข้อมูล 2026-07-25) อัตรา NPL ที่ ธปท. เผยแพร่ — 4.48% ณ 2026 ไตรมาส 1, จาก 4.33% ไตรมาสก่อน เปลี่ยน +0.24 จุดใน 1 ปี และต่ำสุด 3.08% ณ 2021 ไตรมาส 1</a:t>
             </a:r>
           </a:p>
         </p:txBody>
@@ -37087,7 +37087,7 @@
                 </a:solidFill>
                 <a:latin typeface="Kanit"/>
               </a:rPr>
-              <a:t>338 จาก 928 อำเภอ · แม่น้ำเกินระดับ 133 จาก 795 สถานี</a:t>
+              <a:t>338 จาก 928 อำเภอ · แม่น้ำเกินระดับ 123 จาก 796 สถานี</a:t>
             </a:r>
           </a:p>
         </p:txBody>
@@ -37859,7 +37859,7 @@
                           </a:solidFill>
                           <a:latin typeface="Kanit"/>
                         </a:rPr>
-                        <a:t>33/157</a:t>
+                        <a:t>29/157</a:t>
                       </a:r>
                     </a:p>
                   </a:txBody>
@@ -38091,7 +38091,7 @@
                           </a:solidFill>
                           <a:latin typeface="Kanit"/>
                         </a:rPr>
-                        <a:t>24/274</a:t>
+                        <a:t>21/274</a:t>
                       </a:r>
                     </a:p>
                   </a:txBody>
@@ -38323,7 +38323,7 @@
                           </a:solidFill>
                           <a:latin typeface="Kanit"/>
                         </a:rPr>
-                        <a:t>29/168</a:t>
+                        <a:t>26/168</a:t>
                       </a:r>
                     </a:p>
                   </a:txBody>
@@ -38787,7 +38787,7 @@
                           </a:solidFill>
                           <a:latin typeface="Kanit"/>
                         </a:rPr>
-                        <a:t>41/144</a:t>
+                        <a:t>41/145</a:t>
                       </a:r>
                     </a:p>
                   </a:txBody>
@@ -43419,7 +43419,7 @@
                           </a:solidFill>
                           <a:latin typeface="Kanit"/>
                         </a:rPr>
-                        <a:t>94.42</a:t>
+                        <a:t>94.74</a:t>
                       </a:r>
                     </a:p>
                   </a:txBody>
@@ -43559,7 +43559,7 @@
                           </a:solidFill>
                           <a:latin typeface="Kanit"/>
                         </a:rPr>
-                        <a:t>16,308</a:t>
+                        <a:t>16,364</a:t>
                       </a:r>
                     </a:p>
                   </a:txBody>
@@ -43699,7 +43699,7 @@
                           </a:solidFill>
                           <a:latin typeface="Kanit"/>
                         </a:rPr>
-                        <a:t>36,479</a:t>
+                        <a:t>36,603</a:t>
                       </a:r>
                     </a:p>
                   </a:txBody>
@@ -43839,7 +43839,7 @@
                           </a:solidFill>
                           <a:latin typeface="Kanit"/>
                         </a:rPr>
-                        <a:t>10.56</a:t>
+                        <a:t>10.60</a:t>
                       </a:r>
                     </a:p>
                   </a:txBody>
@@ -44058,7 +44058,7 @@
                 </a:solidFill>
                 <a:latin typeface="Kanit"/>
               </a:rPr>
-              <a:t>ราคารายเดือนสกุลดอลลาร์ราคาปัจจุบันจาก World Bank Pink Sheet รุ่นข้อมูล 2026M06 (ข้อมูล 60 จุดต่อรายการ ปรับฐานเป็น 100 ณ 2021-07 เพื่อวาดกราฟ — หน่วยต่างกัน จึงใช้แกนเดียวกับระดับราคาดิบไม่ได้) แปลงเป็นบาทด้วยอัตราอ้างอิง ECB USD/THB 33.013 ณ 2026-08-10 สัดส่วนพื้นที่ปลูก วัดจริง จากสัดส่วนพืชของ สศก./กรมส่งเสริมการเกษตร (crop_mix.json) เป็นราคาปัจจุบัน ไม่ได้ปรับเงินเฟ้อ: ทุกตัวเลข ‘เทียบ 5 ปีก่อน’ มีเงินเฟ้อไทยห้าปีซ่อนอยู่ข้างใต้</a:t>
+              <a:t>ราคารายเดือนสกุลดอลลาร์ราคาปัจจุบันจาก World Bank Pink Sheet รุ่นข้อมูล 2026M06 (ข้อมูล 60 จุดต่อรายการ ปรับฐานเป็น 100 ณ 2021-07 เพื่อวาดกราฟ — หน่วยต่างกัน จึงใช้แกนเดียวกับระดับราคาดิบไม่ได้) แปลงเป็นบาทด้วยอัตราอ้างอิง ECB USD/THB 33.125 ณ 2026-08-14 สัดส่วนพื้นที่ปลูก วัดจริง จากสัดส่วนพืชของ สศก./กรมส่งเสริมการเกษตร (crop_mix.json) เป็นราคาปัจจุบัน ไม่ได้ปรับเงินเฟ้อ: ทุกตัวเลข ‘เทียบ 5 ปีก่อน’ มีเงินเฟ้อไทยห้าปีซ่อนอยู่ข้างใต้</a:t>
             </a:r>
           </a:p>
         </p:txBody>

</xml_diff>

<commit_message>
deck(mcom): rebuild — the data moved past the committed figures (run 31995514769)
</commit_message>
<xml_diff>
--- a/docs/decks/mcom-2026-08-05-macro-TH.pptx
+++ b/docs/decks/mcom-2026-08-05-macro-TH.pptx
@@ -6240,7 +6240,7 @@
                 </a:solidFill>
                 <a:latin typeface="Kanit"/>
               </a:rPr>
-              <a:t>123</a:t>
+              <a:t>120</a:t>
             </a:r>
           </a:p>
         </p:txBody>
@@ -6279,7 +6279,7 @@
                 </a:solidFill>
                 <a:latin typeface="Kanit"/>
               </a:rPr>
-              <a:t>จาก 796 (15.5%) · เรียลไทม์ · 2026-08-16</a:t>
+              <a:t>จาก 797 (15.1%) · เรียลไทม์ · 2026-08-17</a:t>
             </a:r>
           </a:p>
         </p:txBody>
@@ -6405,7 +6405,7 @@
                 </a:solidFill>
                 <a:latin typeface="Kanit"/>
               </a:rPr>
-              <a:t>18</a:t>
+              <a:t>8</a:t>
             </a:r>
           </a:p>
         </p:txBody>
@@ -6444,7 +6444,7 @@
                 </a:solidFill>
                 <a:latin typeface="Kanit"/>
               </a:rPr>
-              <a:t>ค่าล่าสุดรายวัน · 2026-08-16</a:t>
+              <a:t>ค่าล่าสุดรายวัน · 2026-08-17</a:t>
             </a:r>
           </a:p>
         </p:txBody>
@@ -7905,7 +7905,7 @@
                           </a:solidFill>
                           <a:latin typeface="Kanit"/>
                         </a:rPr>
-                        <a:t>28</a:t>
+                        <a:t>26</a:t>
                       </a:r>
                     </a:p>
                   </a:txBody>
@@ -7928,7 +7928,7 @@
                           </a:solidFill>
                           <a:latin typeface="Kanit"/>
                         </a:rPr>
-                        <a:t>24</a:t>
+                        <a:t>15</a:t>
                       </a:r>
                     </a:p>
                   </a:txBody>
@@ -7974,7 +7974,7 @@
                           </a:solidFill>
                           <a:latin typeface="Kanit"/>
                         </a:rPr>
-                        <a:t>8/15</a:t>
+                        <a:t>6/14</a:t>
                       </a:r>
                     </a:p>
                   </a:txBody>
@@ -8045,7 +8045,7 @@
                           </a:solidFill>
                           <a:latin typeface="Kanit"/>
                         </a:rPr>
-                        <a:t>17</a:t>
+                        <a:t>15</a:t>
                       </a:r>
                     </a:p>
                   </a:txBody>
@@ -8068,7 +8068,7 @@
                           </a:solidFill>
                           <a:latin typeface="Kanit"/>
                         </a:rPr>
-                        <a:t>7</a:t>
+                        <a:t>0</a:t>
                       </a:r>
                     </a:p>
                   </a:txBody>
@@ -8208,7 +8208,7 @@
                           </a:solidFill>
                           <a:latin typeface="Kanit"/>
                         </a:rPr>
-                        <a:t>5</a:t>
+                        <a:t>4</a:t>
                       </a:r>
                     </a:p>
                   </a:txBody>
@@ -8302,7 +8302,7 @@
                           </a:solidFill>
                           <a:latin typeface="Kanit"/>
                         </a:rPr>
-                        <a:t>บึงกาฬ</a:t>
+                        <a:t>สตูล</a:t>
                       </a:r>
                     </a:p>
                   </a:txBody>
@@ -8325,7 +8325,7 @@
                           </a:solidFill>
                           <a:latin typeface="Kanit"/>
                         </a:rPr>
-                        <a:t>10</a:t>
+                        <a:t>30</a:t>
                       </a:r>
                     </a:p>
                   </a:txBody>
@@ -8348,7 +8348,7 @@
                           </a:solidFill>
                           <a:latin typeface="Kanit"/>
                         </a:rPr>
-                        <a:t>110</a:t>
+                        <a:t>50</a:t>
                       </a:r>
                     </a:p>
                   </a:txBody>
@@ -8371,7 +8371,7 @@
                           </a:solidFill>
                           <a:latin typeface="Kanit"/>
                         </a:rPr>
-                        <a:t>30.0%</a:t>
+                        <a:t>13.3%</a:t>
                       </a:r>
                     </a:p>
                   </a:txBody>
@@ -8394,7 +8394,7 @@
                           </a:solidFill>
                           <a:latin typeface="Kanit"/>
                         </a:rPr>
-                        <a:t>1/1</a:t>
+                        <a:t>1/8</a:t>
                       </a:r>
                     </a:p>
                   </a:txBody>
@@ -8442,7 +8442,7 @@
                           </a:solidFill>
                           <a:latin typeface="Kanit"/>
                         </a:rPr>
-                        <a:t>สตูล</a:t>
+                        <a:t>บึงกาฬ</a:t>
                       </a:r>
                     </a:p>
                   </a:txBody>
@@ -8465,7 +8465,7 @@
                           </a:solidFill>
                           <a:latin typeface="Kanit"/>
                         </a:rPr>
-                        <a:t>33</a:t>
+                        <a:t>10</a:t>
                       </a:r>
                     </a:p>
                   </a:txBody>
@@ -8488,7 +8488,7 @@
                           </a:solidFill>
                           <a:latin typeface="Kanit"/>
                         </a:rPr>
-                        <a:t>70</a:t>
+                        <a:t>35</a:t>
                       </a:r>
                     </a:p>
                   </a:txBody>
@@ -8511,7 +8511,7 @@
                           </a:solidFill>
                           <a:latin typeface="Kanit"/>
                         </a:rPr>
-                        <a:t>24.2%</a:t>
+                        <a:t>10.0%</a:t>
                       </a:r>
                     </a:p>
                   </a:txBody>
@@ -8534,7 +8534,7 @@
                           </a:solidFill>
                           <a:latin typeface="Kanit"/>
                         </a:rPr>
-                        <a:t>1/8</a:t>
+                        <a:t>1/1</a:t>
                       </a:r>
                     </a:p>
                   </a:txBody>
@@ -8582,7 +8582,7 @@
                           </a:solidFill>
                           <a:latin typeface="Kanit"/>
                         </a:rPr>
-                        <a:t>ฉะเชิงเทรา</a:t>
+                        <a:t>สงขลา</a:t>
                       </a:r>
                     </a:p>
                   </a:txBody>
@@ -8605,7 +8605,7 @@
                           </a:solidFill>
                           <a:latin typeface="Kanit"/>
                         </a:rPr>
-                        <a:t>18</a:t>
+                        <a:t>86</a:t>
                       </a:r>
                     </a:p>
                   </a:txBody>
@@ -8628,7 +8628,7 @@
                           </a:solidFill>
                           <a:latin typeface="Kanit"/>
                         </a:rPr>
-                        <a:t>46</a:t>
+                        <a:t>65</a:t>
                       </a:r>
                     </a:p>
                   </a:txBody>
@@ -8651,7 +8651,7 @@
                           </a:solidFill>
                           <a:latin typeface="Kanit"/>
                         </a:rPr>
-                        <a:t>11.1%</a:t>
+                        <a:t>5.8%</a:t>
                       </a:r>
                     </a:p>
                   </a:txBody>
@@ -8674,7 +8674,7 @@
                           </a:solidFill>
                           <a:latin typeface="Kanit"/>
                         </a:rPr>
-                        <a:t>2/4</a:t>
+                        <a:t>3/19</a:t>
                       </a:r>
                     </a:p>
                   </a:txBody>
@@ -8909,7 +8909,7 @@
                 </a:solidFill>
                 <a:latin typeface="Kanit"/>
               </a:rPr>
-              <a:t>พื้นที่ปลูก วัดจริง (สศก. — ข้อมูลอำเภอ×พืช 3,295 แถว) ภัยแล้งเป็นดัชนี SPEI จาก แบบจำลอง คำนวณจากปริมาณฝนและการคายระเหย ปรับเดือนละครั้ง ดึงข้อมูล 2026-07-20 — เป็นสัญญาณที่ครอบคลุมทั้งประเทศดีที่สุดที่มี แต่ไม่มีใครลงพื้นที่ไปเดินดูอำเภอเหล่านั้น ข้อมูลฝนและระดับน้ำ วัดจริง (ThaiWater เรียลไทม์ ดึงทุกวันและสะสมไว้ — วันที่ดึงไม่สำเร็จจะเว้นเป็นช่องว่าง ไม่ใส่ค่าสมมติ) · ฝนถึง 2026-08-16, ระดับน้ำถึง 2026-08-16 ความเสี่ยงน้ำท่วมเชิงโครงสร้าง วัดจริง (สำมะโนพื้นที่ท่วมซ้ำซาก GISTDA มาตราส่วน 1:50,000 ปี 2005-2016 — เป็นบันทึกภาคพื้นดิน 12 ปี ไม่ใช่การพยากรณ์)</a:t>
+              <a:t>พื้นที่ปลูก วัดจริง (สศก. — ข้อมูลอำเภอ×พืช 3,295 แถว) ภัยแล้งเป็นดัชนี SPEI จาก แบบจำลอง คำนวณจากปริมาณฝนและการคายระเหย ปรับเดือนละครั้ง ดึงข้อมูล 2026-07-20 — เป็นสัญญาณที่ครอบคลุมทั้งประเทศดีที่สุดที่มี แต่ไม่มีใครลงพื้นที่ไปเดินดูอำเภอเหล่านั้น ข้อมูลฝนและระดับน้ำ วัดจริง (ThaiWater เรียลไทม์ ดึงทุกวันและสะสมไว้ — วันที่ดึงไม่สำเร็จจะเว้นเป็นช่องว่าง ไม่ใส่ค่าสมมติ) · ฝนถึง 2026-08-17, ระดับน้ำถึง 2026-08-17 ความเสี่ยงน้ำท่วมเชิงโครงสร้าง วัดจริง (สำมะโนพื้นที่ท่วมซ้ำซาก GISTDA มาตราส่วน 1:50,000 ปี 2005-2016 — เป็นบันทึกภาคพื้นดิน 12 ปี ไม่ใช่การพยากรณ์)</a:t>
             </a:r>
           </a:p>
         </p:txBody>
@@ -32047,7 +32047,7 @@
                 </a:solidFill>
                 <a:latin typeface="Kanit"/>
               </a:rPr>
-              <a:t>รุ่นข้อมูล — ราคาโลก 2026M06 · ราคาหน้าฟาร์มไทย 2026-08-13 · ประวัติราคาไทย 2026-08-02 · ต้นทุนการผลิตพืช สศก. ไจอัป 2568 (ปีเพาะปลูก 2568/69, ประมาณการ สศก. มี.ค. 2569) · ภัยแล้ง 2026-06-21 · เงินเฟ้อ 2026-05 · GDP 2026 ไตรมาส 1 · IMF WEO 2026 · ดัชนีราคาขายต่อ 2026-05 · ยอดจดทะเบียนถึง 2026-01 · หนี้ครัวเรือน สสช. SES 2566 · ค่าจ้าง สสช. LFS 2568 · ข้อมูลตรวจวัด 2026-08-16</a:t>
+              <a:t>รุ่นข้อมูล — ราคาโลก 2026M06 · ราคาหน้าฟาร์มไทย 2026-08-13 · ประวัติราคาไทย 2026-08-02 · ต้นทุนการผลิตพืช สศก. ไจอัป 2568 (ปีเพาะปลูก 2568/69, ประมาณการ สศก. มี.ค. 2569) · ภัยแล้ง 2026-06-21 · เงินเฟ้อ 2026-05 · GDP 2026 ไตรมาส 1 · IMF WEO 2026 · ดัชนีราคาขายต่อ 2026-05 · ยอดจดทะเบียนถึง 2026-01 · หนี้ครัวเรือน สสช. SES 2566 · ค่าจ้าง สสช. LFS 2568 · ข้อมูลตรวจวัด 2026-08-17</a:t>
             </a:r>
           </a:p>
         </p:txBody>
@@ -37087,7 +37087,7 @@
                 </a:solidFill>
                 <a:latin typeface="Kanit"/>
               </a:rPr>
-              <a:t>338 จาก 928 อำเภอ · แม่น้ำเกินระดับ 123 จาก 796 สถานี</a:t>
+              <a:t>338 จาก 928 อำเภอ · แม่น้ำเกินระดับ 120 จาก 797 สถานี</a:t>
             </a:r>
           </a:p>
         </p:txBody>
@@ -37859,7 +37859,7 @@
                           </a:solidFill>
                           <a:latin typeface="Kanit"/>
                         </a:rPr>
-                        <a:t>29/157</a:t>
+                        <a:t>26/157</a:t>
                       </a:r>
                     </a:p>
                   </a:txBody>
@@ -38091,7 +38091,7 @@
                           </a:solidFill>
                           <a:latin typeface="Kanit"/>
                         </a:rPr>
-                        <a:t>21/274</a:t>
+                        <a:t>22/274</a:t>
                       </a:r>
                     </a:p>
                   </a:txBody>
@@ -38323,7 +38323,7 @@
                           </a:solidFill>
                           <a:latin typeface="Kanit"/>
                         </a:rPr>
-                        <a:t>26/168</a:t>
+                        <a:t>25/169</a:t>
                       </a:r>
                     </a:p>
                   </a:txBody>

</xml_diff>

<commit_message>
deck(mcom): rebuild — the data moved past the committed figures (run 31995514769) (#482)
Co-authored-by: github-actions[bot] <41898282+github-actions[bot]@users.noreply.github.com>
</commit_message>
<xml_diff>
--- a/docs/decks/mcom-2026-08-05-macro-TH.pptx
+++ b/docs/decks/mcom-2026-08-05-macro-TH.pptx
@@ -6240,7 +6240,7 @@
                 </a:solidFill>
                 <a:latin typeface="Kanit"/>
               </a:rPr>
-              <a:t>123</a:t>
+              <a:t>120</a:t>
             </a:r>
           </a:p>
         </p:txBody>
@@ -6279,7 +6279,7 @@
                 </a:solidFill>
                 <a:latin typeface="Kanit"/>
               </a:rPr>
-              <a:t>จาก 796 (15.5%) · เรียลไทม์ · 2026-08-16</a:t>
+              <a:t>จาก 797 (15.1%) · เรียลไทม์ · 2026-08-17</a:t>
             </a:r>
           </a:p>
         </p:txBody>
@@ -6405,7 +6405,7 @@
                 </a:solidFill>
                 <a:latin typeface="Kanit"/>
               </a:rPr>
-              <a:t>18</a:t>
+              <a:t>8</a:t>
             </a:r>
           </a:p>
         </p:txBody>
@@ -6444,7 +6444,7 @@
                 </a:solidFill>
                 <a:latin typeface="Kanit"/>
               </a:rPr>
-              <a:t>ค่าล่าสุดรายวัน · 2026-08-16</a:t>
+              <a:t>ค่าล่าสุดรายวัน · 2026-08-17</a:t>
             </a:r>
           </a:p>
         </p:txBody>
@@ -7905,7 +7905,7 @@
                           </a:solidFill>
                           <a:latin typeface="Kanit"/>
                         </a:rPr>
-                        <a:t>28</a:t>
+                        <a:t>26</a:t>
                       </a:r>
                     </a:p>
                   </a:txBody>
@@ -7928,7 +7928,7 @@
                           </a:solidFill>
                           <a:latin typeface="Kanit"/>
                         </a:rPr>
-                        <a:t>24</a:t>
+                        <a:t>15</a:t>
                       </a:r>
                     </a:p>
                   </a:txBody>
@@ -7974,7 +7974,7 @@
                           </a:solidFill>
                           <a:latin typeface="Kanit"/>
                         </a:rPr>
-                        <a:t>8/15</a:t>
+                        <a:t>6/14</a:t>
                       </a:r>
                     </a:p>
                   </a:txBody>
@@ -8045,7 +8045,7 @@
                           </a:solidFill>
                           <a:latin typeface="Kanit"/>
                         </a:rPr>
-                        <a:t>17</a:t>
+                        <a:t>15</a:t>
                       </a:r>
                     </a:p>
                   </a:txBody>
@@ -8068,7 +8068,7 @@
                           </a:solidFill>
                           <a:latin typeface="Kanit"/>
                         </a:rPr>
-                        <a:t>7</a:t>
+                        <a:t>0</a:t>
                       </a:r>
                     </a:p>
                   </a:txBody>
@@ -8208,7 +8208,7 @@
                           </a:solidFill>
                           <a:latin typeface="Kanit"/>
                         </a:rPr>
-                        <a:t>5</a:t>
+                        <a:t>4</a:t>
                       </a:r>
                     </a:p>
                   </a:txBody>
@@ -8302,7 +8302,7 @@
                           </a:solidFill>
                           <a:latin typeface="Kanit"/>
                         </a:rPr>
-                        <a:t>บึงกาฬ</a:t>
+                        <a:t>สตูล</a:t>
                       </a:r>
                     </a:p>
                   </a:txBody>
@@ -8325,7 +8325,7 @@
                           </a:solidFill>
                           <a:latin typeface="Kanit"/>
                         </a:rPr>
-                        <a:t>10</a:t>
+                        <a:t>30</a:t>
                       </a:r>
                     </a:p>
                   </a:txBody>
@@ -8348,7 +8348,7 @@
                           </a:solidFill>
                           <a:latin typeface="Kanit"/>
                         </a:rPr>
-                        <a:t>110</a:t>
+                        <a:t>50</a:t>
                       </a:r>
                     </a:p>
                   </a:txBody>
@@ -8371,7 +8371,7 @@
                           </a:solidFill>
                           <a:latin typeface="Kanit"/>
                         </a:rPr>
-                        <a:t>30.0%</a:t>
+                        <a:t>13.3%</a:t>
                       </a:r>
                     </a:p>
                   </a:txBody>
@@ -8394,7 +8394,7 @@
                           </a:solidFill>
                           <a:latin typeface="Kanit"/>
                         </a:rPr>
-                        <a:t>1/1</a:t>
+                        <a:t>1/8</a:t>
                       </a:r>
                     </a:p>
                   </a:txBody>
@@ -8442,7 +8442,7 @@
                           </a:solidFill>
                           <a:latin typeface="Kanit"/>
                         </a:rPr>
-                        <a:t>สตูล</a:t>
+                        <a:t>บึงกาฬ</a:t>
                       </a:r>
                     </a:p>
                   </a:txBody>
@@ -8465,7 +8465,7 @@
                           </a:solidFill>
                           <a:latin typeface="Kanit"/>
                         </a:rPr>
-                        <a:t>33</a:t>
+                        <a:t>10</a:t>
                       </a:r>
                     </a:p>
                   </a:txBody>
@@ -8488,7 +8488,7 @@
                           </a:solidFill>
                           <a:latin typeface="Kanit"/>
                         </a:rPr>
-                        <a:t>70</a:t>
+                        <a:t>35</a:t>
                       </a:r>
                     </a:p>
                   </a:txBody>
@@ -8511,7 +8511,7 @@
                           </a:solidFill>
                           <a:latin typeface="Kanit"/>
                         </a:rPr>
-                        <a:t>24.2%</a:t>
+                        <a:t>10.0%</a:t>
                       </a:r>
                     </a:p>
                   </a:txBody>
@@ -8534,7 +8534,7 @@
                           </a:solidFill>
                           <a:latin typeface="Kanit"/>
                         </a:rPr>
-                        <a:t>1/8</a:t>
+                        <a:t>1/1</a:t>
                       </a:r>
                     </a:p>
                   </a:txBody>
@@ -8582,7 +8582,7 @@
                           </a:solidFill>
                           <a:latin typeface="Kanit"/>
                         </a:rPr>
-                        <a:t>ฉะเชิงเทรา</a:t>
+                        <a:t>สงขลา</a:t>
                       </a:r>
                     </a:p>
                   </a:txBody>
@@ -8605,7 +8605,7 @@
                           </a:solidFill>
                           <a:latin typeface="Kanit"/>
                         </a:rPr>
-                        <a:t>18</a:t>
+                        <a:t>86</a:t>
                       </a:r>
                     </a:p>
                   </a:txBody>
@@ -8628,7 +8628,7 @@
                           </a:solidFill>
                           <a:latin typeface="Kanit"/>
                         </a:rPr>
-                        <a:t>46</a:t>
+                        <a:t>65</a:t>
                       </a:r>
                     </a:p>
                   </a:txBody>
@@ -8651,7 +8651,7 @@
                           </a:solidFill>
                           <a:latin typeface="Kanit"/>
                         </a:rPr>
-                        <a:t>11.1%</a:t>
+                        <a:t>5.8%</a:t>
                       </a:r>
                     </a:p>
                   </a:txBody>
@@ -8674,7 +8674,7 @@
                           </a:solidFill>
                           <a:latin typeface="Kanit"/>
                         </a:rPr>
-                        <a:t>2/4</a:t>
+                        <a:t>3/19</a:t>
                       </a:r>
                     </a:p>
                   </a:txBody>
@@ -8909,7 +8909,7 @@
                 </a:solidFill>
                 <a:latin typeface="Kanit"/>
               </a:rPr>
-              <a:t>พื้นที่ปลูก วัดจริง (สศก. — ข้อมูลอำเภอ×พืช 3,295 แถว) ภัยแล้งเป็นดัชนี SPEI จาก แบบจำลอง คำนวณจากปริมาณฝนและการคายระเหย ปรับเดือนละครั้ง ดึงข้อมูล 2026-07-20 — เป็นสัญญาณที่ครอบคลุมทั้งประเทศดีที่สุดที่มี แต่ไม่มีใครลงพื้นที่ไปเดินดูอำเภอเหล่านั้น ข้อมูลฝนและระดับน้ำ วัดจริง (ThaiWater เรียลไทม์ ดึงทุกวันและสะสมไว้ — วันที่ดึงไม่สำเร็จจะเว้นเป็นช่องว่าง ไม่ใส่ค่าสมมติ) · ฝนถึง 2026-08-16, ระดับน้ำถึง 2026-08-16 ความเสี่ยงน้ำท่วมเชิงโครงสร้าง วัดจริง (สำมะโนพื้นที่ท่วมซ้ำซาก GISTDA มาตราส่วน 1:50,000 ปี 2005-2016 — เป็นบันทึกภาคพื้นดิน 12 ปี ไม่ใช่การพยากรณ์)</a:t>
+              <a:t>พื้นที่ปลูก วัดจริง (สศก. — ข้อมูลอำเภอ×พืช 3,295 แถว) ภัยแล้งเป็นดัชนี SPEI จาก แบบจำลอง คำนวณจากปริมาณฝนและการคายระเหย ปรับเดือนละครั้ง ดึงข้อมูล 2026-07-20 — เป็นสัญญาณที่ครอบคลุมทั้งประเทศดีที่สุดที่มี แต่ไม่มีใครลงพื้นที่ไปเดินดูอำเภอเหล่านั้น ข้อมูลฝนและระดับน้ำ วัดจริง (ThaiWater เรียลไทม์ ดึงทุกวันและสะสมไว้ — วันที่ดึงไม่สำเร็จจะเว้นเป็นช่องว่าง ไม่ใส่ค่าสมมติ) · ฝนถึง 2026-08-17, ระดับน้ำถึง 2026-08-17 ความเสี่ยงน้ำท่วมเชิงโครงสร้าง วัดจริง (สำมะโนพื้นที่ท่วมซ้ำซาก GISTDA มาตราส่วน 1:50,000 ปี 2005-2016 — เป็นบันทึกภาคพื้นดิน 12 ปี ไม่ใช่การพยากรณ์)</a:t>
             </a:r>
           </a:p>
         </p:txBody>
@@ -32047,7 +32047,7 @@
                 </a:solidFill>
                 <a:latin typeface="Kanit"/>
               </a:rPr>
-              <a:t>รุ่นข้อมูล — ราคาโลก 2026M06 · ราคาหน้าฟาร์มไทย 2026-08-13 · ประวัติราคาไทย 2026-08-02 · ต้นทุนการผลิตพืช สศก. ไจอัป 2568 (ปีเพาะปลูก 2568/69, ประมาณการ สศก. มี.ค. 2569) · ภัยแล้ง 2026-06-21 · เงินเฟ้อ 2026-05 · GDP 2026 ไตรมาส 1 · IMF WEO 2026 · ดัชนีราคาขายต่อ 2026-05 · ยอดจดทะเบียนถึง 2026-01 · หนี้ครัวเรือน สสช. SES 2566 · ค่าจ้าง สสช. LFS 2568 · ข้อมูลตรวจวัด 2026-08-16</a:t>
+              <a:t>รุ่นข้อมูล — ราคาโลก 2026M06 · ราคาหน้าฟาร์มไทย 2026-08-13 · ประวัติราคาไทย 2026-08-02 · ต้นทุนการผลิตพืช สศก. ไจอัป 2568 (ปีเพาะปลูก 2568/69, ประมาณการ สศก. มี.ค. 2569) · ภัยแล้ง 2026-06-21 · เงินเฟ้อ 2026-05 · GDP 2026 ไตรมาส 1 · IMF WEO 2026 · ดัชนีราคาขายต่อ 2026-05 · ยอดจดทะเบียนถึง 2026-01 · หนี้ครัวเรือน สสช. SES 2566 · ค่าจ้าง สสช. LFS 2568 · ข้อมูลตรวจวัด 2026-08-17</a:t>
             </a:r>
           </a:p>
         </p:txBody>
@@ -37087,7 +37087,7 @@
                 </a:solidFill>
                 <a:latin typeface="Kanit"/>
               </a:rPr>
-              <a:t>338 จาก 928 อำเภอ · แม่น้ำเกินระดับ 123 จาก 796 สถานี</a:t>
+              <a:t>338 จาก 928 อำเภอ · แม่น้ำเกินระดับ 120 จาก 797 สถานี</a:t>
             </a:r>
           </a:p>
         </p:txBody>
@@ -37859,7 +37859,7 @@
                           </a:solidFill>
                           <a:latin typeface="Kanit"/>
                         </a:rPr>
-                        <a:t>29/157</a:t>
+                        <a:t>26/157</a:t>
                       </a:r>
                     </a:p>
                   </a:txBody>
@@ -38091,7 +38091,7 @@
                           </a:solidFill>
                           <a:latin typeface="Kanit"/>
                         </a:rPr>
-                        <a:t>21/274</a:t>
+                        <a:t>22/274</a:t>
                       </a:r>
                     </a:p>
                   </a:txBody>
@@ -38323,7 +38323,7 @@
                           </a:solidFill>
                           <a:latin typeface="Kanit"/>
                         </a:rPr>
-                        <a:t>26/168</a:t>
+                        <a:t>25/169</a:t>
                       </a:r>
                     </a:p>
                   </a:txBody>

</xml_diff>

<commit_message>
deck(mcom): rebuild — the data moved past the committed figures (run 32549672014)
</commit_message>
<xml_diff>
--- a/docs/decks/mcom-2026-08-05-macro-TH.pptx
+++ b/docs/decks/mcom-2026-08-05-macro-TH.pptx
@@ -6240,7 +6240,7 @@
                 </a:solidFill>
                 <a:latin typeface="Kanit"/>
               </a:rPr>
-              <a:t>120</a:t>
+              <a:t>141</a:t>
             </a:r>
           </a:p>
         </p:txBody>
@@ -6279,7 +6279,7 @@
                 </a:solidFill>
                 <a:latin typeface="Kanit"/>
               </a:rPr>
-              <a:t>จาก 797 (15.1%) · เรียลไทม์ · 2026-08-17</a:t>
+              <a:t>จาก 796 (17.7%) · เรียลไทม์ · 2026-08-22</a:t>
             </a:r>
           </a:p>
         </p:txBody>
@@ -6405,7 +6405,7 @@
                 </a:solidFill>
                 <a:latin typeface="Kanit"/>
               </a:rPr>
-              <a:t>8</a:t>
+              <a:t>17</a:t>
             </a:r>
           </a:p>
         </p:txBody>
@@ -6444,7 +6444,7 @@
                 </a:solidFill>
                 <a:latin typeface="Kanit"/>
               </a:rPr>
-              <a:t>ค่าล่าสุดรายวัน · 2026-08-17</a:t>
+              <a:t>ค่าล่าสุดรายวัน · 2026-08-22</a:t>
             </a:r>
           </a:p>
         </p:txBody>
@@ -7882,7 +7882,7 @@
                           </a:solidFill>
                           <a:latin typeface="Kanit"/>
                         </a:rPr>
-                        <a:t>นครพนม</a:t>
+                        <a:t>น่าน</a:t>
                       </a:r>
                     </a:p>
                   </a:txBody>
@@ -7905,7 +7905,7 @@
                           </a:solidFill>
                           <a:latin typeface="Kanit"/>
                         </a:rPr>
-                        <a:t>26</a:t>
+                        <a:t>215</a:t>
                       </a:r>
                     </a:p>
                   </a:txBody>
@@ -7928,7 +7928,7 @@
                           </a:solidFill>
                           <a:latin typeface="Kanit"/>
                         </a:rPr>
-                        <a:t>15</a:t>
+                        <a:t>68</a:t>
                       </a:r>
                     </a:p>
                   </a:txBody>
@@ -7947,11 +7947,11 @@
                       <a:r>
                         <a:rPr sz="900" b="1">
                           <a:solidFill>
-                            <a:srgbClr val="606060"/>
-                          </a:solidFill>
-                          <a:latin typeface="Kanit"/>
-                        </a:rPr>
-                        <a:t>0.0%</a:t>
+                            <a:srgbClr val="F5C242"/>
+                          </a:solidFill>
+                          <a:latin typeface="Kanit"/>
+                        </a:rPr>
+                        <a:t>1.9%</a:t>
                       </a:r>
                     </a:p>
                   </a:txBody>
@@ -7974,7 +7974,7 @@
                           </a:solidFill>
                           <a:latin typeface="Kanit"/>
                         </a:rPr>
-                        <a:t>6/14</a:t>
+                        <a:t>4/28</a:t>
                       </a:r>
                     </a:p>
                   </a:txBody>
@@ -8022,7 +8022,7 @@
                           </a:solidFill>
                           <a:latin typeface="Kanit"/>
                         </a:rPr>
-                        <a:t>มุกดาหาร</a:t>
+                        <a:t>นครพนม</a:t>
                       </a:r>
                     </a:p>
                   </a:txBody>
@@ -8045,7 +8045,7 @@
                           </a:solidFill>
                           <a:latin typeface="Kanit"/>
                         </a:rPr>
-                        <a:t>15</a:t>
+                        <a:t>28</a:t>
                       </a:r>
                     </a:p>
                   </a:txBody>
@@ -8068,7 +8068,7 @@
                           </a:solidFill>
                           <a:latin typeface="Kanit"/>
                         </a:rPr>
-                        <a:t>0</a:t>
+                        <a:t>8</a:t>
                       </a:r>
                     </a:p>
                   </a:txBody>
@@ -8114,7 +8114,7 @@
                           </a:solidFill>
                           <a:latin typeface="Kanit"/>
                         </a:rPr>
-                        <a:t>2/2</a:t>
+                        <a:t>8/14</a:t>
                       </a:r>
                     </a:p>
                   </a:txBody>
@@ -8162,7 +8162,7 @@
                           </a:solidFill>
                           <a:latin typeface="Kanit"/>
                         </a:rPr>
-                        <a:t>สกลนคร</a:t>
+                        <a:t>มุกดาหาร</a:t>
                       </a:r>
                     </a:p>
                   </a:txBody>
@@ -8185,7 +8185,7 @@
                           </a:solidFill>
                           <a:latin typeface="Kanit"/>
                         </a:rPr>
-                        <a:t>35</a:t>
+                        <a:t>17</a:t>
                       </a:r>
                     </a:p>
                   </a:txBody>
@@ -8208,7 +8208,7 @@
                           </a:solidFill>
                           <a:latin typeface="Kanit"/>
                         </a:rPr>
-                        <a:t>4</a:t>
+                        <a:t>12</a:t>
                       </a:r>
                     </a:p>
                   </a:txBody>
@@ -8254,7 +8254,7 @@
                           </a:solidFill>
                           <a:latin typeface="Kanit"/>
                         </a:rPr>
-                        <a:t>7/13</a:t>
+                        <a:t>2/2</a:t>
                       </a:r>
                     </a:p>
                   </a:txBody>
@@ -8302,7 +8302,7 @@
                           </a:solidFill>
                           <a:latin typeface="Kanit"/>
                         </a:rPr>
-                        <a:t>สตูล</a:t>
+                        <a:t>สกลนคร</a:t>
                       </a:r>
                     </a:p>
                   </a:txBody>
@@ -8325,7 +8325,7 @@
                           </a:solidFill>
                           <a:latin typeface="Kanit"/>
                         </a:rPr>
-                        <a:t>30</a:t>
+                        <a:t>38</a:t>
                       </a:r>
                     </a:p>
                   </a:txBody>
@@ -8348,7 +8348,7 @@
                           </a:solidFill>
                           <a:latin typeface="Kanit"/>
                         </a:rPr>
-                        <a:t>50</a:t>
+                        <a:t>22</a:t>
                       </a:r>
                     </a:p>
                   </a:txBody>
@@ -8367,11 +8367,11 @@
                       <a:r>
                         <a:rPr sz="900" b="1">
                           <a:solidFill>
-                            <a:srgbClr val="F5C242"/>
-                          </a:solidFill>
-                          <a:latin typeface="Kanit"/>
-                        </a:rPr>
-                        <a:t>13.3%</a:t>
+                            <a:srgbClr val="606060"/>
+                          </a:solidFill>
+                          <a:latin typeface="Kanit"/>
+                        </a:rPr>
+                        <a:t>0.0%</a:t>
                       </a:r>
                     </a:p>
                   </a:txBody>
@@ -8394,7 +8394,7 @@
                           </a:solidFill>
                           <a:latin typeface="Kanit"/>
                         </a:rPr>
-                        <a:t>1/8</a:t>
+                        <a:t>7/13</a:t>
                       </a:r>
                     </a:p>
                   </a:txBody>
@@ -8413,11 +8413,11 @@
                       <a:r>
                         <a:rPr sz="900" b="1">
                           <a:solidFill>
-                            <a:srgbClr val="F5C242"/>
-                          </a:solidFill>
-                          <a:latin typeface="Kanit"/>
-                        </a:rPr>
-                        <a:t>4</a:t>
+                            <a:srgbClr val="CC0000"/>
+                          </a:solidFill>
+                          <a:latin typeface="Kanit"/>
+                        </a:rPr>
+                        <a:t>5</a:t>
                       </a:r>
                     </a:p>
                   </a:txBody>
@@ -8442,7 +8442,7 @@
                           </a:solidFill>
                           <a:latin typeface="Kanit"/>
                         </a:rPr>
-                        <a:t>บึงกาฬ</a:t>
+                        <a:t>เพชรบูรณ์</a:t>
                       </a:r>
                     </a:p>
                   </a:txBody>
@@ -8465,7 +8465,7 @@
                           </a:solidFill>
                           <a:latin typeface="Kanit"/>
                         </a:rPr>
-                        <a:t>10</a:t>
+                        <a:t>80</a:t>
                       </a:r>
                     </a:p>
                   </a:txBody>
@@ -8488,7 +8488,7 @@
                           </a:solidFill>
                           <a:latin typeface="Kanit"/>
                         </a:rPr>
-                        <a:t>35</a:t>
+                        <a:t>18</a:t>
                       </a:r>
                     </a:p>
                   </a:txBody>
@@ -8507,11 +8507,11 @@
                       <a:r>
                         <a:rPr sz="900" b="1">
                           <a:solidFill>
-                            <a:srgbClr val="F5C242"/>
-                          </a:solidFill>
-                          <a:latin typeface="Kanit"/>
-                        </a:rPr>
-                        <a:t>10.0%</a:t>
+                            <a:srgbClr val="606060"/>
+                          </a:solidFill>
+                          <a:latin typeface="Kanit"/>
+                        </a:rPr>
+                        <a:t>0.0%</a:t>
                       </a:r>
                     </a:p>
                   </a:txBody>
@@ -8534,7 +8534,7 @@
                           </a:solidFill>
                           <a:latin typeface="Kanit"/>
                         </a:rPr>
-                        <a:t>1/1</a:t>
+                        <a:t>4/9</a:t>
                       </a:r>
                     </a:p>
                   </a:txBody>
@@ -8553,11 +8553,11 @@
                       <a:r>
                         <a:rPr sz="900" b="1">
                           <a:solidFill>
-                            <a:srgbClr val="F5C242"/>
-                          </a:solidFill>
-                          <a:latin typeface="Kanit"/>
-                        </a:rPr>
-                        <a:t>4</a:t>
+                            <a:srgbClr val="CC0000"/>
+                          </a:solidFill>
+                          <a:latin typeface="Kanit"/>
+                        </a:rPr>
+                        <a:t>5</a:t>
                       </a:r>
                     </a:p>
                   </a:txBody>
@@ -8582,7 +8582,7 @@
                           </a:solidFill>
                           <a:latin typeface="Kanit"/>
                         </a:rPr>
-                        <a:t>สงขลา</a:t>
+                        <a:t>กาญจนบุรี</a:t>
                       </a:r>
                     </a:p>
                   </a:txBody>
@@ -8605,7 +8605,7 @@
                           </a:solidFill>
                           <a:latin typeface="Kanit"/>
                         </a:rPr>
-                        <a:t>86</a:t>
+                        <a:t>93</a:t>
                       </a:r>
                     </a:p>
                   </a:txBody>
@@ -8628,7 +8628,7 @@
                           </a:solidFill>
                           <a:latin typeface="Kanit"/>
                         </a:rPr>
-                        <a:t>65</a:t>
+                        <a:t>45</a:t>
                       </a:r>
                     </a:p>
                   </a:txBody>
@@ -8651,7 +8651,7 @@
                           </a:solidFill>
                           <a:latin typeface="Kanit"/>
                         </a:rPr>
-                        <a:t>5.8%</a:t>
+                        <a:t>6.5%</a:t>
                       </a:r>
                     </a:p>
                   </a:txBody>
@@ -8674,7 +8674,7 @@
                           </a:solidFill>
                           <a:latin typeface="Kanit"/>
                         </a:rPr>
-                        <a:t>3/19</a:t>
+                        <a:t>4/26</a:t>
                       </a:r>
                     </a:p>
                   </a:txBody>
@@ -8909,7 +8909,7 @@
                 </a:solidFill>
                 <a:latin typeface="Kanit"/>
               </a:rPr>
-              <a:t>พื้นที่ปลูก วัดจริง (สศก. — ข้อมูลอำเภอ×พืช 3,295 แถว) ภัยแล้งเป็นดัชนี SPEI จาก แบบจำลอง คำนวณจากปริมาณฝนและการคายระเหย ปรับเดือนละครั้ง ดึงข้อมูล 2026-07-20 — เป็นสัญญาณที่ครอบคลุมทั้งประเทศดีที่สุดที่มี แต่ไม่มีใครลงพื้นที่ไปเดินดูอำเภอเหล่านั้น ข้อมูลฝนและระดับน้ำ วัดจริง (ThaiWater เรียลไทม์ ดึงทุกวันและสะสมไว้ — วันที่ดึงไม่สำเร็จจะเว้นเป็นช่องว่าง ไม่ใส่ค่าสมมติ) · ฝนถึง 2026-08-17, ระดับน้ำถึง 2026-08-17 ความเสี่ยงน้ำท่วมเชิงโครงสร้าง วัดจริง (สำมะโนพื้นที่ท่วมซ้ำซาก GISTDA มาตราส่วน 1:50,000 ปี 2005-2016 — เป็นบันทึกภาคพื้นดิน 12 ปี ไม่ใช่การพยากรณ์)</a:t>
+              <a:t>พื้นที่ปลูก วัดจริง (สศก. — ข้อมูลอำเภอ×พืช 3,295 แถว) ภัยแล้งเป็นดัชนี SPEI จาก แบบจำลอง คำนวณจากปริมาณฝนและการคายระเหย ปรับเดือนละครั้ง ดึงข้อมูล 2026-07-20 — เป็นสัญญาณที่ครอบคลุมทั้งประเทศดีที่สุดที่มี แต่ไม่มีใครลงพื้นที่ไปเดินดูอำเภอเหล่านั้น ข้อมูลฝนและระดับน้ำ วัดจริง (ThaiWater เรียลไทม์ ดึงทุกวันและสะสมไว้ — วันที่ดึงไม่สำเร็จจะเว้นเป็นช่องว่าง ไม่ใส่ค่าสมมติ) · ฝนถึง 2026-08-22, ระดับน้ำถึง 2026-08-22 ความเสี่ยงน้ำท่วมเชิงโครงสร้าง วัดจริง (สำมะโนพื้นที่ท่วมซ้ำซาก GISTDA มาตราส่วน 1:50,000 ปี 2005-2016 — เป็นบันทึกภาคพื้นดิน 12 ปี ไม่ใช่การพยากรณ์)</a:t>
             </a:r>
           </a:p>
         </p:txBody>
@@ -31476,7 +31476,7 @@
                 </a:solidFill>
                 <a:latin typeface="Kanit"/>
               </a:rPr>
-              <a:t>รายได้จากพืชค่ากลางเพิ่มขึ้น +16.9% แต่มีสี่จังหวัดที่ลดลง — ทั้งหมดอยู่ในแหล่งปลูกมะพร้าว โดยหนักที่สุดคือสมุทรสงครามที่ −63.2%</a:t>
+              <a:t>รายได้จากพืชค่ากลางเพิ่มขึ้น +17.2% แต่มีสี่จังหวัดที่ลดลง — ทั้งหมดอยู่ในแหล่งปลูกมะพร้าว โดยหนักที่สุดคือสมุทรสงครามที่ −62.8%</a:t>
             </a:r>
           </a:p>
         </p:txBody>
@@ -32047,7 +32047,7 @@
                 </a:solidFill>
                 <a:latin typeface="Kanit"/>
               </a:rPr>
-              <a:t>รุ่นข้อมูล — ราคาโลก 2026M06 · ราคาหน้าฟาร์มไทย 2026-08-13 · ประวัติราคาไทย 2026-08-02 · ต้นทุนการผลิตพืช สศก. ไจอัป 2568 (ปีเพาะปลูก 2568/69, ประมาณการ สศก. มี.ค. 2569) · ภัยแล้ง 2026-06-21 · เงินเฟ้อ 2026-05 · GDP 2026 ไตรมาส 1 · IMF WEO 2026 · ดัชนีราคาขายต่อ 2026-05 · ยอดจดทะเบียนถึง 2026-01 · หนี้ครัวเรือน สสช. SES 2566 · ค่าจ้าง สสช. LFS 2568 · ข้อมูลตรวจวัด 2026-08-17</a:t>
+              <a:t>รุ่นข้อมูล — ราคาโลก 2026M06 · ราคาหน้าฟาร์มไทย 2026-08-20 · ประวัติราคาไทย 2026-08-17 · ต้นทุนการผลิตพืช สศก. ไจอัป 2568 (ปีเพาะปลูก 2568/69, ประมาณการ สศก. มี.ค. 2569) · ภัยแล้ง 2026-06-21 · เงินเฟ้อ 2026-05 · GDP 2026 ไตรมาส 1 · IMF WEO 2026 · ดัชนีราคาขายต่อ 2026-05 · ยอดจดทะเบียนถึง 2026-01 · หนี้ครัวเรือน สสช. SES 2566 · ค่าจ้าง สสช. LFS 2568 · ข้อมูลตรวจวัด 2026-08-22</a:t>
             </a:r>
           </a:p>
         </p:txBody>
@@ -32545,8 +32545,8 @@
               </a:rPr>
               <a:t>Not on the world index — the farm gate (ราคาที่เกษตรกรขายได้) says otherwise.
 • Five of seventeen Thai farm-gate prices are falling year on year.
-• Beef: farm gate −6.1% vs world index +11.8%.
-• Margin over price: a 26% price move becomes an 87% swing in crop income.</a:t>
+• Beef: farm gate −6.1% vs world index +8.8%.
+• Margin over price: a 26% price move becomes an 86% swing in crop income.</a:t>
             </a:r>
           </a:p>
         </p:txBody>
@@ -33912,7 +33912,7 @@
                 </a:solidFill>
                 <a:latin typeface="Kanit"/>
               </a:rPr>
-              <a:t>33.12</a:t>
+              <a:t>33.02</a:t>
             </a:r>
           </a:p>
         </p:txBody>
@@ -33951,7 +33951,7 @@
                 </a:solidFill>
                 <a:latin typeface="Kanit"/>
               </a:rPr>
-              <a:t>อัตราอ้างอิง ECB · 2026-08-14</a:t>
+              <a:t>อัตราอ้างอิง ECB · 2026-08-17</a:t>
             </a:r>
           </a:p>
         </p:txBody>
@@ -35798,7 +35798,7 @@
                 </a:solidFill>
                 <a:latin typeface="Kanit"/>
               </a:rPr>
-              <a:t>สศช. 2026 ไตรมาส 1 · TPSO 2026-05 · ธนาคารแห่งประเทศไทย 2026-06 · BIS 2025 ไตรมาส 4 · ECB 2026-08-14, ทั้งหมดดึงจากหน่วยงานผู้เผยแพร่โดยตรง ตารางเทียบประเทศใช้ IMF World Economic Outlook 2026 (ดึงข้อมูล 2026-07-25) อัตรา NPL ที่ ธปท. เผยแพร่ — 4.48% ณ 2026 ไตรมาส 1, จาก 4.33% ไตรมาสก่อน เปลี่ยน +0.24 จุดใน 1 ปี และต่ำสุด 3.08% ณ 2021 ไตรมาส 1</a:t>
+              <a:t>สศช. 2026 ไตรมาส 1 · TPSO 2026-05 · ธนาคารแห่งประเทศไทย 2026-06 · BIS 2025 ไตรมาส 4 · ECB 2026-08-17, ทั้งหมดดึงจากหน่วยงานผู้เผยแพร่โดยตรง ตารางเทียบประเทศใช้ IMF World Economic Outlook 2026 (ดึงข้อมูล 2026-07-25) อัตรา NPL ที่ ธปท. เผยแพร่ — 4.48% ณ 2026 ไตรมาส 1, จาก 4.33% ไตรมาสก่อน เปลี่ยน +0.24 จุดใน 1 ปี และต่ำสุด 3.08% ณ 2021 ไตรมาส 1</a:t>
             </a:r>
           </a:p>
         </p:txBody>
@@ -37087,7 +37087,7 @@
                 </a:solidFill>
                 <a:latin typeface="Kanit"/>
               </a:rPr>
-              <a:t>338 จาก 928 อำเภอ · แม่น้ำเกินระดับ 120 จาก 797 สถานี</a:t>
+              <a:t>338 จาก 928 อำเภอ · แม่น้ำเกินระดับ 141 จาก 796 สถานี</a:t>
             </a:r>
           </a:p>
         </p:txBody>
@@ -37859,7 +37859,7 @@
                           </a:solidFill>
                           <a:latin typeface="Kanit"/>
                         </a:rPr>
-                        <a:t>26/157</a:t>
+                        <a:t>33/155</a:t>
                       </a:r>
                     </a:p>
                   </a:txBody>
@@ -38091,7 +38091,7 @@
                           </a:solidFill>
                           <a:latin typeface="Kanit"/>
                         </a:rPr>
-                        <a:t>22/274</a:t>
+                        <a:t>36/275</a:t>
                       </a:r>
                     </a:p>
                   </a:txBody>
@@ -38323,7 +38323,7 @@
                           </a:solidFill>
                           <a:latin typeface="Kanit"/>
                         </a:rPr>
-                        <a:t>25/169</a:t>
+                        <a:t>26/168</a:t>
                       </a:r>
                     </a:p>
                   </a:txBody>
@@ -38555,7 +38555,7 @@
                           </a:solidFill>
                           <a:latin typeface="Kanit"/>
                         </a:rPr>
-                        <a:t>6/52</a:t>
+                        <a:t>7/52</a:t>
                       </a:r>
                     </a:p>
                   </a:txBody>
@@ -38787,7 +38787,7 @@
                           </a:solidFill>
                           <a:latin typeface="Kanit"/>
                         </a:rPr>
-                        <a:t>41/145</a:t>
+                        <a:t>39/146</a:t>
                       </a:r>
                     </a:p>
                   </a:txBody>
@@ -39936,7 +39936,7 @@
                           </a:solidFill>
                           <a:latin typeface="Kanit"/>
                         </a:rPr>
-                        <a:t>−67.6%</a:t>
+                        <a:t>−67.2%</a:t>
                       </a:r>
                     </a:p>
                   </a:txBody>
@@ -39959,7 +39959,7 @@
                           </a:solidFill>
                           <a:latin typeface="Kanit"/>
                         </a:rPr>
-                        <a:t>−58.7%</a:t>
+                        <a:t>−48.8%</a:t>
                       </a:r>
                     </a:p>
                   </a:txBody>
@@ -40122,7 +40122,7 @@
                           </a:solidFill>
                           <a:latin typeface="Kanit"/>
                         </a:rPr>
-                        <a:t>+47.7%</a:t>
+                        <a:t>+48.0%</a:t>
                       </a:r>
                     </a:p>
                   </a:txBody>
@@ -40791,7 +40791,7 @@
                 </a:solidFill>
                 <a:latin typeface="Kanit"/>
               </a:rPr>
-              <a:t>ราคา วัดจริง — ราคาหน้าฟาร์มไทยจากราคารายวันของ NABC และราคาอ้อยประกาศของ สอน. ราคาล่าสุด 2026-08-13 การเปลี่ยนแปลงหกเดือนคำนวณจากข้อมูลรายเดือนของ NABC เอง (thai_price_history รุ่นข้อมูล 2026-08-02) พืชที่ไม่มีข้อมูลรายเดือนจะกำกับไว้ ไม่ประมาณการขึ้นมา แหล่งผลิตเป็นการอ่านแบบ ประมาณการ ว่าสินค้าแต่ละชนิดปลูกที่ไหน และแหล่งผลิตทับซ้อนกันได้ บัญชีอาชีพเกษตรเป็นข้อมูลของเราเองและ วัดจริง — บัญชีที่บันทึกอาชีพว่า เกษตร ในจังหวัดแหล่งผลิต จากฐานข้อมูล 382,735 บัญชี ณ 2026-07 ไม่เผยแพร่ช่องที่มีน้อยกว่า 30 บัญชี คนกลุ่มนี้อาศัยอยู่ในพื้นที่ที่ปลูกพืชนั้น แต่ไม่ได้ยืนยันว่าปลูกพืชนั้นเอง</a:t>
+              <a:t>ราคา วัดจริง — ราคาหน้าฟาร์มไทยจากราคารายวันของ NABC และราคาอ้อยประกาศของ สอน. ราคาล่าสุด 2026-08-20 การเปลี่ยนแปลงหกเดือนคำนวณจากข้อมูลรายเดือนของ NABC เอง (thai_price_history รุ่นข้อมูล 2026-08-17) พืชที่ไม่มีข้อมูลรายเดือนจะกำกับไว้ ไม่ประมาณการขึ้นมา แหล่งผลิตเป็นการอ่านแบบ ประมาณการ ว่าสินค้าแต่ละชนิดปลูกที่ไหน และแหล่งผลิตทับซ้อนกันได้ บัญชีอาชีพเกษตรเป็นข้อมูลของเราเองและ วัดจริง — บัญชีที่บันทึกอาชีพว่า เกษตร ในจังหวัดแหล่งผลิต จากฐานข้อมูล 382,735 บัญชี ณ 2026-07 ไม่เผยแพร่ช่องที่มีน้อยกว่า 30 บัญชี คนกลุ่มนี้อาศัยอยู่ในพื้นที่ที่ปลูกพืชนั้น แต่ไม่ได้ยืนยันว่าปลูกพืชนั้นเอง</a:t>
             </a:r>
           </a:p>
         </p:txBody>
@@ -40957,7 +40957,7 @@
                 </a:solidFill>
                 <a:latin typeface="Kanit"/>
               </a:rPr>
-              <a:t>เนื้อวัวตลาดโลก +11.8% ราคาหน้าฟาร์มไทย −6.1% — ต่างกัน 17.9 จุด และไปคนละทาง ลูกค้าอาชีพเกษตรของเรา 31,240 รายอาศัยอยู่ในแหล่งเลี้ยงวัวคืออีสาน</a:t>
+              <a:t>เนื้อวัวตลาดโลก +8.8% ราคาหน้าฟาร์มไทย −6.1% — ต่างกัน 14.9 จุด และไปคนละทาง ลูกค้าอาชีพเกษตรของเรา 31,240 รายอาศัยอยู่ในแหล่งเลี้ยงวัวคืออีสาน</a:t>
             </a:r>
           </a:p>
         </p:txBody>
@@ -41888,8 +41888,8 @@
         </p:nvSpPr>
         <p:spPr>
           <a:xfrm>
-            <a:off x="795528" y="1995005"/>
-            <a:ext cx="6428232" cy="1131906"/>
+            <a:off x="795528" y="2030750"/>
+            <a:ext cx="6428232" cy="1114034"/>
           </a:xfrm>
           <a:custGeom>
             <a:avLst/>
@@ -41898,186 +41898,186 @@
             <a:cxnLst/>
             <a:rect l="l" t="t" r="r" b="b"/>
             <a:pathLst>
-              <a:path w="6428232" h="1131906">
+              <a:path w="6428232" h="1114034">
                 <a:moveTo>
-                  <a:pt x="0" y="783628"/>
+                  <a:pt x="0" y="747883"/>
                 </a:moveTo>
                 <a:lnTo>
-                  <a:pt x="108953" y="759881"/>
-                </a:lnTo>
-                <a:lnTo>
-                  <a:pt x="217906" y="846951"/>
-                </a:lnTo>
-                <a:lnTo>
-                  <a:pt x="326859" y="783628"/>
-                </a:lnTo>
-                <a:lnTo>
-                  <a:pt x="435812" y="736135"/>
-                </a:lnTo>
-                <a:lnTo>
-                  <a:pt x="544765" y="744050"/>
-                </a:lnTo>
-                <a:lnTo>
-                  <a:pt x="653718" y="704473"/>
-                </a:lnTo>
-                <a:lnTo>
-                  <a:pt x="762671" y="593657"/>
-                </a:lnTo>
-                <a:lnTo>
-                  <a:pt x="871624" y="585742"/>
-                </a:lnTo>
-                <a:lnTo>
-                  <a:pt x="980577" y="609488"/>
-                </a:lnTo>
-                <a:lnTo>
-                  <a:pt x="1089530" y="633234"/>
-                </a:lnTo>
-                <a:lnTo>
-                  <a:pt x="1198483" y="656981"/>
-                </a:lnTo>
-                <a:lnTo>
-                  <a:pt x="1307437" y="854866"/>
-                </a:lnTo>
-                <a:lnTo>
-                  <a:pt x="1416390" y="989429"/>
-                </a:lnTo>
-                <a:lnTo>
-                  <a:pt x="1525343" y="1092329"/>
-                </a:lnTo>
-                <a:lnTo>
-                  <a:pt x="1634296" y="1076498"/>
-                </a:lnTo>
-                <a:lnTo>
-                  <a:pt x="1743249" y="1131906"/>
-                </a:lnTo>
-                <a:lnTo>
-                  <a:pt x="1852202" y="1044837"/>
-                </a:lnTo>
-                <a:lnTo>
-                  <a:pt x="1961155" y="973598"/>
-                </a:lnTo>
-                <a:lnTo>
-                  <a:pt x="2070108" y="981513"/>
-                </a:lnTo>
-                <a:lnTo>
-                  <a:pt x="2179061" y="1013175"/>
-                </a:lnTo>
-                <a:lnTo>
-                  <a:pt x="2288014" y="1044837"/>
-                </a:lnTo>
-                <a:lnTo>
-                  <a:pt x="2396967" y="1029006"/>
-                </a:lnTo>
-                <a:lnTo>
-                  <a:pt x="2505920" y="1052752"/>
-                </a:lnTo>
-                <a:lnTo>
-                  <a:pt x="2614874" y="1084414"/>
-                </a:lnTo>
-                <a:lnTo>
-                  <a:pt x="2723827" y="1100245"/>
-                </a:lnTo>
-                <a:lnTo>
-                  <a:pt x="2832780" y="1036921"/>
-                </a:lnTo>
-                <a:lnTo>
-                  <a:pt x="2941733" y="989429"/>
-                </a:lnTo>
-                <a:lnTo>
-                  <a:pt x="3050686" y="941936"/>
-                </a:lnTo>
-                <a:lnTo>
-                  <a:pt x="3159639" y="949851"/>
-                </a:lnTo>
-                <a:lnTo>
-                  <a:pt x="3268592" y="839035"/>
-                </a:lnTo>
-                <a:lnTo>
-                  <a:pt x="3377545" y="664896"/>
-                </a:lnTo>
-                <a:lnTo>
-                  <a:pt x="3486498" y="372025"/>
-                </a:lnTo>
-                <a:lnTo>
-                  <a:pt x="3595451" y="459095"/>
-                </a:lnTo>
-                <a:lnTo>
-                  <a:pt x="3704404" y="561996"/>
-                </a:lnTo>
-                <a:lnTo>
-                  <a:pt x="3813357" y="474926"/>
-                </a:lnTo>
-                <a:lnTo>
-                  <a:pt x="3922311" y="633234"/>
-                </a:lnTo>
-                <a:lnTo>
-                  <a:pt x="4031264" y="372025"/>
-                </a:lnTo>
-                <a:lnTo>
-                  <a:pt x="4140217" y="166224"/>
-                </a:lnTo>
-                <a:lnTo>
-                  <a:pt x="4249170" y="182055"/>
-                </a:lnTo>
-                <a:lnTo>
-                  <a:pt x="4358123" y="451180"/>
-                </a:lnTo>
-                <a:lnTo>
-                  <a:pt x="4467076" y="379941"/>
-                </a:lnTo>
-                <a:lnTo>
-                  <a:pt x="4576029" y="387856"/>
-                </a:lnTo>
-                <a:lnTo>
-                  <a:pt x="4684982" y="356194"/>
-                </a:lnTo>
-                <a:lnTo>
-                  <a:pt x="4793935" y="395772"/>
-                </a:lnTo>
-                <a:lnTo>
-                  <a:pt x="4902888" y="577826"/>
-                </a:lnTo>
-                <a:lnTo>
-                  <a:pt x="5011841" y="530334"/>
-                </a:lnTo>
-                <a:lnTo>
-                  <a:pt x="5120794" y="554080"/>
-                </a:lnTo>
-                <a:lnTo>
-                  <a:pt x="5229748" y="498672"/>
-                </a:lnTo>
-                <a:lnTo>
-                  <a:pt x="5338701" y="561996"/>
-                </a:lnTo>
-                <a:lnTo>
-                  <a:pt x="5447654" y="593657"/>
-                </a:lnTo>
-                <a:lnTo>
-                  <a:pt x="5556607" y="680727"/>
-                </a:lnTo>
-                <a:lnTo>
-                  <a:pt x="5665560" y="656981"/>
-                </a:lnTo>
-                <a:lnTo>
-                  <a:pt x="5774513" y="633234"/>
-                </a:lnTo>
-                <a:lnTo>
-                  <a:pt x="5883466" y="569911"/>
-                </a:lnTo>
-                <a:lnTo>
-                  <a:pt x="5992419" y="474926"/>
-                </a:lnTo>
-                <a:lnTo>
-                  <a:pt x="6101372" y="372025"/>
-                </a:lnTo>
-                <a:lnTo>
-                  <a:pt x="6210325" y="277040"/>
-                </a:lnTo>
-                <a:lnTo>
-                  <a:pt x="6319278" y="134562"/>
-                </a:lnTo>
-                <a:lnTo>
-                  <a:pt x="6428232" y="0"/>
+                  <a:pt x="108953" y="833577"/>
+                </a:lnTo>
+                <a:lnTo>
+                  <a:pt x="217906" y="771254"/>
+                </a:lnTo>
+                <a:lnTo>
+                  <a:pt x="326859" y="724511"/>
+                </a:lnTo>
+                <a:lnTo>
+                  <a:pt x="435812" y="732302"/>
+                </a:lnTo>
+                <a:lnTo>
+                  <a:pt x="544765" y="693349"/>
+                </a:lnTo>
+                <a:lnTo>
+                  <a:pt x="653718" y="584283"/>
+                </a:lnTo>
+                <a:lnTo>
+                  <a:pt x="762671" y="576493"/>
+                </a:lnTo>
+                <a:lnTo>
+                  <a:pt x="871624" y="599864"/>
+                </a:lnTo>
+                <a:lnTo>
+                  <a:pt x="980577" y="623235"/>
+                </a:lnTo>
+                <a:lnTo>
+                  <a:pt x="1089530" y="646607"/>
+                </a:lnTo>
+                <a:lnTo>
+                  <a:pt x="1198483" y="841368"/>
+                </a:lnTo>
+                <a:lnTo>
+                  <a:pt x="1307437" y="973805"/>
+                </a:lnTo>
+                <a:lnTo>
+                  <a:pt x="1416390" y="1075081"/>
+                </a:lnTo>
+                <a:lnTo>
+                  <a:pt x="1525343" y="1059500"/>
+                </a:lnTo>
+                <a:lnTo>
+                  <a:pt x="1634296" y="1114034"/>
+                </a:lnTo>
+                <a:lnTo>
+                  <a:pt x="1743249" y="1028339"/>
+                </a:lnTo>
+                <a:lnTo>
+                  <a:pt x="1852202" y="958225"/>
+                </a:lnTo>
+                <a:lnTo>
+                  <a:pt x="1961155" y="966015"/>
+                </a:lnTo>
+                <a:lnTo>
+                  <a:pt x="2070108" y="997177"/>
+                </a:lnTo>
+                <a:lnTo>
+                  <a:pt x="2179061" y="1028339"/>
+                </a:lnTo>
+                <a:lnTo>
+                  <a:pt x="2288014" y="1012758"/>
+                </a:lnTo>
+                <a:lnTo>
+                  <a:pt x="2396967" y="1036129"/>
+                </a:lnTo>
+                <a:lnTo>
+                  <a:pt x="2505920" y="1067291"/>
+                </a:lnTo>
+                <a:lnTo>
+                  <a:pt x="2614874" y="1082872"/>
+                </a:lnTo>
+                <a:lnTo>
+                  <a:pt x="2723827" y="1020548"/>
+                </a:lnTo>
+                <a:lnTo>
+                  <a:pt x="2832780" y="973805"/>
+                </a:lnTo>
+                <a:lnTo>
+                  <a:pt x="2941733" y="927063"/>
+                </a:lnTo>
+                <a:lnTo>
+                  <a:pt x="3050686" y="934853"/>
+                </a:lnTo>
+                <a:lnTo>
+                  <a:pt x="3159639" y="825787"/>
+                </a:lnTo>
+                <a:lnTo>
+                  <a:pt x="3268592" y="654397"/>
+                </a:lnTo>
+                <a:lnTo>
+                  <a:pt x="3377545" y="366151"/>
+                </a:lnTo>
+                <a:lnTo>
+                  <a:pt x="3486498" y="451846"/>
+                </a:lnTo>
+                <a:lnTo>
+                  <a:pt x="3595451" y="553121"/>
+                </a:lnTo>
+                <a:lnTo>
+                  <a:pt x="3704404" y="467426"/>
+                </a:lnTo>
+                <a:lnTo>
+                  <a:pt x="3813357" y="623235"/>
+                </a:lnTo>
+                <a:lnTo>
+                  <a:pt x="3922311" y="366151"/>
+                </a:lnTo>
+                <a:lnTo>
+                  <a:pt x="4031264" y="163599"/>
+                </a:lnTo>
+                <a:lnTo>
+                  <a:pt x="4140217" y="179180"/>
+                </a:lnTo>
+                <a:lnTo>
+                  <a:pt x="4249170" y="444055"/>
+                </a:lnTo>
+                <a:lnTo>
+                  <a:pt x="4358123" y="373941"/>
+                </a:lnTo>
+                <a:lnTo>
+                  <a:pt x="4467076" y="381731"/>
+                </a:lnTo>
+                <a:lnTo>
+                  <a:pt x="4576029" y="350570"/>
+                </a:lnTo>
+                <a:lnTo>
+                  <a:pt x="4684982" y="389522"/>
+                </a:lnTo>
+                <a:lnTo>
+                  <a:pt x="4793935" y="568702"/>
+                </a:lnTo>
+                <a:lnTo>
+                  <a:pt x="4902888" y="521960"/>
+                </a:lnTo>
+                <a:lnTo>
+                  <a:pt x="5011841" y="545331"/>
+                </a:lnTo>
+                <a:lnTo>
+                  <a:pt x="5120794" y="490798"/>
+                </a:lnTo>
+                <a:lnTo>
+                  <a:pt x="5229748" y="553121"/>
+                </a:lnTo>
+                <a:lnTo>
+                  <a:pt x="5338701" y="584283"/>
+                </a:lnTo>
+                <a:lnTo>
+                  <a:pt x="5447654" y="669978"/>
+                </a:lnTo>
+                <a:lnTo>
+                  <a:pt x="5556607" y="646607"/>
+                </a:lnTo>
+                <a:lnTo>
+                  <a:pt x="5665560" y="623235"/>
+                </a:lnTo>
+                <a:lnTo>
+                  <a:pt x="5774513" y="560912"/>
+                </a:lnTo>
+                <a:lnTo>
+                  <a:pt x="5883466" y="467426"/>
+                </a:lnTo>
+                <a:lnTo>
+                  <a:pt x="5992419" y="366151"/>
+                </a:lnTo>
+                <a:lnTo>
+                  <a:pt x="6101372" y="272665"/>
+                </a:lnTo>
+                <a:lnTo>
+                  <a:pt x="6210325" y="132437"/>
+                </a:lnTo>
+                <a:lnTo>
+                  <a:pt x="6319278" y="0"/>
+                </a:lnTo>
+                <a:lnTo>
+                  <a:pt x="6428232" y="62323"/>
                 </a:lnTo>
               </a:path>
             </a:pathLst>
@@ -42120,8 +42120,8 @@
         </p:nvSpPr>
         <p:spPr>
           <a:xfrm>
-            <a:off x="795528" y="1899102"/>
-            <a:ext cx="6428232" cy="1086899"/>
+            <a:off x="795528" y="1834693"/>
+            <a:ext cx="6428232" cy="1116567"/>
           </a:xfrm>
           <a:custGeom>
             <a:avLst/>
@@ -42130,186 +42130,186 @@
             <a:cxnLst/>
             <a:rect l="l" t="t" r="r" b="b"/>
             <a:pathLst>
-              <a:path w="6428232" h="1086899">
+              <a:path w="6428232" h="1116567">
                 <a:moveTo>
-                  <a:pt x="0" y="879531"/>
+                  <a:pt x="0" y="943940"/>
                 </a:moveTo>
                 <a:lnTo>
-                  <a:pt x="108953" y="918859"/>
-                </a:lnTo>
-                <a:lnTo>
-                  <a:pt x="217906" y="929585"/>
-                </a:lnTo>
-                <a:lnTo>
-                  <a:pt x="326859" y="926010"/>
-                </a:lnTo>
-                <a:lnTo>
-                  <a:pt x="435812" y="929585"/>
-                </a:lnTo>
-                <a:lnTo>
-                  <a:pt x="544765" y="929585"/>
-                </a:lnTo>
-                <a:lnTo>
-                  <a:pt x="653718" y="833051"/>
-                </a:lnTo>
-                <a:lnTo>
-                  <a:pt x="762671" y="833051"/>
-                </a:lnTo>
-                <a:lnTo>
-                  <a:pt x="871624" y="850928"/>
-                </a:lnTo>
-                <a:lnTo>
-                  <a:pt x="980577" y="818750"/>
-                </a:lnTo>
-                <a:lnTo>
-                  <a:pt x="1089530" y="700764"/>
-                </a:lnTo>
-                <a:lnTo>
-                  <a:pt x="1198483" y="772271"/>
-                </a:lnTo>
-                <a:lnTo>
-                  <a:pt x="1307437" y="865229"/>
-                </a:lnTo>
-                <a:lnTo>
-                  <a:pt x="1416390" y="818750"/>
-                </a:lnTo>
-                <a:lnTo>
-                  <a:pt x="1525343" y="790147"/>
-                </a:lnTo>
-                <a:lnTo>
-                  <a:pt x="1634296" y="818750"/>
-                </a:lnTo>
-                <a:lnTo>
-                  <a:pt x="1743249" y="786572"/>
-                </a:lnTo>
-                <a:lnTo>
-                  <a:pt x="1852202" y="690038"/>
-                </a:lnTo>
-                <a:lnTo>
-                  <a:pt x="1961155" y="511272"/>
-                </a:lnTo>
-                <a:lnTo>
-                  <a:pt x="2070108" y="600655"/>
-                </a:lnTo>
-                <a:lnTo>
-                  <a:pt x="2179061" y="657860"/>
-                </a:lnTo>
-                <a:lnTo>
-                  <a:pt x="2288014" y="568477"/>
-                </a:lnTo>
-                <a:lnTo>
-                  <a:pt x="2396967" y="536299"/>
-                </a:lnTo>
-                <a:lnTo>
-                  <a:pt x="2505920" y="521998"/>
-                </a:lnTo>
-                <a:lnTo>
-                  <a:pt x="2614874" y="404012"/>
-                </a:lnTo>
-                <a:lnTo>
-                  <a:pt x="2723827" y="89383"/>
-                </a:lnTo>
-                <a:lnTo>
-                  <a:pt x="2832780" y="143013"/>
-                </a:lnTo>
-                <a:lnTo>
-                  <a:pt x="2941733" y="250273"/>
-                </a:lnTo>
-                <a:lnTo>
-                  <a:pt x="3050686" y="221670"/>
-                </a:lnTo>
-                <a:lnTo>
-                  <a:pt x="3159639" y="57206"/>
-                </a:lnTo>
-                <a:lnTo>
-                  <a:pt x="3268592" y="0"/>
-                </a:lnTo>
-                <a:lnTo>
-                  <a:pt x="3377545" y="128712"/>
-                </a:lnTo>
-                <a:lnTo>
-                  <a:pt x="3486498" y="168041"/>
-                </a:lnTo>
-                <a:lnTo>
-                  <a:pt x="3595451" y="243122"/>
-                </a:lnTo>
-                <a:lnTo>
-                  <a:pt x="3704404" y="114411"/>
-                </a:lnTo>
-                <a:lnTo>
-                  <a:pt x="3813357" y="100109"/>
-                </a:lnTo>
-                <a:lnTo>
-                  <a:pt x="3922311" y="250273"/>
-                </a:lnTo>
-                <a:lnTo>
-                  <a:pt x="4031264" y="253848"/>
-                </a:lnTo>
-                <a:lnTo>
-                  <a:pt x="4140217" y="286026"/>
-                </a:lnTo>
-                <a:lnTo>
-                  <a:pt x="4249170" y="518423"/>
-                </a:lnTo>
-                <a:lnTo>
-                  <a:pt x="4358123" y="532724"/>
-                </a:lnTo>
-                <a:lnTo>
-                  <a:pt x="4467076" y="475519"/>
-                </a:lnTo>
-                <a:lnTo>
-                  <a:pt x="4576029" y="650710"/>
-                </a:lnTo>
-                <a:lnTo>
-                  <a:pt x="4684982" y="797298"/>
-                </a:lnTo>
-                <a:lnTo>
-                  <a:pt x="4793935" y="840202"/>
-                </a:lnTo>
-                <a:lnTo>
-                  <a:pt x="4902888" y="875955"/>
-                </a:lnTo>
-                <a:lnTo>
-                  <a:pt x="5011841" y="818750"/>
-                </a:lnTo>
-                <a:lnTo>
-                  <a:pt x="5120794" y="861654"/>
-                </a:lnTo>
-                <a:lnTo>
-                  <a:pt x="5229748" y="958188"/>
-                </a:lnTo>
-                <a:lnTo>
-                  <a:pt x="5338701" y="1018968"/>
-                </a:lnTo>
-                <a:lnTo>
-                  <a:pt x="5447654" y="1022544"/>
-                </a:lnTo>
-                <a:lnTo>
-                  <a:pt x="5556607" y="1086899"/>
-                </a:lnTo>
-                <a:lnTo>
-                  <a:pt x="5665560" y="1043996"/>
-                </a:lnTo>
-                <a:lnTo>
-                  <a:pt x="5774513" y="843777"/>
-                </a:lnTo>
-                <a:lnTo>
-                  <a:pt x="5883466" y="900982"/>
-                </a:lnTo>
-                <a:lnTo>
-                  <a:pt x="5992419" y="897407"/>
-                </a:lnTo>
-                <a:lnTo>
-                  <a:pt x="6101372" y="997516"/>
-                </a:lnTo>
-                <a:lnTo>
-                  <a:pt x="6210325" y="918859"/>
-                </a:lnTo>
-                <a:lnTo>
-                  <a:pt x="6319278" y="786572"/>
-                </a:lnTo>
-                <a:lnTo>
-                  <a:pt x="6428232" y="593504"/>
+                  <a:pt x="108953" y="954958"/>
+                </a:lnTo>
+                <a:lnTo>
+                  <a:pt x="217906" y="951285"/>
+                </a:lnTo>
+                <a:lnTo>
+                  <a:pt x="326859" y="954958"/>
+                </a:lnTo>
+                <a:lnTo>
+                  <a:pt x="435812" y="954958"/>
+                </a:lnTo>
+                <a:lnTo>
+                  <a:pt x="544765" y="855790"/>
+                </a:lnTo>
+                <a:lnTo>
+                  <a:pt x="653718" y="855790"/>
+                </a:lnTo>
+                <a:lnTo>
+                  <a:pt x="762671" y="874154"/>
+                </a:lnTo>
+                <a:lnTo>
+                  <a:pt x="871624" y="841098"/>
+                </a:lnTo>
+                <a:lnTo>
+                  <a:pt x="980577" y="719892"/>
+                </a:lnTo>
+                <a:lnTo>
+                  <a:pt x="1089530" y="793350"/>
+                </a:lnTo>
+                <a:lnTo>
+                  <a:pt x="1198483" y="888846"/>
+                </a:lnTo>
+                <a:lnTo>
+                  <a:pt x="1307437" y="841098"/>
+                </a:lnTo>
+                <a:lnTo>
+                  <a:pt x="1416390" y="811715"/>
+                </a:lnTo>
+                <a:lnTo>
+                  <a:pt x="1525343" y="841098"/>
+                </a:lnTo>
+                <a:lnTo>
+                  <a:pt x="1634296" y="808042"/>
+                </a:lnTo>
+                <a:lnTo>
+                  <a:pt x="1743249" y="708873"/>
+                </a:lnTo>
+                <a:lnTo>
+                  <a:pt x="1852202" y="525227"/>
+                </a:lnTo>
+                <a:lnTo>
+                  <a:pt x="1961155" y="617050"/>
+                </a:lnTo>
+                <a:lnTo>
+                  <a:pt x="2070108" y="675817"/>
+                </a:lnTo>
+                <a:lnTo>
+                  <a:pt x="2179061" y="583994"/>
+                </a:lnTo>
+                <a:lnTo>
+                  <a:pt x="2288014" y="550938"/>
+                </a:lnTo>
+                <a:lnTo>
+                  <a:pt x="2396967" y="536246"/>
+                </a:lnTo>
+                <a:lnTo>
+                  <a:pt x="2505920" y="415040"/>
+                </a:lnTo>
+                <a:lnTo>
+                  <a:pt x="2614874" y="91823"/>
+                </a:lnTo>
+                <a:lnTo>
+                  <a:pt x="2723827" y="146917"/>
+                </a:lnTo>
+                <a:lnTo>
+                  <a:pt x="2832780" y="257104"/>
+                </a:lnTo>
+                <a:lnTo>
+                  <a:pt x="2941733" y="227721"/>
+                </a:lnTo>
+                <a:lnTo>
+                  <a:pt x="3050686" y="58767"/>
+                </a:lnTo>
+                <a:lnTo>
+                  <a:pt x="3159639" y="0"/>
+                </a:lnTo>
+                <a:lnTo>
+                  <a:pt x="3268592" y="132225"/>
+                </a:lnTo>
+                <a:lnTo>
+                  <a:pt x="3377545" y="172627"/>
+                </a:lnTo>
+                <a:lnTo>
+                  <a:pt x="3486498" y="249758"/>
+                </a:lnTo>
+                <a:lnTo>
+                  <a:pt x="3595451" y="117533"/>
+                </a:lnTo>
+                <a:lnTo>
+                  <a:pt x="3704404" y="102842"/>
+                </a:lnTo>
+                <a:lnTo>
+                  <a:pt x="3813357" y="257104"/>
+                </a:lnTo>
+                <a:lnTo>
+                  <a:pt x="3922311" y="260777"/>
+                </a:lnTo>
+                <a:lnTo>
+                  <a:pt x="4031264" y="293833"/>
+                </a:lnTo>
+                <a:lnTo>
+                  <a:pt x="4140217" y="532573"/>
+                </a:lnTo>
+                <a:lnTo>
+                  <a:pt x="4249170" y="547265"/>
+                </a:lnTo>
+                <a:lnTo>
+                  <a:pt x="4358123" y="488498"/>
+                </a:lnTo>
+                <a:lnTo>
+                  <a:pt x="4467076" y="668471"/>
+                </a:lnTo>
+                <a:lnTo>
+                  <a:pt x="4576029" y="819060"/>
+                </a:lnTo>
+                <a:lnTo>
+                  <a:pt x="4684982" y="863135"/>
+                </a:lnTo>
+                <a:lnTo>
+                  <a:pt x="4793935" y="899865"/>
+                </a:lnTo>
+                <a:lnTo>
+                  <a:pt x="4902888" y="841098"/>
+                </a:lnTo>
+                <a:lnTo>
+                  <a:pt x="5011841" y="885173"/>
+                </a:lnTo>
+                <a:lnTo>
+                  <a:pt x="5120794" y="984342"/>
+                </a:lnTo>
+                <a:lnTo>
+                  <a:pt x="5229748" y="1046781"/>
+                </a:lnTo>
+                <a:lnTo>
+                  <a:pt x="5338701" y="1050454"/>
+                </a:lnTo>
+                <a:lnTo>
+                  <a:pt x="5447654" y="1116567"/>
+                </a:lnTo>
+                <a:lnTo>
+                  <a:pt x="5556607" y="1072492"/>
+                </a:lnTo>
+                <a:lnTo>
+                  <a:pt x="5665560" y="866808"/>
+                </a:lnTo>
+                <a:lnTo>
+                  <a:pt x="5774513" y="925575"/>
+                </a:lnTo>
+                <a:lnTo>
+                  <a:pt x="5883466" y="921902"/>
+                </a:lnTo>
+                <a:lnTo>
+                  <a:pt x="5992419" y="1024744"/>
+                </a:lnTo>
+                <a:lnTo>
+                  <a:pt x="6101372" y="943940"/>
+                </a:lnTo>
+                <a:lnTo>
+                  <a:pt x="6210325" y="808042"/>
+                </a:lnTo>
+                <a:lnTo>
+                  <a:pt x="6319278" y="609704"/>
+                </a:lnTo>
+                <a:lnTo>
+                  <a:pt x="6428232" y="708873"/>
                 </a:lnTo>
               </a:path>
             </a:pathLst>
@@ -42352,8 +42352,8 @@
         </p:nvSpPr>
         <p:spPr>
           <a:xfrm>
-            <a:off x="795528" y="1784416"/>
-            <a:ext cx="6428232" cy="1354864"/>
+            <a:off x="795528" y="1955587"/>
+            <a:ext cx="6428232" cy="1261139"/>
           </a:xfrm>
           <a:custGeom>
             <a:avLst/>
@@ -42362,186 +42362,186 @@
             <a:cxnLst/>
             <a:rect l="l" t="t" r="r" b="b"/>
             <a:pathLst>
-              <a:path w="6428232" h="1354864">
+              <a:path w="6428232" h="1261139">
                 <a:moveTo>
-                  <a:pt x="0" y="994217"/>
+                  <a:pt x="0" y="823046"/>
                 </a:moveTo>
                 <a:lnTo>
-                  <a:pt x="108953" y="884212"/>
-                </a:lnTo>
-                <a:lnTo>
-                  <a:pt x="217906" y="829906"/>
-                </a:lnTo>
-                <a:lnTo>
-                  <a:pt x="326859" y="650279"/>
-                </a:lnTo>
-                <a:lnTo>
-                  <a:pt x="435812" y="607113"/>
-                </a:lnTo>
-                <a:lnTo>
-                  <a:pt x="544765" y="705977"/>
-                </a:lnTo>
-                <a:lnTo>
-                  <a:pt x="653718" y="601543"/>
-                </a:lnTo>
-                <a:lnTo>
-                  <a:pt x="762671" y="355077"/>
-                </a:lnTo>
-                <a:lnTo>
-                  <a:pt x="871624" y="0"/>
-                </a:lnTo>
-                <a:lnTo>
-                  <a:pt x="980577" y="130891"/>
-                </a:lnTo>
-                <a:lnTo>
-                  <a:pt x="1089530" y="83548"/>
-                </a:lnTo>
-                <a:lnTo>
-                  <a:pt x="1198483" y="384319"/>
-                </a:lnTo>
-                <a:lnTo>
-                  <a:pt x="1307437" y="1002571"/>
-                </a:lnTo>
-                <a:lnTo>
-                  <a:pt x="1416390" y="1045738"/>
-                </a:lnTo>
-                <a:lnTo>
-                  <a:pt x="1525343" y="1208655"/>
-                </a:lnTo>
-                <a:lnTo>
-                  <a:pt x="1634296" y="1236505"/>
-                </a:lnTo>
-                <a:lnTo>
-                  <a:pt x="1743249" y="1157134"/>
-                </a:lnTo>
-                <a:lnTo>
-                  <a:pt x="1852202" y="1165489"/>
-                </a:lnTo>
-                <a:lnTo>
-                  <a:pt x="1961155" y="1162704"/>
-                </a:lnTo>
-                <a:lnTo>
-                  <a:pt x="2070108" y="1151564"/>
-                </a:lnTo>
-                <a:lnTo>
-                  <a:pt x="2179061" y="1120930"/>
-                </a:lnTo>
-                <a:lnTo>
-                  <a:pt x="2288014" y="1074979"/>
-                </a:lnTo>
-                <a:lnTo>
-                  <a:pt x="2396967" y="1173844"/>
-                </a:lnTo>
-                <a:lnTo>
-                  <a:pt x="2505920" y="1336762"/>
-                </a:lnTo>
-                <a:lnTo>
-                  <a:pt x="2614874" y="1250429"/>
-                </a:lnTo>
-                <a:lnTo>
-                  <a:pt x="2723827" y="1275493"/>
-                </a:lnTo>
-                <a:lnTo>
-                  <a:pt x="2832780" y="1318660"/>
-                </a:lnTo>
-                <a:lnTo>
-                  <a:pt x="2941733" y="1354864"/>
-                </a:lnTo>
-                <a:lnTo>
-                  <a:pt x="3050686" y="1318660"/>
-                </a:lnTo>
-                <a:lnTo>
-                  <a:pt x="3159639" y="1340939"/>
-                </a:lnTo>
-                <a:lnTo>
-                  <a:pt x="3268592" y="1297773"/>
-                </a:lnTo>
-                <a:lnTo>
-                  <a:pt x="3377545" y="1281063"/>
-                </a:lnTo>
-                <a:lnTo>
-                  <a:pt x="3486498" y="1161312"/>
-                </a:lnTo>
-                <a:lnTo>
-                  <a:pt x="3595451" y="1171059"/>
-                </a:lnTo>
-                <a:lnTo>
-                  <a:pt x="3704404" y="1278278"/>
-                </a:lnTo>
-                <a:lnTo>
-                  <a:pt x="3813357" y="1257391"/>
-                </a:lnTo>
-                <a:lnTo>
-                  <a:pt x="3922311" y="1226757"/>
-                </a:lnTo>
-                <a:lnTo>
-                  <a:pt x="4031264" y="1175236"/>
-                </a:lnTo>
-                <a:lnTo>
-                  <a:pt x="4140217" y="1105613"/>
-                </a:lnTo>
-                <a:lnTo>
-                  <a:pt x="4249170" y="974722"/>
-                </a:lnTo>
-                <a:lnTo>
-                  <a:pt x="4358123" y="846616"/>
-                </a:lnTo>
-                <a:lnTo>
-                  <a:pt x="4467076" y="817374"/>
-                </a:lnTo>
-                <a:lnTo>
-                  <a:pt x="4576029" y="984469"/>
-                </a:lnTo>
-                <a:lnTo>
-                  <a:pt x="4684982" y="988647"/>
-                </a:lnTo>
-                <a:lnTo>
-                  <a:pt x="4793935" y="987254"/>
-                </a:lnTo>
-                <a:lnTo>
-                  <a:pt x="4902888" y="1090296"/>
-                </a:lnTo>
-                <a:lnTo>
-                  <a:pt x="5011841" y="1210048"/>
-                </a:lnTo>
-                <a:lnTo>
-                  <a:pt x="5120794" y="1172451"/>
-                </a:lnTo>
-                <a:lnTo>
-                  <a:pt x="5229748" y="1115361"/>
-                </a:lnTo>
-                <a:lnTo>
-                  <a:pt x="5338701" y="1045738"/>
-                </a:lnTo>
-                <a:lnTo>
-                  <a:pt x="5447654" y="1030420"/>
-                </a:lnTo>
-                <a:lnTo>
-                  <a:pt x="5556607" y="1029028"/>
-                </a:lnTo>
-                <a:lnTo>
-                  <a:pt x="5665560" y="1105613"/>
-                </a:lnTo>
-                <a:lnTo>
-                  <a:pt x="5774513" y="1109791"/>
-                </a:lnTo>
-                <a:lnTo>
-                  <a:pt x="5883466" y="1074979"/>
-                </a:lnTo>
-                <a:lnTo>
-                  <a:pt x="5992419" y="1027636"/>
-                </a:lnTo>
-                <a:lnTo>
-                  <a:pt x="6101372" y="930163"/>
-                </a:lnTo>
-                <a:lnTo>
-                  <a:pt x="6210325" y="878642"/>
-                </a:lnTo>
-                <a:lnTo>
-                  <a:pt x="6319278" y="892567"/>
-                </a:lnTo>
-                <a:lnTo>
-                  <a:pt x="6428232" y="935733"/>
+                  <a:pt x="108953" y="772496"/>
+                </a:lnTo>
+                <a:lnTo>
+                  <a:pt x="217906" y="605295"/>
+                </a:lnTo>
+                <a:lnTo>
+                  <a:pt x="326859" y="565115"/>
+                </a:lnTo>
+                <a:lnTo>
+                  <a:pt x="435812" y="657140"/>
+                </a:lnTo>
+                <a:lnTo>
+                  <a:pt x="544765" y="559930"/>
+                </a:lnTo>
+                <a:lnTo>
+                  <a:pt x="653718" y="330515"/>
+                </a:lnTo>
+                <a:lnTo>
+                  <a:pt x="762671" y="0"/>
+                </a:lnTo>
+                <a:lnTo>
+                  <a:pt x="871624" y="121837"/>
+                </a:lnTo>
+                <a:lnTo>
+                  <a:pt x="980577" y="77768"/>
+                </a:lnTo>
+                <a:lnTo>
+                  <a:pt x="1089530" y="357733"/>
+                </a:lnTo>
+                <a:lnTo>
+                  <a:pt x="1198483" y="933217"/>
+                </a:lnTo>
+                <a:lnTo>
+                  <a:pt x="1307437" y="973397"/>
+                </a:lnTo>
+                <a:lnTo>
+                  <a:pt x="1416390" y="1125045"/>
+                </a:lnTo>
+                <a:lnTo>
+                  <a:pt x="1525343" y="1150967"/>
+                </a:lnTo>
+                <a:lnTo>
+                  <a:pt x="1634296" y="1077088"/>
+                </a:lnTo>
+                <a:lnTo>
+                  <a:pt x="1743249" y="1084865"/>
+                </a:lnTo>
+                <a:lnTo>
+                  <a:pt x="1852202" y="1082272"/>
+                </a:lnTo>
+                <a:lnTo>
+                  <a:pt x="1961155" y="1071903"/>
+                </a:lnTo>
+                <a:lnTo>
+                  <a:pt x="2070108" y="1043388"/>
+                </a:lnTo>
+                <a:lnTo>
+                  <a:pt x="2179061" y="1000616"/>
+                </a:lnTo>
+                <a:lnTo>
+                  <a:pt x="2288014" y="1092641"/>
+                </a:lnTo>
+                <a:lnTo>
+                  <a:pt x="2396967" y="1244289"/>
+                </a:lnTo>
+                <a:lnTo>
+                  <a:pt x="2505920" y="1163929"/>
+                </a:lnTo>
+                <a:lnTo>
+                  <a:pt x="2614874" y="1187259"/>
+                </a:lnTo>
+                <a:lnTo>
+                  <a:pt x="2723827" y="1227439"/>
+                </a:lnTo>
+                <a:lnTo>
+                  <a:pt x="2832780" y="1261139"/>
+                </a:lnTo>
+                <a:lnTo>
+                  <a:pt x="2941733" y="1227439"/>
+                </a:lnTo>
+                <a:lnTo>
+                  <a:pt x="3050686" y="1248177"/>
+                </a:lnTo>
+                <a:lnTo>
+                  <a:pt x="3159639" y="1207997"/>
+                </a:lnTo>
+                <a:lnTo>
+                  <a:pt x="3268592" y="1192444"/>
+                </a:lnTo>
+                <a:lnTo>
+                  <a:pt x="3377545" y="1080976"/>
+                </a:lnTo>
+                <a:lnTo>
+                  <a:pt x="3486498" y="1090049"/>
+                </a:lnTo>
+                <a:lnTo>
+                  <a:pt x="3595451" y="1189851"/>
+                </a:lnTo>
+                <a:lnTo>
+                  <a:pt x="3704404" y="1170409"/>
+                </a:lnTo>
+                <a:lnTo>
+                  <a:pt x="3813357" y="1141894"/>
+                </a:lnTo>
+                <a:lnTo>
+                  <a:pt x="3922311" y="1093938"/>
+                </a:lnTo>
+                <a:lnTo>
+                  <a:pt x="4031264" y="1029131"/>
+                </a:lnTo>
+                <a:lnTo>
+                  <a:pt x="4140217" y="907294"/>
+                </a:lnTo>
+                <a:lnTo>
+                  <a:pt x="4249170" y="788050"/>
+                </a:lnTo>
+                <a:lnTo>
+                  <a:pt x="4358123" y="760831"/>
+                </a:lnTo>
+                <a:lnTo>
+                  <a:pt x="4467076" y="916367"/>
+                </a:lnTo>
+                <a:lnTo>
+                  <a:pt x="4576029" y="920256"/>
+                </a:lnTo>
+                <a:lnTo>
+                  <a:pt x="4684982" y="918959"/>
+                </a:lnTo>
+                <a:lnTo>
+                  <a:pt x="4793935" y="1014873"/>
+                </a:lnTo>
+                <a:lnTo>
+                  <a:pt x="4902888" y="1126341"/>
+                </a:lnTo>
+                <a:lnTo>
+                  <a:pt x="5011841" y="1091345"/>
+                </a:lnTo>
+                <a:lnTo>
+                  <a:pt x="5120794" y="1038204"/>
+                </a:lnTo>
+                <a:lnTo>
+                  <a:pt x="5229748" y="973397"/>
+                </a:lnTo>
+                <a:lnTo>
+                  <a:pt x="5338701" y="959140"/>
+                </a:lnTo>
+                <a:lnTo>
+                  <a:pt x="5447654" y="957843"/>
+                </a:lnTo>
+                <a:lnTo>
+                  <a:pt x="5556607" y="1029131"/>
+                </a:lnTo>
+                <a:lnTo>
+                  <a:pt x="5665560" y="1033019"/>
+                </a:lnTo>
+                <a:lnTo>
+                  <a:pt x="5774513" y="1000616"/>
+                </a:lnTo>
+                <a:lnTo>
+                  <a:pt x="5883466" y="956547"/>
+                </a:lnTo>
+                <a:lnTo>
+                  <a:pt x="5992419" y="865818"/>
+                </a:lnTo>
+                <a:lnTo>
+                  <a:pt x="6101372" y="817861"/>
+                </a:lnTo>
+                <a:lnTo>
+                  <a:pt x="6210325" y="830822"/>
+                </a:lnTo>
+                <a:lnTo>
+                  <a:pt x="6319278" y="872299"/>
+                </a:lnTo>
+                <a:lnTo>
+                  <a:pt x="6428232" y="876187"/>
                 </a:lnTo>
               </a:path>
             </a:pathLst>
@@ -42584,8 +42584,8 @@
         </p:nvSpPr>
         <p:spPr>
           <a:xfrm>
-            <a:off x="795528" y="2057517"/>
-            <a:ext cx="6428232" cy="1024743"/>
+            <a:off x="795528" y="2262289"/>
+            <a:ext cx="6428232" cy="929418"/>
           </a:xfrm>
           <a:custGeom>
             <a:avLst/>
@@ -42594,186 +42594,186 @@
             <a:cxnLst/>
             <a:rect l="l" t="t" r="r" b="b"/>
             <a:pathLst>
-              <a:path w="6428232" h="1024743">
+              <a:path w="6428232" h="929418">
                 <a:moveTo>
-                  <a:pt x="0" y="721116"/>
+                  <a:pt x="0" y="516344"/>
                 </a:moveTo>
                 <a:lnTo>
-                  <a:pt x="108953" y="569302"/>
-                </a:lnTo>
-                <a:lnTo>
-                  <a:pt x="217906" y="569302"/>
-                </a:lnTo>
-                <a:lnTo>
-                  <a:pt x="326859" y="607255"/>
-                </a:lnTo>
-                <a:lnTo>
-                  <a:pt x="435812" y="569302"/>
-                </a:lnTo>
-                <a:lnTo>
-                  <a:pt x="544765" y="607255"/>
-                </a:lnTo>
-                <a:lnTo>
-                  <a:pt x="653718" y="683162"/>
-                </a:lnTo>
-                <a:lnTo>
-                  <a:pt x="762671" y="721116"/>
-                </a:lnTo>
-                <a:lnTo>
-                  <a:pt x="871624" y="607255"/>
-                </a:lnTo>
-                <a:lnTo>
-                  <a:pt x="980577" y="569302"/>
-                </a:lnTo>
-                <a:lnTo>
-                  <a:pt x="1089530" y="569302"/>
-                </a:lnTo>
-                <a:lnTo>
-                  <a:pt x="1198483" y="607255"/>
-                </a:lnTo>
-                <a:lnTo>
-                  <a:pt x="1307437" y="683162"/>
-                </a:lnTo>
-                <a:lnTo>
-                  <a:pt x="1416390" y="721116"/>
-                </a:lnTo>
-                <a:lnTo>
-                  <a:pt x="1525343" y="721116"/>
-                </a:lnTo>
-                <a:lnTo>
-                  <a:pt x="1634296" y="721116"/>
-                </a:lnTo>
-                <a:lnTo>
-                  <a:pt x="1743249" y="645209"/>
-                </a:lnTo>
-                <a:lnTo>
-                  <a:pt x="1852202" y="607255"/>
-                </a:lnTo>
-                <a:lnTo>
-                  <a:pt x="1961155" y="607255"/>
-                </a:lnTo>
-                <a:lnTo>
-                  <a:pt x="2070108" y="493395"/>
-                </a:lnTo>
-                <a:lnTo>
-                  <a:pt x="2179061" y="493395"/>
-                </a:lnTo>
-                <a:lnTo>
-                  <a:pt x="2288014" y="189767"/>
-                </a:lnTo>
-                <a:lnTo>
-                  <a:pt x="2396967" y="75907"/>
-                </a:lnTo>
-                <a:lnTo>
-                  <a:pt x="2505920" y="151814"/>
-                </a:lnTo>
-                <a:lnTo>
-                  <a:pt x="2614874" y="227721"/>
-                </a:lnTo>
-                <a:lnTo>
-                  <a:pt x="2723827" y="189767"/>
-                </a:lnTo>
-                <a:lnTo>
-                  <a:pt x="2832780" y="0"/>
-                </a:lnTo>
-                <a:lnTo>
-                  <a:pt x="2941733" y="37953"/>
-                </a:lnTo>
-                <a:lnTo>
-                  <a:pt x="3050686" y="37953"/>
-                </a:lnTo>
-                <a:lnTo>
-                  <a:pt x="3159639" y="379534"/>
-                </a:lnTo>
-                <a:lnTo>
-                  <a:pt x="3268592" y="379534"/>
-                </a:lnTo>
-                <a:lnTo>
-                  <a:pt x="3377545" y="303627"/>
-                </a:lnTo>
-                <a:lnTo>
-                  <a:pt x="3486498" y="379534"/>
-                </a:lnTo>
-                <a:lnTo>
-                  <a:pt x="3595451" y="493395"/>
-                </a:lnTo>
-                <a:lnTo>
-                  <a:pt x="3704404" y="607255"/>
-                </a:lnTo>
-                <a:lnTo>
-                  <a:pt x="3813357" y="569302"/>
-                </a:lnTo>
-                <a:lnTo>
-                  <a:pt x="3922311" y="569302"/>
-                </a:lnTo>
-                <a:lnTo>
-                  <a:pt x="4031264" y="645209"/>
-                </a:lnTo>
-                <a:lnTo>
-                  <a:pt x="4140217" y="493395"/>
-                </a:lnTo>
-                <a:lnTo>
-                  <a:pt x="4249170" y="455441"/>
-                </a:lnTo>
-                <a:lnTo>
-                  <a:pt x="4358123" y="493395"/>
-                </a:lnTo>
-                <a:lnTo>
-                  <a:pt x="4467076" y="531348"/>
-                </a:lnTo>
-                <a:lnTo>
-                  <a:pt x="4576029" y="683162"/>
-                </a:lnTo>
-                <a:lnTo>
-                  <a:pt x="4684982" y="607255"/>
-                </a:lnTo>
-                <a:lnTo>
-                  <a:pt x="4793935" y="607255"/>
-                </a:lnTo>
-                <a:lnTo>
-                  <a:pt x="4902888" y="683162"/>
-                </a:lnTo>
-                <a:lnTo>
-                  <a:pt x="5011841" y="721116"/>
-                </a:lnTo>
-                <a:lnTo>
-                  <a:pt x="5120794" y="797022"/>
-                </a:lnTo>
-                <a:lnTo>
-                  <a:pt x="5229748" y="797022"/>
-                </a:lnTo>
-                <a:lnTo>
-                  <a:pt x="5338701" y="797022"/>
-                </a:lnTo>
-                <a:lnTo>
-                  <a:pt x="5447654" y="872929"/>
-                </a:lnTo>
-                <a:lnTo>
-                  <a:pt x="5556607" y="910883"/>
-                </a:lnTo>
-                <a:lnTo>
-                  <a:pt x="5665560" y="986790"/>
-                </a:lnTo>
-                <a:lnTo>
-                  <a:pt x="5774513" y="986790"/>
-                </a:lnTo>
-                <a:lnTo>
-                  <a:pt x="5883466" y="986790"/>
-                </a:lnTo>
-                <a:lnTo>
-                  <a:pt x="5992419" y="1024743"/>
-                </a:lnTo>
-                <a:lnTo>
-                  <a:pt x="6101372" y="948836"/>
-                </a:lnTo>
-                <a:lnTo>
-                  <a:pt x="6210325" y="986790"/>
-                </a:lnTo>
-                <a:lnTo>
-                  <a:pt x="6319278" y="910883"/>
-                </a:lnTo>
-                <a:lnTo>
-                  <a:pt x="6428232" y="986790"/>
+                  <a:pt x="108953" y="516344"/>
+                </a:lnTo>
+                <a:lnTo>
+                  <a:pt x="217906" y="550766"/>
+                </a:lnTo>
+                <a:lnTo>
+                  <a:pt x="326859" y="516344"/>
+                </a:lnTo>
+                <a:lnTo>
+                  <a:pt x="435812" y="550766"/>
+                </a:lnTo>
+                <a:lnTo>
+                  <a:pt x="544765" y="619612"/>
+                </a:lnTo>
+                <a:lnTo>
+                  <a:pt x="653718" y="654035"/>
+                </a:lnTo>
+                <a:lnTo>
+                  <a:pt x="762671" y="550766"/>
+                </a:lnTo>
+                <a:lnTo>
+                  <a:pt x="871624" y="516344"/>
+                </a:lnTo>
+                <a:lnTo>
+                  <a:pt x="980577" y="516344"/>
+                </a:lnTo>
+                <a:lnTo>
+                  <a:pt x="1089530" y="550766"/>
+                </a:lnTo>
+                <a:lnTo>
+                  <a:pt x="1198483" y="619612"/>
+                </a:lnTo>
+                <a:lnTo>
+                  <a:pt x="1307437" y="654035"/>
+                </a:lnTo>
+                <a:lnTo>
+                  <a:pt x="1416390" y="654035"/>
+                </a:lnTo>
+                <a:lnTo>
+                  <a:pt x="1525343" y="654035"/>
+                </a:lnTo>
+                <a:lnTo>
+                  <a:pt x="1634296" y="585189"/>
+                </a:lnTo>
+                <a:lnTo>
+                  <a:pt x="1743249" y="550766"/>
+                </a:lnTo>
+                <a:lnTo>
+                  <a:pt x="1852202" y="550766"/>
+                </a:lnTo>
+                <a:lnTo>
+                  <a:pt x="1961155" y="447498"/>
+                </a:lnTo>
+                <a:lnTo>
+                  <a:pt x="2070108" y="447498"/>
+                </a:lnTo>
+                <a:lnTo>
+                  <a:pt x="2179061" y="172114"/>
+                </a:lnTo>
+                <a:lnTo>
+                  <a:pt x="2288014" y="68846"/>
+                </a:lnTo>
+                <a:lnTo>
+                  <a:pt x="2396967" y="137692"/>
+                </a:lnTo>
+                <a:lnTo>
+                  <a:pt x="2505920" y="206537"/>
+                </a:lnTo>
+                <a:lnTo>
+                  <a:pt x="2614874" y="172114"/>
+                </a:lnTo>
+                <a:lnTo>
+                  <a:pt x="2723827" y="0"/>
+                </a:lnTo>
+                <a:lnTo>
+                  <a:pt x="2832780" y="34423"/>
+                </a:lnTo>
+                <a:lnTo>
+                  <a:pt x="2941733" y="34423"/>
+                </a:lnTo>
+                <a:lnTo>
+                  <a:pt x="3050686" y="344229"/>
+                </a:lnTo>
+                <a:lnTo>
+                  <a:pt x="3159639" y="344229"/>
+                </a:lnTo>
+                <a:lnTo>
+                  <a:pt x="3268592" y="275383"/>
+                </a:lnTo>
+                <a:lnTo>
+                  <a:pt x="3377545" y="344229"/>
+                </a:lnTo>
+                <a:lnTo>
+                  <a:pt x="3486498" y="447498"/>
+                </a:lnTo>
+                <a:lnTo>
+                  <a:pt x="3595451" y="550766"/>
+                </a:lnTo>
+                <a:lnTo>
+                  <a:pt x="3704404" y="516344"/>
+                </a:lnTo>
+                <a:lnTo>
+                  <a:pt x="3813357" y="516344"/>
+                </a:lnTo>
+                <a:lnTo>
+                  <a:pt x="3922311" y="585189"/>
+                </a:lnTo>
+                <a:lnTo>
+                  <a:pt x="4031264" y="447498"/>
+                </a:lnTo>
+                <a:lnTo>
+                  <a:pt x="4140217" y="413075"/>
+                </a:lnTo>
+                <a:lnTo>
+                  <a:pt x="4249170" y="447498"/>
+                </a:lnTo>
+                <a:lnTo>
+                  <a:pt x="4358123" y="481921"/>
+                </a:lnTo>
+                <a:lnTo>
+                  <a:pt x="4467076" y="619612"/>
+                </a:lnTo>
+                <a:lnTo>
+                  <a:pt x="4576029" y="550766"/>
+                </a:lnTo>
+                <a:lnTo>
+                  <a:pt x="4684982" y="550766"/>
+                </a:lnTo>
+                <a:lnTo>
+                  <a:pt x="4793935" y="619612"/>
+                </a:lnTo>
+                <a:lnTo>
+                  <a:pt x="4902888" y="654035"/>
+                </a:lnTo>
+                <a:lnTo>
+                  <a:pt x="5011841" y="722881"/>
+                </a:lnTo>
+                <a:lnTo>
+                  <a:pt x="5120794" y="722881"/>
+                </a:lnTo>
+                <a:lnTo>
+                  <a:pt x="5229748" y="722881"/>
+                </a:lnTo>
+                <a:lnTo>
+                  <a:pt x="5338701" y="791727"/>
+                </a:lnTo>
+                <a:lnTo>
+                  <a:pt x="5447654" y="826150"/>
+                </a:lnTo>
+                <a:lnTo>
+                  <a:pt x="5556607" y="894995"/>
+                </a:lnTo>
+                <a:lnTo>
+                  <a:pt x="5665560" y="894995"/>
+                </a:lnTo>
+                <a:lnTo>
+                  <a:pt x="5774513" y="894995"/>
+                </a:lnTo>
+                <a:lnTo>
+                  <a:pt x="5883466" y="929418"/>
+                </a:lnTo>
+                <a:lnTo>
+                  <a:pt x="5992419" y="860573"/>
+                </a:lnTo>
+                <a:lnTo>
+                  <a:pt x="6101372" y="894995"/>
+                </a:lnTo>
+                <a:lnTo>
+                  <a:pt x="6210325" y="826150"/>
+                </a:lnTo>
+                <a:lnTo>
+                  <a:pt x="6319278" y="894995"/>
+                </a:lnTo>
+                <a:lnTo>
+                  <a:pt x="6428232" y="826150"/>
                 </a:lnTo>
               </a:path>
             </a:pathLst>
@@ -42816,7 +42816,7 @@
         </p:nvSpPr>
         <p:spPr>
           <a:xfrm>
-            <a:off x="612647" y="3739896"/>
+            <a:off x="503694" y="3739896"/>
             <a:ext cx="365760" cy="125730"/>
           </a:xfrm>
           <a:prstGeom prst="rect">
@@ -42855,7 +42855,7 @@
         </p:nvSpPr>
         <p:spPr>
           <a:xfrm>
-            <a:off x="2573803" y="3739896"/>
+            <a:off x="2464850" y="3739896"/>
             <a:ext cx="365760" cy="125730"/>
           </a:xfrm>
           <a:prstGeom prst="rect">
@@ -42894,7 +42894,7 @@
         </p:nvSpPr>
         <p:spPr>
           <a:xfrm>
-            <a:off x="4534959" y="3739896"/>
+            <a:off x="4426005" y="3739896"/>
             <a:ext cx="365760" cy="125730"/>
           </a:xfrm>
           <a:prstGeom prst="rect">
@@ -42933,7 +42933,7 @@
         </p:nvSpPr>
         <p:spPr>
           <a:xfrm>
-            <a:off x="6496114" y="3739896"/>
+            <a:off x="6387161" y="3739896"/>
             <a:ext cx="365760" cy="125730"/>
           </a:xfrm>
           <a:prstGeom prst="rect">
@@ -43164,8 +43164,8 @@
                 </a:solidFill>
                 <a:latin typeface="Kanit"/>
               </a:rPr>
-              <a:t>• น้ำตาล: ราคาโลก −45% เทียบจุดสูงสุด 2023-09 — ลดลงใน 26 จาก 33 เดือนล่าสุด ไม่ใช่การย่อตัวปีเดียว
-• ยางพารา: อยู่ต่ำกว่าระดับปี 2021 ของตัวเองถึง 20 จาก 60 เดือนล่าสุด และเพิ่งกลับขึ้นมาได้ หลังยืนเหนือระดับนั้นมา 29 เดือน</a:t>
+              <a:t>• น้ำตาล: ราคาโลก −41% เทียบจุดสูงสุด 2023-09 — ลดลงใน 26 จาก 34 เดือนล่าสุด ไม่ใช่การย่อตัวปีเดียว
+• ยางพารา: อยู่ต่ำกว่าระดับปี 2021 ของตัวเองถึง 21 จาก 60 เดือนล่าสุด และเพิ่งกลับขึ้นมาได้ หลังยืนเหนือระดับนั้นมา 30 เดือน</a:t>
             </a:r>
           </a:p>
         </p:txBody>
@@ -43419,7 +43419,7 @@
                           </a:solidFill>
                           <a:latin typeface="Kanit"/>
                         </a:rPr>
-                        <a:t>94.74</a:t>
+                        <a:t>91.81</a:t>
                       </a:r>
                     </a:p>
                   </a:txBody>
@@ -43442,7 +43442,7 @@
                           </a:solidFill>
                           <a:latin typeface="Kanit"/>
                         </a:rPr>
-                        <a:t>+0.0%</a:t>
+                        <a:t>-2.8%</a:t>
                       </a:r>
                     </a:p>
                   </a:txBody>
@@ -43465,7 +43465,7 @@
                           </a:solidFill>
                           <a:latin typeface="Kanit"/>
                         </a:rPr>
-                        <a:t>+52.9%</a:t>
+                        <a:t>+46.3%</a:t>
                       </a:r>
                     </a:p>
                   </a:txBody>
@@ -43559,7 +43559,7 @@
                           </a:solidFill>
                           <a:latin typeface="Kanit"/>
                         </a:rPr>
-                        <a:t>16,364</a:t>
+                        <a:t>15,423</a:t>
                       </a:r>
                     </a:p>
                   </a:txBody>
@@ -43582,7 +43582,7 @@
                           </a:solidFill>
                           <a:latin typeface="Kanit"/>
                         </a:rPr>
-                        <a:t>-25.2%</a:t>
+                        <a:t>-29.2%</a:t>
                       </a:r>
                     </a:p>
                   </a:txBody>
@@ -43605,7 +43605,7 @@
                           </a:solidFill>
                           <a:latin typeface="Kanit"/>
                         </a:rPr>
-                        <a:t>+19.3%</a:t>
+                        <a:t>+15.9%</a:t>
                       </a:r>
                     </a:p>
                   </a:txBody>
@@ -43699,7 +43699,7 @@
                           </a:solidFill>
                           <a:latin typeface="Kanit"/>
                         </a:rPr>
-                        <a:t>36,603</a:t>
+                        <a:t>36,361</a:t>
                       </a:r>
                     </a:p>
                   </a:txBody>
@@ -43722,7 +43722,7 @@
                           </a:solidFill>
                           <a:latin typeface="Kanit"/>
                         </a:rPr>
-                        <a:t>-37.8%</a:t>
+                        <a:t>-38.0%</a:t>
                       </a:r>
                     </a:p>
                   </a:txBody>
@@ -43741,11 +43741,11 @@
                       <a:r>
                         <a:rPr sz="1000" b="1">
                           <a:solidFill>
-                            <a:srgbClr val="15795F"/>
-                          </a:solidFill>
-                          <a:latin typeface="Kanit"/>
-                        </a:rPr>
-                        <a:t>+4.0%</a:t>
+                            <a:srgbClr val="CC0000"/>
+                          </a:solidFill>
+                          <a:latin typeface="Kanit"/>
+                        </a:rPr>
+                        <a:t>-3.6%</a:t>
                       </a:r>
                     </a:p>
                   </a:txBody>
@@ -43839,7 +43839,7 @@
                           </a:solidFill>
                           <a:latin typeface="Kanit"/>
                         </a:rPr>
-                        <a:t>10.60</a:t>
+                        <a:t>11.23</a:t>
                       </a:r>
                     </a:p>
                   </a:txBody>
@@ -43862,7 +43862,7 @@
                           </a:solidFill>
                           <a:latin typeface="Kanit"/>
                         </a:rPr>
-                        <a:t>-44.8%</a:t>
+                        <a:t>-41.4%</a:t>
                       </a:r>
                     </a:p>
                   </a:txBody>
@@ -43885,7 +43885,7 @@
                           </a:solidFill>
                           <a:latin typeface="Kanit"/>
                         </a:rPr>
-                        <a:t>-17.9%</a:t>
+                        <a:t>-20.9%</a:t>
                       </a:r>
                     </a:p>
                   </a:txBody>
@@ -44058,7 +44058,7 @@
                 </a:solidFill>
                 <a:latin typeface="Kanit"/>
               </a:rPr>
-              <a:t>ราคารายเดือนสกุลดอลลาร์ราคาปัจจุบันจาก World Bank Pink Sheet รุ่นข้อมูล 2026M06 (ข้อมูล 60 จุดต่อรายการ ปรับฐานเป็น 100 ณ 2021-07 เพื่อวาดกราฟ — หน่วยต่างกัน จึงใช้แกนเดียวกับระดับราคาดิบไม่ได้) แปลงเป็นบาทด้วยอัตราอ้างอิง ECB USD/THB 33.125 ณ 2026-08-14 สัดส่วนพื้นที่ปลูก วัดจริง จากสัดส่วนพืชของ สศก./กรมส่งเสริมการเกษตร (crop_mix.json) เป็นราคาปัจจุบัน ไม่ได้ปรับเงินเฟ้อ: ทุกตัวเลข ‘เทียบ 5 ปีก่อน’ มีเงินเฟ้อไทยห้าปีซ่อนอยู่ข้างใต้</a:t>
+              <a:t>ราคารายเดือนสกุลดอลลาร์ราคาปัจจุบันจาก World Bank Pink Sheet รุ่นข้อมูล 2026M07 (ข้อมูล 60 จุดต่อรายการ ปรับฐานเป็น 100 ณ 2021-07 เพื่อวาดกราฟ — หน่วยต่างกัน จึงใช้แกนเดียวกับระดับราคาดิบไม่ได้) แปลงเป็นบาทด้วยอัตราอ้างอิง ECB USD/THB 33.025 ณ 2026-08-17 สัดส่วนพื้นที่ปลูก วัดจริง จากสัดส่วนพืชของ สศก./กรมส่งเสริมการเกษตร (crop_mix.json) เป็นราคาปัจจุบัน ไม่ได้ปรับเงินเฟ้อ: ทุกตัวเลข ‘เทียบ 5 ปีก่อน’ มีเงินเฟ้อไทยห้าปีซ่อนอยู่ข้างใต้</a:t>
             </a:r>
           </a:p>
         </p:txBody>
@@ -44679,7 +44679,7 @@
                 </a:solidFill>
                 <a:latin typeface="Kanit"/>
               </a:rPr>
-              <a:t>มะพร้าว −67.6% สับปะรด −18.4% อ้อย −17.9% เทียบปีก่อน</a:t>
+              <a:t>มะพร้าว −67.2% สับปะรด −18.4% อ้อย −17.9% เทียบปีก่อน</a:t>
             </a:r>
           </a:p>
         </p:txBody>
@@ -44805,7 +44805,7 @@
                 </a:solidFill>
                 <a:latin typeface="Kanit"/>
               </a:rPr>
-              <a:t>+16.9%</a:t>
+              <a:t>+17.2%</a:t>
             </a:r>
           </a:p>
         </p:txBody>
@@ -45279,7 +45279,7 @@
                           </a:solidFill>
                           <a:latin typeface="Kanit"/>
                         </a:rPr>
-                        <a:t>+6.7%</a:t>
+                        <a:t>+6.8%</a:t>
                       </a:r>
                     </a:p>
                   </a:txBody>
@@ -45348,7 +45348,7 @@
                           </a:solidFill>
                           <a:latin typeface="Kanit"/>
                         </a:rPr>
-                        <a:t>-63.2%</a:t>
+                        <a:t>-62.8%</a:t>
                       </a:r>
                     </a:p>
                   </a:txBody>
@@ -45419,7 +45419,7 @@
                           </a:solidFill>
                           <a:latin typeface="Kanit"/>
                         </a:rPr>
-                        <a:t>+15.6%</a:t>
+                        <a:t>+15.9%</a:t>
                       </a:r>
                     </a:p>
                   </a:txBody>
@@ -45488,7 +45488,7 @@
                           </a:solidFill>
                           <a:latin typeface="Kanit"/>
                         </a:rPr>
-                        <a:t>+10.0%</a:t>
+                        <a:t>+10.2%</a:t>
                       </a:r>
                     </a:p>
                   </a:txBody>
@@ -45559,7 +45559,7 @@
                           </a:solidFill>
                           <a:latin typeface="Kanit"/>
                         </a:rPr>
-                        <a:t>+16.8%</a:t>
+                        <a:t>+17.2%</a:t>
                       </a:r>
                     </a:p>
                   </a:txBody>
@@ -45628,7 +45628,7 @@
                           </a:solidFill>
                           <a:latin typeface="Kanit"/>
                         </a:rPr>
-                        <a:t>+8.7%</a:t>
+                        <a:t>+8.8%</a:t>
                       </a:r>
                     </a:p>
                   </a:txBody>
@@ -45699,7 +45699,7 @@
                           </a:solidFill>
                           <a:latin typeface="Kanit"/>
                         </a:rPr>
-                        <a:t>+26.0%</a:t>
+                        <a:t>+25.7%</a:t>
                       </a:r>
                     </a:p>
                   </a:txBody>
@@ -45768,7 +45768,7 @@
                           </a:solidFill>
                           <a:latin typeface="Kanit"/>
                         </a:rPr>
-                        <a:t>+10.8%</a:t>
+                        <a:t>+11.3%</a:t>
                       </a:r>
                     </a:p>
                   </a:txBody>
@@ -45839,7 +45839,7 @@
                           </a:solidFill>
                           <a:latin typeface="Kanit"/>
                         </a:rPr>
-                        <a:t>+36.7%</a:t>
+                        <a:t>+35.8%</a:t>
                       </a:r>
                     </a:p>
                   </a:txBody>
@@ -45908,7 +45908,7 @@
                           </a:solidFill>
                           <a:latin typeface="Kanit"/>
                         </a:rPr>
-                        <a:t>+28.8%</a:t>
+                        <a:t>+27.9%</a:t>
                       </a:r>
                     </a:p>
                   </a:txBody>
@@ -46084,8 +46084,8 @@
                 </a:solidFill>
                 <a:latin typeface="Kanit"/>
               </a:rPr>
-              <a:t>•  ราคาหน้าฟาร์ม: ยางพารา +42% มันสำปะหลัง +64% ปาล์ม +25% ข้าว +14% รายได้จากพืชเพิ่มขึ้นทุกภาค
-•  มีสี่จังหวัดที่ลดลง — ทั้งหมดเป็นมะพร้าว และอยู่ฝั่งอ่าวไทยตะวันตก ราคามะพร้าวลดลง 68%
+              <a:t>•  ราคาหน้าฟาร์ม: ยางพารา +41% มันสำปะหลัง +69% ปาล์ม +24% ข้าว +14% รายได้จากพืชเพิ่มขึ้นทุกภาค
+•  มีสี่จังหวัดที่ลดลง — ทั้งหมดเป็นมะพร้าว และอยู่ฝั่งอ่าวไทยตะวันตก ราคามะพร้าวลดลง 67%
 •  กำไรบนกระดาษยังไม่ใช่เงินสด — ตารางถัดไปหักราคาด้วยต้นทุน</a:t>
             </a:r>
           </a:p>
@@ -46387,7 +46387,7 @@
                           </a:solidFill>
                           <a:latin typeface="Kanit"/>
                         </a:rPr>
-                        <a:t>+16.9%</a:t>
+                        <a:t>+17.6%</a:t>
                       </a:r>
                     </a:p>
                   </a:txBody>
@@ -46550,7 +46550,7 @@
                           </a:solidFill>
                           <a:latin typeface="Kanit"/>
                         </a:rPr>
-                        <a:t>+21.3%</a:t>
+                        <a:t>+21.7%</a:t>
                       </a:r>
                     </a:p>
                   </a:txBody>
@@ -46713,7 +46713,7 @@
                           </a:solidFill>
                           <a:latin typeface="Kanit"/>
                         </a:rPr>
-                        <a:t>+11.2%</a:t>
+                        <a:t>+11.6%</a:t>
                       </a:r>
                     </a:p>
                   </a:txBody>
@@ -46876,7 +46876,7 @@
                           </a:solidFill>
                           <a:latin typeface="Kanit"/>
                         </a:rPr>
-                        <a:t>+34.5%</a:t>
+                        <a:t>+33.6%</a:t>
                       </a:r>
                     </a:p>
                   </a:txBody>
@@ -47039,7 +47039,7 @@
                           </a:solidFill>
                           <a:latin typeface="Kanit"/>
                         </a:rPr>
-                        <a:t>+16.9%</a:t>
+                        <a:t>+17.2%</a:t>
                       </a:r>
                     </a:p>
                   </a:txBody>
@@ -47202,7 +47202,7 @@
                           </a:solidFill>
                           <a:latin typeface="Kanit"/>
                         </a:rPr>
-                        <a:t>+15.6%</a:t>
+                        <a:t>+15.8%</a:t>
                       </a:r>
                     </a:p>
                   </a:txBody>
@@ -47829,7 +47829,7 @@
                 </a:solidFill>
                 <a:latin typeface="Kanit"/>
               </a:rPr>
-              <a:t>สี่รายการมีทิศทางไม่ตรงกันระหว่างเทียบปีก่อนกับหกเดือน ตัวเลขรายปีเพียงตัวเดียวจึงอาจชี้ผิดทางได้</a:t>
+              <a:t>สามรายการมีทิศทางไม่ตรงกันระหว่างเทียบปีก่อนกับหกเดือน ตัวเลขรายปีเพียงตัวเดียวจึงอาจชี้ผิดทางได้</a:t>
             </a:r>
           </a:p>
         </p:txBody>
@@ -47985,7 +47985,7 @@
                 </a:solidFill>
                 <a:latin typeface="Kanit"/>
               </a:rPr>
-              <a:t>฿543.53 /ร้อยผล · ใต้·ตอ.</a:t>
+              <a:t>฿620.00 /ร้อยผล · ใต้·ตอ.</a:t>
             </a:r>
           </a:p>
         </p:txBody>
@@ -48024,7 +48024,7 @@
                 </a:solidFill>
                 <a:latin typeface="Kanit"/>
               </a:rPr>
-              <a:t>เทียบปีก่อน −67.6%</a:t>
+              <a:t>เทียบปีก่อน −67.2%</a:t>
             </a:r>
           </a:p>
         </p:txBody>
@@ -48063,7 +48063,7 @@
                 </a:solidFill>
                 <a:latin typeface="Kanit"/>
               </a:rPr>
-              <a:t>6 เดือน −58.7%</a:t>
+              <a:t>6 เดือน −48.8%</a:t>
             </a:r>
           </a:p>
         </p:txBody>
@@ -48137,19 +48137,19 @@
                   <a:pt x="0" y="0"/>
                 </a:moveTo>
                 <a:lnTo>
-                  <a:pt x="412943" y="149367"/>
-                </a:lnTo>
-                <a:lnTo>
-                  <a:pt x="825886" y="262297"/>
-                </a:lnTo>
-                <a:lnTo>
-                  <a:pt x="1238829" y="246096"/>
-                </a:lnTo>
-                <a:lnTo>
-                  <a:pt x="1651772" y="414999"/>
-                </a:lnTo>
-                <a:lnTo>
-                  <a:pt x="2064715" y="457200"/>
+                  <a:pt x="412943" y="170015"/>
+                </a:lnTo>
+                <a:lnTo>
+                  <a:pt x="825886" y="147424"/>
+                </a:lnTo>
+                <a:lnTo>
+                  <a:pt x="1238829" y="401963"/>
+                </a:lnTo>
+                <a:lnTo>
+                  <a:pt x="1651772" y="457200"/>
+                </a:lnTo>
+                <a:lnTo>
+                  <a:pt x="2064715" y="387883"/>
                 </a:lnTo>
               </a:path>
             </a:pathLst>
@@ -48192,7 +48192,7 @@
         </p:nvSpPr>
         <p:spPr>
           <a:xfrm>
-            <a:off x="2480767" y="2862072"/>
+            <a:off x="2480767" y="2792755"/>
             <a:ext cx="82296" cy="82296"/>
           </a:xfrm>
           <a:prstGeom prst="roundRect">
@@ -48303,7 +48303,7 @@
                 </a:solidFill>
                 <a:latin typeface="Kanit"/>
               </a:rPr>
-              <a:t>฿9.75 /กก. · ตอ.·ตต.·เหนือ</a:t>
+              <a:t>฿9.77 /กก. · ตอ.·ตต.·เหนือ</a:t>
             </a:r>
           </a:p>
         </p:txBody>
@@ -48381,7 +48381,7 @@
                 </a:solidFill>
                 <a:latin typeface="Kanit"/>
               </a:rPr>
-              <a:t>6 เดือน +47.7%</a:t>
+              <a:t>6 เดือน +48.0%</a:t>
             </a:r>
           </a:p>
         </p:txBody>
@@ -48452,19 +48452,19 @@
             <a:pathLst>
               <a:path w="2064715" h="457200">
                 <a:moveTo>
-                  <a:pt x="0" y="347240"/>
+                  <a:pt x="0" y="346494"/>
                 </a:moveTo>
                 <a:lnTo>
-                  <a:pt x="412943" y="400773"/>
+                  <a:pt x="412943" y="401128"/>
                 </a:lnTo>
                 <a:lnTo>
                   <a:pt x="825886" y="457200"/>
                 </a:lnTo>
                 <a:lnTo>
-                  <a:pt x="1238829" y="380517"/>
-                </a:lnTo>
-                <a:lnTo>
-                  <a:pt x="1651772" y="211237"/>
+                  <a:pt x="1238829" y="380999"/>
+                </a:lnTo>
+                <a:lnTo>
+                  <a:pt x="1651772" y="212784"/>
                 </a:lnTo>
                 <a:lnTo>
                   <a:pt x="2064715" y="0"/>
@@ -48557,6 +48557,324 @@
         <p:spPr>
           <a:xfrm>
             <a:off x="5016398" y="1970531"/>
+            <a:ext cx="2156155" cy="150876"/>
+          </a:xfrm>
+          <a:prstGeom prst="rect">
+            <a:avLst/>
+          </a:prstGeom>
+          <a:noFill/>
+        </p:spPr>
+        <p:txBody>
+          <a:bodyPr wrap="square" lIns="0" rIns="0" tIns="0" bIns="0" anchor="t">
+            <a:noAutofit/>
+          </a:bodyPr>
+          <a:lstStyle/>
+          <a:p>
+            <a:pPr algn="l">
+              <a:lnSpc>
+                <a:spcPts val="1188"/>
+              </a:lnSpc>
+            </a:pPr>
+            <a:r>
+              <a:rPr sz="900" b="1">
+                <a:solidFill>
+                  <a:srgbClr val="1E2F5C"/>
+                </a:solidFill>
+                <a:latin typeface="Kanit"/>
+              </a:rPr>
+              <a:t>กุ้งขาว</a:t>
+            </a:r>
+          </a:p>
+        </p:txBody>
+      </p:sp>
+      <p:sp>
+        <p:nvSpPr>
+          <p:cNvPr id="30" name="TextBox 29"/>
+          <p:cNvSpPr txBox="1"/>
+          <p:nvPr/>
+        </p:nvSpPr>
+        <p:spPr>
+          <a:xfrm>
+            <a:off x="5016398" y="2112263"/>
+            <a:ext cx="2156155" cy="125730"/>
+          </a:xfrm>
+          <a:prstGeom prst="rect">
+            <a:avLst/>
+          </a:prstGeom>
+          <a:noFill/>
+        </p:spPr>
+        <p:txBody>
+          <a:bodyPr wrap="square" lIns="0" rIns="0" tIns="0" bIns="0" anchor="t">
+            <a:noAutofit/>
+          </a:bodyPr>
+          <a:lstStyle/>
+          <a:p>
+            <a:pPr algn="l">
+              <a:lnSpc>
+                <a:spcPts val="990"/>
+              </a:lnSpc>
+            </a:pPr>
+            <a:r>
+              <a:rPr sz="750" b="0">
+                <a:solidFill>
+                  <a:srgbClr val="606060"/>
+                </a:solidFill>
+                <a:latin typeface="Kanit"/>
+              </a:rPr>
+              <a:t>฿143.33 /กก. · ชายฝั่งใต้·ตอ.</a:t>
+            </a:r>
+          </a:p>
+        </p:txBody>
+      </p:sp>
+      <p:sp>
+        <p:nvSpPr>
+          <p:cNvPr id="31" name="TextBox 30"/>
+          <p:cNvSpPr txBox="1"/>
+          <p:nvPr/>
+        </p:nvSpPr>
+        <p:spPr>
+          <a:xfrm>
+            <a:off x="5016398" y="2244851"/>
+            <a:ext cx="1078077" cy="134112"/>
+          </a:xfrm>
+          <a:prstGeom prst="rect">
+            <a:avLst/>
+          </a:prstGeom>
+          <a:noFill/>
+        </p:spPr>
+        <p:txBody>
+          <a:bodyPr wrap="square" lIns="0" rIns="0" tIns="0" bIns="0" anchor="t">
+            <a:noAutofit/>
+          </a:bodyPr>
+          <a:lstStyle/>
+          <a:p>
+            <a:pPr algn="l">
+              <a:lnSpc>
+                <a:spcPts val="1056"/>
+              </a:lnSpc>
+            </a:pPr>
+            <a:r>
+              <a:rPr sz="800" b="1">
+                <a:solidFill>
+                  <a:srgbClr val="15795F"/>
+                </a:solidFill>
+                <a:latin typeface="Kanit"/>
+              </a:rPr>
+              <a:t>เทียบปีก่อน +1.6%</a:t>
+            </a:r>
+          </a:p>
+        </p:txBody>
+      </p:sp>
+      <p:sp>
+        <p:nvSpPr>
+          <p:cNvPr id="32" name="TextBox 31"/>
+          <p:cNvSpPr txBox="1"/>
+          <p:nvPr/>
+        </p:nvSpPr>
+        <p:spPr>
+          <a:xfrm>
+            <a:off x="6094475" y="2244851"/>
+            <a:ext cx="1078077" cy="134112"/>
+          </a:xfrm>
+          <a:prstGeom prst="rect">
+            <a:avLst/>
+          </a:prstGeom>
+          <a:noFill/>
+        </p:spPr>
+        <p:txBody>
+          <a:bodyPr wrap="square" lIns="0" rIns="0" tIns="0" bIns="0" anchor="t">
+            <a:noAutofit/>
+          </a:bodyPr>
+          <a:lstStyle/>
+          <a:p>
+            <a:pPr algn="l">
+              <a:lnSpc>
+                <a:spcPts val="1056"/>
+              </a:lnSpc>
+            </a:pPr>
+            <a:r>
+              <a:rPr sz="800" b="1">
+                <a:solidFill>
+                  <a:srgbClr val="CC0000"/>
+                </a:solidFill>
+                <a:latin typeface="Kanit"/>
+              </a:rPr>
+              <a:t>6 เดือน −1.9%</a:t>
+            </a:r>
+          </a:p>
+        </p:txBody>
+      </p:sp>
+      <p:sp>
+        <p:nvSpPr>
+          <p:cNvPr id="33" name="Rectangle 32"/>
+          <p:cNvSpPr/>
+          <p:nvPr/>
+        </p:nvSpPr>
+        <p:spPr>
+          <a:xfrm>
+            <a:off x="5016398" y="2400300"/>
+            <a:ext cx="2156155" cy="548640"/>
+          </a:xfrm>
+          <a:prstGeom prst="rect">
+            <a:avLst/>
+          </a:prstGeom>
+          <a:solidFill>
+            <a:srgbClr val="FBFCFE"/>
+          </a:solidFill>
+          <a:ln w="9525">
+            <a:solidFill>
+              <a:srgbClr val="D9DEE9"/>
+            </a:solidFill>
+          </a:ln>
+          <a:effectLst/>
+        </p:spPr>
+        <p:style>
+          <a:lnRef idx="1">
+            <a:schemeClr val="accent1"/>
+          </a:lnRef>
+          <a:fillRef idx="3">
+            <a:schemeClr val="accent1"/>
+          </a:fillRef>
+          <a:effectRef idx="2">
+            <a:schemeClr val="accent1"/>
+          </a:effectRef>
+          <a:fontRef idx="minor">
+            <a:schemeClr val="lt1"/>
+          </a:fontRef>
+        </p:style>
+        <p:txBody>
+          <a:bodyPr rtlCol="0" anchor="ctr" wrap="none"/>
+          <a:lstStyle/>
+          <a:p>
+            <a:pPr algn="ctr"/>
+          </a:p>
+        </p:txBody>
+      </p:sp>
+      <p:sp>
+        <p:nvSpPr>
+          <p:cNvPr id="34" name="Freeform 33"/>
+          <p:cNvSpPr/>
+          <p:nvPr/>
+        </p:nvSpPr>
+        <p:spPr>
+          <a:xfrm>
+            <a:off x="5062118" y="2446020"/>
+            <a:ext cx="2064715" cy="457200"/>
+          </a:xfrm>
+          <a:custGeom>
+            <a:avLst/>
+            <a:gdLst/>
+            <a:ahLst/>
+            <a:cxnLst/>
+            <a:rect l="l" t="t" r="r" b="b"/>
+            <a:pathLst>
+              <a:path w="2064715" h="457200">
+                <a:moveTo>
+                  <a:pt x="0" y="222838"/>
+                </a:moveTo>
+                <a:lnTo>
+                  <a:pt x="412943" y="418928"/>
+                </a:lnTo>
+                <a:lnTo>
+                  <a:pt x="825886" y="457200"/>
+                </a:lnTo>
+                <a:lnTo>
+                  <a:pt x="1238829" y="423249"/>
+                </a:lnTo>
+                <a:lnTo>
+                  <a:pt x="1651772" y="173867"/>
+                </a:lnTo>
+                <a:lnTo>
+                  <a:pt x="2064715" y="0"/>
+                </a:lnTo>
+              </a:path>
+            </a:pathLst>
+          </a:custGeom>
+          <a:noFill/>
+          <a:ln w="20320">
+            <a:solidFill>
+              <a:srgbClr val="CC0000"/>
+            </a:solidFill>
+          </a:ln>
+          <a:effectLst/>
+        </p:spPr>
+        <p:style>
+          <a:lnRef idx="1">
+            <a:schemeClr val="accent1"/>
+          </a:lnRef>
+          <a:fillRef idx="3">
+            <a:schemeClr val="accent1"/>
+          </a:fillRef>
+          <a:effectRef idx="2">
+            <a:schemeClr val="accent1"/>
+          </a:effectRef>
+          <a:fontRef idx="minor">
+            <a:schemeClr val="lt1"/>
+          </a:fontRef>
+        </p:style>
+        <p:txBody>
+          <a:bodyPr rtlCol="0" anchor="ctr"/>
+          <a:lstStyle/>
+          <a:p>
+            <a:pPr algn="ctr"/>
+          </a:p>
+        </p:txBody>
+      </p:sp>
+      <p:sp>
+        <p:nvSpPr>
+          <p:cNvPr id="35" name="Rounded Rectangle 34"/>
+          <p:cNvSpPr/>
+          <p:nvPr/>
+        </p:nvSpPr>
+        <p:spPr>
+          <a:xfrm>
+            <a:off x="7085685" y="2404872"/>
+            <a:ext cx="82296" cy="82296"/>
+          </a:xfrm>
+          <a:prstGeom prst="roundRect">
+            <a:avLst>
+              <a:gd name="adj" fmla="val 50000"/>
+            </a:avLst>
+          </a:prstGeom>
+          <a:solidFill>
+            <a:srgbClr val="CC0000"/>
+          </a:solidFill>
+          <a:ln>
+            <a:noFill/>
+          </a:ln>
+          <a:effectLst/>
+        </p:spPr>
+        <p:style>
+          <a:lnRef idx="1">
+            <a:schemeClr val="accent1"/>
+          </a:lnRef>
+          <a:fillRef idx="3">
+            <a:schemeClr val="accent1"/>
+          </a:fillRef>
+          <a:effectRef idx="2">
+            <a:schemeClr val="accent1"/>
+          </a:effectRef>
+          <a:fontRef idx="minor">
+            <a:schemeClr val="lt1"/>
+          </a:fontRef>
+        </p:style>
+        <p:txBody>
+          <a:bodyPr rtlCol="0" anchor="ctr" wrap="none"/>
+          <a:lstStyle/>
+          <a:p>
+            <a:pPr algn="ctr"/>
+          </a:p>
+        </p:txBody>
+      </p:sp>
+      <p:sp>
+        <p:nvSpPr>
+          <p:cNvPr id="36" name="TextBox 35"/>
+          <p:cNvSpPr txBox="1"/>
+          <p:nvPr/>
+        </p:nvSpPr>
+        <p:spPr>
+          <a:xfrm>
+            <a:off x="7318857" y="1970531"/>
             <a:ext cx="2156155" cy="150876"/>
           </a:xfrm>
           <a:prstGeom prst="rect">
@@ -48589,13 +48907,13 @@
       </p:sp>
       <p:sp>
         <p:nvSpPr>
-          <p:cNvPr id="30" name="TextBox 29"/>
+          <p:cNvPr id="37" name="TextBox 36"/>
           <p:cNvSpPr txBox="1"/>
           <p:nvPr/>
         </p:nvSpPr>
         <p:spPr>
           <a:xfrm>
-            <a:off x="5016398" y="2112263"/>
+            <a:off x="7318857" y="2112263"/>
             <a:ext cx="2156155" cy="125730"/>
           </a:xfrm>
           <a:prstGeom prst="rect">
@@ -48621,20 +48939,20 @@
                 </a:solidFill>
                 <a:latin typeface="Kanit"/>
               </a:rPr>
-              <a:t>฿338.24 /ร้อยฟอง · กลาง·ตอ.</a:t>
+              <a:t>฿343.75 /ร้อยฟอง · กลาง·ตอ.</a:t>
             </a:r>
           </a:p>
         </p:txBody>
       </p:sp>
       <p:sp>
         <p:nvSpPr>
-          <p:cNvPr id="31" name="TextBox 30"/>
+          <p:cNvPr id="38" name="TextBox 37"/>
           <p:cNvSpPr txBox="1"/>
           <p:nvPr/>
         </p:nvSpPr>
         <p:spPr>
           <a:xfrm>
-            <a:off x="5016398" y="2244851"/>
+            <a:off x="7318857" y="2244851"/>
             <a:ext cx="1078077" cy="134112"/>
           </a:xfrm>
           <a:prstGeom prst="rect">
@@ -48660,20 +48978,20 @@
                 </a:solidFill>
                 <a:latin typeface="Kanit"/>
               </a:rPr>
-              <a:t>เทียบปีก่อน +0.7%</a:t>
+              <a:t>เทียบปีก่อน +2.0%</a:t>
             </a:r>
           </a:p>
         </p:txBody>
       </p:sp>
       <p:sp>
         <p:nvSpPr>
-          <p:cNvPr id="32" name="TextBox 31"/>
+          <p:cNvPr id="39" name="TextBox 38"/>
           <p:cNvSpPr txBox="1"/>
           <p:nvPr/>
         </p:nvSpPr>
         <p:spPr>
           <a:xfrm>
-            <a:off x="6094475" y="2244851"/>
+            <a:off x="8396935" y="2244851"/>
             <a:ext cx="1078077" cy="134112"/>
           </a:xfrm>
           <a:prstGeom prst="rect">
@@ -48699,20 +49017,20 @@
                 </a:solidFill>
                 <a:latin typeface="Kanit"/>
               </a:rPr>
-              <a:t>6 เดือน +5.0%</a:t>
+              <a:t>6 เดือน +13.6%</a:t>
             </a:r>
           </a:p>
         </p:txBody>
       </p:sp>
       <p:sp>
         <p:nvSpPr>
-          <p:cNvPr id="33" name="Rectangle 32"/>
+          <p:cNvPr id="40" name="Rectangle 39"/>
           <p:cNvSpPr/>
           <p:nvPr/>
         </p:nvSpPr>
         <p:spPr>
           <a:xfrm>
-            <a:off x="5016398" y="2400300"/>
+            <a:off x="7318857" y="2400300"/>
             <a:ext cx="2156155" cy="548640"/>
           </a:xfrm>
           <a:prstGeom prst="rect">
@@ -48752,13 +49070,13 @@
       </p:sp>
       <p:sp>
         <p:nvSpPr>
-          <p:cNvPr id="34" name="Freeform 33"/>
+          <p:cNvPr id="41" name="Freeform 40"/>
           <p:cNvSpPr/>
           <p:nvPr/>
         </p:nvSpPr>
         <p:spPr>
           <a:xfrm>
-            <a:off x="5062118" y="2446020"/>
+            <a:off x="7364577" y="2446020"/>
             <a:ext cx="2064715" cy="457200"/>
           </a:xfrm>
           <a:custGeom>
@@ -48773,16 +49091,16 @@
                   <a:pt x="0" y="457200"/>
                 </a:moveTo>
                 <a:lnTo>
-                  <a:pt x="412943" y="391702"/>
-                </a:lnTo>
-                <a:lnTo>
-                  <a:pt x="825886" y="105409"/>
-                </a:lnTo>
-                <a:lnTo>
-                  <a:pt x="1238829" y="105409"/>
-                </a:lnTo>
-                <a:lnTo>
-                  <a:pt x="1651772" y="214144"/>
+                  <a:pt x="412943" y="173996"/>
+                </a:lnTo>
+                <a:lnTo>
+                  <a:pt x="825886" y="173996"/>
+                </a:lnTo>
+                <a:lnTo>
+                  <a:pt x="1238829" y="281558"/>
+                </a:lnTo>
+                <a:lnTo>
+                  <a:pt x="1651772" y="66435"/>
                 </a:lnTo>
                 <a:lnTo>
                   <a:pt x="2064715" y="0"/>
@@ -48822,13 +49140,13 @@
       </p:sp>
       <p:sp>
         <p:nvSpPr>
-          <p:cNvPr id="35" name="Rounded Rectangle 34"/>
+          <p:cNvPr id="42" name="Rounded Rectangle 41"/>
           <p:cNvSpPr/>
           <p:nvPr/>
         </p:nvSpPr>
         <p:spPr>
           <a:xfrm>
-            <a:off x="7085685" y="2404872"/>
+            <a:off x="9388144" y="2404872"/>
             <a:ext cx="82296" cy="82296"/>
           </a:xfrm>
           <a:prstGeom prst="roundRect">
@@ -48868,13 +49186,13 @@
       </p:sp>
       <p:sp>
         <p:nvSpPr>
-          <p:cNvPr id="36" name="TextBox 35"/>
+          <p:cNvPr id="43" name="TextBox 42"/>
           <p:cNvSpPr txBox="1"/>
           <p:nvPr/>
         </p:nvSpPr>
         <p:spPr>
           <a:xfrm>
-            <a:off x="7318857" y="1970531"/>
+            <a:off x="9621316" y="1970531"/>
             <a:ext cx="2156155" cy="150876"/>
           </a:xfrm>
           <a:prstGeom prst="rect">
@@ -48900,20 +49218,20 @@
                 </a:solidFill>
                 <a:latin typeface="Kanit"/>
               </a:rPr>
-              <a:t>กุ้งขาว</a:t>
+              <a:t>ไก่เนื้อ</a:t>
             </a:r>
           </a:p>
         </p:txBody>
       </p:sp>
       <p:sp>
         <p:nvSpPr>
-          <p:cNvPr id="37" name="TextBox 36"/>
+          <p:cNvPr id="44" name="TextBox 43"/>
           <p:cNvSpPr txBox="1"/>
           <p:nvPr/>
         </p:nvSpPr>
         <p:spPr>
           <a:xfrm>
-            <a:off x="7318857" y="2112263"/>
+            <a:off x="9621316" y="2112263"/>
             <a:ext cx="2156155" cy="125730"/>
           </a:xfrm>
           <a:prstGeom prst="rect">
@@ -48939,20 +49257,20 @@
                 </a:solidFill>
                 <a:latin typeface="Kanit"/>
               </a:rPr>
-              <a:t>฿133.82 /กก. · ชายฝั่งใต้·ตอ.</a:t>
+              <a:t>฿43.00 /กก. · กลาง·ตอ.</a:t>
             </a:r>
           </a:p>
         </p:txBody>
       </p:sp>
       <p:sp>
         <p:nvSpPr>
-          <p:cNvPr id="38" name="TextBox 37"/>
+          <p:cNvPr id="45" name="TextBox 44"/>
           <p:cNvSpPr txBox="1"/>
           <p:nvPr/>
         </p:nvSpPr>
         <p:spPr>
           <a:xfrm>
-            <a:off x="7318857" y="2244851"/>
+            <a:off x="9621316" y="2244851"/>
             <a:ext cx="1078077" cy="134112"/>
           </a:xfrm>
           <a:prstGeom prst="rect">
@@ -48978,20 +49296,20 @@
                 </a:solidFill>
                 <a:latin typeface="Kanit"/>
               </a:rPr>
-              <a:t>เทียบปีก่อน +1.1%</a:t>
+              <a:t>เทียบปีก่อน +3.5%</a:t>
             </a:r>
           </a:p>
         </p:txBody>
       </p:sp>
       <p:sp>
         <p:nvSpPr>
-          <p:cNvPr id="39" name="TextBox 38"/>
+          <p:cNvPr id="46" name="TextBox 45"/>
           <p:cNvSpPr txBox="1"/>
           <p:nvPr/>
         </p:nvSpPr>
         <p:spPr>
           <a:xfrm>
-            <a:off x="8396935" y="2244851"/>
+            <a:off x="10699394" y="2244851"/>
             <a:ext cx="1078077" cy="134112"/>
           </a:xfrm>
           <a:prstGeom prst="rect">
@@ -49013,24 +49331,24 @@
             <a:r>
               <a:rPr sz="800" b="1">
                 <a:solidFill>
-                  <a:srgbClr val="CC0000"/>
+                  <a:srgbClr val="15795F"/>
                 </a:solidFill>
                 <a:latin typeface="Kanit"/>
               </a:rPr>
-              <a:t>6 เดือน −15.8%</a:t>
+              <a:t>6 เดือน +2.3%</a:t>
             </a:r>
           </a:p>
         </p:txBody>
       </p:sp>
       <p:sp>
         <p:nvSpPr>
-          <p:cNvPr id="40" name="Rectangle 39"/>
+          <p:cNvPr id="47" name="Rectangle 46"/>
           <p:cNvSpPr/>
           <p:nvPr/>
         </p:nvSpPr>
         <p:spPr>
           <a:xfrm>
-            <a:off x="7318857" y="2400300"/>
+            <a:off x="9621316" y="2400300"/>
             <a:ext cx="2156155" cy="548640"/>
           </a:xfrm>
           <a:prstGeom prst="rect">
@@ -49070,13 +49388,13 @@
       </p:sp>
       <p:sp>
         <p:nvSpPr>
-          <p:cNvPr id="41" name="Freeform 40"/>
+          <p:cNvPr id="48" name="Freeform 47"/>
           <p:cNvSpPr/>
           <p:nvPr/>
         </p:nvSpPr>
         <p:spPr>
           <a:xfrm>
-            <a:off x="7364577" y="2446020"/>
+            <a:off x="9667036" y="2446020"/>
             <a:ext cx="2064715" cy="457200"/>
           </a:xfrm>
           <a:custGeom>
@@ -49091,19 +49409,19 @@
                   <a:pt x="0" y="0"/>
                 </a:moveTo>
                 <a:lnTo>
-                  <a:pt x="412943" y="247179"/>
-                </a:lnTo>
-                <a:lnTo>
-                  <a:pt x="825886" y="420769"/>
+                  <a:pt x="412943" y="114807"/>
+                </a:lnTo>
+                <a:lnTo>
+                  <a:pt x="825886" y="305815"/>
                 </a:lnTo>
                 <a:lnTo>
                   <a:pt x="1238829" y="457200"/>
                 </a:lnTo>
                 <a:lnTo>
-                  <a:pt x="1651772" y="424594"/>
-                </a:lnTo>
-                <a:lnTo>
-                  <a:pt x="2064715" y="223135"/>
+                  <a:pt x="1651772" y="244855"/>
+                </a:lnTo>
+                <a:lnTo>
+                  <a:pt x="2064715" y="91439"/>
                 </a:lnTo>
               </a:path>
             </a:pathLst>
@@ -49111,7 +49429,7 @@
           <a:noFill/>
           <a:ln w="20320">
             <a:solidFill>
-              <a:srgbClr val="CC0000"/>
+              <a:srgbClr val="15795F"/>
             </a:solidFill>
           </a:ln>
           <a:effectLst/>
@@ -49140,13 +49458,13 @@
       </p:sp>
       <p:sp>
         <p:nvSpPr>
-          <p:cNvPr id="42" name="Rounded Rectangle 41"/>
+          <p:cNvPr id="49" name="Rounded Rectangle 48"/>
           <p:cNvSpPr/>
           <p:nvPr/>
         </p:nvSpPr>
         <p:spPr>
           <a:xfrm>
-            <a:off x="9388144" y="2628007"/>
+            <a:off x="11690603" y="2496311"/>
             <a:ext cx="82296" cy="82296"/>
           </a:xfrm>
           <a:prstGeom prst="roundRect">
@@ -49155,7 +49473,7 @@
             </a:avLst>
           </a:prstGeom>
           <a:solidFill>
-            <a:srgbClr val="CC0000"/>
+            <a:srgbClr val="15795F"/>
           </a:solidFill>
           <a:ln>
             <a:noFill/>
@@ -49186,13 +49504,13 @@
       </p:sp>
       <p:sp>
         <p:nvSpPr>
-          <p:cNvPr id="43" name="TextBox 42"/>
+          <p:cNvPr id="50" name="TextBox 49"/>
           <p:cNvSpPr txBox="1"/>
           <p:nvPr/>
         </p:nvSpPr>
         <p:spPr>
           <a:xfrm>
-            <a:off x="9621316" y="1970531"/>
+            <a:off x="411480" y="3076956"/>
             <a:ext cx="2156155" cy="150876"/>
           </a:xfrm>
           <a:prstGeom prst="rect">
@@ -49225,13 +49543,13 @@
       </p:sp>
       <p:sp>
         <p:nvSpPr>
-          <p:cNvPr id="44" name="TextBox 43"/>
+          <p:cNvPr id="51" name="TextBox 50"/>
           <p:cNvSpPr txBox="1"/>
           <p:nvPr/>
         </p:nvSpPr>
         <p:spPr>
           <a:xfrm>
-            <a:off x="9621316" y="2112263"/>
+            <a:off x="411480" y="3218687"/>
             <a:ext cx="2156155" cy="125730"/>
           </a:xfrm>
           <a:prstGeom prst="rect">
@@ -49257,20 +49575,20 @@
                 </a:solidFill>
                 <a:latin typeface="Kanit"/>
               </a:rPr>
-              <a:t>฿66.65 /กก. · กลาง·ตต.·ตอ.</a:t>
+              <a:t>฿70.12 /กก. · กลาง·ตต.·ตอ.</a:t>
             </a:r>
           </a:p>
         </p:txBody>
       </p:sp>
       <p:sp>
         <p:nvSpPr>
-          <p:cNvPr id="45" name="TextBox 44"/>
+          <p:cNvPr id="52" name="TextBox 51"/>
           <p:cNvSpPr txBox="1"/>
           <p:nvPr/>
         </p:nvSpPr>
         <p:spPr>
           <a:xfrm>
-            <a:off x="9621316" y="2244851"/>
+            <a:off x="411480" y="3351275"/>
             <a:ext cx="1078077" cy="134112"/>
           </a:xfrm>
           <a:prstGeom prst="rect">
@@ -49296,20 +49614,20 @@
                 </a:solidFill>
                 <a:latin typeface="Kanit"/>
               </a:rPr>
-              <a:t>เทียบปีก่อน +1.5%</a:t>
+              <a:t>เทียบปีก่อน +5.4%</a:t>
             </a:r>
           </a:p>
         </p:txBody>
       </p:sp>
       <p:sp>
         <p:nvSpPr>
-          <p:cNvPr id="46" name="TextBox 45"/>
+          <p:cNvPr id="53" name="TextBox 52"/>
           <p:cNvSpPr txBox="1"/>
           <p:nvPr/>
         </p:nvSpPr>
         <p:spPr>
           <a:xfrm>
-            <a:off x="10699394" y="2244851"/>
+            <a:off x="1489557" y="3351275"/>
             <a:ext cx="1078077" cy="134112"/>
           </a:xfrm>
           <a:prstGeom prst="rect">
@@ -49335,20 +49653,20 @@
                 </a:solidFill>
                 <a:latin typeface="Kanit"/>
               </a:rPr>
-              <a:t>6 เดือน +6.1%</a:t>
+              <a:t>6 เดือน +26.3%</a:t>
             </a:r>
           </a:p>
         </p:txBody>
       </p:sp>
       <p:sp>
         <p:nvSpPr>
-          <p:cNvPr id="47" name="Rectangle 46"/>
+          <p:cNvPr id="54" name="Rectangle 53"/>
           <p:cNvSpPr/>
           <p:nvPr/>
         </p:nvSpPr>
         <p:spPr>
           <a:xfrm>
-            <a:off x="9621316" y="2400300"/>
+            <a:off x="411480" y="3506724"/>
             <a:ext cx="2156155" cy="548640"/>
           </a:xfrm>
           <a:prstGeom prst="rect">
@@ -49388,13 +49706,13 @@
       </p:sp>
       <p:sp>
         <p:nvSpPr>
-          <p:cNvPr id="48" name="Freeform 47"/>
+          <p:cNvPr id="55" name="Freeform 54"/>
           <p:cNvSpPr/>
           <p:nvPr/>
         </p:nvSpPr>
         <p:spPr>
           <a:xfrm>
-            <a:off x="9667036" y="2446020"/>
+            <a:off x="457200" y="3552444"/>
             <a:ext cx="2064715" cy="457200"/>
           </a:xfrm>
           <a:custGeom>
@@ -49406,22 +49724,22 @@
             <a:pathLst>
               <a:path w="2064715" h="457200">
                 <a:moveTo>
-                  <a:pt x="0" y="457200"/>
+                  <a:pt x="0" y="358828"/>
                 </a:moveTo>
                 <a:lnTo>
-                  <a:pt x="412943" y="182662"/>
-                </a:lnTo>
-                <a:lnTo>
-                  <a:pt x="825886" y="0"/>
-                </a:lnTo>
-                <a:lnTo>
-                  <a:pt x="1238829" y="252749"/>
-                </a:lnTo>
-                <a:lnTo>
-                  <a:pt x="1651772" y="129642"/>
-                </a:lnTo>
-                <a:lnTo>
-                  <a:pt x="2064715" y="53019"/>
+                  <a:pt x="412943" y="100410"/>
+                </a:lnTo>
+                <a:lnTo>
+                  <a:pt x="825886" y="457200"/>
+                </a:lnTo>
+                <a:lnTo>
+                  <a:pt x="1238829" y="286450"/>
+                </a:lnTo>
+                <a:lnTo>
+                  <a:pt x="1651772" y="170749"/>
+                </a:lnTo>
+                <a:lnTo>
+                  <a:pt x="2064715" y="0"/>
                 </a:lnTo>
               </a:path>
             </a:pathLst>
@@ -49458,13 +49776,13 @@
       </p:sp>
       <p:sp>
         <p:nvSpPr>
-          <p:cNvPr id="49" name="Rounded Rectangle 48"/>
+          <p:cNvPr id="56" name="Rounded Rectangle 55"/>
           <p:cNvSpPr/>
           <p:nvPr/>
         </p:nvSpPr>
         <p:spPr>
           <a:xfrm>
-            <a:off x="11690603" y="2457891"/>
+            <a:off x="2480767" y="3511296"/>
             <a:ext cx="82296" cy="82296"/>
           </a:xfrm>
           <a:prstGeom prst="roundRect">
@@ -49474,324 +49792,6 @@
           </a:prstGeom>
           <a:solidFill>
             <a:srgbClr val="15795F"/>
-          </a:solidFill>
-          <a:ln>
-            <a:noFill/>
-          </a:ln>
-          <a:effectLst/>
-        </p:spPr>
-        <p:style>
-          <a:lnRef idx="1">
-            <a:schemeClr val="accent1"/>
-          </a:lnRef>
-          <a:fillRef idx="3">
-            <a:schemeClr val="accent1"/>
-          </a:fillRef>
-          <a:effectRef idx="2">
-            <a:schemeClr val="accent1"/>
-          </a:effectRef>
-          <a:fontRef idx="minor">
-            <a:schemeClr val="lt1"/>
-          </a:fontRef>
-        </p:style>
-        <p:txBody>
-          <a:bodyPr rtlCol="0" anchor="ctr" wrap="none"/>
-          <a:lstStyle/>
-          <a:p>
-            <a:pPr algn="ctr"/>
-          </a:p>
-        </p:txBody>
-      </p:sp>
-      <p:sp>
-        <p:nvSpPr>
-          <p:cNvPr id="50" name="TextBox 49"/>
-          <p:cNvSpPr txBox="1"/>
-          <p:nvPr/>
-        </p:nvSpPr>
-        <p:spPr>
-          <a:xfrm>
-            <a:off x="411480" y="3076956"/>
-            <a:ext cx="2156155" cy="150876"/>
-          </a:xfrm>
-          <a:prstGeom prst="rect">
-            <a:avLst/>
-          </a:prstGeom>
-          <a:noFill/>
-        </p:spPr>
-        <p:txBody>
-          <a:bodyPr wrap="square" lIns="0" rIns="0" tIns="0" bIns="0" anchor="t">
-            <a:noAutofit/>
-          </a:bodyPr>
-          <a:lstStyle/>
-          <a:p>
-            <a:pPr algn="l">
-              <a:lnSpc>
-                <a:spcPts val="1188"/>
-              </a:lnSpc>
-            </a:pPr>
-            <a:r>
-              <a:rPr sz="900" b="1">
-                <a:solidFill>
-                  <a:srgbClr val="1E2F5C"/>
-                </a:solidFill>
-                <a:latin typeface="Kanit"/>
-              </a:rPr>
-              <a:t>ไก่เนื้อ</a:t>
-            </a:r>
-          </a:p>
-        </p:txBody>
-      </p:sp>
-      <p:sp>
-        <p:nvSpPr>
-          <p:cNvPr id="51" name="TextBox 50"/>
-          <p:cNvSpPr txBox="1"/>
-          <p:nvPr/>
-        </p:nvSpPr>
-        <p:spPr>
-          <a:xfrm>
-            <a:off x="411480" y="3218687"/>
-            <a:ext cx="2156155" cy="125730"/>
-          </a:xfrm>
-          <a:prstGeom prst="rect">
-            <a:avLst/>
-          </a:prstGeom>
-          <a:noFill/>
-        </p:spPr>
-        <p:txBody>
-          <a:bodyPr wrap="square" lIns="0" rIns="0" tIns="0" bIns="0" anchor="t">
-            <a:noAutofit/>
-          </a:bodyPr>
-          <a:lstStyle/>
-          <a:p>
-            <a:pPr algn="l">
-              <a:lnSpc>
-                <a:spcPts val="990"/>
-              </a:lnSpc>
-            </a:pPr>
-            <a:r>
-              <a:rPr sz="750" b="0">
-                <a:solidFill>
-                  <a:srgbClr val="606060"/>
-                </a:solidFill>
-                <a:latin typeface="Kanit"/>
-              </a:rPr>
-              <a:t>฿41.19 /กก. · กลาง·ตอ.</a:t>
-            </a:r>
-          </a:p>
-        </p:txBody>
-      </p:sp>
-      <p:sp>
-        <p:nvSpPr>
-          <p:cNvPr id="52" name="TextBox 51"/>
-          <p:cNvSpPr txBox="1"/>
-          <p:nvPr/>
-        </p:nvSpPr>
-        <p:spPr>
-          <a:xfrm>
-            <a:off x="411480" y="3351275"/>
-            <a:ext cx="1078077" cy="134112"/>
-          </a:xfrm>
-          <a:prstGeom prst="rect">
-            <a:avLst/>
-          </a:prstGeom>
-          <a:noFill/>
-        </p:spPr>
-        <p:txBody>
-          <a:bodyPr wrap="square" lIns="0" rIns="0" tIns="0" bIns="0" anchor="t">
-            <a:noAutofit/>
-          </a:bodyPr>
-          <a:lstStyle/>
-          <a:p>
-            <a:pPr algn="l">
-              <a:lnSpc>
-                <a:spcPts val="1056"/>
-              </a:lnSpc>
-            </a:pPr>
-            <a:r>
-              <a:rPr sz="800" b="1">
-                <a:solidFill>
-                  <a:srgbClr val="15795F"/>
-                </a:solidFill>
-                <a:latin typeface="Kanit"/>
-              </a:rPr>
-              <a:t>เทียบปีก่อน +2.0%</a:t>
-            </a:r>
-          </a:p>
-        </p:txBody>
-      </p:sp>
-      <p:sp>
-        <p:nvSpPr>
-          <p:cNvPr id="53" name="TextBox 52"/>
-          <p:cNvSpPr txBox="1"/>
-          <p:nvPr/>
-        </p:nvSpPr>
-        <p:spPr>
-          <a:xfrm>
-            <a:off x="1489557" y="3351275"/>
-            <a:ext cx="1078077" cy="134112"/>
-          </a:xfrm>
-          <a:prstGeom prst="rect">
-            <a:avLst/>
-          </a:prstGeom>
-          <a:noFill/>
-        </p:spPr>
-        <p:txBody>
-          <a:bodyPr wrap="square" lIns="0" rIns="0" tIns="0" bIns="0" anchor="t">
-            <a:noAutofit/>
-          </a:bodyPr>
-          <a:lstStyle/>
-          <a:p>
-            <a:pPr algn="l">
-              <a:lnSpc>
-                <a:spcPts val="1056"/>
-              </a:lnSpc>
-            </a:pPr>
-            <a:r>
-              <a:rPr sz="800" b="1">
-                <a:solidFill>
-                  <a:srgbClr val="CC0000"/>
-                </a:solidFill>
-                <a:latin typeface="Kanit"/>
-              </a:rPr>
-              <a:t>6 เดือน −1.9%</a:t>
-            </a:r>
-          </a:p>
-        </p:txBody>
-      </p:sp>
-      <p:sp>
-        <p:nvSpPr>
-          <p:cNvPr id="54" name="Rectangle 53"/>
-          <p:cNvSpPr/>
-          <p:nvPr/>
-        </p:nvSpPr>
-        <p:spPr>
-          <a:xfrm>
-            <a:off x="411480" y="3506724"/>
-            <a:ext cx="2156155" cy="548640"/>
-          </a:xfrm>
-          <a:prstGeom prst="rect">
-            <a:avLst/>
-          </a:prstGeom>
-          <a:solidFill>
-            <a:srgbClr val="FBFCFE"/>
-          </a:solidFill>
-          <a:ln w="9525">
-            <a:solidFill>
-              <a:srgbClr val="D9DEE9"/>
-            </a:solidFill>
-          </a:ln>
-          <a:effectLst/>
-        </p:spPr>
-        <p:style>
-          <a:lnRef idx="1">
-            <a:schemeClr val="accent1"/>
-          </a:lnRef>
-          <a:fillRef idx="3">
-            <a:schemeClr val="accent1"/>
-          </a:fillRef>
-          <a:effectRef idx="2">
-            <a:schemeClr val="accent1"/>
-          </a:effectRef>
-          <a:fontRef idx="minor">
-            <a:schemeClr val="lt1"/>
-          </a:fontRef>
-        </p:style>
-        <p:txBody>
-          <a:bodyPr rtlCol="0" anchor="ctr" wrap="none"/>
-          <a:lstStyle/>
-          <a:p>
-            <a:pPr algn="ctr"/>
-          </a:p>
-        </p:txBody>
-      </p:sp>
-      <p:sp>
-        <p:nvSpPr>
-          <p:cNvPr id="55" name="Freeform 54"/>
-          <p:cNvSpPr/>
-          <p:nvPr/>
-        </p:nvSpPr>
-        <p:spPr>
-          <a:xfrm>
-            <a:off x="457200" y="3552444"/>
-            <a:ext cx="2064715" cy="457200"/>
-          </a:xfrm>
-          <a:custGeom>
-            <a:avLst/>
-            <a:gdLst/>
-            <a:ahLst/>
-            <a:cxnLst/>
-            <a:rect l="l" t="t" r="r" b="b"/>
-            <a:pathLst>
-              <a:path w="2064715" h="457200">
-                <a:moveTo>
-                  <a:pt x="0" y="187960"/>
-                </a:moveTo>
-                <a:lnTo>
-                  <a:pt x="412943" y="0"/>
-                </a:lnTo>
-                <a:lnTo>
-                  <a:pt x="825886" y="114807"/>
-                </a:lnTo>
-                <a:lnTo>
-                  <a:pt x="1238829" y="305815"/>
-                </a:lnTo>
-                <a:lnTo>
-                  <a:pt x="1651772" y="457200"/>
-                </a:lnTo>
-                <a:lnTo>
-                  <a:pt x="2064715" y="275336"/>
-                </a:lnTo>
-              </a:path>
-            </a:pathLst>
-          </a:custGeom>
-          <a:noFill/>
-          <a:ln w="20320">
-            <a:solidFill>
-              <a:srgbClr val="CC0000"/>
-            </a:solidFill>
-          </a:ln>
-          <a:effectLst/>
-        </p:spPr>
-        <p:style>
-          <a:lnRef idx="1">
-            <a:schemeClr val="accent1"/>
-          </a:lnRef>
-          <a:fillRef idx="3">
-            <a:schemeClr val="accent1"/>
-          </a:fillRef>
-          <a:effectRef idx="2">
-            <a:schemeClr val="accent1"/>
-          </a:effectRef>
-          <a:fontRef idx="minor">
-            <a:schemeClr val="lt1"/>
-          </a:fontRef>
-        </p:style>
-        <p:txBody>
-          <a:bodyPr rtlCol="0" anchor="ctr"/>
-          <a:lstStyle/>
-          <a:p>
-            <a:pPr algn="ctr"/>
-          </a:p>
-        </p:txBody>
-      </p:sp>
-      <p:sp>
-        <p:nvSpPr>
-          <p:cNvPr id="56" name="Rounded Rectangle 55"/>
-          <p:cNvSpPr/>
-          <p:nvPr/>
-        </p:nvSpPr>
-        <p:spPr>
-          <a:xfrm>
-            <a:off x="2480767" y="3786632"/>
-            <a:ext cx="82296" cy="82296"/>
-          </a:xfrm>
-          <a:prstGeom prst="roundRect">
-            <a:avLst>
-              <a:gd name="adj" fmla="val 50000"/>
-            </a:avLst>
-          </a:prstGeom>
-          <a:solidFill>
-            <a:srgbClr val="CC0000"/>
           </a:solidFill>
           <a:ln>
             <a:noFill/>
@@ -49893,7 +49893,7 @@
                 </a:solidFill>
                 <a:latin typeface="Kanit"/>
               </a:rPr>
-              <a:t>฿17,727 /ตัน · อีสาน·เหนือ·กลาง</a:t>
+              <a:t>฿17,768 /ตัน · อีสาน·เหนือ·กลาง</a:t>
             </a:r>
           </a:p>
         </p:txBody>
@@ -49932,7 +49932,7 @@
                 </a:solidFill>
                 <a:latin typeface="Kanit"/>
               </a:rPr>
-              <a:t>เทียบปีก่อน +14.0%</a:t>
+              <a:t>เทียบปีก่อน +14.2%</a:t>
             </a:r>
           </a:p>
         </p:txBody>
@@ -49971,7 +49971,7 @@
                 </a:solidFill>
                 <a:latin typeface="Kanit"/>
               </a:rPr>
-              <a:t>6 เดือน +8.1%</a:t>
+              <a:t>6 เดือน +8.0%</a:t>
             </a:r>
           </a:p>
         </p:txBody>
@@ -50045,16 +50045,16 @@
                   <a:pt x="0" y="457200"/>
                 </a:moveTo>
                 <a:lnTo>
-                  <a:pt x="412943" y="340931"/>
-                </a:lnTo>
-                <a:lnTo>
-                  <a:pt x="825886" y="253323"/>
-                </a:lnTo>
-                <a:lnTo>
-                  <a:pt x="1238829" y="103264"/>
-                </a:lnTo>
-                <a:lnTo>
-                  <a:pt x="1651772" y="6195"/>
+                  <a:pt x="412943" y="341616"/>
+                </a:lnTo>
+                <a:lnTo>
+                  <a:pt x="825886" y="154005"/>
+                </a:lnTo>
+                <a:lnTo>
+                  <a:pt x="1238829" y="47789"/>
+                </a:lnTo>
+                <a:lnTo>
+                  <a:pt x="1651772" y="27620"/>
                 </a:lnTo>
                 <a:lnTo>
                   <a:pt x="2064715" y="0"/>
@@ -50211,7 +50211,7 @@
                 </a:solidFill>
                 <a:latin typeface="Kanit"/>
               </a:rPr>
-              <a:t>฿10.76 /กก. · เหนือ</a:t>
+              <a:t>฿10.04 /กก. · เหนือ</a:t>
             </a:r>
           </a:p>
         </p:txBody>
@@ -50289,7 +50289,7 @@
                 </a:solidFill>
                 <a:latin typeface="Kanit"/>
               </a:rPr>
-              <a:t>6 เดือน +22.1%</a:t>
+              <a:t>6 เดือน +12.7%</a:t>
             </a:r>
           </a:p>
         </p:txBody>
@@ -50363,19 +50363,19 @@
                   <a:pt x="0" y="457200"/>
                 </a:moveTo>
                 <a:lnTo>
-                  <a:pt x="412943" y="415234"/>
-                </a:lnTo>
-                <a:lnTo>
-                  <a:pt x="825886" y="315843"/>
-                </a:lnTo>
-                <a:lnTo>
-                  <a:pt x="1238829" y="81721"/>
-                </a:lnTo>
-                <a:lnTo>
-                  <a:pt x="1651772" y="0"/>
-                </a:lnTo>
-                <a:lnTo>
-                  <a:pt x="2064715" y="46382"/>
+                  <a:pt x="412943" y="357808"/>
+                </a:lnTo>
+                <a:lnTo>
+                  <a:pt x="825886" y="86967"/>
+                </a:lnTo>
+                <a:lnTo>
+                  <a:pt x="1238829" y="0"/>
+                </a:lnTo>
+                <a:lnTo>
+                  <a:pt x="1651772" y="49695"/>
+                </a:lnTo>
+                <a:lnTo>
+                  <a:pt x="2064715" y="226115"/>
                 </a:lnTo>
               </a:path>
             </a:pathLst>
@@ -50418,7 +50418,7 @@
         </p:nvSpPr>
         <p:spPr>
           <a:xfrm>
-            <a:off x="7085685" y="3557678"/>
+            <a:off x="7085685" y="3737411"/>
             <a:ext cx="82296" cy="82296"/>
           </a:xfrm>
           <a:prstGeom prst="roundRect">
@@ -50529,7 +50529,7 @@
                 </a:solidFill>
                 <a:latin typeface="Kanit"/>
               </a:rPr>
-              <a:t>฿8.21 /กก. · ใต้</a:t>
+              <a:t>฿8.65 /กก. · ใต้</a:t>
             </a:r>
           </a:p>
         </p:txBody>
@@ -50568,7 +50568,7 @@
                 </a:solidFill>
                 <a:latin typeface="Kanit"/>
               </a:rPr>
-              <a:t>เทียบปีก่อน +24.7%</a:t>
+              <a:t>เทียบปีก่อน +23.9%</a:t>
             </a:r>
           </a:p>
         </p:txBody>
@@ -50607,7 +50607,7 @@
                 </a:solidFill>
                 <a:latin typeface="Kanit"/>
               </a:rPr>
-              <a:t>6 เดือน +28.7%</a:t>
+              <a:t>6 เดือน +26.6%</a:t>
             </a:r>
           </a:p>
         </p:txBody>
@@ -50681,16 +50681,16 @@
                   <a:pt x="0" y="457200"/>
                 </a:moveTo>
                 <a:lnTo>
-                  <a:pt x="412943" y="330385"/>
-                </a:lnTo>
-                <a:lnTo>
-                  <a:pt x="825886" y="320373"/>
-                </a:lnTo>
-                <a:lnTo>
-                  <a:pt x="1238829" y="337059"/>
-                </a:lnTo>
-                <a:lnTo>
-                  <a:pt x="1651772" y="180210"/>
+                  <a:pt x="412943" y="444499"/>
+                </a:lnTo>
+                <a:lnTo>
+                  <a:pt x="825886" y="457200"/>
+                </a:lnTo>
+                <a:lnTo>
+                  <a:pt x="1238829" y="311149"/>
+                </a:lnTo>
+                <a:lnTo>
+                  <a:pt x="1651772" y="114300"/>
                 </a:lnTo>
                 <a:lnTo>
                   <a:pt x="2064715" y="0"/>
@@ -50847,7 +50847,7 @@
                 </a:solidFill>
                 <a:latin typeface="Kanit"/>
               </a:rPr>
-              <a:t>฿84.55 /กก. · ใต้·ตอ.</a:t>
+              <a:t>฿81.86 /กก. · ใต้·ตอ.</a:t>
             </a:r>
           </a:p>
         </p:txBody>
@@ -50886,7 +50886,7 @@
                 </a:solidFill>
                 <a:latin typeface="Kanit"/>
               </a:rPr>
-              <a:t>เทียบปีก่อน +42.4%</a:t>
+              <a:t>เทียบปีก่อน +41.4%</a:t>
             </a:r>
           </a:p>
         </p:txBody>
@@ -50925,7 +50925,7 @@
                 </a:solidFill>
                 <a:latin typeface="Kanit"/>
               </a:rPr>
-              <a:t>6 เดือน +49.0%</a:t>
+              <a:t>6 เดือน +35.6%</a:t>
             </a:r>
           </a:p>
         </p:txBody>
@@ -50999,19 +50999,19 @@
                   <a:pt x="0" y="457200"/>
                 </a:moveTo>
                 <a:lnTo>
-                  <a:pt x="412943" y="318935"/>
-                </a:lnTo>
-                <a:lnTo>
-                  <a:pt x="825886" y="199735"/>
-                </a:lnTo>
-                <a:lnTo>
-                  <a:pt x="1238829" y="108509"/>
-                </a:lnTo>
-                <a:lnTo>
-                  <a:pt x="1651772" y="0"/>
-                </a:lnTo>
-                <a:lnTo>
-                  <a:pt x="2064715" y="26013"/>
+                  <a:pt x="412943" y="286327"/>
+                </a:lnTo>
+                <a:lnTo>
+                  <a:pt x="825886" y="157274"/>
+                </a:lnTo>
+                <a:lnTo>
+                  <a:pt x="1238829" y="0"/>
+                </a:lnTo>
+                <a:lnTo>
+                  <a:pt x="1651772" y="37202"/>
+                </a:lnTo>
+                <a:lnTo>
+                  <a:pt x="2064715" y="104678"/>
                 </a:lnTo>
               </a:path>
             </a:pathLst>
@@ -51054,7 +51054,7 @@
         </p:nvSpPr>
         <p:spPr>
           <a:xfrm>
-            <a:off x="11690603" y="3537309"/>
+            <a:off x="11690603" y="3615974"/>
             <a:ext cx="82296" cy="82296"/>
           </a:xfrm>
           <a:prstGeom prst="roundRect">
@@ -51165,7 +51165,7 @@
                 </a:solidFill>
                 <a:latin typeface="Kanit"/>
               </a:rPr>
-              <a:t>฿3.41 /กก. · อีสาน·เหนือ·ตอ.</a:t>
+              <a:t>฿3.75 /กก. · อีสาน·เหนือ·ตอ.</a:t>
             </a:r>
           </a:p>
         </p:txBody>
@@ -51204,7 +51204,7 @@
                 </a:solidFill>
                 <a:latin typeface="Kanit"/>
               </a:rPr>
-              <a:t>เทียบปีก่อน +64.3%</a:t>
+              <a:t>เทียบปีก่อน +69.4%</a:t>
             </a:r>
           </a:p>
         </p:txBody>
@@ -51243,7 +51243,7 @@
                 </a:solidFill>
                 <a:latin typeface="Kanit"/>
               </a:rPr>
-              <a:t>6 เดือน +40.3%</a:t>
+              <a:t>6 เดือน +49.4%</a:t>
             </a:r>
           </a:p>
         </p:txBody>
@@ -51317,16 +51317,16 @@
                   <a:pt x="0" y="457200"/>
                 </a:moveTo>
                 <a:lnTo>
-                  <a:pt x="412943" y="381000"/>
-                </a:lnTo>
-                <a:lnTo>
-                  <a:pt x="825886" y="254000"/>
-                </a:lnTo>
-                <a:lnTo>
-                  <a:pt x="1238829" y="152400"/>
-                </a:lnTo>
-                <a:lnTo>
-                  <a:pt x="1651772" y="25400"/>
+                  <a:pt x="412943" y="352338"/>
+                </a:lnTo>
+                <a:lnTo>
+                  <a:pt x="825886" y="268448"/>
+                </a:lnTo>
+                <a:lnTo>
+                  <a:pt x="1238829" y="163586"/>
+                </a:lnTo>
+                <a:lnTo>
+                  <a:pt x="1651772" y="130030"/>
                 </a:lnTo>
                 <a:lnTo>
                   <a:pt x="2064715" y="0"/>
@@ -51483,7 +51483,7 @@
                 </a:solidFill>
                 <a:latin typeface="Kanit"/>
               </a:rPr>
-              <a:t>฿85.88 /ร้อยผล · กลาง·ตต.</a:t>
+              <a:t>฿120.00 /ร้อยผล · กลาง·ตต.</a:t>
             </a:r>
           </a:p>
         </p:txBody>
@@ -51522,7 +51522,7 @@
                 </a:solidFill>
                 <a:latin typeface="Kanit"/>
               </a:rPr>
-              <a:t>เทียบปีก่อน +126.5%</a:t>
+              <a:t>เทียบปีก่อน +96.8%</a:t>
             </a:r>
           </a:p>
         </p:txBody>
@@ -51561,7 +51561,7 @@
                 </a:solidFill>
                 <a:latin typeface="Kanit"/>
               </a:rPr>
-              <a:t>6 เดือน −44.6%</a:t>
+              <a:t>6 เดือน −42.9%</a:t>
             </a:r>
           </a:p>
         </p:txBody>
@@ -51632,22 +51632,22 @@
             <a:pathLst>
               <a:path w="2064715" h="457200">
                 <a:moveTo>
-                  <a:pt x="0" y="375183"/>
+                  <a:pt x="0" y="213177"/>
                 </a:moveTo>
                 <a:lnTo>
-                  <a:pt x="412943" y="213449"/>
-                </a:lnTo>
-                <a:lnTo>
-                  <a:pt x="825886" y="0"/>
-                </a:lnTo>
-                <a:lnTo>
-                  <a:pt x="1238829" y="260067"/>
-                </a:lnTo>
-                <a:lnTo>
-                  <a:pt x="1651772" y="443905"/>
-                </a:lnTo>
-                <a:lnTo>
-                  <a:pt x="2064715" y="457200"/>
+                  <a:pt x="412943" y="0"/>
+                </a:lnTo>
+                <a:lnTo>
+                  <a:pt x="825886" y="259737"/>
+                </a:lnTo>
+                <a:lnTo>
+                  <a:pt x="1238829" y="443342"/>
+                </a:lnTo>
+                <a:lnTo>
+                  <a:pt x="1651772" y="457200"/>
+                </a:lnTo>
+                <a:lnTo>
+                  <a:pt x="2064715" y="434102"/>
                 </a:lnTo>
               </a:path>
             </a:pathLst>
@@ -51690,7 +51690,7 @@
         </p:nvSpPr>
         <p:spPr>
           <a:xfrm>
-            <a:off x="4783226" y="5074919"/>
+            <a:off x="4783226" y="5051821"/>
             <a:ext cx="82296" cy="82296"/>
           </a:xfrm>
           <a:prstGeom prst="roundRect">
@@ -51886,7 +51886,7 @@
                 </a:solidFill>
                 <a:latin typeface="Kanit"/>
               </a:rPr>
-              <a:t>ราคาหน้าฟาร์ม วัดจริง — ราคารายวันของ NABC เฉลี่ยเป็นรายเดือน หน่วยเป็นบาทตามที่เผยแพร่ (ไม่มีการแปลงสกุลเงิน) ราคาล่าสุด 2026-08-13, รุ่นข้อมูลย้อนหลัง 2026-08-02 ราคาหน้าฟาร์ม (ราคาที่เกษตรกรขายได้) คือเงินที่เกษตรกรได้รับเมื่อขายครั้งแรก ก่อนพ่อค้าคนกลาง โรงสี หรือค่าขนส่งจะหักส่วนแบ่ง — ไม่ใช่ดัชนีโลก และไม่ใช่ราคาในซูเปอร์มาร์เก็ต แหล่งผลิตเป็นการอ่านแบบ ประมาณการ ว่าสินค้าแต่ละชนิดผลิตที่ไหน และทับซ้อนกันได้ น้ำตาลเป็นราคาอ้อยประกาศของ สอน. ปีละหนึ่งจุด จึงไม่มีการเปลี่ยนแปลงหกเดือนให้แสดง</a:t>
+              <a:t>ราคาหน้าฟาร์ม วัดจริง — ราคารายวันของ NABC เฉลี่ยเป็นรายเดือน หน่วยเป็นบาทตามที่เผยแพร่ (ไม่มีการแปลงสกุลเงิน) ราคาล่าสุด 2026-08-20, รุ่นข้อมูลย้อนหลัง 2026-08-17 ราคาหน้าฟาร์ม (ราคาที่เกษตรกรขายได้) คือเงินที่เกษตรกรได้รับเมื่อขายครั้งแรก ก่อนพ่อค้าคนกลาง โรงสี หรือค่าขนส่งจะหักส่วนแบ่ง — ไม่ใช่ดัชนีโลก และไม่ใช่ราคาในซูเปอร์มาร์เก็ต แหล่งผลิตเป็นการอ่านแบบ ประมาณการ ว่าสินค้าแต่ละชนิดผลิตที่ไหน และทับซ้อนกันได้ น้ำตาลเป็นราคาอ้อยประกาศของ สอน. ปีละหนึ่งจุด จึงไม่มีการเปลี่ยนแปลงหกเดือนให้แสดง</a:t>
             </a:r>
           </a:p>
         </p:txBody>
@@ -52543,7 +52543,7 @@
                           </a:solidFill>
                           <a:latin typeface="Kanit"/>
                         </a:rPr>
-                        <a:t>+9.1%</a:t>
+                        <a:t>+9.3%</a:t>
                       </a:r>
                     </a:p>
                   </a:txBody>
@@ -52775,7 +52775,7 @@
                           </a:solidFill>
                           <a:latin typeface="Kanit"/>
                         </a:rPr>
-                        <a:t>+12.8%</a:t>
+                        <a:t>+10.5%</a:t>
                       </a:r>
                     </a:p>
                   </a:txBody>
@@ -53007,7 +53007,7 @@
                           </a:solidFill>
                           <a:latin typeface="Kanit"/>
                         </a:rPr>
-                        <a:t>+9.4%</a:t>
+                        <a:t>+9.6%</a:t>
                       </a:r>
                     </a:p>
                   </a:txBody>
@@ -53239,7 +53239,7 @@
                           </a:solidFill>
                           <a:latin typeface="Kanit"/>
                         </a:rPr>
-                        <a:t>+9.3%</a:t>
+                        <a:t>+9.2%</a:t>
                       </a:r>
                     </a:p>
                   </a:txBody>
@@ -53471,7 +53471,7 @@
                           </a:solidFill>
                           <a:latin typeface="Kanit"/>
                         </a:rPr>
-                        <a:t>+14.5%</a:t>
+                        <a:t>+10.7%</a:t>
                       </a:r>
                     </a:p>
                   </a:txBody>

</xml_diff>

<commit_message>
deck(mcom): rebuild — the data moved past the committed figures (run 32549672014) (#559)
Co-authored-by: github-actions[bot] <41898282+github-actions[bot]@users.noreply.github.com>
</commit_message>
<xml_diff>
--- a/docs/decks/mcom-2026-08-05-macro-TH.pptx
+++ b/docs/decks/mcom-2026-08-05-macro-TH.pptx
@@ -6240,7 +6240,7 @@
                 </a:solidFill>
                 <a:latin typeface="Kanit"/>
               </a:rPr>
-              <a:t>120</a:t>
+              <a:t>141</a:t>
             </a:r>
           </a:p>
         </p:txBody>
@@ -6279,7 +6279,7 @@
                 </a:solidFill>
                 <a:latin typeface="Kanit"/>
               </a:rPr>
-              <a:t>จาก 797 (15.1%) · เรียลไทม์ · 2026-08-17</a:t>
+              <a:t>จาก 796 (17.7%) · เรียลไทม์ · 2026-08-22</a:t>
             </a:r>
           </a:p>
         </p:txBody>
@@ -6405,7 +6405,7 @@
                 </a:solidFill>
                 <a:latin typeface="Kanit"/>
               </a:rPr>
-              <a:t>8</a:t>
+              <a:t>17</a:t>
             </a:r>
           </a:p>
         </p:txBody>
@@ -6444,7 +6444,7 @@
                 </a:solidFill>
                 <a:latin typeface="Kanit"/>
               </a:rPr>
-              <a:t>ค่าล่าสุดรายวัน · 2026-08-17</a:t>
+              <a:t>ค่าล่าสุดรายวัน · 2026-08-22</a:t>
             </a:r>
           </a:p>
         </p:txBody>
@@ -7882,7 +7882,7 @@
                           </a:solidFill>
                           <a:latin typeface="Kanit"/>
                         </a:rPr>
-                        <a:t>นครพนม</a:t>
+                        <a:t>น่าน</a:t>
                       </a:r>
                     </a:p>
                   </a:txBody>
@@ -7905,7 +7905,7 @@
                           </a:solidFill>
                           <a:latin typeface="Kanit"/>
                         </a:rPr>
-                        <a:t>26</a:t>
+                        <a:t>215</a:t>
                       </a:r>
                     </a:p>
                   </a:txBody>
@@ -7928,7 +7928,7 @@
                           </a:solidFill>
                           <a:latin typeface="Kanit"/>
                         </a:rPr>
-                        <a:t>15</a:t>
+                        <a:t>68</a:t>
                       </a:r>
                     </a:p>
                   </a:txBody>
@@ -7947,11 +7947,11 @@
                       <a:r>
                         <a:rPr sz="900" b="1">
                           <a:solidFill>
-                            <a:srgbClr val="606060"/>
-                          </a:solidFill>
-                          <a:latin typeface="Kanit"/>
-                        </a:rPr>
-                        <a:t>0.0%</a:t>
+                            <a:srgbClr val="F5C242"/>
+                          </a:solidFill>
+                          <a:latin typeface="Kanit"/>
+                        </a:rPr>
+                        <a:t>1.9%</a:t>
                       </a:r>
                     </a:p>
                   </a:txBody>
@@ -7974,7 +7974,7 @@
                           </a:solidFill>
                           <a:latin typeface="Kanit"/>
                         </a:rPr>
-                        <a:t>6/14</a:t>
+                        <a:t>4/28</a:t>
                       </a:r>
                     </a:p>
                   </a:txBody>
@@ -8022,7 +8022,7 @@
                           </a:solidFill>
                           <a:latin typeface="Kanit"/>
                         </a:rPr>
-                        <a:t>มุกดาหาร</a:t>
+                        <a:t>นครพนม</a:t>
                       </a:r>
                     </a:p>
                   </a:txBody>
@@ -8045,7 +8045,7 @@
                           </a:solidFill>
                           <a:latin typeface="Kanit"/>
                         </a:rPr>
-                        <a:t>15</a:t>
+                        <a:t>28</a:t>
                       </a:r>
                     </a:p>
                   </a:txBody>
@@ -8068,7 +8068,7 @@
                           </a:solidFill>
                           <a:latin typeface="Kanit"/>
                         </a:rPr>
-                        <a:t>0</a:t>
+                        <a:t>8</a:t>
                       </a:r>
                     </a:p>
                   </a:txBody>
@@ -8114,7 +8114,7 @@
                           </a:solidFill>
                           <a:latin typeface="Kanit"/>
                         </a:rPr>
-                        <a:t>2/2</a:t>
+                        <a:t>8/14</a:t>
                       </a:r>
                     </a:p>
                   </a:txBody>
@@ -8162,7 +8162,7 @@
                           </a:solidFill>
                           <a:latin typeface="Kanit"/>
                         </a:rPr>
-                        <a:t>สกลนคร</a:t>
+                        <a:t>มุกดาหาร</a:t>
                       </a:r>
                     </a:p>
                   </a:txBody>
@@ -8185,7 +8185,7 @@
                           </a:solidFill>
                           <a:latin typeface="Kanit"/>
                         </a:rPr>
-                        <a:t>35</a:t>
+                        <a:t>17</a:t>
                       </a:r>
                     </a:p>
                   </a:txBody>
@@ -8208,7 +8208,7 @@
                           </a:solidFill>
                           <a:latin typeface="Kanit"/>
                         </a:rPr>
-                        <a:t>4</a:t>
+                        <a:t>12</a:t>
                       </a:r>
                     </a:p>
                   </a:txBody>
@@ -8254,7 +8254,7 @@
                           </a:solidFill>
                           <a:latin typeface="Kanit"/>
                         </a:rPr>
-                        <a:t>7/13</a:t>
+                        <a:t>2/2</a:t>
                       </a:r>
                     </a:p>
                   </a:txBody>
@@ -8302,7 +8302,7 @@
                           </a:solidFill>
                           <a:latin typeface="Kanit"/>
                         </a:rPr>
-                        <a:t>สตูล</a:t>
+                        <a:t>สกลนคร</a:t>
                       </a:r>
                     </a:p>
                   </a:txBody>
@@ -8325,7 +8325,7 @@
                           </a:solidFill>
                           <a:latin typeface="Kanit"/>
                         </a:rPr>
-                        <a:t>30</a:t>
+                        <a:t>38</a:t>
                       </a:r>
                     </a:p>
                   </a:txBody>
@@ -8348,7 +8348,7 @@
                           </a:solidFill>
                           <a:latin typeface="Kanit"/>
                         </a:rPr>
-                        <a:t>50</a:t>
+                        <a:t>22</a:t>
                       </a:r>
                     </a:p>
                   </a:txBody>
@@ -8367,11 +8367,11 @@
                       <a:r>
                         <a:rPr sz="900" b="1">
                           <a:solidFill>
-                            <a:srgbClr val="F5C242"/>
-                          </a:solidFill>
-                          <a:latin typeface="Kanit"/>
-                        </a:rPr>
-                        <a:t>13.3%</a:t>
+                            <a:srgbClr val="606060"/>
+                          </a:solidFill>
+                          <a:latin typeface="Kanit"/>
+                        </a:rPr>
+                        <a:t>0.0%</a:t>
                       </a:r>
                     </a:p>
                   </a:txBody>
@@ -8394,7 +8394,7 @@
                           </a:solidFill>
                           <a:latin typeface="Kanit"/>
                         </a:rPr>
-                        <a:t>1/8</a:t>
+                        <a:t>7/13</a:t>
                       </a:r>
                     </a:p>
                   </a:txBody>
@@ -8413,11 +8413,11 @@
                       <a:r>
                         <a:rPr sz="900" b="1">
                           <a:solidFill>
-                            <a:srgbClr val="F5C242"/>
-                          </a:solidFill>
-                          <a:latin typeface="Kanit"/>
-                        </a:rPr>
-                        <a:t>4</a:t>
+                            <a:srgbClr val="CC0000"/>
+                          </a:solidFill>
+                          <a:latin typeface="Kanit"/>
+                        </a:rPr>
+                        <a:t>5</a:t>
                       </a:r>
                     </a:p>
                   </a:txBody>
@@ -8442,7 +8442,7 @@
                           </a:solidFill>
                           <a:latin typeface="Kanit"/>
                         </a:rPr>
-                        <a:t>บึงกาฬ</a:t>
+                        <a:t>เพชรบูรณ์</a:t>
                       </a:r>
                     </a:p>
                   </a:txBody>
@@ -8465,7 +8465,7 @@
                           </a:solidFill>
                           <a:latin typeface="Kanit"/>
                         </a:rPr>
-                        <a:t>10</a:t>
+                        <a:t>80</a:t>
                       </a:r>
                     </a:p>
                   </a:txBody>
@@ -8488,7 +8488,7 @@
                           </a:solidFill>
                           <a:latin typeface="Kanit"/>
                         </a:rPr>
-                        <a:t>35</a:t>
+                        <a:t>18</a:t>
                       </a:r>
                     </a:p>
                   </a:txBody>
@@ -8507,11 +8507,11 @@
                       <a:r>
                         <a:rPr sz="900" b="1">
                           <a:solidFill>
-                            <a:srgbClr val="F5C242"/>
-                          </a:solidFill>
-                          <a:latin typeface="Kanit"/>
-                        </a:rPr>
-                        <a:t>10.0%</a:t>
+                            <a:srgbClr val="606060"/>
+                          </a:solidFill>
+                          <a:latin typeface="Kanit"/>
+                        </a:rPr>
+                        <a:t>0.0%</a:t>
                       </a:r>
                     </a:p>
                   </a:txBody>
@@ -8534,7 +8534,7 @@
                           </a:solidFill>
                           <a:latin typeface="Kanit"/>
                         </a:rPr>
-                        <a:t>1/1</a:t>
+                        <a:t>4/9</a:t>
                       </a:r>
                     </a:p>
                   </a:txBody>
@@ -8553,11 +8553,11 @@
                       <a:r>
                         <a:rPr sz="900" b="1">
                           <a:solidFill>
-                            <a:srgbClr val="F5C242"/>
-                          </a:solidFill>
-                          <a:latin typeface="Kanit"/>
-                        </a:rPr>
-                        <a:t>4</a:t>
+                            <a:srgbClr val="CC0000"/>
+                          </a:solidFill>
+                          <a:latin typeface="Kanit"/>
+                        </a:rPr>
+                        <a:t>5</a:t>
                       </a:r>
                     </a:p>
                   </a:txBody>
@@ -8582,7 +8582,7 @@
                           </a:solidFill>
                           <a:latin typeface="Kanit"/>
                         </a:rPr>
-                        <a:t>สงขลา</a:t>
+                        <a:t>กาญจนบุรี</a:t>
                       </a:r>
                     </a:p>
                   </a:txBody>
@@ -8605,7 +8605,7 @@
                           </a:solidFill>
                           <a:latin typeface="Kanit"/>
                         </a:rPr>
-                        <a:t>86</a:t>
+                        <a:t>93</a:t>
                       </a:r>
                     </a:p>
                   </a:txBody>
@@ -8628,7 +8628,7 @@
                           </a:solidFill>
                           <a:latin typeface="Kanit"/>
                         </a:rPr>
-                        <a:t>65</a:t>
+                        <a:t>45</a:t>
                       </a:r>
                     </a:p>
                   </a:txBody>
@@ -8651,7 +8651,7 @@
                           </a:solidFill>
                           <a:latin typeface="Kanit"/>
                         </a:rPr>
-                        <a:t>5.8%</a:t>
+                        <a:t>6.5%</a:t>
                       </a:r>
                     </a:p>
                   </a:txBody>
@@ -8674,7 +8674,7 @@
                           </a:solidFill>
                           <a:latin typeface="Kanit"/>
                         </a:rPr>
-                        <a:t>3/19</a:t>
+                        <a:t>4/26</a:t>
                       </a:r>
                     </a:p>
                   </a:txBody>
@@ -8909,7 +8909,7 @@
                 </a:solidFill>
                 <a:latin typeface="Kanit"/>
               </a:rPr>
-              <a:t>พื้นที่ปลูก วัดจริง (สศก. — ข้อมูลอำเภอ×พืช 3,295 แถว) ภัยแล้งเป็นดัชนี SPEI จาก แบบจำลอง คำนวณจากปริมาณฝนและการคายระเหย ปรับเดือนละครั้ง ดึงข้อมูล 2026-07-20 — เป็นสัญญาณที่ครอบคลุมทั้งประเทศดีที่สุดที่มี แต่ไม่มีใครลงพื้นที่ไปเดินดูอำเภอเหล่านั้น ข้อมูลฝนและระดับน้ำ วัดจริง (ThaiWater เรียลไทม์ ดึงทุกวันและสะสมไว้ — วันที่ดึงไม่สำเร็จจะเว้นเป็นช่องว่าง ไม่ใส่ค่าสมมติ) · ฝนถึง 2026-08-17, ระดับน้ำถึง 2026-08-17 ความเสี่ยงน้ำท่วมเชิงโครงสร้าง วัดจริง (สำมะโนพื้นที่ท่วมซ้ำซาก GISTDA มาตราส่วน 1:50,000 ปี 2005-2016 — เป็นบันทึกภาคพื้นดิน 12 ปี ไม่ใช่การพยากรณ์)</a:t>
+              <a:t>พื้นที่ปลูก วัดจริง (สศก. — ข้อมูลอำเภอ×พืช 3,295 แถว) ภัยแล้งเป็นดัชนี SPEI จาก แบบจำลอง คำนวณจากปริมาณฝนและการคายระเหย ปรับเดือนละครั้ง ดึงข้อมูล 2026-07-20 — เป็นสัญญาณที่ครอบคลุมทั้งประเทศดีที่สุดที่มี แต่ไม่มีใครลงพื้นที่ไปเดินดูอำเภอเหล่านั้น ข้อมูลฝนและระดับน้ำ วัดจริง (ThaiWater เรียลไทม์ ดึงทุกวันและสะสมไว้ — วันที่ดึงไม่สำเร็จจะเว้นเป็นช่องว่าง ไม่ใส่ค่าสมมติ) · ฝนถึง 2026-08-22, ระดับน้ำถึง 2026-08-22 ความเสี่ยงน้ำท่วมเชิงโครงสร้าง วัดจริง (สำมะโนพื้นที่ท่วมซ้ำซาก GISTDA มาตราส่วน 1:50,000 ปี 2005-2016 — เป็นบันทึกภาคพื้นดิน 12 ปี ไม่ใช่การพยากรณ์)</a:t>
             </a:r>
           </a:p>
         </p:txBody>
@@ -31476,7 +31476,7 @@
                 </a:solidFill>
                 <a:latin typeface="Kanit"/>
               </a:rPr>
-              <a:t>รายได้จากพืชค่ากลางเพิ่มขึ้น +16.9% แต่มีสี่จังหวัดที่ลดลง — ทั้งหมดอยู่ในแหล่งปลูกมะพร้าว โดยหนักที่สุดคือสมุทรสงครามที่ −63.2%</a:t>
+              <a:t>รายได้จากพืชค่ากลางเพิ่มขึ้น +17.2% แต่มีสี่จังหวัดที่ลดลง — ทั้งหมดอยู่ในแหล่งปลูกมะพร้าว โดยหนักที่สุดคือสมุทรสงครามที่ −62.8%</a:t>
             </a:r>
           </a:p>
         </p:txBody>
@@ -32047,7 +32047,7 @@
                 </a:solidFill>
                 <a:latin typeface="Kanit"/>
               </a:rPr>
-              <a:t>รุ่นข้อมูล — ราคาโลก 2026M06 · ราคาหน้าฟาร์มไทย 2026-08-13 · ประวัติราคาไทย 2026-08-02 · ต้นทุนการผลิตพืช สศก. ไจอัป 2568 (ปีเพาะปลูก 2568/69, ประมาณการ สศก. มี.ค. 2569) · ภัยแล้ง 2026-06-21 · เงินเฟ้อ 2026-05 · GDP 2026 ไตรมาส 1 · IMF WEO 2026 · ดัชนีราคาขายต่อ 2026-05 · ยอดจดทะเบียนถึง 2026-01 · หนี้ครัวเรือน สสช. SES 2566 · ค่าจ้าง สสช. LFS 2568 · ข้อมูลตรวจวัด 2026-08-17</a:t>
+              <a:t>รุ่นข้อมูล — ราคาโลก 2026M06 · ราคาหน้าฟาร์มไทย 2026-08-20 · ประวัติราคาไทย 2026-08-17 · ต้นทุนการผลิตพืช สศก. ไจอัป 2568 (ปีเพาะปลูก 2568/69, ประมาณการ สศก. มี.ค. 2569) · ภัยแล้ง 2026-06-21 · เงินเฟ้อ 2026-05 · GDP 2026 ไตรมาส 1 · IMF WEO 2026 · ดัชนีราคาขายต่อ 2026-05 · ยอดจดทะเบียนถึง 2026-01 · หนี้ครัวเรือน สสช. SES 2566 · ค่าจ้าง สสช. LFS 2568 · ข้อมูลตรวจวัด 2026-08-22</a:t>
             </a:r>
           </a:p>
         </p:txBody>
@@ -32545,8 +32545,8 @@
               </a:rPr>
               <a:t>Not on the world index — the farm gate (ราคาที่เกษตรกรขายได้) says otherwise.
 • Five of seventeen Thai farm-gate prices are falling year on year.
-• Beef: farm gate −6.1% vs world index +11.8%.
-• Margin over price: a 26% price move becomes an 87% swing in crop income.</a:t>
+• Beef: farm gate −6.1% vs world index +8.8%.
+• Margin over price: a 26% price move becomes an 86% swing in crop income.</a:t>
             </a:r>
           </a:p>
         </p:txBody>
@@ -33912,7 +33912,7 @@
                 </a:solidFill>
                 <a:latin typeface="Kanit"/>
               </a:rPr>
-              <a:t>33.12</a:t>
+              <a:t>33.02</a:t>
             </a:r>
           </a:p>
         </p:txBody>
@@ -33951,7 +33951,7 @@
                 </a:solidFill>
                 <a:latin typeface="Kanit"/>
               </a:rPr>
-              <a:t>อัตราอ้างอิง ECB · 2026-08-14</a:t>
+              <a:t>อัตราอ้างอิง ECB · 2026-08-17</a:t>
             </a:r>
           </a:p>
         </p:txBody>
@@ -35798,7 +35798,7 @@
                 </a:solidFill>
                 <a:latin typeface="Kanit"/>
               </a:rPr>
-              <a:t>สศช. 2026 ไตรมาส 1 · TPSO 2026-05 · ธนาคารแห่งประเทศไทย 2026-06 · BIS 2025 ไตรมาส 4 · ECB 2026-08-14, ทั้งหมดดึงจากหน่วยงานผู้เผยแพร่โดยตรง ตารางเทียบประเทศใช้ IMF World Economic Outlook 2026 (ดึงข้อมูล 2026-07-25) อัตรา NPL ที่ ธปท. เผยแพร่ — 4.48% ณ 2026 ไตรมาส 1, จาก 4.33% ไตรมาสก่อน เปลี่ยน +0.24 จุดใน 1 ปี และต่ำสุด 3.08% ณ 2021 ไตรมาส 1</a:t>
+              <a:t>สศช. 2026 ไตรมาส 1 · TPSO 2026-05 · ธนาคารแห่งประเทศไทย 2026-06 · BIS 2025 ไตรมาส 4 · ECB 2026-08-17, ทั้งหมดดึงจากหน่วยงานผู้เผยแพร่โดยตรง ตารางเทียบประเทศใช้ IMF World Economic Outlook 2026 (ดึงข้อมูล 2026-07-25) อัตรา NPL ที่ ธปท. เผยแพร่ — 4.48% ณ 2026 ไตรมาส 1, จาก 4.33% ไตรมาสก่อน เปลี่ยน +0.24 จุดใน 1 ปี และต่ำสุด 3.08% ณ 2021 ไตรมาส 1</a:t>
             </a:r>
           </a:p>
         </p:txBody>
@@ -37087,7 +37087,7 @@
                 </a:solidFill>
                 <a:latin typeface="Kanit"/>
               </a:rPr>
-              <a:t>338 จาก 928 อำเภอ · แม่น้ำเกินระดับ 120 จาก 797 สถานี</a:t>
+              <a:t>338 จาก 928 อำเภอ · แม่น้ำเกินระดับ 141 จาก 796 สถานี</a:t>
             </a:r>
           </a:p>
         </p:txBody>
@@ -37859,7 +37859,7 @@
                           </a:solidFill>
                           <a:latin typeface="Kanit"/>
                         </a:rPr>
-                        <a:t>26/157</a:t>
+                        <a:t>33/155</a:t>
                       </a:r>
                     </a:p>
                   </a:txBody>
@@ -38091,7 +38091,7 @@
                           </a:solidFill>
                           <a:latin typeface="Kanit"/>
                         </a:rPr>
-                        <a:t>22/274</a:t>
+                        <a:t>36/275</a:t>
                       </a:r>
                     </a:p>
                   </a:txBody>
@@ -38323,7 +38323,7 @@
                           </a:solidFill>
                           <a:latin typeface="Kanit"/>
                         </a:rPr>
-                        <a:t>25/169</a:t>
+                        <a:t>26/168</a:t>
                       </a:r>
                     </a:p>
                   </a:txBody>
@@ -38555,7 +38555,7 @@
                           </a:solidFill>
                           <a:latin typeface="Kanit"/>
                         </a:rPr>
-                        <a:t>6/52</a:t>
+                        <a:t>7/52</a:t>
                       </a:r>
                     </a:p>
                   </a:txBody>
@@ -38787,7 +38787,7 @@
                           </a:solidFill>
                           <a:latin typeface="Kanit"/>
                         </a:rPr>
-                        <a:t>41/145</a:t>
+                        <a:t>39/146</a:t>
                       </a:r>
                     </a:p>
                   </a:txBody>
@@ -39936,7 +39936,7 @@
                           </a:solidFill>
                           <a:latin typeface="Kanit"/>
                         </a:rPr>
-                        <a:t>−67.6%</a:t>
+                        <a:t>−67.2%</a:t>
                       </a:r>
                     </a:p>
                   </a:txBody>
@@ -39959,7 +39959,7 @@
                           </a:solidFill>
                           <a:latin typeface="Kanit"/>
                         </a:rPr>
-                        <a:t>−58.7%</a:t>
+                        <a:t>−48.8%</a:t>
                       </a:r>
                     </a:p>
                   </a:txBody>
@@ -40122,7 +40122,7 @@
                           </a:solidFill>
                           <a:latin typeface="Kanit"/>
                         </a:rPr>
-                        <a:t>+47.7%</a:t>
+                        <a:t>+48.0%</a:t>
                       </a:r>
                     </a:p>
                   </a:txBody>
@@ -40791,7 +40791,7 @@
                 </a:solidFill>
                 <a:latin typeface="Kanit"/>
               </a:rPr>
-              <a:t>ราคา วัดจริง — ราคาหน้าฟาร์มไทยจากราคารายวันของ NABC และราคาอ้อยประกาศของ สอน. ราคาล่าสุด 2026-08-13 การเปลี่ยนแปลงหกเดือนคำนวณจากข้อมูลรายเดือนของ NABC เอง (thai_price_history รุ่นข้อมูล 2026-08-02) พืชที่ไม่มีข้อมูลรายเดือนจะกำกับไว้ ไม่ประมาณการขึ้นมา แหล่งผลิตเป็นการอ่านแบบ ประมาณการ ว่าสินค้าแต่ละชนิดปลูกที่ไหน และแหล่งผลิตทับซ้อนกันได้ บัญชีอาชีพเกษตรเป็นข้อมูลของเราเองและ วัดจริง — บัญชีที่บันทึกอาชีพว่า เกษตร ในจังหวัดแหล่งผลิต จากฐานข้อมูล 382,735 บัญชี ณ 2026-07 ไม่เผยแพร่ช่องที่มีน้อยกว่า 30 บัญชี คนกลุ่มนี้อาศัยอยู่ในพื้นที่ที่ปลูกพืชนั้น แต่ไม่ได้ยืนยันว่าปลูกพืชนั้นเอง</a:t>
+              <a:t>ราคา วัดจริง — ราคาหน้าฟาร์มไทยจากราคารายวันของ NABC และราคาอ้อยประกาศของ สอน. ราคาล่าสุด 2026-08-20 การเปลี่ยนแปลงหกเดือนคำนวณจากข้อมูลรายเดือนของ NABC เอง (thai_price_history รุ่นข้อมูล 2026-08-17) พืชที่ไม่มีข้อมูลรายเดือนจะกำกับไว้ ไม่ประมาณการขึ้นมา แหล่งผลิตเป็นการอ่านแบบ ประมาณการ ว่าสินค้าแต่ละชนิดปลูกที่ไหน และแหล่งผลิตทับซ้อนกันได้ บัญชีอาชีพเกษตรเป็นข้อมูลของเราเองและ วัดจริง — บัญชีที่บันทึกอาชีพว่า เกษตร ในจังหวัดแหล่งผลิต จากฐานข้อมูล 382,735 บัญชี ณ 2026-07 ไม่เผยแพร่ช่องที่มีน้อยกว่า 30 บัญชี คนกลุ่มนี้อาศัยอยู่ในพื้นที่ที่ปลูกพืชนั้น แต่ไม่ได้ยืนยันว่าปลูกพืชนั้นเอง</a:t>
             </a:r>
           </a:p>
         </p:txBody>
@@ -40957,7 +40957,7 @@
                 </a:solidFill>
                 <a:latin typeface="Kanit"/>
               </a:rPr>
-              <a:t>เนื้อวัวตลาดโลก +11.8% ราคาหน้าฟาร์มไทย −6.1% — ต่างกัน 17.9 จุด และไปคนละทาง ลูกค้าอาชีพเกษตรของเรา 31,240 รายอาศัยอยู่ในแหล่งเลี้ยงวัวคืออีสาน</a:t>
+              <a:t>เนื้อวัวตลาดโลก +8.8% ราคาหน้าฟาร์มไทย −6.1% — ต่างกัน 14.9 จุด และไปคนละทาง ลูกค้าอาชีพเกษตรของเรา 31,240 รายอาศัยอยู่ในแหล่งเลี้ยงวัวคืออีสาน</a:t>
             </a:r>
           </a:p>
         </p:txBody>
@@ -41888,8 +41888,8 @@
         </p:nvSpPr>
         <p:spPr>
           <a:xfrm>
-            <a:off x="795528" y="1995005"/>
-            <a:ext cx="6428232" cy="1131906"/>
+            <a:off x="795528" y="2030750"/>
+            <a:ext cx="6428232" cy="1114034"/>
           </a:xfrm>
           <a:custGeom>
             <a:avLst/>
@@ -41898,186 +41898,186 @@
             <a:cxnLst/>
             <a:rect l="l" t="t" r="r" b="b"/>
             <a:pathLst>
-              <a:path w="6428232" h="1131906">
+              <a:path w="6428232" h="1114034">
                 <a:moveTo>
-                  <a:pt x="0" y="783628"/>
+                  <a:pt x="0" y="747883"/>
                 </a:moveTo>
                 <a:lnTo>
-                  <a:pt x="108953" y="759881"/>
-                </a:lnTo>
-                <a:lnTo>
-                  <a:pt x="217906" y="846951"/>
-                </a:lnTo>
-                <a:lnTo>
-                  <a:pt x="326859" y="783628"/>
-                </a:lnTo>
-                <a:lnTo>
-                  <a:pt x="435812" y="736135"/>
-                </a:lnTo>
-                <a:lnTo>
-                  <a:pt x="544765" y="744050"/>
-                </a:lnTo>
-                <a:lnTo>
-                  <a:pt x="653718" y="704473"/>
-                </a:lnTo>
-                <a:lnTo>
-                  <a:pt x="762671" y="593657"/>
-                </a:lnTo>
-                <a:lnTo>
-                  <a:pt x="871624" y="585742"/>
-                </a:lnTo>
-                <a:lnTo>
-                  <a:pt x="980577" y="609488"/>
-                </a:lnTo>
-                <a:lnTo>
-                  <a:pt x="1089530" y="633234"/>
-                </a:lnTo>
-                <a:lnTo>
-                  <a:pt x="1198483" y="656981"/>
-                </a:lnTo>
-                <a:lnTo>
-                  <a:pt x="1307437" y="854866"/>
-                </a:lnTo>
-                <a:lnTo>
-                  <a:pt x="1416390" y="989429"/>
-                </a:lnTo>
-                <a:lnTo>
-                  <a:pt x="1525343" y="1092329"/>
-                </a:lnTo>
-                <a:lnTo>
-                  <a:pt x="1634296" y="1076498"/>
-                </a:lnTo>
-                <a:lnTo>
-                  <a:pt x="1743249" y="1131906"/>
-                </a:lnTo>
-                <a:lnTo>
-                  <a:pt x="1852202" y="1044837"/>
-                </a:lnTo>
-                <a:lnTo>
-                  <a:pt x="1961155" y="973598"/>
-                </a:lnTo>
-                <a:lnTo>
-                  <a:pt x="2070108" y="981513"/>
-                </a:lnTo>
-                <a:lnTo>
-                  <a:pt x="2179061" y="1013175"/>
-                </a:lnTo>
-                <a:lnTo>
-                  <a:pt x="2288014" y="1044837"/>
-                </a:lnTo>
-                <a:lnTo>
-                  <a:pt x="2396967" y="1029006"/>
-                </a:lnTo>
-                <a:lnTo>
-                  <a:pt x="2505920" y="1052752"/>
-                </a:lnTo>
-                <a:lnTo>
-                  <a:pt x="2614874" y="1084414"/>
-                </a:lnTo>
-                <a:lnTo>
-                  <a:pt x="2723827" y="1100245"/>
-                </a:lnTo>
-                <a:lnTo>
-                  <a:pt x="2832780" y="1036921"/>
-                </a:lnTo>
-                <a:lnTo>
-                  <a:pt x="2941733" y="989429"/>
-                </a:lnTo>
-                <a:lnTo>
-                  <a:pt x="3050686" y="941936"/>
-                </a:lnTo>
-                <a:lnTo>
-                  <a:pt x="3159639" y="949851"/>
-                </a:lnTo>
-                <a:lnTo>
-                  <a:pt x="3268592" y="839035"/>
-                </a:lnTo>
-                <a:lnTo>
-                  <a:pt x="3377545" y="664896"/>
-                </a:lnTo>
-                <a:lnTo>
-                  <a:pt x="3486498" y="372025"/>
-                </a:lnTo>
-                <a:lnTo>
-                  <a:pt x="3595451" y="459095"/>
-                </a:lnTo>
-                <a:lnTo>
-                  <a:pt x="3704404" y="561996"/>
-                </a:lnTo>
-                <a:lnTo>
-                  <a:pt x="3813357" y="474926"/>
-                </a:lnTo>
-                <a:lnTo>
-                  <a:pt x="3922311" y="633234"/>
-                </a:lnTo>
-                <a:lnTo>
-                  <a:pt x="4031264" y="372025"/>
-                </a:lnTo>
-                <a:lnTo>
-                  <a:pt x="4140217" y="166224"/>
-                </a:lnTo>
-                <a:lnTo>
-                  <a:pt x="4249170" y="182055"/>
-                </a:lnTo>
-                <a:lnTo>
-                  <a:pt x="4358123" y="451180"/>
-                </a:lnTo>
-                <a:lnTo>
-                  <a:pt x="4467076" y="379941"/>
-                </a:lnTo>
-                <a:lnTo>
-                  <a:pt x="4576029" y="387856"/>
-                </a:lnTo>
-                <a:lnTo>
-                  <a:pt x="4684982" y="356194"/>
-                </a:lnTo>
-                <a:lnTo>
-                  <a:pt x="4793935" y="395772"/>
-                </a:lnTo>
-                <a:lnTo>
-                  <a:pt x="4902888" y="577826"/>
-                </a:lnTo>
-                <a:lnTo>
-                  <a:pt x="5011841" y="530334"/>
-                </a:lnTo>
-                <a:lnTo>
-                  <a:pt x="5120794" y="554080"/>
-                </a:lnTo>
-                <a:lnTo>
-                  <a:pt x="5229748" y="498672"/>
-                </a:lnTo>
-                <a:lnTo>
-                  <a:pt x="5338701" y="561996"/>
-                </a:lnTo>
-                <a:lnTo>
-                  <a:pt x="5447654" y="593657"/>
-                </a:lnTo>
-                <a:lnTo>
-                  <a:pt x="5556607" y="680727"/>
-                </a:lnTo>
-                <a:lnTo>
-                  <a:pt x="5665560" y="656981"/>
-                </a:lnTo>
-                <a:lnTo>
-                  <a:pt x="5774513" y="633234"/>
-                </a:lnTo>
-                <a:lnTo>
-                  <a:pt x="5883466" y="569911"/>
-                </a:lnTo>
-                <a:lnTo>
-                  <a:pt x="5992419" y="474926"/>
-                </a:lnTo>
-                <a:lnTo>
-                  <a:pt x="6101372" y="372025"/>
-                </a:lnTo>
-                <a:lnTo>
-                  <a:pt x="6210325" y="277040"/>
-                </a:lnTo>
-                <a:lnTo>
-                  <a:pt x="6319278" y="134562"/>
-                </a:lnTo>
-                <a:lnTo>
-                  <a:pt x="6428232" y="0"/>
+                  <a:pt x="108953" y="833577"/>
+                </a:lnTo>
+                <a:lnTo>
+                  <a:pt x="217906" y="771254"/>
+                </a:lnTo>
+                <a:lnTo>
+                  <a:pt x="326859" y="724511"/>
+                </a:lnTo>
+                <a:lnTo>
+                  <a:pt x="435812" y="732302"/>
+                </a:lnTo>
+                <a:lnTo>
+                  <a:pt x="544765" y="693349"/>
+                </a:lnTo>
+                <a:lnTo>
+                  <a:pt x="653718" y="584283"/>
+                </a:lnTo>
+                <a:lnTo>
+                  <a:pt x="762671" y="576493"/>
+                </a:lnTo>
+                <a:lnTo>
+                  <a:pt x="871624" y="599864"/>
+                </a:lnTo>
+                <a:lnTo>
+                  <a:pt x="980577" y="623235"/>
+                </a:lnTo>
+                <a:lnTo>
+                  <a:pt x="1089530" y="646607"/>
+                </a:lnTo>
+                <a:lnTo>
+                  <a:pt x="1198483" y="841368"/>
+                </a:lnTo>
+                <a:lnTo>
+                  <a:pt x="1307437" y="973805"/>
+                </a:lnTo>
+                <a:lnTo>
+                  <a:pt x="1416390" y="1075081"/>
+                </a:lnTo>
+                <a:lnTo>
+                  <a:pt x="1525343" y="1059500"/>
+                </a:lnTo>
+                <a:lnTo>
+                  <a:pt x="1634296" y="1114034"/>
+                </a:lnTo>
+                <a:lnTo>
+                  <a:pt x="1743249" y="1028339"/>
+                </a:lnTo>
+                <a:lnTo>
+                  <a:pt x="1852202" y="958225"/>
+                </a:lnTo>
+                <a:lnTo>
+                  <a:pt x="1961155" y="966015"/>
+                </a:lnTo>
+                <a:lnTo>
+                  <a:pt x="2070108" y="997177"/>
+                </a:lnTo>
+                <a:lnTo>
+                  <a:pt x="2179061" y="1028339"/>
+                </a:lnTo>
+                <a:lnTo>
+                  <a:pt x="2288014" y="1012758"/>
+                </a:lnTo>
+                <a:lnTo>
+                  <a:pt x="2396967" y="1036129"/>
+                </a:lnTo>
+                <a:lnTo>
+                  <a:pt x="2505920" y="1067291"/>
+                </a:lnTo>
+                <a:lnTo>
+                  <a:pt x="2614874" y="1082872"/>
+                </a:lnTo>
+                <a:lnTo>
+                  <a:pt x="2723827" y="1020548"/>
+                </a:lnTo>
+                <a:lnTo>
+                  <a:pt x="2832780" y="973805"/>
+                </a:lnTo>
+                <a:lnTo>
+                  <a:pt x="2941733" y="927063"/>
+                </a:lnTo>
+                <a:lnTo>
+                  <a:pt x="3050686" y="934853"/>
+                </a:lnTo>
+                <a:lnTo>
+                  <a:pt x="3159639" y="825787"/>
+                </a:lnTo>
+                <a:lnTo>
+                  <a:pt x="3268592" y="654397"/>
+                </a:lnTo>
+                <a:lnTo>
+                  <a:pt x="3377545" y="366151"/>
+                </a:lnTo>
+                <a:lnTo>
+                  <a:pt x="3486498" y="451846"/>
+                </a:lnTo>
+                <a:lnTo>
+                  <a:pt x="3595451" y="553121"/>
+                </a:lnTo>
+                <a:lnTo>
+                  <a:pt x="3704404" y="467426"/>
+                </a:lnTo>
+                <a:lnTo>
+                  <a:pt x="3813357" y="623235"/>
+                </a:lnTo>
+                <a:lnTo>
+                  <a:pt x="3922311" y="366151"/>
+                </a:lnTo>
+                <a:lnTo>
+                  <a:pt x="4031264" y="163599"/>
+                </a:lnTo>
+                <a:lnTo>
+                  <a:pt x="4140217" y="179180"/>
+                </a:lnTo>
+                <a:lnTo>
+                  <a:pt x="4249170" y="444055"/>
+                </a:lnTo>
+                <a:lnTo>
+                  <a:pt x="4358123" y="373941"/>
+                </a:lnTo>
+                <a:lnTo>
+                  <a:pt x="4467076" y="381731"/>
+                </a:lnTo>
+                <a:lnTo>
+                  <a:pt x="4576029" y="350570"/>
+                </a:lnTo>
+                <a:lnTo>
+                  <a:pt x="4684982" y="389522"/>
+                </a:lnTo>
+                <a:lnTo>
+                  <a:pt x="4793935" y="568702"/>
+                </a:lnTo>
+                <a:lnTo>
+                  <a:pt x="4902888" y="521960"/>
+                </a:lnTo>
+                <a:lnTo>
+                  <a:pt x="5011841" y="545331"/>
+                </a:lnTo>
+                <a:lnTo>
+                  <a:pt x="5120794" y="490798"/>
+                </a:lnTo>
+                <a:lnTo>
+                  <a:pt x="5229748" y="553121"/>
+                </a:lnTo>
+                <a:lnTo>
+                  <a:pt x="5338701" y="584283"/>
+                </a:lnTo>
+                <a:lnTo>
+                  <a:pt x="5447654" y="669978"/>
+                </a:lnTo>
+                <a:lnTo>
+                  <a:pt x="5556607" y="646607"/>
+                </a:lnTo>
+                <a:lnTo>
+                  <a:pt x="5665560" y="623235"/>
+                </a:lnTo>
+                <a:lnTo>
+                  <a:pt x="5774513" y="560912"/>
+                </a:lnTo>
+                <a:lnTo>
+                  <a:pt x="5883466" y="467426"/>
+                </a:lnTo>
+                <a:lnTo>
+                  <a:pt x="5992419" y="366151"/>
+                </a:lnTo>
+                <a:lnTo>
+                  <a:pt x="6101372" y="272665"/>
+                </a:lnTo>
+                <a:lnTo>
+                  <a:pt x="6210325" y="132437"/>
+                </a:lnTo>
+                <a:lnTo>
+                  <a:pt x="6319278" y="0"/>
+                </a:lnTo>
+                <a:lnTo>
+                  <a:pt x="6428232" y="62323"/>
                 </a:lnTo>
               </a:path>
             </a:pathLst>
@@ -42120,8 +42120,8 @@
         </p:nvSpPr>
         <p:spPr>
           <a:xfrm>
-            <a:off x="795528" y="1899102"/>
-            <a:ext cx="6428232" cy="1086899"/>
+            <a:off x="795528" y="1834693"/>
+            <a:ext cx="6428232" cy="1116567"/>
           </a:xfrm>
           <a:custGeom>
             <a:avLst/>
@@ -42130,186 +42130,186 @@
             <a:cxnLst/>
             <a:rect l="l" t="t" r="r" b="b"/>
             <a:pathLst>
-              <a:path w="6428232" h="1086899">
+              <a:path w="6428232" h="1116567">
                 <a:moveTo>
-                  <a:pt x="0" y="879531"/>
+                  <a:pt x="0" y="943940"/>
                 </a:moveTo>
                 <a:lnTo>
-                  <a:pt x="108953" y="918859"/>
-                </a:lnTo>
-                <a:lnTo>
-                  <a:pt x="217906" y="929585"/>
-                </a:lnTo>
-                <a:lnTo>
-                  <a:pt x="326859" y="926010"/>
-                </a:lnTo>
-                <a:lnTo>
-                  <a:pt x="435812" y="929585"/>
-                </a:lnTo>
-                <a:lnTo>
-                  <a:pt x="544765" y="929585"/>
-                </a:lnTo>
-                <a:lnTo>
-                  <a:pt x="653718" y="833051"/>
-                </a:lnTo>
-                <a:lnTo>
-                  <a:pt x="762671" y="833051"/>
-                </a:lnTo>
-                <a:lnTo>
-                  <a:pt x="871624" y="850928"/>
-                </a:lnTo>
-                <a:lnTo>
-                  <a:pt x="980577" y="818750"/>
-                </a:lnTo>
-                <a:lnTo>
-                  <a:pt x="1089530" y="700764"/>
-                </a:lnTo>
-                <a:lnTo>
-                  <a:pt x="1198483" y="772271"/>
-                </a:lnTo>
-                <a:lnTo>
-                  <a:pt x="1307437" y="865229"/>
-                </a:lnTo>
-                <a:lnTo>
-                  <a:pt x="1416390" y="818750"/>
-                </a:lnTo>
-                <a:lnTo>
-                  <a:pt x="1525343" y="790147"/>
-                </a:lnTo>
-                <a:lnTo>
-                  <a:pt x="1634296" y="818750"/>
-                </a:lnTo>
-                <a:lnTo>
-                  <a:pt x="1743249" y="786572"/>
-                </a:lnTo>
-                <a:lnTo>
-                  <a:pt x="1852202" y="690038"/>
-                </a:lnTo>
-                <a:lnTo>
-                  <a:pt x="1961155" y="511272"/>
-                </a:lnTo>
-                <a:lnTo>
-                  <a:pt x="2070108" y="600655"/>
-                </a:lnTo>
-                <a:lnTo>
-                  <a:pt x="2179061" y="657860"/>
-                </a:lnTo>
-                <a:lnTo>
-                  <a:pt x="2288014" y="568477"/>
-                </a:lnTo>
-                <a:lnTo>
-                  <a:pt x="2396967" y="536299"/>
-                </a:lnTo>
-                <a:lnTo>
-                  <a:pt x="2505920" y="521998"/>
-                </a:lnTo>
-                <a:lnTo>
-                  <a:pt x="2614874" y="404012"/>
-                </a:lnTo>
-                <a:lnTo>
-                  <a:pt x="2723827" y="89383"/>
-                </a:lnTo>
-                <a:lnTo>
-                  <a:pt x="2832780" y="143013"/>
-                </a:lnTo>
-                <a:lnTo>
-                  <a:pt x="2941733" y="250273"/>
-                </a:lnTo>
-                <a:lnTo>
-                  <a:pt x="3050686" y="221670"/>
-                </a:lnTo>
-                <a:lnTo>
-                  <a:pt x="3159639" y="57206"/>
-                </a:lnTo>
-                <a:lnTo>
-                  <a:pt x="3268592" y="0"/>
-                </a:lnTo>
-                <a:lnTo>
-                  <a:pt x="3377545" y="128712"/>
-                </a:lnTo>
-                <a:lnTo>
-                  <a:pt x="3486498" y="168041"/>
-                </a:lnTo>
-                <a:lnTo>
-                  <a:pt x="3595451" y="243122"/>
-                </a:lnTo>
-                <a:lnTo>
-                  <a:pt x="3704404" y="114411"/>
-                </a:lnTo>
-                <a:lnTo>
-                  <a:pt x="3813357" y="100109"/>
-                </a:lnTo>
-                <a:lnTo>
-                  <a:pt x="3922311" y="250273"/>
-                </a:lnTo>
-                <a:lnTo>
-                  <a:pt x="4031264" y="253848"/>
-                </a:lnTo>
-                <a:lnTo>
-                  <a:pt x="4140217" y="286026"/>
-                </a:lnTo>
-                <a:lnTo>
-                  <a:pt x="4249170" y="518423"/>
-                </a:lnTo>
-                <a:lnTo>
-                  <a:pt x="4358123" y="532724"/>
-                </a:lnTo>
-                <a:lnTo>
-                  <a:pt x="4467076" y="475519"/>
-                </a:lnTo>
-                <a:lnTo>
-                  <a:pt x="4576029" y="650710"/>
-                </a:lnTo>
-                <a:lnTo>
-                  <a:pt x="4684982" y="797298"/>
-                </a:lnTo>
-                <a:lnTo>
-                  <a:pt x="4793935" y="840202"/>
-                </a:lnTo>
-                <a:lnTo>
-                  <a:pt x="4902888" y="875955"/>
-                </a:lnTo>
-                <a:lnTo>
-                  <a:pt x="5011841" y="818750"/>
-                </a:lnTo>
-                <a:lnTo>
-                  <a:pt x="5120794" y="861654"/>
-                </a:lnTo>
-                <a:lnTo>
-                  <a:pt x="5229748" y="958188"/>
-                </a:lnTo>
-                <a:lnTo>
-                  <a:pt x="5338701" y="1018968"/>
-                </a:lnTo>
-                <a:lnTo>
-                  <a:pt x="5447654" y="1022544"/>
-                </a:lnTo>
-                <a:lnTo>
-                  <a:pt x="5556607" y="1086899"/>
-                </a:lnTo>
-                <a:lnTo>
-                  <a:pt x="5665560" y="1043996"/>
-                </a:lnTo>
-                <a:lnTo>
-                  <a:pt x="5774513" y="843777"/>
-                </a:lnTo>
-                <a:lnTo>
-                  <a:pt x="5883466" y="900982"/>
-                </a:lnTo>
-                <a:lnTo>
-                  <a:pt x="5992419" y="897407"/>
-                </a:lnTo>
-                <a:lnTo>
-                  <a:pt x="6101372" y="997516"/>
-                </a:lnTo>
-                <a:lnTo>
-                  <a:pt x="6210325" y="918859"/>
-                </a:lnTo>
-                <a:lnTo>
-                  <a:pt x="6319278" y="786572"/>
-                </a:lnTo>
-                <a:lnTo>
-                  <a:pt x="6428232" y="593504"/>
+                  <a:pt x="108953" y="954958"/>
+                </a:lnTo>
+                <a:lnTo>
+                  <a:pt x="217906" y="951285"/>
+                </a:lnTo>
+                <a:lnTo>
+                  <a:pt x="326859" y="954958"/>
+                </a:lnTo>
+                <a:lnTo>
+                  <a:pt x="435812" y="954958"/>
+                </a:lnTo>
+                <a:lnTo>
+                  <a:pt x="544765" y="855790"/>
+                </a:lnTo>
+                <a:lnTo>
+                  <a:pt x="653718" y="855790"/>
+                </a:lnTo>
+                <a:lnTo>
+                  <a:pt x="762671" y="874154"/>
+                </a:lnTo>
+                <a:lnTo>
+                  <a:pt x="871624" y="841098"/>
+                </a:lnTo>
+                <a:lnTo>
+                  <a:pt x="980577" y="719892"/>
+                </a:lnTo>
+                <a:lnTo>
+                  <a:pt x="1089530" y="793350"/>
+                </a:lnTo>
+                <a:lnTo>
+                  <a:pt x="1198483" y="888846"/>
+                </a:lnTo>
+                <a:lnTo>
+                  <a:pt x="1307437" y="841098"/>
+                </a:lnTo>
+                <a:lnTo>
+                  <a:pt x="1416390" y="811715"/>
+                </a:lnTo>
+                <a:lnTo>
+                  <a:pt x="1525343" y="841098"/>
+                </a:lnTo>
+                <a:lnTo>
+                  <a:pt x="1634296" y="808042"/>
+                </a:lnTo>
+                <a:lnTo>
+                  <a:pt x="1743249" y="708873"/>
+                </a:lnTo>
+                <a:lnTo>
+                  <a:pt x="1852202" y="525227"/>
+                </a:lnTo>
+                <a:lnTo>
+                  <a:pt x="1961155" y="617050"/>
+                </a:lnTo>
+                <a:lnTo>
+                  <a:pt x="2070108" y="675817"/>
+                </a:lnTo>
+                <a:lnTo>
+                  <a:pt x="2179061" y="583994"/>
+                </a:lnTo>
+                <a:lnTo>
+                  <a:pt x="2288014" y="550938"/>
+                </a:lnTo>
+                <a:lnTo>
+                  <a:pt x="2396967" y="536246"/>
+                </a:lnTo>
+                <a:lnTo>
+                  <a:pt x="2505920" y="415040"/>
+                </a:lnTo>
+                <a:lnTo>
+                  <a:pt x="2614874" y="91823"/>
+                </a:lnTo>
+                <a:lnTo>
+                  <a:pt x="2723827" y="146917"/>
+                </a:lnTo>
+                <a:lnTo>
+                  <a:pt x="2832780" y="257104"/>
+                </a:lnTo>
+                <a:lnTo>
+                  <a:pt x="2941733" y="227721"/>
+                </a:lnTo>
+                <a:lnTo>
+                  <a:pt x="3050686" y="58767"/>
+                </a:lnTo>
+                <a:lnTo>
+                  <a:pt x="3159639" y="0"/>
+                </a:lnTo>
+                <a:lnTo>
+                  <a:pt x="3268592" y="132225"/>
+                </a:lnTo>
+                <a:lnTo>
+                  <a:pt x="3377545" y="172627"/>
+                </a:lnTo>
+                <a:lnTo>
+                  <a:pt x="3486498" y="249758"/>
+                </a:lnTo>
+                <a:lnTo>
+                  <a:pt x="3595451" y="117533"/>
+                </a:lnTo>
+                <a:lnTo>
+                  <a:pt x="3704404" y="102842"/>
+                </a:lnTo>
+                <a:lnTo>
+                  <a:pt x="3813357" y="257104"/>
+                </a:lnTo>
+                <a:lnTo>
+                  <a:pt x="3922311" y="260777"/>
+                </a:lnTo>
+                <a:lnTo>
+                  <a:pt x="4031264" y="293833"/>
+                </a:lnTo>
+                <a:lnTo>
+                  <a:pt x="4140217" y="532573"/>
+                </a:lnTo>
+                <a:lnTo>
+                  <a:pt x="4249170" y="547265"/>
+                </a:lnTo>
+                <a:lnTo>
+                  <a:pt x="4358123" y="488498"/>
+                </a:lnTo>
+                <a:lnTo>
+                  <a:pt x="4467076" y="668471"/>
+                </a:lnTo>
+                <a:lnTo>
+                  <a:pt x="4576029" y="819060"/>
+                </a:lnTo>
+                <a:lnTo>
+                  <a:pt x="4684982" y="863135"/>
+                </a:lnTo>
+                <a:lnTo>
+                  <a:pt x="4793935" y="899865"/>
+                </a:lnTo>
+                <a:lnTo>
+                  <a:pt x="4902888" y="841098"/>
+                </a:lnTo>
+                <a:lnTo>
+                  <a:pt x="5011841" y="885173"/>
+                </a:lnTo>
+                <a:lnTo>
+                  <a:pt x="5120794" y="984342"/>
+                </a:lnTo>
+                <a:lnTo>
+                  <a:pt x="5229748" y="1046781"/>
+                </a:lnTo>
+                <a:lnTo>
+                  <a:pt x="5338701" y="1050454"/>
+                </a:lnTo>
+                <a:lnTo>
+                  <a:pt x="5447654" y="1116567"/>
+                </a:lnTo>
+                <a:lnTo>
+                  <a:pt x="5556607" y="1072492"/>
+                </a:lnTo>
+                <a:lnTo>
+                  <a:pt x="5665560" y="866808"/>
+                </a:lnTo>
+                <a:lnTo>
+                  <a:pt x="5774513" y="925575"/>
+                </a:lnTo>
+                <a:lnTo>
+                  <a:pt x="5883466" y="921902"/>
+                </a:lnTo>
+                <a:lnTo>
+                  <a:pt x="5992419" y="1024744"/>
+                </a:lnTo>
+                <a:lnTo>
+                  <a:pt x="6101372" y="943940"/>
+                </a:lnTo>
+                <a:lnTo>
+                  <a:pt x="6210325" y="808042"/>
+                </a:lnTo>
+                <a:lnTo>
+                  <a:pt x="6319278" y="609704"/>
+                </a:lnTo>
+                <a:lnTo>
+                  <a:pt x="6428232" y="708873"/>
                 </a:lnTo>
               </a:path>
             </a:pathLst>
@@ -42352,8 +42352,8 @@
         </p:nvSpPr>
         <p:spPr>
           <a:xfrm>
-            <a:off x="795528" y="1784416"/>
-            <a:ext cx="6428232" cy="1354864"/>
+            <a:off x="795528" y="1955587"/>
+            <a:ext cx="6428232" cy="1261139"/>
           </a:xfrm>
           <a:custGeom>
             <a:avLst/>
@@ -42362,186 +42362,186 @@
             <a:cxnLst/>
             <a:rect l="l" t="t" r="r" b="b"/>
             <a:pathLst>
-              <a:path w="6428232" h="1354864">
+              <a:path w="6428232" h="1261139">
                 <a:moveTo>
-                  <a:pt x="0" y="994217"/>
+                  <a:pt x="0" y="823046"/>
                 </a:moveTo>
                 <a:lnTo>
-                  <a:pt x="108953" y="884212"/>
-                </a:lnTo>
-                <a:lnTo>
-                  <a:pt x="217906" y="829906"/>
-                </a:lnTo>
-                <a:lnTo>
-                  <a:pt x="326859" y="650279"/>
-                </a:lnTo>
-                <a:lnTo>
-                  <a:pt x="435812" y="607113"/>
-                </a:lnTo>
-                <a:lnTo>
-                  <a:pt x="544765" y="705977"/>
-                </a:lnTo>
-                <a:lnTo>
-                  <a:pt x="653718" y="601543"/>
-                </a:lnTo>
-                <a:lnTo>
-                  <a:pt x="762671" y="355077"/>
-                </a:lnTo>
-                <a:lnTo>
-                  <a:pt x="871624" y="0"/>
-                </a:lnTo>
-                <a:lnTo>
-                  <a:pt x="980577" y="130891"/>
-                </a:lnTo>
-                <a:lnTo>
-                  <a:pt x="1089530" y="83548"/>
-                </a:lnTo>
-                <a:lnTo>
-                  <a:pt x="1198483" y="384319"/>
-                </a:lnTo>
-                <a:lnTo>
-                  <a:pt x="1307437" y="1002571"/>
-                </a:lnTo>
-                <a:lnTo>
-                  <a:pt x="1416390" y="1045738"/>
-                </a:lnTo>
-                <a:lnTo>
-                  <a:pt x="1525343" y="1208655"/>
-                </a:lnTo>
-                <a:lnTo>
-                  <a:pt x="1634296" y="1236505"/>
-                </a:lnTo>
-                <a:lnTo>
-                  <a:pt x="1743249" y="1157134"/>
-                </a:lnTo>
-                <a:lnTo>
-                  <a:pt x="1852202" y="1165489"/>
-                </a:lnTo>
-                <a:lnTo>
-                  <a:pt x="1961155" y="1162704"/>
-                </a:lnTo>
-                <a:lnTo>
-                  <a:pt x="2070108" y="1151564"/>
-                </a:lnTo>
-                <a:lnTo>
-                  <a:pt x="2179061" y="1120930"/>
-                </a:lnTo>
-                <a:lnTo>
-                  <a:pt x="2288014" y="1074979"/>
-                </a:lnTo>
-                <a:lnTo>
-                  <a:pt x="2396967" y="1173844"/>
-                </a:lnTo>
-                <a:lnTo>
-                  <a:pt x="2505920" y="1336762"/>
-                </a:lnTo>
-                <a:lnTo>
-                  <a:pt x="2614874" y="1250429"/>
-                </a:lnTo>
-                <a:lnTo>
-                  <a:pt x="2723827" y="1275493"/>
-                </a:lnTo>
-                <a:lnTo>
-                  <a:pt x="2832780" y="1318660"/>
-                </a:lnTo>
-                <a:lnTo>
-                  <a:pt x="2941733" y="1354864"/>
-                </a:lnTo>
-                <a:lnTo>
-                  <a:pt x="3050686" y="1318660"/>
-                </a:lnTo>
-                <a:lnTo>
-                  <a:pt x="3159639" y="1340939"/>
-                </a:lnTo>
-                <a:lnTo>
-                  <a:pt x="3268592" y="1297773"/>
-                </a:lnTo>
-                <a:lnTo>
-                  <a:pt x="3377545" y="1281063"/>
-                </a:lnTo>
-                <a:lnTo>
-                  <a:pt x="3486498" y="1161312"/>
-                </a:lnTo>
-                <a:lnTo>
-                  <a:pt x="3595451" y="1171059"/>
-                </a:lnTo>
-                <a:lnTo>
-                  <a:pt x="3704404" y="1278278"/>
-                </a:lnTo>
-                <a:lnTo>
-                  <a:pt x="3813357" y="1257391"/>
-                </a:lnTo>
-                <a:lnTo>
-                  <a:pt x="3922311" y="1226757"/>
-                </a:lnTo>
-                <a:lnTo>
-                  <a:pt x="4031264" y="1175236"/>
-                </a:lnTo>
-                <a:lnTo>
-                  <a:pt x="4140217" y="1105613"/>
-                </a:lnTo>
-                <a:lnTo>
-                  <a:pt x="4249170" y="974722"/>
-                </a:lnTo>
-                <a:lnTo>
-                  <a:pt x="4358123" y="846616"/>
-                </a:lnTo>
-                <a:lnTo>
-                  <a:pt x="4467076" y="817374"/>
-                </a:lnTo>
-                <a:lnTo>
-                  <a:pt x="4576029" y="984469"/>
-                </a:lnTo>
-                <a:lnTo>
-                  <a:pt x="4684982" y="988647"/>
-                </a:lnTo>
-                <a:lnTo>
-                  <a:pt x="4793935" y="987254"/>
-                </a:lnTo>
-                <a:lnTo>
-                  <a:pt x="4902888" y="1090296"/>
-                </a:lnTo>
-                <a:lnTo>
-                  <a:pt x="5011841" y="1210048"/>
-                </a:lnTo>
-                <a:lnTo>
-                  <a:pt x="5120794" y="1172451"/>
-                </a:lnTo>
-                <a:lnTo>
-                  <a:pt x="5229748" y="1115361"/>
-                </a:lnTo>
-                <a:lnTo>
-                  <a:pt x="5338701" y="1045738"/>
-                </a:lnTo>
-                <a:lnTo>
-                  <a:pt x="5447654" y="1030420"/>
-                </a:lnTo>
-                <a:lnTo>
-                  <a:pt x="5556607" y="1029028"/>
-                </a:lnTo>
-                <a:lnTo>
-                  <a:pt x="5665560" y="1105613"/>
-                </a:lnTo>
-                <a:lnTo>
-                  <a:pt x="5774513" y="1109791"/>
-                </a:lnTo>
-                <a:lnTo>
-                  <a:pt x="5883466" y="1074979"/>
-                </a:lnTo>
-                <a:lnTo>
-                  <a:pt x="5992419" y="1027636"/>
-                </a:lnTo>
-                <a:lnTo>
-                  <a:pt x="6101372" y="930163"/>
-                </a:lnTo>
-                <a:lnTo>
-                  <a:pt x="6210325" y="878642"/>
-                </a:lnTo>
-                <a:lnTo>
-                  <a:pt x="6319278" y="892567"/>
-                </a:lnTo>
-                <a:lnTo>
-                  <a:pt x="6428232" y="935733"/>
+                  <a:pt x="108953" y="772496"/>
+                </a:lnTo>
+                <a:lnTo>
+                  <a:pt x="217906" y="605295"/>
+                </a:lnTo>
+                <a:lnTo>
+                  <a:pt x="326859" y="565115"/>
+                </a:lnTo>
+                <a:lnTo>
+                  <a:pt x="435812" y="657140"/>
+                </a:lnTo>
+                <a:lnTo>
+                  <a:pt x="544765" y="559930"/>
+                </a:lnTo>
+                <a:lnTo>
+                  <a:pt x="653718" y="330515"/>
+                </a:lnTo>
+                <a:lnTo>
+                  <a:pt x="762671" y="0"/>
+                </a:lnTo>
+                <a:lnTo>
+                  <a:pt x="871624" y="121837"/>
+                </a:lnTo>
+                <a:lnTo>
+                  <a:pt x="980577" y="77768"/>
+                </a:lnTo>
+                <a:lnTo>
+                  <a:pt x="1089530" y="357733"/>
+                </a:lnTo>
+                <a:lnTo>
+                  <a:pt x="1198483" y="933217"/>
+                </a:lnTo>
+                <a:lnTo>
+                  <a:pt x="1307437" y="973397"/>
+                </a:lnTo>
+                <a:lnTo>
+                  <a:pt x="1416390" y="1125045"/>
+                </a:lnTo>
+                <a:lnTo>
+                  <a:pt x="1525343" y="1150967"/>
+                </a:lnTo>
+                <a:lnTo>
+                  <a:pt x="1634296" y="1077088"/>
+                </a:lnTo>
+                <a:lnTo>
+                  <a:pt x="1743249" y="1084865"/>
+                </a:lnTo>
+                <a:lnTo>
+                  <a:pt x="1852202" y="1082272"/>
+                </a:lnTo>
+                <a:lnTo>
+                  <a:pt x="1961155" y="1071903"/>
+                </a:lnTo>
+                <a:lnTo>
+                  <a:pt x="2070108" y="1043388"/>
+                </a:lnTo>
+                <a:lnTo>
+                  <a:pt x="2179061" y="1000616"/>
+                </a:lnTo>
+                <a:lnTo>
+                  <a:pt x="2288014" y="1092641"/>
+                </a:lnTo>
+                <a:lnTo>
+                  <a:pt x="2396967" y="1244289"/>
+                </a:lnTo>
+                <a:lnTo>
+                  <a:pt x="2505920" y="1163929"/>
+                </a:lnTo>
+                <a:lnTo>
+                  <a:pt x="2614874" y="1187259"/>
+                </a:lnTo>
+                <a:lnTo>
+                  <a:pt x="2723827" y="1227439"/>
+                </a:lnTo>
+                <a:lnTo>
+                  <a:pt x="2832780" y="1261139"/>
+                </a:lnTo>
+                <a:lnTo>
+                  <a:pt x="2941733" y="1227439"/>
+                </a:lnTo>
+                <a:lnTo>
+                  <a:pt x="3050686" y="1248177"/>
+                </a:lnTo>
+                <a:lnTo>
+                  <a:pt x="3159639" y="1207997"/>
+                </a:lnTo>
+                <a:lnTo>
+                  <a:pt x="3268592" y="1192444"/>
+                </a:lnTo>
+                <a:lnTo>
+                  <a:pt x="3377545" y="1080976"/>
+                </a:lnTo>
+                <a:lnTo>
+                  <a:pt x="3486498" y="1090049"/>
+                </a:lnTo>
+                <a:lnTo>
+                  <a:pt x="3595451" y="1189851"/>
+                </a:lnTo>
+                <a:lnTo>
+                  <a:pt x="3704404" y="1170409"/>
+                </a:lnTo>
+                <a:lnTo>
+                  <a:pt x="3813357" y="1141894"/>
+                </a:lnTo>
+                <a:lnTo>
+                  <a:pt x="3922311" y="1093938"/>
+                </a:lnTo>
+                <a:lnTo>
+                  <a:pt x="4031264" y="1029131"/>
+                </a:lnTo>
+                <a:lnTo>
+                  <a:pt x="4140217" y="907294"/>
+                </a:lnTo>
+                <a:lnTo>
+                  <a:pt x="4249170" y="788050"/>
+                </a:lnTo>
+                <a:lnTo>
+                  <a:pt x="4358123" y="760831"/>
+                </a:lnTo>
+                <a:lnTo>
+                  <a:pt x="4467076" y="916367"/>
+                </a:lnTo>
+                <a:lnTo>
+                  <a:pt x="4576029" y="920256"/>
+                </a:lnTo>
+                <a:lnTo>
+                  <a:pt x="4684982" y="918959"/>
+                </a:lnTo>
+                <a:lnTo>
+                  <a:pt x="4793935" y="1014873"/>
+                </a:lnTo>
+                <a:lnTo>
+                  <a:pt x="4902888" y="1126341"/>
+                </a:lnTo>
+                <a:lnTo>
+                  <a:pt x="5011841" y="1091345"/>
+                </a:lnTo>
+                <a:lnTo>
+                  <a:pt x="5120794" y="1038204"/>
+                </a:lnTo>
+                <a:lnTo>
+                  <a:pt x="5229748" y="973397"/>
+                </a:lnTo>
+                <a:lnTo>
+                  <a:pt x="5338701" y="959140"/>
+                </a:lnTo>
+                <a:lnTo>
+                  <a:pt x="5447654" y="957843"/>
+                </a:lnTo>
+                <a:lnTo>
+                  <a:pt x="5556607" y="1029131"/>
+                </a:lnTo>
+                <a:lnTo>
+                  <a:pt x="5665560" y="1033019"/>
+                </a:lnTo>
+                <a:lnTo>
+                  <a:pt x="5774513" y="1000616"/>
+                </a:lnTo>
+                <a:lnTo>
+                  <a:pt x="5883466" y="956547"/>
+                </a:lnTo>
+                <a:lnTo>
+                  <a:pt x="5992419" y="865818"/>
+                </a:lnTo>
+                <a:lnTo>
+                  <a:pt x="6101372" y="817861"/>
+                </a:lnTo>
+                <a:lnTo>
+                  <a:pt x="6210325" y="830822"/>
+                </a:lnTo>
+                <a:lnTo>
+                  <a:pt x="6319278" y="872299"/>
+                </a:lnTo>
+                <a:lnTo>
+                  <a:pt x="6428232" y="876187"/>
                 </a:lnTo>
               </a:path>
             </a:pathLst>
@@ -42584,8 +42584,8 @@
         </p:nvSpPr>
         <p:spPr>
           <a:xfrm>
-            <a:off x="795528" y="2057517"/>
-            <a:ext cx="6428232" cy="1024743"/>
+            <a:off x="795528" y="2262289"/>
+            <a:ext cx="6428232" cy="929418"/>
           </a:xfrm>
           <a:custGeom>
             <a:avLst/>
@@ -42594,186 +42594,186 @@
             <a:cxnLst/>
             <a:rect l="l" t="t" r="r" b="b"/>
             <a:pathLst>
-              <a:path w="6428232" h="1024743">
+              <a:path w="6428232" h="929418">
                 <a:moveTo>
-                  <a:pt x="0" y="721116"/>
+                  <a:pt x="0" y="516344"/>
                 </a:moveTo>
                 <a:lnTo>
-                  <a:pt x="108953" y="569302"/>
-                </a:lnTo>
-                <a:lnTo>
-                  <a:pt x="217906" y="569302"/>
-                </a:lnTo>
-                <a:lnTo>
-                  <a:pt x="326859" y="607255"/>
-                </a:lnTo>
-                <a:lnTo>
-                  <a:pt x="435812" y="569302"/>
-                </a:lnTo>
-                <a:lnTo>
-                  <a:pt x="544765" y="607255"/>
-                </a:lnTo>
-                <a:lnTo>
-                  <a:pt x="653718" y="683162"/>
-                </a:lnTo>
-                <a:lnTo>
-                  <a:pt x="762671" y="721116"/>
-                </a:lnTo>
-                <a:lnTo>
-                  <a:pt x="871624" y="607255"/>
-                </a:lnTo>
-                <a:lnTo>
-                  <a:pt x="980577" y="569302"/>
-                </a:lnTo>
-                <a:lnTo>
-                  <a:pt x="1089530" y="569302"/>
-                </a:lnTo>
-                <a:lnTo>
-                  <a:pt x="1198483" y="607255"/>
-                </a:lnTo>
-                <a:lnTo>
-                  <a:pt x="1307437" y="683162"/>
-                </a:lnTo>
-                <a:lnTo>
-                  <a:pt x="1416390" y="721116"/>
-                </a:lnTo>
-                <a:lnTo>
-                  <a:pt x="1525343" y="721116"/>
-                </a:lnTo>
-                <a:lnTo>
-                  <a:pt x="1634296" y="721116"/>
-                </a:lnTo>
-                <a:lnTo>
-                  <a:pt x="1743249" y="645209"/>
-                </a:lnTo>
-                <a:lnTo>
-                  <a:pt x="1852202" y="607255"/>
-                </a:lnTo>
-                <a:lnTo>
-                  <a:pt x="1961155" y="607255"/>
-                </a:lnTo>
-                <a:lnTo>
-                  <a:pt x="2070108" y="493395"/>
-                </a:lnTo>
-                <a:lnTo>
-                  <a:pt x="2179061" y="493395"/>
-                </a:lnTo>
-                <a:lnTo>
-                  <a:pt x="2288014" y="189767"/>
-                </a:lnTo>
-                <a:lnTo>
-                  <a:pt x="2396967" y="75907"/>
-                </a:lnTo>
-                <a:lnTo>
-                  <a:pt x="2505920" y="151814"/>
-                </a:lnTo>
-                <a:lnTo>
-                  <a:pt x="2614874" y="227721"/>
-                </a:lnTo>
-                <a:lnTo>
-                  <a:pt x="2723827" y="189767"/>
-                </a:lnTo>
-                <a:lnTo>
-                  <a:pt x="2832780" y="0"/>
-                </a:lnTo>
-                <a:lnTo>
-                  <a:pt x="2941733" y="37953"/>
-                </a:lnTo>
-                <a:lnTo>
-                  <a:pt x="3050686" y="37953"/>
-                </a:lnTo>
-                <a:lnTo>
-                  <a:pt x="3159639" y="379534"/>
-                </a:lnTo>
-                <a:lnTo>
-                  <a:pt x="3268592" y="379534"/>
-                </a:lnTo>
-                <a:lnTo>
-                  <a:pt x="3377545" y="303627"/>
-                </a:lnTo>
-                <a:lnTo>
-                  <a:pt x="3486498" y="379534"/>
-                </a:lnTo>
-                <a:lnTo>
-                  <a:pt x="3595451" y="493395"/>
-                </a:lnTo>
-                <a:lnTo>
-                  <a:pt x="3704404" y="607255"/>
-                </a:lnTo>
-                <a:lnTo>
-                  <a:pt x="3813357" y="569302"/>
-                </a:lnTo>
-                <a:lnTo>
-                  <a:pt x="3922311" y="569302"/>
-                </a:lnTo>
-                <a:lnTo>
-                  <a:pt x="4031264" y="645209"/>
-                </a:lnTo>
-                <a:lnTo>
-                  <a:pt x="4140217" y="493395"/>
-                </a:lnTo>
-                <a:lnTo>
-                  <a:pt x="4249170" y="455441"/>
-                </a:lnTo>
-                <a:lnTo>
-                  <a:pt x="4358123" y="493395"/>
-                </a:lnTo>
-                <a:lnTo>
-                  <a:pt x="4467076" y="531348"/>
-                </a:lnTo>
-                <a:lnTo>
-                  <a:pt x="4576029" y="683162"/>
-                </a:lnTo>
-                <a:lnTo>
-                  <a:pt x="4684982" y="607255"/>
-                </a:lnTo>
-                <a:lnTo>
-                  <a:pt x="4793935" y="607255"/>
-                </a:lnTo>
-                <a:lnTo>
-                  <a:pt x="4902888" y="683162"/>
-                </a:lnTo>
-                <a:lnTo>
-                  <a:pt x="5011841" y="721116"/>
-                </a:lnTo>
-                <a:lnTo>
-                  <a:pt x="5120794" y="797022"/>
-                </a:lnTo>
-                <a:lnTo>
-                  <a:pt x="5229748" y="797022"/>
-                </a:lnTo>
-                <a:lnTo>
-                  <a:pt x="5338701" y="797022"/>
-                </a:lnTo>
-                <a:lnTo>
-                  <a:pt x="5447654" y="872929"/>
-                </a:lnTo>
-                <a:lnTo>
-                  <a:pt x="5556607" y="910883"/>
-                </a:lnTo>
-                <a:lnTo>
-                  <a:pt x="5665560" y="986790"/>
-                </a:lnTo>
-                <a:lnTo>
-                  <a:pt x="5774513" y="986790"/>
-                </a:lnTo>
-                <a:lnTo>
-                  <a:pt x="5883466" y="986790"/>
-                </a:lnTo>
-                <a:lnTo>
-                  <a:pt x="5992419" y="1024743"/>
-                </a:lnTo>
-                <a:lnTo>
-                  <a:pt x="6101372" y="948836"/>
-                </a:lnTo>
-                <a:lnTo>
-                  <a:pt x="6210325" y="986790"/>
-                </a:lnTo>
-                <a:lnTo>
-                  <a:pt x="6319278" y="910883"/>
-                </a:lnTo>
-                <a:lnTo>
-                  <a:pt x="6428232" y="986790"/>
+                  <a:pt x="108953" y="516344"/>
+                </a:lnTo>
+                <a:lnTo>
+                  <a:pt x="217906" y="550766"/>
+                </a:lnTo>
+                <a:lnTo>
+                  <a:pt x="326859" y="516344"/>
+                </a:lnTo>
+                <a:lnTo>
+                  <a:pt x="435812" y="550766"/>
+                </a:lnTo>
+                <a:lnTo>
+                  <a:pt x="544765" y="619612"/>
+                </a:lnTo>
+                <a:lnTo>
+                  <a:pt x="653718" y="654035"/>
+                </a:lnTo>
+                <a:lnTo>
+                  <a:pt x="762671" y="550766"/>
+                </a:lnTo>
+                <a:lnTo>
+                  <a:pt x="871624" y="516344"/>
+                </a:lnTo>
+                <a:lnTo>
+                  <a:pt x="980577" y="516344"/>
+                </a:lnTo>
+                <a:lnTo>
+                  <a:pt x="1089530" y="550766"/>
+                </a:lnTo>
+                <a:lnTo>
+                  <a:pt x="1198483" y="619612"/>
+                </a:lnTo>
+                <a:lnTo>
+                  <a:pt x="1307437" y="654035"/>
+                </a:lnTo>
+                <a:lnTo>
+                  <a:pt x="1416390" y="654035"/>
+                </a:lnTo>
+                <a:lnTo>
+                  <a:pt x="1525343" y="654035"/>
+                </a:lnTo>
+                <a:lnTo>
+                  <a:pt x="1634296" y="585189"/>
+                </a:lnTo>
+                <a:lnTo>
+                  <a:pt x="1743249" y="550766"/>
+                </a:lnTo>
+                <a:lnTo>
+                  <a:pt x="1852202" y="550766"/>
+                </a:lnTo>
+                <a:lnTo>
+                  <a:pt x="1961155" y="447498"/>
+                </a:lnTo>
+                <a:lnTo>
+                  <a:pt x="2070108" y="447498"/>
+                </a:lnTo>
+                <a:lnTo>
+                  <a:pt x="2179061" y="172114"/>
+                </a:lnTo>
+                <a:lnTo>
+                  <a:pt x="2288014" y="68846"/>
+                </a:lnTo>
+                <a:lnTo>
+                  <a:pt x="2396967" y="137692"/>
+                </a:lnTo>
+                <a:lnTo>
+                  <a:pt x="2505920" y="206537"/>
+                </a:lnTo>
+                <a:lnTo>
+                  <a:pt x="2614874" y="172114"/>
+                </a:lnTo>
+                <a:lnTo>
+                  <a:pt x="2723827" y="0"/>
+                </a:lnTo>
+                <a:lnTo>
+                  <a:pt x="2832780" y="34423"/>
+                </a:lnTo>
+                <a:lnTo>
+                  <a:pt x="2941733" y="34423"/>
+                </a:lnTo>
+                <a:lnTo>
+                  <a:pt x="3050686" y="344229"/>
+                </a:lnTo>
+                <a:lnTo>
+                  <a:pt x="3159639" y="344229"/>
+                </a:lnTo>
+                <a:lnTo>
+                  <a:pt x="3268592" y="275383"/>
+                </a:lnTo>
+                <a:lnTo>
+                  <a:pt x="3377545" y="344229"/>
+                </a:lnTo>
+                <a:lnTo>
+                  <a:pt x="3486498" y="447498"/>
+                </a:lnTo>
+                <a:lnTo>
+                  <a:pt x="3595451" y="550766"/>
+                </a:lnTo>
+                <a:lnTo>
+                  <a:pt x="3704404" y="516344"/>
+                </a:lnTo>
+                <a:lnTo>
+                  <a:pt x="3813357" y="516344"/>
+                </a:lnTo>
+                <a:lnTo>
+                  <a:pt x="3922311" y="585189"/>
+                </a:lnTo>
+                <a:lnTo>
+                  <a:pt x="4031264" y="447498"/>
+                </a:lnTo>
+                <a:lnTo>
+                  <a:pt x="4140217" y="413075"/>
+                </a:lnTo>
+                <a:lnTo>
+                  <a:pt x="4249170" y="447498"/>
+                </a:lnTo>
+                <a:lnTo>
+                  <a:pt x="4358123" y="481921"/>
+                </a:lnTo>
+                <a:lnTo>
+                  <a:pt x="4467076" y="619612"/>
+                </a:lnTo>
+                <a:lnTo>
+                  <a:pt x="4576029" y="550766"/>
+                </a:lnTo>
+                <a:lnTo>
+                  <a:pt x="4684982" y="550766"/>
+                </a:lnTo>
+                <a:lnTo>
+                  <a:pt x="4793935" y="619612"/>
+                </a:lnTo>
+                <a:lnTo>
+                  <a:pt x="4902888" y="654035"/>
+                </a:lnTo>
+                <a:lnTo>
+                  <a:pt x="5011841" y="722881"/>
+                </a:lnTo>
+                <a:lnTo>
+                  <a:pt x="5120794" y="722881"/>
+                </a:lnTo>
+                <a:lnTo>
+                  <a:pt x="5229748" y="722881"/>
+                </a:lnTo>
+                <a:lnTo>
+                  <a:pt x="5338701" y="791727"/>
+                </a:lnTo>
+                <a:lnTo>
+                  <a:pt x="5447654" y="826150"/>
+                </a:lnTo>
+                <a:lnTo>
+                  <a:pt x="5556607" y="894995"/>
+                </a:lnTo>
+                <a:lnTo>
+                  <a:pt x="5665560" y="894995"/>
+                </a:lnTo>
+                <a:lnTo>
+                  <a:pt x="5774513" y="894995"/>
+                </a:lnTo>
+                <a:lnTo>
+                  <a:pt x="5883466" y="929418"/>
+                </a:lnTo>
+                <a:lnTo>
+                  <a:pt x="5992419" y="860573"/>
+                </a:lnTo>
+                <a:lnTo>
+                  <a:pt x="6101372" y="894995"/>
+                </a:lnTo>
+                <a:lnTo>
+                  <a:pt x="6210325" y="826150"/>
+                </a:lnTo>
+                <a:lnTo>
+                  <a:pt x="6319278" y="894995"/>
+                </a:lnTo>
+                <a:lnTo>
+                  <a:pt x="6428232" y="826150"/>
                 </a:lnTo>
               </a:path>
             </a:pathLst>
@@ -42816,7 +42816,7 @@
         </p:nvSpPr>
         <p:spPr>
           <a:xfrm>
-            <a:off x="612647" y="3739896"/>
+            <a:off x="503694" y="3739896"/>
             <a:ext cx="365760" cy="125730"/>
           </a:xfrm>
           <a:prstGeom prst="rect">
@@ -42855,7 +42855,7 @@
         </p:nvSpPr>
         <p:spPr>
           <a:xfrm>
-            <a:off x="2573803" y="3739896"/>
+            <a:off x="2464850" y="3739896"/>
             <a:ext cx="365760" cy="125730"/>
           </a:xfrm>
           <a:prstGeom prst="rect">
@@ -42894,7 +42894,7 @@
         </p:nvSpPr>
         <p:spPr>
           <a:xfrm>
-            <a:off x="4534959" y="3739896"/>
+            <a:off x="4426005" y="3739896"/>
             <a:ext cx="365760" cy="125730"/>
           </a:xfrm>
           <a:prstGeom prst="rect">
@@ -42933,7 +42933,7 @@
         </p:nvSpPr>
         <p:spPr>
           <a:xfrm>
-            <a:off x="6496114" y="3739896"/>
+            <a:off x="6387161" y="3739896"/>
             <a:ext cx="365760" cy="125730"/>
           </a:xfrm>
           <a:prstGeom prst="rect">
@@ -43164,8 +43164,8 @@
                 </a:solidFill>
                 <a:latin typeface="Kanit"/>
               </a:rPr>
-              <a:t>• น้ำตาล: ราคาโลก −45% เทียบจุดสูงสุด 2023-09 — ลดลงใน 26 จาก 33 เดือนล่าสุด ไม่ใช่การย่อตัวปีเดียว
-• ยางพารา: อยู่ต่ำกว่าระดับปี 2021 ของตัวเองถึง 20 จาก 60 เดือนล่าสุด และเพิ่งกลับขึ้นมาได้ หลังยืนเหนือระดับนั้นมา 29 เดือน</a:t>
+              <a:t>• น้ำตาล: ราคาโลก −41% เทียบจุดสูงสุด 2023-09 — ลดลงใน 26 จาก 34 เดือนล่าสุด ไม่ใช่การย่อตัวปีเดียว
+• ยางพารา: อยู่ต่ำกว่าระดับปี 2021 ของตัวเองถึง 21 จาก 60 เดือนล่าสุด และเพิ่งกลับขึ้นมาได้ หลังยืนเหนือระดับนั้นมา 30 เดือน</a:t>
             </a:r>
           </a:p>
         </p:txBody>
@@ -43419,7 +43419,7 @@
                           </a:solidFill>
                           <a:latin typeface="Kanit"/>
                         </a:rPr>
-                        <a:t>94.74</a:t>
+                        <a:t>91.81</a:t>
                       </a:r>
                     </a:p>
                   </a:txBody>
@@ -43442,7 +43442,7 @@
                           </a:solidFill>
                           <a:latin typeface="Kanit"/>
                         </a:rPr>
-                        <a:t>+0.0%</a:t>
+                        <a:t>-2.8%</a:t>
                       </a:r>
                     </a:p>
                   </a:txBody>
@@ -43465,7 +43465,7 @@
                           </a:solidFill>
                           <a:latin typeface="Kanit"/>
                         </a:rPr>
-                        <a:t>+52.9%</a:t>
+                        <a:t>+46.3%</a:t>
                       </a:r>
                     </a:p>
                   </a:txBody>
@@ -43559,7 +43559,7 @@
                           </a:solidFill>
                           <a:latin typeface="Kanit"/>
                         </a:rPr>
-                        <a:t>16,364</a:t>
+                        <a:t>15,423</a:t>
                       </a:r>
                     </a:p>
                   </a:txBody>
@@ -43582,7 +43582,7 @@
                           </a:solidFill>
                           <a:latin typeface="Kanit"/>
                         </a:rPr>
-                        <a:t>-25.2%</a:t>
+                        <a:t>-29.2%</a:t>
                       </a:r>
                     </a:p>
                   </a:txBody>
@@ -43605,7 +43605,7 @@
                           </a:solidFill>
                           <a:latin typeface="Kanit"/>
                         </a:rPr>
-                        <a:t>+19.3%</a:t>
+                        <a:t>+15.9%</a:t>
                       </a:r>
                     </a:p>
                   </a:txBody>
@@ -43699,7 +43699,7 @@
                           </a:solidFill>
                           <a:latin typeface="Kanit"/>
                         </a:rPr>
-                        <a:t>36,603</a:t>
+                        <a:t>36,361</a:t>
                       </a:r>
                     </a:p>
                   </a:txBody>
@@ -43722,7 +43722,7 @@
                           </a:solidFill>
                           <a:latin typeface="Kanit"/>
                         </a:rPr>
-                        <a:t>-37.8%</a:t>
+                        <a:t>-38.0%</a:t>
                       </a:r>
                     </a:p>
                   </a:txBody>
@@ -43741,11 +43741,11 @@
                       <a:r>
                         <a:rPr sz="1000" b="1">
                           <a:solidFill>
-                            <a:srgbClr val="15795F"/>
-                          </a:solidFill>
-                          <a:latin typeface="Kanit"/>
-                        </a:rPr>
-                        <a:t>+4.0%</a:t>
+                            <a:srgbClr val="CC0000"/>
+                          </a:solidFill>
+                          <a:latin typeface="Kanit"/>
+                        </a:rPr>
+                        <a:t>-3.6%</a:t>
                       </a:r>
                     </a:p>
                   </a:txBody>
@@ -43839,7 +43839,7 @@
                           </a:solidFill>
                           <a:latin typeface="Kanit"/>
                         </a:rPr>
-                        <a:t>10.60</a:t>
+                        <a:t>11.23</a:t>
                       </a:r>
                     </a:p>
                   </a:txBody>
@@ -43862,7 +43862,7 @@
                           </a:solidFill>
                           <a:latin typeface="Kanit"/>
                         </a:rPr>
-                        <a:t>-44.8%</a:t>
+                        <a:t>-41.4%</a:t>
                       </a:r>
                     </a:p>
                   </a:txBody>
@@ -43885,7 +43885,7 @@
                           </a:solidFill>
                           <a:latin typeface="Kanit"/>
                         </a:rPr>
-                        <a:t>-17.9%</a:t>
+                        <a:t>-20.9%</a:t>
                       </a:r>
                     </a:p>
                   </a:txBody>
@@ -44058,7 +44058,7 @@
                 </a:solidFill>
                 <a:latin typeface="Kanit"/>
               </a:rPr>
-              <a:t>ราคารายเดือนสกุลดอลลาร์ราคาปัจจุบันจาก World Bank Pink Sheet รุ่นข้อมูล 2026M06 (ข้อมูล 60 จุดต่อรายการ ปรับฐานเป็น 100 ณ 2021-07 เพื่อวาดกราฟ — หน่วยต่างกัน จึงใช้แกนเดียวกับระดับราคาดิบไม่ได้) แปลงเป็นบาทด้วยอัตราอ้างอิง ECB USD/THB 33.125 ณ 2026-08-14 สัดส่วนพื้นที่ปลูก วัดจริง จากสัดส่วนพืชของ สศก./กรมส่งเสริมการเกษตร (crop_mix.json) เป็นราคาปัจจุบัน ไม่ได้ปรับเงินเฟ้อ: ทุกตัวเลข ‘เทียบ 5 ปีก่อน’ มีเงินเฟ้อไทยห้าปีซ่อนอยู่ข้างใต้</a:t>
+              <a:t>ราคารายเดือนสกุลดอลลาร์ราคาปัจจุบันจาก World Bank Pink Sheet รุ่นข้อมูล 2026M07 (ข้อมูล 60 จุดต่อรายการ ปรับฐานเป็น 100 ณ 2021-07 เพื่อวาดกราฟ — หน่วยต่างกัน จึงใช้แกนเดียวกับระดับราคาดิบไม่ได้) แปลงเป็นบาทด้วยอัตราอ้างอิง ECB USD/THB 33.025 ณ 2026-08-17 สัดส่วนพื้นที่ปลูก วัดจริง จากสัดส่วนพืชของ สศก./กรมส่งเสริมการเกษตร (crop_mix.json) เป็นราคาปัจจุบัน ไม่ได้ปรับเงินเฟ้อ: ทุกตัวเลข ‘เทียบ 5 ปีก่อน’ มีเงินเฟ้อไทยห้าปีซ่อนอยู่ข้างใต้</a:t>
             </a:r>
           </a:p>
         </p:txBody>
@@ -44679,7 +44679,7 @@
                 </a:solidFill>
                 <a:latin typeface="Kanit"/>
               </a:rPr>
-              <a:t>มะพร้าว −67.6% สับปะรด −18.4% อ้อย −17.9% เทียบปีก่อน</a:t>
+              <a:t>มะพร้าว −67.2% สับปะรด −18.4% อ้อย −17.9% เทียบปีก่อน</a:t>
             </a:r>
           </a:p>
         </p:txBody>
@@ -44805,7 +44805,7 @@
                 </a:solidFill>
                 <a:latin typeface="Kanit"/>
               </a:rPr>
-              <a:t>+16.9%</a:t>
+              <a:t>+17.2%</a:t>
             </a:r>
           </a:p>
         </p:txBody>
@@ -45279,7 +45279,7 @@
                           </a:solidFill>
                           <a:latin typeface="Kanit"/>
                         </a:rPr>
-                        <a:t>+6.7%</a:t>
+                        <a:t>+6.8%</a:t>
                       </a:r>
                     </a:p>
                   </a:txBody>
@@ -45348,7 +45348,7 @@
                           </a:solidFill>
                           <a:latin typeface="Kanit"/>
                         </a:rPr>
-                        <a:t>-63.2%</a:t>
+                        <a:t>-62.8%</a:t>
                       </a:r>
                     </a:p>
                   </a:txBody>
@@ -45419,7 +45419,7 @@
                           </a:solidFill>
                           <a:latin typeface="Kanit"/>
                         </a:rPr>
-                        <a:t>+15.6%</a:t>
+                        <a:t>+15.9%</a:t>
                       </a:r>
                     </a:p>
                   </a:txBody>
@@ -45488,7 +45488,7 @@
                           </a:solidFill>
                           <a:latin typeface="Kanit"/>
                         </a:rPr>
-                        <a:t>+10.0%</a:t>
+                        <a:t>+10.2%</a:t>
                       </a:r>
                     </a:p>
                   </a:txBody>
@@ -45559,7 +45559,7 @@
                           </a:solidFill>
                           <a:latin typeface="Kanit"/>
                         </a:rPr>
-                        <a:t>+16.8%</a:t>
+                        <a:t>+17.2%</a:t>
                       </a:r>
                     </a:p>
                   </a:txBody>
@@ -45628,7 +45628,7 @@
                           </a:solidFill>
                           <a:latin typeface="Kanit"/>
                         </a:rPr>
-                        <a:t>+8.7%</a:t>
+                        <a:t>+8.8%</a:t>
                       </a:r>
                     </a:p>
                   </a:txBody>
@@ -45699,7 +45699,7 @@
                           </a:solidFill>
                           <a:latin typeface="Kanit"/>
                         </a:rPr>
-                        <a:t>+26.0%</a:t>
+                        <a:t>+25.7%</a:t>
                       </a:r>
                     </a:p>
                   </a:txBody>
@@ -45768,7 +45768,7 @@
                           </a:solidFill>
                           <a:latin typeface="Kanit"/>
                         </a:rPr>
-                        <a:t>+10.8%</a:t>
+                        <a:t>+11.3%</a:t>
                       </a:r>
                     </a:p>
                   </a:txBody>
@@ -45839,7 +45839,7 @@
                           </a:solidFill>
                           <a:latin typeface="Kanit"/>
                         </a:rPr>
-                        <a:t>+36.7%</a:t>
+                        <a:t>+35.8%</a:t>
                       </a:r>
                     </a:p>
                   </a:txBody>
@@ -45908,7 +45908,7 @@
                           </a:solidFill>
                           <a:latin typeface="Kanit"/>
                         </a:rPr>
-                        <a:t>+28.8%</a:t>
+                        <a:t>+27.9%</a:t>
                       </a:r>
                     </a:p>
                   </a:txBody>
@@ -46084,8 +46084,8 @@
                 </a:solidFill>
                 <a:latin typeface="Kanit"/>
               </a:rPr>
-              <a:t>•  ราคาหน้าฟาร์ม: ยางพารา +42% มันสำปะหลัง +64% ปาล์ม +25% ข้าว +14% รายได้จากพืชเพิ่มขึ้นทุกภาค
-•  มีสี่จังหวัดที่ลดลง — ทั้งหมดเป็นมะพร้าว และอยู่ฝั่งอ่าวไทยตะวันตก ราคามะพร้าวลดลง 68%
+              <a:t>•  ราคาหน้าฟาร์ม: ยางพารา +41% มันสำปะหลัง +69% ปาล์ม +24% ข้าว +14% รายได้จากพืชเพิ่มขึ้นทุกภาค
+•  มีสี่จังหวัดที่ลดลง — ทั้งหมดเป็นมะพร้าว และอยู่ฝั่งอ่าวไทยตะวันตก ราคามะพร้าวลดลง 67%
 •  กำไรบนกระดาษยังไม่ใช่เงินสด — ตารางถัดไปหักราคาด้วยต้นทุน</a:t>
             </a:r>
           </a:p>
@@ -46387,7 +46387,7 @@
                           </a:solidFill>
                           <a:latin typeface="Kanit"/>
                         </a:rPr>
-                        <a:t>+16.9%</a:t>
+                        <a:t>+17.6%</a:t>
                       </a:r>
                     </a:p>
                   </a:txBody>
@@ -46550,7 +46550,7 @@
                           </a:solidFill>
                           <a:latin typeface="Kanit"/>
                         </a:rPr>
-                        <a:t>+21.3%</a:t>
+                        <a:t>+21.7%</a:t>
                       </a:r>
                     </a:p>
                   </a:txBody>
@@ -46713,7 +46713,7 @@
                           </a:solidFill>
                           <a:latin typeface="Kanit"/>
                         </a:rPr>
-                        <a:t>+11.2%</a:t>
+                        <a:t>+11.6%</a:t>
                       </a:r>
                     </a:p>
                   </a:txBody>
@@ -46876,7 +46876,7 @@
                           </a:solidFill>
                           <a:latin typeface="Kanit"/>
                         </a:rPr>
-                        <a:t>+34.5%</a:t>
+                        <a:t>+33.6%</a:t>
                       </a:r>
                     </a:p>
                   </a:txBody>
@@ -47039,7 +47039,7 @@
                           </a:solidFill>
                           <a:latin typeface="Kanit"/>
                         </a:rPr>
-                        <a:t>+16.9%</a:t>
+                        <a:t>+17.2%</a:t>
                       </a:r>
                     </a:p>
                   </a:txBody>
@@ -47202,7 +47202,7 @@
                           </a:solidFill>
                           <a:latin typeface="Kanit"/>
                         </a:rPr>
-                        <a:t>+15.6%</a:t>
+                        <a:t>+15.8%</a:t>
                       </a:r>
                     </a:p>
                   </a:txBody>
@@ -47829,7 +47829,7 @@
                 </a:solidFill>
                 <a:latin typeface="Kanit"/>
               </a:rPr>
-              <a:t>สี่รายการมีทิศทางไม่ตรงกันระหว่างเทียบปีก่อนกับหกเดือน ตัวเลขรายปีเพียงตัวเดียวจึงอาจชี้ผิดทางได้</a:t>
+              <a:t>สามรายการมีทิศทางไม่ตรงกันระหว่างเทียบปีก่อนกับหกเดือน ตัวเลขรายปีเพียงตัวเดียวจึงอาจชี้ผิดทางได้</a:t>
             </a:r>
           </a:p>
         </p:txBody>
@@ -47985,7 +47985,7 @@
                 </a:solidFill>
                 <a:latin typeface="Kanit"/>
               </a:rPr>
-              <a:t>฿543.53 /ร้อยผล · ใต้·ตอ.</a:t>
+              <a:t>฿620.00 /ร้อยผล · ใต้·ตอ.</a:t>
             </a:r>
           </a:p>
         </p:txBody>
@@ -48024,7 +48024,7 @@
                 </a:solidFill>
                 <a:latin typeface="Kanit"/>
               </a:rPr>
-              <a:t>เทียบปีก่อน −67.6%</a:t>
+              <a:t>เทียบปีก่อน −67.2%</a:t>
             </a:r>
           </a:p>
         </p:txBody>
@@ -48063,7 +48063,7 @@
                 </a:solidFill>
                 <a:latin typeface="Kanit"/>
               </a:rPr>
-              <a:t>6 เดือน −58.7%</a:t>
+              <a:t>6 เดือน −48.8%</a:t>
             </a:r>
           </a:p>
         </p:txBody>
@@ -48137,19 +48137,19 @@
                   <a:pt x="0" y="0"/>
                 </a:moveTo>
                 <a:lnTo>
-                  <a:pt x="412943" y="149367"/>
-                </a:lnTo>
-                <a:lnTo>
-                  <a:pt x="825886" y="262297"/>
-                </a:lnTo>
-                <a:lnTo>
-                  <a:pt x="1238829" y="246096"/>
-                </a:lnTo>
-                <a:lnTo>
-                  <a:pt x="1651772" y="414999"/>
-                </a:lnTo>
-                <a:lnTo>
-                  <a:pt x="2064715" y="457200"/>
+                  <a:pt x="412943" y="170015"/>
+                </a:lnTo>
+                <a:lnTo>
+                  <a:pt x="825886" y="147424"/>
+                </a:lnTo>
+                <a:lnTo>
+                  <a:pt x="1238829" y="401963"/>
+                </a:lnTo>
+                <a:lnTo>
+                  <a:pt x="1651772" y="457200"/>
+                </a:lnTo>
+                <a:lnTo>
+                  <a:pt x="2064715" y="387883"/>
                 </a:lnTo>
               </a:path>
             </a:pathLst>
@@ -48192,7 +48192,7 @@
         </p:nvSpPr>
         <p:spPr>
           <a:xfrm>
-            <a:off x="2480767" y="2862072"/>
+            <a:off x="2480767" y="2792755"/>
             <a:ext cx="82296" cy="82296"/>
           </a:xfrm>
           <a:prstGeom prst="roundRect">
@@ -48303,7 +48303,7 @@
                 </a:solidFill>
                 <a:latin typeface="Kanit"/>
               </a:rPr>
-              <a:t>฿9.75 /กก. · ตอ.·ตต.·เหนือ</a:t>
+              <a:t>฿9.77 /กก. · ตอ.·ตต.·เหนือ</a:t>
             </a:r>
           </a:p>
         </p:txBody>
@@ -48381,7 +48381,7 @@
                 </a:solidFill>
                 <a:latin typeface="Kanit"/>
               </a:rPr>
-              <a:t>6 เดือน +47.7%</a:t>
+              <a:t>6 เดือน +48.0%</a:t>
             </a:r>
           </a:p>
         </p:txBody>
@@ -48452,19 +48452,19 @@
             <a:pathLst>
               <a:path w="2064715" h="457200">
                 <a:moveTo>
-                  <a:pt x="0" y="347240"/>
+                  <a:pt x="0" y="346494"/>
                 </a:moveTo>
                 <a:lnTo>
-                  <a:pt x="412943" y="400773"/>
+                  <a:pt x="412943" y="401128"/>
                 </a:lnTo>
                 <a:lnTo>
                   <a:pt x="825886" y="457200"/>
                 </a:lnTo>
                 <a:lnTo>
-                  <a:pt x="1238829" y="380517"/>
-                </a:lnTo>
-                <a:lnTo>
-                  <a:pt x="1651772" y="211237"/>
+                  <a:pt x="1238829" y="380999"/>
+                </a:lnTo>
+                <a:lnTo>
+                  <a:pt x="1651772" y="212784"/>
                 </a:lnTo>
                 <a:lnTo>
                   <a:pt x="2064715" y="0"/>
@@ -48557,6 +48557,324 @@
         <p:spPr>
           <a:xfrm>
             <a:off x="5016398" y="1970531"/>
+            <a:ext cx="2156155" cy="150876"/>
+          </a:xfrm>
+          <a:prstGeom prst="rect">
+            <a:avLst/>
+          </a:prstGeom>
+          <a:noFill/>
+        </p:spPr>
+        <p:txBody>
+          <a:bodyPr wrap="square" lIns="0" rIns="0" tIns="0" bIns="0" anchor="t">
+            <a:noAutofit/>
+          </a:bodyPr>
+          <a:lstStyle/>
+          <a:p>
+            <a:pPr algn="l">
+              <a:lnSpc>
+                <a:spcPts val="1188"/>
+              </a:lnSpc>
+            </a:pPr>
+            <a:r>
+              <a:rPr sz="900" b="1">
+                <a:solidFill>
+                  <a:srgbClr val="1E2F5C"/>
+                </a:solidFill>
+                <a:latin typeface="Kanit"/>
+              </a:rPr>
+              <a:t>กุ้งขาว</a:t>
+            </a:r>
+          </a:p>
+        </p:txBody>
+      </p:sp>
+      <p:sp>
+        <p:nvSpPr>
+          <p:cNvPr id="30" name="TextBox 29"/>
+          <p:cNvSpPr txBox="1"/>
+          <p:nvPr/>
+        </p:nvSpPr>
+        <p:spPr>
+          <a:xfrm>
+            <a:off x="5016398" y="2112263"/>
+            <a:ext cx="2156155" cy="125730"/>
+          </a:xfrm>
+          <a:prstGeom prst="rect">
+            <a:avLst/>
+          </a:prstGeom>
+          <a:noFill/>
+        </p:spPr>
+        <p:txBody>
+          <a:bodyPr wrap="square" lIns="0" rIns="0" tIns="0" bIns="0" anchor="t">
+            <a:noAutofit/>
+          </a:bodyPr>
+          <a:lstStyle/>
+          <a:p>
+            <a:pPr algn="l">
+              <a:lnSpc>
+                <a:spcPts val="990"/>
+              </a:lnSpc>
+            </a:pPr>
+            <a:r>
+              <a:rPr sz="750" b="0">
+                <a:solidFill>
+                  <a:srgbClr val="606060"/>
+                </a:solidFill>
+                <a:latin typeface="Kanit"/>
+              </a:rPr>
+              <a:t>฿143.33 /กก. · ชายฝั่งใต้·ตอ.</a:t>
+            </a:r>
+          </a:p>
+        </p:txBody>
+      </p:sp>
+      <p:sp>
+        <p:nvSpPr>
+          <p:cNvPr id="31" name="TextBox 30"/>
+          <p:cNvSpPr txBox="1"/>
+          <p:nvPr/>
+        </p:nvSpPr>
+        <p:spPr>
+          <a:xfrm>
+            <a:off x="5016398" y="2244851"/>
+            <a:ext cx="1078077" cy="134112"/>
+          </a:xfrm>
+          <a:prstGeom prst="rect">
+            <a:avLst/>
+          </a:prstGeom>
+          <a:noFill/>
+        </p:spPr>
+        <p:txBody>
+          <a:bodyPr wrap="square" lIns="0" rIns="0" tIns="0" bIns="0" anchor="t">
+            <a:noAutofit/>
+          </a:bodyPr>
+          <a:lstStyle/>
+          <a:p>
+            <a:pPr algn="l">
+              <a:lnSpc>
+                <a:spcPts val="1056"/>
+              </a:lnSpc>
+            </a:pPr>
+            <a:r>
+              <a:rPr sz="800" b="1">
+                <a:solidFill>
+                  <a:srgbClr val="15795F"/>
+                </a:solidFill>
+                <a:latin typeface="Kanit"/>
+              </a:rPr>
+              <a:t>เทียบปีก่อน +1.6%</a:t>
+            </a:r>
+          </a:p>
+        </p:txBody>
+      </p:sp>
+      <p:sp>
+        <p:nvSpPr>
+          <p:cNvPr id="32" name="TextBox 31"/>
+          <p:cNvSpPr txBox="1"/>
+          <p:nvPr/>
+        </p:nvSpPr>
+        <p:spPr>
+          <a:xfrm>
+            <a:off x="6094475" y="2244851"/>
+            <a:ext cx="1078077" cy="134112"/>
+          </a:xfrm>
+          <a:prstGeom prst="rect">
+            <a:avLst/>
+          </a:prstGeom>
+          <a:noFill/>
+        </p:spPr>
+        <p:txBody>
+          <a:bodyPr wrap="square" lIns="0" rIns="0" tIns="0" bIns="0" anchor="t">
+            <a:noAutofit/>
+          </a:bodyPr>
+          <a:lstStyle/>
+          <a:p>
+            <a:pPr algn="l">
+              <a:lnSpc>
+                <a:spcPts val="1056"/>
+              </a:lnSpc>
+            </a:pPr>
+            <a:r>
+              <a:rPr sz="800" b="1">
+                <a:solidFill>
+                  <a:srgbClr val="CC0000"/>
+                </a:solidFill>
+                <a:latin typeface="Kanit"/>
+              </a:rPr>
+              <a:t>6 เดือน −1.9%</a:t>
+            </a:r>
+          </a:p>
+        </p:txBody>
+      </p:sp>
+      <p:sp>
+        <p:nvSpPr>
+          <p:cNvPr id="33" name="Rectangle 32"/>
+          <p:cNvSpPr/>
+          <p:nvPr/>
+        </p:nvSpPr>
+        <p:spPr>
+          <a:xfrm>
+            <a:off x="5016398" y="2400300"/>
+            <a:ext cx="2156155" cy="548640"/>
+          </a:xfrm>
+          <a:prstGeom prst="rect">
+            <a:avLst/>
+          </a:prstGeom>
+          <a:solidFill>
+            <a:srgbClr val="FBFCFE"/>
+          </a:solidFill>
+          <a:ln w="9525">
+            <a:solidFill>
+              <a:srgbClr val="D9DEE9"/>
+            </a:solidFill>
+          </a:ln>
+          <a:effectLst/>
+        </p:spPr>
+        <p:style>
+          <a:lnRef idx="1">
+            <a:schemeClr val="accent1"/>
+          </a:lnRef>
+          <a:fillRef idx="3">
+            <a:schemeClr val="accent1"/>
+          </a:fillRef>
+          <a:effectRef idx="2">
+            <a:schemeClr val="accent1"/>
+          </a:effectRef>
+          <a:fontRef idx="minor">
+            <a:schemeClr val="lt1"/>
+          </a:fontRef>
+        </p:style>
+        <p:txBody>
+          <a:bodyPr rtlCol="0" anchor="ctr" wrap="none"/>
+          <a:lstStyle/>
+          <a:p>
+            <a:pPr algn="ctr"/>
+          </a:p>
+        </p:txBody>
+      </p:sp>
+      <p:sp>
+        <p:nvSpPr>
+          <p:cNvPr id="34" name="Freeform 33"/>
+          <p:cNvSpPr/>
+          <p:nvPr/>
+        </p:nvSpPr>
+        <p:spPr>
+          <a:xfrm>
+            <a:off x="5062118" y="2446020"/>
+            <a:ext cx="2064715" cy="457200"/>
+          </a:xfrm>
+          <a:custGeom>
+            <a:avLst/>
+            <a:gdLst/>
+            <a:ahLst/>
+            <a:cxnLst/>
+            <a:rect l="l" t="t" r="r" b="b"/>
+            <a:pathLst>
+              <a:path w="2064715" h="457200">
+                <a:moveTo>
+                  <a:pt x="0" y="222838"/>
+                </a:moveTo>
+                <a:lnTo>
+                  <a:pt x="412943" y="418928"/>
+                </a:lnTo>
+                <a:lnTo>
+                  <a:pt x="825886" y="457200"/>
+                </a:lnTo>
+                <a:lnTo>
+                  <a:pt x="1238829" y="423249"/>
+                </a:lnTo>
+                <a:lnTo>
+                  <a:pt x="1651772" y="173867"/>
+                </a:lnTo>
+                <a:lnTo>
+                  <a:pt x="2064715" y="0"/>
+                </a:lnTo>
+              </a:path>
+            </a:pathLst>
+          </a:custGeom>
+          <a:noFill/>
+          <a:ln w="20320">
+            <a:solidFill>
+              <a:srgbClr val="CC0000"/>
+            </a:solidFill>
+          </a:ln>
+          <a:effectLst/>
+        </p:spPr>
+        <p:style>
+          <a:lnRef idx="1">
+            <a:schemeClr val="accent1"/>
+          </a:lnRef>
+          <a:fillRef idx="3">
+            <a:schemeClr val="accent1"/>
+          </a:fillRef>
+          <a:effectRef idx="2">
+            <a:schemeClr val="accent1"/>
+          </a:effectRef>
+          <a:fontRef idx="minor">
+            <a:schemeClr val="lt1"/>
+          </a:fontRef>
+        </p:style>
+        <p:txBody>
+          <a:bodyPr rtlCol="0" anchor="ctr"/>
+          <a:lstStyle/>
+          <a:p>
+            <a:pPr algn="ctr"/>
+          </a:p>
+        </p:txBody>
+      </p:sp>
+      <p:sp>
+        <p:nvSpPr>
+          <p:cNvPr id="35" name="Rounded Rectangle 34"/>
+          <p:cNvSpPr/>
+          <p:nvPr/>
+        </p:nvSpPr>
+        <p:spPr>
+          <a:xfrm>
+            <a:off x="7085685" y="2404872"/>
+            <a:ext cx="82296" cy="82296"/>
+          </a:xfrm>
+          <a:prstGeom prst="roundRect">
+            <a:avLst>
+              <a:gd name="adj" fmla="val 50000"/>
+            </a:avLst>
+          </a:prstGeom>
+          <a:solidFill>
+            <a:srgbClr val="CC0000"/>
+          </a:solidFill>
+          <a:ln>
+            <a:noFill/>
+          </a:ln>
+          <a:effectLst/>
+        </p:spPr>
+        <p:style>
+          <a:lnRef idx="1">
+            <a:schemeClr val="accent1"/>
+          </a:lnRef>
+          <a:fillRef idx="3">
+            <a:schemeClr val="accent1"/>
+          </a:fillRef>
+          <a:effectRef idx="2">
+            <a:schemeClr val="accent1"/>
+          </a:effectRef>
+          <a:fontRef idx="minor">
+            <a:schemeClr val="lt1"/>
+          </a:fontRef>
+        </p:style>
+        <p:txBody>
+          <a:bodyPr rtlCol="0" anchor="ctr" wrap="none"/>
+          <a:lstStyle/>
+          <a:p>
+            <a:pPr algn="ctr"/>
+          </a:p>
+        </p:txBody>
+      </p:sp>
+      <p:sp>
+        <p:nvSpPr>
+          <p:cNvPr id="36" name="TextBox 35"/>
+          <p:cNvSpPr txBox="1"/>
+          <p:nvPr/>
+        </p:nvSpPr>
+        <p:spPr>
+          <a:xfrm>
+            <a:off x="7318857" y="1970531"/>
             <a:ext cx="2156155" cy="150876"/>
           </a:xfrm>
           <a:prstGeom prst="rect">
@@ -48589,13 +48907,13 @@
       </p:sp>
       <p:sp>
         <p:nvSpPr>
-          <p:cNvPr id="30" name="TextBox 29"/>
+          <p:cNvPr id="37" name="TextBox 36"/>
           <p:cNvSpPr txBox="1"/>
           <p:nvPr/>
         </p:nvSpPr>
         <p:spPr>
           <a:xfrm>
-            <a:off x="5016398" y="2112263"/>
+            <a:off x="7318857" y="2112263"/>
             <a:ext cx="2156155" cy="125730"/>
           </a:xfrm>
           <a:prstGeom prst="rect">
@@ -48621,20 +48939,20 @@
                 </a:solidFill>
                 <a:latin typeface="Kanit"/>
               </a:rPr>
-              <a:t>฿338.24 /ร้อยฟอง · กลาง·ตอ.</a:t>
+              <a:t>฿343.75 /ร้อยฟอง · กลาง·ตอ.</a:t>
             </a:r>
           </a:p>
         </p:txBody>
       </p:sp>
       <p:sp>
         <p:nvSpPr>
-          <p:cNvPr id="31" name="TextBox 30"/>
+          <p:cNvPr id="38" name="TextBox 37"/>
           <p:cNvSpPr txBox="1"/>
           <p:nvPr/>
         </p:nvSpPr>
         <p:spPr>
           <a:xfrm>
-            <a:off x="5016398" y="2244851"/>
+            <a:off x="7318857" y="2244851"/>
             <a:ext cx="1078077" cy="134112"/>
           </a:xfrm>
           <a:prstGeom prst="rect">
@@ -48660,20 +48978,20 @@
                 </a:solidFill>
                 <a:latin typeface="Kanit"/>
               </a:rPr>
-              <a:t>เทียบปีก่อน +0.7%</a:t>
+              <a:t>เทียบปีก่อน +2.0%</a:t>
             </a:r>
           </a:p>
         </p:txBody>
       </p:sp>
       <p:sp>
         <p:nvSpPr>
-          <p:cNvPr id="32" name="TextBox 31"/>
+          <p:cNvPr id="39" name="TextBox 38"/>
           <p:cNvSpPr txBox="1"/>
           <p:nvPr/>
         </p:nvSpPr>
         <p:spPr>
           <a:xfrm>
-            <a:off x="6094475" y="2244851"/>
+            <a:off x="8396935" y="2244851"/>
             <a:ext cx="1078077" cy="134112"/>
           </a:xfrm>
           <a:prstGeom prst="rect">
@@ -48699,20 +49017,20 @@
                 </a:solidFill>
                 <a:latin typeface="Kanit"/>
               </a:rPr>
-              <a:t>6 เดือน +5.0%</a:t>
+              <a:t>6 เดือน +13.6%</a:t>
             </a:r>
           </a:p>
         </p:txBody>
       </p:sp>
       <p:sp>
         <p:nvSpPr>
-          <p:cNvPr id="33" name="Rectangle 32"/>
+          <p:cNvPr id="40" name="Rectangle 39"/>
           <p:cNvSpPr/>
           <p:nvPr/>
         </p:nvSpPr>
         <p:spPr>
           <a:xfrm>
-            <a:off x="5016398" y="2400300"/>
+            <a:off x="7318857" y="2400300"/>
             <a:ext cx="2156155" cy="548640"/>
           </a:xfrm>
           <a:prstGeom prst="rect">
@@ -48752,13 +49070,13 @@
       </p:sp>
       <p:sp>
         <p:nvSpPr>
-          <p:cNvPr id="34" name="Freeform 33"/>
+          <p:cNvPr id="41" name="Freeform 40"/>
           <p:cNvSpPr/>
           <p:nvPr/>
         </p:nvSpPr>
         <p:spPr>
           <a:xfrm>
-            <a:off x="5062118" y="2446020"/>
+            <a:off x="7364577" y="2446020"/>
             <a:ext cx="2064715" cy="457200"/>
           </a:xfrm>
           <a:custGeom>
@@ -48773,16 +49091,16 @@
                   <a:pt x="0" y="457200"/>
                 </a:moveTo>
                 <a:lnTo>
-                  <a:pt x="412943" y="391702"/>
-                </a:lnTo>
-                <a:lnTo>
-                  <a:pt x="825886" y="105409"/>
-                </a:lnTo>
-                <a:lnTo>
-                  <a:pt x="1238829" y="105409"/>
-                </a:lnTo>
-                <a:lnTo>
-                  <a:pt x="1651772" y="214144"/>
+                  <a:pt x="412943" y="173996"/>
+                </a:lnTo>
+                <a:lnTo>
+                  <a:pt x="825886" y="173996"/>
+                </a:lnTo>
+                <a:lnTo>
+                  <a:pt x="1238829" y="281558"/>
+                </a:lnTo>
+                <a:lnTo>
+                  <a:pt x="1651772" y="66435"/>
                 </a:lnTo>
                 <a:lnTo>
                   <a:pt x="2064715" y="0"/>
@@ -48822,13 +49140,13 @@
       </p:sp>
       <p:sp>
         <p:nvSpPr>
-          <p:cNvPr id="35" name="Rounded Rectangle 34"/>
+          <p:cNvPr id="42" name="Rounded Rectangle 41"/>
           <p:cNvSpPr/>
           <p:nvPr/>
         </p:nvSpPr>
         <p:spPr>
           <a:xfrm>
-            <a:off x="7085685" y="2404872"/>
+            <a:off x="9388144" y="2404872"/>
             <a:ext cx="82296" cy="82296"/>
           </a:xfrm>
           <a:prstGeom prst="roundRect">
@@ -48868,13 +49186,13 @@
       </p:sp>
       <p:sp>
         <p:nvSpPr>
-          <p:cNvPr id="36" name="TextBox 35"/>
+          <p:cNvPr id="43" name="TextBox 42"/>
           <p:cNvSpPr txBox="1"/>
           <p:nvPr/>
         </p:nvSpPr>
         <p:spPr>
           <a:xfrm>
-            <a:off x="7318857" y="1970531"/>
+            <a:off x="9621316" y="1970531"/>
             <a:ext cx="2156155" cy="150876"/>
           </a:xfrm>
           <a:prstGeom prst="rect">
@@ -48900,20 +49218,20 @@
                 </a:solidFill>
                 <a:latin typeface="Kanit"/>
               </a:rPr>
-              <a:t>กุ้งขาว</a:t>
+              <a:t>ไก่เนื้อ</a:t>
             </a:r>
           </a:p>
         </p:txBody>
       </p:sp>
       <p:sp>
         <p:nvSpPr>
-          <p:cNvPr id="37" name="TextBox 36"/>
+          <p:cNvPr id="44" name="TextBox 43"/>
           <p:cNvSpPr txBox="1"/>
           <p:nvPr/>
         </p:nvSpPr>
         <p:spPr>
           <a:xfrm>
-            <a:off x="7318857" y="2112263"/>
+            <a:off x="9621316" y="2112263"/>
             <a:ext cx="2156155" cy="125730"/>
           </a:xfrm>
           <a:prstGeom prst="rect">
@@ -48939,20 +49257,20 @@
                 </a:solidFill>
                 <a:latin typeface="Kanit"/>
               </a:rPr>
-              <a:t>฿133.82 /กก. · ชายฝั่งใต้·ตอ.</a:t>
+              <a:t>฿43.00 /กก. · กลาง·ตอ.</a:t>
             </a:r>
           </a:p>
         </p:txBody>
       </p:sp>
       <p:sp>
         <p:nvSpPr>
-          <p:cNvPr id="38" name="TextBox 37"/>
+          <p:cNvPr id="45" name="TextBox 44"/>
           <p:cNvSpPr txBox="1"/>
           <p:nvPr/>
         </p:nvSpPr>
         <p:spPr>
           <a:xfrm>
-            <a:off x="7318857" y="2244851"/>
+            <a:off x="9621316" y="2244851"/>
             <a:ext cx="1078077" cy="134112"/>
           </a:xfrm>
           <a:prstGeom prst="rect">
@@ -48978,20 +49296,20 @@
                 </a:solidFill>
                 <a:latin typeface="Kanit"/>
               </a:rPr>
-              <a:t>เทียบปีก่อน +1.1%</a:t>
+              <a:t>เทียบปีก่อน +3.5%</a:t>
             </a:r>
           </a:p>
         </p:txBody>
       </p:sp>
       <p:sp>
         <p:nvSpPr>
-          <p:cNvPr id="39" name="TextBox 38"/>
+          <p:cNvPr id="46" name="TextBox 45"/>
           <p:cNvSpPr txBox="1"/>
           <p:nvPr/>
         </p:nvSpPr>
         <p:spPr>
           <a:xfrm>
-            <a:off x="8396935" y="2244851"/>
+            <a:off x="10699394" y="2244851"/>
             <a:ext cx="1078077" cy="134112"/>
           </a:xfrm>
           <a:prstGeom prst="rect">
@@ -49013,24 +49331,24 @@
             <a:r>
               <a:rPr sz="800" b="1">
                 <a:solidFill>
-                  <a:srgbClr val="CC0000"/>
+                  <a:srgbClr val="15795F"/>
                 </a:solidFill>
                 <a:latin typeface="Kanit"/>
               </a:rPr>
-              <a:t>6 เดือน −15.8%</a:t>
+              <a:t>6 เดือน +2.3%</a:t>
             </a:r>
           </a:p>
         </p:txBody>
       </p:sp>
       <p:sp>
         <p:nvSpPr>
-          <p:cNvPr id="40" name="Rectangle 39"/>
+          <p:cNvPr id="47" name="Rectangle 46"/>
           <p:cNvSpPr/>
           <p:nvPr/>
         </p:nvSpPr>
         <p:spPr>
           <a:xfrm>
-            <a:off x="7318857" y="2400300"/>
+            <a:off x="9621316" y="2400300"/>
             <a:ext cx="2156155" cy="548640"/>
           </a:xfrm>
           <a:prstGeom prst="rect">
@@ -49070,13 +49388,13 @@
       </p:sp>
       <p:sp>
         <p:nvSpPr>
-          <p:cNvPr id="41" name="Freeform 40"/>
+          <p:cNvPr id="48" name="Freeform 47"/>
           <p:cNvSpPr/>
           <p:nvPr/>
         </p:nvSpPr>
         <p:spPr>
           <a:xfrm>
-            <a:off x="7364577" y="2446020"/>
+            <a:off x="9667036" y="2446020"/>
             <a:ext cx="2064715" cy="457200"/>
           </a:xfrm>
           <a:custGeom>
@@ -49091,19 +49409,19 @@
                   <a:pt x="0" y="0"/>
                 </a:moveTo>
                 <a:lnTo>
-                  <a:pt x="412943" y="247179"/>
-                </a:lnTo>
-                <a:lnTo>
-                  <a:pt x="825886" y="420769"/>
+                  <a:pt x="412943" y="114807"/>
+                </a:lnTo>
+                <a:lnTo>
+                  <a:pt x="825886" y="305815"/>
                 </a:lnTo>
                 <a:lnTo>
                   <a:pt x="1238829" y="457200"/>
                 </a:lnTo>
                 <a:lnTo>
-                  <a:pt x="1651772" y="424594"/>
-                </a:lnTo>
-                <a:lnTo>
-                  <a:pt x="2064715" y="223135"/>
+                  <a:pt x="1651772" y="244855"/>
+                </a:lnTo>
+                <a:lnTo>
+                  <a:pt x="2064715" y="91439"/>
                 </a:lnTo>
               </a:path>
             </a:pathLst>
@@ -49111,7 +49429,7 @@
           <a:noFill/>
           <a:ln w="20320">
             <a:solidFill>
-              <a:srgbClr val="CC0000"/>
+              <a:srgbClr val="15795F"/>
             </a:solidFill>
           </a:ln>
           <a:effectLst/>
@@ -49140,13 +49458,13 @@
       </p:sp>
       <p:sp>
         <p:nvSpPr>
-          <p:cNvPr id="42" name="Rounded Rectangle 41"/>
+          <p:cNvPr id="49" name="Rounded Rectangle 48"/>
           <p:cNvSpPr/>
           <p:nvPr/>
         </p:nvSpPr>
         <p:spPr>
           <a:xfrm>
-            <a:off x="9388144" y="2628007"/>
+            <a:off x="11690603" y="2496311"/>
             <a:ext cx="82296" cy="82296"/>
           </a:xfrm>
           <a:prstGeom prst="roundRect">
@@ -49155,7 +49473,7 @@
             </a:avLst>
           </a:prstGeom>
           <a:solidFill>
-            <a:srgbClr val="CC0000"/>
+            <a:srgbClr val="15795F"/>
           </a:solidFill>
           <a:ln>
             <a:noFill/>
@@ -49186,13 +49504,13 @@
       </p:sp>
       <p:sp>
         <p:nvSpPr>
-          <p:cNvPr id="43" name="TextBox 42"/>
+          <p:cNvPr id="50" name="TextBox 49"/>
           <p:cNvSpPr txBox="1"/>
           <p:nvPr/>
         </p:nvSpPr>
         <p:spPr>
           <a:xfrm>
-            <a:off x="9621316" y="1970531"/>
+            <a:off x="411480" y="3076956"/>
             <a:ext cx="2156155" cy="150876"/>
           </a:xfrm>
           <a:prstGeom prst="rect">
@@ -49225,13 +49543,13 @@
       </p:sp>
       <p:sp>
         <p:nvSpPr>
-          <p:cNvPr id="44" name="TextBox 43"/>
+          <p:cNvPr id="51" name="TextBox 50"/>
           <p:cNvSpPr txBox="1"/>
           <p:nvPr/>
         </p:nvSpPr>
         <p:spPr>
           <a:xfrm>
-            <a:off x="9621316" y="2112263"/>
+            <a:off x="411480" y="3218687"/>
             <a:ext cx="2156155" cy="125730"/>
           </a:xfrm>
           <a:prstGeom prst="rect">
@@ -49257,20 +49575,20 @@
                 </a:solidFill>
                 <a:latin typeface="Kanit"/>
               </a:rPr>
-              <a:t>฿66.65 /กก. · กลาง·ตต.·ตอ.</a:t>
+              <a:t>฿70.12 /กก. · กลาง·ตต.·ตอ.</a:t>
             </a:r>
           </a:p>
         </p:txBody>
       </p:sp>
       <p:sp>
         <p:nvSpPr>
-          <p:cNvPr id="45" name="TextBox 44"/>
+          <p:cNvPr id="52" name="TextBox 51"/>
           <p:cNvSpPr txBox="1"/>
           <p:nvPr/>
         </p:nvSpPr>
         <p:spPr>
           <a:xfrm>
-            <a:off x="9621316" y="2244851"/>
+            <a:off x="411480" y="3351275"/>
             <a:ext cx="1078077" cy="134112"/>
           </a:xfrm>
           <a:prstGeom prst="rect">
@@ -49296,20 +49614,20 @@
                 </a:solidFill>
                 <a:latin typeface="Kanit"/>
               </a:rPr>
-              <a:t>เทียบปีก่อน +1.5%</a:t>
+              <a:t>เทียบปีก่อน +5.4%</a:t>
             </a:r>
           </a:p>
         </p:txBody>
       </p:sp>
       <p:sp>
         <p:nvSpPr>
-          <p:cNvPr id="46" name="TextBox 45"/>
+          <p:cNvPr id="53" name="TextBox 52"/>
           <p:cNvSpPr txBox="1"/>
           <p:nvPr/>
         </p:nvSpPr>
         <p:spPr>
           <a:xfrm>
-            <a:off x="10699394" y="2244851"/>
+            <a:off x="1489557" y="3351275"/>
             <a:ext cx="1078077" cy="134112"/>
           </a:xfrm>
           <a:prstGeom prst="rect">
@@ -49335,20 +49653,20 @@
                 </a:solidFill>
                 <a:latin typeface="Kanit"/>
               </a:rPr>
-              <a:t>6 เดือน +6.1%</a:t>
+              <a:t>6 เดือน +26.3%</a:t>
             </a:r>
           </a:p>
         </p:txBody>
       </p:sp>
       <p:sp>
         <p:nvSpPr>
-          <p:cNvPr id="47" name="Rectangle 46"/>
+          <p:cNvPr id="54" name="Rectangle 53"/>
           <p:cNvSpPr/>
           <p:nvPr/>
         </p:nvSpPr>
         <p:spPr>
           <a:xfrm>
-            <a:off x="9621316" y="2400300"/>
+            <a:off x="411480" y="3506724"/>
             <a:ext cx="2156155" cy="548640"/>
           </a:xfrm>
           <a:prstGeom prst="rect">
@@ -49388,13 +49706,13 @@
       </p:sp>
       <p:sp>
         <p:nvSpPr>
-          <p:cNvPr id="48" name="Freeform 47"/>
+          <p:cNvPr id="55" name="Freeform 54"/>
           <p:cNvSpPr/>
           <p:nvPr/>
         </p:nvSpPr>
         <p:spPr>
           <a:xfrm>
-            <a:off x="9667036" y="2446020"/>
+            <a:off x="457200" y="3552444"/>
             <a:ext cx="2064715" cy="457200"/>
           </a:xfrm>
           <a:custGeom>
@@ -49406,22 +49724,22 @@
             <a:pathLst>
               <a:path w="2064715" h="457200">
                 <a:moveTo>
-                  <a:pt x="0" y="457200"/>
+                  <a:pt x="0" y="358828"/>
                 </a:moveTo>
                 <a:lnTo>
-                  <a:pt x="412943" y="182662"/>
-                </a:lnTo>
-                <a:lnTo>
-                  <a:pt x="825886" y="0"/>
-                </a:lnTo>
-                <a:lnTo>
-                  <a:pt x="1238829" y="252749"/>
-                </a:lnTo>
-                <a:lnTo>
-                  <a:pt x="1651772" y="129642"/>
-                </a:lnTo>
-                <a:lnTo>
-                  <a:pt x="2064715" y="53019"/>
+                  <a:pt x="412943" y="100410"/>
+                </a:lnTo>
+                <a:lnTo>
+                  <a:pt x="825886" y="457200"/>
+                </a:lnTo>
+                <a:lnTo>
+                  <a:pt x="1238829" y="286450"/>
+                </a:lnTo>
+                <a:lnTo>
+                  <a:pt x="1651772" y="170749"/>
+                </a:lnTo>
+                <a:lnTo>
+                  <a:pt x="2064715" y="0"/>
                 </a:lnTo>
               </a:path>
             </a:pathLst>
@@ -49458,13 +49776,13 @@
       </p:sp>
       <p:sp>
         <p:nvSpPr>
-          <p:cNvPr id="49" name="Rounded Rectangle 48"/>
+          <p:cNvPr id="56" name="Rounded Rectangle 55"/>
           <p:cNvSpPr/>
           <p:nvPr/>
         </p:nvSpPr>
         <p:spPr>
           <a:xfrm>
-            <a:off x="11690603" y="2457891"/>
+            <a:off x="2480767" y="3511296"/>
             <a:ext cx="82296" cy="82296"/>
           </a:xfrm>
           <a:prstGeom prst="roundRect">
@@ -49474,324 +49792,6 @@
           </a:prstGeom>
           <a:solidFill>
             <a:srgbClr val="15795F"/>
-          </a:solidFill>
-          <a:ln>
-            <a:noFill/>
-          </a:ln>
-          <a:effectLst/>
-        </p:spPr>
-        <p:style>
-          <a:lnRef idx="1">
-            <a:schemeClr val="accent1"/>
-          </a:lnRef>
-          <a:fillRef idx="3">
-            <a:schemeClr val="accent1"/>
-          </a:fillRef>
-          <a:effectRef idx="2">
-            <a:schemeClr val="accent1"/>
-          </a:effectRef>
-          <a:fontRef idx="minor">
-            <a:schemeClr val="lt1"/>
-          </a:fontRef>
-        </p:style>
-        <p:txBody>
-          <a:bodyPr rtlCol="0" anchor="ctr" wrap="none"/>
-          <a:lstStyle/>
-          <a:p>
-            <a:pPr algn="ctr"/>
-          </a:p>
-        </p:txBody>
-      </p:sp>
-      <p:sp>
-        <p:nvSpPr>
-          <p:cNvPr id="50" name="TextBox 49"/>
-          <p:cNvSpPr txBox="1"/>
-          <p:nvPr/>
-        </p:nvSpPr>
-        <p:spPr>
-          <a:xfrm>
-            <a:off x="411480" y="3076956"/>
-            <a:ext cx="2156155" cy="150876"/>
-          </a:xfrm>
-          <a:prstGeom prst="rect">
-            <a:avLst/>
-          </a:prstGeom>
-          <a:noFill/>
-        </p:spPr>
-        <p:txBody>
-          <a:bodyPr wrap="square" lIns="0" rIns="0" tIns="0" bIns="0" anchor="t">
-            <a:noAutofit/>
-          </a:bodyPr>
-          <a:lstStyle/>
-          <a:p>
-            <a:pPr algn="l">
-              <a:lnSpc>
-                <a:spcPts val="1188"/>
-              </a:lnSpc>
-            </a:pPr>
-            <a:r>
-              <a:rPr sz="900" b="1">
-                <a:solidFill>
-                  <a:srgbClr val="1E2F5C"/>
-                </a:solidFill>
-                <a:latin typeface="Kanit"/>
-              </a:rPr>
-              <a:t>ไก่เนื้อ</a:t>
-            </a:r>
-          </a:p>
-        </p:txBody>
-      </p:sp>
-      <p:sp>
-        <p:nvSpPr>
-          <p:cNvPr id="51" name="TextBox 50"/>
-          <p:cNvSpPr txBox="1"/>
-          <p:nvPr/>
-        </p:nvSpPr>
-        <p:spPr>
-          <a:xfrm>
-            <a:off x="411480" y="3218687"/>
-            <a:ext cx="2156155" cy="125730"/>
-          </a:xfrm>
-          <a:prstGeom prst="rect">
-            <a:avLst/>
-          </a:prstGeom>
-          <a:noFill/>
-        </p:spPr>
-        <p:txBody>
-          <a:bodyPr wrap="square" lIns="0" rIns="0" tIns="0" bIns="0" anchor="t">
-            <a:noAutofit/>
-          </a:bodyPr>
-          <a:lstStyle/>
-          <a:p>
-            <a:pPr algn="l">
-              <a:lnSpc>
-                <a:spcPts val="990"/>
-              </a:lnSpc>
-            </a:pPr>
-            <a:r>
-              <a:rPr sz="750" b="0">
-                <a:solidFill>
-                  <a:srgbClr val="606060"/>
-                </a:solidFill>
-                <a:latin typeface="Kanit"/>
-              </a:rPr>
-              <a:t>฿41.19 /กก. · กลาง·ตอ.</a:t>
-            </a:r>
-          </a:p>
-        </p:txBody>
-      </p:sp>
-      <p:sp>
-        <p:nvSpPr>
-          <p:cNvPr id="52" name="TextBox 51"/>
-          <p:cNvSpPr txBox="1"/>
-          <p:nvPr/>
-        </p:nvSpPr>
-        <p:spPr>
-          <a:xfrm>
-            <a:off x="411480" y="3351275"/>
-            <a:ext cx="1078077" cy="134112"/>
-          </a:xfrm>
-          <a:prstGeom prst="rect">
-            <a:avLst/>
-          </a:prstGeom>
-          <a:noFill/>
-        </p:spPr>
-        <p:txBody>
-          <a:bodyPr wrap="square" lIns="0" rIns="0" tIns="0" bIns="0" anchor="t">
-            <a:noAutofit/>
-          </a:bodyPr>
-          <a:lstStyle/>
-          <a:p>
-            <a:pPr algn="l">
-              <a:lnSpc>
-                <a:spcPts val="1056"/>
-              </a:lnSpc>
-            </a:pPr>
-            <a:r>
-              <a:rPr sz="800" b="1">
-                <a:solidFill>
-                  <a:srgbClr val="15795F"/>
-                </a:solidFill>
-                <a:latin typeface="Kanit"/>
-              </a:rPr>
-              <a:t>เทียบปีก่อน +2.0%</a:t>
-            </a:r>
-          </a:p>
-        </p:txBody>
-      </p:sp>
-      <p:sp>
-        <p:nvSpPr>
-          <p:cNvPr id="53" name="TextBox 52"/>
-          <p:cNvSpPr txBox="1"/>
-          <p:nvPr/>
-        </p:nvSpPr>
-        <p:spPr>
-          <a:xfrm>
-            <a:off x="1489557" y="3351275"/>
-            <a:ext cx="1078077" cy="134112"/>
-          </a:xfrm>
-          <a:prstGeom prst="rect">
-            <a:avLst/>
-          </a:prstGeom>
-          <a:noFill/>
-        </p:spPr>
-        <p:txBody>
-          <a:bodyPr wrap="square" lIns="0" rIns="0" tIns="0" bIns="0" anchor="t">
-            <a:noAutofit/>
-          </a:bodyPr>
-          <a:lstStyle/>
-          <a:p>
-            <a:pPr algn="l">
-              <a:lnSpc>
-                <a:spcPts val="1056"/>
-              </a:lnSpc>
-            </a:pPr>
-            <a:r>
-              <a:rPr sz="800" b="1">
-                <a:solidFill>
-                  <a:srgbClr val="CC0000"/>
-                </a:solidFill>
-                <a:latin typeface="Kanit"/>
-              </a:rPr>
-              <a:t>6 เดือน −1.9%</a:t>
-            </a:r>
-          </a:p>
-        </p:txBody>
-      </p:sp>
-      <p:sp>
-        <p:nvSpPr>
-          <p:cNvPr id="54" name="Rectangle 53"/>
-          <p:cNvSpPr/>
-          <p:nvPr/>
-        </p:nvSpPr>
-        <p:spPr>
-          <a:xfrm>
-            <a:off x="411480" y="3506724"/>
-            <a:ext cx="2156155" cy="548640"/>
-          </a:xfrm>
-          <a:prstGeom prst="rect">
-            <a:avLst/>
-          </a:prstGeom>
-          <a:solidFill>
-            <a:srgbClr val="FBFCFE"/>
-          </a:solidFill>
-          <a:ln w="9525">
-            <a:solidFill>
-              <a:srgbClr val="D9DEE9"/>
-            </a:solidFill>
-          </a:ln>
-          <a:effectLst/>
-        </p:spPr>
-        <p:style>
-          <a:lnRef idx="1">
-            <a:schemeClr val="accent1"/>
-          </a:lnRef>
-          <a:fillRef idx="3">
-            <a:schemeClr val="accent1"/>
-          </a:fillRef>
-          <a:effectRef idx="2">
-            <a:schemeClr val="accent1"/>
-          </a:effectRef>
-          <a:fontRef idx="minor">
-            <a:schemeClr val="lt1"/>
-          </a:fontRef>
-        </p:style>
-        <p:txBody>
-          <a:bodyPr rtlCol="0" anchor="ctr" wrap="none"/>
-          <a:lstStyle/>
-          <a:p>
-            <a:pPr algn="ctr"/>
-          </a:p>
-        </p:txBody>
-      </p:sp>
-      <p:sp>
-        <p:nvSpPr>
-          <p:cNvPr id="55" name="Freeform 54"/>
-          <p:cNvSpPr/>
-          <p:nvPr/>
-        </p:nvSpPr>
-        <p:spPr>
-          <a:xfrm>
-            <a:off x="457200" y="3552444"/>
-            <a:ext cx="2064715" cy="457200"/>
-          </a:xfrm>
-          <a:custGeom>
-            <a:avLst/>
-            <a:gdLst/>
-            <a:ahLst/>
-            <a:cxnLst/>
-            <a:rect l="l" t="t" r="r" b="b"/>
-            <a:pathLst>
-              <a:path w="2064715" h="457200">
-                <a:moveTo>
-                  <a:pt x="0" y="187960"/>
-                </a:moveTo>
-                <a:lnTo>
-                  <a:pt x="412943" y="0"/>
-                </a:lnTo>
-                <a:lnTo>
-                  <a:pt x="825886" y="114807"/>
-                </a:lnTo>
-                <a:lnTo>
-                  <a:pt x="1238829" y="305815"/>
-                </a:lnTo>
-                <a:lnTo>
-                  <a:pt x="1651772" y="457200"/>
-                </a:lnTo>
-                <a:lnTo>
-                  <a:pt x="2064715" y="275336"/>
-                </a:lnTo>
-              </a:path>
-            </a:pathLst>
-          </a:custGeom>
-          <a:noFill/>
-          <a:ln w="20320">
-            <a:solidFill>
-              <a:srgbClr val="CC0000"/>
-            </a:solidFill>
-          </a:ln>
-          <a:effectLst/>
-        </p:spPr>
-        <p:style>
-          <a:lnRef idx="1">
-            <a:schemeClr val="accent1"/>
-          </a:lnRef>
-          <a:fillRef idx="3">
-            <a:schemeClr val="accent1"/>
-          </a:fillRef>
-          <a:effectRef idx="2">
-            <a:schemeClr val="accent1"/>
-          </a:effectRef>
-          <a:fontRef idx="minor">
-            <a:schemeClr val="lt1"/>
-          </a:fontRef>
-        </p:style>
-        <p:txBody>
-          <a:bodyPr rtlCol="0" anchor="ctr"/>
-          <a:lstStyle/>
-          <a:p>
-            <a:pPr algn="ctr"/>
-          </a:p>
-        </p:txBody>
-      </p:sp>
-      <p:sp>
-        <p:nvSpPr>
-          <p:cNvPr id="56" name="Rounded Rectangle 55"/>
-          <p:cNvSpPr/>
-          <p:nvPr/>
-        </p:nvSpPr>
-        <p:spPr>
-          <a:xfrm>
-            <a:off x="2480767" y="3786632"/>
-            <a:ext cx="82296" cy="82296"/>
-          </a:xfrm>
-          <a:prstGeom prst="roundRect">
-            <a:avLst>
-              <a:gd name="adj" fmla="val 50000"/>
-            </a:avLst>
-          </a:prstGeom>
-          <a:solidFill>
-            <a:srgbClr val="CC0000"/>
           </a:solidFill>
           <a:ln>
             <a:noFill/>
@@ -49893,7 +49893,7 @@
                 </a:solidFill>
                 <a:latin typeface="Kanit"/>
               </a:rPr>
-              <a:t>฿17,727 /ตัน · อีสาน·เหนือ·กลาง</a:t>
+              <a:t>฿17,768 /ตัน · อีสาน·เหนือ·กลาง</a:t>
             </a:r>
           </a:p>
         </p:txBody>
@@ -49932,7 +49932,7 @@
                 </a:solidFill>
                 <a:latin typeface="Kanit"/>
               </a:rPr>
-              <a:t>เทียบปีก่อน +14.0%</a:t>
+              <a:t>เทียบปีก่อน +14.2%</a:t>
             </a:r>
           </a:p>
         </p:txBody>
@@ -49971,7 +49971,7 @@
                 </a:solidFill>
                 <a:latin typeface="Kanit"/>
               </a:rPr>
-              <a:t>6 เดือน +8.1%</a:t>
+              <a:t>6 เดือน +8.0%</a:t>
             </a:r>
           </a:p>
         </p:txBody>
@@ -50045,16 +50045,16 @@
                   <a:pt x="0" y="457200"/>
                 </a:moveTo>
                 <a:lnTo>
-                  <a:pt x="412943" y="340931"/>
-                </a:lnTo>
-                <a:lnTo>
-                  <a:pt x="825886" y="253323"/>
-                </a:lnTo>
-                <a:lnTo>
-                  <a:pt x="1238829" y="103264"/>
-                </a:lnTo>
-                <a:lnTo>
-                  <a:pt x="1651772" y="6195"/>
+                  <a:pt x="412943" y="341616"/>
+                </a:lnTo>
+                <a:lnTo>
+                  <a:pt x="825886" y="154005"/>
+                </a:lnTo>
+                <a:lnTo>
+                  <a:pt x="1238829" y="47789"/>
+                </a:lnTo>
+                <a:lnTo>
+                  <a:pt x="1651772" y="27620"/>
                 </a:lnTo>
                 <a:lnTo>
                   <a:pt x="2064715" y="0"/>
@@ -50211,7 +50211,7 @@
                 </a:solidFill>
                 <a:latin typeface="Kanit"/>
               </a:rPr>
-              <a:t>฿10.76 /กก. · เหนือ</a:t>
+              <a:t>฿10.04 /กก. · เหนือ</a:t>
             </a:r>
           </a:p>
         </p:txBody>
@@ -50289,7 +50289,7 @@
                 </a:solidFill>
                 <a:latin typeface="Kanit"/>
               </a:rPr>
-              <a:t>6 เดือน +22.1%</a:t>
+              <a:t>6 เดือน +12.7%</a:t>
             </a:r>
           </a:p>
         </p:txBody>
@@ -50363,19 +50363,19 @@
                   <a:pt x="0" y="457200"/>
                 </a:moveTo>
                 <a:lnTo>
-                  <a:pt x="412943" y="415234"/>
-                </a:lnTo>
-                <a:lnTo>
-                  <a:pt x="825886" y="315843"/>
-                </a:lnTo>
-                <a:lnTo>
-                  <a:pt x="1238829" y="81721"/>
-                </a:lnTo>
-                <a:lnTo>
-                  <a:pt x="1651772" y="0"/>
-                </a:lnTo>
-                <a:lnTo>
-                  <a:pt x="2064715" y="46382"/>
+                  <a:pt x="412943" y="357808"/>
+                </a:lnTo>
+                <a:lnTo>
+                  <a:pt x="825886" y="86967"/>
+                </a:lnTo>
+                <a:lnTo>
+                  <a:pt x="1238829" y="0"/>
+                </a:lnTo>
+                <a:lnTo>
+                  <a:pt x="1651772" y="49695"/>
+                </a:lnTo>
+                <a:lnTo>
+                  <a:pt x="2064715" y="226115"/>
                 </a:lnTo>
               </a:path>
             </a:pathLst>
@@ -50418,7 +50418,7 @@
         </p:nvSpPr>
         <p:spPr>
           <a:xfrm>
-            <a:off x="7085685" y="3557678"/>
+            <a:off x="7085685" y="3737411"/>
             <a:ext cx="82296" cy="82296"/>
           </a:xfrm>
           <a:prstGeom prst="roundRect">
@@ -50529,7 +50529,7 @@
                 </a:solidFill>
                 <a:latin typeface="Kanit"/>
               </a:rPr>
-              <a:t>฿8.21 /กก. · ใต้</a:t>
+              <a:t>฿8.65 /กก. · ใต้</a:t>
             </a:r>
           </a:p>
         </p:txBody>
@@ -50568,7 +50568,7 @@
                 </a:solidFill>
                 <a:latin typeface="Kanit"/>
               </a:rPr>
-              <a:t>เทียบปีก่อน +24.7%</a:t>
+              <a:t>เทียบปีก่อน +23.9%</a:t>
             </a:r>
           </a:p>
         </p:txBody>
@@ -50607,7 +50607,7 @@
                 </a:solidFill>
                 <a:latin typeface="Kanit"/>
               </a:rPr>
-              <a:t>6 เดือน +28.7%</a:t>
+              <a:t>6 เดือน +26.6%</a:t>
             </a:r>
           </a:p>
         </p:txBody>
@@ -50681,16 +50681,16 @@
                   <a:pt x="0" y="457200"/>
                 </a:moveTo>
                 <a:lnTo>
-                  <a:pt x="412943" y="330385"/>
-                </a:lnTo>
-                <a:lnTo>
-                  <a:pt x="825886" y="320373"/>
-                </a:lnTo>
-                <a:lnTo>
-                  <a:pt x="1238829" y="337059"/>
-                </a:lnTo>
-                <a:lnTo>
-                  <a:pt x="1651772" y="180210"/>
+                  <a:pt x="412943" y="444499"/>
+                </a:lnTo>
+                <a:lnTo>
+                  <a:pt x="825886" y="457200"/>
+                </a:lnTo>
+                <a:lnTo>
+                  <a:pt x="1238829" y="311149"/>
+                </a:lnTo>
+                <a:lnTo>
+                  <a:pt x="1651772" y="114300"/>
                 </a:lnTo>
                 <a:lnTo>
                   <a:pt x="2064715" y="0"/>
@@ -50847,7 +50847,7 @@
                 </a:solidFill>
                 <a:latin typeface="Kanit"/>
               </a:rPr>
-              <a:t>฿84.55 /กก. · ใต้·ตอ.</a:t>
+              <a:t>฿81.86 /กก. · ใต้·ตอ.</a:t>
             </a:r>
           </a:p>
         </p:txBody>
@@ -50886,7 +50886,7 @@
                 </a:solidFill>
                 <a:latin typeface="Kanit"/>
               </a:rPr>
-              <a:t>เทียบปีก่อน +42.4%</a:t>
+              <a:t>เทียบปีก่อน +41.4%</a:t>
             </a:r>
           </a:p>
         </p:txBody>
@@ -50925,7 +50925,7 @@
                 </a:solidFill>
                 <a:latin typeface="Kanit"/>
               </a:rPr>
-              <a:t>6 เดือน +49.0%</a:t>
+              <a:t>6 เดือน +35.6%</a:t>
             </a:r>
           </a:p>
         </p:txBody>
@@ -50999,19 +50999,19 @@
                   <a:pt x="0" y="457200"/>
                 </a:moveTo>
                 <a:lnTo>
-                  <a:pt x="412943" y="318935"/>
-                </a:lnTo>
-                <a:lnTo>
-                  <a:pt x="825886" y="199735"/>
-                </a:lnTo>
-                <a:lnTo>
-                  <a:pt x="1238829" y="108509"/>
-                </a:lnTo>
-                <a:lnTo>
-                  <a:pt x="1651772" y="0"/>
-                </a:lnTo>
-                <a:lnTo>
-                  <a:pt x="2064715" y="26013"/>
+                  <a:pt x="412943" y="286327"/>
+                </a:lnTo>
+                <a:lnTo>
+                  <a:pt x="825886" y="157274"/>
+                </a:lnTo>
+                <a:lnTo>
+                  <a:pt x="1238829" y="0"/>
+                </a:lnTo>
+                <a:lnTo>
+                  <a:pt x="1651772" y="37202"/>
+                </a:lnTo>
+                <a:lnTo>
+                  <a:pt x="2064715" y="104678"/>
                 </a:lnTo>
               </a:path>
             </a:pathLst>
@@ -51054,7 +51054,7 @@
         </p:nvSpPr>
         <p:spPr>
           <a:xfrm>
-            <a:off x="11690603" y="3537309"/>
+            <a:off x="11690603" y="3615974"/>
             <a:ext cx="82296" cy="82296"/>
           </a:xfrm>
           <a:prstGeom prst="roundRect">
@@ -51165,7 +51165,7 @@
                 </a:solidFill>
                 <a:latin typeface="Kanit"/>
               </a:rPr>
-              <a:t>฿3.41 /กก. · อีสาน·เหนือ·ตอ.</a:t>
+              <a:t>฿3.75 /กก. · อีสาน·เหนือ·ตอ.</a:t>
             </a:r>
           </a:p>
         </p:txBody>
@@ -51204,7 +51204,7 @@
                 </a:solidFill>
                 <a:latin typeface="Kanit"/>
               </a:rPr>
-              <a:t>เทียบปีก่อน +64.3%</a:t>
+              <a:t>เทียบปีก่อน +69.4%</a:t>
             </a:r>
           </a:p>
         </p:txBody>
@@ -51243,7 +51243,7 @@
                 </a:solidFill>
                 <a:latin typeface="Kanit"/>
               </a:rPr>
-              <a:t>6 เดือน +40.3%</a:t>
+              <a:t>6 เดือน +49.4%</a:t>
             </a:r>
           </a:p>
         </p:txBody>
@@ -51317,16 +51317,16 @@
                   <a:pt x="0" y="457200"/>
                 </a:moveTo>
                 <a:lnTo>
-                  <a:pt x="412943" y="381000"/>
-                </a:lnTo>
-                <a:lnTo>
-                  <a:pt x="825886" y="254000"/>
-                </a:lnTo>
-                <a:lnTo>
-                  <a:pt x="1238829" y="152400"/>
-                </a:lnTo>
-                <a:lnTo>
-                  <a:pt x="1651772" y="25400"/>
+                  <a:pt x="412943" y="352338"/>
+                </a:lnTo>
+                <a:lnTo>
+                  <a:pt x="825886" y="268448"/>
+                </a:lnTo>
+                <a:lnTo>
+                  <a:pt x="1238829" y="163586"/>
+                </a:lnTo>
+                <a:lnTo>
+                  <a:pt x="1651772" y="130030"/>
                 </a:lnTo>
                 <a:lnTo>
                   <a:pt x="2064715" y="0"/>
@@ -51483,7 +51483,7 @@
                 </a:solidFill>
                 <a:latin typeface="Kanit"/>
               </a:rPr>
-              <a:t>฿85.88 /ร้อยผล · กลาง·ตต.</a:t>
+              <a:t>฿120.00 /ร้อยผล · กลาง·ตต.</a:t>
             </a:r>
           </a:p>
         </p:txBody>
@@ -51522,7 +51522,7 @@
                 </a:solidFill>
                 <a:latin typeface="Kanit"/>
               </a:rPr>
-              <a:t>เทียบปีก่อน +126.5%</a:t>
+              <a:t>เทียบปีก่อน +96.8%</a:t>
             </a:r>
           </a:p>
         </p:txBody>
@@ -51561,7 +51561,7 @@
                 </a:solidFill>
                 <a:latin typeface="Kanit"/>
               </a:rPr>
-              <a:t>6 เดือน −44.6%</a:t>
+              <a:t>6 เดือน −42.9%</a:t>
             </a:r>
           </a:p>
         </p:txBody>
@@ -51632,22 +51632,22 @@
             <a:pathLst>
               <a:path w="2064715" h="457200">
                 <a:moveTo>
-                  <a:pt x="0" y="375183"/>
+                  <a:pt x="0" y="213177"/>
                 </a:moveTo>
                 <a:lnTo>
-                  <a:pt x="412943" y="213449"/>
-                </a:lnTo>
-                <a:lnTo>
-                  <a:pt x="825886" y="0"/>
-                </a:lnTo>
-                <a:lnTo>
-                  <a:pt x="1238829" y="260067"/>
-                </a:lnTo>
-                <a:lnTo>
-                  <a:pt x="1651772" y="443905"/>
-                </a:lnTo>
-                <a:lnTo>
-                  <a:pt x="2064715" y="457200"/>
+                  <a:pt x="412943" y="0"/>
+                </a:lnTo>
+                <a:lnTo>
+                  <a:pt x="825886" y="259737"/>
+                </a:lnTo>
+                <a:lnTo>
+                  <a:pt x="1238829" y="443342"/>
+                </a:lnTo>
+                <a:lnTo>
+                  <a:pt x="1651772" y="457200"/>
+                </a:lnTo>
+                <a:lnTo>
+                  <a:pt x="2064715" y="434102"/>
                 </a:lnTo>
               </a:path>
             </a:pathLst>
@@ -51690,7 +51690,7 @@
         </p:nvSpPr>
         <p:spPr>
           <a:xfrm>
-            <a:off x="4783226" y="5074919"/>
+            <a:off x="4783226" y="5051821"/>
             <a:ext cx="82296" cy="82296"/>
           </a:xfrm>
           <a:prstGeom prst="roundRect">
@@ -51886,7 +51886,7 @@
                 </a:solidFill>
                 <a:latin typeface="Kanit"/>
               </a:rPr>
-              <a:t>ราคาหน้าฟาร์ม วัดจริง — ราคารายวันของ NABC เฉลี่ยเป็นรายเดือน หน่วยเป็นบาทตามที่เผยแพร่ (ไม่มีการแปลงสกุลเงิน) ราคาล่าสุด 2026-08-13, รุ่นข้อมูลย้อนหลัง 2026-08-02 ราคาหน้าฟาร์ม (ราคาที่เกษตรกรขายได้) คือเงินที่เกษตรกรได้รับเมื่อขายครั้งแรก ก่อนพ่อค้าคนกลาง โรงสี หรือค่าขนส่งจะหักส่วนแบ่ง — ไม่ใช่ดัชนีโลก และไม่ใช่ราคาในซูเปอร์มาร์เก็ต แหล่งผลิตเป็นการอ่านแบบ ประมาณการ ว่าสินค้าแต่ละชนิดผลิตที่ไหน และทับซ้อนกันได้ น้ำตาลเป็นราคาอ้อยประกาศของ สอน. ปีละหนึ่งจุด จึงไม่มีการเปลี่ยนแปลงหกเดือนให้แสดง</a:t>
+              <a:t>ราคาหน้าฟาร์ม วัดจริง — ราคารายวันของ NABC เฉลี่ยเป็นรายเดือน หน่วยเป็นบาทตามที่เผยแพร่ (ไม่มีการแปลงสกุลเงิน) ราคาล่าสุด 2026-08-20, รุ่นข้อมูลย้อนหลัง 2026-08-17 ราคาหน้าฟาร์ม (ราคาที่เกษตรกรขายได้) คือเงินที่เกษตรกรได้รับเมื่อขายครั้งแรก ก่อนพ่อค้าคนกลาง โรงสี หรือค่าขนส่งจะหักส่วนแบ่ง — ไม่ใช่ดัชนีโลก และไม่ใช่ราคาในซูเปอร์มาร์เก็ต แหล่งผลิตเป็นการอ่านแบบ ประมาณการ ว่าสินค้าแต่ละชนิดผลิตที่ไหน และทับซ้อนกันได้ น้ำตาลเป็นราคาอ้อยประกาศของ สอน. ปีละหนึ่งจุด จึงไม่มีการเปลี่ยนแปลงหกเดือนให้แสดง</a:t>
             </a:r>
           </a:p>
         </p:txBody>
@@ -52543,7 +52543,7 @@
                           </a:solidFill>
                           <a:latin typeface="Kanit"/>
                         </a:rPr>
-                        <a:t>+9.1%</a:t>
+                        <a:t>+9.3%</a:t>
                       </a:r>
                     </a:p>
                   </a:txBody>
@@ -52775,7 +52775,7 @@
                           </a:solidFill>
                           <a:latin typeface="Kanit"/>
                         </a:rPr>
-                        <a:t>+12.8%</a:t>
+                        <a:t>+10.5%</a:t>
                       </a:r>
                     </a:p>
                   </a:txBody>
@@ -53007,7 +53007,7 @@
                           </a:solidFill>
                           <a:latin typeface="Kanit"/>
                         </a:rPr>
-                        <a:t>+9.4%</a:t>
+                        <a:t>+9.6%</a:t>
                       </a:r>
                     </a:p>
                   </a:txBody>
@@ -53239,7 +53239,7 @@
                           </a:solidFill>
                           <a:latin typeface="Kanit"/>
                         </a:rPr>
-                        <a:t>+9.3%</a:t>
+                        <a:t>+9.2%</a:t>
                       </a:r>
                     </a:p>
                   </a:txBody>
@@ -53471,7 +53471,7 @@
                           </a:solidFill>
                           <a:latin typeface="Kanit"/>
                         </a:rPr>
-                        <a:t>+14.5%</a:t>
+                        <a:t>+10.7%</a:t>
                       </a:r>
                     </a:p>
                   </a:txBody>

</xml_diff>

<commit_message>
deck(mcom): rebuild — the data moved past the committed figures (run 32836868860)
</commit_message>
<xml_diff>
--- a/docs/decks/mcom-2026-08-05-macro-TH.pptx
+++ b/docs/decks/mcom-2026-08-05-macro-TH.pptx
@@ -6240,7 +6240,7 @@
                 </a:solidFill>
                 <a:latin typeface="Kanit"/>
               </a:rPr>
-              <a:t>141</a:t>
+              <a:t>134</a:t>
             </a:r>
           </a:p>
         </p:txBody>
@@ -6279,7 +6279,7 @@
                 </a:solidFill>
                 <a:latin typeface="Kanit"/>
               </a:rPr>
-              <a:t>จาก 796 (17.7%) · เรียลไทม์ · 2026-08-22</a:t>
+              <a:t>จาก 795 (16.9%) · เรียลไทม์ · 2026-08-25</a:t>
             </a:r>
           </a:p>
         </p:txBody>
@@ -6405,7 +6405,7 @@
                 </a:solidFill>
                 <a:latin typeface="Kanit"/>
               </a:rPr>
-              <a:t>17</a:t>
+              <a:t>15</a:t>
             </a:r>
           </a:p>
         </p:txBody>
@@ -6444,7 +6444,7 @@
                 </a:solidFill>
                 <a:latin typeface="Kanit"/>
               </a:rPr>
-              <a:t>ค่าล่าสุดรายวัน · 2026-08-22</a:t>
+              <a:t>ค่าล่าสุดรายวัน · 2026-08-25</a:t>
             </a:r>
           </a:p>
         </p:txBody>
@@ -7882,7 +7882,7 @@
                           </a:solidFill>
                           <a:latin typeface="Kanit"/>
                         </a:rPr>
-                        <a:t>น่าน</a:t>
+                        <a:t>มุกดาหาร</a:t>
                       </a:r>
                     </a:p>
                   </a:txBody>
@@ -7905,7 +7905,7 @@
                           </a:solidFill>
                           <a:latin typeface="Kanit"/>
                         </a:rPr>
-                        <a:t>215</a:t>
+                        <a:t>18</a:t>
                       </a:r>
                     </a:p>
                   </a:txBody>
@@ -7928,7 +7928,7 @@
                           </a:solidFill>
                           <a:latin typeface="Kanit"/>
                         </a:rPr>
-                        <a:t>68</a:t>
+                        <a:t>37</a:t>
                       </a:r>
                     </a:p>
                   </a:txBody>
@@ -7951,7 +7951,7 @@
                           </a:solidFill>
                           <a:latin typeface="Kanit"/>
                         </a:rPr>
-                        <a:t>1.9%</a:t>
+                        <a:t>5.6%</a:t>
                       </a:r>
                     </a:p>
                   </a:txBody>
@@ -7974,7 +7974,7 @@
                           </a:solidFill>
                           <a:latin typeface="Kanit"/>
                         </a:rPr>
-                        <a:t>4/28</a:t>
+                        <a:t>2/2</a:t>
                       </a:r>
                     </a:p>
                   </a:txBody>
@@ -8022,7 +8022,7 @@
                           </a:solidFill>
                           <a:latin typeface="Kanit"/>
                         </a:rPr>
-                        <a:t>นครพนม</a:t>
+                        <a:t>สกลนคร</a:t>
                       </a:r>
                     </a:p>
                   </a:txBody>
@@ -8045,7 +8045,7 @@
                           </a:solidFill>
                           <a:latin typeface="Kanit"/>
                         </a:rPr>
-                        <a:t>28</a:t>
+                        <a:t>38</a:t>
                       </a:r>
                     </a:p>
                   </a:txBody>
@@ -8114,7 +8114,7 @@
                           </a:solidFill>
                           <a:latin typeface="Kanit"/>
                         </a:rPr>
-                        <a:t>8/14</a:t>
+                        <a:t>7/13</a:t>
                       </a:r>
                     </a:p>
                   </a:txBody>
@@ -8162,7 +8162,7 @@
                           </a:solidFill>
                           <a:latin typeface="Kanit"/>
                         </a:rPr>
-                        <a:t>มุกดาหาร</a:t>
+                        <a:t>สมุทรปราการ</a:t>
                       </a:r>
                     </a:p>
                   </a:txBody>
@@ -8185,7 +8185,7 @@
                           </a:solidFill>
                           <a:latin typeface="Kanit"/>
                         </a:rPr>
-                        <a:t>17</a:t>
+                        <a:t>16</a:t>
                       </a:r>
                     </a:p>
                   </a:txBody>
@@ -8208,7 +8208,7 @@
                           </a:solidFill>
                           <a:latin typeface="Kanit"/>
                         </a:rPr>
-                        <a:t>12</a:t>
+                        <a:t>1</a:t>
                       </a:r>
                     </a:p>
                   </a:txBody>
@@ -8254,7 +8254,7 @@
                           </a:solidFill>
                           <a:latin typeface="Kanit"/>
                         </a:rPr>
-                        <a:t>2/2</a:t>
+                        <a:t>4/5</a:t>
                       </a:r>
                     </a:p>
                   </a:txBody>
@@ -8302,7 +8302,7 @@
                           </a:solidFill>
                           <a:latin typeface="Kanit"/>
                         </a:rPr>
-                        <a:t>สกลนคร</a:t>
+                        <a:t>นราธิวาส</a:t>
                       </a:r>
                     </a:p>
                   </a:txBody>
@@ -8325,7 +8325,7 @@
                           </a:solidFill>
                           <a:latin typeface="Kanit"/>
                         </a:rPr>
-                        <a:t>38</a:t>
+                        <a:t>67</a:t>
                       </a:r>
                     </a:p>
                   </a:txBody>
@@ -8348,7 +8348,7 @@
                           </a:solidFill>
                           <a:latin typeface="Kanit"/>
                         </a:rPr>
-                        <a:t>22</a:t>
+                        <a:t>40</a:t>
                       </a:r>
                     </a:p>
                   </a:txBody>
@@ -8367,11 +8367,11 @@
                       <a:r>
                         <a:rPr sz="900" b="1">
                           <a:solidFill>
-                            <a:srgbClr val="606060"/>
-                          </a:solidFill>
-                          <a:latin typeface="Kanit"/>
-                        </a:rPr>
-                        <a:t>0.0%</a:t>
+                            <a:srgbClr val="F5C242"/>
+                          </a:solidFill>
+                          <a:latin typeface="Kanit"/>
+                        </a:rPr>
+                        <a:t>4.5%</a:t>
                       </a:r>
                     </a:p>
                   </a:txBody>
@@ -8394,7 +8394,7 @@
                           </a:solidFill>
                           <a:latin typeface="Kanit"/>
                         </a:rPr>
-                        <a:t>7/13</a:t>
+                        <a:t>5/10</a:t>
                       </a:r>
                     </a:p>
                   </a:txBody>
@@ -8413,11 +8413,11 @@
                       <a:r>
                         <a:rPr sz="900" b="1">
                           <a:solidFill>
-                            <a:srgbClr val="CC0000"/>
-                          </a:solidFill>
-                          <a:latin typeface="Kanit"/>
-                        </a:rPr>
-                        <a:t>5</a:t>
+                            <a:srgbClr val="F5C242"/>
+                          </a:solidFill>
+                          <a:latin typeface="Kanit"/>
+                        </a:rPr>
+                        <a:t>4</a:t>
                       </a:r>
                     </a:p>
                   </a:txBody>
@@ -8442,7 +8442,7 @@
                           </a:solidFill>
                           <a:latin typeface="Kanit"/>
                         </a:rPr>
-                        <a:t>เพชรบูรณ์</a:t>
+                        <a:t>สงขลา</a:t>
                       </a:r>
                     </a:p>
                   </a:txBody>
@@ -8465,7 +8465,7 @@
                           </a:solidFill>
                           <a:latin typeface="Kanit"/>
                         </a:rPr>
-                        <a:t>80</a:t>
+                        <a:t>95</a:t>
                       </a:r>
                     </a:p>
                   </a:txBody>
@@ -8488,7 +8488,7 @@
                           </a:solidFill>
                           <a:latin typeface="Kanit"/>
                         </a:rPr>
-                        <a:t>18</a:t>
+                        <a:t>40</a:t>
                       </a:r>
                     </a:p>
                   </a:txBody>
@@ -8507,11 +8507,11 @@
                       <a:r>
                         <a:rPr sz="900" b="1">
                           <a:solidFill>
-                            <a:srgbClr val="606060"/>
-                          </a:solidFill>
-                          <a:latin typeface="Kanit"/>
-                        </a:rPr>
-                        <a:t>0.0%</a:t>
+                            <a:srgbClr val="F5C242"/>
+                          </a:solidFill>
+                          <a:latin typeface="Kanit"/>
+                        </a:rPr>
+                        <a:t>2.1%</a:t>
                       </a:r>
                     </a:p>
                   </a:txBody>
@@ -8534,7 +8534,7 @@
                           </a:solidFill>
                           <a:latin typeface="Kanit"/>
                         </a:rPr>
-                        <a:t>4/9</a:t>
+                        <a:t>3/19</a:t>
                       </a:r>
                     </a:p>
                   </a:txBody>
@@ -8553,11 +8553,11 @@
                       <a:r>
                         <a:rPr sz="900" b="1">
                           <a:solidFill>
-                            <a:srgbClr val="CC0000"/>
-                          </a:solidFill>
-                          <a:latin typeface="Kanit"/>
-                        </a:rPr>
-                        <a:t>5</a:t>
+                            <a:srgbClr val="F5C242"/>
+                          </a:solidFill>
+                          <a:latin typeface="Kanit"/>
+                        </a:rPr>
+                        <a:t>4</a:t>
                       </a:r>
                     </a:p>
                   </a:txBody>
@@ -8582,7 +8582,7 @@
                           </a:solidFill>
                           <a:latin typeface="Kanit"/>
                         </a:rPr>
-                        <a:t>กาญจนบุรี</a:t>
+                        <a:t>พะเยา</a:t>
                       </a:r>
                     </a:p>
                   </a:txBody>
@@ -8605,7 +8605,7 @@
                           </a:solidFill>
                           <a:latin typeface="Kanit"/>
                         </a:rPr>
-                        <a:t>93</a:t>
+                        <a:t>124</a:t>
                       </a:r>
                     </a:p>
                   </a:txBody>
@@ -8628,7 +8628,7 @@
                           </a:solidFill>
                           <a:latin typeface="Kanit"/>
                         </a:rPr>
-                        <a:t>45</a:t>
+                        <a:t>39</a:t>
                       </a:r>
                     </a:p>
                   </a:txBody>
@@ -8651,7 +8651,7 @@
                           </a:solidFill>
                           <a:latin typeface="Kanit"/>
                         </a:rPr>
-                        <a:t>6.5%</a:t>
+                        <a:t>1.6%</a:t>
                       </a:r>
                     </a:p>
                   </a:txBody>
@@ -8674,7 +8674,7 @@
                           </a:solidFill>
                           <a:latin typeface="Kanit"/>
                         </a:rPr>
-                        <a:t>4/26</a:t>
+                        <a:t>3/13</a:t>
                       </a:r>
                     </a:p>
                   </a:txBody>
@@ -8909,7 +8909,7 @@
                 </a:solidFill>
                 <a:latin typeface="Kanit"/>
               </a:rPr>
-              <a:t>พื้นที่ปลูก วัดจริง (สศก. — ข้อมูลอำเภอ×พืช 3,295 แถว) ภัยแล้งเป็นดัชนี SPEI จาก แบบจำลอง คำนวณจากปริมาณฝนและการคายระเหย ปรับเดือนละครั้ง ดึงข้อมูล 2026-07-20 — เป็นสัญญาณที่ครอบคลุมทั้งประเทศดีที่สุดที่มี แต่ไม่มีใครลงพื้นที่ไปเดินดูอำเภอเหล่านั้น ข้อมูลฝนและระดับน้ำ วัดจริง (ThaiWater เรียลไทม์ ดึงทุกวันและสะสมไว้ — วันที่ดึงไม่สำเร็จจะเว้นเป็นช่องว่าง ไม่ใส่ค่าสมมติ) · ฝนถึง 2026-08-22, ระดับน้ำถึง 2026-08-22 ความเสี่ยงน้ำท่วมเชิงโครงสร้าง วัดจริง (สำมะโนพื้นที่ท่วมซ้ำซาก GISTDA มาตราส่วน 1:50,000 ปี 2005-2016 — เป็นบันทึกภาคพื้นดิน 12 ปี ไม่ใช่การพยากรณ์)</a:t>
+              <a:t>พื้นที่ปลูก วัดจริง (สศก. — ข้อมูลอำเภอ×พืช 3,295 แถว) ภัยแล้งเป็นดัชนี SPEI จาก แบบจำลอง คำนวณจากปริมาณฝนและการคายระเหย ปรับเดือนละครั้ง ดึงข้อมูล 2026-07-20 — เป็นสัญญาณที่ครอบคลุมทั้งประเทศดีที่สุดที่มี แต่ไม่มีใครลงพื้นที่ไปเดินดูอำเภอเหล่านั้น ข้อมูลฝนและระดับน้ำ วัดจริง (ThaiWater เรียลไทม์ ดึงทุกวันและสะสมไว้ — วันที่ดึงไม่สำเร็จจะเว้นเป็นช่องว่าง ไม่ใส่ค่าสมมติ) · ฝนถึง 2026-08-25, ระดับน้ำถึง 2026-08-25 ความเสี่ยงน้ำท่วมเชิงโครงสร้าง วัดจริง (สำมะโนพื้นที่ท่วมซ้ำซาก GISTDA มาตราส่วน 1:50,000 ปี 2005-2016 — เป็นบันทึกภาคพื้นดิน 12 ปี ไม่ใช่การพยากรณ์)</a:t>
             </a:r>
           </a:p>
         </p:txBody>
@@ -31476,7 +31476,7 @@
                 </a:solidFill>
                 <a:latin typeface="Kanit"/>
               </a:rPr>
-              <a:t>รายได้จากพืชค่ากลางเพิ่มขึ้น +17.2% แต่มีสี่จังหวัดที่ลดลง — ทั้งหมดอยู่ในแหล่งปลูกมะพร้าว โดยหนักที่สุดคือสมุทรสงครามที่ −62.8%</a:t>
+              <a:t>รายได้จากพืชค่ากลางเพิ่มขึ้น +17.0% แต่มีสี่จังหวัดที่ลดลง — ทั้งหมดอยู่ในแหล่งปลูกมะพร้าว โดยหนักที่สุดคือสมุทรสงครามที่ −62.5%</a:t>
             </a:r>
           </a:p>
         </p:txBody>
@@ -32047,7 +32047,7 @@
                 </a:solidFill>
                 <a:latin typeface="Kanit"/>
               </a:rPr>
-              <a:t>รุ่นข้อมูล — ราคาโลก 2026M06 · ราคาหน้าฟาร์มไทย 2026-08-20 · ประวัติราคาไทย 2026-08-17 · ต้นทุนการผลิตพืช สศก. ไจอัป 2568 (ปีเพาะปลูก 2568/69, ประมาณการ สศก. มี.ค. 2569) · ภัยแล้ง 2026-06-21 · เงินเฟ้อ 2026-05 · GDP 2026 ไตรมาส 1 · IMF WEO 2026 · ดัชนีราคาขายต่อ 2026-05 · ยอดจดทะเบียนถึง 2026-01 · หนี้ครัวเรือน สสช. SES 2566 · ค่าจ้าง สสช. LFS 2568 · ข้อมูลตรวจวัด 2026-08-22</a:t>
+              <a:t>รุ่นข้อมูล — ราคาโลก 2026M06 · ราคาหน้าฟาร์มไทย 2026-08-24 · ประวัติราคาไทย 2026-08-23 · ต้นทุนการผลิตพืช สศก. ไจอัป 2568 (ปีเพาะปลูก 2568/69, ประมาณการ สศก. มี.ค. 2569) · ภัยแล้ง 2026-06-21 · เงินเฟ้อ 2026-05 · GDP 2026 ไตรมาส 1 · IMF WEO 2026 · ดัชนีราคาขายต่อ 2026-05 · ยอดจดทะเบียนถึง 2026-01 · หนี้ครัวเรือน สสช. SES 2566 · ค่าจ้าง สสช. LFS 2568 · ข้อมูลตรวจวัด 2026-08-25</a:t>
             </a:r>
           </a:p>
         </p:txBody>
@@ -32546,7 +32546,7 @@
               <a:t>Not on the world index — the farm gate (ราคาที่เกษตรกรขายได้) says otherwise.
 • Five of seventeen Thai farm-gate prices are falling year on year.
 • Beef: farm gate −6.1% vs world index +8.8%.
-• Margin over price: a 26% price move becomes an 86% swing in crop income.</a:t>
+• Margin over price: a 26% price move becomes an 84% swing in crop income.</a:t>
             </a:r>
           </a:p>
         </p:txBody>
@@ -33912,7 +33912,7 @@
                 </a:solidFill>
                 <a:latin typeface="Kanit"/>
               </a:rPr>
-              <a:t>33.02</a:t>
+              <a:t>32.69</a:t>
             </a:r>
           </a:p>
         </p:txBody>
@@ -33951,7 +33951,7 @@
                 </a:solidFill>
                 <a:latin typeface="Kanit"/>
               </a:rPr>
-              <a:t>อัตราอ้างอิง ECB · 2026-08-17</a:t>
+              <a:t>อัตราอ้างอิง ECB · 2026-08-24</a:t>
             </a:r>
           </a:p>
         </p:txBody>
@@ -35798,7 +35798,7 @@
                 </a:solidFill>
                 <a:latin typeface="Kanit"/>
               </a:rPr>
-              <a:t>สศช. 2026 ไตรมาส 1 · TPSO 2026-05 · ธนาคารแห่งประเทศไทย 2026-06 · BIS 2025 ไตรมาส 4 · ECB 2026-08-17, ทั้งหมดดึงจากหน่วยงานผู้เผยแพร่โดยตรง ตารางเทียบประเทศใช้ IMF World Economic Outlook 2026 (ดึงข้อมูล 2026-07-25) อัตรา NPL ที่ ธปท. เผยแพร่ — 4.48% ณ 2026 ไตรมาส 1, จาก 4.33% ไตรมาสก่อน เปลี่ยน +0.24 จุดใน 1 ปี และต่ำสุด 3.08% ณ 2021 ไตรมาส 1</a:t>
+              <a:t>สศช. 2026 ไตรมาส 1 · TPSO 2026-05 · ธนาคารแห่งประเทศไทย 2026-06 · BIS 2025 ไตรมาส 4 · ECB 2026-08-24, ทั้งหมดดึงจากหน่วยงานผู้เผยแพร่โดยตรง ตารางเทียบประเทศใช้ IMF World Economic Outlook 2026 (ดึงข้อมูล 2026-07-25) อัตรา NPL ที่ ธปท. เผยแพร่ — 4.48% ณ 2026 ไตรมาส 1, จาก 4.33% ไตรมาสก่อน เปลี่ยน +0.24 จุดใน 1 ปี และต่ำสุด 3.08% ณ 2021 ไตรมาส 1</a:t>
             </a:r>
           </a:p>
         </p:txBody>
@@ -37087,7 +37087,7 @@
                 </a:solidFill>
                 <a:latin typeface="Kanit"/>
               </a:rPr>
-              <a:t>338 จาก 928 อำเภอ · แม่น้ำเกินระดับ 141 จาก 796 สถานี</a:t>
+              <a:t>338 จาก 928 อำเภอ · แม่น้ำเกินระดับ 134 จาก 795 สถานี</a:t>
             </a:r>
           </a:p>
         </p:txBody>
@@ -37859,7 +37859,7 @@
                           </a:solidFill>
                           <a:latin typeface="Kanit"/>
                         </a:rPr>
-                        <a:t>33/155</a:t>
+                        <a:t>29/156</a:t>
                       </a:r>
                     </a:p>
                   </a:txBody>
@@ -38091,7 +38091,7 @@
                           </a:solidFill>
                           <a:latin typeface="Kanit"/>
                         </a:rPr>
-                        <a:t>36/275</a:t>
+                        <a:t>29/275</a:t>
                       </a:r>
                     </a:p>
                   </a:txBody>
@@ -38555,7 +38555,7 @@
                           </a:solidFill>
                           <a:latin typeface="Kanit"/>
                         </a:rPr>
-                        <a:t>7/52</a:t>
+                        <a:t>8/51</a:t>
                       </a:r>
                     </a:p>
                   </a:txBody>
@@ -38787,7 +38787,7 @@
                           </a:solidFill>
                           <a:latin typeface="Kanit"/>
                         </a:rPr>
-                        <a:t>39/146</a:t>
+                        <a:t>42/145</a:t>
                       </a:r>
                     </a:p>
                   </a:txBody>
@@ -39936,7 +39936,7 @@
                           </a:solidFill>
                           <a:latin typeface="Kanit"/>
                         </a:rPr>
-                        <a:t>−67.2%</a:t>
+                        <a:t>−66.9%</a:t>
                       </a:r>
                     </a:p>
                   </a:txBody>
@@ -39959,7 +39959,7 @@
                           </a:solidFill>
                           <a:latin typeface="Kanit"/>
                         </a:rPr>
-                        <a:t>−48.8%</a:t>
+                        <a:t>−50.1%</a:t>
                       </a:r>
                     </a:p>
                   </a:txBody>
@@ -40791,7 +40791,7 @@
                 </a:solidFill>
                 <a:latin typeface="Kanit"/>
               </a:rPr>
-              <a:t>ราคา วัดจริง — ราคาหน้าฟาร์มไทยจากราคารายวันของ NABC และราคาอ้อยประกาศของ สอน. ราคาล่าสุด 2026-08-20 การเปลี่ยนแปลงหกเดือนคำนวณจากข้อมูลรายเดือนของ NABC เอง (thai_price_history รุ่นข้อมูล 2026-08-17) พืชที่ไม่มีข้อมูลรายเดือนจะกำกับไว้ ไม่ประมาณการขึ้นมา แหล่งผลิตเป็นการอ่านแบบ ประมาณการ ว่าสินค้าแต่ละชนิดปลูกที่ไหน และแหล่งผลิตทับซ้อนกันได้ บัญชีอาชีพเกษตรเป็นข้อมูลของเราเองและ วัดจริง — บัญชีที่บันทึกอาชีพว่า เกษตร ในจังหวัดแหล่งผลิต จากฐานข้อมูล 382,735 บัญชี ณ 2026-07 ไม่เผยแพร่ช่องที่มีน้อยกว่า 30 บัญชี คนกลุ่มนี้อาศัยอยู่ในพื้นที่ที่ปลูกพืชนั้น แต่ไม่ได้ยืนยันว่าปลูกพืชนั้นเอง</a:t>
+              <a:t>ราคา วัดจริง — ราคาหน้าฟาร์มไทยจากราคารายวันของ NABC และราคาอ้อยประกาศของ สอน. ราคาล่าสุด 2026-08-24 การเปลี่ยนแปลงหกเดือนคำนวณจากข้อมูลรายเดือนของ NABC เอง (thai_price_history รุ่นข้อมูล 2026-08-23) พืชที่ไม่มีข้อมูลรายเดือนจะกำกับไว้ ไม่ประมาณการขึ้นมา แหล่งผลิตเป็นการอ่านแบบ ประมาณการ ว่าสินค้าแต่ละชนิดปลูกที่ไหน และแหล่งผลิตทับซ้อนกันได้ บัญชีอาชีพเกษตรเป็นข้อมูลของเราเองและ วัดจริง — บัญชีที่บันทึกอาชีพว่า เกษตร ในจังหวัดแหล่งผลิต จากฐานข้อมูล 382,735 บัญชี ณ 2026-07 ไม่เผยแพร่ช่องที่มีน้อยกว่า 30 บัญชี คนกลุ่มนี้อาศัยอยู่ในพื้นที่ที่ปลูกพืชนั้น แต่ไม่ได้ยืนยันว่าปลูกพืชนั้นเอง</a:t>
             </a:r>
           </a:p>
         </p:txBody>
@@ -43419,7 +43419,7 @@
                           </a:solidFill>
                           <a:latin typeface="Kanit"/>
                         </a:rPr>
-                        <a:t>91.81</a:t>
+                        <a:t>90.86</a:t>
                       </a:r>
                     </a:p>
                   </a:txBody>
@@ -43559,7 +43559,7 @@
                           </a:solidFill>
                           <a:latin typeface="Kanit"/>
                         </a:rPr>
-                        <a:t>15,423</a:t>
+                        <a:t>15,264</a:t>
                       </a:r>
                     </a:p>
                   </a:txBody>
@@ -43699,7 +43699,7 @@
                           </a:solidFill>
                           <a:latin typeface="Kanit"/>
                         </a:rPr>
-                        <a:t>36,361</a:t>
+                        <a:t>35,986</a:t>
                       </a:r>
                     </a:p>
                   </a:txBody>
@@ -43839,7 +43839,7 @@
                           </a:solidFill>
                           <a:latin typeface="Kanit"/>
                         </a:rPr>
-                        <a:t>11.23</a:t>
+                        <a:t>11.11</a:t>
                       </a:r>
                     </a:p>
                   </a:txBody>
@@ -44058,7 +44058,7 @@
                 </a:solidFill>
                 <a:latin typeface="Kanit"/>
               </a:rPr>
-              <a:t>ราคารายเดือนสกุลดอลลาร์ราคาปัจจุบันจาก World Bank Pink Sheet รุ่นข้อมูล 2026M07 (ข้อมูล 60 จุดต่อรายการ ปรับฐานเป็น 100 ณ 2021-07 เพื่อวาดกราฟ — หน่วยต่างกัน จึงใช้แกนเดียวกับระดับราคาดิบไม่ได้) แปลงเป็นบาทด้วยอัตราอ้างอิง ECB USD/THB 33.025 ณ 2026-08-17 สัดส่วนพื้นที่ปลูก วัดจริง จากสัดส่วนพืชของ สศก./กรมส่งเสริมการเกษตร (crop_mix.json) เป็นราคาปัจจุบัน ไม่ได้ปรับเงินเฟ้อ: ทุกตัวเลข ‘เทียบ 5 ปีก่อน’ มีเงินเฟ้อไทยห้าปีซ่อนอยู่ข้างใต้</a:t>
+              <a:t>ราคารายเดือนสกุลดอลลาร์ราคาปัจจุบันจาก World Bank Pink Sheet รุ่นข้อมูล 2026M07 (ข้อมูล 60 จุดต่อรายการ ปรับฐานเป็น 100 ณ 2021-07 เพื่อวาดกราฟ — หน่วยต่างกัน จึงใช้แกนเดียวกับระดับราคาดิบไม่ได้) แปลงเป็นบาทด้วยอัตราอ้างอิง ECB USD/THB 32.685 ณ 2026-08-24 สัดส่วนพื้นที่ปลูก วัดจริง จากสัดส่วนพืชของ สศก./กรมส่งเสริมการเกษตร (crop_mix.json) เป็นราคาปัจจุบัน ไม่ได้ปรับเงินเฟ้อ: ทุกตัวเลข ‘เทียบ 5 ปีก่อน’ มีเงินเฟ้อไทยห้าปีซ่อนอยู่ข้างใต้</a:t>
             </a:r>
           </a:p>
         </p:txBody>
@@ -44679,7 +44679,7 @@
                 </a:solidFill>
                 <a:latin typeface="Kanit"/>
               </a:rPr>
-              <a:t>มะพร้าว −67.2% สับปะรด −18.4% อ้อย −17.9% เทียบปีก่อน</a:t>
+              <a:t>มะพร้าว −66.9% สับปะรด −18.4% อ้อย −17.9% เทียบปีก่อน</a:t>
             </a:r>
           </a:p>
         </p:txBody>
@@ -44805,7 +44805,7 @@
                 </a:solidFill>
                 <a:latin typeface="Kanit"/>
               </a:rPr>
-              <a:t>+17.2%</a:t>
+              <a:t>+17.0%</a:t>
             </a:r>
           </a:p>
         </p:txBody>
@@ -45279,7 +45279,7 @@
                           </a:solidFill>
                           <a:latin typeface="Kanit"/>
                         </a:rPr>
-                        <a:t>+6.8%</a:t>
+                        <a:t>+7.0%</a:t>
                       </a:r>
                     </a:p>
                   </a:txBody>
@@ -45348,7 +45348,7 @@
                           </a:solidFill>
                           <a:latin typeface="Kanit"/>
                         </a:rPr>
-                        <a:t>-62.8%</a:t>
+                        <a:t>-62.5%</a:t>
                       </a:r>
                     </a:p>
                   </a:txBody>
@@ -45419,7 +45419,7 @@
                           </a:solidFill>
                           <a:latin typeface="Kanit"/>
                         </a:rPr>
-                        <a:t>+15.9%</a:t>
+                        <a:t>+16.0%</a:t>
                       </a:r>
                     </a:p>
                   </a:txBody>
@@ -45488,7 +45488,7 @@
                           </a:solidFill>
                           <a:latin typeface="Kanit"/>
                         </a:rPr>
-                        <a:t>+10.2%</a:t>
+                        <a:t>+10.3%</a:t>
                       </a:r>
                     </a:p>
                   </a:txBody>
@@ -45559,7 +45559,7 @@
                           </a:solidFill>
                           <a:latin typeface="Kanit"/>
                         </a:rPr>
-                        <a:t>+17.2%</a:t>
+                        <a:t>+17.5%</a:t>
                       </a:r>
                     </a:p>
                   </a:txBody>
@@ -45628,7 +45628,7 @@
                           </a:solidFill>
                           <a:latin typeface="Kanit"/>
                         </a:rPr>
-                        <a:t>+8.8%</a:t>
+                        <a:t>+8.9%</a:t>
                       </a:r>
                     </a:p>
                   </a:txBody>
@@ -45699,7 +45699,7 @@
                           </a:solidFill>
                           <a:latin typeface="Kanit"/>
                         </a:rPr>
-                        <a:t>+25.7%</a:t>
+                        <a:t>+25.2%</a:t>
                       </a:r>
                     </a:p>
                   </a:txBody>
@@ -45768,7 +45768,7 @@
                           </a:solidFill>
                           <a:latin typeface="Kanit"/>
                         </a:rPr>
-                        <a:t>+11.3%</a:t>
+                        <a:t>+11.6%</a:t>
                       </a:r>
                     </a:p>
                   </a:txBody>
@@ -45839,7 +45839,7 @@
                           </a:solidFill>
                           <a:latin typeface="Kanit"/>
                         </a:rPr>
-                        <a:t>+35.8%</a:t>
+                        <a:t>+34.8%</a:t>
                       </a:r>
                     </a:p>
                   </a:txBody>
@@ -45908,7 +45908,7 @@
                           </a:solidFill>
                           <a:latin typeface="Kanit"/>
                         </a:rPr>
-                        <a:t>+27.9%</a:t>
+                        <a:t>+27.1%</a:t>
                       </a:r>
                     </a:p>
                   </a:txBody>
@@ -46084,7 +46084,7 @@
                 </a:solidFill>
                 <a:latin typeface="Kanit"/>
               </a:rPr>
-              <a:t>•  ราคาหน้าฟาร์ม: ยางพารา +41% มันสำปะหลัง +69% ปาล์ม +24% ข้าว +14% รายได้จากพืชเพิ่มขึ้นทุกภาค
+              <a:t>•  ราคาหน้าฟาร์ม: ยางพารา +40% มันสำปะหลัง +72% ปาล์ม +23% ข้าว +14% รายได้จากพืชเพิ่มขึ้นทุกภาค
 •  มีสี่จังหวัดที่ลดลง — ทั้งหมดเป็นมะพร้าว และอยู่ฝั่งอ่าวไทยตะวันตก ราคามะพร้าวลดลง 67%
 •  กำไรบนกระดาษยังไม่ใช่เงินสด — ตารางถัดไปหักราคาด้วยต้นทุน</a:t>
             </a:r>
@@ -46387,7 +46387,7 @@
                           </a:solidFill>
                           <a:latin typeface="Kanit"/>
                         </a:rPr>
-                        <a:t>+17.6%</a:t>
+                        <a:t>+18.0%</a:t>
                       </a:r>
                     </a:p>
                   </a:txBody>
@@ -46550,7 +46550,7 @@
                           </a:solidFill>
                           <a:latin typeface="Kanit"/>
                         </a:rPr>
-                        <a:t>+21.7%</a:t>
+                        <a:t>+21.9%</a:t>
                       </a:r>
                     </a:p>
                   </a:txBody>
@@ -46713,7 +46713,7 @@
                           </a:solidFill>
                           <a:latin typeface="Kanit"/>
                         </a:rPr>
-                        <a:t>+11.6%</a:t>
+                        <a:t>+11.9%</a:t>
                       </a:r>
                     </a:p>
                   </a:txBody>
@@ -46876,7 +46876,7 @@
                           </a:solidFill>
                           <a:latin typeface="Kanit"/>
                         </a:rPr>
-                        <a:t>+33.6%</a:t>
+                        <a:t>+32.7%</a:t>
                       </a:r>
                     </a:p>
                   </a:txBody>
@@ -47039,7 +47039,7 @@
                           </a:solidFill>
                           <a:latin typeface="Kanit"/>
                         </a:rPr>
-                        <a:t>+17.2%</a:t>
+                        <a:t>+17.4%</a:t>
                       </a:r>
                     </a:p>
                   </a:txBody>
@@ -47202,7 +47202,7 @@
                           </a:solidFill>
                           <a:latin typeface="Kanit"/>
                         </a:rPr>
-                        <a:t>+15.8%</a:t>
+                        <a:t>+16.0%</a:t>
                       </a:r>
                     </a:p>
                   </a:txBody>
@@ -47985,7 +47985,7 @@
                 </a:solidFill>
                 <a:latin typeface="Kanit"/>
               </a:rPr>
-              <a:t>฿620.00 /ร้อยผล · ใต้·ตอ.</a:t>
+              <a:t>฿606.15 /ร้อยผล · ใต้·ตอ.</a:t>
             </a:r>
           </a:p>
         </p:txBody>
@@ -48024,7 +48024,7 @@
                 </a:solidFill>
                 <a:latin typeface="Kanit"/>
               </a:rPr>
-              <a:t>เทียบปีก่อน −67.2%</a:t>
+              <a:t>เทียบปีก่อน −66.9%</a:t>
             </a:r>
           </a:p>
         </p:txBody>
@@ -48063,7 +48063,7 @@
                 </a:solidFill>
                 <a:latin typeface="Kanit"/>
               </a:rPr>
-              <a:t>6 เดือน −48.8%</a:t>
+              <a:t>6 เดือน −50.1%</a:t>
             </a:r>
           </a:p>
         </p:txBody>
@@ -48137,19 +48137,19 @@
                   <a:pt x="0" y="0"/>
                 </a:moveTo>
                 <a:lnTo>
-                  <a:pt x="412943" y="170015"/>
-                </a:lnTo>
-                <a:lnTo>
-                  <a:pt x="825886" y="147424"/>
-                </a:lnTo>
-                <a:lnTo>
-                  <a:pt x="1238829" y="401963"/>
+                  <a:pt x="412943" y="167653"/>
+                </a:lnTo>
+                <a:lnTo>
+                  <a:pt x="825886" y="145107"/>
+                </a:lnTo>
+                <a:lnTo>
+                  <a:pt x="1238829" y="402654"/>
                 </a:lnTo>
                 <a:lnTo>
                   <a:pt x="1651772" y="457200"/>
                 </a:lnTo>
                 <a:lnTo>
-                  <a:pt x="2064715" y="387883"/>
+                  <a:pt x="2064715" y="401204"/>
                 </a:lnTo>
               </a:path>
             </a:pathLst>
@@ -48192,7 +48192,7 @@
         </p:nvSpPr>
         <p:spPr>
           <a:xfrm>
-            <a:off x="2480767" y="2792755"/>
+            <a:off x="2480767" y="2806076"/>
             <a:ext cx="82296" cy="82296"/>
           </a:xfrm>
           <a:prstGeom prst="roundRect">
@@ -48621,7 +48621,7 @@
                 </a:solidFill>
                 <a:latin typeface="Kanit"/>
               </a:rPr>
-              <a:t>฿143.33 /กก. · ชายฝั่งใต้·ตอ.</a:t>
+              <a:t>฿143.00 /กก. · ชายฝั่งใต้·ตอ.</a:t>
             </a:r>
           </a:p>
         </p:txBody>
@@ -48660,7 +48660,7 @@
                 </a:solidFill>
                 <a:latin typeface="Kanit"/>
               </a:rPr>
-              <a:t>เทียบปีก่อน +1.6%</a:t>
+              <a:t>เทียบปีก่อน +1.4%</a:t>
             </a:r>
           </a:p>
         </p:txBody>
@@ -48699,7 +48699,7 @@
                 </a:solidFill>
                 <a:latin typeface="Kanit"/>
               </a:rPr>
-              <a:t>6 เดือน −1.9%</a:t>
+              <a:t>6 เดือน −2.1%</a:t>
             </a:r>
           </a:p>
         </p:txBody>
@@ -48770,19 +48770,19 @@
             <a:pathLst>
               <a:path w="2064715" h="457200">
                 <a:moveTo>
-                  <a:pt x="0" y="222838"/>
+                  <a:pt x="0" y="217911"/>
                 </a:moveTo>
                 <a:lnTo>
-                  <a:pt x="412943" y="418928"/>
+                  <a:pt x="412943" y="415692"/>
                 </a:lnTo>
                 <a:lnTo>
                   <a:pt x="825886" y="457200"/>
                 </a:lnTo>
                 <a:lnTo>
-                  <a:pt x="1238829" y="423249"/>
-                </a:lnTo>
-                <a:lnTo>
-                  <a:pt x="1651772" y="173867"/>
+                  <a:pt x="1238829" y="420051"/>
+                </a:lnTo>
+                <a:lnTo>
+                  <a:pt x="1651772" y="168518"/>
                 </a:lnTo>
                 <a:lnTo>
                   <a:pt x="2064715" y="0"/>
@@ -48939,7 +48939,7 @@
                 </a:solidFill>
                 <a:latin typeface="Kanit"/>
               </a:rPr>
-              <a:t>฿343.75 /ร้อยฟอง · กลาง·ตอ.</a:t>
+              <a:t>฿346.15 /ร้อยฟอง · กลาง·ตอ.</a:t>
             </a:r>
           </a:p>
         </p:txBody>
@@ -48978,7 +48978,7 @@
                 </a:solidFill>
                 <a:latin typeface="Kanit"/>
               </a:rPr>
-              <a:t>เทียบปีก่อน +2.0%</a:t>
+              <a:t>เทียบปีก่อน +3.2%</a:t>
             </a:r>
           </a:p>
         </p:txBody>
@@ -49017,7 +49017,7 @@
                 </a:solidFill>
                 <a:latin typeface="Kanit"/>
               </a:rPr>
-              <a:t>6 เดือน +13.6%</a:t>
+              <a:t>6 เดือน +14.4%</a:t>
             </a:r>
           </a:p>
         </p:txBody>
@@ -49091,16 +49091,16 @@
                   <a:pt x="0" y="457200"/>
                 </a:moveTo>
                 <a:lnTo>
-                  <a:pt x="412943" y="173996"/>
-                </a:lnTo>
-                <a:lnTo>
-                  <a:pt x="825886" y="173996"/>
-                </a:lnTo>
-                <a:lnTo>
-                  <a:pt x="1238829" y="281558"/>
-                </a:lnTo>
-                <a:lnTo>
-                  <a:pt x="1651772" y="66435"/>
+                  <a:pt x="412943" y="191637"/>
+                </a:lnTo>
+                <a:lnTo>
+                  <a:pt x="825886" y="191637"/>
+                </a:lnTo>
+                <a:lnTo>
+                  <a:pt x="1238829" y="292498"/>
+                </a:lnTo>
+                <a:lnTo>
+                  <a:pt x="1651772" y="90775"/>
                 </a:lnTo>
                 <a:lnTo>
                   <a:pt x="2064715" y="0"/>
@@ -49409,19 +49409,19 @@
                   <a:pt x="0" y="0"/>
                 </a:moveTo>
                 <a:lnTo>
-                  <a:pt x="412943" y="114807"/>
-                </a:lnTo>
-                <a:lnTo>
-                  <a:pt x="825886" y="305815"/>
+                  <a:pt x="412943" y="111737"/>
+                </a:lnTo>
+                <a:lnTo>
+                  <a:pt x="825886" y="304458"/>
                 </a:lnTo>
                 <a:lnTo>
                   <a:pt x="1238829" y="457200"/>
                 </a:lnTo>
                 <a:lnTo>
-                  <a:pt x="1651772" y="244855"/>
-                </a:lnTo>
-                <a:lnTo>
-                  <a:pt x="2064715" y="91439"/>
+                  <a:pt x="1651772" y="242951"/>
+                </a:lnTo>
+                <a:lnTo>
+                  <a:pt x="2064715" y="88159"/>
                 </a:lnTo>
               </a:path>
             </a:pathLst>
@@ -49464,7 +49464,7 @@
         </p:nvSpPr>
         <p:spPr>
           <a:xfrm>
-            <a:off x="11690603" y="2496311"/>
+            <a:off x="11690603" y="2493031"/>
             <a:ext cx="82296" cy="82296"/>
           </a:xfrm>
           <a:prstGeom prst="roundRect">
@@ -49575,7 +49575,7 @@
                 </a:solidFill>
                 <a:latin typeface="Kanit"/>
               </a:rPr>
-              <a:t>฿70.12 /กก. · กลาง·ตต.·ตอ.</a:t>
+              <a:t>฿70.33 /กก. · กลาง·ตต.·ตอ.</a:t>
             </a:r>
           </a:p>
         </p:txBody>
@@ -49614,7 +49614,7 @@
                 </a:solidFill>
                 <a:latin typeface="Kanit"/>
               </a:rPr>
-              <a:t>เทียบปีก่อน +5.4%</a:t>
+              <a:t>เทียบปีก่อน +8.8%</a:t>
             </a:r>
           </a:p>
         </p:txBody>
@@ -49653,7 +49653,7 @@
                 </a:solidFill>
                 <a:latin typeface="Kanit"/>
               </a:rPr>
-              <a:t>6 เดือน +26.3%</a:t>
+              <a:t>6 เดือน +26.7%</a:t>
             </a:r>
           </a:p>
         </p:txBody>
@@ -49724,19 +49724,19 @@
             <a:pathLst>
               <a:path w="2064715" h="457200">
                 <a:moveTo>
-                  <a:pt x="0" y="358828"/>
+                  <a:pt x="0" y="361078"/>
                 </a:moveTo>
                 <a:lnTo>
-                  <a:pt x="412943" y="100410"/>
+                  <a:pt x="412943" y="110564"/>
                 </a:lnTo>
                 <a:lnTo>
                   <a:pt x="825886" y="457200"/>
                 </a:lnTo>
                 <a:lnTo>
-                  <a:pt x="1238829" y="286450"/>
-                </a:lnTo>
-                <a:lnTo>
-                  <a:pt x="1651772" y="170749"/>
+                  <a:pt x="1238829" y="293843"/>
+                </a:lnTo>
+                <a:lnTo>
+                  <a:pt x="1651772" y="177301"/>
                 </a:lnTo>
                 <a:lnTo>
                   <a:pt x="2064715" y="0"/>
@@ -49893,7 +49893,7 @@
                 </a:solidFill>
                 <a:latin typeface="Kanit"/>
               </a:rPr>
-              <a:t>฿17,768 /ตัน · อีสาน·เหนือ·กลาง</a:t>
+              <a:t>฿17,815 /ตัน · อีสาน·เหนือ·กลาง</a:t>
             </a:r>
           </a:p>
         </p:txBody>
@@ -49932,7 +49932,7 @@
                 </a:solidFill>
                 <a:latin typeface="Kanit"/>
               </a:rPr>
-              <a:t>เทียบปีก่อน +14.2%</a:t>
+              <a:t>เทียบปีก่อน +14.4%</a:t>
             </a:r>
           </a:p>
         </p:txBody>
@@ -49971,7 +49971,7 @@
                 </a:solidFill>
                 <a:latin typeface="Kanit"/>
               </a:rPr>
-              <a:t>6 เดือน +8.0%</a:t>
+              <a:t>6 เดือน +8.2%</a:t>
             </a:r>
           </a:p>
         </p:txBody>
@@ -50045,16 +50045,16 @@
                   <a:pt x="0" y="457200"/>
                 </a:moveTo>
                 <a:lnTo>
-                  <a:pt x="412943" y="341616"/>
-                </a:lnTo>
-                <a:lnTo>
-                  <a:pt x="825886" y="154005"/>
-                </a:lnTo>
-                <a:lnTo>
-                  <a:pt x="1238829" y="47789"/>
-                </a:lnTo>
-                <a:lnTo>
-                  <a:pt x="1651772" y="27620"/>
+                  <a:pt x="412943" y="349810"/>
+                </a:lnTo>
+                <a:lnTo>
+                  <a:pt x="825886" y="168554"/>
+                </a:lnTo>
+                <a:lnTo>
+                  <a:pt x="1238829" y="54643"/>
+                </a:lnTo>
+                <a:lnTo>
+                  <a:pt x="1651772" y="63603"/>
                 </a:lnTo>
                 <a:lnTo>
                   <a:pt x="2064715" y="0"/>
@@ -50211,7 +50211,7 @@
                 </a:solidFill>
                 <a:latin typeface="Kanit"/>
               </a:rPr>
-              <a:t>฿10.04 /กก. · เหนือ</a:t>
+              <a:t>฿9.87 /กก. · เหนือ</a:t>
             </a:r>
           </a:p>
         </p:txBody>
@@ -50250,7 +50250,7 @@
                 </a:solidFill>
                 <a:latin typeface="Kanit"/>
               </a:rPr>
-              <a:t>เทียบปีก่อน +16.5%</a:t>
+              <a:t>เทียบปีก่อน +15.9%</a:t>
             </a:r>
           </a:p>
         </p:txBody>
@@ -50289,7 +50289,7 @@
                 </a:solidFill>
                 <a:latin typeface="Kanit"/>
               </a:rPr>
-              <a:t>6 เดือน +12.7%</a:t>
+              <a:t>6 เดือน +10.9%</a:t>
             </a:r>
           </a:p>
         </p:txBody>
@@ -50363,19 +50363,19 @@
                   <a:pt x="0" y="457200"/>
                 </a:moveTo>
                 <a:lnTo>
-                  <a:pt x="412943" y="357808"/>
-                </a:lnTo>
-                <a:lnTo>
-                  <a:pt x="825886" y="86967"/>
+                  <a:pt x="412943" y="355874"/>
+                </a:lnTo>
+                <a:lnTo>
+                  <a:pt x="825886" y="86497"/>
                 </a:lnTo>
                 <a:lnTo>
                   <a:pt x="1238829" y="0"/>
                 </a:lnTo>
                 <a:lnTo>
-                  <a:pt x="1651772" y="49695"/>
-                </a:lnTo>
-                <a:lnTo>
-                  <a:pt x="2064715" y="226115"/>
+                  <a:pt x="1651772" y="46955"/>
+                </a:lnTo>
+                <a:lnTo>
+                  <a:pt x="2064715" y="269377"/>
                 </a:lnTo>
               </a:path>
             </a:pathLst>
@@ -50418,7 +50418,7 @@
         </p:nvSpPr>
         <p:spPr>
           <a:xfrm>
-            <a:off x="7085685" y="3737411"/>
+            <a:off x="7085685" y="3780673"/>
             <a:ext cx="82296" cy="82296"/>
           </a:xfrm>
           <a:prstGeom prst="roundRect">
@@ -50529,7 +50529,7 @@
                 </a:solidFill>
                 <a:latin typeface="Kanit"/>
               </a:rPr>
-              <a:t>฿8.65 /กก. · ใต้</a:t>
+              <a:t>฿8.55 /กก. · ใต้</a:t>
             </a:r>
           </a:p>
         </p:txBody>
@@ -50568,7 +50568,7 @@
                 </a:solidFill>
                 <a:latin typeface="Kanit"/>
               </a:rPr>
-              <a:t>เทียบปีก่อน +23.9%</a:t>
+              <a:t>เทียบปีก่อน +23.3%</a:t>
             </a:r>
           </a:p>
         </p:txBody>
@@ -50607,7 +50607,7 @@
                 </a:solidFill>
                 <a:latin typeface="Kanit"/>
               </a:rPr>
-              <a:t>6 เดือน +26.6%</a:t>
+              <a:t>6 เดือน +25.0%</a:t>
             </a:r>
           </a:p>
         </p:txBody>
@@ -50678,19 +50678,19 @@
             <a:pathLst>
               <a:path w="2064715" h="457200">
                 <a:moveTo>
-                  <a:pt x="0" y="457200"/>
+                  <a:pt x="0" y="453788"/>
                 </a:moveTo>
                 <a:lnTo>
-                  <a:pt x="412943" y="444499"/>
+                  <a:pt x="412943" y="446964"/>
                 </a:lnTo>
                 <a:lnTo>
                   <a:pt x="825886" y="457200"/>
                 </a:lnTo>
                 <a:lnTo>
-                  <a:pt x="1238829" y="311149"/>
-                </a:lnTo>
-                <a:lnTo>
-                  <a:pt x="1651772" y="114300"/>
+                  <a:pt x="1238829" y="300250"/>
+                </a:lnTo>
+                <a:lnTo>
+                  <a:pt x="1651772" y="85298"/>
                 </a:lnTo>
                 <a:lnTo>
                   <a:pt x="2064715" y="0"/>
@@ -50847,7 +50847,7 @@
                 </a:solidFill>
                 <a:latin typeface="Kanit"/>
               </a:rPr>
-              <a:t>฿81.86 /กก. · ใต้·ตอ.</a:t>
+              <a:t>฿81.51 /กก. · ใต้·ตอ.</a:t>
             </a:r>
           </a:p>
         </p:txBody>
@@ -50886,7 +50886,7 @@
                 </a:solidFill>
                 <a:latin typeface="Kanit"/>
               </a:rPr>
-              <a:t>เทียบปีก่อน +41.4%</a:t>
+              <a:t>เทียบปีก่อน +40.2%</a:t>
             </a:r>
           </a:p>
         </p:txBody>
@@ -50925,7 +50925,7 @@
                 </a:solidFill>
                 <a:latin typeface="Kanit"/>
               </a:rPr>
-              <a:t>6 เดือน +35.6%</a:t>
+              <a:t>6 เดือน +35.1%</a:t>
             </a:r>
           </a:p>
         </p:txBody>
@@ -50999,19 +50999,19 @@
                   <a:pt x="0" y="457200"/>
                 </a:moveTo>
                 <a:lnTo>
-                  <a:pt x="412943" y="286327"/>
-                </a:lnTo>
-                <a:lnTo>
-                  <a:pt x="825886" y="157274"/>
+                  <a:pt x="412943" y="287287"/>
+                </a:lnTo>
+                <a:lnTo>
+                  <a:pt x="825886" y="158892"/>
                 </a:lnTo>
                 <a:lnTo>
                   <a:pt x="1238829" y="0"/>
                 </a:lnTo>
                 <a:lnTo>
-                  <a:pt x="1651772" y="37202"/>
-                </a:lnTo>
-                <a:lnTo>
-                  <a:pt x="2064715" y="104678"/>
+                  <a:pt x="1651772" y="38185"/>
+                </a:lnTo>
+                <a:lnTo>
+                  <a:pt x="2064715" y="115325"/>
                 </a:lnTo>
               </a:path>
             </a:pathLst>
@@ -51054,7 +51054,7 @@
         </p:nvSpPr>
         <p:spPr>
           <a:xfrm>
-            <a:off x="11690603" y="3615974"/>
+            <a:off x="11690603" y="3626621"/>
             <a:ext cx="82296" cy="82296"/>
           </a:xfrm>
           <a:prstGeom prst="roundRect">
@@ -51204,7 +51204,7 @@
                 </a:solidFill>
                 <a:latin typeface="Kanit"/>
               </a:rPr>
-              <a:t>เทียบปีก่อน +69.4%</a:t>
+              <a:t>เทียบปีก่อน +72.1%</a:t>
             </a:r>
           </a:p>
         </p:txBody>
@@ -51243,7 +51243,7 @@
                 </a:solidFill>
                 <a:latin typeface="Kanit"/>
               </a:rPr>
-              <a:t>6 เดือน +49.4%</a:t>
+              <a:t>6 เดือน +48.8%</a:t>
             </a:r>
           </a:p>
         </p:txBody>
@@ -51326,7 +51326,7 @@
                   <a:pt x="1238829" y="163586"/>
                 </a:lnTo>
                 <a:lnTo>
-                  <a:pt x="1651772" y="130030"/>
+                  <a:pt x="1651772" y="125835"/>
                 </a:lnTo>
                 <a:lnTo>
                   <a:pt x="2064715" y="0"/>
@@ -51483,7 +51483,7 @@
                 </a:solidFill>
                 <a:latin typeface="Kanit"/>
               </a:rPr>
-              <a:t>฿120.00 /ร้อยผล · กลาง·ตต.</a:t>
+              <a:t>฿129.23 /ร้อยผล · กลาง·ตต.</a:t>
             </a:r>
           </a:p>
         </p:txBody>
@@ -51522,7 +51522,7 @@
                 </a:solidFill>
                 <a:latin typeface="Kanit"/>
               </a:rPr>
-              <a:t>เทียบปีก่อน +96.8%</a:t>
+              <a:t>เทียบปีก่อน +102.6%</a:t>
             </a:r>
           </a:p>
         </p:txBody>
@@ -51561,7 +51561,7 @@
                 </a:solidFill>
                 <a:latin typeface="Kanit"/>
               </a:rPr>
-              <a:t>6 เดือน −42.9%</a:t>
+              <a:t>6 เดือน −38.5%</a:t>
             </a:r>
           </a:p>
         </p:txBody>
@@ -51647,7 +51647,7 @@
                   <a:pt x="1651772" y="457200"/>
                 </a:lnTo>
                 <a:lnTo>
-                  <a:pt x="2064715" y="434102"/>
+                  <a:pt x="2064715" y="428011"/>
                 </a:lnTo>
               </a:path>
             </a:pathLst>
@@ -51690,7 +51690,7 @@
         </p:nvSpPr>
         <p:spPr>
           <a:xfrm>
-            <a:off x="4783226" y="5051821"/>
+            <a:off x="4783226" y="5045730"/>
             <a:ext cx="82296" cy="82296"/>
           </a:xfrm>
           <a:prstGeom prst="roundRect">
@@ -51886,7 +51886,7 @@
                 </a:solidFill>
                 <a:latin typeface="Kanit"/>
               </a:rPr>
-              <a:t>ราคาหน้าฟาร์ม วัดจริง — ราคารายวันของ NABC เฉลี่ยเป็นรายเดือน หน่วยเป็นบาทตามที่เผยแพร่ (ไม่มีการแปลงสกุลเงิน) ราคาล่าสุด 2026-08-20, รุ่นข้อมูลย้อนหลัง 2026-08-17 ราคาหน้าฟาร์ม (ราคาที่เกษตรกรขายได้) คือเงินที่เกษตรกรได้รับเมื่อขายครั้งแรก ก่อนพ่อค้าคนกลาง โรงสี หรือค่าขนส่งจะหักส่วนแบ่ง — ไม่ใช่ดัชนีโลก และไม่ใช่ราคาในซูเปอร์มาร์เก็ต แหล่งผลิตเป็นการอ่านแบบ ประมาณการ ว่าสินค้าแต่ละชนิดผลิตที่ไหน และทับซ้อนกันได้ น้ำตาลเป็นราคาอ้อยประกาศของ สอน. ปีละหนึ่งจุด จึงไม่มีการเปลี่ยนแปลงหกเดือนให้แสดง</a:t>
+              <a:t>ราคาหน้าฟาร์ม วัดจริง — ราคารายวันของ NABC เฉลี่ยเป็นรายเดือน หน่วยเป็นบาทตามที่เผยแพร่ (ไม่มีการแปลงสกุลเงิน) ราคาล่าสุด 2026-08-24, รุ่นข้อมูลย้อนหลัง 2026-08-23 ราคาหน้าฟาร์ม (ราคาที่เกษตรกรขายได้) คือเงินที่เกษตรกรได้รับเมื่อขายครั้งแรก ก่อนพ่อค้าคนกลาง โรงสี หรือค่าขนส่งจะหักส่วนแบ่ง — ไม่ใช่ดัชนีโลก และไม่ใช่ราคาในซูเปอร์มาร์เก็ต แหล่งผลิตเป็นการอ่านแบบ ประมาณการ ว่าสินค้าแต่ละชนิดผลิตที่ไหน และทับซ้อนกันได้ น้ำตาลเป็นราคาอ้อยประกาศของ สอน. ปีละหนึ่งจุด จึงไม่มีการเปลี่ยนแปลงหกเดือนให้แสดง</a:t>
             </a:r>
           </a:p>
         </p:txBody>

</xml_diff>

<commit_message>
deck(mcom): rebuild — the data moved past the committed figures (run 32836868860) (#621)
Co-authored-by: github-actions[bot] <41898282+github-actions[bot]@users.noreply.github.com>
</commit_message>
<xml_diff>
--- a/docs/decks/mcom-2026-08-05-macro-TH.pptx
+++ b/docs/decks/mcom-2026-08-05-macro-TH.pptx
@@ -6240,7 +6240,7 @@
                 </a:solidFill>
                 <a:latin typeface="Kanit"/>
               </a:rPr>
-              <a:t>141</a:t>
+              <a:t>134</a:t>
             </a:r>
           </a:p>
         </p:txBody>
@@ -6279,7 +6279,7 @@
                 </a:solidFill>
                 <a:latin typeface="Kanit"/>
               </a:rPr>
-              <a:t>จาก 796 (17.7%) · เรียลไทม์ · 2026-08-22</a:t>
+              <a:t>จาก 795 (16.9%) · เรียลไทม์ · 2026-08-25</a:t>
             </a:r>
           </a:p>
         </p:txBody>
@@ -6405,7 +6405,7 @@
                 </a:solidFill>
                 <a:latin typeface="Kanit"/>
               </a:rPr>
-              <a:t>17</a:t>
+              <a:t>15</a:t>
             </a:r>
           </a:p>
         </p:txBody>
@@ -6444,7 +6444,7 @@
                 </a:solidFill>
                 <a:latin typeface="Kanit"/>
               </a:rPr>
-              <a:t>ค่าล่าสุดรายวัน · 2026-08-22</a:t>
+              <a:t>ค่าล่าสุดรายวัน · 2026-08-25</a:t>
             </a:r>
           </a:p>
         </p:txBody>
@@ -7882,7 +7882,7 @@
                           </a:solidFill>
                           <a:latin typeface="Kanit"/>
                         </a:rPr>
-                        <a:t>น่าน</a:t>
+                        <a:t>มุกดาหาร</a:t>
                       </a:r>
                     </a:p>
                   </a:txBody>
@@ -7905,7 +7905,7 @@
                           </a:solidFill>
                           <a:latin typeface="Kanit"/>
                         </a:rPr>
-                        <a:t>215</a:t>
+                        <a:t>18</a:t>
                       </a:r>
                     </a:p>
                   </a:txBody>
@@ -7928,7 +7928,7 @@
                           </a:solidFill>
                           <a:latin typeface="Kanit"/>
                         </a:rPr>
-                        <a:t>68</a:t>
+                        <a:t>37</a:t>
                       </a:r>
                     </a:p>
                   </a:txBody>
@@ -7951,7 +7951,7 @@
                           </a:solidFill>
                           <a:latin typeface="Kanit"/>
                         </a:rPr>
-                        <a:t>1.9%</a:t>
+                        <a:t>5.6%</a:t>
                       </a:r>
                     </a:p>
                   </a:txBody>
@@ -7974,7 +7974,7 @@
                           </a:solidFill>
                           <a:latin typeface="Kanit"/>
                         </a:rPr>
-                        <a:t>4/28</a:t>
+                        <a:t>2/2</a:t>
                       </a:r>
                     </a:p>
                   </a:txBody>
@@ -8022,7 +8022,7 @@
                           </a:solidFill>
                           <a:latin typeface="Kanit"/>
                         </a:rPr>
-                        <a:t>นครพนม</a:t>
+                        <a:t>สกลนคร</a:t>
                       </a:r>
                     </a:p>
                   </a:txBody>
@@ -8045,7 +8045,7 @@
                           </a:solidFill>
                           <a:latin typeface="Kanit"/>
                         </a:rPr>
-                        <a:t>28</a:t>
+                        <a:t>38</a:t>
                       </a:r>
                     </a:p>
                   </a:txBody>
@@ -8114,7 +8114,7 @@
                           </a:solidFill>
                           <a:latin typeface="Kanit"/>
                         </a:rPr>
-                        <a:t>8/14</a:t>
+                        <a:t>7/13</a:t>
                       </a:r>
                     </a:p>
                   </a:txBody>
@@ -8162,7 +8162,7 @@
                           </a:solidFill>
                           <a:latin typeface="Kanit"/>
                         </a:rPr>
-                        <a:t>มุกดาหาร</a:t>
+                        <a:t>สมุทรปราการ</a:t>
                       </a:r>
                     </a:p>
                   </a:txBody>
@@ -8185,7 +8185,7 @@
                           </a:solidFill>
                           <a:latin typeface="Kanit"/>
                         </a:rPr>
-                        <a:t>17</a:t>
+                        <a:t>16</a:t>
                       </a:r>
                     </a:p>
                   </a:txBody>
@@ -8208,7 +8208,7 @@
                           </a:solidFill>
                           <a:latin typeface="Kanit"/>
                         </a:rPr>
-                        <a:t>12</a:t>
+                        <a:t>1</a:t>
                       </a:r>
                     </a:p>
                   </a:txBody>
@@ -8254,7 +8254,7 @@
                           </a:solidFill>
                           <a:latin typeface="Kanit"/>
                         </a:rPr>
-                        <a:t>2/2</a:t>
+                        <a:t>4/5</a:t>
                       </a:r>
                     </a:p>
                   </a:txBody>
@@ -8302,7 +8302,7 @@
                           </a:solidFill>
                           <a:latin typeface="Kanit"/>
                         </a:rPr>
-                        <a:t>สกลนคร</a:t>
+                        <a:t>นราธิวาส</a:t>
                       </a:r>
                     </a:p>
                   </a:txBody>
@@ -8325,7 +8325,7 @@
                           </a:solidFill>
                           <a:latin typeface="Kanit"/>
                         </a:rPr>
-                        <a:t>38</a:t>
+                        <a:t>67</a:t>
                       </a:r>
                     </a:p>
                   </a:txBody>
@@ -8348,7 +8348,7 @@
                           </a:solidFill>
                           <a:latin typeface="Kanit"/>
                         </a:rPr>
-                        <a:t>22</a:t>
+                        <a:t>40</a:t>
                       </a:r>
                     </a:p>
                   </a:txBody>
@@ -8367,11 +8367,11 @@
                       <a:r>
                         <a:rPr sz="900" b="1">
                           <a:solidFill>
-                            <a:srgbClr val="606060"/>
-                          </a:solidFill>
-                          <a:latin typeface="Kanit"/>
-                        </a:rPr>
-                        <a:t>0.0%</a:t>
+                            <a:srgbClr val="F5C242"/>
+                          </a:solidFill>
+                          <a:latin typeface="Kanit"/>
+                        </a:rPr>
+                        <a:t>4.5%</a:t>
                       </a:r>
                     </a:p>
                   </a:txBody>
@@ -8394,7 +8394,7 @@
                           </a:solidFill>
                           <a:latin typeface="Kanit"/>
                         </a:rPr>
-                        <a:t>7/13</a:t>
+                        <a:t>5/10</a:t>
                       </a:r>
                     </a:p>
                   </a:txBody>
@@ -8413,11 +8413,11 @@
                       <a:r>
                         <a:rPr sz="900" b="1">
                           <a:solidFill>
-                            <a:srgbClr val="CC0000"/>
-                          </a:solidFill>
-                          <a:latin typeface="Kanit"/>
-                        </a:rPr>
-                        <a:t>5</a:t>
+                            <a:srgbClr val="F5C242"/>
+                          </a:solidFill>
+                          <a:latin typeface="Kanit"/>
+                        </a:rPr>
+                        <a:t>4</a:t>
                       </a:r>
                     </a:p>
                   </a:txBody>
@@ -8442,7 +8442,7 @@
                           </a:solidFill>
                           <a:latin typeface="Kanit"/>
                         </a:rPr>
-                        <a:t>เพชรบูรณ์</a:t>
+                        <a:t>สงขลา</a:t>
                       </a:r>
                     </a:p>
                   </a:txBody>
@@ -8465,7 +8465,7 @@
                           </a:solidFill>
                           <a:latin typeface="Kanit"/>
                         </a:rPr>
-                        <a:t>80</a:t>
+                        <a:t>95</a:t>
                       </a:r>
                     </a:p>
                   </a:txBody>
@@ -8488,7 +8488,7 @@
                           </a:solidFill>
                           <a:latin typeface="Kanit"/>
                         </a:rPr>
-                        <a:t>18</a:t>
+                        <a:t>40</a:t>
                       </a:r>
                     </a:p>
                   </a:txBody>
@@ -8507,11 +8507,11 @@
                       <a:r>
                         <a:rPr sz="900" b="1">
                           <a:solidFill>
-                            <a:srgbClr val="606060"/>
-                          </a:solidFill>
-                          <a:latin typeface="Kanit"/>
-                        </a:rPr>
-                        <a:t>0.0%</a:t>
+                            <a:srgbClr val="F5C242"/>
+                          </a:solidFill>
+                          <a:latin typeface="Kanit"/>
+                        </a:rPr>
+                        <a:t>2.1%</a:t>
                       </a:r>
                     </a:p>
                   </a:txBody>
@@ -8534,7 +8534,7 @@
                           </a:solidFill>
                           <a:latin typeface="Kanit"/>
                         </a:rPr>
-                        <a:t>4/9</a:t>
+                        <a:t>3/19</a:t>
                       </a:r>
                     </a:p>
                   </a:txBody>
@@ -8553,11 +8553,11 @@
                       <a:r>
                         <a:rPr sz="900" b="1">
                           <a:solidFill>
-                            <a:srgbClr val="CC0000"/>
-                          </a:solidFill>
-                          <a:latin typeface="Kanit"/>
-                        </a:rPr>
-                        <a:t>5</a:t>
+                            <a:srgbClr val="F5C242"/>
+                          </a:solidFill>
+                          <a:latin typeface="Kanit"/>
+                        </a:rPr>
+                        <a:t>4</a:t>
                       </a:r>
                     </a:p>
                   </a:txBody>
@@ -8582,7 +8582,7 @@
                           </a:solidFill>
                           <a:latin typeface="Kanit"/>
                         </a:rPr>
-                        <a:t>กาญจนบุรี</a:t>
+                        <a:t>พะเยา</a:t>
                       </a:r>
                     </a:p>
                   </a:txBody>
@@ -8605,7 +8605,7 @@
                           </a:solidFill>
                           <a:latin typeface="Kanit"/>
                         </a:rPr>
-                        <a:t>93</a:t>
+                        <a:t>124</a:t>
                       </a:r>
                     </a:p>
                   </a:txBody>
@@ -8628,7 +8628,7 @@
                           </a:solidFill>
                           <a:latin typeface="Kanit"/>
                         </a:rPr>
-                        <a:t>45</a:t>
+                        <a:t>39</a:t>
                       </a:r>
                     </a:p>
                   </a:txBody>
@@ -8651,7 +8651,7 @@
                           </a:solidFill>
                           <a:latin typeface="Kanit"/>
                         </a:rPr>
-                        <a:t>6.5%</a:t>
+                        <a:t>1.6%</a:t>
                       </a:r>
                     </a:p>
                   </a:txBody>
@@ -8674,7 +8674,7 @@
                           </a:solidFill>
                           <a:latin typeface="Kanit"/>
                         </a:rPr>
-                        <a:t>4/26</a:t>
+                        <a:t>3/13</a:t>
                       </a:r>
                     </a:p>
                   </a:txBody>
@@ -8909,7 +8909,7 @@
                 </a:solidFill>
                 <a:latin typeface="Kanit"/>
               </a:rPr>
-              <a:t>พื้นที่ปลูก วัดจริง (สศก. — ข้อมูลอำเภอ×พืช 3,295 แถว) ภัยแล้งเป็นดัชนี SPEI จาก แบบจำลอง คำนวณจากปริมาณฝนและการคายระเหย ปรับเดือนละครั้ง ดึงข้อมูล 2026-07-20 — เป็นสัญญาณที่ครอบคลุมทั้งประเทศดีที่สุดที่มี แต่ไม่มีใครลงพื้นที่ไปเดินดูอำเภอเหล่านั้น ข้อมูลฝนและระดับน้ำ วัดจริง (ThaiWater เรียลไทม์ ดึงทุกวันและสะสมไว้ — วันที่ดึงไม่สำเร็จจะเว้นเป็นช่องว่าง ไม่ใส่ค่าสมมติ) · ฝนถึง 2026-08-22, ระดับน้ำถึง 2026-08-22 ความเสี่ยงน้ำท่วมเชิงโครงสร้าง วัดจริง (สำมะโนพื้นที่ท่วมซ้ำซาก GISTDA มาตราส่วน 1:50,000 ปี 2005-2016 — เป็นบันทึกภาคพื้นดิน 12 ปี ไม่ใช่การพยากรณ์)</a:t>
+              <a:t>พื้นที่ปลูก วัดจริง (สศก. — ข้อมูลอำเภอ×พืช 3,295 แถว) ภัยแล้งเป็นดัชนี SPEI จาก แบบจำลอง คำนวณจากปริมาณฝนและการคายระเหย ปรับเดือนละครั้ง ดึงข้อมูล 2026-07-20 — เป็นสัญญาณที่ครอบคลุมทั้งประเทศดีที่สุดที่มี แต่ไม่มีใครลงพื้นที่ไปเดินดูอำเภอเหล่านั้น ข้อมูลฝนและระดับน้ำ วัดจริง (ThaiWater เรียลไทม์ ดึงทุกวันและสะสมไว้ — วันที่ดึงไม่สำเร็จจะเว้นเป็นช่องว่าง ไม่ใส่ค่าสมมติ) · ฝนถึง 2026-08-25, ระดับน้ำถึง 2026-08-25 ความเสี่ยงน้ำท่วมเชิงโครงสร้าง วัดจริง (สำมะโนพื้นที่ท่วมซ้ำซาก GISTDA มาตราส่วน 1:50,000 ปี 2005-2016 — เป็นบันทึกภาคพื้นดิน 12 ปี ไม่ใช่การพยากรณ์)</a:t>
             </a:r>
           </a:p>
         </p:txBody>
@@ -31476,7 +31476,7 @@
                 </a:solidFill>
                 <a:latin typeface="Kanit"/>
               </a:rPr>
-              <a:t>รายได้จากพืชค่ากลางเพิ่มขึ้น +17.2% แต่มีสี่จังหวัดที่ลดลง — ทั้งหมดอยู่ในแหล่งปลูกมะพร้าว โดยหนักที่สุดคือสมุทรสงครามที่ −62.8%</a:t>
+              <a:t>รายได้จากพืชค่ากลางเพิ่มขึ้น +17.0% แต่มีสี่จังหวัดที่ลดลง — ทั้งหมดอยู่ในแหล่งปลูกมะพร้าว โดยหนักที่สุดคือสมุทรสงครามที่ −62.5%</a:t>
             </a:r>
           </a:p>
         </p:txBody>
@@ -32047,7 +32047,7 @@
                 </a:solidFill>
                 <a:latin typeface="Kanit"/>
               </a:rPr>
-              <a:t>รุ่นข้อมูล — ราคาโลก 2026M06 · ราคาหน้าฟาร์มไทย 2026-08-20 · ประวัติราคาไทย 2026-08-17 · ต้นทุนการผลิตพืช สศก. ไจอัป 2568 (ปีเพาะปลูก 2568/69, ประมาณการ สศก. มี.ค. 2569) · ภัยแล้ง 2026-06-21 · เงินเฟ้อ 2026-05 · GDP 2026 ไตรมาส 1 · IMF WEO 2026 · ดัชนีราคาขายต่อ 2026-05 · ยอดจดทะเบียนถึง 2026-01 · หนี้ครัวเรือน สสช. SES 2566 · ค่าจ้าง สสช. LFS 2568 · ข้อมูลตรวจวัด 2026-08-22</a:t>
+              <a:t>รุ่นข้อมูล — ราคาโลก 2026M06 · ราคาหน้าฟาร์มไทย 2026-08-24 · ประวัติราคาไทย 2026-08-23 · ต้นทุนการผลิตพืช สศก. ไจอัป 2568 (ปีเพาะปลูก 2568/69, ประมาณการ สศก. มี.ค. 2569) · ภัยแล้ง 2026-06-21 · เงินเฟ้อ 2026-05 · GDP 2026 ไตรมาส 1 · IMF WEO 2026 · ดัชนีราคาขายต่อ 2026-05 · ยอดจดทะเบียนถึง 2026-01 · หนี้ครัวเรือน สสช. SES 2566 · ค่าจ้าง สสช. LFS 2568 · ข้อมูลตรวจวัด 2026-08-25</a:t>
             </a:r>
           </a:p>
         </p:txBody>
@@ -32546,7 +32546,7 @@
               <a:t>Not on the world index — the farm gate (ราคาที่เกษตรกรขายได้) says otherwise.
 • Five of seventeen Thai farm-gate prices are falling year on year.
 • Beef: farm gate −6.1% vs world index +8.8%.
-• Margin over price: a 26% price move becomes an 86% swing in crop income.</a:t>
+• Margin over price: a 26% price move becomes an 84% swing in crop income.</a:t>
             </a:r>
           </a:p>
         </p:txBody>
@@ -33912,7 +33912,7 @@
                 </a:solidFill>
                 <a:latin typeface="Kanit"/>
               </a:rPr>
-              <a:t>33.02</a:t>
+              <a:t>32.69</a:t>
             </a:r>
           </a:p>
         </p:txBody>
@@ -33951,7 +33951,7 @@
                 </a:solidFill>
                 <a:latin typeface="Kanit"/>
               </a:rPr>
-              <a:t>อัตราอ้างอิง ECB · 2026-08-17</a:t>
+              <a:t>อัตราอ้างอิง ECB · 2026-08-24</a:t>
             </a:r>
           </a:p>
         </p:txBody>
@@ -35798,7 +35798,7 @@
                 </a:solidFill>
                 <a:latin typeface="Kanit"/>
               </a:rPr>
-              <a:t>สศช. 2026 ไตรมาส 1 · TPSO 2026-05 · ธนาคารแห่งประเทศไทย 2026-06 · BIS 2025 ไตรมาส 4 · ECB 2026-08-17, ทั้งหมดดึงจากหน่วยงานผู้เผยแพร่โดยตรง ตารางเทียบประเทศใช้ IMF World Economic Outlook 2026 (ดึงข้อมูล 2026-07-25) อัตรา NPL ที่ ธปท. เผยแพร่ — 4.48% ณ 2026 ไตรมาส 1, จาก 4.33% ไตรมาสก่อน เปลี่ยน +0.24 จุดใน 1 ปี และต่ำสุด 3.08% ณ 2021 ไตรมาส 1</a:t>
+              <a:t>สศช. 2026 ไตรมาส 1 · TPSO 2026-05 · ธนาคารแห่งประเทศไทย 2026-06 · BIS 2025 ไตรมาส 4 · ECB 2026-08-24, ทั้งหมดดึงจากหน่วยงานผู้เผยแพร่โดยตรง ตารางเทียบประเทศใช้ IMF World Economic Outlook 2026 (ดึงข้อมูล 2026-07-25) อัตรา NPL ที่ ธปท. เผยแพร่ — 4.48% ณ 2026 ไตรมาส 1, จาก 4.33% ไตรมาสก่อน เปลี่ยน +0.24 จุดใน 1 ปี และต่ำสุด 3.08% ณ 2021 ไตรมาส 1</a:t>
             </a:r>
           </a:p>
         </p:txBody>
@@ -37087,7 +37087,7 @@
                 </a:solidFill>
                 <a:latin typeface="Kanit"/>
               </a:rPr>
-              <a:t>338 จาก 928 อำเภอ · แม่น้ำเกินระดับ 141 จาก 796 สถานี</a:t>
+              <a:t>338 จาก 928 อำเภอ · แม่น้ำเกินระดับ 134 จาก 795 สถานี</a:t>
             </a:r>
           </a:p>
         </p:txBody>
@@ -37859,7 +37859,7 @@
                           </a:solidFill>
                           <a:latin typeface="Kanit"/>
                         </a:rPr>
-                        <a:t>33/155</a:t>
+                        <a:t>29/156</a:t>
                       </a:r>
                     </a:p>
                   </a:txBody>
@@ -38091,7 +38091,7 @@
                           </a:solidFill>
                           <a:latin typeface="Kanit"/>
                         </a:rPr>
-                        <a:t>36/275</a:t>
+                        <a:t>29/275</a:t>
                       </a:r>
                     </a:p>
                   </a:txBody>
@@ -38555,7 +38555,7 @@
                           </a:solidFill>
                           <a:latin typeface="Kanit"/>
                         </a:rPr>
-                        <a:t>7/52</a:t>
+                        <a:t>8/51</a:t>
                       </a:r>
                     </a:p>
                   </a:txBody>
@@ -38787,7 +38787,7 @@
                           </a:solidFill>
                           <a:latin typeface="Kanit"/>
                         </a:rPr>
-                        <a:t>39/146</a:t>
+                        <a:t>42/145</a:t>
                       </a:r>
                     </a:p>
                   </a:txBody>
@@ -39936,7 +39936,7 @@
                           </a:solidFill>
                           <a:latin typeface="Kanit"/>
                         </a:rPr>
-                        <a:t>−67.2%</a:t>
+                        <a:t>−66.9%</a:t>
                       </a:r>
                     </a:p>
                   </a:txBody>
@@ -39959,7 +39959,7 @@
                           </a:solidFill>
                           <a:latin typeface="Kanit"/>
                         </a:rPr>
-                        <a:t>−48.8%</a:t>
+                        <a:t>−50.1%</a:t>
                       </a:r>
                     </a:p>
                   </a:txBody>
@@ -40791,7 +40791,7 @@
                 </a:solidFill>
                 <a:latin typeface="Kanit"/>
               </a:rPr>
-              <a:t>ราคา วัดจริง — ราคาหน้าฟาร์มไทยจากราคารายวันของ NABC และราคาอ้อยประกาศของ สอน. ราคาล่าสุด 2026-08-20 การเปลี่ยนแปลงหกเดือนคำนวณจากข้อมูลรายเดือนของ NABC เอง (thai_price_history รุ่นข้อมูล 2026-08-17) พืชที่ไม่มีข้อมูลรายเดือนจะกำกับไว้ ไม่ประมาณการขึ้นมา แหล่งผลิตเป็นการอ่านแบบ ประมาณการ ว่าสินค้าแต่ละชนิดปลูกที่ไหน และแหล่งผลิตทับซ้อนกันได้ บัญชีอาชีพเกษตรเป็นข้อมูลของเราเองและ วัดจริง — บัญชีที่บันทึกอาชีพว่า เกษตร ในจังหวัดแหล่งผลิต จากฐานข้อมูล 382,735 บัญชี ณ 2026-07 ไม่เผยแพร่ช่องที่มีน้อยกว่า 30 บัญชี คนกลุ่มนี้อาศัยอยู่ในพื้นที่ที่ปลูกพืชนั้น แต่ไม่ได้ยืนยันว่าปลูกพืชนั้นเอง</a:t>
+              <a:t>ราคา วัดจริง — ราคาหน้าฟาร์มไทยจากราคารายวันของ NABC และราคาอ้อยประกาศของ สอน. ราคาล่าสุด 2026-08-24 การเปลี่ยนแปลงหกเดือนคำนวณจากข้อมูลรายเดือนของ NABC เอง (thai_price_history รุ่นข้อมูล 2026-08-23) พืชที่ไม่มีข้อมูลรายเดือนจะกำกับไว้ ไม่ประมาณการขึ้นมา แหล่งผลิตเป็นการอ่านแบบ ประมาณการ ว่าสินค้าแต่ละชนิดปลูกที่ไหน และแหล่งผลิตทับซ้อนกันได้ บัญชีอาชีพเกษตรเป็นข้อมูลของเราเองและ วัดจริง — บัญชีที่บันทึกอาชีพว่า เกษตร ในจังหวัดแหล่งผลิต จากฐานข้อมูล 382,735 บัญชี ณ 2026-07 ไม่เผยแพร่ช่องที่มีน้อยกว่า 30 บัญชี คนกลุ่มนี้อาศัยอยู่ในพื้นที่ที่ปลูกพืชนั้น แต่ไม่ได้ยืนยันว่าปลูกพืชนั้นเอง</a:t>
             </a:r>
           </a:p>
         </p:txBody>
@@ -43419,7 +43419,7 @@
                           </a:solidFill>
                           <a:latin typeface="Kanit"/>
                         </a:rPr>
-                        <a:t>91.81</a:t>
+                        <a:t>90.86</a:t>
                       </a:r>
                     </a:p>
                   </a:txBody>
@@ -43559,7 +43559,7 @@
                           </a:solidFill>
                           <a:latin typeface="Kanit"/>
                         </a:rPr>
-                        <a:t>15,423</a:t>
+                        <a:t>15,264</a:t>
                       </a:r>
                     </a:p>
                   </a:txBody>
@@ -43699,7 +43699,7 @@
                           </a:solidFill>
                           <a:latin typeface="Kanit"/>
                         </a:rPr>
-                        <a:t>36,361</a:t>
+                        <a:t>35,986</a:t>
                       </a:r>
                     </a:p>
                   </a:txBody>
@@ -43839,7 +43839,7 @@
                           </a:solidFill>
                           <a:latin typeface="Kanit"/>
                         </a:rPr>
-                        <a:t>11.23</a:t>
+                        <a:t>11.11</a:t>
                       </a:r>
                     </a:p>
                   </a:txBody>
@@ -44058,7 +44058,7 @@
                 </a:solidFill>
                 <a:latin typeface="Kanit"/>
               </a:rPr>
-              <a:t>ราคารายเดือนสกุลดอลลาร์ราคาปัจจุบันจาก World Bank Pink Sheet รุ่นข้อมูล 2026M07 (ข้อมูล 60 จุดต่อรายการ ปรับฐานเป็น 100 ณ 2021-07 เพื่อวาดกราฟ — หน่วยต่างกัน จึงใช้แกนเดียวกับระดับราคาดิบไม่ได้) แปลงเป็นบาทด้วยอัตราอ้างอิง ECB USD/THB 33.025 ณ 2026-08-17 สัดส่วนพื้นที่ปลูก วัดจริง จากสัดส่วนพืชของ สศก./กรมส่งเสริมการเกษตร (crop_mix.json) เป็นราคาปัจจุบัน ไม่ได้ปรับเงินเฟ้อ: ทุกตัวเลข ‘เทียบ 5 ปีก่อน’ มีเงินเฟ้อไทยห้าปีซ่อนอยู่ข้างใต้</a:t>
+              <a:t>ราคารายเดือนสกุลดอลลาร์ราคาปัจจุบันจาก World Bank Pink Sheet รุ่นข้อมูล 2026M07 (ข้อมูล 60 จุดต่อรายการ ปรับฐานเป็น 100 ณ 2021-07 เพื่อวาดกราฟ — หน่วยต่างกัน จึงใช้แกนเดียวกับระดับราคาดิบไม่ได้) แปลงเป็นบาทด้วยอัตราอ้างอิง ECB USD/THB 32.685 ณ 2026-08-24 สัดส่วนพื้นที่ปลูก วัดจริง จากสัดส่วนพืชของ สศก./กรมส่งเสริมการเกษตร (crop_mix.json) เป็นราคาปัจจุบัน ไม่ได้ปรับเงินเฟ้อ: ทุกตัวเลข ‘เทียบ 5 ปีก่อน’ มีเงินเฟ้อไทยห้าปีซ่อนอยู่ข้างใต้</a:t>
             </a:r>
           </a:p>
         </p:txBody>
@@ -44679,7 +44679,7 @@
                 </a:solidFill>
                 <a:latin typeface="Kanit"/>
               </a:rPr>
-              <a:t>มะพร้าว −67.2% สับปะรด −18.4% อ้อย −17.9% เทียบปีก่อน</a:t>
+              <a:t>มะพร้าว −66.9% สับปะรด −18.4% อ้อย −17.9% เทียบปีก่อน</a:t>
             </a:r>
           </a:p>
         </p:txBody>
@@ -44805,7 +44805,7 @@
                 </a:solidFill>
                 <a:latin typeface="Kanit"/>
               </a:rPr>
-              <a:t>+17.2%</a:t>
+              <a:t>+17.0%</a:t>
             </a:r>
           </a:p>
         </p:txBody>
@@ -45279,7 +45279,7 @@
                           </a:solidFill>
                           <a:latin typeface="Kanit"/>
                         </a:rPr>
-                        <a:t>+6.8%</a:t>
+                        <a:t>+7.0%</a:t>
                       </a:r>
                     </a:p>
                   </a:txBody>
@@ -45348,7 +45348,7 @@
                           </a:solidFill>
                           <a:latin typeface="Kanit"/>
                         </a:rPr>
-                        <a:t>-62.8%</a:t>
+                        <a:t>-62.5%</a:t>
                       </a:r>
                     </a:p>
                   </a:txBody>
@@ -45419,7 +45419,7 @@
                           </a:solidFill>
                           <a:latin typeface="Kanit"/>
                         </a:rPr>
-                        <a:t>+15.9%</a:t>
+                        <a:t>+16.0%</a:t>
                       </a:r>
                     </a:p>
                   </a:txBody>
@@ -45488,7 +45488,7 @@
                           </a:solidFill>
                           <a:latin typeface="Kanit"/>
                         </a:rPr>
-                        <a:t>+10.2%</a:t>
+                        <a:t>+10.3%</a:t>
                       </a:r>
                     </a:p>
                   </a:txBody>
@@ -45559,7 +45559,7 @@
                           </a:solidFill>
                           <a:latin typeface="Kanit"/>
                         </a:rPr>
-                        <a:t>+17.2%</a:t>
+                        <a:t>+17.5%</a:t>
                       </a:r>
                     </a:p>
                   </a:txBody>
@@ -45628,7 +45628,7 @@
                           </a:solidFill>
                           <a:latin typeface="Kanit"/>
                         </a:rPr>
-                        <a:t>+8.8%</a:t>
+                        <a:t>+8.9%</a:t>
                       </a:r>
                     </a:p>
                   </a:txBody>
@@ -45699,7 +45699,7 @@
                           </a:solidFill>
                           <a:latin typeface="Kanit"/>
                         </a:rPr>
-                        <a:t>+25.7%</a:t>
+                        <a:t>+25.2%</a:t>
                       </a:r>
                     </a:p>
                   </a:txBody>
@@ -45768,7 +45768,7 @@
                           </a:solidFill>
                           <a:latin typeface="Kanit"/>
                         </a:rPr>
-                        <a:t>+11.3%</a:t>
+                        <a:t>+11.6%</a:t>
                       </a:r>
                     </a:p>
                   </a:txBody>
@@ -45839,7 +45839,7 @@
                           </a:solidFill>
                           <a:latin typeface="Kanit"/>
                         </a:rPr>
-                        <a:t>+35.8%</a:t>
+                        <a:t>+34.8%</a:t>
                       </a:r>
                     </a:p>
                   </a:txBody>
@@ -45908,7 +45908,7 @@
                           </a:solidFill>
                           <a:latin typeface="Kanit"/>
                         </a:rPr>
-                        <a:t>+27.9%</a:t>
+                        <a:t>+27.1%</a:t>
                       </a:r>
                     </a:p>
                   </a:txBody>
@@ -46084,7 +46084,7 @@
                 </a:solidFill>
                 <a:latin typeface="Kanit"/>
               </a:rPr>
-              <a:t>•  ราคาหน้าฟาร์ม: ยางพารา +41% มันสำปะหลัง +69% ปาล์ม +24% ข้าว +14% รายได้จากพืชเพิ่มขึ้นทุกภาค
+              <a:t>•  ราคาหน้าฟาร์ม: ยางพารา +40% มันสำปะหลัง +72% ปาล์ม +23% ข้าว +14% รายได้จากพืชเพิ่มขึ้นทุกภาค
 •  มีสี่จังหวัดที่ลดลง — ทั้งหมดเป็นมะพร้าว และอยู่ฝั่งอ่าวไทยตะวันตก ราคามะพร้าวลดลง 67%
 •  กำไรบนกระดาษยังไม่ใช่เงินสด — ตารางถัดไปหักราคาด้วยต้นทุน</a:t>
             </a:r>
@@ -46387,7 +46387,7 @@
                           </a:solidFill>
                           <a:latin typeface="Kanit"/>
                         </a:rPr>
-                        <a:t>+17.6%</a:t>
+                        <a:t>+18.0%</a:t>
                       </a:r>
                     </a:p>
                   </a:txBody>
@@ -46550,7 +46550,7 @@
                           </a:solidFill>
                           <a:latin typeface="Kanit"/>
                         </a:rPr>
-                        <a:t>+21.7%</a:t>
+                        <a:t>+21.9%</a:t>
                       </a:r>
                     </a:p>
                   </a:txBody>
@@ -46713,7 +46713,7 @@
                           </a:solidFill>
                           <a:latin typeface="Kanit"/>
                         </a:rPr>
-                        <a:t>+11.6%</a:t>
+                        <a:t>+11.9%</a:t>
                       </a:r>
                     </a:p>
                   </a:txBody>
@@ -46876,7 +46876,7 @@
                           </a:solidFill>
                           <a:latin typeface="Kanit"/>
                         </a:rPr>
-                        <a:t>+33.6%</a:t>
+                        <a:t>+32.7%</a:t>
                       </a:r>
                     </a:p>
                   </a:txBody>
@@ -47039,7 +47039,7 @@
                           </a:solidFill>
                           <a:latin typeface="Kanit"/>
                         </a:rPr>
-                        <a:t>+17.2%</a:t>
+                        <a:t>+17.4%</a:t>
                       </a:r>
                     </a:p>
                   </a:txBody>
@@ -47202,7 +47202,7 @@
                           </a:solidFill>
                           <a:latin typeface="Kanit"/>
                         </a:rPr>
-                        <a:t>+15.8%</a:t>
+                        <a:t>+16.0%</a:t>
                       </a:r>
                     </a:p>
                   </a:txBody>
@@ -47985,7 +47985,7 @@
                 </a:solidFill>
                 <a:latin typeface="Kanit"/>
               </a:rPr>
-              <a:t>฿620.00 /ร้อยผล · ใต้·ตอ.</a:t>
+              <a:t>฿606.15 /ร้อยผล · ใต้·ตอ.</a:t>
             </a:r>
           </a:p>
         </p:txBody>
@@ -48024,7 +48024,7 @@
                 </a:solidFill>
                 <a:latin typeface="Kanit"/>
               </a:rPr>
-              <a:t>เทียบปีก่อน −67.2%</a:t>
+              <a:t>เทียบปีก่อน −66.9%</a:t>
             </a:r>
           </a:p>
         </p:txBody>
@@ -48063,7 +48063,7 @@
                 </a:solidFill>
                 <a:latin typeface="Kanit"/>
               </a:rPr>
-              <a:t>6 เดือน −48.8%</a:t>
+              <a:t>6 เดือน −50.1%</a:t>
             </a:r>
           </a:p>
         </p:txBody>
@@ -48137,19 +48137,19 @@
                   <a:pt x="0" y="0"/>
                 </a:moveTo>
                 <a:lnTo>
-                  <a:pt x="412943" y="170015"/>
-                </a:lnTo>
-                <a:lnTo>
-                  <a:pt x="825886" y="147424"/>
-                </a:lnTo>
-                <a:lnTo>
-                  <a:pt x="1238829" y="401963"/>
+                  <a:pt x="412943" y="167653"/>
+                </a:lnTo>
+                <a:lnTo>
+                  <a:pt x="825886" y="145107"/>
+                </a:lnTo>
+                <a:lnTo>
+                  <a:pt x="1238829" y="402654"/>
                 </a:lnTo>
                 <a:lnTo>
                   <a:pt x="1651772" y="457200"/>
                 </a:lnTo>
                 <a:lnTo>
-                  <a:pt x="2064715" y="387883"/>
+                  <a:pt x="2064715" y="401204"/>
                 </a:lnTo>
               </a:path>
             </a:pathLst>
@@ -48192,7 +48192,7 @@
         </p:nvSpPr>
         <p:spPr>
           <a:xfrm>
-            <a:off x="2480767" y="2792755"/>
+            <a:off x="2480767" y="2806076"/>
             <a:ext cx="82296" cy="82296"/>
           </a:xfrm>
           <a:prstGeom prst="roundRect">
@@ -48621,7 +48621,7 @@
                 </a:solidFill>
                 <a:latin typeface="Kanit"/>
               </a:rPr>
-              <a:t>฿143.33 /กก. · ชายฝั่งใต้·ตอ.</a:t>
+              <a:t>฿143.00 /กก. · ชายฝั่งใต้·ตอ.</a:t>
             </a:r>
           </a:p>
         </p:txBody>
@@ -48660,7 +48660,7 @@
                 </a:solidFill>
                 <a:latin typeface="Kanit"/>
               </a:rPr>
-              <a:t>เทียบปีก่อน +1.6%</a:t>
+              <a:t>เทียบปีก่อน +1.4%</a:t>
             </a:r>
           </a:p>
         </p:txBody>
@@ -48699,7 +48699,7 @@
                 </a:solidFill>
                 <a:latin typeface="Kanit"/>
               </a:rPr>
-              <a:t>6 เดือน −1.9%</a:t>
+              <a:t>6 เดือน −2.1%</a:t>
             </a:r>
           </a:p>
         </p:txBody>
@@ -48770,19 +48770,19 @@
             <a:pathLst>
               <a:path w="2064715" h="457200">
                 <a:moveTo>
-                  <a:pt x="0" y="222838"/>
+                  <a:pt x="0" y="217911"/>
                 </a:moveTo>
                 <a:lnTo>
-                  <a:pt x="412943" y="418928"/>
+                  <a:pt x="412943" y="415692"/>
                 </a:lnTo>
                 <a:lnTo>
                   <a:pt x="825886" y="457200"/>
                 </a:lnTo>
                 <a:lnTo>
-                  <a:pt x="1238829" y="423249"/>
-                </a:lnTo>
-                <a:lnTo>
-                  <a:pt x="1651772" y="173867"/>
+                  <a:pt x="1238829" y="420051"/>
+                </a:lnTo>
+                <a:lnTo>
+                  <a:pt x="1651772" y="168518"/>
                 </a:lnTo>
                 <a:lnTo>
                   <a:pt x="2064715" y="0"/>
@@ -48939,7 +48939,7 @@
                 </a:solidFill>
                 <a:latin typeface="Kanit"/>
               </a:rPr>
-              <a:t>฿343.75 /ร้อยฟอง · กลาง·ตอ.</a:t>
+              <a:t>฿346.15 /ร้อยฟอง · กลาง·ตอ.</a:t>
             </a:r>
           </a:p>
         </p:txBody>
@@ -48978,7 +48978,7 @@
                 </a:solidFill>
                 <a:latin typeface="Kanit"/>
               </a:rPr>
-              <a:t>เทียบปีก่อน +2.0%</a:t>
+              <a:t>เทียบปีก่อน +3.2%</a:t>
             </a:r>
           </a:p>
         </p:txBody>
@@ -49017,7 +49017,7 @@
                 </a:solidFill>
                 <a:latin typeface="Kanit"/>
               </a:rPr>
-              <a:t>6 เดือน +13.6%</a:t>
+              <a:t>6 เดือน +14.4%</a:t>
             </a:r>
           </a:p>
         </p:txBody>
@@ -49091,16 +49091,16 @@
                   <a:pt x="0" y="457200"/>
                 </a:moveTo>
                 <a:lnTo>
-                  <a:pt x="412943" y="173996"/>
-                </a:lnTo>
-                <a:lnTo>
-                  <a:pt x="825886" y="173996"/>
-                </a:lnTo>
-                <a:lnTo>
-                  <a:pt x="1238829" y="281558"/>
-                </a:lnTo>
-                <a:lnTo>
-                  <a:pt x="1651772" y="66435"/>
+                  <a:pt x="412943" y="191637"/>
+                </a:lnTo>
+                <a:lnTo>
+                  <a:pt x="825886" y="191637"/>
+                </a:lnTo>
+                <a:lnTo>
+                  <a:pt x="1238829" y="292498"/>
+                </a:lnTo>
+                <a:lnTo>
+                  <a:pt x="1651772" y="90775"/>
                 </a:lnTo>
                 <a:lnTo>
                   <a:pt x="2064715" y="0"/>
@@ -49409,19 +49409,19 @@
                   <a:pt x="0" y="0"/>
                 </a:moveTo>
                 <a:lnTo>
-                  <a:pt x="412943" y="114807"/>
-                </a:lnTo>
-                <a:lnTo>
-                  <a:pt x="825886" y="305815"/>
+                  <a:pt x="412943" y="111737"/>
+                </a:lnTo>
+                <a:lnTo>
+                  <a:pt x="825886" y="304458"/>
                 </a:lnTo>
                 <a:lnTo>
                   <a:pt x="1238829" y="457200"/>
                 </a:lnTo>
                 <a:lnTo>
-                  <a:pt x="1651772" y="244855"/>
-                </a:lnTo>
-                <a:lnTo>
-                  <a:pt x="2064715" y="91439"/>
+                  <a:pt x="1651772" y="242951"/>
+                </a:lnTo>
+                <a:lnTo>
+                  <a:pt x="2064715" y="88159"/>
                 </a:lnTo>
               </a:path>
             </a:pathLst>
@@ -49464,7 +49464,7 @@
         </p:nvSpPr>
         <p:spPr>
           <a:xfrm>
-            <a:off x="11690603" y="2496311"/>
+            <a:off x="11690603" y="2493031"/>
             <a:ext cx="82296" cy="82296"/>
           </a:xfrm>
           <a:prstGeom prst="roundRect">
@@ -49575,7 +49575,7 @@
                 </a:solidFill>
                 <a:latin typeface="Kanit"/>
               </a:rPr>
-              <a:t>฿70.12 /กก. · กลาง·ตต.·ตอ.</a:t>
+              <a:t>฿70.33 /กก. · กลาง·ตต.·ตอ.</a:t>
             </a:r>
           </a:p>
         </p:txBody>
@@ -49614,7 +49614,7 @@
                 </a:solidFill>
                 <a:latin typeface="Kanit"/>
               </a:rPr>
-              <a:t>เทียบปีก่อน +5.4%</a:t>
+              <a:t>เทียบปีก่อน +8.8%</a:t>
             </a:r>
           </a:p>
         </p:txBody>
@@ -49653,7 +49653,7 @@
                 </a:solidFill>
                 <a:latin typeface="Kanit"/>
               </a:rPr>
-              <a:t>6 เดือน +26.3%</a:t>
+              <a:t>6 เดือน +26.7%</a:t>
             </a:r>
           </a:p>
         </p:txBody>
@@ -49724,19 +49724,19 @@
             <a:pathLst>
               <a:path w="2064715" h="457200">
                 <a:moveTo>
-                  <a:pt x="0" y="358828"/>
+                  <a:pt x="0" y="361078"/>
                 </a:moveTo>
                 <a:lnTo>
-                  <a:pt x="412943" y="100410"/>
+                  <a:pt x="412943" y="110564"/>
                 </a:lnTo>
                 <a:lnTo>
                   <a:pt x="825886" y="457200"/>
                 </a:lnTo>
                 <a:lnTo>
-                  <a:pt x="1238829" y="286450"/>
-                </a:lnTo>
-                <a:lnTo>
-                  <a:pt x="1651772" y="170749"/>
+                  <a:pt x="1238829" y="293843"/>
+                </a:lnTo>
+                <a:lnTo>
+                  <a:pt x="1651772" y="177301"/>
                 </a:lnTo>
                 <a:lnTo>
                   <a:pt x="2064715" y="0"/>
@@ -49893,7 +49893,7 @@
                 </a:solidFill>
                 <a:latin typeface="Kanit"/>
               </a:rPr>
-              <a:t>฿17,768 /ตัน · อีสาน·เหนือ·กลาง</a:t>
+              <a:t>฿17,815 /ตัน · อีสาน·เหนือ·กลาง</a:t>
             </a:r>
           </a:p>
         </p:txBody>
@@ -49932,7 +49932,7 @@
                 </a:solidFill>
                 <a:latin typeface="Kanit"/>
               </a:rPr>
-              <a:t>เทียบปีก่อน +14.2%</a:t>
+              <a:t>เทียบปีก่อน +14.4%</a:t>
             </a:r>
           </a:p>
         </p:txBody>
@@ -49971,7 +49971,7 @@
                 </a:solidFill>
                 <a:latin typeface="Kanit"/>
               </a:rPr>
-              <a:t>6 เดือน +8.0%</a:t>
+              <a:t>6 เดือน +8.2%</a:t>
             </a:r>
           </a:p>
         </p:txBody>
@@ -50045,16 +50045,16 @@
                   <a:pt x="0" y="457200"/>
                 </a:moveTo>
                 <a:lnTo>
-                  <a:pt x="412943" y="341616"/>
-                </a:lnTo>
-                <a:lnTo>
-                  <a:pt x="825886" y="154005"/>
-                </a:lnTo>
-                <a:lnTo>
-                  <a:pt x="1238829" y="47789"/>
-                </a:lnTo>
-                <a:lnTo>
-                  <a:pt x="1651772" y="27620"/>
+                  <a:pt x="412943" y="349810"/>
+                </a:lnTo>
+                <a:lnTo>
+                  <a:pt x="825886" y="168554"/>
+                </a:lnTo>
+                <a:lnTo>
+                  <a:pt x="1238829" y="54643"/>
+                </a:lnTo>
+                <a:lnTo>
+                  <a:pt x="1651772" y="63603"/>
                 </a:lnTo>
                 <a:lnTo>
                   <a:pt x="2064715" y="0"/>
@@ -50211,7 +50211,7 @@
                 </a:solidFill>
                 <a:latin typeface="Kanit"/>
               </a:rPr>
-              <a:t>฿10.04 /กก. · เหนือ</a:t>
+              <a:t>฿9.87 /กก. · เหนือ</a:t>
             </a:r>
           </a:p>
         </p:txBody>
@@ -50250,7 +50250,7 @@
                 </a:solidFill>
                 <a:latin typeface="Kanit"/>
               </a:rPr>
-              <a:t>เทียบปีก่อน +16.5%</a:t>
+              <a:t>เทียบปีก่อน +15.9%</a:t>
             </a:r>
           </a:p>
         </p:txBody>
@@ -50289,7 +50289,7 @@
                 </a:solidFill>
                 <a:latin typeface="Kanit"/>
               </a:rPr>
-              <a:t>6 เดือน +12.7%</a:t>
+              <a:t>6 เดือน +10.9%</a:t>
             </a:r>
           </a:p>
         </p:txBody>
@@ -50363,19 +50363,19 @@
                   <a:pt x="0" y="457200"/>
                 </a:moveTo>
                 <a:lnTo>
-                  <a:pt x="412943" y="357808"/>
-                </a:lnTo>
-                <a:lnTo>
-                  <a:pt x="825886" y="86967"/>
+                  <a:pt x="412943" y="355874"/>
+                </a:lnTo>
+                <a:lnTo>
+                  <a:pt x="825886" y="86497"/>
                 </a:lnTo>
                 <a:lnTo>
                   <a:pt x="1238829" y="0"/>
                 </a:lnTo>
                 <a:lnTo>
-                  <a:pt x="1651772" y="49695"/>
-                </a:lnTo>
-                <a:lnTo>
-                  <a:pt x="2064715" y="226115"/>
+                  <a:pt x="1651772" y="46955"/>
+                </a:lnTo>
+                <a:lnTo>
+                  <a:pt x="2064715" y="269377"/>
                 </a:lnTo>
               </a:path>
             </a:pathLst>
@@ -50418,7 +50418,7 @@
         </p:nvSpPr>
         <p:spPr>
           <a:xfrm>
-            <a:off x="7085685" y="3737411"/>
+            <a:off x="7085685" y="3780673"/>
             <a:ext cx="82296" cy="82296"/>
           </a:xfrm>
           <a:prstGeom prst="roundRect">
@@ -50529,7 +50529,7 @@
                 </a:solidFill>
                 <a:latin typeface="Kanit"/>
               </a:rPr>
-              <a:t>฿8.65 /กก. · ใต้</a:t>
+              <a:t>฿8.55 /กก. · ใต้</a:t>
             </a:r>
           </a:p>
         </p:txBody>
@@ -50568,7 +50568,7 @@
                 </a:solidFill>
                 <a:latin typeface="Kanit"/>
               </a:rPr>
-              <a:t>เทียบปีก่อน +23.9%</a:t>
+              <a:t>เทียบปีก่อน +23.3%</a:t>
             </a:r>
           </a:p>
         </p:txBody>
@@ -50607,7 +50607,7 @@
                 </a:solidFill>
                 <a:latin typeface="Kanit"/>
               </a:rPr>
-              <a:t>6 เดือน +26.6%</a:t>
+              <a:t>6 เดือน +25.0%</a:t>
             </a:r>
           </a:p>
         </p:txBody>
@@ -50678,19 +50678,19 @@
             <a:pathLst>
               <a:path w="2064715" h="457200">
                 <a:moveTo>
-                  <a:pt x="0" y="457200"/>
+                  <a:pt x="0" y="453788"/>
                 </a:moveTo>
                 <a:lnTo>
-                  <a:pt x="412943" y="444499"/>
+                  <a:pt x="412943" y="446964"/>
                 </a:lnTo>
                 <a:lnTo>
                   <a:pt x="825886" y="457200"/>
                 </a:lnTo>
                 <a:lnTo>
-                  <a:pt x="1238829" y="311149"/>
-                </a:lnTo>
-                <a:lnTo>
-                  <a:pt x="1651772" y="114300"/>
+                  <a:pt x="1238829" y="300250"/>
+                </a:lnTo>
+                <a:lnTo>
+                  <a:pt x="1651772" y="85298"/>
                 </a:lnTo>
                 <a:lnTo>
                   <a:pt x="2064715" y="0"/>
@@ -50847,7 +50847,7 @@
                 </a:solidFill>
                 <a:latin typeface="Kanit"/>
               </a:rPr>
-              <a:t>฿81.86 /กก. · ใต้·ตอ.</a:t>
+              <a:t>฿81.51 /กก. · ใต้·ตอ.</a:t>
             </a:r>
           </a:p>
         </p:txBody>
@@ -50886,7 +50886,7 @@
                 </a:solidFill>
                 <a:latin typeface="Kanit"/>
               </a:rPr>
-              <a:t>เทียบปีก่อน +41.4%</a:t>
+              <a:t>เทียบปีก่อน +40.2%</a:t>
             </a:r>
           </a:p>
         </p:txBody>
@@ -50925,7 +50925,7 @@
                 </a:solidFill>
                 <a:latin typeface="Kanit"/>
               </a:rPr>
-              <a:t>6 เดือน +35.6%</a:t>
+              <a:t>6 เดือน +35.1%</a:t>
             </a:r>
           </a:p>
         </p:txBody>
@@ -50999,19 +50999,19 @@
                   <a:pt x="0" y="457200"/>
                 </a:moveTo>
                 <a:lnTo>
-                  <a:pt x="412943" y="286327"/>
-                </a:lnTo>
-                <a:lnTo>
-                  <a:pt x="825886" y="157274"/>
+                  <a:pt x="412943" y="287287"/>
+                </a:lnTo>
+                <a:lnTo>
+                  <a:pt x="825886" y="158892"/>
                 </a:lnTo>
                 <a:lnTo>
                   <a:pt x="1238829" y="0"/>
                 </a:lnTo>
                 <a:lnTo>
-                  <a:pt x="1651772" y="37202"/>
-                </a:lnTo>
-                <a:lnTo>
-                  <a:pt x="2064715" y="104678"/>
+                  <a:pt x="1651772" y="38185"/>
+                </a:lnTo>
+                <a:lnTo>
+                  <a:pt x="2064715" y="115325"/>
                 </a:lnTo>
               </a:path>
             </a:pathLst>
@@ -51054,7 +51054,7 @@
         </p:nvSpPr>
         <p:spPr>
           <a:xfrm>
-            <a:off x="11690603" y="3615974"/>
+            <a:off x="11690603" y="3626621"/>
             <a:ext cx="82296" cy="82296"/>
           </a:xfrm>
           <a:prstGeom prst="roundRect">
@@ -51204,7 +51204,7 @@
                 </a:solidFill>
                 <a:latin typeface="Kanit"/>
               </a:rPr>
-              <a:t>เทียบปีก่อน +69.4%</a:t>
+              <a:t>เทียบปีก่อน +72.1%</a:t>
             </a:r>
           </a:p>
         </p:txBody>
@@ -51243,7 +51243,7 @@
                 </a:solidFill>
                 <a:latin typeface="Kanit"/>
               </a:rPr>
-              <a:t>6 เดือน +49.4%</a:t>
+              <a:t>6 เดือน +48.8%</a:t>
             </a:r>
           </a:p>
         </p:txBody>
@@ -51326,7 +51326,7 @@
                   <a:pt x="1238829" y="163586"/>
                 </a:lnTo>
                 <a:lnTo>
-                  <a:pt x="1651772" y="130030"/>
+                  <a:pt x="1651772" y="125835"/>
                 </a:lnTo>
                 <a:lnTo>
                   <a:pt x="2064715" y="0"/>
@@ -51483,7 +51483,7 @@
                 </a:solidFill>
                 <a:latin typeface="Kanit"/>
               </a:rPr>
-              <a:t>฿120.00 /ร้อยผล · กลาง·ตต.</a:t>
+              <a:t>฿129.23 /ร้อยผล · กลาง·ตต.</a:t>
             </a:r>
           </a:p>
         </p:txBody>
@@ -51522,7 +51522,7 @@
                 </a:solidFill>
                 <a:latin typeface="Kanit"/>
               </a:rPr>
-              <a:t>เทียบปีก่อน +96.8%</a:t>
+              <a:t>เทียบปีก่อน +102.6%</a:t>
             </a:r>
           </a:p>
         </p:txBody>
@@ -51561,7 +51561,7 @@
                 </a:solidFill>
                 <a:latin typeface="Kanit"/>
               </a:rPr>
-              <a:t>6 เดือน −42.9%</a:t>
+              <a:t>6 เดือน −38.5%</a:t>
             </a:r>
           </a:p>
         </p:txBody>
@@ -51647,7 +51647,7 @@
                   <a:pt x="1651772" y="457200"/>
                 </a:lnTo>
                 <a:lnTo>
-                  <a:pt x="2064715" y="434102"/>
+                  <a:pt x="2064715" y="428011"/>
                 </a:lnTo>
               </a:path>
             </a:pathLst>
@@ -51690,7 +51690,7 @@
         </p:nvSpPr>
         <p:spPr>
           <a:xfrm>
-            <a:off x="4783226" y="5051821"/>
+            <a:off x="4783226" y="5045730"/>
             <a:ext cx="82296" cy="82296"/>
           </a:xfrm>
           <a:prstGeom prst="roundRect">
@@ -51886,7 +51886,7 @@
                 </a:solidFill>
                 <a:latin typeface="Kanit"/>
               </a:rPr>
-              <a:t>ราคาหน้าฟาร์ม วัดจริง — ราคารายวันของ NABC เฉลี่ยเป็นรายเดือน หน่วยเป็นบาทตามที่เผยแพร่ (ไม่มีการแปลงสกุลเงิน) ราคาล่าสุด 2026-08-20, รุ่นข้อมูลย้อนหลัง 2026-08-17 ราคาหน้าฟาร์ม (ราคาที่เกษตรกรขายได้) คือเงินที่เกษตรกรได้รับเมื่อขายครั้งแรก ก่อนพ่อค้าคนกลาง โรงสี หรือค่าขนส่งจะหักส่วนแบ่ง — ไม่ใช่ดัชนีโลก และไม่ใช่ราคาในซูเปอร์มาร์เก็ต แหล่งผลิตเป็นการอ่านแบบ ประมาณการ ว่าสินค้าแต่ละชนิดผลิตที่ไหน และทับซ้อนกันได้ น้ำตาลเป็นราคาอ้อยประกาศของ สอน. ปีละหนึ่งจุด จึงไม่มีการเปลี่ยนแปลงหกเดือนให้แสดง</a:t>
+              <a:t>ราคาหน้าฟาร์ม วัดจริง — ราคารายวันของ NABC เฉลี่ยเป็นรายเดือน หน่วยเป็นบาทตามที่เผยแพร่ (ไม่มีการแปลงสกุลเงิน) ราคาล่าสุด 2026-08-24, รุ่นข้อมูลย้อนหลัง 2026-08-23 ราคาหน้าฟาร์ม (ราคาที่เกษตรกรขายได้) คือเงินที่เกษตรกรได้รับเมื่อขายครั้งแรก ก่อนพ่อค้าคนกลาง โรงสี หรือค่าขนส่งจะหักส่วนแบ่ง — ไม่ใช่ดัชนีโลก และไม่ใช่ราคาในซูเปอร์มาร์เก็ต แหล่งผลิตเป็นการอ่านแบบ ประมาณการ ว่าสินค้าแต่ละชนิดผลิตที่ไหน และทับซ้อนกันได้ น้ำตาลเป็นราคาอ้อยประกาศของ สอน. ปีละหนึ่งจุด จึงไม่มีการเปลี่ยนแปลงหกเดือนให้แสดง</a:t>
             </a:r>
           </a:p>
         </p:txBody>

</xml_diff>

<commit_message>
deck(mcom): rebuild — the data moved past the committed figures (run 32906371319)
</commit_message>
<xml_diff>
--- a/docs/decks/mcom-2026-08-05-macro-TH.pptx
+++ b/docs/decks/mcom-2026-08-05-macro-TH.pptx
@@ -6240,7 +6240,7 @@
                 </a:solidFill>
                 <a:latin typeface="Kanit"/>
               </a:rPr>
-              <a:t>134</a:t>
+              <a:t>133</a:t>
             </a:r>
           </a:p>
         </p:txBody>
@@ -6279,7 +6279,7 @@
                 </a:solidFill>
                 <a:latin typeface="Kanit"/>
               </a:rPr>
-              <a:t>จาก 795 (16.9%) · เรียลไทม์ · 2026-08-25</a:t>
+              <a:t>จาก 795 (16.7%) · เรียลไทม์ · 2026-08-26</a:t>
             </a:r>
           </a:p>
         </p:txBody>
@@ -6405,7 +6405,7 @@
                 </a:solidFill>
                 <a:latin typeface="Kanit"/>
               </a:rPr>
-              <a:t>15</a:t>
+              <a:t>14</a:t>
             </a:r>
           </a:p>
         </p:txBody>
@@ -6444,7 +6444,7 @@
                 </a:solidFill>
                 <a:latin typeface="Kanit"/>
               </a:rPr>
-              <a:t>ค่าล่าสุดรายวัน · 2026-08-25</a:t>
+              <a:t>ค่าล่าสุดรายวัน · 2026-08-26</a:t>
             </a:r>
           </a:p>
         </p:txBody>
@@ -7882,7 +7882,7 @@
                           </a:solidFill>
                           <a:latin typeface="Kanit"/>
                         </a:rPr>
-                        <a:t>มุกดาหาร</a:t>
+                        <a:t>สกลนคร</a:t>
                       </a:r>
                     </a:p>
                   </a:txBody>
@@ -7905,7 +7905,7 @@
                           </a:solidFill>
                           <a:latin typeface="Kanit"/>
                         </a:rPr>
-                        <a:t>18</a:t>
+                        <a:t>38</a:t>
                       </a:r>
                     </a:p>
                   </a:txBody>
@@ -7928,7 +7928,7 @@
                           </a:solidFill>
                           <a:latin typeface="Kanit"/>
                         </a:rPr>
-                        <a:t>37</a:t>
+                        <a:t>44</a:t>
                       </a:r>
                     </a:p>
                   </a:txBody>
@@ -7951,7 +7951,7 @@
                           </a:solidFill>
                           <a:latin typeface="Kanit"/>
                         </a:rPr>
-                        <a:t>5.6%</a:t>
+                        <a:t>2.6%</a:t>
                       </a:r>
                     </a:p>
                   </a:txBody>
@@ -7974,7 +7974,7 @@
                           </a:solidFill>
                           <a:latin typeface="Kanit"/>
                         </a:rPr>
-                        <a:t>2/2</a:t>
+                        <a:t>7/13</a:t>
                       </a:r>
                     </a:p>
                   </a:txBody>
@@ -8022,7 +8022,7 @@
                           </a:solidFill>
                           <a:latin typeface="Kanit"/>
                         </a:rPr>
-                        <a:t>สกลนคร</a:t>
+                        <a:t>มุกดาหาร</a:t>
                       </a:r>
                     </a:p>
                   </a:txBody>
@@ -8045,7 +8045,7 @@
                           </a:solidFill>
                           <a:latin typeface="Kanit"/>
                         </a:rPr>
-                        <a:t>38</a:t>
+                        <a:t>17</a:t>
                       </a:r>
                     </a:p>
                   </a:txBody>
@@ -8068,7 +8068,7 @@
                           </a:solidFill>
                           <a:latin typeface="Kanit"/>
                         </a:rPr>
-                        <a:t>8</a:t>
+                        <a:t>16</a:t>
                       </a:r>
                     </a:p>
                   </a:txBody>
@@ -8114,7 +8114,7 @@
                           </a:solidFill>
                           <a:latin typeface="Kanit"/>
                         </a:rPr>
-                        <a:t>7/13</a:t>
+                        <a:t>2/2</a:t>
                       </a:r>
                     </a:p>
                   </a:txBody>
@@ -8162,7 +8162,7 @@
                           </a:solidFill>
                           <a:latin typeface="Kanit"/>
                         </a:rPr>
-                        <a:t>สมุทรปราการ</a:t>
+                        <a:t>บึงกาฬ</a:t>
                       </a:r>
                     </a:p>
                   </a:txBody>
@@ -8185,7 +8185,7 @@
                           </a:solidFill>
                           <a:latin typeface="Kanit"/>
                         </a:rPr>
-                        <a:t>16</a:t>
+                        <a:t>10</a:t>
                       </a:r>
                     </a:p>
                   </a:txBody>
@@ -8208,7 +8208,7 @@
                           </a:solidFill>
                           <a:latin typeface="Kanit"/>
                         </a:rPr>
-                        <a:t>1</a:t>
+                        <a:t>41</a:t>
                       </a:r>
                     </a:p>
                   </a:txBody>
@@ -8227,11 +8227,11 @@
                       <a:r>
                         <a:rPr sz="900" b="1">
                           <a:solidFill>
-                            <a:srgbClr val="606060"/>
-                          </a:solidFill>
-                          <a:latin typeface="Kanit"/>
-                        </a:rPr>
-                        <a:t>0.0%</a:t>
+                            <a:srgbClr val="F5C242"/>
+                          </a:solidFill>
+                          <a:latin typeface="Kanit"/>
+                        </a:rPr>
+                        <a:t>20.0%</a:t>
                       </a:r>
                     </a:p>
                   </a:txBody>
@@ -8254,7 +8254,7 @@
                           </a:solidFill>
                           <a:latin typeface="Kanit"/>
                         </a:rPr>
-                        <a:t>4/5</a:t>
+                        <a:t>1/1</a:t>
                       </a:r>
                     </a:p>
                   </a:txBody>
@@ -8273,11 +8273,11 @@
                       <a:r>
                         <a:rPr sz="900" b="1">
                           <a:solidFill>
-                            <a:srgbClr val="CC0000"/>
-                          </a:solidFill>
-                          <a:latin typeface="Kanit"/>
-                        </a:rPr>
-                        <a:t>5</a:t>
+                            <a:srgbClr val="F5C242"/>
+                          </a:solidFill>
+                          <a:latin typeface="Kanit"/>
+                        </a:rPr>
+                        <a:t>4</a:t>
                       </a:r>
                     </a:p>
                   </a:txBody>
@@ -8348,7 +8348,7 @@
                           </a:solidFill>
                           <a:latin typeface="Kanit"/>
                         </a:rPr>
-                        <a:t>40</a:t>
+                        <a:t>78</a:t>
                       </a:r>
                     </a:p>
                   </a:txBody>
@@ -8371,7 +8371,7 @@
                           </a:solidFill>
                           <a:latin typeface="Kanit"/>
                         </a:rPr>
-                        <a:t>4.5%</a:t>
+                        <a:t>9.0%</a:t>
                       </a:r>
                     </a:p>
                   </a:txBody>
@@ -8442,7 +8442,7 @@
                           </a:solidFill>
                           <a:latin typeface="Kanit"/>
                         </a:rPr>
-                        <a:t>สงขลา</a:t>
+                        <a:t>กาญจนบุรี</a:t>
                       </a:r>
                     </a:p>
                   </a:txBody>
@@ -8465,7 +8465,7 @@
                           </a:solidFill>
                           <a:latin typeface="Kanit"/>
                         </a:rPr>
-                        <a:t>95</a:t>
+                        <a:t>87</a:t>
                       </a:r>
                     </a:p>
                   </a:txBody>
@@ -8488,7 +8488,7 @@
                           </a:solidFill>
                           <a:latin typeface="Kanit"/>
                         </a:rPr>
-                        <a:t>40</a:t>
+                        <a:t>66</a:t>
                       </a:r>
                     </a:p>
                   </a:txBody>
@@ -8511,7 +8511,7 @@
                           </a:solidFill>
                           <a:latin typeface="Kanit"/>
                         </a:rPr>
-                        <a:t>2.1%</a:t>
+                        <a:t>6.9%</a:t>
                       </a:r>
                     </a:p>
                   </a:txBody>
@@ -8534,7 +8534,7 @@
                           </a:solidFill>
                           <a:latin typeface="Kanit"/>
                         </a:rPr>
-                        <a:t>3/19</a:t>
+                        <a:t>4/26</a:t>
                       </a:r>
                     </a:p>
                   </a:txBody>
@@ -8582,7 +8582,7 @@
                           </a:solidFill>
                           <a:latin typeface="Kanit"/>
                         </a:rPr>
-                        <a:t>พะเยา</a:t>
+                        <a:t>น่าน</a:t>
                       </a:r>
                     </a:p>
                   </a:txBody>
@@ -8605,7 +8605,7 @@
                           </a:solidFill>
                           <a:latin typeface="Kanit"/>
                         </a:rPr>
-                        <a:t>124</a:t>
+                        <a:t>214</a:t>
                       </a:r>
                     </a:p>
                   </a:txBody>
@@ -8628,7 +8628,7 @@
                           </a:solidFill>
                           <a:latin typeface="Kanit"/>
                         </a:rPr>
-                        <a:t>39</a:t>
+                        <a:t>93</a:t>
                       </a:r>
                     </a:p>
                   </a:txBody>
@@ -8651,7 +8651,7 @@
                           </a:solidFill>
                           <a:latin typeface="Kanit"/>
                         </a:rPr>
-                        <a:t>1.6%</a:t>
+                        <a:t>6.5%</a:t>
                       </a:r>
                     </a:p>
                   </a:txBody>
@@ -8674,7 +8674,7 @@
                           </a:solidFill>
                           <a:latin typeface="Kanit"/>
                         </a:rPr>
-                        <a:t>3/13</a:t>
+                        <a:t>1/28</a:t>
                       </a:r>
                     </a:p>
                   </a:txBody>
@@ -8909,7 +8909,7 @@
                 </a:solidFill>
                 <a:latin typeface="Kanit"/>
               </a:rPr>
-              <a:t>พื้นที่ปลูก วัดจริง (สศก. — ข้อมูลอำเภอ×พืช 3,295 แถว) ภัยแล้งเป็นดัชนี SPEI จาก แบบจำลอง คำนวณจากปริมาณฝนและการคายระเหย ปรับเดือนละครั้ง ดึงข้อมูล 2026-07-20 — เป็นสัญญาณที่ครอบคลุมทั้งประเทศดีที่สุดที่มี แต่ไม่มีใครลงพื้นที่ไปเดินดูอำเภอเหล่านั้น ข้อมูลฝนและระดับน้ำ วัดจริง (ThaiWater เรียลไทม์ ดึงทุกวันและสะสมไว้ — วันที่ดึงไม่สำเร็จจะเว้นเป็นช่องว่าง ไม่ใส่ค่าสมมติ) · ฝนถึง 2026-08-25, ระดับน้ำถึง 2026-08-25 ความเสี่ยงน้ำท่วมเชิงโครงสร้าง วัดจริง (สำมะโนพื้นที่ท่วมซ้ำซาก GISTDA มาตราส่วน 1:50,000 ปี 2005-2016 — เป็นบันทึกภาคพื้นดิน 12 ปี ไม่ใช่การพยากรณ์)</a:t>
+              <a:t>พื้นที่ปลูก วัดจริง (สศก. — ข้อมูลอำเภอ×พืช 3,295 แถว) ภัยแล้งเป็นดัชนี SPEI จาก แบบจำลอง คำนวณจากปริมาณฝนและการคายระเหย ปรับเดือนละครั้ง ดึงข้อมูล 2026-07-20 — เป็นสัญญาณที่ครอบคลุมทั้งประเทศดีที่สุดที่มี แต่ไม่มีใครลงพื้นที่ไปเดินดูอำเภอเหล่านั้น ข้อมูลฝนและระดับน้ำ วัดจริง (ThaiWater เรียลไทม์ ดึงทุกวันและสะสมไว้ — วันที่ดึงไม่สำเร็จจะเว้นเป็นช่องว่าง ไม่ใส่ค่าสมมติ) · ฝนถึง 2026-08-26, ระดับน้ำถึง 2026-08-26 ความเสี่ยงน้ำท่วมเชิงโครงสร้าง วัดจริง (สำมะโนพื้นที่ท่วมซ้ำซาก GISTDA มาตราส่วน 1:50,000 ปี 2005-2016 — เป็นบันทึกภาคพื้นดิน 12 ปี ไม่ใช่การพยากรณ์)</a:t>
             </a:r>
           </a:p>
         </p:txBody>
@@ -32047,7 +32047,7 @@
                 </a:solidFill>
                 <a:latin typeface="Kanit"/>
               </a:rPr>
-              <a:t>รุ่นข้อมูล — ราคาโลก 2026M06 · ราคาหน้าฟาร์มไทย 2026-08-24 · ประวัติราคาไทย 2026-08-23 · ต้นทุนการผลิตพืช สศก. ไจอัป 2568 (ปีเพาะปลูก 2568/69, ประมาณการ สศก. มี.ค. 2569) · ภัยแล้ง 2026-06-21 · เงินเฟ้อ 2026-05 · GDP 2026 ไตรมาส 1 · IMF WEO 2026 · ดัชนีราคาขายต่อ 2026-05 · ยอดจดทะเบียนถึง 2026-01 · หนี้ครัวเรือน สสช. SES 2566 · ค่าจ้าง สสช. LFS 2568 · ข้อมูลตรวจวัด 2026-08-25</a:t>
+              <a:t>รุ่นข้อมูล — ราคาโลก 2026M06 · ราคาหน้าฟาร์มไทย 2026-08-24 · ประวัติราคาไทย 2026-08-23 · ต้นทุนการผลิตพืช สศก. ไจอัป 2568 (ปีเพาะปลูก 2568/69, ประมาณการ สศก. มี.ค. 2569) · ภัยแล้ง 2026-06-21 · เงินเฟ้อ 2026-05 · GDP 2026 ไตรมาส 1 · IMF WEO 2026 · ดัชนีราคาขายต่อ 2026-05 · ยอดจดทะเบียนถึง 2026-01 · หนี้ครัวเรือน สสช. SES 2566 · ค่าจ้าง สสช. LFS 2568 · ข้อมูลตรวจวัด 2026-08-26</a:t>
             </a:r>
           </a:p>
         </p:txBody>
@@ -37087,7 +37087,7 @@
                 </a:solidFill>
                 <a:latin typeface="Kanit"/>
               </a:rPr>
-              <a:t>338 จาก 928 อำเภอ · แม่น้ำเกินระดับ 134 จาก 795 สถานี</a:t>
+              <a:t>338 จาก 928 อำเภอ · แม่น้ำเกินระดับ 133 จาก 795 สถานี</a:t>
             </a:r>
           </a:p>
         </p:txBody>
@@ -38091,7 +38091,7 @@
                           </a:solidFill>
                           <a:latin typeface="Kanit"/>
                         </a:rPr>
-                        <a:t>29/275</a:t>
+                        <a:t>28/275</a:t>
                       </a:r>
                     </a:p>
                   </a:txBody>
@@ -38555,7 +38555,7 @@
                           </a:solidFill>
                           <a:latin typeface="Kanit"/>
                         </a:rPr>
-                        <a:t>8/51</a:t>
+                        <a:t>7/51</a:t>
                       </a:r>
                     </a:p>
                   </a:txBody>
@@ -38787,7 +38787,7 @@
                           </a:solidFill>
                           <a:latin typeface="Kanit"/>
                         </a:rPr>
-                        <a:t>42/145</a:t>
+                        <a:t>43/145</a:t>
                       </a:r>
                     </a:p>
                   </a:txBody>

</xml_diff>

<commit_message>
deck(mcom): rebuild — the data moved past the committed figures (run 32906371319) (#633)
Co-authored-by: github-actions[bot] <41898282+github-actions[bot]@users.noreply.github.com>
</commit_message>
<xml_diff>
--- a/docs/decks/mcom-2026-08-05-macro-TH.pptx
+++ b/docs/decks/mcom-2026-08-05-macro-TH.pptx
@@ -6240,7 +6240,7 @@
                 </a:solidFill>
                 <a:latin typeface="Kanit"/>
               </a:rPr>
-              <a:t>134</a:t>
+              <a:t>133</a:t>
             </a:r>
           </a:p>
         </p:txBody>
@@ -6279,7 +6279,7 @@
                 </a:solidFill>
                 <a:latin typeface="Kanit"/>
               </a:rPr>
-              <a:t>จาก 795 (16.9%) · เรียลไทม์ · 2026-08-25</a:t>
+              <a:t>จาก 795 (16.7%) · เรียลไทม์ · 2026-08-26</a:t>
             </a:r>
           </a:p>
         </p:txBody>
@@ -6405,7 +6405,7 @@
                 </a:solidFill>
                 <a:latin typeface="Kanit"/>
               </a:rPr>
-              <a:t>15</a:t>
+              <a:t>14</a:t>
             </a:r>
           </a:p>
         </p:txBody>
@@ -6444,7 +6444,7 @@
                 </a:solidFill>
                 <a:latin typeface="Kanit"/>
               </a:rPr>
-              <a:t>ค่าล่าสุดรายวัน · 2026-08-25</a:t>
+              <a:t>ค่าล่าสุดรายวัน · 2026-08-26</a:t>
             </a:r>
           </a:p>
         </p:txBody>
@@ -7882,7 +7882,7 @@
                           </a:solidFill>
                           <a:latin typeface="Kanit"/>
                         </a:rPr>
-                        <a:t>มุกดาหาร</a:t>
+                        <a:t>สกลนคร</a:t>
                       </a:r>
                     </a:p>
                   </a:txBody>
@@ -7905,7 +7905,7 @@
                           </a:solidFill>
                           <a:latin typeface="Kanit"/>
                         </a:rPr>
-                        <a:t>18</a:t>
+                        <a:t>38</a:t>
                       </a:r>
                     </a:p>
                   </a:txBody>
@@ -7928,7 +7928,7 @@
                           </a:solidFill>
                           <a:latin typeface="Kanit"/>
                         </a:rPr>
-                        <a:t>37</a:t>
+                        <a:t>44</a:t>
                       </a:r>
                     </a:p>
                   </a:txBody>
@@ -7951,7 +7951,7 @@
                           </a:solidFill>
                           <a:latin typeface="Kanit"/>
                         </a:rPr>
-                        <a:t>5.6%</a:t>
+                        <a:t>2.6%</a:t>
                       </a:r>
                     </a:p>
                   </a:txBody>
@@ -7974,7 +7974,7 @@
                           </a:solidFill>
                           <a:latin typeface="Kanit"/>
                         </a:rPr>
-                        <a:t>2/2</a:t>
+                        <a:t>7/13</a:t>
                       </a:r>
                     </a:p>
                   </a:txBody>
@@ -8022,7 +8022,7 @@
                           </a:solidFill>
                           <a:latin typeface="Kanit"/>
                         </a:rPr>
-                        <a:t>สกลนคร</a:t>
+                        <a:t>มุกดาหาร</a:t>
                       </a:r>
                     </a:p>
                   </a:txBody>
@@ -8045,7 +8045,7 @@
                           </a:solidFill>
                           <a:latin typeface="Kanit"/>
                         </a:rPr>
-                        <a:t>38</a:t>
+                        <a:t>17</a:t>
                       </a:r>
                     </a:p>
                   </a:txBody>
@@ -8068,7 +8068,7 @@
                           </a:solidFill>
                           <a:latin typeface="Kanit"/>
                         </a:rPr>
-                        <a:t>8</a:t>
+                        <a:t>16</a:t>
                       </a:r>
                     </a:p>
                   </a:txBody>
@@ -8114,7 +8114,7 @@
                           </a:solidFill>
                           <a:latin typeface="Kanit"/>
                         </a:rPr>
-                        <a:t>7/13</a:t>
+                        <a:t>2/2</a:t>
                       </a:r>
                     </a:p>
                   </a:txBody>
@@ -8162,7 +8162,7 @@
                           </a:solidFill>
                           <a:latin typeface="Kanit"/>
                         </a:rPr>
-                        <a:t>สมุทรปราการ</a:t>
+                        <a:t>บึงกาฬ</a:t>
                       </a:r>
                     </a:p>
                   </a:txBody>
@@ -8185,7 +8185,7 @@
                           </a:solidFill>
                           <a:latin typeface="Kanit"/>
                         </a:rPr>
-                        <a:t>16</a:t>
+                        <a:t>10</a:t>
                       </a:r>
                     </a:p>
                   </a:txBody>
@@ -8208,7 +8208,7 @@
                           </a:solidFill>
                           <a:latin typeface="Kanit"/>
                         </a:rPr>
-                        <a:t>1</a:t>
+                        <a:t>41</a:t>
                       </a:r>
                     </a:p>
                   </a:txBody>
@@ -8227,11 +8227,11 @@
                       <a:r>
                         <a:rPr sz="900" b="1">
                           <a:solidFill>
-                            <a:srgbClr val="606060"/>
-                          </a:solidFill>
-                          <a:latin typeface="Kanit"/>
-                        </a:rPr>
-                        <a:t>0.0%</a:t>
+                            <a:srgbClr val="F5C242"/>
+                          </a:solidFill>
+                          <a:latin typeface="Kanit"/>
+                        </a:rPr>
+                        <a:t>20.0%</a:t>
                       </a:r>
                     </a:p>
                   </a:txBody>
@@ -8254,7 +8254,7 @@
                           </a:solidFill>
                           <a:latin typeface="Kanit"/>
                         </a:rPr>
-                        <a:t>4/5</a:t>
+                        <a:t>1/1</a:t>
                       </a:r>
                     </a:p>
                   </a:txBody>
@@ -8273,11 +8273,11 @@
                       <a:r>
                         <a:rPr sz="900" b="1">
                           <a:solidFill>
-                            <a:srgbClr val="CC0000"/>
-                          </a:solidFill>
-                          <a:latin typeface="Kanit"/>
-                        </a:rPr>
-                        <a:t>5</a:t>
+                            <a:srgbClr val="F5C242"/>
+                          </a:solidFill>
+                          <a:latin typeface="Kanit"/>
+                        </a:rPr>
+                        <a:t>4</a:t>
                       </a:r>
                     </a:p>
                   </a:txBody>
@@ -8348,7 +8348,7 @@
                           </a:solidFill>
                           <a:latin typeface="Kanit"/>
                         </a:rPr>
-                        <a:t>40</a:t>
+                        <a:t>78</a:t>
                       </a:r>
                     </a:p>
                   </a:txBody>
@@ -8371,7 +8371,7 @@
                           </a:solidFill>
                           <a:latin typeface="Kanit"/>
                         </a:rPr>
-                        <a:t>4.5%</a:t>
+                        <a:t>9.0%</a:t>
                       </a:r>
                     </a:p>
                   </a:txBody>
@@ -8442,7 +8442,7 @@
                           </a:solidFill>
                           <a:latin typeface="Kanit"/>
                         </a:rPr>
-                        <a:t>สงขลา</a:t>
+                        <a:t>กาญจนบุรี</a:t>
                       </a:r>
                     </a:p>
                   </a:txBody>
@@ -8465,7 +8465,7 @@
                           </a:solidFill>
                           <a:latin typeface="Kanit"/>
                         </a:rPr>
-                        <a:t>95</a:t>
+                        <a:t>87</a:t>
                       </a:r>
                     </a:p>
                   </a:txBody>
@@ -8488,7 +8488,7 @@
                           </a:solidFill>
                           <a:latin typeface="Kanit"/>
                         </a:rPr>
-                        <a:t>40</a:t>
+                        <a:t>66</a:t>
                       </a:r>
                     </a:p>
                   </a:txBody>
@@ -8511,7 +8511,7 @@
                           </a:solidFill>
                           <a:latin typeface="Kanit"/>
                         </a:rPr>
-                        <a:t>2.1%</a:t>
+                        <a:t>6.9%</a:t>
                       </a:r>
                     </a:p>
                   </a:txBody>
@@ -8534,7 +8534,7 @@
                           </a:solidFill>
                           <a:latin typeface="Kanit"/>
                         </a:rPr>
-                        <a:t>3/19</a:t>
+                        <a:t>4/26</a:t>
                       </a:r>
                     </a:p>
                   </a:txBody>
@@ -8582,7 +8582,7 @@
                           </a:solidFill>
                           <a:latin typeface="Kanit"/>
                         </a:rPr>
-                        <a:t>พะเยา</a:t>
+                        <a:t>น่าน</a:t>
                       </a:r>
                     </a:p>
                   </a:txBody>
@@ -8605,7 +8605,7 @@
                           </a:solidFill>
                           <a:latin typeface="Kanit"/>
                         </a:rPr>
-                        <a:t>124</a:t>
+                        <a:t>214</a:t>
                       </a:r>
                     </a:p>
                   </a:txBody>
@@ -8628,7 +8628,7 @@
                           </a:solidFill>
                           <a:latin typeface="Kanit"/>
                         </a:rPr>
-                        <a:t>39</a:t>
+                        <a:t>93</a:t>
                       </a:r>
                     </a:p>
                   </a:txBody>
@@ -8651,7 +8651,7 @@
                           </a:solidFill>
                           <a:latin typeface="Kanit"/>
                         </a:rPr>
-                        <a:t>1.6%</a:t>
+                        <a:t>6.5%</a:t>
                       </a:r>
                     </a:p>
                   </a:txBody>
@@ -8674,7 +8674,7 @@
                           </a:solidFill>
                           <a:latin typeface="Kanit"/>
                         </a:rPr>
-                        <a:t>3/13</a:t>
+                        <a:t>1/28</a:t>
                       </a:r>
                     </a:p>
                   </a:txBody>
@@ -8909,7 +8909,7 @@
                 </a:solidFill>
                 <a:latin typeface="Kanit"/>
               </a:rPr>
-              <a:t>พื้นที่ปลูก วัดจริง (สศก. — ข้อมูลอำเภอ×พืช 3,295 แถว) ภัยแล้งเป็นดัชนี SPEI จาก แบบจำลอง คำนวณจากปริมาณฝนและการคายระเหย ปรับเดือนละครั้ง ดึงข้อมูล 2026-07-20 — เป็นสัญญาณที่ครอบคลุมทั้งประเทศดีที่สุดที่มี แต่ไม่มีใครลงพื้นที่ไปเดินดูอำเภอเหล่านั้น ข้อมูลฝนและระดับน้ำ วัดจริง (ThaiWater เรียลไทม์ ดึงทุกวันและสะสมไว้ — วันที่ดึงไม่สำเร็จจะเว้นเป็นช่องว่าง ไม่ใส่ค่าสมมติ) · ฝนถึง 2026-08-25, ระดับน้ำถึง 2026-08-25 ความเสี่ยงน้ำท่วมเชิงโครงสร้าง วัดจริง (สำมะโนพื้นที่ท่วมซ้ำซาก GISTDA มาตราส่วน 1:50,000 ปี 2005-2016 — เป็นบันทึกภาคพื้นดิน 12 ปี ไม่ใช่การพยากรณ์)</a:t>
+              <a:t>พื้นที่ปลูก วัดจริง (สศก. — ข้อมูลอำเภอ×พืช 3,295 แถว) ภัยแล้งเป็นดัชนี SPEI จาก แบบจำลอง คำนวณจากปริมาณฝนและการคายระเหย ปรับเดือนละครั้ง ดึงข้อมูล 2026-07-20 — เป็นสัญญาณที่ครอบคลุมทั้งประเทศดีที่สุดที่มี แต่ไม่มีใครลงพื้นที่ไปเดินดูอำเภอเหล่านั้น ข้อมูลฝนและระดับน้ำ วัดจริง (ThaiWater เรียลไทม์ ดึงทุกวันและสะสมไว้ — วันที่ดึงไม่สำเร็จจะเว้นเป็นช่องว่าง ไม่ใส่ค่าสมมติ) · ฝนถึง 2026-08-26, ระดับน้ำถึง 2026-08-26 ความเสี่ยงน้ำท่วมเชิงโครงสร้าง วัดจริง (สำมะโนพื้นที่ท่วมซ้ำซาก GISTDA มาตราส่วน 1:50,000 ปี 2005-2016 — เป็นบันทึกภาคพื้นดิน 12 ปี ไม่ใช่การพยากรณ์)</a:t>
             </a:r>
           </a:p>
         </p:txBody>
@@ -32047,7 +32047,7 @@
                 </a:solidFill>
                 <a:latin typeface="Kanit"/>
               </a:rPr>
-              <a:t>รุ่นข้อมูล — ราคาโลก 2026M06 · ราคาหน้าฟาร์มไทย 2026-08-24 · ประวัติราคาไทย 2026-08-23 · ต้นทุนการผลิตพืช สศก. ไจอัป 2568 (ปีเพาะปลูก 2568/69, ประมาณการ สศก. มี.ค. 2569) · ภัยแล้ง 2026-06-21 · เงินเฟ้อ 2026-05 · GDP 2026 ไตรมาส 1 · IMF WEO 2026 · ดัชนีราคาขายต่อ 2026-05 · ยอดจดทะเบียนถึง 2026-01 · หนี้ครัวเรือน สสช. SES 2566 · ค่าจ้าง สสช. LFS 2568 · ข้อมูลตรวจวัด 2026-08-25</a:t>
+              <a:t>รุ่นข้อมูล — ราคาโลก 2026M06 · ราคาหน้าฟาร์มไทย 2026-08-24 · ประวัติราคาไทย 2026-08-23 · ต้นทุนการผลิตพืช สศก. ไจอัป 2568 (ปีเพาะปลูก 2568/69, ประมาณการ สศก. มี.ค. 2569) · ภัยแล้ง 2026-06-21 · เงินเฟ้อ 2026-05 · GDP 2026 ไตรมาส 1 · IMF WEO 2026 · ดัชนีราคาขายต่อ 2026-05 · ยอดจดทะเบียนถึง 2026-01 · หนี้ครัวเรือน สสช. SES 2566 · ค่าจ้าง สสช. LFS 2568 · ข้อมูลตรวจวัด 2026-08-26</a:t>
             </a:r>
           </a:p>
         </p:txBody>
@@ -37087,7 +37087,7 @@
                 </a:solidFill>
                 <a:latin typeface="Kanit"/>
               </a:rPr>
-              <a:t>338 จาก 928 อำเภอ · แม่น้ำเกินระดับ 134 จาก 795 สถานี</a:t>
+              <a:t>338 จาก 928 อำเภอ · แม่น้ำเกินระดับ 133 จาก 795 สถานี</a:t>
             </a:r>
           </a:p>
         </p:txBody>
@@ -38091,7 +38091,7 @@
                           </a:solidFill>
                           <a:latin typeface="Kanit"/>
                         </a:rPr>
-                        <a:t>29/275</a:t>
+                        <a:t>28/275</a:t>
                       </a:r>
                     </a:p>
                   </a:txBody>
@@ -38555,7 +38555,7 @@
                           </a:solidFill>
                           <a:latin typeface="Kanit"/>
                         </a:rPr>
-                        <a:t>8/51</a:t>
+                        <a:t>7/51</a:t>
                       </a:r>
                     </a:p>
                   </a:txBody>
@@ -38787,7 +38787,7 @@
                           </a:solidFill>
                           <a:latin typeface="Kanit"/>
                         </a:rPr>
-                        <a:t>42/145</a:t>
+                        <a:t>43/145</a:t>
                       </a:r>
                     </a:p>
                   </a:txBody>

</xml_diff>

<commit_message>
deck(mcom): rebuild — the data moved past the committed figures (run 32930435448)
</commit_message>
<xml_diff>
--- a/docs/decks/mcom-2026-08-05-macro-TH.pptx
+++ b/docs/decks/mcom-2026-08-05-macro-TH.pptx
@@ -6240,7 +6240,7 @@
                 </a:solidFill>
                 <a:latin typeface="Kanit"/>
               </a:rPr>
-              <a:t>133</a:t>
+              <a:t>126</a:t>
             </a:r>
           </a:p>
         </p:txBody>
@@ -6279,7 +6279,7 @@
                 </a:solidFill>
                 <a:latin typeface="Kanit"/>
               </a:rPr>
-              <a:t>จาก 795 (16.7%) · เรียลไทม์ · 2026-08-26</a:t>
+              <a:t>จาก 795 (15.8%) · เรียลไทม์ · 2026-08-26</a:t>
             </a:r>
           </a:p>
         </p:txBody>
@@ -6405,7 +6405,7 @@
                 </a:solidFill>
                 <a:latin typeface="Kanit"/>
               </a:rPr>
-              <a:t>14</a:t>
+              <a:t>12</a:t>
             </a:r>
           </a:p>
         </p:txBody>
@@ -7928,7 +7928,7 @@
                           </a:solidFill>
                           <a:latin typeface="Kanit"/>
                         </a:rPr>
-                        <a:t>44</a:t>
+                        <a:t>42</a:t>
                       </a:r>
                     </a:p>
                   </a:txBody>
@@ -8045,7 +8045,7 @@
                           </a:solidFill>
                           <a:latin typeface="Kanit"/>
                         </a:rPr>
-                        <a:t>17</a:t>
+                        <a:t>18</a:t>
                       </a:r>
                     </a:p>
                   </a:txBody>
@@ -8068,7 +8068,7 @@
                           </a:solidFill>
                           <a:latin typeface="Kanit"/>
                         </a:rPr>
-                        <a:t>16</a:t>
+                        <a:t>6</a:t>
                       </a:r>
                     </a:p>
                   </a:txBody>
@@ -8231,7 +8231,7 @@
                           </a:solidFill>
                           <a:latin typeface="Kanit"/>
                         </a:rPr>
-                        <a:t>20.0%</a:t>
+                        <a:t>10.0%</a:t>
                       </a:r>
                     </a:p>
                   </a:txBody>
@@ -8302,7 +8302,7 @@
                           </a:solidFill>
                           <a:latin typeface="Kanit"/>
                         </a:rPr>
-                        <a:t>นราธิวาส</a:t>
+                        <a:t>กาญจนบุรี</a:t>
                       </a:r>
                     </a:p>
                   </a:txBody>
@@ -8325,7 +8325,7 @@
                           </a:solidFill>
                           <a:latin typeface="Kanit"/>
                         </a:rPr>
-                        <a:t>67</a:t>
+                        <a:t>86</a:t>
                       </a:r>
                     </a:p>
                   </a:txBody>
@@ -8348,7 +8348,7 @@
                           </a:solidFill>
                           <a:latin typeface="Kanit"/>
                         </a:rPr>
-                        <a:t>78</a:t>
+                        <a:t>81</a:t>
                       </a:r>
                     </a:p>
                   </a:txBody>
@@ -8371,7 +8371,7 @@
                           </a:solidFill>
                           <a:latin typeface="Kanit"/>
                         </a:rPr>
-                        <a:t>9.0%</a:t>
+                        <a:t>9.3%</a:t>
                       </a:r>
                     </a:p>
                   </a:txBody>
@@ -8394,7 +8394,7 @@
                           </a:solidFill>
                           <a:latin typeface="Kanit"/>
                         </a:rPr>
-                        <a:t>5/10</a:t>
+                        <a:t>4/26</a:t>
                       </a:r>
                     </a:p>
                   </a:txBody>
@@ -8442,7 +8442,7 @@
                           </a:solidFill>
                           <a:latin typeface="Kanit"/>
                         </a:rPr>
-                        <a:t>กาญจนบุรี</a:t>
+                        <a:t>นราธิวาส</a:t>
                       </a:r>
                     </a:p>
                   </a:txBody>
@@ -8465,7 +8465,7 @@
                           </a:solidFill>
                           <a:latin typeface="Kanit"/>
                         </a:rPr>
-                        <a:t>87</a:t>
+                        <a:t>67</a:t>
                       </a:r>
                     </a:p>
                   </a:txBody>
@@ -8488,7 +8488,7 @@
                           </a:solidFill>
                           <a:latin typeface="Kanit"/>
                         </a:rPr>
-                        <a:t>66</a:t>
+                        <a:t>78</a:t>
                       </a:r>
                     </a:p>
                   </a:txBody>
@@ -8511,7 +8511,7 @@
                           </a:solidFill>
                           <a:latin typeface="Kanit"/>
                         </a:rPr>
-                        <a:t>6.9%</a:t>
+                        <a:t>9.0%</a:t>
                       </a:r>
                     </a:p>
                   </a:txBody>
@@ -8534,7 +8534,7 @@
                           </a:solidFill>
                           <a:latin typeface="Kanit"/>
                         </a:rPr>
-                        <a:t>4/26</a:t>
+                        <a:t>5/10</a:t>
                       </a:r>
                     </a:p>
                   </a:txBody>
@@ -8605,7 +8605,7 @@
                           </a:solidFill>
                           <a:latin typeface="Kanit"/>
                         </a:rPr>
-                        <a:t>214</a:t>
+                        <a:t>210</a:t>
                       </a:r>
                     </a:p>
                   </a:txBody>
@@ -8651,7 +8651,7 @@
                           </a:solidFill>
                           <a:latin typeface="Kanit"/>
                         </a:rPr>
-                        <a:t>6.5%</a:t>
+                        <a:t>6.7%</a:t>
                       </a:r>
                     </a:p>
                   </a:txBody>
@@ -37087,7 +37087,7 @@
                 </a:solidFill>
                 <a:latin typeface="Kanit"/>
               </a:rPr>
-              <a:t>338 จาก 928 อำเภอ · แม่น้ำเกินระดับ 133 จาก 795 สถานี</a:t>
+              <a:t>338 จาก 928 อำเภอ · แม่น้ำเกินระดับ 126 จาก 795 สถานี</a:t>
             </a:r>
           </a:p>
         </p:txBody>
@@ -38091,7 +38091,7 @@
                           </a:solidFill>
                           <a:latin typeface="Kanit"/>
                         </a:rPr>
-                        <a:t>28/275</a:t>
+                        <a:t>26/275</a:t>
                       </a:r>
                     </a:p>
                   </a:txBody>
@@ -38323,7 +38323,7 @@
                           </a:solidFill>
                           <a:latin typeface="Kanit"/>
                         </a:rPr>
-                        <a:t>26/168</a:t>
+                        <a:t>25/168</a:t>
                       </a:r>
                     </a:p>
                   </a:txBody>
@@ -38555,7 +38555,7 @@
                           </a:solidFill>
                           <a:latin typeface="Kanit"/>
                         </a:rPr>
-                        <a:t>7/51</a:t>
+                        <a:t>6/51</a:t>
                       </a:r>
                     </a:p>
                   </a:txBody>
@@ -38787,7 +38787,7 @@
                           </a:solidFill>
                           <a:latin typeface="Kanit"/>
                         </a:rPr>
-                        <a:t>43/145</a:t>
+                        <a:t>40/145</a:t>
                       </a:r>
                     </a:p>
                   </a:txBody>

</xml_diff>

<commit_message>
deck(mcom): rebuild — the data moved past the committed figures (run 32930435448) (#639)
Co-authored-by: github-actions[bot] <41898282+github-actions[bot]@users.noreply.github.com>
</commit_message>
<xml_diff>
--- a/docs/decks/mcom-2026-08-05-macro-TH.pptx
+++ b/docs/decks/mcom-2026-08-05-macro-TH.pptx
@@ -6240,7 +6240,7 @@
                 </a:solidFill>
                 <a:latin typeface="Kanit"/>
               </a:rPr>
-              <a:t>133</a:t>
+              <a:t>126</a:t>
             </a:r>
           </a:p>
         </p:txBody>
@@ -6279,7 +6279,7 @@
                 </a:solidFill>
                 <a:latin typeface="Kanit"/>
               </a:rPr>
-              <a:t>จาก 795 (16.7%) · เรียลไทม์ · 2026-08-26</a:t>
+              <a:t>จาก 795 (15.8%) · เรียลไทม์ · 2026-08-26</a:t>
             </a:r>
           </a:p>
         </p:txBody>
@@ -6405,7 +6405,7 @@
                 </a:solidFill>
                 <a:latin typeface="Kanit"/>
               </a:rPr>
-              <a:t>14</a:t>
+              <a:t>12</a:t>
             </a:r>
           </a:p>
         </p:txBody>
@@ -7928,7 +7928,7 @@
                           </a:solidFill>
                           <a:latin typeface="Kanit"/>
                         </a:rPr>
-                        <a:t>44</a:t>
+                        <a:t>42</a:t>
                       </a:r>
                     </a:p>
                   </a:txBody>
@@ -8045,7 +8045,7 @@
                           </a:solidFill>
                           <a:latin typeface="Kanit"/>
                         </a:rPr>
-                        <a:t>17</a:t>
+                        <a:t>18</a:t>
                       </a:r>
                     </a:p>
                   </a:txBody>
@@ -8068,7 +8068,7 @@
                           </a:solidFill>
                           <a:latin typeface="Kanit"/>
                         </a:rPr>
-                        <a:t>16</a:t>
+                        <a:t>6</a:t>
                       </a:r>
                     </a:p>
                   </a:txBody>
@@ -8231,7 +8231,7 @@
                           </a:solidFill>
                           <a:latin typeface="Kanit"/>
                         </a:rPr>
-                        <a:t>20.0%</a:t>
+                        <a:t>10.0%</a:t>
                       </a:r>
                     </a:p>
                   </a:txBody>
@@ -8302,7 +8302,7 @@
                           </a:solidFill>
                           <a:latin typeface="Kanit"/>
                         </a:rPr>
-                        <a:t>นราธิวาส</a:t>
+                        <a:t>กาญจนบุรี</a:t>
                       </a:r>
                     </a:p>
                   </a:txBody>
@@ -8325,7 +8325,7 @@
                           </a:solidFill>
                           <a:latin typeface="Kanit"/>
                         </a:rPr>
-                        <a:t>67</a:t>
+                        <a:t>86</a:t>
                       </a:r>
                     </a:p>
                   </a:txBody>
@@ -8348,7 +8348,7 @@
                           </a:solidFill>
                           <a:latin typeface="Kanit"/>
                         </a:rPr>
-                        <a:t>78</a:t>
+                        <a:t>81</a:t>
                       </a:r>
                     </a:p>
                   </a:txBody>
@@ -8371,7 +8371,7 @@
                           </a:solidFill>
                           <a:latin typeface="Kanit"/>
                         </a:rPr>
-                        <a:t>9.0%</a:t>
+                        <a:t>9.3%</a:t>
                       </a:r>
                     </a:p>
                   </a:txBody>
@@ -8394,7 +8394,7 @@
                           </a:solidFill>
                           <a:latin typeface="Kanit"/>
                         </a:rPr>
-                        <a:t>5/10</a:t>
+                        <a:t>4/26</a:t>
                       </a:r>
                     </a:p>
                   </a:txBody>
@@ -8442,7 +8442,7 @@
                           </a:solidFill>
                           <a:latin typeface="Kanit"/>
                         </a:rPr>
-                        <a:t>กาญจนบุรี</a:t>
+                        <a:t>นราธิวาส</a:t>
                       </a:r>
                     </a:p>
                   </a:txBody>
@@ -8465,7 +8465,7 @@
                           </a:solidFill>
                           <a:latin typeface="Kanit"/>
                         </a:rPr>
-                        <a:t>87</a:t>
+                        <a:t>67</a:t>
                       </a:r>
                     </a:p>
                   </a:txBody>
@@ -8488,7 +8488,7 @@
                           </a:solidFill>
                           <a:latin typeface="Kanit"/>
                         </a:rPr>
-                        <a:t>66</a:t>
+                        <a:t>78</a:t>
                       </a:r>
                     </a:p>
                   </a:txBody>
@@ -8511,7 +8511,7 @@
                           </a:solidFill>
                           <a:latin typeface="Kanit"/>
                         </a:rPr>
-                        <a:t>6.9%</a:t>
+                        <a:t>9.0%</a:t>
                       </a:r>
                     </a:p>
                   </a:txBody>
@@ -8534,7 +8534,7 @@
                           </a:solidFill>
                           <a:latin typeface="Kanit"/>
                         </a:rPr>
-                        <a:t>4/26</a:t>
+                        <a:t>5/10</a:t>
                       </a:r>
                     </a:p>
                   </a:txBody>
@@ -8605,7 +8605,7 @@
                           </a:solidFill>
                           <a:latin typeface="Kanit"/>
                         </a:rPr>
-                        <a:t>214</a:t>
+                        <a:t>210</a:t>
                       </a:r>
                     </a:p>
                   </a:txBody>
@@ -8651,7 +8651,7 @@
                           </a:solidFill>
                           <a:latin typeface="Kanit"/>
                         </a:rPr>
-                        <a:t>6.5%</a:t>
+                        <a:t>6.7%</a:t>
                       </a:r>
                     </a:p>
                   </a:txBody>
@@ -37087,7 +37087,7 @@
                 </a:solidFill>
                 <a:latin typeface="Kanit"/>
               </a:rPr>
-              <a:t>338 จาก 928 อำเภอ · แม่น้ำเกินระดับ 133 จาก 795 สถานี</a:t>
+              <a:t>338 จาก 928 อำเภอ · แม่น้ำเกินระดับ 126 จาก 795 สถานี</a:t>
             </a:r>
           </a:p>
         </p:txBody>
@@ -38091,7 +38091,7 @@
                           </a:solidFill>
                           <a:latin typeface="Kanit"/>
                         </a:rPr>
-                        <a:t>28/275</a:t>
+                        <a:t>26/275</a:t>
                       </a:r>
                     </a:p>
                   </a:txBody>
@@ -38323,7 +38323,7 @@
                           </a:solidFill>
                           <a:latin typeface="Kanit"/>
                         </a:rPr>
-                        <a:t>26/168</a:t>
+                        <a:t>25/168</a:t>
                       </a:r>
                     </a:p>
                   </a:txBody>
@@ -38555,7 +38555,7 @@
                           </a:solidFill>
                           <a:latin typeface="Kanit"/>
                         </a:rPr>
-                        <a:t>7/51</a:t>
+                        <a:t>6/51</a:t>
                       </a:r>
                     </a:p>
                   </a:txBody>
@@ -38787,7 +38787,7 @@
                           </a:solidFill>
                           <a:latin typeface="Kanit"/>
                         </a:rPr>
-                        <a:t>43/145</a:t>
+                        <a:t>40/145</a:t>
                       </a:r>
                     </a:p>
                   </a:txBody>

</xml_diff>

<commit_message>
deck(mcom): rebuild — the data moved past the committed figures (run 32990343062)
</commit_message>
<xml_diff>
--- a/docs/decks/mcom-2026-08-05-macro-TH.pptx
+++ b/docs/decks/mcom-2026-08-05-macro-TH.pptx
@@ -6240,7 +6240,7 @@
                 </a:solidFill>
                 <a:latin typeface="Kanit"/>
               </a:rPr>
-              <a:t>126</a:t>
+              <a:t>129</a:t>
             </a:r>
           </a:p>
         </p:txBody>
@@ -6279,7 +6279,7 @@
                 </a:solidFill>
                 <a:latin typeface="Kanit"/>
               </a:rPr>
-              <a:t>จาก 795 (15.8%) · เรียลไทม์ · 2026-08-26</a:t>
+              <a:t>จาก 795 (16.2%) · เรียลไทม์ · 2026-08-26</a:t>
             </a:r>
           </a:p>
         </p:txBody>
@@ -6405,7 +6405,7 @@
                 </a:solidFill>
                 <a:latin typeface="Kanit"/>
               </a:rPr>
-              <a:t>12</a:t>
+              <a:t>14</a:t>
             </a:r>
           </a:p>
         </p:txBody>
@@ -8068,7 +8068,7 @@
                           </a:solidFill>
                           <a:latin typeface="Kanit"/>
                         </a:rPr>
-                        <a:t>6</a:t>
+                        <a:t>2</a:t>
                       </a:r>
                     </a:p>
                   </a:txBody>
@@ -8162,7 +8162,7 @@
                           </a:solidFill>
                           <a:latin typeface="Kanit"/>
                         </a:rPr>
-                        <a:t>บึงกาฬ</a:t>
+                        <a:t>สมุทรปราการ</a:t>
                       </a:r>
                     </a:p>
                   </a:txBody>
@@ -8185,7 +8185,7 @@
                           </a:solidFill>
                           <a:latin typeface="Kanit"/>
                         </a:rPr>
-                        <a:t>10</a:t>
+                        <a:t>15</a:t>
                       </a:r>
                     </a:p>
                   </a:txBody>
@@ -8208,7 +8208,7 @@
                           </a:solidFill>
                           <a:latin typeface="Kanit"/>
                         </a:rPr>
-                        <a:t>41</a:t>
+                        <a:t>6</a:t>
                       </a:r>
                     </a:p>
                   </a:txBody>
@@ -8227,11 +8227,11 @@
                       <a:r>
                         <a:rPr sz="900" b="1">
                           <a:solidFill>
-                            <a:srgbClr val="F5C242"/>
-                          </a:solidFill>
-                          <a:latin typeface="Kanit"/>
-                        </a:rPr>
-                        <a:t>10.0%</a:t>
+                            <a:srgbClr val="606060"/>
+                          </a:solidFill>
+                          <a:latin typeface="Kanit"/>
+                        </a:rPr>
+                        <a:t>0.0%</a:t>
                       </a:r>
                     </a:p>
                   </a:txBody>
@@ -8254,7 +8254,7 @@
                           </a:solidFill>
                           <a:latin typeface="Kanit"/>
                         </a:rPr>
-                        <a:t>1/1</a:t>
+                        <a:t>4/5</a:t>
                       </a:r>
                     </a:p>
                   </a:txBody>
@@ -8273,11 +8273,11 @@
                       <a:r>
                         <a:rPr sz="900" b="1">
                           <a:solidFill>
-                            <a:srgbClr val="F5C242"/>
-                          </a:solidFill>
-                          <a:latin typeface="Kanit"/>
-                        </a:rPr>
-                        <a:t>4</a:t>
+                            <a:srgbClr val="CC0000"/>
+                          </a:solidFill>
+                          <a:latin typeface="Kanit"/>
+                        </a:rPr>
+                        <a:t>5</a:t>
                       </a:r>
                     </a:p>
                   </a:txBody>
@@ -8302,7 +8302,7 @@
                           </a:solidFill>
                           <a:latin typeface="Kanit"/>
                         </a:rPr>
-                        <a:t>กาญจนบุรี</a:t>
+                        <a:t>บึงกาฬ</a:t>
                       </a:r>
                     </a:p>
                   </a:txBody>
@@ -8325,7 +8325,7 @@
                           </a:solidFill>
                           <a:latin typeface="Kanit"/>
                         </a:rPr>
-                        <a:t>86</a:t>
+                        <a:t>10</a:t>
                       </a:r>
                     </a:p>
                   </a:txBody>
@@ -8348,7 +8348,7 @@
                           </a:solidFill>
                           <a:latin typeface="Kanit"/>
                         </a:rPr>
-                        <a:t>81</a:t>
+                        <a:t>41</a:t>
                       </a:r>
                     </a:p>
                   </a:txBody>
@@ -8371,7 +8371,7 @@
                           </a:solidFill>
                           <a:latin typeface="Kanit"/>
                         </a:rPr>
-                        <a:t>9.3%</a:t>
+                        <a:t>20.0%</a:t>
                       </a:r>
                     </a:p>
                   </a:txBody>
@@ -8394,7 +8394,7 @@
                           </a:solidFill>
                           <a:latin typeface="Kanit"/>
                         </a:rPr>
-                        <a:t>4/26</a:t>
+                        <a:t>1/1</a:t>
                       </a:r>
                     </a:p>
                   </a:txBody>
@@ -8442,7 +8442,7 @@
                           </a:solidFill>
                           <a:latin typeface="Kanit"/>
                         </a:rPr>
-                        <a:t>นราธิวาส</a:t>
+                        <a:t>กาญจนบุรี</a:t>
                       </a:r>
                     </a:p>
                   </a:txBody>
@@ -8465,7 +8465,7 @@
                           </a:solidFill>
                           <a:latin typeface="Kanit"/>
                         </a:rPr>
-                        <a:t>67</a:t>
+                        <a:t>87</a:t>
                       </a:r>
                     </a:p>
                   </a:txBody>
@@ -8511,7 +8511,7 @@
                           </a:solidFill>
                           <a:latin typeface="Kanit"/>
                         </a:rPr>
-                        <a:t>9.0%</a:t>
+                        <a:t>11.5%</a:t>
                       </a:r>
                     </a:p>
                   </a:txBody>
@@ -8534,7 +8534,7 @@
                           </a:solidFill>
                           <a:latin typeface="Kanit"/>
                         </a:rPr>
-                        <a:t>5/10</a:t>
+                        <a:t>5/26</a:t>
                       </a:r>
                     </a:p>
                   </a:txBody>
@@ -8582,7 +8582,7 @@
                           </a:solidFill>
                           <a:latin typeface="Kanit"/>
                         </a:rPr>
-                        <a:t>น่าน</a:t>
+                        <a:t>ตาก</a:t>
                       </a:r>
                     </a:p>
                   </a:txBody>
@@ -8605,7 +8605,7 @@
                           </a:solidFill>
                           <a:latin typeface="Kanit"/>
                         </a:rPr>
-                        <a:t>210</a:t>
+                        <a:t>112</a:t>
                       </a:r>
                     </a:p>
                   </a:txBody>
@@ -8628,7 +8628,7 @@
                           </a:solidFill>
                           <a:latin typeface="Kanit"/>
                         </a:rPr>
-                        <a:t>93</a:t>
+                        <a:t>116</a:t>
                       </a:r>
                     </a:p>
                   </a:txBody>
@@ -8651,7 +8651,7 @@
                           </a:solidFill>
                           <a:latin typeface="Kanit"/>
                         </a:rPr>
-                        <a:t>6.7%</a:t>
+                        <a:t>9.8%</a:t>
                       </a:r>
                     </a:p>
                   </a:txBody>
@@ -8674,7 +8674,7 @@
                           </a:solidFill>
                           <a:latin typeface="Kanit"/>
                         </a:rPr>
-                        <a:t>1/28</a:t>
+                        <a:t>1/17</a:t>
                       </a:r>
                     </a:p>
                   </a:txBody>
@@ -31476,7 +31476,7 @@
                 </a:solidFill>
                 <a:latin typeface="Kanit"/>
               </a:rPr>
-              <a:t>รายได้จากพืชค่ากลางเพิ่มขึ้น +17.0% แต่มีสี่จังหวัดที่ลดลง — ทั้งหมดอยู่ในแหล่งปลูกมะพร้าว โดยหนักที่สุดคือสมุทรสงครามที่ −62.5%</a:t>
+              <a:t>รายได้จากพืชค่ากลางเพิ่มขึ้น +17.0% แต่มีสี่จังหวัดที่ลดลง — ทั้งหมดอยู่ในแหล่งปลูกมะพร้าว โดยหนักที่สุดคือสมุทรสงครามที่ −62.7%</a:t>
             </a:r>
           </a:p>
         </p:txBody>
@@ -32047,7 +32047,7 @@
                 </a:solidFill>
                 <a:latin typeface="Kanit"/>
               </a:rPr>
-              <a:t>รุ่นข้อมูล — ราคาโลก 2026M06 · ราคาหน้าฟาร์มไทย 2026-08-24 · ประวัติราคาไทย 2026-08-23 · ต้นทุนการผลิตพืช สศก. ไจอัป 2568 (ปีเพาะปลูก 2568/69, ประมาณการ สศก. มี.ค. 2569) · ภัยแล้ง 2026-06-21 · เงินเฟ้อ 2026-05 · GDP 2026 ไตรมาส 1 · IMF WEO 2026 · ดัชนีราคาขายต่อ 2026-05 · ยอดจดทะเบียนถึง 2026-01 · หนี้ครัวเรือน สสช. SES 2566 · ค่าจ้าง สสช. LFS 2568 · ข้อมูลตรวจวัด 2026-08-26</a:t>
+              <a:t>รุ่นข้อมูล — ราคาโลก 2026M06 · ราคาหน้าฟาร์มไทย 2026-08-26 · ประวัติราคาไทย 2026-08-23 · ต้นทุนการผลิตพืช สศก. ไจอัป 2568 (ปีเพาะปลูก 2568/69, ประมาณการ สศก. มี.ค. 2569) · ภัยแล้ง 2026-06-21 · เงินเฟ้อ 2026-05 · GDP 2026 ไตรมาส 1 · IMF WEO 2026 · ดัชนีราคาขายต่อ 2026-05 · ยอดจดทะเบียนถึง 2026-01 · หนี้ครัวเรือน สสช. SES 2566 · ค่าจ้าง สสช. LFS 2568 · ข้อมูลตรวจวัด 2026-08-26</a:t>
             </a:r>
           </a:p>
         </p:txBody>
@@ -32546,7 +32546,7 @@
               <a:t>Not on the world index — the farm gate (ราคาที่เกษตรกรขายได้) says otherwise.
 • Five of seventeen Thai farm-gate prices are falling year on year.
 • Beef: farm gate −6.1% vs world index +8.8%.
-• Margin over price: a 26% price move becomes an 84% swing in crop income.</a:t>
+• Margin over price: a 26% price move becomes an 87% swing in crop income.</a:t>
             </a:r>
           </a:p>
         </p:txBody>
@@ -37087,7 +37087,7 @@
                 </a:solidFill>
                 <a:latin typeface="Kanit"/>
               </a:rPr>
-              <a:t>338 จาก 928 อำเภอ · แม่น้ำเกินระดับ 126 จาก 795 สถานี</a:t>
+              <a:t>338 จาก 928 อำเภอ · แม่น้ำเกินระดับ 129 จาก 795 สถานี</a:t>
             </a:r>
           </a:p>
         </p:txBody>
@@ -37859,7 +37859,7 @@
                           </a:solidFill>
                           <a:latin typeface="Kanit"/>
                         </a:rPr>
-                        <a:t>29/156</a:t>
+                        <a:t>31/156</a:t>
                       </a:r>
                     </a:p>
                   </a:txBody>
@@ -38091,7 +38091,7 @@
                           </a:solidFill>
                           <a:latin typeface="Kanit"/>
                         </a:rPr>
-                        <a:t>26/275</a:t>
+                        <a:t>24/275</a:t>
                       </a:r>
                     </a:p>
                   </a:txBody>
@@ -38787,7 +38787,7 @@
                           </a:solidFill>
                           <a:latin typeface="Kanit"/>
                         </a:rPr>
-                        <a:t>40/145</a:t>
+                        <a:t>43/145</a:t>
                       </a:r>
                     </a:p>
                   </a:txBody>
@@ -39936,7 +39936,7 @@
                           </a:solidFill>
                           <a:latin typeface="Kanit"/>
                         </a:rPr>
-                        <a:t>−66.9%</a:t>
+                        <a:t>−67.1%</a:t>
                       </a:r>
                     </a:p>
                   </a:txBody>
@@ -40791,7 +40791,7 @@
                 </a:solidFill>
                 <a:latin typeface="Kanit"/>
               </a:rPr>
-              <a:t>ราคา วัดจริง — ราคาหน้าฟาร์มไทยจากราคารายวันของ NABC และราคาอ้อยประกาศของ สอน. ราคาล่าสุด 2026-08-24 การเปลี่ยนแปลงหกเดือนคำนวณจากข้อมูลรายเดือนของ NABC เอง (thai_price_history รุ่นข้อมูล 2026-08-23) พืชที่ไม่มีข้อมูลรายเดือนจะกำกับไว้ ไม่ประมาณการขึ้นมา แหล่งผลิตเป็นการอ่านแบบ ประมาณการ ว่าสินค้าแต่ละชนิดปลูกที่ไหน และแหล่งผลิตทับซ้อนกันได้ บัญชีอาชีพเกษตรเป็นข้อมูลของเราเองและ วัดจริง — บัญชีที่บันทึกอาชีพว่า เกษตร ในจังหวัดแหล่งผลิต จากฐานข้อมูล 382,735 บัญชี ณ 2026-07 ไม่เผยแพร่ช่องที่มีน้อยกว่า 30 บัญชี คนกลุ่มนี้อาศัยอยู่ในพื้นที่ที่ปลูกพืชนั้น แต่ไม่ได้ยืนยันว่าปลูกพืชนั้นเอง</a:t>
+              <a:t>ราคา วัดจริง — ราคาหน้าฟาร์มไทยจากราคารายวันของ NABC และราคาอ้อยประกาศของ สอน. ราคาล่าสุด 2026-08-26 การเปลี่ยนแปลงหกเดือนคำนวณจากข้อมูลรายเดือนของ NABC เอง (thai_price_history รุ่นข้อมูล 2026-08-23) พืชที่ไม่มีข้อมูลรายเดือนจะกำกับไว้ ไม่ประมาณการขึ้นมา แหล่งผลิตเป็นการอ่านแบบ ประมาณการ ว่าสินค้าแต่ละชนิดปลูกที่ไหน และแหล่งผลิตทับซ้อนกันได้ บัญชีอาชีพเกษตรเป็นข้อมูลของเราเองและ วัดจริง — บัญชีที่บันทึกอาชีพว่า เกษตร ในจังหวัดแหล่งผลิต จากฐานข้อมูล 382,735 บัญชี ณ 2026-07 ไม่เผยแพร่ช่องที่มีน้อยกว่า 30 บัญชี คนกลุ่มนี้อาศัยอยู่ในพื้นที่ที่ปลูกพืชนั้น แต่ไม่ได้ยืนยันว่าปลูกพืชนั้นเอง</a:t>
             </a:r>
           </a:p>
         </p:txBody>
@@ -44679,7 +44679,7 @@
                 </a:solidFill>
                 <a:latin typeface="Kanit"/>
               </a:rPr>
-              <a:t>มะพร้าว −66.9% สับปะรด −18.4% อ้อย −17.9% เทียบปีก่อน</a:t>
+              <a:t>มะพร้าว −67.1% สับปะรด −18.4% อ้อย −17.9% เทียบปีก่อน</a:t>
             </a:r>
           </a:p>
         </p:txBody>
@@ -45279,7 +45279,7 @@
                           </a:solidFill>
                           <a:latin typeface="Kanit"/>
                         </a:rPr>
-                        <a:t>+7.0%</a:t>
+                        <a:t>+6.9%</a:t>
                       </a:r>
                     </a:p>
                   </a:txBody>
@@ -45348,7 +45348,7 @@
                           </a:solidFill>
                           <a:latin typeface="Kanit"/>
                         </a:rPr>
-                        <a:t>-62.5%</a:t>
+                        <a:t>-62.7%</a:t>
                       </a:r>
                     </a:p>
                   </a:txBody>
@@ -45419,7 +45419,7 @@
                           </a:solidFill>
                           <a:latin typeface="Kanit"/>
                         </a:rPr>
-                        <a:t>+16.0%</a:t>
+                        <a:t>+16.1%</a:t>
                       </a:r>
                     </a:p>
                   </a:txBody>
@@ -45628,7 +45628,7 @@
                           </a:solidFill>
                           <a:latin typeface="Kanit"/>
                         </a:rPr>
-                        <a:t>+8.9%</a:t>
+                        <a:t>+8.8%</a:t>
                       </a:r>
                     </a:p>
                   </a:txBody>
@@ -45699,7 +45699,7 @@
                           </a:solidFill>
                           <a:latin typeface="Kanit"/>
                         </a:rPr>
-                        <a:t>+25.2%</a:t>
+                        <a:t>+25.1%</a:t>
                       </a:r>
                     </a:p>
                   </a:txBody>
@@ -45768,7 +45768,7 @@
                           </a:solidFill>
                           <a:latin typeface="Kanit"/>
                         </a:rPr>
-                        <a:t>+11.6%</a:t>
+                        <a:t>+11.7%</a:t>
                       </a:r>
                     </a:p>
                   </a:txBody>
@@ -45839,7 +45839,7 @@
                           </a:solidFill>
                           <a:latin typeface="Kanit"/>
                         </a:rPr>
-                        <a:t>+34.8%</a:t>
+                        <a:t>+34.7%</a:t>
                       </a:r>
                     </a:p>
                   </a:txBody>
@@ -45908,7 +45908,7 @@
                           </a:solidFill>
                           <a:latin typeface="Kanit"/>
                         </a:rPr>
-                        <a:t>+27.1%</a:t>
+                        <a:t>+27.0%</a:t>
                       </a:r>
                     </a:p>
                   </a:txBody>
@@ -46084,7 +46084,7 @@
                 </a:solidFill>
                 <a:latin typeface="Kanit"/>
               </a:rPr>
-              <a:t>•  ราคาหน้าฟาร์ม: ยางพารา +40% มันสำปะหลัง +72% ปาล์ม +23% ข้าว +14% รายได้จากพืชเพิ่มขึ้นทุกภาค
+              <a:t>•  ราคาหน้าฟาร์ม: ยางพารา +40% มันสำปะหลัง +73% ปาล์ม +23% ข้าว +14% รายได้จากพืชเพิ่มขึ้นทุกภาค
 •  มีสี่จังหวัดที่ลดลง — ทั้งหมดเป็นมะพร้าว และอยู่ฝั่งอ่าวไทยตะวันตก ราคามะพร้าวลดลง 67%
 •  กำไรบนกระดาษยังไม่ใช่เงินสด — ตารางถัดไปหักราคาด้วยต้นทุน</a:t>
             </a:r>
@@ -46387,7 +46387,7 @@
                           </a:solidFill>
                           <a:latin typeface="Kanit"/>
                         </a:rPr>
-                        <a:t>+18.0%</a:t>
+                        <a:t>+18.2%</a:t>
                       </a:r>
                     </a:p>
                   </a:txBody>
@@ -46876,7 +46876,7 @@
                           </a:solidFill>
                           <a:latin typeface="Kanit"/>
                         </a:rPr>
-                        <a:t>+32.7%</a:t>
+                        <a:t>+32.6%</a:t>
                       </a:r>
                     </a:p>
                   </a:txBody>
@@ -47202,7 +47202,7 @@
                           </a:solidFill>
                           <a:latin typeface="Kanit"/>
                         </a:rPr>
-                        <a:t>+16.0%</a:t>
+                        <a:t>+15.9%</a:t>
                       </a:r>
                     </a:p>
                   </a:txBody>
@@ -48024,7 +48024,7 @@
                 </a:solidFill>
                 <a:latin typeface="Kanit"/>
               </a:rPr>
-              <a:t>เทียบปีก่อน −66.9%</a:t>
+              <a:t>เทียบปีก่อน −67.1%</a:t>
             </a:r>
           </a:p>
         </p:txBody>
@@ -48660,7 +48660,7 @@
                 </a:solidFill>
                 <a:latin typeface="Kanit"/>
               </a:rPr>
-              <a:t>เทียบปีก่อน +1.4%</a:t>
+              <a:t>เทียบปีก่อน +1.3%</a:t>
             </a:r>
           </a:p>
         </p:txBody>
@@ -48900,6 +48900,324 @@
                 </a:solidFill>
                 <a:latin typeface="Kanit"/>
               </a:rPr>
+              <a:t>ไก่เนื้อ</a:t>
+            </a:r>
+          </a:p>
+        </p:txBody>
+      </p:sp>
+      <p:sp>
+        <p:nvSpPr>
+          <p:cNvPr id="37" name="TextBox 36"/>
+          <p:cNvSpPr txBox="1"/>
+          <p:nvPr/>
+        </p:nvSpPr>
+        <p:spPr>
+          <a:xfrm>
+            <a:off x="7318857" y="2112263"/>
+            <a:ext cx="2156155" cy="125730"/>
+          </a:xfrm>
+          <a:prstGeom prst="rect">
+            <a:avLst/>
+          </a:prstGeom>
+          <a:noFill/>
+        </p:spPr>
+        <p:txBody>
+          <a:bodyPr wrap="square" lIns="0" rIns="0" tIns="0" bIns="0" anchor="t">
+            <a:noAutofit/>
+          </a:bodyPr>
+          <a:lstStyle/>
+          <a:p>
+            <a:pPr algn="l">
+              <a:lnSpc>
+                <a:spcPts val="990"/>
+              </a:lnSpc>
+            </a:pPr>
+            <a:r>
+              <a:rPr sz="750" b="0">
+                <a:solidFill>
+                  <a:srgbClr val="606060"/>
+                </a:solidFill>
+                <a:latin typeface="Kanit"/>
+              </a:rPr>
+              <a:t>฿43.00 /กก. · กลาง·ตอ.</a:t>
+            </a:r>
+          </a:p>
+        </p:txBody>
+      </p:sp>
+      <p:sp>
+        <p:nvSpPr>
+          <p:cNvPr id="38" name="TextBox 37"/>
+          <p:cNvSpPr txBox="1"/>
+          <p:nvPr/>
+        </p:nvSpPr>
+        <p:spPr>
+          <a:xfrm>
+            <a:off x="7318857" y="2244851"/>
+            <a:ext cx="1078077" cy="134112"/>
+          </a:xfrm>
+          <a:prstGeom prst="rect">
+            <a:avLst/>
+          </a:prstGeom>
+          <a:noFill/>
+        </p:spPr>
+        <p:txBody>
+          <a:bodyPr wrap="square" lIns="0" rIns="0" tIns="0" bIns="0" anchor="t">
+            <a:noAutofit/>
+          </a:bodyPr>
+          <a:lstStyle/>
+          <a:p>
+            <a:pPr algn="l">
+              <a:lnSpc>
+                <a:spcPts val="1056"/>
+              </a:lnSpc>
+            </a:pPr>
+            <a:r>
+              <a:rPr sz="800" b="1">
+                <a:solidFill>
+                  <a:srgbClr val="15795F"/>
+                </a:solidFill>
+                <a:latin typeface="Kanit"/>
+              </a:rPr>
+              <a:t>เทียบปีก่อน +3.6%</a:t>
+            </a:r>
+          </a:p>
+        </p:txBody>
+      </p:sp>
+      <p:sp>
+        <p:nvSpPr>
+          <p:cNvPr id="39" name="TextBox 38"/>
+          <p:cNvSpPr txBox="1"/>
+          <p:nvPr/>
+        </p:nvSpPr>
+        <p:spPr>
+          <a:xfrm>
+            <a:off x="8396935" y="2244851"/>
+            <a:ext cx="1078077" cy="134112"/>
+          </a:xfrm>
+          <a:prstGeom prst="rect">
+            <a:avLst/>
+          </a:prstGeom>
+          <a:noFill/>
+        </p:spPr>
+        <p:txBody>
+          <a:bodyPr wrap="square" lIns="0" rIns="0" tIns="0" bIns="0" anchor="t">
+            <a:noAutofit/>
+          </a:bodyPr>
+          <a:lstStyle/>
+          <a:p>
+            <a:pPr algn="l">
+              <a:lnSpc>
+                <a:spcPts val="1056"/>
+              </a:lnSpc>
+            </a:pPr>
+            <a:r>
+              <a:rPr sz="800" b="1">
+                <a:solidFill>
+                  <a:srgbClr val="15795F"/>
+                </a:solidFill>
+                <a:latin typeface="Kanit"/>
+              </a:rPr>
+              <a:t>6 เดือน +2.3%</a:t>
+            </a:r>
+          </a:p>
+        </p:txBody>
+      </p:sp>
+      <p:sp>
+        <p:nvSpPr>
+          <p:cNvPr id="40" name="Rectangle 39"/>
+          <p:cNvSpPr/>
+          <p:nvPr/>
+        </p:nvSpPr>
+        <p:spPr>
+          <a:xfrm>
+            <a:off x="7318857" y="2400300"/>
+            <a:ext cx="2156155" cy="548640"/>
+          </a:xfrm>
+          <a:prstGeom prst="rect">
+            <a:avLst/>
+          </a:prstGeom>
+          <a:solidFill>
+            <a:srgbClr val="FBFCFE"/>
+          </a:solidFill>
+          <a:ln w="9525">
+            <a:solidFill>
+              <a:srgbClr val="D9DEE9"/>
+            </a:solidFill>
+          </a:ln>
+          <a:effectLst/>
+        </p:spPr>
+        <p:style>
+          <a:lnRef idx="1">
+            <a:schemeClr val="accent1"/>
+          </a:lnRef>
+          <a:fillRef idx="3">
+            <a:schemeClr val="accent1"/>
+          </a:fillRef>
+          <a:effectRef idx="2">
+            <a:schemeClr val="accent1"/>
+          </a:effectRef>
+          <a:fontRef idx="minor">
+            <a:schemeClr val="lt1"/>
+          </a:fontRef>
+        </p:style>
+        <p:txBody>
+          <a:bodyPr rtlCol="0" anchor="ctr" wrap="none"/>
+          <a:lstStyle/>
+          <a:p>
+            <a:pPr algn="ctr"/>
+          </a:p>
+        </p:txBody>
+      </p:sp>
+      <p:sp>
+        <p:nvSpPr>
+          <p:cNvPr id="41" name="Freeform 40"/>
+          <p:cNvSpPr/>
+          <p:nvPr/>
+        </p:nvSpPr>
+        <p:spPr>
+          <a:xfrm>
+            <a:off x="7364577" y="2446020"/>
+            <a:ext cx="2064715" cy="457200"/>
+          </a:xfrm>
+          <a:custGeom>
+            <a:avLst/>
+            <a:gdLst/>
+            <a:ahLst/>
+            <a:cxnLst/>
+            <a:rect l="l" t="t" r="r" b="b"/>
+            <a:pathLst>
+              <a:path w="2064715" h="457200">
+                <a:moveTo>
+                  <a:pt x="0" y="0"/>
+                </a:moveTo>
+                <a:lnTo>
+                  <a:pt x="412943" y="111737"/>
+                </a:lnTo>
+                <a:lnTo>
+                  <a:pt x="825886" y="304458"/>
+                </a:lnTo>
+                <a:lnTo>
+                  <a:pt x="1238829" y="457200"/>
+                </a:lnTo>
+                <a:lnTo>
+                  <a:pt x="1651772" y="242951"/>
+                </a:lnTo>
+                <a:lnTo>
+                  <a:pt x="2064715" y="88159"/>
+                </a:lnTo>
+              </a:path>
+            </a:pathLst>
+          </a:custGeom>
+          <a:noFill/>
+          <a:ln w="20320">
+            <a:solidFill>
+              <a:srgbClr val="15795F"/>
+            </a:solidFill>
+          </a:ln>
+          <a:effectLst/>
+        </p:spPr>
+        <p:style>
+          <a:lnRef idx="1">
+            <a:schemeClr val="accent1"/>
+          </a:lnRef>
+          <a:fillRef idx="3">
+            <a:schemeClr val="accent1"/>
+          </a:fillRef>
+          <a:effectRef idx="2">
+            <a:schemeClr val="accent1"/>
+          </a:effectRef>
+          <a:fontRef idx="minor">
+            <a:schemeClr val="lt1"/>
+          </a:fontRef>
+        </p:style>
+        <p:txBody>
+          <a:bodyPr rtlCol="0" anchor="ctr"/>
+          <a:lstStyle/>
+          <a:p>
+            <a:pPr algn="ctr"/>
+          </a:p>
+        </p:txBody>
+      </p:sp>
+      <p:sp>
+        <p:nvSpPr>
+          <p:cNvPr id="42" name="Rounded Rectangle 41"/>
+          <p:cNvSpPr/>
+          <p:nvPr/>
+        </p:nvSpPr>
+        <p:spPr>
+          <a:xfrm>
+            <a:off x="9388144" y="2493031"/>
+            <a:ext cx="82296" cy="82296"/>
+          </a:xfrm>
+          <a:prstGeom prst="roundRect">
+            <a:avLst>
+              <a:gd name="adj" fmla="val 50000"/>
+            </a:avLst>
+          </a:prstGeom>
+          <a:solidFill>
+            <a:srgbClr val="15795F"/>
+          </a:solidFill>
+          <a:ln>
+            <a:noFill/>
+          </a:ln>
+          <a:effectLst/>
+        </p:spPr>
+        <p:style>
+          <a:lnRef idx="1">
+            <a:schemeClr val="accent1"/>
+          </a:lnRef>
+          <a:fillRef idx="3">
+            <a:schemeClr val="accent1"/>
+          </a:fillRef>
+          <a:effectRef idx="2">
+            <a:schemeClr val="accent1"/>
+          </a:effectRef>
+          <a:fontRef idx="minor">
+            <a:schemeClr val="lt1"/>
+          </a:fontRef>
+        </p:style>
+        <p:txBody>
+          <a:bodyPr rtlCol="0" anchor="ctr" wrap="none"/>
+          <a:lstStyle/>
+          <a:p>
+            <a:pPr algn="ctr"/>
+          </a:p>
+        </p:txBody>
+      </p:sp>
+      <p:sp>
+        <p:nvSpPr>
+          <p:cNvPr id="43" name="TextBox 42"/>
+          <p:cNvSpPr txBox="1"/>
+          <p:nvPr/>
+        </p:nvSpPr>
+        <p:spPr>
+          <a:xfrm>
+            <a:off x="9621316" y="1970531"/>
+            <a:ext cx="2156155" cy="150876"/>
+          </a:xfrm>
+          <a:prstGeom prst="rect">
+            <a:avLst/>
+          </a:prstGeom>
+          <a:noFill/>
+        </p:spPr>
+        <p:txBody>
+          <a:bodyPr wrap="square" lIns="0" rIns="0" tIns="0" bIns="0" anchor="t">
+            <a:noAutofit/>
+          </a:bodyPr>
+          <a:lstStyle/>
+          <a:p>
+            <a:pPr algn="l">
+              <a:lnSpc>
+                <a:spcPts val="1188"/>
+              </a:lnSpc>
+            </a:pPr>
+            <a:r>
+              <a:rPr sz="900" b="1">
+                <a:solidFill>
+                  <a:srgbClr val="1E2F5C"/>
+                </a:solidFill>
+                <a:latin typeface="Kanit"/>
+              </a:rPr>
               <a:t>ไข่ไก่</a:t>
             </a:r>
           </a:p>
@@ -48907,13 +49225,13 @@
       </p:sp>
       <p:sp>
         <p:nvSpPr>
-          <p:cNvPr id="37" name="TextBox 36"/>
+          <p:cNvPr id="44" name="TextBox 43"/>
           <p:cNvSpPr txBox="1"/>
           <p:nvPr/>
         </p:nvSpPr>
         <p:spPr>
           <a:xfrm>
-            <a:off x="7318857" y="2112263"/>
+            <a:off x="9621316" y="2112263"/>
             <a:ext cx="2156155" cy="125730"/>
           </a:xfrm>
           <a:prstGeom prst="rect">
@@ -48946,13 +49264,13 @@
       </p:sp>
       <p:sp>
         <p:nvSpPr>
-          <p:cNvPr id="38" name="TextBox 37"/>
+          <p:cNvPr id="45" name="TextBox 44"/>
           <p:cNvSpPr txBox="1"/>
           <p:nvPr/>
         </p:nvSpPr>
         <p:spPr>
           <a:xfrm>
-            <a:off x="7318857" y="2244851"/>
+            <a:off x="9621316" y="2244851"/>
             <a:ext cx="1078077" cy="134112"/>
           </a:xfrm>
           <a:prstGeom prst="rect">
@@ -48978,20 +49296,20 @@
                 </a:solidFill>
                 <a:latin typeface="Kanit"/>
               </a:rPr>
-              <a:t>เทียบปีก่อน +3.2%</a:t>
+              <a:t>เทียบปีก่อน +3.7%</a:t>
             </a:r>
           </a:p>
         </p:txBody>
       </p:sp>
       <p:sp>
         <p:nvSpPr>
-          <p:cNvPr id="39" name="TextBox 38"/>
+          <p:cNvPr id="46" name="TextBox 45"/>
           <p:cNvSpPr txBox="1"/>
           <p:nvPr/>
         </p:nvSpPr>
         <p:spPr>
           <a:xfrm>
-            <a:off x="8396935" y="2244851"/>
+            <a:off x="10699394" y="2244851"/>
             <a:ext cx="1078077" cy="134112"/>
           </a:xfrm>
           <a:prstGeom prst="rect">
@@ -49024,13 +49342,13 @@
       </p:sp>
       <p:sp>
         <p:nvSpPr>
-          <p:cNvPr id="40" name="Rectangle 39"/>
+          <p:cNvPr id="47" name="Rectangle 46"/>
           <p:cNvSpPr/>
           <p:nvPr/>
         </p:nvSpPr>
         <p:spPr>
           <a:xfrm>
-            <a:off x="7318857" y="2400300"/>
+            <a:off x="9621316" y="2400300"/>
             <a:ext cx="2156155" cy="548640"/>
           </a:xfrm>
           <a:prstGeom prst="rect">
@@ -49070,13 +49388,13 @@
       </p:sp>
       <p:sp>
         <p:nvSpPr>
-          <p:cNvPr id="41" name="Freeform 40"/>
+          <p:cNvPr id="48" name="Freeform 47"/>
           <p:cNvSpPr/>
           <p:nvPr/>
         </p:nvSpPr>
         <p:spPr>
           <a:xfrm>
-            <a:off x="7364577" y="2446020"/>
+            <a:off x="9667036" y="2446020"/>
             <a:ext cx="2064715" cy="457200"/>
           </a:xfrm>
           <a:custGeom>
@@ -49140,331 +49458,13 @@
       </p:sp>
       <p:sp>
         <p:nvSpPr>
-          <p:cNvPr id="42" name="Rounded Rectangle 41"/>
-          <p:cNvSpPr/>
-          <p:nvPr/>
-        </p:nvSpPr>
-        <p:spPr>
-          <a:xfrm>
-            <a:off x="9388144" y="2404872"/>
-            <a:ext cx="82296" cy="82296"/>
-          </a:xfrm>
-          <a:prstGeom prst="roundRect">
-            <a:avLst>
-              <a:gd name="adj" fmla="val 50000"/>
-            </a:avLst>
-          </a:prstGeom>
-          <a:solidFill>
-            <a:srgbClr val="15795F"/>
-          </a:solidFill>
-          <a:ln>
-            <a:noFill/>
-          </a:ln>
-          <a:effectLst/>
-        </p:spPr>
-        <p:style>
-          <a:lnRef idx="1">
-            <a:schemeClr val="accent1"/>
-          </a:lnRef>
-          <a:fillRef idx="3">
-            <a:schemeClr val="accent1"/>
-          </a:fillRef>
-          <a:effectRef idx="2">
-            <a:schemeClr val="accent1"/>
-          </a:effectRef>
-          <a:fontRef idx="minor">
-            <a:schemeClr val="lt1"/>
-          </a:fontRef>
-        </p:style>
-        <p:txBody>
-          <a:bodyPr rtlCol="0" anchor="ctr" wrap="none"/>
-          <a:lstStyle/>
-          <a:p>
-            <a:pPr algn="ctr"/>
-          </a:p>
-        </p:txBody>
-      </p:sp>
-      <p:sp>
-        <p:nvSpPr>
-          <p:cNvPr id="43" name="TextBox 42"/>
-          <p:cNvSpPr txBox="1"/>
-          <p:nvPr/>
-        </p:nvSpPr>
-        <p:spPr>
-          <a:xfrm>
-            <a:off x="9621316" y="1970531"/>
-            <a:ext cx="2156155" cy="150876"/>
-          </a:xfrm>
-          <a:prstGeom prst="rect">
-            <a:avLst/>
-          </a:prstGeom>
-          <a:noFill/>
-        </p:spPr>
-        <p:txBody>
-          <a:bodyPr wrap="square" lIns="0" rIns="0" tIns="0" bIns="0" anchor="t">
-            <a:noAutofit/>
-          </a:bodyPr>
-          <a:lstStyle/>
-          <a:p>
-            <a:pPr algn="l">
-              <a:lnSpc>
-                <a:spcPts val="1188"/>
-              </a:lnSpc>
-            </a:pPr>
-            <a:r>
-              <a:rPr sz="900" b="1">
-                <a:solidFill>
-                  <a:srgbClr val="1E2F5C"/>
-                </a:solidFill>
-                <a:latin typeface="Kanit"/>
-              </a:rPr>
-              <a:t>ไก่เนื้อ</a:t>
-            </a:r>
-          </a:p>
-        </p:txBody>
-      </p:sp>
-      <p:sp>
-        <p:nvSpPr>
-          <p:cNvPr id="44" name="TextBox 43"/>
-          <p:cNvSpPr txBox="1"/>
-          <p:nvPr/>
-        </p:nvSpPr>
-        <p:spPr>
-          <a:xfrm>
-            <a:off x="9621316" y="2112263"/>
-            <a:ext cx="2156155" cy="125730"/>
-          </a:xfrm>
-          <a:prstGeom prst="rect">
-            <a:avLst/>
-          </a:prstGeom>
-          <a:noFill/>
-        </p:spPr>
-        <p:txBody>
-          <a:bodyPr wrap="square" lIns="0" rIns="0" tIns="0" bIns="0" anchor="t">
-            <a:noAutofit/>
-          </a:bodyPr>
-          <a:lstStyle/>
-          <a:p>
-            <a:pPr algn="l">
-              <a:lnSpc>
-                <a:spcPts val="990"/>
-              </a:lnSpc>
-            </a:pPr>
-            <a:r>
-              <a:rPr sz="750" b="0">
-                <a:solidFill>
-                  <a:srgbClr val="606060"/>
-                </a:solidFill>
-                <a:latin typeface="Kanit"/>
-              </a:rPr>
-              <a:t>฿43.00 /กก. · กลาง·ตอ.</a:t>
-            </a:r>
-          </a:p>
-        </p:txBody>
-      </p:sp>
-      <p:sp>
-        <p:nvSpPr>
-          <p:cNvPr id="45" name="TextBox 44"/>
-          <p:cNvSpPr txBox="1"/>
-          <p:nvPr/>
-        </p:nvSpPr>
-        <p:spPr>
-          <a:xfrm>
-            <a:off x="9621316" y="2244851"/>
-            <a:ext cx="1078077" cy="134112"/>
-          </a:xfrm>
-          <a:prstGeom prst="rect">
-            <a:avLst/>
-          </a:prstGeom>
-          <a:noFill/>
-        </p:spPr>
-        <p:txBody>
-          <a:bodyPr wrap="square" lIns="0" rIns="0" tIns="0" bIns="0" anchor="t">
-            <a:noAutofit/>
-          </a:bodyPr>
-          <a:lstStyle/>
-          <a:p>
-            <a:pPr algn="l">
-              <a:lnSpc>
-                <a:spcPts val="1056"/>
-              </a:lnSpc>
-            </a:pPr>
-            <a:r>
-              <a:rPr sz="800" b="1">
-                <a:solidFill>
-                  <a:srgbClr val="15795F"/>
-                </a:solidFill>
-                <a:latin typeface="Kanit"/>
-              </a:rPr>
-              <a:t>เทียบปีก่อน +3.5%</a:t>
-            </a:r>
-          </a:p>
-        </p:txBody>
-      </p:sp>
-      <p:sp>
-        <p:nvSpPr>
-          <p:cNvPr id="46" name="TextBox 45"/>
-          <p:cNvSpPr txBox="1"/>
-          <p:nvPr/>
-        </p:nvSpPr>
-        <p:spPr>
-          <a:xfrm>
-            <a:off x="10699394" y="2244851"/>
-            <a:ext cx="1078077" cy="134112"/>
-          </a:xfrm>
-          <a:prstGeom prst="rect">
-            <a:avLst/>
-          </a:prstGeom>
-          <a:noFill/>
-        </p:spPr>
-        <p:txBody>
-          <a:bodyPr wrap="square" lIns="0" rIns="0" tIns="0" bIns="0" anchor="t">
-            <a:noAutofit/>
-          </a:bodyPr>
-          <a:lstStyle/>
-          <a:p>
-            <a:pPr algn="l">
-              <a:lnSpc>
-                <a:spcPts val="1056"/>
-              </a:lnSpc>
-            </a:pPr>
-            <a:r>
-              <a:rPr sz="800" b="1">
-                <a:solidFill>
-                  <a:srgbClr val="15795F"/>
-                </a:solidFill>
-                <a:latin typeface="Kanit"/>
-              </a:rPr>
-              <a:t>6 เดือน +2.3%</a:t>
-            </a:r>
-          </a:p>
-        </p:txBody>
-      </p:sp>
-      <p:sp>
-        <p:nvSpPr>
-          <p:cNvPr id="47" name="Rectangle 46"/>
-          <p:cNvSpPr/>
-          <p:nvPr/>
-        </p:nvSpPr>
-        <p:spPr>
-          <a:xfrm>
-            <a:off x="9621316" y="2400300"/>
-            <a:ext cx="2156155" cy="548640"/>
-          </a:xfrm>
-          <a:prstGeom prst="rect">
-            <a:avLst/>
-          </a:prstGeom>
-          <a:solidFill>
-            <a:srgbClr val="FBFCFE"/>
-          </a:solidFill>
-          <a:ln w="9525">
-            <a:solidFill>
-              <a:srgbClr val="D9DEE9"/>
-            </a:solidFill>
-          </a:ln>
-          <a:effectLst/>
-        </p:spPr>
-        <p:style>
-          <a:lnRef idx="1">
-            <a:schemeClr val="accent1"/>
-          </a:lnRef>
-          <a:fillRef idx="3">
-            <a:schemeClr val="accent1"/>
-          </a:fillRef>
-          <a:effectRef idx="2">
-            <a:schemeClr val="accent1"/>
-          </a:effectRef>
-          <a:fontRef idx="minor">
-            <a:schemeClr val="lt1"/>
-          </a:fontRef>
-        </p:style>
-        <p:txBody>
-          <a:bodyPr rtlCol="0" anchor="ctr" wrap="none"/>
-          <a:lstStyle/>
-          <a:p>
-            <a:pPr algn="ctr"/>
-          </a:p>
-        </p:txBody>
-      </p:sp>
-      <p:sp>
-        <p:nvSpPr>
-          <p:cNvPr id="48" name="Freeform 47"/>
-          <p:cNvSpPr/>
-          <p:nvPr/>
-        </p:nvSpPr>
-        <p:spPr>
-          <a:xfrm>
-            <a:off x="9667036" y="2446020"/>
-            <a:ext cx="2064715" cy="457200"/>
-          </a:xfrm>
-          <a:custGeom>
-            <a:avLst/>
-            <a:gdLst/>
-            <a:ahLst/>
-            <a:cxnLst/>
-            <a:rect l="l" t="t" r="r" b="b"/>
-            <a:pathLst>
-              <a:path w="2064715" h="457200">
-                <a:moveTo>
-                  <a:pt x="0" y="0"/>
-                </a:moveTo>
-                <a:lnTo>
-                  <a:pt x="412943" y="111737"/>
-                </a:lnTo>
-                <a:lnTo>
-                  <a:pt x="825886" y="304458"/>
-                </a:lnTo>
-                <a:lnTo>
-                  <a:pt x="1238829" y="457200"/>
-                </a:lnTo>
-                <a:lnTo>
-                  <a:pt x="1651772" y="242951"/>
-                </a:lnTo>
-                <a:lnTo>
-                  <a:pt x="2064715" y="88159"/>
-                </a:lnTo>
-              </a:path>
-            </a:pathLst>
-          </a:custGeom>
-          <a:noFill/>
-          <a:ln w="20320">
-            <a:solidFill>
-              <a:srgbClr val="15795F"/>
-            </a:solidFill>
-          </a:ln>
-          <a:effectLst/>
-        </p:spPr>
-        <p:style>
-          <a:lnRef idx="1">
-            <a:schemeClr val="accent1"/>
-          </a:lnRef>
-          <a:fillRef idx="3">
-            <a:schemeClr val="accent1"/>
-          </a:fillRef>
-          <a:effectRef idx="2">
-            <a:schemeClr val="accent1"/>
-          </a:effectRef>
-          <a:fontRef idx="minor">
-            <a:schemeClr val="lt1"/>
-          </a:fontRef>
-        </p:style>
-        <p:txBody>
-          <a:bodyPr rtlCol="0" anchor="ctr"/>
-          <a:lstStyle/>
-          <a:p>
-            <a:pPr algn="ctr"/>
-          </a:p>
-        </p:txBody>
-      </p:sp>
-      <p:sp>
-        <p:nvSpPr>
           <p:cNvPr id="49" name="Rounded Rectangle 48"/>
           <p:cNvSpPr/>
           <p:nvPr/>
         </p:nvSpPr>
         <p:spPr>
           <a:xfrm>
-            <a:off x="11690603" y="2493031"/>
+            <a:off x="11690603" y="2404872"/>
             <a:ext cx="82296" cy="82296"/>
           </a:xfrm>
           <a:prstGeom prst="roundRect">
@@ -49614,7 +49614,7 @@
                 </a:solidFill>
                 <a:latin typeface="Kanit"/>
               </a:rPr>
-              <a:t>เทียบปีก่อน +8.8%</a:t>
+              <a:t>เทียบปีก่อน +10.6%</a:t>
             </a:r>
           </a:p>
         </p:txBody>
@@ -49932,7 +49932,7 @@
                 </a:solidFill>
                 <a:latin typeface="Kanit"/>
               </a:rPr>
-              <a:t>เทียบปีก่อน +14.4%</a:t>
+              <a:t>เทียบปีก่อน +14.3%</a:t>
             </a:r>
           </a:p>
         </p:txBody>
@@ -50250,7 +50250,7 @@
                 </a:solidFill>
                 <a:latin typeface="Kanit"/>
               </a:rPr>
-              <a:t>เทียบปีก่อน +15.9%</a:t>
+              <a:t>เทียบปีก่อน +16.6%</a:t>
             </a:r>
           </a:p>
         </p:txBody>
@@ -50568,7 +50568,7 @@
                 </a:solidFill>
                 <a:latin typeface="Kanit"/>
               </a:rPr>
-              <a:t>เทียบปีก่อน +23.3%</a:t>
+              <a:t>เทียบปีก่อน +23.2%</a:t>
             </a:r>
           </a:p>
         </p:txBody>
@@ -50886,7 +50886,7 @@
                 </a:solidFill>
                 <a:latin typeface="Kanit"/>
               </a:rPr>
-              <a:t>เทียบปีก่อน +40.2%</a:t>
+              <a:t>เทียบปีก่อน +40.1%</a:t>
             </a:r>
           </a:p>
         </p:txBody>
@@ -51204,7 +51204,7 @@
                 </a:solidFill>
                 <a:latin typeface="Kanit"/>
               </a:rPr>
-              <a:t>เทียบปีก่อน +72.1%</a:t>
+              <a:t>เทียบปีก่อน +73.3%</a:t>
             </a:r>
           </a:p>
         </p:txBody>
@@ -51522,7 +51522,7 @@
                 </a:solidFill>
                 <a:latin typeface="Kanit"/>
               </a:rPr>
-              <a:t>เทียบปีก่อน +102.6%</a:t>
+              <a:t>เทียบปีก่อน +107.4%</a:t>
             </a:r>
           </a:p>
         </p:txBody>
@@ -51886,7 +51886,7 @@
                 </a:solidFill>
                 <a:latin typeface="Kanit"/>
               </a:rPr>
-              <a:t>ราคาหน้าฟาร์ม วัดจริง — ราคารายวันของ NABC เฉลี่ยเป็นรายเดือน หน่วยเป็นบาทตามที่เผยแพร่ (ไม่มีการแปลงสกุลเงิน) ราคาล่าสุด 2026-08-24, รุ่นข้อมูลย้อนหลัง 2026-08-23 ราคาหน้าฟาร์ม (ราคาที่เกษตรกรขายได้) คือเงินที่เกษตรกรได้รับเมื่อขายครั้งแรก ก่อนพ่อค้าคนกลาง โรงสี หรือค่าขนส่งจะหักส่วนแบ่ง — ไม่ใช่ดัชนีโลก และไม่ใช่ราคาในซูเปอร์มาร์เก็ต แหล่งผลิตเป็นการอ่านแบบ ประมาณการ ว่าสินค้าแต่ละชนิดผลิตที่ไหน และทับซ้อนกันได้ น้ำตาลเป็นราคาอ้อยประกาศของ สอน. ปีละหนึ่งจุด จึงไม่มีการเปลี่ยนแปลงหกเดือนให้แสดง</a:t>
+              <a:t>ราคาหน้าฟาร์ม วัดจริง — ราคารายวันของ NABC เฉลี่ยเป็นรายเดือน หน่วยเป็นบาทตามที่เผยแพร่ (ไม่มีการแปลงสกุลเงิน) ราคาล่าสุด 2026-08-26, รุ่นข้อมูลย้อนหลัง 2026-08-23 ราคาหน้าฟาร์ม (ราคาที่เกษตรกรขายได้) คือเงินที่เกษตรกรได้รับเมื่อขายครั้งแรก ก่อนพ่อค้าคนกลาง โรงสี หรือค่าขนส่งจะหักส่วนแบ่ง — ไม่ใช่ดัชนีโลก และไม่ใช่ราคาในซูเปอร์มาร์เก็ต แหล่งผลิตเป็นการอ่านแบบ ประมาณการ ว่าสินค้าแต่ละชนิดผลิตที่ไหน และทับซ้อนกันได้ น้ำตาลเป็นราคาอ้อยประกาศของ สอน. ปีละหนึ่งจุด จึงไม่มีการเปลี่ยนแปลงหกเดือนให้แสดง</a:t>
             </a:r>
           </a:p>
         </p:txBody>

</xml_diff>

<commit_message>
deck(mcom): rebuild — the data moved past the committed figures (run 32990343062) (#647)
Co-authored-by: github-actions[bot] <41898282+github-actions[bot]@users.noreply.github.com>
</commit_message>
<xml_diff>
--- a/docs/decks/mcom-2026-08-05-macro-TH.pptx
+++ b/docs/decks/mcom-2026-08-05-macro-TH.pptx
@@ -6240,7 +6240,7 @@
                 </a:solidFill>
                 <a:latin typeface="Kanit"/>
               </a:rPr>
-              <a:t>126</a:t>
+              <a:t>129</a:t>
             </a:r>
           </a:p>
         </p:txBody>
@@ -6279,7 +6279,7 @@
                 </a:solidFill>
                 <a:latin typeface="Kanit"/>
               </a:rPr>
-              <a:t>จาก 795 (15.8%) · เรียลไทม์ · 2026-08-26</a:t>
+              <a:t>จาก 795 (16.2%) · เรียลไทม์ · 2026-08-26</a:t>
             </a:r>
           </a:p>
         </p:txBody>
@@ -6405,7 +6405,7 @@
                 </a:solidFill>
                 <a:latin typeface="Kanit"/>
               </a:rPr>
-              <a:t>12</a:t>
+              <a:t>14</a:t>
             </a:r>
           </a:p>
         </p:txBody>
@@ -8068,7 +8068,7 @@
                           </a:solidFill>
                           <a:latin typeface="Kanit"/>
                         </a:rPr>
-                        <a:t>6</a:t>
+                        <a:t>2</a:t>
                       </a:r>
                     </a:p>
                   </a:txBody>
@@ -8162,7 +8162,7 @@
                           </a:solidFill>
                           <a:latin typeface="Kanit"/>
                         </a:rPr>
-                        <a:t>บึงกาฬ</a:t>
+                        <a:t>สมุทรปราการ</a:t>
                       </a:r>
                     </a:p>
                   </a:txBody>
@@ -8185,7 +8185,7 @@
                           </a:solidFill>
                           <a:latin typeface="Kanit"/>
                         </a:rPr>
-                        <a:t>10</a:t>
+                        <a:t>15</a:t>
                       </a:r>
                     </a:p>
                   </a:txBody>
@@ -8208,7 +8208,7 @@
                           </a:solidFill>
                           <a:latin typeface="Kanit"/>
                         </a:rPr>
-                        <a:t>41</a:t>
+                        <a:t>6</a:t>
                       </a:r>
                     </a:p>
                   </a:txBody>
@@ -8227,11 +8227,11 @@
                       <a:r>
                         <a:rPr sz="900" b="1">
                           <a:solidFill>
-                            <a:srgbClr val="F5C242"/>
-                          </a:solidFill>
-                          <a:latin typeface="Kanit"/>
-                        </a:rPr>
-                        <a:t>10.0%</a:t>
+                            <a:srgbClr val="606060"/>
+                          </a:solidFill>
+                          <a:latin typeface="Kanit"/>
+                        </a:rPr>
+                        <a:t>0.0%</a:t>
                       </a:r>
                     </a:p>
                   </a:txBody>
@@ -8254,7 +8254,7 @@
                           </a:solidFill>
                           <a:latin typeface="Kanit"/>
                         </a:rPr>
-                        <a:t>1/1</a:t>
+                        <a:t>4/5</a:t>
                       </a:r>
                     </a:p>
                   </a:txBody>
@@ -8273,11 +8273,11 @@
                       <a:r>
                         <a:rPr sz="900" b="1">
                           <a:solidFill>
-                            <a:srgbClr val="F5C242"/>
-                          </a:solidFill>
-                          <a:latin typeface="Kanit"/>
-                        </a:rPr>
-                        <a:t>4</a:t>
+                            <a:srgbClr val="CC0000"/>
+                          </a:solidFill>
+                          <a:latin typeface="Kanit"/>
+                        </a:rPr>
+                        <a:t>5</a:t>
                       </a:r>
                     </a:p>
                   </a:txBody>
@@ -8302,7 +8302,7 @@
                           </a:solidFill>
                           <a:latin typeface="Kanit"/>
                         </a:rPr>
-                        <a:t>กาญจนบุรี</a:t>
+                        <a:t>บึงกาฬ</a:t>
                       </a:r>
                     </a:p>
                   </a:txBody>
@@ -8325,7 +8325,7 @@
                           </a:solidFill>
                           <a:latin typeface="Kanit"/>
                         </a:rPr>
-                        <a:t>86</a:t>
+                        <a:t>10</a:t>
                       </a:r>
                     </a:p>
                   </a:txBody>
@@ -8348,7 +8348,7 @@
                           </a:solidFill>
                           <a:latin typeface="Kanit"/>
                         </a:rPr>
-                        <a:t>81</a:t>
+                        <a:t>41</a:t>
                       </a:r>
                     </a:p>
                   </a:txBody>
@@ -8371,7 +8371,7 @@
                           </a:solidFill>
                           <a:latin typeface="Kanit"/>
                         </a:rPr>
-                        <a:t>9.3%</a:t>
+                        <a:t>20.0%</a:t>
                       </a:r>
                     </a:p>
                   </a:txBody>
@@ -8394,7 +8394,7 @@
                           </a:solidFill>
                           <a:latin typeface="Kanit"/>
                         </a:rPr>
-                        <a:t>4/26</a:t>
+                        <a:t>1/1</a:t>
                       </a:r>
                     </a:p>
                   </a:txBody>
@@ -8442,7 +8442,7 @@
                           </a:solidFill>
                           <a:latin typeface="Kanit"/>
                         </a:rPr>
-                        <a:t>นราธิวาส</a:t>
+                        <a:t>กาญจนบุรี</a:t>
                       </a:r>
                     </a:p>
                   </a:txBody>
@@ -8465,7 +8465,7 @@
                           </a:solidFill>
                           <a:latin typeface="Kanit"/>
                         </a:rPr>
-                        <a:t>67</a:t>
+                        <a:t>87</a:t>
                       </a:r>
                     </a:p>
                   </a:txBody>
@@ -8511,7 +8511,7 @@
                           </a:solidFill>
                           <a:latin typeface="Kanit"/>
                         </a:rPr>
-                        <a:t>9.0%</a:t>
+                        <a:t>11.5%</a:t>
                       </a:r>
                     </a:p>
                   </a:txBody>
@@ -8534,7 +8534,7 @@
                           </a:solidFill>
                           <a:latin typeface="Kanit"/>
                         </a:rPr>
-                        <a:t>5/10</a:t>
+                        <a:t>5/26</a:t>
                       </a:r>
                     </a:p>
                   </a:txBody>
@@ -8582,7 +8582,7 @@
                           </a:solidFill>
                           <a:latin typeface="Kanit"/>
                         </a:rPr>
-                        <a:t>น่าน</a:t>
+                        <a:t>ตาก</a:t>
                       </a:r>
                     </a:p>
                   </a:txBody>
@@ -8605,7 +8605,7 @@
                           </a:solidFill>
                           <a:latin typeface="Kanit"/>
                         </a:rPr>
-                        <a:t>210</a:t>
+                        <a:t>112</a:t>
                       </a:r>
                     </a:p>
                   </a:txBody>
@@ -8628,7 +8628,7 @@
                           </a:solidFill>
                           <a:latin typeface="Kanit"/>
                         </a:rPr>
-                        <a:t>93</a:t>
+                        <a:t>116</a:t>
                       </a:r>
                     </a:p>
                   </a:txBody>
@@ -8651,7 +8651,7 @@
                           </a:solidFill>
                           <a:latin typeface="Kanit"/>
                         </a:rPr>
-                        <a:t>6.7%</a:t>
+                        <a:t>9.8%</a:t>
                       </a:r>
                     </a:p>
                   </a:txBody>
@@ -8674,7 +8674,7 @@
                           </a:solidFill>
                           <a:latin typeface="Kanit"/>
                         </a:rPr>
-                        <a:t>1/28</a:t>
+                        <a:t>1/17</a:t>
                       </a:r>
                     </a:p>
                   </a:txBody>
@@ -31476,7 +31476,7 @@
                 </a:solidFill>
                 <a:latin typeface="Kanit"/>
               </a:rPr>
-              <a:t>รายได้จากพืชค่ากลางเพิ่มขึ้น +17.0% แต่มีสี่จังหวัดที่ลดลง — ทั้งหมดอยู่ในแหล่งปลูกมะพร้าว โดยหนักที่สุดคือสมุทรสงครามที่ −62.5%</a:t>
+              <a:t>รายได้จากพืชค่ากลางเพิ่มขึ้น +17.0% แต่มีสี่จังหวัดที่ลดลง — ทั้งหมดอยู่ในแหล่งปลูกมะพร้าว โดยหนักที่สุดคือสมุทรสงครามที่ −62.7%</a:t>
             </a:r>
           </a:p>
         </p:txBody>
@@ -32047,7 +32047,7 @@
                 </a:solidFill>
                 <a:latin typeface="Kanit"/>
               </a:rPr>
-              <a:t>รุ่นข้อมูล — ราคาโลก 2026M06 · ราคาหน้าฟาร์มไทย 2026-08-24 · ประวัติราคาไทย 2026-08-23 · ต้นทุนการผลิตพืช สศก. ไจอัป 2568 (ปีเพาะปลูก 2568/69, ประมาณการ สศก. มี.ค. 2569) · ภัยแล้ง 2026-06-21 · เงินเฟ้อ 2026-05 · GDP 2026 ไตรมาส 1 · IMF WEO 2026 · ดัชนีราคาขายต่อ 2026-05 · ยอดจดทะเบียนถึง 2026-01 · หนี้ครัวเรือน สสช. SES 2566 · ค่าจ้าง สสช. LFS 2568 · ข้อมูลตรวจวัด 2026-08-26</a:t>
+              <a:t>รุ่นข้อมูล — ราคาโลก 2026M06 · ราคาหน้าฟาร์มไทย 2026-08-26 · ประวัติราคาไทย 2026-08-23 · ต้นทุนการผลิตพืช สศก. ไจอัป 2568 (ปีเพาะปลูก 2568/69, ประมาณการ สศก. มี.ค. 2569) · ภัยแล้ง 2026-06-21 · เงินเฟ้อ 2026-05 · GDP 2026 ไตรมาส 1 · IMF WEO 2026 · ดัชนีราคาขายต่อ 2026-05 · ยอดจดทะเบียนถึง 2026-01 · หนี้ครัวเรือน สสช. SES 2566 · ค่าจ้าง สสช. LFS 2568 · ข้อมูลตรวจวัด 2026-08-26</a:t>
             </a:r>
           </a:p>
         </p:txBody>
@@ -32546,7 +32546,7 @@
               <a:t>Not on the world index — the farm gate (ราคาที่เกษตรกรขายได้) says otherwise.
 • Five of seventeen Thai farm-gate prices are falling year on year.
 • Beef: farm gate −6.1% vs world index +8.8%.
-• Margin over price: a 26% price move becomes an 84% swing in crop income.</a:t>
+• Margin over price: a 26% price move becomes an 87% swing in crop income.</a:t>
             </a:r>
           </a:p>
         </p:txBody>
@@ -37087,7 +37087,7 @@
                 </a:solidFill>
                 <a:latin typeface="Kanit"/>
               </a:rPr>
-              <a:t>338 จาก 928 อำเภอ · แม่น้ำเกินระดับ 126 จาก 795 สถานี</a:t>
+              <a:t>338 จาก 928 อำเภอ · แม่น้ำเกินระดับ 129 จาก 795 สถานี</a:t>
             </a:r>
           </a:p>
         </p:txBody>
@@ -37859,7 +37859,7 @@
                           </a:solidFill>
                           <a:latin typeface="Kanit"/>
                         </a:rPr>
-                        <a:t>29/156</a:t>
+                        <a:t>31/156</a:t>
                       </a:r>
                     </a:p>
                   </a:txBody>
@@ -38091,7 +38091,7 @@
                           </a:solidFill>
                           <a:latin typeface="Kanit"/>
                         </a:rPr>
-                        <a:t>26/275</a:t>
+                        <a:t>24/275</a:t>
                       </a:r>
                     </a:p>
                   </a:txBody>
@@ -38787,7 +38787,7 @@
                           </a:solidFill>
                           <a:latin typeface="Kanit"/>
                         </a:rPr>
-                        <a:t>40/145</a:t>
+                        <a:t>43/145</a:t>
                       </a:r>
                     </a:p>
                   </a:txBody>
@@ -39936,7 +39936,7 @@
                           </a:solidFill>
                           <a:latin typeface="Kanit"/>
                         </a:rPr>
-                        <a:t>−66.9%</a:t>
+                        <a:t>−67.1%</a:t>
                       </a:r>
                     </a:p>
                   </a:txBody>
@@ -40791,7 +40791,7 @@
                 </a:solidFill>
                 <a:latin typeface="Kanit"/>
               </a:rPr>
-              <a:t>ราคา วัดจริง — ราคาหน้าฟาร์มไทยจากราคารายวันของ NABC และราคาอ้อยประกาศของ สอน. ราคาล่าสุด 2026-08-24 การเปลี่ยนแปลงหกเดือนคำนวณจากข้อมูลรายเดือนของ NABC เอง (thai_price_history รุ่นข้อมูล 2026-08-23) พืชที่ไม่มีข้อมูลรายเดือนจะกำกับไว้ ไม่ประมาณการขึ้นมา แหล่งผลิตเป็นการอ่านแบบ ประมาณการ ว่าสินค้าแต่ละชนิดปลูกที่ไหน และแหล่งผลิตทับซ้อนกันได้ บัญชีอาชีพเกษตรเป็นข้อมูลของเราเองและ วัดจริง — บัญชีที่บันทึกอาชีพว่า เกษตร ในจังหวัดแหล่งผลิต จากฐานข้อมูล 382,735 บัญชี ณ 2026-07 ไม่เผยแพร่ช่องที่มีน้อยกว่า 30 บัญชี คนกลุ่มนี้อาศัยอยู่ในพื้นที่ที่ปลูกพืชนั้น แต่ไม่ได้ยืนยันว่าปลูกพืชนั้นเอง</a:t>
+              <a:t>ราคา วัดจริง — ราคาหน้าฟาร์มไทยจากราคารายวันของ NABC และราคาอ้อยประกาศของ สอน. ราคาล่าสุด 2026-08-26 การเปลี่ยนแปลงหกเดือนคำนวณจากข้อมูลรายเดือนของ NABC เอง (thai_price_history รุ่นข้อมูล 2026-08-23) พืชที่ไม่มีข้อมูลรายเดือนจะกำกับไว้ ไม่ประมาณการขึ้นมา แหล่งผลิตเป็นการอ่านแบบ ประมาณการ ว่าสินค้าแต่ละชนิดปลูกที่ไหน และแหล่งผลิตทับซ้อนกันได้ บัญชีอาชีพเกษตรเป็นข้อมูลของเราเองและ วัดจริง — บัญชีที่บันทึกอาชีพว่า เกษตร ในจังหวัดแหล่งผลิต จากฐานข้อมูล 382,735 บัญชี ณ 2026-07 ไม่เผยแพร่ช่องที่มีน้อยกว่า 30 บัญชี คนกลุ่มนี้อาศัยอยู่ในพื้นที่ที่ปลูกพืชนั้น แต่ไม่ได้ยืนยันว่าปลูกพืชนั้นเอง</a:t>
             </a:r>
           </a:p>
         </p:txBody>
@@ -44679,7 +44679,7 @@
                 </a:solidFill>
                 <a:latin typeface="Kanit"/>
               </a:rPr>
-              <a:t>มะพร้าว −66.9% สับปะรด −18.4% อ้อย −17.9% เทียบปีก่อน</a:t>
+              <a:t>มะพร้าว −67.1% สับปะรด −18.4% อ้อย −17.9% เทียบปีก่อน</a:t>
             </a:r>
           </a:p>
         </p:txBody>
@@ -45279,7 +45279,7 @@
                           </a:solidFill>
                           <a:latin typeface="Kanit"/>
                         </a:rPr>
-                        <a:t>+7.0%</a:t>
+                        <a:t>+6.9%</a:t>
                       </a:r>
                     </a:p>
                   </a:txBody>
@@ -45348,7 +45348,7 @@
                           </a:solidFill>
                           <a:latin typeface="Kanit"/>
                         </a:rPr>
-                        <a:t>-62.5%</a:t>
+                        <a:t>-62.7%</a:t>
                       </a:r>
                     </a:p>
                   </a:txBody>
@@ -45419,7 +45419,7 @@
                           </a:solidFill>
                           <a:latin typeface="Kanit"/>
                         </a:rPr>
-                        <a:t>+16.0%</a:t>
+                        <a:t>+16.1%</a:t>
                       </a:r>
                     </a:p>
                   </a:txBody>
@@ -45628,7 +45628,7 @@
                           </a:solidFill>
                           <a:latin typeface="Kanit"/>
                         </a:rPr>
-                        <a:t>+8.9%</a:t>
+                        <a:t>+8.8%</a:t>
                       </a:r>
                     </a:p>
                   </a:txBody>
@@ -45699,7 +45699,7 @@
                           </a:solidFill>
                           <a:latin typeface="Kanit"/>
                         </a:rPr>
-                        <a:t>+25.2%</a:t>
+                        <a:t>+25.1%</a:t>
                       </a:r>
                     </a:p>
                   </a:txBody>
@@ -45768,7 +45768,7 @@
                           </a:solidFill>
                           <a:latin typeface="Kanit"/>
                         </a:rPr>
-                        <a:t>+11.6%</a:t>
+                        <a:t>+11.7%</a:t>
                       </a:r>
                     </a:p>
                   </a:txBody>
@@ -45839,7 +45839,7 @@
                           </a:solidFill>
                           <a:latin typeface="Kanit"/>
                         </a:rPr>
-                        <a:t>+34.8%</a:t>
+                        <a:t>+34.7%</a:t>
                       </a:r>
                     </a:p>
                   </a:txBody>
@@ -45908,7 +45908,7 @@
                           </a:solidFill>
                           <a:latin typeface="Kanit"/>
                         </a:rPr>
-                        <a:t>+27.1%</a:t>
+                        <a:t>+27.0%</a:t>
                       </a:r>
                     </a:p>
                   </a:txBody>
@@ -46084,7 +46084,7 @@
                 </a:solidFill>
                 <a:latin typeface="Kanit"/>
               </a:rPr>
-              <a:t>•  ราคาหน้าฟาร์ม: ยางพารา +40% มันสำปะหลัง +72% ปาล์ม +23% ข้าว +14% รายได้จากพืชเพิ่มขึ้นทุกภาค
+              <a:t>•  ราคาหน้าฟาร์ม: ยางพารา +40% มันสำปะหลัง +73% ปาล์ม +23% ข้าว +14% รายได้จากพืชเพิ่มขึ้นทุกภาค
 •  มีสี่จังหวัดที่ลดลง — ทั้งหมดเป็นมะพร้าว และอยู่ฝั่งอ่าวไทยตะวันตก ราคามะพร้าวลดลง 67%
 •  กำไรบนกระดาษยังไม่ใช่เงินสด — ตารางถัดไปหักราคาด้วยต้นทุน</a:t>
             </a:r>
@@ -46387,7 +46387,7 @@
                           </a:solidFill>
                           <a:latin typeface="Kanit"/>
                         </a:rPr>
-                        <a:t>+18.0%</a:t>
+                        <a:t>+18.2%</a:t>
                       </a:r>
                     </a:p>
                   </a:txBody>
@@ -46876,7 +46876,7 @@
                           </a:solidFill>
                           <a:latin typeface="Kanit"/>
                         </a:rPr>
-                        <a:t>+32.7%</a:t>
+                        <a:t>+32.6%</a:t>
                       </a:r>
                     </a:p>
                   </a:txBody>
@@ -47202,7 +47202,7 @@
                           </a:solidFill>
                           <a:latin typeface="Kanit"/>
                         </a:rPr>
-                        <a:t>+16.0%</a:t>
+                        <a:t>+15.9%</a:t>
                       </a:r>
                     </a:p>
                   </a:txBody>
@@ -48024,7 +48024,7 @@
                 </a:solidFill>
                 <a:latin typeface="Kanit"/>
               </a:rPr>
-              <a:t>เทียบปีก่อน −66.9%</a:t>
+              <a:t>เทียบปีก่อน −67.1%</a:t>
             </a:r>
           </a:p>
         </p:txBody>
@@ -48660,7 +48660,7 @@
                 </a:solidFill>
                 <a:latin typeface="Kanit"/>
               </a:rPr>
-              <a:t>เทียบปีก่อน +1.4%</a:t>
+              <a:t>เทียบปีก่อน +1.3%</a:t>
             </a:r>
           </a:p>
         </p:txBody>
@@ -48900,6 +48900,324 @@
                 </a:solidFill>
                 <a:latin typeface="Kanit"/>
               </a:rPr>
+              <a:t>ไก่เนื้อ</a:t>
+            </a:r>
+          </a:p>
+        </p:txBody>
+      </p:sp>
+      <p:sp>
+        <p:nvSpPr>
+          <p:cNvPr id="37" name="TextBox 36"/>
+          <p:cNvSpPr txBox="1"/>
+          <p:nvPr/>
+        </p:nvSpPr>
+        <p:spPr>
+          <a:xfrm>
+            <a:off x="7318857" y="2112263"/>
+            <a:ext cx="2156155" cy="125730"/>
+          </a:xfrm>
+          <a:prstGeom prst="rect">
+            <a:avLst/>
+          </a:prstGeom>
+          <a:noFill/>
+        </p:spPr>
+        <p:txBody>
+          <a:bodyPr wrap="square" lIns="0" rIns="0" tIns="0" bIns="0" anchor="t">
+            <a:noAutofit/>
+          </a:bodyPr>
+          <a:lstStyle/>
+          <a:p>
+            <a:pPr algn="l">
+              <a:lnSpc>
+                <a:spcPts val="990"/>
+              </a:lnSpc>
+            </a:pPr>
+            <a:r>
+              <a:rPr sz="750" b="0">
+                <a:solidFill>
+                  <a:srgbClr val="606060"/>
+                </a:solidFill>
+                <a:latin typeface="Kanit"/>
+              </a:rPr>
+              <a:t>฿43.00 /กก. · กลาง·ตอ.</a:t>
+            </a:r>
+          </a:p>
+        </p:txBody>
+      </p:sp>
+      <p:sp>
+        <p:nvSpPr>
+          <p:cNvPr id="38" name="TextBox 37"/>
+          <p:cNvSpPr txBox="1"/>
+          <p:nvPr/>
+        </p:nvSpPr>
+        <p:spPr>
+          <a:xfrm>
+            <a:off x="7318857" y="2244851"/>
+            <a:ext cx="1078077" cy="134112"/>
+          </a:xfrm>
+          <a:prstGeom prst="rect">
+            <a:avLst/>
+          </a:prstGeom>
+          <a:noFill/>
+        </p:spPr>
+        <p:txBody>
+          <a:bodyPr wrap="square" lIns="0" rIns="0" tIns="0" bIns="0" anchor="t">
+            <a:noAutofit/>
+          </a:bodyPr>
+          <a:lstStyle/>
+          <a:p>
+            <a:pPr algn="l">
+              <a:lnSpc>
+                <a:spcPts val="1056"/>
+              </a:lnSpc>
+            </a:pPr>
+            <a:r>
+              <a:rPr sz="800" b="1">
+                <a:solidFill>
+                  <a:srgbClr val="15795F"/>
+                </a:solidFill>
+                <a:latin typeface="Kanit"/>
+              </a:rPr>
+              <a:t>เทียบปีก่อน +3.6%</a:t>
+            </a:r>
+          </a:p>
+        </p:txBody>
+      </p:sp>
+      <p:sp>
+        <p:nvSpPr>
+          <p:cNvPr id="39" name="TextBox 38"/>
+          <p:cNvSpPr txBox="1"/>
+          <p:nvPr/>
+        </p:nvSpPr>
+        <p:spPr>
+          <a:xfrm>
+            <a:off x="8396935" y="2244851"/>
+            <a:ext cx="1078077" cy="134112"/>
+          </a:xfrm>
+          <a:prstGeom prst="rect">
+            <a:avLst/>
+          </a:prstGeom>
+          <a:noFill/>
+        </p:spPr>
+        <p:txBody>
+          <a:bodyPr wrap="square" lIns="0" rIns="0" tIns="0" bIns="0" anchor="t">
+            <a:noAutofit/>
+          </a:bodyPr>
+          <a:lstStyle/>
+          <a:p>
+            <a:pPr algn="l">
+              <a:lnSpc>
+                <a:spcPts val="1056"/>
+              </a:lnSpc>
+            </a:pPr>
+            <a:r>
+              <a:rPr sz="800" b="1">
+                <a:solidFill>
+                  <a:srgbClr val="15795F"/>
+                </a:solidFill>
+                <a:latin typeface="Kanit"/>
+              </a:rPr>
+              <a:t>6 เดือน +2.3%</a:t>
+            </a:r>
+          </a:p>
+        </p:txBody>
+      </p:sp>
+      <p:sp>
+        <p:nvSpPr>
+          <p:cNvPr id="40" name="Rectangle 39"/>
+          <p:cNvSpPr/>
+          <p:nvPr/>
+        </p:nvSpPr>
+        <p:spPr>
+          <a:xfrm>
+            <a:off x="7318857" y="2400300"/>
+            <a:ext cx="2156155" cy="548640"/>
+          </a:xfrm>
+          <a:prstGeom prst="rect">
+            <a:avLst/>
+          </a:prstGeom>
+          <a:solidFill>
+            <a:srgbClr val="FBFCFE"/>
+          </a:solidFill>
+          <a:ln w="9525">
+            <a:solidFill>
+              <a:srgbClr val="D9DEE9"/>
+            </a:solidFill>
+          </a:ln>
+          <a:effectLst/>
+        </p:spPr>
+        <p:style>
+          <a:lnRef idx="1">
+            <a:schemeClr val="accent1"/>
+          </a:lnRef>
+          <a:fillRef idx="3">
+            <a:schemeClr val="accent1"/>
+          </a:fillRef>
+          <a:effectRef idx="2">
+            <a:schemeClr val="accent1"/>
+          </a:effectRef>
+          <a:fontRef idx="minor">
+            <a:schemeClr val="lt1"/>
+          </a:fontRef>
+        </p:style>
+        <p:txBody>
+          <a:bodyPr rtlCol="0" anchor="ctr" wrap="none"/>
+          <a:lstStyle/>
+          <a:p>
+            <a:pPr algn="ctr"/>
+          </a:p>
+        </p:txBody>
+      </p:sp>
+      <p:sp>
+        <p:nvSpPr>
+          <p:cNvPr id="41" name="Freeform 40"/>
+          <p:cNvSpPr/>
+          <p:nvPr/>
+        </p:nvSpPr>
+        <p:spPr>
+          <a:xfrm>
+            <a:off x="7364577" y="2446020"/>
+            <a:ext cx="2064715" cy="457200"/>
+          </a:xfrm>
+          <a:custGeom>
+            <a:avLst/>
+            <a:gdLst/>
+            <a:ahLst/>
+            <a:cxnLst/>
+            <a:rect l="l" t="t" r="r" b="b"/>
+            <a:pathLst>
+              <a:path w="2064715" h="457200">
+                <a:moveTo>
+                  <a:pt x="0" y="0"/>
+                </a:moveTo>
+                <a:lnTo>
+                  <a:pt x="412943" y="111737"/>
+                </a:lnTo>
+                <a:lnTo>
+                  <a:pt x="825886" y="304458"/>
+                </a:lnTo>
+                <a:lnTo>
+                  <a:pt x="1238829" y="457200"/>
+                </a:lnTo>
+                <a:lnTo>
+                  <a:pt x="1651772" y="242951"/>
+                </a:lnTo>
+                <a:lnTo>
+                  <a:pt x="2064715" y="88159"/>
+                </a:lnTo>
+              </a:path>
+            </a:pathLst>
+          </a:custGeom>
+          <a:noFill/>
+          <a:ln w="20320">
+            <a:solidFill>
+              <a:srgbClr val="15795F"/>
+            </a:solidFill>
+          </a:ln>
+          <a:effectLst/>
+        </p:spPr>
+        <p:style>
+          <a:lnRef idx="1">
+            <a:schemeClr val="accent1"/>
+          </a:lnRef>
+          <a:fillRef idx="3">
+            <a:schemeClr val="accent1"/>
+          </a:fillRef>
+          <a:effectRef idx="2">
+            <a:schemeClr val="accent1"/>
+          </a:effectRef>
+          <a:fontRef idx="minor">
+            <a:schemeClr val="lt1"/>
+          </a:fontRef>
+        </p:style>
+        <p:txBody>
+          <a:bodyPr rtlCol="0" anchor="ctr"/>
+          <a:lstStyle/>
+          <a:p>
+            <a:pPr algn="ctr"/>
+          </a:p>
+        </p:txBody>
+      </p:sp>
+      <p:sp>
+        <p:nvSpPr>
+          <p:cNvPr id="42" name="Rounded Rectangle 41"/>
+          <p:cNvSpPr/>
+          <p:nvPr/>
+        </p:nvSpPr>
+        <p:spPr>
+          <a:xfrm>
+            <a:off x="9388144" y="2493031"/>
+            <a:ext cx="82296" cy="82296"/>
+          </a:xfrm>
+          <a:prstGeom prst="roundRect">
+            <a:avLst>
+              <a:gd name="adj" fmla="val 50000"/>
+            </a:avLst>
+          </a:prstGeom>
+          <a:solidFill>
+            <a:srgbClr val="15795F"/>
+          </a:solidFill>
+          <a:ln>
+            <a:noFill/>
+          </a:ln>
+          <a:effectLst/>
+        </p:spPr>
+        <p:style>
+          <a:lnRef idx="1">
+            <a:schemeClr val="accent1"/>
+          </a:lnRef>
+          <a:fillRef idx="3">
+            <a:schemeClr val="accent1"/>
+          </a:fillRef>
+          <a:effectRef idx="2">
+            <a:schemeClr val="accent1"/>
+          </a:effectRef>
+          <a:fontRef idx="minor">
+            <a:schemeClr val="lt1"/>
+          </a:fontRef>
+        </p:style>
+        <p:txBody>
+          <a:bodyPr rtlCol="0" anchor="ctr" wrap="none"/>
+          <a:lstStyle/>
+          <a:p>
+            <a:pPr algn="ctr"/>
+          </a:p>
+        </p:txBody>
+      </p:sp>
+      <p:sp>
+        <p:nvSpPr>
+          <p:cNvPr id="43" name="TextBox 42"/>
+          <p:cNvSpPr txBox="1"/>
+          <p:nvPr/>
+        </p:nvSpPr>
+        <p:spPr>
+          <a:xfrm>
+            <a:off x="9621316" y="1970531"/>
+            <a:ext cx="2156155" cy="150876"/>
+          </a:xfrm>
+          <a:prstGeom prst="rect">
+            <a:avLst/>
+          </a:prstGeom>
+          <a:noFill/>
+        </p:spPr>
+        <p:txBody>
+          <a:bodyPr wrap="square" lIns="0" rIns="0" tIns="0" bIns="0" anchor="t">
+            <a:noAutofit/>
+          </a:bodyPr>
+          <a:lstStyle/>
+          <a:p>
+            <a:pPr algn="l">
+              <a:lnSpc>
+                <a:spcPts val="1188"/>
+              </a:lnSpc>
+            </a:pPr>
+            <a:r>
+              <a:rPr sz="900" b="1">
+                <a:solidFill>
+                  <a:srgbClr val="1E2F5C"/>
+                </a:solidFill>
+                <a:latin typeface="Kanit"/>
+              </a:rPr>
               <a:t>ไข่ไก่</a:t>
             </a:r>
           </a:p>
@@ -48907,13 +49225,13 @@
       </p:sp>
       <p:sp>
         <p:nvSpPr>
-          <p:cNvPr id="37" name="TextBox 36"/>
+          <p:cNvPr id="44" name="TextBox 43"/>
           <p:cNvSpPr txBox="1"/>
           <p:nvPr/>
         </p:nvSpPr>
         <p:spPr>
           <a:xfrm>
-            <a:off x="7318857" y="2112263"/>
+            <a:off x="9621316" y="2112263"/>
             <a:ext cx="2156155" cy="125730"/>
           </a:xfrm>
           <a:prstGeom prst="rect">
@@ -48946,13 +49264,13 @@
       </p:sp>
       <p:sp>
         <p:nvSpPr>
-          <p:cNvPr id="38" name="TextBox 37"/>
+          <p:cNvPr id="45" name="TextBox 44"/>
           <p:cNvSpPr txBox="1"/>
           <p:nvPr/>
         </p:nvSpPr>
         <p:spPr>
           <a:xfrm>
-            <a:off x="7318857" y="2244851"/>
+            <a:off x="9621316" y="2244851"/>
             <a:ext cx="1078077" cy="134112"/>
           </a:xfrm>
           <a:prstGeom prst="rect">
@@ -48978,20 +49296,20 @@
                 </a:solidFill>
                 <a:latin typeface="Kanit"/>
               </a:rPr>
-              <a:t>เทียบปีก่อน +3.2%</a:t>
+              <a:t>เทียบปีก่อน +3.7%</a:t>
             </a:r>
           </a:p>
         </p:txBody>
       </p:sp>
       <p:sp>
         <p:nvSpPr>
-          <p:cNvPr id="39" name="TextBox 38"/>
+          <p:cNvPr id="46" name="TextBox 45"/>
           <p:cNvSpPr txBox="1"/>
           <p:nvPr/>
         </p:nvSpPr>
         <p:spPr>
           <a:xfrm>
-            <a:off x="8396935" y="2244851"/>
+            <a:off x="10699394" y="2244851"/>
             <a:ext cx="1078077" cy="134112"/>
           </a:xfrm>
           <a:prstGeom prst="rect">
@@ -49024,13 +49342,13 @@
       </p:sp>
       <p:sp>
         <p:nvSpPr>
-          <p:cNvPr id="40" name="Rectangle 39"/>
+          <p:cNvPr id="47" name="Rectangle 46"/>
           <p:cNvSpPr/>
           <p:nvPr/>
         </p:nvSpPr>
         <p:spPr>
           <a:xfrm>
-            <a:off x="7318857" y="2400300"/>
+            <a:off x="9621316" y="2400300"/>
             <a:ext cx="2156155" cy="548640"/>
           </a:xfrm>
           <a:prstGeom prst="rect">
@@ -49070,13 +49388,13 @@
       </p:sp>
       <p:sp>
         <p:nvSpPr>
-          <p:cNvPr id="41" name="Freeform 40"/>
+          <p:cNvPr id="48" name="Freeform 47"/>
           <p:cNvSpPr/>
           <p:nvPr/>
         </p:nvSpPr>
         <p:spPr>
           <a:xfrm>
-            <a:off x="7364577" y="2446020"/>
+            <a:off x="9667036" y="2446020"/>
             <a:ext cx="2064715" cy="457200"/>
           </a:xfrm>
           <a:custGeom>
@@ -49140,331 +49458,13 @@
       </p:sp>
       <p:sp>
         <p:nvSpPr>
-          <p:cNvPr id="42" name="Rounded Rectangle 41"/>
-          <p:cNvSpPr/>
-          <p:nvPr/>
-        </p:nvSpPr>
-        <p:spPr>
-          <a:xfrm>
-            <a:off x="9388144" y="2404872"/>
-            <a:ext cx="82296" cy="82296"/>
-          </a:xfrm>
-          <a:prstGeom prst="roundRect">
-            <a:avLst>
-              <a:gd name="adj" fmla="val 50000"/>
-            </a:avLst>
-          </a:prstGeom>
-          <a:solidFill>
-            <a:srgbClr val="15795F"/>
-          </a:solidFill>
-          <a:ln>
-            <a:noFill/>
-          </a:ln>
-          <a:effectLst/>
-        </p:spPr>
-        <p:style>
-          <a:lnRef idx="1">
-            <a:schemeClr val="accent1"/>
-          </a:lnRef>
-          <a:fillRef idx="3">
-            <a:schemeClr val="accent1"/>
-          </a:fillRef>
-          <a:effectRef idx="2">
-            <a:schemeClr val="accent1"/>
-          </a:effectRef>
-          <a:fontRef idx="minor">
-            <a:schemeClr val="lt1"/>
-          </a:fontRef>
-        </p:style>
-        <p:txBody>
-          <a:bodyPr rtlCol="0" anchor="ctr" wrap="none"/>
-          <a:lstStyle/>
-          <a:p>
-            <a:pPr algn="ctr"/>
-          </a:p>
-        </p:txBody>
-      </p:sp>
-      <p:sp>
-        <p:nvSpPr>
-          <p:cNvPr id="43" name="TextBox 42"/>
-          <p:cNvSpPr txBox="1"/>
-          <p:nvPr/>
-        </p:nvSpPr>
-        <p:spPr>
-          <a:xfrm>
-            <a:off x="9621316" y="1970531"/>
-            <a:ext cx="2156155" cy="150876"/>
-          </a:xfrm>
-          <a:prstGeom prst="rect">
-            <a:avLst/>
-          </a:prstGeom>
-          <a:noFill/>
-        </p:spPr>
-        <p:txBody>
-          <a:bodyPr wrap="square" lIns="0" rIns="0" tIns="0" bIns="0" anchor="t">
-            <a:noAutofit/>
-          </a:bodyPr>
-          <a:lstStyle/>
-          <a:p>
-            <a:pPr algn="l">
-              <a:lnSpc>
-                <a:spcPts val="1188"/>
-              </a:lnSpc>
-            </a:pPr>
-            <a:r>
-              <a:rPr sz="900" b="1">
-                <a:solidFill>
-                  <a:srgbClr val="1E2F5C"/>
-                </a:solidFill>
-                <a:latin typeface="Kanit"/>
-              </a:rPr>
-              <a:t>ไก่เนื้อ</a:t>
-            </a:r>
-          </a:p>
-        </p:txBody>
-      </p:sp>
-      <p:sp>
-        <p:nvSpPr>
-          <p:cNvPr id="44" name="TextBox 43"/>
-          <p:cNvSpPr txBox="1"/>
-          <p:nvPr/>
-        </p:nvSpPr>
-        <p:spPr>
-          <a:xfrm>
-            <a:off x="9621316" y="2112263"/>
-            <a:ext cx="2156155" cy="125730"/>
-          </a:xfrm>
-          <a:prstGeom prst="rect">
-            <a:avLst/>
-          </a:prstGeom>
-          <a:noFill/>
-        </p:spPr>
-        <p:txBody>
-          <a:bodyPr wrap="square" lIns="0" rIns="0" tIns="0" bIns="0" anchor="t">
-            <a:noAutofit/>
-          </a:bodyPr>
-          <a:lstStyle/>
-          <a:p>
-            <a:pPr algn="l">
-              <a:lnSpc>
-                <a:spcPts val="990"/>
-              </a:lnSpc>
-            </a:pPr>
-            <a:r>
-              <a:rPr sz="750" b="0">
-                <a:solidFill>
-                  <a:srgbClr val="606060"/>
-                </a:solidFill>
-                <a:latin typeface="Kanit"/>
-              </a:rPr>
-              <a:t>฿43.00 /กก. · กลาง·ตอ.</a:t>
-            </a:r>
-          </a:p>
-        </p:txBody>
-      </p:sp>
-      <p:sp>
-        <p:nvSpPr>
-          <p:cNvPr id="45" name="TextBox 44"/>
-          <p:cNvSpPr txBox="1"/>
-          <p:nvPr/>
-        </p:nvSpPr>
-        <p:spPr>
-          <a:xfrm>
-            <a:off x="9621316" y="2244851"/>
-            <a:ext cx="1078077" cy="134112"/>
-          </a:xfrm>
-          <a:prstGeom prst="rect">
-            <a:avLst/>
-          </a:prstGeom>
-          <a:noFill/>
-        </p:spPr>
-        <p:txBody>
-          <a:bodyPr wrap="square" lIns="0" rIns="0" tIns="0" bIns="0" anchor="t">
-            <a:noAutofit/>
-          </a:bodyPr>
-          <a:lstStyle/>
-          <a:p>
-            <a:pPr algn="l">
-              <a:lnSpc>
-                <a:spcPts val="1056"/>
-              </a:lnSpc>
-            </a:pPr>
-            <a:r>
-              <a:rPr sz="800" b="1">
-                <a:solidFill>
-                  <a:srgbClr val="15795F"/>
-                </a:solidFill>
-                <a:latin typeface="Kanit"/>
-              </a:rPr>
-              <a:t>เทียบปีก่อน +3.5%</a:t>
-            </a:r>
-          </a:p>
-        </p:txBody>
-      </p:sp>
-      <p:sp>
-        <p:nvSpPr>
-          <p:cNvPr id="46" name="TextBox 45"/>
-          <p:cNvSpPr txBox="1"/>
-          <p:nvPr/>
-        </p:nvSpPr>
-        <p:spPr>
-          <a:xfrm>
-            <a:off x="10699394" y="2244851"/>
-            <a:ext cx="1078077" cy="134112"/>
-          </a:xfrm>
-          <a:prstGeom prst="rect">
-            <a:avLst/>
-          </a:prstGeom>
-          <a:noFill/>
-        </p:spPr>
-        <p:txBody>
-          <a:bodyPr wrap="square" lIns="0" rIns="0" tIns="0" bIns="0" anchor="t">
-            <a:noAutofit/>
-          </a:bodyPr>
-          <a:lstStyle/>
-          <a:p>
-            <a:pPr algn="l">
-              <a:lnSpc>
-                <a:spcPts val="1056"/>
-              </a:lnSpc>
-            </a:pPr>
-            <a:r>
-              <a:rPr sz="800" b="1">
-                <a:solidFill>
-                  <a:srgbClr val="15795F"/>
-                </a:solidFill>
-                <a:latin typeface="Kanit"/>
-              </a:rPr>
-              <a:t>6 เดือน +2.3%</a:t>
-            </a:r>
-          </a:p>
-        </p:txBody>
-      </p:sp>
-      <p:sp>
-        <p:nvSpPr>
-          <p:cNvPr id="47" name="Rectangle 46"/>
-          <p:cNvSpPr/>
-          <p:nvPr/>
-        </p:nvSpPr>
-        <p:spPr>
-          <a:xfrm>
-            <a:off x="9621316" y="2400300"/>
-            <a:ext cx="2156155" cy="548640"/>
-          </a:xfrm>
-          <a:prstGeom prst="rect">
-            <a:avLst/>
-          </a:prstGeom>
-          <a:solidFill>
-            <a:srgbClr val="FBFCFE"/>
-          </a:solidFill>
-          <a:ln w="9525">
-            <a:solidFill>
-              <a:srgbClr val="D9DEE9"/>
-            </a:solidFill>
-          </a:ln>
-          <a:effectLst/>
-        </p:spPr>
-        <p:style>
-          <a:lnRef idx="1">
-            <a:schemeClr val="accent1"/>
-          </a:lnRef>
-          <a:fillRef idx="3">
-            <a:schemeClr val="accent1"/>
-          </a:fillRef>
-          <a:effectRef idx="2">
-            <a:schemeClr val="accent1"/>
-          </a:effectRef>
-          <a:fontRef idx="minor">
-            <a:schemeClr val="lt1"/>
-          </a:fontRef>
-        </p:style>
-        <p:txBody>
-          <a:bodyPr rtlCol="0" anchor="ctr" wrap="none"/>
-          <a:lstStyle/>
-          <a:p>
-            <a:pPr algn="ctr"/>
-          </a:p>
-        </p:txBody>
-      </p:sp>
-      <p:sp>
-        <p:nvSpPr>
-          <p:cNvPr id="48" name="Freeform 47"/>
-          <p:cNvSpPr/>
-          <p:nvPr/>
-        </p:nvSpPr>
-        <p:spPr>
-          <a:xfrm>
-            <a:off x="9667036" y="2446020"/>
-            <a:ext cx="2064715" cy="457200"/>
-          </a:xfrm>
-          <a:custGeom>
-            <a:avLst/>
-            <a:gdLst/>
-            <a:ahLst/>
-            <a:cxnLst/>
-            <a:rect l="l" t="t" r="r" b="b"/>
-            <a:pathLst>
-              <a:path w="2064715" h="457200">
-                <a:moveTo>
-                  <a:pt x="0" y="0"/>
-                </a:moveTo>
-                <a:lnTo>
-                  <a:pt x="412943" y="111737"/>
-                </a:lnTo>
-                <a:lnTo>
-                  <a:pt x="825886" y="304458"/>
-                </a:lnTo>
-                <a:lnTo>
-                  <a:pt x="1238829" y="457200"/>
-                </a:lnTo>
-                <a:lnTo>
-                  <a:pt x="1651772" y="242951"/>
-                </a:lnTo>
-                <a:lnTo>
-                  <a:pt x="2064715" y="88159"/>
-                </a:lnTo>
-              </a:path>
-            </a:pathLst>
-          </a:custGeom>
-          <a:noFill/>
-          <a:ln w="20320">
-            <a:solidFill>
-              <a:srgbClr val="15795F"/>
-            </a:solidFill>
-          </a:ln>
-          <a:effectLst/>
-        </p:spPr>
-        <p:style>
-          <a:lnRef idx="1">
-            <a:schemeClr val="accent1"/>
-          </a:lnRef>
-          <a:fillRef idx="3">
-            <a:schemeClr val="accent1"/>
-          </a:fillRef>
-          <a:effectRef idx="2">
-            <a:schemeClr val="accent1"/>
-          </a:effectRef>
-          <a:fontRef idx="minor">
-            <a:schemeClr val="lt1"/>
-          </a:fontRef>
-        </p:style>
-        <p:txBody>
-          <a:bodyPr rtlCol="0" anchor="ctr"/>
-          <a:lstStyle/>
-          <a:p>
-            <a:pPr algn="ctr"/>
-          </a:p>
-        </p:txBody>
-      </p:sp>
-      <p:sp>
-        <p:nvSpPr>
           <p:cNvPr id="49" name="Rounded Rectangle 48"/>
           <p:cNvSpPr/>
           <p:nvPr/>
         </p:nvSpPr>
         <p:spPr>
           <a:xfrm>
-            <a:off x="11690603" y="2493031"/>
+            <a:off x="11690603" y="2404872"/>
             <a:ext cx="82296" cy="82296"/>
           </a:xfrm>
           <a:prstGeom prst="roundRect">
@@ -49614,7 +49614,7 @@
                 </a:solidFill>
                 <a:latin typeface="Kanit"/>
               </a:rPr>
-              <a:t>เทียบปีก่อน +8.8%</a:t>
+              <a:t>เทียบปีก่อน +10.6%</a:t>
             </a:r>
           </a:p>
         </p:txBody>
@@ -49932,7 +49932,7 @@
                 </a:solidFill>
                 <a:latin typeface="Kanit"/>
               </a:rPr>
-              <a:t>เทียบปีก่อน +14.4%</a:t>
+              <a:t>เทียบปีก่อน +14.3%</a:t>
             </a:r>
           </a:p>
         </p:txBody>
@@ -50250,7 +50250,7 @@
                 </a:solidFill>
                 <a:latin typeface="Kanit"/>
               </a:rPr>
-              <a:t>เทียบปีก่อน +15.9%</a:t>
+              <a:t>เทียบปีก่อน +16.6%</a:t>
             </a:r>
           </a:p>
         </p:txBody>
@@ -50568,7 +50568,7 @@
                 </a:solidFill>
                 <a:latin typeface="Kanit"/>
               </a:rPr>
-              <a:t>เทียบปีก่อน +23.3%</a:t>
+              <a:t>เทียบปีก่อน +23.2%</a:t>
             </a:r>
           </a:p>
         </p:txBody>
@@ -50886,7 +50886,7 @@
                 </a:solidFill>
                 <a:latin typeface="Kanit"/>
               </a:rPr>
-              <a:t>เทียบปีก่อน +40.2%</a:t>
+              <a:t>เทียบปีก่อน +40.1%</a:t>
             </a:r>
           </a:p>
         </p:txBody>
@@ -51204,7 +51204,7 @@
                 </a:solidFill>
                 <a:latin typeface="Kanit"/>
               </a:rPr>
-              <a:t>เทียบปีก่อน +72.1%</a:t>
+              <a:t>เทียบปีก่อน +73.3%</a:t>
             </a:r>
           </a:p>
         </p:txBody>
@@ -51522,7 +51522,7 @@
                 </a:solidFill>
                 <a:latin typeface="Kanit"/>
               </a:rPr>
-              <a:t>เทียบปีก่อน +102.6%</a:t>
+              <a:t>เทียบปีก่อน +107.4%</a:t>
             </a:r>
           </a:p>
         </p:txBody>
@@ -51886,7 +51886,7 @@
                 </a:solidFill>
                 <a:latin typeface="Kanit"/>
               </a:rPr>
-              <a:t>ราคาหน้าฟาร์ม วัดจริง — ราคารายวันของ NABC เฉลี่ยเป็นรายเดือน หน่วยเป็นบาทตามที่เผยแพร่ (ไม่มีการแปลงสกุลเงิน) ราคาล่าสุด 2026-08-24, รุ่นข้อมูลย้อนหลัง 2026-08-23 ราคาหน้าฟาร์ม (ราคาที่เกษตรกรขายได้) คือเงินที่เกษตรกรได้รับเมื่อขายครั้งแรก ก่อนพ่อค้าคนกลาง โรงสี หรือค่าขนส่งจะหักส่วนแบ่ง — ไม่ใช่ดัชนีโลก และไม่ใช่ราคาในซูเปอร์มาร์เก็ต แหล่งผลิตเป็นการอ่านแบบ ประมาณการ ว่าสินค้าแต่ละชนิดผลิตที่ไหน และทับซ้อนกันได้ น้ำตาลเป็นราคาอ้อยประกาศของ สอน. ปีละหนึ่งจุด จึงไม่มีการเปลี่ยนแปลงหกเดือนให้แสดง</a:t>
+              <a:t>ราคาหน้าฟาร์ม วัดจริง — ราคารายวันของ NABC เฉลี่ยเป็นรายเดือน หน่วยเป็นบาทตามที่เผยแพร่ (ไม่มีการแปลงสกุลเงิน) ราคาล่าสุด 2026-08-26, รุ่นข้อมูลย้อนหลัง 2026-08-23 ราคาหน้าฟาร์ม (ราคาที่เกษตรกรขายได้) คือเงินที่เกษตรกรได้รับเมื่อขายครั้งแรก ก่อนพ่อค้าคนกลาง โรงสี หรือค่าขนส่งจะหักส่วนแบ่ง — ไม่ใช่ดัชนีโลก และไม่ใช่ราคาในซูเปอร์มาร์เก็ต แหล่งผลิตเป็นการอ่านแบบ ประมาณการ ว่าสินค้าแต่ละชนิดผลิตที่ไหน และทับซ้อนกันได้ น้ำตาลเป็นราคาอ้อยประกาศของ สอน. ปีละหนึ่งจุด จึงไม่มีการเปลี่ยนแปลงหกเดือนให้แสดง</a:t>
             </a:r>
           </a:p>
         </p:txBody>

</xml_diff>

<commit_message>
deck(mcom): rebuild — the data moved past the committed figures (run 33121997489)
</commit_message>
<xml_diff>
--- a/docs/decks/mcom-2026-08-05-macro-TH.pptx
+++ b/docs/decks/mcom-2026-08-05-macro-TH.pptx
@@ -6240,7 +6240,7 @@
                 </a:solidFill>
                 <a:latin typeface="Kanit"/>
               </a:rPr>
-              <a:t>129</a:t>
+              <a:t>131</a:t>
             </a:r>
           </a:p>
         </p:txBody>
@@ -6279,7 +6279,7 @@
                 </a:solidFill>
                 <a:latin typeface="Kanit"/>
               </a:rPr>
-              <a:t>จาก 795 (16.2%) · เรียลไทม์ · 2026-08-26</a:t>
+              <a:t>จาก 795 (16.5%) · เรียลไทม์ · 2026-08-28</a:t>
             </a:r>
           </a:p>
         </p:txBody>
@@ -6405,7 +6405,7 @@
                 </a:solidFill>
                 <a:latin typeface="Kanit"/>
               </a:rPr>
-              <a:t>14</a:t>
+              <a:t>13</a:t>
             </a:r>
           </a:p>
         </p:txBody>
@@ -6444,7 +6444,7 @@
                 </a:solidFill>
                 <a:latin typeface="Kanit"/>
               </a:rPr>
-              <a:t>ค่าล่าสุดรายวัน · 2026-08-26</a:t>
+              <a:t>ค่าล่าสุดรายวัน · 2026-08-28</a:t>
             </a:r>
           </a:p>
         </p:txBody>
@@ -7905,7 +7905,7 @@
                           </a:solidFill>
                           <a:latin typeface="Kanit"/>
                         </a:rPr>
-                        <a:t>38</a:t>
+                        <a:t>36</a:t>
                       </a:r>
                     </a:p>
                   </a:txBody>
@@ -7928,7 +7928,7 @@
                           </a:solidFill>
                           <a:latin typeface="Kanit"/>
                         </a:rPr>
-                        <a:t>42</a:t>
+                        <a:t>33</a:t>
                       </a:r>
                     </a:p>
                   </a:txBody>
@@ -7947,11 +7947,11 @@
                       <a:r>
                         <a:rPr sz="900" b="1">
                           <a:solidFill>
-                            <a:srgbClr val="F5C242"/>
-                          </a:solidFill>
-                          <a:latin typeface="Kanit"/>
-                        </a:rPr>
-                        <a:t>2.6%</a:t>
+                            <a:srgbClr val="606060"/>
+                          </a:solidFill>
+                          <a:latin typeface="Kanit"/>
+                        </a:rPr>
+                        <a:t>0.0%</a:t>
                       </a:r>
                     </a:p>
                   </a:txBody>
@@ -8022,7 +8022,7 @@
                           </a:solidFill>
                           <a:latin typeface="Kanit"/>
                         </a:rPr>
-                        <a:t>มุกดาหาร</a:t>
+                        <a:t>กาญจนบุรี</a:t>
                       </a:r>
                     </a:p>
                   </a:txBody>
@@ -8045,7 +8045,7 @@
                           </a:solidFill>
                           <a:latin typeface="Kanit"/>
                         </a:rPr>
-                        <a:t>18</a:t>
+                        <a:t>88</a:t>
                       </a:r>
                     </a:p>
                   </a:txBody>
@@ -8068,7 +8068,7 @@
                           </a:solidFill>
                           <a:latin typeface="Kanit"/>
                         </a:rPr>
-                        <a:t>2</a:t>
+                        <a:t>66</a:t>
                       </a:r>
                     </a:p>
                   </a:txBody>
@@ -8087,11 +8087,11 @@
                       <a:r>
                         <a:rPr sz="900" b="1">
                           <a:solidFill>
-                            <a:srgbClr val="606060"/>
-                          </a:solidFill>
-                          <a:latin typeface="Kanit"/>
-                        </a:rPr>
-                        <a:t>0.0%</a:t>
+                            <a:srgbClr val="F5C242"/>
+                          </a:solidFill>
+                          <a:latin typeface="Kanit"/>
+                        </a:rPr>
+                        <a:t>19.3%</a:t>
                       </a:r>
                     </a:p>
                   </a:txBody>
@@ -8114,7 +8114,7 @@
                           </a:solidFill>
                           <a:latin typeface="Kanit"/>
                         </a:rPr>
-                        <a:t>2/2</a:t>
+                        <a:t>5/26</a:t>
                       </a:r>
                     </a:p>
                   </a:txBody>
@@ -8133,11 +8133,11 @@
                       <a:r>
                         <a:rPr sz="900" b="1">
                           <a:solidFill>
-                            <a:srgbClr val="CC0000"/>
-                          </a:solidFill>
-                          <a:latin typeface="Kanit"/>
-                        </a:rPr>
-                        <a:t>5</a:t>
+                            <a:srgbClr val="F5C242"/>
+                          </a:solidFill>
+                          <a:latin typeface="Kanit"/>
+                        </a:rPr>
+                        <a:t>4</a:t>
                       </a:r>
                     </a:p>
                   </a:txBody>
@@ -8162,7 +8162,7 @@
                           </a:solidFill>
                           <a:latin typeface="Kanit"/>
                         </a:rPr>
-                        <a:t>สมุทรปราการ</a:t>
+                        <a:t>ชุมพร</a:t>
                       </a:r>
                     </a:p>
                   </a:txBody>
@@ -8185,7 +8185,7 @@
                           </a:solidFill>
                           <a:latin typeface="Kanit"/>
                         </a:rPr>
-                        <a:t>15</a:t>
+                        <a:t>90</a:t>
                       </a:r>
                     </a:p>
                   </a:txBody>
@@ -8208,7 +8208,7 @@
                           </a:solidFill>
                           <a:latin typeface="Kanit"/>
                         </a:rPr>
-                        <a:t>6</a:t>
+                        <a:t>65</a:t>
                       </a:r>
                     </a:p>
                   </a:txBody>
@@ -8227,11 +8227,11 @@
                       <a:r>
                         <a:rPr sz="900" b="1">
                           <a:solidFill>
-                            <a:srgbClr val="606060"/>
-                          </a:solidFill>
-                          <a:latin typeface="Kanit"/>
-                        </a:rPr>
-                        <a:t>0.0%</a:t>
+                            <a:srgbClr val="F5C242"/>
+                          </a:solidFill>
+                          <a:latin typeface="Kanit"/>
+                        </a:rPr>
+                        <a:t>12.2%</a:t>
                       </a:r>
                     </a:p>
                   </a:txBody>
@@ -8254,7 +8254,7 @@
                           </a:solidFill>
                           <a:latin typeface="Kanit"/>
                         </a:rPr>
-                        <a:t>4/5</a:t>
+                        <a:t>3/15</a:t>
                       </a:r>
                     </a:p>
                   </a:txBody>
@@ -8273,11 +8273,11 @@
                       <a:r>
                         <a:rPr sz="900" b="1">
                           <a:solidFill>
-                            <a:srgbClr val="CC0000"/>
-                          </a:solidFill>
-                          <a:latin typeface="Kanit"/>
-                        </a:rPr>
-                        <a:t>5</a:t>
+                            <a:srgbClr val="F5C242"/>
+                          </a:solidFill>
+                          <a:latin typeface="Kanit"/>
+                        </a:rPr>
+                        <a:t>4</a:t>
                       </a:r>
                     </a:p>
                   </a:txBody>
@@ -8302,7 +8302,7 @@
                           </a:solidFill>
                           <a:latin typeface="Kanit"/>
                         </a:rPr>
-                        <a:t>บึงกาฬ</a:t>
+                        <a:t>ตราด</a:t>
                       </a:r>
                     </a:p>
                   </a:txBody>
@@ -8325,7 +8325,7 @@
                           </a:solidFill>
                           <a:latin typeface="Kanit"/>
                         </a:rPr>
-                        <a:t>10</a:t>
+                        <a:t>44</a:t>
                       </a:r>
                     </a:p>
                   </a:txBody>
@@ -8348,7 +8348,7 @@
                           </a:solidFill>
                           <a:latin typeface="Kanit"/>
                         </a:rPr>
-                        <a:t>41</a:t>
+                        <a:t>61</a:t>
                       </a:r>
                     </a:p>
                   </a:txBody>
@@ -8371,7 +8371,7 @@
                           </a:solidFill>
                           <a:latin typeface="Kanit"/>
                         </a:rPr>
-                        <a:t>20.0%</a:t>
+                        <a:t>6.8%</a:t>
                       </a:r>
                     </a:p>
                   </a:txBody>
@@ -8394,7 +8394,7 @@
                           </a:solidFill>
                           <a:latin typeface="Kanit"/>
                         </a:rPr>
-                        <a:t>1/1</a:t>
+                        <a:t>3/9</a:t>
                       </a:r>
                     </a:p>
                   </a:txBody>
@@ -8442,7 +8442,7 @@
                           </a:solidFill>
                           <a:latin typeface="Kanit"/>
                         </a:rPr>
-                        <a:t>กาญจนบุรี</a:t>
+                        <a:t>ตาก</a:t>
                       </a:r>
                     </a:p>
                   </a:txBody>
@@ -8465,7 +8465,7 @@
                           </a:solidFill>
                           <a:latin typeface="Kanit"/>
                         </a:rPr>
-                        <a:t>87</a:t>
+                        <a:t>109</a:t>
                       </a:r>
                     </a:p>
                   </a:txBody>
@@ -8488,7 +8488,7 @@
                           </a:solidFill>
                           <a:latin typeface="Kanit"/>
                         </a:rPr>
-                        <a:t>78</a:t>
+                        <a:t>51</a:t>
                       </a:r>
                     </a:p>
                   </a:txBody>
@@ -8511,7 +8511,7 @@
                           </a:solidFill>
                           <a:latin typeface="Kanit"/>
                         </a:rPr>
-                        <a:t>11.5%</a:t>
+                        <a:t>2.8%</a:t>
                       </a:r>
                     </a:p>
                   </a:txBody>
@@ -8534,7 +8534,7 @@
                           </a:solidFill>
                           <a:latin typeface="Kanit"/>
                         </a:rPr>
-                        <a:t>5/26</a:t>
+                        <a:t>1/17</a:t>
                       </a:r>
                     </a:p>
                   </a:txBody>
@@ -8582,7 +8582,7 @@
                           </a:solidFill>
                           <a:latin typeface="Kanit"/>
                         </a:rPr>
-                        <a:t>ตาก</a:t>
+                        <a:t>ลำพูน</a:t>
                       </a:r>
                     </a:p>
                   </a:txBody>
@@ -8605,7 +8605,7 @@
                           </a:solidFill>
                           <a:latin typeface="Kanit"/>
                         </a:rPr>
-                        <a:t>112</a:t>
+                        <a:t>73</a:t>
                       </a:r>
                     </a:p>
                   </a:txBody>
@@ -8628,7 +8628,7 @@
                           </a:solidFill>
                           <a:latin typeface="Kanit"/>
                         </a:rPr>
-                        <a:t>116</a:t>
+                        <a:t>43</a:t>
                       </a:r>
                     </a:p>
                   </a:txBody>
@@ -8651,7 +8651,7 @@
                           </a:solidFill>
                           <a:latin typeface="Kanit"/>
                         </a:rPr>
-                        <a:t>9.8%</a:t>
+                        <a:t>2.7%</a:t>
                       </a:r>
                     </a:p>
                   </a:txBody>
@@ -8674,7 +8674,7 @@
                           </a:solidFill>
                           <a:latin typeface="Kanit"/>
                         </a:rPr>
-                        <a:t>1/17</a:t>
+                        <a:t>1/11</a:t>
                       </a:r>
                     </a:p>
                   </a:txBody>
@@ -8909,7 +8909,7 @@
                 </a:solidFill>
                 <a:latin typeface="Kanit"/>
               </a:rPr>
-              <a:t>พื้นที่ปลูก วัดจริง (สศก. — ข้อมูลอำเภอ×พืช 3,295 แถว) ภัยแล้งเป็นดัชนี SPEI จาก แบบจำลอง คำนวณจากปริมาณฝนและการคายระเหย ปรับเดือนละครั้ง ดึงข้อมูล 2026-07-20 — เป็นสัญญาณที่ครอบคลุมทั้งประเทศดีที่สุดที่มี แต่ไม่มีใครลงพื้นที่ไปเดินดูอำเภอเหล่านั้น ข้อมูลฝนและระดับน้ำ วัดจริง (ThaiWater เรียลไทม์ ดึงทุกวันและสะสมไว้ — วันที่ดึงไม่สำเร็จจะเว้นเป็นช่องว่าง ไม่ใส่ค่าสมมติ) · ฝนถึง 2026-08-26, ระดับน้ำถึง 2026-08-26 ความเสี่ยงน้ำท่วมเชิงโครงสร้าง วัดจริง (สำมะโนพื้นที่ท่วมซ้ำซาก GISTDA มาตราส่วน 1:50,000 ปี 2005-2016 — เป็นบันทึกภาคพื้นดิน 12 ปี ไม่ใช่การพยากรณ์)</a:t>
+              <a:t>พื้นที่ปลูก วัดจริง (สศก. — ข้อมูลอำเภอ×พืช 3,295 แถว) ภัยแล้งเป็นดัชนี SPEI จาก แบบจำลอง คำนวณจากปริมาณฝนและการคายระเหย ปรับเดือนละครั้ง ดึงข้อมูล 2026-07-20 — เป็นสัญญาณที่ครอบคลุมทั้งประเทศดีที่สุดที่มี แต่ไม่มีใครลงพื้นที่ไปเดินดูอำเภอเหล่านั้น ข้อมูลฝนและระดับน้ำ วัดจริง (ThaiWater เรียลไทม์ ดึงทุกวันและสะสมไว้ — วันที่ดึงไม่สำเร็จจะเว้นเป็นช่องว่าง ไม่ใส่ค่าสมมติ) · ฝนถึง 2026-08-28, ระดับน้ำถึง 2026-08-28 ความเสี่ยงน้ำท่วมเชิงโครงสร้าง วัดจริง (สำมะโนพื้นที่ท่วมซ้ำซาก GISTDA มาตราส่วน 1:50,000 ปี 2005-2016 — เป็นบันทึกภาคพื้นดิน 12 ปี ไม่ใช่การพยากรณ์)</a:t>
             </a:r>
           </a:p>
         </p:txBody>
@@ -32047,7 +32047,7 @@
                 </a:solidFill>
                 <a:latin typeface="Kanit"/>
               </a:rPr>
-              <a:t>รุ่นข้อมูล — ราคาโลก 2026M06 · ราคาหน้าฟาร์มไทย 2026-08-26 · ประวัติราคาไทย 2026-08-23 · ต้นทุนการผลิตพืช สศก. ไจอัป 2568 (ปีเพาะปลูก 2568/69, ประมาณการ สศก. มี.ค. 2569) · ภัยแล้ง 2026-06-21 · เงินเฟ้อ 2026-05 · GDP 2026 ไตรมาส 1 · IMF WEO 2026 · ดัชนีราคาขายต่อ 2026-05 · ยอดจดทะเบียนถึง 2026-01 · หนี้ครัวเรือน สสช. SES 2566 · ค่าจ้าง สสช. LFS 2568 · ข้อมูลตรวจวัด 2026-08-26</a:t>
+              <a:t>รุ่นข้อมูล — ราคาโลก 2026M06 · ราคาหน้าฟาร์มไทย 2026-08-26 · ประวัติราคาไทย 2026-08-23 · ต้นทุนการผลิตพืช สศก. ไจอัป 2568 (ปีเพาะปลูก 2568/69, ประมาณการ สศก. มี.ค. 2569) · ภัยแล้ง 2026-06-21 · เงินเฟ้อ 2026-05 · GDP 2026 ไตรมาส 1 · IMF WEO 2026 · ดัชนีราคาขายต่อ 2026-05 · ยอดจดทะเบียนถึง 2026-01 · หนี้ครัวเรือน สสช. SES 2566 · ค่าจ้าง สสช. LFS 2568 · ข้อมูลตรวจวัด 2026-08-28</a:t>
             </a:r>
           </a:p>
         </p:txBody>
@@ -37087,7 +37087,7 @@
                 </a:solidFill>
                 <a:latin typeface="Kanit"/>
               </a:rPr>
-              <a:t>338 จาก 928 อำเภอ · แม่น้ำเกินระดับ 129 จาก 795 สถานี</a:t>
+              <a:t>338 จาก 928 อำเภอ · แม่น้ำเกินระดับ 131 จาก 795 สถานี</a:t>
             </a:r>
           </a:p>
         </p:txBody>
@@ -37859,7 +37859,7 @@
                           </a:solidFill>
                           <a:latin typeface="Kanit"/>
                         </a:rPr>
-                        <a:t>31/156</a:t>
+                        <a:t>27/156</a:t>
                       </a:r>
                     </a:p>
                   </a:txBody>
@@ -38091,7 +38091,7 @@
                           </a:solidFill>
                           <a:latin typeface="Kanit"/>
                         </a:rPr>
-                        <a:t>24/275</a:t>
+                        <a:t>22/274</a:t>
                       </a:r>
                     </a:p>
                   </a:txBody>
@@ -38323,7 +38323,7 @@
                           </a:solidFill>
                           <a:latin typeface="Kanit"/>
                         </a:rPr>
-                        <a:t>25/168</a:t>
+                        <a:t>30/168</a:t>
                       </a:r>
                     </a:p>
                   </a:txBody>
@@ -38555,7 +38555,7 @@
                           </a:solidFill>
                           <a:latin typeface="Kanit"/>
                         </a:rPr>
-                        <a:t>6/51</a:t>
+                        <a:t>7/52</a:t>
                       </a:r>
                     </a:p>
                   </a:txBody>
@@ -38787,7 +38787,7 @@
                           </a:solidFill>
                           <a:latin typeface="Kanit"/>
                         </a:rPr>
-                        <a:t>43/145</a:t>
+                        <a:t>45/145</a:t>
                       </a:r>
                     </a:p>
                   </a:txBody>

</xml_diff>

<commit_message>
deck(mcom): rebuild — the data moved past the committed figures (run 33121997489) (#666)
Co-authored-by: github-actions[bot] <41898282+github-actions[bot]@users.noreply.github.com>
</commit_message>
<xml_diff>
--- a/docs/decks/mcom-2026-08-05-macro-TH.pptx
+++ b/docs/decks/mcom-2026-08-05-macro-TH.pptx
@@ -6240,7 +6240,7 @@
                 </a:solidFill>
                 <a:latin typeface="Kanit"/>
               </a:rPr>
-              <a:t>129</a:t>
+              <a:t>131</a:t>
             </a:r>
           </a:p>
         </p:txBody>
@@ -6279,7 +6279,7 @@
                 </a:solidFill>
                 <a:latin typeface="Kanit"/>
               </a:rPr>
-              <a:t>จาก 795 (16.2%) · เรียลไทม์ · 2026-08-26</a:t>
+              <a:t>จาก 795 (16.5%) · เรียลไทม์ · 2026-08-28</a:t>
             </a:r>
           </a:p>
         </p:txBody>
@@ -6405,7 +6405,7 @@
                 </a:solidFill>
                 <a:latin typeface="Kanit"/>
               </a:rPr>
-              <a:t>14</a:t>
+              <a:t>13</a:t>
             </a:r>
           </a:p>
         </p:txBody>
@@ -6444,7 +6444,7 @@
                 </a:solidFill>
                 <a:latin typeface="Kanit"/>
               </a:rPr>
-              <a:t>ค่าล่าสุดรายวัน · 2026-08-26</a:t>
+              <a:t>ค่าล่าสุดรายวัน · 2026-08-28</a:t>
             </a:r>
           </a:p>
         </p:txBody>
@@ -7905,7 +7905,7 @@
                           </a:solidFill>
                           <a:latin typeface="Kanit"/>
                         </a:rPr>
-                        <a:t>38</a:t>
+                        <a:t>36</a:t>
                       </a:r>
                     </a:p>
                   </a:txBody>
@@ -7928,7 +7928,7 @@
                           </a:solidFill>
                           <a:latin typeface="Kanit"/>
                         </a:rPr>
-                        <a:t>42</a:t>
+                        <a:t>33</a:t>
                       </a:r>
                     </a:p>
                   </a:txBody>
@@ -7947,11 +7947,11 @@
                       <a:r>
                         <a:rPr sz="900" b="1">
                           <a:solidFill>
-                            <a:srgbClr val="F5C242"/>
-                          </a:solidFill>
-                          <a:latin typeface="Kanit"/>
-                        </a:rPr>
-                        <a:t>2.6%</a:t>
+                            <a:srgbClr val="606060"/>
+                          </a:solidFill>
+                          <a:latin typeface="Kanit"/>
+                        </a:rPr>
+                        <a:t>0.0%</a:t>
                       </a:r>
                     </a:p>
                   </a:txBody>
@@ -8022,7 +8022,7 @@
                           </a:solidFill>
                           <a:latin typeface="Kanit"/>
                         </a:rPr>
-                        <a:t>มุกดาหาร</a:t>
+                        <a:t>กาญจนบุรี</a:t>
                       </a:r>
                     </a:p>
                   </a:txBody>
@@ -8045,7 +8045,7 @@
                           </a:solidFill>
                           <a:latin typeface="Kanit"/>
                         </a:rPr>
-                        <a:t>18</a:t>
+                        <a:t>88</a:t>
                       </a:r>
                     </a:p>
                   </a:txBody>
@@ -8068,7 +8068,7 @@
                           </a:solidFill>
                           <a:latin typeface="Kanit"/>
                         </a:rPr>
-                        <a:t>2</a:t>
+                        <a:t>66</a:t>
                       </a:r>
                     </a:p>
                   </a:txBody>
@@ -8087,11 +8087,11 @@
                       <a:r>
                         <a:rPr sz="900" b="1">
                           <a:solidFill>
-                            <a:srgbClr val="606060"/>
-                          </a:solidFill>
-                          <a:latin typeface="Kanit"/>
-                        </a:rPr>
-                        <a:t>0.0%</a:t>
+                            <a:srgbClr val="F5C242"/>
+                          </a:solidFill>
+                          <a:latin typeface="Kanit"/>
+                        </a:rPr>
+                        <a:t>19.3%</a:t>
                       </a:r>
                     </a:p>
                   </a:txBody>
@@ -8114,7 +8114,7 @@
                           </a:solidFill>
                           <a:latin typeface="Kanit"/>
                         </a:rPr>
-                        <a:t>2/2</a:t>
+                        <a:t>5/26</a:t>
                       </a:r>
                     </a:p>
                   </a:txBody>
@@ -8133,11 +8133,11 @@
                       <a:r>
                         <a:rPr sz="900" b="1">
                           <a:solidFill>
-                            <a:srgbClr val="CC0000"/>
-                          </a:solidFill>
-                          <a:latin typeface="Kanit"/>
-                        </a:rPr>
-                        <a:t>5</a:t>
+                            <a:srgbClr val="F5C242"/>
+                          </a:solidFill>
+                          <a:latin typeface="Kanit"/>
+                        </a:rPr>
+                        <a:t>4</a:t>
                       </a:r>
                     </a:p>
                   </a:txBody>
@@ -8162,7 +8162,7 @@
                           </a:solidFill>
                           <a:latin typeface="Kanit"/>
                         </a:rPr>
-                        <a:t>สมุทรปราการ</a:t>
+                        <a:t>ชุมพร</a:t>
                       </a:r>
                     </a:p>
                   </a:txBody>
@@ -8185,7 +8185,7 @@
                           </a:solidFill>
                           <a:latin typeface="Kanit"/>
                         </a:rPr>
-                        <a:t>15</a:t>
+                        <a:t>90</a:t>
                       </a:r>
                     </a:p>
                   </a:txBody>
@@ -8208,7 +8208,7 @@
                           </a:solidFill>
                           <a:latin typeface="Kanit"/>
                         </a:rPr>
-                        <a:t>6</a:t>
+                        <a:t>65</a:t>
                       </a:r>
                     </a:p>
                   </a:txBody>
@@ -8227,11 +8227,11 @@
                       <a:r>
                         <a:rPr sz="900" b="1">
                           <a:solidFill>
-                            <a:srgbClr val="606060"/>
-                          </a:solidFill>
-                          <a:latin typeface="Kanit"/>
-                        </a:rPr>
-                        <a:t>0.0%</a:t>
+                            <a:srgbClr val="F5C242"/>
+                          </a:solidFill>
+                          <a:latin typeface="Kanit"/>
+                        </a:rPr>
+                        <a:t>12.2%</a:t>
                       </a:r>
                     </a:p>
                   </a:txBody>
@@ -8254,7 +8254,7 @@
                           </a:solidFill>
                           <a:latin typeface="Kanit"/>
                         </a:rPr>
-                        <a:t>4/5</a:t>
+                        <a:t>3/15</a:t>
                       </a:r>
                     </a:p>
                   </a:txBody>
@@ -8273,11 +8273,11 @@
                       <a:r>
                         <a:rPr sz="900" b="1">
                           <a:solidFill>
-                            <a:srgbClr val="CC0000"/>
-                          </a:solidFill>
-                          <a:latin typeface="Kanit"/>
-                        </a:rPr>
-                        <a:t>5</a:t>
+                            <a:srgbClr val="F5C242"/>
+                          </a:solidFill>
+                          <a:latin typeface="Kanit"/>
+                        </a:rPr>
+                        <a:t>4</a:t>
                       </a:r>
                     </a:p>
                   </a:txBody>
@@ -8302,7 +8302,7 @@
                           </a:solidFill>
                           <a:latin typeface="Kanit"/>
                         </a:rPr>
-                        <a:t>บึงกาฬ</a:t>
+                        <a:t>ตราด</a:t>
                       </a:r>
                     </a:p>
                   </a:txBody>
@@ -8325,7 +8325,7 @@
                           </a:solidFill>
                           <a:latin typeface="Kanit"/>
                         </a:rPr>
-                        <a:t>10</a:t>
+                        <a:t>44</a:t>
                       </a:r>
                     </a:p>
                   </a:txBody>
@@ -8348,7 +8348,7 @@
                           </a:solidFill>
                           <a:latin typeface="Kanit"/>
                         </a:rPr>
-                        <a:t>41</a:t>
+                        <a:t>61</a:t>
                       </a:r>
                     </a:p>
                   </a:txBody>
@@ -8371,7 +8371,7 @@
                           </a:solidFill>
                           <a:latin typeface="Kanit"/>
                         </a:rPr>
-                        <a:t>20.0%</a:t>
+                        <a:t>6.8%</a:t>
                       </a:r>
                     </a:p>
                   </a:txBody>
@@ -8394,7 +8394,7 @@
                           </a:solidFill>
                           <a:latin typeface="Kanit"/>
                         </a:rPr>
-                        <a:t>1/1</a:t>
+                        <a:t>3/9</a:t>
                       </a:r>
                     </a:p>
                   </a:txBody>
@@ -8442,7 +8442,7 @@
                           </a:solidFill>
                           <a:latin typeface="Kanit"/>
                         </a:rPr>
-                        <a:t>กาญจนบุรี</a:t>
+                        <a:t>ตาก</a:t>
                       </a:r>
                     </a:p>
                   </a:txBody>
@@ -8465,7 +8465,7 @@
                           </a:solidFill>
                           <a:latin typeface="Kanit"/>
                         </a:rPr>
-                        <a:t>87</a:t>
+                        <a:t>109</a:t>
                       </a:r>
                     </a:p>
                   </a:txBody>
@@ -8488,7 +8488,7 @@
                           </a:solidFill>
                           <a:latin typeface="Kanit"/>
                         </a:rPr>
-                        <a:t>78</a:t>
+                        <a:t>51</a:t>
                       </a:r>
                     </a:p>
                   </a:txBody>
@@ -8511,7 +8511,7 @@
                           </a:solidFill>
                           <a:latin typeface="Kanit"/>
                         </a:rPr>
-                        <a:t>11.5%</a:t>
+                        <a:t>2.8%</a:t>
                       </a:r>
                     </a:p>
                   </a:txBody>
@@ -8534,7 +8534,7 @@
                           </a:solidFill>
                           <a:latin typeface="Kanit"/>
                         </a:rPr>
-                        <a:t>5/26</a:t>
+                        <a:t>1/17</a:t>
                       </a:r>
                     </a:p>
                   </a:txBody>
@@ -8582,7 +8582,7 @@
                           </a:solidFill>
                           <a:latin typeface="Kanit"/>
                         </a:rPr>
-                        <a:t>ตาก</a:t>
+                        <a:t>ลำพูน</a:t>
                       </a:r>
                     </a:p>
                   </a:txBody>
@@ -8605,7 +8605,7 @@
                           </a:solidFill>
                           <a:latin typeface="Kanit"/>
                         </a:rPr>
-                        <a:t>112</a:t>
+                        <a:t>73</a:t>
                       </a:r>
                     </a:p>
                   </a:txBody>
@@ -8628,7 +8628,7 @@
                           </a:solidFill>
                           <a:latin typeface="Kanit"/>
                         </a:rPr>
-                        <a:t>116</a:t>
+                        <a:t>43</a:t>
                       </a:r>
                     </a:p>
                   </a:txBody>
@@ -8651,7 +8651,7 @@
                           </a:solidFill>
                           <a:latin typeface="Kanit"/>
                         </a:rPr>
-                        <a:t>9.8%</a:t>
+                        <a:t>2.7%</a:t>
                       </a:r>
                     </a:p>
                   </a:txBody>
@@ -8674,7 +8674,7 @@
                           </a:solidFill>
                           <a:latin typeface="Kanit"/>
                         </a:rPr>
-                        <a:t>1/17</a:t>
+                        <a:t>1/11</a:t>
                       </a:r>
                     </a:p>
                   </a:txBody>
@@ -8909,7 +8909,7 @@
                 </a:solidFill>
                 <a:latin typeface="Kanit"/>
               </a:rPr>
-              <a:t>พื้นที่ปลูก วัดจริง (สศก. — ข้อมูลอำเภอ×พืช 3,295 แถว) ภัยแล้งเป็นดัชนี SPEI จาก แบบจำลอง คำนวณจากปริมาณฝนและการคายระเหย ปรับเดือนละครั้ง ดึงข้อมูล 2026-07-20 — เป็นสัญญาณที่ครอบคลุมทั้งประเทศดีที่สุดที่มี แต่ไม่มีใครลงพื้นที่ไปเดินดูอำเภอเหล่านั้น ข้อมูลฝนและระดับน้ำ วัดจริง (ThaiWater เรียลไทม์ ดึงทุกวันและสะสมไว้ — วันที่ดึงไม่สำเร็จจะเว้นเป็นช่องว่าง ไม่ใส่ค่าสมมติ) · ฝนถึง 2026-08-26, ระดับน้ำถึง 2026-08-26 ความเสี่ยงน้ำท่วมเชิงโครงสร้าง วัดจริง (สำมะโนพื้นที่ท่วมซ้ำซาก GISTDA มาตราส่วน 1:50,000 ปี 2005-2016 — เป็นบันทึกภาคพื้นดิน 12 ปี ไม่ใช่การพยากรณ์)</a:t>
+              <a:t>พื้นที่ปลูก วัดจริง (สศก. — ข้อมูลอำเภอ×พืช 3,295 แถว) ภัยแล้งเป็นดัชนี SPEI จาก แบบจำลอง คำนวณจากปริมาณฝนและการคายระเหย ปรับเดือนละครั้ง ดึงข้อมูล 2026-07-20 — เป็นสัญญาณที่ครอบคลุมทั้งประเทศดีที่สุดที่มี แต่ไม่มีใครลงพื้นที่ไปเดินดูอำเภอเหล่านั้น ข้อมูลฝนและระดับน้ำ วัดจริง (ThaiWater เรียลไทม์ ดึงทุกวันและสะสมไว้ — วันที่ดึงไม่สำเร็จจะเว้นเป็นช่องว่าง ไม่ใส่ค่าสมมติ) · ฝนถึง 2026-08-28, ระดับน้ำถึง 2026-08-28 ความเสี่ยงน้ำท่วมเชิงโครงสร้าง วัดจริง (สำมะโนพื้นที่ท่วมซ้ำซาก GISTDA มาตราส่วน 1:50,000 ปี 2005-2016 — เป็นบันทึกภาคพื้นดิน 12 ปี ไม่ใช่การพยากรณ์)</a:t>
             </a:r>
           </a:p>
         </p:txBody>
@@ -32047,7 +32047,7 @@
                 </a:solidFill>
                 <a:latin typeface="Kanit"/>
               </a:rPr>
-              <a:t>รุ่นข้อมูล — ราคาโลก 2026M06 · ราคาหน้าฟาร์มไทย 2026-08-26 · ประวัติราคาไทย 2026-08-23 · ต้นทุนการผลิตพืช สศก. ไจอัป 2568 (ปีเพาะปลูก 2568/69, ประมาณการ สศก. มี.ค. 2569) · ภัยแล้ง 2026-06-21 · เงินเฟ้อ 2026-05 · GDP 2026 ไตรมาส 1 · IMF WEO 2026 · ดัชนีราคาขายต่อ 2026-05 · ยอดจดทะเบียนถึง 2026-01 · หนี้ครัวเรือน สสช. SES 2566 · ค่าจ้าง สสช. LFS 2568 · ข้อมูลตรวจวัด 2026-08-26</a:t>
+              <a:t>รุ่นข้อมูล — ราคาโลก 2026M06 · ราคาหน้าฟาร์มไทย 2026-08-26 · ประวัติราคาไทย 2026-08-23 · ต้นทุนการผลิตพืช สศก. ไจอัป 2568 (ปีเพาะปลูก 2568/69, ประมาณการ สศก. มี.ค. 2569) · ภัยแล้ง 2026-06-21 · เงินเฟ้อ 2026-05 · GDP 2026 ไตรมาส 1 · IMF WEO 2026 · ดัชนีราคาขายต่อ 2026-05 · ยอดจดทะเบียนถึง 2026-01 · หนี้ครัวเรือน สสช. SES 2566 · ค่าจ้าง สสช. LFS 2568 · ข้อมูลตรวจวัด 2026-08-28</a:t>
             </a:r>
           </a:p>
         </p:txBody>
@@ -37087,7 +37087,7 @@
                 </a:solidFill>
                 <a:latin typeface="Kanit"/>
               </a:rPr>
-              <a:t>338 จาก 928 อำเภอ · แม่น้ำเกินระดับ 129 จาก 795 สถานี</a:t>
+              <a:t>338 จาก 928 อำเภอ · แม่น้ำเกินระดับ 131 จาก 795 สถานี</a:t>
             </a:r>
           </a:p>
         </p:txBody>
@@ -37859,7 +37859,7 @@
                           </a:solidFill>
                           <a:latin typeface="Kanit"/>
                         </a:rPr>
-                        <a:t>31/156</a:t>
+                        <a:t>27/156</a:t>
                       </a:r>
                     </a:p>
                   </a:txBody>
@@ -38091,7 +38091,7 @@
                           </a:solidFill>
                           <a:latin typeface="Kanit"/>
                         </a:rPr>
-                        <a:t>24/275</a:t>
+                        <a:t>22/274</a:t>
                       </a:r>
                     </a:p>
                   </a:txBody>
@@ -38323,7 +38323,7 @@
                           </a:solidFill>
                           <a:latin typeface="Kanit"/>
                         </a:rPr>
-                        <a:t>25/168</a:t>
+                        <a:t>30/168</a:t>
                       </a:r>
                     </a:p>
                   </a:txBody>
@@ -38555,7 +38555,7 @@
                           </a:solidFill>
                           <a:latin typeface="Kanit"/>
                         </a:rPr>
-                        <a:t>6/51</a:t>
+                        <a:t>7/52</a:t>
                       </a:r>
                     </a:p>
                   </a:txBody>
@@ -38787,7 +38787,7 @@
                           </a:solidFill>
                           <a:latin typeface="Kanit"/>
                         </a:rPr>
-                        <a:t>43/145</a:t>
+                        <a:t>45/145</a:t>
                       </a:r>
                     </a:p>
                   </a:txBody>

</xml_diff>

<commit_message>
deck(mcom): rebuild — the data moved past the committed figures (run 33189629322)
</commit_message>
<xml_diff>
--- a/docs/decks/mcom-2026-08-05-macro-TH.pptx
+++ b/docs/decks/mcom-2026-08-05-macro-TH.pptx
@@ -6240,7 +6240,7 @@
                 </a:solidFill>
                 <a:latin typeface="Kanit"/>
               </a:rPr>
-              <a:t>131</a:t>
+              <a:t>129</a:t>
             </a:r>
           </a:p>
         </p:txBody>
@@ -6279,7 +6279,7 @@
                 </a:solidFill>
                 <a:latin typeface="Kanit"/>
               </a:rPr>
-              <a:t>จาก 795 (16.5%) · เรียลไทม์ · 2026-08-28</a:t>
+              <a:t>จาก 795 (16.2%) · เรียลไทม์ · 2026-08-28</a:t>
             </a:r>
           </a:p>
         </p:txBody>
@@ -6405,7 +6405,7 @@
                 </a:solidFill>
                 <a:latin typeface="Kanit"/>
               </a:rPr>
-              <a:t>13</a:t>
+              <a:t>22</a:t>
             </a:r>
           </a:p>
         </p:txBody>
@@ -7905,7 +7905,7 @@
                           </a:solidFill>
                           <a:latin typeface="Kanit"/>
                         </a:rPr>
-                        <a:t>36</a:t>
+                        <a:t>38</a:t>
                       </a:r>
                     </a:p>
                   </a:txBody>
@@ -8022,7 +8022,7 @@
                           </a:solidFill>
                           <a:latin typeface="Kanit"/>
                         </a:rPr>
-                        <a:t>กาญจนบุรี</a:t>
+                        <a:t>ตราด</a:t>
                       </a:r>
                     </a:p>
                   </a:txBody>
@@ -8045,7 +8045,7 @@
                           </a:solidFill>
                           <a:latin typeface="Kanit"/>
                         </a:rPr>
-                        <a:t>88</a:t>
+                        <a:t>44</a:t>
                       </a:r>
                     </a:p>
                   </a:txBody>
@@ -8068,7 +8068,7 @@
                           </a:solidFill>
                           <a:latin typeface="Kanit"/>
                         </a:rPr>
-                        <a:t>66</a:t>
+                        <a:t>199</a:t>
                       </a:r>
                     </a:p>
                   </a:txBody>
@@ -8091,7 +8091,7 @@
                           </a:solidFill>
                           <a:latin typeface="Kanit"/>
                         </a:rPr>
-                        <a:t>19.3%</a:t>
+                        <a:t>72.7%</a:t>
                       </a:r>
                     </a:p>
                   </a:txBody>
@@ -8114,7 +8114,7 @@
                           </a:solidFill>
                           <a:latin typeface="Kanit"/>
                         </a:rPr>
-                        <a:t>5/26</a:t>
+                        <a:t>4/9</a:t>
                       </a:r>
                     </a:p>
                   </a:txBody>
@@ -8162,7 +8162,7 @@
                           </a:solidFill>
                           <a:latin typeface="Kanit"/>
                         </a:rPr>
-                        <a:t>ชุมพร</a:t>
+                        <a:t>ปทุมธานี</a:t>
                       </a:r>
                     </a:p>
                   </a:txBody>
@@ -8185,7 +8185,7 @@
                           </a:solidFill>
                           <a:latin typeface="Kanit"/>
                         </a:rPr>
-                        <a:t>90</a:t>
+                        <a:t>10</a:t>
                       </a:r>
                     </a:p>
                   </a:txBody>
@@ -8208,7 +8208,7 @@
                           </a:solidFill>
                           <a:latin typeface="Kanit"/>
                         </a:rPr>
-                        <a:t>65</a:t>
+                        <a:t>71</a:t>
                       </a:r>
                     </a:p>
                   </a:txBody>
@@ -8231,7 +8231,7 @@
                           </a:solidFill>
                           <a:latin typeface="Kanit"/>
                         </a:rPr>
-                        <a:t>12.2%</a:t>
+                        <a:t>50.0%</a:t>
                       </a:r>
                     </a:p>
                   </a:txBody>
@@ -8254,7 +8254,7 @@
                           </a:solidFill>
                           <a:latin typeface="Kanit"/>
                         </a:rPr>
-                        <a:t>3/15</a:t>
+                        <a:t>1/4</a:t>
                       </a:r>
                     </a:p>
                   </a:txBody>
@@ -8302,7 +8302,7 @@
                           </a:solidFill>
                           <a:latin typeface="Kanit"/>
                         </a:rPr>
-                        <a:t>ตราด</a:t>
+                        <a:t>นครนายก</a:t>
                       </a:r>
                     </a:p>
                   </a:txBody>
@@ -8325,7 +8325,7 @@
                           </a:solidFill>
                           <a:latin typeface="Kanit"/>
                         </a:rPr>
-                        <a:t>44</a:t>
+                        <a:t>26</a:t>
                       </a:r>
                     </a:p>
                   </a:txBody>
@@ -8348,7 +8348,7 @@
                           </a:solidFill>
                           <a:latin typeface="Kanit"/>
                         </a:rPr>
-                        <a:t>61</a:t>
+                        <a:t>81</a:t>
                       </a:r>
                     </a:p>
                   </a:txBody>
@@ -8371,7 +8371,7 @@
                           </a:solidFill>
                           <a:latin typeface="Kanit"/>
                         </a:rPr>
-                        <a:t>6.8%</a:t>
+                        <a:t>46.2%</a:t>
                       </a:r>
                     </a:p>
                   </a:txBody>
@@ -8394,7 +8394,7 @@
                           </a:solidFill>
                           <a:latin typeface="Kanit"/>
                         </a:rPr>
-                        <a:t>3/9</a:t>
+                        <a:t>1/6</a:t>
                       </a:r>
                     </a:p>
                   </a:txBody>
@@ -8442,7 +8442,7 @@
                           </a:solidFill>
                           <a:latin typeface="Kanit"/>
                         </a:rPr>
-                        <a:t>ตาก</a:t>
+                        <a:t>จันทบุรี</a:t>
                       </a:r>
                     </a:p>
                   </a:txBody>
@@ -8465,7 +8465,7 @@
                           </a:solidFill>
                           <a:latin typeface="Kanit"/>
                         </a:rPr>
-                        <a:t>109</a:t>
+                        <a:t>52</a:t>
                       </a:r>
                     </a:p>
                   </a:txBody>
@@ -8488,7 +8488,7 @@
                           </a:solidFill>
                           <a:latin typeface="Kanit"/>
                         </a:rPr>
-                        <a:t>51</a:t>
+                        <a:t>172</a:t>
                       </a:r>
                     </a:p>
                   </a:txBody>
@@ -8511,7 +8511,7 @@
                           </a:solidFill>
                           <a:latin typeface="Kanit"/>
                         </a:rPr>
-                        <a:t>2.8%</a:t>
+                        <a:t>34.6%</a:t>
                       </a:r>
                     </a:p>
                   </a:txBody>
@@ -8534,7 +8534,7 @@
                           </a:solidFill>
                           <a:latin typeface="Kanit"/>
                         </a:rPr>
-                        <a:t>1/17</a:t>
+                        <a:t>1/11</a:t>
                       </a:r>
                     </a:p>
                   </a:txBody>
@@ -8582,7 +8582,7 @@
                           </a:solidFill>
                           <a:latin typeface="Kanit"/>
                         </a:rPr>
-                        <a:t>ลำพูน</a:t>
+                        <a:t>ลพบุรี</a:t>
                       </a:r>
                     </a:p>
                   </a:txBody>
@@ -8605,7 +8605,7 @@
                           </a:solidFill>
                           <a:latin typeface="Kanit"/>
                         </a:rPr>
-                        <a:t>73</a:t>
+                        <a:t>27</a:t>
                       </a:r>
                     </a:p>
                   </a:txBody>
@@ -8628,7 +8628,7 @@
                           </a:solidFill>
                           <a:latin typeface="Kanit"/>
                         </a:rPr>
-                        <a:t>43</a:t>
+                        <a:t>61</a:t>
                       </a:r>
                     </a:p>
                   </a:txBody>
@@ -8651,7 +8651,7 @@
                           </a:solidFill>
                           <a:latin typeface="Kanit"/>
                         </a:rPr>
-                        <a:t>2.7%</a:t>
+                        <a:t>25.9%</a:t>
                       </a:r>
                     </a:p>
                   </a:txBody>
@@ -8674,7 +8674,7 @@
                           </a:solidFill>
                           <a:latin typeface="Kanit"/>
                         </a:rPr>
-                        <a:t>1/11</a:t>
+                        <a:t>4/8</a:t>
                       </a:r>
                     </a:p>
                   </a:txBody>
@@ -31476,7 +31476,7 @@
                 </a:solidFill>
                 <a:latin typeface="Kanit"/>
               </a:rPr>
-              <a:t>รายได้จากพืชค่ากลางเพิ่มขึ้น +17.0% แต่มีสี่จังหวัดที่ลดลง — ทั้งหมดอยู่ในแหล่งปลูกมะพร้าว โดยหนักที่สุดคือสมุทรสงครามที่ −62.7%</a:t>
+              <a:t>รายได้จากพืชค่ากลางเพิ่มขึ้น +16.8% แต่มีสี่จังหวัดที่ลดลง — ทั้งหมดอยู่ในแหล่งปลูกมะพร้าว โดยหนักที่สุดคือสมุทรสงครามที่ −63.0%</a:t>
             </a:r>
           </a:p>
         </p:txBody>
@@ -32047,7 +32047,7 @@
                 </a:solidFill>
                 <a:latin typeface="Kanit"/>
               </a:rPr>
-              <a:t>รุ่นข้อมูล — ราคาโลก 2026M06 · ราคาหน้าฟาร์มไทย 2026-08-26 · ประวัติราคาไทย 2026-08-23 · ต้นทุนการผลิตพืช สศก. ไจอัป 2568 (ปีเพาะปลูก 2568/69, ประมาณการ สศก. มี.ค. 2569) · ภัยแล้ง 2026-06-21 · เงินเฟ้อ 2026-05 · GDP 2026 ไตรมาส 1 · IMF WEO 2026 · ดัชนีราคาขายต่อ 2026-05 · ยอดจดทะเบียนถึง 2026-01 · หนี้ครัวเรือน สสช. SES 2566 · ค่าจ้าง สสช. LFS 2568 · ข้อมูลตรวจวัด 2026-08-28</a:t>
+              <a:t>รุ่นข้อมูล — ราคาโลก 2026M06 · ราคาหน้าฟาร์มไทย 2026-08-28 · ประวัติราคาไทย 2026-08-23 · ต้นทุนการผลิตพืช สศก. ไจอัป 2568 (ปีเพาะปลูก 2568/69, ประมาณการ สศก. มี.ค. 2569) · ภัยแล้ง 2026-06-21 · เงินเฟ้อ 2026-05 · GDP 2026 ไตรมาส 1 · IMF WEO 2026 · ดัชนีราคาขายต่อ 2026-05 · ยอดจดทะเบียนถึง 2026-01 · หนี้ครัวเรือน สสช. SES 2566 · ค่าจ้าง สสช. LFS 2568 · ข้อมูลตรวจวัด 2026-08-28</a:t>
             </a:r>
           </a:p>
         </p:txBody>
@@ -32546,7 +32546,7 @@
               <a:t>Not on the world index — the farm gate (ราคาที่เกษตรกรขายได้) says otherwise.
 • Five of seventeen Thai farm-gate prices are falling year on year.
 • Beef: farm gate −6.1% vs world index +8.8%.
-• Margin over price: a 26% price move becomes an 87% swing in crop income.</a:t>
+• Margin over price: a 26% price move becomes an 86% swing in crop income.</a:t>
             </a:r>
           </a:p>
         </p:txBody>
@@ -37087,7 +37087,7 @@
                 </a:solidFill>
                 <a:latin typeface="Kanit"/>
               </a:rPr>
-              <a:t>338 จาก 928 อำเภอ · แม่น้ำเกินระดับ 131 จาก 795 สถานี</a:t>
+              <a:t>338 จาก 928 อำเภอ · แม่น้ำเกินระดับ 129 จาก 795 สถานี</a:t>
             </a:r>
           </a:p>
         </p:txBody>
@@ -37859,7 +37859,7 @@
                           </a:solidFill>
                           <a:latin typeface="Kanit"/>
                         </a:rPr>
-                        <a:t>27/156</a:t>
+                        <a:t>26/156</a:t>
                       </a:r>
                     </a:p>
                   </a:txBody>
@@ -38091,7 +38091,7 @@
                           </a:solidFill>
                           <a:latin typeface="Kanit"/>
                         </a:rPr>
-                        <a:t>22/274</a:t>
+                        <a:t>21/274</a:t>
                       </a:r>
                     </a:p>
                   </a:txBody>
@@ -38323,7 +38323,7 @@
                           </a:solidFill>
                           <a:latin typeface="Kanit"/>
                         </a:rPr>
-                        <a:t>30/168</a:t>
+                        <a:t>29/168</a:t>
                       </a:r>
                     </a:p>
                   </a:txBody>
@@ -38555,7 +38555,7 @@
                           </a:solidFill>
                           <a:latin typeface="Kanit"/>
                         </a:rPr>
-                        <a:t>7/52</a:t>
+                        <a:t>8/52</a:t>
                       </a:r>
                     </a:p>
                   </a:txBody>
@@ -39936,7 +39936,7 @@
                           </a:solidFill>
                           <a:latin typeface="Kanit"/>
                         </a:rPr>
-                        <a:t>−67.1%</a:t>
+                        <a:t>−67.4%</a:t>
                       </a:r>
                     </a:p>
                   </a:txBody>
@@ -40791,7 +40791,7 @@
                 </a:solidFill>
                 <a:latin typeface="Kanit"/>
               </a:rPr>
-              <a:t>ราคา วัดจริง — ราคาหน้าฟาร์มไทยจากราคารายวันของ NABC และราคาอ้อยประกาศของ สอน. ราคาล่าสุด 2026-08-26 การเปลี่ยนแปลงหกเดือนคำนวณจากข้อมูลรายเดือนของ NABC เอง (thai_price_history รุ่นข้อมูล 2026-08-23) พืชที่ไม่มีข้อมูลรายเดือนจะกำกับไว้ ไม่ประมาณการขึ้นมา แหล่งผลิตเป็นการอ่านแบบ ประมาณการ ว่าสินค้าแต่ละชนิดปลูกที่ไหน และแหล่งผลิตทับซ้อนกันได้ บัญชีอาชีพเกษตรเป็นข้อมูลของเราเองและ วัดจริง — บัญชีที่บันทึกอาชีพว่า เกษตร ในจังหวัดแหล่งผลิต จากฐานข้อมูล 382,735 บัญชี ณ 2026-07 ไม่เผยแพร่ช่องที่มีน้อยกว่า 30 บัญชี คนกลุ่มนี้อาศัยอยู่ในพื้นที่ที่ปลูกพืชนั้น แต่ไม่ได้ยืนยันว่าปลูกพืชนั้นเอง</a:t>
+              <a:t>ราคา วัดจริง — ราคาหน้าฟาร์มไทยจากราคารายวันของ NABC และราคาอ้อยประกาศของ สอน. ราคาล่าสุด 2026-08-28 การเปลี่ยนแปลงหกเดือนคำนวณจากข้อมูลรายเดือนของ NABC เอง (thai_price_history รุ่นข้อมูล 2026-08-23) พืชที่ไม่มีข้อมูลรายเดือนจะกำกับไว้ ไม่ประมาณการขึ้นมา แหล่งผลิตเป็นการอ่านแบบ ประมาณการ ว่าสินค้าแต่ละชนิดปลูกที่ไหน และแหล่งผลิตทับซ้อนกันได้ บัญชีอาชีพเกษตรเป็นข้อมูลของเราเองและ วัดจริง — บัญชีที่บันทึกอาชีพว่า เกษตร ในจังหวัดแหล่งผลิต จากฐานข้อมูล 382,735 บัญชี ณ 2026-07 ไม่เผยแพร่ช่องที่มีน้อยกว่า 30 บัญชี คนกลุ่มนี้อาศัยอยู่ในพื้นที่ที่ปลูกพืชนั้น แต่ไม่ได้ยืนยันว่าปลูกพืชนั้นเอง</a:t>
             </a:r>
           </a:p>
         </p:txBody>
@@ -44679,7 +44679,7 @@
                 </a:solidFill>
                 <a:latin typeface="Kanit"/>
               </a:rPr>
-              <a:t>มะพร้าว −67.1% สับปะรด −18.4% อ้อย −17.9% เทียบปีก่อน</a:t>
+              <a:t>มะพร้าว −67.4% สับปะรด −18.4% อ้อย −17.9% เทียบปีก่อน</a:t>
             </a:r>
           </a:p>
         </p:txBody>
@@ -44805,7 +44805,7 @@
                 </a:solidFill>
                 <a:latin typeface="Kanit"/>
               </a:rPr>
-              <a:t>+17.0%</a:t>
+              <a:t>+16.8%</a:t>
             </a:r>
           </a:p>
         </p:txBody>
@@ -45279,7 +45279,7 @@
                           </a:solidFill>
                           <a:latin typeface="Kanit"/>
                         </a:rPr>
-                        <a:t>+6.9%</a:t>
+                        <a:t>+6.7%</a:t>
                       </a:r>
                     </a:p>
                   </a:txBody>
@@ -45348,7 +45348,7 @@
                           </a:solidFill>
                           <a:latin typeface="Kanit"/>
                         </a:rPr>
-                        <a:t>-62.7%</a:t>
+                        <a:t>-63.0%</a:t>
                       </a:r>
                     </a:p>
                   </a:txBody>
@@ -45419,7 +45419,7 @@
                           </a:solidFill>
                           <a:latin typeface="Kanit"/>
                         </a:rPr>
-                        <a:t>+16.1%</a:t>
+                        <a:t>+15.9%</a:t>
                       </a:r>
                     </a:p>
                   </a:txBody>
@@ -45488,7 +45488,7 @@
                           </a:solidFill>
                           <a:latin typeface="Kanit"/>
                         </a:rPr>
-                        <a:t>+10.3%</a:t>
+                        <a:t>+10.1%</a:t>
                       </a:r>
                     </a:p>
                   </a:txBody>
@@ -45559,7 +45559,7 @@
                           </a:solidFill>
                           <a:latin typeface="Kanit"/>
                         </a:rPr>
-                        <a:t>+17.5%</a:t>
+                        <a:t>+17.3%</a:t>
                       </a:r>
                     </a:p>
                   </a:txBody>
@@ -45628,7 +45628,7 @@
                           </a:solidFill>
                           <a:latin typeface="Kanit"/>
                         </a:rPr>
-                        <a:t>+8.8%</a:t>
+                        <a:t>+8.6%</a:t>
                       </a:r>
                     </a:p>
                   </a:txBody>
@@ -45699,7 +45699,7 @@
                           </a:solidFill>
                           <a:latin typeface="Kanit"/>
                         </a:rPr>
-                        <a:t>+25.1%</a:t>
+                        <a:t>+24.9%</a:t>
                       </a:r>
                     </a:p>
                   </a:txBody>
@@ -45768,7 +45768,7 @@
                           </a:solidFill>
                           <a:latin typeface="Kanit"/>
                         </a:rPr>
-                        <a:t>+11.7%</a:t>
+                        <a:t>+11.6%</a:t>
                       </a:r>
                     </a:p>
                   </a:txBody>
@@ -45839,7 +45839,7 @@
                           </a:solidFill>
                           <a:latin typeface="Kanit"/>
                         </a:rPr>
-                        <a:t>+34.7%</a:t>
+                        <a:t>+34.4%</a:t>
                       </a:r>
                     </a:p>
                   </a:txBody>
@@ -45908,7 +45908,7 @@
                           </a:solidFill>
                           <a:latin typeface="Kanit"/>
                         </a:rPr>
-                        <a:t>+27.0%</a:t>
+                        <a:t>+26.9%</a:t>
                       </a:r>
                     </a:p>
                   </a:txBody>
@@ -46084,7 +46084,7 @@
                 </a:solidFill>
                 <a:latin typeface="Kanit"/>
               </a:rPr>
-              <a:t>•  ราคาหน้าฟาร์ม: ยางพารา +40% มันสำปะหลัง +73% ปาล์ม +23% ข้าว +14% รายได้จากพืชเพิ่มขึ้นทุกภาค
+              <a:t>•  ราคาหน้าฟาร์ม: ยางพารา +40% มันสำปะหลัง +74% ปาล์ม +23% ข้าว +14% รายได้จากพืชเพิ่มขึ้นทุกภาค
 •  มีสี่จังหวัดที่ลดลง — ทั้งหมดเป็นมะพร้าว และอยู่ฝั่งอ่าวไทยตะวันตก ราคามะพร้าวลดลง 67%
 •  กำไรบนกระดาษยังไม่ใช่เงินสด — ตารางถัดไปหักราคาด้วยต้นทุน</a:t>
             </a:r>
@@ -46387,7 +46387,7 @@
                           </a:solidFill>
                           <a:latin typeface="Kanit"/>
                         </a:rPr>
-                        <a:t>+18.2%</a:t>
+                        <a:t>+18.0%</a:t>
                       </a:r>
                     </a:p>
                   </a:txBody>
@@ -46550,7 +46550,7 @@
                           </a:solidFill>
                           <a:latin typeface="Kanit"/>
                         </a:rPr>
-                        <a:t>+21.9%</a:t>
+                        <a:t>+21.7%</a:t>
                       </a:r>
                     </a:p>
                   </a:txBody>
@@ -46713,7 +46713,7 @@
                           </a:solidFill>
                           <a:latin typeface="Kanit"/>
                         </a:rPr>
-                        <a:t>+11.9%</a:t>
+                        <a:t>+11.8%</a:t>
                       </a:r>
                     </a:p>
                   </a:txBody>
@@ -46876,7 +46876,7 @@
                           </a:solidFill>
                           <a:latin typeface="Kanit"/>
                         </a:rPr>
-                        <a:t>+32.6%</a:t>
+                        <a:t>+32.4%</a:t>
                       </a:r>
                     </a:p>
                   </a:txBody>
@@ -47039,7 +47039,7 @@
                           </a:solidFill>
                           <a:latin typeface="Kanit"/>
                         </a:rPr>
-                        <a:t>+17.4%</a:t>
+                        <a:t>+17.1%</a:t>
                       </a:r>
                     </a:p>
                   </a:txBody>
@@ -47202,7 +47202,7 @@
                           </a:solidFill>
                           <a:latin typeface="Kanit"/>
                         </a:rPr>
-                        <a:t>+15.9%</a:t>
+                        <a:t>+15.6%</a:t>
                       </a:r>
                     </a:p>
                   </a:txBody>
@@ -48024,7 +48024,7 @@
                 </a:solidFill>
                 <a:latin typeface="Kanit"/>
               </a:rPr>
-              <a:t>เทียบปีก่อน −67.1%</a:t>
+              <a:t>เทียบปีก่อน −67.4%</a:t>
             </a:r>
           </a:p>
         </p:txBody>
@@ -48660,7 +48660,7 @@
                 </a:solidFill>
                 <a:latin typeface="Kanit"/>
               </a:rPr>
-              <a:t>เทียบปีก่อน +1.3%</a:t>
+              <a:t>เทียบปีก่อน +0.9%</a:t>
             </a:r>
           </a:p>
         </p:txBody>
@@ -48978,7 +48978,7 @@
                 </a:solidFill>
                 <a:latin typeface="Kanit"/>
               </a:rPr>
-              <a:t>เทียบปีก่อน +3.6%</a:t>
+              <a:t>เทียบปีก่อน +3.9%</a:t>
             </a:r>
           </a:p>
         </p:txBody>
@@ -49296,7 +49296,7 @@
                 </a:solidFill>
                 <a:latin typeface="Kanit"/>
               </a:rPr>
-              <a:t>เทียบปีก่อน +3.7%</a:t>
+              <a:t>เทียบปีก่อน +4.4%</a:t>
             </a:r>
           </a:p>
         </p:txBody>
@@ -49614,7 +49614,7 @@
                 </a:solidFill>
                 <a:latin typeface="Kanit"/>
               </a:rPr>
-              <a:t>เทียบปีก่อน +10.6%</a:t>
+              <a:t>เทียบปีก่อน +13.1%</a:t>
             </a:r>
           </a:p>
         </p:txBody>
@@ -49932,7 +49932,7 @@
                 </a:solidFill>
                 <a:latin typeface="Kanit"/>
               </a:rPr>
-              <a:t>เทียบปีก่อน +14.3%</a:t>
+              <a:t>เทียบปีก่อน +14.0%</a:t>
             </a:r>
           </a:p>
         </p:txBody>
@@ -50250,7 +50250,7 @@
                 </a:solidFill>
                 <a:latin typeface="Kanit"/>
               </a:rPr>
-              <a:t>เทียบปีก่อน +16.6%</a:t>
+              <a:t>เทียบปีก่อน +16.8%</a:t>
             </a:r>
           </a:p>
         </p:txBody>
@@ -50568,7 +50568,7 @@
                 </a:solidFill>
                 <a:latin typeface="Kanit"/>
               </a:rPr>
-              <a:t>เทียบปีก่อน +23.2%</a:t>
+              <a:t>เทียบปีก่อน +23.1%</a:t>
             </a:r>
           </a:p>
         </p:txBody>
@@ -50886,7 +50886,7 @@
                 </a:solidFill>
                 <a:latin typeface="Kanit"/>
               </a:rPr>
-              <a:t>เทียบปีก่อน +40.1%</a:t>
+              <a:t>เทียบปีก่อน +39.8%</a:t>
             </a:r>
           </a:p>
         </p:txBody>
@@ -51204,7 +51204,7 @@
                 </a:solidFill>
                 <a:latin typeface="Kanit"/>
               </a:rPr>
-              <a:t>เทียบปีก่อน +73.3%</a:t>
+              <a:t>เทียบปีก่อน +73.7%</a:t>
             </a:r>
           </a:p>
         </p:txBody>
@@ -51522,7 +51522,7 @@
                 </a:solidFill>
                 <a:latin typeface="Kanit"/>
               </a:rPr>
-              <a:t>เทียบปีก่อน +107.4%</a:t>
+              <a:t>เทียบปีก่อน +111.6%</a:t>
             </a:r>
           </a:p>
         </p:txBody>
@@ -51886,7 +51886,7 @@
                 </a:solidFill>
                 <a:latin typeface="Kanit"/>
               </a:rPr>
-              <a:t>ราคาหน้าฟาร์ม วัดจริง — ราคารายวันของ NABC เฉลี่ยเป็นรายเดือน หน่วยเป็นบาทตามที่เผยแพร่ (ไม่มีการแปลงสกุลเงิน) ราคาล่าสุด 2026-08-26, รุ่นข้อมูลย้อนหลัง 2026-08-23 ราคาหน้าฟาร์ม (ราคาที่เกษตรกรขายได้) คือเงินที่เกษตรกรได้รับเมื่อขายครั้งแรก ก่อนพ่อค้าคนกลาง โรงสี หรือค่าขนส่งจะหักส่วนแบ่ง — ไม่ใช่ดัชนีโลก และไม่ใช่ราคาในซูเปอร์มาร์เก็ต แหล่งผลิตเป็นการอ่านแบบ ประมาณการ ว่าสินค้าแต่ละชนิดผลิตที่ไหน และทับซ้อนกันได้ น้ำตาลเป็นราคาอ้อยประกาศของ สอน. ปีละหนึ่งจุด จึงไม่มีการเปลี่ยนแปลงหกเดือนให้แสดง</a:t>
+              <a:t>ราคาหน้าฟาร์ม วัดจริง — ราคารายวันของ NABC เฉลี่ยเป็นรายเดือน หน่วยเป็นบาทตามที่เผยแพร่ (ไม่มีการแปลงสกุลเงิน) ราคาล่าสุด 2026-08-28, รุ่นข้อมูลย้อนหลัง 2026-08-23 ราคาหน้าฟาร์ม (ราคาที่เกษตรกรขายได้) คือเงินที่เกษตรกรได้รับเมื่อขายครั้งแรก ก่อนพ่อค้าคนกลาง โรงสี หรือค่าขนส่งจะหักส่วนแบ่ง — ไม่ใช่ดัชนีโลก และไม่ใช่ราคาในซูเปอร์มาร์เก็ต แหล่งผลิตเป็นการอ่านแบบ ประมาณการ ว่าสินค้าแต่ละชนิดผลิตที่ไหน และทับซ้อนกันได้ น้ำตาลเป็นราคาอ้อยประกาศของ สอน. ปีละหนึ่งจุด จึงไม่มีการเปลี่ยนแปลงหกเดือนให้แสดง</a:t>
             </a:r>
           </a:p>
         </p:txBody>

</xml_diff>

<commit_message>
deck(mcom): rebuild — the data moved past the committed figures (run 33189629322) (#680)
Co-authored-by: github-actions[bot] <41898282+github-actions[bot]@users.noreply.github.com>
</commit_message>
<xml_diff>
--- a/docs/decks/mcom-2026-08-05-macro-TH.pptx
+++ b/docs/decks/mcom-2026-08-05-macro-TH.pptx
@@ -6240,7 +6240,7 @@
                 </a:solidFill>
                 <a:latin typeface="Kanit"/>
               </a:rPr>
-              <a:t>131</a:t>
+              <a:t>129</a:t>
             </a:r>
           </a:p>
         </p:txBody>
@@ -6279,7 +6279,7 @@
                 </a:solidFill>
                 <a:latin typeface="Kanit"/>
               </a:rPr>
-              <a:t>จาก 795 (16.5%) · เรียลไทม์ · 2026-08-28</a:t>
+              <a:t>จาก 795 (16.2%) · เรียลไทม์ · 2026-08-28</a:t>
             </a:r>
           </a:p>
         </p:txBody>
@@ -6405,7 +6405,7 @@
                 </a:solidFill>
                 <a:latin typeface="Kanit"/>
               </a:rPr>
-              <a:t>13</a:t>
+              <a:t>22</a:t>
             </a:r>
           </a:p>
         </p:txBody>
@@ -7905,7 +7905,7 @@
                           </a:solidFill>
                           <a:latin typeface="Kanit"/>
                         </a:rPr>
-                        <a:t>36</a:t>
+                        <a:t>38</a:t>
                       </a:r>
                     </a:p>
                   </a:txBody>
@@ -8022,7 +8022,7 @@
                           </a:solidFill>
                           <a:latin typeface="Kanit"/>
                         </a:rPr>
-                        <a:t>กาญจนบุรี</a:t>
+                        <a:t>ตราด</a:t>
                       </a:r>
                     </a:p>
                   </a:txBody>
@@ -8045,7 +8045,7 @@
                           </a:solidFill>
                           <a:latin typeface="Kanit"/>
                         </a:rPr>
-                        <a:t>88</a:t>
+                        <a:t>44</a:t>
                       </a:r>
                     </a:p>
                   </a:txBody>
@@ -8068,7 +8068,7 @@
                           </a:solidFill>
                           <a:latin typeface="Kanit"/>
                         </a:rPr>
-                        <a:t>66</a:t>
+                        <a:t>199</a:t>
                       </a:r>
                     </a:p>
                   </a:txBody>
@@ -8091,7 +8091,7 @@
                           </a:solidFill>
                           <a:latin typeface="Kanit"/>
                         </a:rPr>
-                        <a:t>19.3%</a:t>
+                        <a:t>72.7%</a:t>
                       </a:r>
                     </a:p>
                   </a:txBody>
@@ -8114,7 +8114,7 @@
                           </a:solidFill>
                           <a:latin typeface="Kanit"/>
                         </a:rPr>
-                        <a:t>5/26</a:t>
+                        <a:t>4/9</a:t>
                       </a:r>
                     </a:p>
                   </a:txBody>
@@ -8162,7 +8162,7 @@
                           </a:solidFill>
                           <a:latin typeface="Kanit"/>
                         </a:rPr>
-                        <a:t>ชุมพร</a:t>
+                        <a:t>ปทุมธานี</a:t>
                       </a:r>
                     </a:p>
                   </a:txBody>
@@ -8185,7 +8185,7 @@
                           </a:solidFill>
                           <a:latin typeface="Kanit"/>
                         </a:rPr>
-                        <a:t>90</a:t>
+                        <a:t>10</a:t>
                       </a:r>
                     </a:p>
                   </a:txBody>
@@ -8208,7 +8208,7 @@
                           </a:solidFill>
                           <a:latin typeface="Kanit"/>
                         </a:rPr>
-                        <a:t>65</a:t>
+                        <a:t>71</a:t>
                       </a:r>
                     </a:p>
                   </a:txBody>
@@ -8231,7 +8231,7 @@
                           </a:solidFill>
                           <a:latin typeface="Kanit"/>
                         </a:rPr>
-                        <a:t>12.2%</a:t>
+                        <a:t>50.0%</a:t>
                       </a:r>
                     </a:p>
                   </a:txBody>
@@ -8254,7 +8254,7 @@
                           </a:solidFill>
                           <a:latin typeface="Kanit"/>
                         </a:rPr>
-                        <a:t>3/15</a:t>
+                        <a:t>1/4</a:t>
                       </a:r>
                     </a:p>
                   </a:txBody>
@@ -8302,7 +8302,7 @@
                           </a:solidFill>
                           <a:latin typeface="Kanit"/>
                         </a:rPr>
-                        <a:t>ตราด</a:t>
+                        <a:t>นครนายก</a:t>
                       </a:r>
                     </a:p>
                   </a:txBody>
@@ -8325,7 +8325,7 @@
                           </a:solidFill>
                           <a:latin typeface="Kanit"/>
                         </a:rPr>
-                        <a:t>44</a:t>
+                        <a:t>26</a:t>
                       </a:r>
                     </a:p>
                   </a:txBody>
@@ -8348,7 +8348,7 @@
                           </a:solidFill>
                           <a:latin typeface="Kanit"/>
                         </a:rPr>
-                        <a:t>61</a:t>
+                        <a:t>81</a:t>
                       </a:r>
                     </a:p>
                   </a:txBody>
@@ -8371,7 +8371,7 @@
                           </a:solidFill>
                           <a:latin typeface="Kanit"/>
                         </a:rPr>
-                        <a:t>6.8%</a:t>
+                        <a:t>46.2%</a:t>
                       </a:r>
                     </a:p>
                   </a:txBody>
@@ -8394,7 +8394,7 @@
                           </a:solidFill>
                           <a:latin typeface="Kanit"/>
                         </a:rPr>
-                        <a:t>3/9</a:t>
+                        <a:t>1/6</a:t>
                       </a:r>
                     </a:p>
                   </a:txBody>
@@ -8442,7 +8442,7 @@
                           </a:solidFill>
                           <a:latin typeface="Kanit"/>
                         </a:rPr>
-                        <a:t>ตาก</a:t>
+                        <a:t>จันทบุรี</a:t>
                       </a:r>
                     </a:p>
                   </a:txBody>
@@ -8465,7 +8465,7 @@
                           </a:solidFill>
                           <a:latin typeface="Kanit"/>
                         </a:rPr>
-                        <a:t>109</a:t>
+                        <a:t>52</a:t>
                       </a:r>
                     </a:p>
                   </a:txBody>
@@ -8488,7 +8488,7 @@
                           </a:solidFill>
                           <a:latin typeface="Kanit"/>
                         </a:rPr>
-                        <a:t>51</a:t>
+                        <a:t>172</a:t>
                       </a:r>
                     </a:p>
                   </a:txBody>
@@ -8511,7 +8511,7 @@
                           </a:solidFill>
                           <a:latin typeface="Kanit"/>
                         </a:rPr>
-                        <a:t>2.8%</a:t>
+                        <a:t>34.6%</a:t>
                       </a:r>
                     </a:p>
                   </a:txBody>
@@ -8534,7 +8534,7 @@
                           </a:solidFill>
                           <a:latin typeface="Kanit"/>
                         </a:rPr>
-                        <a:t>1/17</a:t>
+                        <a:t>1/11</a:t>
                       </a:r>
                     </a:p>
                   </a:txBody>
@@ -8582,7 +8582,7 @@
                           </a:solidFill>
                           <a:latin typeface="Kanit"/>
                         </a:rPr>
-                        <a:t>ลำพูน</a:t>
+                        <a:t>ลพบุรี</a:t>
                       </a:r>
                     </a:p>
                   </a:txBody>
@@ -8605,7 +8605,7 @@
                           </a:solidFill>
                           <a:latin typeface="Kanit"/>
                         </a:rPr>
-                        <a:t>73</a:t>
+                        <a:t>27</a:t>
                       </a:r>
                     </a:p>
                   </a:txBody>
@@ -8628,7 +8628,7 @@
                           </a:solidFill>
                           <a:latin typeface="Kanit"/>
                         </a:rPr>
-                        <a:t>43</a:t>
+                        <a:t>61</a:t>
                       </a:r>
                     </a:p>
                   </a:txBody>
@@ -8651,7 +8651,7 @@
                           </a:solidFill>
                           <a:latin typeface="Kanit"/>
                         </a:rPr>
-                        <a:t>2.7%</a:t>
+                        <a:t>25.9%</a:t>
                       </a:r>
                     </a:p>
                   </a:txBody>
@@ -8674,7 +8674,7 @@
                           </a:solidFill>
                           <a:latin typeface="Kanit"/>
                         </a:rPr>
-                        <a:t>1/11</a:t>
+                        <a:t>4/8</a:t>
                       </a:r>
                     </a:p>
                   </a:txBody>
@@ -31476,7 +31476,7 @@
                 </a:solidFill>
                 <a:latin typeface="Kanit"/>
               </a:rPr>
-              <a:t>รายได้จากพืชค่ากลางเพิ่มขึ้น +17.0% แต่มีสี่จังหวัดที่ลดลง — ทั้งหมดอยู่ในแหล่งปลูกมะพร้าว โดยหนักที่สุดคือสมุทรสงครามที่ −62.7%</a:t>
+              <a:t>รายได้จากพืชค่ากลางเพิ่มขึ้น +16.8% แต่มีสี่จังหวัดที่ลดลง — ทั้งหมดอยู่ในแหล่งปลูกมะพร้าว โดยหนักที่สุดคือสมุทรสงครามที่ −63.0%</a:t>
             </a:r>
           </a:p>
         </p:txBody>
@@ -32047,7 +32047,7 @@
                 </a:solidFill>
                 <a:latin typeface="Kanit"/>
               </a:rPr>
-              <a:t>รุ่นข้อมูล — ราคาโลก 2026M06 · ราคาหน้าฟาร์มไทย 2026-08-26 · ประวัติราคาไทย 2026-08-23 · ต้นทุนการผลิตพืช สศก. ไจอัป 2568 (ปีเพาะปลูก 2568/69, ประมาณการ สศก. มี.ค. 2569) · ภัยแล้ง 2026-06-21 · เงินเฟ้อ 2026-05 · GDP 2026 ไตรมาส 1 · IMF WEO 2026 · ดัชนีราคาขายต่อ 2026-05 · ยอดจดทะเบียนถึง 2026-01 · หนี้ครัวเรือน สสช. SES 2566 · ค่าจ้าง สสช. LFS 2568 · ข้อมูลตรวจวัด 2026-08-28</a:t>
+              <a:t>รุ่นข้อมูล — ราคาโลก 2026M06 · ราคาหน้าฟาร์มไทย 2026-08-28 · ประวัติราคาไทย 2026-08-23 · ต้นทุนการผลิตพืช สศก. ไจอัป 2568 (ปีเพาะปลูก 2568/69, ประมาณการ สศก. มี.ค. 2569) · ภัยแล้ง 2026-06-21 · เงินเฟ้อ 2026-05 · GDP 2026 ไตรมาส 1 · IMF WEO 2026 · ดัชนีราคาขายต่อ 2026-05 · ยอดจดทะเบียนถึง 2026-01 · หนี้ครัวเรือน สสช. SES 2566 · ค่าจ้าง สสช. LFS 2568 · ข้อมูลตรวจวัด 2026-08-28</a:t>
             </a:r>
           </a:p>
         </p:txBody>
@@ -32546,7 +32546,7 @@
               <a:t>Not on the world index — the farm gate (ราคาที่เกษตรกรขายได้) says otherwise.
 • Five of seventeen Thai farm-gate prices are falling year on year.
 • Beef: farm gate −6.1% vs world index +8.8%.
-• Margin over price: a 26% price move becomes an 87% swing in crop income.</a:t>
+• Margin over price: a 26% price move becomes an 86% swing in crop income.</a:t>
             </a:r>
           </a:p>
         </p:txBody>
@@ -37087,7 +37087,7 @@
                 </a:solidFill>
                 <a:latin typeface="Kanit"/>
               </a:rPr>
-              <a:t>338 จาก 928 อำเภอ · แม่น้ำเกินระดับ 131 จาก 795 สถานี</a:t>
+              <a:t>338 จาก 928 อำเภอ · แม่น้ำเกินระดับ 129 จาก 795 สถานี</a:t>
             </a:r>
           </a:p>
         </p:txBody>
@@ -37859,7 +37859,7 @@
                           </a:solidFill>
                           <a:latin typeface="Kanit"/>
                         </a:rPr>
-                        <a:t>27/156</a:t>
+                        <a:t>26/156</a:t>
                       </a:r>
                     </a:p>
                   </a:txBody>
@@ -38091,7 +38091,7 @@
                           </a:solidFill>
                           <a:latin typeface="Kanit"/>
                         </a:rPr>
-                        <a:t>22/274</a:t>
+                        <a:t>21/274</a:t>
                       </a:r>
                     </a:p>
                   </a:txBody>
@@ -38323,7 +38323,7 @@
                           </a:solidFill>
                           <a:latin typeface="Kanit"/>
                         </a:rPr>
-                        <a:t>30/168</a:t>
+                        <a:t>29/168</a:t>
                       </a:r>
                     </a:p>
                   </a:txBody>
@@ -38555,7 +38555,7 @@
                           </a:solidFill>
                           <a:latin typeface="Kanit"/>
                         </a:rPr>
-                        <a:t>7/52</a:t>
+                        <a:t>8/52</a:t>
                       </a:r>
                     </a:p>
                   </a:txBody>
@@ -39936,7 +39936,7 @@
                           </a:solidFill>
                           <a:latin typeface="Kanit"/>
                         </a:rPr>
-                        <a:t>−67.1%</a:t>
+                        <a:t>−67.4%</a:t>
                       </a:r>
                     </a:p>
                   </a:txBody>
@@ -40791,7 +40791,7 @@
                 </a:solidFill>
                 <a:latin typeface="Kanit"/>
               </a:rPr>
-              <a:t>ราคา วัดจริง — ราคาหน้าฟาร์มไทยจากราคารายวันของ NABC และราคาอ้อยประกาศของ สอน. ราคาล่าสุด 2026-08-26 การเปลี่ยนแปลงหกเดือนคำนวณจากข้อมูลรายเดือนของ NABC เอง (thai_price_history รุ่นข้อมูล 2026-08-23) พืชที่ไม่มีข้อมูลรายเดือนจะกำกับไว้ ไม่ประมาณการขึ้นมา แหล่งผลิตเป็นการอ่านแบบ ประมาณการ ว่าสินค้าแต่ละชนิดปลูกที่ไหน และแหล่งผลิตทับซ้อนกันได้ บัญชีอาชีพเกษตรเป็นข้อมูลของเราเองและ วัดจริง — บัญชีที่บันทึกอาชีพว่า เกษตร ในจังหวัดแหล่งผลิต จากฐานข้อมูล 382,735 บัญชี ณ 2026-07 ไม่เผยแพร่ช่องที่มีน้อยกว่า 30 บัญชี คนกลุ่มนี้อาศัยอยู่ในพื้นที่ที่ปลูกพืชนั้น แต่ไม่ได้ยืนยันว่าปลูกพืชนั้นเอง</a:t>
+              <a:t>ราคา วัดจริง — ราคาหน้าฟาร์มไทยจากราคารายวันของ NABC และราคาอ้อยประกาศของ สอน. ราคาล่าสุด 2026-08-28 การเปลี่ยนแปลงหกเดือนคำนวณจากข้อมูลรายเดือนของ NABC เอง (thai_price_history รุ่นข้อมูล 2026-08-23) พืชที่ไม่มีข้อมูลรายเดือนจะกำกับไว้ ไม่ประมาณการขึ้นมา แหล่งผลิตเป็นการอ่านแบบ ประมาณการ ว่าสินค้าแต่ละชนิดปลูกที่ไหน และแหล่งผลิตทับซ้อนกันได้ บัญชีอาชีพเกษตรเป็นข้อมูลของเราเองและ วัดจริง — บัญชีที่บันทึกอาชีพว่า เกษตร ในจังหวัดแหล่งผลิต จากฐานข้อมูล 382,735 บัญชี ณ 2026-07 ไม่เผยแพร่ช่องที่มีน้อยกว่า 30 บัญชี คนกลุ่มนี้อาศัยอยู่ในพื้นที่ที่ปลูกพืชนั้น แต่ไม่ได้ยืนยันว่าปลูกพืชนั้นเอง</a:t>
             </a:r>
           </a:p>
         </p:txBody>
@@ -44679,7 +44679,7 @@
                 </a:solidFill>
                 <a:latin typeface="Kanit"/>
               </a:rPr>
-              <a:t>มะพร้าว −67.1% สับปะรด −18.4% อ้อย −17.9% เทียบปีก่อน</a:t>
+              <a:t>มะพร้าว −67.4% สับปะรด −18.4% อ้อย −17.9% เทียบปีก่อน</a:t>
             </a:r>
           </a:p>
         </p:txBody>
@@ -44805,7 +44805,7 @@
                 </a:solidFill>
                 <a:latin typeface="Kanit"/>
               </a:rPr>
-              <a:t>+17.0%</a:t>
+              <a:t>+16.8%</a:t>
             </a:r>
           </a:p>
         </p:txBody>
@@ -45279,7 +45279,7 @@
                           </a:solidFill>
                           <a:latin typeface="Kanit"/>
                         </a:rPr>
-                        <a:t>+6.9%</a:t>
+                        <a:t>+6.7%</a:t>
                       </a:r>
                     </a:p>
                   </a:txBody>
@@ -45348,7 +45348,7 @@
                           </a:solidFill>
                           <a:latin typeface="Kanit"/>
                         </a:rPr>
-                        <a:t>-62.7%</a:t>
+                        <a:t>-63.0%</a:t>
                       </a:r>
                     </a:p>
                   </a:txBody>
@@ -45419,7 +45419,7 @@
                           </a:solidFill>
                           <a:latin typeface="Kanit"/>
                         </a:rPr>
-                        <a:t>+16.1%</a:t>
+                        <a:t>+15.9%</a:t>
                       </a:r>
                     </a:p>
                   </a:txBody>
@@ -45488,7 +45488,7 @@
                           </a:solidFill>
                           <a:latin typeface="Kanit"/>
                         </a:rPr>
-                        <a:t>+10.3%</a:t>
+                        <a:t>+10.1%</a:t>
                       </a:r>
                     </a:p>
                   </a:txBody>
@@ -45559,7 +45559,7 @@
                           </a:solidFill>
                           <a:latin typeface="Kanit"/>
                         </a:rPr>
-                        <a:t>+17.5%</a:t>
+                        <a:t>+17.3%</a:t>
                       </a:r>
                     </a:p>
                   </a:txBody>
@@ -45628,7 +45628,7 @@
                           </a:solidFill>
                           <a:latin typeface="Kanit"/>
                         </a:rPr>
-                        <a:t>+8.8%</a:t>
+                        <a:t>+8.6%</a:t>
                       </a:r>
                     </a:p>
                   </a:txBody>
@@ -45699,7 +45699,7 @@
                           </a:solidFill>
                           <a:latin typeface="Kanit"/>
                         </a:rPr>
-                        <a:t>+25.1%</a:t>
+                        <a:t>+24.9%</a:t>
                       </a:r>
                     </a:p>
                   </a:txBody>
@@ -45768,7 +45768,7 @@
                           </a:solidFill>
                           <a:latin typeface="Kanit"/>
                         </a:rPr>
-                        <a:t>+11.7%</a:t>
+                        <a:t>+11.6%</a:t>
                       </a:r>
                     </a:p>
                   </a:txBody>
@@ -45839,7 +45839,7 @@
                           </a:solidFill>
                           <a:latin typeface="Kanit"/>
                         </a:rPr>
-                        <a:t>+34.7%</a:t>
+                        <a:t>+34.4%</a:t>
                       </a:r>
                     </a:p>
                   </a:txBody>
@@ -45908,7 +45908,7 @@
                           </a:solidFill>
                           <a:latin typeface="Kanit"/>
                         </a:rPr>
-                        <a:t>+27.0%</a:t>
+                        <a:t>+26.9%</a:t>
                       </a:r>
                     </a:p>
                   </a:txBody>
@@ -46084,7 +46084,7 @@
                 </a:solidFill>
                 <a:latin typeface="Kanit"/>
               </a:rPr>
-              <a:t>•  ราคาหน้าฟาร์ม: ยางพารา +40% มันสำปะหลัง +73% ปาล์ม +23% ข้าว +14% รายได้จากพืชเพิ่มขึ้นทุกภาค
+              <a:t>•  ราคาหน้าฟาร์ม: ยางพารา +40% มันสำปะหลัง +74% ปาล์ม +23% ข้าว +14% รายได้จากพืชเพิ่มขึ้นทุกภาค
 •  มีสี่จังหวัดที่ลดลง — ทั้งหมดเป็นมะพร้าว และอยู่ฝั่งอ่าวไทยตะวันตก ราคามะพร้าวลดลง 67%
 •  กำไรบนกระดาษยังไม่ใช่เงินสด — ตารางถัดไปหักราคาด้วยต้นทุน</a:t>
             </a:r>
@@ -46387,7 +46387,7 @@
                           </a:solidFill>
                           <a:latin typeface="Kanit"/>
                         </a:rPr>
-                        <a:t>+18.2%</a:t>
+                        <a:t>+18.0%</a:t>
                       </a:r>
                     </a:p>
                   </a:txBody>
@@ -46550,7 +46550,7 @@
                           </a:solidFill>
                           <a:latin typeface="Kanit"/>
                         </a:rPr>
-                        <a:t>+21.9%</a:t>
+                        <a:t>+21.7%</a:t>
                       </a:r>
                     </a:p>
                   </a:txBody>
@@ -46713,7 +46713,7 @@
                           </a:solidFill>
                           <a:latin typeface="Kanit"/>
                         </a:rPr>
-                        <a:t>+11.9%</a:t>
+                        <a:t>+11.8%</a:t>
                       </a:r>
                     </a:p>
                   </a:txBody>
@@ -46876,7 +46876,7 @@
                           </a:solidFill>
                           <a:latin typeface="Kanit"/>
                         </a:rPr>
-                        <a:t>+32.6%</a:t>
+                        <a:t>+32.4%</a:t>
                       </a:r>
                     </a:p>
                   </a:txBody>
@@ -47039,7 +47039,7 @@
                           </a:solidFill>
                           <a:latin typeface="Kanit"/>
                         </a:rPr>
-                        <a:t>+17.4%</a:t>
+                        <a:t>+17.1%</a:t>
                       </a:r>
                     </a:p>
                   </a:txBody>
@@ -47202,7 +47202,7 @@
                           </a:solidFill>
                           <a:latin typeface="Kanit"/>
                         </a:rPr>
-                        <a:t>+15.9%</a:t>
+                        <a:t>+15.6%</a:t>
                       </a:r>
                     </a:p>
                   </a:txBody>
@@ -48024,7 +48024,7 @@
                 </a:solidFill>
                 <a:latin typeface="Kanit"/>
               </a:rPr>
-              <a:t>เทียบปีก่อน −67.1%</a:t>
+              <a:t>เทียบปีก่อน −67.4%</a:t>
             </a:r>
           </a:p>
         </p:txBody>
@@ -48660,7 +48660,7 @@
                 </a:solidFill>
                 <a:latin typeface="Kanit"/>
               </a:rPr>
-              <a:t>เทียบปีก่อน +1.3%</a:t>
+              <a:t>เทียบปีก่อน +0.9%</a:t>
             </a:r>
           </a:p>
         </p:txBody>
@@ -48978,7 +48978,7 @@
                 </a:solidFill>
                 <a:latin typeface="Kanit"/>
               </a:rPr>
-              <a:t>เทียบปีก่อน +3.6%</a:t>
+              <a:t>เทียบปีก่อน +3.9%</a:t>
             </a:r>
           </a:p>
         </p:txBody>
@@ -49296,7 +49296,7 @@
                 </a:solidFill>
                 <a:latin typeface="Kanit"/>
               </a:rPr>
-              <a:t>เทียบปีก่อน +3.7%</a:t>
+              <a:t>เทียบปีก่อน +4.4%</a:t>
             </a:r>
           </a:p>
         </p:txBody>
@@ -49614,7 +49614,7 @@
                 </a:solidFill>
                 <a:latin typeface="Kanit"/>
               </a:rPr>
-              <a:t>เทียบปีก่อน +10.6%</a:t>
+              <a:t>เทียบปีก่อน +13.1%</a:t>
             </a:r>
           </a:p>
         </p:txBody>
@@ -49932,7 +49932,7 @@
                 </a:solidFill>
                 <a:latin typeface="Kanit"/>
               </a:rPr>
-              <a:t>เทียบปีก่อน +14.3%</a:t>
+              <a:t>เทียบปีก่อน +14.0%</a:t>
             </a:r>
           </a:p>
         </p:txBody>
@@ -50250,7 +50250,7 @@
                 </a:solidFill>
                 <a:latin typeface="Kanit"/>
               </a:rPr>
-              <a:t>เทียบปีก่อน +16.6%</a:t>
+              <a:t>เทียบปีก่อน +16.8%</a:t>
             </a:r>
           </a:p>
         </p:txBody>
@@ -50568,7 +50568,7 @@
                 </a:solidFill>
                 <a:latin typeface="Kanit"/>
               </a:rPr>
-              <a:t>เทียบปีก่อน +23.2%</a:t>
+              <a:t>เทียบปีก่อน +23.1%</a:t>
             </a:r>
           </a:p>
         </p:txBody>
@@ -50886,7 +50886,7 @@
                 </a:solidFill>
                 <a:latin typeface="Kanit"/>
               </a:rPr>
-              <a:t>เทียบปีก่อน +40.1%</a:t>
+              <a:t>เทียบปีก่อน +39.8%</a:t>
             </a:r>
           </a:p>
         </p:txBody>
@@ -51204,7 +51204,7 @@
                 </a:solidFill>
                 <a:latin typeface="Kanit"/>
               </a:rPr>
-              <a:t>เทียบปีก่อน +73.3%</a:t>
+              <a:t>เทียบปีก่อน +73.7%</a:t>
             </a:r>
           </a:p>
         </p:txBody>
@@ -51522,7 +51522,7 @@
                 </a:solidFill>
                 <a:latin typeface="Kanit"/>
               </a:rPr>
-              <a:t>เทียบปีก่อน +107.4%</a:t>
+              <a:t>เทียบปีก่อน +111.6%</a:t>
             </a:r>
           </a:p>
         </p:txBody>
@@ -51886,7 +51886,7 @@
                 </a:solidFill>
                 <a:latin typeface="Kanit"/>
               </a:rPr>
-              <a:t>ราคาหน้าฟาร์ม วัดจริง — ราคารายวันของ NABC เฉลี่ยเป็นรายเดือน หน่วยเป็นบาทตามที่เผยแพร่ (ไม่มีการแปลงสกุลเงิน) ราคาล่าสุด 2026-08-26, รุ่นข้อมูลย้อนหลัง 2026-08-23 ราคาหน้าฟาร์ม (ราคาที่เกษตรกรขายได้) คือเงินที่เกษตรกรได้รับเมื่อขายครั้งแรก ก่อนพ่อค้าคนกลาง โรงสี หรือค่าขนส่งจะหักส่วนแบ่ง — ไม่ใช่ดัชนีโลก และไม่ใช่ราคาในซูเปอร์มาร์เก็ต แหล่งผลิตเป็นการอ่านแบบ ประมาณการ ว่าสินค้าแต่ละชนิดผลิตที่ไหน และทับซ้อนกันได้ น้ำตาลเป็นราคาอ้อยประกาศของ สอน. ปีละหนึ่งจุด จึงไม่มีการเปลี่ยนแปลงหกเดือนให้แสดง</a:t>
+              <a:t>ราคาหน้าฟาร์ม วัดจริง — ราคารายวันของ NABC เฉลี่ยเป็นรายเดือน หน่วยเป็นบาทตามที่เผยแพร่ (ไม่มีการแปลงสกุลเงิน) ราคาล่าสุด 2026-08-28, รุ่นข้อมูลย้อนหลัง 2026-08-23 ราคาหน้าฟาร์ม (ราคาที่เกษตรกรขายได้) คือเงินที่เกษตรกรได้รับเมื่อขายครั้งแรก ก่อนพ่อค้าคนกลาง โรงสี หรือค่าขนส่งจะหักส่วนแบ่ง — ไม่ใช่ดัชนีโลก และไม่ใช่ราคาในซูเปอร์มาร์เก็ต แหล่งผลิตเป็นการอ่านแบบ ประมาณการ ว่าสินค้าแต่ละชนิดผลิตที่ไหน และทับซ้อนกันได้ น้ำตาลเป็นราคาอ้อยประกาศของ สอน. ปีละหนึ่งจุด จึงไม่มีการเปลี่ยนแปลงหกเดือนให้แสดง</a:t>
             </a:r>
           </a:p>
         </p:txBody>

</xml_diff>

<commit_message>
deck(mcom): rebuild — the data moved past the committed figures (run 33223777745)
</commit_message>
<xml_diff>
--- a/docs/decks/mcom-2026-08-05-macro-TH.pptx
+++ b/docs/decks/mcom-2026-08-05-macro-TH.pptx
@@ -6240,7 +6240,7 @@
                 </a:solidFill>
                 <a:latin typeface="Kanit"/>
               </a:rPr>
-              <a:t>129</a:t>
+              <a:t>135</a:t>
             </a:r>
           </a:p>
         </p:txBody>
@@ -6279,7 +6279,7 @@
                 </a:solidFill>
                 <a:latin typeface="Kanit"/>
               </a:rPr>
-              <a:t>จาก 795 (16.2%) · เรียลไทม์ · 2026-08-28</a:t>
+              <a:t>จาก 794 (17.0%) · เรียลไทม์ · 2026-08-29</a:t>
             </a:r>
           </a:p>
         </p:txBody>
@@ -6444,7 +6444,7 @@
                 </a:solidFill>
                 <a:latin typeface="Kanit"/>
               </a:rPr>
-              <a:t>ค่าล่าสุดรายวัน · 2026-08-28</a:t>
+              <a:t>ค่าล่าสุดรายวัน · 2026-08-29</a:t>
             </a:r>
           </a:p>
         </p:txBody>
@@ -7928,7 +7928,7 @@
                           </a:solidFill>
                           <a:latin typeface="Kanit"/>
                         </a:rPr>
-                        <a:t>33</a:t>
+                        <a:t>23</a:t>
                       </a:r>
                     </a:p>
                   </a:txBody>
@@ -8045,7 +8045,7 @@
                           </a:solidFill>
                           <a:latin typeface="Kanit"/>
                         </a:rPr>
-                        <a:t>44</a:t>
+                        <a:t>42</a:t>
                       </a:r>
                     </a:p>
                   </a:txBody>
@@ -8068,7 +8068,7 @@
                           </a:solidFill>
                           <a:latin typeface="Kanit"/>
                         </a:rPr>
-                        <a:t>199</a:t>
+                        <a:t>196</a:t>
                       </a:r>
                     </a:p>
                   </a:txBody>
@@ -8091,7 +8091,7 @@
                           </a:solidFill>
                           <a:latin typeface="Kanit"/>
                         </a:rPr>
-                        <a:t>72.7%</a:t>
+                        <a:t>73.8%</a:t>
                       </a:r>
                     </a:p>
                   </a:txBody>
@@ -8162,7 +8162,7 @@
                           </a:solidFill>
                           <a:latin typeface="Kanit"/>
                         </a:rPr>
-                        <a:t>ปทุมธานี</a:t>
+                        <a:t>ระนอง</a:t>
                       </a:r>
                     </a:p>
                   </a:txBody>
@@ -8185,7 +8185,7 @@
                           </a:solidFill>
                           <a:latin typeface="Kanit"/>
                         </a:rPr>
-                        <a:t>10</a:t>
+                        <a:t>50</a:t>
                       </a:r>
                     </a:p>
                   </a:txBody>
@@ -8208,7 +8208,7 @@
                           </a:solidFill>
                           <a:latin typeface="Kanit"/>
                         </a:rPr>
-                        <a:t>71</a:t>
+                        <a:t>137</a:t>
                       </a:r>
                     </a:p>
                   </a:txBody>
@@ -8231,7 +8231,7 @@
                           </a:solidFill>
                           <a:latin typeface="Kanit"/>
                         </a:rPr>
-                        <a:t>50.0%</a:t>
+                        <a:t>56.0%</a:t>
                       </a:r>
                     </a:p>
                   </a:txBody>
@@ -8302,7 +8302,7 @@
                           </a:solidFill>
                           <a:latin typeface="Kanit"/>
                         </a:rPr>
-                        <a:t>นครนายก</a:t>
+                        <a:t>ปทุมธานี</a:t>
                       </a:r>
                     </a:p>
                   </a:txBody>
@@ -8325,7 +8325,7 @@
                           </a:solidFill>
                           <a:latin typeface="Kanit"/>
                         </a:rPr>
-                        <a:t>26</a:t>
+                        <a:t>10</a:t>
                       </a:r>
                     </a:p>
                   </a:txBody>
@@ -8348,7 +8348,7 @@
                           </a:solidFill>
                           <a:latin typeface="Kanit"/>
                         </a:rPr>
-                        <a:t>81</a:t>
+                        <a:t>72</a:t>
                       </a:r>
                     </a:p>
                   </a:txBody>
@@ -8371,7 +8371,7 @@
                           </a:solidFill>
                           <a:latin typeface="Kanit"/>
                         </a:rPr>
-                        <a:t>46.2%</a:t>
+                        <a:t>50.0%</a:t>
                       </a:r>
                     </a:p>
                   </a:txBody>
@@ -8394,7 +8394,7 @@
                           </a:solidFill>
                           <a:latin typeface="Kanit"/>
                         </a:rPr>
-                        <a:t>1/6</a:t>
+                        <a:t>2/4</a:t>
                       </a:r>
                     </a:p>
                   </a:txBody>
@@ -8442,7 +8442,7 @@
                           </a:solidFill>
                           <a:latin typeface="Kanit"/>
                         </a:rPr>
-                        <a:t>จันทบุรี</a:t>
+                        <a:t>นครนายก</a:t>
                       </a:r>
                     </a:p>
                   </a:txBody>
@@ -8465,7 +8465,7 @@
                           </a:solidFill>
                           <a:latin typeface="Kanit"/>
                         </a:rPr>
-                        <a:t>52</a:t>
+                        <a:t>26</a:t>
                       </a:r>
                     </a:p>
                   </a:txBody>
@@ -8488,7 +8488,7 @@
                           </a:solidFill>
                           <a:latin typeface="Kanit"/>
                         </a:rPr>
-                        <a:t>172</a:t>
+                        <a:t>119</a:t>
                       </a:r>
                     </a:p>
                   </a:txBody>
@@ -8511,7 +8511,7 @@
                           </a:solidFill>
                           <a:latin typeface="Kanit"/>
                         </a:rPr>
-                        <a:t>34.6%</a:t>
+                        <a:t>46.2%</a:t>
                       </a:r>
                     </a:p>
                   </a:txBody>
@@ -8534,7 +8534,7 @@
                           </a:solidFill>
                           <a:latin typeface="Kanit"/>
                         </a:rPr>
-                        <a:t>1/11</a:t>
+                        <a:t>2/6</a:t>
                       </a:r>
                     </a:p>
                   </a:txBody>
@@ -8582,7 +8582,7 @@
                           </a:solidFill>
                           <a:latin typeface="Kanit"/>
                         </a:rPr>
-                        <a:t>ลพบุรี</a:t>
+                        <a:t>จันทบุรี</a:t>
                       </a:r>
                     </a:p>
                   </a:txBody>
@@ -8605,7 +8605,7 @@
                           </a:solidFill>
                           <a:latin typeface="Kanit"/>
                         </a:rPr>
-                        <a:t>27</a:t>
+                        <a:t>52</a:t>
                       </a:r>
                     </a:p>
                   </a:txBody>
@@ -8628,7 +8628,7 @@
                           </a:solidFill>
                           <a:latin typeface="Kanit"/>
                         </a:rPr>
-                        <a:t>61</a:t>
+                        <a:t>168</a:t>
                       </a:r>
                     </a:p>
                   </a:txBody>
@@ -8651,7 +8651,7 @@
                           </a:solidFill>
                           <a:latin typeface="Kanit"/>
                         </a:rPr>
-                        <a:t>25.9%</a:t>
+                        <a:t>34.6%</a:t>
                       </a:r>
                     </a:p>
                   </a:txBody>
@@ -8674,7 +8674,7 @@
                           </a:solidFill>
                           <a:latin typeface="Kanit"/>
                         </a:rPr>
-                        <a:t>4/8</a:t>
+                        <a:t>5/11</a:t>
                       </a:r>
                     </a:p>
                   </a:txBody>
@@ -8909,7 +8909,7 @@
                 </a:solidFill>
                 <a:latin typeface="Kanit"/>
               </a:rPr>
-              <a:t>พื้นที่ปลูก วัดจริง (สศก. — ข้อมูลอำเภอ×พืช 3,295 แถว) ภัยแล้งเป็นดัชนี SPEI จาก แบบจำลอง คำนวณจากปริมาณฝนและการคายระเหย ปรับเดือนละครั้ง ดึงข้อมูล 2026-07-20 — เป็นสัญญาณที่ครอบคลุมทั้งประเทศดีที่สุดที่มี แต่ไม่มีใครลงพื้นที่ไปเดินดูอำเภอเหล่านั้น ข้อมูลฝนและระดับน้ำ วัดจริง (ThaiWater เรียลไทม์ ดึงทุกวันและสะสมไว้ — วันที่ดึงไม่สำเร็จจะเว้นเป็นช่องว่าง ไม่ใส่ค่าสมมติ) · ฝนถึง 2026-08-28, ระดับน้ำถึง 2026-08-28 ความเสี่ยงน้ำท่วมเชิงโครงสร้าง วัดจริง (สำมะโนพื้นที่ท่วมซ้ำซาก GISTDA มาตราส่วน 1:50,000 ปี 2005-2016 — เป็นบันทึกภาคพื้นดิน 12 ปี ไม่ใช่การพยากรณ์)</a:t>
+              <a:t>พื้นที่ปลูก วัดจริง (สศก. — ข้อมูลอำเภอ×พืช 3,295 แถว) ภัยแล้งเป็นดัชนี SPEI จาก แบบจำลอง คำนวณจากปริมาณฝนและการคายระเหย ปรับเดือนละครั้ง ดึงข้อมูล 2026-07-20 — เป็นสัญญาณที่ครอบคลุมทั้งประเทศดีที่สุดที่มี แต่ไม่มีใครลงพื้นที่ไปเดินดูอำเภอเหล่านั้น ข้อมูลฝนและระดับน้ำ วัดจริง (ThaiWater เรียลไทม์ ดึงทุกวันและสะสมไว้ — วันที่ดึงไม่สำเร็จจะเว้นเป็นช่องว่าง ไม่ใส่ค่าสมมติ) · ฝนถึง 2026-08-29, ระดับน้ำถึง 2026-08-29 ความเสี่ยงน้ำท่วมเชิงโครงสร้าง วัดจริง (สำมะโนพื้นที่ท่วมซ้ำซาก GISTDA มาตราส่วน 1:50,000 ปี 2005-2016 — เป็นบันทึกภาคพื้นดิน 12 ปี ไม่ใช่การพยากรณ์)</a:t>
             </a:r>
           </a:p>
         </p:txBody>
@@ -32047,7 +32047,7 @@
                 </a:solidFill>
                 <a:latin typeface="Kanit"/>
               </a:rPr>
-              <a:t>รุ่นข้อมูล — ราคาโลก 2026M06 · ราคาหน้าฟาร์มไทย 2026-08-28 · ประวัติราคาไทย 2026-08-23 · ต้นทุนการผลิตพืช สศก. ไจอัป 2568 (ปีเพาะปลูก 2568/69, ประมาณการ สศก. มี.ค. 2569) · ภัยแล้ง 2026-06-21 · เงินเฟ้อ 2026-05 · GDP 2026 ไตรมาส 1 · IMF WEO 2026 · ดัชนีราคาขายต่อ 2026-05 · ยอดจดทะเบียนถึง 2026-01 · หนี้ครัวเรือน สสช. SES 2566 · ค่าจ้าง สสช. LFS 2568 · ข้อมูลตรวจวัด 2026-08-28</a:t>
+              <a:t>รุ่นข้อมูล — ราคาโลก 2026M06 · ราคาหน้าฟาร์มไทย 2026-08-28 · ประวัติราคาไทย 2026-08-23 · ต้นทุนการผลิตพืช สศก. ไจอัป 2568 (ปีเพาะปลูก 2568/69, ประมาณการ สศก. มี.ค. 2569) · ภัยแล้ง 2026-06-21 · เงินเฟ้อ 2026-05 · GDP 2026 ไตรมาส 1 · IMF WEO 2026 · ดัชนีราคาขายต่อ 2026-05 · ยอดจดทะเบียนถึง 2026-01 · หนี้ครัวเรือน สสช. SES 2566 · ค่าจ้าง สสช. LFS 2568 · ข้อมูลตรวจวัด 2026-08-29</a:t>
             </a:r>
           </a:p>
         </p:txBody>
@@ -37087,7 +37087,7 @@
                 </a:solidFill>
                 <a:latin typeface="Kanit"/>
               </a:rPr>
-              <a:t>338 จาก 928 อำเภอ · แม่น้ำเกินระดับ 129 จาก 795 สถานี</a:t>
+              <a:t>338 จาก 928 อำเภอ · แม่น้ำเกินระดับ 135 จาก 794 สถานี</a:t>
             </a:r>
           </a:p>
         </p:txBody>
@@ -37859,7 +37859,7 @@
                           </a:solidFill>
                           <a:latin typeface="Kanit"/>
                         </a:rPr>
-                        <a:t>26/156</a:t>
+                        <a:t>25/156</a:t>
                       </a:r>
                     </a:p>
                   </a:txBody>
@@ -38091,7 +38091,7 @@
                           </a:solidFill>
                           <a:latin typeface="Kanit"/>
                         </a:rPr>
-                        <a:t>21/274</a:t>
+                        <a:t>20/273</a:t>
                       </a:r>
                     </a:p>
                   </a:txBody>
@@ -38323,7 +38323,7 @@
                           </a:solidFill>
                           <a:latin typeface="Kanit"/>
                         </a:rPr>
-                        <a:t>29/168</a:t>
+                        <a:t>30/168</a:t>
                       </a:r>
                     </a:p>
                   </a:txBody>
@@ -38555,7 +38555,7 @@
                           </a:solidFill>
                           <a:latin typeface="Kanit"/>
                         </a:rPr>
-                        <a:t>8/52</a:t>
+                        <a:t>13/52</a:t>
                       </a:r>
                     </a:p>
                   </a:txBody>
@@ -38787,7 +38787,7 @@
                           </a:solidFill>
                           <a:latin typeface="Kanit"/>
                         </a:rPr>
-                        <a:t>45/145</a:t>
+                        <a:t>47/145</a:t>
                       </a:r>
                     </a:p>
                   </a:txBody>

</xml_diff>

<commit_message>
deck(mcom): rebuild — the data moved past the committed figures (run 33223777745) (#686)
Co-authored-by: github-actions[bot] <41898282+github-actions[bot]@users.noreply.github.com>
</commit_message>
<xml_diff>
--- a/docs/decks/mcom-2026-08-05-macro-TH.pptx
+++ b/docs/decks/mcom-2026-08-05-macro-TH.pptx
@@ -6240,7 +6240,7 @@
                 </a:solidFill>
                 <a:latin typeface="Kanit"/>
               </a:rPr>
-              <a:t>129</a:t>
+              <a:t>135</a:t>
             </a:r>
           </a:p>
         </p:txBody>
@@ -6279,7 +6279,7 @@
                 </a:solidFill>
                 <a:latin typeface="Kanit"/>
               </a:rPr>
-              <a:t>จาก 795 (16.2%) · เรียลไทม์ · 2026-08-28</a:t>
+              <a:t>จาก 794 (17.0%) · เรียลไทม์ · 2026-08-29</a:t>
             </a:r>
           </a:p>
         </p:txBody>
@@ -6444,7 +6444,7 @@
                 </a:solidFill>
                 <a:latin typeface="Kanit"/>
               </a:rPr>
-              <a:t>ค่าล่าสุดรายวัน · 2026-08-28</a:t>
+              <a:t>ค่าล่าสุดรายวัน · 2026-08-29</a:t>
             </a:r>
           </a:p>
         </p:txBody>
@@ -7928,7 +7928,7 @@
                           </a:solidFill>
                           <a:latin typeface="Kanit"/>
                         </a:rPr>
-                        <a:t>33</a:t>
+                        <a:t>23</a:t>
                       </a:r>
                     </a:p>
                   </a:txBody>
@@ -8045,7 +8045,7 @@
                           </a:solidFill>
                           <a:latin typeface="Kanit"/>
                         </a:rPr>
-                        <a:t>44</a:t>
+                        <a:t>42</a:t>
                       </a:r>
                     </a:p>
                   </a:txBody>
@@ -8068,7 +8068,7 @@
                           </a:solidFill>
                           <a:latin typeface="Kanit"/>
                         </a:rPr>
-                        <a:t>199</a:t>
+                        <a:t>196</a:t>
                       </a:r>
                     </a:p>
                   </a:txBody>
@@ -8091,7 +8091,7 @@
                           </a:solidFill>
                           <a:latin typeface="Kanit"/>
                         </a:rPr>
-                        <a:t>72.7%</a:t>
+                        <a:t>73.8%</a:t>
                       </a:r>
                     </a:p>
                   </a:txBody>
@@ -8162,7 +8162,7 @@
                           </a:solidFill>
                           <a:latin typeface="Kanit"/>
                         </a:rPr>
-                        <a:t>ปทุมธานี</a:t>
+                        <a:t>ระนอง</a:t>
                       </a:r>
                     </a:p>
                   </a:txBody>
@@ -8185,7 +8185,7 @@
                           </a:solidFill>
                           <a:latin typeface="Kanit"/>
                         </a:rPr>
-                        <a:t>10</a:t>
+                        <a:t>50</a:t>
                       </a:r>
                     </a:p>
                   </a:txBody>
@@ -8208,7 +8208,7 @@
                           </a:solidFill>
                           <a:latin typeface="Kanit"/>
                         </a:rPr>
-                        <a:t>71</a:t>
+                        <a:t>137</a:t>
                       </a:r>
                     </a:p>
                   </a:txBody>
@@ -8231,7 +8231,7 @@
                           </a:solidFill>
                           <a:latin typeface="Kanit"/>
                         </a:rPr>
-                        <a:t>50.0%</a:t>
+                        <a:t>56.0%</a:t>
                       </a:r>
                     </a:p>
                   </a:txBody>
@@ -8302,7 +8302,7 @@
                           </a:solidFill>
                           <a:latin typeface="Kanit"/>
                         </a:rPr>
-                        <a:t>นครนายก</a:t>
+                        <a:t>ปทุมธานี</a:t>
                       </a:r>
                     </a:p>
                   </a:txBody>
@@ -8325,7 +8325,7 @@
                           </a:solidFill>
                           <a:latin typeface="Kanit"/>
                         </a:rPr>
-                        <a:t>26</a:t>
+                        <a:t>10</a:t>
                       </a:r>
                     </a:p>
                   </a:txBody>
@@ -8348,7 +8348,7 @@
                           </a:solidFill>
                           <a:latin typeface="Kanit"/>
                         </a:rPr>
-                        <a:t>81</a:t>
+                        <a:t>72</a:t>
                       </a:r>
                     </a:p>
                   </a:txBody>
@@ -8371,7 +8371,7 @@
                           </a:solidFill>
                           <a:latin typeface="Kanit"/>
                         </a:rPr>
-                        <a:t>46.2%</a:t>
+                        <a:t>50.0%</a:t>
                       </a:r>
                     </a:p>
                   </a:txBody>
@@ -8394,7 +8394,7 @@
                           </a:solidFill>
                           <a:latin typeface="Kanit"/>
                         </a:rPr>
-                        <a:t>1/6</a:t>
+                        <a:t>2/4</a:t>
                       </a:r>
                     </a:p>
                   </a:txBody>
@@ -8442,7 +8442,7 @@
                           </a:solidFill>
                           <a:latin typeface="Kanit"/>
                         </a:rPr>
-                        <a:t>จันทบุรี</a:t>
+                        <a:t>นครนายก</a:t>
                       </a:r>
                     </a:p>
                   </a:txBody>
@@ -8465,7 +8465,7 @@
                           </a:solidFill>
                           <a:latin typeface="Kanit"/>
                         </a:rPr>
-                        <a:t>52</a:t>
+                        <a:t>26</a:t>
                       </a:r>
                     </a:p>
                   </a:txBody>
@@ -8488,7 +8488,7 @@
                           </a:solidFill>
                           <a:latin typeface="Kanit"/>
                         </a:rPr>
-                        <a:t>172</a:t>
+                        <a:t>119</a:t>
                       </a:r>
                     </a:p>
                   </a:txBody>
@@ -8511,7 +8511,7 @@
                           </a:solidFill>
                           <a:latin typeface="Kanit"/>
                         </a:rPr>
-                        <a:t>34.6%</a:t>
+                        <a:t>46.2%</a:t>
                       </a:r>
                     </a:p>
                   </a:txBody>
@@ -8534,7 +8534,7 @@
                           </a:solidFill>
                           <a:latin typeface="Kanit"/>
                         </a:rPr>
-                        <a:t>1/11</a:t>
+                        <a:t>2/6</a:t>
                       </a:r>
                     </a:p>
                   </a:txBody>
@@ -8582,7 +8582,7 @@
                           </a:solidFill>
                           <a:latin typeface="Kanit"/>
                         </a:rPr>
-                        <a:t>ลพบุรี</a:t>
+                        <a:t>จันทบุรี</a:t>
                       </a:r>
                     </a:p>
                   </a:txBody>
@@ -8605,7 +8605,7 @@
                           </a:solidFill>
                           <a:latin typeface="Kanit"/>
                         </a:rPr>
-                        <a:t>27</a:t>
+                        <a:t>52</a:t>
                       </a:r>
                     </a:p>
                   </a:txBody>
@@ -8628,7 +8628,7 @@
                           </a:solidFill>
                           <a:latin typeface="Kanit"/>
                         </a:rPr>
-                        <a:t>61</a:t>
+                        <a:t>168</a:t>
                       </a:r>
                     </a:p>
                   </a:txBody>
@@ -8651,7 +8651,7 @@
                           </a:solidFill>
                           <a:latin typeface="Kanit"/>
                         </a:rPr>
-                        <a:t>25.9%</a:t>
+                        <a:t>34.6%</a:t>
                       </a:r>
                     </a:p>
                   </a:txBody>
@@ -8674,7 +8674,7 @@
                           </a:solidFill>
                           <a:latin typeface="Kanit"/>
                         </a:rPr>
-                        <a:t>4/8</a:t>
+                        <a:t>5/11</a:t>
                       </a:r>
                     </a:p>
                   </a:txBody>
@@ -8909,7 +8909,7 @@
                 </a:solidFill>
                 <a:latin typeface="Kanit"/>
               </a:rPr>
-              <a:t>พื้นที่ปลูก วัดจริง (สศก. — ข้อมูลอำเภอ×พืช 3,295 แถว) ภัยแล้งเป็นดัชนี SPEI จาก แบบจำลอง คำนวณจากปริมาณฝนและการคายระเหย ปรับเดือนละครั้ง ดึงข้อมูล 2026-07-20 — เป็นสัญญาณที่ครอบคลุมทั้งประเทศดีที่สุดที่มี แต่ไม่มีใครลงพื้นที่ไปเดินดูอำเภอเหล่านั้น ข้อมูลฝนและระดับน้ำ วัดจริง (ThaiWater เรียลไทม์ ดึงทุกวันและสะสมไว้ — วันที่ดึงไม่สำเร็จจะเว้นเป็นช่องว่าง ไม่ใส่ค่าสมมติ) · ฝนถึง 2026-08-28, ระดับน้ำถึง 2026-08-28 ความเสี่ยงน้ำท่วมเชิงโครงสร้าง วัดจริง (สำมะโนพื้นที่ท่วมซ้ำซาก GISTDA มาตราส่วน 1:50,000 ปี 2005-2016 — เป็นบันทึกภาคพื้นดิน 12 ปี ไม่ใช่การพยากรณ์)</a:t>
+              <a:t>พื้นที่ปลูก วัดจริง (สศก. — ข้อมูลอำเภอ×พืช 3,295 แถว) ภัยแล้งเป็นดัชนี SPEI จาก แบบจำลอง คำนวณจากปริมาณฝนและการคายระเหย ปรับเดือนละครั้ง ดึงข้อมูล 2026-07-20 — เป็นสัญญาณที่ครอบคลุมทั้งประเทศดีที่สุดที่มี แต่ไม่มีใครลงพื้นที่ไปเดินดูอำเภอเหล่านั้น ข้อมูลฝนและระดับน้ำ วัดจริง (ThaiWater เรียลไทม์ ดึงทุกวันและสะสมไว้ — วันที่ดึงไม่สำเร็จจะเว้นเป็นช่องว่าง ไม่ใส่ค่าสมมติ) · ฝนถึง 2026-08-29, ระดับน้ำถึง 2026-08-29 ความเสี่ยงน้ำท่วมเชิงโครงสร้าง วัดจริง (สำมะโนพื้นที่ท่วมซ้ำซาก GISTDA มาตราส่วน 1:50,000 ปี 2005-2016 — เป็นบันทึกภาคพื้นดิน 12 ปี ไม่ใช่การพยากรณ์)</a:t>
             </a:r>
           </a:p>
         </p:txBody>
@@ -32047,7 +32047,7 @@
                 </a:solidFill>
                 <a:latin typeface="Kanit"/>
               </a:rPr>
-              <a:t>รุ่นข้อมูล — ราคาโลก 2026M06 · ราคาหน้าฟาร์มไทย 2026-08-28 · ประวัติราคาไทย 2026-08-23 · ต้นทุนการผลิตพืช สศก. ไจอัป 2568 (ปีเพาะปลูก 2568/69, ประมาณการ สศก. มี.ค. 2569) · ภัยแล้ง 2026-06-21 · เงินเฟ้อ 2026-05 · GDP 2026 ไตรมาส 1 · IMF WEO 2026 · ดัชนีราคาขายต่อ 2026-05 · ยอดจดทะเบียนถึง 2026-01 · หนี้ครัวเรือน สสช. SES 2566 · ค่าจ้าง สสช. LFS 2568 · ข้อมูลตรวจวัด 2026-08-28</a:t>
+              <a:t>รุ่นข้อมูล — ราคาโลก 2026M06 · ราคาหน้าฟาร์มไทย 2026-08-28 · ประวัติราคาไทย 2026-08-23 · ต้นทุนการผลิตพืช สศก. ไจอัป 2568 (ปีเพาะปลูก 2568/69, ประมาณการ สศก. มี.ค. 2569) · ภัยแล้ง 2026-06-21 · เงินเฟ้อ 2026-05 · GDP 2026 ไตรมาส 1 · IMF WEO 2026 · ดัชนีราคาขายต่อ 2026-05 · ยอดจดทะเบียนถึง 2026-01 · หนี้ครัวเรือน สสช. SES 2566 · ค่าจ้าง สสช. LFS 2568 · ข้อมูลตรวจวัด 2026-08-29</a:t>
             </a:r>
           </a:p>
         </p:txBody>
@@ -37087,7 +37087,7 @@
                 </a:solidFill>
                 <a:latin typeface="Kanit"/>
               </a:rPr>
-              <a:t>338 จาก 928 อำเภอ · แม่น้ำเกินระดับ 129 จาก 795 สถานี</a:t>
+              <a:t>338 จาก 928 อำเภอ · แม่น้ำเกินระดับ 135 จาก 794 สถานี</a:t>
             </a:r>
           </a:p>
         </p:txBody>
@@ -37859,7 +37859,7 @@
                           </a:solidFill>
                           <a:latin typeface="Kanit"/>
                         </a:rPr>
-                        <a:t>26/156</a:t>
+                        <a:t>25/156</a:t>
                       </a:r>
                     </a:p>
                   </a:txBody>
@@ -38091,7 +38091,7 @@
                           </a:solidFill>
                           <a:latin typeface="Kanit"/>
                         </a:rPr>
-                        <a:t>21/274</a:t>
+                        <a:t>20/273</a:t>
                       </a:r>
                     </a:p>
                   </a:txBody>
@@ -38323,7 +38323,7 @@
                           </a:solidFill>
                           <a:latin typeface="Kanit"/>
                         </a:rPr>
-                        <a:t>29/168</a:t>
+                        <a:t>30/168</a:t>
                       </a:r>
                     </a:p>
                   </a:txBody>
@@ -38555,7 +38555,7 @@
                           </a:solidFill>
                           <a:latin typeface="Kanit"/>
                         </a:rPr>
-                        <a:t>8/52</a:t>
+                        <a:t>13/52</a:t>
                       </a:r>
                     </a:p>
                   </a:txBody>
@@ -38787,7 +38787,7 @@
                           </a:solidFill>
                           <a:latin typeface="Kanit"/>
                         </a:rPr>
-                        <a:t>45/145</a:t>
+                        <a:t>47/145</a:t>
                       </a:r>
                     </a:p>
                   </a:txBody>

</xml_diff>

<commit_message>
deck(mcom): rebuild — the data moved past the committed figures (run 33233634714)
</commit_message>
<xml_diff>
--- a/docs/decks/mcom-2026-08-05-macro-TH.pptx
+++ b/docs/decks/mcom-2026-08-05-macro-TH.pptx
@@ -6240,7 +6240,7 @@
                 </a:solidFill>
                 <a:latin typeface="Kanit"/>
               </a:rPr>
-              <a:t>135</a:t>
+              <a:t>127</a:t>
             </a:r>
           </a:p>
         </p:txBody>
@@ -6279,7 +6279,7 @@
                 </a:solidFill>
                 <a:latin typeface="Kanit"/>
               </a:rPr>
-              <a:t>จาก 794 (17.0%) · เรียลไทม์ · 2026-08-29</a:t>
+              <a:t>จาก 793 (16.0%) · เรียลไทม์ · 2026-08-29</a:t>
             </a:r>
           </a:p>
         </p:txBody>
@@ -8068,7 +8068,7 @@
                           </a:solidFill>
                           <a:latin typeface="Kanit"/>
                         </a:rPr>
-                        <a:t>196</a:t>
+                        <a:t>200</a:t>
                       </a:r>
                     </a:p>
                   </a:txBody>
@@ -8091,7 +8091,7 @@
                           </a:solidFill>
                           <a:latin typeface="Kanit"/>
                         </a:rPr>
-                        <a:t>73.8%</a:t>
+                        <a:t>76.2%</a:t>
                       </a:r>
                     </a:p>
                   </a:txBody>
@@ -8162,7 +8162,7 @@
                           </a:solidFill>
                           <a:latin typeface="Kanit"/>
                         </a:rPr>
-                        <a:t>ระนอง</a:t>
+                        <a:t>นครนายก</a:t>
                       </a:r>
                     </a:p>
                   </a:txBody>
@@ -8185,7 +8185,7 @@
                           </a:solidFill>
                           <a:latin typeface="Kanit"/>
                         </a:rPr>
-                        <a:t>50</a:t>
+                        <a:t>26</a:t>
                       </a:r>
                     </a:p>
                   </a:txBody>
@@ -8208,7 +8208,7 @@
                           </a:solidFill>
                           <a:latin typeface="Kanit"/>
                         </a:rPr>
-                        <a:t>137</a:t>
+                        <a:t>127</a:t>
                       </a:r>
                     </a:p>
                   </a:txBody>
@@ -8231,7 +8231,7 @@
                           </a:solidFill>
                           <a:latin typeface="Kanit"/>
                         </a:rPr>
-                        <a:t>56.0%</a:t>
+                        <a:t>50.0%</a:t>
                       </a:r>
                     </a:p>
                   </a:txBody>
@@ -8254,7 +8254,7 @@
                           </a:solidFill>
                           <a:latin typeface="Kanit"/>
                         </a:rPr>
-                        <a:t>1/4</a:t>
+                        <a:t>2/6</a:t>
                       </a:r>
                     </a:p>
                   </a:txBody>
@@ -8394,7 +8394,7 @@
                           </a:solidFill>
                           <a:latin typeface="Kanit"/>
                         </a:rPr>
-                        <a:t>2/4</a:t>
+                        <a:t>3/4</a:t>
                       </a:r>
                     </a:p>
                   </a:txBody>
@@ -8442,7 +8442,7 @@
                           </a:solidFill>
                           <a:latin typeface="Kanit"/>
                         </a:rPr>
-                        <a:t>นครนายก</a:t>
+                        <a:t>จันทบุรี</a:t>
                       </a:r>
                     </a:p>
                   </a:txBody>
@@ -8465,7 +8465,7 @@
                           </a:solidFill>
                           <a:latin typeface="Kanit"/>
                         </a:rPr>
-                        <a:t>26</a:t>
+                        <a:t>52</a:t>
                       </a:r>
                     </a:p>
                   </a:txBody>
@@ -8488,7 +8488,7 @@
                           </a:solidFill>
                           <a:latin typeface="Kanit"/>
                         </a:rPr>
-                        <a:t>119</a:t>
+                        <a:t>170</a:t>
                       </a:r>
                     </a:p>
                   </a:txBody>
@@ -8511,7 +8511,7 @@
                           </a:solidFill>
                           <a:latin typeface="Kanit"/>
                         </a:rPr>
-                        <a:t>46.2%</a:t>
+                        <a:t>34.6%</a:t>
                       </a:r>
                     </a:p>
                   </a:txBody>
@@ -8534,7 +8534,7 @@
                           </a:solidFill>
                           <a:latin typeface="Kanit"/>
                         </a:rPr>
-                        <a:t>2/6</a:t>
+                        <a:t>3/11</a:t>
                       </a:r>
                     </a:p>
                   </a:txBody>
@@ -8582,7 +8582,7 @@
                           </a:solidFill>
                           <a:latin typeface="Kanit"/>
                         </a:rPr>
-                        <a:t>จันทบุรี</a:t>
+                        <a:t>ลพบุรี</a:t>
                       </a:r>
                     </a:p>
                   </a:txBody>
@@ -8605,7 +8605,7 @@
                           </a:solidFill>
                           <a:latin typeface="Kanit"/>
                         </a:rPr>
-                        <a:t>52</a:t>
+                        <a:t>27</a:t>
                       </a:r>
                     </a:p>
                   </a:txBody>
@@ -8628,7 +8628,7 @@
                           </a:solidFill>
                           <a:latin typeface="Kanit"/>
                         </a:rPr>
-                        <a:t>168</a:t>
+                        <a:t>82</a:t>
                       </a:r>
                     </a:p>
                   </a:txBody>
@@ -8651,7 +8651,7 @@
                           </a:solidFill>
                           <a:latin typeface="Kanit"/>
                         </a:rPr>
-                        <a:t>34.6%</a:t>
+                        <a:t>29.6%</a:t>
                       </a:r>
                     </a:p>
                   </a:txBody>
@@ -8674,7 +8674,7 @@
                           </a:solidFill>
                           <a:latin typeface="Kanit"/>
                         </a:rPr>
-                        <a:t>5/11</a:t>
+                        <a:t>3/8</a:t>
                       </a:r>
                     </a:p>
                   </a:txBody>
@@ -37087,7 +37087,7 @@
                 </a:solidFill>
                 <a:latin typeface="Kanit"/>
               </a:rPr>
-              <a:t>338 จาก 928 อำเภอ · แม่น้ำเกินระดับ 135 จาก 794 สถานี</a:t>
+              <a:t>338 จาก 928 อำเภอ · แม่น้ำเกินระดับ 127 จาก 793 สถานี</a:t>
             </a:r>
           </a:p>
         </p:txBody>
@@ -37859,7 +37859,7 @@
                           </a:solidFill>
                           <a:latin typeface="Kanit"/>
                         </a:rPr>
-                        <a:t>25/156</a:t>
+                        <a:t>24/156</a:t>
                       </a:r>
                     </a:p>
                   </a:txBody>
@@ -38091,7 +38091,7 @@
                           </a:solidFill>
                           <a:latin typeface="Kanit"/>
                         </a:rPr>
-                        <a:t>20/273</a:t>
+                        <a:t>20/272</a:t>
                       </a:r>
                     </a:p>
                   </a:txBody>
@@ -38323,7 +38323,7 @@
                           </a:solidFill>
                           <a:latin typeface="Kanit"/>
                         </a:rPr>
-                        <a:t>30/168</a:t>
+                        <a:t>29/168</a:t>
                       </a:r>
                     </a:p>
                   </a:txBody>
@@ -38555,7 +38555,7 @@
                           </a:solidFill>
                           <a:latin typeface="Kanit"/>
                         </a:rPr>
-                        <a:t>13/52</a:t>
+                        <a:t>10/52</a:t>
                       </a:r>
                     </a:p>
                   </a:txBody>
@@ -38787,7 +38787,7 @@
                           </a:solidFill>
                           <a:latin typeface="Kanit"/>
                         </a:rPr>
-                        <a:t>47/145</a:t>
+                        <a:t>44/145</a:t>
                       </a:r>
                     </a:p>
                   </a:txBody>

</xml_diff>

<commit_message>
deck(mcom): rebuild — the data moved past the committed figures (run 33233634714) (#693)
Co-authored-by: github-actions[bot] <41898282+github-actions[bot]@users.noreply.github.com>
</commit_message>
<xml_diff>
--- a/docs/decks/mcom-2026-08-05-macro-TH.pptx
+++ b/docs/decks/mcom-2026-08-05-macro-TH.pptx
@@ -6240,7 +6240,7 @@
                 </a:solidFill>
                 <a:latin typeface="Kanit"/>
               </a:rPr>
-              <a:t>135</a:t>
+              <a:t>127</a:t>
             </a:r>
           </a:p>
         </p:txBody>
@@ -6279,7 +6279,7 @@
                 </a:solidFill>
                 <a:latin typeface="Kanit"/>
               </a:rPr>
-              <a:t>จาก 794 (17.0%) · เรียลไทม์ · 2026-08-29</a:t>
+              <a:t>จาก 793 (16.0%) · เรียลไทม์ · 2026-08-29</a:t>
             </a:r>
           </a:p>
         </p:txBody>
@@ -8068,7 +8068,7 @@
                           </a:solidFill>
                           <a:latin typeface="Kanit"/>
                         </a:rPr>
-                        <a:t>196</a:t>
+                        <a:t>200</a:t>
                       </a:r>
                     </a:p>
                   </a:txBody>
@@ -8091,7 +8091,7 @@
                           </a:solidFill>
                           <a:latin typeface="Kanit"/>
                         </a:rPr>
-                        <a:t>73.8%</a:t>
+                        <a:t>76.2%</a:t>
                       </a:r>
                     </a:p>
                   </a:txBody>
@@ -8162,7 +8162,7 @@
                           </a:solidFill>
                           <a:latin typeface="Kanit"/>
                         </a:rPr>
-                        <a:t>ระนอง</a:t>
+                        <a:t>นครนายก</a:t>
                       </a:r>
                     </a:p>
                   </a:txBody>
@@ -8185,7 +8185,7 @@
                           </a:solidFill>
                           <a:latin typeface="Kanit"/>
                         </a:rPr>
-                        <a:t>50</a:t>
+                        <a:t>26</a:t>
                       </a:r>
                     </a:p>
                   </a:txBody>
@@ -8208,7 +8208,7 @@
                           </a:solidFill>
                           <a:latin typeface="Kanit"/>
                         </a:rPr>
-                        <a:t>137</a:t>
+                        <a:t>127</a:t>
                       </a:r>
                     </a:p>
                   </a:txBody>
@@ -8231,7 +8231,7 @@
                           </a:solidFill>
                           <a:latin typeface="Kanit"/>
                         </a:rPr>
-                        <a:t>56.0%</a:t>
+                        <a:t>50.0%</a:t>
                       </a:r>
                     </a:p>
                   </a:txBody>
@@ -8254,7 +8254,7 @@
                           </a:solidFill>
                           <a:latin typeface="Kanit"/>
                         </a:rPr>
-                        <a:t>1/4</a:t>
+                        <a:t>2/6</a:t>
                       </a:r>
                     </a:p>
                   </a:txBody>
@@ -8394,7 +8394,7 @@
                           </a:solidFill>
                           <a:latin typeface="Kanit"/>
                         </a:rPr>
-                        <a:t>2/4</a:t>
+                        <a:t>3/4</a:t>
                       </a:r>
                     </a:p>
                   </a:txBody>
@@ -8442,7 +8442,7 @@
                           </a:solidFill>
                           <a:latin typeface="Kanit"/>
                         </a:rPr>
-                        <a:t>นครนายก</a:t>
+                        <a:t>จันทบุรี</a:t>
                       </a:r>
                     </a:p>
                   </a:txBody>
@@ -8465,7 +8465,7 @@
                           </a:solidFill>
                           <a:latin typeface="Kanit"/>
                         </a:rPr>
-                        <a:t>26</a:t>
+                        <a:t>52</a:t>
                       </a:r>
                     </a:p>
                   </a:txBody>
@@ -8488,7 +8488,7 @@
                           </a:solidFill>
                           <a:latin typeface="Kanit"/>
                         </a:rPr>
-                        <a:t>119</a:t>
+                        <a:t>170</a:t>
                       </a:r>
                     </a:p>
                   </a:txBody>
@@ -8511,7 +8511,7 @@
                           </a:solidFill>
                           <a:latin typeface="Kanit"/>
                         </a:rPr>
-                        <a:t>46.2%</a:t>
+                        <a:t>34.6%</a:t>
                       </a:r>
                     </a:p>
                   </a:txBody>
@@ -8534,7 +8534,7 @@
                           </a:solidFill>
                           <a:latin typeface="Kanit"/>
                         </a:rPr>
-                        <a:t>2/6</a:t>
+                        <a:t>3/11</a:t>
                       </a:r>
                     </a:p>
                   </a:txBody>
@@ -8582,7 +8582,7 @@
                           </a:solidFill>
                           <a:latin typeface="Kanit"/>
                         </a:rPr>
-                        <a:t>จันทบุรี</a:t>
+                        <a:t>ลพบุรี</a:t>
                       </a:r>
                     </a:p>
                   </a:txBody>
@@ -8605,7 +8605,7 @@
                           </a:solidFill>
                           <a:latin typeface="Kanit"/>
                         </a:rPr>
-                        <a:t>52</a:t>
+                        <a:t>27</a:t>
                       </a:r>
                     </a:p>
                   </a:txBody>
@@ -8628,7 +8628,7 @@
                           </a:solidFill>
                           <a:latin typeface="Kanit"/>
                         </a:rPr>
-                        <a:t>168</a:t>
+                        <a:t>82</a:t>
                       </a:r>
                     </a:p>
                   </a:txBody>
@@ -8651,7 +8651,7 @@
                           </a:solidFill>
                           <a:latin typeface="Kanit"/>
                         </a:rPr>
-                        <a:t>34.6%</a:t>
+                        <a:t>29.6%</a:t>
                       </a:r>
                     </a:p>
                   </a:txBody>
@@ -8674,7 +8674,7 @@
                           </a:solidFill>
                           <a:latin typeface="Kanit"/>
                         </a:rPr>
-                        <a:t>5/11</a:t>
+                        <a:t>3/8</a:t>
                       </a:r>
                     </a:p>
                   </a:txBody>
@@ -37087,7 +37087,7 @@
                 </a:solidFill>
                 <a:latin typeface="Kanit"/>
               </a:rPr>
-              <a:t>338 จาก 928 อำเภอ · แม่น้ำเกินระดับ 135 จาก 794 สถานี</a:t>
+              <a:t>338 จาก 928 อำเภอ · แม่น้ำเกินระดับ 127 จาก 793 สถานี</a:t>
             </a:r>
           </a:p>
         </p:txBody>
@@ -37859,7 +37859,7 @@
                           </a:solidFill>
                           <a:latin typeface="Kanit"/>
                         </a:rPr>
-                        <a:t>25/156</a:t>
+                        <a:t>24/156</a:t>
                       </a:r>
                     </a:p>
                   </a:txBody>
@@ -38091,7 +38091,7 @@
                           </a:solidFill>
                           <a:latin typeface="Kanit"/>
                         </a:rPr>
-                        <a:t>20/273</a:t>
+                        <a:t>20/272</a:t>
                       </a:r>
                     </a:p>
                   </a:txBody>
@@ -38323,7 +38323,7 @@
                           </a:solidFill>
                           <a:latin typeface="Kanit"/>
                         </a:rPr>
-                        <a:t>30/168</a:t>
+                        <a:t>29/168</a:t>
                       </a:r>
                     </a:p>
                   </a:txBody>
@@ -38555,7 +38555,7 @@
                           </a:solidFill>
                           <a:latin typeface="Kanit"/>
                         </a:rPr>
-                        <a:t>13/52</a:t>
+                        <a:t>10/52</a:t>
                       </a:r>
                     </a:p>
                   </a:txBody>
@@ -38787,7 +38787,7 @@
                           </a:solidFill>
                           <a:latin typeface="Kanit"/>
                         </a:rPr>
-                        <a:t>47/145</a:t>
+                        <a:t>44/145</a:t>
                       </a:r>
                     </a:p>
                   </a:txBody>

</xml_diff>

<commit_message>
deck(mcom): rebuild — the data moved past the committed figures (run 33278360381)
</commit_message>
<xml_diff>
--- a/docs/decks/mcom-2026-08-05-macro-TH.pptx
+++ b/docs/decks/mcom-2026-08-05-macro-TH.pptx
@@ -6240,7 +6240,7 @@
                 </a:solidFill>
                 <a:latin typeface="Kanit"/>
               </a:rPr>
-              <a:t>127</a:t>
+              <a:t>136</a:t>
             </a:r>
           </a:p>
         </p:txBody>
@@ -6279,7 +6279,7 @@
                 </a:solidFill>
                 <a:latin typeface="Kanit"/>
               </a:rPr>
-              <a:t>จาก 793 (16.0%) · เรียลไทม์ · 2026-08-29</a:t>
+              <a:t>จาก 793 (17.2%) · เรียลไทม์ · 2026-08-30</a:t>
             </a:r>
           </a:p>
         </p:txBody>
@@ -6405,7 +6405,7 @@
                 </a:solidFill>
                 <a:latin typeface="Kanit"/>
               </a:rPr>
-              <a:t>22</a:t>
+              <a:t>37</a:t>
             </a:r>
           </a:p>
         </p:txBody>
@@ -6444,7 +6444,7 @@
                 </a:solidFill>
                 <a:latin typeface="Kanit"/>
               </a:rPr>
-              <a:t>ค่าล่าสุดรายวัน · 2026-08-29</a:t>
+              <a:t>ค่าล่าสุดรายวัน · 2026-08-30</a:t>
             </a:r>
           </a:p>
         </p:txBody>
@@ -7905,7 +7905,7 @@
                           </a:solidFill>
                           <a:latin typeface="Kanit"/>
                         </a:rPr>
-                        <a:t>38</a:t>
+                        <a:t>37</a:t>
                       </a:r>
                     </a:p>
                   </a:txBody>
@@ -7928,7 +7928,7 @@
                           </a:solidFill>
                           <a:latin typeface="Kanit"/>
                         </a:rPr>
-                        <a:t>23</a:t>
+                        <a:t>8</a:t>
                       </a:r>
                     </a:p>
                   </a:txBody>
@@ -8022,7 +8022,7 @@
                           </a:solidFill>
                           <a:latin typeface="Kanit"/>
                         </a:rPr>
-                        <a:t>ตราด</a:t>
+                        <a:t>ยโสธร</a:t>
                       </a:r>
                     </a:p>
                   </a:txBody>
@@ -8045,7 +8045,7 @@
                           </a:solidFill>
                           <a:latin typeface="Kanit"/>
                         </a:rPr>
-                        <a:t>42</a:t>
+                        <a:t>15</a:t>
                       </a:r>
                     </a:p>
                   </a:txBody>
@@ -8068,7 +8068,7 @@
                           </a:solidFill>
                           <a:latin typeface="Kanit"/>
                         </a:rPr>
-                        <a:t>200</a:t>
+                        <a:t>76</a:t>
                       </a:r>
                     </a:p>
                   </a:txBody>
@@ -8091,7 +8091,7 @@
                           </a:solidFill>
                           <a:latin typeface="Kanit"/>
                         </a:rPr>
-                        <a:t>76.2%</a:t>
+                        <a:t>33.3%</a:t>
                       </a:r>
                     </a:p>
                   </a:txBody>
@@ -8114,7 +8114,7 @@
                           </a:solidFill>
                           <a:latin typeface="Kanit"/>
                         </a:rPr>
-                        <a:t>4/9</a:t>
+                        <a:t>2/5</a:t>
                       </a:r>
                     </a:p>
                   </a:txBody>
@@ -8162,7 +8162,7 @@
                           </a:solidFill>
                           <a:latin typeface="Kanit"/>
                         </a:rPr>
-                        <a:t>นครนายก</a:t>
+                        <a:t>ปราจีนบุรี</a:t>
                       </a:r>
                     </a:p>
                   </a:txBody>
@@ -8185,7 +8185,7 @@
                           </a:solidFill>
                           <a:latin typeface="Kanit"/>
                         </a:rPr>
-                        <a:t>26</a:t>
+                        <a:t>33</a:t>
                       </a:r>
                     </a:p>
                   </a:txBody>
@@ -8208,7 +8208,7 @@
                           </a:solidFill>
                           <a:latin typeface="Kanit"/>
                         </a:rPr>
-                        <a:t>127</a:t>
+                        <a:t>75</a:t>
                       </a:r>
                     </a:p>
                   </a:txBody>
@@ -8231,7 +8231,7 @@
                           </a:solidFill>
                           <a:latin typeface="Kanit"/>
                         </a:rPr>
-                        <a:t>50.0%</a:t>
+                        <a:t>21.2%</a:t>
                       </a:r>
                     </a:p>
                   </a:txBody>
@@ -8254,7 +8254,7 @@
                           </a:solidFill>
                           <a:latin typeface="Kanit"/>
                         </a:rPr>
-                        <a:t>2/6</a:t>
+                        <a:t>2/15</a:t>
                       </a:r>
                     </a:p>
                   </a:txBody>
@@ -8302,7 +8302,7 @@
                           </a:solidFill>
                           <a:latin typeface="Kanit"/>
                         </a:rPr>
-                        <a:t>ปทุมธานี</a:t>
+                        <a:t>จันทบุรี</a:t>
                       </a:r>
                     </a:p>
                   </a:txBody>
@@ -8325,7 +8325,7 @@
                           </a:solidFill>
                           <a:latin typeface="Kanit"/>
                         </a:rPr>
-                        <a:t>10</a:t>
+                        <a:t>53</a:t>
                       </a:r>
                     </a:p>
                   </a:txBody>
@@ -8348,7 +8348,7 @@
                           </a:solidFill>
                           <a:latin typeface="Kanit"/>
                         </a:rPr>
-                        <a:t>72</a:t>
+                        <a:t>58</a:t>
                       </a:r>
                     </a:p>
                   </a:txBody>
@@ -8371,7 +8371,7 @@
                           </a:solidFill>
                           <a:latin typeface="Kanit"/>
                         </a:rPr>
-                        <a:t>50.0%</a:t>
+                        <a:t>17.0%</a:t>
                       </a:r>
                     </a:p>
                   </a:txBody>
@@ -8394,7 +8394,7 @@
                           </a:solidFill>
                           <a:latin typeface="Kanit"/>
                         </a:rPr>
-                        <a:t>3/4</a:t>
+                        <a:t>5/11</a:t>
                       </a:r>
                     </a:p>
                   </a:txBody>
@@ -8442,7 +8442,7 @@
                           </a:solidFill>
                           <a:latin typeface="Kanit"/>
                         </a:rPr>
-                        <a:t>จันทบุรี</a:t>
+                        <a:t>ตราด</a:t>
                       </a:r>
                     </a:p>
                   </a:txBody>
@@ -8465,7 +8465,7 @@
                           </a:solidFill>
                           <a:latin typeface="Kanit"/>
                         </a:rPr>
-                        <a:t>52</a:t>
+                        <a:t>42</a:t>
                       </a:r>
                     </a:p>
                   </a:txBody>
@@ -8488,7 +8488,7 @@
                           </a:solidFill>
                           <a:latin typeface="Kanit"/>
                         </a:rPr>
-                        <a:t>170</a:t>
+                        <a:t>64</a:t>
                       </a:r>
                     </a:p>
                   </a:txBody>
@@ -8511,7 +8511,7 @@
                           </a:solidFill>
                           <a:latin typeface="Kanit"/>
                         </a:rPr>
-                        <a:t>34.6%</a:t>
+                        <a:t>16.7%</a:t>
                       </a:r>
                     </a:p>
                   </a:txBody>
@@ -8534,7 +8534,7 @@
                           </a:solidFill>
                           <a:latin typeface="Kanit"/>
                         </a:rPr>
-                        <a:t>3/11</a:t>
+                        <a:t>5/9</a:t>
                       </a:r>
                     </a:p>
                   </a:txBody>
@@ -8582,7 +8582,7 @@
                           </a:solidFill>
                           <a:latin typeface="Kanit"/>
                         </a:rPr>
-                        <a:t>ลพบุรี</a:t>
+                        <a:t>ชุมพร</a:t>
                       </a:r>
                     </a:p>
                   </a:txBody>
@@ -8605,7 +8605,7 @@
                           </a:solidFill>
                           <a:latin typeface="Kanit"/>
                         </a:rPr>
-                        <a:t>27</a:t>
+                        <a:t>91</a:t>
                       </a:r>
                     </a:p>
                   </a:txBody>
@@ -8628,7 +8628,7 @@
                           </a:solidFill>
                           <a:latin typeface="Kanit"/>
                         </a:rPr>
-                        <a:t>82</a:t>
+                        <a:t>52</a:t>
                       </a:r>
                     </a:p>
                   </a:txBody>
@@ -8651,7 +8651,7 @@
                           </a:solidFill>
                           <a:latin typeface="Kanit"/>
                         </a:rPr>
-                        <a:t>29.6%</a:t>
+                        <a:t>13.2%</a:t>
                       </a:r>
                     </a:p>
                   </a:txBody>
@@ -8674,7 +8674,7 @@
                           </a:solidFill>
                           <a:latin typeface="Kanit"/>
                         </a:rPr>
-                        <a:t>3/8</a:t>
+                        <a:t>3/14</a:t>
                       </a:r>
                     </a:p>
                   </a:txBody>
@@ -8909,7 +8909,7 @@
                 </a:solidFill>
                 <a:latin typeface="Kanit"/>
               </a:rPr>
-              <a:t>พื้นที่ปลูก วัดจริง (สศก. — ข้อมูลอำเภอ×พืช 3,295 แถว) ภัยแล้งเป็นดัชนี SPEI จาก แบบจำลอง คำนวณจากปริมาณฝนและการคายระเหย ปรับเดือนละครั้ง ดึงข้อมูล 2026-07-20 — เป็นสัญญาณที่ครอบคลุมทั้งประเทศดีที่สุดที่มี แต่ไม่มีใครลงพื้นที่ไปเดินดูอำเภอเหล่านั้น ข้อมูลฝนและระดับน้ำ วัดจริง (ThaiWater เรียลไทม์ ดึงทุกวันและสะสมไว้ — วันที่ดึงไม่สำเร็จจะเว้นเป็นช่องว่าง ไม่ใส่ค่าสมมติ) · ฝนถึง 2026-08-29, ระดับน้ำถึง 2026-08-29 ความเสี่ยงน้ำท่วมเชิงโครงสร้าง วัดจริง (สำมะโนพื้นที่ท่วมซ้ำซาก GISTDA มาตราส่วน 1:50,000 ปี 2005-2016 — เป็นบันทึกภาคพื้นดิน 12 ปี ไม่ใช่การพยากรณ์)</a:t>
+              <a:t>พื้นที่ปลูก วัดจริง (สศก. — ข้อมูลอำเภอ×พืช 3,295 แถว) ภัยแล้งเป็นดัชนี SPEI จาก แบบจำลอง คำนวณจากปริมาณฝนและการคายระเหย ปรับเดือนละครั้ง ดึงข้อมูล 2026-07-20 — เป็นสัญญาณที่ครอบคลุมทั้งประเทศดีที่สุดที่มี แต่ไม่มีใครลงพื้นที่ไปเดินดูอำเภอเหล่านั้น ข้อมูลฝนและระดับน้ำ วัดจริง (ThaiWater เรียลไทม์ ดึงทุกวันและสะสมไว้ — วันที่ดึงไม่สำเร็จจะเว้นเป็นช่องว่าง ไม่ใส่ค่าสมมติ) · ฝนถึง 2026-08-30, ระดับน้ำถึง 2026-08-30 ความเสี่ยงน้ำท่วมเชิงโครงสร้าง วัดจริง (สำมะโนพื้นที่ท่วมซ้ำซาก GISTDA มาตราส่วน 1:50,000 ปี 2005-2016 — เป็นบันทึกภาคพื้นดิน 12 ปี ไม่ใช่การพยากรณ์)</a:t>
             </a:r>
           </a:p>
         </p:txBody>
@@ -32047,7 +32047,7 @@
                 </a:solidFill>
                 <a:latin typeface="Kanit"/>
               </a:rPr>
-              <a:t>รุ่นข้อมูล — ราคาโลก 2026M06 · ราคาหน้าฟาร์มไทย 2026-08-28 · ประวัติราคาไทย 2026-08-23 · ต้นทุนการผลิตพืช สศก. ไจอัป 2568 (ปีเพาะปลูก 2568/69, ประมาณการ สศก. มี.ค. 2569) · ภัยแล้ง 2026-06-21 · เงินเฟ้อ 2026-05 · GDP 2026 ไตรมาส 1 · IMF WEO 2026 · ดัชนีราคาขายต่อ 2026-05 · ยอดจดทะเบียนถึง 2026-01 · หนี้ครัวเรือน สสช. SES 2566 · ค่าจ้าง สสช. LFS 2568 · ข้อมูลตรวจวัด 2026-08-29</a:t>
+              <a:t>รุ่นข้อมูล — ราคาโลก 2026M06 · ราคาหน้าฟาร์มไทย 2026-08-28 · ประวัติราคาไทย 2026-08-23 · ต้นทุนการผลิตพืช สศก. ไจอัป 2568 (ปีเพาะปลูก 2568/69, ประมาณการ สศก. มี.ค. 2569) · ภัยแล้ง 2026-06-21 · เงินเฟ้อ 2026-05 · GDP 2026 ไตรมาส 1 · IMF WEO 2026 · ดัชนีราคาขายต่อ 2026-05 · ยอดจดทะเบียนถึง 2026-01 · หนี้ครัวเรือน สสช. SES 2566 · ค่าจ้าง สสช. LFS 2568 · ข้อมูลตรวจวัด 2026-08-30</a:t>
             </a:r>
           </a:p>
         </p:txBody>
@@ -37087,7 +37087,7 @@
                 </a:solidFill>
                 <a:latin typeface="Kanit"/>
               </a:rPr>
-              <a:t>338 จาก 928 อำเภอ · แม่น้ำเกินระดับ 127 จาก 793 สถานี</a:t>
+              <a:t>338 จาก 928 อำเภอ · แม่น้ำเกินระดับ 136 จาก 793 สถานี</a:t>
             </a:r>
           </a:p>
         </p:txBody>
@@ -37859,7 +37859,7 @@
                           </a:solidFill>
                           <a:latin typeface="Kanit"/>
                         </a:rPr>
-                        <a:t>24/156</a:t>
+                        <a:t>25/156</a:t>
                       </a:r>
                     </a:p>
                   </a:txBody>
@@ -38091,7 +38091,7 @@
                           </a:solidFill>
                           <a:latin typeface="Kanit"/>
                         </a:rPr>
-                        <a:t>20/272</a:t>
+                        <a:t>19/273</a:t>
                       </a:r>
                     </a:p>
                   </a:txBody>
@@ -38323,7 +38323,7 @@
                           </a:solidFill>
                           <a:latin typeface="Kanit"/>
                         </a:rPr>
-                        <a:t>29/168</a:t>
+                        <a:t>31/167</a:t>
                       </a:r>
                     </a:p>
                   </a:txBody>
@@ -38555,7 +38555,7 @@
                           </a:solidFill>
                           <a:latin typeface="Kanit"/>
                         </a:rPr>
-                        <a:t>10/52</a:t>
+                        <a:t>15/52</a:t>
                       </a:r>
                     </a:p>
                   </a:txBody>
@@ -38787,7 +38787,7 @@
                           </a:solidFill>
                           <a:latin typeface="Kanit"/>
                         </a:rPr>
-                        <a:t>44/145</a:t>
+                        <a:t>46/145</a:t>
                       </a:r>
                     </a:p>
                   </a:txBody>

</xml_diff>

<commit_message>
deck(mcom): rebuild — the data moved past the committed figures (run 33278360381) (#697)
Co-authored-by: github-actions[bot] <41898282+github-actions[bot]@users.noreply.github.com>
</commit_message>
<xml_diff>
--- a/docs/decks/mcom-2026-08-05-macro-TH.pptx
+++ b/docs/decks/mcom-2026-08-05-macro-TH.pptx
@@ -6240,7 +6240,7 @@
                 </a:solidFill>
                 <a:latin typeface="Kanit"/>
               </a:rPr>
-              <a:t>127</a:t>
+              <a:t>136</a:t>
             </a:r>
           </a:p>
         </p:txBody>
@@ -6279,7 +6279,7 @@
                 </a:solidFill>
                 <a:latin typeface="Kanit"/>
               </a:rPr>
-              <a:t>จาก 793 (16.0%) · เรียลไทม์ · 2026-08-29</a:t>
+              <a:t>จาก 793 (17.2%) · เรียลไทม์ · 2026-08-30</a:t>
             </a:r>
           </a:p>
         </p:txBody>
@@ -6405,7 +6405,7 @@
                 </a:solidFill>
                 <a:latin typeface="Kanit"/>
               </a:rPr>
-              <a:t>22</a:t>
+              <a:t>37</a:t>
             </a:r>
           </a:p>
         </p:txBody>
@@ -6444,7 +6444,7 @@
                 </a:solidFill>
                 <a:latin typeface="Kanit"/>
               </a:rPr>
-              <a:t>ค่าล่าสุดรายวัน · 2026-08-29</a:t>
+              <a:t>ค่าล่าสุดรายวัน · 2026-08-30</a:t>
             </a:r>
           </a:p>
         </p:txBody>
@@ -7905,7 +7905,7 @@
                           </a:solidFill>
                           <a:latin typeface="Kanit"/>
                         </a:rPr>
-                        <a:t>38</a:t>
+                        <a:t>37</a:t>
                       </a:r>
                     </a:p>
                   </a:txBody>
@@ -7928,7 +7928,7 @@
                           </a:solidFill>
                           <a:latin typeface="Kanit"/>
                         </a:rPr>
-                        <a:t>23</a:t>
+                        <a:t>8</a:t>
                       </a:r>
                     </a:p>
                   </a:txBody>
@@ -8022,7 +8022,7 @@
                           </a:solidFill>
                           <a:latin typeface="Kanit"/>
                         </a:rPr>
-                        <a:t>ตราด</a:t>
+                        <a:t>ยโสธร</a:t>
                       </a:r>
                     </a:p>
                   </a:txBody>
@@ -8045,7 +8045,7 @@
                           </a:solidFill>
                           <a:latin typeface="Kanit"/>
                         </a:rPr>
-                        <a:t>42</a:t>
+                        <a:t>15</a:t>
                       </a:r>
                     </a:p>
                   </a:txBody>
@@ -8068,7 +8068,7 @@
                           </a:solidFill>
                           <a:latin typeface="Kanit"/>
                         </a:rPr>
-                        <a:t>200</a:t>
+                        <a:t>76</a:t>
                       </a:r>
                     </a:p>
                   </a:txBody>
@@ -8091,7 +8091,7 @@
                           </a:solidFill>
                           <a:latin typeface="Kanit"/>
                         </a:rPr>
-                        <a:t>76.2%</a:t>
+                        <a:t>33.3%</a:t>
                       </a:r>
                     </a:p>
                   </a:txBody>
@@ -8114,7 +8114,7 @@
                           </a:solidFill>
                           <a:latin typeface="Kanit"/>
                         </a:rPr>
-                        <a:t>4/9</a:t>
+                        <a:t>2/5</a:t>
                       </a:r>
                     </a:p>
                   </a:txBody>
@@ -8162,7 +8162,7 @@
                           </a:solidFill>
                           <a:latin typeface="Kanit"/>
                         </a:rPr>
-                        <a:t>นครนายก</a:t>
+                        <a:t>ปราจีนบุรี</a:t>
                       </a:r>
                     </a:p>
                   </a:txBody>
@@ -8185,7 +8185,7 @@
                           </a:solidFill>
                           <a:latin typeface="Kanit"/>
                         </a:rPr>
-                        <a:t>26</a:t>
+                        <a:t>33</a:t>
                       </a:r>
                     </a:p>
                   </a:txBody>
@@ -8208,7 +8208,7 @@
                           </a:solidFill>
                           <a:latin typeface="Kanit"/>
                         </a:rPr>
-                        <a:t>127</a:t>
+                        <a:t>75</a:t>
                       </a:r>
                     </a:p>
                   </a:txBody>
@@ -8231,7 +8231,7 @@
                           </a:solidFill>
                           <a:latin typeface="Kanit"/>
                         </a:rPr>
-                        <a:t>50.0%</a:t>
+                        <a:t>21.2%</a:t>
                       </a:r>
                     </a:p>
                   </a:txBody>
@@ -8254,7 +8254,7 @@
                           </a:solidFill>
                           <a:latin typeface="Kanit"/>
                         </a:rPr>
-                        <a:t>2/6</a:t>
+                        <a:t>2/15</a:t>
                       </a:r>
                     </a:p>
                   </a:txBody>
@@ -8302,7 +8302,7 @@
                           </a:solidFill>
                           <a:latin typeface="Kanit"/>
                         </a:rPr>
-                        <a:t>ปทุมธานี</a:t>
+                        <a:t>จันทบุรี</a:t>
                       </a:r>
                     </a:p>
                   </a:txBody>
@@ -8325,7 +8325,7 @@
                           </a:solidFill>
                           <a:latin typeface="Kanit"/>
                         </a:rPr>
-                        <a:t>10</a:t>
+                        <a:t>53</a:t>
                       </a:r>
                     </a:p>
                   </a:txBody>
@@ -8348,7 +8348,7 @@
                           </a:solidFill>
                           <a:latin typeface="Kanit"/>
                         </a:rPr>
-                        <a:t>72</a:t>
+                        <a:t>58</a:t>
                       </a:r>
                     </a:p>
                   </a:txBody>
@@ -8371,7 +8371,7 @@
                           </a:solidFill>
                           <a:latin typeface="Kanit"/>
                         </a:rPr>
-                        <a:t>50.0%</a:t>
+                        <a:t>17.0%</a:t>
                       </a:r>
                     </a:p>
                   </a:txBody>
@@ -8394,7 +8394,7 @@
                           </a:solidFill>
                           <a:latin typeface="Kanit"/>
                         </a:rPr>
-                        <a:t>3/4</a:t>
+                        <a:t>5/11</a:t>
                       </a:r>
                     </a:p>
                   </a:txBody>
@@ -8442,7 +8442,7 @@
                           </a:solidFill>
                           <a:latin typeface="Kanit"/>
                         </a:rPr>
-                        <a:t>จันทบุรี</a:t>
+                        <a:t>ตราด</a:t>
                       </a:r>
                     </a:p>
                   </a:txBody>
@@ -8465,7 +8465,7 @@
                           </a:solidFill>
                           <a:latin typeface="Kanit"/>
                         </a:rPr>
-                        <a:t>52</a:t>
+                        <a:t>42</a:t>
                       </a:r>
                     </a:p>
                   </a:txBody>
@@ -8488,7 +8488,7 @@
                           </a:solidFill>
                           <a:latin typeface="Kanit"/>
                         </a:rPr>
-                        <a:t>170</a:t>
+                        <a:t>64</a:t>
                       </a:r>
                     </a:p>
                   </a:txBody>
@@ -8511,7 +8511,7 @@
                           </a:solidFill>
                           <a:latin typeface="Kanit"/>
                         </a:rPr>
-                        <a:t>34.6%</a:t>
+                        <a:t>16.7%</a:t>
                       </a:r>
                     </a:p>
                   </a:txBody>
@@ -8534,7 +8534,7 @@
                           </a:solidFill>
                           <a:latin typeface="Kanit"/>
                         </a:rPr>
-                        <a:t>3/11</a:t>
+                        <a:t>5/9</a:t>
                       </a:r>
                     </a:p>
                   </a:txBody>
@@ -8582,7 +8582,7 @@
                           </a:solidFill>
                           <a:latin typeface="Kanit"/>
                         </a:rPr>
-                        <a:t>ลพบุรี</a:t>
+                        <a:t>ชุมพร</a:t>
                       </a:r>
                     </a:p>
                   </a:txBody>
@@ -8605,7 +8605,7 @@
                           </a:solidFill>
                           <a:latin typeface="Kanit"/>
                         </a:rPr>
-                        <a:t>27</a:t>
+                        <a:t>91</a:t>
                       </a:r>
                     </a:p>
                   </a:txBody>
@@ -8628,7 +8628,7 @@
                           </a:solidFill>
                           <a:latin typeface="Kanit"/>
                         </a:rPr>
-                        <a:t>82</a:t>
+                        <a:t>52</a:t>
                       </a:r>
                     </a:p>
                   </a:txBody>
@@ -8651,7 +8651,7 @@
                           </a:solidFill>
                           <a:latin typeface="Kanit"/>
                         </a:rPr>
-                        <a:t>29.6%</a:t>
+                        <a:t>13.2%</a:t>
                       </a:r>
                     </a:p>
                   </a:txBody>
@@ -8674,7 +8674,7 @@
                           </a:solidFill>
                           <a:latin typeface="Kanit"/>
                         </a:rPr>
-                        <a:t>3/8</a:t>
+                        <a:t>3/14</a:t>
                       </a:r>
                     </a:p>
                   </a:txBody>
@@ -8909,7 +8909,7 @@
                 </a:solidFill>
                 <a:latin typeface="Kanit"/>
               </a:rPr>
-              <a:t>พื้นที่ปลูก วัดจริง (สศก. — ข้อมูลอำเภอ×พืช 3,295 แถว) ภัยแล้งเป็นดัชนี SPEI จาก แบบจำลอง คำนวณจากปริมาณฝนและการคายระเหย ปรับเดือนละครั้ง ดึงข้อมูล 2026-07-20 — เป็นสัญญาณที่ครอบคลุมทั้งประเทศดีที่สุดที่มี แต่ไม่มีใครลงพื้นที่ไปเดินดูอำเภอเหล่านั้น ข้อมูลฝนและระดับน้ำ วัดจริง (ThaiWater เรียลไทม์ ดึงทุกวันและสะสมไว้ — วันที่ดึงไม่สำเร็จจะเว้นเป็นช่องว่าง ไม่ใส่ค่าสมมติ) · ฝนถึง 2026-08-29, ระดับน้ำถึง 2026-08-29 ความเสี่ยงน้ำท่วมเชิงโครงสร้าง วัดจริง (สำมะโนพื้นที่ท่วมซ้ำซาก GISTDA มาตราส่วน 1:50,000 ปี 2005-2016 — เป็นบันทึกภาคพื้นดิน 12 ปี ไม่ใช่การพยากรณ์)</a:t>
+              <a:t>พื้นที่ปลูก วัดจริง (สศก. — ข้อมูลอำเภอ×พืช 3,295 แถว) ภัยแล้งเป็นดัชนี SPEI จาก แบบจำลอง คำนวณจากปริมาณฝนและการคายระเหย ปรับเดือนละครั้ง ดึงข้อมูล 2026-07-20 — เป็นสัญญาณที่ครอบคลุมทั้งประเทศดีที่สุดที่มี แต่ไม่มีใครลงพื้นที่ไปเดินดูอำเภอเหล่านั้น ข้อมูลฝนและระดับน้ำ วัดจริง (ThaiWater เรียลไทม์ ดึงทุกวันและสะสมไว้ — วันที่ดึงไม่สำเร็จจะเว้นเป็นช่องว่าง ไม่ใส่ค่าสมมติ) · ฝนถึง 2026-08-30, ระดับน้ำถึง 2026-08-30 ความเสี่ยงน้ำท่วมเชิงโครงสร้าง วัดจริง (สำมะโนพื้นที่ท่วมซ้ำซาก GISTDA มาตราส่วน 1:50,000 ปี 2005-2016 — เป็นบันทึกภาคพื้นดิน 12 ปี ไม่ใช่การพยากรณ์)</a:t>
             </a:r>
           </a:p>
         </p:txBody>
@@ -32047,7 +32047,7 @@
                 </a:solidFill>
                 <a:latin typeface="Kanit"/>
               </a:rPr>
-              <a:t>รุ่นข้อมูล — ราคาโลก 2026M06 · ราคาหน้าฟาร์มไทย 2026-08-28 · ประวัติราคาไทย 2026-08-23 · ต้นทุนการผลิตพืช สศก. ไจอัป 2568 (ปีเพาะปลูก 2568/69, ประมาณการ สศก. มี.ค. 2569) · ภัยแล้ง 2026-06-21 · เงินเฟ้อ 2026-05 · GDP 2026 ไตรมาส 1 · IMF WEO 2026 · ดัชนีราคาขายต่อ 2026-05 · ยอดจดทะเบียนถึง 2026-01 · หนี้ครัวเรือน สสช. SES 2566 · ค่าจ้าง สสช. LFS 2568 · ข้อมูลตรวจวัด 2026-08-29</a:t>
+              <a:t>รุ่นข้อมูล — ราคาโลก 2026M06 · ราคาหน้าฟาร์มไทย 2026-08-28 · ประวัติราคาไทย 2026-08-23 · ต้นทุนการผลิตพืช สศก. ไจอัป 2568 (ปีเพาะปลูก 2568/69, ประมาณการ สศก. มี.ค. 2569) · ภัยแล้ง 2026-06-21 · เงินเฟ้อ 2026-05 · GDP 2026 ไตรมาส 1 · IMF WEO 2026 · ดัชนีราคาขายต่อ 2026-05 · ยอดจดทะเบียนถึง 2026-01 · หนี้ครัวเรือน สสช. SES 2566 · ค่าจ้าง สสช. LFS 2568 · ข้อมูลตรวจวัด 2026-08-30</a:t>
             </a:r>
           </a:p>
         </p:txBody>
@@ -37087,7 +37087,7 @@
                 </a:solidFill>
                 <a:latin typeface="Kanit"/>
               </a:rPr>
-              <a:t>338 จาก 928 อำเภอ · แม่น้ำเกินระดับ 127 จาก 793 สถานี</a:t>
+              <a:t>338 จาก 928 อำเภอ · แม่น้ำเกินระดับ 136 จาก 793 สถานี</a:t>
             </a:r>
           </a:p>
         </p:txBody>
@@ -37859,7 +37859,7 @@
                           </a:solidFill>
                           <a:latin typeface="Kanit"/>
                         </a:rPr>
-                        <a:t>24/156</a:t>
+                        <a:t>25/156</a:t>
                       </a:r>
                     </a:p>
                   </a:txBody>
@@ -38091,7 +38091,7 @@
                           </a:solidFill>
                           <a:latin typeface="Kanit"/>
                         </a:rPr>
-                        <a:t>20/272</a:t>
+                        <a:t>19/273</a:t>
                       </a:r>
                     </a:p>
                   </a:txBody>
@@ -38323,7 +38323,7 @@
                           </a:solidFill>
                           <a:latin typeface="Kanit"/>
                         </a:rPr>
-                        <a:t>29/168</a:t>
+                        <a:t>31/167</a:t>
                       </a:r>
                     </a:p>
                   </a:txBody>
@@ -38555,7 +38555,7 @@
                           </a:solidFill>
                           <a:latin typeface="Kanit"/>
                         </a:rPr>
-                        <a:t>10/52</a:t>
+                        <a:t>15/52</a:t>
                       </a:r>
                     </a:p>
                   </a:txBody>
@@ -38787,7 +38787,7 @@
                           </a:solidFill>
                           <a:latin typeface="Kanit"/>
                         </a:rPr>
-                        <a:t>44/145</a:t>
+                        <a:t>46/145</a:t>
                       </a:r>
                     </a:p>
                   </a:txBody>

</xml_diff>

<commit_message>
deck(mcom): rebuild — the data moved past the committed figures (run 33469929190)
</commit_message>
<xml_diff>
--- a/docs/decks/mcom-2026-08-05-macro-TH.pptx
+++ b/docs/decks/mcom-2026-08-05-macro-TH.pptx
@@ -6240,7 +6240,7 @@
                 </a:solidFill>
                 <a:latin typeface="Kanit"/>
               </a:rPr>
-              <a:t>136</a:t>
+              <a:t>133</a:t>
             </a:r>
           </a:p>
         </p:txBody>
@@ -6279,7 +6279,7 @@
                 </a:solidFill>
                 <a:latin typeface="Kanit"/>
               </a:rPr>
-              <a:t>จาก 793 (17.2%) · เรียลไทม์ · 2026-08-30</a:t>
+              <a:t>จาก 793 (16.8%) · เรียลไทม์ · 2026-09-01</a:t>
             </a:r>
           </a:p>
         </p:txBody>
@@ -6405,7 +6405,7 @@
                 </a:solidFill>
                 <a:latin typeface="Kanit"/>
               </a:rPr>
-              <a:t>37</a:t>
+              <a:t>29</a:t>
             </a:r>
           </a:p>
         </p:txBody>
@@ -6444,7 +6444,7 @@
                 </a:solidFill>
                 <a:latin typeface="Kanit"/>
               </a:rPr>
-              <a:t>ค่าล่าสุดรายวัน · 2026-08-30</a:t>
+              <a:t>ค่าล่าสุดรายวัน · 2026-09-01</a:t>
             </a:r>
           </a:p>
         </p:txBody>
@@ -7882,7 +7882,7 @@
                           </a:solidFill>
                           <a:latin typeface="Kanit"/>
                         </a:rPr>
-                        <a:t>สกลนคร</a:t>
+                        <a:t>กาญจนบุรี</a:t>
                       </a:r>
                     </a:p>
                   </a:txBody>
@@ -7905,7 +7905,7 @@
                           </a:solidFill>
                           <a:latin typeface="Kanit"/>
                         </a:rPr>
-                        <a:t>37</a:t>
+                        <a:t>86</a:t>
                       </a:r>
                     </a:p>
                   </a:txBody>
@@ -7928,7 +7928,7 @@
                           </a:solidFill>
                           <a:latin typeface="Kanit"/>
                         </a:rPr>
-                        <a:t>8</a:t>
+                        <a:t>94</a:t>
                       </a:r>
                     </a:p>
                   </a:txBody>
@@ -7947,11 +7947,11 @@
                       <a:r>
                         <a:rPr sz="900" b="1">
                           <a:solidFill>
-                            <a:srgbClr val="606060"/>
-                          </a:solidFill>
-                          <a:latin typeface="Kanit"/>
-                        </a:rPr>
-                        <a:t>0.0%</a:t>
+                            <a:srgbClr val="F5C242"/>
+                          </a:solidFill>
+                          <a:latin typeface="Kanit"/>
+                        </a:rPr>
+                        <a:t>18.6%</a:t>
                       </a:r>
                     </a:p>
                   </a:txBody>
@@ -7974,7 +7974,7 @@
                           </a:solidFill>
                           <a:latin typeface="Kanit"/>
                         </a:rPr>
-                        <a:t>7/13</a:t>
+                        <a:t>6/26</a:t>
                       </a:r>
                     </a:p>
                   </a:txBody>
@@ -8022,7 +8022,7 @@
                           </a:solidFill>
                           <a:latin typeface="Kanit"/>
                         </a:rPr>
-                        <a:t>ยโสธร</a:t>
+                        <a:t>อุทัยธานี</a:t>
                       </a:r>
                     </a:p>
                   </a:txBody>
@@ -8045,7 +8045,7 @@
                           </a:solidFill>
                           <a:latin typeface="Kanit"/>
                         </a:rPr>
-                        <a:t>15</a:t>
+                        <a:t>44</a:t>
                       </a:r>
                     </a:p>
                   </a:txBody>
@@ -8068,7 +8068,7 @@
                           </a:solidFill>
                           <a:latin typeface="Kanit"/>
                         </a:rPr>
-                        <a:t>76</a:t>
+                        <a:t>53</a:t>
                       </a:r>
                     </a:p>
                   </a:txBody>
@@ -8091,7 +8091,7 @@
                           </a:solidFill>
                           <a:latin typeface="Kanit"/>
                         </a:rPr>
-                        <a:t>33.3%</a:t>
+                        <a:t>6.8%</a:t>
                       </a:r>
                     </a:p>
                   </a:txBody>
@@ -8114,7 +8114,7 @@
                           </a:solidFill>
                           <a:latin typeface="Kanit"/>
                         </a:rPr>
-                        <a:t>2/5</a:t>
+                        <a:t>1/4</a:t>
                       </a:r>
                     </a:p>
                   </a:txBody>
@@ -8133,11 +8133,11 @@
                       <a:r>
                         <a:rPr sz="900" b="1">
                           <a:solidFill>
-                            <a:srgbClr val="F5C242"/>
-                          </a:solidFill>
-                          <a:latin typeface="Kanit"/>
-                        </a:rPr>
-                        <a:t>4</a:t>
+                            <a:srgbClr val="CC0000"/>
+                          </a:solidFill>
+                          <a:latin typeface="Kanit"/>
+                        </a:rPr>
+                        <a:t>5</a:t>
                       </a:r>
                     </a:p>
                   </a:txBody>
@@ -8162,7 +8162,7 @@
                           </a:solidFill>
                           <a:latin typeface="Kanit"/>
                         </a:rPr>
-                        <a:t>ปราจีนบุรี</a:t>
+                        <a:t>เลย</a:t>
                       </a:r>
                     </a:p>
                   </a:txBody>
@@ -8185,7 +8185,7 @@
                           </a:solidFill>
                           <a:latin typeface="Kanit"/>
                         </a:rPr>
-                        <a:t>33</a:t>
+                        <a:t>111</a:t>
                       </a:r>
                     </a:p>
                   </a:txBody>
@@ -8208,7 +8208,7 @@
                           </a:solidFill>
                           <a:latin typeface="Kanit"/>
                         </a:rPr>
-                        <a:t>75</a:t>
+                        <a:t>127</a:t>
                       </a:r>
                     </a:p>
                   </a:txBody>
@@ -8231,7 +8231,7 @@
                           </a:solidFill>
                           <a:latin typeface="Kanit"/>
                         </a:rPr>
-                        <a:t>21.2%</a:t>
+                        <a:t>0.9%</a:t>
                       </a:r>
                     </a:p>
                   </a:txBody>
@@ -8254,7 +8254,7 @@
                           </a:solidFill>
                           <a:latin typeface="Kanit"/>
                         </a:rPr>
-                        <a:t>2/15</a:t>
+                        <a:t>1/8</a:t>
                       </a:r>
                     </a:p>
                   </a:txBody>
@@ -8273,11 +8273,11 @@
                       <a:r>
                         <a:rPr sz="900" b="1">
                           <a:solidFill>
-                            <a:srgbClr val="F5C242"/>
-                          </a:solidFill>
-                          <a:latin typeface="Kanit"/>
-                        </a:rPr>
-                        <a:t>4</a:t>
+                            <a:srgbClr val="CC0000"/>
+                          </a:solidFill>
+                          <a:latin typeface="Kanit"/>
+                        </a:rPr>
+                        <a:t>5</a:t>
                       </a:r>
                     </a:p>
                   </a:txBody>
@@ -8302,7 +8302,7 @@
                           </a:solidFill>
                           <a:latin typeface="Kanit"/>
                         </a:rPr>
-                        <a:t>จันทบุรี</a:t>
+                        <a:t>สกลนคร</a:t>
                       </a:r>
                     </a:p>
                   </a:txBody>
@@ -8325,7 +8325,7 @@
                           </a:solidFill>
                           <a:latin typeface="Kanit"/>
                         </a:rPr>
-                        <a:t>53</a:t>
+                        <a:t>38</a:t>
                       </a:r>
                     </a:p>
                   </a:txBody>
@@ -8348,7 +8348,7 @@
                           </a:solidFill>
                           <a:latin typeface="Kanit"/>
                         </a:rPr>
-                        <a:t>58</a:t>
+                        <a:t>14</a:t>
                       </a:r>
                     </a:p>
                   </a:txBody>
@@ -8367,11 +8367,11 @@
                       <a:r>
                         <a:rPr sz="900" b="1">
                           <a:solidFill>
-                            <a:srgbClr val="F5C242"/>
-                          </a:solidFill>
-                          <a:latin typeface="Kanit"/>
-                        </a:rPr>
-                        <a:t>17.0%</a:t>
+                            <a:srgbClr val="606060"/>
+                          </a:solidFill>
+                          <a:latin typeface="Kanit"/>
+                        </a:rPr>
+                        <a:t>0.0%</a:t>
                       </a:r>
                     </a:p>
                   </a:txBody>
@@ -8394,7 +8394,7 @@
                           </a:solidFill>
                           <a:latin typeface="Kanit"/>
                         </a:rPr>
-                        <a:t>5/11</a:t>
+                        <a:t>7/13</a:t>
                       </a:r>
                     </a:p>
                   </a:txBody>
@@ -8413,11 +8413,11 @@
                       <a:r>
                         <a:rPr sz="900" b="1">
                           <a:solidFill>
-                            <a:srgbClr val="F5C242"/>
-                          </a:solidFill>
-                          <a:latin typeface="Kanit"/>
-                        </a:rPr>
-                        <a:t>4</a:t>
+                            <a:srgbClr val="CC0000"/>
+                          </a:solidFill>
+                          <a:latin typeface="Kanit"/>
+                        </a:rPr>
+                        <a:t>5</a:t>
                       </a:r>
                     </a:p>
                   </a:txBody>
@@ -8442,7 +8442,7 @@
                           </a:solidFill>
                           <a:latin typeface="Kanit"/>
                         </a:rPr>
-                        <a:t>ตราด</a:t>
+                        <a:t>สมุทรปราการ</a:t>
                       </a:r>
                     </a:p>
                   </a:txBody>
@@ -8465,7 +8465,7 @@
                           </a:solidFill>
                           <a:latin typeface="Kanit"/>
                         </a:rPr>
-                        <a:t>42</a:t>
+                        <a:t>16</a:t>
                       </a:r>
                     </a:p>
                   </a:txBody>
@@ -8488,7 +8488,7 @@
                           </a:solidFill>
                           <a:latin typeface="Kanit"/>
                         </a:rPr>
-                        <a:t>64</a:t>
+                        <a:t>20</a:t>
                       </a:r>
                     </a:p>
                   </a:txBody>
@@ -8507,11 +8507,11 @@
                       <a:r>
                         <a:rPr sz="900" b="1">
                           <a:solidFill>
-                            <a:srgbClr val="F5C242"/>
-                          </a:solidFill>
-                          <a:latin typeface="Kanit"/>
-                        </a:rPr>
-                        <a:t>16.7%</a:t>
+                            <a:srgbClr val="606060"/>
+                          </a:solidFill>
+                          <a:latin typeface="Kanit"/>
+                        </a:rPr>
+                        <a:t>0.0%</a:t>
                       </a:r>
                     </a:p>
                   </a:txBody>
@@ -8534,7 +8534,7 @@
                           </a:solidFill>
                           <a:latin typeface="Kanit"/>
                         </a:rPr>
-                        <a:t>5/9</a:t>
+                        <a:t>4/5</a:t>
                       </a:r>
                     </a:p>
                   </a:txBody>
@@ -8553,11 +8553,11 @@
                       <a:r>
                         <a:rPr sz="900" b="1">
                           <a:solidFill>
-                            <a:srgbClr val="F5C242"/>
-                          </a:solidFill>
-                          <a:latin typeface="Kanit"/>
-                        </a:rPr>
-                        <a:t>4</a:t>
+                            <a:srgbClr val="CC0000"/>
+                          </a:solidFill>
+                          <a:latin typeface="Kanit"/>
+                        </a:rPr>
+                        <a:t>5</a:t>
                       </a:r>
                     </a:p>
                   </a:txBody>
@@ -8582,7 +8582,7 @@
                           </a:solidFill>
                           <a:latin typeface="Kanit"/>
                         </a:rPr>
-                        <a:t>ชุมพร</a:t>
+                        <a:t>อุบลราชธานี</a:t>
                       </a:r>
                     </a:p>
                   </a:txBody>
@@ -8605,7 +8605,7 @@
                           </a:solidFill>
                           <a:latin typeface="Kanit"/>
                         </a:rPr>
-                        <a:t>91</a:t>
+                        <a:t>46</a:t>
                       </a:r>
                     </a:p>
                   </a:txBody>
@@ -8628,7 +8628,7 @@
                           </a:solidFill>
                           <a:latin typeface="Kanit"/>
                         </a:rPr>
-                        <a:t>52</a:t>
+                        <a:t>65</a:t>
                       </a:r>
                     </a:p>
                   </a:txBody>
@@ -8651,7 +8651,7 @@
                           </a:solidFill>
                           <a:latin typeface="Kanit"/>
                         </a:rPr>
-                        <a:t>13.2%</a:t>
+                        <a:t>23.9%</a:t>
                       </a:r>
                     </a:p>
                   </a:txBody>
@@ -8674,7 +8674,7 @@
                           </a:solidFill>
                           <a:latin typeface="Kanit"/>
                         </a:rPr>
-                        <a:t>3/14</a:t>
+                        <a:t>2/15</a:t>
                       </a:r>
                     </a:p>
                   </a:txBody>
@@ -8909,7 +8909,7 @@
                 </a:solidFill>
                 <a:latin typeface="Kanit"/>
               </a:rPr>
-              <a:t>พื้นที่ปลูก วัดจริง (สศก. — ข้อมูลอำเภอ×พืช 3,295 แถว) ภัยแล้งเป็นดัชนี SPEI จาก แบบจำลอง คำนวณจากปริมาณฝนและการคายระเหย ปรับเดือนละครั้ง ดึงข้อมูล 2026-07-20 — เป็นสัญญาณที่ครอบคลุมทั้งประเทศดีที่สุดที่มี แต่ไม่มีใครลงพื้นที่ไปเดินดูอำเภอเหล่านั้น ข้อมูลฝนและระดับน้ำ วัดจริง (ThaiWater เรียลไทม์ ดึงทุกวันและสะสมไว้ — วันที่ดึงไม่สำเร็จจะเว้นเป็นช่องว่าง ไม่ใส่ค่าสมมติ) · ฝนถึง 2026-08-30, ระดับน้ำถึง 2026-08-30 ความเสี่ยงน้ำท่วมเชิงโครงสร้าง วัดจริง (สำมะโนพื้นที่ท่วมซ้ำซาก GISTDA มาตราส่วน 1:50,000 ปี 2005-2016 — เป็นบันทึกภาคพื้นดิน 12 ปี ไม่ใช่การพยากรณ์)</a:t>
+              <a:t>พื้นที่ปลูก วัดจริง (สศก. — ข้อมูลอำเภอ×พืช 3,295 แถว) ภัยแล้งเป็นดัชนี SPEI จาก แบบจำลอง คำนวณจากปริมาณฝนและการคายระเหย ปรับเดือนละครั้ง ดึงข้อมูล 2026-07-20 — เป็นสัญญาณที่ครอบคลุมทั้งประเทศดีที่สุดที่มี แต่ไม่มีใครลงพื้นที่ไปเดินดูอำเภอเหล่านั้น ข้อมูลฝนและระดับน้ำ วัดจริง (ThaiWater เรียลไทม์ ดึงทุกวันและสะสมไว้ — วันที่ดึงไม่สำเร็จจะเว้นเป็นช่องว่าง ไม่ใส่ค่าสมมติ) · ฝนถึง 2026-09-01, ระดับน้ำถึง 2026-09-01 ความเสี่ยงน้ำท่วมเชิงโครงสร้าง วัดจริง (สำมะโนพื้นที่ท่วมซ้ำซาก GISTDA มาตราส่วน 1:50,000 ปี 2005-2016 — เป็นบันทึกภาคพื้นดิน 12 ปี ไม่ใช่การพยากรณ์)</a:t>
             </a:r>
           </a:p>
         </p:txBody>
@@ -32047,7 +32047,7 @@
                 </a:solidFill>
                 <a:latin typeface="Kanit"/>
               </a:rPr>
-              <a:t>รุ่นข้อมูล — ราคาโลก 2026M06 · ราคาหน้าฟาร์มไทย 2026-08-28 · ประวัติราคาไทย 2026-08-23 · ต้นทุนการผลิตพืช สศก. ไจอัป 2568 (ปีเพาะปลูก 2568/69, ประมาณการ สศก. มี.ค. 2569) · ภัยแล้ง 2026-06-21 · เงินเฟ้อ 2026-05 · GDP 2026 ไตรมาส 1 · IMF WEO 2026 · ดัชนีราคาขายต่อ 2026-05 · ยอดจดทะเบียนถึง 2026-01 · หนี้ครัวเรือน สสช. SES 2566 · ค่าจ้าง สสช. LFS 2568 · ข้อมูลตรวจวัด 2026-08-30</a:t>
+              <a:t>รุ่นข้อมูล — ราคาโลก 2026M06 · ราคาหน้าฟาร์มไทย 2026-08-28 · ประวัติราคาไทย 2026-08-29 · ต้นทุนการผลิตพืช สศก. ไจอัป 2568 (ปีเพาะปลูก 2568/69, ประมาณการ สศก. มี.ค. 2569) · ภัยแล้ง 2026-06-21 · เงินเฟ้อ 2026-05 · GDP 2026 ไตรมาส 1 · IMF WEO 2026 · ดัชนีราคาขายต่อ 2026-05 · ยอดจดทะเบียนถึง 2026-01 · หนี้ครัวเรือน สสช. SES 2566 · ค่าจ้าง สสช. LFS 2568 · ข้อมูลตรวจวัด 2026-09-01</a:t>
             </a:r>
           </a:p>
         </p:txBody>
@@ -33786,7 +33786,7 @@
                 </a:solidFill>
                 <a:latin typeface="Kanit"/>
               </a:rPr>
-              <a:t>ธนาคารแห่งประเทศไทย · 2026-06</a:t>
+              <a:t>ธนาคารแห่งประเทศไทย · 2026-08</a:t>
             </a:r>
           </a:p>
         </p:txBody>
@@ -33912,7 +33912,7 @@
                 </a:solidFill>
                 <a:latin typeface="Kanit"/>
               </a:rPr>
-              <a:t>32.69</a:t>
+              <a:t>33.16</a:t>
             </a:r>
           </a:p>
         </p:txBody>
@@ -33951,7 +33951,7 @@
                 </a:solidFill>
                 <a:latin typeface="Kanit"/>
               </a:rPr>
-              <a:t>อัตราอ้างอิง ECB · 2026-08-24</a:t>
+              <a:t>อัตราอ้างอิง ECB · 2026-08-31</a:t>
             </a:r>
           </a:p>
         </p:txBody>
@@ -35798,7 +35798,7 @@
                 </a:solidFill>
                 <a:latin typeface="Kanit"/>
               </a:rPr>
-              <a:t>สศช. 2026 ไตรมาส 1 · TPSO 2026-05 · ธนาคารแห่งประเทศไทย 2026-06 · BIS 2025 ไตรมาส 4 · ECB 2026-08-24, ทั้งหมดดึงจากหน่วยงานผู้เผยแพร่โดยตรง ตารางเทียบประเทศใช้ IMF World Economic Outlook 2026 (ดึงข้อมูล 2026-07-25) อัตรา NPL ที่ ธปท. เผยแพร่ — 4.48% ณ 2026 ไตรมาส 1, จาก 4.33% ไตรมาสก่อน เปลี่ยน +0.24 จุดใน 1 ปี และต่ำสุด 3.08% ณ 2021 ไตรมาส 1</a:t>
+              <a:t>สศช. 2026 ไตรมาส 1 · TPSO 2026-05 · ธนาคารแห่งประเทศไทย 2026-08 · BIS 2025 ไตรมาส 4 · ECB 2026-08-31, ทั้งหมดดึงจากหน่วยงานผู้เผยแพร่โดยตรง ตารางเทียบประเทศใช้ IMF World Economic Outlook 2026 (ดึงข้อมูล 2026-07-25) อัตรา NPL ที่ ธปท. เผยแพร่ — 4.48% ณ 2026 ไตรมาส 1, จาก 4.33% ไตรมาสก่อน เปลี่ยน +0.24 จุดใน 1 ปี และต่ำสุด 3.08% ณ 2021 ไตรมาส 1</a:t>
             </a:r>
           </a:p>
         </p:txBody>
@@ -37087,7 +37087,7 @@
                 </a:solidFill>
                 <a:latin typeface="Kanit"/>
               </a:rPr>
-              <a:t>338 จาก 928 อำเภอ · แม่น้ำเกินระดับ 136 จาก 793 สถานี</a:t>
+              <a:t>338 จาก 928 อำเภอ · แม่น้ำเกินระดับ 133 จาก 793 สถานี</a:t>
             </a:r>
           </a:p>
         </p:txBody>
@@ -37859,7 +37859,7 @@
                           </a:solidFill>
                           <a:latin typeface="Kanit"/>
                         </a:rPr>
-                        <a:t>25/156</a:t>
+                        <a:t>27/156</a:t>
                       </a:r>
                     </a:p>
                   </a:txBody>
@@ -38091,7 +38091,7 @@
                           </a:solidFill>
                           <a:latin typeface="Kanit"/>
                         </a:rPr>
-                        <a:t>19/273</a:t>
+                        <a:t>17/274</a:t>
                       </a:r>
                     </a:p>
                   </a:txBody>
@@ -38323,7 +38323,7 @@
                           </a:solidFill>
                           <a:latin typeface="Kanit"/>
                         </a:rPr>
-                        <a:t>31/167</a:t>
+                        <a:t>25/167</a:t>
                       </a:r>
                     </a:p>
                   </a:txBody>
@@ -38555,7 +38555,7 @@
                           </a:solidFill>
                           <a:latin typeface="Kanit"/>
                         </a:rPr>
-                        <a:t>15/52</a:t>
+                        <a:t>15/51</a:t>
                       </a:r>
                     </a:p>
                   </a:txBody>
@@ -38787,7 +38787,7 @@
                           </a:solidFill>
                           <a:latin typeface="Kanit"/>
                         </a:rPr>
-                        <a:t>46/145</a:t>
+                        <a:t>49/145</a:t>
                       </a:r>
                     </a:p>
                   </a:txBody>
@@ -39959,7 +39959,7 @@
                           </a:solidFill>
                           <a:latin typeface="Kanit"/>
                         </a:rPr>
-                        <a:t>−50.1%</a:t>
+                        <a:t>−50.7%</a:t>
                       </a:r>
                     </a:p>
                   </a:txBody>
@@ -40791,7 +40791,7 @@
                 </a:solidFill>
                 <a:latin typeface="Kanit"/>
               </a:rPr>
-              <a:t>ราคา วัดจริง — ราคาหน้าฟาร์มไทยจากราคารายวันของ NABC และราคาอ้อยประกาศของ สอน. ราคาล่าสุด 2026-08-28 การเปลี่ยนแปลงหกเดือนคำนวณจากข้อมูลรายเดือนของ NABC เอง (thai_price_history รุ่นข้อมูล 2026-08-23) พืชที่ไม่มีข้อมูลรายเดือนจะกำกับไว้ ไม่ประมาณการขึ้นมา แหล่งผลิตเป็นการอ่านแบบ ประมาณการ ว่าสินค้าแต่ละชนิดปลูกที่ไหน และแหล่งผลิตทับซ้อนกันได้ บัญชีอาชีพเกษตรเป็นข้อมูลของเราเองและ วัดจริง — บัญชีที่บันทึกอาชีพว่า เกษตร ในจังหวัดแหล่งผลิต จากฐานข้อมูล 382,735 บัญชี ณ 2026-07 ไม่เผยแพร่ช่องที่มีน้อยกว่า 30 บัญชี คนกลุ่มนี้อาศัยอยู่ในพื้นที่ที่ปลูกพืชนั้น แต่ไม่ได้ยืนยันว่าปลูกพืชนั้นเอง</a:t>
+              <a:t>ราคา วัดจริง — ราคาหน้าฟาร์มไทยจากราคารายวันของ NABC และราคาอ้อยประกาศของ สอน. ราคาล่าสุด 2026-08-28 การเปลี่ยนแปลงหกเดือนคำนวณจากข้อมูลรายเดือนของ NABC เอง (thai_price_history รุ่นข้อมูล 2026-08-29) พืชที่ไม่มีข้อมูลรายเดือนจะกำกับไว้ ไม่ประมาณการขึ้นมา แหล่งผลิตเป็นการอ่านแบบ ประมาณการ ว่าสินค้าแต่ละชนิดปลูกที่ไหน และแหล่งผลิตทับซ้อนกันได้ บัญชีอาชีพเกษตรเป็นข้อมูลของเราเองและ วัดจริง — บัญชีที่บันทึกอาชีพว่า เกษตร ในจังหวัดแหล่งผลิต จากฐานข้อมูล 382,735 บัญชี ณ 2026-07 ไม่เผยแพร่ช่องที่มีน้อยกว่า 30 บัญชี คนกลุ่มนี้อาศัยอยู่ในพื้นที่ที่ปลูกพืชนั้น แต่ไม่ได้ยืนยันว่าปลูกพืชนั้นเอง</a:t>
             </a:r>
           </a:p>
         </p:txBody>
@@ -43419,7 +43419,7 @@
                           </a:solidFill>
                           <a:latin typeface="Kanit"/>
                         </a:rPr>
-                        <a:t>90.86</a:t>
+                        <a:t>92.20</a:t>
                       </a:r>
                     </a:p>
                   </a:txBody>
@@ -43559,7 +43559,7 @@
                           </a:solidFill>
                           <a:latin typeface="Kanit"/>
                         </a:rPr>
-                        <a:t>15,264</a:t>
+                        <a:t>15,488</a:t>
                       </a:r>
                     </a:p>
                   </a:txBody>
@@ -43699,7 +43699,7 @@
                           </a:solidFill>
                           <a:latin typeface="Kanit"/>
                         </a:rPr>
-                        <a:t>35,986</a:t>
+                        <a:t>36,515</a:t>
                       </a:r>
                     </a:p>
                   </a:txBody>
@@ -43839,7 +43839,7 @@
                           </a:solidFill>
                           <a:latin typeface="Kanit"/>
                         </a:rPr>
-                        <a:t>11.11</a:t>
+                        <a:t>11.28</a:t>
                       </a:r>
                     </a:p>
                   </a:txBody>
@@ -44058,7 +44058,7 @@
                 </a:solidFill>
                 <a:latin typeface="Kanit"/>
               </a:rPr>
-              <a:t>ราคารายเดือนสกุลดอลลาร์ราคาปัจจุบันจาก World Bank Pink Sheet รุ่นข้อมูล 2026M07 (ข้อมูล 60 จุดต่อรายการ ปรับฐานเป็น 100 ณ 2021-07 เพื่อวาดกราฟ — หน่วยต่างกัน จึงใช้แกนเดียวกับระดับราคาดิบไม่ได้) แปลงเป็นบาทด้วยอัตราอ้างอิง ECB USD/THB 32.685 ณ 2026-08-24 สัดส่วนพื้นที่ปลูก วัดจริง จากสัดส่วนพืชของ สศก./กรมส่งเสริมการเกษตร (crop_mix.json) เป็นราคาปัจจุบัน ไม่ได้ปรับเงินเฟ้อ: ทุกตัวเลข ‘เทียบ 5 ปีก่อน’ มีเงินเฟ้อไทยห้าปีซ่อนอยู่ข้างใต้</a:t>
+              <a:t>ราคารายเดือนสกุลดอลลาร์ราคาปัจจุบันจาก World Bank Pink Sheet รุ่นข้อมูล 2026M07 (ข้อมูล 60 จุดต่อรายการ ปรับฐานเป็น 100 ณ 2021-07 เพื่อวาดกราฟ — หน่วยต่างกัน จึงใช้แกนเดียวกับระดับราคาดิบไม่ได้) แปลงเป็นบาทด้วยอัตราอ้างอิง ECB USD/THB 33.165 ณ 2026-08-31 สัดส่วนพื้นที่ปลูก วัดจริง จากสัดส่วนพืชของ สศก./กรมส่งเสริมการเกษตร (crop_mix.json) เป็นราคาปัจจุบัน ไม่ได้ปรับเงินเฟ้อ: ทุกตัวเลข ‘เทียบ 5 ปีก่อน’ มีเงินเฟ้อไทยห้าปีซ่อนอยู่ข้างใต้</a:t>
             </a:r>
           </a:p>
         </p:txBody>
@@ -47985,7 +47985,7 @@
                 </a:solidFill>
                 <a:latin typeface="Kanit"/>
               </a:rPr>
-              <a:t>฿606.15 /ร้อยผล · ใต้·ตอ.</a:t>
+              <a:t>฿596.84 /ร้อยผล · ใต้·ตอ.</a:t>
             </a:r>
           </a:p>
         </p:txBody>
@@ -48063,7 +48063,7 @@
                 </a:solidFill>
                 <a:latin typeface="Kanit"/>
               </a:rPr>
-              <a:t>6 เดือน −50.1%</a:t>
+              <a:t>6 เดือน −50.7%</a:t>
             </a:r>
           </a:p>
         </p:txBody>
@@ -48137,19 +48137,19 @@
                   <a:pt x="0" y="0"/>
                 </a:moveTo>
                 <a:lnTo>
-                  <a:pt x="412943" y="167653"/>
-                </a:lnTo>
-                <a:lnTo>
-                  <a:pt x="825886" y="145107"/>
-                </a:lnTo>
-                <a:lnTo>
-                  <a:pt x="1238829" y="402654"/>
+                  <a:pt x="412943" y="170673"/>
+                </a:lnTo>
+                <a:lnTo>
+                  <a:pt x="825886" y="145193"/>
+                </a:lnTo>
+                <a:lnTo>
+                  <a:pt x="1238829" y="399195"/>
                 </a:lnTo>
                 <a:lnTo>
                   <a:pt x="1651772" y="457200"/>
                 </a:lnTo>
                 <a:lnTo>
-                  <a:pt x="2064715" y="401204"/>
+                  <a:pt x="2064715" y="409348"/>
                 </a:lnTo>
               </a:path>
             </a:pathLst>
@@ -48192,7 +48192,7 @@
         </p:nvSpPr>
         <p:spPr>
           <a:xfrm>
-            <a:off x="2480767" y="2806076"/>
+            <a:off x="2480767" y="2814220"/>
             <a:ext cx="82296" cy="82296"/>
           </a:xfrm>
           <a:prstGeom prst="roundRect">
@@ -48621,7 +48621,7 @@
                 </a:solidFill>
                 <a:latin typeface="Kanit"/>
               </a:rPr>
-              <a:t>฿143.00 /กก. · ชายฝั่งใต้·ตอ.</a:t>
+              <a:t>฿143.14 /กก. · ชายฝั่งใต้·ตอ.</a:t>
             </a:r>
           </a:p>
         </p:txBody>
@@ -48699,7 +48699,7 @@
                 </a:solidFill>
                 <a:latin typeface="Kanit"/>
               </a:rPr>
-              <a:t>6 เดือน −2.1%</a:t>
+              <a:t>6 เดือน −2.0%</a:t>
             </a:r>
           </a:p>
         </p:txBody>
@@ -48770,19 +48770,19 @@
             <a:pathLst>
               <a:path w="2064715" h="457200">
                 <a:moveTo>
-                  <a:pt x="0" y="217911"/>
+                  <a:pt x="0" y="216948"/>
                 </a:moveTo>
                 <a:lnTo>
-                  <a:pt x="412943" y="415692"/>
+                  <a:pt x="412943" y="415955"/>
                 </a:lnTo>
                 <a:lnTo>
                   <a:pt x="825886" y="457200"/>
                 </a:lnTo>
                 <a:lnTo>
-                  <a:pt x="1238829" y="420051"/>
-                </a:lnTo>
-                <a:lnTo>
-                  <a:pt x="1651772" y="168518"/>
+                  <a:pt x="1238829" y="420285"/>
+                </a:lnTo>
+                <a:lnTo>
+                  <a:pt x="1651772" y="170341"/>
                 </a:lnTo>
                 <a:lnTo>
                   <a:pt x="2064715" y="0"/>
@@ -48939,7 +48939,7 @@
                 </a:solidFill>
                 <a:latin typeface="Kanit"/>
               </a:rPr>
-              <a:t>฿43.00 /กก. · กลาง·ตอ.</a:t>
+              <a:t>฿43.05 /กก. · กลาง·ตอ.</a:t>
             </a:r>
           </a:p>
         </p:txBody>
@@ -49017,7 +49017,7 @@
                 </a:solidFill>
                 <a:latin typeface="Kanit"/>
               </a:rPr>
-              <a:t>6 เดือน +2.3%</a:t>
+              <a:t>6 เดือน +2.4%</a:t>
             </a:r>
           </a:p>
         </p:txBody>
@@ -49091,19 +49091,19 @@
                   <a:pt x="0" y="0"/>
                 </a:moveTo>
                 <a:lnTo>
-                  <a:pt x="412943" y="111737"/>
-                </a:lnTo>
-                <a:lnTo>
-                  <a:pt x="825886" y="304458"/>
+                  <a:pt x="412943" y="119484"/>
+                </a:lnTo>
+                <a:lnTo>
+                  <a:pt x="825886" y="305129"/>
                 </a:lnTo>
                 <a:lnTo>
                   <a:pt x="1238829" y="457200"/>
                 </a:lnTo>
                 <a:lnTo>
-                  <a:pt x="1651772" y="242951"/>
-                </a:lnTo>
-                <a:lnTo>
-                  <a:pt x="2064715" y="88159"/>
+                  <a:pt x="1651772" y="245880"/>
+                </a:lnTo>
+                <a:lnTo>
+                  <a:pt x="2064715" y="91834"/>
                 </a:lnTo>
               </a:path>
             </a:pathLst>
@@ -49146,7 +49146,7 @@
         </p:nvSpPr>
         <p:spPr>
           <a:xfrm>
-            <a:off x="9388144" y="2493031"/>
+            <a:off x="9388144" y="2496706"/>
             <a:ext cx="82296" cy="82296"/>
           </a:xfrm>
           <a:prstGeom prst="roundRect">
@@ -49257,7 +49257,7 @@
                 </a:solidFill>
                 <a:latin typeface="Kanit"/>
               </a:rPr>
-              <a:t>฿346.15 /ร้อยฟอง · กลาง·ตอ.</a:t>
+              <a:t>฿350.53 /ร้อยฟอง · กลาง·ตอ.</a:t>
             </a:r>
           </a:p>
         </p:txBody>
@@ -49335,7 +49335,7 @@
                 </a:solidFill>
                 <a:latin typeface="Kanit"/>
               </a:rPr>
-              <a:t>6 เดือน +14.4%</a:t>
+              <a:t>6 เดือน +15.9%</a:t>
             </a:r>
           </a:p>
         </p:txBody>
@@ -49409,16 +49409,16 @@
                   <a:pt x="0" y="457200"/>
                 </a:moveTo>
                 <a:lnTo>
-                  <a:pt x="412943" y="191637"/>
-                </a:lnTo>
-                <a:lnTo>
-                  <a:pt x="825886" y="191637"/>
-                </a:lnTo>
-                <a:lnTo>
-                  <a:pt x="1238829" y="292498"/>
-                </a:lnTo>
-                <a:lnTo>
-                  <a:pt x="1651772" y="90775"/>
+                  <a:pt x="412943" y="218744"/>
+                </a:lnTo>
+                <a:lnTo>
+                  <a:pt x="825886" y="218744"/>
+                </a:lnTo>
+                <a:lnTo>
+                  <a:pt x="1238829" y="309310"/>
+                </a:lnTo>
+                <a:lnTo>
+                  <a:pt x="1651772" y="128177"/>
                 </a:lnTo>
                 <a:lnTo>
                   <a:pt x="2064715" y="0"/>
@@ -49575,7 +49575,7 @@
                 </a:solidFill>
                 <a:latin typeface="Kanit"/>
               </a:rPr>
-              <a:t>฿70.33 /กก. · กลาง·ตต.·ตอ.</a:t>
+              <a:t>฿71.18 /กก. · กลาง·ตต.·ตอ.</a:t>
             </a:r>
           </a:p>
         </p:txBody>
@@ -49653,7 +49653,7 @@
                 </a:solidFill>
                 <a:latin typeface="Kanit"/>
               </a:rPr>
-              <a:t>6 เดือน +26.7%</a:t>
+              <a:t>6 เดือน +28.2%</a:t>
             </a:r>
           </a:p>
         </p:txBody>
@@ -49724,19 +49724,19 @@
             <a:pathLst>
               <a:path w="2064715" h="457200">
                 <a:moveTo>
-                  <a:pt x="0" y="361078"/>
+                  <a:pt x="0" y="371819"/>
                 </a:moveTo>
                 <a:lnTo>
-                  <a:pt x="412943" y="110564"/>
+                  <a:pt x="412943" y="140924"/>
                 </a:lnTo>
                 <a:lnTo>
                   <a:pt x="825886" y="457200"/>
                 </a:lnTo>
                 <a:lnTo>
-                  <a:pt x="1238829" y="293843"/>
-                </a:lnTo>
-                <a:lnTo>
-                  <a:pt x="1651772" y="177301"/>
+                  <a:pt x="1238829" y="309849"/>
+                </a:lnTo>
+                <a:lnTo>
+                  <a:pt x="1651772" y="196008"/>
                 </a:lnTo>
                 <a:lnTo>
                   <a:pt x="2064715" y="0"/>
@@ -49893,7 +49893,7 @@
                 </a:solidFill>
                 <a:latin typeface="Kanit"/>
               </a:rPr>
-              <a:t>฿17,815 /ตัน · อีสาน·เหนือ·กลาง</a:t>
+              <a:t>฿17,763 /ตัน · อีสาน·เหนือ·กลาง</a:t>
             </a:r>
           </a:p>
         </p:txBody>
@@ -49971,7 +49971,7 @@
                 </a:solidFill>
                 <a:latin typeface="Kanit"/>
               </a:rPr>
-              <a:t>6 เดือน +8.2%</a:t>
+              <a:t>6 เดือน +7.7%</a:t>
             </a:r>
           </a:p>
         </p:txBody>
@@ -50045,16 +50045,16 @@
                   <a:pt x="0" y="457200"/>
                 </a:moveTo>
                 <a:lnTo>
-                  <a:pt x="412943" y="349810"/>
-                </a:lnTo>
-                <a:lnTo>
-                  <a:pt x="825886" y="168554"/>
-                </a:lnTo>
-                <a:lnTo>
-                  <a:pt x="1238829" y="54643"/>
-                </a:lnTo>
-                <a:lnTo>
-                  <a:pt x="1651772" y="63603"/>
+                  <a:pt x="412943" y="341371"/>
+                </a:lnTo>
+                <a:lnTo>
+                  <a:pt x="825886" y="153981"/>
+                </a:lnTo>
+                <a:lnTo>
+                  <a:pt x="1238829" y="34219"/>
+                </a:lnTo>
+                <a:lnTo>
+                  <a:pt x="1651772" y="23720"/>
                 </a:lnTo>
                 <a:lnTo>
                   <a:pt x="2064715" y="0"/>
@@ -50211,7 +50211,7 @@
                 </a:solidFill>
                 <a:latin typeface="Kanit"/>
               </a:rPr>
-              <a:t>฿9.87 /กก. · เหนือ</a:t>
+              <a:t>฿9.76 /กก. · เหนือ</a:t>
             </a:r>
           </a:p>
         </p:txBody>
@@ -50289,7 +50289,7 @@
                 </a:solidFill>
                 <a:latin typeface="Kanit"/>
               </a:rPr>
-              <a:t>6 เดือน +10.9%</a:t>
+              <a:t>6 เดือน +9.7%</a:t>
             </a:r>
           </a:p>
         </p:txBody>
@@ -50363,19 +50363,19 @@
                   <a:pt x="0" y="457200"/>
                 </a:moveTo>
                 <a:lnTo>
-                  <a:pt x="412943" y="355874"/>
-                </a:lnTo>
-                <a:lnTo>
-                  <a:pt x="825886" y="86497"/>
+                  <a:pt x="412943" y="350931"/>
+                </a:lnTo>
+                <a:lnTo>
+                  <a:pt x="825886" y="79083"/>
                 </a:lnTo>
                 <a:lnTo>
                   <a:pt x="1238829" y="0"/>
                 </a:lnTo>
                 <a:lnTo>
-                  <a:pt x="1651772" y="46955"/>
-                </a:lnTo>
-                <a:lnTo>
-                  <a:pt x="2064715" y="269377"/>
+                  <a:pt x="1651772" y="54369"/>
+                </a:lnTo>
+                <a:lnTo>
+                  <a:pt x="2064715" y="294090"/>
                 </a:lnTo>
               </a:path>
             </a:pathLst>
@@ -50418,7 +50418,7 @@
         </p:nvSpPr>
         <p:spPr>
           <a:xfrm>
-            <a:off x="7085685" y="3780673"/>
+            <a:off x="7085685" y="3805386"/>
             <a:ext cx="82296" cy="82296"/>
           </a:xfrm>
           <a:prstGeom prst="roundRect">
@@ -50529,7 +50529,7 @@
                 </a:solidFill>
                 <a:latin typeface="Kanit"/>
               </a:rPr>
-              <a:t>฿8.55 /กก. · ใต้</a:t>
+              <a:t>฿8.51 /กก. · ใต้</a:t>
             </a:r>
           </a:p>
         </p:txBody>
@@ -50607,7 +50607,7 @@
                 </a:solidFill>
                 <a:latin typeface="Kanit"/>
               </a:rPr>
-              <a:t>6 เดือน +25.0%</a:t>
+              <a:t>6 เดือน +24.6%</a:t>
             </a:r>
           </a:p>
         </p:txBody>
@@ -50678,19 +50678,19 @@
             <a:pathLst>
               <a:path w="2064715" h="457200">
                 <a:moveTo>
-                  <a:pt x="0" y="453788"/>
+                  <a:pt x="0" y="453709"/>
                 </a:moveTo>
                 <a:lnTo>
-                  <a:pt x="412943" y="446964"/>
+                  <a:pt x="412943" y="439749"/>
                 </a:lnTo>
                 <a:lnTo>
                   <a:pt x="825886" y="457200"/>
                 </a:lnTo>
                 <a:lnTo>
-                  <a:pt x="1238829" y="300250"/>
-                </a:lnTo>
-                <a:lnTo>
-                  <a:pt x="1651772" y="85298"/>
+                  <a:pt x="1238829" y="293166"/>
+                </a:lnTo>
+                <a:lnTo>
+                  <a:pt x="1651772" y="76781"/>
                 </a:lnTo>
                 <a:lnTo>
                   <a:pt x="2064715" y="0"/>
@@ -50847,7 +50847,7 @@
                 </a:solidFill>
                 <a:latin typeface="Kanit"/>
               </a:rPr>
-              <a:t>฿81.51 /กก. · ใต้·ตอ.</a:t>
+              <a:t>฿81.23 /กก. · ใต้·ตอ.</a:t>
             </a:r>
           </a:p>
         </p:txBody>
@@ -50925,7 +50925,7 @@
                 </a:solidFill>
                 <a:latin typeface="Kanit"/>
               </a:rPr>
-              <a:t>6 เดือน +35.1%</a:t>
+              <a:t>6 เดือน +34.6%</a:t>
             </a:r>
           </a:p>
         </p:txBody>
@@ -50999,19 +50999,19 @@
                   <a:pt x="0" y="457200"/>
                 </a:moveTo>
                 <a:lnTo>
-                  <a:pt x="412943" y="287287"/>
-                </a:lnTo>
-                <a:lnTo>
-                  <a:pt x="825886" y="158892"/>
+                  <a:pt x="412943" y="282748"/>
+                </a:lnTo>
+                <a:lnTo>
+                  <a:pt x="825886" y="158359"/>
                 </a:lnTo>
                 <a:lnTo>
                   <a:pt x="1238829" y="0"/>
                 </a:lnTo>
                 <a:lnTo>
-                  <a:pt x="1651772" y="38185"/>
-                </a:lnTo>
-                <a:lnTo>
-                  <a:pt x="2064715" y="115325"/>
+                  <a:pt x="1651772" y="39334"/>
+                </a:lnTo>
+                <a:lnTo>
+                  <a:pt x="2064715" y="122090"/>
                 </a:lnTo>
               </a:path>
             </a:pathLst>
@@ -51054,7 +51054,7 @@
         </p:nvSpPr>
         <p:spPr>
           <a:xfrm>
-            <a:off x="11690603" y="3626621"/>
+            <a:off x="11690603" y="3633386"/>
             <a:ext cx="82296" cy="82296"/>
           </a:xfrm>
           <a:prstGeom prst="roundRect">
@@ -51165,7 +51165,7 @@
                 </a:solidFill>
                 <a:latin typeface="Kanit"/>
               </a:rPr>
-              <a:t>฿3.75 /กก. · อีสาน·เหนือ·ตอ.</a:t>
+              <a:t>฿3.81 /กก. · อีสาน·เหนือ·ตอ.</a:t>
             </a:r>
           </a:p>
         </p:txBody>
@@ -51243,7 +51243,7 @@
                 </a:solidFill>
                 <a:latin typeface="Kanit"/>
               </a:rPr>
-              <a:t>6 เดือน +48.8%</a:t>
+              <a:t>6 เดือน +51.8%</a:t>
             </a:r>
           </a:p>
         </p:txBody>
@@ -51317,16 +51317,16 @@
                   <a:pt x="0" y="457200"/>
                 </a:moveTo>
                 <a:lnTo>
-                  <a:pt x="412943" y="352338"/>
-                </a:lnTo>
-                <a:lnTo>
-                  <a:pt x="825886" y="268448"/>
-                </a:lnTo>
-                <a:lnTo>
-                  <a:pt x="1238829" y="163586"/>
-                </a:lnTo>
-                <a:lnTo>
-                  <a:pt x="1651772" y="125835"/>
+                  <a:pt x="412943" y="357809"/>
+                </a:lnTo>
+                <a:lnTo>
+                  <a:pt x="825886" y="278296"/>
+                </a:lnTo>
+                <a:lnTo>
+                  <a:pt x="1238829" y="178905"/>
+                </a:lnTo>
+                <a:lnTo>
+                  <a:pt x="1651772" y="143124"/>
                 </a:lnTo>
                 <a:lnTo>
                   <a:pt x="2064715" y="0"/>
@@ -51483,7 +51483,7 @@
                 </a:solidFill>
                 <a:latin typeface="Kanit"/>
               </a:rPr>
-              <a:t>฿129.23 /ร้อยผล · กลาง·ตต.</a:t>
+              <a:t>฿146.32 /ร้อยผล · กลาง·ตต.</a:t>
             </a:r>
           </a:p>
         </p:txBody>
@@ -51561,7 +51561,7 @@
                 </a:solidFill>
                 <a:latin typeface="Kanit"/>
               </a:rPr>
-              <a:t>6 เดือน −38.5%</a:t>
+              <a:t>6 เดือน −30.3%</a:t>
             </a:r>
           </a:p>
         </p:txBody>
@@ -51647,7 +51647,7 @@
                   <a:pt x="1651772" y="457200"/>
                 </a:lnTo>
                 <a:lnTo>
-                  <a:pt x="2064715" y="428011"/>
+                  <a:pt x="2064715" y="416732"/>
                 </a:lnTo>
               </a:path>
             </a:pathLst>
@@ -51690,7 +51690,7 @@
         </p:nvSpPr>
         <p:spPr>
           <a:xfrm>
-            <a:off x="4783226" y="5045730"/>
+            <a:off x="4783226" y="5034451"/>
             <a:ext cx="82296" cy="82296"/>
           </a:xfrm>
           <a:prstGeom prst="roundRect">
@@ -51886,7 +51886,7 @@
                 </a:solidFill>
                 <a:latin typeface="Kanit"/>
               </a:rPr>
-              <a:t>ราคาหน้าฟาร์ม วัดจริง — ราคารายวันของ NABC เฉลี่ยเป็นรายเดือน หน่วยเป็นบาทตามที่เผยแพร่ (ไม่มีการแปลงสกุลเงิน) ราคาล่าสุด 2026-08-28, รุ่นข้อมูลย้อนหลัง 2026-08-23 ราคาหน้าฟาร์ม (ราคาที่เกษตรกรขายได้) คือเงินที่เกษตรกรได้รับเมื่อขายครั้งแรก ก่อนพ่อค้าคนกลาง โรงสี หรือค่าขนส่งจะหักส่วนแบ่ง — ไม่ใช่ดัชนีโลก และไม่ใช่ราคาในซูเปอร์มาร์เก็ต แหล่งผลิตเป็นการอ่านแบบ ประมาณการ ว่าสินค้าแต่ละชนิดผลิตที่ไหน และทับซ้อนกันได้ น้ำตาลเป็นราคาอ้อยประกาศของ สอน. ปีละหนึ่งจุด จึงไม่มีการเปลี่ยนแปลงหกเดือนให้แสดง</a:t>
+              <a:t>ราคาหน้าฟาร์ม วัดจริง — ราคารายวันของ NABC เฉลี่ยเป็นรายเดือน หน่วยเป็นบาทตามที่เผยแพร่ (ไม่มีการแปลงสกุลเงิน) ราคาล่าสุด 2026-08-28, รุ่นข้อมูลย้อนหลัง 2026-08-29 ราคาหน้าฟาร์ม (ราคาที่เกษตรกรขายได้) คือเงินที่เกษตรกรได้รับเมื่อขายครั้งแรก ก่อนพ่อค้าคนกลาง โรงสี หรือค่าขนส่งจะหักส่วนแบ่ง — ไม่ใช่ดัชนีโลก และไม่ใช่ราคาในซูเปอร์มาร์เก็ต แหล่งผลิตเป็นการอ่านแบบ ประมาณการ ว่าสินค้าแต่ละชนิดผลิตที่ไหน และทับซ้อนกันได้ น้ำตาลเป็นราคาอ้อยประกาศของ สอน. ปีละหนึ่งจุด จึงไม่มีการเปลี่ยนแปลงหกเดือนให้แสดง</a:t>
             </a:r>
           </a:p>
         </p:txBody>

</xml_diff>

<commit_message>
deck(mcom): rebuild — the data moved past the committed figures (run 33469929190) (#755)
Co-authored-by: github-actions[bot] <41898282+github-actions[bot]@users.noreply.github.com>
</commit_message>
<xml_diff>
--- a/docs/decks/mcom-2026-08-05-macro-TH.pptx
+++ b/docs/decks/mcom-2026-08-05-macro-TH.pptx
@@ -6240,7 +6240,7 @@
                 </a:solidFill>
                 <a:latin typeface="Kanit"/>
               </a:rPr>
-              <a:t>136</a:t>
+              <a:t>133</a:t>
             </a:r>
           </a:p>
         </p:txBody>
@@ -6279,7 +6279,7 @@
                 </a:solidFill>
                 <a:latin typeface="Kanit"/>
               </a:rPr>
-              <a:t>จาก 793 (17.2%) · เรียลไทม์ · 2026-08-30</a:t>
+              <a:t>จาก 793 (16.8%) · เรียลไทม์ · 2026-09-01</a:t>
             </a:r>
           </a:p>
         </p:txBody>
@@ -6405,7 +6405,7 @@
                 </a:solidFill>
                 <a:latin typeface="Kanit"/>
               </a:rPr>
-              <a:t>37</a:t>
+              <a:t>29</a:t>
             </a:r>
           </a:p>
         </p:txBody>
@@ -6444,7 +6444,7 @@
                 </a:solidFill>
                 <a:latin typeface="Kanit"/>
               </a:rPr>
-              <a:t>ค่าล่าสุดรายวัน · 2026-08-30</a:t>
+              <a:t>ค่าล่าสุดรายวัน · 2026-09-01</a:t>
             </a:r>
           </a:p>
         </p:txBody>
@@ -7882,7 +7882,7 @@
                           </a:solidFill>
                           <a:latin typeface="Kanit"/>
                         </a:rPr>
-                        <a:t>สกลนคร</a:t>
+                        <a:t>กาญจนบุรี</a:t>
                       </a:r>
                     </a:p>
                   </a:txBody>
@@ -7905,7 +7905,7 @@
                           </a:solidFill>
                           <a:latin typeface="Kanit"/>
                         </a:rPr>
-                        <a:t>37</a:t>
+                        <a:t>86</a:t>
                       </a:r>
                     </a:p>
                   </a:txBody>
@@ -7928,7 +7928,7 @@
                           </a:solidFill>
                           <a:latin typeface="Kanit"/>
                         </a:rPr>
-                        <a:t>8</a:t>
+                        <a:t>94</a:t>
                       </a:r>
                     </a:p>
                   </a:txBody>
@@ -7947,11 +7947,11 @@
                       <a:r>
                         <a:rPr sz="900" b="1">
                           <a:solidFill>
-                            <a:srgbClr val="606060"/>
-                          </a:solidFill>
-                          <a:latin typeface="Kanit"/>
-                        </a:rPr>
-                        <a:t>0.0%</a:t>
+                            <a:srgbClr val="F5C242"/>
+                          </a:solidFill>
+                          <a:latin typeface="Kanit"/>
+                        </a:rPr>
+                        <a:t>18.6%</a:t>
                       </a:r>
                     </a:p>
                   </a:txBody>
@@ -7974,7 +7974,7 @@
                           </a:solidFill>
                           <a:latin typeface="Kanit"/>
                         </a:rPr>
-                        <a:t>7/13</a:t>
+                        <a:t>6/26</a:t>
                       </a:r>
                     </a:p>
                   </a:txBody>
@@ -8022,7 +8022,7 @@
                           </a:solidFill>
                           <a:latin typeface="Kanit"/>
                         </a:rPr>
-                        <a:t>ยโสธร</a:t>
+                        <a:t>อุทัยธานี</a:t>
                       </a:r>
                     </a:p>
                   </a:txBody>
@@ -8045,7 +8045,7 @@
                           </a:solidFill>
                           <a:latin typeface="Kanit"/>
                         </a:rPr>
-                        <a:t>15</a:t>
+                        <a:t>44</a:t>
                       </a:r>
                     </a:p>
                   </a:txBody>
@@ -8068,7 +8068,7 @@
                           </a:solidFill>
                           <a:latin typeface="Kanit"/>
                         </a:rPr>
-                        <a:t>76</a:t>
+                        <a:t>53</a:t>
                       </a:r>
                     </a:p>
                   </a:txBody>
@@ -8091,7 +8091,7 @@
                           </a:solidFill>
                           <a:latin typeface="Kanit"/>
                         </a:rPr>
-                        <a:t>33.3%</a:t>
+                        <a:t>6.8%</a:t>
                       </a:r>
                     </a:p>
                   </a:txBody>
@@ -8114,7 +8114,7 @@
                           </a:solidFill>
                           <a:latin typeface="Kanit"/>
                         </a:rPr>
-                        <a:t>2/5</a:t>
+                        <a:t>1/4</a:t>
                       </a:r>
                     </a:p>
                   </a:txBody>
@@ -8133,11 +8133,11 @@
                       <a:r>
                         <a:rPr sz="900" b="1">
                           <a:solidFill>
-                            <a:srgbClr val="F5C242"/>
-                          </a:solidFill>
-                          <a:latin typeface="Kanit"/>
-                        </a:rPr>
-                        <a:t>4</a:t>
+                            <a:srgbClr val="CC0000"/>
+                          </a:solidFill>
+                          <a:latin typeface="Kanit"/>
+                        </a:rPr>
+                        <a:t>5</a:t>
                       </a:r>
                     </a:p>
                   </a:txBody>
@@ -8162,7 +8162,7 @@
                           </a:solidFill>
                           <a:latin typeface="Kanit"/>
                         </a:rPr>
-                        <a:t>ปราจีนบุรี</a:t>
+                        <a:t>เลย</a:t>
                       </a:r>
                     </a:p>
                   </a:txBody>
@@ -8185,7 +8185,7 @@
                           </a:solidFill>
                           <a:latin typeface="Kanit"/>
                         </a:rPr>
-                        <a:t>33</a:t>
+                        <a:t>111</a:t>
                       </a:r>
                     </a:p>
                   </a:txBody>
@@ -8208,7 +8208,7 @@
                           </a:solidFill>
                           <a:latin typeface="Kanit"/>
                         </a:rPr>
-                        <a:t>75</a:t>
+                        <a:t>127</a:t>
                       </a:r>
                     </a:p>
                   </a:txBody>
@@ -8231,7 +8231,7 @@
                           </a:solidFill>
                           <a:latin typeface="Kanit"/>
                         </a:rPr>
-                        <a:t>21.2%</a:t>
+                        <a:t>0.9%</a:t>
                       </a:r>
                     </a:p>
                   </a:txBody>
@@ -8254,7 +8254,7 @@
                           </a:solidFill>
                           <a:latin typeface="Kanit"/>
                         </a:rPr>
-                        <a:t>2/15</a:t>
+                        <a:t>1/8</a:t>
                       </a:r>
                     </a:p>
                   </a:txBody>
@@ -8273,11 +8273,11 @@
                       <a:r>
                         <a:rPr sz="900" b="1">
                           <a:solidFill>
-                            <a:srgbClr val="F5C242"/>
-                          </a:solidFill>
-                          <a:latin typeface="Kanit"/>
-                        </a:rPr>
-                        <a:t>4</a:t>
+                            <a:srgbClr val="CC0000"/>
+                          </a:solidFill>
+                          <a:latin typeface="Kanit"/>
+                        </a:rPr>
+                        <a:t>5</a:t>
                       </a:r>
                     </a:p>
                   </a:txBody>
@@ -8302,7 +8302,7 @@
                           </a:solidFill>
                           <a:latin typeface="Kanit"/>
                         </a:rPr>
-                        <a:t>จันทบุรี</a:t>
+                        <a:t>สกลนคร</a:t>
                       </a:r>
                     </a:p>
                   </a:txBody>
@@ -8325,7 +8325,7 @@
                           </a:solidFill>
                           <a:latin typeface="Kanit"/>
                         </a:rPr>
-                        <a:t>53</a:t>
+                        <a:t>38</a:t>
                       </a:r>
                     </a:p>
                   </a:txBody>
@@ -8348,7 +8348,7 @@
                           </a:solidFill>
                           <a:latin typeface="Kanit"/>
                         </a:rPr>
-                        <a:t>58</a:t>
+                        <a:t>14</a:t>
                       </a:r>
                     </a:p>
                   </a:txBody>
@@ -8367,11 +8367,11 @@
                       <a:r>
                         <a:rPr sz="900" b="1">
                           <a:solidFill>
-                            <a:srgbClr val="F5C242"/>
-                          </a:solidFill>
-                          <a:latin typeface="Kanit"/>
-                        </a:rPr>
-                        <a:t>17.0%</a:t>
+                            <a:srgbClr val="606060"/>
+                          </a:solidFill>
+                          <a:latin typeface="Kanit"/>
+                        </a:rPr>
+                        <a:t>0.0%</a:t>
                       </a:r>
                     </a:p>
                   </a:txBody>
@@ -8394,7 +8394,7 @@
                           </a:solidFill>
                           <a:latin typeface="Kanit"/>
                         </a:rPr>
-                        <a:t>5/11</a:t>
+                        <a:t>7/13</a:t>
                       </a:r>
                     </a:p>
                   </a:txBody>
@@ -8413,11 +8413,11 @@
                       <a:r>
                         <a:rPr sz="900" b="1">
                           <a:solidFill>
-                            <a:srgbClr val="F5C242"/>
-                          </a:solidFill>
-                          <a:latin typeface="Kanit"/>
-                        </a:rPr>
-                        <a:t>4</a:t>
+                            <a:srgbClr val="CC0000"/>
+                          </a:solidFill>
+                          <a:latin typeface="Kanit"/>
+                        </a:rPr>
+                        <a:t>5</a:t>
                       </a:r>
                     </a:p>
                   </a:txBody>
@@ -8442,7 +8442,7 @@
                           </a:solidFill>
                           <a:latin typeface="Kanit"/>
                         </a:rPr>
-                        <a:t>ตราด</a:t>
+                        <a:t>สมุทรปราการ</a:t>
                       </a:r>
                     </a:p>
                   </a:txBody>
@@ -8465,7 +8465,7 @@
                           </a:solidFill>
                           <a:latin typeface="Kanit"/>
                         </a:rPr>
-                        <a:t>42</a:t>
+                        <a:t>16</a:t>
                       </a:r>
                     </a:p>
                   </a:txBody>
@@ -8488,7 +8488,7 @@
                           </a:solidFill>
                           <a:latin typeface="Kanit"/>
                         </a:rPr>
-                        <a:t>64</a:t>
+                        <a:t>20</a:t>
                       </a:r>
                     </a:p>
                   </a:txBody>
@@ -8507,11 +8507,11 @@
                       <a:r>
                         <a:rPr sz="900" b="1">
                           <a:solidFill>
-                            <a:srgbClr val="F5C242"/>
-                          </a:solidFill>
-                          <a:latin typeface="Kanit"/>
-                        </a:rPr>
-                        <a:t>16.7%</a:t>
+                            <a:srgbClr val="606060"/>
+                          </a:solidFill>
+                          <a:latin typeface="Kanit"/>
+                        </a:rPr>
+                        <a:t>0.0%</a:t>
                       </a:r>
                     </a:p>
                   </a:txBody>
@@ -8534,7 +8534,7 @@
                           </a:solidFill>
                           <a:latin typeface="Kanit"/>
                         </a:rPr>
-                        <a:t>5/9</a:t>
+                        <a:t>4/5</a:t>
                       </a:r>
                     </a:p>
                   </a:txBody>
@@ -8553,11 +8553,11 @@
                       <a:r>
                         <a:rPr sz="900" b="1">
                           <a:solidFill>
-                            <a:srgbClr val="F5C242"/>
-                          </a:solidFill>
-                          <a:latin typeface="Kanit"/>
-                        </a:rPr>
-                        <a:t>4</a:t>
+                            <a:srgbClr val="CC0000"/>
+                          </a:solidFill>
+                          <a:latin typeface="Kanit"/>
+                        </a:rPr>
+                        <a:t>5</a:t>
                       </a:r>
                     </a:p>
                   </a:txBody>
@@ -8582,7 +8582,7 @@
                           </a:solidFill>
                           <a:latin typeface="Kanit"/>
                         </a:rPr>
-                        <a:t>ชุมพร</a:t>
+                        <a:t>อุบลราชธานี</a:t>
                       </a:r>
                     </a:p>
                   </a:txBody>
@@ -8605,7 +8605,7 @@
                           </a:solidFill>
                           <a:latin typeface="Kanit"/>
                         </a:rPr>
-                        <a:t>91</a:t>
+                        <a:t>46</a:t>
                       </a:r>
                     </a:p>
                   </a:txBody>
@@ -8628,7 +8628,7 @@
                           </a:solidFill>
                           <a:latin typeface="Kanit"/>
                         </a:rPr>
-                        <a:t>52</a:t>
+                        <a:t>65</a:t>
                       </a:r>
                     </a:p>
                   </a:txBody>
@@ -8651,7 +8651,7 @@
                           </a:solidFill>
                           <a:latin typeface="Kanit"/>
                         </a:rPr>
-                        <a:t>13.2%</a:t>
+                        <a:t>23.9%</a:t>
                       </a:r>
                     </a:p>
                   </a:txBody>
@@ -8674,7 +8674,7 @@
                           </a:solidFill>
                           <a:latin typeface="Kanit"/>
                         </a:rPr>
-                        <a:t>3/14</a:t>
+                        <a:t>2/15</a:t>
                       </a:r>
                     </a:p>
                   </a:txBody>
@@ -8909,7 +8909,7 @@
                 </a:solidFill>
                 <a:latin typeface="Kanit"/>
               </a:rPr>
-              <a:t>พื้นที่ปลูก วัดจริง (สศก. — ข้อมูลอำเภอ×พืช 3,295 แถว) ภัยแล้งเป็นดัชนี SPEI จาก แบบจำลอง คำนวณจากปริมาณฝนและการคายระเหย ปรับเดือนละครั้ง ดึงข้อมูล 2026-07-20 — เป็นสัญญาณที่ครอบคลุมทั้งประเทศดีที่สุดที่มี แต่ไม่มีใครลงพื้นที่ไปเดินดูอำเภอเหล่านั้น ข้อมูลฝนและระดับน้ำ วัดจริง (ThaiWater เรียลไทม์ ดึงทุกวันและสะสมไว้ — วันที่ดึงไม่สำเร็จจะเว้นเป็นช่องว่าง ไม่ใส่ค่าสมมติ) · ฝนถึง 2026-08-30, ระดับน้ำถึง 2026-08-30 ความเสี่ยงน้ำท่วมเชิงโครงสร้าง วัดจริง (สำมะโนพื้นที่ท่วมซ้ำซาก GISTDA มาตราส่วน 1:50,000 ปี 2005-2016 — เป็นบันทึกภาคพื้นดิน 12 ปี ไม่ใช่การพยากรณ์)</a:t>
+              <a:t>พื้นที่ปลูก วัดจริง (สศก. — ข้อมูลอำเภอ×พืช 3,295 แถว) ภัยแล้งเป็นดัชนี SPEI จาก แบบจำลอง คำนวณจากปริมาณฝนและการคายระเหย ปรับเดือนละครั้ง ดึงข้อมูล 2026-07-20 — เป็นสัญญาณที่ครอบคลุมทั้งประเทศดีที่สุดที่มี แต่ไม่มีใครลงพื้นที่ไปเดินดูอำเภอเหล่านั้น ข้อมูลฝนและระดับน้ำ วัดจริง (ThaiWater เรียลไทม์ ดึงทุกวันและสะสมไว้ — วันที่ดึงไม่สำเร็จจะเว้นเป็นช่องว่าง ไม่ใส่ค่าสมมติ) · ฝนถึง 2026-09-01, ระดับน้ำถึง 2026-09-01 ความเสี่ยงน้ำท่วมเชิงโครงสร้าง วัดจริง (สำมะโนพื้นที่ท่วมซ้ำซาก GISTDA มาตราส่วน 1:50,000 ปี 2005-2016 — เป็นบันทึกภาคพื้นดิน 12 ปี ไม่ใช่การพยากรณ์)</a:t>
             </a:r>
           </a:p>
         </p:txBody>
@@ -32047,7 +32047,7 @@
                 </a:solidFill>
                 <a:latin typeface="Kanit"/>
               </a:rPr>
-              <a:t>รุ่นข้อมูล — ราคาโลก 2026M06 · ราคาหน้าฟาร์มไทย 2026-08-28 · ประวัติราคาไทย 2026-08-23 · ต้นทุนการผลิตพืช สศก. ไจอัป 2568 (ปีเพาะปลูก 2568/69, ประมาณการ สศก. มี.ค. 2569) · ภัยแล้ง 2026-06-21 · เงินเฟ้อ 2026-05 · GDP 2026 ไตรมาส 1 · IMF WEO 2026 · ดัชนีราคาขายต่อ 2026-05 · ยอดจดทะเบียนถึง 2026-01 · หนี้ครัวเรือน สสช. SES 2566 · ค่าจ้าง สสช. LFS 2568 · ข้อมูลตรวจวัด 2026-08-30</a:t>
+              <a:t>รุ่นข้อมูล — ราคาโลก 2026M06 · ราคาหน้าฟาร์มไทย 2026-08-28 · ประวัติราคาไทย 2026-08-29 · ต้นทุนการผลิตพืช สศก. ไจอัป 2568 (ปีเพาะปลูก 2568/69, ประมาณการ สศก. มี.ค. 2569) · ภัยแล้ง 2026-06-21 · เงินเฟ้อ 2026-05 · GDP 2026 ไตรมาส 1 · IMF WEO 2026 · ดัชนีราคาขายต่อ 2026-05 · ยอดจดทะเบียนถึง 2026-01 · หนี้ครัวเรือน สสช. SES 2566 · ค่าจ้าง สสช. LFS 2568 · ข้อมูลตรวจวัด 2026-09-01</a:t>
             </a:r>
           </a:p>
         </p:txBody>
@@ -33786,7 +33786,7 @@
                 </a:solidFill>
                 <a:latin typeface="Kanit"/>
               </a:rPr>
-              <a:t>ธนาคารแห่งประเทศไทย · 2026-06</a:t>
+              <a:t>ธนาคารแห่งประเทศไทย · 2026-08</a:t>
             </a:r>
           </a:p>
         </p:txBody>
@@ -33912,7 +33912,7 @@
                 </a:solidFill>
                 <a:latin typeface="Kanit"/>
               </a:rPr>
-              <a:t>32.69</a:t>
+              <a:t>33.16</a:t>
             </a:r>
           </a:p>
         </p:txBody>
@@ -33951,7 +33951,7 @@
                 </a:solidFill>
                 <a:latin typeface="Kanit"/>
               </a:rPr>
-              <a:t>อัตราอ้างอิง ECB · 2026-08-24</a:t>
+              <a:t>อัตราอ้างอิง ECB · 2026-08-31</a:t>
             </a:r>
           </a:p>
         </p:txBody>
@@ -35798,7 +35798,7 @@
                 </a:solidFill>
                 <a:latin typeface="Kanit"/>
               </a:rPr>
-              <a:t>สศช. 2026 ไตรมาส 1 · TPSO 2026-05 · ธนาคารแห่งประเทศไทย 2026-06 · BIS 2025 ไตรมาส 4 · ECB 2026-08-24, ทั้งหมดดึงจากหน่วยงานผู้เผยแพร่โดยตรง ตารางเทียบประเทศใช้ IMF World Economic Outlook 2026 (ดึงข้อมูล 2026-07-25) อัตรา NPL ที่ ธปท. เผยแพร่ — 4.48% ณ 2026 ไตรมาส 1, จาก 4.33% ไตรมาสก่อน เปลี่ยน +0.24 จุดใน 1 ปี และต่ำสุด 3.08% ณ 2021 ไตรมาส 1</a:t>
+              <a:t>สศช. 2026 ไตรมาส 1 · TPSO 2026-05 · ธนาคารแห่งประเทศไทย 2026-08 · BIS 2025 ไตรมาส 4 · ECB 2026-08-31, ทั้งหมดดึงจากหน่วยงานผู้เผยแพร่โดยตรง ตารางเทียบประเทศใช้ IMF World Economic Outlook 2026 (ดึงข้อมูล 2026-07-25) อัตรา NPL ที่ ธปท. เผยแพร่ — 4.48% ณ 2026 ไตรมาส 1, จาก 4.33% ไตรมาสก่อน เปลี่ยน +0.24 จุดใน 1 ปี และต่ำสุด 3.08% ณ 2021 ไตรมาส 1</a:t>
             </a:r>
           </a:p>
         </p:txBody>
@@ -37087,7 +37087,7 @@
                 </a:solidFill>
                 <a:latin typeface="Kanit"/>
               </a:rPr>
-              <a:t>338 จาก 928 อำเภอ · แม่น้ำเกินระดับ 136 จาก 793 สถานี</a:t>
+              <a:t>338 จาก 928 อำเภอ · แม่น้ำเกินระดับ 133 จาก 793 สถานี</a:t>
             </a:r>
           </a:p>
         </p:txBody>
@@ -37859,7 +37859,7 @@
                           </a:solidFill>
                           <a:latin typeface="Kanit"/>
                         </a:rPr>
-                        <a:t>25/156</a:t>
+                        <a:t>27/156</a:t>
                       </a:r>
                     </a:p>
                   </a:txBody>
@@ -38091,7 +38091,7 @@
                           </a:solidFill>
                           <a:latin typeface="Kanit"/>
                         </a:rPr>
-                        <a:t>19/273</a:t>
+                        <a:t>17/274</a:t>
                       </a:r>
                     </a:p>
                   </a:txBody>
@@ -38323,7 +38323,7 @@
                           </a:solidFill>
                           <a:latin typeface="Kanit"/>
                         </a:rPr>
-                        <a:t>31/167</a:t>
+                        <a:t>25/167</a:t>
                       </a:r>
                     </a:p>
                   </a:txBody>
@@ -38555,7 +38555,7 @@
                           </a:solidFill>
                           <a:latin typeface="Kanit"/>
                         </a:rPr>
-                        <a:t>15/52</a:t>
+                        <a:t>15/51</a:t>
                       </a:r>
                     </a:p>
                   </a:txBody>
@@ -38787,7 +38787,7 @@
                           </a:solidFill>
                           <a:latin typeface="Kanit"/>
                         </a:rPr>
-                        <a:t>46/145</a:t>
+                        <a:t>49/145</a:t>
                       </a:r>
                     </a:p>
                   </a:txBody>
@@ -39959,7 +39959,7 @@
                           </a:solidFill>
                           <a:latin typeface="Kanit"/>
                         </a:rPr>
-                        <a:t>−50.1%</a:t>
+                        <a:t>−50.7%</a:t>
                       </a:r>
                     </a:p>
                   </a:txBody>
@@ -40791,7 +40791,7 @@
                 </a:solidFill>
                 <a:latin typeface="Kanit"/>
               </a:rPr>
-              <a:t>ราคา วัดจริง — ราคาหน้าฟาร์มไทยจากราคารายวันของ NABC และราคาอ้อยประกาศของ สอน. ราคาล่าสุด 2026-08-28 การเปลี่ยนแปลงหกเดือนคำนวณจากข้อมูลรายเดือนของ NABC เอง (thai_price_history รุ่นข้อมูล 2026-08-23) พืชที่ไม่มีข้อมูลรายเดือนจะกำกับไว้ ไม่ประมาณการขึ้นมา แหล่งผลิตเป็นการอ่านแบบ ประมาณการ ว่าสินค้าแต่ละชนิดปลูกที่ไหน และแหล่งผลิตทับซ้อนกันได้ บัญชีอาชีพเกษตรเป็นข้อมูลของเราเองและ วัดจริง — บัญชีที่บันทึกอาชีพว่า เกษตร ในจังหวัดแหล่งผลิต จากฐานข้อมูล 382,735 บัญชี ณ 2026-07 ไม่เผยแพร่ช่องที่มีน้อยกว่า 30 บัญชี คนกลุ่มนี้อาศัยอยู่ในพื้นที่ที่ปลูกพืชนั้น แต่ไม่ได้ยืนยันว่าปลูกพืชนั้นเอง</a:t>
+              <a:t>ราคา วัดจริง — ราคาหน้าฟาร์มไทยจากราคารายวันของ NABC และราคาอ้อยประกาศของ สอน. ราคาล่าสุด 2026-08-28 การเปลี่ยนแปลงหกเดือนคำนวณจากข้อมูลรายเดือนของ NABC เอง (thai_price_history รุ่นข้อมูล 2026-08-29) พืชที่ไม่มีข้อมูลรายเดือนจะกำกับไว้ ไม่ประมาณการขึ้นมา แหล่งผลิตเป็นการอ่านแบบ ประมาณการ ว่าสินค้าแต่ละชนิดปลูกที่ไหน และแหล่งผลิตทับซ้อนกันได้ บัญชีอาชีพเกษตรเป็นข้อมูลของเราเองและ วัดจริง — บัญชีที่บันทึกอาชีพว่า เกษตร ในจังหวัดแหล่งผลิต จากฐานข้อมูล 382,735 บัญชี ณ 2026-07 ไม่เผยแพร่ช่องที่มีน้อยกว่า 30 บัญชี คนกลุ่มนี้อาศัยอยู่ในพื้นที่ที่ปลูกพืชนั้น แต่ไม่ได้ยืนยันว่าปลูกพืชนั้นเอง</a:t>
             </a:r>
           </a:p>
         </p:txBody>
@@ -43419,7 +43419,7 @@
                           </a:solidFill>
                           <a:latin typeface="Kanit"/>
                         </a:rPr>
-                        <a:t>90.86</a:t>
+                        <a:t>92.20</a:t>
                       </a:r>
                     </a:p>
                   </a:txBody>
@@ -43559,7 +43559,7 @@
                           </a:solidFill>
                           <a:latin typeface="Kanit"/>
                         </a:rPr>
-                        <a:t>15,264</a:t>
+                        <a:t>15,488</a:t>
                       </a:r>
                     </a:p>
                   </a:txBody>
@@ -43699,7 +43699,7 @@
                           </a:solidFill>
                           <a:latin typeface="Kanit"/>
                         </a:rPr>
-                        <a:t>35,986</a:t>
+                        <a:t>36,515</a:t>
                       </a:r>
                     </a:p>
                   </a:txBody>
@@ -43839,7 +43839,7 @@
                           </a:solidFill>
                           <a:latin typeface="Kanit"/>
                         </a:rPr>
-                        <a:t>11.11</a:t>
+                        <a:t>11.28</a:t>
                       </a:r>
                     </a:p>
                   </a:txBody>
@@ -44058,7 +44058,7 @@
                 </a:solidFill>
                 <a:latin typeface="Kanit"/>
               </a:rPr>
-              <a:t>ราคารายเดือนสกุลดอลลาร์ราคาปัจจุบันจาก World Bank Pink Sheet รุ่นข้อมูล 2026M07 (ข้อมูล 60 จุดต่อรายการ ปรับฐานเป็น 100 ณ 2021-07 เพื่อวาดกราฟ — หน่วยต่างกัน จึงใช้แกนเดียวกับระดับราคาดิบไม่ได้) แปลงเป็นบาทด้วยอัตราอ้างอิง ECB USD/THB 32.685 ณ 2026-08-24 สัดส่วนพื้นที่ปลูก วัดจริง จากสัดส่วนพืชของ สศก./กรมส่งเสริมการเกษตร (crop_mix.json) เป็นราคาปัจจุบัน ไม่ได้ปรับเงินเฟ้อ: ทุกตัวเลข ‘เทียบ 5 ปีก่อน’ มีเงินเฟ้อไทยห้าปีซ่อนอยู่ข้างใต้</a:t>
+              <a:t>ราคารายเดือนสกุลดอลลาร์ราคาปัจจุบันจาก World Bank Pink Sheet รุ่นข้อมูล 2026M07 (ข้อมูล 60 จุดต่อรายการ ปรับฐานเป็น 100 ณ 2021-07 เพื่อวาดกราฟ — หน่วยต่างกัน จึงใช้แกนเดียวกับระดับราคาดิบไม่ได้) แปลงเป็นบาทด้วยอัตราอ้างอิง ECB USD/THB 33.165 ณ 2026-08-31 สัดส่วนพื้นที่ปลูก วัดจริง จากสัดส่วนพืชของ สศก./กรมส่งเสริมการเกษตร (crop_mix.json) เป็นราคาปัจจุบัน ไม่ได้ปรับเงินเฟ้อ: ทุกตัวเลข ‘เทียบ 5 ปีก่อน’ มีเงินเฟ้อไทยห้าปีซ่อนอยู่ข้างใต้</a:t>
             </a:r>
           </a:p>
         </p:txBody>
@@ -47985,7 +47985,7 @@
                 </a:solidFill>
                 <a:latin typeface="Kanit"/>
               </a:rPr>
-              <a:t>฿606.15 /ร้อยผล · ใต้·ตอ.</a:t>
+              <a:t>฿596.84 /ร้อยผล · ใต้·ตอ.</a:t>
             </a:r>
           </a:p>
         </p:txBody>
@@ -48063,7 +48063,7 @@
                 </a:solidFill>
                 <a:latin typeface="Kanit"/>
               </a:rPr>
-              <a:t>6 เดือน −50.1%</a:t>
+              <a:t>6 เดือน −50.7%</a:t>
             </a:r>
           </a:p>
         </p:txBody>
@@ -48137,19 +48137,19 @@
                   <a:pt x="0" y="0"/>
                 </a:moveTo>
                 <a:lnTo>
-                  <a:pt x="412943" y="167653"/>
-                </a:lnTo>
-                <a:lnTo>
-                  <a:pt x="825886" y="145107"/>
-                </a:lnTo>
-                <a:lnTo>
-                  <a:pt x="1238829" y="402654"/>
+                  <a:pt x="412943" y="170673"/>
+                </a:lnTo>
+                <a:lnTo>
+                  <a:pt x="825886" y="145193"/>
+                </a:lnTo>
+                <a:lnTo>
+                  <a:pt x="1238829" y="399195"/>
                 </a:lnTo>
                 <a:lnTo>
                   <a:pt x="1651772" y="457200"/>
                 </a:lnTo>
                 <a:lnTo>
-                  <a:pt x="2064715" y="401204"/>
+                  <a:pt x="2064715" y="409348"/>
                 </a:lnTo>
               </a:path>
             </a:pathLst>
@@ -48192,7 +48192,7 @@
         </p:nvSpPr>
         <p:spPr>
           <a:xfrm>
-            <a:off x="2480767" y="2806076"/>
+            <a:off x="2480767" y="2814220"/>
             <a:ext cx="82296" cy="82296"/>
           </a:xfrm>
           <a:prstGeom prst="roundRect">
@@ -48621,7 +48621,7 @@
                 </a:solidFill>
                 <a:latin typeface="Kanit"/>
               </a:rPr>
-              <a:t>฿143.00 /กก. · ชายฝั่งใต้·ตอ.</a:t>
+              <a:t>฿143.14 /กก. · ชายฝั่งใต้·ตอ.</a:t>
             </a:r>
           </a:p>
         </p:txBody>
@@ -48699,7 +48699,7 @@
                 </a:solidFill>
                 <a:latin typeface="Kanit"/>
               </a:rPr>
-              <a:t>6 เดือน −2.1%</a:t>
+              <a:t>6 เดือน −2.0%</a:t>
             </a:r>
           </a:p>
         </p:txBody>
@@ -48770,19 +48770,19 @@
             <a:pathLst>
               <a:path w="2064715" h="457200">
                 <a:moveTo>
-                  <a:pt x="0" y="217911"/>
+                  <a:pt x="0" y="216948"/>
                 </a:moveTo>
                 <a:lnTo>
-                  <a:pt x="412943" y="415692"/>
+                  <a:pt x="412943" y="415955"/>
                 </a:lnTo>
                 <a:lnTo>
                   <a:pt x="825886" y="457200"/>
                 </a:lnTo>
                 <a:lnTo>
-                  <a:pt x="1238829" y="420051"/>
-                </a:lnTo>
-                <a:lnTo>
-                  <a:pt x="1651772" y="168518"/>
+                  <a:pt x="1238829" y="420285"/>
+                </a:lnTo>
+                <a:lnTo>
+                  <a:pt x="1651772" y="170341"/>
                 </a:lnTo>
                 <a:lnTo>
                   <a:pt x="2064715" y="0"/>
@@ -48939,7 +48939,7 @@
                 </a:solidFill>
                 <a:latin typeface="Kanit"/>
               </a:rPr>
-              <a:t>฿43.00 /กก. · กลาง·ตอ.</a:t>
+              <a:t>฿43.05 /กก. · กลาง·ตอ.</a:t>
             </a:r>
           </a:p>
         </p:txBody>
@@ -49017,7 +49017,7 @@
                 </a:solidFill>
                 <a:latin typeface="Kanit"/>
               </a:rPr>
-              <a:t>6 เดือน +2.3%</a:t>
+              <a:t>6 เดือน +2.4%</a:t>
             </a:r>
           </a:p>
         </p:txBody>
@@ -49091,19 +49091,19 @@
                   <a:pt x="0" y="0"/>
                 </a:moveTo>
                 <a:lnTo>
-                  <a:pt x="412943" y="111737"/>
-                </a:lnTo>
-                <a:lnTo>
-                  <a:pt x="825886" y="304458"/>
+                  <a:pt x="412943" y="119484"/>
+                </a:lnTo>
+                <a:lnTo>
+                  <a:pt x="825886" y="305129"/>
                 </a:lnTo>
                 <a:lnTo>
                   <a:pt x="1238829" y="457200"/>
                 </a:lnTo>
                 <a:lnTo>
-                  <a:pt x="1651772" y="242951"/>
-                </a:lnTo>
-                <a:lnTo>
-                  <a:pt x="2064715" y="88159"/>
+                  <a:pt x="1651772" y="245880"/>
+                </a:lnTo>
+                <a:lnTo>
+                  <a:pt x="2064715" y="91834"/>
                 </a:lnTo>
               </a:path>
             </a:pathLst>
@@ -49146,7 +49146,7 @@
         </p:nvSpPr>
         <p:spPr>
           <a:xfrm>
-            <a:off x="9388144" y="2493031"/>
+            <a:off x="9388144" y="2496706"/>
             <a:ext cx="82296" cy="82296"/>
           </a:xfrm>
           <a:prstGeom prst="roundRect">
@@ -49257,7 +49257,7 @@
                 </a:solidFill>
                 <a:latin typeface="Kanit"/>
               </a:rPr>
-              <a:t>฿346.15 /ร้อยฟอง · กลาง·ตอ.</a:t>
+              <a:t>฿350.53 /ร้อยฟอง · กลาง·ตอ.</a:t>
             </a:r>
           </a:p>
         </p:txBody>
@@ -49335,7 +49335,7 @@
                 </a:solidFill>
                 <a:latin typeface="Kanit"/>
               </a:rPr>
-              <a:t>6 เดือน +14.4%</a:t>
+              <a:t>6 เดือน +15.9%</a:t>
             </a:r>
           </a:p>
         </p:txBody>
@@ -49409,16 +49409,16 @@
                   <a:pt x="0" y="457200"/>
                 </a:moveTo>
                 <a:lnTo>
-                  <a:pt x="412943" y="191637"/>
-                </a:lnTo>
-                <a:lnTo>
-                  <a:pt x="825886" y="191637"/>
-                </a:lnTo>
-                <a:lnTo>
-                  <a:pt x="1238829" y="292498"/>
-                </a:lnTo>
-                <a:lnTo>
-                  <a:pt x="1651772" y="90775"/>
+                  <a:pt x="412943" y="218744"/>
+                </a:lnTo>
+                <a:lnTo>
+                  <a:pt x="825886" y="218744"/>
+                </a:lnTo>
+                <a:lnTo>
+                  <a:pt x="1238829" y="309310"/>
+                </a:lnTo>
+                <a:lnTo>
+                  <a:pt x="1651772" y="128177"/>
                 </a:lnTo>
                 <a:lnTo>
                   <a:pt x="2064715" y="0"/>
@@ -49575,7 +49575,7 @@
                 </a:solidFill>
                 <a:latin typeface="Kanit"/>
               </a:rPr>
-              <a:t>฿70.33 /กก. · กลาง·ตต.·ตอ.</a:t>
+              <a:t>฿71.18 /กก. · กลาง·ตต.·ตอ.</a:t>
             </a:r>
           </a:p>
         </p:txBody>
@@ -49653,7 +49653,7 @@
                 </a:solidFill>
                 <a:latin typeface="Kanit"/>
               </a:rPr>
-              <a:t>6 เดือน +26.7%</a:t>
+              <a:t>6 เดือน +28.2%</a:t>
             </a:r>
           </a:p>
         </p:txBody>
@@ -49724,19 +49724,19 @@
             <a:pathLst>
               <a:path w="2064715" h="457200">
                 <a:moveTo>
-                  <a:pt x="0" y="361078"/>
+                  <a:pt x="0" y="371819"/>
                 </a:moveTo>
                 <a:lnTo>
-                  <a:pt x="412943" y="110564"/>
+                  <a:pt x="412943" y="140924"/>
                 </a:lnTo>
                 <a:lnTo>
                   <a:pt x="825886" y="457200"/>
                 </a:lnTo>
                 <a:lnTo>
-                  <a:pt x="1238829" y="293843"/>
-                </a:lnTo>
-                <a:lnTo>
-                  <a:pt x="1651772" y="177301"/>
+                  <a:pt x="1238829" y="309849"/>
+                </a:lnTo>
+                <a:lnTo>
+                  <a:pt x="1651772" y="196008"/>
                 </a:lnTo>
                 <a:lnTo>
                   <a:pt x="2064715" y="0"/>
@@ -49893,7 +49893,7 @@
                 </a:solidFill>
                 <a:latin typeface="Kanit"/>
               </a:rPr>
-              <a:t>฿17,815 /ตัน · อีสาน·เหนือ·กลาง</a:t>
+              <a:t>฿17,763 /ตัน · อีสาน·เหนือ·กลาง</a:t>
             </a:r>
           </a:p>
         </p:txBody>
@@ -49971,7 +49971,7 @@
                 </a:solidFill>
                 <a:latin typeface="Kanit"/>
               </a:rPr>
-              <a:t>6 เดือน +8.2%</a:t>
+              <a:t>6 เดือน +7.7%</a:t>
             </a:r>
           </a:p>
         </p:txBody>
@@ -50045,16 +50045,16 @@
                   <a:pt x="0" y="457200"/>
                 </a:moveTo>
                 <a:lnTo>
-                  <a:pt x="412943" y="349810"/>
-                </a:lnTo>
-                <a:lnTo>
-                  <a:pt x="825886" y="168554"/>
-                </a:lnTo>
-                <a:lnTo>
-                  <a:pt x="1238829" y="54643"/>
-                </a:lnTo>
-                <a:lnTo>
-                  <a:pt x="1651772" y="63603"/>
+                  <a:pt x="412943" y="341371"/>
+                </a:lnTo>
+                <a:lnTo>
+                  <a:pt x="825886" y="153981"/>
+                </a:lnTo>
+                <a:lnTo>
+                  <a:pt x="1238829" y="34219"/>
+                </a:lnTo>
+                <a:lnTo>
+                  <a:pt x="1651772" y="23720"/>
                 </a:lnTo>
                 <a:lnTo>
                   <a:pt x="2064715" y="0"/>
@@ -50211,7 +50211,7 @@
                 </a:solidFill>
                 <a:latin typeface="Kanit"/>
               </a:rPr>
-              <a:t>฿9.87 /กก. · เหนือ</a:t>
+              <a:t>฿9.76 /กก. · เหนือ</a:t>
             </a:r>
           </a:p>
         </p:txBody>
@@ -50289,7 +50289,7 @@
                 </a:solidFill>
                 <a:latin typeface="Kanit"/>
               </a:rPr>
-              <a:t>6 เดือน +10.9%</a:t>
+              <a:t>6 เดือน +9.7%</a:t>
             </a:r>
           </a:p>
         </p:txBody>
@@ -50363,19 +50363,19 @@
                   <a:pt x="0" y="457200"/>
                 </a:moveTo>
                 <a:lnTo>
-                  <a:pt x="412943" y="355874"/>
-                </a:lnTo>
-                <a:lnTo>
-                  <a:pt x="825886" y="86497"/>
+                  <a:pt x="412943" y="350931"/>
+                </a:lnTo>
+                <a:lnTo>
+                  <a:pt x="825886" y="79083"/>
                 </a:lnTo>
                 <a:lnTo>
                   <a:pt x="1238829" y="0"/>
                 </a:lnTo>
                 <a:lnTo>
-                  <a:pt x="1651772" y="46955"/>
-                </a:lnTo>
-                <a:lnTo>
-                  <a:pt x="2064715" y="269377"/>
+                  <a:pt x="1651772" y="54369"/>
+                </a:lnTo>
+                <a:lnTo>
+                  <a:pt x="2064715" y="294090"/>
                 </a:lnTo>
               </a:path>
             </a:pathLst>
@@ -50418,7 +50418,7 @@
         </p:nvSpPr>
         <p:spPr>
           <a:xfrm>
-            <a:off x="7085685" y="3780673"/>
+            <a:off x="7085685" y="3805386"/>
             <a:ext cx="82296" cy="82296"/>
           </a:xfrm>
           <a:prstGeom prst="roundRect">
@@ -50529,7 +50529,7 @@
                 </a:solidFill>
                 <a:latin typeface="Kanit"/>
               </a:rPr>
-              <a:t>฿8.55 /กก. · ใต้</a:t>
+              <a:t>฿8.51 /กก. · ใต้</a:t>
             </a:r>
           </a:p>
         </p:txBody>
@@ -50607,7 +50607,7 @@
                 </a:solidFill>
                 <a:latin typeface="Kanit"/>
               </a:rPr>
-              <a:t>6 เดือน +25.0%</a:t>
+              <a:t>6 เดือน +24.6%</a:t>
             </a:r>
           </a:p>
         </p:txBody>
@@ -50678,19 +50678,19 @@
             <a:pathLst>
               <a:path w="2064715" h="457200">
                 <a:moveTo>
-                  <a:pt x="0" y="453788"/>
+                  <a:pt x="0" y="453709"/>
                 </a:moveTo>
                 <a:lnTo>
-                  <a:pt x="412943" y="446964"/>
+                  <a:pt x="412943" y="439749"/>
                 </a:lnTo>
                 <a:lnTo>
                   <a:pt x="825886" y="457200"/>
                 </a:lnTo>
                 <a:lnTo>
-                  <a:pt x="1238829" y="300250"/>
-                </a:lnTo>
-                <a:lnTo>
-                  <a:pt x="1651772" y="85298"/>
+                  <a:pt x="1238829" y="293166"/>
+                </a:lnTo>
+                <a:lnTo>
+                  <a:pt x="1651772" y="76781"/>
                 </a:lnTo>
                 <a:lnTo>
                   <a:pt x="2064715" y="0"/>
@@ -50847,7 +50847,7 @@
                 </a:solidFill>
                 <a:latin typeface="Kanit"/>
               </a:rPr>
-              <a:t>฿81.51 /กก. · ใต้·ตอ.</a:t>
+              <a:t>฿81.23 /กก. · ใต้·ตอ.</a:t>
             </a:r>
           </a:p>
         </p:txBody>
@@ -50925,7 +50925,7 @@
                 </a:solidFill>
                 <a:latin typeface="Kanit"/>
               </a:rPr>
-              <a:t>6 เดือน +35.1%</a:t>
+              <a:t>6 เดือน +34.6%</a:t>
             </a:r>
           </a:p>
         </p:txBody>
@@ -50999,19 +50999,19 @@
                   <a:pt x="0" y="457200"/>
                 </a:moveTo>
                 <a:lnTo>
-                  <a:pt x="412943" y="287287"/>
-                </a:lnTo>
-                <a:lnTo>
-                  <a:pt x="825886" y="158892"/>
+                  <a:pt x="412943" y="282748"/>
+                </a:lnTo>
+                <a:lnTo>
+                  <a:pt x="825886" y="158359"/>
                 </a:lnTo>
                 <a:lnTo>
                   <a:pt x="1238829" y="0"/>
                 </a:lnTo>
                 <a:lnTo>
-                  <a:pt x="1651772" y="38185"/>
-                </a:lnTo>
-                <a:lnTo>
-                  <a:pt x="2064715" y="115325"/>
+                  <a:pt x="1651772" y="39334"/>
+                </a:lnTo>
+                <a:lnTo>
+                  <a:pt x="2064715" y="122090"/>
                 </a:lnTo>
               </a:path>
             </a:pathLst>
@@ -51054,7 +51054,7 @@
         </p:nvSpPr>
         <p:spPr>
           <a:xfrm>
-            <a:off x="11690603" y="3626621"/>
+            <a:off x="11690603" y="3633386"/>
             <a:ext cx="82296" cy="82296"/>
           </a:xfrm>
           <a:prstGeom prst="roundRect">
@@ -51165,7 +51165,7 @@
                 </a:solidFill>
                 <a:latin typeface="Kanit"/>
               </a:rPr>
-              <a:t>฿3.75 /กก. · อีสาน·เหนือ·ตอ.</a:t>
+              <a:t>฿3.81 /กก. · อีสาน·เหนือ·ตอ.</a:t>
             </a:r>
           </a:p>
         </p:txBody>
@@ -51243,7 +51243,7 @@
                 </a:solidFill>
                 <a:latin typeface="Kanit"/>
               </a:rPr>
-              <a:t>6 เดือน +48.8%</a:t>
+              <a:t>6 เดือน +51.8%</a:t>
             </a:r>
           </a:p>
         </p:txBody>
@@ -51317,16 +51317,16 @@
                   <a:pt x="0" y="457200"/>
                 </a:moveTo>
                 <a:lnTo>
-                  <a:pt x="412943" y="352338"/>
-                </a:lnTo>
-                <a:lnTo>
-                  <a:pt x="825886" y="268448"/>
-                </a:lnTo>
-                <a:lnTo>
-                  <a:pt x="1238829" y="163586"/>
-                </a:lnTo>
-                <a:lnTo>
-                  <a:pt x="1651772" y="125835"/>
+                  <a:pt x="412943" y="357809"/>
+                </a:lnTo>
+                <a:lnTo>
+                  <a:pt x="825886" y="278296"/>
+                </a:lnTo>
+                <a:lnTo>
+                  <a:pt x="1238829" y="178905"/>
+                </a:lnTo>
+                <a:lnTo>
+                  <a:pt x="1651772" y="143124"/>
                 </a:lnTo>
                 <a:lnTo>
                   <a:pt x="2064715" y="0"/>
@@ -51483,7 +51483,7 @@
                 </a:solidFill>
                 <a:latin typeface="Kanit"/>
               </a:rPr>
-              <a:t>฿129.23 /ร้อยผล · กลาง·ตต.</a:t>
+              <a:t>฿146.32 /ร้อยผล · กลาง·ตต.</a:t>
             </a:r>
           </a:p>
         </p:txBody>
@@ -51561,7 +51561,7 @@
                 </a:solidFill>
                 <a:latin typeface="Kanit"/>
               </a:rPr>
-              <a:t>6 เดือน −38.5%</a:t>
+              <a:t>6 เดือน −30.3%</a:t>
             </a:r>
           </a:p>
         </p:txBody>
@@ -51647,7 +51647,7 @@
                   <a:pt x="1651772" y="457200"/>
                 </a:lnTo>
                 <a:lnTo>
-                  <a:pt x="2064715" y="428011"/>
+                  <a:pt x="2064715" y="416732"/>
                 </a:lnTo>
               </a:path>
             </a:pathLst>
@@ -51690,7 +51690,7 @@
         </p:nvSpPr>
         <p:spPr>
           <a:xfrm>
-            <a:off x="4783226" y="5045730"/>
+            <a:off x="4783226" y="5034451"/>
             <a:ext cx="82296" cy="82296"/>
           </a:xfrm>
           <a:prstGeom prst="roundRect">
@@ -51886,7 +51886,7 @@
                 </a:solidFill>
                 <a:latin typeface="Kanit"/>
               </a:rPr>
-              <a:t>ราคาหน้าฟาร์ม วัดจริง — ราคารายวันของ NABC เฉลี่ยเป็นรายเดือน หน่วยเป็นบาทตามที่เผยแพร่ (ไม่มีการแปลงสกุลเงิน) ราคาล่าสุด 2026-08-28, รุ่นข้อมูลย้อนหลัง 2026-08-23 ราคาหน้าฟาร์ม (ราคาที่เกษตรกรขายได้) คือเงินที่เกษตรกรได้รับเมื่อขายครั้งแรก ก่อนพ่อค้าคนกลาง โรงสี หรือค่าขนส่งจะหักส่วนแบ่ง — ไม่ใช่ดัชนีโลก และไม่ใช่ราคาในซูเปอร์มาร์เก็ต แหล่งผลิตเป็นการอ่านแบบ ประมาณการ ว่าสินค้าแต่ละชนิดผลิตที่ไหน และทับซ้อนกันได้ น้ำตาลเป็นราคาอ้อยประกาศของ สอน. ปีละหนึ่งจุด จึงไม่มีการเปลี่ยนแปลงหกเดือนให้แสดง</a:t>
+              <a:t>ราคาหน้าฟาร์ม วัดจริง — ราคารายวันของ NABC เฉลี่ยเป็นรายเดือน หน่วยเป็นบาทตามที่เผยแพร่ (ไม่มีการแปลงสกุลเงิน) ราคาล่าสุด 2026-08-28, รุ่นข้อมูลย้อนหลัง 2026-08-29 ราคาหน้าฟาร์ม (ราคาที่เกษตรกรขายได้) คือเงินที่เกษตรกรได้รับเมื่อขายครั้งแรก ก่อนพ่อค้าคนกลาง โรงสี หรือค่าขนส่งจะหักส่วนแบ่ง — ไม่ใช่ดัชนีโลก และไม่ใช่ราคาในซูเปอร์มาร์เก็ต แหล่งผลิตเป็นการอ่านแบบ ประมาณการ ว่าสินค้าแต่ละชนิดผลิตที่ไหน และทับซ้อนกันได้ น้ำตาลเป็นราคาอ้อยประกาศของ สอน. ปีละหนึ่งจุด จึงไม่มีการเปลี่ยนแปลงหกเดือนให้แสดง</a:t>
             </a:r>
           </a:p>
         </p:txBody>

</xml_diff>

<commit_message>
deck(mcom): rebuild — the data moved past the committed figures (run 33575611939)
</commit_message>
<xml_diff>
--- a/docs/decks/mcom-2026-08-05-macro-TH.pptx
+++ b/docs/decks/mcom-2026-08-05-macro-TH.pptx
@@ -6240,7 +6240,7 @@
                 </a:solidFill>
                 <a:latin typeface="Kanit"/>
               </a:rPr>
-              <a:t>133</a:t>
+              <a:t>131</a:t>
             </a:r>
           </a:p>
         </p:txBody>
@@ -6279,7 +6279,7 @@
                 </a:solidFill>
                 <a:latin typeface="Kanit"/>
               </a:rPr>
-              <a:t>จาก 793 (16.8%) · เรียลไทม์ · 2026-09-01</a:t>
+              <a:t>จาก 792 (16.5%) · เรียลไทม์ · 2026-09-02</a:t>
             </a:r>
           </a:p>
         </p:txBody>
@@ -6405,7 +6405,7 @@
                 </a:solidFill>
                 <a:latin typeface="Kanit"/>
               </a:rPr>
-              <a:t>29</a:t>
+              <a:t>18</a:t>
             </a:r>
           </a:p>
         </p:txBody>
@@ -6444,7 +6444,7 @@
                 </a:solidFill>
                 <a:latin typeface="Kanit"/>
               </a:rPr>
-              <a:t>ค่าล่าสุดรายวัน · 2026-09-01</a:t>
+              <a:t>ค่าล่าสุดรายวัน · 2026-09-02</a:t>
             </a:r>
           </a:p>
         </p:txBody>
@@ -7882,7 +7882,7 @@
                           </a:solidFill>
                           <a:latin typeface="Kanit"/>
                         </a:rPr>
-                        <a:t>กาญจนบุรี</a:t>
+                        <a:t>สกลนคร</a:t>
                       </a:r>
                     </a:p>
                   </a:txBody>
@@ -7905,7 +7905,7 @@
                           </a:solidFill>
                           <a:latin typeface="Kanit"/>
                         </a:rPr>
-                        <a:t>86</a:t>
+                        <a:t>38</a:t>
                       </a:r>
                     </a:p>
                   </a:txBody>
@@ -7928,7 +7928,7 @@
                           </a:solidFill>
                           <a:latin typeface="Kanit"/>
                         </a:rPr>
-                        <a:t>94</a:t>
+                        <a:t>40</a:t>
                       </a:r>
                     </a:p>
                   </a:txBody>
@@ -7951,7 +7951,7 @@
                           </a:solidFill>
                           <a:latin typeface="Kanit"/>
                         </a:rPr>
-                        <a:t>18.6%</a:t>
+                        <a:t>2.6%</a:t>
                       </a:r>
                     </a:p>
                   </a:txBody>
@@ -7974,7 +7974,7 @@
                           </a:solidFill>
                           <a:latin typeface="Kanit"/>
                         </a:rPr>
-                        <a:t>6/26</a:t>
+                        <a:t>7/12</a:t>
                       </a:r>
                     </a:p>
                   </a:txBody>
@@ -8045,7 +8045,7 @@
                           </a:solidFill>
                           <a:latin typeface="Kanit"/>
                         </a:rPr>
-                        <a:t>44</a:t>
+                        <a:t>42</a:t>
                       </a:r>
                     </a:p>
                   </a:txBody>
@@ -8068,7 +8068,7 @@
                           </a:solidFill>
                           <a:latin typeface="Kanit"/>
                         </a:rPr>
-                        <a:t>53</a:t>
+                        <a:t>5</a:t>
                       </a:r>
                     </a:p>
                   </a:txBody>
@@ -8087,11 +8087,11 @@
                       <a:r>
                         <a:rPr sz="900" b="1">
                           <a:solidFill>
-                            <a:srgbClr val="F5C242"/>
-                          </a:solidFill>
-                          <a:latin typeface="Kanit"/>
-                        </a:rPr>
-                        <a:t>6.8%</a:t>
+                            <a:srgbClr val="606060"/>
+                          </a:solidFill>
+                          <a:latin typeface="Kanit"/>
+                        </a:rPr>
+                        <a:t>0.0%</a:t>
                       </a:r>
                     </a:p>
                   </a:txBody>
@@ -8185,7 +8185,7 @@
                           </a:solidFill>
                           <a:latin typeface="Kanit"/>
                         </a:rPr>
-                        <a:t>111</a:t>
+                        <a:t>110</a:t>
                       </a:r>
                     </a:p>
                   </a:txBody>
@@ -8208,7 +8208,7 @@
                           </a:solidFill>
                           <a:latin typeface="Kanit"/>
                         </a:rPr>
-                        <a:t>127</a:t>
+                        <a:t>5</a:t>
                       </a:r>
                     </a:p>
                   </a:txBody>
@@ -8227,11 +8227,11 @@
                       <a:r>
                         <a:rPr sz="900" b="1">
                           <a:solidFill>
-                            <a:srgbClr val="F5C242"/>
-                          </a:solidFill>
-                          <a:latin typeface="Kanit"/>
-                        </a:rPr>
-                        <a:t>0.9%</a:t>
+                            <a:srgbClr val="606060"/>
+                          </a:solidFill>
+                          <a:latin typeface="Kanit"/>
+                        </a:rPr>
+                        <a:t>0.0%</a:t>
                       </a:r>
                     </a:p>
                   </a:txBody>
@@ -8302,7 +8302,7 @@
                           </a:solidFill>
                           <a:latin typeface="Kanit"/>
                         </a:rPr>
-                        <a:t>สกลนคร</a:t>
+                        <a:t>บึงกาฬ</a:t>
                       </a:r>
                     </a:p>
                   </a:txBody>
@@ -8325,7 +8325,7 @@
                           </a:solidFill>
                           <a:latin typeface="Kanit"/>
                         </a:rPr>
-                        <a:t>38</a:t>
+                        <a:t>11</a:t>
                       </a:r>
                     </a:p>
                   </a:txBody>
@@ -8348,7 +8348,7 @@
                           </a:solidFill>
                           <a:latin typeface="Kanit"/>
                         </a:rPr>
-                        <a:t>14</a:t>
+                        <a:t>55</a:t>
                       </a:r>
                     </a:p>
                   </a:txBody>
@@ -8367,11 +8367,11 @@
                       <a:r>
                         <a:rPr sz="900" b="1">
                           <a:solidFill>
-                            <a:srgbClr val="606060"/>
-                          </a:solidFill>
-                          <a:latin typeface="Kanit"/>
-                        </a:rPr>
-                        <a:t>0.0%</a:t>
+                            <a:srgbClr val="F5C242"/>
+                          </a:solidFill>
+                          <a:latin typeface="Kanit"/>
+                        </a:rPr>
+                        <a:t>36.4%</a:t>
                       </a:r>
                     </a:p>
                   </a:txBody>
@@ -8394,7 +8394,7 @@
                           </a:solidFill>
                           <a:latin typeface="Kanit"/>
                         </a:rPr>
-                        <a:t>7/13</a:t>
+                        <a:t>1/1</a:t>
                       </a:r>
                     </a:p>
                   </a:txBody>
@@ -8413,11 +8413,11 @@
                       <a:r>
                         <a:rPr sz="900" b="1">
                           <a:solidFill>
-                            <a:srgbClr val="CC0000"/>
-                          </a:solidFill>
-                          <a:latin typeface="Kanit"/>
-                        </a:rPr>
-                        <a:t>5</a:t>
+                            <a:srgbClr val="F5C242"/>
+                          </a:solidFill>
+                          <a:latin typeface="Kanit"/>
+                        </a:rPr>
+                        <a:t>4</a:t>
                       </a:r>
                     </a:p>
                   </a:txBody>
@@ -8442,7 +8442,7 @@
                           </a:solidFill>
                           <a:latin typeface="Kanit"/>
                         </a:rPr>
-                        <a:t>สมุทรปราการ</a:t>
+                        <a:t>อุดรธานี</a:t>
                       </a:r>
                     </a:p>
                   </a:txBody>
@@ -8465,7 +8465,7 @@
                           </a:solidFill>
                           <a:latin typeface="Kanit"/>
                         </a:rPr>
-                        <a:t>16</a:t>
+                        <a:t>35</a:t>
                       </a:r>
                     </a:p>
                   </a:txBody>
@@ -8488,7 +8488,7 @@
                           </a:solidFill>
                           <a:latin typeface="Kanit"/>
                         </a:rPr>
-                        <a:t>20</a:t>
+                        <a:t>44</a:t>
                       </a:r>
                     </a:p>
                   </a:txBody>
@@ -8507,11 +8507,11 @@
                       <a:r>
                         <a:rPr sz="900" b="1">
                           <a:solidFill>
-                            <a:srgbClr val="606060"/>
-                          </a:solidFill>
-                          <a:latin typeface="Kanit"/>
-                        </a:rPr>
-                        <a:t>0.0%</a:t>
+                            <a:srgbClr val="F5C242"/>
+                          </a:solidFill>
+                          <a:latin typeface="Kanit"/>
+                        </a:rPr>
+                        <a:t>17.1%</a:t>
                       </a:r>
                     </a:p>
                   </a:txBody>
@@ -8534,7 +8534,7 @@
                           </a:solidFill>
                           <a:latin typeface="Kanit"/>
                         </a:rPr>
-                        <a:t>4/5</a:t>
+                        <a:t>3/7</a:t>
                       </a:r>
                     </a:p>
                   </a:txBody>
@@ -8553,11 +8553,11 @@
                       <a:r>
                         <a:rPr sz="900" b="1">
                           <a:solidFill>
-                            <a:srgbClr val="CC0000"/>
-                          </a:solidFill>
-                          <a:latin typeface="Kanit"/>
-                        </a:rPr>
-                        <a:t>5</a:t>
+                            <a:srgbClr val="F5C242"/>
+                          </a:solidFill>
+                          <a:latin typeface="Kanit"/>
+                        </a:rPr>
+                        <a:t>4</a:t>
                       </a:r>
                     </a:p>
                   </a:txBody>
@@ -8582,7 +8582,7 @@
                           </a:solidFill>
                           <a:latin typeface="Kanit"/>
                         </a:rPr>
-                        <a:t>อุบลราชธานี</a:t>
+                        <a:t>สมุทรสงคราม</a:t>
                       </a:r>
                     </a:p>
                   </a:txBody>
@@ -8605,7 +8605,7 @@
                           </a:solidFill>
                           <a:latin typeface="Kanit"/>
                         </a:rPr>
-                        <a:t>46</a:t>
+                        <a:t>6</a:t>
                       </a:r>
                     </a:p>
                   </a:txBody>
@@ -8628,7 +8628,7 @@
                           </a:solidFill>
                           <a:latin typeface="Kanit"/>
                         </a:rPr>
-                        <a:t>65</a:t>
+                        <a:t>35</a:t>
                       </a:r>
                     </a:p>
                   </a:txBody>
@@ -8651,7 +8651,7 @@
                           </a:solidFill>
                           <a:latin typeface="Kanit"/>
                         </a:rPr>
-                        <a:t>23.9%</a:t>
+                        <a:t>16.7%</a:t>
                       </a:r>
                     </a:p>
                   </a:txBody>
@@ -8674,7 +8674,7 @@
                           </a:solidFill>
                           <a:latin typeface="Kanit"/>
                         </a:rPr>
-                        <a:t>2/15</a:t>
+                        <a:t>1/2</a:t>
                       </a:r>
                     </a:p>
                   </a:txBody>
@@ -8909,7 +8909,7 @@
                 </a:solidFill>
                 <a:latin typeface="Kanit"/>
               </a:rPr>
-              <a:t>พื้นที่ปลูก วัดจริง (สศก. — ข้อมูลอำเภอ×พืช 3,295 แถว) ภัยแล้งเป็นดัชนี SPEI จาก แบบจำลอง คำนวณจากปริมาณฝนและการคายระเหย ปรับเดือนละครั้ง ดึงข้อมูล 2026-07-20 — เป็นสัญญาณที่ครอบคลุมทั้งประเทศดีที่สุดที่มี แต่ไม่มีใครลงพื้นที่ไปเดินดูอำเภอเหล่านั้น ข้อมูลฝนและระดับน้ำ วัดจริง (ThaiWater เรียลไทม์ ดึงทุกวันและสะสมไว้ — วันที่ดึงไม่สำเร็จจะเว้นเป็นช่องว่าง ไม่ใส่ค่าสมมติ) · ฝนถึง 2026-09-01, ระดับน้ำถึง 2026-09-01 ความเสี่ยงน้ำท่วมเชิงโครงสร้าง วัดจริง (สำมะโนพื้นที่ท่วมซ้ำซาก GISTDA มาตราส่วน 1:50,000 ปี 2005-2016 — เป็นบันทึกภาคพื้นดิน 12 ปี ไม่ใช่การพยากรณ์)</a:t>
+              <a:t>พื้นที่ปลูก วัดจริง (สศก. — ข้อมูลอำเภอ×พืช 3,295 แถว) ภัยแล้งเป็นดัชนี SPEI จาก แบบจำลอง คำนวณจากปริมาณฝนและการคายระเหย ปรับเดือนละครั้ง ดึงข้อมูล 2026-07-20 — เป็นสัญญาณที่ครอบคลุมทั้งประเทศดีที่สุดที่มี แต่ไม่มีใครลงพื้นที่ไปเดินดูอำเภอเหล่านั้น ข้อมูลฝนและระดับน้ำ วัดจริง (ThaiWater เรียลไทม์ ดึงทุกวันและสะสมไว้ — วันที่ดึงไม่สำเร็จจะเว้นเป็นช่องว่าง ไม่ใส่ค่าสมมติ) · ฝนถึง 2026-09-02, ระดับน้ำถึง 2026-09-02 ความเสี่ยงน้ำท่วมเชิงโครงสร้าง วัดจริง (สำมะโนพื้นที่ท่วมซ้ำซาก GISTDA มาตราส่วน 1:50,000 ปี 2005-2016 — เป็นบันทึกภาคพื้นดิน 12 ปี ไม่ใช่การพยากรณ์)</a:t>
             </a:r>
           </a:p>
         </p:txBody>
@@ -32047,7 +32047,7 @@
                 </a:solidFill>
                 <a:latin typeface="Kanit"/>
               </a:rPr>
-              <a:t>รุ่นข้อมูล — ราคาโลก 2026M06 · ราคาหน้าฟาร์มไทย 2026-08-28 · ประวัติราคาไทย 2026-08-29 · ต้นทุนการผลิตพืช สศก. ไจอัป 2568 (ปีเพาะปลูก 2568/69, ประมาณการ สศก. มี.ค. 2569) · ภัยแล้ง 2026-06-21 · เงินเฟ้อ 2026-05 · GDP 2026 ไตรมาส 1 · IMF WEO 2026 · ดัชนีราคาขายต่อ 2026-05 · ยอดจดทะเบียนถึง 2026-01 · หนี้ครัวเรือน สสช. SES 2566 · ค่าจ้าง สสช. LFS 2568 · ข้อมูลตรวจวัด 2026-09-01</a:t>
+              <a:t>รุ่นข้อมูล — ราคาโลก 2026M06 · ราคาหน้าฟาร์มไทย 2026-08-28 · ประวัติราคาไทย 2026-08-29 · ต้นทุนการผลิตพืช สศก. ไจอัป 2568 (ปีเพาะปลูก 2568/69, ประมาณการ สศก. มี.ค. 2569) · ภัยแล้ง 2026-06-21 · เงินเฟ้อ 2026-05 · GDP 2026 ไตรมาส 1 · IMF WEO 2026 · ดัชนีราคาขายต่อ 2026-05 · ยอดจดทะเบียนถึง 2026-01 · หนี้ครัวเรือน สสช. SES 2566 · ค่าจ้าง สสช. LFS 2568 · ข้อมูลตรวจวัด 2026-09-02</a:t>
             </a:r>
           </a:p>
         </p:txBody>
@@ -37087,7 +37087,7 @@
                 </a:solidFill>
                 <a:latin typeface="Kanit"/>
               </a:rPr>
-              <a:t>338 จาก 928 อำเภอ · แม่น้ำเกินระดับ 133 จาก 793 สถานี</a:t>
+              <a:t>338 จาก 928 อำเภอ · แม่น้ำเกินระดับ 131 จาก 792 สถานี</a:t>
             </a:r>
           </a:p>
         </p:txBody>
@@ -37859,7 +37859,7 @@
                           </a:solidFill>
                           <a:latin typeface="Kanit"/>
                         </a:rPr>
-                        <a:t>27/156</a:t>
+                        <a:t>28/157</a:t>
                       </a:r>
                     </a:p>
                   </a:txBody>
@@ -38555,7 +38555,7 @@
                           </a:solidFill>
                           <a:latin typeface="Kanit"/>
                         </a:rPr>
-                        <a:t>15/51</a:t>
+                        <a:t>16/51</a:t>
                       </a:r>
                     </a:p>
                   </a:txBody>
@@ -38787,7 +38787,7 @@
                           </a:solidFill>
                           <a:latin typeface="Kanit"/>
                         </a:rPr>
-                        <a:t>49/145</a:t>
+                        <a:t>45/143</a:t>
                       </a:r>
                     </a:p>
                   </a:txBody>

</xml_diff>

<commit_message>
deck(mcom): rebuild — the data moved past the committed figures (run 33575611939) (#770)
Co-authored-by: github-actions[bot] <41898282+github-actions[bot]@users.noreply.github.com>
</commit_message>
<xml_diff>
--- a/docs/decks/mcom-2026-08-05-macro-TH.pptx
+++ b/docs/decks/mcom-2026-08-05-macro-TH.pptx
@@ -6240,7 +6240,7 @@
                 </a:solidFill>
                 <a:latin typeface="Kanit"/>
               </a:rPr>
-              <a:t>133</a:t>
+              <a:t>131</a:t>
             </a:r>
           </a:p>
         </p:txBody>
@@ -6279,7 +6279,7 @@
                 </a:solidFill>
                 <a:latin typeface="Kanit"/>
               </a:rPr>
-              <a:t>จาก 793 (16.8%) · เรียลไทม์ · 2026-09-01</a:t>
+              <a:t>จาก 792 (16.5%) · เรียลไทม์ · 2026-09-02</a:t>
             </a:r>
           </a:p>
         </p:txBody>
@@ -6405,7 +6405,7 @@
                 </a:solidFill>
                 <a:latin typeface="Kanit"/>
               </a:rPr>
-              <a:t>29</a:t>
+              <a:t>18</a:t>
             </a:r>
           </a:p>
         </p:txBody>
@@ -6444,7 +6444,7 @@
                 </a:solidFill>
                 <a:latin typeface="Kanit"/>
               </a:rPr>
-              <a:t>ค่าล่าสุดรายวัน · 2026-09-01</a:t>
+              <a:t>ค่าล่าสุดรายวัน · 2026-09-02</a:t>
             </a:r>
           </a:p>
         </p:txBody>
@@ -7882,7 +7882,7 @@
                           </a:solidFill>
                           <a:latin typeface="Kanit"/>
                         </a:rPr>
-                        <a:t>กาญจนบุรี</a:t>
+                        <a:t>สกลนคร</a:t>
                       </a:r>
                     </a:p>
                   </a:txBody>
@@ -7905,7 +7905,7 @@
                           </a:solidFill>
                           <a:latin typeface="Kanit"/>
                         </a:rPr>
-                        <a:t>86</a:t>
+                        <a:t>38</a:t>
                       </a:r>
                     </a:p>
                   </a:txBody>
@@ -7928,7 +7928,7 @@
                           </a:solidFill>
                           <a:latin typeface="Kanit"/>
                         </a:rPr>
-                        <a:t>94</a:t>
+                        <a:t>40</a:t>
                       </a:r>
                     </a:p>
                   </a:txBody>
@@ -7951,7 +7951,7 @@
                           </a:solidFill>
                           <a:latin typeface="Kanit"/>
                         </a:rPr>
-                        <a:t>18.6%</a:t>
+                        <a:t>2.6%</a:t>
                       </a:r>
                     </a:p>
                   </a:txBody>
@@ -7974,7 +7974,7 @@
                           </a:solidFill>
                           <a:latin typeface="Kanit"/>
                         </a:rPr>
-                        <a:t>6/26</a:t>
+                        <a:t>7/12</a:t>
                       </a:r>
                     </a:p>
                   </a:txBody>
@@ -8045,7 +8045,7 @@
                           </a:solidFill>
                           <a:latin typeface="Kanit"/>
                         </a:rPr>
-                        <a:t>44</a:t>
+                        <a:t>42</a:t>
                       </a:r>
                     </a:p>
                   </a:txBody>
@@ -8068,7 +8068,7 @@
                           </a:solidFill>
                           <a:latin typeface="Kanit"/>
                         </a:rPr>
-                        <a:t>53</a:t>
+                        <a:t>5</a:t>
                       </a:r>
                     </a:p>
                   </a:txBody>
@@ -8087,11 +8087,11 @@
                       <a:r>
                         <a:rPr sz="900" b="1">
                           <a:solidFill>
-                            <a:srgbClr val="F5C242"/>
-                          </a:solidFill>
-                          <a:latin typeface="Kanit"/>
-                        </a:rPr>
-                        <a:t>6.8%</a:t>
+                            <a:srgbClr val="606060"/>
+                          </a:solidFill>
+                          <a:latin typeface="Kanit"/>
+                        </a:rPr>
+                        <a:t>0.0%</a:t>
                       </a:r>
                     </a:p>
                   </a:txBody>
@@ -8185,7 +8185,7 @@
                           </a:solidFill>
                           <a:latin typeface="Kanit"/>
                         </a:rPr>
-                        <a:t>111</a:t>
+                        <a:t>110</a:t>
                       </a:r>
                     </a:p>
                   </a:txBody>
@@ -8208,7 +8208,7 @@
                           </a:solidFill>
                           <a:latin typeface="Kanit"/>
                         </a:rPr>
-                        <a:t>127</a:t>
+                        <a:t>5</a:t>
                       </a:r>
                     </a:p>
                   </a:txBody>
@@ -8227,11 +8227,11 @@
                       <a:r>
                         <a:rPr sz="900" b="1">
                           <a:solidFill>
-                            <a:srgbClr val="F5C242"/>
-                          </a:solidFill>
-                          <a:latin typeface="Kanit"/>
-                        </a:rPr>
-                        <a:t>0.9%</a:t>
+                            <a:srgbClr val="606060"/>
+                          </a:solidFill>
+                          <a:latin typeface="Kanit"/>
+                        </a:rPr>
+                        <a:t>0.0%</a:t>
                       </a:r>
                     </a:p>
                   </a:txBody>
@@ -8302,7 +8302,7 @@
                           </a:solidFill>
                           <a:latin typeface="Kanit"/>
                         </a:rPr>
-                        <a:t>สกลนคร</a:t>
+                        <a:t>บึงกาฬ</a:t>
                       </a:r>
                     </a:p>
                   </a:txBody>
@@ -8325,7 +8325,7 @@
                           </a:solidFill>
                           <a:latin typeface="Kanit"/>
                         </a:rPr>
-                        <a:t>38</a:t>
+                        <a:t>11</a:t>
                       </a:r>
                     </a:p>
                   </a:txBody>
@@ -8348,7 +8348,7 @@
                           </a:solidFill>
                           <a:latin typeface="Kanit"/>
                         </a:rPr>
-                        <a:t>14</a:t>
+                        <a:t>55</a:t>
                       </a:r>
                     </a:p>
                   </a:txBody>
@@ -8367,11 +8367,11 @@
                       <a:r>
                         <a:rPr sz="900" b="1">
                           <a:solidFill>
-                            <a:srgbClr val="606060"/>
-                          </a:solidFill>
-                          <a:latin typeface="Kanit"/>
-                        </a:rPr>
-                        <a:t>0.0%</a:t>
+                            <a:srgbClr val="F5C242"/>
+                          </a:solidFill>
+                          <a:latin typeface="Kanit"/>
+                        </a:rPr>
+                        <a:t>36.4%</a:t>
                       </a:r>
                     </a:p>
                   </a:txBody>
@@ -8394,7 +8394,7 @@
                           </a:solidFill>
                           <a:latin typeface="Kanit"/>
                         </a:rPr>
-                        <a:t>7/13</a:t>
+                        <a:t>1/1</a:t>
                       </a:r>
                     </a:p>
                   </a:txBody>
@@ -8413,11 +8413,11 @@
                       <a:r>
                         <a:rPr sz="900" b="1">
                           <a:solidFill>
-                            <a:srgbClr val="CC0000"/>
-                          </a:solidFill>
-                          <a:latin typeface="Kanit"/>
-                        </a:rPr>
-                        <a:t>5</a:t>
+                            <a:srgbClr val="F5C242"/>
+                          </a:solidFill>
+                          <a:latin typeface="Kanit"/>
+                        </a:rPr>
+                        <a:t>4</a:t>
                       </a:r>
                     </a:p>
                   </a:txBody>
@@ -8442,7 +8442,7 @@
                           </a:solidFill>
                           <a:latin typeface="Kanit"/>
                         </a:rPr>
-                        <a:t>สมุทรปราการ</a:t>
+                        <a:t>อุดรธานี</a:t>
                       </a:r>
                     </a:p>
                   </a:txBody>
@@ -8465,7 +8465,7 @@
                           </a:solidFill>
                           <a:latin typeface="Kanit"/>
                         </a:rPr>
-                        <a:t>16</a:t>
+                        <a:t>35</a:t>
                       </a:r>
                     </a:p>
                   </a:txBody>
@@ -8488,7 +8488,7 @@
                           </a:solidFill>
                           <a:latin typeface="Kanit"/>
                         </a:rPr>
-                        <a:t>20</a:t>
+                        <a:t>44</a:t>
                       </a:r>
                     </a:p>
                   </a:txBody>
@@ -8507,11 +8507,11 @@
                       <a:r>
                         <a:rPr sz="900" b="1">
                           <a:solidFill>
-                            <a:srgbClr val="606060"/>
-                          </a:solidFill>
-                          <a:latin typeface="Kanit"/>
-                        </a:rPr>
-                        <a:t>0.0%</a:t>
+                            <a:srgbClr val="F5C242"/>
+                          </a:solidFill>
+                          <a:latin typeface="Kanit"/>
+                        </a:rPr>
+                        <a:t>17.1%</a:t>
                       </a:r>
                     </a:p>
                   </a:txBody>
@@ -8534,7 +8534,7 @@
                           </a:solidFill>
                           <a:latin typeface="Kanit"/>
                         </a:rPr>
-                        <a:t>4/5</a:t>
+                        <a:t>3/7</a:t>
                       </a:r>
                     </a:p>
                   </a:txBody>
@@ -8553,11 +8553,11 @@
                       <a:r>
                         <a:rPr sz="900" b="1">
                           <a:solidFill>
-                            <a:srgbClr val="CC0000"/>
-                          </a:solidFill>
-                          <a:latin typeface="Kanit"/>
-                        </a:rPr>
-                        <a:t>5</a:t>
+                            <a:srgbClr val="F5C242"/>
+                          </a:solidFill>
+                          <a:latin typeface="Kanit"/>
+                        </a:rPr>
+                        <a:t>4</a:t>
                       </a:r>
                     </a:p>
                   </a:txBody>
@@ -8582,7 +8582,7 @@
                           </a:solidFill>
                           <a:latin typeface="Kanit"/>
                         </a:rPr>
-                        <a:t>อุบลราชธานี</a:t>
+                        <a:t>สมุทรสงคราม</a:t>
                       </a:r>
                     </a:p>
                   </a:txBody>
@@ -8605,7 +8605,7 @@
                           </a:solidFill>
                           <a:latin typeface="Kanit"/>
                         </a:rPr>
-                        <a:t>46</a:t>
+                        <a:t>6</a:t>
                       </a:r>
                     </a:p>
                   </a:txBody>
@@ -8628,7 +8628,7 @@
                           </a:solidFill>
                           <a:latin typeface="Kanit"/>
                         </a:rPr>
-                        <a:t>65</a:t>
+                        <a:t>35</a:t>
                       </a:r>
                     </a:p>
                   </a:txBody>
@@ -8651,7 +8651,7 @@
                           </a:solidFill>
                           <a:latin typeface="Kanit"/>
                         </a:rPr>
-                        <a:t>23.9%</a:t>
+                        <a:t>16.7%</a:t>
                       </a:r>
                     </a:p>
                   </a:txBody>
@@ -8674,7 +8674,7 @@
                           </a:solidFill>
                           <a:latin typeface="Kanit"/>
                         </a:rPr>
-                        <a:t>2/15</a:t>
+                        <a:t>1/2</a:t>
                       </a:r>
                     </a:p>
                   </a:txBody>
@@ -8909,7 +8909,7 @@
                 </a:solidFill>
                 <a:latin typeface="Kanit"/>
               </a:rPr>
-              <a:t>พื้นที่ปลูก วัดจริง (สศก. — ข้อมูลอำเภอ×พืช 3,295 แถว) ภัยแล้งเป็นดัชนี SPEI จาก แบบจำลอง คำนวณจากปริมาณฝนและการคายระเหย ปรับเดือนละครั้ง ดึงข้อมูล 2026-07-20 — เป็นสัญญาณที่ครอบคลุมทั้งประเทศดีที่สุดที่มี แต่ไม่มีใครลงพื้นที่ไปเดินดูอำเภอเหล่านั้น ข้อมูลฝนและระดับน้ำ วัดจริง (ThaiWater เรียลไทม์ ดึงทุกวันและสะสมไว้ — วันที่ดึงไม่สำเร็จจะเว้นเป็นช่องว่าง ไม่ใส่ค่าสมมติ) · ฝนถึง 2026-09-01, ระดับน้ำถึง 2026-09-01 ความเสี่ยงน้ำท่วมเชิงโครงสร้าง วัดจริง (สำมะโนพื้นที่ท่วมซ้ำซาก GISTDA มาตราส่วน 1:50,000 ปี 2005-2016 — เป็นบันทึกภาคพื้นดิน 12 ปี ไม่ใช่การพยากรณ์)</a:t>
+              <a:t>พื้นที่ปลูก วัดจริง (สศก. — ข้อมูลอำเภอ×พืช 3,295 แถว) ภัยแล้งเป็นดัชนี SPEI จาก แบบจำลอง คำนวณจากปริมาณฝนและการคายระเหย ปรับเดือนละครั้ง ดึงข้อมูล 2026-07-20 — เป็นสัญญาณที่ครอบคลุมทั้งประเทศดีที่สุดที่มี แต่ไม่มีใครลงพื้นที่ไปเดินดูอำเภอเหล่านั้น ข้อมูลฝนและระดับน้ำ วัดจริง (ThaiWater เรียลไทม์ ดึงทุกวันและสะสมไว้ — วันที่ดึงไม่สำเร็จจะเว้นเป็นช่องว่าง ไม่ใส่ค่าสมมติ) · ฝนถึง 2026-09-02, ระดับน้ำถึง 2026-09-02 ความเสี่ยงน้ำท่วมเชิงโครงสร้าง วัดจริง (สำมะโนพื้นที่ท่วมซ้ำซาก GISTDA มาตราส่วน 1:50,000 ปี 2005-2016 — เป็นบันทึกภาคพื้นดิน 12 ปี ไม่ใช่การพยากรณ์)</a:t>
             </a:r>
           </a:p>
         </p:txBody>
@@ -32047,7 +32047,7 @@
                 </a:solidFill>
                 <a:latin typeface="Kanit"/>
               </a:rPr>
-              <a:t>รุ่นข้อมูล — ราคาโลก 2026M06 · ราคาหน้าฟาร์มไทย 2026-08-28 · ประวัติราคาไทย 2026-08-29 · ต้นทุนการผลิตพืช สศก. ไจอัป 2568 (ปีเพาะปลูก 2568/69, ประมาณการ สศก. มี.ค. 2569) · ภัยแล้ง 2026-06-21 · เงินเฟ้อ 2026-05 · GDP 2026 ไตรมาส 1 · IMF WEO 2026 · ดัชนีราคาขายต่อ 2026-05 · ยอดจดทะเบียนถึง 2026-01 · หนี้ครัวเรือน สสช. SES 2566 · ค่าจ้าง สสช. LFS 2568 · ข้อมูลตรวจวัด 2026-09-01</a:t>
+              <a:t>รุ่นข้อมูล — ราคาโลก 2026M06 · ราคาหน้าฟาร์มไทย 2026-08-28 · ประวัติราคาไทย 2026-08-29 · ต้นทุนการผลิตพืช สศก. ไจอัป 2568 (ปีเพาะปลูก 2568/69, ประมาณการ สศก. มี.ค. 2569) · ภัยแล้ง 2026-06-21 · เงินเฟ้อ 2026-05 · GDP 2026 ไตรมาส 1 · IMF WEO 2026 · ดัชนีราคาขายต่อ 2026-05 · ยอดจดทะเบียนถึง 2026-01 · หนี้ครัวเรือน สสช. SES 2566 · ค่าจ้าง สสช. LFS 2568 · ข้อมูลตรวจวัด 2026-09-02</a:t>
             </a:r>
           </a:p>
         </p:txBody>
@@ -37087,7 +37087,7 @@
                 </a:solidFill>
                 <a:latin typeface="Kanit"/>
               </a:rPr>
-              <a:t>338 จาก 928 อำเภอ · แม่น้ำเกินระดับ 133 จาก 793 สถานี</a:t>
+              <a:t>338 จาก 928 อำเภอ · แม่น้ำเกินระดับ 131 จาก 792 สถานี</a:t>
             </a:r>
           </a:p>
         </p:txBody>
@@ -37859,7 +37859,7 @@
                           </a:solidFill>
                           <a:latin typeface="Kanit"/>
                         </a:rPr>
-                        <a:t>27/156</a:t>
+                        <a:t>28/157</a:t>
                       </a:r>
                     </a:p>
                   </a:txBody>
@@ -38555,7 +38555,7 @@
                           </a:solidFill>
                           <a:latin typeface="Kanit"/>
                         </a:rPr>
-                        <a:t>15/51</a:t>
+                        <a:t>16/51</a:t>
                       </a:r>
                     </a:p>
                   </a:txBody>
@@ -38787,7 +38787,7 @@
                           </a:solidFill>
                           <a:latin typeface="Kanit"/>
                         </a:rPr>
-                        <a:t>49/145</a:t>
+                        <a:t>45/143</a:t>
                       </a:r>
                     </a:p>
                   </a:txBody>

</xml_diff>

<commit_message>
deck(mcom): rebuild — the data moved past the committed figures (run 33952594874)
</commit_message>
<xml_diff>
--- a/docs/decks/mcom-2026-08-05-macro-TH.pptx
+++ b/docs/decks/mcom-2026-08-05-macro-TH.pptx
@@ -6240,7 +6240,7 @@
                 </a:solidFill>
                 <a:latin typeface="Kanit"/>
               </a:rPr>
-              <a:t>131</a:t>
+              <a:t>123</a:t>
             </a:r>
           </a:p>
         </p:txBody>
@@ -6279,7 +6279,7 @@
                 </a:solidFill>
                 <a:latin typeface="Kanit"/>
               </a:rPr>
-              <a:t>จาก 792 (16.5%) · เรียลไทม์ · 2026-09-02</a:t>
+              <a:t>จาก 793 (15.5%) · เรียลไทม์ · 2026-09-05</a:t>
             </a:r>
           </a:p>
         </p:txBody>
@@ -6405,7 +6405,7 @@
                 </a:solidFill>
                 <a:latin typeface="Kanit"/>
               </a:rPr>
-              <a:t>18</a:t>
+              <a:t>25</a:t>
             </a:r>
           </a:p>
         </p:txBody>
@@ -6444,7 +6444,7 @@
                 </a:solidFill>
                 <a:latin typeface="Kanit"/>
               </a:rPr>
-              <a:t>ค่าล่าสุดรายวัน · 2026-09-02</a:t>
+              <a:t>ค่าล่าสุดรายวัน · 2026-09-05</a:t>
             </a:r>
           </a:p>
         </p:txBody>
@@ -7928,7 +7928,7 @@
                           </a:solidFill>
                           <a:latin typeface="Kanit"/>
                         </a:rPr>
-                        <a:t>40</a:t>
+                        <a:t>52</a:t>
                       </a:r>
                     </a:p>
                   </a:txBody>
@@ -7974,7 +7974,7 @@
                           </a:solidFill>
                           <a:latin typeface="Kanit"/>
                         </a:rPr>
-                        <a:t>7/12</a:t>
+                        <a:t>6/13</a:t>
                       </a:r>
                     </a:p>
                   </a:txBody>
@@ -8045,7 +8045,7 @@
                           </a:solidFill>
                           <a:latin typeface="Kanit"/>
                         </a:rPr>
-                        <a:t>42</a:t>
+                        <a:t>44</a:t>
                       </a:r>
                     </a:p>
                   </a:txBody>
@@ -8068,7 +8068,7 @@
                           </a:solidFill>
                           <a:latin typeface="Kanit"/>
                         </a:rPr>
-                        <a:t>5</a:t>
+                        <a:t>9</a:t>
                       </a:r>
                     </a:p>
                   </a:txBody>
@@ -8162,7 +8162,7 @@
                           </a:solidFill>
                           <a:latin typeface="Kanit"/>
                         </a:rPr>
-                        <a:t>เลย</a:t>
+                        <a:t>นครพนม</a:t>
                       </a:r>
                     </a:p>
                   </a:txBody>
@@ -8185,7 +8185,7 @@
                           </a:solidFill>
                           <a:latin typeface="Kanit"/>
                         </a:rPr>
-                        <a:t>110</a:t>
+                        <a:t>28</a:t>
                       </a:r>
                     </a:p>
                   </a:txBody>
@@ -8208,7 +8208,7 @@
                           </a:solidFill>
                           <a:latin typeface="Kanit"/>
                         </a:rPr>
-                        <a:t>5</a:t>
+                        <a:t>49</a:t>
                       </a:r>
                     </a:p>
                   </a:txBody>
@@ -8227,11 +8227,11 @@
                       <a:r>
                         <a:rPr sz="900" b="1">
                           <a:solidFill>
-                            <a:srgbClr val="606060"/>
-                          </a:solidFill>
-                          <a:latin typeface="Kanit"/>
-                        </a:rPr>
-                        <a:t>0.0%</a:t>
+                            <a:srgbClr val="F5C242"/>
+                          </a:solidFill>
+                          <a:latin typeface="Kanit"/>
+                        </a:rPr>
+                        <a:t>25.0%</a:t>
                       </a:r>
                     </a:p>
                   </a:txBody>
@@ -8254,7 +8254,7 @@
                           </a:solidFill>
                           <a:latin typeface="Kanit"/>
                         </a:rPr>
-                        <a:t>1/8</a:t>
+                        <a:t>8/14</a:t>
                       </a:r>
                     </a:p>
                   </a:txBody>
@@ -8273,11 +8273,11 @@
                       <a:r>
                         <a:rPr sz="900" b="1">
                           <a:solidFill>
-                            <a:srgbClr val="CC0000"/>
-                          </a:solidFill>
-                          <a:latin typeface="Kanit"/>
-                        </a:rPr>
-                        <a:t>5</a:t>
+                            <a:srgbClr val="F5C242"/>
+                          </a:solidFill>
+                          <a:latin typeface="Kanit"/>
+                        </a:rPr>
+                        <a:t>4</a:t>
                       </a:r>
                     </a:p>
                   </a:txBody>
@@ -8302,7 +8302,7 @@
                           </a:solidFill>
                           <a:latin typeface="Kanit"/>
                         </a:rPr>
-                        <a:t>บึงกาฬ</a:t>
+                        <a:t>พะเยา</a:t>
                       </a:r>
                     </a:p>
                   </a:txBody>
@@ -8325,7 +8325,7 @@
                           </a:solidFill>
                           <a:latin typeface="Kanit"/>
                         </a:rPr>
-                        <a:t>11</a:t>
+                        <a:t>126</a:t>
                       </a:r>
                     </a:p>
                   </a:txBody>
@@ -8348,7 +8348,7 @@
                           </a:solidFill>
                           <a:latin typeface="Kanit"/>
                         </a:rPr>
-                        <a:t>55</a:t>
+                        <a:t>88</a:t>
                       </a:r>
                     </a:p>
                   </a:txBody>
@@ -8371,7 +8371,7 @@
                           </a:solidFill>
                           <a:latin typeface="Kanit"/>
                         </a:rPr>
-                        <a:t>36.4%</a:t>
+                        <a:t>14.3%</a:t>
                       </a:r>
                     </a:p>
                   </a:txBody>
@@ -8394,7 +8394,7 @@
                           </a:solidFill>
                           <a:latin typeface="Kanit"/>
                         </a:rPr>
-                        <a:t>1/1</a:t>
+                        <a:t>3/13</a:t>
                       </a:r>
                     </a:p>
                   </a:txBody>
@@ -8442,7 +8442,7 @@
                           </a:solidFill>
                           <a:latin typeface="Kanit"/>
                         </a:rPr>
-                        <a:t>อุดรธานี</a:t>
+                        <a:t>น่าน</a:t>
                       </a:r>
                     </a:p>
                   </a:txBody>
@@ -8465,7 +8465,7 @@
                           </a:solidFill>
                           <a:latin typeface="Kanit"/>
                         </a:rPr>
-                        <a:t>35</a:t>
+                        <a:t>217</a:t>
                       </a:r>
                     </a:p>
                   </a:txBody>
@@ -8488,7 +8488,7 @@
                           </a:solidFill>
                           <a:latin typeface="Kanit"/>
                         </a:rPr>
-                        <a:t>44</a:t>
+                        <a:t>101</a:t>
                       </a:r>
                     </a:p>
                   </a:txBody>
@@ -8511,7 +8511,7 @@
                           </a:solidFill>
                           <a:latin typeface="Kanit"/>
                         </a:rPr>
-                        <a:t>17.1%</a:t>
+                        <a:t>13.8%</a:t>
                       </a:r>
                     </a:p>
                   </a:txBody>
@@ -8534,7 +8534,7 @@
                           </a:solidFill>
                           <a:latin typeface="Kanit"/>
                         </a:rPr>
-                        <a:t>3/7</a:t>
+                        <a:t>1/26</a:t>
                       </a:r>
                     </a:p>
                   </a:txBody>
@@ -8582,7 +8582,7 @@
                           </a:solidFill>
                           <a:latin typeface="Kanit"/>
                         </a:rPr>
-                        <a:t>สมุทรสงคราม</a:t>
+                        <a:t>อุบลราชธานี</a:t>
                       </a:r>
                     </a:p>
                   </a:txBody>
@@ -8605,7 +8605,7 @@
                           </a:solidFill>
                           <a:latin typeface="Kanit"/>
                         </a:rPr>
-                        <a:t>6</a:t>
+                        <a:t>46</a:t>
                       </a:r>
                     </a:p>
                   </a:txBody>
@@ -8628,7 +8628,7 @@
                           </a:solidFill>
                           <a:latin typeface="Kanit"/>
                         </a:rPr>
-                        <a:t>35</a:t>
+                        <a:t>68</a:t>
                       </a:r>
                     </a:p>
                   </a:txBody>
@@ -8651,7 +8651,7 @@
                           </a:solidFill>
                           <a:latin typeface="Kanit"/>
                         </a:rPr>
-                        <a:t>16.7%</a:t>
+                        <a:t>10.9%</a:t>
                       </a:r>
                     </a:p>
                   </a:txBody>
@@ -8674,7 +8674,7 @@
                           </a:solidFill>
                           <a:latin typeface="Kanit"/>
                         </a:rPr>
-                        <a:t>1/2</a:t>
+                        <a:t>2/14</a:t>
                       </a:r>
                     </a:p>
                   </a:txBody>
@@ -8909,7 +8909,7 @@
                 </a:solidFill>
                 <a:latin typeface="Kanit"/>
               </a:rPr>
-              <a:t>พื้นที่ปลูก วัดจริง (สศก. — ข้อมูลอำเภอ×พืช 3,295 แถว) ภัยแล้งเป็นดัชนี SPEI จาก แบบจำลอง คำนวณจากปริมาณฝนและการคายระเหย ปรับเดือนละครั้ง ดึงข้อมูล 2026-07-20 — เป็นสัญญาณที่ครอบคลุมทั้งประเทศดีที่สุดที่มี แต่ไม่มีใครลงพื้นที่ไปเดินดูอำเภอเหล่านั้น ข้อมูลฝนและระดับน้ำ วัดจริง (ThaiWater เรียลไทม์ ดึงทุกวันและสะสมไว้ — วันที่ดึงไม่สำเร็จจะเว้นเป็นช่องว่าง ไม่ใส่ค่าสมมติ) · ฝนถึง 2026-09-02, ระดับน้ำถึง 2026-09-02 ความเสี่ยงน้ำท่วมเชิงโครงสร้าง วัดจริง (สำมะโนพื้นที่ท่วมซ้ำซาก GISTDA มาตราส่วน 1:50,000 ปี 2005-2016 — เป็นบันทึกภาคพื้นดิน 12 ปี ไม่ใช่การพยากรณ์)</a:t>
+              <a:t>พื้นที่ปลูก วัดจริง (สศก. — ข้อมูลอำเภอ×พืช 3,295 แถว) ภัยแล้งเป็นดัชนี SPEI จาก แบบจำลอง คำนวณจากปริมาณฝนและการคายระเหย ปรับเดือนละครั้ง ดึงข้อมูล 2026-07-20 — เป็นสัญญาณที่ครอบคลุมทั้งประเทศดีที่สุดที่มี แต่ไม่มีใครลงพื้นที่ไปเดินดูอำเภอเหล่านั้น ข้อมูลฝนและระดับน้ำ วัดจริง (ThaiWater เรียลไทม์ ดึงทุกวันและสะสมไว้ — วันที่ดึงไม่สำเร็จจะเว้นเป็นช่องว่าง ไม่ใส่ค่าสมมติ) · ฝนถึง 2026-09-05, ระดับน้ำถึง 2026-09-05 ความเสี่ยงน้ำท่วมเชิงโครงสร้าง วัดจริง (สำมะโนพื้นที่ท่วมซ้ำซาก GISTDA มาตราส่วน 1:50,000 ปี 2005-2016 — เป็นบันทึกภาคพื้นดิน 12 ปี ไม่ใช่การพยากรณ์)</a:t>
             </a:r>
           </a:p>
         </p:txBody>
@@ -31476,7 +31476,7 @@
                 </a:solidFill>
                 <a:latin typeface="Kanit"/>
               </a:rPr>
-              <a:t>รายได้จากพืชค่ากลางเพิ่มขึ้น +16.8% แต่มีสี่จังหวัดที่ลดลง — ทั้งหมดอยู่ในแหล่งปลูกมะพร้าว โดยหนักที่สุดคือสมุทรสงครามที่ −63.0%</a:t>
+              <a:t>รายได้จากพืชค่ากลางเพิ่มขึ้น +16.4% แต่มีสี่จังหวัดที่ลดลง — ทั้งหมดอยู่ในแหล่งปลูกมะพร้าว โดยหนักที่สุดคือสมุทรสงครามที่ −63.5%</a:t>
             </a:r>
           </a:p>
         </p:txBody>
@@ -31842,7 +31842,7 @@
                 </a:solidFill>
                 <a:latin typeface="Kanit"/>
               </a:rPr>
-              <a:t>รายได้ขนส่งขยับ −2.8% จากตัวเลขราคาน้ำมันระดับประเทศตัวเดียว โดยไม่มีข้อมูลค่าขนส่งของไทยรองรับ ส่วนภัยแล้งเป็นแบบจำลองปริมาณฝน — ไม่มีใครลงพื้นที่ไปเดินดูอำเภอเหล่านั้น</a:t>
+              <a:t>รายได้ขนส่งขยับ −4.8% จากตัวเลขราคาน้ำมันระดับประเทศตัวเดียว โดยไม่มีข้อมูลค่าขนส่งของไทยรองรับ ส่วนภัยแล้งเป็นแบบจำลองปริมาณฝน — ไม่มีใครลงพื้นที่ไปเดินดูอำเภอเหล่านั้น</a:t>
             </a:r>
           </a:p>
         </p:txBody>
@@ -32047,7 +32047,7 @@
                 </a:solidFill>
                 <a:latin typeface="Kanit"/>
               </a:rPr>
-              <a:t>รุ่นข้อมูล — ราคาโลก 2026M06 · ราคาหน้าฟาร์มไทย 2026-08-28 · ประวัติราคาไทย 2026-08-29 · ต้นทุนการผลิตพืช สศก. ไจอัป 2568 (ปีเพาะปลูก 2568/69, ประมาณการ สศก. มี.ค. 2569) · ภัยแล้ง 2026-06-21 · เงินเฟ้อ 2026-05 · GDP 2026 ไตรมาส 1 · IMF WEO 2026 · ดัชนีราคาขายต่อ 2026-05 · ยอดจดทะเบียนถึง 2026-01 · หนี้ครัวเรือน สสช. SES 2566 · ค่าจ้าง สสช. LFS 2568 · ข้อมูลตรวจวัด 2026-09-02</a:t>
+              <a:t>รุ่นข้อมูล — ราคาโลก 2026M06 · ราคาหน้าฟาร์มไทย 2026-09-03 · ประวัติราคาไทย 2026-08-29 · ต้นทุนการผลิตพืช สศก. ไจอัป 2568 (ปีเพาะปลูก 2568/69, ประมาณการ สศก. มี.ค. 2569) · ภัยแล้ง 2026-06-21 · เงินเฟ้อ 2026-05 · GDP 2026 ไตรมาส 1 · IMF WEO 2026 · ดัชนีราคาขายต่อ 2026-05 · ยอดจดทะเบียนถึง 2026-01 · หนี้ครัวเรือน สสช. SES 2566 · ค่าจ้าง สสช. LFS 2568 · ข้อมูลตรวจวัด 2026-09-05</a:t>
             </a:r>
           </a:p>
         </p:txBody>
@@ -32546,7 +32546,7 @@
               <a:t>Not on the world index — the farm gate (ราคาที่เกษตรกรขายได้) says otherwise.
 • Five of seventeen Thai farm-gate prices are falling year on year.
 • Beef: farm gate −6.1% vs world index +8.8%.
-• Margin over price: a 26% price move becomes an 86% swing in crop income.</a:t>
+• Margin over price: a 26% price move becomes an 85% swing in crop income.</a:t>
             </a:r>
           </a:p>
         </p:txBody>
@@ -37087,7 +37087,7 @@
                 </a:solidFill>
                 <a:latin typeface="Kanit"/>
               </a:rPr>
-              <a:t>338 จาก 928 อำเภอ · แม่น้ำเกินระดับ 131 จาก 792 สถานี</a:t>
+              <a:t>338 จาก 928 อำเภอ · แม่น้ำเกินระดับ 123 จาก 793 สถานี</a:t>
             </a:r>
           </a:p>
         </p:txBody>
@@ -37859,7 +37859,7 @@
                           </a:solidFill>
                           <a:latin typeface="Kanit"/>
                         </a:rPr>
-                        <a:t>28/157</a:t>
+                        <a:t>26/157</a:t>
                       </a:r>
                     </a:p>
                   </a:txBody>
@@ -38091,7 +38091,7 @@
                           </a:solidFill>
                           <a:latin typeface="Kanit"/>
                         </a:rPr>
-                        <a:t>17/274</a:t>
+                        <a:t>19/274</a:t>
                       </a:r>
                     </a:p>
                   </a:txBody>
@@ -38323,7 +38323,7 @@
                           </a:solidFill>
                           <a:latin typeface="Kanit"/>
                         </a:rPr>
-                        <a:t>25/167</a:t>
+                        <a:t>26/168</a:t>
                       </a:r>
                     </a:p>
                   </a:txBody>
@@ -38555,7 +38555,7 @@
                           </a:solidFill>
                           <a:latin typeface="Kanit"/>
                         </a:rPr>
-                        <a:t>16/51</a:t>
+                        <a:t>15/51</a:t>
                       </a:r>
                     </a:p>
                   </a:txBody>
@@ -38787,7 +38787,7 @@
                           </a:solidFill>
                           <a:latin typeface="Kanit"/>
                         </a:rPr>
-                        <a:t>45/143</a:t>
+                        <a:t>37/143</a:t>
                       </a:r>
                     </a:p>
                   </a:txBody>
@@ -39936,7 +39936,7 @@
                           </a:solidFill>
                           <a:latin typeface="Kanit"/>
                         </a:rPr>
-                        <a:t>−67.4%</a:t>
+                        <a:t>−67.9%</a:t>
                       </a:r>
                     </a:p>
                   </a:txBody>
@@ -40791,7 +40791,7 @@
                 </a:solidFill>
                 <a:latin typeface="Kanit"/>
               </a:rPr>
-              <a:t>ราคา วัดจริง — ราคาหน้าฟาร์มไทยจากราคารายวันของ NABC และราคาอ้อยประกาศของ สอน. ราคาล่าสุด 2026-08-28 การเปลี่ยนแปลงหกเดือนคำนวณจากข้อมูลรายเดือนของ NABC เอง (thai_price_history รุ่นข้อมูล 2026-08-29) พืชที่ไม่มีข้อมูลรายเดือนจะกำกับไว้ ไม่ประมาณการขึ้นมา แหล่งผลิตเป็นการอ่านแบบ ประมาณการ ว่าสินค้าแต่ละชนิดปลูกที่ไหน และแหล่งผลิตทับซ้อนกันได้ บัญชีอาชีพเกษตรเป็นข้อมูลของเราเองและ วัดจริง — บัญชีที่บันทึกอาชีพว่า เกษตร ในจังหวัดแหล่งผลิต จากฐานข้อมูล 382,735 บัญชี ณ 2026-07 ไม่เผยแพร่ช่องที่มีน้อยกว่า 30 บัญชี คนกลุ่มนี้อาศัยอยู่ในพื้นที่ที่ปลูกพืชนั้น แต่ไม่ได้ยืนยันว่าปลูกพืชนั้นเอง</a:t>
+              <a:t>ราคา วัดจริง — ราคาหน้าฟาร์มไทยจากราคารายวันของ NABC และราคาอ้อยประกาศของ สอน. ราคาล่าสุด 2026-09-03 การเปลี่ยนแปลงหกเดือนคำนวณจากข้อมูลรายเดือนของ NABC เอง (thai_price_history รุ่นข้อมูล 2026-08-29) พืชที่ไม่มีข้อมูลรายเดือนจะกำกับไว้ ไม่ประมาณการขึ้นมา แหล่งผลิตเป็นการอ่านแบบ ประมาณการ ว่าสินค้าแต่ละชนิดปลูกที่ไหน และแหล่งผลิตทับซ้อนกันได้ บัญชีอาชีพเกษตรเป็นข้อมูลของเราเองและ วัดจริง — บัญชีที่บันทึกอาชีพว่า เกษตร ในจังหวัดแหล่งผลิต จากฐานข้อมูล 382,735 บัญชี ณ 2026-07 ไม่เผยแพร่ช่องที่มีน้อยกว่า 30 บัญชี คนกลุ่มนี้อาศัยอยู่ในพื้นที่ที่ปลูกพืชนั้น แต่ไม่ได้ยืนยันว่าปลูกพืชนั้นเอง</a:t>
             </a:r>
           </a:p>
         </p:txBody>
@@ -44679,7 +44679,7 @@
                 </a:solidFill>
                 <a:latin typeface="Kanit"/>
               </a:rPr>
-              <a:t>มะพร้าว −67.4% สับปะรด −18.4% อ้อย −17.9% เทียบปีก่อน</a:t>
+              <a:t>มะพร้าว −67.9% สับปะรด −18.4% อ้อย −17.9% เทียบปีก่อน</a:t>
             </a:r>
           </a:p>
         </p:txBody>
@@ -44805,7 +44805,7 @@
                 </a:solidFill>
                 <a:latin typeface="Kanit"/>
               </a:rPr>
-              <a:t>+16.8%</a:t>
+              <a:t>+16.4%</a:t>
             </a:r>
           </a:p>
         </p:txBody>
@@ -45279,7 +45279,7 @@
                           </a:solidFill>
                           <a:latin typeface="Kanit"/>
                         </a:rPr>
-                        <a:t>+6.7%</a:t>
+                        <a:t>+6.2%</a:t>
                       </a:r>
                     </a:p>
                   </a:txBody>
@@ -45348,7 +45348,7 @@
                           </a:solidFill>
                           <a:latin typeface="Kanit"/>
                         </a:rPr>
-                        <a:t>-63.0%</a:t>
+                        <a:t>-63.5%</a:t>
                       </a:r>
                     </a:p>
                   </a:txBody>
@@ -45419,7 +45419,7 @@
                           </a:solidFill>
                           <a:latin typeface="Kanit"/>
                         </a:rPr>
-                        <a:t>+15.9%</a:t>
+                        <a:t>+15.4%</a:t>
                       </a:r>
                     </a:p>
                   </a:txBody>
@@ -45488,7 +45488,7 @@
                           </a:solidFill>
                           <a:latin typeface="Kanit"/>
                         </a:rPr>
-                        <a:t>+10.1%</a:t>
+                        <a:t>+9.6%</a:t>
                       </a:r>
                     </a:p>
                   </a:txBody>
@@ -45559,7 +45559,7 @@
                           </a:solidFill>
                           <a:latin typeface="Kanit"/>
                         </a:rPr>
-                        <a:t>+17.3%</a:t>
+                        <a:t>+16.9%</a:t>
                       </a:r>
                     </a:p>
                   </a:txBody>
@@ -45628,7 +45628,7 @@
                           </a:solidFill>
                           <a:latin typeface="Kanit"/>
                         </a:rPr>
-                        <a:t>+8.6%</a:t>
+                        <a:t>+8.3%</a:t>
                       </a:r>
                     </a:p>
                   </a:txBody>
@@ -45699,7 +45699,7 @@
                           </a:solidFill>
                           <a:latin typeface="Kanit"/>
                         </a:rPr>
-                        <a:t>+24.9%</a:t>
+                        <a:t>+24.8%</a:t>
                       </a:r>
                     </a:p>
                   </a:txBody>
@@ -45768,7 +45768,7 @@
                           </a:solidFill>
                           <a:latin typeface="Kanit"/>
                         </a:rPr>
-                        <a:t>+11.6%</a:t>
+                        <a:t>+11.3%</a:t>
                       </a:r>
                     </a:p>
                   </a:txBody>
@@ -45908,7 +45908,7 @@
                           </a:solidFill>
                           <a:latin typeface="Kanit"/>
                         </a:rPr>
-                        <a:t>+26.9%</a:t>
+                        <a:t>+26.8%</a:t>
                       </a:r>
                     </a:p>
                   </a:txBody>
@@ -46084,8 +46084,8 @@
                 </a:solidFill>
                 <a:latin typeface="Kanit"/>
               </a:rPr>
-              <a:t>•  ราคาหน้าฟาร์ม: ยางพารา +40% มันสำปะหลัง +74% ปาล์ม +23% ข้าว +14% รายได้จากพืชเพิ่มขึ้นทุกภาค
-•  มีสี่จังหวัดที่ลดลง — ทั้งหมดเป็นมะพร้าว และอยู่ฝั่งอ่าวไทยตะวันตก ราคามะพร้าวลดลง 67%
+              <a:t>•  ราคาหน้าฟาร์ม: ยางพารา +40% มันสำปะหลัง +75% ปาล์ม +23% ข้าว +13% รายได้จากพืชเพิ่มขึ้นทุกภาค
+•  มีสี่จังหวัดที่ลดลง — ทั้งหมดเป็นมะพร้าว และอยู่ฝั่งอ่าวไทยตะวันตก ราคามะพร้าวลดลง 68%
 •  กำไรบนกระดาษยังไม่ใช่เงินสด — ตารางถัดไปหักราคาด้วยต้นทุน</a:t>
             </a:r>
           </a:p>
@@ -46387,7 +46387,7 @@
                           </a:solidFill>
                           <a:latin typeface="Kanit"/>
                         </a:rPr>
-                        <a:t>+18.0%</a:t>
+                        <a:t>+17.6%</a:t>
                       </a:r>
                     </a:p>
                   </a:txBody>
@@ -46550,7 +46550,7 @@
                           </a:solidFill>
                           <a:latin typeface="Kanit"/>
                         </a:rPr>
-                        <a:t>+21.7%</a:t>
+                        <a:t>+21.3%</a:t>
                       </a:r>
                     </a:p>
                   </a:txBody>
@@ -46713,7 +46713,7 @@
                           </a:solidFill>
                           <a:latin typeface="Kanit"/>
                         </a:rPr>
-                        <a:t>+11.8%</a:t>
+                        <a:t>+11.3%</a:t>
                       </a:r>
                     </a:p>
                   </a:txBody>
@@ -47039,7 +47039,7 @@
                           </a:solidFill>
                           <a:latin typeface="Kanit"/>
                         </a:rPr>
-                        <a:t>+17.1%</a:t>
+                        <a:t>+16.7%</a:t>
                       </a:r>
                     </a:p>
                   </a:txBody>
@@ -47202,7 +47202,7 @@
                           </a:solidFill>
                           <a:latin typeface="Kanit"/>
                         </a:rPr>
-                        <a:t>+15.6%</a:t>
+                        <a:t>+15.1%</a:t>
                       </a:r>
                     </a:p>
                   </a:txBody>
@@ -48024,7 +48024,7 @@
                 </a:solidFill>
                 <a:latin typeface="Kanit"/>
               </a:rPr>
-              <a:t>เทียบปีก่อน −67.4%</a:t>
+              <a:t>เทียบปีก่อน −67.9%</a:t>
             </a:r>
           </a:p>
         </p:txBody>
@@ -48660,7 +48660,7 @@
                 </a:solidFill>
                 <a:latin typeface="Kanit"/>
               </a:rPr>
-              <a:t>เทียบปีก่อน +0.9%</a:t>
+              <a:t>เทียบปีก่อน +1.0%</a:t>
             </a:r>
           </a:p>
         </p:txBody>
@@ -48978,7 +48978,7 @@
                 </a:solidFill>
                 <a:latin typeface="Kanit"/>
               </a:rPr>
-              <a:t>เทียบปีก่อน +3.9%</a:t>
+              <a:t>เทียบปีก่อน +4.5%</a:t>
             </a:r>
           </a:p>
         </p:txBody>
@@ -49296,7 +49296,7 @@
                 </a:solidFill>
                 <a:latin typeface="Kanit"/>
               </a:rPr>
-              <a:t>เทียบปีก่อน +4.4%</a:t>
+              <a:t>เทียบปีก่อน +5.6%</a:t>
             </a:r>
           </a:p>
         </p:txBody>
@@ -49536,6 +49536,642 @@
                 </a:solidFill>
                 <a:latin typeface="Kanit"/>
               </a:rPr>
+              <a:t>ข้าวหอมมะลิ</a:t>
+            </a:r>
+          </a:p>
+        </p:txBody>
+      </p:sp>
+      <p:sp>
+        <p:nvSpPr>
+          <p:cNvPr id="51" name="TextBox 50"/>
+          <p:cNvSpPr txBox="1"/>
+          <p:nvPr/>
+        </p:nvSpPr>
+        <p:spPr>
+          <a:xfrm>
+            <a:off x="411480" y="3218687"/>
+            <a:ext cx="2156155" cy="125730"/>
+          </a:xfrm>
+          <a:prstGeom prst="rect">
+            <a:avLst/>
+          </a:prstGeom>
+          <a:noFill/>
+        </p:spPr>
+        <p:txBody>
+          <a:bodyPr wrap="square" lIns="0" rIns="0" tIns="0" bIns="0" anchor="t">
+            <a:noAutofit/>
+          </a:bodyPr>
+          <a:lstStyle/>
+          <a:p>
+            <a:pPr algn="l">
+              <a:lnSpc>
+                <a:spcPts val="990"/>
+              </a:lnSpc>
+            </a:pPr>
+            <a:r>
+              <a:rPr sz="750" b="0">
+                <a:solidFill>
+                  <a:srgbClr val="606060"/>
+                </a:solidFill>
+                <a:latin typeface="Kanit"/>
+              </a:rPr>
+              <a:t>฿17,763 /ตัน · อีสาน·เหนือ·กลาง</a:t>
+            </a:r>
+          </a:p>
+        </p:txBody>
+      </p:sp>
+      <p:sp>
+        <p:nvSpPr>
+          <p:cNvPr id="52" name="TextBox 51"/>
+          <p:cNvSpPr txBox="1"/>
+          <p:nvPr/>
+        </p:nvSpPr>
+        <p:spPr>
+          <a:xfrm>
+            <a:off x="411480" y="3351275"/>
+            <a:ext cx="1078077" cy="134112"/>
+          </a:xfrm>
+          <a:prstGeom prst="rect">
+            <a:avLst/>
+          </a:prstGeom>
+          <a:noFill/>
+        </p:spPr>
+        <p:txBody>
+          <a:bodyPr wrap="square" lIns="0" rIns="0" tIns="0" bIns="0" anchor="t">
+            <a:noAutofit/>
+          </a:bodyPr>
+          <a:lstStyle/>
+          <a:p>
+            <a:pPr algn="l">
+              <a:lnSpc>
+                <a:spcPts val="1056"/>
+              </a:lnSpc>
+            </a:pPr>
+            <a:r>
+              <a:rPr sz="800" b="1">
+                <a:solidFill>
+                  <a:srgbClr val="15795F"/>
+                </a:solidFill>
+                <a:latin typeface="Kanit"/>
+              </a:rPr>
+              <a:t>เทียบปีก่อน +13.4%</a:t>
+            </a:r>
+          </a:p>
+        </p:txBody>
+      </p:sp>
+      <p:sp>
+        <p:nvSpPr>
+          <p:cNvPr id="53" name="TextBox 52"/>
+          <p:cNvSpPr txBox="1"/>
+          <p:nvPr/>
+        </p:nvSpPr>
+        <p:spPr>
+          <a:xfrm>
+            <a:off x="1489557" y="3351275"/>
+            <a:ext cx="1078077" cy="134112"/>
+          </a:xfrm>
+          <a:prstGeom prst="rect">
+            <a:avLst/>
+          </a:prstGeom>
+          <a:noFill/>
+        </p:spPr>
+        <p:txBody>
+          <a:bodyPr wrap="square" lIns="0" rIns="0" tIns="0" bIns="0" anchor="t">
+            <a:noAutofit/>
+          </a:bodyPr>
+          <a:lstStyle/>
+          <a:p>
+            <a:pPr algn="l">
+              <a:lnSpc>
+                <a:spcPts val="1056"/>
+              </a:lnSpc>
+            </a:pPr>
+            <a:r>
+              <a:rPr sz="800" b="1">
+                <a:solidFill>
+                  <a:srgbClr val="15795F"/>
+                </a:solidFill>
+                <a:latin typeface="Kanit"/>
+              </a:rPr>
+              <a:t>6 เดือน +7.7%</a:t>
+            </a:r>
+          </a:p>
+        </p:txBody>
+      </p:sp>
+      <p:sp>
+        <p:nvSpPr>
+          <p:cNvPr id="54" name="Rectangle 53"/>
+          <p:cNvSpPr/>
+          <p:nvPr/>
+        </p:nvSpPr>
+        <p:spPr>
+          <a:xfrm>
+            <a:off x="411480" y="3506724"/>
+            <a:ext cx="2156155" cy="548640"/>
+          </a:xfrm>
+          <a:prstGeom prst="rect">
+            <a:avLst/>
+          </a:prstGeom>
+          <a:solidFill>
+            <a:srgbClr val="FBFCFE"/>
+          </a:solidFill>
+          <a:ln w="9525">
+            <a:solidFill>
+              <a:srgbClr val="D9DEE9"/>
+            </a:solidFill>
+          </a:ln>
+          <a:effectLst/>
+        </p:spPr>
+        <p:style>
+          <a:lnRef idx="1">
+            <a:schemeClr val="accent1"/>
+          </a:lnRef>
+          <a:fillRef idx="3">
+            <a:schemeClr val="accent1"/>
+          </a:fillRef>
+          <a:effectRef idx="2">
+            <a:schemeClr val="accent1"/>
+          </a:effectRef>
+          <a:fontRef idx="minor">
+            <a:schemeClr val="lt1"/>
+          </a:fontRef>
+        </p:style>
+        <p:txBody>
+          <a:bodyPr rtlCol="0" anchor="ctr" wrap="none"/>
+          <a:lstStyle/>
+          <a:p>
+            <a:pPr algn="ctr"/>
+          </a:p>
+        </p:txBody>
+      </p:sp>
+      <p:sp>
+        <p:nvSpPr>
+          <p:cNvPr id="55" name="Freeform 54"/>
+          <p:cNvSpPr/>
+          <p:nvPr/>
+        </p:nvSpPr>
+        <p:spPr>
+          <a:xfrm>
+            <a:off x="457200" y="3552444"/>
+            <a:ext cx="2064715" cy="457200"/>
+          </a:xfrm>
+          <a:custGeom>
+            <a:avLst/>
+            <a:gdLst/>
+            <a:ahLst/>
+            <a:cxnLst/>
+            <a:rect l="l" t="t" r="r" b="b"/>
+            <a:pathLst>
+              <a:path w="2064715" h="457200">
+                <a:moveTo>
+                  <a:pt x="0" y="457200"/>
+                </a:moveTo>
+                <a:lnTo>
+                  <a:pt x="412943" y="341371"/>
+                </a:lnTo>
+                <a:lnTo>
+                  <a:pt x="825886" y="153981"/>
+                </a:lnTo>
+                <a:lnTo>
+                  <a:pt x="1238829" y="34219"/>
+                </a:lnTo>
+                <a:lnTo>
+                  <a:pt x="1651772" y="23720"/>
+                </a:lnTo>
+                <a:lnTo>
+                  <a:pt x="2064715" y="0"/>
+                </a:lnTo>
+              </a:path>
+            </a:pathLst>
+          </a:custGeom>
+          <a:noFill/>
+          <a:ln w="20320">
+            <a:solidFill>
+              <a:srgbClr val="15795F"/>
+            </a:solidFill>
+          </a:ln>
+          <a:effectLst/>
+        </p:spPr>
+        <p:style>
+          <a:lnRef idx="1">
+            <a:schemeClr val="accent1"/>
+          </a:lnRef>
+          <a:fillRef idx="3">
+            <a:schemeClr val="accent1"/>
+          </a:fillRef>
+          <a:effectRef idx="2">
+            <a:schemeClr val="accent1"/>
+          </a:effectRef>
+          <a:fontRef idx="minor">
+            <a:schemeClr val="lt1"/>
+          </a:fontRef>
+        </p:style>
+        <p:txBody>
+          <a:bodyPr rtlCol="0" anchor="ctr"/>
+          <a:lstStyle/>
+          <a:p>
+            <a:pPr algn="ctr"/>
+          </a:p>
+        </p:txBody>
+      </p:sp>
+      <p:sp>
+        <p:nvSpPr>
+          <p:cNvPr id="56" name="Rounded Rectangle 55"/>
+          <p:cNvSpPr/>
+          <p:nvPr/>
+        </p:nvSpPr>
+        <p:spPr>
+          <a:xfrm>
+            <a:off x="2480767" y="3511296"/>
+            <a:ext cx="82296" cy="82296"/>
+          </a:xfrm>
+          <a:prstGeom prst="roundRect">
+            <a:avLst>
+              <a:gd name="adj" fmla="val 50000"/>
+            </a:avLst>
+          </a:prstGeom>
+          <a:solidFill>
+            <a:srgbClr val="15795F"/>
+          </a:solidFill>
+          <a:ln>
+            <a:noFill/>
+          </a:ln>
+          <a:effectLst/>
+        </p:spPr>
+        <p:style>
+          <a:lnRef idx="1">
+            <a:schemeClr val="accent1"/>
+          </a:lnRef>
+          <a:fillRef idx="3">
+            <a:schemeClr val="accent1"/>
+          </a:fillRef>
+          <a:effectRef idx="2">
+            <a:schemeClr val="accent1"/>
+          </a:effectRef>
+          <a:fontRef idx="minor">
+            <a:schemeClr val="lt1"/>
+          </a:fontRef>
+        </p:style>
+        <p:txBody>
+          <a:bodyPr rtlCol="0" anchor="ctr" wrap="none"/>
+          <a:lstStyle/>
+          <a:p>
+            <a:pPr algn="ctr"/>
+          </a:p>
+        </p:txBody>
+      </p:sp>
+      <p:sp>
+        <p:nvSpPr>
+          <p:cNvPr id="57" name="TextBox 56"/>
+          <p:cNvSpPr txBox="1"/>
+          <p:nvPr/>
+        </p:nvSpPr>
+        <p:spPr>
+          <a:xfrm>
+            <a:off x="2713939" y="3076956"/>
+            <a:ext cx="2156155" cy="150876"/>
+          </a:xfrm>
+          <a:prstGeom prst="rect">
+            <a:avLst/>
+          </a:prstGeom>
+          <a:noFill/>
+        </p:spPr>
+        <p:txBody>
+          <a:bodyPr wrap="square" lIns="0" rIns="0" tIns="0" bIns="0" anchor="t">
+            <a:noAutofit/>
+          </a:bodyPr>
+          <a:lstStyle/>
+          <a:p>
+            <a:pPr algn="l">
+              <a:lnSpc>
+                <a:spcPts val="1188"/>
+              </a:lnSpc>
+            </a:pPr>
+            <a:r>
+              <a:rPr sz="900" b="1">
+                <a:solidFill>
+                  <a:srgbClr val="1E2F5C"/>
+                </a:solidFill>
+                <a:latin typeface="Kanit"/>
+              </a:rPr>
+              <a:t>ข้าวโพดเลี้ยงสัตว์</a:t>
+            </a:r>
+          </a:p>
+        </p:txBody>
+      </p:sp>
+      <p:sp>
+        <p:nvSpPr>
+          <p:cNvPr id="58" name="TextBox 57"/>
+          <p:cNvSpPr txBox="1"/>
+          <p:nvPr/>
+        </p:nvSpPr>
+        <p:spPr>
+          <a:xfrm>
+            <a:off x="2713939" y="3218687"/>
+            <a:ext cx="2156155" cy="125730"/>
+          </a:xfrm>
+          <a:prstGeom prst="rect">
+            <a:avLst/>
+          </a:prstGeom>
+          <a:noFill/>
+        </p:spPr>
+        <p:txBody>
+          <a:bodyPr wrap="square" lIns="0" rIns="0" tIns="0" bIns="0" anchor="t">
+            <a:noAutofit/>
+          </a:bodyPr>
+          <a:lstStyle/>
+          <a:p>
+            <a:pPr algn="l">
+              <a:lnSpc>
+                <a:spcPts val="990"/>
+              </a:lnSpc>
+            </a:pPr>
+            <a:r>
+              <a:rPr sz="750" b="0">
+                <a:solidFill>
+                  <a:srgbClr val="606060"/>
+                </a:solidFill>
+                <a:latin typeface="Kanit"/>
+              </a:rPr>
+              <a:t>฿9.76 /กก. · เหนือ</a:t>
+            </a:r>
+          </a:p>
+        </p:txBody>
+      </p:sp>
+      <p:sp>
+        <p:nvSpPr>
+          <p:cNvPr id="59" name="TextBox 58"/>
+          <p:cNvSpPr txBox="1"/>
+          <p:nvPr/>
+        </p:nvSpPr>
+        <p:spPr>
+          <a:xfrm>
+            <a:off x="2713939" y="3351275"/>
+            <a:ext cx="1078077" cy="134112"/>
+          </a:xfrm>
+          <a:prstGeom prst="rect">
+            <a:avLst/>
+          </a:prstGeom>
+          <a:noFill/>
+        </p:spPr>
+        <p:txBody>
+          <a:bodyPr wrap="square" lIns="0" rIns="0" tIns="0" bIns="0" anchor="t">
+            <a:noAutofit/>
+          </a:bodyPr>
+          <a:lstStyle/>
+          <a:p>
+            <a:pPr algn="l">
+              <a:lnSpc>
+                <a:spcPts val="1056"/>
+              </a:lnSpc>
+            </a:pPr>
+            <a:r>
+              <a:rPr sz="800" b="1">
+                <a:solidFill>
+                  <a:srgbClr val="15795F"/>
+                </a:solidFill>
+                <a:latin typeface="Kanit"/>
+              </a:rPr>
+              <a:t>เทียบปีก่อน +15.5%</a:t>
+            </a:r>
+          </a:p>
+        </p:txBody>
+      </p:sp>
+      <p:sp>
+        <p:nvSpPr>
+          <p:cNvPr id="60" name="TextBox 59"/>
+          <p:cNvSpPr txBox="1"/>
+          <p:nvPr/>
+        </p:nvSpPr>
+        <p:spPr>
+          <a:xfrm>
+            <a:off x="3792016" y="3351275"/>
+            <a:ext cx="1078077" cy="134112"/>
+          </a:xfrm>
+          <a:prstGeom prst="rect">
+            <a:avLst/>
+          </a:prstGeom>
+          <a:noFill/>
+        </p:spPr>
+        <p:txBody>
+          <a:bodyPr wrap="square" lIns="0" rIns="0" tIns="0" bIns="0" anchor="t">
+            <a:noAutofit/>
+          </a:bodyPr>
+          <a:lstStyle/>
+          <a:p>
+            <a:pPr algn="l">
+              <a:lnSpc>
+                <a:spcPts val="1056"/>
+              </a:lnSpc>
+            </a:pPr>
+            <a:r>
+              <a:rPr sz="800" b="1">
+                <a:solidFill>
+                  <a:srgbClr val="15795F"/>
+                </a:solidFill>
+                <a:latin typeface="Kanit"/>
+              </a:rPr>
+              <a:t>6 เดือน +9.7%</a:t>
+            </a:r>
+          </a:p>
+        </p:txBody>
+      </p:sp>
+      <p:sp>
+        <p:nvSpPr>
+          <p:cNvPr id="61" name="Rectangle 60"/>
+          <p:cNvSpPr/>
+          <p:nvPr/>
+        </p:nvSpPr>
+        <p:spPr>
+          <a:xfrm>
+            <a:off x="2713939" y="3506724"/>
+            <a:ext cx="2156155" cy="548640"/>
+          </a:xfrm>
+          <a:prstGeom prst="rect">
+            <a:avLst/>
+          </a:prstGeom>
+          <a:solidFill>
+            <a:srgbClr val="FBFCFE"/>
+          </a:solidFill>
+          <a:ln w="9525">
+            <a:solidFill>
+              <a:srgbClr val="D9DEE9"/>
+            </a:solidFill>
+          </a:ln>
+          <a:effectLst/>
+        </p:spPr>
+        <p:style>
+          <a:lnRef idx="1">
+            <a:schemeClr val="accent1"/>
+          </a:lnRef>
+          <a:fillRef idx="3">
+            <a:schemeClr val="accent1"/>
+          </a:fillRef>
+          <a:effectRef idx="2">
+            <a:schemeClr val="accent1"/>
+          </a:effectRef>
+          <a:fontRef idx="minor">
+            <a:schemeClr val="lt1"/>
+          </a:fontRef>
+        </p:style>
+        <p:txBody>
+          <a:bodyPr rtlCol="0" anchor="ctr" wrap="none"/>
+          <a:lstStyle/>
+          <a:p>
+            <a:pPr algn="ctr"/>
+          </a:p>
+        </p:txBody>
+      </p:sp>
+      <p:sp>
+        <p:nvSpPr>
+          <p:cNvPr id="62" name="Freeform 61"/>
+          <p:cNvSpPr/>
+          <p:nvPr/>
+        </p:nvSpPr>
+        <p:spPr>
+          <a:xfrm>
+            <a:off x="2759659" y="3552444"/>
+            <a:ext cx="2064715" cy="457200"/>
+          </a:xfrm>
+          <a:custGeom>
+            <a:avLst/>
+            <a:gdLst/>
+            <a:ahLst/>
+            <a:cxnLst/>
+            <a:rect l="l" t="t" r="r" b="b"/>
+            <a:pathLst>
+              <a:path w="2064715" h="457200">
+                <a:moveTo>
+                  <a:pt x="0" y="457200"/>
+                </a:moveTo>
+                <a:lnTo>
+                  <a:pt x="412943" y="350931"/>
+                </a:lnTo>
+                <a:lnTo>
+                  <a:pt x="825886" y="79083"/>
+                </a:lnTo>
+                <a:lnTo>
+                  <a:pt x="1238829" y="0"/>
+                </a:lnTo>
+                <a:lnTo>
+                  <a:pt x="1651772" y="54369"/>
+                </a:lnTo>
+                <a:lnTo>
+                  <a:pt x="2064715" y="294090"/>
+                </a:lnTo>
+              </a:path>
+            </a:pathLst>
+          </a:custGeom>
+          <a:noFill/>
+          <a:ln w="20320">
+            <a:solidFill>
+              <a:srgbClr val="15795F"/>
+            </a:solidFill>
+          </a:ln>
+          <a:effectLst/>
+        </p:spPr>
+        <p:style>
+          <a:lnRef idx="1">
+            <a:schemeClr val="accent1"/>
+          </a:lnRef>
+          <a:fillRef idx="3">
+            <a:schemeClr val="accent1"/>
+          </a:fillRef>
+          <a:effectRef idx="2">
+            <a:schemeClr val="accent1"/>
+          </a:effectRef>
+          <a:fontRef idx="minor">
+            <a:schemeClr val="lt1"/>
+          </a:fontRef>
+        </p:style>
+        <p:txBody>
+          <a:bodyPr rtlCol="0" anchor="ctr"/>
+          <a:lstStyle/>
+          <a:p>
+            <a:pPr algn="ctr"/>
+          </a:p>
+        </p:txBody>
+      </p:sp>
+      <p:sp>
+        <p:nvSpPr>
+          <p:cNvPr id="63" name="Rounded Rectangle 62"/>
+          <p:cNvSpPr/>
+          <p:nvPr/>
+        </p:nvSpPr>
+        <p:spPr>
+          <a:xfrm>
+            <a:off x="4783226" y="3805386"/>
+            <a:ext cx="82296" cy="82296"/>
+          </a:xfrm>
+          <a:prstGeom prst="roundRect">
+            <a:avLst>
+              <a:gd name="adj" fmla="val 50000"/>
+            </a:avLst>
+          </a:prstGeom>
+          <a:solidFill>
+            <a:srgbClr val="15795F"/>
+          </a:solidFill>
+          <a:ln>
+            <a:noFill/>
+          </a:ln>
+          <a:effectLst/>
+        </p:spPr>
+        <p:style>
+          <a:lnRef idx="1">
+            <a:schemeClr val="accent1"/>
+          </a:lnRef>
+          <a:fillRef idx="3">
+            <a:schemeClr val="accent1"/>
+          </a:fillRef>
+          <a:effectRef idx="2">
+            <a:schemeClr val="accent1"/>
+          </a:effectRef>
+          <a:fontRef idx="minor">
+            <a:schemeClr val="lt1"/>
+          </a:fontRef>
+        </p:style>
+        <p:txBody>
+          <a:bodyPr rtlCol="0" anchor="ctr" wrap="none"/>
+          <a:lstStyle/>
+          <a:p>
+            <a:pPr algn="ctr"/>
+          </a:p>
+        </p:txBody>
+      </p:sp>
+      <p:sp>
+        <p:nvSpPr>
+          <p:cNvPr id="64" name="TextBox 63"/>
+          <p:cNvSpPr txBox="1"/>
+          <p:nvPr/>
+        </p:nvSpPr>
+        <p:spPr>
+          <a:xfrm>
+            <a:off x="5016398" y="3076956"/>
+            <a:ext cx="2156155" cy="150876"/>
+          </a:xfrm>
+          <a:prstGeom prst="rect">
+            <a:avLst/>
+          </a:prstGeom>
+          <a:noFill/>
+        </p:spPr>
+        <p:txBody>
+          <a:bodyPr wrap="square" lIns="0" rIns="0" tIns="0" bIns="0" anchor="t">
+            <a:noAutofit/>
+          </a:bodyPr>
+          <a:lstStyle/>
+          <a:p>
+            <a:pPr algn="l">
+              <a:lnSpc>
+                <a:spcPts val="1188"/>
+              </a:lnSpc>
+            </a:pPr>
+            <a:r>
+              <a:rPr sz="900" b="1">
+                <a:solidFill>
+                  <a:srgbClr val="1E2F5C"/>
+                </a:solidFill>
+                <a:latin typeface="Kanit"/>
+              </a:rPr>
               <a:t>สุกร</a:t>
             </a:r>
           </a:p>
@@ -49543,13 +50179,13 @@
       </p:sp>
       <p:sp>
         <p:nvSpPr>
-          <p:cNvPr id="51" name="TextBox 50"/>
+          <p:cNvPr id="65" name="TextBox 64"/>
           <p:cNvSpPr txBox="1"/>
           <p:nvPr/>
         </p:nvSpPr>
         <p:spPr>
           <a:xfrm>
-            <a:off x="411480" y="3218687"/>
+            <a:off x="5016398" y="3218687"/>
             <a:ext cx="2156155" cy="125730"/>
           </a:xfrm>
           <a:prstGeom prst="rect">
@@ -49582,13 +50218,13 @@
       </p:sp>
       <p:sp>
         <p:nvSpPr>
-          <p:cNvPr id="52" name="TextBox 51"/>
+          <p:cNvPr id="66" name="TextBox 65"/>
           <p:cNvSpPr txBox="1"/>
           <p:nvPr/>
         </p:nvSpPr>
         <p:spPr>
           <a:xfrm>
-            <a:off x="411480" y="3351275"/>
+            <a:off x="5016398" y="3351275"/>
             <a:ext cx="1078077" cy="134112"/>
           </a:xfrm>
           <a:prstGeom prst="rect">
@@ -49614,20 +50250,20 @@
                 </a:solidFill>
                 <a:latin typeface="Kanit"/>
               </a:rPr>
-              <a:t>เทียบปีก่อน +13.1%</a:t>
+              <a:t>เทียบปีก่อน +18.0%</a:t>
             </a:r>
           </a:p>
         </p:txBody>
       </p:sp>
       <p:sp>
         <p:nvSpPr>
-          <p:cNvPr id="53" name="TextBox 52"/>
+          <p:cNvPr id="67" name="TextBox 66"/>
           <p:cNvSpPr txBox="1"/>
           <p:nvPr/>
         </p:nvSpPr>
         <p:spPr>
           <a:xfrm>
-            <a:off x="1489557" y="3351275"/>
+            <a:off x="6094475" y="3351275"/>
             <a:ext cx="1078077" cy="134112"/>
           </a:xfrm>
           <a:prstGeom prst="rect">
@@ -49660,13 +50296,13 @@
       </p:sp>
       <p:sp>
         <p:nvSpPr>
-          <p:cNvPr id="54" name="Rectangle 53"/>
+          <p:cNvPr id="68" name="Rectangle 67"/>
           <p:cNvSpPr/>
           <p:nvPr/>
         </p:nvSpPr>
         <p:spPr>
           <a:xfrm>
-            <a:off x="411480" y="3506724"/>
+            <a:off x="5016398" y="3506724"/>
             <a:ext cx="2156155" cy="548640"/>
           </a:xfrm>
           <a:prstGeom prst="rect">
@@ -49706,13 +50342,13 @@
       </p:sp>
       <p:sp>
         <p:nvSpPr>
-          <p:cNvPr id="55" name="Freeform 54"/>
+          <p:cNvPr id="69" name="Freeform 68"/>
           <p:cNvSpPr/>
           <p:nvPr/>
         </p:nvSpPr>
         <p:spPr>
           <a:xfrm>
-            <a:off x="457200" y="3552444"/>
+            <a:off x="5062118" y="3552444"/>
             <a:ext cx="2064715" cy="457200"/>
           </a:xfrm>
           <a:custGeom>
@@ -49776,649 +50412,13 @@
       </p:sp>
       <p:sp>
         <p:nvSpPr>
-          <p:cNvPr id="56" name="Rounded Rectangle 55"/>
-          <p:cNvSpPr/>
-          <p:nvPr/>
-        </p:nvSpPr>
-        <p:spPr>
-          <a:xfrm>
-            <a:off x="2480767" y="3511296"/>
-            <a:ext cx="82296" cy="82296"/>
-          </a:xfrm>
-          <a:prstGeom prst="roundRect">
-            <a:avLst>
-              <a:gd name="adj" fmla="val 50000"/>
-            </a:avLst>
-          </a:prstGeom>
-          <a:solidFill>
-            <a:srgbClr val="15795F"/>
-          </a:solidFill>
-          <a:ln>
-            <a:noFill/>
-          </a:ln>
-          <a:effectLst/>
-        </p:spPr>
-        <p:style>
-          <a:lnRef idx="1">
-            <a:schemeClr val="accent1"/>
-          </a:lnRef>
-          <a:fillRef idx="3">
-            <a:schemeClr val="accent1"/>
-          </a:fillRef>
-          <a:effectRef idx="2">
-            <a:schemeClr val="accent1"/>
-          </a:effectRef>
-          <a:fontRef idx="minor">
-            <a:schemeClr val="lt1"/>
-          </a:fontRef>
-        </p:style>
-        <p:txBody>
-          <a:bodyPr rtlCol="0" anchor="ctr" wrap="none"/>
-          <a:lstStyle/>
-          <a:p>
-            <a:pPr algn="ctr"/>
-          </a:p>
-        </p:txBody>
-      </p:sp>
-      <p:sp>
-        <p:nvSpPr>
-          <p:cNvPr id="57" name="TextBox 56"/>
-          <p:cNvSpPr txBox="1"/>
-          <p:nvPr/>
-        </p:nvSpPr>
-        <p:spPr>
-          <a:xfrm>
-            <a:off x="2713939" y="3076956"/>
-            <a:ext cx="2156155" cy="150876"/>
-          </a:xfrm>
-          <a:prstGeom prst="rect">
-            <a:avLst/>
-          </a:prstGeom>
-          <a:noFill/>
-        </p:spPr>
-        <p:txBody>
-          <a:bodyPr wrap="square" lIns="0" rIns="0" tIns="0" bIns="0" anchor="t">
-            <a:noAutofit/>
-          </a:bodyPr>
-          <a:lstStyle/>
-          <a:p>
-            <a:pPr algn="l">
-              <a:lnSpc>
-                <a:spcPts val="1188"/>
-              </a:lnSpc>
-            </a:pPr>
-            <a:r>
-              <a:rPr sz="900" b="1">
-                <a:solidFill>
-                  <a:srgbClr val="1E2F5C"/>
-                </a:solidFill>
-                <a:latin typeface="Kanit"/>
-              </a:rPr>
-              <a:t>ข้าวหอมมะลิ</a:t>
-            </a:r>
-          </a:p>
-        </p:txBody>
-      </p:sp>
-      <p:sp>
-        <p:nvSpPr>
-          <p:cNvPr id="58" name="TextBox 57"/>
-          <p:cNvSpPr txBox="1"/>
-          <p:nvPr/>
-        </p:nvSpPr>
-        <p:spPr>
-          <a:xfrm>
-            <a:off x="2713939" y="3218687"/>
-            <a:ext cx="2156155" cy="125730"/>
-          </a:xfrm>
-          <a:prstGeom prst="rect">
-            <a:avLst/>
-          </a:prstGeom>
-          <a:noFill/>
-        </p:spPr>
-        <p:txBody>
-          <a:bodyPr wrap="square" lIns="0" rIns="0" tIns="0" bIns="0" anchor="t">
-            <a:noAutofit/>
-          </a:bodyPr>
-          <a:lstStyle/>
-          <a:p>
-            <a:pPr algn="l">
-              <a:lnSpc>
-                <a:spcPts val="990"/>
-              </a:lnSpc>
-            </a:pPr>
-            <a:r>
-              <a:rPr sz="750" b="0">
-                <a:solidFill>
-                  <a:srgbClr val="606060"/>
-                </a:solidFill>
-                <a:latin typeface="Kanit"/>
-              </a:rPr>
-              <a:t>฿17,763 /ตัน · อีสาน·เหนือ·กลาง</a:t>
-            </a:r>
-          </a:p>
-        </p:txBody>
-      </p:sp>
-      <p:sp>
-        <p:nvSpPr>
-          <p:cNvPr id="59" name="TextBox 58"/>
-          <p:cNvSpPr txBox="1"/>
-          <p:nvPr/>
-        </p:nvSpPr>
-        <p:spPr>
-          <a:xfrm>
-            <a:off x="2713939" y="3351275"/>
-            <a:ext cx="1078077" cy="134112"/>
-          </a:xfrm>
-          <a:prstGeom prst="rect">
-            <a:avLst/>
-          </a:prstGeom>
-          <a:noFill/>
-        </p:spPr>
-        <p:txBody>
-          <a:bodyPr wrap="square" lIns="0" rIns="0" tIns="0" bIns="0" anchor="t">
-            <a:noAutofit/>
-          </a:bodyPr>
-          <a:lstStyle/>
-          <a:p>
-            <a:pPr algn="l">
-              <a:lnSpc>
-                <a:spcPts val="1056"/>
-              </a:lnSpc>
-            </a:pPr>
-            <a:r>
-              <a:rPr sz="800" b="1">
-                <a:solidFill>
-                  <a:srgbClr val="15795F"/>
-                </a:solidFill>
-                <a:latin typeface="Kanit"/>
-              </a:rPr>
-              <a:t>เทียบปีก่อน +14.0%</a:t>
-            </a:r>
-          </a:p>
-        </p:txBody>
-      </p:sp>
-      <p:sp>
-        <p:nvSpPr>
-          <p:cNvPr id="60" name="TextBox 59"/>
-          <p:cNvSpPr txBox="1"/>
-          <p:nvPr/>
-        </p:nvSpPr>
-        <p:spPr>
-          <a:xfrm>
-            <a:off x="3792016" y="3351275"/>
-            <a:ext cx="1078077" cy="134112"/>
-          </a:xfrm>
-          <a:prstGeom prst="rect">
-            <a:avLst/>
-          </a:prstGeom>
-          <a:noFill/>
-        </p:spPr>
-        <p:txBody>
-          <a:bodyPr wrap="square" lIns="0" rIns="0" tIns="0" bIns="0" anchor="t">
-            <a:noAutofit/>
-          </a:bodyPr>
-          <a:lstStyle/>
-          <a:p>
-            <a:pPr algn="l">
-              <a:lnSpc>
-                <a:spcPts val="1056"/>
-              </a:lnSpc>
-            </a:pPr>
-            <a:r>
-              <a:rPr sz="800" b="1">
-                <a:solidFill>
-                  <a:srgbClr val="15795F"/>
-                </a:solidFill>
-                <a:latin typeface="Kanit"/>
-              </a:rPr>
-              <a:t>6 เดือน +7.7%</a:t>
-            </a:r>
-          </a:p>
-        </p:txBody>
-      </p:sp>
-      <p:sp>
-        <p:nvSpPr>
-          <p:cNvPr id="61" name="Rectangle 60"/>
-          <p:cNvSpPr/>
-          <p:nvPr/>
-        </p:nvSpPr>
-        <p:spPr>
-          <a:xfrm>
-            <a:off x="2713939" y="3506724"/>
-            <a:ext cx="2156155" cy="548640"/>
-          </a:xfrm>
-          <a:prstGeom prst="rect">
-            <a:avLst/>
-          </a:prstGeom>
-          <a:solidFill>
-            <a:srgbClr val="FBFCFE"/>
-          </a:solidFill>
-          <a:ln w="9525">
-            <a:solidFill>
-              <a:srgbClr val="D9DEE9"/>
-            </a:solidFill>
-          </a:ln>
-          <a:effectLst/>
-        </p:spPr>
-        <p:style>
-          <a:lnRef idx="1">
-            <a:schemeClr val="accent1"/>
-          </a:lnRef>
-          <a:fillRef idx="3">
-            <a:schemeClr val="accent1"/>
-          </a:fillRef>
-          <a:effectRef idx="2">
-            <a:schemeClr val="accent1"/>
-          </a:effectRef>
-          <a:fontRef idx="minor">
-            <a:schemeClr val="lt1"/>
-          </a:fontRef>
-        </p:style>
-        <p:txBody>
-          <a:bodyPr rtlCol="0" anchor="ctr" wrap="none"/>
-          <a:lstStyle/>
-          <a:p>
-            <a:pPr algn="ctr"/>
-          </a:p>
-        </p:txBody>
-      </p:sp>
-      <p:sp>
-        <p:nvSpPr>
-          <p:cNvPr id="62" name="Freeform 61"/>
-          <p:cNvSpPr/>
-          <p:nvPr/>
-        </p:nvSpPr>
-        <p:spPr>
-          <a:xfrm>
-            <a:off x="2759659" y="3552444"/>
-            <a:ext cx="2064715" cy="457200"/>
-          </a:xfrm>
-          <a:custGeom>
-            <a:avLst/>
-            <a:gdLst/>
-            <a:ahLst/>
-            <a:cxnLst/>
-            <a:rect l="l" t="t" r="r" b="b"/>
-            <a:pathLst>
-              <a:path w="2064715" h="457200">
-                <a:moveTo>
-                  <a:pt x="0" y="457200"/>
-                </a:moveTo>
-                <a:lnTo>
-                  <a:pt x="412943" y="341371"/>
-                </a:lnTo>
-                <a:lnTo>
-                  <a:pt x="825886" y="153981"/>
-                </a:lnTo>
-                <a:lnTo>
-                  <a:pt x="1238829" y="34219"/>
-                </a:lnTo>
-                <a:lnTo>
-                  <a:pt x="1651772" y="23720"/>
-                </a:lnTo>
-                <a:lnTo>
-                  <a:pt x="2064715" y="0"/>
-                </a:lnTo>
-              </a:path>
-            </a:pathLst>
-          </a:custGeom>
-          <a:noFill/>
-          <a:ln w="20320">
-            <a:solidFill>
-              <a:srgbClr val="15795F"/>
-            </a:solidFill>
-          </a:ln>
-          <a:effectLst/>
-        </p:spPr>
-        <p:style>
-          <a:lnRef idx="1">
-            <a:schemeClr val="accent1"/>
-          </a:lnRef>
-          <a:fillRef idx="3">
-            <a:schemeClr val="accent1"/>
-          </a:fillRef>
-          <a:effectRef idx="2">
-            <a:schemeClr val="accent1"/>
-          </a:effectRef>
-          <a:fontRef idx="minor">
-            <a:schemeClr val="lt1"/>
-          </a:fontRef>
-        </p:style>
-        <p:txBody>
-          <a:bodyPr rtlCol="0" anchor="ctr"/>
-          <a:lstStyle/>
-          <a:p>
-            <a:pPr algn="ctr"/>
-          </a:p>
-        </p:txBody>
-      </p:sp>
-      <p:sp>
-        <p:nvSpPr>
-          <p:cNvPr id="63" name="Rounded Rectangle 62"/>
-          <p:cNvSpPr/>
-          <p:nvPr/>
-        </p:nvSpPr>
-        <p:spPr>
-          <a:xfrm>
-            <a:off x="4783226" y="3511296"/>
-            <a:ext cx="82296" cy="82296"/>
-          </a:xfrm>
-          <a:prstGeom prst="roundRect">
-            <a:avLst>
-              <a:gd name="adj" fmla="val 50000"/>
-            </a:avLst>
-          </a:prstGeom>
-          <a:solidFill>
-            <a:srgbClr val="15795F"/>
-          </a:solidFill>
-          <a:ln>
-            <a:noFill/>
-          </a:ln>
-          <a:effectLst/>
-        </p:spPr>
-        <p:style>
-          <a:lnRef idx="1">
-            <a:schemeClr val="accent1"/>
-          </a:lnRef>
-          <a:fillRef idx="3">
-            <a:schemeClr val="accent1"/>
-          </a:fillRef>
-          <a:effectRef idx="2">
-            <a:schemeClr val="accent1"/>
-          </a:effectRef>
-          <a:fontRef idx="minor">
-            <a:schemeClr val="lt1"/>
-          </a:fontRef>
-        </p:style>
-        <p:txBody>
-          <a:bodyPr rtlCol="0" anchor="ctr" wrap="none"/>
-          <a:lstStyle/>
-          <a:p>
-            <a:pPr algn="ctr"/>
-          </a:p>
-        </p:txBody>
-      </p:sp>
-      <p:sp>
-        <p:nvSpPr>
-          <p:cNvPr id="64" name="TextBox 63"/>
-          <p:cNvSpPr txBox="1"/>
-          <p:nvPr/>
-        </p:nvSpPr>
-        <p:spPr>
-          <a:xfrm>
-            <a:off x="5016398" y="3076956"/>
-            <a:ext cx="2156155" cy="150876"/>
-          </a:xfrm>
-          <a:prstGeom prst="rect">
-            <a:avLst/>
-          </a:prstGeom>
-          <a:noFill/>
-        </p:spPr>
-        <p:txBody>
-          <a:bodyPr wrap="square" lIns="0" rIns="0" tIns="0" bIns="0" anchor="t">
-            <a:noAutofit/>
-          </a:bodyPr>
-          <a:lstStyle/>
-          <a:p>
-            <a:pPr algn="l">
-              <a:lnSpc>
-                <a:spcPts val="1188"/>
-              </a:lnSpc>
-            </a:pPr>
-            <a:r>
-              <a:rPr sz="900" b="1">
-                <a:solidFill>
-                  <a:srgbClr val="1E2F5C"/>
-                </a:solidFill>
-                <a:latin typeface="Kanit"/>
-              </a:rPr>
-              <a:t>ข้าวโพดเลี้ยงสัตว์</a:t>
-            </a:r>
-          </a:p>
-        </p:txBody>
-      </p:sp>
-      <p:sp>
-        <p:nvSpPr>
-          <p:cNvPr id="65" name="TextBox 64"/>
-          <p:cNvSpPr txBox="1"/>
-          <p:nvPr/>
-        </p:nvSpPr>
-        <p:spPr>
-          <a:xfrm>
-            <a:off x="5016398" y="3218687"/>
-            <a:ext cx="2156155" cy="125730"/>
-          </a:xfrm>
-          <a:prstGeom prst="rect">
-            <a:avLst/>
-          </a:prstGeom>
-          <a:noFill/>
-        </p:spPr>
-        <p:txBody>
-          <a:bodyPr wrap="square" lIns="0" rIns="0" tIns="0" bIns="0" anchor="t">
-            <a:noAutofit/>
-          </a:bodyPr>
-          <a:lstStyle/>
-          <a:p>
-            <a:pPr algn="l">
-              <a:lnSpc>
-                <a:spcPts val="990"/>
-              </a:lnSpc>
-            </a:pPr>
-            <a:r>
-              <a:rPr sz="750" b="0">
-                <a:solidFill>
-                  <a:srgbClr val="606060"/>
-                </a:solidFill>
-                <a:latin typeface="Kanit"/>
-              </a:rPr>
-              <a:t>฿9.76 /กก. · เหนือ</a:t>
-            </a:r>
-          </a:p>
-        </p:txBody>
-      </p:sp>
-      <p:sp>
-        <p:nvSpPr>
-          <p:cNvPr id="66" name="TextBox 65"/>
-          <p:cNvSpPr txBox="1"/>
-          <p:nvPr/>
-        </p:nvSpPr>
-        <p:spPr>
-          <a:xfrm>
-            <a:off x="5016398" y="3351275"/>
-            <a:ext cx="1078077" cy="134112"/>
-          </a:xfrm>
-          <a:prstGeom prst="rect">
-            <a:avLst/>
-          </a:prstGeom>
-          <a:noFill/>
-        </p:spPr>
-        <p:txBody>
-          <a:bodyPr wrap="square" lIns="0" rIns="0" tIns="0" bIns="0" anchor="t">
-            <a:noAutofit/>
-          </a:bodyPr>
-          <a:lstStyle/>
-          <a:p>
-            <a:pPr algn="l">
-              <a:lnSpc>
-                <a:spcPts val="1056"/>
-              </a:lnSpc>
-            </a:pPr>
-            <a:r>
-              <a:rPr sz="800" b="1">
-                <a:solidFill>
-                  <a:srgbClr val="15795F"/>
-                </a:solidFill>
-                <a:latin typeface="Kanit"/>
-              </a:rPr>
-              <a:t>เทียบปีก่อน +16.8%</a:t>
-            </a:r>
-          </a:p>
-        </p:txBody>
-      </p:sp>
-      <p:sp>
-        <p:nvSpPr>
-          <p:cNvPr id="67" name="TextBox 66"/>
-          <p:cNvSpPr txBox="1"/>
-          <p:nvPr/>
-        </p:nvSpPr>
-        <p:spPr>
-          <a:xfrm>
-            <a:off x="6094475" y="3351275"/>
-            <a:ext cx="1078077" cy="134112"/>
-          </a:xfrm>
-          <a:prstGeom prst="rect">
-            <a:avLst/>
-          </a:prstGeom>
-          <a:noFill/>
-        </p:spPr>
-        <p:txBody>
-          <a:bodyPr wrap="square" lIns="0" rIns="0" tIns="0" bIns="0" anchor="t">
-            <a:noAutofit/>
-          </a:bodyPr>
-          <a:lstStyle/>
-          <a:p>
-            <a:pPr algn="l">
-              <a:lnSpc>
-                <a:spcPts val="1056"/>
-              </a:lnSpc>
-            </a:pPr>
-            <a:r>
-              <a:rPr sz="800" b="1">
-                <a:solidFill>
-                  <a:srgbClr val="15795F"/>
-                </a:solidFill>
-                <a:latin typeface="Kanit"/>
-              </a:rPr>
-              <a:t>6 เดือน +9.7%</a:t>
-            </a:r>
-          </a:p>
-        </p:txBody>
-      </p:sp>
-      <p:sp>
-        <p:nvSpPr>
-          <p:cNvPr id="68" name="Rectangle 67"/>
-          <p:cNvSpPr/>
-          <p:nvPr/>
-        </p:nvSpPr>
-        <p:spPr>
-          <a:xfrm>
-            <a:off x="5016398" y="3506724"/>
-            <a:ext cx="2156155" cy="548640"/>
-          </a:xfrm>
-          <a:prstGeom prst="rect">
-            <a:avLst/>
-          </a:prstGeom>
-          <a:solidFill>
-            <a:srgbClr val="FBFCFE"/>
-          </a:solidFill>
-          <a:ln w="9525">
-            <a:solidFill>
-              <a:srgbClr val="D9DEE9"/>
-            </a:solidFill>
-          </a:ln>
-          <a:effectLst/>
-        </p:spPr>
-        <p:style>
-          <a:lnRef idx="1">
-            <a:schemeClr val="accent1"/>
-          </a:lnRef>
-          <a:fillRef idx="3">
-            <a:schemeClr val="accent1"/>
-          </a:fillRef>
-          <a:effectRef idx="2">
-            <a:schemeClr val="accent1"/>
-          </a:effectRef>
-          <a:fontRef idx="minor">
-            <a:schemeClr val="lt1"/>
-          </a:fontRef>
-        </p:style>
-        <p:txBody>
-          <a:bodyPr rtlCol="0" anchor="ctr" wrap="none"/>
-          <a:lstStyle/>
-          <a:p>
-            <a:pPr algn="ctr"/>
-          </a:p>
-        </p:txBody>
-      </p:sp>
-      <p:sp>
-        <p:nvSpPr>
-          <p:cNvPr id="69" name="Freeform 68"/>
-          <p:cNvSpPr/>
-          <p:nvPr/>
-        </p:nvSpPr>
-        <p:spPr>
-          <a:xfrm>
-            <a:off x="5062118" y="3552444"/>
-            <a:ext cx="2064715" cy="457200"/>
-          </a:xfrm>
-          <a:custGeom>
-            <a:avLst/>
-            <a:gdLst/>
-            <a:ahLst/>
-            <a:cxnLst/>
-            <a:rect l="l" t="t" r="r" b="b"/>
-            <a:pathLst>
-              <a:path w="2064715" h="457200">
-                <a:moveTo>
-                  <a:pt x="0" y="457200"/>
-                </a:moveTo>
-                <a:lnTo>
-                  <a:pt x="412943" y="350931"/>
-                </a:lnTo>
-                <a:lnTo>
-                  <a:pt x="825886" y="79083"/>
-                </a:lnTo>
-                <a:lnTo>
-                  <a:pt x="1238829" y="0"/>
-                </a:lnTo>
-                <a:lnTo>
-                  <a:pt x="1651772" y="54369"/>
-                </a:lnTo>
-                <a:lnTo>
-                  <a:pt x="2064715" y="294090"/>
-                </a:lnTo>
-              </a:path>
-            </a:pathLst>
-          </a:custGeom>
-          <a:noFill/>
-          <a:ln w="20320">
-            <a:solidFill>
-              <a:srgbClr val="15795F"/>
-            </a:solidFill>
-          </a:ln>
-          <a:effectLst/>
-        </p:spPr>
-        <p:style>
-          <a:lnRef idx="1">
-            <a:schemeClr val="accent1"/>
-          </a:lnRef>
-          <a:fillRef idx="3">
-            <a:schemeClr val="accent1"/>
-          </a:fillRef>
-          <a:effectRef idx="2">
-            <a:schemeClr val="accent1"/>
-          </a:effectRef>
-          <a:fontRef idx="minor">
-            <a:schemeClr val="lt1"/>
-          </a:fontRef>
-        </p:style>
-        <p:txBody>
-          <a:bodyPr rtlCol="0" anchor="ctr"/>
-          <a:lstStyle/>
-          <a:p>
-            <a:pPr algn="ctr"/>
-          </a:p>
-        </p:txBody>
-      </p:sp>
-      <p:sp>
-        <p:nvSpPr>
           <p:cNvPr id="70" name="Rounded Rectangle 69"/>
           <p:cNvSpPr/>
           <p:nvPr/>
         </p:nvSpPr>
         <p:spPr>
           <a:xfrm>
-            <a:off x="7085685" y="3805386"/>
+            <a:off x="7085685" y="3511296"/>
             <a:ext cx="82296" cy="82296"/>
           </a:xfrm>
           <a:prstGeom prst="roundRect">
@@ -51204,7 +51204,7 @@
                 </a:solidFill>
                 <a:latin typeface="Kanit"/>
               </a:rPr>
-              <a:t>เทียบปีก่อน +73.7%</a:t>
+              <a:t>เทียบปีก่อน +74.8%</a:t>
             </a:r>
           </a:p>
         </p:txBody>
@@ -51522,7 +51522,7 @@
                 </a:solidFill>
                 <a:latin typeface="Kanit"/>
               </a:rPr>
-              <a:t>เทียบปีก่อน +111.6%</a:t>
+              <a:t>เทียบปีก่อน +134.7%</a:t>
             </a:r>
           </a:p>
         </p:txBody>
@@ -51886,7 +51886,7 @@
                 </a:solidFill>
                 <a:latin typeface="Kanit"/>
               </a:rPr>
-              <a:t>ราคาหน้าฟาร์ม วัดจริง — ราคารายวันของ NABC เฉลี่ยเป็นรายเดือน หน่วยเป็นบาทตามที่เผยแพร่ (ไม่มีการแปลงสกุลเงิน) ราคาล่าสุด 2026-08-28, รุ่นข้อมูลย้อนหลัง 2026-08-29 ราคาหน้าฟาร์ม (ราคาที่เกษตรกรขายได้) คือเงินที่เกษตรกรได้รับเมื่อขายครั้งแรก ก่อนพ่อค้าคนกลาง โรงสี หรือค่าขนส่งจะหักส่วนแบ่ง — ไม่ใช่ดัชนีโลก และไม่ใช่ราคาในซูเปอร์มาร์เก็ต แหล่งผลิตเป็นการอ่านแบบ ประมาณการ ว่าสินค้าแต่ละชนิดผลิตที่ไหน และทับซ้อนกันได้ น้ำตาลเป็นราคาอ้อยประกาศของ สอน. ปีละหนึ่งจุด จึงไม่มีการเปลี่ยนแปลงหกเดือนให้แสดง</a:t>
+              <a:t>ราคาหน้าฟาร์ม วัดจริง — ราคารายวันของ NABC เฉลี่ยเป็นรายเดือน หน่วยเป็นบาทตามที่เผยแพร่ (ไม่มีการแปลงสกุลเงิน) ราคาล่าสุด 2026-09-03, รุ่นข้อมูลย้อนหลัง 2026-08-29 ราคาหน้าฟาร์ม (ราคาที่เกษตรกรขายได้) คือเงินที่เกษตรกรได้รับเมื่อขายครั้งแรก ก่อนพ่อค้าคนกลาง โรงสี หรือค่าขนส่งจะหักส่วนแบ่ง — ไม่ใช่ดัชนีโลก และไม่ใช่ราคาในซูเปอร์มาร์เก็ต แหล่งผลิตเป็นการอ่านแบบ ประมาณการ ว่าสินค้าแต่ละชนิดผลิตที่ไหน และทับซ้อนกันได้ น้ำตาลเป็นราคาอ้อยประกาศของ สอน. ปีละหนึ่งจุด จึงไม่มีการเปลี่ยนแปลงหกเดือนให้แสดง</a:t>
             </a:r>
           </a:p>
         </p:txBody>
@@ -52543,7 +52543,7 @@
                           </a:solidFill>
                           <a:latin typeface="Kanit"/>
                         </a:rPr>
-                        <a:t>+9.3%</a:t>
+                        <a:t>+8.5%</a:t>
                       </a:r>
                     </a:p>
                   </a:txBody>
@@ -52775,7 +52775,7 @@
                           </a:solidFill>
                           <a:latin typeface="Kanit"/>
                         </a:rPr>
-                        <a:t>+10.5%</a:t>
+                        <a:t>+9.6%</a:t>
                       </a:r>
                     </a:p>
                   </a:txBody>
@@ -53007,7 +53007,7 @@
                           </a:solidFill>
                           <a:latin typeface="Kanit"/>
                         </a:rPr>
-                        <a:t>+9.6%</a:t>
+                        <a:t>+8.7%</a:t>
                       </a:r>
                     </a:p>
                   </a:txBody>
@@ -53239,7 +53239,7 @@
                           </a:solidFill>
                           <a:latin typeface="Kanit"/>
                         </a:rPr>
-                        <a:t>+9.2%</a:t>
+                        <a:t>+8.3%</a:t>
                       </a:r>
                     </a:p>
                   </a:txBody>
@@ -53471,7 +53471,7 @@
                           </a:solidFill>
                           <a:latin typeface="Kanit"/>
                         </a:rPr>
-                        <a:t>+10.7%</a:t>
+                        <a:t>+9.8%</a:t>
                       </a:r>
                     </a:p>
                   </a:txBody>
@@ -53766,7 +53766,7 @@
                 </a:solidFill>
                 <a:latin typeface="Kanit"/>
               </a:rPr>
-              <a:t>รายได้ วัดจริง — รายได้รายจังหวัดจากการสำรวจภาวะเศรษฐกิจและสังคมของครัวเรือน สสช. (สสช. SES 2566) ค่าจ้างรายภาคจากการสำรวจแรงงาน สสช. (2568 (เฉลี่ย 4 ไตรมาส)) หน่วยบาท/เดือน ค่าของภาค = ค่าเฉลี่ยไม่ถ่วงน้ำหนักของจังหวัดในภาคนั้น การเปลี่ยนแปลงเป็น ประมาณการ — แบบจำลองลำดับที่หนึ่งของรอบราคาและน้ำมัน (ตัวขับเคลื่อนราคาน้ำมัน 2026M07) ใช้ค่าสัมประสิทธิ์ที่มีเอกสารอ้างอิง ไม่ได้ประมาณค่าทางสถิติ ไม่มีข้อมูล SES/LFS รายเดือน จึงไม่มีตัวเลข 6 เดือนวางเทียบไว้</a:t>
+              <a:t>รายได้ วัดจริง — รายได้รายจังหวัดจากการสำรวจภาวะเศรษฐกิจและสังคมของครัวเรือน สสช. (สสช. SES 2566) ค่าจ้างรายภาคจากการสำรวจแรงงาน สสช. (2568 (เฉลี่ย 4 ไตรมาส)) หน่วยบาท/เดือน ค่าของภาค = ค่าเฉลี่ยไม่ถ่วงน้ำหนักของจังหวัดในภาคนั้น การเปลี่ยนแปลงเป็น ประมาณการ — แบบจำลองลำดับที่หนึ่งของรอบราคาและน้ำมัน (ตัวขับเคลื่อนราคาน้ำมัน 2026M08) ใช้ค่าสัมประสิทธิ์ที่มีเอกสารอ้างอิง ไม่ได้ประมาณค่าทางสถิติ ไม่มีข้อมูล SES/LFS รายเดือน จึงไม่มีตัวเลข 6 เดือนวางเทียบไว้</a:t>
             </a:r>
           </a:p>
         </p:txBody>
@@ -54100,7 +54100,7 @@
                 </a:solidFill>
                 <a:latin typeface="Kanit"/>
               </a:rPr>
-              <a:t>• ลดลง −2.75% ทุกภาค โรงงานเคลื่อนไปทางเดียวกัน ส่วนออฟฟิศนิ่ง — เพราะไม่มีช่องทางส่งผ่านในแบบจำลอง ซึ่งไม่เหมือนกับการไม่เปลี่ยนแปลง
+              <a:t>• ลดลง −4.77% ทุกภาค โรงงานเคลื่อนไปทางเดียวกัน ส่วนออฟฟิศนิ่ง — เพราะไม่มีช่องทางส่งผ่านในแบบจำลอง ซึ่งไม่เหมือนกับการไม่เปลี่ยนแปลง
 • มาจากการเคลื่อนไหวของราคาน้ำมันดิบที่วัดได้หนึ่งค่า ผ่านค่าสัมประสิทธิ์ที่เลือกไว้หนึ่งค่า ไม่มีข้อมูลดีเซลหรือค่าขนส่งของไทยรองรับ
 • ยังสำคัญ: อาชีพนี้ตัวรถคือรายได้ โทรไปก่อนดีกว่าโทรไปสาย</a:t>
             </a:r>

</xml_diff>

<commit_message>
deck(mcom): rebuild — the data moved past the committed figures (run 33952594874) (#815)
Co-authored-by: github-actions[bot] <41898282+github-actions[bot]@users.noreply.github.com>
</commit_message>
<xml_diff>
--- a/docs/decks/mcom-2026-08-05-macro-TH.pptx
+++ b/docs/decks/mcom-2026-08-05-macro-TH.pptx
@@ -6240,7 +6240,7 @@
                 </a:solidFill>
                 <a:latin typeface="Kanit"/>
               </a:rPr>
-              <a:t>131</a:t>
+              <a:t>123</a:t>
             </a:r>
           </a:p>
         </p:txBody>
@@ -6279,7 +6279,7 @@
                 </a:solidFill>
                 <a:latin typeface="Kanit"/>
               </a:rPr>
-              <a:t>จาก 792 (16.5%) · เรียลไทม์ · 2026-09-02</a:t>
+              <a:t>จาก 793 (15.5%) · เรียลไทม์ · 2026-09-05</a:t>
             </a:r>
           </a:p>
         </p:txBody>
@@ -6405,7 +6405,7 @@
                 </a:solidFill>
                 <a:latin typeface="Kanit"/>
               </a:rPr>
-              <a:t>18</a:t>
+              <a:t>25</a:t>
             </a:r>
           </a:p>
         </p:txBody>
@@ -6444,7 +6444,7 @@
                 </a:solidFill>
                 <a:latin typeface="Kanit"/>
               </a:rPr>
-              <a:t>ค่าล่าสุดรายวัน · 2026-09-02</a:t>
+              <a:t>ค่าล่าสุดรายวัน · 2026-09-05</a:t>
             </a:r>
           </a:p>
         </p:txBody>
@@ -7928,7 +7928,7 @@
                           </a:solidFill>
                           <a:latin typeface="Kanit"/>
                         </a:rPr>
-                        <a:t>40</a:t>
+                        <a:t>52</a:t>
                       </a:r>
                     </a:p>
                   </a:txBody>
@@ -7974,7 +7974,7 @@
                           </a:solidFill>
                           <a:latin typeface="Kanit"/>
                         </a:rPr>
-                        <a:t>7/12</a:t>
+                        <a:t>6/13</a:t>
                       </a:r>
                     </a:p>
                   </a:txBody>
@@ -8045,7 +8045,7 @@
                           </a:solidFill>
                           <a:latin typeface="Kanit"/>
                         </a:rPr>
-                        <a:t>42</a:t>
+                        <a:t>44</a:t>
                       </a:r>
                     </a:p>
                   </a:txBody>
@@ -8068,7 +8068,7 @@
                           </a:solidFill>
                           <a:latin typeface="Kanit"/>
                         </a:rPr>
-                        <a:t>5</a:t>
+                        <a:t>9</a:t>
                       </a:r>
                     </a:p>
                   </a:txBody>
@@ -8162,7 +8162,7 @@
                           </a:solidFill>
                           <a:latin typeface="Kanit"/>
                         </a:rPr>
-                        <a:t>เลย</a:t>
+                        <a:t>นครพนม</a:t>
                       </a:r>
                     </a:p>
                   </a:txBody>
@@ -8185,7 +8185,7 @@
                           </a:solidFill>
                           <a:latin typeface="Kanit"/>
                         </a:rPr>
-                        <a:t>110</a:t>
+                        <a:t>28</a:t>
                       </a:r>
                     </a:p>
                   </a:txBody>
@@ -8208,7 +8208,7 @@
                           </a:solidFill>
                           <a:latin typeface="Kanit"/>
                         </a:rPr>
-                        <a:t>5</a:t>
+                        <a:t>49</a:t>
                       </a:r>
                     </a:p>
                   </a:txBody>
@@ -8227,11 +8227,11 @@
                       <a:r>
                         <a:rPr sz="900" b="1">
                           <a:solidFill>
-                            <a:srgbClr val="606060"/>
-                          </a:solidFill>
-                          <a:latin typeface="Kanit"/>
-                        </a:rPr>
-                        <a:t>0.0%</a:t>
+                            <a:srgbClr val="F5C242"/>
+                          </a:solidFill>
+                          <a:latin typeface="Kanit"/>
+                        </a:rPr>
+                        <a:t>25.0%</a:t>
                       </a:r>
                     </a:p>
                   </a:txBody>
@@ -8254,7 +8254,7 @@
                           </a:solidFill>
                           <a:latin typeface="Kanit"/>
                         </a:rPr>
-                        <a:t>1/8</a:t>
+                        <a:t>8/14</a:t>
                       </a:r>
                     </a:p>
                   </a:txBody>
@@ -8273,11 +8273,11 @@
                       <a:r>
                         <a:rPr sz="900" b="1">
                           <a:solidFill>
-                            <a:srgbClr val="CC0000"/>
-                          </a:solidFill>
-                          <a:latin typeface="Kanit"/>
-                        </a:rPr>
-                        <a:t>5</a:t>
+                            <a:srgbClr val="F5C242"/>
+                          </a:solidFill>
+                          <a:latin typeface="Kanit"/>
+                        </a:rPr>
+                        <a:t>4</a:t>
                       </a:r>
                     </a:p>
                   </a:txBody>
@@ -8302,7 +8302,7 @@
                           </a:solidFill>
                           <a:latin typeface="Kanit"/>
                         </a:rPr>
-                        <a:t>บึงกาฬ</a:t>
+                        <a:t>พะเยา</a:t>
                       </a:r>
                     </a:p>
                   </a:txBody>
@@ -8325,7 +8325,7 @@
                           </a:solidFill>
                           <a:latin typeface="Kanit"/>
                         </a:rPr>
-                        <a:t>11</a:t>
+                        <a:t>126</a:t>
                       </a:r>
                     </a:p>
                   </a:txBody>
@@ -8348,7 +8348,7 @@
                           </a:solidFill>
                           <a:latin typeface="Kanit"/>
                         </a:rPr>
-                        <a:t>55</a:t>
+                        <a:t>88</a:t>
                       </a:r>
                     </a:p>
                   </a:txBody>
@@ -8371,7 +8371,7 @@
                           </a:solidFill>
                           <a:latin typeface="Kanit"/>
                         </a:rPr>
-                        <a:t>36.4%</a:t>
+                        <a:t>14.3%</a:t>
                       </a:r>
                     </a:p>
                   </a:txBody>
@@ -8394,7 +8394,7 @@
                           </a:solidFill>
                           <a:latin typeface="Kanit"/>
                         </a:rPr>
-                        <a:t>1/1</a:t>
+                        <a:t>3/13</a:t>
                       </a:r>
                     </a:p>
                   </a:txBody>
@@ -8442,7 +8442,7 @@
                           </a:solidFill>
                           <a:latin typeface="Kanit"/>
                         </a:rPr>
-                        <a:t>อุดรธานี</a:t>
+                        <a:t>น่าน</a:t>
                       </a:r>
                     </a:p>
                   </a:txBody>
@@ -8465,7 +8465,7 @@
                           </a:solidFill>
                           <a:latin typeface="Kanit"/>
                         </a:rPr>
-                        <a:t>35</a:t>
+                        <a:t>217</a:t>
                       </a:r>
                     </a:p>
                   </a:txBody>
@@ -8488,7 +8488,7 @@
                           </a:solidFill>
                           <a:latin typeface="Kanit"/>
                         </a:rPr>
-                        <a:t>44</a:t>
+                        <a:t>101</a:t>
                       </a:r>
                     </a:p>
                   </a:txBody>
@@ -8511,7 +8511,7 @@
                           </a:solidFill>
                           <a:latin typeface="Kanit"/>
                         </a:rPr>
-                        <a:t>17.1%</a:t>
+                        <a:t>13.8%</a:t>
                       </a:r>
                     </a:p>
                   </a:txBody>
@@ -8534,7 +8534,7 @@
                           </a:solidFill>
                           <a:latin typeface="Kanit"/>
                         </a:rPr>
-                        <a:t>3/7</a:t>
+                        <a:t>1/26</a:t>
                       </a:r>
                     </a:p>
                   </a:txBody>
@@ -8582,7 +8582,7 @@
                           </a:solidFill>
                           <a:latin typeface="Kanit"/>
                         </a:rPr>
-                        <a:t>สมุทรสงคราม</a:t>
+                        <a:t>อุบลราชธานี</a:t>
                       </a:r>
                     </a:p>
                   </a:txBody>
@@ -8605,7 +8605,7 @@
                           </a:solidFill>
                           <a:latin typeface="Kanit"/>
                         </a:rPr>
-                        <a:t>6</a:t>
+                        <a:t>46</a:t>
                       </a:r>
                     </a:p>
                   </a:txBody>
@@ -8628,7 +8628,7 @@
                           </a:solidFill>
                           <a:latin typeface="Kanit"/>
                         </a:rPr>
-                        <a:t>35</a:t>
+                        <a:t>68</a:t>
                       </a:r>
                     </a:p>
                   </a:txBody>
@@ -8651,7 +8651,7 @@
                           </a:solidFill>
                           <a:latin typeface="Kanit"/>
                         </a:rPr>
-                        <a:t>16.7%</a:t>
+                        <a:t>10.9%</a:t>
                       </a:r>
                     </a:p>
                   </a:txBody>
@@ -8674,7 +8674,7 @@
                           </a:solidFill>
                           <a:latin typeface="Kanit"/>
                         </a:rPr>
-                        <a:t>1/2</a:t>
+                        <a:t>2/14</a:t>
                       </a:r>
                     </a:p>
                   </a:txBody>
@@ -8909,7 +8909,7 @@
                 </a:solidFill>
                 <a:latin typeface="Kanit"/>
               </a:rPr>
-              <a:t>พื้นที่ปลูก วัดจริง (สศก. — ข้อมูลอำเภอ×พืช 3,295 แถว) ภัยแล้งเป็นดัชนี SPEI จาก แบบจำลอง คำนวณจากปริมาณฝนและการคายระเหย ปรับเดือนละครั้ง ดึงข้อมูล 2026-07-20 — เป็นสัญญาณที่ครอบคลุมทั้งประเทศดีที่สุดที่มี แต่ไม่มีใครลงพื้นที่ไปเดินดูอำเภอเหล่านั้น ข้อมูลฝนและระดับน้ำ วัดจริง (ThaiWater เรียลไทม์ ดึงทุกวันและสะสมไว้ — วันที่ดึงไม่สำเร็จจะเว้นเป็นช่องว่าง ไม่ใส่ค่าสมมติ) · ฝนถึง 2026-09-02, ระดับน้ำถึง 2026-09-02 ความเสี่ยงน้ำท่วมเชิงโครงสร้าง วัดจริง (สำมะโนพื้นที่ท่วมซ้ำซาก GISTDA มาตราส่วน 1:50,000 ปี 2005-2016 — เป็นบันทึกภาคพื้นดิน 12 ปี ไม่ใช่การพยากรณ์)</a:t>
+              <a:t>พื้นที่ปลูก วัดจริง (สศก. — ข้อมูลอำเภอ×พืช 3,295 แถว) ภัยแล้งเป็นดัชนี SPEI จาก แบบจำลอง คำนวณจากปริมาณฝนและการคายระเหย ปรับเดือนละครั้ง ดึงข้อมูล 2026-07-20 — เป็นสัญญาณที่ครอบคลุมทั้งประเทศดีที่สุดที่มี แต่ไม่มีใครลงพื้นที่ไปเดินดูอำเภอเหล่านั้น ข้อมูลฝนและระดับน้ำ วัดจริง (ThaiWater เรียลไทม์ ดึงทุกวันและสะสมไว้ — วันที่ดึงไม่สำเร็จจะเว้นเป็นช่องว่าง ไม่ใส่ค่าสมมติ) · ฝนถึง 2026-09-05, ระดับน้ำถึง 2026-09-05 ความเสี่ยงน้ำท่วมเชิงโครงสร้าง วัดจริง (สำมะโนพื้นที่ท่วมซ้ำซาก GISTDA มาตราส่วน 1:50,000 ปี 2005-2016 — เป็นบันทึกภาคพื้นดิน 12 ปี ไม่ใช่การพยากรณ์)</a:t>
             </a:r>
           </a:p>
         </p:txBody>
@@ -31476,7 +31476,7 @@
                 </a:solidFill>
                 <a:latin typeface="Kanit"/>
               </a:rPr>
-              <a:t>รายได้จากพืชค่ากลางเพิ่มขึ้น +16.8% แต่มีสี่จังหวัดที่ลดลง — ทั้งหมดอยู่ในแหล่งปลูกมะพร้าว โดยหนักที่สุดคือสมุทรสงครามที่ −63.0%</a:t>
+              <a:t>รายได้จากพืชค่ากลางเพิ่มขึ้น +16.4% แต่มีสี่จังหวัดที่ลดลง — ทั้งหมดอยู่ในแหล่งปลูกมะพร้าว โดยหนักที่สุดคือสมุทรสงครามที่ −63.5%</a:t>
             </a:r>
           </a:p>
         </p:txBody>
@@ -31842,7 +31842,7 @@
                 </a:solidFill>
                 <a:latin typeface="Kanit"/>
               </a:rPr>
-              <a:t>รายได้ขนส่งขยับ −2.8% จากตัวเลขราคาน้ำมันระดับประเทศตัวเดียว โดยไม่มีข้อมูลค่าขนส่งของไทยรองรับ ส่วนภัยแล้งเป็นแบบจำลองปริมาณฝน — ไม่มีใครลงพื้นที่ไปเดินดูอำเภอเหล่านั้น</a:t>
+              <a:t>รายได้ขนส่งขยับ −4.8% จากตัวเลขราคาน้ำมันระดับประเทศตัวเดียว โดยไม่มีข้อมูลค่าขนส่งของไทยรองรับ ส่วนภัยแล้งเป็นแบบจำลองปริมาณฝน — ไม่มีใครลงพื้นที่ไปเดินดูอำเภอเหล่านั้น</a:t>
             </a:r>
           </a:p>
         </p:txBody>
@@ -32047,7 +32047,7 @@
                 </a:solidFill>
                 <a:latin typeface="Kanit"/>
               </a:rPr>
-              <a:t>รุ่นข้อมูล — ราคาโลก 2026M06 · ราคาหน้าฟาร์มไทย 2026-08-28 · ประวัติราคาไทย 2026-08-29 · ต้นทุนการผลิตพืช สศก. ไจอัป 2568 (ปีเพาะปลูก 2568/69, ประมาณการ สศก. มี.ค. 2569) · ภัยแล้ง 2026-06-21 · เงินเฟ้อ 2026-05 · GDP 2026 ไตรมาส 1 · IMF WEO 2026 · ดัชนีราคาขายต่อ 2026-05 · ยอดจดทะเบียนถึง 2026-01 · หนี้ครัวเรือน สสช. SES 2566 · ค่าจ้าง สสช. LFS 2568 · ข้อมูลตรวจวัด 2026-09-02</a:t>
+              <a:t>รุ่นข้อมูล — ราคาโลก 2026M06 · ราคาหน้าฟาร์มไทย 2026-09-03 · ประวัติราคาไทย 2026-08-29 · ต้นทุนการผลิตพืช สศก. ไจอัป 2568 (ปีเพาะปลูก 2568/69, ประมาณการ สศก. มี.ค. 2569) · ภัยแล้ง 2026-06-21 · เงินเฟ้อ 2026-05 · GDP 2026 ไตรมาส 1 · IMF WEO 2026 · ดัชนีราคาขายต่อ 2026-05 · ยอดจดทะเบียนถึง 2026-01 · หนี้ครัวเรือน สสช. SES 2566 · ค่าจ้าง สสช. LFS 2568 · ข้อมูลตรวจวัด 2026-09-05</a:t>
             </a:r>
           </a:p>
         </p:txBody>
@@ -32546,7 +32546,7 @@
               <a:t>Not on the world index — the farm gate (ราคาที่เกษตรกรขายได้) says otherwise.
 • Five of seventeen Thai farm-gate prices are falling year on year.
 • Beef: farm gate −6.1% vs world index +8.8%.
-• Margin over price: a 26% price move becomes an 86% swing in crop income.</a:t>
+• Margin over price: a 26% price move becomes an 85% swing in crop income.</a:t>
             </a:r>
           </a:p>
         </p:txBody>
@@ -37087,7 +37087,7 @@
                 </a:solidFill>
                 <a:latin typeface="Kanit"/>
               </a:rPr>
-              <a:t>338 จาก 928 อำเภอ · แม่น้ำเกินระดับ 131 จาก 792 สถานี</a:t>
+              <a:t>338 จาก 928 อำเภอ · แม่น้ำเกินระดับ 123 จาก 793 สถานี</a:t>
             </a:r>
           </a:p>
         </p:txBody>
@@ -37859,7 +37859,7 @@
                           </a:solidFill>
                           <a:latin typeface="Kanit"/>
                         </a:rPr>
-                        <a:t>28/157</a:t>
+                        <a:t>26/157</a:t>
                       </a:r>
                     </a:p>
                   </a:txBody>
@@ -38091,7 +38091,7 @@
                           </a:solidFill>
                           <a:latin typeface="Kanit"/>
                         </a:rPr>
-                        <a:t>17/274</a:t>
+                        <a:t>19/274</a:t>
                       </a:r>
                     </a:p>
                   </a:txBody>
@@ -38323,7 +38323,7 @@
                           </a:solidFill>
                           <a:latin typeface="Kanit"/>
                         </a:rPr>
-                        <a:t>25/167</a:t>
+                        <a:t>26/168</a:t>
                       </a:r>
                     </a:p>
                   </a:txBody>
@@ -38555,7 +38555,7 @@
                           </a:solidFill>
                           <a:latin typeface="Kanit"/>
                         </a:rPr>
-                        <a:t>16/51</a:t>
+                        <a:t>15/51</a:t>
                       </a:r>
                     </a:p>
                   </a:txBody>
@@ -38787,7 +38787,7 @@
                           </a:solidFill>
                           <a:latin typeface="Kanit"/>
                         </a:rPr>
-                        <a:t>45/143</a:t>
+                        <a:t>37/143</a:t>
                       </a:r>
                     </a:p>
                   </a:txBody>
@@ -39936,7 +39936,7 @@
                           </a:solidFill>
                           <a:latin typeface="Kanit"/>
                         </a:rPr>
-                        <a:t>−67.4%</a:t>
+                        <a:t>−67.9%</a:t>
                       </a:r>
                     </a:p>
                   </a:txBody>
@@ -40791,7 +40791,7 @@
                 </a:solidFill>
                 <a:latin typeface="Kanit"/>
               </a:rPr>
-              <a:t>ราคา วัดจริง — ราคาหน้าฟาร์มไทยจากราคารายวันของ NABC และราคาอ้อยประกาศของ สอน. ราคาล่าสุด 2026-08-28 การเปลี่ยนแปลงหกเดือนคำนวณจากข้อมูลรายเดือนของ NABC เอง (thai_price_history รุ่นข้อมูล 2026-08-29) พืชที่ไม่มีข้อมูลรายเดือนจะกำกับไว้ ไม่ประมาณการขึ้นมา แหล่งผลิตเป็นการอ่านแบบ ประมาณการ ว่าสินค้าแต่ละชนิดปลูกที่ไหน และแหล่งผลิตทับซ้อนกันได้ บัญชีอาชีพเกษตรเป็นข้อมูลของเราเองและ วัดจริง — บัญชีที่บันทึกอาชีพว่า เกษตร ในจังหวัดแหล่งผลิต จากฐานข้อมูล 382,735 บัญชี ณ 2026-07 ไม่เผยแพร่ช่องที่มีน้อยกว่า 30 บัญชี คนกลุ่มนี้อาศัยอยู่ในพื้นที่ที่ปลูกพืชนั้น แต่ไม่ได้ยืนยันว่าปลูกพืชนั้นเอง</a:t>
+              <a:t>ราคา วัดจริง — ราคาหน้าฟาร์มไทยจากราคารายวันของ NABC และราคาอ้อยประกาศของ สอน. ราคาล่าสุด 2026-09-03 การเปลี่ยนแปลงหกเดือนคำนวณจากข้อมูลรายเดือนของ NABC เอง (thai_price_history รุ่นข้อมูล 2026-08-29) พืชที่ไม่มีข้อมูลรายเดือนจะกำกับไว้ ไม่ประมาณการขึ้นมา แหล่งผลิตเป็นการอ่านแบบ ประมาณการ ว่าสินค้าแต่ละชนิดปลูกที่ไหน และแหล่งผลิตทับซ้อนกันได้ บัญชีอาชีพเกษตรเป็นข้อมูลของเราเองและ วัดจริง — บัญชีที่บันทึกอาชีพว่า เกษตร ในจังหวัดแหล่งผลิต จากฐานข้อมูล 382,735 บัญชี ณ 2026-07 ไม่เผยแพร่ช่องที่มีน้อยกว่า 30 บัญชี คนกลุ่มนี้อาศัยอยู่ในพื้นที่ที่ปลูกพืชนั้น แต่ไม่ได้ยืนยันว่าปลูกพืชนั้นเอง</a:t>
             </a:r>
           </a:p>
         </p:txBody>
@@ -44679,7 +44679,7 @@
                 </a:solidFill>
                 <a:latin typeface="Kanit"/>
               </a:rPr>
-              <a:t>มะพร้าว −67.4% สับปะรด −18.4% อ้อย −17.9% เทียบปีก่อน</a:t>
+              <a:t>มะพร้าว −67.9% สับปะรด −18.4% อ้อย −17.9% เทียบปีก่อน</a:t>
             </a:r>
           </a:p>
         </p:txBody>
@@ -44805,7 +44805,7 @@
                 </a:solidFill>
                 <a:latin typeface="Kanit"/>
               </a:rPr>
-              <a:t>+16.8%</a:t>
+              <a:t>+16.4%</a:t>
             </a:r>
           </a:p>
         </p:txBody>
@@ -45279,7 +45279,7 @@
                           </a:solidFill>
                           <a:latin typeface="Kanit"/>
                         </a:rPr>
-                        <a:t>+6.7%</a:t>
+                        <a:t>+6.2%</a:t>
                       </a:r>
                     </a:p>
                   </a:txBody>
@@ -45348,7 +45348,7 @@
                           </a:solidFill>
                           <a:latin typeface="Kanit"/>
                         </a:rPr>
-                        <a:t>-63.0%</a:t>
+                        <a:t>-63.5%</a:t>
                       </a:r>
                     </a:p>
                   </a:txBody>
@@ -45419,7 +45419,7 @@
                           </a:solidFill>
                           <a:latin typeface="Kanit"/>
                         </a:rPr>
-                        <a:t>+15.9%</a:t>
+                        <a:t>+15.4%</a:t>
                       </a:r>
                     </a:p>
                   </a:txBody>
@@ -45488,7 +45488,7 @@
                           </a:solidFill>
                           <a:latin typeface="Kanit"/>
                         </a:rPr>
-                        <a:t>+10.1%</a:t>
+                        <a:t>+9.6%</a:t>
                       </a:r>
                     </a:p>
                   </a:txBody>
@@ -45559,7 +45559,7 @@
                           </a:solidFill>
                           <a:latin typeface="Kanit"/>
                         </a:rPr>
-                        <a:t>+17.3%</a:t>
+                        <a:t>+16.9%</a:t>
                       </a:r>
                     </a:p>
                   </a:txBody>
@@ -45628,7 +45628,7 @@
                           </a:solidFill>
                           <a:latin typeface="Kanit"/>
                         </a:rPr>
-                        <a:t>+8.6%</a:t>
+                        <a:t>+8.3%</a:t>
                       </a:r>
                     </a:p>
                   </a:txBody>
@@ -45699,7 +45699,7 @@
                           </a:solidFill>
                           <a:latin typeface="Kanit"/>
                         </a:rPr>
-                        <a:t>+24.9%</a:t>
+                        <a:t>+24.8%</a:t>
                       </a:r>
                     </a:p>
                   </a:txBody>
@@ -45768,7 +45768,7 @@
                           </a:solidFill>
                           <a:latin typeface="Kanit"/>
                         </a:rPr>
-                        <a:t>+11.6%</a:t>
+                        <a:t>+11.3%</a:t>
                       </a:r>
                     </a:p>
                   </a:txBody>
@@ -45908,7 +45908,7 @@
                           </a:solidFill>
                           <a:latin typeface="Kanit"/>
                         </a:rPr>
-                        <a:t>+26.9%</a:t>
+                        <a:t>+26.8%</a:t>
                       </a:r>
                     </a:p>
                   </a:txBody>
@@ -46084,8 +46084,8 @@
                 </a:solidFill>
                 <a:latin typeface="Kanit"/>
               </a:rPr>
-              <a:t>•  ราคาหน้าฟาร์ม: ยางพารา +40% มันสำปะหลัง +74% ปาล์ม +23% ข้าว +14% รายได้จากพืชเพิ่มขึ้นทุกภาค
-•  มีสี่จังหวัดที่ลดลง — ทั้งหมดเป็นมะพร้าว และอยู่ฝั่งอ่าวไทยตะวันตก ราคามะพร้าวลดลง 67%
+              <a:t>•  ราคาหน้าฟาร์ม: ยางพารา +40% มันสำปะหลัง +75% ปาล์ม +23% ข้าว +13% รายได้จากพืชเพิ่มขึ้นทุกภาค
+•  มีสี่จังหวัดที่ลดลง — ทั้งหมดเป็นมะพร้าว และอยู่ฝั่งอ่าวไทยตะวันตก ราคามะพร้าวลดลง 68%
 •  กำไรบนกระดาษยังไม่ใช่เงินสด — ตารางถัดไปหักราคาด้วยต้นทุน</a:t>
             </a:r>
           </a:p>
@@ -46387,7 +46387,7 @@
                           </a:solidFill>
                           <a:latin typeface="Kanit"/>
                         </a:rPr>
-                        <a:t>+18.0%</a:t>
+                        <a:t>+17.6%</a:t>
                       </a:r>
                     </a:p>
                   </a:txBody>
@@ -46550,7 +46550,7 @@
                           </a:solidFill>
                           <a:latin typeface="Kanit"/>
                         </a:rPr>
-                        <a:t>+21.7%</a:t>
+                        <a:t>+21.3%</a:t>
                       </a:r>
                     </a:p>
                   </a:txBody>
@@ -46713,7 +46713,7 @@
                           </a:solidFill>
                           <a:latin typeface="Kanit"/>
                         </a:rPr>
-                        <a:t>+11.8%</a:t>
+                        <a:t>+11.3%</a:t>
                       </a:r>
                     </a:p>
                   </a:txBody>
@@ -47039,7 +47039,7 @@
                           </a:solidFill>
                           <a:latin typeface="Kanit"/>
                         </a:rPr>
-                        <a:t>+17.1%</a:t>
+                        <a:t>+16.7%</a:t>
                       </a:r>
                     </a:p>
                   </a:txBody>
@@ -47202,7 +47202,7 @@
                           </a:solidFill>
                           <a:latin typeface="Kanit"/>
                         </a:rPr>
-                        <a:t>+15.6%</a:t>
+                        <a:t>+15.1%</a:t>
                       </a:r>
                     </a:p>
                   </a:txBody>
@@ -48024,7 +48024,7 @@
                 </a:solidFill>
                 <a:latin typeface="Kanit"/>
               </a:rPr>
-              <a:t>เทียบปีก่อน −67.4%</a:t>
+              <a:t>เทียบปีก่อน −67.9%</a:t>
             </a:r>
           </a:p>
         </p:txBody>
@@ -48660,7 +48660,7 @@
                 </a:solidFill>
                 <a:latin typeface="Kanit"/>
               </a:rPr>
-              <a:t>เทียบปีก่อน +0.9%</a:t>
+              <a:t>เทียบปีก่อน +1.0%</a:t>
             </a:r>
           </a:p>
         </p:txBody>
@@ -48978,7 +48978,7 @@
                 </a:solidFill>
                 <a:latin typeface="Kanit"/>
               </a:rPr>
-              <a:t>เทียบปีก่อน +3.9%</a:t>
+              <a:t>เทียบปีก่อน +4.5%</a:t>
             </a:r>
           </a:p>
         </p:txBody>
@@ -49296,7 +49296,7 @@
                 </a:solidFill>
                 <a:latin typeface="Kanit"/>
               </a:rPr>
-              <a:t>เทียบปีก่อน +4.4%</a:t>
+              <a:t>เทียบปีก่อน +5.6%</a:t>
             </a:r>
           </a:p>
         </p:txBody>
@@ -49536,6 +49536,642 @@
                 </a:solidFill>
                 <a:latin typeface="Kanit"/>
               </a:rPr>
+              <a:t>ข้าวหอมมะลิ</a:t>
+            </a:r>
+          </a:p>
+        </p:txBody>
+      </p:sp>
+      <p:sp>
+        <p:nvSpPr>
+          <p:cNvPr id="51" name="TextBox 50"/>
+          <p:cNvSpPr txBox="1"/>
+          <p:nvPr/>
+        </p:nvSpPr>
+        <p:spPr>
+          <a:xfrm>
+            <a:off x="411480" y="3218687"/>
+            <a:ext cx="2156155" cy="125730"/>
+          </a:xfrm>
+          <a:prstGeom prst="rect">
+            <a:avLst/>
+          </a:prstGeom>
+          <a:noFill/>
+        </p:spPr>
+        <p:txBody>
+          <a:bodyPr wrap="square" lIns="0" rIns="0" tIns="0" bIns="0" anchor="t">
+            <a:noAutofit/>
+          </a:bodyPr>
+          <a:lstStyle/>
+          <a:p>
+            <a:pPr algn="l">
+              <a:lnSpc>
+                <a:spcPts val="990"/>
+              </a:lnSpc>
+            </a:pPr>
+            <a:r>
+              <a:rPr sz="750" b="0">
+                <a:solidFill>
+                  <a:srgbClr val="606060"/>
+                </a:solidFill>
+                <a:latin typeface="Kanit"/>
+              </a:rPr>
+              <a:t>฿17,763 /ตัน · อีสาน·เหนือ·กลาง</a:t>
+            </a:r>
+          </a:p>
+        </p:txBody>
+      </p:sp>
+      <p:sp>
+        <p:nvSpPr>
+          <p:cNvPr id="52" name="TextBox 51"/>
+          <p:cNvSpPr txBox="1"/>
+          <p:nvPr/>
+        </p:nvSpPr>
+        <p:spPr>
+          <a:xfrm>
+            <a:off x="411480" y="3351275"/>
+            <a:ext cx="1078077" cy="134112"/>
+          </a:xfrm>
+          <a:prstGeom prst="rect">
+            <a:avLst/>
+          </a:prstGeom>
+          <a:noFill/>
+        </p:spPr>
+        <p:txBody>
+          <a:bodyPr wrap="square" lIns="0" rIns="0" tIns="0" bIns="0" anchor="t">
+            <a:noAutofit/>
+          </a:bodyPr>
+          <a:lstStyle/>
+          <a:p>
+            <a:pPr algn="l">
+              <a:lnSpc>
+                <a:spcPts val="1056"/>
+              </a:lnSpc>
+            </a:pPr>
+            <a:r>
+              <a:rPr sz="800" b="1">
+                <a:solidFill>
+                  <a:srgbClr val="15795F"/>
+                </a:solidFill>
+                <a:latin typeface="Kanit"/>
+              </a:rPr>
+              <a:t>เทียบปีก่อน +13.4%</a:t>
+            </a:r>
+          </a:p>
+        </p:txBody>
+      </p:sp>
+      <p:sp>
+        <p:nvSpPr>
+          <p:cNvPr id="53" name="TextBox 52"/>
+          <p:cNvSpPr txBox="1"/>
+          <p:nvPr/>
+        </p:nvSpPr>
+        <p:spPr>
+          <a:xfrm>
+            <a:off x="1489557" y="3351275"/>
+            <a:ext cx="1078077" cy="134112"/>
+          </a:xfrm>
+          <a:prstGeom prst="rect">
+            <a:avLst/>
+          </a:prstGeom>
+          <a:noFill/>
+        </p:spPr>
+        <p:txBody>
+          <a:bodyPr wrap="square" lIns="0" rIns="0" tIns="0" bIns="0" anchor="t">
+            <a:noAutofit/>
+          </a:bodyPr>
+          <a:lstStyle/>
+          <a:p>
+            <a:pPr algn="l">
+              <a:lnSpc>
+                <a:spcPts val="1056"/>
+              </a:lnSpc>
+            </a:pPr>
+            <a:r>
+              <a:rPr sz="800" b="1">
+                <a:solidFill>
+                  <a:srgbClr val="15795F"/>
+                </a:solidFill>
+                <a:latin typeface="Kanit"/>
+              </a:rPr>
+              <a:t>6 เดือน +7.7%</a:t>
+            </a:r>
+          </a:p>
+        </p:txBody>
+      </p:sp>
+      <p:sp>
+        <p:nvSpPr>
+          <p:cNvPr id="54" name="Rectangle 53"/>
+          <p:cNvSpPr/>
+          <p:nvPr/>
+        </p:nvSpPr>
+        <p:spPr>
+          <a:xfrm>
+            <a:off x="411480" y="3506724"/>
+            <a:ext cx="2156155" cy="548640"/>
+          </a:xfrm>
+          <a:prstGeom prst="rect">
+            <a:avLst/>
+          </a:prstGeom>
+          <a:solidFill>
+            <a:srgbClr val="FBFCFE"/>
+          </a:solidFill>
+          <a:ln w="9525">
+            <a:solidFill>
+              <a:srgbClr val="D9DEE9"/>
+            </a:solidFill>
+          </a:ln>
+          <a:effectLst/>
+        </p:spPr>
+        <p:style>
+          <a:lnRef idx="1">
+            <a:schemeClr val="accent1"/>
+          </a:lnRef>
+          <a:fillRef idx="3">
+            <a:schemeClr val="accent1"/>
+          </a:fillRef>
+          <a:effectRef idx="2">
+            <a:schemeClr val="accent1"/>
+          </a:effectRef>
+          <a:fontRef idx="minor">
+            <a:schemeClr val="lt1"/>
+          </a:fontRef>
+        </p:style>
+        <p:txBody>
+          <a:bodyPr rtlCol="0" anchor="ctr" wrap="none"/>
+          <a:lstStyle/>
+          <a:p>
+            <a:pPr algn="ctr"/>
+          </a:p>
+        </p:txBody>
+      </p:sp>
+      <p:sp>
+        <p:nvSpPr>
+          <p:cNvPr id="55" name="Freeform 54"/>
+          <p:cNvSpPr/>
+          <p:nvPr/>
+        </p:nvSpPr>
+        <p:spPr>
+          <a:xfrm>
+            <a:off x="457200" y="3552444"/>
+            <a:ext cx="2064715" cy="457200"/>
+          </a:xfrm>
+          <a:custGeom>
+            <a:avLst/>
+            <a:gdLst/>
+            <a:ahLst/>
+            <a:cxnLst/>
+            <a:rect l="l" t="t" r="r" b="b"/>
+            <a:pathLst>
+              <a:path w="2064715" h="457200">
+                <a:moveTo>
+                  <a:pt x="0" y="457200"/>
+                </a:moveTo>
+                <a:lnTo>
+                  <a:pt x="412943" y="341371"/>
+                </a:lnTo>
+                <a:lnTo>
+                  <a:pt x="825886" y="153981"/>
+                </a:lnTo>
+                <a:lnTo>
+                  <a:pt x="1238829" y="34219"/>
+                </a:lnTo>
+                <a:lnTo>
+                  <a:pt x="1651772" y="23720"/>
+                </a:lnTo>
+                <a:lnTo>
+                  <a:pt x="2064715" y="0"/>
+                </a:lnTo>
+              </a:path>
+            </a:pathLst>
+          </a:custGeom>
+          <a:noFill/>
+          <a:ln w="20320">
+            <a:solidFill>
+              <a:srgbClr val="15795F"/>
+            </a:solidFill>
+          </a:ln>
+          <a:effectLst/>
+        </p:spPr>
+        <p:style>
+          <a:lnRef idx="1">
+            <a:schemeClr val="accent1"/>
+          </a:lnRef>
+          <a:fillRef idx="3">
+            <a:schemeClr val="accent1"/>
+          </a:fillRef>
+          <a:effectRef idx="2">
+            <a:schemeClr val="accent1"/>
+          </a:effectRef>
+          <a:fontRef idx="minor">
+            <a:schemeClr val="lt1"/>
+          </a:fontRef>
+        </p:style>
+        <p:txBody>
+          <a:bodyPr rtlCol="0" anchor="ctr"/>
+          <a:lstStyle/>
+          <a:p>
+            <a:pPr algn="ctr"/>
+          </a:p>
+        </p:txBody>
+      </p:sp>
+      <p:sp>
+        <p:nvSpPr>
+          <p:cNvPr id="56" name="Rounded Rectangle 55"/>
+          <p:cNvSpPr/>
+          <p:nvPr/>
+        </p:nvSpPr>
+        <p:spPr>
+          <a:xfrm>
+            <a:off x="2480767" y="3511296"/>
+            <a:ext cx="82296" cy="82296"/>
+          </a:xfrm>
+          <a:prstGeom prst="roundRect">
+            <a:avLst>
+              <a:gd name="adj" fmla="val 50000"/>
+            </a:avLst>
+          </a:prstGeom>
+          <a:solidFill>
+            <a:srgbClr val="15795F"/>
+          </a:solidFill>
+          <a:ln>
+            <a:noFill/>
+          </a:ln>
+          <a:effectLst/>
+        </p:spPr>
+        <p:style>
+          <a:lnRef idx="1">
+            <a:schemeClr val="accent1"/>
+          </a:lnRef>
+          <a:fillRef idx="3">
+            <a:schemeClr val="accent1"/>
+          </a:fillRef>
+          <a:effectRef idx="2">
+            <a:schemeClr val="accent1"/>
+          </a:effectRef>
+          <a:fontRef idx="minor">
+            <a:schemeClr val="lt1"/>
+          </a:fontRef>
+        </p:style>
+        <p:txBody>
+          <a:bodyPr rtlCol="0" anchor="ctr" wrap="none"/>
+          <a:lstStyle/>
+          <a:p>
+            <a:pPr algn="ctr"/>
+          </a:p>
+        </p:txBody>
+      </p:sp>
+      <p:sp>
+        <p:nvSpPr>
+          <p:cNvPr id="57" name="TextBox 56"/>
+          <p:cNvSpPr txBox="1"/>
+          <p:nvPr/>
+        </p:nvSpPr>
+        <p:spPr>
+          <a:xfrm>
+            <a:off x="2713939" y="3076956"/>
+            <a:ext cx="2156155" cy="150876"/>
+          </a:xfrm>
+          <a:prstGeom prst="rect">
+            <a:avLst/>
+          </a:prstGeom>
+          <a:noFill/>
+        </p:spPr>
+        <p:txBody>
+          <a:bodyPr wrap="square" lIns="0" rIns="0" tIns="0" bIns="0" anchor="t">
+            <a:noAutofit/>
+          </a:bodyPr>
+          <a:lstStyle/>
+          <a:p>
+            <a:pPr algn="l">
+              <a:lnSpc>
+                <a:spcPts val="1188"/>
+              </a:lnSpc>
+            </a:pPr>
+            <a:r>
+              <a:rPr sz="900" b="1">
+                <a:solidFill>
+                  <a:srgbClr val="1E2F5C"/>
+                </a:solidFill>
+                <a:latin typeface="Kanit"/>
+              </a:rPr>
+              <a:t>ข้าวโพดเลี้ยงสัตว์</a:t>
+            </a:r>
+          </a:p>
+        </p:txBody>
+      </p:sp>
+      <p:sp>
+        <p:nvSpPr>
+          <p:cNvPr id="58" name="TextBox 57"/>
+          <p:cNvSpPr txBox="1"/>
+          <p:nvPr/>
+        </p:nvSpPr>
+        <p:spPr>
+          <a:xfrm>
+            <a:off x="2713939" y="3218687"/>
+            <a:ext cx="2156155" cy="125730"/>
+          </a:xfrm>
+          <a:prstGeom prst="rect">
+            <a:avLst/>
+          </a:prstGeom>
+          <a:noFill/>
+        </p:spPr>
+        <p:txBody>
+          <a:bodyPr wrap="square" lIns="0" rIns="0" tIns="0" bIns="0" anchor="t">
+            <a:noAutofit/>
+          </a:bodyPr>
+          <a:lstStyle/>
+          <a:p>
+            <a:pPr algn="l">
+              <a:lnSpc>
+                <a:spcPts val="990"/>
+              </a:lnSpc>
+            </a:pPr>
+            <a:r>
+              <a:rPr sz="750" b="0">
+                <a:solidFill>
+                  <a:srgbClr val="606060"/>
+                </a:solidFill>
+                <a:latin typeface="Kanit"/>
+              </a:rPr>
+              <a:t>฿9.76 /กก. · เหนือ</a:t>
+            </a:r>
+          </a:p>
+        </p:txBody>
+      </p:sp>
+      <p:sp>
+        <p:nvSpPr>
+          <p:cNvPr id="59" name="TextBox 58"/>
+          <p:cNvSpPr txBox="1"/>
+          <p:nvPr/>
+        </p:nvSpPr>
+        <p:spPr>
+          <a:xfrm>
+            <a:off x="2713939" y="3351275"/>
+            <a:ext cx="1078077" cy="134112"/>
+          </a:xfrm>
+          <a:prstGeom prst="rect">
+            <a:avLst/>
+          </a:prstGeom>
+          <a:noFill/>
+        </p:spPr>
+        <p:txBody>
+          <a:bodyPr wrap="square" lIns="0" rIns="0" tIns="0" bIns="0" anchor="t">
+            <a:noAutofit/>
+          </a:bodyPr>
+          <a:lstStyle/>
+          <a:p>
+            <a:pPr algn="l">
+              <a:lnSpc>
+                <a:spcPts val="1056"/>
+              </a:lnSpc>
+            </a:pPr>
+            <a:r>
+              <a:rPr sz="800" b="1">
+                <a:solidFill>
+                  <a:srgbClr val="15795F"/>
+                </a:solidFill>
+                <a:latin typeface="Kanit"/>
+              </a:rPr>
+              <a:t>เทียบปีก่อน +15.5%</a:t>
+            </a:r>
+          </a:p>
+        </p:txBody>
+      </p:sp>
+      <p:sp>
+        <p:nvSpPr>
+          <p:cNvPr id="60" name="TextBox 59"/>
+          <p:cNvSpPr txBox="1"/>
+          <p:nvPr/>
+        </p:nvSpPr>
+        <p:spPr>
+          <a:xfrm>
+            <a:off x="3792016" y="3351275"/>
+            <a:ext cx="1078077" cy="134112"/>
+          </a:xfrm>
+          <a:prstGeom prst="rect">
+            <a:avLst/>
+          </a:prstGeom>
+          <a:noFill/>
+        </p:spPr>
+        <p:txBody>
+          <a:bodyPr wrap="square" lIns="0" rIns="0" tIns="0" bIns="0" anchor="t">
+            <a:noAutofit/>
+          </a:bodyPr>
+          <a:lstStyle/>
+          <a:p>
+            <a:pPr algn="l">
+              <a:lnSpc>
+                <a:spcPts val="1056"/>
+              </a:lnSpc>
+            </a:pPr>
+            <a:r>
+              <a:rPr sz="800" b="1">
+                <a:solidFill>
+                  <a:srgbClr val="15795F"/>
+                </a:solidFill>
+                <a:latin typeface="Kanit"/>
+              </a:rPr>
+              <a:t>6 เดือน +9.7%</a:t>
+            </a:r>
+          </a:p>
+        </p:txBody>
+      </p:sp>
+      <p:sp>
+        <p:nvSpPr>
+          <p:cNvPr id="61" name="Rectangle 60"/>
+          <p:cNvSpPr/>
+          <p:nvPr/>
+        </p:nvSpPr>
+        <p:spPr>
+          <a:xfrm>
+            <a:off x="2713939" y="3506724"/>
+            <a:ext cx="2156155" cy="548640"/>
+          </a:xfrm>
+          <a:prstGeom prst="rect">
+            <a:avLst/>
+          </a:prstGeom>
+          <a:solidFill>
+            <a:srgbClr val="FBFCFE"/>
+          </a:solidFill>
+          <a:ln w="9525">
+            <a:solidFill>
+              <a:srgbClr val="D9DEE9"/>
+            </a:solidFill>
+          </a:ln>
+          <a:effectLst/>
+        </p:spPr>
+        <p:style>
+          <a:lnRef idx="1">
+            <a:schemeClr val="accent1"/>
+          </a:lnRef>
+          <a:fillRef idx="3">
+            <a:schemeClr val="accent1"/>
+          </a:fillRef>
+          <a:effectRef idx="2">
+            <a:schemeClr val="accent1"/>
+          </a:effectRef>
+          <a:fontRef idx="minor">
+            <a:schemeClr val="lt1"/>
+          </a:fontRef>
+        </p:style>
+        <p:txBody>
+          <a:bodyPr rtlCol="0" anchor="ctr" wrap="none"/>
+          <a:lstStyle/>
+          <a:p>
+            <a:pPr algn="ctr"/>
+          </a:p>
+        </p:txBody>
+      </p:sp>
+      <p:sp>
+        <p:nvSpPr>
+          <p:cNvPr id="62" name="Freeform 61"/>
+          <p:cNvSpPr/>
+          <p:nvPr/>
+        </p:nvSpPr>
+        <p:spPr>
+          <a:xfrm>
+            <a:off x="2759659" y="3552444"/>
+            <a:ext cx="2064715" cy="457200"/>
+          </a:xfrm>
+          <a:custGeom>
+            <a:avLst/>
+            <a:gdLst/>
+            <a:ahLst/>
+            <a:cxnLst/>
+            <a:rect l="l" t="t" r="r" b="b"/>
+            <a:pathLst>
+              <a:path w="2064715" h="457200">
+                <a:moveTo>
+                  <a:pt x="0" y="457200"/>
+                </a:moveTo>
+                <a:lnTo>
+                  <a:pt x="412943" y="350931"/>
+                </a:lnTo>
+                <a:lnTo>
+                  <a:pt x="825886" y="79083"/>
+                </a:lnTo>
+                <a:lnTo>
+                  <a:pt x="1238829" y="0"/>
+                </a:lnTo>
+                <a:lnTo>
+                  <a:pt x="1651772" y="54369"/>
+                </a:lnTo>
+                <a:lnTo>
+                  <a:pt x="2064715" y="294090"/>
+                </a:lnTo>
+              </a:path>
+            </a:pathLst>
+          </a:custGeom>
+          <a:noFill/>
+          <a:ln w="20320">
+            <a:solidFill>
+              <a:srgbClr val="15795F"/>
+            </a:solidFill>
+          </a:ln>
+          <a:effectLst/>
+        </p:spPr>
+        <p:style>
+          <a:lnRef idx="1">
+            <a:schemeClr val="accent1"/>
+          </a:lnRef>
+          <a:fillRef idx="3">
+            <a:schemeClr val="accent1"/>
+          </a:fillRef>
+          <a:effectRef idx="2">
+            <a:schemeClr val="accent1"/>
+          </a:effectRef>
+          <a:fontRef idx="minor">
+            <a:schemeClr val="lt1"/>
+          </a:fontRef>
+        </p:style>
+        <p:txBody>
+          <a:bodyPr rtlCol="0" anchor="ctr"/>
+          <a:lstStyle/>
+          <a:p>
+            <a:pPr algn="ctr"/>
+          </a:p>
+        </p:txBody>
+      </p:sp>
+      <p:sp>
+        <p:nvSpPr>
+          <p:cNvPr id="63" name="Rounded Rectangle 62"/>
+          <p:cNvSpPr/>
+          <p:nvPr/>
+        </p:nvSpPr>
+        <p:spPr>
+          <a:xfrm>
+            <a:off x="4783226" y="3805386"/>
+            <a:ext cx="82296" cy="82296"/>
+          </a:xfrm>
+          <a:prstGeom prst="roundRect">
+            <a:avLst>
+              <a:gd name="adj" fmla="val 50000"/>
+            </a:avLst>
+          </a:prstGeom>
+          <a:solidFill>
+            <a:srgbClr val="15795F"/>
+          </a:solidFill>
+          <a:ln>
+            <a:noFill/>
+          </a:ln>
+          <a:effectLst/>
+        </p:spPr>
+        <p:style>
+          <a:lnRef idx="1">
+            <a:schemeClr val="accent1"/>
+          </a:lnRef>
+          <a:fillRef idx="3">
+            <a:schemeClr val="accent1"/>
+          </a:fillRef>
+          <a:effectRef idx="2">
+            <a:schemeClr val="accent1"/>
+          </a:effectRef>
+          <a:fontRef idx="minor">
+            <a:schemeClr val="lt1"/>
+          </a:fontRef>
+        </p:style>
+        <p:txBody>
+          <a:bodyPr rtlCol="0" anchor="ctr" wrap="none"/>
+          <a:lstStyle/>
+          <a:p>
+            <a:pPr algn="ctr"/>
+          </a:p>
+        </p:txBody>
+      </p:sp>
+      <p:sp>
+        <p:nvSpPr>
+          <p:cNvPr id="64" name="TextBox 63"/>
+          <p:cNvSpPr txBox="1"/>
+          <p:nvPr/>
+        </p:nvSpPr>
+        <p:spPr>
+          <a:xfrm>
+            <a:off x="5016398" y="3076956"/>
+            <a:ext cx="2156155" cy="150876"/>
+          </a:xfrm>
+          <a:prstGeom prst="rect">
+            <a:avLst/>
+          </a:prstGeom>
+          <a:noFill/>
+        </p:spPr>
+        <p:txBody>
+          <a:bodyPr wrap="square" lIns="0" rIns="0" tIns="0" bIns="0" anchor="t">
+            <a:noAutofit/>
+          </a:bodyPr>
+          <a:lstStyle/>
+          <a:p>
+            <a:pPr algn="l">
+              <a:lnSpc>
+                <a:spcPts val="1188"/>
+              </a:lnSpc>
+            </a:pPr>
+            <a:r>
+              <a:rPr sz="900" b="1">
+                <a:solidFill>
+                  <a:srgbClr val="1E2F5C"/>
+                </a:solidFill>
+                <a:latin typeface="Kanit"/>
+              </a:rPr>
               <a:t>สุกร</a:t>
             </a:r>
           </a:p>
@@ -49543,13 +50179,13 @@
       </p:sp>
       <p:sp>
         <p:nvSpPr>
-          <p:cNvPr id="51" name="TextBox 50"/>
+          <p:cNvPr id="65" name="TextBox 64"/>
           <p:cNvSpPr txBox="1"/>
           <p:nvPr/>
         </p:nvSpPr>
         <p:spPr>
           <a:xfrm>
-            <a:off x="411480" y="3218687"/>
+            <a:off x="5016398" y="3218687"/>
             <a:ext cx="2156155" cy="125730"/>
           </a:xfrm>
           <a:prstGeom prst="rect">
@@ -49582,13 +50218,13 @@
       </p:sp>
       <p:sp>
         <p:nvSpPr>
-          <p:cNvPr id="52" name="TextBox 51"/>
+          <p:cNvPr id="66" name="TextBox 65"/>
           <p:cNvSpPr txBox="1"/>
           <p:nvPr/>
         </p:nvSpPr>
         <p:spPr>
           <a:xfrm>
-            <a:off x="411480" y="3351275"/>
+            <a:off x="5016398" y="3351275"/>
             <a:ext cx="1078077" cy="134112"/>
           </a:xfrm>
           <a:prstGeom prst="rect">
@@ -49614,20 +50250,20 @@
                 </a:solidFill>
                 <a:latin typeface="Kanit"/>
               </a:rPr>
-              <a:t>เทียบปีก่อน +13.1%</a:t>
+              <a:t>เทียบปีก่อน +18.0%</a:t>
             </a:r>
           </a:p>
         </p:txBody>
       </p:sp>
       <p:sp>
         <p:nvSpPr>
-          <p:cNvPr id="53" name="TextBox 52"/>
+          <p:cNvPr id="67" name="TextBox 66"/>
           <p:cNvSpPr txBox="1"/>
           <p:nvPr/>
         </p:nvSpPr>
         <p:spPr>
           <a:xfrm>
-            <a:off x="1489557" y="3351275"/>
+            <a:off x="6094475" y="3351275"/>
             <a:ext cx="1078077" cy="134112"/>
           </a:xfrm>
           <a:prstGeom prst="rect">
@@ -49660,13 +50296,13 @@
       </p:sp>
       <p:sp>
         <p:nvSpPr>
-          <p:cNvPr id="54" name="Rectangle 53"/>
+          <p:cNvPr id="68" name="Rectangle 67"/>
           <p:cNvSpPr/>
           <p:nvPr/>
         </p:nvSpPr>
         <p:spPr>
           <a:xfrm>
-            <a:off x="411480" y="3506724"/>
+            <a:off x="5016398" y="3506724"/>
             <a:ext cx="2156155" cy="548640"/>
           </a:xfrm>
           <a:prstGeom prst="rect">
@@ -49706,13 +50342,13 @@
       </p:sp>
       <p:sp>
         <p:nvSpPr>
-          <p:cNvPr id="55" name="Freeform 54"/>
+          <p:cNvPr id="69" name="Freeform 68"/>
           <p:cNvSpPr/>
           <p:nvPr/>
         </p:nvSpPr>
         <p:spPr>
           <a:xfrm>
-            <a:off x="457200" y="3552444"/>
+            <a:off x="5062118" y="3552444"/>
             <a:ext cx="2064715" cy="457200"/>
           </a:xfrm>
           <a:custGeom>
@@ -49776,649 +50412,13 @@
       </p:sp>
       <p:sp>
         <p:nvSpPr>
-          <p:cNvPr id="56" name="Rounded Rectangle 55"/>
-          <p:cNvSpPr/>
-          <p:nvPr/>
-        </p:nvSpPr>
-        <p:spPr>
-          <a:xfrm>
-            <a:off x="2480767" y="3511296"/>
-            <a:ext cx="82296" cy="82296"/>
-          </a:xfrm>
-          <a:prstGeom prst="roundRect">
-            <a:avLst>
-              <a:gd name="adj" fmla="val 50000"/>
-            </a:avLst>
-          </a:prstGeom>
-          <a:solidFill>
-            <a:srgbClr val="15795F"/>
-          </a:solidFill>
-          <a:ln>
-            <a:noFill/>
-          </a:ln>
-          <a:effectLst/>
-        </p:spPr>
-        <p:style>
-          <a:lnRef idx="1">
-            <a:schemeClr val="accent1"/>
-          </a:lnRef>
-          <a:fillRef idx="3">
-            <a:schemeClr val="accent1"/>
-          </a:fillRef>
-          <a:effectRef idx="2">
-            <a:schemeClr val="accent1"/>
-          </a:effectRef>
-          <a:fontRef idx="minor">
-            <a:schemeClr val="lt1"/>
-          </a:fontRef>
-        </p:style>
-        <p:txBody>
-          <a:bodyPr rtlCol="0" anchor="ctr" wrap="none"/>
-          <a:lstStyle/>
-          <a:p>
-            <a:pPr algn="ctr"/>
-          </a:p>
-        </p:txBody>
-      </p:sp>
-      <p:sp>
-        <p:nvSpPr>
-          <p:cNvPr id="57" name="TextBox 56"/>
-          <p:cNvSpPr txBox="1"/>
-          <p:nvPr/>
-        </p:nvSpPr>
-        <p:spPr>
-          <a:xfrm>
-            <a:off x="2713939" y="3076956"/>
-            <a:ext cx="2156155" cy="150876"/>
-          </a:xfrm>
-          <a:prstGeom prst="rect">
-            <a:avLst/>
-          </a:prstGeom>
-          <a:noFill/>
-        </p:spPr>
-        <p:txBody>
-          <a:bodyPr wrap="square" lIns="0" rIns="0" tIns="0" bIns="0" anchor="t">
-            <a:noAutofit/>
-          </a:bodyPr>
-          <a:lstStyle/>
-          <a:p>
-            <a:pPr algn="l">
-              <a:lnSpc>
-                <a:spcPts val="1188"/>
-              </a:lnSpc>
-            </a:pPr>
-            <a:r>
-              <a:rPr sz="900" b="1">
-                <a:solidFill>
-                  <a:srgbClr val="1E2F5C"/>
-                </a:solidFill>
-                <a:latin typeface="Kanit"/>
-              </a:rPr>
-              <a:t>ข้าวหอมมะลิ</a:t>
-            </a:r>
-          </a:p>
-        </p:txBody>
-      </p:sp>
-      <p:sp>
-        <p:nvSpPr>
-          <p:cNvPr id="58" name="TextBox 57"/>
-          <p:cNvSpPr txBox="1"/>
-          <p:nvPr/>
-        </p:nvSpPr>
-        <p:spPr>
-          <a:xfrm>
-            <a:off x="2713939" y="3218687"/>
-            <a:ext cx="2156155" cy="125730"/>
-          </a:xfrm>
-          <a:prstGeom prst="rect">
-            <a:avLst/>
-          </a:prstGeom>
-          <a:noFill/>
-        </p:spPr>
-        <p:txBody>
-          <a:bodyPr wrap="square" lIns="0" rIns="0" tIns="0" bIns="0" anchor="t">
-            <a:noAutofit/>
-          </a:bodyPr>
-          <a:lstStyle/>
-          <a:p>
-            <a:pPr algn="l">
-              <a:lnSpc>
-                <a:spcPts val="990"/>
-              </a:lnSpc>
-            </a:pPr>
-            <a:r>
-              <a:rPr sz="750" b="0">
-                <a:solidFill>
-                  <a:srgbClr val="606060"/>
-                </a:solidFill>
-                <a:latin typeface="Kanit"/>
-              </a:rPr>
-              <a:t>฿17,763 /ตัน · อีสาน·เหนือ·กลาง</a:t>
-            </a:r>
-          </a:p>
-        </p:txBody>
-      </p:sp>
-      <p:sp>
-        <p:nvSpPr>
-          <p:cNvPr id="59" name="TextBox 58"/>
-          <p:cNvSpPr txBox="1"/>
-          <p:nvPr/>
-        </p:nvSpPr>
-        <p:spPr>
-          <a:xfrm>
-            <a:off x="2713939" y="3351275"/>
-            <a:ext cx="1078077" cy="134112"/>
-          </a:xfrm>
-          <a:prstGeom prst="rect">
-            <a:avLst/>
-          </a:prstGeom>
-          <a:noFill/>
-        </p:spPr>
-        <p:txBody>
-          <a:bodyPr wrap="square" lIns="0" rIns="0" tIns="0" bIns="0" anchor="t">
-            <a:noAutofit/>
-          </a:bodyPr>
-          <a:lstStyle/>
-          <a:p>
-            <a:pPr algn="l">
-              <a:lnSpc>
-                <a:spcPts val="1056"/>
-              </a:lnSpc>
-            </a:pPr>
-            <a:r>
-              <a:rPr sz="800" b="1">
-                <a:solidFill>
-                  <a:srgbClr val="15795F"/>
-                </a:solidFill>
-                <a:latin typeface="Kanit"/>
-              </a:rPr>
-              <a:t>เทียบปีก่อน +14.0%</a:t>
-            </a:r>
-          </a:p>
-        </p:txBody>
-      </p:sp>
-      <p:sp>
-        <p:nvSpPr>
-          <p:cNvPr id="60" name="TextBox 59"/>
-          <p:cNvSpPr txBox="1"/>
-          <p:nvPr/>
-        </p:nvSpPr>
-        <p:spPr>
-          <a:xfrm>
-            <a:off x="3792016" y="3351275"/>
-            <a:ext cx="1078077" cy="134112"/>
-          </a:xfrm>
-          <a:prstGeom prst="rect">
-            <a:avLst/>
-          </a:prstGeom>
-          <a:noFill/>
-        </p:spPr>
-        <p:txBody>
-          <a:bodyPr wrap="square" lIns="0" rIns="0" tIns="0" bIns="0" anchor="t">
-            <a:noAutofit/>
-          </a:bodyPr>
-          <a:lstStyle/>
-          <a:p>
-            <a:pPr algn="l">
-              <a:lnSpc>
-                <a:spcPts val="1056"/>
-              </a:lnSpc>
-            </a:pPr>
-            <a:r>
-              <a:rPr sz="800" b="1">
-                <a:solidFill>
-                  <a:srgbClr val="15795F"/>
-                </a:solidFill>
-                <a:latin typeface="Kanit"/>
-              </a:rPr>
-              <a:t>6 เดือน +7.7%</a:t>
-            </a:r>
-          </a:p>
-        </p:txBody>
-      </p:sp>
-      <p:sp>
-        <p:nvSpPr>
-          <p:cNvPr id="61" name="Rectangle 60"/>
-          <p:cNvSpPr/>
-          <p:nvPr/>
-        </p:nvSpPr>
-        <p:spPr>
-          <a:xfrm>
-            <a:off x="2713939" y="3506724"/>
-            <a:ext cx="2156155" cy="548640"/>
-          </a:xfrm>
-          <a:prstGeom prst="rect">
-            <a:avLst/>
-          </a:prstGeom>
-          <a:solidFill>
-            <a:srgbClr val="FBFCFE"/>
-          </a:solidFill>
-          <a:ln w="9525">
-            <a:solidFill>
-              <a:srgbClr val="D9DEE9"/>
-            </a:solidFill>
-          </a:ln>
-          <a:effectLst/>
-        </p:spPr>
-        <p:style>
-          <a:lnRef idx="1">
-            <a:schemeClr val="accent1"/>
-          </a:lnRef>
-          <a:fillRef idx="3">
-            <a:schemeClr val="accent1"/>
-          </a:fillRef>
-          <a:effectRef idx="2">
-            <a:schemeClr val="accent1"/>
-          </a:effectRef>
-          <a:fontRef idx="minor">
-            <a:schemeClr val="lt1"/>
-          </a:fontRef>
-        </p:style>
-        <p:txBody>
-          <a:bodyPr rtlCol="0" anchor="ctr" wrap="none"/>
-          <a:lstStyle/>
-          <a:p>
-            <a:pPr algn="ctr"/>
-          </a:p>
-        </p:txBody>
-      </p:sp>
-      <p:sp>
-        <p:nvSpPr>
-          <p:cNvPr id="62" name="Freeform 61"/>
-          <p:cNvSpPr/>
-          <p:nvPr/>
-        </p:nvSpPr>
-        <p:spPr>
-          <a:xfrm>
-            <a:off x="2759659" y="3552444"/>
-            <a:ext cx="2064715" cy="457200"/>
-          </a:xfrm>
-          <a:custGeom>
-            <a:avLst/>
-            <a:gdLst/>
-            <a:ahLst/>
-            <a:cxnLst/>
-            <a:rect l="l" t="t" r="r" b="b"/>
-            <a:pathLst>
-              <a:path w="2064715" h="457200">
-                <a:moveTo>
-                  <a:pt x="0" y="457200"/>
-                </a:moveTo>
-                <a:lnTo>
-                  <a:pt x="412943" y="341371"/>
-                </a:lnTo>
-                <a:lnTo>
-                  <a:pt x="825886" y="153981"/>
-                </a:lnTo>
-                <a:lnTo>
-                  <a:pt x="1238829" y="34219"/>
-                </a:lnTo>
-                <a:lnTo>
-                  <a:pt x="1651772" y="23720"/>
-                </a:lnTo>
-                <a:lnTo>
-                  <a:pt x="2064715" y="0"/>
-                </a:lnTo>
-              </a:path>
-            </a:pathLst>
-          </a:custGeom>
-          <a:noFill/>
-          <a:ln w="20320">
-            <a:solidFill>
-              <a:srgbClr val="15795F"/>
-            </a:solidFill>
-          </a:ln>
-          <a:effectLst/>
-        </p:spPr>
-        <p:style>
-          <a:lnRef idx="1">
-            <a:schemeClr val="accent1"/>
-          </a:lnRef>
-          <a:fillRef idx="3">
-            <a:schemeClr val="accent1"/>
-          </a:fillRef>
-          <a:effectRef idx="2">
-            <a:schemeClr val="accent1"/>
-          </a:effectRef>
-          <a:fontRef idx="minor">
-            <a:schemeClr val="lt1"/>
-          </a:fontRef>
-        </p:style>
-        <p:txBody>
-          <a:bodyPr rtlCol="0" anchor="ctr"/>
-          <a:lstStyle/>
-          <a:p>
-            <a:pPr algn="ctr"/>
-          </a:p>
-        </p:txBody>
-      </p:sp>
-      <p:sp>
-        <p:nvSpPr>
-          <p:cNvPr id="63" name="Rounded Rectangle 62"/>
-          <p:cNvSpPr/>
-          <p:nvPr/>
-        </p:nvSpPr>
-        <p:spPr>
-          <a:xfrm>
-            <a:off x="4783226" y="3511296"/>
-            <a:ext cx="82296" cy="82296"/>
-          </a:xfrm>
-          <a:prstGeom prst="roundRect">
-            <a:avLst>
-              <a:gd name="adj" fmla="val 50000"/>
-            </a:avLst>
-          </a:prstGeom>
-          <a:solidFill>
-            <a:srgbClr val="15795F"/>
-          </a:solidFill>
-          <a:ln>
-            <a:noFill/>
-          </a:ln>
-          <a:effectLst/>
-        </p:spPr>
-        <p:style>
-          <a:lnRef idx="1">
-            <a:schemeClr val="accent1"/>
-          </a:lnRef>
-          <a:fillRef idx="3">
-            <a:schemeClr val="accent1"/>
-          </a:fillRef>
-          <a:effectRef idx="2">
-            <a:schemeClr val="accent1"/>
-          </a:effectRef>
-          <a:fontRef idx="minor">
-            <a:schemeClr val="lt1"/>
-          </a:fontRef>
-        </p:style>
-        <p:txBody>
-          <a:bodyPr rtlCol="0" anchor="ctr" wrap="none"/>
-          <a:lstStyle/>
-          <a:p>
-            <a:pPr algn="ctr"/>
-          </a:p>
-        </p:txBody>
-      </p:sp>
-      <p:sp>
-        <p:nvSpPr>
-          <p:cNvPr id="64" name="TextBox 63"/>
-          <p:cNvSpPr txBox="1"/>
-          <p:nvPr/>
-        </p:nvSpPr>
-        <p:spPr>
-          <a:xfrm>
-            <a:off x="5016398" y="3076956"/>
-            <a:ext cx="2156155" cy="150876"/>
-          </a:xfrm>
-          <a:prstGeom prst="rect">
-            <a:avLst/>
-          </a:prstGeom>
-          <a:noFill/>
-        </p:spPr>
-        <p:txBody>
-          <a:bodyPr wrap="square" lIns="0" rIns="0" tIns="0" bIns="0" anchor="t">
-            <a:noAutofit/>
-          </a:bodyPr>
-          <a:lstStyle/>
-          <a:p>
-            <a:pPr algn="l">
-              <a:lnSpc>
-                <a:spcPts val="1188"/>
-              </a:lnSpc>
-            </a:pPr>
-            <a:r>
-              <a:rPr sz="900" b="1">
-                <a:solidFill>
-                  <a:srgbClr val="1E2F5C"/>
-                </a:solidFill>
-                <a:latin typeface="Kanit"/>
-              </a:rPr>
-              <a:t>ข้าวโพดเลี้ยงสัตว์</a:t>
-            </a:r>
-          </a:p>
-        </p:txBody>
-      </p:sp>
-      <p:sp>
-        <p:nvSpPr>
-          <p:cNvPr id="65" name="TextBox 64"/>
-          <p:cNvSpPr txBox="1"/>
-          <p:nvPr/>
-        </p:nvSpPr>
-        <p:spPr>
-          <a:xfrm>
-            <a:off x="5016398" y="3218687"/>
-            <a:ext cx="2156155" cy="125730"/>
-          </a:xfrm>
-          <a:prstGeom prst="rect">
-            <a:avLst/>
-          </a:prstGeom>
-          <a:noFill/>
-        </p:spPr>
-        <p:txBody>
-          <a:bodyPr wrap="square" lIns="0" rIns="0" tIns="0" bIns="0" anchor="t">
-            <a:noAutofit/>
-          </a:bodyPr>
-          <a:lstStyle/>
-          <a:p>
-            <a:pPr algn="l">
-              <a:lnSpc>
-                <a:spcPts val="990"/>
-              </a:lnSpc>
-            </a:pPr>
-            <a:r>
-              <a:rPr sz="750" b="0">
-                <a:solidFill>
-                  <a:srgbClr val="606060"/>
-                </a:solidFill>
-                <a:latin typeface="Kanit"/>
-              </a:rPr>
-              <a:t>฿9.76 /กก. · เหนือ</a:t>
-            </a:r>
-          </a:p>
-        </p:txBody>
-      </p:sp>
-      <p:sp>
-        <p:nvSpPr>
-          <p:cNvPr id="66" name="TextBox 65"/>
-          <p:cNvSpPr txBox="1"/>
-          <p:nvPr/>
-        </p:nvSpPr>
-        <p:spPr>
-          <a:xfrm>
-            <a:off x="5016398" y="3351275"/>
-            <a:ext cx="1078077" cy="134112"/>
-          </a:xfrm>
-          <a:prstGeom prst="rect">
-            <a:avLst/>
-          </a:prstGeom>
-          <a:noFill/>
-        </p:spPr>
-        <p:txBody>
-          <a:bodyPr wrap="square" lIns="0" rIns="0" tIns="0" bIns="0" anchor="t">
-            <a:noAutofit/>
-          </a:bodyPr>
-          <a:lstStyle/>
-          <a:p>
-            <a:pPr algn="l">
-              <a:lnSpc>
-                <a:spcPts val="1056"/>
-              </a:lnSpc>
-            </a:pPr>
-            <a:r>
-              <a:rPr sz="800" b="1">
-                <a:solidFill>
-                  <a:srgbClr val="15795F"/>
-                </a:solidFill>
-                <a:latin typeface="Kanit"/>
-              </a:rPr>
-              <a:t>เทียบปีก่อน +16.8%</a:t>
-            </a:r>
-          </a:p>
-        </p:txBody>
-      </p:sp>
-      <p:sp>
-        <p:nvSpPr>
-          <p:cNvPr id="67" name="TextBox 66"/>
-          <p:cNvSpPr txBox="1"/>
-          <p:nvPr/>
-        </p:nvSpPr>
-        <p:spPr>
-          <a:xfrm>
-            <a:off x="6094475" y="3351275"/>
-            <a:ext cx="1078077" cy="134112"/>
-          </a:xfrm>
-          <a:prstGeom prst="rect">
-            <a:avLst/>
-          </a:prstGeom>
-          <a:noFill/>
-        </p:spPr>
-        <p:txBody>
-          <a:bodyPr wrap="square" lIns="0" rIns="0" tIns="0" bIns="0" anchor="t">
-            <a:noAutofit/>
-          </a:bodyPr>
-          <a:lstStyle/>
-          <a:p>
-            <a:pPr algn="l">
-              <a:lnSpc>
-                <a:spcPts val="1056"/>
-              </a:lnSpc>
-            </a:pPr>
-            <a:r>
-              <a:rPr sz="800" b="1">
-                <a:solidFill>
-                  <a:srgbClr val="15795F"/>
-                </a:solidFill>
-                <a:latin typeface="Kanit"/>
-              </a:rPr>
-              <a:t>6 เดือน +9.7%</a:t>
-            </a:r>
-          </a:p>
-        </p:txBody>
-      </p:sp>
-      <p:sp>
-        <p:nvSpPr>
-          <p:cNvPr id="68" name="Rectangle 67"/>
-          <p:cNvSpPr/>
-          <p:nvPr/>
-        </p:nvSpPr>
-        <p:spPr>
-          <a:xfrm>
-            <a:off x="5016398" y="3506724"/>
-            <a:ext cx="2156155" cy="548640"/>
-          </a:xfrm>
-          <a:prstGeom prst="rect">
-            <a:avLst/>
-          </a:prstGeom>
-          <a:solidFill>
-            <a:srgbClr val="FBFCFE"/>
-          </a:solidFill>
-          <a:ln w="9525">
-            <a:solidFill>
-              <a:srgbClr val="D9DEE9"/>
-            </a:solidFill>
-          </a:ln>
-          <a:effectLst/>
-        </p:spPr>
-        <p:style>
-          <a:lnRef idx="1">
-            <a:schemeClr val="accent1"/>
-          </a:lnRef>
-          <a:fillRef idx="3">
-            <a:schemeClr val="accent1"/>
-          </a:fillRef>
-          <a:effectRef idx="2">
-            <a:schemeClr val="accent1"/>
-          </a:effectRef>
-          <a:fontRef idx="minor">
-            <a:schemeClr val="lt1"/>
-          </a:fontRef>
-        </p:style>
-        <p:txBody>
-          <a:bodyPr rtlCol="0" anchor="ctr" wrap="none"/>
-          <a:lstStyle/>
-          <a:p>
-            <a:pPr algn="ctr"/>
-          </a:p>
-        </p:txBody>
-      </p:sp>
-      <p:sp>
-        <p:nvSpPr>
-          <p:cNvPr id="69" name="Freeform 68"/>
-          <p:cNvSpPr/>
-          <p:nvPr/>
-        </p:nvSpPr>
-        <p:spPr>
-          <a:xfrm>
-            <a:off x="5062118" y="3552444"/>
-            <a:ext cx="2064715" cy="457200"/>
-          </a:xfrm>
-          <a:custGeom>
-            <a:avLst/>
-            <a:gdLst/>
-            <a:ahLst/>
-            <a:cxnLst/>
-            <a:rect l="l" t="t" r="r" b="b"/>
-            <a:pathLst>
-              <a:path w="2064715" h="457200">
-                <a:moveTo>
-                  <a:pt x="0" y="457200"/>
-                </a:moveTo>
-                <a:lnTo>
-                  <a:pt x="412943" y="350931"/>
-                </a:lnTo>
-                <a:lnTo>
-                  <a:pt x="825886" y="79083"/>
-                </a:lnTo>
-                <a:lnTo>
-                  <a:pt x="1238829" y="0"/>
-                </a:lnTo>
-                <a:lnTo>
-                  <a:pt x="1651772" y="54369"/>
-                </a:lnTo>
-                <a:lnTo>
-                  <a:pt x="2064715" y="294090"/>
-                </a:lnTo>
-              </a:path>
-            </a:pathLst>
-          </a:custGeom>
-          <a:noFill/>
-          <a:ln w="20320">
-            <a:solidFill>
-              <a:srgbClr val="15795F"/>
-            </a:solidFill>
-          </a:ln>
-          <a:effectLst/>
-        </p:spPr>
-        <p:style>
-          <a:lnRef idx="1">
-            <a:schemeClr val="accent1"/>
-          </a:lnRef>
-          <a:fillRef idx="3">
-            <a:schemeClr val="accent1"/>
-          </a:fillRef>
-          <a:effectRef idx="2">
-            <a:schemeClr val="accent1"/>
-          </a:effectRef>
-          <a:fontRef idx="minor">
-            <a:schemeClr val="lt1"/>
-          </a:fontRef>
-        </p:style>
-        <p:txBody>
-          <a:bodyPr rtlCol="0" anchor="ctr"/>
-          <a:lstStyle/>
-          <a:p>
-            <a:pPr algn="ctr"/>
-          </a:p>
-        </p:txBody>
-      </p:sp>
-      <p:sp>
-        <p:nvSpPr>
           <p:cNvPr id="70" name="Rounded Rectangle 69"/>
           <p:cNvSpPr/>
           <p:nvPr/>
         </p:nvSpPr>
         <p:spPr>
           <a:xfrm>
-            <a:off x="7085685" y="3805386"/>
+            <a:off x="7085685" y="3511296"/>
             <a:ext cx="82296" cy="82296"/>
           </a:xfrm>
           <a:prstGeom prst="roundRect">
@@ -51204,7 +51204,7 @@
                 </a:solidFill>
                 <a:latin typeface="Kanit"/>
               </a:rPr>
-              <a:t>เทียบปีก่อน +73.7%</a:t>
+              <a:t>เทียบปีก่อน +74.8%</a:t>
             </a:r>
           </a:p>
         </p:txBody>
@@ -51522,7 +51522,7 @@
                 </a:solidFill>
                 <a:latin typeface="Kanit"/>
               </a:rPr>
-              <a:t>เทียบปีก่อน +111.6%</a:t>
+              <a:t>เทียบปีก่อน +134.7%</a:t>
             </a:r>
           </a:p>
         </p:txBody>
@@ -51886,7 +51886,7 @@
                 </a:solidFill>
                 <a:latin typeface="Kanit"/>
               </a:rPr>
-              <a:t>ราคาหน้าฟาร์ม วัดจริง — ราคารายวันของ NABC เฉลี่ยเป็นรายเดือน หน่วยเป็นบาทตามที่เผยแพร่ (ไม่มีการแปลงสกุลเงิน) ราคาล่าสุด 2026-08-28, รุ่นข้อมูลย้อนหลัง 2026-08-29 ราคาหน้าฟาร์ม (ราคาที่เกษตรกรขายได้) คือเงินที่เกษตรกรได้รับเมื่อขายครั้งแรก ก่อนพ่อค้าคนกลาง โรงสี หรือค่าขนส่งจะหักส่วนแบ่ง — ไม่ใช่ดัชนีโลก และไม่ใช่ราคาในซูเปอร์มาร์เก็ต แหล่งผลิตเป็นการอ่านแบบ ประมาณการ ว่าสินค้าแต่ละชนิดผลิตที่ไหน และทับซ้อนกันได้ น้ำตาลเป็นราคาอ้อยประกาศของ สอน. ปีละหนึ่งจุด จึงไม่มีการเปลี่ยนแปลงหกเดือนให้แสดง</a:t>
+              <a:t>ราคาหน้าฟาร์ม วัดจริง — ราคารายวันของ NABC เฉลี่ยเป็นรายเดือน หน่วยเป็นบาทตามที่เผยแพร่ (ไม่มีการแปลงสกุลเงิน) ราคาล่าสุด 2026-09-03, รุ่นข้อมูลย้อนหลัง 2026-08-29 ราคาหน้าฟาร์ม (ราคาที่เกษตรกรขายได้) คือเงินที่เกษตรกรได้รับเมื่อขายครั้งแรก ก่อนพ่อค้าคนกลาง โรงสี หรือค่าขนส่งจะหักส่วนแบ่ง — ไม่ใช่ดัชนีโลก และไม่ใช่ราคาในซูเปอร์มาร์เก็ต แหล่งผลิตเป็นการอ่านแบบ ประมาณการ ว่าสินค้าแต่ละชนิดผลิตที่ไหน และทับซ้อนกันได้ น้ำตาลเป็นราคาอ้อยประกาศของ สอน. ปีละหนึ่งจุด จึงไม่มีการเปลี่ยนแปลงหกเดือนให้แสดง</a:t>
             </a:r>
           </a:p>
         </p:txBody>
@@ -52543,7 +52543,7 @@
                           </a:solidFill>
                           <a:latin typeface="Kanit"/>
                         </a:rPr>
-                        <a:t>+9.3%</a:t>
+                        <a:t>+8.5%</a:t>
                       </a:r>
                     </a:p>
                   </a:txBody>
@@ -52775,7 +52775,7 @@
                           </a:solidFill>
                           <a:latin typeface="Kanit"/>
                         </a:rPr>
-                        <a:t>+10.5%</a:t>
+                        <a:t>+9.6%</a:t>
                       </a:r>
                     </a:p>
                   </a:txBody>
@@ -53007,7 +53007,7 @@
                           </a:solidFill>
                           <a:latin typeface="Kanit"/>
                         </a:rPr>
-                        <a:t>+9.6%</a:t>
+                        <a:t>+8.7%</a:t>
                       </a:r>
                     </a:p>
                   </a:txBody>
@@ -53239,7 +53239,7 @@
                           </a:solidFill>
                           <a:latin typeface="Kanit"/>
                         </a:rPr>
-                        <a:t>+9.2%</a:t>
+                        <a:t>+8.3%</a:t>
                       </a:r>
                     </a:p>
                   </a:txBody>
@@ -53471,7 +53471,7 @@
                           </a:solidFill>
                           <a:latin typeface="Kanit"/>
                         </a:rPr>
-                        <a:t>+10.7%</a:t>
+                        <a:t>+9.8%</a:t>
                       </a:r>
                     </a:p>
                   </a:txBody>
@@ -53766,7 +53766,7 @@
                 </a:solidFill>
                 <a:latin typeface="Kanit"/>
               </a:rPr>
-              <a:t>รายได้ วัดจริง — รายได้รายจังหวัดจากการสำรวจภาวะเศรษฐกิจและสังคมของครัวเรือน สสช. (สสช. SES 2566) ค่าจ้างรายภาคจากการสำรวจแรงงาน สสช. (2568 (เฉลี่ย 4 ไตรมาส)) หน่วยบาท/เดือน ค่าของภาค = ค่าเฉลี่ยไม่ถ่วงน้ำหนักของจังหวัดในภาคนั้น การเปลี่ยนแปลงเป็น ประมาณการ — แบบจำลองลำดับที่หนึ่งของรอบราคาและน้ำมัน (ตัวขับเคลื่อนราคาน้ำมัน 2026M07) ใช้ค่าสัมประสิทธิ์ที่มีเอกสารอ้างอิง ไม่ได้ประมาณค่าทางสถิติ ไม่มีข้อมูล SES/LFS รายเดือน จึงไม่มีตัวเลข 6 เดือนวางเทียบไว้</a:t>
+              <a:t>รายได้ วัดจริง — รายได้รายจังหวัดจากการสำรวจภาวะเศรษฐกิจและสังคมของครัวเรือน สสช. (สสช. SES 2566) ค่าจ้างรายภาคจากการสำรวจแรงงาน สสช. (2568 (เฉลี่ย 4 ไตรมาส)) หน่วยบาท/เดือน ค่าของภาค = ค่าเฉลี่ยไม่ถ่วงน้ำหนักของจังหวัดในภาคนั้น การเปลี่ยนแปลงเป็น ประมาณการ — แบบจำลองลำดับที่หนึ่งของรอบราคาและน้ำมัน (ตัวขับเคลื่อนราคาน้ำมัน 2026M08) ใช้ค่าสัมประสิทธิ์ที่มีเอกสารอ้างอิง ไม่ได้ประมาณค่าทางสถิติ ไม่มีข้อมูล SES/LFS รายเดือน จึงไม่มีตัวเลข 6 เดือนวางเทียบไว้</a:t>
             </a:r>
           </a:p>
         </p:txBody>
@@ -54100,7 +54100,7 @@
                 </a:solidFill>
                 <a:latin typeface="Kanit"/>
               </a:rPr>
-              <a:t>• ลดลง −2.75% ทุกภาค โรงงานเคลื่อนไปทางเดียวกัน ส่วนออฟฟิศนิ่ง — เพราะไม่มีช่องทางส่งผ่านในแบบจำลอง ซึ่งไม่เหมือนกับการไม่เปลี่ยนแปลง
+              <a:t>• ลดลง −4.77% ทุกภาค โรงงานเคลื่อนไปทางเดียวกัน ส่วนออฟฟิศนิ่ง — เพราะไม่มีช่องทางส่งผ่านในแบบจำลอง ซึ่งไม่เหมือนกับการไม่เปลี่ยนแปลง
 • มาจากการเคลื่อนไหวของราคาน้ำมันดิบที่วัดได้หนึ่งค่า ผ่านค่าสัมประสิทธิ์ที่เลือกไว้หนึ่งค่า ไม่มีข้อมูลดีเซลหรือค่าขนส่งของไทยรองรับ
 • ยังสำคัญ: อาชีพนี้ตัวรถคือรายได้ โทรไปก่อนดีกว่าโทรไปสาย</a:t>
             </a:r>

</xml_diff>

<commit_message>
deck(mcom): rebuild — the data moved past the committed figures (run 34045523534)
</commit_message>
<xml_diff>
--- a/docs/decks/mcom-2026-08-05-macro-TH.pptx
+++ b/docs/decks/mcom-2026-08-05-macro-TH.pptx
@@ -6240,7 +6240,7 @@
                 </a:solidFill>
                 <a:latin typeface="Kanit"/>
               </a:rPr>
-              <a:t>123</a:t>
+              <a:t>133</a:t>
             </a:r>
           </a:p>
         </p:txBody>
@@ -6279,7 +6279,7 @@
                 </a:solidFill>
                 <a:latin typeface="Kanit"/>
               </a:rPr>
-              <a:t>จาก 793 (15.5%) · เรียลไทม์ · 2026-09-05</a:t>
+              <a:t>จาก 792 (16.8%) · เรียลไทม์ · 2026-09-06</a:t>
             </a:r>
           </a:p>
         </p:txBody>
@@ -6405,7 +6405,7 @@
                 </a:solidFill>
                 <a:latin typeface="Kanit"/>
               </a:rPr>
-              <a:t>25</a:t>
+              <a:t>39</a:t>
             </a:r>
           </a:p>
         </p:txBody>
@@ -6444,7 +6444,7 @@
                 </a:solidFill>
                 <a:latin typeface="Kanit"/>
               </a:rPr>
-              <a:t>ค่าล่าสุดรายวัน · 2026-09-05</a:t>
+              <a:t>ค่าล่าสุดรายวัน · 2026-09-06</a:t>
             </a:r>
           </a:p>
         </p:txBody>
@@ -7928,7 +7928,7 @@
                           </a:solidFill>
                           <a:latin typeface="Kanit"/>
                         </a:rPr>
-                        <a:t>52</a:t>
+                        <a:t>58</a:t>
                       </a:r>
                     </a:p>
                   </a:txBody>
@@ -7951,7 +7951,7 @@
                           </a:solidFill>
                           <a:latin typeface="Kanit"/>
                         </a:rPr>
-                        <a:t>2.6%</a:t>
+                        <a:t>15.8%</a:t>
                       </a:r>
                     </a:p>
                   </a:txBody>
@@ -8022,7 +8022,7 @@
                           </a:solidFill>
                           <a:latin typeface="Kanit"/>
                         </a:rPr>
-                        <a:t>อุทัยธานี</a:t>
+                        <a:t>สมุทรปราการ</a:t>
                       </a:r>
                     </a:p>
                   </a:txBody>
@@ -8045,7 +8045,7 @@
                           </a:solidFill>
                           <a:latin typeface="Kanit"/>
                         </a:rPr>
-                        <a:t>44</a:t>
+                        <a:t>15</a:t>
                       </a:r>
                     </a:p>
                   </a:txBody>
@@ -8068,7 +8068,7 @@
                           </a:solidFill>
                           <a:latin typeface="Kanit"/>
                         </a:rPr>
-                        <a:t>9</a:t>
+                        <a:t>13</a:t>
                       </a:r>
                     </a:p>
                   </a:txBody>
@@ -8114,7 +8114,7 @@
                           </a:solidFill>
                           <a:latin typeface="Kanit"/>
                         </a:rPr>
-                        <a:t>1/4</a:t>
+                        <a:t>4/4</a:t>
                       </a:r>
                     </a:p>
                   </a:txBody>
@@ -8162,7 +8162,7 @@
                           </a:solidFill>
                           <a:latin typeface="Kanit"/>
                         </a:rPr>
-                        <a:t>นครพนม</a:t>
+                        <a:t>อุทัยธานี</a:t>
                       </a:r>
                     </a:p>
                   </a:txBody>
@@ -8185,7 +8185,7 @@
                           </a:solidFill>
                           <a:latin typeface="Kanit"/>
                         </a:rPr>
-                        <a:t>28</a:t>
+                        <a:t>45</a:t>
                       </a:r>
                     </a:p>
                   </a:txBody>
@@ -8208,7 +8208,7 @@
                           </a:solidFill>
                           <a:latin typeface="Kanit"/>
                         </a:rPr>
-                        <a:t>49</a:t>
+                        <a:t>13</a:t>
                       </a:r>
                     </a:p>
                   </a:txBody>
@@ -8227,11 +8227,11 @@
                       <a:r>
                         <a:rPr sz="900" b="1">
                           <a:solidFill>
-                            <a:srgbClr val="F5C242"/>
-                          </a:solidFill>
-                          <a:latin typeface="Kanit"/>
-                        </a:rPr>
-                        <a:t>25.0%</a:t>
+                            <a:srgbClr val="606060"/>
+                          </a:solidFill>
+                          <a:latin typeface="Kanit"/>
+                        </a:rPr>
+                        <a:t>0.0%</a:t>
                       </a:r>
                     </a:p>
                   </a:txBody>
@@ -8254,7 +8254,7 @@
                           </a:solidFill>
                           <a:latin typeface="Kanit"/>
                         </a:rPr>
-                        <a:t>8/14</a:t>
+                        <a:t>1/4</a:t>
                       </a:r>
                     </a:p>
                   </a:txBody>
@@ -8273,11 +8273,11 @@
                       <a:r>
                         <a:rPr sz="900" b="1">
                           <a:solidFill>
-                            <a:srgbClr val="F5C242"/>
-                          </a:solidFill>
-                          <a:latin typeface="Kanit"/>
-                        </a:rPr>
-                        <a:t>4</a:t>
+                            <a:srgbClr val="CC0000"/>
+                          </a:solidFill>
+                          <a:latin typeface="Kanit"/>
+                        </a:rPr>
+                        <a:t>5</a:t>
                       </a:r>
                     </a:p>
                   </a:txBody>
@@ -8302,7 +8302,7 @@
                           </a:solidFill>
                           <a:latin typeface="Kanit"/>
                         </a:rPr>
-                        <a:t>พะเยา</a:t>
+                        <a:t>บึงกาฬ</a:t>
                       </a:r>
                     </a:p>
                   </a:txBody>
@@ -8325,7 +8325,7 @@
                           </a:solidFill>
                           <a:latin typeface="Kanit"/>
                         </a:rPr>
-                        <a:t>126</a:t>
+                        <a:t>11</a:t>
                       </a:r>
                     </a:p>
                   </a:txBody>
@@ -8348,7 +8348,7 @@
                           </a:solidFill>
                           <a:latin typeface="Kanit"/>
                         </a:rPr>
-                        <a:t>88</a:t>
+                        <a:t>134</a:t>
                       </a:r>
                     </a:p>
                   </a:txBody>
@@ -8371,7 +8371,7 @@
                           </a:solidFill>
                           <a:latin typeface="Kanit"/>
                         </a:rPr>
-                        <a:t>14.3%</a:t>
+                        <a:t>45.5%</a:t>
                       </a:r>
                     </a:p>
                   </a:txBody>
@@ -8394,7 +8394,7 @@
                           </a:solidFill>
                           <a:latin typeface="Kanit"/>
                         </a:rPr>
-                        <a:t>3/13</a:t>
+                        <a:t>1/1</a:t>
                       </a:r>
                     </a:p>
                   </a:txBody>
@@ -8442,7 +8442,7 @@
                           </a:solidFill>
                           <a:latin typeface="Kanit"/>
                         </a:rPr>
-                        <a:t>น่าน</a:t>
+                        <a:t>นครนายก</a:t>
                       </a:r>
                     </a:p>
                   </a:txBody>
@@ -8465,7 +8465,7 @@
                           </a:solidFill>
                           <a:latin typeface="Kanit"/>
                         </a:rPr>
-                        <a:t>217</a:t>
+                        <a:t>26</a:t>
                       </a:r>
                     </a:p>
                   </a:txBody>
@@ -8488,7 +8488,7 @@
                           </a:solidFill>
                           <a:latin typeface="Kanit"/>
                         </a:rPr>
-                        <a:t>101</a:t>
+                        <a:t>60</a:t>
                       </a:r>
                     </a:p>
                   </a:txBody>
@@ -8511,7 +8511,7 @@
                           </a:solidFill>
                           <a:latin typeface="Kanit"/>
                         </a:rPr>
-                        <a:t>13.8%</a:t>
+                        <a:t>42.3%</a:t>
                       </a:r>
                     </a:p>
                   </a:txBody>
@@ -8534,7 +8534,7 @@
                           </a:solidFill>
                           <a:latin typeface="Kanit"/>
                         </a:rPr>
-                        <a:t>1/26</a:t>
+                        <a:t>2/6</a:t>
                       </a:r>
                     </a:p>
                   </a:txBody>
@@ -8582,7 +8582,7 @@
                           </a:solidFill>
                           <a:latin typeface="Kanit"/>
                         </a:rPr>
-                        <a:t>อุบลราชธานี</a:t>
+                        <a:t>ปราจีนบุรี</a:t>
                       </a:r>
                     </a:p>
                   </a:txBody>
@@ -8605,7 +8605,7 @@
                           </a:solidFill>
                           <a:latin typeface="Kanit"/>
                         </a:rPr>
-                        <a:t>46</a:t>
+                        <a:t>35</a:t>
                       </a:r>
                     </a:p>
                   </a:txBody>
@@ -8651,7 +8651,7 @@
                           </a:solidFill>
                           <a:latin typeface="Kanit"/>
                         </a:rPr>
-                        <a:t>10.9%</a:t>
+                        <a:t>37.1%</a:t>
                       </a:r>
                     </a:p>
                   </a:txBody>
@@ -8674,7 +8674,7 @@
                           </a:solidFill>
                           <a:latin typeface="Kanit"/>
                         </a:rPr>
-                        <a:t>2/14</a:t>
+                        <a:t>5/15</a:t>
                       </a:r>
                     </a:p>
                   </a:txBody>
@@ -8909,7 +8909,7 @@
                 </a:solidFill>
                 <a:latin typeface="Kanit"/>
               </a:rPr>
-              <a:t>พื้นที่ปลูก วัดจริง (สศก. — ข้อมูลอำเภอ×พืช 3,295 แถว) ภัยแล้งเป็นดัชนี SPEI จาก แบบจำลอง คำนวณจากปริมาณฝนและการคายระเหย ปรับเดือนละครั้ง ดึงข้อมูล 2026-07-20 — เป็นสัญญาณที่ครอบคลุมทั้งประเทศดีที่สุดที่มี แต่ไม่มีใครลงพื้นที่ไปเดินดูอำเภอเหล่านั้น ข้อมูลฝนและระดับน้ำ วัดจริง (ThaiWater เรียลไทม์ ดึงทุกวันและสะสมไว้ — วันที่ดึงไม่สำเร็จจะเว้นเป็นช่องว่าง ไม่ใส่ค่าสมมติ) · ฝนถึง 2026-09-05, ระดับน้ำถึง 2026-09-05 ความเสี่ยงน้ำท่วมเชิงโครงสร้าง วัดจริง (สำมะโนพื้นที่ท่วมซ้ำซาก GISTDA มาตราส่วน 1:50,000 ปี 2005-2016 — เป็นบันทึกภาคพื้นดิน 12 ปี ไม่ใช่การพยากรณ์)</a:t>
+              <a:t>พื้นที่ปลูก วัดจริง (สศก. — ข้อมูลอำเภอ×พืช 3,295 แถว) ภัยแล้งเป็นดัชนี SPEI จาก แบบจำลอง คำนวณจากปริมาณฝนและการคายระเหย ปรับเดือนละครั้ง ดึงข้อมูล 2026-07-20 — เป็นสัญญาณที่ครอบคลุมทั้งประเทศดีที่สุดที่มี แต่ไม่มีใครลงพื้นที่ไปเดินดูอำเภอเหล่านั้น ข้อมูลฝนและระดับน้ำ วัดจริง (ThaiWater เรียลไทม์ ดึงทุกวันและสะสมไว้ — วันที่ดึงไม่สำเร็จจะเว้นเป็นช่องว่าง ไม่ใส่ค่าสมมติ) · ฝนถึง 2026-09-06, ระดับน้ำถึง 2026-09-06 ความเสี่ยงน้ำท่วมเชิงโครงสร้าง วัดจริง (สำมะโนพื้นที่ท่วมซ้ำซาก GISTDA มาตราส่วน 1:50,000 ปี 2005-2016 — เป็นบันทึกภาคพื้นดิน 12 ปี ไม่ใช่การพยากรณ์)</a:t>
             </a:r>
           </a:p>
         </p:txBody>
@@ -32047,7 +32047,7 @@
                 </a:solidFill>
                 <a:latin typeface="Kanit"/>
               </a:rPr>
-              <a:t>รุ่นข้อมูล — ราคาโลก 2026M06 · ราคาหน้าฟาร์มไทย 2026-09-03 · ประวัติราคาไทย 2026-08-29 · ต้นทุนการผลิตพืช สศก. ไจอัป 2568 (ปีเพาะปลูก 2568/69, ประมาณการ สศก. มี.ค. 2569) · ภัยแล้ง 2026-06-21 · เงินเฟ้อ 2026-05 · GDP 2026 ไตรมาส 1 · IMF WEO 2026 · ดัชนีราคาขายต่อ 2026-05 · ยอดจดทะเบียนถึง 2026-01 · หนี้ครัวเรือน สสช. SES 2566 · ค่าจ้าง สสช. LFS 2568 · ข้อมูลตรวจวัด 2026-09-05</a:t>
+              <a:t>รุ่นข้อมูล — ราคาโลก 2026M06 · ราคาหน้าฟาร์มไทย 2026-09-03 · ประวัติราคาไทย 2026-09-05 · ต้นทุนการผลิตพืช สศก. ไจอัป 2568 (ปีเพาะปลูก 2568/69, ประมาณการ สศก. มี.ค. 2569) · ภัยแล้ง 2026-06-21 · เงินเฟ้อ 2026-05 · GDP 2026 ไตรมาส 1 · IMF WEO 2026 · ดัชนีราคาขายต่อ 2026-05 · ยอดจดทะเบียนถึง 2026-01 · หนี้ครัวเรือน สสช. SES 2566 · ค่าจ้าง สสช. LFS 2568 · ข้อมูลตรวจวัด 2026-09-06</a:t>
             </a:r>
           </a:p>
         </p:txBody>
@@ -33912,7 +33912,7 @@
                 </a:solidFill>
                 <a:latin typeface="Kanit"/>
               </a:rPr>
-              <a:t>33.16</a:t>
+              <a:t>32.92</a:t>
             </a:r>
           </a:p>
         </p:txBody>
@@ -33951,7 +33951,7 @@
                 </a:solidFill>
                 <a:latin typeface="Kanit"/>
               </a:rPr>
-              <a:t>อัตราอ้างอิง ECB · 2026-08-31</a:t>
+              <a:t>อัตราอ้างอิง ECB · 2026-09-04</a:t>
             </a:r>
           </a:p>
         </p:txBody>
@@ -35798,7 +35798,7 @@
                 </a:solidFill>
                 <a:latin typeface="Kanit"/>
               </a:rPr>
-              <a:t>สศช. 2026 ไตรมาส 1 · TPSO 2026-05 · ธนาคารแห่งประเทศไทย 2026-08 · BIS 2025 ไตรมาส 4 · ECB 2026-08-31, ทั้งหมดดึงจากหน่วยงานผู้เผยแพร่โดยตรง ตารางเทียบประเทศใช้ IMF World Economic Outlook 2026 (ดึงข้อมูล 2026-07-25) อัตรา NPL ที่ ธปท. เผยแพร่ — 4.48% ณ 2026 ไตรมาส 1, จาก 4.33% ไตรมาสก่อน เปลี่ยน +0.24 จุดใน 1 ปี และต่ำสุด 3.08% ณ 2021 ไตรมาส 1</a:t>
+              <a:t>สศช. 2026 ไตรมาส 1 · TPSO 2026-05 · ธนาคารแห่งประเทศไทย 2026-08 · BIS 2025 ไตรมาส 4 · ECB 2026-09-04, ทั้งหมดดึงจากหน่วยงานผู้เผยแพร่โดยตรง ตารางเทียบประเทศใช้ IMF World Economic Outlook 2026 (ดึงข้อมูล 2026-07-25) อัตรา NPL ที่ ธปท. เผยแพร่ — 4.48% ณ 2026 ไตรมาส 1, จาก 4.33% ไตรมาสก่อน เปลี่ยน +0.24 จุดใน 1 ปี และต่ำสุด 3.08% ณ 2021 ไตรมาส 1</a:t>
             </a:r>
           </a:p>
         </p:txBody>
@@ -37087,7 +37087,7 @@
                 </a:solidFill>
                 <a:latin typeface="Kanit"/>
               </a:rPr>
-              <a:t>338 จาก 928 อำเภอ · แม่น้ำเกินระดับ 123 จาก 793 สถานี</a:t>
+              <a:t>338 จาก 928 อำเภอ · แม่น้ำเกินระดับ 133 จาก 792 สถานี</a:t>
             </a:r>
           </a:p>
         </p:txBody>
@@ -37859,7 +37859,7 @@
                           </a:solidFill>
                           <a:latin typeface="Kanit"/>
                         </a:rPr>
-                        <a:t>26/157</a:t>
+                        <a:t>29/157</a:t>
                       </a:r>
                     </a:p>
                   </a:txBody>
@@ -38091,7 +38091,7 @@
                           </a:solidFill>
                           <a:latin typeface="Kanit"/>
                         </a:rPr>
-                        <a:t>19/274</a:t>
+                        <a:t>16/274</a:t>
                       </a:r>
                     </a:p>
                   </a:txBody>
@@ -38323,7 +38323,7 @@
                           </a:solidFill>
                           <a:latin typeface="Kanit"/>
                         </a:rPr>
-                        <a:t>26/168</a:t>
+                        <a:t>29/167</a:t>
                       </a:r>
                     </a:p>
                   </a:txBody>
@@ -38555,7 +38555,7 @@
                           </a:solidFill>
                           <a:latin typeface="Kanit"/>
                         </a:rPr>
-                        <a:t>15/51</a:t>
+                        <a:t>14/51</a:t>
                       </a:r>
                     </a:p>
                   </a:txBody>
@@ -38787,7 +38787,7 @@
                           </a:solidFill>
                           <a:latin typeface="Kanit"/>
                         </a:rPr>
-                        <a:t>37/143</a:t>
+                        <a:t>45/143</a:t>
                       </a:r>
                     </a:p>
                   </a:txBody>
@@ -39959,7 +39959,7 @@
                           </a:solidFill>
                           <a:latin typeface="Kanit"/>
                         </a:rPr>
-                        <a:t>−50.7%</a:t>
+                        <a:t>−41.3%</a:t>
                       </a:r>
                     </a:p>
                   </a:txBody>
@@ -40791,7 +40791,7 @@
                 </a:solidFill>
                 <a:latin typeface="Kanit"/>
               </a:rPr>
-              <a:t>ราคา วัดจริง — ราคาหน้าฟาร์มไทยจากราคารายวันของ NABC และราคาอ้อยประกาศของ สอน. ราคาล่าสุด 2026-09-03 การเปลี่ยนแปลงหกเดือนคำนวณจากข้อมูลรายเดือนของ NABC เอง (thai_price_history รุ่นข้อมูล 2026-08-29) พืชที่ไม่มีข้อมูลรายเดือนจะกำกับไว้ ไม่ประมาณการขึ้นมา แหล่งผลิตเป็นการอ่านแบบ ประมาณการ ว่าสินค้าแต่ละชนิดปลูกที่ไหน และแหล่งผลิตทับซ้อนกันได้ บัญชีอาชีพเกษตรเป็นข้อมูลของเราเองและ วัดจริง — บัญชีที่บันทึกอาชีพว่า เกษตร ในจังหวัดแหล่งผลิต จากฐานข้อมูล 382,735 บัญชี ณ 2026-07 ไม่เผยแพร่ช่องที่มีน้อยกว่า 30 บัญชี คนกลุ่มนี้อาศัยอยู่ในพื้นที่ที่ปลูกพืชนั้น แต่ไม่ได้ยืนยันว่าปลูกพืชนั้นเอง</a:t>
+              <a:t>ราคา วัดจริง — ราคาหน้าฟาร์มไทยจากราคารายวันของ NABC และราคาอ้อยประกาศของ สอน. ราคาล่าสุด 2026-09-03 การเปลี่ยนแปลงหกเดือนคำนวณจากข้อมูลรายเดือนของ NABC เอง (thai_price_history รุ่นข้อมูล 2026-09-05) พืชที่ไม่มีข้อมูลรายเดือนจะกำกับไว้ ไม่ประมาณการขึ้นมา แหล่งผลิตเป็นการอ่านแบบ ประมาณการ ว่าสินค้าแต่ละชนิดปลูกที่ไหน และแหล่งผลิตทับซ้อนกันได้ บัญชีอาชีพเกษตรเป็นข้อมูลของเราเองและ วัดจริง — บัญชีที่บันทึกอาชีพว่า เกษตร ในจังหวัดแหล่งผลิต จากฐานข้อมูล 382,735 บัญชี ณ 2026-07 ไม่เผยแพร่ช่องที่มีน้อยกว่า 30 บัญชี คนกลุ่มนี้อาศัยอยู่ในพื้นที่ที่ปลูกพืชนั้น แต่ไม่ได้ยืนยันว่าปลูกพืชนั้นเอง</a:t>
             </a:r>
           </a:p>
         </p:txBody>
@@ -43419,7 +43419,7 @@
                           </a:solidFill>
                           <a:latin typeface="Kanit"/>
                         </a:rPr>
-                        <a:t>92.20</a:t>
+                        <a:t>91.52</a:t>
                       </a:r>
                     </a:p>
                   </a:txBody>
@@ -43559,7 +43559,7 @@
                           </a:solidFill>
                           <a:latin typeface="Kanit"/>
                         </a:rPr>
-                        <a:t>15,488</a:t>
+                        <a:t>15,374</a:t>
                       </a:r>
                     </a:p>
                   </a:txBody>
@@ -43699,7 +43699,7 @@
                           </a:solidFill>
                           <a:latin typeface="Kanit"/>
                         </a:rPr>
-                        <a:t>36,515</a:t>
+                        <a:t>36,245</a:t>
                       </a:r>
                     </a:p>
                   </a:txBody>
@@ -43839,7 +43839,7 @@
                           </a:solidFill>
                           <a:latin typeface="Kanit"/>
                         </a:rPr>
-                        <a:t>11.28</a:t>
+                        <a:t>11.19</a:t>
                       </a:r>
                     </a:p>
                   </a:txBody>
@@ -44058,7 +44058,7 @@
                 </a:solidFill>
                 <a:latin typeface="Kanit"/>
               </a:rPr>
-              <a:t>ราคารายเดือนสกุลดอลลาร์ราคาปัจจุบันจาก World Bank Pink Sheet รุ่นข้อมูล 2026M07 (ข้อมูล 60 จุดต่อรายการ ปรับฐานเป็น 100 ณ 2021-07 เพื่อวาดกราฟ — หน่วยต่างกัน จึงใช้แกนเดียวกับระดับราคาดิบไม่ได้) แปลงเป็นบาทด้วยอัตราอ้างอิง ECB USD/THB 33.165 ณ 2026-08-31 สัดส่วนพื้นที่ปลูก วัดจริง จากสัดส่วนพืชของ สศก./กรมส่งเสริมการเกษตร (crop_mix.json) เป็นราคาปัจจุบัน ไม่ได้ปรับเงินเฟ้อ: ทุกตัวเลข ‘เทียบ 5 ปีก่อน’ มีเงินเฟ้อไทยห้าปีซ่อนอยู่ข้างใต้</a:t>
+              <a:t>ราคารายเดือนสกุลดอลลาร์ราคาปัจจุบันจาก World Bank Pink Sheet รุ่นข้อมูล 2026M07 (ข้อมูล 60 จุดต่อรายการ ปรับฐานเป็น 100 ณ 2021-07 เพื่อวาดกราฟ — หน่วยต่างกัน จึงใช้แกนเดียวกับระดับราคาดิบไม่ได้) แปลงเป็นบาทด้วยอัตราอ้างอิง ECB USD/THB 32.920 ณ 2026-09-04 สัดส่วนพื้นที่ปลูก วัดจริง จากสัดส่วนพืชของ สศก./กรมส่งเสริมการเกษตร (crop_mix.json) เป็นราคาปัจจุบัน ไม่ได้ปรับเงินเฟ้อ: ทุกตัวเลข ‘เทียบ 5 ปีก่อน’ มีเงินเฟ้อไทยห้าปีซ่อนอยู่ข้างใต้</a:t>
             </a:r>
           </a:p>
         </p:txBody>
@@ -47985,7 +47985,7 @@
                 </a:solidFill>
                 <a:latin typeface="Kanit"/>
               </a:rPr>
-              <a:t>฿596.84 /ร้อยผล · ใต้·ตอ.</a:t>
+              <a:t>฿580.00 /ร้อยผล · ใต้·ตอ.</a:t>
             </a:r>
           </a:p>
         </p:txBody>
@@ -48063,7 +48063,7 @@
                 </a:solidFill>
                 <a:latin typeface="Kanit"/>
               </a:rPr>
-              <a:t>6 เดือน −50.7%</a:t>
+              <a:t>6 เดือน −41.3%</a:t>
             </a:r>
           </a:p>
         </p:txBody>
@@ -48134,22 +48134,22 @@
             <a:pathLst>
               <a:path w="2064715" h="457200">
                 <a:moveTo>
-                  <a:pt x="0" y="0"/>
+                  <a:pt x="0" y="38315"/>
                 </a:moveTo>
                 <a:lnTo>
-                  <a:pt x="412943" y="170673"/>
-                </a:lnTo>
-                <a:lnTo>
-                  <a:pt x="825886" y="145193"/>
-                </a:lnTo>
-                <a:lnTo>
-                  <a:pt x="1238829" y="399195"/>
-                </a:lnTo>
-                <a:lnTo>
-                  <a:pt x="1651772" y="457200"/>
-                </a:lnTo>
-                <a:lnTo>
-                  <a:pt x="2064715" y="409348"/>
+                  <a:pt x="412943" y="0"/>
+                </a:lnTo>
+                <a:lnTo>
+                  <a:pt x="825886" y="372997"/>
+                </a:lnTo>
+                <a:lnTo>
+                  <a:pt x="1238829" y="457200"/>
+                </a:lnTo>
+                <a:lnTo>
+                  <a:pt x="1651772" y="385356"/>
+                </a:lnTo>
+                <a:lnTo>
+                  <a:pt x="2064715" y="411313"/>
                 </a:lnTo>
               </a:path>
             </a:pathLst>
@@ -48192,7 +48192,7 @@
         </p:nvSpPr>
         <p:spPr>
           <a:xfrm>
-            <a:off x="2480767" y="2814220"/>
+            <a:off x="2480767" y="2816185"/>
             <a:ext cx="82296" cy="82296"/>
           </a:xfrm>
           <a:prstGeom prst="roundRect">
@@ -48621,7 +48621,7 @@
                 </a:solidFill>
                 <a:latin typeface="Kanit"/>
               </a:rPr>
-              <a:t>฿143.14 /กก. · ชายฝั่งใต้·ตอ.</a:t>
+              <a:t>฿142.50 /กก. · ชายฝั่งใต้·ตอ.</a:t>
             </a:r>
           </a:p>
         </p:txBody>
@@ -48695,11 +48695,11 @@
             <a:r>
               <a:rPr sz="800" b="1">
                 <a:solidFill>
-                  <a:srgbClr val="CC0000"/>
+                  <a:srgbClr val="15795F"/>
                 </a:solidFill>
                 <a:latin typeface="Kanit"/>
               </a:rPr>
-              <a:t>6 เดือน −2.0%</a:t>
+              <a:t>6 เดือน +8.0%</a:t>
             </a:r>
           </a:p>
         </p:txBody>
@@ -48770,22 +48770,22 @@
             <a:pathLst>
               <a:path w="2064715" h="457200">
                 <a:moveTo>
-                  <a:pt x="0" y="216948"/>
+                  <a:pt x="0" y="415899"/>
                 </a:moveTo>
                 <a:lnTo>
-                  <a:pt x="412943" y="415955"/>
-                </a:lnTo>
-                <a:lnTo>
-                  <a:pt x="825886" y="457200"/>
-                </a:lnTo>
-                <a:lnTo>
-                  <a:pt x="1238829" y="420285"/>
-                </a:lnTo>
-                <a:lnTo>
-                  <a:pt x="1651772" y="170341"/>
-                </a:lnTo>
-                <a:lnTo>
-                  <a:pt x="2064715" y="0"/>
+                  <a:pt x="412943" y="457200"/>
+                </a:lnTo>
+                <a:lnTo>
+                  <a:pt x="825886" y="420235"/>
+                </a:lnTo>
+                <a:lnTo>
+                  <a:pt x="1238829" y="169952"/>
+                </a:lnTo>
+                <a:lnTo>
+                  <a:pt x="1651772" y="0"/>
+                </a:lnTo>
+                <a:lnTo>
+                  <a:pt x="2064715" y="12596"/>
                 </a:lnTo>
               </a:path>
             </a:pathLst>
@@ -48793,7 +48793,7 @@
           <a:noFill/>
           <a:ln w="20320">
             <a:solidFill>
-              <a:srgbClr val="CC0000"/>
+              <a:srgbClr val="15795F"/>
             </a:solidFill>
           </a:ln>
           <a:effectLst/>
@@ -48828,7 +48828,7 @@
         </p:nvSpPr>
         <p:spPr>
           <a:xfrm>
-            <a:off x="7085685" y="2404872"/>
+            <a:off x="7085685" y="2417468"/>
             <a:ext cx="82296" cy="82296"/>
           </a:xfrm>
           <a:prstGeom prst="roundRect">
@@ -48837,7 +48837,7 @@
             </a:avLst>
           </a:prstGeom>
           <a:solidFill>
-            <a:srgbClr val="CC0000"/>
+            <a:srgbClr val="15795F"/>
           </a:solidFill>
           <a:ln>
             <a:noFill/>
@@ -48939,7 +48939,7 @@
                 </a:solidFill>
                 <a:latin typeface="Kanit"/>
               </a:rPr>
-              <a:t>฿43.05 /กก. · กลาง·ตอ.</a:t>
+              <a:t>฿44.00 /กก. · กลาง·ตอ.</a:t>
             </a:r>
           </a:p>
         </p:txBody>
@@ -49017,7 +49017,7 @@
                 </a:solidFill>
                 <a:latin typeface="Kanit"/>
               </a:rPr>
-              <a:t>6 เดือน +2.4%</a:t>
+              <a:t>6 เดือน +0.0%</a:t>
             </a:r>
           </a:p>
         </p:txBody>
@@ -49088,22 +49088,22 @@
             <a:pathLst>
               <a:path w="2064715" h="457200">
                 <a:moveTo>
-                  <a:pt x="0" y="0"/>
+                  <a:pt x="0" y="122251"/>
                 </a:moveTo>
                 <a:lnTo>
-                  <a:pt x="412943" y="119484"/>
-                </a:lnTo>
-                <a:lnTo>
-                  <a:pt x="825886" y="305129"/>
-                </a:lnTo>
-                <a:lnTo>
-                  <a:pt x="1238829" y="457200"/>
-                </a:lnTo>
-                <a:lnTo>
-                  <a:pt x="1651772" y="245880"/>
-                </a:lnTo>
-                <a:lnTo>
-                  <a:pt x="2064715" y="91834"/>
+                  <a:pt x="412943" y="309106"/>
+                </a:lnTo>
+                <a:lnTo>
+                  <a:pt x="825886" y="457200"/>
+                </a:lnTo>
+                <a:lnTo>
+                  <a:pt x="1238829" y="249472"/>
+                </a:lnTo>
+                <a:lnTo>
+                  <a:pt x="1651772" y="89452"/>
+                </a:lnTo>
+                <a:lnTo>
+                  <a:pt x="2064715" y="0"/>
                 </a:lnTo>
               </a:path>
             </a:pathLst>
@@ -49146,7 +49146,7 @@
         </p:nvSpPr>
         <p:spPr>
           <a:xfrm>
-            <a:off x="9388144" y="2496706"/>
+            <a:off x="9388144" y="2404872"/>
             <a:ext cx="82296" cy="82296"/>
           </a:xfrm>
           <a:prstGeom prst="roundRect">
@@ -49257,7 +49257,7 @@
                 </a:solidFill>
                 <a:latin typeface="Kanit"/>
               </a:rPr>
-              <a:t>฿350.53 /ร้อยฟอง · กลาง·ตอ.</a:t>
+              <a:t>฿360.00 /ร้อยฟอง · กลาง·ตอ.</a:t>
             </a:r>
           </a:p>
         </p:txBody>
@@ -49335,7 +49335,7 @@
                 </a:solidFill>
                 <a:latin typeface="Kanit"/>
               </a:rPr>
-              <a:t>6 เดือน +15.9%</a:t>
+              <a:t>6 เดือน +17.0%</a:t>
             </a:r>
           </a:p>
         </p:txBody>
@@ -49406,19 +49406,19 @@
             <a:pathLst>
               <a:path w="2064715" h="457200">
                 <a:moveTo>
-                  <a:pt x="0" y="457200"/>
+                  <a:pt x="0" y="356259"/>
                 </a:moveTo>
                 <a:lnTo>
-                  <a:pt x="412943" y="218744"/>
-                </a:lnTo>
-                <a:lnTo>
-                  <a:pt x="825886" y="218744"/>
-                </a:lnTo>
-                <a:lnTo>
-                  <a:pt x="1238829" y="309310"/>
-                </a:lnTo>
-                <a:lnTo>
-                  <a:pt x="1651772" y="128177"/>
+                  <a:pt x="412943" y="356259"/>
+                </a:lnTo>
+                <a:lnTo>
+                  <a:pt x="825886" y="457200"/>
+                </a:lnTo>
+                <a:lnTo>
+                  <a:pt x="1238829" y="255319"/>
+                </a:lnTo>
+                <a:lnTo>
+                  <a:pt x="1651772" y="106877"/>
                 </a:lnTo>
                 <a:lnTo>
                   <a:pt x="2064715" y="0"/>
@@ -49575,7 +49575,7 @@
                 </a:solidFill>
                 <a:latin typeface="Kanit"/>
               </a:rPr>
-              <a:t>฿17,763 /ตัน · อีสาน·เหนือ·กลาง</a:t>
+              <a:t>฿17,494 /ตัน · อีสาน·เหนือ·กลาง</a:t>
             </a:r>
           </a:p>
         </p:txBody>
@@ -49653,7 +49653,7 @@
                 </a:solidFill>
                 <a:latin typeface="Kanit"/>
               </a:rPr>
-              <a:t>6 เดือน +7.7%</a:t>
+              <a:t>6 เดือน +4.3%</a:t>
             </a:r>
           </a:p>
         </p:txBody>
@@ -49727,19 +49727,19 @@
                   <a:pt x="0" y="457200"/>
                 </a:moveTo>
                 <a:lnTo>
-                  <a:pt x="412943" y="341371"/>
-                </a:lnTo>
-                <a:lnTo>
-                  <a:pt x="825886" y="153981"/>
-                </a:lnTo>
-                <a:lnTo>
-                  <a:pt x="1238829" y="34219"/>
-                </a:lnTo>
-                <a:lnTo>
-                  <a:pt x="1651772" y="23720"/>
-                </a:lnTo>
-                <a:lnTo>
-                  <a:pt x="2064715" y="0"/>
+                  <a:pt x="412943" y="212701"/>
+                </a:lnTo>
+                <a:lnTo>
+                  <a:pt x="825886" y="41154"/>
+                </a:lnTo>
+                <a:lnTo>
+                  <a:pt x="1238829" y="30357"/>
+                </a:lnTo>
+                <a:lnTo>
+                  <a:pt x="1651772" y="0"/>
+                </a:lnTo>
+                <a:lnTo>
+                  <a:pt x="2064715" y="163560"/>
                 </a:lnTo>
               </a:path>
             </a:pathLst>
@@ -49782,7 +49782,7 @@
         </p:nvSpPr>
         <p:spPr>
           <a:xfrm>
-            <a:off x="2480767" y="3511296"/>
+            <a:off x="2480767" y="3674856"/>
             <a:ext cx="82296" cy="82296"/>
           </a:xfrm>
           <a:prstGeom prst="roundRect">
@@ -49893,7 +49893,7 @@
                 </a:solidFill>
                 <a:latin typeface="Kanit"/>
               </a:rPr>
-              <a:t>฿9.76 /กก. · เหนือ</a:t>
+              <a:t>฿9.05 /กก. · เหนือ</a:t>
             </a:r>
           </a:p>
         </p:txBody>
@@ -49967,11 +49967,11 @@
             <a:r>
               <a:rPr sz="800" b="1">
                 <a:solidFill>
-                  <a:srgbClr val="15795F"/>
+                  <a:srgbClr val="CC0000"/>
                 </a:solidFill>
                 <a:latin typeface="Kanit"/>
               </a:rPr>
-              <a:t>6 เดือน +9.7%</a:t>
+              <a:t>6 เดือน −0.3%</a:t>
             </a:r>
           </a:p>
         </p:txBody>
@@ -50042,22 +50042,22 @@
             <a:pathLst>
               <a:path w="2064715" h="457200">
                 <a:moveTo>
-                  <a:pt x="0" y="457200"/>
+                  <a:pt x="0" y="342301"/>
                 </a:moveTo>
                 <a:lnTo>
-                  <a:pt x="412943" y="350931"/>
-                </a:lnTo>
-                <a:lnTo>
-                  <a:pt x="825886" y="79083"/>
-                </a:lnTo>
-                <a:lnTo>
-                  <a:pt x="1238829" y="0"/>
-                </a:lnTo>
-                <a:lnTo>
-                  <a:pt x="1651772" y="54369"/>
-                </a:lnTo>
-                <a:lnTo>
-                  <a:pt x="2064715" y="294090"/>
+                  <a:pt x="412943" y="83780"/>
+                </a:lnTo>
+                <a:lnTo>
+                  <a:pt x="825886" y="0"/>
+                </a:lnTo>
+                <a:lnTo>
+                  <a:pt x="1238829" y="47874"/>
+                </a:lnTo>
+                <a:lnTo>
+                  <a:pt x="1651772" y="292033"/>
+                </a:lnTo>
+                <a:lnTo>
+                  <a:pt x="2064715" y="457200"/>
                 </a:lnTo>
               </a:path>
             </a:pathLst>
@@ -50065,7 +50065,7 @@
           <a:noFill/>
           <a:ln w="20320">
             <a:solidFill>
-              <a:srgbClr val="15795F"/>
+              <a:srgbClr val="CC0000"/>
             </a:solidFill>
           </a:ln>
           <a:effectLst/>
@@ -50100,7 +50100,7 @@
         </p:nvSpPr>
         <p:spPr>
           <a:xfrm>
-            <a:off x="4783226" y="3805386"/>
+            <a:off x="4783226" y="3968496"/>
             <a:ext cx="82296" cy="82296"/>
           </a:xfrm>
           <a:prstGeom prst="roundRect">
@@ -50109,7 +50109,7 @@
             </a:avLst>
           </a:prstGeom>
           <a:solidFill>
-            <a:srgbClr val="15795F"/>
+            <a:srgbClr val="CC0000"/>
           </a:solidFill>
           <a:ln>
             <a:noFill/>
@@ -50211,7 +50211,7 @@
                 </a:solidFill>
                 <a:latin typeface="Kanit"/>
               </a:rPr>
-              <a:t>฿71.18 /กก. · กลาง·ตต.·ตอ.</a:t>
+              <a:t>฿74.67 /กก. · กลาง·ตต.·ตอ.</a:t>
             </a:r>
           </a:p>
         </p:txBody>
@@ -50289,7 +50289,7 @@
                 </a:solidFill>
                 <a:latin typeface="Kanit"/>
               </a:rPr>
-              <a:t>6 เดือน +28.2%</a:t>
+              <a:t>6 เดือน +18.4%</a:t>
             </a:r>
           </a:p>
         </p:txBody>
@@ -50360,19 +50360,19 @@
             <a:pathLst>
               <a:path w="2064715" h="457200">
                 <a:moveTo>
-                  <a:pt x="0" y="371819"/>
+                  <a:pt x="0" y="220046"/>
                 </a:moveTo>
                 <a:lnTo>
-                  <a:pt x="412943" y="140924"/>
-                </a:lnTo>
-                <a:lnTo>
-                  <a:pt x="825886" y="457200"/>
-                </a:lnTo>
-                <a:lnTo>
-                  <a:pt x="1238829" y="309849"/>
-                </a:lnTo>
-                <a:lnTo>
-                  <a:pt x="1651772" y="196008"/>
+                  <a:pt x="412943" y="457200"/>
+                </a:lnTo>
+                <a:lnTo>
+                  <a:pt x="825886" y="343487"/>
+                </a:lnTo>
+                <a:lnTo>
+                  <a:pt x="1238829" y="264994"/>
+                </a:lnTo>
+                <a:lnTo>
+                  <a:pt x="1651772" y="111364"/>
                 </a:lnTo>
                 <a:lnTo>
                   <a:pt x="2064715" y="0"/>
@@ -50529,7 +50529,7 @@
                 </a:solidFill>
                 <a:latin typeface="Kanit"/>
               </a:rPr>
-              <a:t>฿8.51 /กก. · ใต้</a:t>
+              <a:t>฿8.38 /กก. · ใต้</a:t>
             </a:r>
           </a:p>
         </p:txBody>
@@ -50607,7 +50607,7 @@
                 </a:solidFill>
                 <a:latin typeface="Kanit"/>
               </a:rPr>
-              <a:t>6 เดือน +24.6%</a:t>
+              <a:t>6 เดือน +16.2%</a:t>
             </a:r>
           </a:p>
         </p:txBody>
@@ -50678,22 +50678,22 @@
             <a:pathLst>
               <a:path w="2064715" h="457200">
                 <a:moveTo>
-                  <a:pt x="0" y="453709"/>
+                  <a:pt x="0" y="439749"/>
                 </a:moveTo>
                 <a:lnTo>
-                  <a:pt x="412943" y="439749"/>
-                </a:lnTo>
-                <a:lnTo>
-                  <a:pt x="825886" y="457200"/>
-                </a:lnTo>
-                <a:lnTo>
-                  <a:pt x="1238829" y="293166"/>
-                </a:lnTo>
-                <a:lnTo>
-                  <a:pt x="1651772" y="76781"/>
-                </a:lnTo>
-                <a:lnTo>
-                  <a:pt x="2064715" y="0"/>
+                  <a:pt x="412943" y="457200"/>
+                </a:lnTo>
+                <a:lnTo>
+                  <a:pt x="825886" y="293166"/>
+                </a:lnTo>
+                <a:lnTo>
+                  <a:pt x="1238829" y="76781"/>
+                </a:lnTo>
+                <a:lnTo>
+                  <a:pt x="1651772" y="0"/>
+                </a:lnTo>
+                <a:lnTo>
+                  <a:pt x="2064715" y="45370"/>
                 </a:lnTo>
               </a:path>
             </a:pathLst>
@@ -50736,7 +50736,7 @@
         </p:nvSpPr>
         <p:spPr>
           <a:xfrm>
-            <a:off x="9388144" y="3511296"/>
+            <a:off x="9388144" y="3556666"/>
             <a:ext cx="82296" cy="82296"/>
           </a:xfrm>
           <a:prstGeom prst="roundRect">
@@ -50847,7 +50847,7 @@
                 </a:solidFill>
                 <a:latin typeface="Kanit"/>
               </a:rPr>
-              <a:t>฿81.23 /กก. · ใต้·ตอ.</a:t>
+              <a:t>฿80.62 /กก. · ใต้·ตอ.</a:t>
             </a:r>
           </a:p>
         </p:txBody>
@@ -50925,7 +50925,7 @@
                 </a:solidFill>
                 <a:latin typeface="Kanit"/>
               </a:rPr>
-              <a:t>6 เดือน +34.6%</a:t>
+              <a:t>6 เดือน +18.5%</a:t>
             </a:r>
           </a:p>
         </p:txBody>
@@ -50999,19 +50999,19 @@
                   <a:pt x="0" y="457200"/>
                 </a:moveTo>
                 <a:lnTo>
-                  <a:pt x="412943" y="282748"/>
-                </a:lnTo>
-                <a:lnTo>
-                  <a:pt x="825886" y="158359"/>
-                </a:lnTo>
-                <a:lnTo>
-                  <a:pt x="1238829" y="0"/>
-                </a:lnTo>
-                <a:lnTo>
-                  <a:pt x="1651772" y="39334"/>
-                </a:lnTo>
-                <a:lnTo>
-                  <a:pt x="2064715" y="122090"/>
+                  <a:pt x="412943" y="252867"/>
+                </a:lnTo>
+                <a:lnTo>
+                  <a:pt x="825886" y="0"/>
+                </a:lnTo>
+                <a:lnTo>
+                  <a:pt x="1238829" y="66071"/>
+                </a:lnTo>
+                <a:lnTo>
+                  <a:pt x="1651772" y="195360"/>
+                </a:lnTo>
+                <a:lnTo>
+                  <a:pt x="2064715" y="219831"/>
                 </a:lnTo>
               </a:path>
             </a:pathLst>
@@ -51054,7 +51054,7 @@
         </p:nvSpPr>
         <p:spPr>
           <a:xfrm>
-            <a:off x="11690603" y="3633386"/>
+            <a:off x="11690603" y="3731127"/>
             <a:ext cx="82296" cy="82296"/>
           </a:xfrm>
           <a:prstGeom prst="roundRect">
@@ -51165,7 +51165,7 @@
                 </a:solidFill>
                 <a:latin typeface="Kanit"/>
               </a:rPr>
-              <a:t>฿3.81 /กก. · อีสาน·เหนือ·ตอ.</a:t>
+              <a:t>฿3.92 /กก. · อีสาน·เหนือ·ตอ.</a:t>
             </a:r>
           </a:p>
         </p:txBody>
@@ -51243,7 +51243,7 @@
                 </a:solidFill>
                 <a:latin typeface="Kanit"/>
               </a:rPr>
-              <a:t>6 เดือน +51.8%</a:t>
+              <a:t>6 เดือน +47.4%</a:t>
             </a:r>
           </a:p>
         </p:txBody>
@@ -51317,16 +51317,16 @@
                   <a:pt x="0" y="457200"/>
                 </a:moveTo>
                 <a:lnTo>
-                  <a:pt x="412943" y="357809"/>
-                </a:lnTo>
-                <a:lnTo>
-                  <a:pt x="825886" y="278296"/>
-                </a:lnTo>
-                <a:lnTo>
-                  <a:pt x="1238829" y="178905"/>
-                </a:lnTo>
-                <a:lnTo>
-                  <a:pt x="1651772" y="143124"/>
+                  <a:pt x="412943" y="366666"/>
+                </a:lnTo>
+                <a:lnTo>
+                  <a:pt x="825886" y="253498"/>
+                </a:lnTo>
+                <a:lnTo>
+                  <a:pt x="1238829" y="217284"/>
+                </a:lnTo>
+                <a:lnTo>
+                  <a:pt x="1651772" y="49795"/>
                 </a:lnTo>
                 <a:lnTo>
                   <a:pt x="2064715" y="0"/>
@@ -51483,7 +51483,7 @@
                 </a:solidFill>
                 <a:latin typeface="Kanit"/>
               </a:rPr>
-              <a:t>฿146.32 /ร้อยผล · กลาง·ตต.</a:t>
+              <a:t>฿250.00 /ร้อยผล · กลาง·ตต.</a:t>
             </a:r>
           </a:p>
         </p:txBody>
@@ -51561,7 +51561,7 @@
                 </a:solidFill>
                 <a:latin typeface="Kanit"/>
               </a:rPr>
-              <a:t>6 เดือน −30.3%</a:t>
+              <a:t>6 เดือน −45.0%</a:t>
             </a:r>
           </a:p>
         </p:txBody>
@@ -51632,22 +51632,22 @@
             <a:pathLst>
               <a:path w="2064715" h="457200">
                 <a:moveTo>
-                  <a:pt x="0" y="213177"/>
+                  <a:pt x="0" y="0"/>
                 </a:moveTo>
                 <a:lnTo>
-                  <a:pt x="412943" y="0"/>
-                </a:lnTo>
-                <a:lnTo>
-                  <a:pt x="825886" y="259737"/>
-                </a:lnTo>
-                <a:lnTo>
-                  <a:pt x="1238829" y="443342"/>
-                </a:lnTo>
-                <a:lnTo>
-                  <a:pt x="1651772" y="457200"/>
-                </a:lnTo>
-                <a:lnTo>
-                  <a:pt x="2064715" y="416732"/>
+                  <a:pt x="412943" y="259737"/>
+                </a:lnTo>
+                <a:lnTo>
+                  <a:pt x="825886" y="443342"/>
+                </a:lnTo>
+                <a:lnTo>
+                  <a:pt x="1238829" y="457200"/>
+                </a:lnTo>
+                <a:lnTo>
+                  <a:pt x="1651772" y="413314"/>
+                </a:lnTo>
+                <a:lnTo>
+                  <a:pt x="2064715" y="348309"/>
                 </a:lnTo>
               </a:path>
             </a:pathLst>
@@ -51690,7 +51690,7 @@
         </p:nvSpPr>
         <p:spPr>
           <a:xfrm>
-            <a:off x="4783226" y="5034451"/>
+            <a:off x="4783226" y="4966028"/>
             <a:ext cx="82296" cy="82296"/>
           </a:xfrm>
           <a:prstGeom prst="roundRect">
@@ -51886,7 +51886,7 @@
                 </a:solidFill>
                 <a:latin typeface="Kanit"/>
               </a:rPr>
-              <a:t>ราคาหน้าฟาร์ม วัดจริง — ราคารายวันของ NABC เฉลี่ยเป็นรายเดือน หน่วยเป็นบาทตามที่เผยแพร่ (ไม่มีการแปลงสกุลเงิน) ราคาล่าสุด 2026-09-03, รุ่นข้อมูลย้อนหลัง 2026-08-29 ราคาหน้าฟาร์ม (ราคาที่เกษตรกรขายได้) คือเงินที่เกษตรกรได้รับเมื่อขายครั้งแรก ก่อนพ่อค้าคนกลาง โรงสี หรือค่าขนส่งจะหักส่วนแบ่ง — ไม่ใช่ดัชนีโลก และไม่ใช่ราคาในซูเปอร์มาร์เก็ต แหล่งผลิตเป็นการอ่านแบบ ประมาณการ ว่าสินค้าแต่ละชนิดผลิตที่ไหน และทับซ้อนกันได้ น้ำตาลเป็นราคาอ้อยประกาศของ สอน. ปีละหนึ่งจุด จึงไม่มีการเปลี่ยนแปลงหกเดือนให้แสดง</a:t>
+              <a:t>ราคาหน้าฟาร์ม วัดจริง — ราคารายวันของ NABC เฉลี่ยเป็นรายเดือน หน่วยเป็นบาทตามที่เผยแพร่ (ไม่มีการแปลงสกุลเงิน) ราคาล่าสุด 2026-09-03, รุ่นข้อมูลย้อนหลัง 2026-09-05 ราคาหน้าฟาร์ม (ราคาที่เกษตรกรขายได้) คือเงินที่เกษตรกรได้รับเมื่อขายครั้งแรก ก่อนพ่อค้าคนกลาง โรงสี หรือค่าขนส่งจะหักส่วนแบ่ง — ไม่ใช่ดัชนีโลก และไม่ใช่ราคาในซูเปอร์มาร์เก็ต แหล่งผลิตเป็นการอ่านแบบ ประมาณการ ว่าสินค้าแต่ละชนิดผลิตที่ไหน และทับซ้อนกันได้ น้ำตาลเป็นราคาอ้อยประกาศของ สอน. ปีละหนึ่งจุด จึงไม่มีการเปลี่ยนแปลงหกเดือนให้แสดง</a:t>
             </a:r>
           </a:p>
         </p:txBody>

</xml_diff>

<commit_message>
deck(mcom): rebuild — the data moved past the committed figures (run 34045523534) (#841)
Co-authored-by: github-actions[bot] <41898282+github-actions[bot]@users.noreply.github.com>
</commit_message>
<xml_diff>
--- a/docs/decks/mcom-2026-08-05-macro-TH.pptx
+++ b/docs/decks/mcom-2026-08-05-macro-TH.pptx
@@ -6240,7 +6240,7 @@
                 </a:solidFill>
                 <a:latin typeface="Kanit"/>
               </a:rPr>
-              <a:t>123</a:t>
+              <a:t>133</a:t>
             </a:r>
           </a:p>
         </p:txBody>
@@ -6279,7 +6279,7 @@
                 </a:solidFill>
                 <a:latin typeface="Kanit"/>
               </a:rPr>
-              <a:t>จาก 793 (15.5%) · เรียลไทม์ · 2026-09-05</a:t>
+              <a:t>จาก 792 (16.8%) · เรียลไทม์ · 2026-09-06</a:t>
             </a:r>
           </a:p>
         </p:txBody>
@@ -6405,7 +6405,7 @@
                 </a:solidFill>
                 <a:latin typeface="Kanit"/>
               </a:rPr>
-              <a:t>25</a:t>
+              <a:t>39</a:t>
             </a:r>
           </a:p>
         </p:txBody>
@@ -6444,7 +6444,7 @@
                 </a:solidFill>
                 <a:latin typeface="Kanit"/>
               </a:rPr>
-              <a:t>ค่าล่าสุดรายวัน · 2026-09-05</a:t>
+              <a:t>ค่าล่าสุดรายวัน · 2026-09-06</a:t>
             </a:r>
           </a:p>
         </p:txBody>
@@ -7928,7 +7928,7 @@
                           </a:solidFill>
                           <a:latin typeface="Kanit"/>
                         </a:rPr>
-                        <a:t>52</a:t>
+                        <a:t>58</a:t>
                       </a:r>
                     </a:p>
                   </a:txBody>
@@ -7951,7 +7951,7 @@
                           </a:solidFill>
                           <a:latin typeface="Kanit"/>
                         </a:rPr>
-                        <a:t>2.6%</a:t>
+                        <a:t>15.8%</a:t>
                       </a:r>
                     </a:p>
                   </a:txBody>
@@ -8022,7 +8022,7 @@
                           </a:solidFill>
                           <a:latin typeface="Kanit"/>
                         </a:rPr>
-                        <a:t>อุทัยธานี</a:t>
+                        <a:t>สมุทรปราการ</a:t>
                       </a:r>
                     </a:p>
                   </a:txBody>
@@ -8045,7 +8045,7 @@
                           </a:solidFill>
                           <a:latin typeface="Kanit"/>
                         </a:rPr>
-                        <a:t>44</a:t>
+                        <a:t>15</a:t>
                       </a:r>
                     </a:p>
                   </a:txBody>
@@ -8068,7 +8068,7 @@
                           </a:solidFill>
                           <a:latin typeface="Kanit"/>
                         </a:rPr>
-                        <a:t>9</a:t>
+                        <a:t>13</a:t>
                       </a:r>
                     </a:p>
                   </a:txBody>
@@ -8114,7 +8114,7 @@
                           </a:solidFill>
                           <a:latin typeface="Kanit"/>
                         </a:rPr>
-                        <a:t>1/4</a:t>
+                        <a:t>4/4</a:t>
                       </a:r>
                     </a:p>
                   </a:txBody>
@@ -8162,7 +8162,7 @@
                           </a:solidFill>
                           <a:latin typeface="Kanit"/>
                         </a:rPr>
-                        <a:t>นครพนม</a:t>
+                        <a:t>อุทัยธานี</a:t>
                       </a:r>
                     </a:p>
                   </a:txBody>
@@ -8185,7 +8185,7 @@
                           </a:solidFill>
                           <a:latin typeface="Kanit"/>
                         </a:rPr>
-                        <a:t>28</a:t>
+                        <a:t>45</a:t>
                       </a:r>
                     </a:p>
                   </a:txBody>
@@ -8208,7 +8208,7 @@
                           </a:solidFill>
                           <a:latin typeface="Kanit"/>
                         </a:rPr>
-                        <a:t>49</a:t>
+                        <a:t>13</a:t>
                       </a:r>
                     </a:p>
                   </a:txBody>
@@ -8227,11 +8227,11 @@
                       <a:r>
                         <a:rPr sz="900" b="1">
                           <a:solidFill>
-                            <a:srgbClr val="F5C242"/>
-                          </a:solidFill>
-                          <a:latin typeface="Kanit"/>
-                        </a:rPr>
-                        <a:t>25.0%</a:t>
+                            <a:srgbClr val="606060"/>
+                          </a:solidFill>
+                          <a:latin typeface="Kanit"/>
+                        </a:rPr>
+                        <a:t>0.0%</a:t>
                       </a:r>
                     </a:p>
                   </a:txBody>
@@ -8254,7 +8254,7 @@
                           </a:solidFill>
                           <a:latin typeface="Kanit"/>
                         </a:rPr>
-                        <a:t>8/14</a:t>
+                        <a:t>1/4</a:t>
                       </a:r>
                     </a:p>
                   </a:txBody>
@@ -8273,11 +8273,11 @@
                       <a:r>
                         <a:rPr sz="900" b="1">
                           <a:solidFill>
-                            <a:srgbClr val="F5C242"/>
-                          </a:solidFill>
-                          <a:latin typeface="Kanit"/>
-                        </a:rPr>
-                        <a:t>4</a:t>
+                            <a:srgbClr val="CC0000"/>
+                          </a:solidFill>
+                          <a:latin typeface="Kanit"/>
+                        </a:rPr>
+                        <a:t>5</a:t>
                       </a:r>
                     </a:p>
                   </a:txBody>
@@ -8302,7 +8302,7 @@
                           </a:solidFill>
                           <a:latin typeface="Kanit"/>
                         </a:rPr>
-                        <a:t>พะเยา</a:t>
+                        <a:t>บึงกาฬ</a:t>
                       </a:r>
                     </a:p>
                   </a:txBody>
@@ -8325,7 +8325,7 @@
                           </a:solidFill>
                           <a:latin typeface="Kanit"/>
                         </a:rPr>
-                        <a:t>126</a:t>
+                        <a:t>11</a:t>
                       </a:r>
                     </a:p>
                   </a:txBody>
@@ -8348,7 +8348,7 @@
                           </a:solidFill>
                           <a:latin typeface="Kanit"/>
                         </a:rPr>
-                        <a:t>88</a:t>
+                        <a:t>134</a:t>
                       </a:r>
                     </a:p>
                   </a:txBody>
@@ -8371,7 +8371,7 @@
                           </a:solidFill>
                           <a:latin typeface="Kanit"/>
                         </a:rPr>
-                        <a:t>14.3%</a:t>
+                        <a:t>45.5%</a:t>
                       </a:r>
                     </a:p>
                   </a:txBody>
@@ -8394,7 +8394,7 @@
                           </a:solidFill>
                           <a:latin typeface="Kanit"/>
                         </a:rPr>
-                        <a:t>3/13</a:t>
+                        <a:t>1/1</a:t>
                       </a:r>
                     </a:p>
                   </a:txBody>
@@ -8442,7 +8442,7 @@
                           </a:solidFill>
                           <a:latin typeface="Kanit"/>
                         </a:rPr>
-                        <a:t>น่าน</a:t>
+                        <a:t>นครนายก</a:t>
                       </a:r>
                     </a:p>
                   </a:txBody>
@@ -8465,7 +8465,7 @@
                           </a:solidFill>
                           <a:latin typeface="Kanit"/>
                         </a:rPr>
-                        <a:t>217</a:t>
+                        <a:t>26</a:t>
                       </a:r>
                     </a:p>
                   </a:txBody>
@@ -8488,7 +8488,7 @@
                           </a:solidFill>
                           <a:latin typeface="Kanit"/>
                         </a:rPr>
-                        <a:t>101</a:t>
+                        <a:t>60</a:t>
                       </a:r>
                     </a:p>
                   </a:txBody>
@@ -8511,7 +8511,7 @@
                           </a:solidFill>
                           <a:latin typeface="Kanit"/>
                         </a:rPr>
-                        <a:t>13.8%</a:t>
+                        <a:t>42.3%</a:t>
                       </a:r>
                     </a:p>
                   </a:txBody>
@@ -8534,7 +8534,7 @@
                           </a:solidFill>
                           <a:latin typeface="Kanit"/>
                         </a:rPr>
-                        <a:t>1/26</a:t>
+                        <a:t>2/6</a:t>
                       </a:r>
                     </a:p>
                   </a:txBody>
@@ -8582,7 +8582,7 @@
                           </a:solidFill>
                           <a:latin typeface="Kanit"/>
                         </a:rPr>
-                        <a:t>อุบลราชธานี</a:t>
+                        <a:t>ปราจีนบุรี</a:t>
                       </a:r>
                     </a:p>
                   </a:txBody>
@@ -8605,7 +8605,7 @@
                           </a:solidFill>
                           <a:latin typeface="Kanit"/>
                         </a:rPr>
-                        <a:t>46</a:t>
+                        <a:t>35</a:t>
                       </a:r>
                     </a:p>
                   </a:txBody>
@@ -8651,7 +8651,7 @@
                           </a:solidFill>
                           <a:latin typeface="Kanit"/>
                         </a:rPr>
-                        <a:t>10.9%</a:t>
+                        <a:t>37.1%</a:t>
                       </a:r>
                     </a:p>
                   </a:txBody>
@@ -8674,7 +8674,7 @@
                           </a:solidFill>
                           <a:latin typeface="Kanit"/>
                         </a:rPr>
-                        <a:t>2/14</a:t>
+                        <a:t>5/15</a:t>
                       </a:r>
                     </a:p>
                   </a:txBody>
@@ -8909,7 +8909,7 @@
                 </a:solidFill>
                 <a:latin typeface="Kanit"/>
               </a:rPr>
-              <a:t>พื้นที่ปลูก วัดจริง (สศก. — ข้อมูลอำเภอ×พืช 3,295 แถว) ภัยแล้งเป็นดัชนี SPEI จาก แบบจำลอง คำนวณจากปริมาณฝนและการคายระเหย ปรับเดือนละครั้ง ดึงข้อมูล 2026-07-20 — เป็นสัญญาณที่ครอบคลุมทั้งประเทศดีที่สุดที่มี แต่ไม่มีใครลงพื้นที่ไปเดินดูอำเภอเหล่านั้น ข้อมูลฝนและระดับน้ำ วัดจริง (ThaiWater เรียลไทม์ ดึงทุกวันและสะสมไว้ — วันที่ดึงไม่สำเร็จจะเว้นเป็นช่องว่าง ไม่ใส่ค่าสมมติ) · ฝนถึง 2026-09-05, ระดับน้ำถึง 2026-09-05 ความเสี่ยงน้ำท่วมเชิงโครงสร้าง วัดจริง (สำมะโนพื้นที่ท่วมซ้ำซาก GISTDA มาตราส่วน 1:50,000 ปี 2005-2016 — เป็นบันทึกภาคพื้นดิน 12 ปี ไม่ใช่การพยากรณ์)</a:t>
+              <a:t>พื้นที่ปลูก วัดจริง (สศก. — ข้อมูลอำเภอ×พืช 3,295 แถว) ภัยแล้งเป็นดัชนี SPEI จาก แบบจำลอง คำนวณจากปริมาณฝนและการคายระเหย ปรับเดือนละครั้ง ดึงข้อมูล 2026-07-20 — เป็นสัญญาณที่ครอบคลุมทั้งประเทศดีที่สุดที่มี แต่ไม่มีใครลงพื้นที่ไปเดินดูอำเภอเหล่านั้น ข้อมูลฝนและระดับน้ำ วัดจริง (ThaiWater เรียลไทม์ ดึงทุกวันและสะสมไว้ — วันที่ดึงไม่สำเร็จจะเว้นเป็นช่องว่าง ไม่ใส่ค่าสมมติ) · ฝนถึง 2026-09-06, ระดับน้ำถึง 2026-09-06 ความเสี่ยงน้ำท่วมเชิงโครงสร้าง วัดจริง (สำมะโนพื้นที่ท่วมซ้ำซาก GISTDA มาตราส่วน 1:50,000 ปี 2005-2016 — เป็นบันทึกภาคพื้นดิน 12 ปี ไม่ใช่การพยากรณ์)</a:t>
             </a:r>
           </a:p>
         </p:txBody>
@@ -32047,7 +32047,7 @@
                 </a:solidFill>
                 <a:latin typeface="Kanit"/>
               </a:rPr>
-              <a:t>รุ่นข้อมูล — ราคาโลก 2026M06 · ราคาหน้าฟาร์มไทย 2026-09-03 · ประวัติราคาไทย 2026-08-29 · ต้นทุนการผลิตพืช สศก. ไจอัป 2568 (ปีเพาะปลูก 2568/69, ประมาณการ สศก. มี.ค. 2569) · ภัยแล้ง 2026-06-21 · เงินเฟ้อ 2026-05 · GDP 2026 ไตรมาส 1 · IMF WEO 2026 · ดัชนีราคาขายต่อ 2026-05 · ยอดจดทะเบียนถึง 2026-01 · หนี้ครัวเรือน สสช. SES 2566 · ค่าจ้าง สสช. LFS 2568 · ข้อมูลตรวจวัด 2026-09-05</a:t>
+              <a:t>รุ่นข้อมูล — ราคาโลก 2026M06 · ราคาหน้าฟาร์มไทย 2026-09-03 · ประวัติราคาไทย 2026-09-05 · ต้นทุนการผลิตพืช สศก. ไจอัป 2568 (ปีเพาะปลูก 2568/69, ประมาณการ สศก. มี.ค. 2569) · ภัยแล้ง 2026-06-21 · เงินเฟ้อ 2026-05 · GDP 2026 ไตรมาส 1 · IMF WEO 2026 · ดัชนีราคาขายต่อ 2026-05 · ยอดจดทะเบียนถึง 2026-01 · หนี้ครัวเรือน สสช. SES 2566 · ค่าจ้าง สสช. LFS 2568 · ข้อมูลตรวจวัด 2026-09-06</a:t>
             </a:r>
           </a:p>
         </p:txBody>
@@ -33912,7 +33912,7 @@
                 </a:solidFill>
                 <a:latin typeface="Kanit"/>
               </a:rPr>
-              <a:t>33.16</a:t>
+              <a:t>32.92</a:t>
             </a:r>
           </a:p>
         </p:txBody>
@@ -33951,7 +33951,7 @@
                 </a:solidFill>
                 <a:latin typeface="Kanit"/>
               </a:rPr>
-              <a:t>อัตราอ้างอิง ECB · 2026-08-31</a:t>
+              <a:t>อัตราอ้างอิง ECB · 2026-09-04</a:t>
             </a:r>
           </a:p>
         </p:txBody>
@@ -35798,7 +35798,7 @@
                 </a:solidFill>
                 <a:latin typeface="Kanit"/>
               </a:rPr>
-              <a:t>สศช. 2026 ไตรมาส 1 · TPSO 2026-05 · ธนาคารแห่งประเทศไทย 2026-08 · BIS 2025 ไตรมาส 4 · ECB 2026-08-31, ทั้งหมดดึงจากหน่วยงานผู้เผยแพร่โดยตรง ตารางเทียบประเทศใช้ IMF World Economic Outlook 2026 (ดึงข้อมูล 2026-07-25) อัตรา NPL ที่ ธปท. เผยแพร่ — 4.48% ณ 2026 ไตรมาส 1, จาก 4.33% ไตรมาสก่อน เปลี่ยน +0.24 จุดใน 1 ปี และต่ำสุด 3.08% ณ 2021 ไตรมาส 1</a:t>
+              <a:t>สศช. 2026 ไตรมาส 1 · TPSO 2026-05 · ธนาคารแห่งประเทศไทย 2026-08 · BIS 2025 ไตรมาส 4 · ECB 2026-09-04, ทั้งหมดดึงจากหน่วยงานผู้เผยแพร่โดยตรง ตารางเทียบประเทศใช้ IMF World Economic Outlook 2026 (ดึงข้อมูล 2026-07-25) อัตรา NPL ที่ ธปท. เผยแพร่ — 4.48% ณ 2026 ไตรมาส 1, จาก 4.33% ไตรมาสก่อน เปลี่ยน +0.24 จุดใน 1 ปี และต่ำสุด 3.08% ณ 2021 ไตรมาส 1</a:t>
             </a:r>
           </a:p>
         </p:txBody>
@@ -37087,7 +37087,7 @@
                 </a:solidFill>
                 <a:latin typeface="Kanit"/>
               </a:rPr>
-              <a:t>338 จาก 928 อำเภอ · แม่น้ำเกินระดับ 123 จาก 793 สถานี</a:t>
+              <a:t>338 จาก 928 อำเภอ · แม่น้ำเกินระดับ 133 จาก 792 สถานี</a:t>
             </a:r>
           </a:p>
         </p:txBody>
@@ -37859,7 +37859,7 @@
                           </a:solidFill>
                           <a:latin typeface="Kanit"/>
                         </a:rPr>
-                        <a:t>26/157</a:t>
+                        <a:t>29/157</a:t>
                       </a:r>
                     </a:p>
                   </a:txBody>
@@ -38091,7 +38091,7 @@
                           </a:solidFill>
                           <a:latin typeface="Kanit"/>
                         </a:rPr>
-                        <a:t>19/274</a:t>
+                        <a:t>16/274</a:t>
                       </a:r>
                     </a:p>
                   </a:txBody>
@@ -38323,7 +38323,7 @@
                           </a:solidFill>
                           <a:latin typeface="Kanit"/>
                         </a:rPr>
-                        <a:t>26/168</a:t>
+                        <a:t>29/167</a:t>
                       </a:r>
                     </a:p>
                   </a:txBody>
@@ -38555,7 +38555,7 @@
                           </a:solidFill>
                           <a:latin typeface="Kanit"/>
                         </a:rPr>
-                        <a:t>15/51</a:t>
+                        <a:t>14/51</a:t>
                       </a:r>
                     </a:p>
                   </a:txBody>
@@ -38787,7 +38787,7 @@
                           </a:solidFill>
                           <a:latin typeface="Kanit"/>
                         </a:rPr>
-                        <a:t>37/143</a:t>
+                        <a:t>45/143</a:t>
                       </a:r>
                     </a:p>
                   </a:txBody>
@@ -39959,7 +39959,7 @@
                           </a:solidFill>
                           <a:latin typeface="Kanit"/>
                         </a:rPr>
-                        <a:t>−50.7%</a:t>
+                        <a:t>−41.3%</a:t>
                       </a:r>
                     </a:p>
                   </a:txBody>
@@ -40791,7 +40791,7 @@
                 </a:solidFill>
                 <a:latin typeface="Kanit"/>
               </a:rPr>
-              <a:t>ราคา วัดจริง — ราคาหน้าฟาร์มไทยจากราคารายวันของ NABC และราคาอ้อยประกาศของ สอน. ราคาล่าสุด 2026-09-03 การเปลี่ยนแปลงหกเดือนคำนวณจากข้อมูลรายเดือนของ NABC เอง (thai_price_history รุ่นข้อมูล 2026-08-29) พืชที่ไม่มีข้อมูลรายเดือนจะกำกับไว้ ไม่ประมาณการขึ้นมา แหล่งผลิตเป็นการอ่านแบบ ประมาณการ ว่าสินค้าแต่ละชนิดปลูกที่ไหน และแหล่งผลิตทับซ้อนกันได้ บัญชีอาชีพเกษตรเป็นข้อมูลของเราเองและ วัดจริง — บัญชีที่บันทึกอาชีพว่า เกษตร ในจังหวัดแหล่งผลิต จากฐานข้อมูล 382,735 บัญชี ณ 2026-07 ไม่เผยแพร่ช่องที่มีน้อยกว่า 30 บัญชี คนกลุ่มนี้อาศัยอยู่ในพื้นที่ที่ปลูกพืชนั้น แต่ไม่ได้ยืนยันว่าปลูกพืชนั้นเอง</a:t>
+              <a:t>ราคา วัดจริง — ราคาหน้าฟาร์มไทยจากราคารายวันของ NABC และราคาอ้อยประกาศของ สอน. ราคาล่าสุด 2026-09-03 การเปลี่ยนแปลงหกเดือนคำนวณจากข้อมูลรายเดือนของ NABC เอง (thai_price_history รุ่นข้อมูล 2026-09-05) พืชที่ไม่มีข้อมูลรายเดือนจะกำกับไว้ ไม่ประมาณการขึ้นมา แหล่งผลิตเป็นการอ่านแบบ ประมาณการ ว่าสินค้าแต่ละชนิดปลูกที่ไหน และแหล่งผลิตทับซ้อนกันได้ บัญชีอาชีพเกษตรเป็นข้อมูลของเราเองและ วัดจริง — บัญชีที่บันทึกอาชีพว่า เกษตร ในจังหวัดแหล่งผลิต จากฐานข้อมูล 382,735 บัญชี ณ 2026-07 ไม่เผยแพร่ช่องที่มีน้อยกว่า 30 บัญชี คนกลุ่มนี้อาศัยอยู่ในพื้นที่ที่ปลูกพืชนั้น แต่ไม่ได้ยืนยันว่าปลูกพืชนั้นเอง</a:t>
             </a:r>
           </a:p>
         </p:txBody>
@@ -43419,7 +43419,7 @@
                           </a:solidFill>
                           <a:latin typeface="Kanit"/>
                         </a:rPr>
-                        <a:t>92.20</a:t>
+                        <a:t>91.52</a:t>
                       </a:r>
                     </a:p>
                   </a:txBody>
@@ -43559,7 +43559,7 @@
                           </a:solidFill>
                           <a:latin typeface="Kanit"/>
                         </a:rPr>
-                        <a:t>15,488</a:t>
+                        <a:t>15,374</a:t>
                       </a:r>
                     </a:p>
                   </a:txBody>
@@ -43699,7 +43699,7 @@
                           </a:solidFill>
                           <a:latin typeface="Kanit"/>
                         </a:rPr>
-                        <a:t>36,515</a:t>
+                        <a:t>36,245</a:t>
                       </a:r>
                     </a:p>
                   </a:txBody>
@@ -43839,7 +43839,7 @@
                           </a:solidFill>
                           <a:latin typeface="Kanit"/>
                         </a:rPr>
-                        <a:t>11.28</a:t>
+                        <a:t>11.19</a:t>
                       </a:r>
                     </a:p>
                   </a:txBody>
@@ -44058,7 +44058,7 @@
                 </a:solidFill>
                 <a:latin typeface="Kanit"/>
               </a:rPr>
-              <a:t>ราคารายเดือนสกุลดอลลาร์ราคาปัจจุบันจาก World Bank Pink Sheet รุ่นข้อมูล 2026M07 (ข้อมูล 60 จุดต่อรายการ ปรับฐานเป็น 100 ณ 2021-07 เพื่อวาดกราฟ — หน่วยต่างกัน จึงใช้แกนเดียวกับระดับราคาดิบไม่ได้) แปลงเป็นบาทด้วยอัตราอ้างอิง ECB USD/THB 33.165 ณ 2026-08-31 สัดส่วนพื้นที่ปลูก วัดจริง จากสัดส่วนพืชของ สศก./กรมส่งเสริมการเกษตร (crop_mix.json) เป็นราคาปัจจุบัน ไม่ได้ปรับเงินเฟ้อ: ทุกตัวเลข ‘เทียบ 5 ปีก่อน’ มีเงินเฟ้อไทยห้าปีซ่อนอยู่ข้างใต้</a:t>
+              <a:t>ราคารายเดือนสกุลดอลลาร์ราคาปัจจุบันจาก World Bank Pink Sheet รุ่นข้อมูล 2026M07 (ข้อมูล 60 จุดต่อรายการ ปรับฐานเป็น 100 ณ 2021-07 เพื่อวาดกราฟ — หน่วยต่างกัน จึงใช้แกนเดียวกับระดับราคาดิบไม่ได้) แปลงเป็นบาทด้วยอัตราอ้างอิง ECB USD/THB 32.920 ณ 2026-09-04 สัดส่วนพื้นที่ปลูก วัดจริง จากสัดส่วนพืชของ สศก./กรมส่งเสริมการเกษตร (crop_mix.json) เป็นราคาปัจจุบัน ไม่ได้ปรับเงินเฟ้อ: ทุกตัวเลข ‘เทียบ 5 ปีก่อน’ มีเงินเฟ้อไทยห้าปีซ่อนอยู่ข้างใต้</a:t>
             </a:r>
           </a:p>
         </p:txBody>
@@ -47985,7 +47985,7 @@
                 </a:solidFill>
                 <a:latin typeface="Kanit"/>
               </a:rPr>
-              <a:t>฿596.84 /ร้อยผล · ใต้·ตอ.</a:t>
+              <a:t>฿580.00 /ร้อยผล · ใต้·ตอ.</a:t>
             </a:r>
           </a:p>
         </p:txBody>
@@ -48063,7 +48063,7 @@
                 </a:solidFill>
                 <a:latin typeface="Kanit"/>
               </a:rPr>
-              <a:t>6 เดือน −50.7%</a:t>
+              <a:t>6 เดือน −41.3%</a:t>
             </a:r>
           </a:p>
         </p:txBody>
@@ -48134,22 +48134,22 @@
             <a:pathLst>
               <a:path w="2064715" h="457200">
                 <a:moveTo>
-                  <a:pt x="0" y="0"/>
+                  <a:pt x="0" y="38315"/>
                 </a:moveTo>
                 <a:lnTo>
-                  <a:pt x="412943" y="170673"/>
-                </a:lnTo>
-                <a:lnTo>
-                  <a:pt x="825886" y="145193"/>
-                </a:lnTo>
-                <a:lnTo>
-                  <a:pt x="1238829" y="399195"/>
-                </a:lnTo>
-                <a:lnTo>
-                  <a:pt x="1651772" y="457200"/>
-                </a:lnTo>
-                <a:lnTo>
-                  <a:pt x="2064715" y="409348"/>
+                  <a:pt x="412943" y="0"/>
+                </a:lnTo>
+                <a:lnTo>
+                  <a:pt x="825886" y="372997"/>
+                </a:lnTo>
+                <a:lnTo>
+                  <a:pt x="1238829" y="457200"/>
+                </a:lnTo>
+                <a:lnTo>
+                  <a:pt x="1651772" y="385356"/>
+                </a:lnTo>
+                <a:lnTo>
+                  <a:pt x="2064715" y="411313"/>
                 </a:lnTo>
               </a:path>
             </a:pathLst>
@@ -48192,7 +48192,7 @@
         </p:nvSpPr>
         <p:spPr>
           <a:xfrm>
-            <a:off x="2480767" y="2814220"/>
+            <a:off x="2480767" y="2816185"/>
             <a:ext cx="82296" cy="82296"/>
           </a:xfrm>
           <a:prstGeom prst="roundRect">
@@ -48621,7 +48621,7 @@
                 </a:solidFill>
                 <a:latin typeface="Kanit"/>
               </a:rPr>
-              <a:t>฿143.14 /กก. · ชายฝั่งใต้·ตอ.</a:t>
+              <a:t>฿142.50 /กก. · ชายฝั่งใต้·ตอ.</a:t>
             </a:r>
           </a:p>
         </p:txBody>
@@ -48695,11 +48695,11 @@
             <a:r>
               <a:rPr sz="800" b="1">
                 <a:solidFill>
-                  <a:srgbClr val="CC0000"/>
+                  <a:srgbClr val="15795F"/>
                 </a:solidFill>
                 <a:latin typeface="Kanit"/>
               </a:rPr>
-              <a:t>6 เดือน −2.0%</a:t>
+              <a:t>6 เดือน +8.0%</a:t>
             </a:r>
           </a:p>
         </p:txBody>
@@ -48770,22 +48770,22 @@
             <a:pathLst>
               <a:path w="2064715" h="457200">
                 <a:moveTo>
-                  <a:pt x="0" y="216948"/>
+                  <a:pt x="0" y="415899"/>
                 </a:moveTo>
                 <a:lnTo>
-                  <a:pt x="412943" y="415955"/>
-                </a:lnTo>
-                <a:lnTo>
-                  <a:pt x="825886" y="457200"/>
-                </a:lnTo>
-                <a:lnTo>
-                  <a:pt x="1238829" y="420285"/>
-                </a:lnTo>
-                <a:lnTo>
-                  <a:pt x="1651772" y="170341"/>
-                </a:lnTo>
-                <a:lnTo>
-                  <a:pt x="2064715" y="0"/>
+                  <a:pt x="412943" y="457200"/>
+                </a:lnTo>
+                <a:lnTo>
+                  <a:pt x="825886" y="420235"/>
+                </a:lnTo>
+                <a:lnTo>
+                  <a:pt x="1238829" y="169952"/>
+                </a:lnTo>
+                <a:lnTo>
+                  <a:pt x="1651772" y="0"/>
+                </a:lnTo>
+                <a:lnTo>
+                  <a:pt x="2064715" y="12596"/>
                 </a:lnTo>
               </a:path>
             </a:pathLst>
@@ -48793,7 +48793,7 @@
           <a:noFill/>
           <a:ln w="20320">
             <a:solidFill>
-              <a:srgbClr val="CC0000"/>
+              <a:srgbClr val="15795F"/>
             </a:solidFill>
           </a:ln>
           <a:effectLst/>
@@ -48828,7 +48828,7 @@
         </p:nvSpPr>
         <p:spPr>
           <a:xfrm>
-            <a:off x="7085685" y="2404872"/>
+            <a:off x="7085685" y="2417468"/>
             <a:ext cx="82296" cy="82296"/>
           </a:xfrm>
           <a:prstGeom prst="roundRect">
@@ -48837,7 +48837,7 @@
             </a:avLst>
           </a:prstGeom>
           <a:solidFill>
-            <a:srgbClr val="CC0000"/>
+            <a:srgbClr val="15795F"/>
           </a:solidFill>
           <a:ln>
             <a:noFill/>
@@ -48939,7 +48939,7 @@
                 </a:solidFill>
                 <a:latin typeface="Kanit"/>
               </a:rPr>
-              <a:t>฿43.05 /กก. · กลาง·ตอ.</a:t>
+              <a:t>฿44.00 /กก. · กลาง·ตอ.</a:t>
             </a:r>
           </a:p>
         </p:txBody>
@@ -49017,7 +49017,7 @@
                 </a:solidFill>
                 <a:latin typeface="Kanit"/>
               </a:rPr>
-              <a:t>6 เดือน +2.4%</a:t>
+              <a:t>6 เดือน +0.0%</a:t>
             </a:r>
           </a:p>
         </p:txBody>
@@ -49088,22 +49088,22 @@
             <a:pathLst>
               <a:path w="2064715" h="457200">
                 <a:moveTo>
-                  <a:pt x="0" y="0"/>
+                  <a:pt x="0" y="122251"/>
                 </a:moveTo>
                 <a:lnTo>
-                  <a:pt x="412943" y="119484"/>
-                </a:lnTo>
-                <a:lnTo>
-                  <a:pt x="825886" y="305129"/>
-                </a:lnTo>
-                <a:lnTo>
-                  <a:pt x="1238829" y="457200"/>
-                </a:lnTo>
-                <a:lnTo>
-                  <a:pt x="1651772" y="245880"/>
-                </a:lnTo>
-                <a:lnTo>
-                  <a:pt x="2064715" y="91834"/>
+                  <a:pt x="412943" y="309106"/>
+                </a:lnTo>
+                <a:lnTo>
+                  <a:pt x="825886" y="457200"/>
+                </a:lnTo>
+                <a:lnTo>
+                  <a:pt x="1238829" y="249472"/>
+                </a:lnTo>
+                <a:lnTo>
+                  <a:pt x="1651772" y="89452"/>
+                </a:lnTo>
+                <a:lnTo>
+                  <a:pt x="2064715" y="0"/>
                 </a:lnTo>
               </a:path>
             </a:pathLst>
@@ -49146,7 +49146,7 @@
         </p:nvSpPr>
         <p:spPr>
           <a:xfrm>
-            <a:off x="9388144" y="2496706"/>
+            <a:off x="9388144" y="2404872"/>
             <a:ext cx="82296" cy="82296"/>
           </a:xfrm>
           <a:prstGeom prst="roundRect">
@@ -49257,7 +49257,7 @@
                 </a:solidFill>
                 <a:latin typeface="Kanit"/>
               </a:rPr>
-              <a:t>฿350.53 /ร้อยฟอง · กลาง·ตอ.</a:t>
+              <a:t>฿360.00 /ร้อยฟอง · กลาง·ตอ.</a:t>
             </a:r>
           </a:p>
         </p:txBody>
@@ -49335,7 +49335,7 @@
                 </a:solidFill>
                 <a:latin typeface="Kanit"/>
               </a:rPr>
-              <a:t>6 เดือน +15.9%</a:t>
+              <a:t>6 เดือน +17.0%</a:t>
             </a:r>
           </a:p>
         </p:txBody>
@@ -49406,19 +49406,19 @@
             <a:pathLst>
               <a:path w="2064715" h="457200">
                 <a:moveTo>
-                  <a:pt x="0" y="457200"/>
+                  <a:pt x="0" y="356259"/>
                 </a:moveTo>
                 <a:lnTo>
-                  <a:pt x="412943" y="218744"/>
-                </a:lnTo>
-                <a:lnTo>
-                  <a:pt x="825886" y="218744"/>
-                </a:lnTo>
-                <a:lnTo>
-                  <a:pt x="1238829" y="309310"/>
-                </a:lnTo>
-                <a:lnTo>
-                  <a:pt x="1651772" y="128177"/>
+                  <a:pt x="412943" y="356259"/>
+                </a:lnTo>
+                <a:lnTo>
+                  <a:pt x="825886" y="457200"/>
+                </a:lnTo>
+                <a:lnTo>
+                  <a:pt x="1238829" y="255319"/>
+                </a:lnTo>
+                <a:lnTo>
+                  <a:pt x="1651772" y="106877"/>
                 </a:lnTo>
                 <a:lnTo>
                   <a:pt x="2064715" y="0"/>
@@ -49575,7 +49575,7 @@
                 </a:solidFill>
                 <a:latin typeface="Kanit"/>
               </a:rPr>
-              <a:t>฿17,763 /ตัน · อีสาน·เหนือ·กลาง</a:t>
+              <a:t>฿17,494 /ตัน · อีสาน·เหนือ·กลาง</a:t>
             </a:r>
           </a:p>
         </p:txBody>
@@ -49653,7 +49653,7 @@
                 </a:solidFill>
                 <a:latin typeface="Kanit"/>
               </a:rPr>
-              <a:t>6 เดือน +7.7%</a:t>
+              <a:t>6 เดือน +4.3%</a:t>
             </a:r>
           </a:p>
         </p:txBody>
@@ -49727,19 +49727,19 @@
                   <a:pt x="0" y="457200"/>
                 </a:moveTo>
                 <a:lnTo>
-                  <a:pt x="412943" y="341371"/>
-                </a:lnTo>
-                <a:lnTo>
-                  <a:pt x="825886" y="153981"/>
-                </a:lnTo>
-                <a:lnTo>
-                  <a:pt x="1238829" y="34219"/>
-                </a:lnTo>
-                <a:lnTo>
-                  <a:pt x="1651772" y="23720"/>
-                </a:lnTo>
-                <a:lnTo>
-                  <a:pt x="2064715" y="0"/>
+                  <a:pt x="412943" y="212701"/>
+                </a:lnTo>
+                <a:lnTo>
+                  <a:pt x="825886" y="41154"/>
+                </a:lnTo>
+                <a:lnTo>
+                  <a:pt x="1238829" y="30357"/>
+                </a:lnTo>
+                <a:lnTo>
+                  <a:pt x="1651772" y="0"/>
+                </a:lnTo>
+                <a:lnTo>
+                  <a:pt x="2064715" y="163560"/>
                 </a:lnTo>
               </a:path>
             </a:pathLst>
@@ -49782,7 +49782,7 @@
         </p:nvSpPr>
         <p:spPr>
           <a:xfrm>
-            <a:off x="2480767" y="3511296"/>
+            <a:off x="2480767" y="3674856"/>
             <a:ext cx="82296" cy="82296"/>
           </a:xfrm>
           <a:prstGeom prst="roundRect">
@@ -49893,7 +49893,7 @@
                 </a:solidFill>
                 <a:latin typeface="Kanit"/>
               </a:rPr>
-              <a:t>฿9.76 /กก. · เหนือ</a:t>
+              <a:t>฿9.05 /กก. · เหนือ</a:t>
             </a:r>
           </a:p>
         </p:txBody>
@@ -49967,11 +49967,11 @@
             <a:r>
               <a:rPr sz="800" b="1">
                 <a:solidFill>
-                  <a:srgbClr val="15795F"/>
+                  <a:srgbClr val="CC0000"/>
                 </a:solidFill>
                 <a:latin typeface="Kanit"/>
               </a:rPr>
-              <a:t>6 เดือน +9.7%</a:t>
+              <a:t>6 เดือน −0.3%</a:t>
             </a:r>
           </a:p>
         </p:txBody>
@@ -50042,22 +50042,22 @@
             <a:pathLst>
               <a:path w="2064715" h="457200">
                 <a:moveTo>
-                  <a:pt x="0" y="457200"/>
+                  <a:pt x="0" y="342301"/>
                 </a:moveTo>
                 <a:lnTo>
-                  <a:pt x="412943" y="350931"/>
-                </a:lnTo>
-                <a:lnTo>
-                  <a:pt x="825886" y="79083"/>
-                </a:lnTo>
-                <a:lnTo>
-                  <a:pt x="1238829" y="0"/>
-                </a:lnTo>
-                <a:lnTo>
-                  <a:pt x="1651772" y="54369"/>
-                </a:lnTo>
-                <a:lnTo>
-                  <a:pt x="2064715" y="294090"/>
+                  <a:pt x="412943" y="83780"/>
+                </a:lnTo>
+                <a:lnTo>
+                  <a:pt x="825886" y="0"/>
+                </a:lnTo>
+                <a:lnTo>
+                  <a:pt x="1238829" y="47874"/>
+                </a:lnTo>
+                <a:lnTo>
+                  <a:pt x="1651772" y="292033"/>
+                </a:lnTo>
+                <a:lnTo>
+                  <a:pt x="2064715" y="457200"/>
                 </a:lnTo>
               </a:path>
             </a:pathLst>
@@ -50065,7 +50065,7 @@
           <a:noFill/>
           <a:ln w="20320">
             <a:solidFill>
-              <a:srgbClr val="15795F"/>
+              <a:srgbClr val="CC0000"/>
             </a:solidFill>
           </a:ln>
           <a:effectLst/>
@@ -50100,7 +50100,7 @@
         </p:nvSpPr>
         <p:spPr>
           <a:xfrm>
-            <a:off x="4783226" y="3805386"/>
+            <a:off x="4783226" y="3968496"/>
             <a:ext cx="82296" cy="82296"/>
           </a:xfrm>
           <a:prstGeom prst="roundRect">
@@ -50109,7 +50109,7 @@
             </a:avLst>
           </a:prstGeom>
           <a:solidFill>
-            <a:srgbClr val="15795F"/>
+            <a:srgbClr val="CC0000"/>
           </a:solidFill>
           <a:ln>
             <a:noFill/>
@@ -50211,7 +50211,7 @@
                 </a:solidFill>
                 <a:latin typeface="Kanit"/>
               </a:rPr>
-              <a:t>฿71.18 /กก. · กลาง·ตต.·ตอ.</a:t>
+              <a:t>฿74.67 /กก. · กลาง·ตต.·ตอ.</a:t>
             </a:r>
           </a:p>
         </p:txBody>
@@ -50289,7 +50289,7 @@
                 </a:solidFill>
                 <a:latin typeface="Kanit"/>
               </a:rPr>
-              <a:t>6 เดือน +28.2%</a:t>
+              <a:t>6 เดือน +18.4%</a:t>
             </a:r>
           </a:p>
         </p:txBody>
@@ -50360,19 +50360,19 @@
             <a:pathLst>
               <a:path w="2064715" h="457200">
                 <a:moveTo>
-                  <a:pt x="0" y="371819"/>
+                  <a:pt x="0" y="220046"/>
                 </a:moveTo>
                 <a:lnTo>
-                  <a:pt x="412943" y="140924"/>
-                </a:lnTo>
-                <a:lnTo>
-                  <a:pt x="825886" y="457200"/>
-                </a:lnTo>
-                <a:lnTo>
-                  <a:pt x="1238829" y="309849"/>
-                </a:lnTo>
-                <a:lnTo>
-                  <a:pt x="1651772" y="196008"/>
+                  <a:pt x="412943" y="457200"/>
+                </a:lnTo>
+                <a:lnTo>
+                  <a:pt x="825886" y="343487"/>
+                </a:lnTo>
+                <a:lnTo>
+                  <a:pt x="1238829" y="264994"/>
+                </a:lnTo>
+                <a:lnTo>
+                  <a:pt x="1651772" y="111364"/>
                 </a:lnTo>
                 <a:lnTo>
                   <a:pt x="2064715" y="0"/>
@@ -50529,7 +50529,7 @@
                 </a:solidFill>
                 <a:latin typeface="Kanit"/>
               </a:rPr>
-              <a:t>฿8.51 /กก. · ใต้</a:t>
+              <a:t>฿8.38 /กก. · ใต้</a:t>
             </a:r>
           </a:p>
         </p:txBody>
@@ -50607,7 +50607,7 @@
                 </a:solidFill>
                 <a:latin typeface="Kanit"/>
               </a:rPr>
-              <a:t>6 เดือน +24.6%</a:t>
+              <a:t>6 เดือน +16.2%</a:t>
             </a:r>
           </a:p>
         </p:txBody>
@@ -50678,22 +50678,22 @@
             <a:pathLst>
               <a:path w="2064715" h="457200">
                 <a:moveTo>
-                  <a:pt x="0" y="453709"/>
+                  <a:pt x="0" y="439749"/>
                 </a:moveTo>
                 <a:lnTo>
-                  <a:pt x="412943" y="439749"/>
-                </a:lnTo>
-                <a:lnTo>
-                  <a:pt x="825886" y="457200"/>
-                </a:lnTo>
-                <a:lnTo>
-                  <a:pt x="1238829" y="293166"/>
-                </a:lnTo>
-                <a:lnTo>
-                  <a:pt x="1651772" y="76781"/>
-                </a:lnTo>
-                <a:lnTo>
-                  <a:pt x="2064715" y="0"/>
+                  <a:pt x="412943" y="457200"/>
+                </a:lnTo>
+                <a:lnTo>
+                  <a:pt x="825886" y="293166"/>
+                </a:lnTo>
+                <a:lnTo>
+                  <a:pt x="1238829" y="76781"/>
+                </a:lnTo>
+                <a:lnTo>
+                  <a:pt x="1651772" y="0"/>
+                </a:lnTo>
+                <a:lnTo>
+                  <a:pt x="2064715" y="45370"/>
                 </a:lnTo>
               </a:path>
             </a:pathLst>
@@ -50736,7 +50736,7 @@
         </p:nvSpPr>
         <p:spPr>
           <a:xfrm>
-            <a:off x="9388144" y="3511296"/>
+            <a:off x="9388144" y="3556666"/>
             <a:ext cx="82296" cy="82296"/>
           </a:xfrm>
           <a:prstGeom prst="roundRect">
@@ -50847,7 +50847,7 @@
                 </a:solidFill>
                 <a:latin typeface="Kanit"/>
               </a:rPr>
-              <a:t>฿81.23 /กก. · ใต้·ตอ.</a:t>
+              <a:t>฿80.62 /กก. · ใต้·ตอ.</a:t>
             </a:r>
           </a:p>
         </p:txBody>
@@ -50925,7 +50925,7 @@
                 </a:solidFill>
                 <a:latin typeface="Kanit"/>
               </a:rPr>
-              <a:t>6 เดือน +34.6%</a:t>
+              <a:t>6 เดือน +18.5%</a:t>
             </a:r>
           </a:p>
         </p:txBody>
@@ -50999,19 +50999,19 @@
                   <a:pt x="0" y="457200"/>
                 </a:moveTo>
                 <a:lnTo>
-                  <a:pt x="412943" y="282748"/>
-                </a:lnTo>
-                <a:lnTo>
-                  <a:pt x="825886" y="158359"/>
-                </a:lnTo>
-                <a:lnTo>
-                  <a:pt x="1238829" y="0"/>
-                </a:lnTo>
-                <a:lnTo>
-                  <a:pt x="1651772" y="39334"/>
-                </a:lnTo>
-                <a:lnTo>
-                  <a:pt x="2064715" y="122090"/>
+                  <a:pt x="412943" y="252867"/>
+                </a:lnTo>
+                <a:lnTo>
+                  <a:pt x="825886" y="0"/>
+                </a:lnTo>
+                <a:lnTo>
+                  <a:pt x="1238829" y="66071"/>
+                </a:lnTo>
+                <a:lnTo>
+                  <a:pt x="1651772" y="195360"/>
+                </a:lnTo>
+                <a:lnTo>
+                  <a:pt x="2064715" y="219831"/>
                 </a:lnTo>
               </a:path>
             </a:pathLst>
@@ -51054,7 +51054,7 @@
         </p:nvSpPr>
         <p:spPr>
           <a:xfrm>
-            <a:off x="11690603" y="3633386"/>
+            <a:off x="11690603" y="3731127"/>
             <a:ext cx="82296" cy="82296"/>
           </a:xfrm>
           <a:prstGeom prst="roundRect">
@@ -51165,7 +51165,7 @@
                 </a:solidFill>
                 <a:latin typeface="Kanit"/>
               </a:rPr>
-              <a:t>฿3.81 /กก. · อีสาน·เหนือ·ตอ.</a:t>
+              <a:t>฿3.92 /กก. · อีสาน·เหนือ·ตอ.</a:t>
             </a:r>
           </a:p>
         </p:txBody>
@@ -51243,7 +51243,7 @@
                 </a:solidFill>
                 <a:latin typeface="Kanit"/>
               </a:rPr>
-              <a:t>6 เดือน +51.8%</a:t>
+              <a:t>6 เดือน +47.4%</a:t>
             </a:r>
           </a:p>
         </p:txBody>
@@ -51317,16 +51317,16 @@
                   <a:pt x="0" y="457200"/>
                 </a:moveTo>
                 <a:lnTo>
-                  <a:pt x="412943" y="357809"/>
-                </a:lnTo>
-                <a:lnTo>
-                  <a:pt x="825886" y="278296"/>
-                </a:lnTo>
-                <a:lnTo>
-                  <a:pt x="1238829" y="178905"/>
-                </a:lnTo>
-                <a:lnTo>
-                  <a:pt x="1651772" y="143124"/>
+                  <a:pt x="412943" y="366666"/>
+                </a:lnTo>
+                <a:lnTo>
+                  <a:pt x="825886" y="253498"/>
+                </a:lnTo>
+                <a:lnTo>
+                  <a:pt x="1238829" y="217284"/>
+                </a:lnTo>
+                <a:lnTo>
+                  <a:pt x="1651772" y="49795"/>
                 </a:lnTo>
                 <a:lnTo>
                   <a:pt x="2064715" y="0"/>
@@ -51483,7 +51483,7 @@
                 </a:solidFill>
                 <a:latin typeface="Kanit"/>
               </a:rPr>
-              <a:t>฿146.32 /ร้อยผล · กลาง·ตต.</a:t>
+              <a:t>฿250.00 /ร้อยผล · กลาง·ตต.</a:t>
             </a:r>
           </a:p>
         </p:txBody>
@@ -51561,7 +51561,7 @@
                 </a:solidFill>
                 <a:latin typeface="Kanit"/>
               </a:rPr>
-              <a:t>6 เดือน −30.3%</a:t>
+              <a:t>6 เดือน −45.0%</a:t>
             </a:r>
           </a:p>
         </p:txBody>
@@ -51632,22 +51632,22 @@
             <a:pathLst>
               <a:path w="2064715" h="457200">
                 <a:moveTo>
-                  <a:pt x="0" y="213177"/>
+                  <a:pt x="0" y="0"/>
                 </a:moveTo>
                 <a:lnTo>
-                  <a:pt x="412943" y="0"/>
-                </a:lnTo>
-                <a:lnTo>
-                  <a:pt x="825886" y="259737"/>
-                </a:lnTo>
-                <a:lnTo>
-                  <a:pt x="1238829" y="443342"/>
-                </a:lnTo>
-                <a:lnTo>
-                  <a:pt x="1651772" y="457200"/>
-                </a:lnTo>
-                <a:lnTo>
-                  <a:pt x="2064715" y="416732"/>
+                  <a:pt x="412943" y="259737"/>
+                </a:lnTo>
+                <a:lnTo>
+                  <a:pt x="825886" y="443342"/>
+                </a:lnTo>
+                <a:lnTo>
+                  <a:pt x="1238829" y="457200"/>
+                </a:lnTo>
+                <a:lnTo>
+                  <a:pt x="1651772" y="413314"/>
+                </a:lnTo>
+                <a:lnTo>
+                  <a:pt x="2064715" y="348309"/>
                 </a:lnTo>
               </a:path>
             </a:pathLst>
@@ -51690,7 +51690,7 @@
         </p:nvSpPr>
         <p:spPr>
           <a:xfrm>
-            <a:off x="4783226" y="5034451"/>
+            <a:off x="4783226" y="4966028"/>
             <a:ext cx="82296" cy="82296"/>
           </a:xfrm>
           <a:prstGeom prst="roundRect">
@@ -51886,7 +51886,7 @@
                 </a:solidFill>
                 <a:latin typeface="Kanit"/>
               </a:rPr>
-              <a:t>ราคาหน้าฟาร์ม วัดจริง — ราคารายวันของ NABC เฉลี่ยเป็นรายเดือน หน่วยเป็นบาทตามที่เผยแพร่ (ไม่มีการแปลงสกุลเงิน) ราคาล่าสุด 2026-09-03, รุ่นข้อมูลย้อนหลัง 2026-08-29 ราคาหน้าฟาร์ม (ราคาที่เกษตรกรขายได้) คือเงินที่เกษตรกรได้รับเมื่อขายครั้งแรก ก่อนพ่อค้าคนกลาง โรงสี หรือค่าขนส่งจะหักส่วนแบ่ง — ไม่ใช่ดัชนีโลก และไม่ใช่ราคาในซูเปอร์มาร์เก็ต แหล่งผลิตเป็นการอ่านแบบ ประมาณการ ว่าสินค้าแต่ละชนิดผลิตที่ไหน และทับซ้อนกันได้ น้ำตาลเป็นราคาอ้อยประกาศของ สอน. ปีละหนึ่งจุด จึงไม่มีการเปลี่ยนแปลงหกเดือนให้แสดง</a:t>
+              <a:t>ราคาหน้าฟาร์ม วัดจริง — ราคารายวันของ NABC เฉลี่ยเป็นรายเดือน หน่วยเป็นบาทตามที่เผยแพร่ (ไม่มีการแปลงสกุลเงิน) ราคาล่าสุด 2026-09-03, รุ่นข้อมูลย้อนหลัง 2026-09-05 ราคาหน้าฟาร์ม (ราคาที่เกษตรกรขายได้) คือเงินที่เกษตรกรได้รับเมื่อขายครั้งแรก ก่อนพ่อค้าคนกลาง โรงสี หรือค่าขนส่งจะหักส่วนแบ่ง — ไม่ใช่ดัชนีโลก และไม่ใช่ราคาในซูเปอร์มาร์เก็ต แหล่งผลิตเป็นการอ่านแบบ ประมาณการ ว่าสินค้าแต่ละชนิดผลิตที่ไหน และทับซ้อนกันได้ น้ำตาลเป็นราคาอ้อยประกาศของ สอน. ปีละหนึ่งจุด จึงไม่มีการเปลี่ยนแปลงหกเดือนให้แสดง</a:t>
             </a:r>
           </a:p>
         </p:txBody>

</xml_diff>

<commit_message>
deck(mcom): rebuild — the data moved past the committed figures (run 34063910473)
</commit_message>
<xml_diff>
--- a/docs/decks/mcom-2026-08-05-macro-TH.pptx
+++ b/docs/decks/mcom-2026-08-05-macro-TH.pptx
@@ -6240,7 +6240,7 @@
                 </a:solidFill>
                 <a:latin typeface="Kanit"/>
               </a:rPr>
-              <a:t>133</a:t>
+              <a:t>124</a:t>
             </a:r>
           </a:p>
         </p:txBody>
@@ -6279,7 +6279,7 @@
                 </a:solidFill>
                 <a:latin typeface="Kanit"/>
               </a:rPr>
-              <a:t>จาก 792 (16.8%) · เรียลไทม์ · 2026-09-06</a:t>
+              <a:t>จาก 792 (15.7%) · เรียลไทม์ · 2026-09-07</a:t>
             </a:r>
           </a:p>
         </p:txBody>
@@ -6405,7 +6405,7 @@
                 </a:solidFill>
                 <a:latin typeface="Kanit"/>
               </a:rPr>
-              <a:t>39</a:t>
+              <a:t>45</a:t>
             </a:r>
           </a:p>
         </p:txBody>
@@ -6444,7 +6444,7 @@
                 </a:solidFill>
                 <a:latin typeface="Kanit"/>
               </a:rPr>
-              <a:t>ค่าล่าสุดรายวัน · 2026-09-06</a:t>
+              <a:t>ค่าล่าสุดรายวัน · 2026-09-07</a:t>
             </a:r>
           </a:p>
         </p:txBody>
@@ -7928,7 +7928,7 @@
                           </a:solidFill>
                           <a:latin typeface="Kanit"/>
                         </a:rPr>
-                        <a:t>58</a:t>
+                        <a:t>76</a:t>
                       </a:r>
                     </a:p>
                   </a:txBody>
@@ -7951,7 +7951,7 @@
                           </a:solidFill>
                           <a:latin typeface="Kanit"/>
                         </a:rPr>
-                        <a:t>15.8%</a:t>
+                        <a:t>26.3%</a:t>
                       </a:r>
                     </a:p>
                   </a:txBody>
@@ -8022,7 +8022,7 @@
                           </a:solidFill>
                           <a:latin typeface="Kanit"/>
                         </a:rPr>
-                        <a:t>สมุทรปราการ</a:t>
+                        <a:t>อุทัยธานี</a:t>
                       </a:r>
                     </a:p>
                   </a:txBody>
@@ -8045,7 +8045,7 @@
                           </a:solidFill>
                           <a:latin typeface="Kanit"/>
                         </a:rPr>
-                        <a:t>15</a:t>
+                        <a:t>45</a:t>
                       </a:r>
                     </a:p>
                   </a:txBody>
@@ -8114,7 +8114,7 @@
                           </a:solidFill>
                           <a:latin typeface="Kanit"/>
                         </a:rPr>
-                        <a:t>4/4</a:t>
+                        <a:t>1/4</a:t>
                       </a:r>
                     </a:p>
                   </a:txBody>
@@ -8162,7 +8162,7 @@
                           </a:solidFill>
                           <a:latin typeface="Kanit"/>
                         </a:rPr>
-                        <a:t>อุทัยธานี</a:t>
+                        <a:t>บึงกาฬ</a:t>
                       </a:r>
                     </a:p>
                   </a:txBody>
@@ -8185,7 +8185,7 @@
                           </a:solidFill>
                           <a:latin typeface="Kanit"/>
                         </a:rPr>
-                        <a:t>45</a:t>
+                        <a:t>11</a:t>
                       </a:r>
                     </a:p>
                   </a:txBody>
@@ -8208,7 +8208,7 @@
                           </a:solidFill>
                           <a:latin typeface="Kanit"/>
                         </a:rPr>
-                        <a:t>13</a:t>
+                        <a:t>162</a:t>
                       </a:r>
                     </a:p>
                   </a:txBody>
@@ -8227,11 +8227,11 @@
                       <a:r>
                         <a:rPr sz="900" b="1">
                           <a:solidFill>
-                            <a:srgbClr val="606060"/>
-                          </a:solidFill>
-                          <a:latin typeface="Kanit"/>
-                        </a:rPr>
-                        <a:t>0.0%</a:t>
+                            <a:srgbClr val="F5C242"/>
+                          </a:solidFill>
+                          <a:latin typeface="Kanit"/>
+                        </a:rPr>
+                        <a:t>54.5%</a:t>
                       </a:r>
                     </a:p>
                   </a:txBody>
@@ -8254,7 +8254,7 @@
                           </a:solidFill>
                           <a:latin typeface="Kanit"/>
                         </a:rPr>
-                        <a:t>1/4</a:t>
+                        <a:t>1/1</a:t>
                       </a:r>
                     </a:p>
                   </a:txBody>
@@ -8273,11 +8273,11 @@
                       <a:r>
                         <a:rPr sz="900" b="1">
                           <a:solidFill>
-                            <a:srgbClr val="CC0000"/>
-                          </a:solidFill>
-                          <a:latin typeface="Kanit"/>
-                        </a:rPr>
-                        <a:t>5</a:t>
+                            <a:srgbClr val="F5C242"/>
+                          </a:solidFill>
+                          <a:latin typeface="Kanit"/>
+                        </a:rPr>
+                        <a:t>4</a:t>
                       </a:r>
                     </a:p>
                   </a:txBody>
@@ -8302,7 +8302,7 @@
                           </a:solidFill>
                           <a:latin typeface="Kanit"/>
                         </a:rPr>
-                        <a:t>บึงกาฬ</a:t>
+                        <a:t>นครนายก</a:t>
                       </a:r>
                     </a:p>
                   </a:txBody>
@@ -8325,7 +8325,7 @@
                           </a:solidFill>
                           <a:latin typeface="Kanit"/>
                         </a:rPr>
-                        <a:t>11</a:t>
+                        <a:t>26</a:t>
                       </a:r>
                     </a:p>
                   </a:txBody>
@@ -8348,7 +8348,7 @@
                           </a:solidFill>
                           <a:latin typeface="Kanit"/>
                         </a:rPr>
-                        <a:t>134</a:t>
+                        <a:t>69</a:t>
                       </a:r>
                     </a:p>
                   </a:txBody>
@@ -8371,7 +8371,7 @@
                           </a:solidFill>
                           <a:latin typeface="Kanit"/>
                         </a:rPr>
-                        <a:t>45.5%</a:t>
+                        <a:t>42.3%</a:t>
                       </a:r>
                     </a:p>
                   </a:txBody>
@@ -8394,7 +8394,7 @@
                           </a:solidFill>
                           <a:latin typeface="Kanit"/>
                         </a:rPr>
-                        <a:t>1/1</a:t>
+                        <a:t>2/6</a:t>
                       </a:r>
                     </a:p>
                   </a:txBody>
@@ -8442,7 +8442,7 @@
                           </a:solidFill>
                           <a:latin typeface="Kanit"/>
                         </a:rPr>
-                        <a:t>นครนายก</a:t>
+                        <a:t>นนทบุรี</a:t>
                       </a:r>
                     </a:p>
                   </a:txBody>
@@ -8465,7 +8465,7 @@
                           </a:solidFill>
                           <a:latin typeface="Kanit"/>
                         </a:rPr>
-                        <a:t>26</a:t>
+                        <a:t>3</a:t>
                       </a:r>
                     </a:p>
                   </a:txBody>
@@ -8488,7 +8488,7 @@
                           </a:solidFill>
                           <a:latin typeface="Kanit"/>
                         </a:rPr>
-                        <a:t>60</a:t>
+                        <a:t>71</a:t>
                       </a:r>
                     </a:p>
                   </a:txBody>
@@ -8511,7 +8511,7 @@
                           </a:solidFill>
                           <a:latin typeface="Kanit"/>
                         </a:rPr>
-                        <a:t>42.3%</a:t>
+                        <a:t>33.3%</a:t>
                       </a:r>
                     </a:p>
                   </a:txBody>
@@ -8534,7 +8534,7 @@
                           </a:solidFill>
                           <a:latin typeface="Kanit"/>
                         </a:rPr>
-                        <a:t>2/6</a:t>
+                        <a:t>1/2</a:t>
                       </a:r>
                     </a:p>
                   </a:txBody>
@@ -8582,7 +8582,7 @@
                           </a:solidFill>
                           <a:latin typeface="Kanit"/>
                         </a:rPr>
-                        <a:t>ปราจีนบุรี</a:t>
+                        <a:t>พระนครศรีอยุธยา</a:t>
                       </a:r>
                     </a:p>
                   </a:txBody>
@@ -8605,7 +8605,7 @@
                           </a:solidFill>
                           <a:latin typeface="Kanit"/>
                         </a:rPr>
-                        <a:t>35</a:t>
+                        <a:t>30</a:t>
                       </a:r>
                     </a:p>
                   </a:txBody>
@@ -8628,7 +8628,7 @@
                           </a:solidFill>
                           <a:latin typeface="Kanit"/>
                         </a:rPr>
-                        <a:t>68</a:t>
+                        <a:t>71</a:t>
                       </a:r>
                     </a:p>
                   </a:txBody>
@@ -8651,7 +8651,7 @@
                           </a:solidFill>
                           <a:latin typeface="Kanit"/>
                         </a:rPr>
-                        <a:t>37.1%</a:t>
+                        <a:t>30.0%</a:t>
                       </a:r>
                     </a:p>
                   </a:txBody>
@@ -8674,7 +8674,7 @@
                           </a:solidFill>
                           <a:latin typeface="Kanit"/>
                         </a:rPr>
-                        <a:t>5/15</a:t>
+                        <a:t>8/22</a:t>
                       </a:r>
                     </a:p>
                   </a:txBody>
@@ -8909,7 +8909,7 @@
                 </a:solidFill>
                 <a:latin typeface="Kanit"/>
               </a:rPr>
-              <a:t>พื้นที่ปลูก วัดจริง (สศก. — ข้อมูลอำเภอ×พืช 3,295 แถว) ภัยแล้งเป็นดัชนี SPEI จาก แบบจำลอง คำนวณจากปริมาณฝนและการคายระเหย ปรับเดือนละครั้ง ดึงข้อมูล 2026-07-20 — เป็นสัญญาณที่ครอบคลุมทั้งประเทศดีที่สุดที่มี แต่ไม่มีใครลงพื้นที่ไปเดินดูอำเภอเหล่านั้น ข้อมูลฝนและระดับน้ำ วัดจริง (ThaiWater เรียลไทม์ ดึงทุกวันและสะสมไว้ — วันที่ดึงไม่สำเร็จจะเว้นเป็นช่องว่าง ไม่ใส่ค่าสมมติ) · ฝนถึง 2026-09-06, ระดับน้ำถึง 2026-09-06 ความเสี่ยงน้ำท่วมเชิงโครงสร้าง วัดจริง (สำมะโนพื้นที่ท่วมซ้ำซาก GISTDA มาตราส่วน 1:50,000 ปี 2005-2016 — เป็นบันทึกภาคพื้นดิน 12 ปี ไม่ใช่การพยากรณ์)</a:t>
+              <a:t>พื้นที่ปลูก วัดจริง (สศก. — ข้อมูลอำเภอ×พืช 3,295 แถว) ภัยแล้งเป็นดัชนี SPEI จาก แบบจำลอง คำนวณจากปริมาณฝนและการคายระเหย ปรับเดือนละครั้ง ดึงข้อมูล 2026-07-20 — เป็นสัญญาณที่ครอบคลุมทั้งประเทศดีที่สุดที่มี แต่ไม่มีใครลงพื้นที่ไปเดินดูอำเภอเหล่านั้น ข้อมูลฝนและระดับน้ำ วัดจริง (ThaiWater เรียลไทม์ ดึงทุกวันและสะสมไว้ — วันที่ดึงไม่สำเร็จจะเว้นเป็นช่องว่าง ไม่ใส่ค่าสมมติ) · ฝนถึง 2026-09-07, ระดับน้ำถึง 2026-09-07 ความเสี่ยงน้ำท่วมเชิงโครงสร้าง วัดจริง (สำมะโนพื้นที่ท่วมซ้ำซาก GISTDA มาตราส่วน 1:50,000 ปี 2005-2016 — เป็นบันทึกภาคพื้นดิน 12 ปี ไม่ใช่การพยากรณ์)</a:t>
             </a:r>
           </a:p>
         </p:txBody>
@@ -32047,7 +32047,7 @@
                 </a:solidFill>
                 <a:latin typeface="Kanit"/>
               </a:rPr>
-              <a:t>รุ่นข้อมูล — ราคาโลก 2026M06 · ราคาหน้าฟาร์มไทย 2026-09-03 · ประวัติราคาไทย 2026-09-05 · ต้นทุนการผลิตพืช สศก. ไจอัป 2568 (ปีเพาะปลูก 2568/69, ประมาณการ สศก. มี.ค. 2569) · ภัยแล้ง 2026-06-21 · เงินเฟ้อ 2026-05 · GDP 2026 ไตรมาส 1 · IMF WEO 2026 · ดัชนีราคาขายต่อ 2026-05 · ยอดจดทะเบียนถึง 2026-01 · หนี้ครัวเรือน สสช. SES 2566 · ค่าจ้าง สสช. LFS 2568 · ข้อมูลตรวจวัด 2026-09-06</a:t>
+              <a:t>รุ่นข้อมูล — ราคาโลก 2026M06 · ราคาหน้าฟาร์มไทย 2026-09-03 · ประวัติราคาไทย 2026-09-05 · ต้นทุนการผลิตพืช สศก. ไจอัป 2568 (ปีเพาะปลูก 2568/69, ประมาณการ สศก. มี.ค. 2569) · ภัยแล้ง 2026-06-21 · เงินเฟ้อ 2026-05 · GDP 2026 ไตรมาส 1 · IMF WEO 2026 · ดัชนีราคาขายต่อ 2026-05 · ยอดจดทะเบียนถึง 2026-01 · หนี้ครัวเรือน สสช. SES 2566 · ค่าจ้าง สสช. LFS 2568 · ข้อมูลตรวจวัด 2026-09-07</a:t>
             </a:r>
           </a:p>
         </p:txBody>
@@ -37087,7 +37087,7 @@
                 </a:solidFill>
                 <a:latin typeface="Kanit"/>
               </a:rPr>
-              <a:t>338 จาก 928 อำเภอ · แม่น้ำเกินระดับ 133 จาก 792 สถานี</a:t>
+              <a:t>338 จาก 928 อำเภอ · แม่น้ำเกินระดับ 124 จาก 792 สถานี</a:t>
             </a:r>
           </a:p>
         </p:txBody>
@@ -37859,7 +37859,7 @@
                           </a:solidFill>
                           <a:latin typeface="Kanit"/>
                         </a:rPr>
-                        <a:t>29/157</a:t>
+                        <a:t>30/157</a:t>
                       </a:r>
                     </a:p>
                   </a:txBody>
@@ -38323,7 +38323,7 @@
                           </a:solidFill>
                           <a:latin typeface="Kanit"/>
                         </a:rPr>
-                        <a:t>29/167</a:t>
+                        <a:t>26/167</a:t>
                       </a:r>
                     </a:p>
                   </a:txBody>
@@ -38555,7 +38555,7 @@
                           </a:solidFill>
                           <a:latin typeface="Kanit"/>
                         </a:rPr>
-                        <a:t>14/51</a:t>
+                        <a:t>13/51</a:t>
                       </a:r>
                     </a:p>
                   </a:txBody>
@@ -38787,7 +38787,7 @@
                           </a:solidFill>
                           <a:latin typeface="Kanit"/>
                         </a:rPr>
-                        <a:t>45/143</a:t>
+                        <a:t>39/143</a:t>
                       </a:r>
                     </a:p>
                   </a:txBody>

</xml_diff>

<commit_message>
deck(mcom): rebuild — the data moved past the committed figures (run 34063910473) (#847)
Co-authored-by: github-actions[bot] <41898282+github-actions[bot]@users.noreply.github.com>
</commit_message>
<xml_diff>
--- a/docs/decks/mcom-2026-08-05-macro-TH.pptx
+++ b/docs/decks/mcom-2026-08-05-macro-TH.pptx
@@ -6240,7 +6240,7 @@
                 </a:solidFill>
                 <a:latin typeface="Kanit"/>
               </a:rPr>
-              <a:t>133</a:t>
+              <a:t>124</a:t>
             </a:r>
           </a:p>
         </p:txBody>
@@ -6279,7 +6279,7 @@
                 </a:solidFill>
                 <a:latin typeface="Kanit"/>
               </a:rPr>
-              <a:t>จาก 792 (16.8%) · เรียลไทม์ · 2026-09-06</a:t>
+              <a:t>จาก 792 (15.7%) · เรียลไทม์ · 2026-09-07</a:t>
             </a:r>
           </a:p>
         </p:txBody>
@@ -6405,7 +6405,7 @@
                 </a:solidFill>
                 <a:latin typeface="Kanit"/>
               </a:rPr>
-              <a:t>39</a:t>
+              <a:t>45</a:t>
             </a:r>
           </a:p>
         </p:txBody>
@@ -6444,7 +6444,7 @@
                 </a:solidFill>
                 <a:latin typeface="Kanit"/>
               </a:rPr>
-              <a:t>ค่าล่าสุดรายวัน · 2026-09-06</a:t>
+              <a:t>ค่าล่าสุดรายวัน · 2026-09-07</a:t>
             </a:r>
           </a:p>
         </p:txBody>
@@ -7928,7 +7928,7 @@
                           </a:solidFill>
                           <a:latin typeface="Kanit"/>
                         </a:rPr>
-                        <a:t>58</a:t>
+                        <a:t>76</a:t>
                       </a:r>
                     </a:p>
                   </a:txBody>
@@ -7951,7 +7951,7 @@
                           </a:solidFill>
                           <a:latin typeface="Kanit"/>
                         </a:rPr>
-                        <a:t>15.8%</a:t>
+                        <a:t>26.3%</a:t>
                       </a:r>
                     </a:p>
                   </a:txBody>
@@ -8022,7 +8022,7 @@
                           </a:solidFill>
                           <a:latin typeface="Kanit"/>
                         </a:rPr>
-                        <a:t>สมุทรปราการ</a:t>
+                        <a:t>อุทัยธานี</a:t>
                       </a:r>
                     </a:p>
                   </a:txBody>
@@ -8045,7 +8045,7 @@
                           </a:solidFill>
                           <a:latin typeface="Kanit"/>
                         </a:rPr>
-                        <a:t>15</a:t>
+                        <a:t>45</a:t>
                       </a:r>
                     </a:p>
                   </a:txBody>
@@ -8114,7 +8114,7 @@
                           </a:solidFill>
                           <a:latin typeface="Kanit"/>
                         </a:rPr>
-                        <a:t>4/4</a:t>
+                        <a:t>1/4</a:t>
                       </a:r>
                     </a:p>
                   </a:txBody>
@@ -8162,7 +8162,7 @@
                           </a:solidFill>
                           <a:latin typeface="Kanit"/>
                         </a:rPr>
-                        <a:t>อุทัยธานี</a:t>
+                        <a:t>บึงกาฬ</a:t>
                       </a:r>
                     </a:p>
                   </a:txBody>
@@ -8185,7 +8185,7 @@
                           </a:solidFill>
                           <a:latin typeface="Kanit"/>
                         </a:rPr>
-                        <a:t>45</a:t>
+                        <a:t>11</a:t>
                       </a:r>
                     </a:p>
                   </a:txBody>
@@ -8208,7 +8208,7 @@
                           </a:solidFill>
                           <a:latin typeface="Kanit"/>
                         </a:rPr>
-                        <a:t>13</a:t>
+                        <a:t>162</a:t>
                       </a:r>
                     </a:p>
                   </a:txBody>
@@ -8227,11 +8227,11 @@
                       <a:r>
                         <a:rPr sz="900" b="1">
                           <a:solidFill>
-                            <a:srgbClr val="606060"/>
-                          </a:solidFill>
-                          <a:latin typeface="Kanit"/>
-                        </a:rPr>
-                        <a:t>0.0%</a:t>
+                            <a:srgbClr val="F5C242"/>
+                          </a:solidFill>
+                          <a:latin typeface="Kanit"/>
+                        </a:rPr>
+                        <a:t>54.5%</a:t>
                       </a:r>
                     </a:p>
                   </a:txBody>
@@ -8254,7 +8254,7 @@
                           </a:solidFill>
                           <a:latin typeface="Kanit"/>
                         </a:rPr>
-                        <a:t>1/4</a:t>
+                        <a:t>1/1</a:t>
                       </a:r>
                     </a:p>
                   </a:txBody>
@@ -8273,11 +8273,11 @@
                       <a:r>
                         <a:rPr sz="900" b="1">
                           <a:solidFill>
-                            <a:srgbClr val="CC0000"/>
-                          </a:solidFill>
-                          <a:latin typeface="Kanit"/>
-                        </a:rPr>
-                        <a:t>5</a:t>
+                            <a:srgbClr val="F5C242"/>
+                          </a:solidFill>
+                          <a:latin typeface="Kanit"/>
+                        </a:rPr>
+                        <a:t>4</a:t>
                       </a:r>
                     </a:p>
                   </a:txBody>
@@ -8302,7 +8302,7 @@
                           </a:solidFill>
                           <a:latin typeface="Kanit"/>
                         </a:rPr>
-                        <a:t>บึงกาฬ</a:t>
+                        <a:t>นครนายก</a:t>
                       </a:r>
                     </a:p>
                   </a:txBody>
@@ -8325,7 +8325,7 @@
                           </a:solidFill>
                           <a:latin typeface="Kanit"/>
                         </a:rPr>
-                        <a:t>11</a:t>
+                        <a:t>26</a:t>
                       </a:r>
                     </a:p>
                   </a:txBody>
@@ -8348,7 +8348,7 @@
                           </a:solidFill>
                           <a:latin typeface="Kanit"/>
                         </a:rPr>
-                        <a:t>134</a:t>
+                        <a:t>69</a:t>
                       </a:r>
                     </a:p>
                   </a:txBody>
@@ -8371,7 +8371,7 @@
                           </a:solidFill>
                           <a:latin typeface="Kanit"/>
                         </a:rPr>
-                        <a:t>45.5%</a:t>
+                        <a:t>42.3%</a:t>
                       </a:r>
                     </a:p>
                   </a:txBody>
@@ -8394,7 +8394,7 @@
                           </a:solidFill>
                           <a:latin typeface="Kanit"/>
                         </a:rPr>
-                        <a:t>1/1</a:t>
+                        <a:t>2/6</a:t>
                       </a:r>
                     </a:p>
                   </a:txBody>
@@ -8442,7 +8442,7 @@
                           </a:solidFill>
                           <a:latin typeface="Kanit"/>
                         </a:rPr>
-                        <a:t>นครนายก</a:t>
+                        <a:t>นนทบุรี</a:t>
                       </a:r>
                     </a:p>
                   </a:txBody>
@@ -8465,7 +8465,7 @@
                           </a:solidFill>
                           <a:latin typeface="Kanit"/>
                         </a:rPr>
-                        <a:t>26</a:t>
+                        <a:t>3</a:t>
                       </a:r>
                     </a:p>
                   </a:txBody>
@@ -8488,7 +8488,7 @@
                           </a:solidFill>
                           <a:latin typeface="Kanit"/>
                         </a:rPr>
-                        <a:t>60</a:t>
+                        <a:t>71</a:t>
                       </a:r>
                     </a:p>
                   </a:txBody>
@@ -8511,7 +8511,7 @@
                           </a:solidFill>
                           <a:latin typeface="Kanit"/>
                         </a:rPr>
-                        <a:t>42.3%</a:t>
+                        <a:t>33.3%</a:t>
                       </a:r>
                     </a:p>
                   </a:txBody>
@@ -8534,7 +8534,7 @@
                           </a:solidFill>
                           <a:latin typeface="Kanit"/>
                         </a:rPr>
-                        <a:t>2/6</a:t>
+                        <a:t>1/2</a:t>
                       </a:r>
                     </a:p>
                   </a:txBody>
@@ -8582,7 +8582,7 @@
                           </a:solidFill>
                           <a:latin typeface="Kanit"/>
                         </a:rPr>
-                        <a:t>ปราจีนบุรี</a:t>
+                        <a:t>พระนครศรีอยุธยา</a:t>
                       </a:r>
                     </a:p>
                   </a:txBody>
@@ -8605,7 +8605,7 @@
                           </a:solidFill>
                           <a:latin typeface="Kanit"/>
                         </a:rPr>
-                        <a:t>35</a:t>
+                        <a:t>30</a:t>
                       </a:r>
                     </a:p>
                   </a:txBody>
@@ -8628,7 +8628,7 @@
                           </a:solidFill>
                           <a:latin typeface="Kanit"/>
                         </a:rPr>
-                        <a:t>68</a:t>
+                        <a:t>71</a:t>
                       </a:r>
                     </a:p>
                   </a:txBody>
@@ -8651,7 +8651,7 @@
                           </a:solidFill>
                           <a:latin typeface="Kanit"/>
                         </a:rPr>
-                        <a:t>37.1%</a:t>
+                        <a:t>30.0%</a:t>
                       </a:r>
                     </a:p>
                   </a:txBody>
@@ -8674,7 +8674,7 @@
                           </a:solidFill>
                           <a:latin typeface="Kanit"/>
                         </a:rPr>
-                        <a:t>5/15</a:t>
+                        <a:t>8/22</a:t>
                       </a:r>
                     </a:p>
                   </a:txBody>
@@ -8909,7 +8909,7 @@
                 </a:solidFill>
                 <a:latin typeface="Kanit"/>
               </a:rPr>
-              <a:t>พื้นที่ปลูก วัดจริง (สศก. — ข้อมูลอำเภอ×พืช 3,295 แถว) ภัยแล้งเป็นดัชนี SPEI จาก แบบจำลอง คำนวณจากปริมาณฝนและการคายระเหย ปรับเดือนละครั้ง ดึงข้อมูล 2026-07-20 — เป็นสัญญาณที่ครอบคลุมทั้งประเทศดีที่สุดที่มี แต่ไม่มีใครลงพื้นที่ไปเดินดูอำเภอเหล่านั้น ข้อมูลฝนและระดับน้ำ วัดจริง (ThaiWater เรียลไทม์ ดึงทุกวันและสะสมไว้ — วันที่ดึงไม่สำเร็จจะเว้นเป็นช่องว่าง ไม่ใส่ค่าสมมติ) · ฝนถึง 2026-09-06, ระดับน้ำถึง 2026-09-06 ความเสี่ยงน้ำท่วมเชิงโครงสร้าง วัดจริง (สำมะโนพื้นที่ท่วมซ้ำซาก GISTDA มาตราส่วน 1:50,000 ปี 2005-2016 — เป็นบันทึกภาคพื้นดิน 12 ปี ไม่ใช่การพยากรณ์)</a:t>
+              <a:t>พื้นที่ปลูก วัดจริง (สศก. — ข้อมูลอำเภอ×พืช 3,295 แถว) ภัยแล้งเป็นดัชนี SPEI จาก แบบจำลอง คำนวณจากปริมาณฝนและการคายระเหย ปรับเดือนละครั้ง ดึงข้อมูล 2026-07-20 — เป็นสัญญาณที่ครอบคลุมทั้งประเทศดีที่สุดที่มี แต่ไม่มีใครลงพื้นที่ไปเดินดูอำเภอเหล่านั้น ข้อมูลฝนและระดับน้ำ วัดจริง (ThaiWater เรียลไทม์ ดึงทุกวันและสะสมไว้ — วันที่ดึงไม่สำเร็จจะเว้นเป็นช่องว่าง ไม่ใส่ค่าสมมติ) · ฝนถึง 2026-09-07, ระดับน้ำถึง 2026-09-07 ความเสี่ยงน้ำท่วมเชิงโครงสร้าง วัดจริง (สำมะโนพื้นที่ท่วมซ้ำซาก GISTDA มาตราส่วน 1:50,000 ปี 2005-2016 — เป็นบันทึกภาคพื้นดิน 12 ปี ไม่ใช่การพยากรณ์)</a:t>
             </a:r>
           </a:p>
         </p:txBody>
@@ -32047,7 +32047,7 @@
                 </a:solidFill>
                 <a:latin typeface="Kanit"/>
               </a:rPr>
-              <a:t>รุ่นข้อมูล — ราคาโลก 2026M06 · ราคาหน้าฟาร์มไทย 2026-09-03 · ประวัติราคาไทย 2026-09-05 · ต้นทุนการผลิตพืช สศก. ไจอัป 2568 (ปีเพาะปลูก 2568/69, ประมาณการ สศก. มี.ค. 2569) · ภัยแล้ง 2026-06-21 · เงินเฟ้อ 2026-05 · GDP 2026 ไตรมาส 1 · IMF WEO 2026 · ดัชนีราคาขายต่อ 2026-05 · ยอดจดทะเบียนถึง 2026-01 · หนี้ครัวเรือน สสช. SES 2566 · ค่าจ้าง สสช. LFS 2568 · ข้อมูลตรวจวัด 2026-09-06</a:t>
+              <a:t>รุ่นข้อมูล — ราคาโลก 2026M06 · ราคาหน้าฟาร์มไทย 2026-09-03 · ประวัติราคาไทย 2026-09-05 · ต้นทุนการผลิตพืช สศก. ไจอัป 2568 (ปีเพาะปลูก 2568/69, ประมาณการ สศก. มี.ค. 2569) · ภัยแล้ง 2026-06-21 · เงินเฟ้อ 2026-05 · GDP 2026 ไตรมาส 1 · IMF WEO 2026 · ดัชนีราคาขายต่อ 2026-05 · ยอดจดทะเบียนถึง 2026-01 · หนี้ครัวเรือน สสช. SES 2566 · ค่าจ้าง สสช. LFS 2568 · ข้อมูลตรวจวัด 2026-09-07</a:t>
             </a:r>
           </a:p>
         </p:txBody>
@@ -37087,7 +37087,7 @@
                 </a:solidFill>
                 <a:latin typeface="Kanit"/>
               </a:rPr>
-              <a:t>338 จาก 928 อำเภอ · แม่น้ำเกินระดับ 133 จาก 792 สถานี</a:t>
+              <a:t>338 จาก 928 อำเภอ · แม่น้ำเกินระดับ 124 จาก 792 สถานี</a:t>
             </a:r>
           </a:p>
         </p:txBody>
@@ -37859,7 +37859,7 @@
                           </a:solidFill>
                           <a:latin typeface="Kanit"/>
                         </a:rPr>
-                        <a:t>29/157</a:t>
+                        <a:t>30/157</a:t>
                       </a:r>
                     </a:p>
                   </a:txBody>
@@ -38323,7 +38323,7 @@
                           </a:solidFill>
                           <a:latin typeface="Kanit"/>
                         </a:rPr>
-                        <a:t>29/167</a:t>
+                        <a:t>26/167</a:t>
                       </a:r>
                     </a:p>
                   </a:txBody>
@@ -38555,7 +38555,7 @@
                           </a:solidFill>
                           <a:latin typeface="Kanit"/>
                         </a:rPr>
-                        <a:t>14/51</a:t>
+                        <a:t>13/51</a:t>
                       </a:r>
                     </a:p>
                   </a:txBody>
@@ -38787,7 +38787,7 @@
                           </a:solidFill>
                           <a:latin typeface="Kanit"/>
                         </a:rPr>
-                        <a:t>45/143</a:t>
+                        <a:t>39/143</a:t>
                       </a:r>
                     </a:p>
                   </a:txBody>

</xml_diff>

<commit_message>
deck(mcom): rebuild — the data moved past the committed figures (run 34082508439)
</commit_message>
<xml_diff>
--- a/docs/decks/mcom-2026-08-05-macro-TH.pptx
+++ b/docs/decks/mcom-2026-08-05-macro-TH.pptx
@@ -6240,7 +6240,7 @@
                 </a:solidFill>
                 <a:latin typeface="Kanit"/>
               </a:rPr>
-              <a:t>124</a:t>
+              <a:t>123</a:t>
             </a:r>
           </a:p>
         </p:txBody>
@@ -6279,7 +6279,7 @@
                 </a:solidFill>
                 <a:latin typeface="Kanit"/>
               </a:rPr>
-              <a:t>จาก 792 (15.7%) · เรียลไทม์ · 2026-09-07</a:t>
+              <a:t>จาก 792 (15.5%) · เรียลไทม์ · 2026-09-07</a:t>
             </a:r>
           </a:p>
         </p:txBody>
@@ -7951,7 +7951,7 @@
                           </a:solidFill>
                           <a:latin typeface="Kanit"/>
                         </a:rPr>
-                        <a:t>26.3%</a:t>
+                        <a:t>28.9%</a:t>
                       </a:r>
                     </a:p>
                   </a:txBody>
@@ -7974,7 +7974,7 @@
                           </a:solidFill>
                           <a:latin typeface="Kanit"/>
                         </a:rPr>
-                        <a:t>6/13</a:t>
+                        <a:t>7/13</a:t>
                       </a:r>
                     </a:p>
                   </a:txBody>
@@ -8068,7 +8068,7 @@
                           </a:solidFill>
                           <a:latin typeface="Kanit"/>
                         </a:rPr>
-                        <a:t>13</a:t>
+                        <a:t>15</a:t>
                       </a:r>
                     </a:p>
                   </a:txBody>
@@ -8231,7 +8231,7 @@
                           </a:solidFill>
                           <a:latin typeface="Kanit"/>
                         </a:rPr>
-                        <a:t>54.5%</a:t>
+                        <a:t>45.5%</a:t>
                       </a:r>
                     </a:p>
                   </a:txBody>
@@ -8325,7 +8325,7 @@
                           </a:solidFill>
                           <a:latin typeface="Kanit"/>
                         </a:rPr>
-                        <a:t>26</a:t>
+                        <a:t>25</a:t>
                       </a:r>
                     </a:p>
                   </a:txBody>
@@ -8371,7 +8371,7 @@
                           </a:solidFill>
                           <a:latin typeface="Kanit"/>
                         </a:rPr>
-                        <a:t>42.3%</a:t>
+                        <a:t>44.0%</a:t>
                       </a:r>
                     </a:p>
                   </a:txBody>
@@ -8674,7 +8674,7 @@
                           </a:solidFill>
                           <a:latin typeface="Kanit"/>
                         </a:rPr>
-                        <a:t>8/22</a:t>
+                        <a:t>7/22</a:t>
                       </a:r>
                     </a:p>
                   </a:txBody>
@@ -31476,7 +31476,7 @@
                 </a:solidFill>
                 <a:latin typeface="Kanit"/>
               </a:rPr>
-              <a:t>รายได้จากพืชค่ากลางเพิ่มขึ้น +16.4% แต่มีสี่จังหวัดที่ลดลง — ทั้งหมดอยู่ในแหล่งปลูกมะพร้าว โดยหนักที่สุดคือสมุทรสงครามที่ −63.5%</a:t>
+              <a:t>รายได้จากพืชค่ากลางเพิ่มขึ้น +16.3% แต่มีสี่จังหวัดที่ลดลง — ทั้งหมดอยู่ในแหล่งปลูกมะพร้าว โดยหนักที่สุดคือสมุทรสงครามที่ −63.8%</a:t>
             </a:r>
           </a:p>
         </p:txBody>
@@ -32047,7 +32047,7 @@
                 </a:solidFill>
                 <a:latin typeface="Kanit"/>
               </a:rPr>
-              <a:t>รุ่นข้อมูล — ราคาโลก 2026M06 · ราคาหน้าฟาร์มไทย 2026-09-03 · ประวัติราคาไทย 2026-09-05 · ต้นทุนการผลิตพืช สศก. ไจอัป 2568 (ปีเพาะปลูก 2568/69, ประมาณการ สศก. มี.ค. 2569) · ภัยแล้ง 2026-06-21 · เงินเฟ้อ 2026-05 · GDP 2026 ไตรมาส 1 · IMF WEO 2026 · ดัชนีราคาขายต่อ 2026-05 · ยอดจดทะเบียนถึง 2026-01 · หนี้ครัวเรือน สสช. SES 2566 · ค่าจ้าง สสช. LFS 2568 · ข้อมูลตรวจวัด 2026-09-07</a:t>
+              <a:t>รุ่นข้อมูล — ราคาโลก 2026M06 · ราคาหน้าฟาร์มไทย 2026-09-04 · ประวัติราคาไทย 2026-09-05 · ต้นทุนการผลิตพืช สศก. ไจอัป 2568 (ปีเพาะปลูก 2568/69, ประมาณการ สศก. มี.ค. 2569) · ภัยแล้ง 2026-06-21 · เงินเฟ้อ 2026-05 · GDP 2026 ไตรมาส 1 · IMF WEO 2026 · ดัชนีราคาขายต่อ 2026-05 · ยอดจดทะเบียนถึง 2026-01 · หนี้ครัวเรือน สสช. SES 2566 · ค่าจ้าง สสช. LFS 2568 · ข้อมูลตรวจวัด 2026-09-07</a:t>
             </a:r>
           </a:p>
         </p:txBody>
@@ -32546,7 +32546,7 @@
               <a:t>Not on the world index — the farm gate (ราคาที่เกษตรกรขายได้) says otherwise.
 • Five of seventeen Thai farm-gate prices are falling year on year.
 • Beef: farm gate −6.1% vs world index +8.8%.
-• Margin over price: a 26% price move becomes an 85% swing in crop income.</a:t>
+• Margin over price: a 26% price move becomes an 87% swing in crop income.</a:t>
             </a:r>
           </a:p>
         </p:txBody>
@@ -37087,7 +37087,7 @@
                 </a:solidFill>
                 <a:latin typeface="Kanit"/>
               </a:rPr>
-              <a:t>338 จาก 928 อำเภอ · แม่น้ำเกินระดับ 124 จาก 792 สถานี</a:t>
+              <a:t>338 จาก 928 อำเภอ · แม่น้ำเกินระดับ 123 จาก 792 สถานี</a:t>
             </a:r>
           </a:p>
         </p:txBody>
@@ -37859,7 +37859,7 @@
                           </a:solidFill>
                           <a:latin typeface="Kanit"/>
                         </a:rPr>
-                        <a:t>30/157</a:t>
+                        <a:t>29/157</a:t>
                       </a:r>
                     </a:p>
                   </a:txBody>
@@ -38091,7 +38091,7 @@
                           </a:solidFill>
                           <a:latin typeface="Kanit"/>
                         </a:rPr>
-                        <a:t>16/274</a:t>
+                        <a:t>18/274</a:t>
                       </a:r>
                     </a:p>
                   </a:txBody>
@@ -38323,7 +38323,7 @@
                           </a:solidFill>
                           <a:latin typeface="Kanit"/>
                         </a:rPr>
-                        <a:t>26/167</a:t>
+                        <a:t>25/167</a:t>
                       </a:r>
                     </a:p>
                   </a:txBody>
@@ -38555,7 +38555,7 @@
                           </a:solidFill>
                           <a:latin typeface="Kanit"/>
                         </a:rPr>
-                        <a:t>13/51</a:t>
+                        <a:t>14/51</a:t>
                       </a:r>
                     </a:p>
                   </a:txBody>
@@ -38787,7 +38787,7 @@
                           </a:solidFill>
                           <a:latin typeface="Kanit"/>
                         </a:rPr>
-                        <a:t>39/143</a:t>
+                        <a:t>37/143</a:t>
                       </a:r>
                     </a:p>
                   </a:txBody>
@@ -39936,7 +39936,7 @@
                           </a:solidFill>
                           <a:latin typeface="Kanit"/>
                         </a:rPr>
-                        <a:t>−67.9%</a:t>
+                        <a:t>−68.2%</a:t>
                       </a:r>
                     </a:p>
                   </a:txBody>
@@ -40791,7 +40791,7 @@
                 </a:solidFill>
                 <a:latin typeface="Kanit"/>
               </a:rPr>
-              <a:t>ราคา วัดจริง — ราคาหน้าฟาร์มไทยจากราคารายวันของ NABC และราคาอ้อยประกาศของ สอน. ราคาล่าสุด 2026-09-03 การเปลี่ยนแปลงหกเดือนคำนวณจากข้อมูลรายเดือนของ NABC เอง (thai_price_history รุ่นข้อมูล 2026-09-05) พืชที่ไม่มีข้อมูลรายเดือนจะกำกับไว้ ไม่ประมาณการขึ้นมา แหล่งผลิตเป็นการอ่านแบบ ประมาณการ ว่าสินค้าแต่ละชนิดปลูกที่ไหน และแหล่งผลิตทับซ้อนกันได้ บัญชีอาชีพเกษตรเป็นข้อมูลของเราเองและ วัดจริง — บัญชีที่บันทึกอาชีพว่า เกษตร ในจังหวัดแหล่งผลิต จากฐานข้อมูล 382,735 บัญชี ณ 2026-07 ไม่เผยแพร่ช่องที่มีน้อยกว่า 30 บัญชี คนกลุ่มนี้อาศัยอยู่ในพื้นที่ที่ปลูกพืชนั้น แต่ไม่ได้ยืนยันว่าปลูกพืชนั้นเอง</a:t>
+              <a:t>ราคา วัดจริง — ราคาหน้าฟาร์มไทยจากราคารายวันของ NABC และราคาอ้อยประกาศของ สอน. ราคาล่าสุด 2026-09-04 การเปลี่ยนแปลงหกเดือนคำนวณจากข้อมูลรายเดือนของ NABC เอง (thai_price_history รุ่นข้อมูล 2026-09-05) พืชที่ไม่มีข้อมูลรายเดือนจะกำกับไว้ ไม่ประมาณการขึ้นมา แหล่งผลิตเป็นการอ่านแบบ ประมาณการ ว่าสินค้าแต่ละชนิดปลูกที่ไหน และแหล่งผลิตทับซ้อนกันได้ บัญชีอาชีพเกษตรเป็นข้อมูลของเราเองและ วัดจริง — บัญชีที่บันทึกอาชีพว่า เกษตร ในจังหวัดแหล่งผลิต จากฐานข้อมูล 382,735 บัญชี ณ 2026-07 ไม่เผยแพร่ช่องที่มีน้อยกว่า 30 บัญชี คนกลุ่มนี้อาศัยอยู่ในพื้นที่ที่ปลูกพืชนั้น แต่ไม่ได้ยืนยันว่าปลูกพืชนั้นเอง</a:t>
             </a:r>
           </a:p>
         </p:txBody>
@@ -44679,7 +44679,7 @@
                 </a:solidFill>
                 <a:latin typeface="Kanit"/>
               </a:rPr>
-              <a:t>มะพร้าว −67.9% สับปะรด −18.4% อ้อย −17.9% เทียบปีก่อน</a:t>
+              <a:t>มะพร้าว −68.2% สับปะรด −18.4% อ้อย −17.9% เทียบปีก่อน</a:t>
             </a:r>
           </a:p>
         </p:txBody>
@@ -44805,7 +44805,7 @@
                 </a:solidFill>
                 <a:latin typeface="Kanit"/>
               </a:rPr>
-              <a:t>+16.4%</a:t>
+              <a:t>+16.3%</a:t>
             </a:r>
           </a:p>
         </p:txBody>
@@ -45348,7 +45348,7 @@
                           </a:solidFill>
                           <a:latin typeface="Kanit"/>
                         </a:rPr>
-                        <a:t>-63.5%</a:t>
+                        <a:t>-63.8%</a:t>
                       </a:r>
                     </a:p>
                   </a:txBody>
@@ -45419,7 +45419,7 @@
                           </a:solidFill>
                           <a:latin typeface="Kanit"/>
                         </a:rPr>
-                        <a:t>+15.4%</a:t>
+                        <a:t>+15.3%</a:t>
                       </a:r>
                     </a:p>
                   </a:txBody>
@@ -47039,7 +47039,7 @@
                           </a:solidFill>
                           <a:latin typeface="Kanit"/>
                         </a:rPr>
-                        <a:t>+16.7%</a:t>
+                        <a:t>+16.6%</a:t>
                       </a:r>
                     </a:p>
                   </a:txBody>
@@ -48024,7 +48024,7 @@
                 </a:solidFill>
                 <a:latin typeface="Kanit"/>
               </a:rPr>
-              <a:t>เทียบปีก่อน −67.9%</a:t>
+              <a:t>เทียบปีก่อน −68.2%</a:t>
             </a:r>
           </a:p>
         </p:txBody>
@@ -48660,7 +48660,7 @@
                 </a:solidFill>
                 <a:latin typeface="Kanit"/>
               </a:rPr>
-              <a:t>เทียบปีก่อน +1.0%</a:t>
+              <a:t>เทียบปีก่อน +0.9%</a:t>
             </a:r>
           </a:p>
         </p:txBody>
@@ -48978,7 +48978,7 @@
                 </a:solidFill>
                 <a:latin typeface="Kanit"/>
               </a:rPr>
-              <a:t>เทียบปีก่อน +4.5%</a:t>
+              <a:t>เทียบปีก่อน +4.6%</a:t>
             </a:r>
           </a:p>
         </p:txBody>
@@ -49296,7 +49296,7 @@
                 </a:solidFill>
                 <a:latin typeface="Kanit"/>
               </a:rPr>
-              <a:t>เทียบปีก่อน +5.6%</a:t>
+              <a:t>เทียบปีก่อน +5.9%</a:t>
             </a:r>
           </a:p>
         </p:txBody>
@@ -49932,7 +49932,7 @@
                 </a:solidFill>
                 <a:latin typeface="Kanit"/>
               </a:rPr>
-              <a:t>เทียบปีก่อน +15.5%</a:t>
+              <a:t>เทียบปีก่อน +15.1%</a:t>
             </a:r>
           </a:p>
         </p:txBody>
@@ -50250,7 +50250,7 @@
                 </a:solidFill>
                 <a:latin typeface="Kanit"/>
               </a:rPr>
-              <a:t>เทียบปีก่อน +18.0%</a:t>
+              <a:t>เทียบปีก่อน +19.5%</a:t>
             </a:r>
           </a:p>
         </p:txBody>
@@ -51522,7 +51522,7 @@
                 </a:solidFill>
                 <a:latin typeface="Kanit"/>
               </a:rPr>
-              <a:t>เทียบปีก่อน +134.7%</a:t>
+              <a:t>เทียบปีก่อน +161.6%</a:t>
             </a:r>
           </a:p>
         </p:txBody>
@@ -51886,7 +51886,7 @@
                 </a:solidFill>
                 <a:latin typeface="Kanit"/>
               </a:rPr>
-              <a:t>ราคาหน้าฟาร์ม วัดจริง — ราคารายวันของ NABC เฉลี่ยเป็นรายเดือน หน่วยเป็นบาทตามที่เผยแพร่ (ไม่มีการแปลงสกุลเงิน) ราคาล่าสุด 2026-09-03, รุ่นข้อมูลย้อนหลัง 2026-09-05 ราคาหน้าฟาร์ม (ราคาที่เกษตรกรขายได้) คือเงินที่เกษตรกรได้รับเมื่อขายครั้งแรก ก่อนพ่อค้าคนกลาง โรงสี หรือค่าขนส่งจะหักส่วนแบ่ง — ไม่ใช่ดัชนีโลก และไม่ใช่ราคาในซูเปอร์มาร์เก็ต แหล่งผลิตเป็นการอ่านแบบ ประมาณการ ว่าสินค้าแต่ละชนิดผลิตที่ไหน และทับซ้อนกันได้ น้ำตาลเป็นราคาอ้อยประกาศของ สอน. ปีละหนึ่งจุด จึงไม่มีการเปลี่ยนแปลงหกเดือนให้แสดง</a:t>
+              <a:t>ราคาหน้าฟาร์ม วัดจริง — ราคารายวันของ NABC เฉลี่ยเป็นรายเดือน หน่วยเป็นบาทตามที่เผยแพร่ (ไม่มีการแปลงสกุลเงิน) ราคาล่าสุด 2026-09-04, รุ่นข้อมูลย้อนหลัง 2026-09-05 ราคาหน้าฟาร์ม (ราคาที่เกษตรกรขายได้) คือเงินที่เกษตรกรได้รับเมื่อขายครั้งแรก ก่อนพ่อค้าคนกลาง โรงสี หรือค่าขนส่งจะหักส่วนแบ่ง — ไม่ใช่ดัชนีโลก และไม่ใช่ราคาในซูเปอร์มาร์เก็ต แหล่งผลิตเป็นการอ่านแบบ ประมาณการ ว่าสินค้าแต่ละชนิดผลิตที่ไหน และทับซ้อนกันได้ น้ำตาลเป็นราคาอ้อยประกาศของ สอน. ปีละหนึ่งจุด จึงไม่มีการเปลี่ยนแปลงหกเดือนให้แสดง</a:t>
             </a:r>
           </a:p>
         </p:txBody>

</xml_diff>

<commit_message>
deck(mcom): rebuild — the data moved past the committed figures (run 34082508439) (#853)
Co-authored-by: github-actions[bot] <41898282+github-actions[bot]@users.noreply.github.com>
</commit_message>
<xml_diff>
--- a/docs/decks/mcom-2026-08-05-macro-TH.pptx
+++ b/docs/decks/mcom-2026-08-05-macro-TH.pptx
@@ -6240,7 +6240,7 @@
                 </a:solidFill>
                 <a:latin typeface="Kanit"/>
               </a:rPr>
-              <a:t>124</a:t>
+              <a:t>123</a:t>
             </a:r>
           </a:p>
         </p:txBody>
@@ -6279,7 +6279,7 @@
                 </a:solidFill>
                 <a:latin typeface="Kanit"/>
               </a:rPr>
-              <a:t>จาก 792 (15.7%) · เรียลไทม์ · 2026-09-07</a:t>
+              <a:t>จาก 792 (15.5%) · เรียลไทม์ · 2026-09-07</a:t>
             </a:r>
           </a:p>
         </p:txBody>
@@ -7951,7 +7951,7 @@
                           </a:solidFill>
                           <a:latin typeface="Kanit"/>
                         </a:rPr>
-                        <a:t>26.3%</a:t>
+                        <a:t>28.9%</a:t>
                       </a:r>
                     </a:p>
                   </a:txBody>
@@ -7974,7 +7974,7 @@
                           </a:solidFill>
                           <a:latin typeface="Kanit"/>
                         </a:rPr>
-                        <a:t>6/13</a:t>
+                        <a:t>7/13</a:t>
                       </a:r>
                     </a:p>
                   </a:txBody>
@@ -8068,7 +8068,7 @@
                           </a:solidFill>
                           <a:latin typeface="Kanit"/>
                         </a:rPr>
-                        <a:t>13</a:t>
+                        <a:t>15</a:t>
                       </a:r>
                     </a:p>
                   </a:txBody>
@@ -8231,7 +8231,7 @@
                           </a:solidFill>
                           <a:latin typeface="Kanit"/>
                         </a:rPr>
-                        <a:t>54.5%</a:t>
+                        <a:t>45.5%</a:t>
                       </a:r>
                     </a:p>
                   </a:txBody>
@@ -8325,7 +8325,7 @@
                           </a:solidFill>
                           <a:latin typeface="Kanit"/>
                         </a:rPr>
-                        <a:t>26</a:t>
+                        <a:t>25</a:t>
                       </a:r>
                     </a:p>
                   </a:txBody>
@@ -8371,7 +8371,7 @@
                           </a:solidFill>
                           <a:latin typeface="Kanit"/>
                         </a:rPr>
-                        <a:t>42.3%</a:t>
+                        <a:t>44.0%</a:t>
                       </a:r>
                     </a:p>
                   </a:txBody>
@@ -8674,7 +8674,7 @@
                           </a:solidFill>
                           <a:latin typeface="Kanit"/>
                         </a:rPr>
-                        <a:t>8/22</a:t>
+                        <a:t>7/22</a:t>
                       </a:r>
                     </a:p>
                   </a:txBody>
@@ -31476,7 +31476,7 @@
                 </a:solidFill>
                 <a:latin typeface="Kanit"/>
               </a:rPr>
-              <a:t>รายได้จากพืชค่ากลางเพิ่มขึ้น +16.4% แต่มีสี่จังหวัดที่ลดลง — ทั้งหมดอยู่ในแหล่งปลูกมะพร้าว โดยหนักที่สุดคือสมุทรสงครามที่ −63.5%</a:t>
+              <a:t>รายได้จากพืชค่ากลางเพิ่มขึ้น +16.3% แต่มีสี่จังหวัดที่ลดลง — ทั้งหมดอยู่ในแหล่งปลูกมะพร้าว โดยหนักที่สุดคือสมุทรสงครามที่ −63.8%</a:t>
             </a:r>
           </a:p>
         </p:txBody>
@@ -32047,7 +32047,7 @@
                 </a:solidFill>
                 <a:latin typeface="Kanit"/>
               </a:rPr>
-              <a:t>รุ่นข้อมูล — ราคาโลก 2026M06 · ราคาหน้าฟาร์มไทย 2026-09-03 · ประวัติราคาไทย 2026-09-05 · ต้นทุนการผลิตพืช สศก. ไจอัป 2568 (ปีเพาะปลูก 2568/69, ประมาณการ สศก. มี.ค. 2569) · ภัยแล้ง 2026-06-21 · เงินเฟ้อ 2026-05 · GDP 2026 ไตรมาส 1 · IMF WEO 2026 · ดัชนีราคาขายต่อ 2026-05 · ยอดจดทะเบียนถึง 2026-01 · หนี้ครัวเรือน สสช. SES 2566 · ค่าจ้าง สสช. LFS 2568 · ข้อมูลตรวจวัด 2026-09-07</a:t>
+              <a:t>รุ่นข้อมูล — ราคาโลก 2026M06 · ราคาหน้าฟาร์มไทย 2026-09-04 · ประวัติราคาไทย 2026-09-05 · ต้นทุนการผลิตพืช สศก. ไจอัป 2568 (ปีเพาะปลูก 2568/69, ประมาณการ สศก. มี.ค. 2569) · ภัยแล้ง 2026-06-21 · เงินเฟ้อ 2026-05 · GDP 2026 ไตรมาส 1 · IMF WEO 2026 · ดัชนีราคาขายต่อ 2026-05 · ยอดจดทะเบียนถึง 2026-01 · หนี้ครัวเรือน สสช. SES 2566 · ค่าจ้าง สสช. LFS 2568 · ข้อมูลตรวจวัด 2026-09-07</a:t>
             </a:r>
           </a:p>
         </p:txBody>
@@ -32546,7 +32546,7 @@
               <a:t>Not on the world index — the farm gate (ราคาที่เกษตรกรขายได้) says otherwise.
 • Five of seventeen Thai farm-gate prices are falling year on year.
 • Beef: farm gate −6.1% vs world index +8.8%.
-• Margin over price: a 26% price move becomes an 85% swing in crop income.</a:t>
+• Margin over price: a 26% price move becomes an 87% swing in crop income.</a:t>
             </a:r>
           </a:p>
         </p:txBody>
@@ -37087,7 +37087,7 @@
                 </a:solidFill>
                 <a:latin typeface="Kanit"/>
               </a:rPr>
-              <a:t>338 จาก 928 อำเภอ · แม่น้ำเกินระดับ 124 จาก 792 สถานี</a:t>
+              <a:t>338 จาก 928 อำเภอ · แม่น้ำเกินระดับ 123 จาก 792 สถานี</a:t>
             </a:r>
           </a:p>
         </p:txBody>
@@ -37859,7 +37859,7 @@
                           </a:solidFill>
                           <a:latin typeface="Kanit"/>
                         </a:rPr>
-                        <a:t>30/157</a:t>
+                        <a:t>29/157</a:t>
                       </a:r>
                     </a:p>
                   </a:txBody>
@@ -38091,7 +38091,7 @@
                           </a:solidFill>
                           <a:latin typeface="Kanit"/>
                         </a:rPr>
-                        <a:t>16/274</a:t>
+                        <a:t>18/274</a:t>
                       </a:r>
                     </a:p>
                   </a:txBody>
@@ -38323,7 +38323,7 @@
                           </a:solidFill>
                           <a:latin typeface="Kanit"/>
                         </a:rPr>
-                        <a:t>26/167</a:t>
+                        <a:t>25/167</a:t>
                       </a:r>
                     </a:p>
                   </a:txBody>
@@ -38555,7 +38555,7 @@
                           </a:solidFill>
                           <a:latin typeface="Kanit"/>
                         </a:rPr>
-                        <a:t>13/51</a:t>
+                        <a:t>14/51</a:t>
                       </a:r>
                     </a:p>
                   </a:txBody>
@@ -38787,7 +38787,7 @@
                           </a:solidFill>
                           <a:latin typeface="Kanit"/>
                         </a:rPr>
-                        <a:t>39/143</a:t>
+                        <a:t>37/143</a:t>
                       </a:r>
                     </a:p>
                   </a:txBody>
@@ -39936,7 +39936,7 @@
                           </a:solidFill>
                           <a:latin typeface="Kanit"/>
                         </a:rPr>
-                        <a:t>−67.9%</a:t>
+                        <a:t>−68.2%</a:t>
                       </a:r>
                     </a:p>
                   </a:txBody>
@@ -40791,7 +40791,7 @@
                 </a:solidFill>
                 <a:latin typeface="Kanit"/>
               </a:rPr>
-              <a:t>ราคา วัดจริง — ราคาหน้าฟาร์มไทยจากราคารายวันของ NABC และราคาอ้อยประกาศของ สอน. ราคาล่าสุด 2026-09-03 การเปลี่ยนแปลงหกเดือนคำนวณจากข้อมูลรายเดือนของ NABC เอง (thai_price_history รุ่นข้อมูล 2026-09-05) พืชที่ไม่มีข้อมูลรายเดือนจะกำกับไว้ ไม่ประมาณการขึ้นมา แหล่งผลิตเป็นการอ่านแบบ ประมาณการ ว่าสินค้าแต่ละชนิดปลูกที่ไหน และแหล่งผลิตทับซ้อนกันได้ บัญชีอาชีพเกษตรเป็นข้อมูลของเราเองและ วัดจริง — บัญชีที่บันทึกอาชีพว่า เกษตร ในจังหวัดแหล่งผลิต จากฐานข้อมูล 382,735 บัญชี ณ 2026-07 ไม่เผยแพร่ช่องที่มีน้อยกว่า 30 บัญชี คนกลุ่มนี้อาศัยอยู่ในพื้นที่ที่ปลูกพืชนั้น แต่ไม่ได้ยืนยันว่าปลูกพืชนั้นเอง</a:t>
+              <a:t>ราคา วัดจริง — ราคาหน้าฟาร์มไทยจากราคารายวันของ NABC และราคาอ้อยประกาศของ สอน. ราคาล่าสุด 2026-09-04 การเปลี่ยนแปลงหกเดือนคำนวณจากข้อมูลรายเดือนของ NABC เอง (thai_price_history รุ่นข้อมูล 2026-09-05) พืชที่ไม่มีข้อมูลรายเดือนจะกำกับไว้ ไม่ประมาณการขึ้นมา แหล่งผลิตเป็นการอ่านแบบ ประมาณการ ว่าสินค้าแต่ละชนิดปลูกที่ไหน และแหล่งผลิตทับซ้อนกันได้ บัญชีอาชีพเกษตรเป็นข้อมูลของเราเองและ วัดจริง — บัญชีที่บันทึกอาชีพว่า เกษตร ในจังหวัดแหล่งผลิต จากฐานข้อมูล 382,735 บัญชี ณ 2026-07 ไม่เผยแพร่ช่องที่มีน้อยกว่า 30 บัญชี คนกลุ่มนี้อาศัยอยู่ในพื้นที่ที่ปลูกพืชนั้น แต่ไม่ได้ยืนยันว่าปลูกพืชนั้นเอง</a:t>
             </a:r>
           </a:p>
         </p:txBody>
@@ -44679,7 +44679,7 @@
                 </a:solidFill>
                 <a:latin typeface="Kanit"/>
               </a:rPr>
-              <a:t>มะพร้าว −67.9% สับปะรด −18.4% อ้อย −17.9% เทียบปีก่อน</a:t>
+              <a:t>มะพร้าว −68.2% สับปะรด −18.4% อ้อย −17.9% เทียบปีก่อน</a:t>
             </a:r>
           </a:p>
         </p:txBody>
@@ -44805,7 +44805,7 @@
                 </a:solidFill>
                 <a:latin typeface="Kanit"/>
               </a:rPr>
-              <a:t>+16.4%</a:t>
+              <a:t>+16.3%</a:t>
             </a:r>
           </a:p>
         </p:txBody>
@@ -45348,7 +45348,7 @@
                           </a:solidFill>
                           <a:latin typeface="Kanit"/>
                         </a:rPr>
-                        <a:t>-63.5%</a:t>
+                        <a:t>-63.8%</a:t>
                       </a:r>
                     </a:p>
                   </a:txBody>
@@ -45419,7 +45419,7 @@
                           </a:solidFill>
                           <a:latin typeface="Kanit"/>
                         </a:rPr>
-                        <a:t>+15.4%</a:t>
+                        <a:t>+15.3%</a:t>
                       </a:r>
                     </a:p>
                   </a:txBody>
@@ -47039,7 +47039,7 @@
                           </a:solidFill>
                           <a:latin typeface="Kanit"/>
                         </a:rPr>
-                        <a:t>+16.7%</a:t>
+                        <a:t>+16.6%</a:t>
                       </a:r>
                     </a:p>
                   </a:txBody>
@@ -48024,7 +48024,7 @@
                 </a:solidFill>
                 <a:latin typeface="Kanit"/>
               </a:rPr>
-              <a:t>เทียบปีก่อน −67.9%</a:t>
+              <a:t>เทียบปีก่อน −68.2%</a:t>
             </a:r>
           </a:p>
         </p:txBody>
@@ -48660,7 +48660,7 @@
                 </a:solidFill>
                 <a:latin typeface="Kanit"/>
               </a:rPr>
-              <a:t>เทียบปีก่อน +1.0%</a:t>
+              <a:t>เทียบปีก่อน +0.9%</a:t>
             </a:r>
           </a:p>
         </p:txBody>
@@ -48978,7 +48978,7 @@
                 </a:solidFill>
                 <a:latin typeface="Kanit"/>
               </a:rPr>
-              <a:t>เทียบปีก่อน +4.5%</a:t>
+              <a:t>เทียบปีก่อน +4.6%</a:t>
             </a:r>
           </a:p>
         </p:txBody>
@@ -49296,7 +49296,7 @@
                 </a:solidFill>
                 <a:latin typeface="Kanit"/>
               </a:rPr>
-              <a:t>เทียบปีก่อน +5.6%</a:t>
+              <a:t>เทียบปีก่อน +5.9%</a:t>
             </a:r>
           </a:p>
         </p:txBody>
@@ -49932,7 +49932,7 @@
                 </a:solidFill>
                 <a:latin typeface="Kanit"/>
               </a:rPr>
-              <a:t>เทียบปีก่อน +15.5%</a:t>
+              <a:t>เทียบปีก่อน +15.1%</a:t>
             </a:r>
           </a:p>
         </p:txBody>
@@ -50250,7 +50250,7 @@
                 </a:solidFill>
                 <a:latin typeface="Kanit"/>
               </a:rPr>
-              <a:t>เทียบปีก่อน +18.0%</a:t>
+              <a:t>เทียบปีก่อน +19.5%</a:t>
             </a:r>
           </a:p>
         </p:txBody>
@@ -51522,7 +51522,7 @@
                 </a:solidFill>
                 <a:latin typeface="Kanit"/>
               </a:rPr>
-              <a:t>เทียบปีก่อน +134.7%</a:t>
+              <a:t>เทียบปีก่อน +161.6%</a:t>
             </a:r>
           </a:p>
         </p:txBody>
@@ -51886,7 +51886,7 @@
                 </a:solidFill>
                 <a:latin typeface="Kanit"/>
               </a:rPr>
-              <a:t>ราคาหน้าฟาร์ม วัดจริง — ราคารายวันของ NABC เฉลี่ยเป็นรายเดือน หน่วยเป็นบาทตามที่เผยแพร่ (ไม่มีการแปลงสกุลเงิน) ราคาล่าสุด 2026-09-03, รุ่นข้อมูลย้อนหลัง 2026-09-05 ราคาหน้าฟาร์ม (ราคาที่เกษตรกรขายได้) คือเงินที่เกษตรกรได้รับเมื่อขายครั้งแรก ก่อนพ่อค้าคนกลาง โรงสี หรือค่าขนส่งจะหักส่วนแบ่ง — ไม่ใช่ดัชนีโลก และไม่ใช่ราคาในซูเปอร์มาร์เก็ต แหล่งผลิตเป็นการอ่านแบบ ประมาณการ ว่าสินค้าแต่ละชนิดผลิตที่ไหน และทับซ้อนกันได้ น้ำตาลเป็นราคาอ้อยประกาศของ สอน. ปีละหนึ่งจุด จึงไม่มีการเปลี่ยนแปลงหกเดือนให้แสดง</a:t>
+              <a:t>ราคาหน้าฟาร์ม วัดจริง — ราคารายวันของ NABC เฉลี่ยเป็นรายเดือน หน่วยเป็นบาทตามที่เผยแพร่ (ไม่มีการแปลงสกุลเงิน) ราคาล่าสุด 2026-09-04, รุ่นข้อมูลย้อนหลัง 2026-09-05 ราคาหน้าฟาร์ม (ราคาที่เกษตรกรขายได้) คือเงินที่เกษตรกรได้รับเมื่อขายครั้งแรก ก่อนพ่อค้าคนกลาง โรงสี หรือค่าขนส่งจะหักส่วนแบ่ง — ไม่ใช่ดัชนีโลก และไม่ใช่ราคาในซูเปอร์มาร์เก็ต แหล่งผลิตเป็นการอ่านแบบ ประมาณการ ว่าสินค้าแต่ละชนิดผลิตที่ไหน และทับซ้อนกันได้ น้ำตาลเป็นราคาอ้อยประกาศของ สอน. ปีละหนึ่งจุด จึงไม่มีการเปลี่ยนแปลงหกเดือนให้แสดง</a:t>
             </a:r>
           </a:p>
         </p:txBody>

</xml_diff>

<commit_message>
deck(mcom): rebuild — the data moved past the committed figures (run 34091626473)
</commit_message>
<xml_diff>
--- a/docs/decks/mcom-2026-08-05-macro-TH.pptx
+++ b/docs/decks/mcom-2026-08-05-macro-TH.pptx
@@ -6240,7 +6240,7 @@
                 </a:solidFill>
                 <a:latin typeface="Kanit"/>
               </a:rPr>
-              <a:t>123</a:t>
+              <a:t>125</a:t>
             </a:r>
           </a:p>
         </p:txBody>
@@ -6279,7 +6279,7 @@
                 </a:solidFill>
                 <a:latin typeface="Kanit"/>
               </a:rPr>
-              <a:t>จาก 792 (15.5%) · เรียลไทม์ · 2026-09-07</a:t>
+              <a:t>จาก 792 (15.8%) · เรียลไทม์ · 2026-09-07</a:t>
             </a:r>
           </a:p>
         </p:txBody>
@@ -37087,7 +37087,7 @@
                 </a:solidFill>
                 <a:latin typeface="Kanit"/>
               </a:rPr>
-              <a:t>338 จาก 928 อำเภอ · แม่น้ำเกินระดับ 123 จาก 792 สถานี</a:t>
+              <a:t>338 จาก 928 อำเภอ · แม่น้ำเกินระดับ 125 จาก 792 สถานี</a:t>
             </a:r>
           </a:p>
         </p:txBody>
@@ -38787,7 +38787,7 @@
                           </a:solidFill>
                           <a:latin typeface="Kanit"/>
                         </a:rPr>
-                        <a:t>37/143</a:t>
+                        <a:t>39/143</a:t>
                       </a:r>
                     </a:p>
                   </a:txBody>

</xml_diff>

<commit_message>
deck(mcom): rebuild — the data moved past the committed figures (run 34091626473) (#854)
Co-authored-by: github-actions[bot] <41898282+github-actions[bot]@users.noreply.github.com>
</commit_message>
<xml_diff>
--- a/docs/decks/mcom-2026-08-05-macro-TH.pptx
+++ b/docs/decks/mcom-2026-08-05-macro-TH.pptx
@@ -6240,7 +6240,7 @@
                 </a:solidFill>
                 <a:latin typeface="Kanit"/>
               </a:rPr>
-              <a:t>123</a:t>
+              <a:t>125</a:t>
             </a:r>
           </a:p>
         </p:txBody>
@@ -6279,7 +6279,7 @@
                 </a:solidFill>
                 <a:latin typeface="Kanit"/>
               </a:rPr>
-              <a:t>จาก 792 (15.5%) · เรียลไทม์ · 2026-09-07</a:t>
+              <a:t>จาก 792 (15.8%) · เรียลไทม์ · 2026-09-07</a:t>
             </a:r>
           </a:p>
         </p:txBody>
@@ -37087,7 +37087,7 @@
                 </a:solidFill>
                 <a:latin typeface="Kanit"/>
               </a:rPr>
-              <a:t>338 จาก 928 อำเภอ · แม่น้ำเกินระดับ 123 จาก 792 สถานี</a:t>
+              <a:t>338 จาก 928 อำเภอ · แม่น้ำเกินระดับ 125 จาก 792 สถานี</a:t>
             </a:r>
           </a:p>
         </p:txBody>
@@ -38787,7 +38787,7 @@
                           </a:solidFill>
                           <a:latin typeface="Kanit"/>
                         </a:rPr>
-                        <a:t>37/143</a:t>
+                        <a:t>39/143</a:t>
                       </a:r>
                     </a:p>
                   </a:txBody>

</xml_diff>

<commit_message>
deck(mcom): rebuild — the data moved past the committed figures (run 34168480058)
</commit_message>
<xml_diff>
--- a/docs/decks/mcom-2026-08-05-macro-TH.pptx
+++ b/docs/decks/mcom-2026-08-05-macro-TH.pptx
@@ -6240,7 +6240,7 @@
                 </a:solidFill>
                 <a:latin typeface="Kanit"/>
               </a:rPr>
-              <a:t>125</a:t>
+              <a:t>129</a:t>
             </a:r>
           </a:p>
         </p:txBody>
@@ -6279,7 +6279,7 @@
                 </a:solidFill>
                 <a:latin typeface="Kanit"/>
               </a:rPr>
-              <a:t>จาก 792 (15.8%) · เรียลไทม์ · 2026-09-07</a:t>
+              <a:t>จาก 790 (16.3%) · เรียลไทม์ · 2026-09-08</a:t>
             </a:r>
           </a:p>
         </p:txBody>
@@ -6405,7 +6405,7 @@
                 </a:solidFill>
                 <a:latin typeface="Kanit"/>
               </a:rPr>
-              <a:t>45</a:t>
+              <a:t>32</a:t>
             </a:r>
           </a:p>
         </p:txBody>
@@ -6444,7 +6444,7 @@
                 </a:solidFill>
                 <a:latin typeface="Kanit"/>
               </a:rPr>
-              <a:t>ค่าล่าสุดรายวัน · 2026-09-07</a:t>
+              <a:t>ค่าล่าสุดรายวัน · 2026-09-08</a:t>
             </a:r>
           </a:p>
         </p:txBody>
@@ -7928,7 +7928,7 @@
                           </a:solidFill>
                           <a:latin typeface="Kanit"/>
                         </a:rPr>
-                        <a:t>76</a:t>
+                        <a:t>33</a:t>
                       </a:r>
                     </a:p>
                   </a:txBody>
@@ -7947,11 +7947,11 @@
                       <a:r>
                         <a:rPr sz="900" b="1">
                           <a:solidFill>
-                            <a:srgbClr val="F5C242"/>
-                          </a:solidFill>
-                          <a:latin typeface="Kanit"/>
-                        </a:rPr>
-                        <a:t>28.9%</a:t>
+                            <a:srgbClr val="606060"/>
+                          </a:solidFill>
+                          <a:latin typeface="Kanit"/>
+                        </a:rPr>
+                        <a:t>0.0%</a:t>
                       </a:r>
                     </a:p>
                   </a:txBody>
@@ -7974,7 +7974,7 @@
                           </a:solidFill>
                           <a:latin typeface="Kanit"/>
                         </a:rPr>
-                        <a:t>7/13</a:t>
+                        <a:t>7/12</a:t>
                       </a:r>
                     </a:p>
                   </a:txBody>
@@ -8068,7 +8068,7 @@
                           </a:solidFill>
                           <a:latin typeface="Kanit"/>
                         </a:rPr>
-                        <a:t>15</a:t>
+                        <a:t>19</a:t>
                       </a:r>
                     </a:p>
                   </a:txBody>
@@ -8162,7 +8162,7 @@
                           </a:solidFill>
                           <a:latin typeface="Kanit"/>
                         </a:rPr>
-                        <a:t>บึงกาฬ</a:t>
+                        <a:t>ยโสธร</a:t>
                       </a:r>
                     </a:p>
                   </a:txBody>
@@ -8185,7 +8185,7 @@
                           </a:solidFill>
                           <a:latin typeface="Kanit"/>
                         </a:rPr>
-                        <a:t>11</a:t>
+                        <a:t>14</a:t>
                       </a:r>
                     </a:p>
                   </a:txBody>
@@ -8208,7 +8208,7 @@
                           </a:solidFill>
                           <a:latin typeface="Kanit"/>
                         </a:rPr>
-                        <a:t>162</a:t>
+                        <a:t>88</a:t>
                       </a:r>
                     </a:p>
                   </a:txBody>
@@ -8231,7 +8231,7 @@
                           </a:solidFill>
                           <a:latin typeface="Kanit"/>
                         </a:rPr>
-                        <a:t>45.5%</a:t>
+                        <a:t>21.4%</a:t>
                       </a:r>
                     </a:p>
                   </a:txBody>
@@ -8254,7 +8254,7 @@
                           </a:solidFill>
                           <a:latin typeface="Kanit"/>
                         </a:rPr>
-                        <a:t>1/1</a:t>
+                        <a:t>3/5</a:t>
                       </a:r>
                     </a:p>
                   </a:txBody>
@@ -8302,7 +8302,7 @@
                           </a:solidFill>
                           <a:latin typeface="Kanit"/>
                         </a:rPr>
-                        <a:t>นครนายก</a:t>
+                        <a:t>ลำพูน</a:t>
                       </a:r>
                     </a:p>
                   </a:txBody>
@@ -8325,7 +8325,7 @@
                           </a:solidFill>
                           <a:latin typeface="Kanit"/>
                         </a:rPr>
-                        <a:t>25</a:t>
+                        <a:t>76</a:t>
                       </a:r>
                     </a:p>
                   </a:txBody>
@@ -8348,7 +8348,7 @@
                           </a:solidFill>
                           <a:latin typeface="Kanit"/>
                         </a:rPr>
-                        <a:t>69</a:t>
+                        <a:t>70</a:t>
                       </a:r>
                     </a:p>
                   </a:txBody>
@@ -8371,7 +8371,7 @@
                           </a:solidFill>
                           <a:latin typeface="Kanit"/>
                         </a:rPr>
-                        <a:t>44.0%</a:t>
+                        <a:t>10.5%</a:t>
                       </a:r>
                     </a:p>
                   </a:txBody>
@@ -8394,7 +8394,7 @@
                           </a:solidFill>
                           <a:latin typeface="Kanit"/>
                         </a:rPr>
-                        <a:t>2/6</a:t>
+                        <a:t>1/11</a:t>
                       </a:r>
                     </a:p>
                   </a:txBody>
@@ -8442,7 +8442,7 @@
                           </a:solidFill>
                           <a:latin typeface="Kanit"/>
                         </a:rPr>
-                        <a:t>นนทบุรี</a:t>
+                        <a:t>บึงกาฬ</a:t>
                       </a:r>
                     </a:p>
                   </a:txBody>
@@ -8465,7 +8465,7 @@
                           </a:solidFill>
                           <a:latin typeface="Kanit"/>
                         </a:rPr>
-                        <a:t>3</a:t>
+                        <a:t>11</a:t>
                       </a:r>
                     </a:p>
                   </a:txBody>
@@ -8488,7 +8488,7 @@
                           </a:solidFill>
                           <a:latin typeface="Kanit"/>
                         </a:rPr>
-                        <a:t>71</a:t>
+                        <a:t>56</a:t>
                       </a:r>
                     </a:p>
                   </a:txBody>
@@ -8511,7 +8511,7 @@
                           </a:solidFill>
                           <a:latin typeface="Kanit"/>
                         </a:rPr>
-                        <a:t>33.3%</a:t>
+                        <a:t>9.1%</a:t>
                       </a:r>
                     </a:p>
                   </a:txBody>
@@ -8534,7 +8534,7 @@
                           </a:solidFill>
                           <a:latin typeface="Kanit"/>
                         </a:rPr>
-                        <a:t>1/2</a:t>
+                        <a:t>1/1</a:t>
                       </a:r>
                     </a:p>
                   </a:txBody>
@@ -8582,7 +8582,7 @@
                           </a:solidFill>
                           <a:latin typeface="Kanit"/>
                         </a:rPr>
-                        <a:t>พระนครศรีอยุธยา</a:t>
+                        <a:t>พะเยา</a:t>
                       </a:r>
                     </a:p>
                   </a:txBody>
@@ -8605,7 +8605,7 @@
                           </a:solidFill>
                           <a:latin typeface="Kanit"/>
                         </a:rPr>
-                        <a:t>30</a:t>
+                        <a:t>125</a:t>
                       </a:r>
                     </a:p>
                   </a:txBody>
@@ -8628,7 +8628,7 @@
                           </a:solidFill>
                           <a:latin typeface="Kanit"/>
                         </a:rPr>
-                        <a:t>71</a:t>
+                        <a:t>96</a:t>
                       </a:r>
                     </a:p>
                   </a:txBody>
@@ -8651,7 +8651,7 @@
                           </a:solidFill>
                           <a:latin typeface="Kanit"/>
                         </a:rPr>
-                        <a:t>30.0%</a:t>
+                        <a:t>8.8%</a:t>
                       </a:r>
                     </a:p>
                   </a:txBody>
@@ -8674,7 +8674,7 @@
                           </a:solidFill>
                           <a:latin typeface="Kanit"/>
                         </a:rPr>
-                        <a:t>7/22</a:t>
+                        <a:t>3/13</a:t>
                       </a:r>
                     </a:p>
                   </a:txBody>
@@ -8909,7 +8909,7 @@
                 </a:solidFill>
                 <a:latin typeface="Kanit"/>
               </a:rPr>
-              <a:t>พื้นที่ปลูก วัดจริง (สศก. — ข้อมูลอำเภอ×พืช 3,295 แถว) ภัยแล้งเป็นดัชนี SPEI จาก แบบจำลอง คำนวณจากปริมาณฝนและการคายระเหย ปรับเดือนละครั้ง ดึงข้อมูล 2026-07-20 — เป็นสัญญาณที่ครอบคลุมทั้งประเทศดีที่สุดที่มี แต่ไม่มีใครลงพื้นที่ไปเดินดูอำเภอเหล่านั้น ข้อมูลฝนและระดับน้ำ วัดจริง (ThaiWater เรียลไทม์ ดึงทุกวันและสะสมไว้ — วันที่ดึงไม่สำเร็จจะเว้นเป็นช่องว่าง ไม่ใส่ค่าสมมติ) · ฝนถึง 2026-09-07, ระดับน้ำถึง 2026-09-07 ความเสี่ยงน้ำท่วมเชิงโครงสร้าง วัดจริง (สำมะโนพื้นที่ท่วมซ้ำซาก GISTDA มาตราส่วน 1:50,000 ปี 2005-2016 — เป็นบันทึกภาคพื้นดิน 12 ปี ไม่ใช่การพยากรณ์)</a:t>
+              <a:t>พื้นที่ปลูก วัดจริง (สศก. — ข้อมูลอำเภอ×พืช 3,295 แถว) ภัยแล้งเป็นดัชนี SPEI จาก แบบจำลอง คำนวณจากปริมาณฝนและการคายระเหย ปรับเดือนละครั้ง ดึงข้อมูล 2026-07-20 — เป็นสัญญาณที่ครอบคลุมทั้งประเทศดีที่สุดที่มี แต่ไม่มีใครลงพื้นที่ไปเดินดูอำเภอเหล่านั้น ข้อมูลฝนและระดับน้ำ วัดจริง (ThaiWater เรียลไทม์ ดึงทุกวันและสะสมไว้ — วันที่ดึงไม่สำเร็จจะเว้นเป็นช่องว่าง ไม่ใส่ค่าสมมติ) · ฝนถึง 2026-09-08, ระดับน้ำถึง 2026-09-08 ความเสี่ยงน้ำท่วมเชิงโครงสร้าง วัดจริง (สำมะโนพื้นที่ท่วมซ้ำซาก GISTDA มาตราส่วน 1:50,000 ปี 2005-2016 — เป็นบันทึกภาคพื้นดิน 12 ปี ไม่ใช่การพยากรณ์)</a:t>
             </a:r>
           </a:p>
         </p:txBody>
@@ -31476,7 +31476,7 @@
                 </a:solidFill>
                 <a:latin typeface="Kanit"/>
               </a:rPr>
-              <a:t>รายได้จากพืชค่ากลางเพิ่มขึ้น +16.3% แต่มีสี่จังหวัดที่ลดลง — ทั้งหมดอยู่ในแหล่งปลูกมะพร้าว โดยหนักที่สุดคือสมุทรสงครามที่ −63.8%</a:t>
+              <a:t>รายได้จากพืชค่ากลางเพิ่มขึ้น +15.9% แต่มีสี่จังหวัดที่ลดลง — ทั้งหมดอยู่ในแหล่งปลูกมะพร้าว โดยหนักที่สุดคือสมุทรสงครามที่ −64.2%</a:t>
             </a:r>
           </a:p>
         </p:txBody>
@@ -32047,7 +32047,7 @@
                 </a:solidFill>
                 <a:latin typeface="Kanit"/>
               </a:rPr>
-              <a:t>รุ่นข้อมูล — ราคาโลก 2026M06 · ราคาหน้าฟาร์มไทย 2026-09-04 · ประวัติราคาไทย 2026-09-05 · ต้นทุนการผลิตพืช สศก. ไจอัป 2568 (ปีเพาะปลูก 2568/69, ประมาณการ สศก. มี.ค. 2569) · ภัยแล้ง 2026-06-21 · เงินเฟ้อ 2026-05 · GDP 2026 ไตรมาส 1 · IMF WEO 2026 · ดัชนีราคาขายต่อ 2026-05 · ยอดจดทะเบียนถึง 2026-01 · หนี้ครัวเรือน สสช. SES 2566 · ค่าจ้าง สสช. LFS 2568 · ข้อมูลตรวจวัด 2026-09-07</a:t>
+              <a:t>รุ่นข้อมูล — ราคาโลก 2026M06 · ราคาหน้าฟาร์มไทย 2026-09-07 · ประวัติราคาไทย 2026-09-05 · ต้นทุนการผลิตพืช สศก. ไจอัป 2568 (ปีเพาะปลูก 2568/69, ประมาณการ สศก. มี.ค. 2569) · ภัยแล้ง 2026-06-21 · เงินเฟ้อ 2026-05 · GDP 2026 ไตรมาส 1 · IMF WEO 2026 · ดัชนีราคาขายต่อ 2026-05 · ยอดจดทะเบียนถึง 2026-01 · หนี้ครัวเรือน สสช. SES 2566 · ค่าจ้าง สสช. LFS 2568 · ข้อมูลตรวจวัด 2026-09-08</a:t>
             </a:r>
           </a:p>
         </p:txBody>
@@ -32546,7 +32546,7 @@
               <a:t>Not on the world index — the farm gate (ราคาที่เกษตรกรขายได้) says otherwise.
 • Five of seventeen Thai farm-gate prices are falling year on year.
 • Beef: farm gate −6.1% vs world index +8.8%.
-• Margin over price: a 26% price move becomes an 87% swing in crop income.</a:t>
+• Margin over price: a 26% price move becomes an 83% swing in crop income.</a:t>
             </a:r>
           </a:p>
         </p:txBody>
@@ -37087,7 +37087,7 @@
                 </a:solidFill>
                 <a:latin typeface="Kanit"/>
               </a:rPr>
-              <a:t>338 จาก 928 อำเภอ · แม่น้ำเกินระดับ 125 จาก 792 สถานี</a:t>
+              <a:t>338 จาก 928 อำเภอ · แม่น้ำเกินระดับ 129 จาก 790 สถานี</a:t>
             </a:r>
           </a:p>
         </p:txBody>
@@ -37859,7 +37859,7 @@
                           </a:solidFill>
                           <a:latin typeface="Kanit"/>
                         </a:rPr>
-                        <a:t>29/157</a:t>
+                        <a:t>30/155</a:t>
                       </a:r>
                     </a:p>
                   </a:txBody>
@@ -37905,7 +37905,7 @@
                           </a:solidFill>
                           <a:latin typeface="Kanit"/>
                         </a:rPr>
-                        <a:t>0.09</a:t>
+                        <a:t>0.11</a:t>
                       </a:r>
                     </a:p>
                   </a:txBody>
@@ -38137,7 +38137,7 @@
                           </a:solidFill>
                           <a:latin typeface="Kanit"/>
                         </a:rPr>
-                        <a:t>0.14</a:t>
+                        <a:t>0.15</a:t>
                       </a:r>
                     </a:p>
                   </a:txBody>
@@ -38323,7 +38323,7 @@
                           </a:solidFill>
                           <a:latin typeface="Kanit"/>
                         </a:rPr>
-                        <a:t>25/167</a:t>
+                        <a:t>26/167</a:t>
                       </a:r>
                     </a:p>
                   </a:txBody>
@@ -38787,7 +38787,7 @@
                           </a:solidFill>
                           <a:latin typeface="Kanit"/>
                         </a:rPr>
-                        <a:t>39/143</a:t>
+                        <a:t>41/143</a:t>
                       </a:r>
                     </a:p>
                   </a:txBody>
@@ -38833,7 +38833,7 @@
                           </a:solidFill>
                           <a:latin typeface="Kanit"/>
                         </a:rPr>
-                        <a:t>0.26</a:t>
+                        <a:t>0.27</a:t>
                       </a:r>
                     </a:p>
                   </a:txBody>
@@ -39936,7 +39936,7 @@
                           </a:solidFill>
                           <a:latin typeface="Kanit"/>
                         </a:rPr>
-                        <a:t>−68.2%</a:t>
+                        <a:t>−68.6%</a:t>
                       </a:r>
                     </a:p>
                   </a:txBody>
@@ -40791,7 +40791,7 @@
                 </a:solidFill>
                 <a:latin typeface="Kanit"/>
               </a:rPr>
-              <a:t>ราคา วัดจริง — ราคาหน้าฟาร์มไทยจากราคารายวันของ NABC และราคาอ้อยประกาศของ สอน. ราคาล่าสุด 2026-09-04 การเปลี่ยนแปลงหกเดือนคำนวณจากข้อมูลรายเดือนของ NABC เอง (thai_price_history รุ่นข้อมูล 2026-09-05) พืชที่ไม่มีข้อมูลรายเดือนจะกำกับไว้ ไม่ประมาณการขึ้นมา แหล่งผลิตเป็นการอ่านแบบ ประมาณการ ว่าสินค้าแต่ละชนิดปลูกที่ไหน และแหล่งผลิตทับซ้อนกันได้ บัญชีอาชีพเกษตรเป็นข้อมูลของเราเองและ วัดจริง — บัญชีที่บันทึกอาชีพว่า เกษตร ในจังหวัดแหล่งผลิต จากฐานข้อมูล 382,735 บัญชี ณ 2026-07 ไม่เผยแพร่ช่องที่มีน้อยกว่า 30 บัญชี คนกลุ่มนี้อาศัยอยู่ในพื้นที่ที่ปลูกพืชนั้น แต่ไม่ได้ยืนยันว่าปลูกพืชนั้นเอง</a:t>
+              <a:t>ราคา วัดจริง — ราคาหน้าฟาร์มไทยจากราคารายวันของ NABC และราคาอ้อยประกาศของ สอน. ราคาล่าสุด 2026-09-07 การเปลี่ยนแปลงหกเดือนคำนวณจากข้อมูลรายเดือนของ NABC เอง (thai_price_history รุ่นข้อมูล 2026-09-05) พืชที่ไม่มีข้อมูลรายเดือนจะกำกับไว้ ไม่ประมาณการขึ้นมา แหล่งผลิตเป็นการอ่านแบบ ประมาณการ ว่าสินค้าแต่ละชนิดปลูกที่ไหน และแหล่งผลิตทับซ้อนกันได้ บัญชีอาชีพเกษตรเป็นข้อมูลของเราเองและ วัดจริง — บัญชีที่บันทึกอาชีพว่า เกษตร ในจังหวัดแหล่งผลิต จากฐานข้อมูล 382,735 บัญชี ณ 2026-07 ไม่เผยแพร่ช่องที่มีน้อยกว่า 30 บัญชี คนกลุ่มนี้อาศัยอยู่ในพื้นที่ที่ปลูกพืชนั้น แต่ไม่ได้ยืนยันว่าปลูกพืชนั้นเอง</a:t>
             </a:r>
           </a:p>
         </p:txBody>
@@ -44679,7 +44679,7 @@
                 </a:solidFill>
                 <a:latin typeface="Kanit"/>
               </a:rPr>
-              <a:t>มะพร้าว −68.2% สับปะรด −18.4% อ้อย −17.9% เทียบปีก่อน</a:t>
+              <a:t>มะพร้าว −68.6% สับปะรด −18.4% อ้อย −17.9% เทียบปีก่อน</a:t>
             </a:r>
           </a:p>
         </p:txBody>
@@ -44805,7 +44805,7 @@
                 </a:solidFill>
                 <a:latin typeface="Kanit"/>
               </a:rPr>
-              <a:t>+16.3%</a:t>
+              <a:t>+15.9%</a:t>
             </a:r>
           </a:p>
         </p:txBody>
@@ -45279,7 +45279,7 @@
                           </a:solidFill>
                           <a:latin typeface="Kanit"/>
                         </a:rPr>
-                        <a:t>+6.2%</a:t>
+                        <a:t>+6.1%</a:t>
                       </a:r>
                     </a:p>
                   </a:txBody>
@@ -45348,7 +45348,7 @@
                           </a:solidFill>
                           <a:latin typeface="Kanit"/>
                         </a:rPr>
-                        <a:t>-63.8%</a:t>
+                        <a:t>-64.2%</a:t>
                       </a:r>
                     </a:p>
                   </a:txBody>
@@ -45419,7 +45419,7 @@
                           </a:solidFill>
                           <a:latin typeface="Kanit"/>
                         </a:rPr>
-                        <a:t>+15.3%</a:t>
+                        <a:t>+15.1%</a:t>
                       </a:r>
                     </a:p>
                   </a:txBody>
@@ -45488,7 +45488,7 @@
                           </a:solidFill>
                           <a:latin typeface="Kanit"/>
                         </a:rPr>
-                        <a:t>+9.6%</a:t>
+                        <a:t>+9.5%</a:t>
                       </a:r>
                     </a:p>
                   </a:txBody>
@@ -45628,7 +45628,7 @@
                           </a:solidFill>
                           <a:latin typeface="Kanit"/>
                         </a:rPr>
-                        <a:t>+8.3%</a:t>
+                        <a:t>+8.2%</a:t>
                       </a:r>
                     </a:p>
                   </a:txBody>
@@ -46084,8 +46084,8 @@
                 </a:solidFill>
                 <a:latin typeface="Kanit"/>
               </a:rPr>
-              <a:t>•  ราคาหน้าฟาร์ม: ยางพารา +40% มันสำปะหลัง +75% ปาล์ม +23% ข้าว +13% รายได้จากพืชเพิ่มขึ้นทุกภาค
-•  มีสี่จังหวัดที่ลดลง — ทั้งหมดเป็นมะพร้าว และอยู่ฝั่งอ่าวไทยตะวันตก ราคามะพร้าวลดลง 68%
+              <a:t>•  ราคาหน้าฟาร์ม: ยางพารา +40% มันสำปะหลัง +76% ปาล์ม +23% ข้าว +13% รายได้จากพืชเพิ่มขึ้นทุกภาค
+•  มีสี่จังหวัดที่ลดลง — ทั้งหมดเป็นมะพร้าว และอยู่ฝั่งอ่าวไทยตะวันตก ราคามะพร้าวลดลง 69%
 •  กำไรบนกระดาษยังไม่ใช่เงินสด — ตารางถัดไปหักราคาด้วยต้นทุน</a:t>
             </a:r>
           </a:p>
@@ -46713,7 +46713,7 @@
                           </a:solidFill>
                           <a:latin typeface="Kanit"/>
                         </a:rPr>
-                        <a:t>+11.3%</a:t>
+                        <a:t>+11.2%</a:t>
                       </a:r>
                     </a:p>
                   </a:txBody>
@@ -47202,7 +47202,7 @@
                           </a:solidFill>
                           <a:latin typeface="Kanit"/>
                         </a:rPr>
-                        <a:t>+15.1%</a:t>
+                        <a:t>+15.0%</a:t>
                       </a:r>
                     </a:p>
                   </a:txBody>
@@ -48024,7 +48024,7 @@
                 </a:solidFill>
                 <a:latin typeface="Kanit"/>
               </a:rPr>
-              <a:t>เทียบปีก่อน −68.2%</a:t>
+              <a:t>เทียบปีก่อน −68.6%</a:t>
             </a:r>
           </a:p>
         </p:txBody>
@@ -48660,7 +48660,7 @@
                 </a:solidFill>
                 <a:latin typeface="Kanit"/>
               </a:rPr>
-              <a:t>เทียบปีก่อน +0.9%</a:t>
+              <a:t>เทียบปีก่อน +0.6%</a:t>
             </a:r>
           </a:p>
         </p:txBody>
@@ -48978,7 +48978,7 @@
                 </a:solidFill>
                 <a:latin typeface="Kanit"/>
               </a:rPr>
-              <a:t>เทียบปีก่อน +4.6%</a:t>
+              <a:t>เทียบปีก่อน +4.8%</a:t>
             </a:r>
           </a:p>
         </p:txBody>
@@ -49296,7 +49296,7 @@
                 </a:solidFill>
                 <a:latin typeface="Kanit"/>
               </a:rPr>
-              <a:t>เทียบปีก่อน +5.9%</a:t>
+              <a:t>เทียบปีก่อน +6.8%</a:t>
             </a:r>
           </a:p>
         </p:txBody>
@@ -49614,7 +49614,7 @@
                 </a:solidFill>
                 <a:latin typeface="Kanit"/>
               </a:rPr>
-              <a:t>เทียบปีก่อน +13.4%</a:t>
+              <a:t>เทียบปีก่อน +13.3%</a:t>
             </a:r>
           </a:p>
         </p:txBody>
@@ -49932,7 +49932,7 @@
                 </a:solidFill>
                 <a:latin typeface="Kanit"/>
               </a:rPr>
-              <a:t>เทียบปีก่อน +15.1%</a:t>
+              <a:t>เทียบปีก่อน +13.8%</a:t>
             </a:r>
           </a:p>
         </p:txBody>
@@ -50250,7 +50250,7 @@
                 </a:solidFill>
                 <a:latin typeface="Kanit"/>
               </a:rPr>
-              <a:t>เทียบปีก่อน +19.5%</a:t>
+              <a:t>เทียบปีก่อน +21.8%</a:t>
             </a:r>
           </a:p>
         </p:txBody>
@@ -51204,7 +51204,7 @@
                 </a:solidFill>
                 <a:latin typeface="Kanit"/>
               </a:rPr>
-              <a:t>เทียบปีก่อน +74.8%</a:t>
+              <a:t>เทียบปีก่อน +75.9%</a:t>
             </a:r>
           </a:p>
         </p:txBody>
@@ -51522,7 +51522,7 @@
                 </a:solidFill>
                 <a:latin typeface="Kanit"/>
               </a:rPr>
-              <a:t>เทียบปีก่อน +161.6%</a:t>
+              <a:t>เทียบปีก่อน +181.0%</a:t>
             </a:r>
           </a:p>
         </p:txBody>
@@ -51886,7 +51886,7 @@
                 </a:solidFill>
                 <a:latin typeface="Kanit"/>
               </a:rPr>
-              <a:t>ราคาหน้าฟาร์ม วัดจริง — ราคารายวันของ NABC เฉลี่ยเป็นรายเดือน หน่วยเป็นบาทตามที่เผยแพร่ (ไม่มีการแปลงสกุลเงิน) ราคาล่าสุด 2026-09-04, รุ่นข้อมูลย้อนหลัง 2026-09-05 ราคาหน้าฟาร์ม (ราคาที่เกษตรกรขายได้) คือเงินที่เกษตรกรได้รับเมื่อขายครั้งแรก ก่อนพ่อค้าคนกลาง โรงสี หรือค่าขนส่งจะหักส่วนแบ่ง — ไม่ใช่ดัชนีโลก และไม่ใช่ราคาในซูเปอร์มาร์เก็ต แหล่งผลิตเป็นการอ่านแบบ ประมาณการ ว่าสินค้าแต่ละชนิดผลิตที่ไหน และทับซ้อนกันได้ น้ำตาลเป็นราคาอ้อยประกาศของ สอน. ปีละหนึ่งจุด จึงไม่มีการเปลี่ยนแปลงหกเดือนให้แสดง</a:t>
+              <a:t>ราคาหน้าฟาร์ม วัดจริง — ราคารายวันของ NABC เฉลี่ยเป็นรายเดือน หน่วยเป็นบาทตามที่เผยแพร่ (ไม่มีการแปลงสกุลเงิน) ราคาล่าสุด 2026-09-07, รุ่นข้อมูลย้อนหลัง 2026-09-05 ราคาหน้าฟาร์ม (ราคาที่เกษตรกรขายได้) คือเงินที่เกษตรกรได้รับเมื่อขายครั้งแรก ก่อนพ่อค้าคนกลาง โรงสี หรือค่าขนส่งจะหักส่วนแบ่ง — ไม่ใช่ดัชนีโลก และไม่ใช่ราคาในซูเปอร์มาร์เก็ต แหล่งผลิตเป็นการอ่านแบบ ประมาณการ ว่าสินค้าแต่ละชนิดผลิตที่ไหน และทับซ้อนกันได้ น้ำตาลเป็นราคาอ้อยประกาศของ สอน. ปีละหนึ่งจุด จึงไม่มีการเปลี่ยนแปลงหกเดือนให้แสดง</a:t>
             </a:r>
           </a:p>
         </p:txBody>

</xml_diff>

<commit_message>
deck(mcom): rebuild — the data moved past the committed figures (run 34168480058) (#866)
Co-authored-by: github-actions[bot] <41898282+github-actions[bot]@users.noreply.github.com>
</commit_message>
<xml_diff>
--- a/docs/decks/mcom-2026-08-05-macro-TH.pptx
+++ b/docs/decks/mcom-2026-08-05-macro-TH.pptx
@@ -6240,7 +6240,7 @@
                 </a:solidFill>
                 <a:latin typeface="Kanit"/>
               </a:rPr>
-              <a:t>125</a:t>
+              <a:t>129</a:t>
             </a:r>
           </a:p>
         </p:txBody>
@@ -6279,7 +6279,7 @@
                 </a:solidFill>
                 <a:latin typeface="Kanit"/>
               </a:rPr>
-              <a:t>จาก 792 (15.8%) · เรียลไทม์ · 2026-09-07</a:t>
+              <a:t>จาก 790 (16.3%) · เรียลไทม์ · 2026-09-08</a:t>
             </a:r>
           </a:p>
         </p:txBody>
@@ -6405,7 +6405,7 @@
                 </a:solidFill>
                 <a:latin typeface="Kanit"/>
               </a:rPr>
-              <a:t>45</a:t>
+              <a:t>32</a:t>
             </a:r>
           </a:p>
         </p:txBody>
@@ -6444,7 +6444,7 @@
                 </a:solidFill>
                 <a:latin typeface="Kanit"/>
               </a:rPr>
-              <a:t>ค่าล่าสุดรายวัน · 2026-09-07</a:t>
+              <a:t>ค่าล่าสุดรายวัน · 2026-09-08</a:t>
             </a:r>
           </a:p>
         </p:txBody>
@@ -7928,7 +7928,7 @@
                           </a:solidFill>
                           <a:latin typeface="Kanit"/>
                         </a:rPr>
-                        <a:t>76</a:t>
+                        <a:t>33</a:t>
                       </a:r>
                     </a:p>
                   </a:txBody>
@@ -7947,11 +7947,11 @@
                       <a:r>
                         <a:rPr sz="900" b="1">
                           <a:solidFill>
-                            <a:srgbClr val="F5C242"/>
-                          </a:solidFill>
-                          <a:latin typeface="Kanit"/>
-                        </a:rPr>
-                        <a:t>28.9%</a:t>
+                            <a:srgbClr val="606060"/>
+                          </a:solidFill>
+                          <a:latin typeface="Kanit"/>
+                        </a:rPr>
+                        <a:t>0.0%</a:t>
                       </a:r>
                     </a:p>
                   </a:txBody>
@@ -7974,7 +7974,7 @@
                           </a:solidFill>
                           <a:latin typeface="Kanit"/>
                         </a:rPr>
-                        <a:t>7/13</a:t>
+                        <a:t>7/12</a:t>
                       </a:r>
                     </a:p>
                   </a:txBody>
@@ -8068,7 +8068,7 @@
                           </a:solidFill>
                           <a:latin typeface="Kanit"/>
                         </a:rPr>
-                        <a:t>15</a:t>
+                        <a:t>19</a:t>
                       </a:r>
                     </a:p>
                   </a:txBody>
@@ -8162,7 +8162,7 @@
                           </a:solidFill>
                           <a:latin typeface="Kanit"/>
                         </a:rPr>
-                        <a:t>บึงกาฬ</a:t>
+                        <a:t>ยโสธร</a:t>
                       </a:r>
                     </a:p>
                   </a:txBody>
@@ -8185,7 +8185,7 @@
                           </a:solidFill>
                           <a:latin typeface="Kanit"/>
                         </a:rPr>
-                        <a:t>11</a:t>
+                        <a:t>14</a:t>
                       </a:r>
                     </a:p>
                   </a:txBody>
@@ -8208,7 +8208,7 @@
                           </a:solidFill>
                           <a:latin typeface="Kanit"/>
                         </a:rPr>
-                        <a:t>162</a:t>
+                        <a:t>88</a:t>
                       </a:r>
                     </a:p>
                   </a:txBody>
@@ -8231,7 +8231,7 @@
                           </a:solidFill>
                           <a:latin typeface="Kanit"/>
                         </a:rPr>
-                        <a:t>45.5%</a:t>
+                        <a:t>21.4%</a:t>
                       </a:r>
                     </a:p>
                   </a:txBody>
@@ -8254,7 +8254,7 @@
                           </a:solidFill>
                           <a:latin typeface="Kanit"/>
                         </a:rPr>
-                        <a:t>1/1</a:t>
+                        <a:t>3/5</a:t>
                       </a:r>
                     </a:p>
                   </a:txBody>
@@ -8302,7 +8302,7 @@
                           </a:solidFill>
                           <a:latin typeface="Kanit"/>
                         </a:rPr>
-                        <a:t>นครนายก</a:t>
+                        <a:t>ลำพูน</a:t>
                       </a:r>
                     </a:p>
                   </a:txBody>
@@ -8325,7 +8325,7 @@
                           </a:solidFill>
                           <a:latin typeface="Kanit"/>
                         </a:rPr>
-                        <a:t>25</a:t>
+                        <a:t>76</a:t>
                       </a:r>
                     </a:p>
                   </a:txBody>
@@ -8348,7 +8348,7 @@
                           </a:solidFill>
                           <a:latin typeface="Kanit"/>
                         </a:rPr>
-                        <a:t>69</a:t>
+                        <a:t>70</a:t>
                       </a:r>
                     </a:p>
                   </a:txBody>
@@ -8371,7 +8371,7 @@
                           </a:solidFill>
                           <a:latin typeface="Kanit"/>
                         </a:rPr>
-                        <a:t>44.0%</a:t>
+                        <a:t>10.5%</a:t>
                       </a:r>
                     </a:p>
                   </a:txBody>
@@ -8394,7 +8394,7 @@
                           </a:solidFill>
                           <a:latin typeface="Kanit"/>
                         </a:rPr>
-                        <a:t>2/6</a:t>
+                        <a:t>1/11</a:t>
                       </a:r>
                     </a:p>
                   </a:txBody>
@@ -8442,7 +8442,7 @@
                           </a:solidFill>
                           <a:latin typeface="Kanit"/>
                         </a:rPr>
-                        <a:t>นนทบุรี</a:t>
+                        <a:t>บึงกาฬ</a:t>
                       </a:r>
                     </a:p>
                   </a:txBody>
@@ -8465,7 +8465,7 @@
                           </a:solidFill>
                           <a:latin typeface="Kanit"/>
                         </a:rPr>
-                        <a:t>3</a:t>
+                        <a:t>11</a:t>
                       </a:r>
                     </a:p>
                   </a:txBody>
@@ -8488,7 +8488,7 @@
                           </a:solidFill>
                           <a:latin typeface="Kanit"/>
                         </a:rPr>
-                        <a:t>71</a:t>
+                        <a:t>56</a:t>
                       </a:r>
                     </a:p>
                   </a:txBody>
@@ -8511,7 +8511,7 @@
                           </a:solidFill>
                           <a:latin typeface="Kanit"/>
                         </a:rPr>
-                        <a:t>33.3%</a:t>
+                        <a:t>9.1%</a:t>
                       </a:r>
                     </a:p>
                   </a:txBody>
@@ -8534,7 +8534,7 @@
                           </a:solidFill>
                           <a:latin typeface="Kanit"/>
                         </a:rPr>
-                        <a:t>1/2</a:t>
+                        <a:t>1/1</a:t>
                       </a:r>
                     </a:p>
                   </a:txBody>
@@ -8582,7 +8582,7 @@
                           </a:solidFill>
                           <a:latin typeface="Kanit"/>
                         </a:rPr>
-                        <a:t>พระนครศรีอยุธยา</a:t>
+                        <a:t>พะเยา</a:t>
                       </a:r>
                     </a:p>
                   </a:txBody>
@@ -8605,7 +8605,7 @@
                           </a:solidFill>
                           <a:latin typeface="Kanit"/>
                         </a:rPr>
-                        <a:t>30</a:t>
+                        <a:t>125</a:t>
                       </a:r>
                     </a:p>
                   </a:txBody>
@@ -8628,7 +8628,7 @@
                           </a:solidFill>
                           <a:latin typeface="Kanit"/>
                         </a:rPr>
-                        <a:t>71</a:t>
+                        <a:t>96</a:t>
                       </a:r>
                     </a:p>
                   </a:txBody>
@@ -8651,7 +8651,7 @@
                           </a:solidFill>
                           <a:latin typeface="Kanit"/>
                         </a:rPr>
-                        <a:t>30.0%</a:t>
+                        <a:t>8.8%</a:t>
                       </a:r>
                     </a:p>
                   </a:txBody>
@@ -8674,7 +8674,7 @@
                           </a:solidFill>
                           <a:latin typeface="Kanit"/>
                         </a:rPr>
-                        <a:t>7/22</a:t>
+                        <a:t>3/13</a:t>
                       </a:r>
                     </a:p>
                   </a:txBody>
@@ -8909,7 +8909,7 @@
                 </a:solidFill>
                 <a:latin typeface="Kanit"/>
               </a:rPr>
-              <a:t>พื้นที่ปลูก วัดจริง (สศก. — ข้อมูลอำเภอ×พืช 3,295 แถว) ภัยแล้งเป็นดัชนี SPEI จาก แบบจำลอง คำนวณจากปริมาณฝนและการคายระเหย ปรับเดือนละครั้ง ดึงข้อมูล 2026-07-20 — เป็นสัญญาณที่ครอบคลุมทั้งประเทศดีที่สุดที่มี แต่ไม่มีใครลงพื้นที่ไปเดินดูอำเภอเหล่านั้น ข้อมูลฝนและระดับน้ำ วัดจริง (ThaiWater เรียลไทม์ ดึงทุกวันและสะสมไว้ — วันที่ดึงไม่สำเร็จจะเว้นเป็นช่องว่าง ไม่ใส่ค่าสมมติ) · ฝนถึง 2026-09-07, ระดับน้ำถึง 2026-09-07 ความเสี่ยงน้ำท่วมเชิงโครงสร้าง วัดจริง (สำมะโนพื้นที่ท่วมซ้ำซาก GISTDA มาตราส่วน 1:50,000 ปี 2005-2016 — เป็นบันทึกภาคพื้นดิน 12 ปี ไม่ใช่การพยากรณ์)</a:t>
+              <a:t>พื้นที่ปลูก วัดจริง (สศก. — ข้อมูลอำเภอ×พืช 3,295 แถว) ภัยแล้งเป็นดัชนี SPEI จาก แบบจำลอง คำนวณจากปริมาณฝนและการคายระเหย ปรับเดือนละครั้ง ดึงข้อมูล 2026-07-20 — เป็นสัญญาณที่ครอบคลุมทั้งประเทศดีที่สุดที่มี แต่ไม่มีใครลงพื้นที่ไปเดินดูอำเภอเหล่านั้น ข้อมูลฝนและระดับน้ำ วัดจริง (ThaiWater เรียลไทม์ ดึงทุกวันและสะสมไว้ — วันที่ดึงไม่สำเร็จจะเว้นเป็นช่องว่าง ไม่ใส่ค่าสมมติ) · ฝนถึง 2026-09-08, ระดับน้ำถึง 2026-09-08 ความเสี่ยงน้ำท่วมเชิงโครงสร้าง วัดจริง (สำมะโนพื้นที่ท่วมซ้ำซาก GISTDA มาตราส่วน 1:50,000 ปี 2005-2016 — เป็นบันทึกภาคพื้นดิน 12 ปี ไม่ใช่การพยากรณ์)</a:t>
             </a:r>
           </a:p>
         </p:txBody>
@@ -31476,7 +31476,7 @@
                 </a:solidFill>
                 <a:latin typeface="Kanit"/>
               </a:rPr>
-              <a:t>รายได้จากพืชค่ากลางเพิ่มขึ้น +16.3% แต่มีสี่จังหวัดที่ลดลง — ทั้งหมดอยู่ในแหล่งปลูกมะพร้าว โดยหนักที่สุดคือสมุทรสงครามที่ −63.8%</a:t>
+              <a:t>รายได้จากพืชค่ากลางเพิ่มขึ้น +15.9% แต่มีสี่จังหวัดที่ลดลง — ทั้งหมดอยู่ในแหล่งปลูกมะพร้าว โดยหนักที่สุดคือสมุทรสงครามที่ −64.2%</a:t>
             </a:r>
           </a:p>
         </p:txBody>
@@ -32047,7 +32047,7 @@
                 </a:solidFill>
                 <a:latin typeface="Kanit"/>
               </a:rPr>
-              <a:t>รุ่นข้อมูล — ราคาโลก 2026M06 · ราคาหน้าฟาร์มไทย 2026-09-04 · ประวัติราคาไทย 2026-09-05 · ต้นทุนการผลิตพืช สศก. ไจอัป 2568 (ปีเพาะปลูก 2568/69, ประมาณการ สศก. มี.ค. 2569) · ภัยแล้ง 2026-06-21 · เงินเฟ้อ 2026-05 · GDP 2026 ไตรมาส 1 · IMF WEO 2026 · ดัชนีราคาขายต่อ 2026-05 · ยอดจดทะเบียนถึง 2026-01 · หนี้ครัวเรือน สสช. SES 2566 · ค่าจ้าง สสช. LFS 2568 · ข้อมูลตรวจวัด 2026-09-07</a:t>
+              <a:t>รุ่นข้อมูล — ราคาโลก 2026M06 · ราคาหน้าฟาร์มไทย 2026-09-07 · ประวัติราคาไทย 2026-09-05 · ต้นทุนการผลิตพืช สศก. ไจอัป 2568 (ปีเพาะปลูก 2568/69, ประมาณการ สศก. มี.ค. 2569) · ภัยแล้ง 2026-06-21 · เงินเฟ้อ 2026-05 · GDP 2026 ไตรมาส 1 · IMF WEO 2026 · ดัชนีราคาขายต่อ 2026-05 · ยอดจดทะเบียนถึง 2026-01 · หนี้ครัวเรือน สสช. SES 2566 · ค่าจ้าง สสช. LFS 2568 · ข้อมูลตรวจวัด 2026-09-08</a:t>
             </a:r>
           </a:p>
         </p:txBody>
@@ -32546,7 +32546,7 @@
               <a:t>Not on the world index — the farm gate (ราคาที่เกษตรกรขายได้) says otherwise.
 • Five of seventeen Thai farm-gate prices are falling year on year.
 • Beef: farm gate −6.1% vs world index +8.8%.
-• Margin over price: a 26% price move becomes an 87% swing in crop income.</a:t>
+• Margin over price: a 26% price move becomes an 83% swing in crop income.</a:t>
             </a:r>
           </a:p>
         </p:txBody>
@@ -37087,7 +37087,7 @@
                 </a:solidFill>
                 <a:latin typeface="Kanit"/>
               </a:rPr>
-              <a:t>338 จาก 928 อำเภอ · แม่น้ำเกินระดับ 125 จาก 792 สถานี</a:t>
+              <a:t>338 จาก 928 อำเภอ · แม่น้ำเกินระดับ 129 จาก 790 สถานี</a:t>
             </a:r>
           </a:p>
         </p:txBody>
@@ -37859,7 +37859,7 @@
                           </a:solidFill>
                           <a:latin typeface="Kanit"/>
                         </a:rPr>
-                        <a:t>29/157</a:t>
+                        <a:t>30/155</a:t>
                       </a:r>
                     </a:p>
                   </a:txBody>
@@ -37905,7 +37905,7 @@
                           </a:solidFill>
                           <a:latin typeface="Kanit"/>
                         </a:rPr>
-                        <a:t>0.09</a:t>
+                        <a:t>0.11</a:t>
                       </a:r>
                     </a:p>
                   </a:txBody>
@@ -38137,7 +38137,7 @@
                           </a:solidFill>
                           <a:latin typeface="Kanit"/>
                         </a:rPr>
-                        <a:t>0.14</a:t>
+                        <a:t>0.15</a:t>
                       </a:r>
                     </a:p>
                   </a:txBody>
@@ -38323,7 +38323,7 @@
                           </a:solidFill>
                           <a:latin typeface="Kanit"/>
                         </a:rPr>
-                        <a:t>25/167</a:t>
+                        <a:t>26/167</a:t>
                       </a:r>
                     </a:p>
                   </a:txBody>
@@ -38787,7 +38787,7 @@
                           </a:solidFill>
                           <a:latin typeface="Kanit"/>
                         </a:rPr>
-                        <a:t>39/143</a:t>
+                        <a:t>41/143</a:t>
                       </a:r>
                     </a:p>
                   </a:txBody>
@@ -38833,7 +38833,7 @@
                           </a:solidFill>
                           <a:latin typeface="Kanit"/>
                         </a:rPr>
-                        <a:t>0.26</a:t>
+                        <a:t>0.27</a:t>
                       </a:r>
                     </a:p>
                   </a:txBody>
@@ -39936,7 +39936,7 @@
                           </a:solidFill>
                           <a:latin typeface="Kanit"/>
                         </a:rPr>
-                        <a:t>−68.2%</a:t>
+                        <a:t>−68.6%</a:t>
                       </a:r>
                     </a:p>
                   </a:txBody>
@@ -40791,7 +40791,7 @@
                 </a:solidFill>
                 <a:latin typeface="Kanit"/>
               </a:rPr>
-              <a:t>ราคา วัดจริง — ราคาหน้าฟาร์มไทยจากราคารายวันของ NABC และราคาอ้อยประกาศของ สอน. ราคาล่าสุด 2026-09-04 การเปลี่ยนแปลงหกเดือนคำนวณจากข้อมูลรายเดือนของ NABC เอง (thai_price_history รุ่นข้อมูล 2026-09-05) พืชที่ไม่มีข้อมูลรายเดือนจะกำกับไว้ ไม่ประมาณการขึ้นมา แหล่งผลิตเป็นการอ่านแบบ ประมาณการ ว่าสินค้าแต่ละชนิดปลูกที่ไหน และแหล่งผลิตทับซ้อนกันได้ บัญชีอาชีพเกษตรเป็นข้อมูลของเราเองและ วัดจริง — บัญชีที่บันทึกอาชีพว่า เกษตร ในจังหวัดแหล่งผลิต จากฐานข้อมูล 382,735 บัญชี ณ 2026-07 ไม่เผยแพร่ช่องที่มีน้อยกว่า 30 บัญชี คนกลุ่มนี้อาศัยอยู่ในพื้นที่ที่ปลูกพืชนั้น แต่ไม่ได้ยืนยันว่าปลูกพืชนั้นเอง</a:t>
+              <a:t>ราคา วัดจริง — ราคาหน้าฟาร์มไทยจากราคารายวันของ NABC และราคาอ้อยประกาศของ สอน. ราคาล่าสุด 2026-09-07 การเปลี่ยนแปลงหกเดือนคำนวณจากข้อมูลรายเดือนของ NABC เอง (thai_price_history รุ่นข้อมูล 2026-09-05) พืชที่ไม่มีข้อมูลรายเดือนจะกำกับไว้ ไม่ประมาณการขึ้นมา แหล่งผลิตเป็นการอ่านแบบ ประมาณการ ว่าสินค้าแต่ละชนิดปลูกที่ไหน และแหล่งผลิตทับซ้อนกันได้ บัญชีอาชีพเกษตรเป็นข้อมูลของเราเองและ วัดจริง — บัญชีที่บันทึกอาชีพว่า เกษตร ในจังหวัดแหล่งผลิต จากฐานข้อมูล 382,735 บัญชี ณ 2026-07 ไม่เผยแพร่ช่องที่มีน้อยกว่า 30 บัญชี คนกลุ่มนี้อาศัยอยู่ในพื้นที่ที่ปลูกพืชนั้น แต่ไม่ได้ยืนยันว่าปลูกพืชนั้นเอง</a:t>
             </a:r>
           </a:p>
         </p:txBody>
@@ -44679,7 +44679,7 @@
                 </a:solidFill>
                 <a:latin typeface="Kanit"/>
               </a:rPr>
-              <a:t>มะพร้าว −68.2% สับปะรด −18.4% อ้อย −17.9% เทียบปีก่อน</a:t>
+              <a:t>มะพร้าว −68.6% สับปะรด −18.4% อ้อย −17.9% เทียบปีก่อน</a:t>
             </a:r>
           </a:p>
         </p:txBody>
@@ -44805,7 +44805,7 @@
                 </a:solidFill>
                 <a:latin typeface="Kanit"/>
               </a:rPr>
-              <a:t>+16.3%</a:t>
+              <a:t>+15.9%</a:t>
             </a:r>
           </a:p>
         </p:txBody>
@@ -45279,7 +45279,7 @@
                           </a:solidFill>
                           <a:latin typeface="Kanit"/>
                         </a:rPr>
-                        <a:t>+6.2%</a:t>
+                        <a:t>+6.1%</a:t>
                       </a:r>
                     </a:p>
                   </a:txBody>
@@ -45348,7 +45348,7 @@
                           </a:solidFill>
                           <a:latin typeface="Kanit"/>
                         </a:rPr>
-                        <a:t>-63.8%</a:t>
+                        <a:t>-64.2%</a:t>
                       </a:r>
                     </a:p>
                   </a:txBody>
@@ -45419,7 +45419,7 @@
                           </a:solidFill>
                           <a:latin typeface="Kanit"/>
                         </a:rPr>
-                        <a:t>+15.3%</a:t>
+                        <a:t>+15.1%</a:t>
                       </a:r>
                     </a:p>
                   </a:txBody>
@@ -45488,7 +45488,7 @@
                           </a:solidFill>
                           <a:latin typeface="Kanit"/>
                         </a:rPr>
-                        <a:t>+9.6%</a:t>
+                        <a:t>+9.5%</a:t>
                       </a:r>
                     </a:p>
                   </a:txBody>
@@ -45628,7 +45628,7 @@
                           </a:solidFill>
                           <a:latin typeface="Kanit"/>
                         </a:rPr>
-                        <a:t>+8.3%</a:t>
+                        <a:t>+8.2%</a:t>
                       </a:r>
                     </a:p>
                   </a:txBody>
@@ -46084,8 +46084,8 @@
                 </a:solidFill>
                 <a:latin typeface="Kanit"/>
               </a:rPr>
-              <a:t>•  ราคาหน้าฟาร์ม: ยางพารา +40% มันสำปะหลัง +75% ปาล์ม +23% ข้าว +13% รายได้จากพืชเพิ่มขึ้นทุกภาค
-•  มีสี่จังหวัดที่ลดลง — ทั้งหมดเป็นมะพร้าว และอยู่ฝั่งอ่าวไทยตะวันตก ราคามะพร้าวลดลง 68%
+              <a:t>•  ราคาหน้าฟาร์ม: ยางพารา +40% มันสำปะหลัง +76% ปาล์ม +23% ข้าว +13% รายได้จากพืชเพิ่มขึ้นทุกภาค
+•  มีสี่จังหวัดที่ลดลง — ทั้งหมดเป็นมะพร้าว และอยู่ฝั่งอ่าวไทยตะวันตก ราคามะพร้าวลดลง 69%
 •  กำไรบนกระดาษยังไม่ใช่เงินสด — ตารางถัดไปหักราคาด้วยต้นทุน</a:t>
             </a:r>
           </a:p>
@@ -46713,7 +46713,7 @@
                           </a:solidFill>
                           <a:latin typeface="Kanit"/>
                         </a:rPr>
-                        <a:t>+11.3%</a:t>
+                        <a:t>+11.2%</a:t>
                       </a:r>
                     </a:p>
                   </a:txBody>
@@ -47202,7 +47202,7 @@
                           </a:solidFill>
                           <a:latin typeface="Kanit"/>
                         </a:rPr>
-                        <a:t>+15.1%</a:t>
+                        <a:t>+15.0%</a:t>
                       </a:r>
                     </a:p>
                   </a:txBody>
@@ -48024,7 +48024,7 @@
                 </a:solidFill>
                 <a:latin typeface="Kanit"/>
               </a:rPr>
-              <a:t>เทียบปีก่อน −68.2%</a:t>
+              <a:t>เทียบปีก่อน −68.6%</a:t>
             </a:r>
           </a:p>
         </p:txBody>
@@ -48660,7 +48660,7 @@
                 </a:solidFill>
                 <a:latin typeface="Kanit"/>
               </a:rPr>
-              <a:t>เทียบปีก่อน +0.9%</a:t>
+              <a:t>เทียบปีก่อน +0.6%</a:t>
             </a:r>
           </a:p>
         </p:txBody>
@@ -48978,7 +48978,7 @@
                 </a:solidFill>
                 <a:latin typeface="Kanit"/>
               </a:rPr>
-              <a:t>เทียบปีก่อน +4.6%</a:t>
+              <a:t>เทียบปีก่อน +4.8%</a:t>
             </a:r>
           </a:p>
         </p:txBody>
@@ -49296,7 +49296,7 @@
                 </a:solidFill>
                 <a:latin typeface="Kanit"/>
               </a:rPr>
-              <a:t>เทียบปีก่อน +5.9%</a:t>
+              <a:t>เทียบปีก่อน +6.8%</a:t>
             </a:r>
           </a:p>
         </p:txBody>
@@ -49614,7 +49614,7 @@
                 </a:solidFill>
                 <a:latin typeface="Kanit"/>
               </a:rPr>
-              <a:t>เทียบปีก่อน +13.4%</a:t>
+              <a:t>เทียบปีก่อน +13.3%</a:t>
             </a:r>
           </a:p>
         </p:txBody>
@@ -49932,7 +49932,7 @@
                 </a:solidFill>
                 <a:latin typeface="Kanit"/>
               </a:rPr>
-              <a:t>เทียบปีก่อน +15.1%</a:t>
+              <a:t>เทียบปีก่อน +13.8%</a:t>
             </a:r>
           </a:p>
         </p:txBody>
@@ -50250,7 +50250,7 @@
                 </a:solidFill>
                 <a:latin typeface="Kanit"/>
               </a:rPr>
-              <a:t>เทียบปีก่อน +19.5%</a:t>
+              <a:t>เทียบปีก่อน +21.8%</a:t>
             </a:r>
           </a:p>
         </p:txBody>
@@ -51204,7 +51204,7 @@
                 </a:solidFill>
                 <a:latin typeface="Kanit"/>
               </a:rPr>
-              <a:t>เทียบปีก่อน +74.8%</a:t>
+              <a:t>เทียบปีก่อน +75.9%</a:t>
             </a:r>
           </a:p>
         </p:txBody>
@@ -51522,7 +51522,7 @@
                 </a:solidFill>
                 <a:latin typeface="Kanit"/>
               </a:rPr>
-              <a:t>เทียบปีก่อน +161.6%</a:t>
+              <a:t>เทียบปีก่อน +181.0%</a:t>
             </a:r>
           </a:p>
         </p:txBody>
@@ -51886,7 +51886,7 @@
                 </a:solidFill>
                 <a:latin typeface="Kanit"/>
               </a:rPr>
-              <a:t>ราคาหน้าฟาร์ม วัดจริง — ราคารายวันของ NABC เฉลี่ยเป็นรายเดือน หน่วยเป็นบาทตามที่เผยแพร่ (ไม่มีการแปลงสกุลเงิน) ราคาล่าสุด 2026-09-04, รุ่นข้อมูลย้อนหลัง 2026-09-05 ราคาหน้าฟาร์ม (ราคาที่เกษตรกรขายได้) คือเงินที่เกษตรกรได้รับเมื่อขายครั้งแรก ก่อนพ่อค้าคนกลาง โรงสี หรือค่าขนส่งจะหักส่วนแบ่ง — ไม่ใช่ดัชนีโลก และไม่ใช่ราคาในซูเปอร์มาร์เก็ต แหล่งผลิตเป็นการอ่านแบบ ประมาณการ ว่าสินค้าแต่ละชนิดผลิตที่ไหน และทับซ้อนกันได้ น้ำตาลเป็นราคาอ้อยประกาศของ สอน. ปีละหนึ่งจุด จึงไม่มีการเปลี่ยนแปลงหกเดือนให้แสดง</a:t>
+              <a:t>ราคาหน้าฟาร์ม วัดจริง — ราคารายวันของ NABC เฉลี่ยเป็นรายเดือน หน่วยเป็นบาทตามที่เผยแพร่ (ไม่มีการแปลงสกุลเงิน) ราคาล่าสุด 2026-09-07, รุ่นข้อมูลย้อนหลัง 2026-09-05 ราคาหน้าฟาร์ม (ราคาที่เกษตรกรขายได้) คือเงินที่เกษตรกรได้รับเมื่อขายครั้งแรก ก่อนพ่อค้าคนกลาง โรงสี หรือค่าขนส่งจะหักส่วนแบ่ง — ไม่ใช่ดัชนีโลก และไม่ใช่ราคาในซูเปอร์มาร์เก็ต แหล่งผลิตเป็นการอ่านแบบ ประมาณการ ว่าสินค้าแต่ละชนิดผลิตที่ไหน และทับซ้อนกันได้ น้ำตาลเป็นราคาอ้อยประกาศของ สอน. ปีละหนึ่งจุด จึงไม่มีการเปลี่ยนแปลงหกเดือนให้แสดง</a:t>
             </a:r>
           </a:p>
         </p:txBody>

</xml_diff>

<commit_message>
deck(mcom): rebuild — the data moved past the committed figures (run 34339974852)
</commit_message>
<xml_diff>
--- a/docs/decks/mcom-2026-08-05-macro-TH.pptx
+++ b/docs/decks/mcom-2026-08-05-macro-TH.pptx
@@ -6240,7 +6240,7 @@
                 </a:solidFill>
                 <a:latin typeface="Kanit"/>
               </a:rPr>
-              <a:t>129</a:t>
+              <a:t>132</a:t>
             </a:r>
           </a:p>
         </p:txBody>
@@ -6279,7 +6279,7 @@
                 </a:solidFill>
                 <a:latin typeface="Kanit"/>
               </a:rPr>
-              <a:t>จาก 790 (16.3%) · เรียลไทม์ · 2026-09-08</a:t>
+              <a:t>จาก 787 (16.8%) · เรียลไทม์ · 2026-09-09</a:t>
             </a:r>
           </a:p>
         </p:txBody>
@@ -6405,7 +6405,7 @@
                 </a:solidFill>
                 <a:latin typeface="Kanit"/>
               </a:rPr>
-              <a:t>32</a:t>
+              <a:t>34</a:t>
             </a:r>
           </a:p>
         </p:txBody>
@@ -6444,7 +6444,7 @@
                 </a:solidFill>
                 <a:latin typeface="Kanit"/>
               </a:rPr>
-              <a:t>ค่าล่าสุดรายวัน · 2026-09-08</a:t>
+              <a:t>ค่าล่าสุดรายวัน · 2026-09-09</a:t>
             </a:r>
           </a:p>
         </p:txBody>
@@ -7905,7 +7905,7 @@
                           </a:solidFill>
                           <a:latin typeface="Kanit"/>
                         </a:rPr>
-                        <a:t>38</a:t>
+                        <a:t>37</a:t>
                       </a:r>
                     </a:p>
                   </a:txBody>
@@ -7928,7 +7928,7 @@
                           </a:solidFill>
                           <a:latin typeface="Kanit"/>
                         </a:rPr>
-                        <a:t>33</a:t>
+                        <a:t>65</a:t>
                       </a:r>
                     </a:p>
                   </a:txBody>
@@ -7947,11 +7947,11 @@
                       <a:r>
                         <a:rPr sz="900" b="1">
                           <a:solidFill>
-                            <a:srgbClr val="606060"/>
-                          </a:solidFill>
-                          <a:latin typeface="Kanit"/>
-                        </a:rPr>
-                        <a:t>0.0%</a:t>
+                            <a:srgbClr val="F5C242"/>
+                          </a:solidFill>
+                          <a:latin typeface="Kanit"/>
+                        </a:rPr>
+                        <a:t>16.2%</a:t>
                       </a:r>
                     </a:p>
                   </a:txBody>
@@ -8022,7 +8022,7 @@
                           </a:solidFill>
                           <a:latin typeface="Kanit"/>
                         </a:rPr>
-                        <a:t>อุทัยธานี</a:t>
+                        <a:t>สมุทรปราการ</a:t>
                       </a:r>
                     </a:p>
                   </a:txBody>
@@ -8045,7 +8045,7 @@
                           </a:solidFill>
                           <a:latin typeface="Kanit"/>
                         </a:rPr>
-                        <a:t>45</a:t>
+                        <a:t>15</a:t>
                       </a:r>
                     </a:p>
                   </a:txBody>
@@ -8068,7 +8068,7 @@
                           </a:solidFill>
                           <a:latin typeface="Kanit"/>
                         </a:rPr>
-                        <a:t>19</a:t>
+                        <a:t>2</a:t>
                       </a:r>
                     </a:p>
                   </a:txBody>
@@ -8114,7 +8114,7 @@
                           </a:solidFill>
                           <a:latin typeface="Kanit"/>
                         </a:rPr>
-                        <a:t>1/4</a:t>
+                        <a:t>4/4</a:t>
                       </a:r>
                     </a:p>
                   </a:txBody>
@@ -8162,7 +8162,7 @@
                           </a:solidFill>
                           <a:latin typeface="Kanit"/>
                         </a:rPr>
-                        <a:t>ยโสธร</a:t>
+                        <a:t>บึงกาฬ</a:t>
                       </a:r>
                     </a:p>
                   </a:txBody>
@@ -8185,7 +8185,7 @@
                           </a:solidFill>
                           <a:latin typeface="Kanit"/>
                         </a:rPr>
-                        <a:t>14</a:t>
+                        <a:t>11</a:t>
                       </a:r>
                     </a:p>
                   </a:txBody>
@@ -8208,7 +8208,7 @@
                           </a:solidFill>
                           <a:latin typeface="Kanit"/>
                         </a:rPr>
-                        <a:t>88</a:t>
+                        <a:t>150</a:t>
                       </a:r>
                     </a:p>
                   </a:txBody>
@@ -8231,7 +8231,7 @@
                           </a:solidFill>
                           <a:latin typeface="Kanit"/>
                         </a:rPr>
-                        <a:t>21.4%</a:t>
+                        <a:t>54.5%</a:t>
                       </a:r>
                     </a:p>
                   </a:txBody>
@@ -8254,7 +8254,7 @@
                           </a:solidFill>
                           <a:latin typeface="Kanit"/>
                         </a:rPr>
-                        <a:t>3/5</a:t>
+                        <a:t>1/1</a:t>
                       </a:r>
                     </a:p>
                   </a:txBody>
@@ -8302,7 +8302,7 @@
                           </a:solidFill>
                           <a:latin typeface="Kanit"/>
                         </a:rPr>
-                        <a:t>ลำพูน</a:t>
+                        <a:t>หนองบัวลำภู</a:t>
                       </a:r>
                     </a:p>
                   </a:txBody>
@@ -8325,7 +8325,7 @@
                           </a:solidFill>
                           <a:latin typeface="Kanit"/>
                         </a:rPr>
-                        <a:t>76</a:t>
+                        <a:t>30</a:t>
                       </a:r>
                     </a:p>
                   </a:txBody>
@@ -8348,7 +8348,7 @@
                           </a:solidFill>
                           <a:latin typeface="Kanit"/>
                         </a:rPr>
-                        <a:t>70</a:t>
+                        <a:t>98</a:t>
                       </a:r>
                     </a:p>
                   </a:txBody>
@@ -8371,7 +8371,7 @@
                           </a:solidFill>
                           <a:latin typeface="Kanit"/>
                         </a:rPr>
-                        <a:t>10.5%</a:t>
+                        <a:t>26.7%</a:t>
                       </a:r>
                     </a:p>
                   </a:txBody>
@@ -8394,7 +8394,7 @@
                           </a:solidFill>
                           <a:latin typeface="Kanit"/>
                         </a:rPr>
-                        <a:t>1/11</a:t>
+                        <a:t>2/3</a:t>
                       </a:r>
                     </a:p>
                   </a:txBody>
@@ -8442,7 +8442,7 @@
                           </a:solidFill>
                           <a:latin typeface="Kanit"/>
                         </a:rPr>
-                        <a:t>บึงกาฬ</a:t>
+                        <a:t>ชุมพร</a:t>
                       </a:r>
                     </a:p>
                   </a:txBody>
@@ -8465,7 +8465,7 @@
                           </a:solidFill>
                           <a:latin typeface="Kanit"/>
                         </a:rPr>
-                        <a:t>11</a:t>
+                        <a:t>92</a:t>
                       </a:r>
                     </a:p>
                   </a:txBody>
@@ -8488,7 +8488,7 @@
                           </a:solidFill>
                           <a:latin typeface="Kanit"/>
                         </a:rPr>
-                        <a:t>56</a:t>
+                        <a:t>80</a:t>
                       </a:r>
                     </a:p>
                   </a:txBody>
@@ -8511,7 +8511,7 @@
                           </a:solidFill>
                           <a:latin typeface="Kanit"/>
                         </a:rPr>
-                        <a:t>9.1%</a:t>
+                        <a:t>16.3%</a:t>
                       </a:r>
                     </a:p>
                   </a:txBody>
@@ -8534,7 +8534,7 @@
                           </a:solidFill>
                           <a:latin typeface="Kanit"/>
                         </a:rPr>
-                        <a:t>1/1</a:t>
+                        <a:t>2/14</a:t>
                       </a:r>
                     </a:p>
                   </a:txBody>
@@ -8582,7 +8582,7 @@
                           </a:solidFill>
                           <a:latin typeface="Kanit"/>
                         </a:rPr>
-                        <a:t>พะเยา</a:t>
+                        <a:t>อุดรธานี</a:t>
                       </a:r>
                     </a:p>
                   </a:txBody>
@@ -8605,7 +8605,7 @@
                           </a:solidFill>
                           <a:latin typeface="Kanit"/>
                         </a:rPr>
-                        <a:t>125</a:t>
+                        <a:t>35</a:t>
                       </a:r>
                     </a:p>
                   </a:txBody>
@@ -8628,7 +8628,7 @@
                           </a:solidFill>
                           <a:latin typeface="Kanit"/>
                         </a:rPr>
-                        <a:t>96</a:t>
+                        <a:t>127</a:t>
                       </a:r>
                     </a:p>
                   </a:txBody>
@@ -8651,7 +8651,7 @@
                           </a:solidFill>
                           <a:latin typeface="Kanit"/>
                         </a:rPr>
-                        <a:t>8.8%</a:t>
+                        <a:t>14.3%</a:t>
                       </a:r>
                     </a:p>
                   </a:txBody>
@@ -8674,7 +8674,7 @@
                           </a:solidFill>
                           <a:latin typeface="Kanit"/>
                         </a:rPr>
-                        <a:t>3/13</a:t>
+                        <a:t>3/7</a:t>
                       </a:r>
                     </a:p>
                   </a:txBody>
@@ -8909,7 +8909,7 @@
                 </a:solidFill>
                 <a:latin typeface="Kanit"/>
               </a:rPr>
-              <a:t>พื้นที่ปลูก วัดจริง (สศก. — ข้อมูลอำเภอ×พืช 3,295 แถว) ภัยแล้งเป็นดัชนี SPEI จาก แบบจำลอง คำนวณจากปริมาณฝนและการคายระเหย ปรับเดือนละครั้ง ดึงข้อมูล 2026-07-20 — เป็นสัญญาณที่ครอบคลุมทั้งประเทศดีที่สุดที่มี แต่ไม่มีใครลงพื้นที่ไปเดินดูอำเภอเหล่านั้น ข้อมูลฝนและระดับน้ำ วัดจริง (ThaiWater เรียลไทม์ ดึงทุกวันและสะสมไว้ — วันที่ดึงไม่สำเร็จจะเว้นเป็นช่องว่าง ไม่ใส่ค่าสมมติ) · ฝนถึง 2026-09-08, ระดับน้ำถึง 2026-09-08 ความเสี่ยงน้ำท่วมเชิงโครงสร้าง วัดจริง (สำมะโนพื้นที่ท่วมซ้ำซาก GISTDA มาตราส่วน 1:50,000 ปี 2005-2016 — เป็นบันทึกภาคพื้นดิน 12 ปี ไม่ใช่การพยากรณ์)</a:t>
+              <a:t>พื้นที่ปลูก วัดจริง (สศก. — ข้อมูลอำเภอ×พืช 3,295 แถว) ภัยแล้งเป็นดัชนี SPEI จาก แบบจำลอง คำนวณจากปริมาณฝนและการคายระเหย ปรับเดือนละครั้ง ดึงข้อมูล 2026-07-20 — เป็นสัญญาณที่ครอบคลุมทั้งประเทศดีที่สุดที่มี แต่ไม่มีใครลงพื้นที่ไปเดินดูอำเภอเหล่านั้น ข้อมูลฝนและระดับน้ำ วัดจริง (ThaiWater เรียลไทม์ ดึงทุกวันและสะสมไว้ — วันที่ดึงไม่สำเร็จจะเว้นเป็นช่องว่าง ไม่ใส่ค่าสมมติ) · ฝนถึง 2026-09-09, ระดับน้ำถึง 2026-09-09 ความเสี่ยงน้ำท่วมเชิงโครงสร้าง วัดจริง (สำมะโนพื้นที่ท่วมซ้ำซาก GISTDA มาตราส่วน 1:50,000 ปี 2005-2016 — เป็นบันทึกภาคพื้นดิน 12 ปี ไม่ใช่การพยากรณ์)</a:t>
             </a:r>
           </a:p>
         </p:txBody>
@@ -31476,7 +31476,7 @@
                 </a:solidFill>
                 <a:latin typeface="Kanit"/>
               </a:rPr>
-              <a:t>รายได้จากพืชค่ากลางเพิ่มขึ้น +15.9% แต่มีสี่จังหวัดที่ลดลง — ทั้งหมดอยู่ในแหล่งปลูกมะพร้าว โดยหนักที่สุดคือสมุทรสงครามที่ −64.2%</a:t>
+              <a:t>รายได้จากพืชค่ากลางเพิ่มขึ้น +15.6% แต่มีสี่จังหวัดที่ลดลง — ทั้งหมดอยู่ในแหล่งปลูกมะพร้าว โดยหนักที่สุดคือสมุทรสงครามที่ −64.3%</a:t>
             </a:r>
           </a:p>
         </p:txBody>
@@ -32047,7 +32047,7 @@
                 </a:solidFill>
                 <a:latin typeface="Kanit"/>
               </a:rPr>
-              <a:t>รุ่นข้อมูล — ราคาโลก 2026M06 · ราคาหน้าฟาร์มไทย 2026-09-07 · ประวัติราคาไทย 2026-09-05 · ต้นทุนการผลิตพืช สศก. ไจอัป 2568 (ปีเพาะปลูก 2568/69, ประมาณการ สศก. มี.ค. 2569) · ภัยแล้ง 2026-06-21 · เงินเฟ้อ 2026-05 · GDP 2026 ไตรมาส 1 · IMF WEO 2026 · ดัชนีราคาขายต่อ 2026-05 · ยอดจดทะเบียนถึง 2026-01 · หนี้ครัวเรือน สสช. SES 2566 · ค่าจ้าง สสช. LFS 2568 · ข้อมูลตรวจวัด 2026-09-08</a:t>
+              <a:t>รุ่นข้อมูล — ราคาโลก 2026M06 · ราคาหน้าฟาร์มไทย 2026-09-09 · ประวัติราคาไทย 2026-09-05 · ต้นทุนการผลิตพืช สศก. ไจอัป 2568 (ปีเพาะปลูก 2568/69, ประมาณการ สศก. มี.ค. 2569) · ภัยแล้ง 2026-06-21 · เงินเฟ้อ 2026-05 · GDP 2026 ไตรมาส 1 · IMF WEO 2026 · ดัชนีราคาขายต่อ 2026-05 · ยอดจดทะเบียนถึง 2026-01 · หนี้ครัวเรือน สสช. SES 2566 · ค่าจ้าง สสช. LFS 2568 · ข้อมูลตรวจวัด 2026-09-09</a:t>
             </a:r>
           </a:p>
         </p:txBody>
@@ -32546,7 +32546,7 @@
               <a:t>Not on the world index — the farm gate (ราคาที่เกษตรกรขายได้) says otherwise.
 • Five of seventeen Thai farm-gate prices are falling year on year.
 • Beef: farm gate −6.1% vs world index +8.8%.
-• Margin over price: a 26% price move becomes an 83% swing in crop income.</a:t>
+• Margin over price: a 26% price move becomes an 82% swing in crop income.</a:t>
             </a:r>
           </a:p>
         </p:txBody>
@@ -33912,7 +33912,7 @@
                 </a:solidFill>
                 <a:latin typeface="Kanit"/>
               </a:rPr>
-              <a:t>32.92</a:t>
+              <a:t>32.90</a:t>
             </a:r>
           </a:p>
         </p:txBody>
@@ -33951,7 +33951,7 @@
                 </a:solidFill>
                 <a:latin typeface="Kanit"/>
               </a:rPr>
-              <a:t>อัตราอ้างอิง ECB · 2026-09-04</a:t>
+              <a:t>อัตราอ้างอิง ECB · 2026-09-07</a:t>
             </a:r>
           </a:p>
         </p:txBody>
@@ -35798,7 +35798,7 @@
                 </a:solidFill>
                 <a:latin typeface="Kanit"/>
               </a:rPr>
-              <a:t>สศช. 2026 ไตรมาส 1 · TPSO 2026-05 · ธนาคารแห่งประเทศไทย 2026-08 · BIS 2025 ไตรมาส 4 · ECB 2026-09-04, ทั้งหมดดึงจากหน่วยงานผู้เผยแพร่โดยตรง ตารางเทียบประเทศใช้ IMF World Economic Outlook 2026 (ดึงข้อมูล 2026-07-25) อัตรา NPL ที่ ธปท. เผยแพร่ — 4.48% ณ 2026 ไตรมาส 1, จาก 4.33% ไตรมาสก่อน เปลี่ยน +0.24 จุดใน 1 ปี และต่ำสุด 3.08% ณ 2021 ไตรมาส 1</a:t>
+              <a:t>สศช. 2026 ไตรมาส 1 · TPSO 2026-05 · ธนาคารแห่งประเทศไทย 2026-08 · BIS 2025 ไตรมาส 4 · ECB 2026-09-07, ทั้งหมดดึงจากหน่วยงานผู้เผยแพร่โดยตรง ตารางเทียบประเทศใช้ IMF World Economic Outlook 2026 (ดึงข้อมูล 2026-07-25) อัตรา NPL ที่ ธปท. เผยแพร่ — 4.48% ณ 2026 ไตรมาส 1, จาก 4.33% ไตรมาสก่อน เปลี่ยน +0.24 จุดใน 1 ปี และต่ำสุด 3.08% ณ 2021 ไตรมาส 1</a:t>
             </a:r>
           </a:p>
         </p:txBody>
@@ -37087,7 +37087,7 @@
                 </a:solidFill>
                 <a:latin typeface="Kanit"/>
               </a:rPr>
-              <a:t>338 จาก 928 อำเภอ · แม่น้ำเกินระดับ 129 จาก 790 สถานี</a:t>
+              <a:t>338 จาก 928 อำเภอ · แม่น้ำเกินระดับ 132 จาก 787 สถานี</a:t>
             </a:r>
           </a:p>
         </p:txBody>
@@ -37859,7 +37859,7 @@
                           </a:solidFill>
                           <a:latin typeface="Kanit"/>
                         </a:rPr>
-                        <a:t>30/155</a:t>
+                        <a:t>31/154</a:t>
                       </a:r>
                     </a:p>
                   </a:txBody>
@@ -38091,7 +38091,7 @@
                           </a:solidFill>
                           <a:latin typeface="Kanit"/>
                         </a:rPr>
-                        <a:t>18/274</a:t>
+                        <a:t>18/272</a:t>
                       </a:r>
                     </a:p>
                   </a:txBody>
@@ -38555,7 +38555,7 @@
                           </a:solidFill>
                           <a:latin typeface="Kanit"/>
                         </a:rPr>
-                        <a:t>14/51</a:t>
+                        <a:t>12/51</a:t>
                       </a:r>
                     </a:p>
                   </a:txBody>
@@ -38787,7 +38787,7 @@
                           </a:solidFill>
                           <a:latin typeface="Kanit"/>
                         </a:rPr>
-                        <a:t>41/143</a:t>
+                        <a:t>45/143</a:t>
                       </a:r>
                     </a:p>
                   </a:txBody>
@@ -39936,7 +39936,7 @@
                           </a:solidFill>
                           <a:latin typeface="Kanit"/>
                         </a:rPr>
-                        <a:t>−68.6%</a:t>
+                        <a:t>−68.7%</a:t>
                       </a:r>
                     </a:p>
                   </a:txBody>
@@ -40791,7 +40791,7 @@
                 </a:solidFill>
                 <a:latin typeface="Kanit"/>
               </a:rPr>
-              <a:t>ราคา วัดจริง — ราคาหน้าฟาร์มไทยจากราคารายวันของ NABC และราคาอ้อยประกาศของ สอน. ราคาล่าสุด 2026-09-07 การเปลี่ยนแปลงหกเดือนคำนวณจากข้อมูลรายเดือนของ NABC เอง (thai_price_history รุ่นข้อมูล 2026-09-05) พืชที่ไม่มีข้อมูลรายเดือนจะกำกับไว้ ไม่ประมาณการขึ้นมา แหล่งผลิตเป็นการอ่านแบบ ประมาณการ ว่าสินค้าแต่ละชนิดปลูกที่ไหน และแหล่งผลิตทับซ้อนกันได้ บัญชีอาชีพเกษตรเป็นข้อมูลของเราเองและ วัดจริง — บัญชีที่บันทึกอาชีพว่า เกษตร ในจังหวัดแหล่งผลิต จากฐานข้อมูล 382,735 บัญชี ณ 2026-07 ไม่เผยแพร่ช่องที่มีน้อยกว่า 30 บัญชี คนกลุ่มนี้อาศัยอยู่ในพื้นที่ที่ปลูกพืชนั้น แต่ไม่ได้ยืนยันว่าปลูกพืชนั้นเอง</a:t>
+              <a:t>ราคา วัดจริง — ราคาหน้าฟาร์มไทยจากราคารายวันของ NABC และราคาอ้อยประกาศของ สอน. ราคาล่าสุด 2026-09-09 การเปลี่ยนแปลงหกเดือนคำนวณจากข้อมูลรายเดือนของ NABC เอง (thai_price_history รุ่นข้อมูล 2026-09-05) พืชที่ไม่มีข้อมูลรายเดือนจะกำกับไว้ ไม่ประมาณการขึ้นมา แหล่งผลิตเป็นการอ่านแบบ ประมาณการ ว่าสินค้าแต่ละชนิดปลูกที่ไหน และแหล่งผลิตทับซ้อนกันได้ บัญชีอาชีพเกษตรเป็นข้อมูลของเราเองและ วัดจริง — บัญชีที่บันทึกอาชีพว่า เกษตร ในจังหวัดแหล่งผลิต จากฐานข้อมูล 382,735 บัญชี ณ 2026-07 ไม่เผยแพร่ช่องที่มีน้อยกว่า 30 บัญชี คนกลุ่มนี้อาศัยอยู่ในพื้นที่ที่ปลูกพืชนั้น แต่ไม่ได้ยืนยันว่าปลูกพืชนั้นเอง</a:t>
             </a:r>
           </a:p>
         </p:txBody>
@@ -43419,7 +43419,7 @@
                           </a:solidFill>
                           <a:latin typeface="Kanit"/>
                         </a:rPr>
-                        <a:t>91.52</a:t>
+                        <a:t>91.45</a:t>
                       </a:r>
                     </a:p>
                   </a:txBody>
@@ -43559,7 +43559,7 @@
                           </a:solidFill>
                           <a:latin typeface="Kanit"/>
                         </a:rPr>
-                        <a:t>15,374</a:t>
+                        <a:t>15,362</a:t>
                       </a:r>
                     </a:p>
                   </a:txBody>
@@ -43699,7 +43699,7 @@
                           </a:solidFill>
                           <a:latin typeface="Kanit"/>
                         </a:rPr>
-                        <a:t>36,245</a:t>
+                        <a:t>36,217</a:t>
                       </a:r>
                     </a:p>
                   </a:txBody>
@@ -43839,7 +43839,7 @@
                           </a:solidFill>
                           <a:latin typeface="Kanit"/>
                         </a:rPr>
-                        <a:t>11.19</a:t>
+                        <a:t>11.18</a:t>
                       </a:r>
                     </a:p>
                   </a:txBody>
@@ -44058,7 +44058,7 @@
                 </a:solidFill>
                 <a:latin typeface="Kanit"/>
               </a:rPr>
-              <a:t>ราคารายเดือนสกุลดอลลาร์ราคาปัจจุบันจาก World Bank Pink Sheet รุ่นข้อมูล 2026M07 (ข้อมูล 60 จุดต่อรายการ ปรับฐานเป็น 100 ณ 2021-07 เพื่อวาดกราฟ — หน่วยต่างกัน จึงใช้แกนเดียวกับระดับราคาดิบไม่ได้) แปลงเป็นบาทด้วยอัตราอ้างอิง ECB USD/THB 32.920 ณ 2026-09-04 สัดส่วนพื้นที่ปลูก วัดจริง จากสัดส่วนพืชของ สศก./กรมส่งเสริมการเกษตร (crop_mix.json) เป็นราคาปัจจุบัน ไม่ได้ปรับเงินเฟ้อ: ทุกตัวเลข ‘เทียบ 5 ปีก่อน’ มีเงินเฟ้อไทยห้าปีซ่อนอยู่ข้างใต้</a:t>
+              <a:t>ราคารายเดือนสกุลดอลลาร์ราคาปัจจุบันจาก World Bank Pink Sheet รุ่นข้อมูล 2026M07 (ข้อมูล 60 จุดต่อรายการ ปรับฐานเป็น 100 ณ 2021-07 เพื่อวาดกราฟ — หน่วยต่างกัน จึงใช้แกนเดียวกับระดับราคาดิบไม่ได้) แปลงเป็นบาทด้วยอัตราอ้างอิง ECB USD/THB 32.895 ณ 2026-09-07 สัดส่วนพื้นที่ปลูก วัดจริง จากสัดส่วนพืชของ สศก./กรมส่งเสริมการเกษตร (crop_mix.json) เป็นราคาปัจจุบัน ไม่ได้ปรับเงินเฟ้อ: ทุกตัวเลข ‘เทียบ 5 ปีก่อน’ มีเงินเฟ้อไทยห้าปีซ่อนอยู่ข้างใต้</a:t>
             </a:r>
           </a:p>
         </p:txBody>
@@ -44679,7 +44679,7 @@
                 </a:solidFill>
                 <a:latin typeface="Kanit"/>
               </a:rPr>
-              <a:t>มะพร้าว −68.6% สับปะรด −18.4% อ้อย −17.9% เทียบปีก่อน</a:t>
+              <a:t>มะพร้าว −68.7% สับปะรด −18.4% อ้อย −17.9% เทียบปีก่อน</a:t>
             </a:r>
           </a:p>
         </p:txBody>
@@ -44805,7 +44805,7 @@
                 </a:solidFill>
                 <a:latin typeface="Kanit"/>
               </a:rPr>
-              <a:t>+15.9%</a:t>
+              <a:t>+15.6%</a:t>
             </a:r>
           </a:p>
         </p:txBody>
@@ -45279,7 +45279,7 @@
                           </a:solidFill>
                           <a:latin typeface="Kanit"/>
                         </a:rPr>
-                        <a:t>+6.1%</a:t>
+                        <a:t>+5.7%</a:t>
                       </a:r>
                     </a:p>
                   </a:txBody>
@@ -45348,7 +45348,7 @@
                           </a:solidFill>
                           <a:latin typeface="Kanit"/>
                         </a:rPr>
-                        <a:t>-64.2%</a:t>
+                        <a:t>-64.3%</a:t>
                       </a:r>
                     </a:p>
                   </a:txBody>
@@ -45419,7 +45419,7 @@
                           </a:solidFill>
                           <a:latin typeface="Kanit"/>
                         </a:rPr>
-                        <a:t>+15.1%</a:t>
+                        <a:t>+14.8%</a:t>
                       </a:r>
                     </a:p>
                   </a:txBody>
@@ -45488,7 +45488,7 @@
                           </a:solidFill>
                           <a:latin typeface="Kanit"/>
                         </a:rPr>
-                        <a:t>+9.5%</a:t>
+                        <a:t>+9.2%</a:t>
                       </a:r>
                     </a:p>
                   </a:txBody>
@@ -45559,7 +45559,7 @@
                           </a:solidFill>
                           <a:latin typeface="Kanit"/>
                         </a:rPr>
-                        <a:t>+16.9%</a:t>
+                        <a:t>+16.6%</a:t>
                       </a:r>
                     </a:p>
                   </a:txBody>
@@ -45628,7 +45628,7 @@
                           </a:solidFill>
                           <a:latin typeface="Kanit"/>
                         </a:rPr>
-                        <a:t>+8.2%</a:t>
+                        <a:t>+8.0%</a:t>
                       </a:r>
                     </a:p>
                   </a:txBody>
@@ -45699,7 +45699,7 @@
                           </a:solidFill>
                           <a:latin typeface="Kanit"/>
                         </a:rPr>
-                        <a:t>+24.8%</a:t>
+                        <a:t>+25.0%</a:t>
                       </a:r>
                     </a:p>
                   </a:txBody>
@@ -45768,7 +45768,7 @@
                           </a:solidFill>
                           <a:latin typeface="Kanit"/>
                         </a:rPr>
-                        <a:t>+11.3%</a:t>
+                        <a:t>+11.1%</a:t>
                       </a:r>
                     </a:p>
                   </a:txBody>
@@ -45839,7 +45839,7 @@
                           </a:solidFill>
                           <a:latin typeface="Kanit"/>
                         </a:rPr>
-                        <a:t>+34.4%</a:t>
+                        <a:t>+34.8%</a:t>
                       </a:r>
                     </a:p>
                   </a:txBody>
@@ -45908,7 +45908,7 @@
                           </a:solidFill>
                           <a:latin typeface="Kanit"/>
                         </a:rPr>
-                        <a:t>+26.8%</a:t>
+                        <a:t>+27.2%</a:t>
                       </a:r>
                     </a:p>
                   </a:txBody>
@@ -46387,7 +46387,7 @@
                           </a:solidFill>
                           <a:latin typeface="Kanit"/>
                         </a:rPr>
-                        <a:t>+17.6%</a:t>
+                        <a:t>+17.3%</a:t>
                       </a:r>
                     </a:p>
                   </a:txBody>
@@ -46550,7 +46550,7 @@
                           </a:solidFill>
                           <a:latin typeface="Kanit"/>
                         </a:rPr>
-                        <a:t>+21.3%</a:t>
+                        <a:t>+21.0%</a:t>
                       </a:r>
                     </a:p>
                   </a:txBody>
@@ -46713,7 +46713,7 @@
                           </a:solidFill>
                           <a:latin typeface="Kanit"/>
                         </a:rPr>
-                        <a:t>+11.2%</a:t>
+                        <a:t>+10.9%</a:t>
                       </a:r>
                     </a:p>
                   </a:txBody>
@@ -46876,7 +46876,7 @@
                           </a:solidFill>
                           <a:latin typeface="Kanit"/>
                         </a:rPr>
-                        <a:t>+32.4%</a:t>
+                        <a:t>+32.8%</a:t>
                       </a:r>
                     </a:p>
                   </a:txBody>
@@ -47039,7 +47039,7 @@
                           </a:solidFill>
                           <a:latin typeface="Kanit"/>
                         </a:rPr>
-                        <a:t>+16.6%</a:t>
+                        <a:t>+16.3%</a:t>
                       </a:r>
                     </a:p>
                   </a:txBody>
@@ -47202,7 +47202,7 @@
                           </a:solidFill>
                           <a:latin typeface="Kanit"/>
                         </a:rPr>
-                        <a:t>+15.0%</a:t>
+                        <a:t>+14.6%</a:t>
                       </a:r>
                     </a:p>
                   </a:txBody>
@@ -48024,7 +48024,7 @@
                 </a:solidFill>
                 <a:latin typeface="Kanit"/>
               </a:rPr>
-              <a:t>เทียบปีก่อน −68.6%</a:t>
+              <a:t>เทียบปีก่อน −68.7%</a:t>
             </a:r>
           </a:p>
         </p:txBody>
@@ -48660,7 +48660,7 @@
                 </a:solidFill>
                 <a:latin typeface="Kanit"/>
               </a:rPr>
-              <a:t>เทียบปีก่อน +0.6%</a:t>
+              <a:t>เทียบปีก่อน +0.4%</a:t>
             </a:r>
           </a:p>
         </p:txBody>
@@ -48978,7 +48978,7 @@
                 </a:solidFill>
                 <a:latin typeface="Kanit"/>
               </a:rPr>
-              <a:t>เทียบปีก่อน +4.8%</a:t>
+              <a:t>เทียบปีก่อน +5.1%</a:t>
             </a:r>
           </a:p>
         </p:txBody>
@@ -49296,7 +49296,7 @@
                 </a:solidFill>
                 <a:latin typeface="Kanit"/>
               </a:rPr>
-              <a:t>เทียบปีก่อน +6.8%</a:t>
+              <a:t>เทียบปีก่อน +7.1%</a:t>
             </a:r>
           </a:p>
         </p:txBody>
@@ -49614,7 +49614,7 @@
                 </a:solidFill>
                 <a:latin typeface="Kanit"/>
               </a:rPr>
-              <a:t>เทียบปีก่อน +13.3%</a:t>
+              <a:t>เทียบปีก่อน +12.8%</a:t>
             </a:r>
           </a:p>
         </p:txBody>
@@ -49932,7 +49932,7 @@
                 </a:solidFill>
                 <a:latin typeface="Kanit"/>
               </a:rPr>
-              <a:t>เทียบปีก่อน +13.8%</a:t>
+              <a:t>เทียบปีก่อน +13.6%</a:t>
             </a:r>
           </a:p>
         </p:txBody>
@@ -50172,6 +50172,324 @@
                 </a:solidFill>
                 <a:latin typeface="Kanit"/>
               </a:rPr>
+              <a:t>ปาล์มน้ำมัน</a:t>
+            </a:r>
+          </a:p>
+        </p:txBody>
+      </p:sp>
+      <p:sp>
+        <p:nvSpPr>
+          <p:cNvPr id="65" name="TextBox 64"/>
+          <p:cNvSpPr txBox="1"/>
+          <p:nvPr/>
+        </p:nvSpPr>
+        <p:spPr>
+          <a:xfrm>
+            <a:off x="5016398" y="3218687"/>
+            <a:ext cx="2156155" cy="125730"/>
+          </a:xfrm>
+          <a:prstGeom prst="rect">
+            <a:avLst/>
+          </a:prstGeom>
+          <a:noFill/>
+        </p:spPr>
+        <p:txBody>
+          <a:bodyPr wrap="square" lIns="0" rIns="0" tIns="0" bIns="0" anchor="t">
+            <a:noAutofit/>
+          </a:bodyPr>
+          <a:lstStyle/>
+          <a:p>
+            <a:pPr algn="l">
+              <a:lnSpc>
+                <a:spcPts val="990"/>
+              </a:lnSpc>
+            </a:pPr>
+            <a:r>
+              <a:rPr sz="750" b="0">
+                <a:solidFill>
+                  <a:srgbClr val="606060"/>
+                </a:solidFill>
+                <a:latin typeface="Kanit"/>
+              </a:rPr>
+              <a:t>฿8.38 /กก. · ใต้</a:t>
+            </a:r>
+          </a:p>
+        </p:txBody>
+      </p:sp>
+      <p:sp>
+        <p:nvSpPr>
+          <p:cNvPr id="66" name="TextBox 65"/>
+          <p:cNvSpPr txBox="1"/>
+          <p:nvPr/>
+        </p:nvSpPr>
+        <p:spPr>
+          <a:xfrm>
+            <a:off x="5016398" y="3351275"/>
+            <a:ext cx="1078077" cy="134112"/>
+          </a:xfrm>
+          <a:prstGeom prst="rect">
+            <a:avLst/>
+          </a:prstGeom>
+          <a:noFill/>
+        </p:spPr>
+        <p:txBody>
+          <a:bodyPr wrap="square" lIns="0" rIns="0" tIns="0" bIns="0" anchor="t">
+            <a:noAutofit/>
+          </a:bodyPr>
+          <a:lstStyle/>
+          <a:p>
+            <a:pPr algn="l">
+              <a:lnSpc>
+                <a:spcPts val="1056"/>
+              </a:lnSpc>
+            </a:pPr>
+            <a:r>
+              <a:rPr sz="800" b="1">
+                <a:solidFill>
+                  <a:srgbClr val="15795F"/>
+                </a:solidFill>
+                <a:latin typeface="Kanit"/>
+              </a:rPr>
+              <a:t>เทียบปีก่อน +23.4%</a:t>
+            </a:r>
+          </a:p>
+        </p:txBody>
+      </p:sp>
+      <p:sp>
+        <p:nvSpPr>
+          <p:cNvPr id="67" name="TextBox 66"/>
+          <p:cNvSpPr txBox="1"/>
+          <p:nvPr/>
+        </p:nvSpPr>
+        <p:spPr>
+          <a:xfrm>
+            <a:off x="6094475" y="3351275"/>
+            <a:ext cx="1078077" cy="134112"/>
+          </a:xfrm>
+          <a:prstGeom prst="rect">
+            <a:avLst/>
+          </a:prstGeom>
+          <a:noFill/>
+        </p:spPr>
+        <p:txBody>
+          <a:bodyPr wrap="square" lIns="0" rIns="0" tIns="0" bIns="0" anchor="t">
+            <a:noAutofit/>
+          </a:bodyPr>
+          <a:lstStyle/>
+          <a:p>
+            <a:pPr algn="l">
+              <a:lnSpc>
+                <a:spcPts val="1056"/>
+              </a:lnSpc>
+            </a:pPr>
+            <a:r>
+              <a:rPr sz="800" b="1">
+                <a:solidFill>
+                  <a:srgbClr val="15795F"/>
+                </a:solidFill>
+                <a:latin typeface="Kanit"/>
+              </a:rPr>
+              <a:t>6 เดือน +16.2%</a:t>
+            </a:r>
+          </a:p>
+        </p:txBody>
+      </p:sp>
+      <p:sp>
+        <p:nvSpPr>
+          <p:cNvPr id="68" name="Rectangle 67"/>
+          <p:cNvSpPr/>
+          <p:nvPr/>
+        </p:nvSpPr>
+        <p:spPr>
+          <a:xfrm>
+            <a:off x="5016398" y="3506724"/>
+            <a:ext cx="2156155" cy="548640"/>
+          </a:xfrm>
+          <a:prstGeom prst="rect">
+            <a:avLst/>
+          </a:prstGeom>
+          <a:solidFill>
+            <a:srgbClr val="FBFCFE"/>
+          </a:solidFill>
+          <a:ln w="9525">
+            <a:solidFill>
+              <a:srgbClr val="D9DEE9"/>
+            </a:solidFill>
+          </a:ln>
+          <a:effectLst/>
+        </p:spPr>
+        <p:style>
+          <a:lnRef idx="1">
+            <a:schemeClr val="accent1"/>
+          </a:lnRef>
+          <a:fillRef idx="3">
+            <a:schemeClr val="accent1"/>
+          </a:fillRef>
+          <a:effectRef idx="2">
+            <a:schemeClr val="accent1"/>
+          </a:effectRef>
+          <a:fontRef idx="minor">
+            <a:schemeClr val="lt1"/>
+          </a:fontRef>
+        </p:style>
+        <p:txBody>
+          <a:bodyPr rtlCol="0" anchor="ctr" wrap="none"/>
+          <a:lstStyle/>
+          <a:p>
+            <a:pPr algn="ctr"/>
+          </a:p>
+        </p:txBody>
+      </p:sp>
+      <p:sp>
+        <p:nvSpPr>
+          <p:cNvPr id="69" name="Freeform 68"/>
+          <p:cNvSpPr/>
+          <p:nvPr/>
+        </p:nvSpPr>
+        <p:spPr>
+          <a:xfrm>
+            <a:off x="5062118" y="3552444"/>
+            <a:ext cx="2064715" cy="457200"/>
+          </a:xfrm>
+          <a:custGeom>
+            <a:avLst/>
+            <a:gdLst/>
+            <a:ahLst/>
+            <a:cxnLst/>
+            <a:rect l="l" t="t" r="r" b="b"/>
+            <a:pathLst>
+              <a:path w="2064715" h="457200">
+                <a:moveTo>
+                  <a:pt x="0" y="439749"/>
+                </a:moveTo>
+                <a:lnTo>
+                  <a:pt x="412943" y="457200"/>
+                </a:lnTo>
+                <a:lnTo>
+                  <a:pt x="825886" y="293166"/>
+                </a:lnTo>
+                <a:lnTo>
+                  <a:pt x="1238829" y="76781"/>
+                </a:lnTo>
+                <a:lnTo>
+                  <a:pt x="1651772" y="0"/>
+                </a:lnTo>
+                <a:lnTo>
+                  <a:pt x="2064715" y="45370"/>
+                </a:lnTo>
+              </a:path>
+            </a:pathLst>
+          </a:custGeom>
+          <a:noFill/>
+          <a:ln w="20320">
+            <a:solidFill>
+              <a:srgbClr val="15795F"/>
+            </a:solidFill>
+          </a:ln>
+          <a:effectLst/>
+        </p:spPr>
+        <p:style>
+          <a:lnRef idx="1">
+            <a:schemeClr val="accent1"/>
+          </a:lnRef>
+          <a:fillRef idx="3">
+            <a:schemeClr val="accent1"/>
+          </a:fillRef>
+          <a:effectRef idx="2">
+            <a:schemeClr val="accent1"/>
+          </a:effectRef>
+          <a:fontRef idx="minor">
+            <a:schemeClr val="lt1"/>
+          </a:fontRef>
+        </p:style>
+        <p:txBody>
+          <a:bodyPr rtlCol="0" anchor="ctr"/>
+          <a:lstStyle/>
+          <a:p>
+            <a:pPr algn="ctr"/>
+          </a:p>
+        </p:txBody>
+      </p:sp>
+      <p:sp>
+        <p:nvSpPr>
+          <p:cNvPr id="70" name="Rounded Rectangle 69"/>
+          <p:cNvSpPr/>
+          <p:nvPr/>
+        </p:nvSpPr>
+        <p:spPr>
+          <a:xfrm>
+            <a:off x="7085685" y="3556666"/>
+            <a:ext cx="82296" cy="82296"/>
+          </a:xfrm>
+          <a:prstGeom prst="roundRect">
+            <a:avLst>
+              <a:gd name="adj" fmla="val 50000"/>
+            </a:avLst>
+          </a:prstGeom>
+          <a:solidFill>
+            <a:srgbClr val="15795F"/>
+          </a:solidFill>
+          <a:ln>
+            <a:noFill/>
+          </a:ln>
+          <a:effectLst/>
+        </p:spPr>
+        <p:style>
+          <a:lnRef idx="1">
+            <a:schemeClr val="accent1"/>
+          </a:lnRef>
+          <a:fillRef idx="3">
+            <a:schemeClr val="accent1"/>
+          </a:fillRef>
+          <a:effectRef idx="2">
+            <a:schemeClr val="accent1"/>
+          </a:effectRef>
+          <a:fontRef idx="minor">
+            <a:schemeClr val="lt1"/>
+          </a:fontRef>
+        </p:style>
+        <p:txBody>
+          <a:bodyPr rtlCol="0" anchor="ctr" wrap="none"/>
+          <a:lstStyle/>
+          <a:p>
+            <a:pPr algn="ctr"/>
+          </a:p>
+        </p:txBody>
+      </p:sp>
+      <p:sp>
+        <p:nvSpPr>
+          <p:cNvPr id="71" name="TextBox 70"/>
+          <p:cNvSpPr txBox="1"/>
+          <p:nvPr/>
+        </p:nvSpPr>
+        <p:spPr>
+          <a:xfrm>
+            <a:off x="7318857" y="3076956"/>
+            <a:ext cx="2156155" cy="150876"/>
+          </a:xfrm>
+          <a:prstGeom prst="rect">
+            <a:avLst/>
+          </a:prstGeom>
+          <a:noFill/>
+        </p:spPr>
+        <p:txBody>
+          <a:bodyPr wrap="square" lIns="0" rIns="0" tIns="0" bIns="0" anchor="t">
+            <a:noAutofit/>
+          </a:bodyPr>
+          <a:lstStyle/>
+          <a:p>
+            <a:pPr algn="l">
+              <a:lnSpc>
+                <a:spcPts val="1188"/>
+              </a:lnSpc>
+            </a:pPr>
+            <a:r>
+              <a:rPr sz="900" b="1">
+                <a:solidFill>
+                  <a:srgbClr val="1E2F5C"/>
+                </a:solidFill>
+                <a:latin typeface="Kanit"/>
+              </a:rPr>
               <a:t>สุกร</a:t>
             </a:r>
           </a:p>
@@ -50179,13 +50497,13 @@
       </p:sp>
       <p:sp>
         <p:nvSpPr>
-          <p:cNvPr id="65" name="TextBox 64"/>
+          <p:cNvPr id="72" name="TextBox 71"/>
           <p:cNvSpPr txBox="1"/>
           <p:nvPr/>
         </p:nvSpPr>
         <p:spPr>
           <a:xfrm>
-            <a:off x="5016398" y="3218687"/>
+            <a:off x="7318857" y="3218687"/>
             <a:ext cx="2156155" cy="125730"/>
           </a:xfrm>
           <a:prstGeom prst="rect">
@@ -50218,13 +50536,13 @@
       </p:sp>
       <p:sp>
         <p:nvSpPr>
-          <p:cNvPr id="66" name="TextBox 65"/>
+          <p:cNvPr id="73" name="TextBox 72"/>
           <p:cNvSpPr txBox="1"/>
           <p:nvPr/>
         </p:nvSpPr>
         <p:spPr>
           <a:xfrm>
-            <a:off x="5016398" y="3351275"/>
+            <a:off x="7318857" y="3351275"/>
             <a:ext cx="1078077" cy="134112"/>
           </a:xfrm>
           <a:prstGeom prst="rect">
@@ -50250,20 +50568,20 @@
                 </a:solidFill>
                 <a:latin typeface="Kanit"/>
               </a:rPr>
-              <a:t>เทียบปีก่อน +21.8%</a:t>
+              <a:t>เทียบปีก่อน +24.2%</a:t>
             </a:r>
           </a:p>
         </p:txBody>
       </p:sp>
       <p:sp>
         <p:nvSpPr>
-          <p:cNvPr id="67" name="TextBox 66"/>
+          <p:cNvPr id="74" name="TextBox 73"/>
           <p:cNvSpPr txBox="1"/>
           <p:nvPr/>
         </p:nvSpPr>
         <p:spPr>
           <a:xfrm>
-            <a:off x="6094475" y="3351275"/>
+            <a:off x="8396935" y="3351275"/>
             <a:ext cx="1078077" cy="134112"/>
           </a:xfrm>
           <a:prstGeom prst="rect">
@@ -50296,13 +50614,13 @@
       </p:sp>
       <p:sp>
         <p:nvSpPr>
-          <p:cNvPr id="68" name="Rectangle 67"/>
+          <p:cNvPr id="75" name="Rectangle 74"/>
           <p:cNvSpPr/>
           <p:nvPr/>
         </p:nvSpPr>
         <p:spPr>
           <a:xfrm>
-            <a:off x="5016398" y="3506724"/>
+            <a:off x="7318857" y="3506724"/>
             <a:ext cx="2156155" cy="548640"/>
           </a:xfrm>
           <a:prstGeom prst="rect">
@@ -50342,13 +50660,13 @@
       </p:sp>
       <p:sp>
         <p:nvSpPr>
-          <p:cNvPr id="69" name="Freeform 68"/>
+          <p:cNvPr id="76" name="Freeform 75"/>
           <p:cNvSpPr/>
           <p:nvPr/>
         </p:nvSpPr>
         <p:spPr>
           <a:xfrm>
-            <a:off x="5062118" y="3552444"/>
+            <a:off x="7364577" y="3552444"/>
             <a:ext cx="2064715" cy="457200"/>
           </a:xfrm>
           <a:custGeom>
@@ -50412,331 +50730,13 @@
       </p:sp>
       <p:sp>
         <p:nvSpPr>
-          <p:cNvPr id="70" name="Rounded Rectangle 69"/>
-          <p:cNvSpPr/>
-          <p:nvPr/>
-        </p:nvSpPr>
-        <p:spPr>
-          <a:xfrm>
-            <a:off x="7085685" y="3511296"/>
-            <a:ext cx="82296" cy="82296"/>
-          </a:xfrm>
-          <a:prstGeom prst="roundRect">
-            <a:avLst>
-              <a:gd name="adj" fmla="val 50000"/>
-            </a:avLst>
-          </a:prstGeom>
-          <a:solidFill>
-            <a:srgbClr val="15795F"/>
-          </a:solidFill>
-          <a:ln>
-            <a:noFill/>
-          </a:ln>
-          <a:effectLst/>
-        </p:spPr>
-        <p:style>
-          <a:lnRef idx="1">
-            <a:schemeClr val="accent1"/>
-          </a:lnRef>
-          <a:fillRef idx="3">
-            <a:schemeClr val="accent1"/>
-          </a:fillRef>
-          <a:effectRef idx="2">
-            <a:schemeClr val="accent1"/>
-          </a:effectRef>
-          <a:fontRef idx="minor">
-            <a:schemeClr val="lt1"/>
-          </a:fontRef>
-        </p:style>
-        <p:txBody>
-          <a:bodyPr rtlCol="0" anchor="ctr" wrap="none"/>
-          <a:lstStyle/>
-          <a:p>
-            <a:pPr algn="ctr"/>
-          </a:p>
-        </p:txBody>
-      </p:sp>
-      <p:sp>
-        <p:nvSpPr>
-          <p:cNvPr id="71" name="TextBox 70"/>
-          <p:cNvSpPr txBox="1"/>
-          <p:nvPr/>
-        </p:nvSpPr>
-        <p:spPr>
-          <a:xfrm>
-            <a:off x="7318857" y="3076956"/>
-            <a:ext cx="2156155" cy="150876"/>
-          </a:xfrm>
-          <a:prstGeom prst="rect">
-            <a:avLst/>
-          </a:prstGeom>
-          <a:noFill/>
-        </p:spPr>
-        <p:txBody>
-          <a:bodyPr wrap="square" lIns="0" rIns="0" tIns="0" bIns="0" anchor="t">
-            <a:noAutofit/>
-          </a:bodyPr>
-          <a:lstStyle/>
-          <a:p>
-            <a:pPr algn="l">
-              <a:lnSpc>
-                <a:spcPts val="1188"/>
-              </a:lnSpc>
-            </a:pPr>
-            <a:r>
-              <a:rPr sz="900" b="1">
-                <a:solidFill>
-                  <a:srgbClr val="1E2F5C"/>
-                </a:solidFill>
-                <a:latin typeface="Kanit"/>
-              </a:rPr>
-              <a:t>ปาล์มน้ำมัน</a:t>
-            </a:r>
-          </a:p>
-        </p:txBody>
-      </p:sp>
-      <p:sp>
-        <p:nvSpPr>
-          <p:cNvPr id="72" name="TextBox 71"/>
-          <p:cNvSpPr txBox="1"/>
-          <p:nvPr/>
-        </p:nvSpPr>
-        <p:spPr>
-          <a:xfrm>
-            <a:off x="7318857" y="3218687"/>
-            <a:ext cx="2156155" cy="125730"/>
-          </a:xfrm>
-          <a:prstGeom prst="rect">
-            <a:avLst/>
-          </a:prstGeom>
-          <a:noFill/>
-        </p:spPr>
-        <p:txBody>
-          <a:bodyPr wrap="square" lIns="0" rIns="0" tIns="0" bIns="0" anchor="t">
-            <a:noAutofit/>
-          </a:bodyPr>
-          <a:lstStyle/>
-          <a:p>
-            <a:pPr algn="l">
-              <a:lnSpc>
-                <a:spcPts val="990"/>
-              </a:lnSpc>
-            </a:pPr>
-            <a:r>
-              <a:rPr sz="750" b="0">
-                <a:solidFill>
-                  <a:srgbClr val="606060"/>
-                </a:solidFill>
-                <a:latin typeface="Kanit"/>
-              </a:rPr>
-              <a:t>฿8.38 /กก. · ใต้</a:t>
-            </a:r>
-          </a:p>
-        </p:txBody>
-      </p:sp>
-      <p:sp>
-        <p:nvSpPr>
-          <p:cNvPr id="73" name="TextBox 72"/>
-          <p:cNvSpPr txBox="1"/>
-          <p:nvPr/>
-        </p:nvSpPr>
-        <p:spPr>
-          <a:xfrm>
-            <a:off x="7318857" y="3351275"/>
-            <a:ext cx="1078077" cy="134112"/>
-          </a:xfrm>
-          <a:prstGeom prst="rect">
-            <a:avLst/>
-          </a:prstGeom>
-          <a:noFill/>
-        </p:spPr>
-        <p:txBody>
-          <a:bodyPr wrap="square" lIns="0" rIns="0" tIns="0" bIns="0" anchor="t">
-            <a:noAutofit/>
-          </a:bodyPr>
-          <a:lstStyle/>
-          <a:p>
-            <a:pPr algn="l">
-              <a:lnSpc>
-                <a:spcPts val="1056"/>
-              </a:lnSpc>
-            </a:pPr>
-            <a:r>
-              <a:rPr sz="800" b="1">
-                <a:solidFill>
-                  <a:srgbClr val="15795F"/>
-                </a:solidFill>
-                <a:latin typeface="Kanit"/>
-              </a:rPr>
-              <a:t>เทียบปีก่อน +23.1%</a:t>
-            </a:r>
-          </a:p>
-        </p:txBody>
-      </p:sp>
-      <p:sp>
-        <p:nvSpPr>
-          <p:cNvPr id="74" name="TextBox 73"/>
-          <p:cNvSpPr txBox="1"/>
-          <p:nvPr/>
-        </p:nvSpPr>
-        <p:spPr>
-          <a:xfrm>
-            <a:off x="8396935" y="3351275"/>
-            <a:ext cx="1078077" cy="134112"/>
-          </a:xfrm>
-          <a:prstGeom prst="rect">
-            <a:avLst/>
-          </a:prstGeom>
-          <a:noFill/>
-        </p:spPr>
-        <p:txBody>
-          <a:bodyPr wrap="square" lIns="0" rIns="0" tIns="0" bIns="0" anchor="t">
-            <a:noAutofit/>
-          </a:bodyPr>
-          <a:lstStyle/>
-          <a:p>
-            <a:pPr algn="l">
-              <a:lnSpc>
-                <a:spcPts val="1056"/>
-              </a:lnSpc>
-            </a:pPr>
-            <a:r>
-              <a:rPr sz="800" b="1">
-                <a:solidFill>
-                  <a:srgbClr val="15795F"/>
-                </a:solidFill>
-                <a:latin typeface="Kanit"/>
-              </a:rPr>
-              <a:t>6 เดือน +16.2%</a:t>
-            </a:r>
-          </a:p>
-        </p:txBody>
-      </p:sp>
-      <p:sp>
-        <p:nvSpPr>
-          <p:cNvPr id="75" name="Rectangle 74"/>
-          <p:cNvSpPr/>
-          <p:nvPr/>
-        </p:nvSpPr>
-        <p:spPr>
-          <a:xfrm>
-            <a:off x="7318857" y="3506724"/>
-            <a:ext cx="2156155" cy="548640"/>
-          </a:xfrm>
-          <a:prstGeom prst="rect">
-            <a:avLst/>
-          </a:prstGeom>
-          <a:solidFill>
-            <a:srgbClr val="FBFCFE"/>
-          </a:solidFill>
-          <a:ln w="9525">
-            <a:solidFill>
-              <a:srgbClr val="D9DEE9"/>
-            </a:solidFill>
-          </a:ln>
-          <a:effectLst/>
-        </p:spPr>
-        <p:style>
-          <a:lnRef idx="1">
-            <a:schemeClr val="accent1"/>
-          </a:lnRef>
-          <a:fillRef idx="3">
-            <a:schemeClr val="accent1"/>
-          </a:fillRef>
-          <a:effectRef idx="2">
-            <a:schemeClr val="accent1"/>
-          </a:effectRef>
-          <a:fontRef idx="minor">
-            <a:schemeClr val="lt1"/>
-          </a:fontRef>
-        </p:style>
-        <p:txBody>
-          <a:bodyPr rtlCol="0" anchor="ctr" wrap="none"/>
-          <a:lstStyle/>
-          <a:p>
-            <a:pPr algn="ctr"/>
-          </a:p>
-        </p:txBody>
-      </p:sp>
-      <p:sp>
-        <p:nvSpPr>
-          <p:cNvPr id="76" name="Freeform 75"/>
-          <p:cNvSpPr/>
-          <p:nvPr/>
-        </p:nvSpPr>
-        <p:spPr>
-          <a:xfrm>
-            <a:off x="7364577" y="3552444"/>
-            <a:ext cx="2064715" cy="457200"/>
-          </a:xfrm>
-          <a:custGeom>
-            <a:avLst/>
-            <a:gdLst/>
-            <a:ahLst/>
-            <a:cxnLst/>
-            <a:rect l="l" t="t" r="r" b="b"/>
-            <a:pathLst>
-              <a:path w="2064715" h="457200">
-                <a:moveTo>
-                  <a:pt x="0" y="439749"/>
-                </a:moveTo>
-                <a:lnTo>
-                  <a:pt x="412943" y="457200"/>
-                </a:lnTo>
-                <a:lnTo>
-                  <a:pt x="825886" y="293166"/>
-                </a:lnTo>
-                <a:lnTo>
-                  <a:pt x="1238829" y="76781"/>
-                </a:lnTo>
-                <a:lnTo>
-                  <a:pt x="1651772" y="0"/>
-                </a:lnTo>
-                <a:lnTo>
-                  <a:pt x="2064715" y="45370"/>
-                </a:lnTo>
-              </a:path>
-            </a:pathLst>
-          </a:custGeom>
-          <a:noFill/>
-          <a:ln w="20320">
-            <a:solidFill>
-              <a:srgbClr val="15795F"/>
-            </a:solidFill>
-          </a:ln>
-          <a:effectLst/>
-        </p:spPr>
-        <p:style>
-          <a:lnRef idx="1">
-            <a:schemeClr val="accent1"/>
-          </a:lnRef>
-          <a:fillRef idx="3">
-            <a:schemeClr val="accent1"/>
-          </a:fillRef>
-          <a:effectRef idx="2">
-            <a:schemeClr val="accent1"/>
-          </a:effectRef>
-          <a:fontRef idx="minor">
-            <a:schemeClr val="lt1"/>
-          </a:fontRef>
-        </p:style>
-        <p:txBody>
-          <a:bodyPr rtlCol="0" anchor="ctr"/>
-          <a:lstStyle/>
-          <a:p>
-            <a:pPr algn="ctr"/>
-          </a:p>
-        </p:txBody>
-      </p:sp>
-      <p:sp>
-        <p:nvSpPr>
           <p:cNvPr id="77" name="Rounded Rectangle 76"/>
           <p:cNvSpPr/>
           <p:nvPr/>
         </p:nvSpPr>
         <p:spPr>
           <a:xfrm>
-            <a:off x="9388144" y="3556666"/>
+            <a:off x="9388144" y="3511296"/>
             <a:ext cx="82296" cy="82296"/>
           </a:xfrm>
           <a:prstGeom prst="roundRect">
@@ -50886,7 +50886,7 @@
                 </a:solidFill>
                 <a:latin typeface="Kanit"/>
               </a:rPr>
-              <a:t>เทียบปีก่อน +39.8%</a:t>
+              <a:t>เทียบปีก่อน +40.3%</a:t>
             </a:r>
           </a:p>
         </p:txBody>
@@ -51204,7 +51204,7 @@
                 </a:solidFill>
                 <a:latin typeface="Kanit"/>
               </a:rPr>
-              <a:t>เทียบปีก่อน +75.9%</a:t>
+              <a:t>เทียบปีก่อน +76.3%</a:t>
             </a:r>
           </a:p>
         </p:txBody>
@@ -51522,7 +51522,7 @@
                 </a:solidFill>
                 <a:latin typeface="Kanit"/>
               </a:rPr>
-              <a:t>เทียบปีก่อน +181.0%</a:t>
+              <a:t>เทียบปีก่อน +114.6%</a:t>
             </a:r>
           </a:p>
         </p:txBody>
@@ -51886,7 +51886,7 @@
                 </a:solidFill>
                 <a:latin typeface="Kanit"/>
               </a:rPr>
-              <a:t>ราคาหน้าฟาร์ม วัดจริง — ราคารายวันของ NABC เฉลี่ยเป็นรายเดือน หน่วยเป็นบาทตามที่เผยแพร่ (ไม่มีการแปลงสกุลเงิน) ราคาล่าสุด 2026-09-07, รุ่นข้อมูลย้อนหลัง 2026-09-05 ราคาหน้าฟาร์ม (ราคาที่เกษตรกรขายได้) คือเงินที่เกษตรกรได้รับเมื่อขายครั้งแรก ก่อนพ่อค้าคนกลาง โรงสี หรือค่าขนส่งจะหักส่วนแบ่ง — ไม่ใช่ดัชนีโลก และไม่ใช่ราคาในซูเปอร์มาร์เก็ต แหล่งผลิตเป็นการอ่านแบบ ประมาณการ ว่าสินค้าแต่ละชนิดผลิตที่ไหน และทับซ้อนกันได้ น้ำตาลเป็นราคาอ้อยประกาศของ สอน. ปีละหนึ่งจุด จึงไม่มีการเปลี่ยนแปลงหกเดือนให้แสดง</a:t>
+              <a:t>ราคาหน้าฟาร์ม วัดจริง — ราคารายวันของ NABC เฉลี่ยเป็นรายเดือน หน่วยเป็นบาทตามที่เผยแพร่ (ไม่มีการแปลงสกุลเงิน) ราคาล่าสุด 2026-09-09, รุ่นข้อมูลย้อนหลัง 2026-09-05 ราคาหน้าฟาร์ม (ราคาที่เกษตรกรขายได้) คือเงินที่เกษตรกรได้รับเมื่อขายครั้งแรก ก่อนพ่อค้าคนกลาง โรงสี หรือค่าขนส่งจะหักส่วนแบ่ง — ไม่ใช่ดัชนีโลก และไม่ใช่ราคาในซูเปอร์มาร์เก็ต แหล่งผลิตเป็นการอ่านแบบ ประมาณการ ว่าสินค้าแต่ละชนิดผลิตที่ไหน และทับซ้อนกันได้ น้ำตาลเป็นราคาอ้อยประกาศของ สอน. ปีละหนึ่งจุด จึงไม่มีการเปลี่ยนแปลงหกเดือนให้แสดง</a:t>
             </a:r>
           </a:p>
         </p:txBody>

</xml_diff>

<commit_message>
deck(mcom): rebuild — the data moved past the committed figures (run 34339974852) (#887)
Co-authored-by: github-actions[bot] <41898282+github-actions[bot]@users.noreply.github.com>
</commit_message>
<xml_diff>
--- a/docs/decks/mcom-2026-08-05-macro-TH.pptx
+++ b/docs/decks/mcom-2026-08-05-macro-TH.pptx
@@ -6240,7 +6240,7 @@
                 </a:solidFill>
                 <a:latin typeface="Kanit"/>
               </a:rPr>
-              <a:t>129</a:t>
+              <a:t>132</a:t>
             </a:r>
           </a:p>
         </p:txBody>
@@ -6279,7 +6279,7 @@
                 </a:solidFill>
                 <a:latin typeface="Kanit"/>
               </a:rPr>
-              <a:t>จาก 790 (16.3%) · เรียลไทม์ · 2026-09-08</a:t>
+              <a:t>จาก 787 (16.8%) · เรียลไทม์ · 2026-09-09</a:t>
             </a:r>
           </a:p>
         </p:txBody>
@@ -6405,7 +6405,7 @@
                 </a:solidFill>
                 <a:latin typeface="Kanit"/>
               </a:rPr>
-              <a:t>32</a:t>
+              <a:t>34</a:t>
             </a:r>
           </a:p>
         </p:txBody>
@@ -6444,7 +6444,7 @@
                 </a:solidFill>
                 <a:latin typeface="Kanit"/>
               </a:rPr>
-              <a:t>ค่าล่าสุดรายวัน · 2026-09-08</a:t>
+              <a:t>ค่าล่าสุดรายวัน · 2026-09-09</a:t>
             </a:r>
           </a:p>
         </p:txBody>
@@ -7905,7 +7905,7 @@
                           </a:solidFill>
                           <a:latin typeface="Kanit"/>
                         </a:rPr>
-                        <a:t>38</a:t>
+                        <a:t>37</a:t>
                       </a:r>
                     </a:p>
                   </a:txBody>
@@ -7928,7 +7928,7 @@
                           </a:solidFill>
                           <a:latin typeface="Kanit"/>
                         </a:rPr>
-                        <a:t>33</a:t>
+                        <a:t>65</a:t>
                       </a:r>
                     </a:p>
                   </a:txBody>
@@ -7947,11 +7947,11 @@
                       <a:r>
                         <a:rPr sz="900" b="1">
                           <a:solidFill>
-                            <a:srgbClr val="606060"/>
-                          </a:solidFill>
-                          <a:latin typeface="Kanit"/>
-                        </a:rPr>
-                        <a:t>0.0%</a:t>
+                            <a:srgbClr val="F5C242"/>
+                          </a:solidFill>
+                          <a:latin typeface="Kanit"/>
+                        </a:rPr>
+                        <a:t>16.2%</a:t>
                       </a:r>
                     </a:p>
                   </a:txBody>
@@ -8022,7 +8022,7 @@
                           </a:solidFill>
                           <a:latin typeface="Kanit"/>
                         </a:rPr>
-                        <a:t>อุทัยธานี</a:t>
+                        <a:t>สมุทรปราการ</a:t>
                       </a:r>
                     </a:p>
                   </a:txBody>
@@ -8045,7 +8045,7 @@
                           </a:solidFill>
                           <a:latin typeface="Kanit"/>
                         </a:rPr>
-                        <a:t>45</a:t>
+                        <a:t>15</a:t>
                       </a:r>
                     </a:p>
                   </a:txBody>
@@ -8068,7 +8068,7 @@
                           </a:solidFill>
                           <a:latin typeface="Kanit"/>
                         </a:rPr>
-                        <a:t>19</a:t>
+                        <a:t>2</a:t>
                       </a:r>
                     </a:p>
                   </a:txBody>
@@ -8114,7 +8114,7 @@
                           </a:solidFill>
                           <a:latin typeface="Kanit"/>
                         </a:rPr>
-                        <a:t>1/4</a:t>
+                        <a:t>4/4</a:t>
                       </a:r>
                     </a:p>
                   </a:txBody>
@@ -8162,7 +8162,7 @@
                           </a:solidFill>
                           <a:latin typeface="Kanit"/>
                         </a:rPr>
-                        <a:t>ยโสธร</a:t>
+                        <a:t>บึงกาฬ</a:t>
                       </a:r>
                     </a:p>
                   </a:txBody>
@@ -8185,7 +8185,7 @@
                           </a:solidFill>
                           <a:latin typeface="Kanit"/>
                         </a:rPr>
-                        <a:t>14</a:t>
+                        <a:t>11</a:t>
                       </a:r>
                     </a:p>
                   </a:txBody>
@@ -8208,7 +8208,7 @@
                           </a:solidFill>
                           <a:latin typeface="Kanit"/>
                         </a:rPr>
-                        <a:t>88</a:t>
+                        <a:t>150</a:t>
                       </a:r>
                     </a:p>
                   </a:txBody>
@@ -8231,7 +8231,7 @@
                           </a:solidFill>
                           <a:latin typeface="Kanit"/>
                         </a:rPr>
-                        <a:t>21.4%</a:t>
+                        <a:t>54.5%</a:t>
                       </a:r>
                     </a:p>
                   </a:txBody>
@@ -8254,7 +8254,7 @@
                           </a:solidFill>
                           <a:latin typeface="Kanit"/>
                         </a:rPr>
-                        <a:t>3/5</a:t>
+                        <a:t>1/1</a:t>
                       </a:r>
                     </a:p>
                   </a:txBody>
@@ -8302,7 +8302,7 @@
                           </a:solidFill>
                           <a:latin typeface="Kanit"/>
                         </a:rPr>
-                        <a:t>ลำพูน</a:t>
+                        <a:t>หนองบัวลำภู</a:t>
                       </a:r>
                     </a:p>
                   </a:txBody>
@@ -8325,7 +8325,7 @@
                           </a:solidFill>
                           <a:latin typeface="Kanit"/>
                         </a:rPr>
-                        <a:t>76</a:t>
+                        <a:t>30</a:t>
                       </a:r>
                     </a:p>
                   </a:txBody>
@@ -8348,7 +8348,7 @@
                           </a:solidFill>
                           <a:latin typeface="Kanit"/>
                         </a:rPr>
-                        <a:t>70</a:t>
+                        <a:t>98</a:t>
                       </a:r>
                     </a:p>
                   </a:txBody>
@@ -8371,7 +8371,7 @@
                           </a:solidFill>
                           <a:latin typeface="Kanit"/>
                         </a:rPr>
-                        <a:t>10.5%</a:t>
+                        <a:t>26.7%</a:t>
                       </a:r>
                     </a:p>
                   </a:txBody>
@@ -8394,7 +8394,7 @@
                           </a:solidFill>
                           <a:latin typeface="Kanit"/>
                         </a:rPr>
-                        <a:t>1/11</a:t>
+                        <a:t>2/3</a:t>
                       </a:r>
                     </a:p>
                   </a:txBody>
@@ -8442,7 +8442,7 @@
                           </a:solidFill>
                           <a:latin typeface="Kanit"/>
                         </a:rPr>
-                        <a:t>บึงกาฬ</a:t>
+                        <a:t>ชุมพร</a:t>
                       </a:r>
                     </a:p>
                   </a:txBody>
@@ -8465,7 +8465,7 @@
                           </a:solidFill>
                           <a:latin typeface="Kanit"/>
                         </a:rPr>
-                        <a:t>11</a:t>
+                        <a:t>92</a:t>
                       </a:r>
                     </a:p>
                   </a:txBody>
@@ -8488,7 +8488,7 @@
                           </a:solidFill>
                           <a:latin typeface="Kanit"/>
                         </a:rPr>
-                        <a:t>56</a:t>
+                        <a:t>80</a:t>
                       </a:r>
                     </a:p>
                   </a:txBody>
@@ -8511,7 +8511,7 @@
                           </a:solidFill>
                           <a:latin typeface="Kanit"/>
                         </a:rPr>
-                        <a:t>9.1%</a:t>
+                        <a:t>16.3%</a:t>
                       </a:r>
                     </a:p>
                   </a:txBody>
@@ -8534,7 +8534,7 @@
                           </a:solidFill>
                           <a:latin typeface="Kanit"/>
                         </a:rPr>
-                        <a:t>1/1</a:t>
+                        <a:t>2/14</a:t>
                       </a:r>
                     </a:p>
                   </a:txBody>
@@ -8582,7 +8582,7 @@
                           </a:solidFill>
                           <a:latin typeface="Kanit"/>
                         </a:rPr>
-                        <a:t>พะเยา</a:t>
+                        <a:t>อุดรธานี</a:t>
                       </a:r>
                     </a:p>
                   </a:txBody>
@@ -8605,7 +8605,7 @@
                           </a:solidFill>
                           <a:latin typeface="Kanit"/>
                         </a:rPr>
-                        <a:t>125</a:t>
+                        <a:t>35</a:t>
                       </a:r>
                     </a:p>
                   </a:txBody>
@@ -8628,7 +8628,7 @@
                           </a:solidFill>
                           <a:latin typeface="Kanit"/>
                         </a:rPr>
-                        <a:t>96</a:t>
+                        <a:t>127</a:t>
                       </a:r>
                     </a:p>
                   </a:txBody>
@@ -8651,7 +8651,7 @@
                           </a:solidFill>
                           <a:latin typeface="Kanit"/>
                         </a:rPr>
-                        <a:t>8.8%</a:t>
+                        <a:t>14.3%</a:t>
                       </a:r>
                     </a:p>
                   </a:txBody>
@@ -8674,7 +8674,7 @@
                           </a:solidFill>
                           <a:latin typeface="Kanit"/>
                         </a:rPr>
-                        <a:t>3/13</a:t>
+                        <a:t>3/7</a:t>
                       </a:r>
                     </a:p>
                   </a:txBody>
@@ -8909,7 +8909,7 @@
                 </a:solidFill>
                 <a:latin typeface="Kanit"/>
               </a:rPr>
-              <a:t>พื้นที่ปลูก วัดจริง (สศก. — ข้อมูลอำเภอ×พืช 3,295 แถว) ภัยแล้งเป็นดัชนี SPEI จาก แบบจำลอง คำนวณจากปริมาณฝนและการคายระเหย ปรับเดือนละครั้ง ดึงข้อมูล 2026-07-20 — เป็นสัญญาณที่ครอบคลุมทั้งประเทศดีที่สุดที่มี แต่ไม่มีใครลงพื้นที่ไปเดินดูอำเภอเหล่านั้น ข้อมูลฝนและระดับน้ำ วัดจริง (ThaiWater เรียลไทม์ ดึงทุกวันและสะสมไว้ — วันที่ดึงไม่สำเร็จจะเว้นเป็นช่องว่าง ไม่ใส่ค่าสมมติ) · ฝนถึง 2026-09-08, ระดับน้ำถึง 2026-09-08 ความเสี่ยงน้ำท่วมเชิงโครงสร้าง วัดจริง (สำมะโนพื้นที่ท่วมซ้ำซาก GISTDA มาตราส่วน 1:50,000 ปี 2005-2016 — เป็นบันทึกภาคพื้นดิน 12 ปี ไม่ใช่การพยากรณ์)</a:t>
+              <a:t>พื้นที่ปลูก วัดจริง (สศก. — ข้อมูลอำเภอ×พืช 3,295 แถว) ภัยแล้งเป็นดัชนี SPEI จาก แบบจำลอง คำนวณจากปริมาณฝนและการคายระเหย ปรับเดือนละครั้ง ดึงข้อมูล 2026-07-20 — เป็นสัญญาณที่ครอบคลุมทั้งประเทศดีที่สุดที่มี แต่ไม่มีใครลงพื้นที่ไปเดินดูอำเภอเหล่านั้น ข้อมูลฝนและระดับน้ำ วัดจริง (ThaiWater เรียลไทม์ ดึงทุกวันและสะสมไว้ — วันที่ดึงไม่สำเร็จจะเว้นเป็นช่องว่าง ไม่ใส่ค่าสมมติ) · ฝนถึง 2026-09-09, ระดับน้ำถึง 2026-09-09 ความเสี่ยงน้ำท่วมเชิงโครงสร้าง วัดจริง (สำมะโนพื้นที่ท่วมซ้ำซาก GISTDA มาตราส่วน 1:50,000 ปี 2005-2016 — เป็นบันทึกภาคพื้นดิน 12 ปี ไม่ใช่การพยากรณ์)</a:t>
             </a:r>
           </a:p>
         </p:txBody>
@@ -31476,7 +31476,7 @@
                 </a:solidFill>
                 <a:latin typeface="Kanit"/>
               </a:rPr>
-              <a:t>รายได้จากพืชค่ากลางเพิ่มขึ้น +15.9% แต่มีสี่จังหวัดที่ลดลง — ทั้งหมดอยู่ในแหล่งปลูกมะพร้าว โดยหนักที่สุดคือสมุทรสงครามที่ −64.2%</a:t>
+              <a:t>รายได้จากพืชค่ากลางเพิ่มขึ้น +15.6% แต่มีสี่จังหวัดที่ลดลง — ทั้งหมดอยู่ในแหล่งปลูกมะพร้าว โดยหนักที่สุดคือสมุทรสงครามที่ −64.3%</a:t>
             </a:r>
           </a:p>
         </p:txBody>
@@ -32047,7 +32047,7 @@
                 </a:solidFill>
                 <a:latin typeface="Kanit"/>
               </a:rPr>
-              <a:t>รุ่นข้อมูล — ราคาโลก 2026M06 · ราคาหน้าฟาร์มไทย 2026-09-07 · ประวัติราคาไทย 2026-09-05 · ต้นทุนการผลิตพืช สศก. ไจอัป 2568 (ปีเพาะปลูก 2568/69, ประมาณการ สศก. มี.ค. 2569) · ภัยแล้ง 2026-06-21 · เงินเฟ้อ 2026-05 · GDP 2026 ไตรมาส 1 · IMF WEO 2026 · ดัชนีราคาขายต่อ 2026-05 · ยอดจดทะเบียนถึง 2026-01 · หนี้ครัวเรือน สสช. SES 2566 · ค่าจ้าง สสช. LFS 2568 · ข้อมูลตรวจวัด 2026-09-08</a:t>
+              <a:t>รุ่นข้อมูล — ราคาโลก 2026M06 · ราคาหน้าฟาร์มไทย 2026-09-09 · ประวัติราคาไทย 2026-09-05 · ต้นทุนการผลิตพืช สศก. ไจอัป 2568 (ปีเพาะปลูก 2568/69, ประมาณการ สศก. มี.ค. 2569) · ภัยแล้ง 2026-06-21 · เงินเฟ้อ 2026-05 · GDP 2026 ไตรมาส 1 · IMF WEO 2026 · ดัชนีราคาขายต่อ 2026-05 · ยอดจดทะเบียนถึง 2026-01 · หนี้ครัวเรือน สสช. SES 2566 · ค่าจ้าง สสช. LFS 2568 · ข้อมูลตรวจวัด 2026-09-09</a:t>
             </a:r>
           </a:p>
         </p:txBody>
@@ -32546,7 +32546,7 @@
               <a:t>Not on the world index — the farm gate (ราคาที่เกษตรกรขายได้) says otherwise.
 • Five of seventeen Thai farm-gate prices are falling year on year.
 • Beef: farm gate −6.1% vs world index +8.8%.
-• Margin over price: a 26% price move becomes an 83% swing in crop income.</a:t>
+• Margin over price: a 26% price move becomes an 82% swing in crop income.</a:t>
             </a:r>
           </a:p>
         </p:txBody>
@@ -33912,7 +33912,7 @@
                 </a:solidFill>
                 <a:latin typeface="Kanit"/>
               </a:rPr>
-              <a:t>32.92</a:t>
+              <a:t>32.90</a:t>
             </a:r>
           </a:p>
         </p:txBody>
@@ -33951,7 +33951,7 @@
                 </a:solidFill>
                 <a:latin typeface="Kanit"/>
               </a:rPr>
-              <a:t>อัตราอ้างอิง ECB · 2026-09-04</a:t>
+              <a:t>อัตราอ้างอิง ECB · 2026-09-07</a:t>
             </a:r>
           </a:p>
         </p:txBody>
@@ -35798,7 +35798,7 @@
                 </a:solidFill>
                 <a:latin typeface="Kanit"/>
               </a:rPr>
-              <a:t>สศช. 2026 ไตรมาส 1 · TPSO 2026-05 · ธนาคารแห่งประเทศไทย 2026-08 · BIS 2025 ไตรมาส 4 · ECB 2026-09-04, ทั้งหมดดึงจากหน่วยงานผู้เผยแพร่โดยตรง ตารางเทียบประเทศใช้ IMF World Economic Outlook 2026 (ดึงข้อมูล 2026-07-25) อัตรา NPL ที่ ธปท. เผยแพร่ — 4.48% ณ 2026 ไตรมาส 1, จาก 4.33% ไตรมาสก่อน เปลี่ยน +0.24 จุดใน 1 ปี และต่ำสุด 3.08% ณ 2021 ไตรมาส 1</a:t>
+              <a:t>สศช. 2026 ไตรมาส 1 · TPSO 2026-05 · ธนาคารแห่งประเทศไทย 2026-08 · BIS 2025 ไตรมาส 4 · ECB 2026-09-07, ทั้งหมดดึงจากหน่วยงานผู้เผยแพร่โดยตรง ตารางเทียบประเทศใช้ IMF World Economic Outlook 2026 (ดึงข้อมูล 2026-07-25) อัตรา NPL ที่ ธปท. เผยแพร่ — 4.48% ณ 2026 ไตรมาส 1, จาก 4.33% ไตรมาสก่อน เปลี่ยน +0.24 จุดใน 1 ปี และต่ำสุด 3.08% ณ 2021 ไตรมาส 1</a:t>
             </a:r>
           </a:p>
         </p:txBody>
@@ -37087,7 +37087,7 @@
                 </a:solidFill>
                 <a:latin typeface="Kanit"/>
               </a:rPr>
-              <a:t>338 จาก 928 อำเภอ · แม่น้ำเกินระดับ 129 จาก 790 สถานี</a:t>
+              <a:t>338 จาก 928 อำเภอ · แม่น้ำเกินระดับ 132 จาก 787 สถานี</a:t>
             </a:r>
           </a:p>
         </p:txBody>
@@ -37859,7 +37859,7 @@
                           </a:solidFill>
                           <a:latin typeface="Kanit"/>
                         </a:rPr>
-                        <a:t>30/155</a:t>
+                        <a:t>31/154</a:t>
                       </a:r>
                     </a:p>
                   </a:txBody>
@@ -38091,7 +38091,7 @@
                           </a:solidFill>
                           <a:latin typeface="Kanit"/>
                         </a:rPr>
-                        <a:t>18/274</a:t>
+                        <a:t>18/272</a:t>
                       </a:r>
                     </a:p>
                   </a:txBody>
@@ -38555,7 +38555,7 @@
                           </a:solidFill>
                           <a:latin typeface="Kanit"/>
                         </a:rPr>
-                        <a:t>14/51</a:t>
+                        <a:t>12/51</a:t>
                       </a:r>
                     </a:p>
                   </a:txBody>
@@ -38787,7 +38787,7 @@
                           </a:solidFill>
                           <a:latin typeface="Kanit"/>
                         </a:rPr>
-                        <a:t>41/143</a:t>
+                        <a:t>45/143</a:t>
                       </a:r>
                     </a:p>
                   </a:txBody>
@@ -39936,7 +39936,7 @@
                           </a:solidFill>
                           <a:latin typeface="Kanit"/>
                         </a:rPr>
-                        <a:t>−68.6%</a:t>
+                        <a:t>−68.7%</a:t>
                       </a:r>
                     </a:p>
                   </a:txBody>
@@ -40791,7 +40791,7 @@
                 </a:solidFill>
                 <a:latin typeface="Kanit"/>
               </a:rPr>
-              <a:t>ราคา วัดจริง — ราคาหน้าฟาร์มไทยจากราคารายวันของ NABC และราคาอ้อยประกาศของ สอน. ราคาล่าสุด 2026-09-07 การเปลี่ยนแปลงหกเดือนคำนวณจากข้อมูลรายเดือนของ NABC เอง (thai_price_history รุ่นข้อมูล 2026-09-05) พืชที่ไม่มีข้อมูลรายเดือนจะกำกับไว้ ไม่ประมาณการขึ้นมา แหล่งผลิตเป็นการอ่านแบบ ประมาณการ ว่าสินค้าแต่ละชนิดปลูกที่ไหน และแหล่งผลิตทับซ้อนกันได้ บัญชีอาชีพเกษตรเป็นข้อมูลของเราเองและ วัดจริง — บัญชีที่บันทึกอาชีพว่า เกษตร ในจังหวัดแหล่งผลิต จากฐานข้อมูล 382,735 บัญชี ณ 2026-07 ไม่เผยแพร่ช่องที่มีน้อยกว่า 30 บัญชี คนกลุ่มนี้อาศัยอยู่ในพื้นที่ที่ปลูกพืชนั้น แต่ไม่ได้ยืนยันว่าปลูกพืชนั้นเอง</a:t>
+              <a:t>ราคา วัดจริง — ราคาหน้าฟาร์มไทยจากราคารายวันของ NABC และราคาอ้อยประกาศของ สอน. ราคาล่าสุด 2026-09-09 การเปลี่ยนแปลงหกเดือนคำนวณจากข้อมูลรายเดือนของ NABC เอง (thai_price_history รุ่นข้อมูล 2026-09-05) พืชที่ไม่มีข้อมูลรายเดือนจะกำกับไว้ ไม่ประมาณการขึ้นมา แหล่งผลิตเป็นการอ่านแบบ ประมาณการ ว่าสินค้าแต่ละชนิดปลูกที่ไหน และแหล่งผลิตทับซ้อนกันได้ บัญชีอาชีพเกษตรเป็นข้อมูลของเราเองและ วัดจริง — บัญชีที่บันทึกอาชีพว่า เกษตร ในจังหวัดแหล่งผลิต จากฐานข้อมูล 382,735 บัญชี ณ 2026-07 ไม่เผยแพร่ช่องที่มีน้อยกว่า 30 บัญชี คนกลุ่มนี้อาศัยอยู่ในพื้นที่ที่ปลูกพืชนั้น แต่ไม่ได้ยืนยันว่าปลูกพืชนั้นเอง</a:t>
             </a:r>
           </a:p>
         </p:txBody>
@@ -43419,7 +43419,7 @@
                           </a:solidFill>
                           <a:latin typeface="Kanit"/>
                         </a:rPr>
-                        <a:t>91.52</a:t>
+                        <a:t>91.45</a:t>
                       </a:r>
                     </a:p>
                   </a:txBody>
@@ -43559,7 +43559,7 @@
                           </a:solidFill>
                           <a:latin typeface="Kanit"/>
                         </a:rPr>
-                        <a:t>15,374</a:t>
+                        <a:t>15,362</a:t>
                       </a:r>
                     </a:p>
                   </a:txBody>
@@ -43699,7 +43699,7 @@
                           </a:solidFill>
                           <a:latin typeface="Kanit"/>
                         </a:rPr>
-                        <a:t>36,245</a:t>
+                        <a:t>36,217</a:t>
                       </a:r>
                     </a:p>
                   </a:txBody>
@@ -43839,7 +43839,7 @@
                           </a:solidFill>
                           <a:latin typeface="Kanit"/>
                         </a:rPr>
-                        <a:t>11.19</a:t>
+                        <a:t>11.18</a:t>
                       </a:r>
                     </a:p>
                   </a:txBody>
@@ -44058,7 +44058,7 @@
                 </a:solidFill>
                 <a:latin typeface="Kanit"/>
               </a:rPr>
-              <a:t>ราคารายเดือนสกุลดอลลาร์ราคาปัจจุบันจาก World Bank Pink Sheet รุ่นข้อมูล 2026M07 (ข้อมูล 60 จุดต่อรายการ ปรับฐานเป็น 100 ณ 2021-07 เพื่อวาดกราฟ — หน่วยต่างกัน จึงใช้แกนเดียวกับระดับราคาดิบไม่ได้) แปลงเป็นบาทด้วยอัตราอ้างอิง ECB USD/THB 32.920 ณ 2026-09-04 สัดส่วนพื้นที่ปลูก วัดจริง จากสัดส่วนพืชของ สศก./กรมส่งเสริมการเกษตร (crop_mix.json) เป็นราคาปัจจุบัน ไม่ได้ปรับเงินเฟ้อ: ทุกตัวเลข ‘เทียบ 5 ปีก่อน’ มีเงินเฟ้อไทยห้าปีซ่อนอยู่ข้างใต้</a:t>
+              <a:t>ราคารายเดือนสกุลดอลลาร์ราคาปัจจุบันจาก World Bank Pink Sheet รุ่นข้อมูล 2026M07 (ข้อมูล 60 จุดต่อรายการ ปรับฐานเป็น 100 ณ 2021-07 เพื่อวาดกราฟ — หน่วยต่างกัน จึงใช้แกนเดียวกับระดับราคาดิบไม่ได้) แปลงเป็นบาทด้วยอัตราอ้างอิง ECB USD/THB 32.895 ณ 2026-09-07 สัดส่วนพื้นที่ปลูก วัดจริง จากสัดส่วนพืชของ สศก./กรมส่งเสริมการเกษตร (crop_mix.json) เป็นราคาปัจจุบัน ไม่ได้ปรับเงินเฟ้อ: ทุกตัวเลข ‘เทียบ 5 ปีก่อน’ มีเงินเฟ้อไทยห้าปีซ่อนอยู่ข้างใต้</a:t>
             </a:r>
           </a:p>
         </p:txBody>
@@ -44679,7 +44679,7 @@
                 </a:solidFill>
                 <a:latin typeface="Kanit"/>
               </a:rPr>
-              <a:t>มะพร้าว −68.6% สับปะรด −18.4% อ้อย −17.9% เทียบปีก่อน</a:t>
+              <a:t>มะพร้าว −68.7% สับปะรด −18.4% อ้อย −17.9% เทียบปีก่อน</a:t>
             </a:r>
           </a:p>
         </p:txBody>
@@ -44805,7 +44805,7 @@
                 </a:solidFill>
                 <a:latin typeface="Kanit"/>
               </a:rPr>
-              <a:t>+15.9%</a:t>
+              <a:t>+15.6%</a:t>
             </a:r>
           </a:p>
         </p:txBody>
@@ -45279,7 +45279,7 @@
                           </a:solidFill>
                           <a:latin typeface="Kanit"/>
                         </a:rPr>
-                        <a:t>+6.1%</a:t>
+                        <a:t>+5.7%</a:t>
                       </a:r>
                     </a:p>
                   </a:txBody>
@@ -45348,7 +45348,7 @@
                           </a:solidFill>
                           <a:latin typeface="Kanit"/>
                         </a:rPr>
-                        <a:t>-64.2%</a:t>
+                        <a:t>-64.3%</a:t>
                       </a:r>
                     </a:p>
                   </a:txBody>
@@ -45419,7 +45419,7 @@
                           </a:solidFill>
                           <a:latin typeface="Kanit"/>
                         </a:rPr>
-                        <a:t>+15.1%</a:t>
+                        <a:t>+14.8%</a:t>
                       </a:r>
                     </a:p>
                   </a:txBody>
@@ -45488,7 +45488,7 @@
                           </a:solidFill>
                           <a:latin typeface="Kanit"/>
                         </a:rPr>
-                        <a:t>+9.5%</a:t>
+                        <a:t>+9.2%</a:t>
                       </a:r>
                     </a:p>
                   </a:txBody>
@@ -45559,7 +45559,7 @@
                           </a:solidFill>
                           <a:latin typeface="Kanit"/>
                         </a:rPr>
-                        <a:t>+16.9%</a:t>
+                        <a:t>+16.6%</a:t>
                       </a:r>
                     </a:p>
                   </a:txBody>
@@ -45628,7 +45628,7 @@
                           </a:solidFill>
                           <a:latin typeface="Kanit"/>
                         </a:rPr>
-                        <a:t>+8.2%</a:t>
+                        <a:t>+8.0%</a:t>
                       </a:r>
                     </a:p>
                   </a:txBody>
@@ -45699,7 +45699,7 @@
                           </a:solidFill>
                           <a:latin typeface="Kanit"/>
                         </a:rPr>
-                        <a:t>+24.8%</a:t>
+                        <a:t>+25.0%</a:t>
                       </a:r>
                     </a:p>
                   </a:txBody>
@@ -45768,7 +45768,7 @@
                           </a:solidFill>
                           <a:latin typeface="Kanit"/>
                         </a:rPr>
-                        <a:t>+11.3%</a:t>
+                        <a:t>+11.1%</a:t>
                       </a:r>
                     </a:p>
                   </a:txBody>
@@ -45839,7 +45839,7 @@
                           </a:solidFill>
                           <a:latin typeface="Kanit"/>
                         </a:rPr>
-                        <a:t>+34.4%</a:t>
+                        <a:t>+34.8%</a:t>
                       </a:r>
                     </a:p>
                   </a:txBody>
@@ -45908,7 +45908,7 @@
                           </a:solidFill>
                           <a:latin typeface="Kanit"/>
                         </a:rPr>
-                        <a:t>+26.8%</a:t>
+                        <a:t>+27.2%</a:t>
                       </a:r>
                     </a:p>
                   </a:txBody>
@@ -46387,7 +46387,7 @@
                           </a:solidFill>
                           <a:latin typeface="Kanit"/>
                         </a:rPr>
-                        <a:t>+17.6%</a:t>
+                        <a:t>+17.3%</a:t>
                       </a:r>
                     </a:p>
                   </a:txBody>
@@ -46550,7 +46550,7 @@
                           </a:solidFill>
                           <a:latin typeface="Kanit"/>
                         </a:rPr>
-                        <a:t>+21.3%</a:t>
+                        <a:t>+21.0%</a:t>
                       </a:r>
                     </a:p>
                   </a:txBody>
@@ -46713,7 +46713,7 @@
                           </a:solidFill>
                           <a:latin typeface="Kanit"/>
                         </a:rPr>
-                        <a:t>+11.2%</a:t>
+                        <a:t>+10.9%</a:t>
                       </a:r>
                     </a:p>
                   </a:txBody>
@@ -46876,7 +46876,7 @@
                           </a:solidFill>
                           <a:latin typeface="Kanit"/>
                         </a:rPr>
-                        <a:t>+32.4%</a:t>
+                        <a:t>+32.8%</a:t>
                       </a:r>
                     </a:p>
                   </a:txBody>
@@ -47039,7 +47039,7 @@
                           </a:solidFill>
                           <a:latin typeface="Kanit"/>
                         </a:rPr>
-                        <a:t>+16.6%</a:t>
+                        <a:t>+16.3%</a:t>
                       </a:r>
                     </a:p>
                   </a:txBody>
@@ -47202,7 +47202,7 @@
                           </a:solidFill>
                           <a:latin typeface="Kanit"/>
                         </a:rPr>
-                        <a:t>+15.0%</a:t>
+                        <a:t>+14.6%</a:t>
                       </a:r>
                     </a:p>
                   </a:txBody>
@@ -48024,7 +48024,7 @@
                 </a:solidFill>
                 <a:latin typeface="Kanit"/>
               </a:rPr>
-              <a:t>เทียบปีก่อน −68.6%</a:t>
+              <a:t>เทียบปีก่อน −68.7%</a:t>
             </a:r>
           </a:p>
         </p:txBody>
@@ -48660,7 +48660,7 @@
                 </a:solidFill>
                 <a:latin typeface="Kanit"/>
               </a:rPr>
-              <a:t>เทียบปีก่อน +0.6%</a:t>
+              <a:t>เทียบปีก่อน +0.4%</a:t>
             </a:r>
           </a:p>
         </p:txBody>
@@ -48978,7 +48978,7 @@
                 </a:solidFill>
                 <a:latin typeface="Kanit"/>
               </a:rPr>
-              <a:t>เทียบปีก่อน +4.8%</a:t>
+              <a:t>เทียบปีก่อน +5.1%</a:t>
             </a:r>
           </a:p>
         </p:txBody>
@@ -49296,7 +49296,7 @@
                 </a:solidFill>
                 <a:latin typeface="Kanit"/>
               </a:rPr>
-              <a:t>เทียบปีก่อน +6.8%</a:t>
+              <a:t>เทียบปีก่อน +7.1%</a:t>
             </a:r>
           </a:p>
         </p:txBody>
@@ -49614,7 +49614,7 @@
                 </a:solidFill>
                 <a:latin typeface="Kanit"/>
               </a:rPr>
-              <a:t>เทียบปีก่อน +13.3%</a:t>
+              <a:t>เทียบปีก่อน +12.8%</a:t>
             </a:r>
           </a:p>
         </p:txBody>
@@ -49932,7 +49932,7 @@
                 </a:solidFill>
                 <a:latin typeface="Kanit"/>
               </a:rPr>
-              <a:t>เทียบปีก่อน +13.8%</a:t>
+              <a:t>เทียบปีก่อน +13.6%</a:t>
             </a:r>
           </a:p>
         </p:txBody>
@@ -50172,6 +50172,324 @@
                 </a:solidFill>
                 <a:latin typeface="Kanit"/>
               </a:rPr>
+              <a:t>ปาล์มน้ำมัน</a:t>
+            </a:r>
+          </a:p>
+        </p:txBody>
+      </p:sp>
+      <p:sp>
+        <p:nvSpPr>
+          <p:cNvPr id="65" name="TextBox 64"/>
+          <p:cNvSpPr txBox="1"/>
+          <p:nvPr/>
+        </p:nvSpPr>
+        <p:spPr>
+          <a:xfrm>
+            <a:off x="5016398" y="3218687"/>
+            <a:ext cx="2156155" cy="125730"/>
+          </a:xfrm>
+          <a:prstGeom prst="rect">
+            <a:avLst/>
+          </a:prstGeom>
+          <a:noFill/>
+        </p:spPr>
+        <p:txBody>
+          <a:bodyPr wrap="square" lIns="0" rIns="0" tIns="0" bIns="0" anchor="t">
+            <a:noAutofit/>
+          </a:bodyPr>
+          <a:lstStyle/>
+          <a:p>
+            <a:pPr algn="l">
+              <a:lnSpc>
+                <a:spcPts val="990"/>
+              </a:lnSpc>
+            </a:pPr>
+            <a:r>
+              <a:rPr sz="750" b="0">
+                <a:solidFill>
+                  <a:srgbClr val="606060"/>
+                </a:solidFill>
+                <a:latin typeface="Kanit"/>
+              </a:rPr>
+              <a:t>฿8.38 /กก. · ใต้</a:t>
+            </a:r>
+          </a:p>
+        </p:txBody>
+      </p:sp>
+      <p:sp>
+        <p:nvSpPr>
+          <p:cNvPr id="66" name="TextBox 65"/>
+          <p:cNvSpPr txBox="1"/>
+          <p:nvPr/>
+        </p:nvSpPr>
+        <p:spPr>
+          <a:xfrm>
+            <a:off x="5016398" y="3351275"/>
+            <a:ext cx="1078077" cy="134112"/>
+          </a:xfrm>
+          <a:prstGeom prst="rect">
+            <a:avLst/>
+          </a:prstGeom>
+          <a:noFill/>
+        </p:spPr>
+        <p:txBody>
+          <a:bodyPr wrap="square" lIns="0" rIns="0" tIns="0" bIns="0" anchor="t">
+            <a:noAutofit/>
+          </a:bodyPr>
+          <a:lstStyle/>
+          <a:p>
+            <a:pPr algn="l">
+              <a:lnSpc>
+                <a:spcPts val="1056"/>
+              </a:lnSpc>
+            </a:pPr>
+            <a:r>
+              <a:rPr sz="800" b="1">
+                <a:solidFill>
+                  <a:srgbClr val="15795F"/>
+                </a:solidFill>
+                <a:latin typeface="Kanit"/>
+              </a:rPr>
+              <a:t>เทียบปีก่อน +23.4%</a:t>
+            </a:r>
+          </a:p>
+        </p:txBody>
+      </p:sp>
+      <p:sp>
+        <p:nvSpPr>
+          <p:cNvPr id="67" name="TextBox 66"/>
+          <p:cNvSpPr txBox="1"/>
+          <p:nvPr/>
+        </p:nvSpPr>
+        <p:spPr>
+          <a:xfrm>
+            <a:off x="6094475" y="3351275"/>
+            <a:ext cx="1078077" cy="134112"/>
+          </a:xfrm>
+          <a:prstGeom prst="rect">
+            <a:avLst/>
+          </a:prstGeom>
+          <a:noFill/>
+        </p:spPr>
+        <p:txBody>
+          <a:bodyPr wrap="square" lIns="0" rIns="0" tIns="0" bIns="0" anchor="t">
+            <a:noAutofit/>
+          </a:bodyPr>
+          <a:lstStyle/>
+          <a:p>
+            <a:pPr algn="l">
+              <a:lnSpc>
+                <a:spcPts val="1056"/>
+              </a:lnSpc>
+            </a:pPr>
+            <a:r>
+              <a:rPr sz="800" b="1">
+                <a:solidFill>
+                  <a:srgbClr val="15795F"/>
+                </a:solidFill>
+                <a:latin typeface="Kanit"/>
+              </a:rPr>
+              <a:t>6 เดือน +16.2%</a:t>
+            </a:r>
+          </a:p>
+        </p:txBody>
+      </p:sp>
+      <p:sp>
+        <p:nvSpPr>
+          <p:cNvPr id="68" name="Rectangle 67"/>
+          <p:cNvSpPr/>
+          <p:nvPr/>
+        </p:nvSpPr>
+        <p:spPr>
+          <a:xfrm>
+            <a:off x="5016398" y="3506724"/>
+            <a:ext cx="2156155" cy="548640"/>
+          </a:xfrm>
+          <a:prstGeom prst="rect">
+            <a:avLst/>
+          </a:prstGeom>
+          <a:solidFill>
+            <a:srgbClr val="FBFCFE"/>
+          </a:solidFill>
+          <a:ln w="9525">
+            <a:solidFill>
+              <a:srgbClr val="D9DEE9"/>
+            </a:solidFill>
+          </a:ln>
+          <a:effectLst/>
+        </p:spPr>
+        <p:style>
+          <a:lnRef idx="1">
+            <a:schemeClr val="accent1"/>
+          </a:lnRef>
+          <a:fillRef idx="3">
+            <a:schemeClr val="accent1"/>
+          </a:fillRef>
+          <a:effectRef idx="2">
+            <a:schemeClr val="accent1"/>
+          </a:effectRef>
+          <a:fontRef idx="minor">
+            <a:schemeClr val="lt1"/>
+          </a:fontRef>
+        </p:style>
+        <p:txBody>
+          <a:bodyPr rtlCol="0" anchor="ctr" wrap="none"/>
+          <a:lstStyle/>
+          <a:p>
+            <a:pPr algn="ctr"/>
+          </a:p>
+        </p:txBody>
+      </p:sp>
+      <p:sp>
+        <p:nvSpPr>
+          <p:cNvPr id="69" name="Freeform 68"/>
+          <p:cNvSpPr/>
+          <p:nvPr/>
+        </p:nvSpPr>
+        <p:spPr>
+          <a:xfrm>
+            <a:off x="5062118" y="3552444"/>
+            <a:ext cx="2064715" cy="457200"/>
+          </a:xfrm>
+          <a:custGeom>
+            <a:avLst/>
+            <a:gdLst/>
+            <a:ahLst/>
+            <a:cxnLst/>
+            <a:rect l="l" t="t" r="r" b="b"/>
+            <a:pathLst>
+              <a:path w="2064715" h="457200">
+                <a:moveTo>
+                  <a:pt x="0" y="439749"/>
+                </a:moveTo>
+                <a:lnTo>
+                  <a:pt x="412943" y="457200"/>
+                </a:lnTo>
+                <a:lnTo>
+                  <a:pt x="825886" y="293166"/>
+                </a:lnTo>
+                <a:lnTo>
+                  <a:pt x="1238829" y="76781"/>
+                </a:lnTo>
+                <a:lnTo>
+                  <a:pt x="1651772" y="0"/>
+                </a:lnTo>
+                <a:lnTo>
+                  <a:pt x="2064715" y="45370"/>
+                </a:lnTo>
+              </a:path>
+            </a:pathLst>
+          </a:custGeom>
+          <a:noFill/>
+          <a:ln w="20320">
+            <a:solidFill>
+              <a:srgbClr val="15795F"/>
+            </a:solidFill>
+          </a:ln>
+          <a:effectLst/>
+        </p:spPr>
+        <p:style>
+          <a:lnRef idx="1">
+            <a:schemeClr val="accent1"/>
+          </a:lnRef>
+          <a:fillRef idx="3">
+            <a:schemeClr val="accent1"/>
+          </a:fillRef>
+          <a:effectRef idx="2">
+            <a:schemeClr val="accent1"/>
+          </a:effectRef>
+          <a:fontRef idx="minor">
+            <a:schemeClr val="lt1"/>
+          </a:fontRef>
+        </p:style>
+        <p:txBody>
+          <a:bodyPr rtlCol="0" anchor="ctr"/>
+          <a:lstStyle/>
+          <a:p>
+            <a:pPr algn="ctr"/>
+          </a:p>
+        </p:txBody>
+      </p:sp>
+      <p:sp>
+        <p:nvSpPr>
+          <p:cNvPr id="70" name="Rounded Rectangle 69"/>
+          <p:cNvSpPr/>
+          <p:nvPr/>
+        </p:nvSpPr>
+        <p:spPr>
+          <a:xfrm>
+            <a:off x="7085685" y="3556666"/>
+            <a:ext cx="82296" cy="82296"/>
+          </a:xfrm>
+          <a:prstGeom prst="roundRect">
+            <a:avLst>
+              <a:gd name="adj" fmla="val 50000"/>
+            </a:avLst>
+          </a:prstGeom>
+          <a:solidFill>
+            <a:srgbClr val="15795F"/>
+          </a:solidFill>
+          <a:ln>
+            <a:noFill/>
+          </a:ln>
+          <a:effectLst/>
+        </p:spPr>
+        <p:style>
+          <a:lnRef idx="1">
+            <a:schemeClr val="accent1"/>
+          </a:lnRef>
+          <a:fillRef idx="3">
+            <a:schemeClr val="accent1"/>
+          </a:fillRef>
+          <a:effectRef idx="2">
+            <a:schemeClr val="accent1"/>
+          </a:effectRef>
+          <a:fontRef idx="minor">
+            <a:schemeClr val="lt1"/>
+          </a:fontRef>
+        </p:style>
+        <p:txBody>
+          <a:bodyPr rtlCol="0" anchor="ctr" wrap="none"/>
+          <a:lstStyle/>
+          <a:p>
+            <a:pPr algn="ctr"/>
+          </a:p>
+        </p:txBody>
+      </p:sp>
+      <p:sp>
+        <p:nvSpPr>
+          <p:cNvPr id="71" name="TextBox 70"/>
+          <p:cNvSpPr txBox="1"/>
+          <p:nvPr/>
+        </p:nvSpPr>
+        <p:spPr>
+          <a:xfrm>
+            <a:off x="7318857" y="3076956"/>
+            <a:ext cx="2156155" cy="150876"/>
+          </a:xfrm>
+          <a:prstGeom prst="rect">
+            <a:avLst/>
+          </a:prstGeom>
+          <a:noFill/>
+        </p:spPr>
+        <p:txBody>
+          <a:bodyPr wrap="square" lIns="0" rIns="0" tIns="0" bIns="0" anchor="t">
+            <a:noAutofit/>
+          </a:bodyPr>
+          <a:lstStyle/>
+          <a:p>
+            <a:pPr algn="l">
+              <a:lnSpc>
+                <a:spcPts val="1188"/>
+              </a:lnSpc>
+            </a:pPr>
+            <a:r>
+              <a:rPr sz="900" b="1">
+                <a:solidFill>
+                  <a:srgbClr val="1E2F5C"/>
+                </a:solidFill>
+                <a:latin typeface="Kanit"/>
+              </a:rPr>
               <a:t>สุกร</a:t>
             </a:r>
           </a:p>
@@ -50179,13 +50497,13 @@
       </p:sp>
       <p:sp>
         <p:nvSpPr>
-          <p:cNvPr id="65" name="TextBox 64"/>
+          <p:cNvPr id="72" name="TextBox 71"/>
           <p:cNvSpPr txBox="1"/>
           <p:nvPr/>
         </p:nvSpPr>
         <p:spPr>
           <a:xfrm>
-            <a:off x="5016398" y="3218687"/>
+            <a:off x="7318857" y="3218687"/>
             <a:ext cx="2156155" cy="125730"/>
           </a:xfrm>
           <a:prstGeom prst="rect">
@@ -50218,13 +50536,13 @@
       </p:sp>
       <p:sp>
         <p:nvSpPr>
-          <p:cNvPr id="66" name="TextBox 65"/>
+          <p:cNvPr id="73" name="TextBox 72"/>
           <p:cNvSpPr txBox="1"/>
           <p:nvPr/>
         </p:nvSpPr>
         <p:spPr>
           <a:xfrm>
-            <a:off x="5016398" y="3351275"/>
+            <a:off x="7318857" y="3351275"/>
             <a:ext cx="1078077" cy="134112"/>
           </a:xfrm>
           <a:prstGeom prst="rect">
@@ -50250,20 +50568,20 @@
                 </a:solidFill>
                 <a:latin typeface="Kanit"/>
               </a:rPr>
-              <a:t>เทียบปีก่อน +21.8%</a:t>
+              <a:t>เทียบปีก่อน +24.2%</a:t>
             </a:r>
           </a:p>
         </p:txBody>
       </p:sp>
       <p:sp>
         <p:nvSpPr>
-          <p:cNvPr id="67" name="TextBox 66"/>
+          <p:cNvPr id="74" name="TextBox 73"/>
           <p:cNvSpPr txBox="1"/>
           <p:nvPr/>
         </p:nvSpPr>
         <p:spPr>
           <a:xfrm>
-            <a:off x="6094475" y="3351275"/>
+            <a:off x="8396935" y="3351275"/>
             <a:ext cx="1078077" cy="134112"/>
           </a:xfrm>
           <a:prstGeom prst="rect">
@@ -50296,13 +50614,13 @@
       </p:sp>
       <p:sp>
         <p:nvSpPr>
-          <p:cNvPr id="68" name="Rectangle 67"/>
+          <p:cNvPr id="75" name="Rectangle 74"/>
           <p:cNvSpPr/>
           <p:nvPr/>
         </p:nvSpPr>
         <p:spPr>
           <a:xfrm>
-            <a:off x="5016398" y="3506724"/>
+            <a:off x="7318857" y="3506724"/>
             <a:ext cx="2156155" cy="548640"/>
           </a:xfrm>
           <a:prstGeom prst="rect">
@@ -50342,13 +50660,13 @@
       </p:sp>
       <p:sp>
         <p:nvSpPr>
-          <p:cNvPr id="69" name="Freeform 68"/>
+          <p:cNvPr id="76" name="Freeform 75"/>
           <p:cNvSpPr/>
           <p:nvPr/>
         </p:nvSpPr>
         <p:spPr>
           <a:xfrm>
-            <a:off x="5062118" y="3552444"/>
+            <a:off x="7364577" y="3552444"/>
             <a:ext cx="2064715" cy="457200"/>
           </a:xfrm>
           <a:custGeom>
@@ -50412,331 +50730,13 @@
       </p:sp>
       <p:sp>
         <p:nvSpPr>
-          <p:cNvPr id="70" name="Rounded Rectangle 69"/>
-          <p:cNvSpPr/>
-          <p:nvPr/>
-        </p:nvSpPr>
-        <p:spPr>
-          <a:xfrm>
-            <a:off x="7085685" y="3511296"/>
-            <a:ext cx="82296" cy="82296"/>
-          </a:xfrm>
-          <a:prstGeom prst="roundRect">
-            <a:avLst>
-              <a:gd name="adj" fmla="val 50000"/>
-            </a:avLst>
-          </a:prstGeom>
-          <a:solidFill>
-            <a:srgbClr val="15795F"/>
-          </a:solidFill>
-          <a:ln>
-            <a:noFill/>
-          </a:ln>
-          <a:effectLst/>
-        </p:spPr>
-        <p:style>
-          <a:lnRef idx="1">
-            <a:schemeClr val="accent1"/>
-          </a:lnRef>
-          <a:fillRef idx="3">
-            <a:schemeClr val="accent1"/>
-          </a:fillRef>
-          <a:effectRef idx="2">
-            <a:schemeClr val="accent1"/>
-          </a:effectRef>
-          <a:fontRef idx="minor">
-            <a:schemeClr val="lt1"/>
-          </a:fontRef>
-        </p:style>
-        <p:txBody>
-          <a:bodyPr rtlCol="0" anchor="ctr" wrap="none"/>
-          <a:lstStyle/>
-          <a:p>
-            <a:pPr algn="ctr"/>
-          </a:p>
-        </p:txBody>
-      </p:sp>
-      <p:sp>
-        <p:nvSpPr>
-          <p:cNvPr id="71" name="TextBox 70"/>
-          <p:cNvSpPr txBox="1"/>
-          <p:nvPr/>
-        </p:nvSpPr>
-        <p:spPr>
-          <a:xfrm>
-            <a:off x="7318857" y="3076956"/>
-            <a:ext cx="2156155" cy="150876"/>
-          </a:xfrm>
-          <a:prstGeom prst="rect">
-            <a:avLst/>
-          </a:prstGeom>
-          <a:noFill/>
-        </p:spPr>
-        <p:txBody>
-          <a:bodyPr wrap="square" lIns="0" rIns="0" tIns="0" bIns="0" anchor="t">
-            <a:noAutofit/>
-          </a:bodyPr>
-          <a:lstStyle/>
-          <a:p>
-            <a:pPr algn="l">
-              <a:lnSpc>
-                <a:spcPts val="1188"/>
-              </a:lnSpc>
-            </a:pPr>
-            <a:r>
-              <a:rPr sz="900" b="1">
-                <a:solidFill>
-                  <a:srgbClr val="1E2F5C"/>
-                </a:solidFill>
-                <a:latin typeface="Kanit"/>
-              </a:rPr>
-              <a:t>ปาล์มน้ำมัน</a:t>
-            </a:r>
-          </a:p>
-        </p:txBody>
-      </p:sp>
-      <p:sp>
-        <p:nvSpPr>
-          <p:cNvPr id="72" name="TextBox 71"/>
-          <p:cNvSpPr txBox="1"/>
-          <p:nvPr/>
-        </p:nvSpPr>
-        <p:spPr>
-          <a:xfrm>
-            <a:off x="7318857" y="3218687"/>
-            <a:ext cx="2156155" cy="125730"/>
-          </a:xfrm>
-          <a:prstGeom prst="rect">
-            <a:avLst/>
-          </a:prstGeom>
-          <a:noFill/>
-        </p:spPr>
-        <p:txBody>
-          <a:bodyPr wrap="square" lIns="0" rIns="0" tIns="0" bIns="0" anchor="t">
-            <a:noAutofit/>
-          </a:bodyPr>
-          <a:lstStyle/>
-          <a:p>
-            <a:pPr algn="l">
-              <a:lnSpc>
-                <a:spcPts val="990"/>
-              </a:lnSpc>
-            </a:pPr>
-            <a:r>
-              <a:rPr sz="750" b="0">
-                <a:solidFill>
-                  <a:srgbClr val="606060"/>
-                </a:solidFill>
-                <a:latin typeface="Kanit"/>
-              </a:rPr>
-              <a:t>฿8.38 /กก. · ใต้</a:t>
-            </a:r>
-          </a:p>
-        </p:txBody>
-      </p:sp>
-      <p:sp>
-        <p:nvSpPr>
-          <p:cNvPr id="73" name="TextBox 72"/>
-          <p:cNvSpPr txBox="1"/>
-          <p:nvPr/>
-        </p:nvSpPr>
-        <p:spPr>
-          <a:xfrm>
-            <a:off x="7318857" y="3351275"/>
-            <a:ext cx="1078077" cy="134112"/>
-          </a:xfrm>
-          <a:prstGeom prst="rect">
-            <a:avLst/>
-          </a:prstGeom>
-          <a:noFill/>
-        </p:spPr>
-        <p:txBody>
-          <a:bodyPr wrap="square" lIns="0" rIns="0" tIns="0" bIns="0" anchor="t">
-            <a:noAutofit/>
-          </a:bodyPr>
-          <a:lstStyle/>
-          <a:p>
-            <a:pPr algn="l">
-              <a:lnSpc>
-                <a:spcPts val="1056"/>
-              </a:lnSpc>
-            </a:pPr>
-            <a:r>
-              <a:rPr sz="800" b="1">
-                <a:solidFill>
-                  <a:srgbClr val="15795F"/>
-                </a:solidFill>
-                <a:latin typeface="Kanit"/>
-              </a:rPr>
-              <a:t>เทียบปีก่อน +23.1%</a:t>
-            </a:r>
-          </a:p>
-        </p:txBody>
-      </p:sp>
-      <p:sp>
-        <p:nvSpPr>
-          <p:cNvPr id="74" name="TextBox 73"/>
-          <p:cNvSpPr txBox="1"/>
-          <p:nvPr/>
-        </p:nvSpPr>
-        <p:spPr>
-          <a:xfrm>
-            <a:off x="8396935" y="3351275"/>
-            <a:ext cx="1078077" cy="134112"/>
-          </a:xfrm>
-          <a:prstGeom prst="rect">
-            <a:avLst/>
-          </a:prstGeom>
-          <a:noFill/>
-        </p:spPr>
-        <p:txBody>
-          <a:bodyPr wrap="square" lIns="0" rIns="0" tIns="0" bIns="0" anchor="t">
-            <a:noAutofit/>
-          </a:bodyPr>
-          <a:lstStyle/>
-          <a:p>
-            <a:pPr algn="l">
-              <a:lnSpc>
-                <a:spcPts val="1056"/>
-              </a:lnSpc>
-            </a:pPr>
-            <a:r>
-              <a:rPr sz="800" b="1">
-                <a:solidFill>
-                  <a:srgbClr val="15795F"/>
-                </a:solidFill>
-                <a:latin typeface="Kanit"/>
-              </a:rPr>
-              <a:t>6 เดือน +16.2%</a:t>
-            </a:r>
-          </a:p>
-        </p:txBody>
-      </p:sp>
-      <p:sp>
-        <p:nvSpPr>
-          <p:cNvPr id="75" name="Rectangle 74"/>
-          <p:cNvSpPr/>
-          <p:nvPr/>
-        </p:nvSpPr>
-        <p:spPr>
-          <a:xfrm>
-            <a:off x="7318857" y="3506724"/>
-            <a:ext cx="2156155" cy="548640"/>
-          </a:xfrm>
-          <a:prstGeom prst="rect">
-            <a:avLst/>
-          </a:prstGeom>
-          <a:solidFill>
-            <a:srgbClr val="FBFCFE"/>
-          </a:solidFill>
-          <a:ln w="9525">
-            <a:solidFill>
-              <a:srgbClr val="D9DEE9"/>
-            </a:solidFill>
-          </a:ln>
-          <a:effectLst/>
-        </p:spPr>
-        <p:style>
-          <a:lnRef idx="1">
-            <a:schemeClr val="accent1"/>
-          </a:lnRef>
-          <a:fillRef idx="3">
-            <a:schemeClr val="accent1"/>
-          </a:fillRef>
-          <a:effectRef idx="2">
-            <a:schemeClr val="accent1"/>
-          </a:effectRef>
-          <a:fontRef idx="minor">
-            <a:schemeClr val="lt1"/>
-          </a:fontRef>
-        </p:style>
-        <p:txBody>
-          <a:bodyPr rtlCol="0" anchor="ctr" wrap="none"/>
-          <a:lstStyle/>
-          <a:p>
-            <a:pPr algn="ctr"/>
-          </a:p>
-        </p:txBody>
-      </p:sp>
-      <p:sp>
-        <p:nvSpPr>
-          <p:cNvPr id="76" name="Freeform 75"/>
-          <p:cNvSpPr/>
-          <p:nvPr/>
-        </p:nvSpPr>
-        <p:spPr>
-          <a:xfrm>
-            <a:off x="7364577" y="3552444"/>
-            <a:ext cx="2064715" cy="457200"/>
-          </a:xfrm>
-          <a:custGeom>
-            <a:avLst/>
-            <a:gdLst/>
-            <a:ahLst/>
-            <a:cxnLst/>
-            <a:rect l="l" t="t" r="r" b="b"/>
-            <a:pathLst>
-              <a:path w="2064715" h="457200">
-                <a:moveTo>
-                  <a:pt x="0" y="439749"/>
-                </a:moveTo>
-                <a:lnTo>
-                  <a:pt x="412943" y="457200"/>
-                </a:lnTo>
-                <a:lnTo>
-                  <a:pt x="825886" y="293166"/>
-                </a:lnTo>
-                <a:lnTo>
-                  <a:pt x="1238829" y="76781"/>
-                </a:lnTo>
-                <a:lnTo>
-                  <a:pt x="1651772" y="0"/>
-                </a:lnTo>
-                <a:lnTo>
-                  <a:pt x="2064715" y="45370"/>
-                </a:lnTo>
-              </a:path>
-            </a:pathLst>
-          </a:custGeom>
-          <a:noFill/>
-          <a:ln w="20320">
-            <a:solidFill>
-              <a:srgbClr val="15795F"/>
-            </a:solidFill>
-          </a:ln>
-          <a:effectLst/>
-        </p:spPr>
-        <p:style>
-          <a:lnRef idx="1">
-            <a:schemeClr val="accent1"/>
-          </a:lnRef>
-          <a:fillRef idx="3">
-            <a:schemeClr val="accent1"/>
-          </a:fillRef>
-          <a:effectRef idx="2">
-            <a:schemeClr val="accent1"/>
-          </a:effectRef>
-          <a:fontRef idx="minor">
-            <a:schemeClr val="lt1"/>
-          </a:fontRef>
-        </p:style>
-        <p:txBody>
-          <a:bodyPr rtlCol="0" anchor="ctr"/>
-          <a:lstStyle/>
-          <a:p>
-            <a:pPr algn="ctr"/>
-          </a:p>
-        </p:txBody>
-      </p:sp>
-      <p:sp>
-        <p:nvSpPr>
           <p:cNvPr id="77" name="Rounded Rectangle 76"/>
           <p:cNvSpPr/>
           <p:nvPr/>
         </p:nvSpPr>
         <p:spPr>
           <a:xfrm>
-            <a:off x="9388144" y="3556666"/>
+            <a:off x="9388144" y="3511296"/>
             <a:ext cx="82296" cy="82296"/>
           </a:xfrm>
           <a:prstGeom prst="roundRect">
@@ -50886,7 +50886,7 @@
                 </a:solidFill>
                 <a:latin typeface="Kanit"/>
               </a:rPr>
-              <a:t>เทียบปีก่อน +39.8%</a:t>
+              <a:t>เทียบปีก่อน +40.3%</a:t>
             </a:r>
           </a:p>
         </p:txBody>
@@ -51204,7 +51204,7 @@
                 </a:solidFill>
                 <a:latin typeface="Kanit"/>
               </a:rPr>
-              <a:t>เทียบปีก่อน +75.9%</a:t>
+              <a:t>เทียบปีก่อน +76.3%</a:t>
             </a:r>
           </a:p>
         </p:txBody>
@@ -51522,7 +51522,7 @@
                 </a:solidFill>
                 <a:latin typeface="Kanit"/>
               </a:rPr>
-              <a:t>เทียบปีก่อน +181.0%</a:t>
+              <a:t>เทียบปีก่อน +114.6%</a:t>
             </a:r>
           </a:p>
         </p:txBody>
@@ -51886,7 +51886,7 @@
                 </a:solidFill>
                 <a:latin typeface="Kanit"/>
               </a:rPr>
-              <a:t>ราคาหน้าฟาร์ม วัดจริง — ราคารายวันของ NABC เฉลี่ยเป็นรายเดือน หน่วยเป็นบาทตามที่เผยแพร่ (ไม่มีการแปลงสกุลเงิน) ราคาล่าสุด 2026-09-07, รุ่นข้อมูลย้อนหลัง 2026-09-05 ราคาหน้าฟาร์ม (ราคาที่เกษตรกรขายได้) คือเงินที่เกษตรกรได้รับเมื่อขายครั้งแรก ก่อนพ่อค้าคนกลาง โรงสี หรือค่าขนส่งจะหักส่วนแบ่ง — ไม่ใช่ดัชนีโลก และไม่ใช่ราคาในซูเปอร์มาร์เก็ต แหล่งผลิตเป็นการอ่านแบบ ประมาณการ ว่าสินค้าแต่ละชนิดผลิตที่ไหน และทับซ้อนกันได้ น้ำตาลเป็นราคาอ้อยประกาศของ สอน. ปีละหนึ่งจุด จึงไม่มีการเปลี่ยนแปลงหกเดือนให้แสดง</a:t>
+              <a:t>ราคาหน้าฟาร์ม วัดจริง — ราคารายวันของ NABC เฉลี่ยเป็นรายเดือน หน่วยเป็นบาทตามที่เผยแพร่ (ไม่มีการแปลงสกุลเงิน) ราคาล่าสุด 2026-09-09, รุ่นข้อมูลย้อนหลัง 2026-09-05 ราคาหน้าฟาร์ม (ราคาที่เกษตรกรขายได้) คือเงินที่เกษตรกรได้รับเมื่อขายครั้งแรก ก่อนพ่อค้าคนกลาง โรงสี หรือค่าขนส่งจะหักส่วนแบ่ง — ไม่ใช่ดัชนีโลก และไม่ใช่ราคาในซูเปอร์มาร์เก็ต แหล่งผลิตเป็นการอ่านแบบ ประมาณการ ว่าสินค้าแต่ละชนิดผลิตที่ไหน และทับซ้อนกันได้ น้ำตาลเป็นราคาอ้อยประกาศของ สอน. ปีละหนึ่งจุด จึงไม่มีการเปลี่ยนแปลงหกเดือนให้แสดง</a:t>
             </a:r>
           </a:p>
         </p:txBody>

</xml_diff>

<commit_message>
deck(mcom): rebuild — the data moved past the committed figures (run 34466227813)
</commit_message>
<xml_diff>
--- a/docs/decks/mcom-2026-08-05-macro-TH.pptx
+++ b/docs/decks/mcom-2026-08-05-macro-TH.pptx
@@ -6240,7 +6240,7 @@
                 </a:solidFill>
                 <a:latin typeface="Kanit"/>
               </a:rPr>
-              <a:t>132</a:t>
+              <a:t>145</a:t>
             </a:r>
           </a:p>
         </p:txBody>
@@ -6279,7 +6279,7 @@
                 </a:solidFill>
                 <a:latin typeface="Kanit"/>
               </a:rPr>
-              <a:t>จาก 787 (16.8%) · เรียลไทม์ · 2026-09-09</a:t>
+              <a:t>จาก 789 (18.4%) · เรียลไทม์ · 2026-09-10</a:t>
             </a:r>
           </a:p>
         </p:txBody>
@@ -6405,7 +6405,7 @@
                 </a:solidFill>
                 <a:latin typeface="Kanit"/>
               </a:rPr>
-              <a:t>34</a:t>
+              <a:t>51</a:t>
             </a:r>
           </a:p>
         </p:txBody>
@@ -6444,7 +6444,7 @@
                 </a:solidFill>
                 <a:latin typeface="Kanit"/>
               </a:rPr>
-              <a:t>ค่าล่าสุดรายวัน · 2026-09-09</a:t>
+              <a:t>ค่าล่าสุดรายวัน · 2026-09-10</a:t>
             </a:r>
           </a:p>
         </p:txBody>
@@ -7882,7 +7882,7 @@
                           </a:solidFill>
                           <a:latin typeface="Kanit"/>
                         </a:rPr>
-                        <a:t>สกลนคร</a:t>
+                        <a:t>ชุมพร</a:t>
                       </a:r>
                     </a:p>
                   </a:txBody>
@@ -7905,7 +7905,7 @@
                           </a:solidFill>
                           <a:latin typeface="Kanit"/>
                         </a:rPr>
-                        <a:t>37</a:t>
+                        <a:t>89</a:t>
                       </a:r>
                     </a:p>
                   </a:txBody>
@@ -7928,7 +7928,7 @@
                           </a:solidFill>
                           <a:latin typeface="Kanit"/>
                         </a:rPr>
-                        <a:t>65</a:t>
+                        <a:t>60</a:t>
                       </a:r>
                     </a:p>
                   </a:txBody>
@@ -7951,7 +7951,7 @@
                           </a:solidFill>
                           <a:latin typeface="Kanit"/>
                         </a:rPr>
-                        <a:t>16.2%</a:t>
+                        <a:t>6.7%</a:t>
                       </a:r>
                     </a:p>
                   </a:txBody>
@@ -7974,7 +7974,7 @@
                           </a:solidFill>
                           <a:latin typeface="Kanit"/>
                         </a:rPr>
-                        <a:t>7/12</a:t>
+                        <a:t>3/14</a:t>
                       </a:r>
                     </a:p>
                   </a:txBody>
@@ -8022,7 +8022,7 @@
                           </a:solidFill>
                           <a:latin typeface="Kanit"/>
                         </a:rPr>
-                        <a:t>สมุทรปราการ</a:t>
+                        <a:t>สกลนคร</a:t>
                       </a:r>
                     </a:p>
                   </a:txBody>
@@ -8045,7 +8045,7 @@
                           </a:solidFill>
                           <a:latin typeface="Kanit"/>
                         </a:rPr>
-                        <a:t>15</a:t>
+                        <a:t>38</a:t>
                       </a:r>
                     </a:p>
                   </a:txBody>
@@ -8068,7 +8068,7 @@
                           </a:solidFill>
                           <a:latin typeface="Kanit"/>
                         </a:rPr>
-                        <a:t>2</a:t>
+                        <a:t>69</a:t>
                       </a:r>
                     </a:p>
                   </a:txBody>
@@ -8087,11 +8087,11 @@
                       <a:r>
                         <a:rPr sz="900" b="1">
                           <a:solidFill>
-                            <a:srgbClr val="606060"/>
-                          </a:solidFill>
-                          <a:latin typeface="Kanit"/>
-                        </a:rPr>
-                        <a:t>0.0%</a:t>
+                            <a:srgbClr val="F5C242"/>
+                          </a:solidFill>
+                          <a:latin typeface="Kanit"/>
+                        </a:rPr>
+                        <a:t>2.6%</a:t>
                       </a:r>
                     </a:p>
                   </a:txBody>
@@ -8114,7 +8114,7 @@
                           </a:solidFill>
                           <a:latin typeface="Kanit"/>
                         </a:rPr>
-                        <a:t>4/4</a:t>
+                        <a:t>7/12</a:t>
                       </a:r>
                     </a:p>
                   </a:txBody>
@@ -8162,7 +8162,7 @@
                           </a:solidFill>
                           <a:latin typeface="Kanit"/>
                         </a:rPr>
-                        <a:t>บึงกาฬ</a:t>
+                        <a:t>สมุทรปราการ</a:t>
                       </a:r>
                     </a:p>
                   </a:txBody>
@@ -8185,7 +8185,7 @@
                           </a:solidFill>
                           <a:latin typeface="Kanit"/>
                         </a:rPr>
-                        <a:t>11</a:t>
+                        <a:t>15</a:t>
                       </a:r>
                     </a:p>
                   </a:txBody>
@@ -8208,7 +8208,7 @@
                           </a:solidFill>
                           <a:latin typeface="Kanit"/>
                         </a:rPr>
-                        <a:t>150</a:t>
+                        <a:t>19</a:t>
                       </a:r>
                     </a:p>
                   </a:txBody>
@@ -8227,11 +8227,11 @@
                       <a:r>
                         <a:rPr sz="900" b="1">
                           <a:solidFill>
-                            <a:srgbClr val="F5C242"/>
-                          </a:solidFill>
-                          <a:latin typeface="Kanit"/>
-                        </a:rPr>
-                        <a:t>54.5%</a:t>
+                            <a:srgbClr val="606060"/>
+                          </a:solidFill>
+                          <a:latin typeface="Kanit"/>
+                        </a:rPr>
+                        <a:t>0.0%</a:t>
                       </a:r>
                     </a:p>
                   </a:txBody>
@@ -8254,7 +8254,7 @@
                           </a:solidFill>
                           <a:latin typeface="Kanit"/>
                         </a:rPr>
-                        <a:t>1/1</a:t>
+                        <a:t>4/4</a:t>
                       </a:r>
                     </a:p>
                   </a:txBody>
@@ -8273,11 +8273,11 @@
                       <a:r>
                         <a:rPr sz="900" b="1">
                           <a:solidFill>
-                            <a:srgbClr val="F5C242"/>
-                          </a:solidFill>
-                          <a:latin typeface="Kanit"/>
-                        </a:rPr>
-                        <a:t>4</a:t>
+                            <a:srgbClr val="CC0000"/>
+                          </a:solidFill>
+                          <a:latin typeface="Kanit"/>
+                        </a:rPr>
+                        <a:t>5</a:t>
                       </a:r>
                     </a:p>
                   </a:txBody>
@@ -8302,7 +8302,7 @@
                           </a:solidFill>
                           <a:latin typeface="Kanit"/>
                         </a:rPr>
-                        <a:t>หนองบัวลำภู</a:t>
+                        <a:t>อุดรธานี</a:t>
                       </a:r>
                     </a:p>
                   </a:txBody>
@@ -8325,7 +8325,7 @@
                           </a:solidFill>
                           <a:latin typeface="Kanit"/>
                         </a:rPr>
-                        <a:t>30</a:t>
+                        <a:t>35</a:t>
                       </a:r>
                     </a:p>
                   </a:txBody>
@@ -8348,7 +8348,7 @@
                           </a:solidFill>
                           <a:latin typeface="Kanit"/>
                         </a:rPr>
-                        <a:t>98</a:t>
+                        <a:t>65</a:t>
                       </a:r>
                     </a:p>
                   </a:txBody>
@@ -8371,7 +8371,7 @@
                           </a:solidFill>
                           <a:latin typeface="Kanit"/>
                         </a:rPr>
-                        <a:t>26.7%</a:t>
+                        <a:t>37.1%</a:t>
                       </a:r>
                     </a:p>
                   </a:txBody>
@@ -8394,7 +8394,7 @@
                           </a:solidFill>
                           <a:latin typeface="Kanit"/>
                         </a:rPr>
-                        <a:t>2/3</a:t>
+                        <a:t>5/7</a:t>
                       </a:r>
                     </a:p>
                   </a:txBody>
@@ -8442,7 +8442,7 @@
                           </a:solidFill>
                           <a:latin typeface="Kanit"/>
                         </a:rPr>
-                        <a:t>ชุมพร</a:t>
+                        <a:t>ปราจีนบุรี</a:t>
                       </a:r>
                     </a:p>
                   </a:txBody>
@@ -8465,7 +8465,7 @@
                           </a:solidFill>
                           <a:latin typeface="Kanit"/>
                         </a:rPr>
-                        <a:t>92</a:t>
+                        <a:t>35</a:t>
                       </a:r>
                     </a:p>
                   </a:txBody>
@@ -8488,7 +8488,7 @@
                           </a:solidFill>
                           <a:latin typeface="Kanit"/>
                         </a:rPr>
-                        <a:t>80</a:t>
+                        <a:t>66</a:t>
                       </a:r>
                     </a:p>
                   </a:txBody>
@@ -8511,7 +8511,7 @@
                           </a:solidFill>
                           <a:latin typeface="Kanit"/>
                         </a:rPr>
-                        <a:t>16.3%</a:t>
+                        <a:t>34.3%</a:t>
                       </a:r>
                     </a:p>
                   </a:txBody>
@@ -8534,7 +8534,7 @@
                           </a:solidFill>
                           <a:latin typeface="Kanit"/>
                         </a:rPr>
-                        <a:t>2/14</a:t>
+                        <a:t>6/15</a:t>
                       </a:r>
                     </a:p>
                   </a:txBody>
@@ -8582,7 +8582,7 @@
                           </a:solidFill>
                           <a:latin typeface="Kanit"/>
                         </a:rPr>
-                        <a:t>อุดรธานี</a:t>
+                        <a:t>ตราด</a:t>
                       </a:r>
                     </a:p>
                   </a:txBody>
@@ -8605,7 +8605,7 @@
                           </a:solidFill>
                           <a:latin typeface="Kanit"/>
                         </a:rPr>
-                        <a:t>35</a:t>
+                        <a:t>46</a:t>
                       </a:r>
                     </a:p>
                   </a:txBody>
@@ -8628,7 +8628,7 @@
                           </a:solidFill>
                           <a:latin typeface="Kanit"/>
                         </a:rPr>
-                        <a:t>127</a:t>
+                        <a:t>121</a:t>
                       </a:r>
                     </a:p>
                   </a:txBody>
@@ -8651,7 +8651,7 @@
                           </a:solidFill>
                           <a:latin typeface="Kanit"/>
                         </a:rPr>
-                        <a:t>14.3%</a:t>
+                        <a:t>32.6%</a:t>
                       </a:r>
                     </a:p>
                   </a:txBody>
@@ -8674,7 +8674,7 @@
                           </a:solidFill>
                           <a:latin typeface="Kanit"/>
                         </a:rPr>
-                        <a:t>3/7</a:t>
+                        <a:t>4/9</a:t>
                       </a:r>
                     </a:p>
                   </a:txBody>
@@ -8909,7 +8909,7 @@
                 </a:solidFill>
                 <a:latin typeface="Kanit"/>
               </a:rPr>
-              <a:t>พื้นที่ปลูก วัดจริง (สศก. — ข้อมูลอำเภอ×พืช 3,295 แถว) ภัยแล้งเป็นดัชนี SPEI จาก แบบจำลอง คำนวณจากปริมาณฝนและการคายระเหย ปรับเดือนละครั้ง ดึงข้อมูล 2026-07-20 — เป็นสัญญาณที่ครอบคลุมทั้งประเทศดีที่สุดที่มี แต่ไม่มีใครลงพื้นที่ไปเดินดูอำเภอเหล่านั้น ข้อมูลฝนและระดับน้ำ วัดจริง (ThaiWater เรียลไทม์ ดึงทุกวันและสะสมไว้ — วันที่ดึงไม่สำเร็จจะเว้นเป็นช่องว่าง ไม่ใส่ค่าสมมติ) · ฝนถึง 2026-09-09, ระดับน้ำถึง 2026-09-09 ความเสี่ยงน้ำท่วมเชิงโครงสร้าง วัดจริง (สำมะโนพื้นที่ท่วมซ้ำซาก GISTDA มาตราส่วน 1:50,000 ปี 2005-2016 — เป็นบันทึกภาคพื้นดิน 12 ปี ไม่ใช่การพยากรณ์)</a:t>
+              <a:t>พื้นที่ปลูก วัดจริง (สศก. — ข้อมูลอำเภอ×พืช 3,295 แถว) ภัยแล้งเป็นดัชนี SPEI จาก แบบจำลอง คำนวณจากปริมาณฝนและการคายระเหย ปรับเดือนละครั้ง ดึงข้อมูล 2026-07-20 — เป็นสัญญาณที่ครอบคลุมทั้งประเทศดีที่สุดที่มี แต่ไม่มีใครลงพื้นที่ไปเดินดูอำเภอเหล่านั้น ข้อมูลฝนและระดับน้ำ วัดจริง (ThaiWater เรียลไทม์ ดึงทุกวันและสะสมไว้ — วันที่ดึงไม่สำเร็จจะเว้นเป็นช่องว่าง ไม่ใส่ค่าสมมติ) · ฝนถึง 2026-09-10, ระดับน้ำถึง 2026-09-10 ความเสี่ยงน้ำท่วมเชิงโครงสร้าง วัดจริง (สำมะโนพื้นที่ท่วมซ้ำซาก GISTDA มาตราส่วน 1:50,000 ปี 2005-2016 — เป็นบันทึกภาคพื้นดิน 12 ปี ไม่ใช่การพยากรณ์)</a:t>
             </a:r>
           </a:p>
         </p:txBody>
@@ -32047,7 +32047,7 @@
                 </a:solidFill>
                 <a:latin typeface="Kanit"/>
               </a:rPr>
-              <a:t>รุ่นข้อมูล — ราคาโลก 2026M06 · ราคาหน้าฟาร์มไทย 2026-09-09 · ประวัติราคาไทย 2026-09-05 · ต้นทุนการผลิตพืช สศก. ไจอัป 2568 (ปีเพาะปลูก 2568/69, ประมาณการ สศก. มี.ค. 2569) · ภัยแล้ง 2026-06-21 · เงินเฟ้อ 2026-05 · GDP 2026 ไตรมาส 1 · IMF WEO 2026 · ดัชนีราคาขายต่อ 2026-05 · ยอดจดทะเบียนถึง 2026-01 · หนี้ครัวเรือน สสช. SES 2566 · ค่าจ้าง สสช. LFS 2568 · ข้อมูลตรวจวัด 2026-09-09</a:t>
+              <a:t>รุ่นข้อมูล — ราคาโลก 2026M06 · ราคาหน้าฟาร์มไทย 2026-09-09 · ประวัติราคาไทย 2026-09-05 · ต้นทุนการผลิตพืช สศก. ไจอัป 2568 (ปีเพาะปลูก 2568/69, ประมาณการ สศก. มี.ค. 2569) · ภัยแล้ง 2026-06-21 · เงินเฟ้อ 2026-05 · GDP 2026 ไตรมาส 1 · IMF WEO 2026 · ดัชนีราคาขายต่อ 2026-05 · ยอดจดทะเบียนถึง 2026-01 · หนี้ครัวเรือน สสช. SES 2566 · ค่าจ้าง สสช. LFS 2568 · ข้อมูลตรวจวัด 2026-09-10</a:t>
             </a:r>
           </a:p>
         </p:txBody>
@@ -37087,7 +37087,7 @@
                 </a:solidFill>
                 <a:latin typeface="Kanit"/>
               </a:rPr>
-              <a:t>338 จาก 928 อำเภอ · แม่น้ำเกินระดับ 132 จาก 787 สถานี</a:t>
+              <a:t>338 จาก 928 อำเภอ · แม่น้ำเกินระดับ 145 จาก 789 สถานี</a:t>
             </a:r>
           </a:p>
         </p:txBody>
@@ -37859,7 +37859,7 @@
                           </a:solidFill>
                           <a:latin typeface="Kanit"/>
                         </a:rPr>
-                        <a:t>31/154</a:t>
+                        <a:t>39/156</a:t>
                       </a:r>
                     </a:p>
                   </a:txBody>
@@ -38091,7 +38091,7 @@
                           </a:solidFill>
                           <a:latin typeface="Kanit"/>
                         </a:rPr>
-                        <a:t>18/272</a:t>
+                        <a:t>21/272</a:t>
                       </a:r>
                     </a:p>
                   </a:txBody>
@@ -38323,7 +38323,7 @@
                           </a:solidFill>
                           <a:latin typeface="Kanit"/>
                         </a:rPr>
-                        <a:t>26/167</a:t>
+                        <a:t>28/167</a:t>
                       </a:r>
                     </a:p>
                   </a:txBody>
@@ -38555,7 +38555,7 @@
                           </a:solidFill>
                           <a:latin typeface="Kanit"/>
                         </a:rPr>
-                        <a:t>12/51</a:t>
+                        <a:t>13/51</a:t>
                       </a:r>
                     </a:p>
                   </a:txBody>
@@ -38787,7 +38787,7 @@
                           </a:solidFill>
                           <a:latin typeface="Kanit"/>
                         </a:rPr>
-                        <a:t>45/143</a:t>
+                        <a:t>44/143</a:t>
                       </a:r>
                     </a:p>
                   </a:txBody>

</xml_diff>

<commit_message>
deck(mcom): rebuild — the data moved past the committed figures (run 34466227813) (#904)
Co-authored-by: github-actions[bot] <41898282+github-actions[bot]@users.noreply.github.com>
</commit_message>
<xml_diff>
--- a/docs/decks/mcom-2026-08-05-macro-TH.pptx
+++ b/docs/decks/mcom-2026-08-05-macro-TH.pptx
@@ -6240,7 +6240,7 @@
                 </a:solidFill>
                 <a:latin typeface="Kanit"/>
               </a:rPr>
-              <a:t>132</a:t>
+              <a:t>145</a:t>
             </a:r>
           </a:p>
         </p:txBody>
@@ -6279,7 +6279,7 @@
                 </a:solidFill>
                 <a:latin typeface="Kanit"/>
               </a:rPr>
-              <a:t>จาก 787 (16.8%) · เรียลไทม์ · 2026-09-09</a:t>
+              <a:t>จาก 789 (18.4%) · เรียลไทม์ · 2026-09-10</a:t>
             </a:r>
           </a:p>
         </p:txBody>
@@ -6405,7 +6405,7 @@
                 </a:solidFill>
                 <a:latin typeface="Kanit"/>
               </a:rPr>
-              <a:t>34</a:t>
+              <a:t>51</a:t>
             </a:r>
           </a:p>
         </p:txBody>
@@ -6444,7 +6444,7 @@
                 </a:solidFill>
                 <a:latin typeface="Kanit"/>
               </a:rPr>
-              <a:t>ค่าล่าสุดรายวัน · 2026-09-09</a:t>
+              <a:t>ค่าล่าสุดรายวัน · 2026-09-10</a:t>
             </a:r>
           </a:p>
         </p:txBody>
@@ -7882,7 +7882,7 @@
                           </a:solidFill>
                           <a:latin typeface="Kanit"/>
                         </a:rPr>
-                        <a:t>สกลนคร</a:t>
+                        <a:t>ชุมพร</a:t>
                       </a:r>
                     </a:p>
                   </a:txBody>
@@ -7905,7 +7905,7 @@
                           </a:solidFill>
                           <a:latin typeface="Kanit"/>
                         </a:rPr>
-                        <a:t>37</a:t>
+                        <a:t>89</a:t>
                       </a:r>
                     </a:p>
                   </a:txBody>
@@ -7928,7 +7928,7 @@
                           </a:solidFill>
                           <a:latin typeface="Kanit"/>
                         </a:rPr>
-                        <a:t>65</a:t>
+                        <a:t>60</a:t>
                       </a:r>
                     </a:p>
                   </a:txBody>
@@ -7951,7 +7951,7 @@
                           </a:solidFill>
                           <a:latin typeface="Kanit"/>
                         </a:rPr>
-                        <a:t>16.2%</a:t>
+                        <a:t>6.7%</a:t>
                       </a:r>
                     </a:p>
                   </a:txBody>
@@ -7974,7 +7974,7 @@
                           </a:solidFill>
                           <a:latin typeface="Kanit"/>
                         </a:rPr>
-                        <a:t>7/12</a:t>
+                        <a:t>3/14</a:t>
                       </a:r>
                     </a:p>
                   </a:txBody>
@@ -8022,7 +8022,7 @@
                           </a:solidFill>
                           <a:latin typeface="Kanit"/>
                         </a:rPr>
-                        <a:t>สมุทรปราการ</a:t>
+                        <a:t>สกลนคร</a:t>
                       </a:r>
                     </a:p>
                   </a:txBody>
@@ -8045,7 +8045,7 @@
                           </a:solidFill>
                           <a:latin typeface="Kanit"/>
                         </a:rPr>
-                        <a:t>15</a:t>
+                        <a:t>38</a:t>
                       </a:r>
                     </a:p>
                   </a:txBody>
@@ -8068,7 +8068,7 @@
                           </a:solidFill>
                           <a:latin typeface="Kanit"/>
                         </a:rPr>
-                        <a:t>2</a:t>
+                        <a:t>69</a:t>
                       </a:r>
                     </a:p>
                   </a:txBody>
@@ -8087,11 +8087,11 @@
                       <a:r>
                         <a:rPr sz="900" b="1">
                           <a:solidFill>
-                            <a:srgbClr val="606060"/>
-                          </a:solidFill>
-                          <a:latin typeface="Kanit"/>
-                        </a:rPr>
-                        <a:t>0.0%</a:t>
+                            <a:srgbClr val="F5C242"/>
+                          </a:solidFill>
+                          <a:latin typeface="Kanit"/>
+                        </a:rPr>
+                        <a:t>2.6%</a:t>
                       </a:r>
                     </a:p>
                   </a:txBody>
@@ -8114,7 +8114,7 @@
                           </a:solidFill>
                           <a:latin typeface="Kanit"/>
                         </a:rPr>
-                        <a:t>4/4</a:t>
+                        <a:t>7/12</a:t>
                       </a:r>
                     </a:p>
                   </a:txBody>
@@ -8162,7 +8162,7 @@
                           </a:solidFill>
                           <a:latin typeface="Kanit"/>
                         </a:rPr>
-                        <a:t>บึงกาฬ</a:t>
+                        <a:t>สมุทรปราการ</a:t>
                       </a:r>
                     </a:p>
                   </a:txBody>
@@ -8185,7 +8185,7 @@
                           </a:solidFill>
                           <a:latin typeface="Kanit"/>
                         </a:rPr>
-                        <a:t>11</a:t>
+                        <a:t>15</a:t>
                       </a:r>
                     </a:p>
                   </a:txBody>
@@ -8208,7 +8208,7 @@
                           </a:solidFill>
                           <a:latin typeface="Kanit"/>
                         </a:rPr>
-                        <a:t>150</a:t>
+                        <a:t>19</a:t>
                       </a:r>
                     </a:p>
                   </a:txBody>
@@ -8227,11 +8227,11 @@
                       <a:r>
                         <a:rPr sz="900" b="1">
                           <a:solidFill>
-                            <a:srgbClr val="F5C242"/>
-                          </a:solidFill>
-                          <a:latin typeface="Kanit"/>
-                        </a:rPr>
-                        <a:t>54.5%</a:t>
+                            <a:srgbClr val="606060"/>
+                          </a:solidFill>
+                          <a:latin typeface="Kanit"/>
+                        </a:rPr>
+                        <a:t>0.0%</a:t>
                       </a:r>
                     </a:p>
                   </a:txBody>
@@ -8254,7 +8254,7 @@
                           </a:solidFill>
                           <a:latin typeface="Kanit"/>
                         </a:rPr>
-                        <a:t>1/1</a:t>
+                        <a:t>4/4</a:t>
                       </a:r>
                     </a:p>
                   </a:txBody>
@@ -8273,11 +8273,11 @@
                       <a:r>
                         <a:rPr sz="900" b="1">
                           <a:solidFill>
-                            <a:srgbClr val="F5C242"/>
-                          </a:solidFill>
-                          <a:latin typeface="Kanit"/>
-                        </a:rPr>
-                        <a:t>4</a:t>
+                            <a:srgbClr val="CC0000"/>
+                          </a:solidFill>
+                          <a:latin typeface="Kanit"/>
+                        </a:rPr>
+                        <a:t>5</a:t>
                       </a:r>
                     </a:p>
                   </a:txBody>
@@ -8302,7 +8302,7 @@
                           </a:solidFill>
                           <a:latin typeface="Kanit"/>
                         </a:rPr>
-                        <a:t>หนองบัวลำภู</a:t>
+                        <a:t>อุดรธานี</a:t>
                       </a:r>
                     </a:p>
                   </a:txBody>
@@ -8325,7 +8325,7 @@
                           </a:solidFill>
                           <a:latin typeface="Kanit"/>
                         </a:rPr>
-                        <a:t>30</a:t>
+                        <a:t>35</a:t>
                       </a:r>
                     </a:p>
                   </a:txBody>
@@ -8348,7 +8348,7 @@
                           </a:solidFill>
                           <a:latin typeface="Kanit"/>
                         </a:rPr>
-                        <a:t>98</a:t>
+                        <a:t>65</a:t>
                       </a:r>
                     </a:p>
                   </a:txBody>
@@ -8371,7 +8371,7 @@
                           </a:solidFill>
                           <a:latin typeface="Kanit"/>
                         </a:rPr>
-                        <a:t>26.7%</a:t>
+                        <a:t>37.1%</a:t>
                       </a:r>
                     </a:p>
                   </a:txBody>
@@ -8394,7 +8394,7 @@
                           </a:solidFill>
                           <a:latin typeface="Kanit"/>
                         </a:rPr>
-                        <a:t>2/3</a:t>
+                        <a:t>5/7</a:t>
                       </a:r>
                     </a:p>
                   </a:txBody>
@@ -8442,7 +8442,7 @@
                           </a:solidFill>
                           <a:latin typeface="Kanit"/>
                         </a:rPr>
-                        <a:t>ชุมพร</a:t>
+                        <a:t>ปราจีนบุรี</a:t>
                       </a:r>
                     </a:p>
                   </a:txBody>
@@ -8465,7 +8465,7 @@
                           </a:solidFill>
                           <a:latin typeface="Kanit"/>
                         </a:rPr>
-                        <a:t>92</a:t>
+                        <a:t>35</a:t>
                       </a:r>
                     </a:p>
                   </a:txBody>
@@ -8488,7 +8488,7 @@
                           </a:solidFill>
                           <a:latin typeface="Kanit"/>
                         </a:rPr>
-                        <a:t>80</a:t>
+                        <a:t>66</a:t>
                       </a:r>
                     </a:p>
                   </a:txBody>
@@ -8511,7 +8511,7 @@
                           </a:solidFill>
                           <a:latin typeface="Kanit"/>
                         </a:rPr>
-                        <a:t>16.3%</a:t>
+                        <a:t>34.3%</a:t>
                       </a:r>
                     </a:p>
                   </a:txBody>
@@ -8534,7 +8534,7 @@
                           </a:solidFill>
                           <a:latin typeface="Kanit"/>
                         </a:rPr>
-                        <a:t>2/14</a:t>
+                        <a:t>6/15</a:t>
                       </a:r>
                     </a:p>
                   </a:txBody>
@@ -8582,7 +8582,7 @@
                           </a:solidFill>
                           <a:latin typeface="Kanit"/>
                         </a:rPr>
-                        <a:t>อุดรธานี</a:t>
+                        <a:t>ตราด</a:t>
                       </a:r>
                     </a:p>
                   </a:txBody>
@@ -8605,7 +8605,7 @@
                           </a:solidFill>
                           <a:latin typeface="Kanit"/>
                         </a:rPr>
-                        <a:t>35</a:t>
+                        <a:t>46</a:t>
                       </a:r>
                     </a:p>
                   </a:txBody>
@@ -8628,7 +8628,7 @@
                           </a:solidFill>
                           <a:latin typeface="Kanit"/>
                         </a:rPr>
-                        <a:t>127</a:t>
+                        <a:t>121</a:t>
                       </a:r>
                     </a:p>
                   </a:txBody>
@@ -8651,7 +8651,7 @@
                           </a:solidFill>
                           <a:latin typeface="Kanit"/>
                         </a:rPr>
-                        <a:t>14.3%</a:t>
+                        <a:t>32.6%</a:t>
                       </a:r>
                     </a:p>
                   </a:txBody>
@@ -8674,7 +8674,7 @@
                           </a:solidFill>
                           <a:latin typeface="Kanit"/>
                         </a:rPr>
-                        <a:t>3/7</a:t>
+                        <a:t>4/9</a:t>
                       </a:r>
                     </a:p>
                   </a:txBody>
@@ -8909,7 +8909,7 @@
                 </a:solidFill>
                 <a:latin typeface="Kanit"/>
               </a:rPr>
-              <a:t>พื้นที่ปลูก วัดจริง (สศก. — ข้อมูลอำเภอ×พืช 3,295 แถว) ภัยแล้งเป็นดัชนี SPEI จาก แบบจำลอง คำนวณจากปริมาณฝนและการคายระเหย ปรับเดือนละครั้ง ดึงข้อมูล 2026-07-20 — เป็นสัญญาณที่ครอบคลุมทั้งประเทศดีที่สุดที่มี แต่ไม่มีใครลงพื้นที่ไปเดินดูอำเภอเหล่านั้น ข้อมูลฝนและระดับน้ำ วัดจริง (ThaiWater เรียลไทม์ ดึงทุกวันและสะสมไว้ — วันที่ดึงไม่สำเร็จจะเว้นเป็นช่องว่าง ไม่ใส่ค่าสมมติ) · ฝนถึง 2026-09-09, ระดับน้ำถึง 2026-09-09 ความเสี่ยงน้ำท่วมเชิงโครงสร้าง วัดจริง (สำมะโนพื้นที่ท่วมซ้ำซาก GISTDA มาตราส่วน 1:50,000 ปี 2005-2016 — เป็นบันทึกภาคพื้นดิน 12 ปี ไม่ใช่การพยากรณ์)</a:t>
+              <a:t>พื้นที่ปลูก วัดจริง (สศก. — ข้อมูลอำเภอ×พืช 3,295 แถว) ภัยแล้งเป็นดัชนี SPEI จาก แบบจำลอง คำนวณจากปริมาณฝนและการคายระเหย ปรับเดือนละครั้ง ดึงข้อมูล 2026-07-20 — เป็นสัญญาณที่ครอบคลุมทั้งประเทศดีที่สุดที่มี แต่ไม่มีใครลงพื้นที่ไปเดินดูอำเภอเหล่านั้น ข้อมูลฝนและระดับน้ำ วัดจริง (ThaiWater เรียลไทม์ ดึงทุกวันและสะสมไว้ — วันที่ดึงไม่สำเร็จจะเว้นเป็นช่องว่าง ไม่ใส่ค่าสมมติ) · ฝนถึง 2026-09-10, ระดับน้ำถึง 2026-09-10 ความเสี่ยงน้ำท่วมเชิงโครงสร้าง วัดจริง (สำมะโนพื้นที่ท่วมซ้ำซาก GISTDA มาตราส่วน 1:50,000 ปี 2005-2016 — เป็นบันทึกภาคพื้นดิน 12 ปี ไม่ใช่การพยากรณ์)</a:t>
             </a:r>
           </a:p>
         </p:txBody>
@@ -32047,7 +32047,7 @@
                 </a:solidFill>
                 <a:latin typeface="Kanit"/>
               </a:rPr>
-              <a:t>รุ่นข้อมูล — ราคาโลก 2026M06 · ราคาหน้าฟาร์มไทย 2026-09-09 · ประวัติราคาไทย 2026-09-05 · ต้นทุนการผลิตพืช สศก. ไจอัป 2568 (ปีเพาะปลูก 2568/69, ประมาณการ สศก. มี.ค. 2569) · ภัยแล้ง 2026-06-21 · เงินเฟ้อ 2026-05 · GDP 2026 ไตรมาส 1 · IMF WEO 2026 · ดัชนีราคาขายต่อ 2026-05 · ยอดจดทะเบียนถึง 2026-01 · หนี้ครัวเรือน สสช. SES 2566 · ค่าจ้าง สสช. LFS 2568 · ข้อมูลตรวจวัด 2026-09-09</a:t>
+              <a:t>รุ่นข้อมูล — ราคาโลก 2026M06 · ราคาหน้าฟาร์มไทย 2026-09-09 · ประวัติราคาไทย 2026-09-05 · ต้นทุนการผลิตพืช สศก. ไจอัป 2568 (ปีเพาะปลูก 2568/69, ประมาณการ สศก. มี.ค. 2569) · ภัยแล้ง 2026-06-21 · เงินเฟ้อ 2026-05 · GDP 2026 ไตรมาส 1 · IMF WEO 2026 · ดัชนีราคาขายต่อ 2026-05 · ยอดจดทะเบียนถึง 2026-01 · หนี้ครัวเรือน สสช. SES 2566 · ค่าจ้าง สสช. LFS 2568 · ข้อมูลตรวจวัด 2026-09-10</a:t>
             </a:r>
           </a:p>
         </p:txBody>
@@ -37087,7 +37087,7 @@
                 </a:solidFill>
                 <a:latin typeface="Kanit"/>
               </a:rPr>
-              <a:t>338 จาก 928 อำเภอ · แม่น้ำเกินระดับ 132 จาก 787 สถานี</a:t>
+              <a:t>338 จาก 928 อำเภอ · แม่น้ำเกินระดับ 145 จาก 789 สถานี</a:t>
             </a:r>
           </a:p>
         </p:txBody>
@@ -37859,7 +37859,7 @@
                           </a:solidFill>
                           <a:latin typeface="Kanit"/>
                         </a:rPr>
-                        <a:t>31/154</a:t>
+                        <a:t>39/156</a:t>
                       </a:r>
                     </a:p>
                   </a:txBody>
@@ -38091,7 +38091,7 @@
                           </a:solidFill>
                           <a:latin typeface="Kanit"/>
                         </a:rPr>
-                        <a:t>18/272</a:t>
+                        <a:t>21/272</a:t>
                       </a:r>
                     </a:p>
                   </a:txBody>
@@ -38323,7 +38323,7 @@
                           </a:solidFill>
                           <a:latin typeface="Kanit"/>
                         </a:rPr>
-                        <a:t>26/167</a:t>
+                        <a:t>28/167</a:t>
                       </a:r>
                     </a:p>
                   </a:txBody>
@@ -38555,7 +38555,7 @@
                           </a:solidFill>
                           <a:latin typeface="Kanit"/>
                         </a:rPr>
-                        <a:t>12/51</a:t>
+                        <a:t>13/51</a:t>
                       </a:r>
                     </a:p>
                   </a:txBody>
@@ -38787,7 +38787,7 @@
                           </a:solidFill>
                           <a:latin typeface="Kanit"/>
                         </a:rPr>
-                        <a:t>45/143</a:t>
+                        <a:t>44/143</a:t>
                       </a:r>
                     </a:p>
                   </a:txBody>

</xml_diff>

<commit_message>
deck(mcom): rebuild — the data moved past the committed figures (run 34546658719)
</commit_message>
<xml_diff>
--- a/docs/decks/mcom-2026-08-05-macro-TH.pptx
+++ b/docs/decks/mcom-2026-08-05-macro-TH.pptx
@@ -6240,7 +6240,7 @@
                 </a:solidFill>
                 <a:latin typeface="Kanit"/>
               </a:rPr>
-              <a:t>145</a:t>
+              <a:t>147</a:t>
             </a:r>
           </a:p>
         </p:txBody>
@@ -6279,7 +6279,7 @@
                 </a:solidFill>
                 <a:latin typeface="Kanit"/>
               </a:rPr>
-              <a:t>จาก 789 (18.4%) · เรียลไทม์ · 2026-09-10</a:t>
+              <a:t>จาก 788 (18.7%) · เรียลไทม์ · 2026-09-11</a:t>
             </a:r>
           </a:p>
         </p:txBody>
@@ -6405,7 +6405,7 @@
                 </a:solidFill>
                 <a:latin typeface="Kanit"/>
               </a:rPr>
-              <a:t>51</a:t>
+              <a:t>61</a:t>
             </a:r>
           </a:p>
         </p:txBody>
@@ -6444,7 +6444,7 @@
                 </a:solidFill>
                 <a:latin typeface="Kanit"/>
               </a:rPr>
-              <a:t>ค่าล่าสุดรายวัน · 2026-09-10</a:t>
+              <a:t>ค่าล่าสุดรายวัน · 2026-09-11</a:t>
             </a:r>
           </a:p>
         </p:txBody>
@@ -7882,7 +7882,7 @@
                           </a:solidFill>
                           <a:latin typeface="Kanit"/>
                         </a:rPr>
-                        <a:t>ชุมพร</a:t>
+                        <a:t>สกลนคร</a:t>
                       </a:r>
                     </a:p>
                   </a:txBody>
@@ -7905,7 +7905,7 @@
                           </a:solidFill>
                           <a:latin typeface="Kanit"/>
                         </a:rPr>
-                        <a:t>89</a:t>
+                        <a:t>38</a:t>
                       </a:r>
                     </a:p>
                   </a:txBody>
@@ -7928,7 +7928,7 @@
                           </a:solidFill>
                           <a:latin typeface="Kanit"/>
                         </a:rPr>
-                        <a:t>60</a:t>
+                        <a:t>15</a:t>
                       </a:r>
                     </a:p>
                   </a:txBody>
@@ -7947,11 +7947,11 @@
                       <a:r>
                         <a:rPr sz="900" b="1">
                           <a:solidFill>
-                            <a:srgbClr val="F5C242"/>
-                          </a:solidFill>
-                          <a:latin typeface="Kanit"/>
-                        </a:rPr>
-                        <a:t>6.7%</a:t>
+                            <a:srgbClr val="606060"/>
+                          </a:solidFill>
+                          <a:latin typeface="Kanit"/>
+                        </a:rPr>
+                        <a:t>0.0%</a:t>
                       </a:r>
                     </a:p>
                   </a:txBody>
@@ -7974,7 +7974,7 @@
                           </a:solidFill>
                           <a:latin typeface="Kanit"/>
                         </a:rPr>
-                        <a:t>3/14</a:t>
+                        <a:t>7/12</a:t>
                       </a:r>
                     </a:p>
                   </a:txBody>
@@ -8022,7 +8022,7 @@
                           </a:solidFill>
                           <a:latin typeface="Kanit"/>
                         </a:rPr>
-                        <a:t>สกลนคร</a:t>
+                        <a:t>สมุทรปราการ</a:t>
                       </a:r>
                     </a:p>
                   </a:txBody>
@@ -8045,7 +8045,7 @@
                           </a:solidFill>
                           <a:latin typeface="Kanit"/>
                         </a:rPr>
-                        <a:t>38</a:t>
+                        <a:t>15</a:t>
                       </a:r>
                     </a:p>
                   </a:txBody>
@@ -8068,7 +8068,7 @@
                           </a:solidFill>
                           <a:latin typeface="Kanit"/>
                         </a:rPr>
-                        <a:t>69</a:t>
+                        <a:t>94</a:t>
                       </a:r>
                     </a:p>
                   </a:txBody>
@@ -8091,7 +8091,7 @@
                           </a:solidFill>
                           <a:latin typeface="Kanit"/>
                         </a:rPr>
-                        <a:t>2.6%</a:t>
+                        <a:t>60.0%</a:t>
                       </a:r>
                     </a:p>
                   </a:txBody>
@@ -8114,7 +8114,7 @@
                           </a:solidFill>
                           <a:latin typeface="Kanit"/>
                         </a:rPr>
-                        <a:t>7/12</a:t>
+                        <a:t>4/4</a:t>
                       </a:r>
                     </a:p>
                   </a:txBody>
@@ -8133,11 +8133,11 @@
                       <a:r>
                         <a:rPr sz="900" b="1">
                           <a:solidFill>
-                            <a:srgbClr val="CC0000"/>
-                          </a:solidFill>
-                          <a:latin typeface="Kanit"/>
-                        </a:rPr>
-                        <a:t>5</a:t>
+                            <a:srgbClr val="F5C242"/>
+                          </a:solidFill>
+                          <a:latin typeface="Kanit"/>
+                        </a:rPr>
+                        <a:t>4</a:t>
                       </a:r>
                     </a:p>
                   </a:txBody>
@@ -8162,7 +8162,7 @@
                           </a:solidFill>
                           <a:latin typeface="Kanit"/>
                         </a:rPr>
-                        <a:t>สมุทรปราการ</a:t>
+                        <a:t>นครปฐม</a:t>
                       </a:r>
                     </a:p>
                   </a:txBody>
@@ -8185,7 +8185,7 @@
                           </a:solidFill>
                           <a:latin typeface="Kanit"/>
                         </a:rPr>
-                        <a:t>15</a:t>
+                        <a:t>9</a:t>
                       </a:r>
                     </a:p>
                   </a:txBody>
@@ -8208,7 +8208,7 @@
                           </a:solidFill>
                           <a:latin typeface="Kanit"/>
                         </a:rPr>
-                        <a:t>19</a:t>
+                        <a:t>59</a:t>
                       </a:r>
                     </a:p>
                   </a:txBody>
@@ -8227,11 +8227,11 @@
                       <a:r>
                         <a:rPr sz="900" b="1">
                           <a:solidFill>
-                            <a:srgbClr val="606060"/>
-                          </a:solidFill>
-                          <a:latin typeface="Kanit"/>
-                        </a:rPr>
-                        <a:t>0.0%</a:t>
+                            <a:srgbClr val="F5C242"/>
+                          </a:solidFill>
+                          <a:latin typeface="Kanit"/>
+                        </a:rPr>
+                        <a:t>44.4%</a:t>
                       </a:r>
                     </a:p>
                   </a:txBody>
@@ -8254,7 +8254,7 @@
                           </a:solidFill>
                           <a:latin typeface="Kanit"/>
                         </a:rPr>
-                        <a:t>4/4</a:t>
+                        <a:t>5/7</a:t>
                       </a:r>
                     </a:p>
                   </a:txBody>
@@ -8273,11 +8273,11 @@
                       <a:r>
                         <a:rPr sz="900" b="1">
                           <a:solidFill>
-                            <a:srgbClr val="CC0000"/>
-                          </a:solidFill>
-                          <a:latin typeface="Kanit"/>
-                        </a:rPr>
-                        <a:t>5</a:t>
+                            <a:srgbClr val="F5C242"/>
+                          </a:solidFill>
+                          <a:latin typeface="Kanit"/>
+                        </a:rPr>
+                        <a:t>4</a:t>
                       </a:r>
                     </a:p>
                   </a:txBody>
@@ -8302,7 +8302,7 @@
                           </a:solidFill>
                           <a:latin typeface="Kanit"/>
                         </a:rPr>
-                        <a:t>อุดรธานี</a:t>
+                        <a:t>ตราด</a:t>
                       </a:r>
                     </a:p>
                   </a:txBody>
@@ -8325,7 +8325,7 @@
                           </a:solidFill>
                           <a:latin typeface="Kanit"/>
                         </a:rPr>
-                        <a:t>35</a:t>
+                        <a:t>46</a:t>
                       </a:r>
                     </a:p>
                   </a:txBody>
@@ -8348,7 +8348,7 @@
                           </a:solidFill>
                           <a:latin typeface="Kanit"/>
                         </a:rPr>
-                        <a:t>65</a:t>
+                        <a:t>125</a:t>
                       </a:r>
                     </a:p>
                   </a:txBody>
@@ -8371,7 +8371,7 @@
                           </a:solidFill>
                           <a:latin typeface="Kanit"/>
                         </a:rPr>
-                        <a:t>37.1%</a:t>
+                        <a:t>43.5%</a:t>
                       </a:r>
                     </a:p>
                   </a:txBody>
@@ -8394,7 +8394,7 @@
                           </a:solidFill>
                           <a:latin typeface="Kanit"/>
                         </a:rPr>
-                        <a:t>5/7</a:t>
+                        <a:t>4/9</a:t>
                       </a:r>
                     </a:p>
                   </a:txBody>
@@ -8442,7 +8442,7 @@
                           </a:solidFill>
                           <a:latin typeface="Kanit"/>
                         </a:rPr>
-                        <a:t>ปราจีนบุรี</a:t>
+                        <a:t>ศรีสะเกษ</a:t>
                       </a:r>
                     </a:p>
                   </a:txBody>
@@ -8465,7 +8465,7 @@
                           </a:solidFill>
                           <a:latin typeface="Kanit"/>
                         </a:rPr>
-                        <a:t>35</a:t>
+                        <a:t>21</a:t>
                       </a:r>
                     </a:p>
                   </a:txBody>
@@ -8488,7 +8488,7 @@
                           </a:solidFill>
                           <a:latin typeface="Kanit"/>
                         </a:rPr>
-                        <a:t>66</a:t>
+                        <a:t>141</a:t>
                       </a:r>
                     </a:p>
                   </a:txBody>
@@ -8511,7 +8511,7 @@
                           </a:solidFill>
                           <a:latin typeface="Kanit"/>
                         </a:rPr>
-                        <a:t>34.3%</a:t>
+                        <a:t>33.3%</a:t>
                       </a:r>
                     </a:p>
                   </a:txBody>
@@ -8534,7 +8534,7 @@
                           </a:solidFill>
                           <a:latin typeface="Kanit"/>
                         </a:rPr>
-                        <a:t>6/15</a:t>
+                        <a:t>1/9</a:t>
                       </a:r>
                     </a:p>
                   </a:txBody>
@@ -8582,7 +8582,7 @@
                           </a:solidFill>
                           <a:latin typeface="Kanit"/>
                         </a:rPr>
-                        <a:t>ตราด</a:t>
+                        <a:t>สมุทรสงคราม</a:t>
                       </a:r>
                     </a:p>
                   </a:txBody>
@@ -8605,7 +8605,7 @@
                           </a:solidFill>
                           <a:latin typeface="Kanit"/>
                         </a:rPr>
-                        <a:t>46</a:t>
+                        <a:t>6</a:t>
                       </a:r>
                     </a:p>
                   </a:txBody>
@@ -8628,7 +8628,7 @@
                           </a:solidFill>
                           <a:latin typeface="Kanit"/>
                         </a:rPr>
-                        <a:t>121</a:t>
+                        <a:t>65</a:t>
                       </a:r>
                     </a:p>
                   </a:txBody>
@@ -8651,7 +8651,7 @@
                           </a:solidFill>
                           <a:latin typeface="Kanit"/>
                         </a:rPr>
-                        <a:t>32.6%</a:t>
+                        <a:t>33.3%</a:t>
                       </a:r>
                     </a:p>
                   </a:txBody>
@@ -8674,7 +8674,7 @@
                           </a:solidFill>
                           <a:latin typeface="Kanit"/>
                         </a:rPr>
-                        <a:t>4/9</a:t>
+                        <a:t>1/2</a:t>
                       </a:r>
                     </a:p>
                   </a:txBody>
@@ -8909,7 +8909,7 @@
                 </a:solidFill>
                 <a:latin typeface="Kanit"/>
               </a:rPr>
-              <a:t>พื้นที่ปลูก วัดจริง (สศก. — ข้อมูลอำเภอ×พืช 3,295 แถว) ภัยแล้งเป็นดัชนี SPEI จาก แบบจำลอง คำนวณจากปริมาณฝนและการคายระเหย ปรับเดือนละครั้ง ดึงข้อมูล 2026-07-20 — เป็นสัญญาณที่ครอบคลุมทั้งประเทศดีที่สุดที่มี แต่ไม่มีใครลงพื้นที่ไปเดินดูอำเภอเหล่านั้น ข้อมูลฝนและระดับน้ำ วัดจริง (ThaiWater เรียลไทม์ ดึงทุกวันและสะสมไว้ — วันที่ดึงไม่สำเร็จจะเว้นเป็นช่องว่าง ไม่ใส่ค่าสมมติ) · ฝนถึง 2026-09-10, ระดับน้ำถึง 2026-09-10 ความเสี่ยงน้ำท่วมเชิงโครงสร้าง วัดจริง (สำมะโนพื้นที่ท่วมซ้ำซาก GISTDA มาตราส่วน 1:50,000 ปี 2005-2016 — เป็นบันทึกภาคพื้นดิน 12 ปี ไม่ใช่การพยากรณ์)</a:t>
+              <a:t>พื้นที่ปลูก วัดจริง (สศก. — ข้อมูลอำเภอ×พืช 3,295 แถว) ภัยแล้งเป็นดัชนี SPEI จาก แบบจำลอง คำนวณจากปริมาณฝนและการคายระเหย ปรับเดือนละครั้ง ดึงข้อมูล 2026-07-20 — เป็นสัญญาณที่ครอบคลุมทั้งประเทศดีที่สุดที่มี แต่ไม่มีใครลงพื้นที่ไปเดินดูอำเภอเหล่านั้น ข้อมูลฝนและระดับน้ำ วัดจริง (ThaiWater เรียลไทม์ ดึงทุกวันและสะสมไว้ — วันที่ดึงไม่สำเร็จจะเว้นเป็นช่องว่าง ไม่ใส่ค่าสมมติ) · ฝนถึง 2026-09-11, ระดับน้ำถึง 2026-09-11 ความเสี่ยงน้ำท่วมเชิงโครงสร้าง วัดจริง (สำมะโนพื้นที่ท่วมซ้ำซาก GISTDA มาตราส่วน 1:50,000 ปี 2005-2016 — เป็นบันทึกภาคพื้นดิน 12 ปี ไม่ใช่การพยากรณ์)</a:t>
             </a:r>
           </a:p>
         </p:txBody>
@@ -32047,7 +32047,7 @@
                 </a:solidFill>
                 <a:latin typeface="Kanit"/>
               </a:rPr>
-              <a:t>รุ่นข้อมูล — ราคาโลก 2026M06 · ราคาหน้าฟาร์มไทย 2026-09-09 · ประวัติราคาไทย 2026-09-05 · ต้นทุนการผลิตพืช สศก. ไจอัป 2568 (ปีเพาะปลูก 2568/69, ประมาณการ สศก. มี.ค. 2569) · ภัยแล้ง 2026-06-21 · เงินเฟ้อ 2026-05 · GDP 2026 ไตรมาส 1 · IMF WEO 2026 · ดัชนีราคาขายต่อ 2026-05 · ยอดจดทะเบียนถึง 2026-01 · หนี้ครัวเรือน สสช. SES 2566 · ค่าจ้าง สสช. LFS 2568 · ข้อมูลตรวจวัด 2026-09-10</a:t>
+              <a:t>รุ่นข้อมูล — ราคาโลก 2026M06 · ราคาหน้าฟาร์มไทย 2026-09-09 · ประวัติราคาไทย 2026-09-05 · ต้นทุนการผลิตพืช สศก. ไจอัป 2568 (ปีเพาะปลูก 2568/69, ประมาณการ สศก. มี.ค. 2569) · ภัยแล้ง 2026-06-21 · เงินเฟ้อ 2026-05 · GDP 2026 ไตรมาส 1 · IMF WEO 2026 · ดัชนีราคาขายต่อ 2026-05 · ยอดจดทะเบียนถึง 2026-01 · หนี้ครัวเรือน สสช. SES 2566 · ค่าจ้าง สสช. LFS 2568 · ข้อมูลตรวจวัด 2026-09-11</a:t>
             </a:r>
           </a:p>
         </p:txBody>
@@ -37087,7 +37087,7 @@
                 </a:solidFill>
                 <a:latin typeface="Kanit"/>
               </a:rPr>
-              <a:t>338 จาก 928 อำเภอ · แม่น้ำเกินระดับ 145 จาก 789 สถานี</a:t>
+              <a:t>338 จาก 928 อำเภอ · แม่น้ำเกินระดับ 147 จาก 788 สถานี</a:t>
             </a:r>
           </a:p>
         </p:txBody>
@@ -37859,7 +37859,7 @@
                           </a:solidFill>
                           <a:latin typeface="Kanit"/>
                         </a:rPr>
-                        <a:t>39/156</a:t>
+                        <a:t>40/155</a:t>
                       </a:r>
                     </a:p>
                   </a:txBody>
@@ -38091,7 +38091,7 @@
                           </a:solidFill>
                           <a:latin typeface="Kanit"/>
                         </a:rPr>
-                        <a:t>21/272</a:t>
+                        <a:t>19/272</a:t>
                       </a:r>
                     </a:p>
                   </a:txBody>
@@ -38323,7 +38323,7 @@
                           </a:solidFill>
                           <a:latin typeface="Kanit"/>
                         </a:rPr>
-                        <a:t>28/167</a:t>
+                        <a:t>31/167</a:t>
                       </a:r>
                     </a:p>
                   </a:txBody>

</xml_diff>

<commit_message>
deck(mcom): rebuild — the data moved past the committed figures (run 34546658719) (#913)
Co-authored-by: github-actions[bot] <41898282+github-actions[bot]@users.noreply.github.com>
</commit_message>
<xml_diff>
--- a/docs/decks/mcom-2026-08-05-macro-TH.pptx
+++ b/docs/decks/mcom-2026-08-05-macro-TH.pptx
@@ -6240,7 +6240,7 @@
                 </a:solidFill>
                 <a:latin typeface="Kanit"/>
               </a:rPr>
-              <a:t>145</a:t>
+              <a:t>147</a:t>
             </a:r>
           </a:p>
         </p:txBody>
@@ -6279,7 +6279,7 @@
                 </a:solidFill>
                 <a:latin typeface="Kanit"/>
               </a:rPr>
-              <a:t>จาก 789 (18.4%) · เรียลไทม์ · 2026-09-10</a:t>
+              <a:t>จาก 788 (18.7%) · เรียลไทม์ · 2026-09-11</a:t>
             </a:r>
           </a:p>
         </p:txBody>
@@ -6405,7 +6405,7 @@
                 </a:solidFill>
                 <a:latin typeface="Kanit"/>
               </a:rPr>
-              <a:t>51</a:t>
+              <a:t>61</a:t>
             </a:r>
           </a:p>
         </p:txBody>
@@ -6444,7 +6444,7 @@
                 </a:solidFill>
                 <a:latin typeface="Kanit"/>
               </a:rPr>
-              <a:t>ค่าล่าสุดรายวัน · 2026-09-10</a:t>
+              <a:t>ค่าล่าสุดรายวัน · 2026-09-11</a:t>
             </a:r>
           </a:p>
         </p:txBody>
@@ -7882,7 +7882,7 @@
                           </a:solidFill>
                           <a:latin typeface="Kanit"/>
                         </a:rPr>
-                        <a:t>ชุมพร</a:t>
+                        <a:t>สกลนคร</a:t>
                       </a:r>
                     </a:p>
                   </a:txBody>
@@ -7905,7 +7905,7 @@
                           </a:solidFill>
                           <a:latin typeface="Kanit"/>
                         </a:rPr>
-                        <a:t>89</a:t>
+                        <a:t>38</a:t>
                       </a:r>
                     </a:p>
                   </a:txBody>
@@ -7928,7 +7928,7 @@
                           </a:solidFill>
                           <a:latin typeface="Kanit"/>
                         </a:rPr>
-                        <a:t>60</a:t>
+                        <a:t>15</a:t>
                       </a:r>
                     </a:p>
                   </a:txBody>
@@ -7947,11 +7947,11 @@
                       <a:r>
                         <a:rPr sz="900" b="1">
                           <a:solidFill>
-                            <a:srgbClr val="F5C242"/>
-                          </a:solidFill>
-                          <a:latin typeface="Kanit"/>
-                        </a:rPr>
-                        <a:t>6.7%</a:t>
+                            <a:srgbClr val="606060"/>
+                          </a:solidFill>
+                          <a:latin typeface="Kanit"/>
+                        </a:rPr>
+                        <a:t>0.0%</a:t>
                       </a:r>
                     </a:p>
                   </a:txBody>
@@ -7974,7 +7974,7 @@
                           </a:solidFill>
                           <a:latin typeface="Kanit"/>
                         </a:rPr>
-                        <a:t>3/14</a:t>
+                        <a:t>7/12</a:t>
                       </a:r>
                     </a:p>
                   </a:txBody>
@@ -8022,7 +8022,7 @@
                           </a:solidFill>
                           <a:latin typeface="Kanit"/>
                         </a:rPr>
-                        <a:t>สกลนคร</a:t>
+                        <a:t>สมุทรปราการ</a:t>
                       </a:r>
                     </a:p>
                   </a:txBody>
@@ -8045,7 +8045,7 @@
                           </a:solidFill>
                           <a:latin typeface="Kanit"/>
                         </a:rPr>
-                        <a:t>38</a:t>
+                        <a:t>15</a:t>
                       </a:r>
                     </a:p>
                   </a:txBody>
@@ -8068,7 +8068,7 @@
                           </a:solidFill>
                           <a:latin typeface="Kanit"/>
                         </a:rPr>
-                        <a:t>69</a:t>
+                        <a:t>94</a:t>
                       </a:r>
                     </a:p>
                   </a:txBody>
@@ -8091,7 +8091,7 @@
                           </a:solidFill>
                           <a:latin typeface="Kanit"/>
                         </a:rPr>
-                        <a:t>2.6%</a:t>
+                        <a:t>60.0%</a:t>
                       </a:r>
                     </a:p>
                   </a:txBody>
@@ -8114,7 +8114,7 @@
                           </a:solidFill>
                           <a:latin typeface="Kanit"/>
                         </a:rPr>
-                        <a:t>7/12</a:t>
+                        <a:t>4/4</a:t>
                       </a:r>
                     </a:p>
                   </a:txBody>
@@ -8133,11 +8133,11 @@
                       <a:r>
                         <a:rPr sz="900" b="1">
                           <a:solidFill>
-                            <a:srgbClr val="CC0000"/>
-                          </a:solidFill>
-                          <a:latin typeface="Kanit"/>
-                        </a:rPr>
-                        <a:t>5</a:t>
+                            <a:srgbClr val="F5C242"/>
+                          </a:solidFill>
+                          <a:latin typeface="Kanit"/>
+                        </a:rPr>
+                        <a:t>4</a:t>
                       </a:r>
                     </a:p>
                   </a:txBody>
@@ -8162,7 +8162,7 @@
                           </a:solidFill>
                           <a:latin typeface="Kanit"/>
                         </a:rPr>
-                        <a:t>สมุทรปราการ</a:t>
+                        <a:t>นครปฐม</a:t>
                       </a:r>
                     </a:p>
                   </a:txBody>
@@ -8185,7 +8185,7 @@
                           </a:solidFill>
                           <a:latin typeface="Kanit"/>
                         </a:rPr>
-                        <a:t>15</a:t>
+                        <a:t>9</a:t>
                       </a:r>
                     </a:p>
                   </a:txBody>
@@ -8208,7 +8208,7 @@
                           </a:solidFill>
                           <a:latin typeface="Kanit"/>
                         </a:rPr>
-                        <a:t>19</a:t>
+                        <a:t>59</a:t>
                       </a:r>
                     </a:p>
                   </a:txBody>
@@ -8227,11 +8227,11 @@
                       <a:r>
                         <a:rPr sz="900" b="1">
                           <a:solidFill>
-                            <a:srgbClr val="606060"/>
-                          </a:solidFill>
-                          <a:latin typeface="Kanit"/>
-                        </a:rPr>
-                        <a:t>0.0%</a:t>
+                            <a:srgbClr val="F5C242"/>
+                          </a:solidFill>
+                          <a:latin typeface="Kanit"/>
+                        </a:rPr>
+                        <a:t>44.4%</a:t>
                       </a:r>
                     </a:p>
                   </a:txBody>
@@ -8254,7 +8254,7 @@
                           </a:solidFill>
                           <a:latin typeface="Kanit"/>
                         </a:rPr>
-                        <a:t>4/4</a:t>
+                        <a:t>5/7</a:t>
                       </a:r>
                     </a:p>
                   </a:txBody>
@@ -8273,11 +8273,11 @@
                       <a:r>
                         <a:rPr sz="900" b="1">
                           <a:solidFill>
-                            <a:srgbClr val="CC0000"/>
-                          </a:solidFill>
-                          <a:latin typeface="Kanit"/>
-                        </a:rPr>
-                        <a:t>5</a:t>
+                            <a:srgbClr val="F5C242"/>
+                          </a:solidFill>
+                          <a:latin typeface="Kanit"/>
+                        </a:rPr>
+                        <a:t>4</a:t>
                       </a:r>
                     </a:p>
                   </a:txBody>
@@ -8302,7 +8302,7 @@
                           </a:solidFill>
                           <a:latin typeface="Kanit"/>
                         </a:rPr>
-                        <a:t>อุดรธานี</a:t>
+                        <a:t>ตราด</a:t>
                       </a:r>
                     </a:p>
                   </a:txBody>
@@ -8325,7 +8325,7 @@
                           </a:solidFill>
                           <a:latin typeface="Kanit"/>
                         </a:rPr>
-                        <a:t>35</a:t>
+                        <a:t>46</a:t>
                       </a:r>
                     </a:p>
                   </a:txBody>
@@ -8348,7 +8348,7 @@
                           </a:solidFill>
                           <a:latin typeface="Kanit"/>
                         </a:rPr>
-                        <a:t>65</a:t>
+                        <a:t>125</a:t>
                       </a:r>
                     </a:p>
                   </a:txBody>
@@ -8371,7 +8371,7 @@
                           </a:solidFill>
                           <a:latin typeface="Kanit"/>
                         </a:rPr>
-                        <a:t>37.1%</a:t>
+                        <a:t>43.5%</a:t>
                       </a:r>
                     </a:p>
                   </a:txBody>
@@ -8394,7 +8394,7 @@
                           </a:solidFill>
                           <a:latin typeface="Kanit"/>
                         </a:rPr>
-                        <a:t>5/7</a:t>
+                        <a:t>4/9</a:t>
                       </a:r>
                     </a:p>
                   </a:txBody>
@@ -8442,7 +8442,7 @@
                           </a:solidFill>
                           <a:latin typeface="Kanit"/>
                         </a:rPr>
-                        <a:t>ปราจีนบุรี</a:t>
+                        <a:t>ศรีสะเกษ</a:t>
                       </a:r>
                     </a:p>
                   </a:txBody>
@@ -8465,7 +8465,7 @@
                           </a:solidFill>
                           <a:latin typeface="Kanit"/>
                         </a:rPr>
-                        <a:t>35</a:t>
+                        <a:t>21</a:t>
                       </a:r>
                     </a:p>
                   </a:txBody>
@@ -8488,7 +8488,7 @@
                           </a:solidFill>
                           <a:latin typeface="Kanit"/>
                         </a:rPr>
-                        <a:t>66</a:t>
+                        <a:t>141</a:t>
                       </a:r>
                     </a:p>
                   </a:txBody>
@@ -8511,7 +8511,7 @@
                           </a:solidFill>
                           <a:latin typeface="Kanit"/>
                         </a:rPr>
-                        <a:t>34.3%</a:t>
+                        <a:t>33.3%</a:t>
                       </a:r>
                     </a:p>
                   </a:txBody>
@@ -8534,7 +8534,7 @@
                           </a:solidFill>
                           <a:latin typeface="Kanit"/>
                         </a:rPr>
-                        <a:t>6/15</a:t>
+                        <a:t>1/9</a:t>
                       </a:r>
                     </a:p>
                   </a:txBody>
@@ -8582,7 +8582,7 @@
                           </a:solidFill>
                           <a:latin typeface="Kanit"/>
                         </a:rPr>
-                        <a:t>ตราด</a:t>
+                        <a:t>สมุทรสงคราม</a:t>
                       </a:r>
                     </a:p>
                   </a:txBody>
@@ -8605,7 +8605,7 @@
                           </a:solidFill>
                           <a:latin typeface="Kanit"/>
                         </a:rPr>
-                        <a:t>46</a:t>
+                        <a:t>6</a:t>
                       </a:r>
                     </a:p>
                   </a:txBody>
@@ -8628,7 +8628,7 @@
                           </a:solidFill>
                           <a:latin typeface="Kanit"/>
                         </a:rPr>
-                        <a:t>121</a:t>
+                        <a:t>65</a:t>
                       </a:r>
                     </a:p>
                   </a:txBody>
@@ -8651,7 +8651,7 @@
                           </a:solidFill>
                           <a:latin typeface="Kanit"/>
                         </a:rPr>
-                        <a:t>32.6%</a:t>
+                        <a:t>33.3%</a:t>
                       </a:r>
                     </a:p>
                   </a:txBody>
@@ -8674,7 +8674,7 @@
                           </a:solidFill>
                           <a:latin typeface="Kanit"/>
                         </a:rPr>
-                        <a:t>4/9</a:t>
+                        <a:t>1/2</a:t>
                       </a:r>
                     </a:p>
                   </a:txBody>
@@ -8909,7 +8909,7 @@
                 </a:solidFill>
                 <a:latin typeface="Kanit"/>
               </a:rPr>
-              <a:t>พื้นที่ปลูก วัดจริง (สศก. — ข้อมูลอำเภอ×พืช 3,295 แถว) ภัยแล้งเป็นดัชนี SPEI จาก แบบจำลอง คำนวณจากปริมาณฝนและการคายระเหย ปรับเดือนละครั้ง ดึงข้อมูล 2026-07-20 — เป็นสัญญาณที่ครอบคลุมทั้งประเทศดีที่สุดที่มี แต่ไม่มีใครลงพื้นที่ไปเดินดูอำเภอเหล่านั้น ข้อมูลฝนและระดับน้ำ วัดจริง (ThaiWater เรียลไทม์ ดึงทุกวันและสะสมไว้ — วันที่ดึงไม่สำเร็จจะเว้นเป็นช่องว่าง ไม่ใส่ค่าสมมติ) · ฝนถึง 2026-09-10, ระดับน้ำถึง 2026-09-10 ความเสี่ยงน้ำท่วมเชิงโครงสร้าง วัดจริง (สำมะโนพื้นที่ท่วมซ้ำซาก GISTDA มาตราส่วน 1:50,000 ปี 2005-2016 — เป็นบันทึกภาคพื้นดิน 12 ปี ไม่ใช่การพยากรณ์)</a:t>
+              <a:t>พื้นที่ปลูก วัดจริง (สศก. — ข้อมูลอำเภอ×พืช 3,295 แถว) ภัยแล้งเป็นดัชนี SPEI จาก แบบจำลอง คำนวณจากปริมาณฝนและการคายระเหย ปรับเดือนละครั้ง ดึงข้อมูล 2026-07-20 — เป็นสัญญาณที่ครอบคลุมทั้งประเทศดีที่สุดที่มี แต่ไม่มีใครลงพื้นที่ไปเดินดูอำเภอเหล่านั้น ข้อมูลฝนและระดับน้ำ วัดจริง (ThaiWater เรียลไทม์ ดึงทุกวันและสะสมไว้ — วันที่ดึงไม่สำเร็จจะเว้นเป็นช่องว่าง ไม่ใส่ค่าสมมติ) · ฝนถึง 2026-09-11, ระดับน้ำถึง 2026-09-11 ความเสี่ยงน้ำท่วมเชิงโครงสร้าง วัดจริง (สำมะโนพื้นที่ท่วมซ้ำซาก GISTDA มาตราส่วน 1:50,000 ปี 2005-2016 — เป็นบันทึกภาคพื้นดิน 12 ปี ไม่ใช่การพยากรณ์)</a:t>
             </a:r>
           </a:p>
         </p:txBody>
@@ -32047,7 +32047,7 @@
                 </a:solidFill>
                 <a:latin typeface="Kanit"/>
               </a:rPr>
-              <a:t>รุ่นข้อมูล — ราคาโลก 2026M06 · ราคาหน้าฟาร์มไทย 2026-09-09 · ประวัติราคาไทย 2026-09-05 · ต้นทุนการผลิตพืช สศก. ไจอัป 2568 (ปีเพาะปลูก 2568/69, ประมาณการ สศก. มี.ค. 2569) · ภัยแล้ง 2026-06-21 · เงินเฟ้อ 2026-05 · GDP 2026 ไตรมาส 1 · IMF WEO 2026 · ดัชนีราคาขายต่อ 2026-05 · ยอดจดทะเบียนถึง 2026-01 · หนี้ครัวเรือน สสช. SES 2566 · ค่าจ้าง สสช. LFS 2568 · ข้อมูลตรวจวัด 2026-09-10</a:t>
+              <a:t>รุ่นข้อมูล — ราคาโลก 2026M06 · ราคาหน้าฟาร์มไทย 2026-09-09 · ประวัติราคาไทย 2026-09-05 · ต้นทุนการผลิตพืช สศก. ไจอัป 2568 (ปีเพาะปลูก 2568/69, ประมาณการ สศก. มี.ค. 2569) · ภัยแล้ง 2026-06-21 · เงินเฟ้อ 2026-05 · GDP 2026 ไตรมาส 1 · IMF WEO 2026 · ดัชนีราคาขายต่อ 2026-05 · ยอดจดทะเบียนถึง 2026-01 · หนี้ครัวเรือน สสช. SES 2566 · ค่าจ้าง สสช. LFS 2568 · ข้อมูลตรวจวัด 2026-09-11</a:t>
             </a:r>
           </a:p>
         </p:txBody>
@@ -37087,7 +37087,7 @@
                 </a:solidFill>
                 <a:latin typeface="Kanit"/>
               </a:rPr>
-              <a:t>338 จาก 928 อำเภอ · แม่น้ำเกินระดับ 145 จาก 789 สถานี</a:t>
+              <a:t>338 จาก 928 อำเภอ · แม่น้ำเกินระดับ 147 จาก 788 สถานี</a:t>
             </a:r>
           </a:p>
         </p:txBody>
@@ -37859,7 +37859,7 @@
                           </a:solidFill>
                           <a:latin typeface="Kanit"/>
                         </a:rPr>
-                        <a:t>39/156</a:t>
+                        <a:t>40/155</a:t>
                       </a:r>
                     </a:p>
                   </a:txBody>
@@ -38091,7 +38091,7 @@
                           </a:solidFill>
                           <a:latin typeface="Kanit"/>
                         </a:rPr>
-                        <a:t>21/272</a:t>
+                        <a:t>19/272</a:t>
                       </a:r>
                     </a:p>
                   </a:txBody>
@@ -38323,7 +38323,7 @@
                           </a:solidFill>
                           <a:latin typeface="Kanit"/>
                         </a:rPr>
-                        <a:t>28/167</a:t>
+                        <a:t>31/167</a:t>
                       </a:r>
                     </a:p>
                   </a:txBody>

</xml_diff>

<commit_message>
deck(mcom): rebuild — the data moved past the committed figures (run 34598503032)
</commit_message>
<xml_diff>
--- a/docs/decks/mcom-2026-08-05-macro-TH.pptx
+++ b/docs/decks/mcom-2026-08-05-macro-TH.pptx
@@ -6240,7 +6240,7 @@
                 </a:solidFill>
                 <a:latin typeface="Kanit"/>
               </a:rPr>
-              <a:t>147</a:t>
+              <a:t>144</a:t>
             </a:r>
           </a:p>
         </p:txBody>
@@ -6279,7 +6279,7 @@
                 </a:solidFill>
                 <a:latin typeface="Kanit"/>
               </a:rPr>
-              <a:t>จาก 788 (18.7%) · เรียลไทม์ · 2026-09-11</a:t>
+              <a:t>จาก 788 (18.3%) · เรียลไทม์ · 2026-09-11</a:t>
             </a:r>
           </a:p>
         </p:txBody>
@@ -6405,7 +6405,7 @@
                 </a:solidFill>
                 <a:latin typeface="Kanit"/>
               </a:rPr>
-              <a:t>61</a:t>
+              <a:t>51</a:t>
             </a:r>
           </a:p>
         </p:txBody>
@@ -7882,7 +7882,7 @@
                           </a:solidFill>
                           <a:latin typeface="Kanit"/>
                         </a:rPr>
-                        <a:t>สกลนคร</a:t>
+                        <a:t>สมุทรปราการ</a:t>
                       </a:r>
                     </a:p>
                   </a:txBody>
@@ -7905,7 +7905,7 @@
                           </a:solidFill>
                           <a:latin typeface="Kanit"/>
                         </a:rPr>
-                        <a:t>38</a:t>
+                        <a:t>16</a:t>
                       </a:r>
                     </a:p>
                   </a:txBody>
@@ -7928,7 +7928,7 @@
                           </a:solidFill>
                           <a:latin typeface="Kanit"/>
                         </a:rPr>
-                        <a:t>15</a:t>
+                        <a:t>95</a:t>
                       </a:r>
                     </a:p>
                   </a:txBody>
@@ -7947,11 +7947,11 @@
                       <a:r>
                         <a:rPr sz="900" b="1">
                           <a:solidFill>
-                            <a:srgbClr val="606060"/>
-                          </a:solidFill>
-                          <a:latin typeface="Kanit"/>
-                        </a:rPr>
-                        <a:t>0.0%</a:t>
+                            <a:srgbClr val="F5C242"/>
+                          </a:solidFill>
+                          <a:latin typeface="Kanit"/>
+                        </a:rPr>
+                        <a:t>62.5%</a:t>
                       </a:r>
                     </a:p>
                   </a:txBody>
@@ -7974,7 +7974,7 @@
                           </a:solidFill>
                           <a:latin typeface="Kanit"/>
                         </a:rPr>
-                        <a:t>7/12</a:t>
+                        <a:t>4/4</a:t>
                       </a:r>
                     </a:p>
                   </a:txBody>
@@ -8022,7 +8022,7 @@
                           </a:solidFill>
                           <a:latin typeface="Kanit"/>
                         </a:rPr>
-                        <a:t>สมุทรปราการ</a:t>
+                        <a:t>สกลนคร</a:t>
                       </a:r>
                     </a:p>
                   </a:txBody>
@@ -8045,7 +8045,7 @@
                           </a:solidFill>
                           <a:latin typeface="Kanit"/>
                         </a:rPr>
-                        <a:t>15</a:t>
+                        <a:t>38</a:t>
                       </a:r>
                     </a:p>
                   </a:txBody>
@@ -8068,7 +8068,7 @@
                           </a:solidFill>
                           <a:latin typeface="Kanit"/>
                         </a:rPr>
-                        <a:t>94</a:t>
+                        <a:t>7</a:t>
                       </a:r>
                     </a:p>
                   </a:txBody>
@@ -8087,11 +8087,11 @@
                       <a:r>
                         <a:rPr sz="900" b="1">
                           <a:solidFill>
-                            <a:srgbClr val="F5C242"/>
-                          </a:solidFill>
-                          <a:latin typeface="Kanit"/>
-                        </a:rPr>
-                        <a:t>60.0%</a:t>
+                            <a:srgbClr val="606060"/>
+                          </a:solidFill>
+                          <a:latin typeface="Kanit"/>
+                        </a:rPr>
+                        <a:t>0.0%</a:t>
                       </a:r>
                     </a:p>
                   </a:txBody>
@@ -8114,7 +8114,7 @@
                           </a:solidFill>
                           <a:latin typeface="Kanit"/>
                         </a:rPr>
-                        <a:t>4/4</a:t>
+                        <a:t>7/12</a:t>
                       </a:r>
                     </a:p>
                   </a:txBody>
@@ -8133,11 +8133,11 @@
                       <a:r>
                         <a:rPr sz="900" b="1">
                           <a:solidFill>
-                            <a:srgbClr val="F5C242"/>
-                          </a:solidFill>
-                          <a:latin typeface="Kanit"/>
-                        </a:rPr>
-                        <a:t>4</a:t>
+                            <a:srgbClr val="CC0000"/>
+                          </a:solidFill>
+                          <a:latin typeface="Kanit"/>
+                        </a:rPr>
+                        <a:t>5</a:t>
                       </a:r>
                     </a:p>
                   </a:txBody>
@@ -8162,7 +8162,7 @@
                           </a:solidFill>
                           <a:latin typeface="Kanit"/>
                         </a:rPr>
-                        <a:t>นครปฐม</a:t>
+                        <a:t>สมุทรสงคราม</a:t>
                       </a:r>
                     </a:p>
                   </a:txBody>
@@ -8185,7 +8185,7 @@
                           </a:solidFill>
                           <a:latin typeface="Kanit"/>
                         </a:rPr>
-                        <a:t>9</a:t>
+                        <a:t>6</a:t>
                       </a:r>
                     </a:p>
                   </a:txBody>
@@ -8208,7 +8208,7 @@
                           </a:solidFill>
                           <a:latin typeface="Kanit"/>
                         </a:rPr>
-                        <a:t>59</a:t>
+                        <a:t>74</a:t>
                       </a:r>
                     </a:p>
                   </a:txBody>
@@ -8231,7 +8231,7 @@
                           </a:solidFill>
                           <a:latin typeface="Kanit"/>
                         </a:rPr>
-                        <a:t>44.4%</a:t>
+                        <a:t>50.0%</a:t>
                       </a:r>
                     </a:p>
                   </a:txBody>
@@ -8254,7 +8254,7 @@
                           </a:solidFill>
                           <a:latin typeface="Kanit"/>
                         </a:rPr>
-                        <a:t>5/7</a:t>
+                        <a:t>1/2</a:t>
                       </a:r>
                     </a:p>
                   </a:txBody>
@@ -8302,7 +8302,7 @@
                           </a:solidFill>
                           <a:latin typeface="Kanit"/>
                         </a:rPr>
-                        <a:t>ตราด</a:t>
+                        <a:t>นครปฐม</a:t>
                       </a:r>
                     </a:p>
                   </a:txBody>
@@ -8325,7 +8325,7 @@
                           </a:solidFill>
                           <a:latin typeface="Kanit"/>
                         </a:rPr>
-                        <a:t>46</a:t>
+                        <a:t>9</a:t>
                       </a:r>
                     </a:p>
                   </a:txBody>
@@ -8348,7 +8348,7 @@
                           </a:solidFill>
                           <a:latin typeface="Kanit"/>
                         </a:rPr>
-                        <a:t>125</a:t>
+                        <a:t>60</a:t>
                       </a:r>
                     </a:p>
                   </a:txBody>
@@ -8371,7 +8371,7 @@
                           </a:solidFill>
                           <a:latin typeface="Kanit"/>
                         </a:rPr>
-                        <a:t>43.5%</a:t>
+                        <a:t>44.4%</a:t>
                       </a:r>
                     </a:p>
                   </a:txBody>
@@ -8394,7 +8394,7 @@
                           </a:solidFill>
                           <a:latin typeface="Kanit"/>
                         </a:rPr>
-                        <a:t>4/9</a:t>
+                        <a:t>5/7</a:t>
                       </a:r>
                     </a:p>
                   </a:txBody>
@@ -8442,7 +8442,7 @@
                           </a:solidFill>
                           <a:latin typeface="Kanit"/>
                         </a:rPr>
-                        <a:t>ศรีสะเกษ</a:t>
+                        <a:t>สตูล</a:t>
                       </a:r>
                     </a:p>
                   </a:txBody>
@@ -8465,7 +8465,7 @@
                           </a:solidFill>
                           <a:latin typeface="Kanit"/>
                         </a:rPr>
-                        <a:t>21</a:t>
+                        <a:t>37</a:t>
                       </a:r>
                     </a:p>
                   </a:txBody>
@@ -8488,7 +8488,7 @@
                           </a:solidFill>
                           <a:latin typeface="Kanit"/>
                         </a:rPr>
-                        <a:t>141</a:t>
+                        <a:t>83</a:t>
                       </a:r>
                     </a:p>
                   </a:txBody>
@@ -8511,7 +8511,7 @@
                           </a:solidFill>
                           <a:latin typeface="Kanit"/>
                         </a:rPr>
-                        <a:t>33.3%</a:t>
+                        <a:t>40.5%</a:t>
                       </a:r>
                     </a:p>
                   </a:txBody>
@@ -8534,7 +8534,7 @@
                           </a:solidFill>
                           <a:latin typeface="Kanit"/>
                         </a:rPr>
-                        <a:t>1/9</a:t>
+                        <a:t>1/8</a:t>
                       </a:r>
                     </a:p>
                   </a:txBody>
@@ -8582,7 +8582,7 @@
                           </a:solidFill>
                           <a:latin typeface="Kanit"/>
                         </a:rPr>
-                        <a:t>สมุทรสงคราม</a:t>
+                        <a:t>สมุทรสาคร</a:t>
                       </a:r>
                     </a:p>
                   </a:txBody>
@@ -8628,7 +8628,7 @@
                           </a:solidFill>
                           <a:latin typeface="Kanit"/>
                         </a:rPr>
-                        <a:t>65</a:t>
+                        <a:t>104</a:t>
                       </a:r>
                     </a:p>
                   </a:txBody>
@@ -8674,7 +8674,7 @@
                           </a:solidFill>
                           <a:latin typeface="Kanit"/>
                         </a:rPr>
-                        <a:t>1/2</a:t>
+                        <a:t>3/3</a:t>
                       </a:r>
                     </a:p>
                   </a:txBody>
@@ -31476,7 +31476,7 @@
                 </a:solidFill>
                 <a:latin typeface="Kanit"/>
               </a:rPr>
-              <a:t>รายได้จากพืชค่ากลางเพิ่มขึ้น +15.6% แต่มีสี่จังหวัดที่ลดลง — ทั้งหมดอยู่ในแหล่งปลูกมะพร้าว โดยหนักที่สุดคือสมุทรสงครามที่ −64.3%</a:t>
+              <a:t>รายได้จากพืชค่ากลางเพิ่มขึ้น +15.3% แต่มีสี่จังหวัดที่ลดลง — ทั้งหมดอยู่ในแหล่งปลูกมะพร้าว โดยหนักที่สุดคือสมุทรสงครามที่ −64.6%</a:t>
             </a:r>
           </a:p>
         </p:txBody>
@@ -32047,7 +32047,7 @@
                 </a:solidFill>
                 <a:latin typeface="Kanit"/>
               </a:rPr>
-              <a:t>รุ่นข้อมูล — ราคาโลก 2026M06 · ราคาหน้าฟาร์มไทย 2026-09-09 · ประวัติราคาไทย 2026-09-05 · ต้นทุนการผลิตพืช สศก. ไจอัป 2568 (ปีเพาะปลูก 2568/69, ประมาณการ สศก. มี.ค. 2569) · ภัยแล้ง 2026-06-21 · เงินเฟ้อ 2026-05 · GDP 2026 ไตรมาส 1 · IMF WEO 2026 · ดัชนีราคาขายต่อ 2026-05 · ยอดจดทะเบียนถึง 2026-01 · หนี้ครัวเรือน สสช. SES 2566 · ค่าจ้าง สสช. LFS 2568 · ข้อมูลตรวจวัด 2026-09-11</a:t>
+              <a:t>รุ่นข้อมูล — ราคาโลก 2026M06 · ราคาหน้าฟาร์มไทย 2026-09-11 · ประวัติราคาไทย 2026-09-11 · ต้นทุนการผลิตพืช สศก. ไจอัป 2568 (ปีเพาะปลูก 2568/69, ประมาณการ สศก. มี.ค. 2569) · ภัยแล้ง 2026-06-21 · เงินเฟ้อ 2026-05 · GDP 2026 ไตรมาส 1 · IMF WEO 2026 · ดัชนีราคาขายต่อ 2026-05 · ยอดจดทะเบียนถึง 2026-01 · หนี้ครัวเรือน สสช. SES 2566 · ค่าจ้าง สสช. LFS 2568 · ข้อมูลตรวจวัด 2026-09-11</a:t>
             </a:r>
           </a:p>
         </p:txBody>
@@ -32546,7 +32546,7 @@
               <a:t>Not on the world index — the farm gate (ราคาที่เกษตรกรขายได้) says otherwise.
 • Five of seventeen Thai farm-gate prices are falling year on year.
 • Beef: farm gate −6.1% vs world index +8.8%.
-• Margin over price: a 26% price move becomes an 82% swing in crop income.</a:t>
+• Margin over price: a 25% price move becomes an 86% swing in crop income.</a:t>
             </a:r>
           </a:p>
         </p:txBody>
@@ -33912,7 +33912,7 @@
                 </a:solidFill>
                 <a:latin typeface="Kanit"/>
               </a:rPr>
-              <a:t>32.90</a:t>
+              <a:t>32.99</a:t>
             </a:r>
           </a:p>
         </p:txBody>
@@ -33951,7 +33951,7 @@
                 </a:solidFill>
                 <a:latin typeface="Kanit"/>
               </a:rPr>
-              <a:t>อัตราอ้างอิง ECB · 2026-09-07</a:t>
+              <a:t>อัตราอ้างอิง ECB · 2026-09-10</a:t>
             </a:r>
           </a:p>
         </p:txBody>
@@ -34242,7 +34242,7 @@
                 </a:solidFill>
                 <a:latin typeface="Kanit"/>
               </a:rPr>
-              <a:t>32.2 ล้าน</a:t>
+              <a:t>32.1 ล้าน</a:t>
             </a:r>
           </a:p>
         </p:txBody>
@@ -34281,7 +34281,7 @@
                 </a:solidFill>
                 <a:latin typeface="Kanit"/>
               </a:rPr>
-              <a:t>ย้อนหลัง 12 เดือน · −6.6% เทียบปีก่อน · ธปท. 2026-06</a:t>
+              <a:t>ย้อนหลัง 12 เดือน · −5.5% เทียบปีก่อน · ธปท. 2026-07</a:t>
             </a:r>
           </a:p>
         </p:txBody>
@@ -35798,7 +35798,7 @@
                 </a:solidFill>
                 <a:latin typeface="Kanit"/>
               </a:rPr>
-              <a:t>สศช. 2026 ไตรมาส 1 · TPSO 2026-05 · ธนาคารแห่งประเทศไทย 2026-08 · BIS 2025 ไตรมาส 4 · ECB 2026-09-07, ทั้งหมดดึงจากหน่วยงานผู้เผยแพร่โดยตรง ตารางเทียบประเทศใช้ IMF World Economic Outlook 2026 (ดึงข้อมูล 2026-07-25) อัตรา NPL ที่ ธปท. เผยแพร่ — 4.48% ณ 2026 ไตรมาส 1, จาก 4.33% ไตรมาสก่อน เปลี่ยน +0.24 จุดใน 1 ปี และต่ำสุด 3.08% ณ 2021 ไตรมาส 1</a:t>
+              <a:t>สศช. 2026 ไตรมาส 1 · TPSO 2026-05 · ธนาคารแห่งประเทศไทย 2026-08 · BIS 2025 ไตรมาส 4 · ECB 2026-09-10, ทั้งหมดดึงจากหน่วยงานผู้เผยแพร่โดยตรง ตารางเทียบประเทศใช้ IMF World Economic Outlook 2026 (ดึงข้อมูล 2026-07-25) อัตรา NPL ที่ ธปท. เผยแพร่ — 4.48% ณ 2026 ไตรมาส 1, จาก 4.33% ไตรมาสก่อน เปลี่ยน +0.24 จุดใน 1 ปี และต่ำสุด 3.08% ณ 2021 ไตรมาส 1</a:t>
             </a:r>
           </a:p>
         </p:txBody>
@@ -35967,7 +35967,7 @@
               <a:t>• การเติบโต: IMF ประมาณการ 1.5% ตัวเลขจริง +2.8%
 • เงินเฟ้อ: IMF ประมาณการ 0.9% ตัวเลขจริง +2.79%
 • เราใช้ตัวเลขไทยแทนประมาณการทุกครั้งที่มีตัวเลขจริง
-• ข้อยกเว้น: ท่องเที่ยว −6.6% เทียบปีก่อน (ย้อนหลัง 12 เดือน) — หนุนรายได้นอกระบบในภาคใต้และภาคตะวันออก ซึ่งข้อมูลพืชและรถมองไม่เห็น</a:t>
+• ข้อยกเว้น: ท่องเที่ยว −5.5% เทียบปีก่อน (ย้อนหลัง 12 เดือน) — หนุนรายได้นอกระบบในภาคใต้และภาคตะวันออก ซึ่งข้อมูลพืชและรถมองไม่เห็น</a:t>
             </a:r>
           </a:p>
         </p:txBody>
@@ -37087,7 +37087,7 @@
                 </a:solidFill>
                 <a:latin typeface="Kanit"/>
               </a:rPr>
-              <a:t>338 จาก 928 อำเภอ · แม่น้ำเกินระดับ 147 จาก 788 สถานี</a:t>
+              <a:t>338 จาก 928 อำเภอ · แม่น้ำเกินระดับ 144 จาก 788 สถานี</a:t>
             </a:r>
           </a:p>
         </p:txBody>
@@ -38091,7 +38091,7 @@
                           </a:solidFill>
                           <a:latin typeface="Kanit"/>
                         </a:rPr>
-                        <a:t>19/272</a:t>
+                        <a:t>20/272</a:t>
                       </a:r>
                     </a:p>
                   </a:txBody>
@@ -38323,7 +38323,7 @@
                           </a:solidFill>
                           <a:latin typeface="Kanit"/>
                         </a:rPr>
-                        <a:t>31/167</a:t>
+                        <a:t>28/167</a:t>
                       </a:r>
                     </a:p>
                   </a:txBody>
@@ -38787,7 +38787,7 @@
                           </a:solidFill>
                           <a:latin typeface="Kanit"/>
                         </a:rPr>
-                        <a:t>44/143</a:t>
+                        <a:t>43/143</a:t>
                       </a:r>
                     </a:p>
                   </a:txBody>
@@ -39936,7 +39936,7 @@
                           </a:solidFill>
                           <a:latin typeface="Kanit"/>
                         </a:rPr>
-                        <a:t>−68.7%</a:t>
+                        <a:t>−69.0%</a:t>
                       </a:r>
                     </a:p>
                   </a:txBody>
@@ -40791,7 +40791,7 @@
                 </a:solidFill>
                 <a:latin typeface="Kanit"/>
               </a:rPr>
-              <a:t>ราคา วัดจริง — ราคาหน้าฟาร์มไทยจากราคารายวันของ NABC และราคาอ้อยประกาศของ สอน. ราคาล่าสุด 2026-09-09 การเปลี่ยนแปลงหกเดือนคำนวณจากข้อมูลรายเดือนของ NABC เอง (thai_price_history รุ่นข้อมูล 2026-09-05) พืชที่ไม่มีข้อมูลรายเดือนจะกำกับไว้ ไม่ประมาณการขึ้นมา แหล่งผลิตเป็นการอ่านแบบ ประมาณการ ว่าสินค้าแต่ละชนิดปลูกที่ไหน และแหล่งผลิตทับซ้อนกันได้ บัญชีอาชีพเกษตรเป็นข้อมูลของเราเองและ วัดจริง — บัญชีที่บันทึกอาชีพว่า เกษตร ในจังหวัดแหล่งผลิต จากฐานข้อมูล 382,735 บัญชี ณ 2026-07 ไม่เผยแพร่ช่องที่มีน้อยกว่า 30 บัญชี คนกลุ่มนี้อาศัยอยู่ในพื้นที่ที่ปลูกพืชนั้น แต่ไม่ได้ยืนยันว่าปลูกพืชนั้นเอง</a:t>
+              <a:t>ราคา วัดจริง — ราคาหน้าฟาร์มไทยจากราคารายวันของ NABC และราคาอ้อยประกาศของ สอน. ราคาล่าสุด 2026-09-11 การเปลี่ยนแปลงหกเดือนคำนวณจากข้อมูลรายเดือนของ NABC เอง (thai_price_history รุ่นข้อมูล 2026-09-11) พืชที่ไม่มีข้อมูลรายเดือนจะกำกับไว้ ไม่ประมาณการขึ้นมา แหล่งผลิตเป็นการอ่านแบบ ประมาณการ ว่าสินค้าแต่ละชนิดปลูกที่ไหน และแหล่งผลิตทับซ้อนกันได้ บัญชีอาชีพเกษตรเป็นข้อมูลของเราเองและ วัดจริง — บัญชีที่บันทึกอาชีพว่า เกษตร ในจังหวัดแหล่งผลิต จากฐานข้อมูล 382,735 บัญชี ณ 2026-07 ไม่เผยแพร่ช่องที่มีน้อยกว่า 30 บัญชี คนกลุ่มนี้อาศัยอยู่ในพื้นที่ที่ปลูกพืชนั้น แต่ไม่ได้ยืนยันว่าปลูกพืชนั้นเอง</a:t>
             </a:r>
           </a:p>
         </p:txBody>
@@ -43419,7 +43419,7 @@
                           </a:solidFill>
                           <a:latin typeface="Kanit"/>
                         </a:rPr>
-                        <a:t>91.45</a:t>
+                        <a:t>91.73</a:t>
                       </a:r>
                     </a:p>
                   </a:txBody>
@@ -43559,7 +43559,7 @@
                           </a:solidFill>
                           <a:latin typeface="Kanit"/>
                         </a:rPr>
-                        <a:t>15,362</a:t>
+                        <a:t>15,409</a:t>
                       </a:r>
                     </a:p>
                   </a:txBody>
@@ -43699,7 +43699,7 @@
                           </a:solidFill>
                           <a:latin typeface="Kanit"/>
                         </a:rPr>
-                        <a:t>36,217</a:t>
+                        <a:t>36,327</a:t>
                       </a:r>
                     </a:p>
                   </a:txBody>
@@ -43839,7 +43839,7 @@
                           </a:solidFill>
                           <a:latin typeface="Kanit"/>
                         </a:rPr>
-                        <a:t>11.18</a:t>
+                        <a:t>11.22</a:t>
                       </a:r>
                     </a:p>
                   </a:txBody>
@@ -44058,7 +44058,7 @@
                 </a:solidFill>
                 <a:latin typeface="Kanit"/>
               </a:rPr>
-              <a:t>ราคารายเดือนสกุลดอลลาร์ราคาปัจจุบันจาก World Bank Pink Sheet รุ่นข้อมูล 2026M07 (ข้อมูล 60 จุดต่อรายการ ปรับฐานเป็น 100 ณ 2021-07 เพื่อวาดกราฟ — หน่วยต่างกัน จึงใช้แกนเดียวกับระดับราคาดิบไม่ได้) แปลงเป็นบาทด้วยอัตราอ้างอิง ECB USD/THB 32.895 ณ 2026-09-07 สัดส่วนพื้นที่ปลูก วัดจริง จากสัดส่วนพืชของ สศก./กรมส่งเสริมการเกษตร (crop_mix.json) เป็นราคาปัจจุบัน ไม่ได้ปรับเงินเฟ้อ: ทุกตัวเลข ‘เทียบ 5 ปีก่อน’ มีเงินเฟ้อไทยห้าปีซ่อนอยู่ข้างใต้</a:t>
+              <a:t>ราคารายเดือนสกุลดอลลาร์ราคาปัจจุบันจาก World Bank Pink Sheet รุ่นข้อมูล 2026M07 (ข้อมูล 60 จุดต่อรายการ ปรับฐานเป็น 100 ณ 2021-07 เพื่อวาดกราฟ — หน่วยต่างกัน จึงใช้แกนเดียวกับระดับราคาดิบไม่ได้) แปลงเป็นบาทด้วยอัตราอ้างอิง ECB USD/THB 32.995 ณ 2026-09-10 สัดส่วนพื้นที่ปลูก วัดจริง จากสัดส่วนพืชของ สศก./กรมส่งเสริมการเกษตร (crop_mix.json) เป็นราคาปัจจุบัน ไม่ได้ปรับเงินเฟ้อ: ทุกตัวเลข ‘เทียบ 5 ปีก่อน’ มีเงินเฟ้อไทยห้าปีซ่อนอยู่ข้างใต้</a:t>
             </a:r>
           </a:p>
         </p:txBody>
@@ -44679,7 +44679,7 @@
                 </a:solidFill>
                 <a:latin typeface="Kanit"/>
               </a:rPr>
-              <a:t>มะพร้าว −68.7% สับปะรด −18.4% อ้อย −17.9% เทียบปีก่อน</a:t>
+              <a:t>มะพร้าว −69.0% สับปะรด −18.4% อ้อย −17.9% เทียบปีก่อน</a:t>
             </a:r>
           </a:p>
         </p:txBody>
@@ -44805,7 +44805,7 @@
                 </a:solidFill>
                 <a:latin typeface="Kanit"/>
               </a:rPr>
-              <a:t>+15.6%</a:t>
+              <a:t>+15.3%</a:t>
             </a:r>
           </a:p>
         </p:txBody>
@@ -45279,7 +45279,7 @@
                           </a:solidFill>
                           <a:latin typeface="Kanit"/>
                         </a:rPr>
-                        <a:t>+5.7%</a:t>
+                        <a:t>+5.4%</a:t>
                       </a:r>
                     </a:p>
                   </a:txBody>
@@ -45348,7 +45348,7 @@
                           </a:solidFill>
                           <a:latin typeface="Kanit"/>
                         </a:rPr>
-                        <a:t>-64.3%</a:t>
+                        <a:t>-64.6%</a:t>
                       </a:r>
                     </a:p>
                   </a:txBody>
@@ -45419,7 +45419,7 @@
                           </a:solidFill>
                           <a:latin typeface="Kanit"/>
                         </a:rPr>
-                        <a:t>+14.8%</a:t>
+                        <a:t>+14.4%</a:t>
                       </a:r>
                     </a:p>
                   </a:txBody>
@@ -45488,7 +45488,7 @@
                           </a:solidFill>
                           <a:latin typeface="Kanit"/>
                         </a:rPr>
-                        <a:t>+9.2%</a:t>
+                        <a:t>+8.8%</a:t>
                       </a:r>
                     </a:p>
                   </a:txBody>
@@ -45559,7 +45559,7 @@
                           </a:solidFill>
                           <a:latin typeface="Kanit"/>
                         </a:rPr>
-                        <a:t>+16.6%</a:t>
+                        <a:t>+16.4%</a:t>
                       </a:r>
                     </a:p>
                   </a:txBody>
@@ -45628,7 +45628,7 @@
                           </a:solidFill>
                           <a:latin typeface="Kanit"/>
                         </a:rPr>
-                        <a:t>+8.0%</a:t>
+                        <a:t>+7.7%</a:t>
                       </a:r>
                     </a:p>
                   </a:txBody>
@@ -45768,7 +45768,7 @@
                           </a:solidFill>
                           <a:latin typeface="Kanit"/>
                         </a:rPr>
-                        <a:t>+11.1%</a:t>
+                        <a:t>+10.9%</a:t>
                       </a:r>
                     </a:p>
                   </a:txBody>
@@ -45908,7 +45908,7 @@
                           </a:solidFill>
                           <a:latin typeface="Kanit"/>
                         </a:rPr>
-                        <a:t>+27.2%</a:t>
+                        <a:t>+27.3%</a:t>
                       </a:r>
                     </a:p>
                   </a:txBody>
@@ -46084,7 +46084,7 @@
                 </a:solidFill>
                 <a:latin typeface="Kanit"/>
               </a:rPr>
-              <a:t>•  ราคาหน้าฟาร์ม: ยางพารา +40% มันสำปะหลัง +76% ปาล์ม +23% ข้าว +13% รายได้จากพืชเพิ่มขึ้นทุกภาค
+              <a:t>•  ราคาหน้าฟาร์ม: ยางพารา +40% มันสำปะหลัง +77% ปาล์ม +24% ข้าว +12% รายได้จากพืชเพิ่มขึ้นทุกภาค
 •  มีสี่จังหวัดที่ลดลง — ทั้งหมดเป็นมะพร้าว และอยู่ฝั่งอ่าวไทยตะวันตก ราคามะพร้าวลดลง 69%
 •  กำไรบนกระดาษยังไม่ใช่เงินสด — ตารางถัดไปหักราคาด้วยต้นทุน</a:t>
             </a:r>
@@ -46387,7 +46387,7 @@
                           </a:solidFill>
                           <a:latin typeface="Kanit"/>
                         </a:rPr>
-                        <a:t>+17.3%</a:t>
+                        <a:t>+17.0%</a:t>
                       </a:r>
                     </a:p>
                   </a:txBody>
@@ -46550,7 +46550,7 @@
                           </a:solidFill>
                           <a:latin typeface="Kanit"/>
                         </a:rPr>
-                        <a:t>+21.0%</a:t>
+                        <a:t>+20.7%</a:t>
                       </a:r>
                     </a:p>
                   </a:txBody>
@@ -46713,7 +46713,7 @@
                           </a:solidFill>
                           <a:latin typeface="Kanit"/>
                         </a:rPr>
-                        <a:t>+10.9%</a:t>
+                        <a:t>+10.6%</a:t>
                       </a:r>
                     </a:p>
                   </a:txBody>
@@ -47039,7 +47039,7 @@
                           </a:solidFill>
                           <a:latin typeface="Kanit"/>
                         </a:rPr>
-                        <a:t>+16.3%</a:t>
+                        <a:t>+16.0%</a:t>
                       </a:r>
                     </a:p>
                   </a:txBody>
@@ -47202,7 +47202,7 @@
                           </a:solidFill>
                           <a:latin typeface="Kanit"/>
                         </a:rPr>
-                        <a:t>+14.6%</a:t>
+                        <a:t>+14.3%</a:t>
                       </a:r>
                     </a:p>
                   </a:txBody>
@@ -48024,7 +48024,7 @@
                 </a:solidFill>
                 <a:latin typeface="Kanit"/>
               </a:rPr>
-              <a:t>เทียบปีก่อน −68.7%</a:t>
+              <a:t>เทียบปีก่อน −69.0%</a:t>
             </a:r>
           </a:p>
         </p:txBody>
@@ -48134,22 +48134,22 @@
             <a:pathLst>
               <a:path w="2064715" h="457200">
                 <a:moveTo>
-                  <a:pt x="0" y="38315"/>
+                  <a:pt x="0" y="38804"/>
                 </a:moveTo>
                 <a:lnTo>
                   <a:pt x="412943" y="0"/>
                 </a:lnTo>
                 <a:lnTo>
-                  <a:pt x="825886" y="372997"/>
+                  <a:pt x="825886" y="380210"/>
                 </a:lnTo>
                 <a:lnTo>
                   <a:pt x="1238829" y="457200"/>
                 </a:lnTo>
                 <a:lnTo>
-                  <a:pt x="1651772" y="385356"/>
-                </a:lnTo>
-                <a:lnTo>
-                  <a:pt x="2064715" y="411313"/>
+                  <a:pt x="1651772" y="398914"/>
+                </a:lnTo>
+                <a:lnTo>
+                  <a:pt x="2064715" y="419093"/>
                 </a:lnTo>
               </a:path>
             </a:pathLst>
@@ -48192,7 +48192,7 @@
         </p:nvSpPr>
         <p:spPr>
           <a:xfrm>
-            <a:off x="2480767" y="2816185"/>
+            <a:off x="2480767" y="2823965"/>
             <a:ext cx="82296" cy="82296"/>
           </a:xfrm>
           <a:prstGeom prst="roundRect">
@@ -48621,7 +48621,7 @@
                 </a:solidFill>
                 <a:latin typeface="Kanit"/>
               </a:rPr>
-              <a:t>฿142.50 /กก. · ชายฝั่งใต้·ตอ.</a:t>
+              <a:t>฿141.25 /กก. · ชายฝั่งใต้·ตอ.</a:t>
             </a:r>
           </a:p>
         </p:txBody>
@@ -48660,7 +48660,7 @@
                 </a:solidFill>
                 <a:latin typeface="Kanit"/>
               </a:rPr>
-              <a:t>เทียบปีก่อน +0.4%</a:t>
+              <a:t>เทียบปีก่อน +0.3%</a:t>
             </a:r>
           </a:p>
         </p:txBody>
@@ -48699,7 +48699,7 @@
                 </a:solidFill>
                 <a:latin typeface="Kanit"/>
               </a:rPr>
-              <a:t>6 เดือน +8.0%</a:t>
+              <a:t>6 เดือน +6.7%</a:t>
             </a:r>
           </a:p>
         </p:txBody>
@@ -48776,7 +48776,7 @@
                   <a:pt x="412943" y="457200"/>
                 </a:lnTo>
                 <a:lnTo>
-                  <a:pt x="825886" y="420235"/>
+                  <a:pt x="825886" y="425604"/>
                 </a:lnTo>
                 <a:lnTo>
                   <a:pt x="1238829" y="169952"/>
@@ -48785,7 +48785,7 @@
                   <a:pt x="1651772" y="0"/>
                 </a:lnTo>
                 <a:lnTo>
-                  <a:pt x="2064715" y="12596"/>
+                  <a:pt x="2064715" y="38409"/>
                 </a:lnTo>
               </a:path>
             </a:pathLst>
@@ -48828,7 +48828,7 @@
         </p:nvSpPr>
         <p:spPr>
           <a:xfrm>
-            <a:off x="7085685" y="2417468"/>
+            <a:off x="7085685" y="2443281"/>
             <a:ext cx="82296" cy="82296"/>
           </a:xfrm>
           <a:prstGeom prst="roundRect">
@@ -48978,7 +48978,7 @@
                 </a:solidFill>
                 <a:latin typeface="Kanit"/>
               </a:rPr>
-              <a:t>เทียบปีก่อน +5.1%</a:t>
+              <a:t>เทียบปีก่อน +5.4%</a:t>
             </a:r>
           </a:p>
         </p:txBody>
@@ -49017,7 +49017,7 @@
                 </a:solidFill>
                 <a:latin typeface="Kanit"/>
               </a:rPr>
-              <a:t>6 เดือน +0.0%</a:t>
+              <a:t>6 เดือน +0.2%</a:t>
             </a:r>
           </a:p>
         </p:txBody>
@@ -49088,7 +49088,7 @@
             <a:pathLst>
               <a:path w="2064715" h="457200">
                 <a:moveTo>
-                  <a:pt x="0" y="122251"/>
+                  <a:pt x="0" y="119269"/>
                 </a:moveTo>
                 <a:lnTo>
                   <a:pt x="412943" y="309106"/>
@@ -49296,7 +49296,7 @@
                 </a:solidFill>
                 <a:latin typeface="Kanit"/>
               </a:rPr>
-              <a:t>เทียบปีก่อน +7.1%</a:t>
+              <a:t>เทียบปีก่อน +7.6%</a:t>
             </a:r>
           </a:p>
         </p:txBody>
@@ -49536,7 +49536,7 @@
                 </a:solidFill>
                 <a:latin typeface="Kanit"/>
               </a:rPr>
-              <a:t>ข้าวหอมมะลิ</a:t>
+              <a:t>ข้าวโพดเลี้ยงสัตว์</a:t>
             </a:r>
           </a:p>
         </p:txBody>
@@ -49575,7 +49575,7 @@
                 </a:solidFill>
                 <a:latin typeface="Kanit"/>
               </a:rPr>
-              <a:t>฿17,494 /ตัน · อีสาน·เหนือ·กลาง</a:t>
+              <a:t>฿8.92 /กก. · เหนือ</a:t>
             </a:r>
           </a:p>
         </p:txBody>
@@ -49614,7 +49614,7 @@
                 </a:solidFill>
                 <a:latin typeface="Kanit"/>
               </a:rPr>
-              <a:t>เทียบปีก่อน +12.8%</a:t>
+              <a:t>เทียบปีก่อน +12.1%</a:t>
             </a:r>
           </a:p>
         </p:txBody>
@@ -49628,6 +49628,285 @@
         <p:spPr>
           <a:xfrm>
             <a:off x="1489557" y="3351275"/>
+            <a:ext cx="1078077" cy="134112"/>
+          </a:xfrm>
+          <a:prstGeom prst="rect">
+            <a:avLst/>
+          </a:prstGeom>
+          <a:noFill/>
+        </p:spPr>
+        <p:txBody>
+          <a:bodyPr wrap="square" lIns="0" rIns="0" tIns="0" bIns="0" anchor="t">
+            <a:noAutofit/>
+          </a:bodyPr>
+          <a:lstStyle/>
+          <a:p>
+            <a:pPr algn="l">
+              <a:lnSpc>
+                <a:spcPts val="1056"/>
+              </a:lnSpc>
+            </a:pPr>
+            <a:r>
+              <a:rPr sz="800" b="1">
+                <a:solidFill>
+                  <a:srgbClr val="CC0000"/>
+                </a:solidFill>
+                <a:latin typeface="Kanit"/>
+              </a:rPr>
+              <a:t>6 เดือน −2.0%</a:t>
+            </a:r>
+          </a:p>
+        </p:txBody>
+      </p:sp>
+      <p:sp>
+        <p:nvSpPr>
+          <p:cNvPr id="54" name="Rectangle 53"/>
+          <p:cNvSpPr/>
+          <p:nvPr/>
+        </p:nvSpPr>
+        <p:spPr>
+          <a:xfrm>
+            <a:off x="411480" y="3506724"/>
+            <a:ext cx="2156155" cy="548640"/>
+          </a:xfrm>
+          <a:prstGeom prst="rect">
+            <a:avLst/>
+          </a:prstGeom>
+          <a:solidFill>
+            <a:srgbClr val="FBFCFE"/>
+          </a:solidFill>
+          <a:ln w="9525">
+            <a:solidFill>
+              <a:srgbClr val="D9DEE9"/>
+            </a:solidFill>
+          </a:ln>
+          <a:effectLst/>
+        </p:spPr>
+        <p:style>
+          <a:lnRef idx="1">
+            <a:schemeClr val="accent1"/>
+          </a:lnRef>
+          <a:fillRef idx="3">
+            <a:schemeClr val="accent1"/>
+          </a:fillRef>
+          <a:effectRef idx="2">
+            <a:schemeClr val="accent1"/>
+          </a:effectRef>
+          <a:fontRef idx="minor">
+            <a:schemeClr val="lt1"/>
+          </a:fontRef>
+        </p:style>
+        <p:txBody>
+          <a:bodyPr rtlCol="0" anchor="ctr" wrap="none"/>
+          <a:lstStyle/>
+          <a:p>
+            <a:pPr algn="ctr"/>
+          </a:p>
+        </p:txBody>
+      </p:sp>
+      <p:sp>
+        <p:nvSpPr>
+          <p:cNvPr id="55" name="Freeform 54"/>
+          <p:cNvSpPr/>
+          <p:nvPr/>
+        </p:nvSpPr>
+        <p:spPr>
+          <a:xfrm>
+            <a:off x="457200" y="3552444"/>
+            <a:ext cx="2064715" cy="457200"/>
+          </a:xfrm>
+          <a:custGeom>
+            <a:avLst/>
+            <a:gdLst/>
+            <a:ahLst/>
+            <a:cxnLst/>
+            <a:rect l="l" t="t" r="r" b="b"/>
+            <a:pathLst>
+              <a:path w="2064715" h="457200">
+                <a:moveTo>
+                  <a:pt x="0" y="321155"/>
+                </a:moveTo>
+                <a:lnTo>
+                  <a:pt x="412943" y="80288"/>
+                </a:lnTo>
+                <a:lnTo>
+                  <a:pt x="825886" y="0"/>
+                </a:lnTo>
+                <a:lnTo>
+                  <a:pt x="1238829" y="53525"/>
+                </a:lnTo>
+                <a:lnTo>
+                  <a:pt x="1651772" y="274319"/>
+                </a:lnTo>
+                <a:lnTo>
+                  <a:pt x="2064715" y="457200"/>
+                </a:lnTo>
+              </a:path>
+            </a:pathLst>
+          </a:custGeom>
+          <a:noFill/>
+          <a:ln w="20320">
+            <a:solidFill>
+              <a:srgbClr val="CC0000"/>
+            </a:solidFill>
+          </a:ln>
+          <a:effectLst/>
+        </p:spPr>
+        <p:style>
+          <a:lnRef idx="1">
+            <a:schemeClr val="accent1"/>
+          </a:lnRef>
+          <a:fillRef idx="3">
+            <a:schemeClr val="accent1"/>
+          </a:fillRef>
+          <a:effectRef idx="2">
+            <a:schemeClr val="accent1"/>
+          </a:effectRef>
+          <a:fontRef idx="minor">
+            <a:schemeClr val="lt1"/>
+          </a:fontRef>
+        </p:style>
+        <p:txBody>
+          <a:bodyPr rtlCol="0" anchor="ctr"/>
+          <a:lstStyle/>
+          <a:p>
+            <a:pPr algn="ctr"/>
+          </a:p>
+        </p:txBody>
+      </p:sp>
+      <p:sp>
+        <p:nvSpPr>
+          <p:cNvPr id="56" name="Rounded Rectangle 55"/>
+          <p:cNvSpPr/>
+          <p:nvPr/>
+        </p:nvSpPr>
+        <p:spPr>
+          <a:xfrm>
+            <a:off x="2480767" y="3968496"/>
+            <a:ext cx="82296" cy="82296"/>
+          </a:xfrm>
+          <a:prstGeom prst="roundRect">
+            <a:avLst>
+              <a:gd name="adj" fmla="val 50000"/>
+            </a:avLst>
+          </a:prstGeom>
+          <a:solidFill>
+            <a:srgbClr val="CC0000"/>
+          </a:solidFill>
+          <a:ln>
+            <a:noFill/>
+          </a:ln>
+          <a:effectLst/>
+        </p:spPr>
+        <p:style>
+          <a:lnRef idx="1">
+            <a:schemeClr val="accent1"/>
+          </a:lnRef>
+          <a:fillRef idx="3">
+            <a:schemeClr val="accent1"/>
+          </a:fillRef>
+          <a:effectRef idx="2">
+            <a:schemeClr val="accent1"/>
+          </a:effectRef>
+          <a:fontRef idx="minor">
+            <a:schemeClr val="lt1"/>
+          </a:fontRef>
+        </p:style>
+        <p:txBody>
+          <a:bodyPr rtlCol="0" anchor="ctr" wrap="none"/>
+          <a:lstStyle/>
+          <a:p>
+            <a:pPr algn="ctr"/>
+          </a:p>
+        </p:txBody>
+      </p:sp>
+      <p:sp>
+        <p:nvSpPr>
+          <p:cNvPr id="57" name="TextBox 56"/>
+          <p:cNvSpPr txBox="1"/>
+          <p:nvPr/>
+        </p:nvSpPr>
+        <p:spPr>
+          <a:xfrm>
+            <a:off x="2713939" y="3076956"/>
+            <a:ext cx="2156155" cy="150876"/>
+          </a:xfrm>
+          <a:prstGeom prst="rect">
+            <a:avLst/>
+          </a:prstGeom>
+          <a:noFill/>
+        </p:spPr>
+        <p:txBody>
+          <a:bodyPr wrap="square" lIns="0" rIns="0" tIns="0" bIns="0" anchor="t">
+            <a:noAutofit/>
+          </a:bodyPr>
+          <a:lstStyle/>
+          <a:p>
+            <a:pPr algn="l">
+              <a:lnSpc>
+                <a:spcPts val="1188"/>
+              </a:lnSpc>
+            </a:pPr>
+            <a:r>
+              <a:rPr sz="900" b="1">
+                <a:solidFill>
+                  <a:srgbClr val="1E2F5C"/>
+                </a:solidFill>
+                <a:latin typeface="Kanit"/>
+              </a:rPr>
+              <a:t>ข้าวหอมมะลิ</a:t>
+            </a:r>
+          </a:p>
+        </p:txBody>
+      </p:sp>
+      <p:sp>
+        <p:nvSpPr>
+          <p:cNvPr id="58" name="TextBox 57"/>
+          <p:cNvSpPr txBox="1"/>
+          <p:nvPr/>
+        </p:nvSpPr>
+        <p:spPr>
+          <a:xfrm>
+            <a:off x="2713939" y="3218687"/>
+            <a:ext cx="2156155" cy="125730"/>
+          </a:xfrm>
+          <a:prstGeom prst="rect">
+            <a:avLst/>
+          </a:prstGeom>
+          <a:noFill/>
+        </p:spPr>
+        <p:txBody>
+          <a:bodyPr wrap="square" lIns="0" rIns="0" tIns="0" bIns="0" anchor="t">
+            <a:noAutofit/>
+          </a:bodyPr>
+          <a:lstStyle/>
+          <a:p>
+            <a:pPr algn="l">
+              <a:lnSpc>
+                <a:spcPts val="990"/>
+              </a:lnSpc>
+            </a:pPr>
+            <a:r>
+              <a:rPr sz="750" b="0">
+                <a:solidFill>
+                  <a:srgbClr val="606060"/>
+                </a:solidFill>
+                <a:latin typeface="Kanit"/>
+              </a:rPr>
+              <a:t>฿17,443 /ตัน · อีสาน·เหนือ·กลาง</a:t>
+            </a:r>
+          </a:p>
+        </p:txBody>
+      </p:sp>
+      <p:sp>
+        <p:nvSpPr>
+          <p:cNvPr id="59" name="TextBox 58"/>
+          <p:cNvSpPr txBox="1"/>
+          <p:nvPr/>
+        </p:nvSpPr>
+        <p:spPr>
+          <a:xfrm>
+            <a:off x="2713939" y="3351275"/>
             <a:ext cx="1078077" cy="134112"/>
           </a:xfrm>
           <a:prstGeom prst="rect">
@@ -49653,260 +49932,20 @@
                 </a:solidFill>
                 <a:latin typeface="Kanit"/>
               </a:rPr>
-              <a:t>6 เดือน +4.3%</a:t>
+              <a:t>เทียบปีก่อน +12.4%</a:t>
             </a:r>
           </a:p>
         </p:txBody>
       </p:sp>
       <p:sp>
         <p:nvSpPr>
-          <p:cNvPr id="54" name="Rectangle 53"/>
-          <p:cNvSpPr/>
-          <p:nvPr/>
-        </p:nvSpPr>
-        <p:spPr>
-          <a:xfrm>
-            <a:off x="411480" y="3506724"/>
-            <a:ext cx="2156155" cy="548640"/>
-          </a:xfrm>
-          <a:prstGeom prst="rect">
-            <a:avLst/>
-          </a:prstGeom>
-          <a:solidFill>
-            <a:srgbClr val="FBFCFE"/>
-          </a:solidFill>
-          <a:ln w="9525">
-            <a:solidFill>
-              <a:srgbClr val="D9DEE9"/>
-            </a:solidFill>
-          </a:ln>
-          <a:effectLst/>
-        </p:spPr>
-        <p:style>
-          <a:lnRef idx="1">
-            <a:schemeClr val="accent1"/>
-          </a:lnRef>
-          <a:fillRef idx="3">
-            <a:schemeClr val="accent1"/>
-          </a:fillRef>
-          <a:effectRef idx="2">
-            <a:schemeClr val="accent1"/>
-          </a:effectRef>
-          <a:fontRef idx="minor">
-            <a:schemeClr val="lt1"/>
-          </a:fontRef>
-        </p:style>
-        <p:txBody>
-          <a:bodyPr rtlCol="0" anchor="ctr" wrap="none"/>
-          <a:lstStyle/>
-          <a:p>
-            <a:pPr algn="ctr"/>
-          </a:p>
-        </p:txBody>
-      </p:sp>
-      <p:sp>
-        <p:nvSpPr>
-          <p:cNvPr id="55" name="Freeform 54"/>
-          <p:cNvSpPr/>
-          <p:nvPr/>
-        </p:nvSpPr>
-        <p:spPr>
-          <a:xfrm>
-            <a:off x="457200" y="3552444"/>
-            <a:ext cx="2064715" cy="457200"/>
-          </a:xfrm>
-          <a:custGeom>
-            <a:avLst/>
-            <a:gdLst/>
-            <a:ahLst/>
-            <a:cxnLst/>
-            <a:rect l="l" t="t" r="r" b="b"/>
-            <a:pathLst>
-              <a:path w="2064715" h="457200">
-                <a:moveTo>
-                  <a:pt x="0" y="457200"/>
-                </a:moveTo>
-                <a:lnTo>
-                  <a:pt x="412943" y="212701"/>
-                </a:lnTo>
-                <a:lnTo>
-                  <a:pt x="825886" y="41154"/>
-                </a:lnTo>
-                <a:lnTo>
-                  <a:pt x="1238829" y="30357"/>
-                </a:lnTo>
-                <a:lnTo>
-                  <a:pt x="1651772" y="0"/>
-                </a:lnTo>
-                <a:lnTo>
-                  <a:pt x="2064715" y="163560"/>
-                </a:lnTo>
-              </a:path>
-            </a:pathLst>
-          </a:custGeom>
-          <a:noFill/>
-          <a:ln w="20320">
-            <a:solidFill>
-              <a:srgbClr val="15795F"/>
-            </a:solidFill>
-          </a:ln>
-          <a:effectLst/>
-        </p:spPr>
-        <p:style>
-          <a:lnRef idx="1">
-            <a:schemeClr val="accent1"/>
-          </a:lnRef>
-          <a:fillRef idx="3">
-            <a:schemeClr val="accent1"/>
-          </a:fillRef>
-          <a:effectRef idx="2">
-            <a:schemeClr val="accent1"/>
-          </a:effectRef>
-          <a:fontRef idx="minor">
-            <a:schemeClr val="lt1"/>
-          </a:fontRef>
-        </p:style>
-        <p:txBody>
-          <a:bodyPr rtlCol="0" anchor="ctr"/>
-          <a:lstStyle/>
-          <a:p>
-            <a:pPr algn="ctr"/>
-          </a:p>
-        </p:txBody>
-      </p:sp>
-      <p:sp>
-        <p:nvSpPr>
-          <p:cNvPr id="56" name="Rounded Rectangle 55"/>
-          <p:cNvSpPr/>
-          <p:nvPr/>
-        </p:nvSpPr>
-        <p:spPr>
-          <a:xfrm>
-            <a:off x="2480767" y="3674856"/>
-            <a:ext cx="82296" cy="82296"/>
-          </a:xfrm>
-          <a:prstGeom prst="roundRect">
-            <a:avLst>
-              <a:gd name="adj" fmla="val 50000"/>
-            </a:avLst>
-          </a:prstGeom>
-          <a:solidFill>
-            <a:srgbClr val="15795F"/>
-          </a:solidFill>
-          <a:ln>
-            <a:noFill/>
-          </a:ln>
-          <a:effectLst/>
-        </p:spPr>
-        <p:style>
-          <a:lnRef idx="1">
-            <a:schemeClr val="accent1"/>
-          </a:lnRef>
-          <a:fillRef idx="3">
-            <a:schemeClr val="accent1"/>
-          </a:fillRef>
-          <a:effectRef idx="2">
-            <a:schemeClr val="accent1"/>
-          </a:effectRef>
-          <a:fontRef idx="minor">
-            <a:schemeClr val="lt1"/>
-          </a:fontRef>
-        </p:style>
-        <p:txBody>
-          <a:bodyPr rtlCol="0" anchor="ctr" wrap="none"/>
-          <a:lstStyle/>
-          <a:p>
-            <a:pPr algn="ctr"/>
-          </a:p>
-        </p:txBody>
-      </p:sp>
-      <p:sp>
-        <p:nvSpPr>
-          <p:cNvPr id="57" name="TextBox 56"/>
+          <p:cNvPr id="60" name="TextBox 59"/>
           <p:cNvSpPr txBox="1"/>
           <p:nvPr/>
         </p:nvSpPr>
         <p:spPr>
           <a:xfrm>
-            <a:off x="2713939" y="3076956"/>
-            <a:ext cx="2156155" cy="150876"/>
-          </a:xfrm>
-          <a:prstGeom prst="rect">
-            <a:avLst/>
-          </a:prstGeom>
-          <a:noFill/>
-        </p:spPr>
-        <p:txBody>
-          <a:bodyPr wrap="square" lIns="0" rIns="0" tIns="0" bIns="0" anchor="t">
-            <a:noAutofit/>
-          </a:bodyPr>
-          <a:lstStyle/>
-          <a:p>
-            <a:pPr algn="l">
-              <a:lnSpc>
-                <a:spcPts val="1188"/>
-              </a:lnSpc>
-            </a:pPr>
-            <a:r>
-              <a:rPr sz="900" b="1">
-                <a:solidFill>
-                  <a:srgbClr val="1E2F5C"/>
-                </a:solidFill>
-                <a:latin typeface="Kanit"/>
-              </a:rPr>
-              <a:t>ข้าวโพดเลี้ยงสัตว์</a:t>
-            </a:r>
-          </a:p>
-        </p:txBody>
-      </p:sp>
-      <p:sp>
-        <p:nvSpPr>
-          <p:cNvPr id="58" name="TextBox 57"/>
-          <p:cNvSpPr txBox="1"/>
-          <p:nvPr/>
-        </p:nvSpPr>
-        <p:spPr>
-          <a:xfrm>
-            <a:off x="2713939" y="3218687"/>
-            <a:ext cx="2156155" cy="125730"/>
-          </a:xfrm>
-          <a:prstGeom prst="rect">
-            <a:avLst/>
-          </a:prstGeom>
-          <a:noFill/>
-        </p:spPr>
-        <p:txBody>
-          <a:bodyPr wrap="square" lIns="0" rIns="0" tIns="0" bIns="0" anchor="t">
-            <a:noAutofit/>
-          </a:bodyPr>
-          <a:lstStyle/>
-          <a:p>
-            <a:pPr algn="l">
-              <a:lnSpc>
-                <a:spcPts val="990"/>
-              </a:lnSpc>
-            </a:pPr>
-            <a:r>
-              <a:rPr sz="750" b="0">
-                <a:solidFill>
-                  <a:srgbClr val="606060"/>
-                </a:solidFill>
-                <a:latin typeface="Kanit"/>
-              </a:rPr>
-              <a:t>฿9.05 /กก. · เหนือ</a:t>
-            </a:r>
-          </a:p>
-        </p:txBody>
-      </p:sp>
-      <p:sp>
-        <p:nvSpPr>
-          <p:cNvPr id="59" name="TextBox 58"/>
-          <p:cNvSpPr txBox="1"/>
-          <p:nvPr/>
-        </p:nvSpPr>
-        <p:spPr>
-          <a:xfrm>
-            <a:off x="2713939" y="3351275"/>
+            <a:off x="3792016" y="3351275"/>
             <a:ext cx="1078077" cy="134112"/>
           </a:xfrm>
           <a:prstGeom prst="rect">
@@ -49932,46 +49971,7 @@
                 </a:solidFill>
                 <a:latin typeface="Kanit"/>
               </a:rPr>
-              <a:t>เทียบปีก่อน +13.6%</a:t>
-            </a:r>
-          </a:p>
-        </p:txBody>
-      </p:sp>
-      <p:sp>
-        <p:nvSpPr>
-          <p:cNvPr id="60" name="TextBox 59"/>
-          <p:cNvSpPr txBox="1"/>
-          <p:nvPr/>
-        </p:nvSpPr>
-        <p:spPr>
-          <a:xfrm>
-            <a:off x="3792016" y="3351275"/>
-            <a:ext cx="1078077" cy="134112"/>
-          </a:xfrm>
-          <a:prstGeom prst="rect">
-            <a:avLst/>
-          </a:prstGeom>
-          <a:noFill/>
-        </p:spPr>
-        <p:txBody>
-          <a:bodyPr wrap="square" lIns="0" rIns="0" tIns="0" bIns="0" anchor="t">
-            <a:noAutofit/>
-          </a:bodyPr>
-          <a:lstStyle/>
-          <a:p>
-            <a:pPr algn="l">
-              <a:lnSpc>
-                <a:spcPts val="1056"/>
-              </a:lnSpc>
-            </a:pPr>
-            <a:r>
-              <a:rPr sz="800" b="1">
-                <a:solidFill>
-                  <a:srgbClr val="CC0000"/>
-                </a:solidFill>
-                <a:latin typeface="Kanit"/>
-              </a:rPr>
-              <a:t>6 เดือน −0.3%</a:t>
+              <a:t>6 เดือน +4.0%</a:t>
             </a:r>
           </a:p>
         </p:txBody>
@@ -50042,22 +50042,22 @@
             <a:pathLst>
               <a:path w="2064715" h="457200">
                 <a:moveTo>
-                  <a:pt x="0" y="342301"/>
+                  <a:pt x="0" y="457200"/>
                 </a:moveTo>
                 <a:lnTo>
-                  <a:pt x="412943" y="83780"/>
-                </a:lnTo>
-                <a:lnTo>
-                  <a:pt x="825886" y="0"/>
-                </a:lnTo>
-                <a:lnTo>
-                  <a:pt x="1238829" y="47874"/>
-                </a:lnTo>
-                <a:lnTo>
-                  <a:pt x="1651772" y="292033"/>
-                </a:lnTo>
-                <a:lnTo>
-                  <a:pt x="2064715" y="457200"/>
+                  <a:pt x="412943" y="237319"/>
+                </a:lnTo>
+                <a:lnTo>
+                  <a:pt x="825886" y="75982"/>
+                </a:lnTo>
+                <a:lnTo>
+                  <a:pt x="1238829" y="44763"/>
+                </a:lnTo>
+                <a:lnTo>
+                  <a:pt x="1651772" y="0"/>
+                </a:lnTo>
+                <a:lnTo>
+                  <a:pt x="2064715" y="211262"/>
                 </a:lnTo>
               </a:path>
             </a:pathLst>
@@ -50065,7 +50065,7 @@
           <a:noFill/>
           <a:ln w="20320">
             <a:solidFill>
-              <a:srgbClr val="CC0000"/>
+              <a:srgbClr val="15795F"/>
             </a:solidFill>
           </a:ln>
           <a:effectLst/>
@@ -50100,7 +50100,7 @@
         </p:nvSpPr>
         <p:spPr>
           <a:xfrm>
-            <a:off x="4783226" y="3968496"/>
+            <a:off x="4783226" y="3722558"/>
             <a:ext cx="82296" cy="82296"/>
           </a:xfrm>
           <a:prstGeom prst="roundRect">
@@ -50109,7 +50109,7 @@
             </a:avLst>
           </a:prstGeom>
           <a:solidFill>
-            <a:srgbClr val="CC0000"/>
+            <a:srgbClr val="15795F"/>
           </a:solidFill>
           <a:ln>
             <a:noFill/>
@@ -50211,7 +50211,7 @@
                 </a:solidFill>
                 <a:latin typeface="Kanit"/>
               </a:rPr>
-              <a:t>฿8.38 /กก. · ใต้</a:t>
+              <a:t>฿8.41 /กก. · ใต้</a:t>
             </a:r>
           </a:p>
         </p:txBody>
@@ -50250,7 +50250,7 @@
                 </a:solidFill>
                 <a:latin typeface="Kanit"/>
               </a:rPr>
-              <a:t>เทียบปีก่อน +23.4%</a:t>
+              <a:t>เทียบปีก่อน +23.6%</a:t>
             </a:r>
           </a:p>
         </p:txBody>
@@ -50289,7 +50289,7 @@
                 </a:solidFill>
                 <a:latin typeface="Kanit"/>
               </a:rPr>
-              <a:t>6 เดือน +16.2%</a:t>
+              <a:t>6 เดือน +16.6%</a:t>
             </a:r>
           </a:p>
         </p:txBody>
@@ -50366,7 +50366,7 @@
                   <a:pt x="412943" y="457200"/>
                 </a:lnTo>
                 <a:lnTo>
-                  <a:pt x="825886" y="293166"/>
+                  <a:pt x="825886" y="296656"/>
                 </a:lnTo>
                 <a:lnTo>
                   <a:pt x="1238829" y="76781"/>
@@ -50375,7 +50375,7 @@
                   <a:pt x="1651772" y="0"/>
                 </a:lnTo>
                 <a:lnTo>
-                  <a:pt x="2064715" y="45370"/>
+                  <a:pt x="2064715" y="34900"/>
                 </a:lnTo>
               </a:path>
             </a:pathLst>
@@ -50418,7 +50418,7 @@
         </p:nvSpPr>
         <p:spPr>
           <a:xfrm>
-            <a:off x="7085685" y="3556666"/>
+            <a:off x="7085685" y="3546196"/>
             <a:ext cx="82296" cy="82296"/>
           </a:xfrm>
           <a:prstGeom prst="roundRect">
@@ -50529,7 +50529,7 @@
                 </a:solidFill>
                 <a:latin typeface="Kanit"/>
               </a:rPr>
-              <a:t>฿74.67 /กก. · กลาง·ตต.·ตอ.</a:t>
+              <a:t>฿74.74 /กก. · กลาง·ตต.·ตอ.</a:t>
             </a:r>
           </a:p>
         </p:txBody>
@@ -50568,7 +50568,7 @@
                 </a:solidFill>
                 <a:latin typeface="Kanit"/>
               </a:rPr>
-              <a:t>เทียบปีก่อน +24.2%</a:t>
+              <a:t>เทียบปีก่อน +26.9%</a:t>
             </a:r>
           </a:p>
         </p:txBody>
@@ -50607,7 +50607,7 @@
                 </a:solidFill>
                 <a:latin typeface="Kanit"/>
               </a:rPr>
-              <a:t>6 เดือน +18.4%</a:t>
+              <a:t>6 เดือน +18.5%</a:t>
             </a:r>
           </a:p>
         </p:txBody>
@@ -50678,19 +50678,19 @@
             <a:pathLst>
               <a:path w="2064715" h="457200">
                 <a:moveTo>
-                  <a:pt x="0" y="220046"/>
+                  <a:pt x="0" y="223049"/>
                 </a:moveTo>
                 <a:lnTo>
                   <a:pt x="412943" y="457200"/>
                 </a:lnTo>
                 <a:lnTo>
-                  <a:pt x="825886" y="343487"/>
-                </a:lnTo>
-                <a:lnTo>
-                  <a:pt x="1238829" y="264994"/>
-                </a:lnTo>
-                <a:lnTo>
-                  <a:pt x="1651772" y="111364"/>
+                  <a:pt x="825886" y="346852"/>
+                </a:lnTo>
+                <a:lnTo>
+                  <a:pt x="1238829" y="262074"/>
+                </a:lnTo>
+                <a:lnTo>
+                  <a:pt x="1651772" y="114047"/>
                 </a:lnTo>
                 <a:lnTo>
                   <a:pt x="2064715" y="0"/>
@@ -50847,7 +50847,7 @@
                 </a:solidFill>
                 <a:latin typeface="Kanit"/>
               </a:rPr>
-              <a:t>฿80.62 /กก. · ใต้·ตอ.</a:t>
+              <a:t>฿81.03 /กก. · ใต้·ตอ.</a:t>
             </a:r>
           </a:p>
         </p:txBody>
@@ -50925,7 +50925,7 @@
                 </a:solidFill>
                 <a:latin typeface="Kanit"/>
               </a:rPr>
-              <a:t>6 เดือน +18.5%</a:t>
+              <a:t>6 เดือน +18.9%</a:t>
             </a:r>
           </a:p>
         </p:txBody>
@@ -51005,13 +51005,13 @@
                   <a:pt x="825886" y="0"/>
                 </a:lnTo>
                 <a:lnTo>
-                  <a:pt x="1238829" y="66071"/>
+                  <a:pt x="1238829" y="62808"/>
                 </a:lnTo>
                 <a:lnTo>
                   <a:pt x="1651772" y="195360"/>
                 </a:lnTo>
                 <a:lnTo>
-                  <a:pt x="2064715" y="219831"/>
+                  <a:pt x="2064715" y="203109"/>
                 </a:lnTo>
               </a:path>
             </a:pathLst>
@@ -51054,7 +51054,7 @@
         </p:nvSpPr>
         <p:spPr>
           <a:xfrm>
-            <a:off x="11690603" y="3731127"/>
+            <a:off x="11690603" y="3714405"/>
             <a:ext cx="82296" cy="82296"/>
           </a:xfrm>
           <a:prstGeom prst="roundRect">
@@ -51165,7 +51165,7 @@
                 </a:solidFill>
                 <a:latin typeface="Kanit"/>
               </a:rPr>
-              <a:t>฿3.92 /กก. · อีสาน·เหนือ·ตอ.</a:t>
+              <a:t>฿3.93 /กก. · อีสาน·เหนือ·ตอ.</a:t>
             </a:r>
           </a:p>
         </p:txBody>
@@ -51204,7 +51204,7 @@
                 </a:solidFill>
                 <a:latin typeface="Kanit"/>
               </a:rPr>
-              <a:t>เทียบปีก่อน +76.3%</a:t>
+              <a:t>เทียบปีก่อน +77.2%</a:t>
             </a:r>
           </a:p>
         </p:txBody>
@@ -51243,7 +51243,7 @@
                 </a:solidFill>
                 <a:latin typeface="Kanit"/>
               </a:rPr>
-              <a:t>6 เดือน +47.4%</a:t>
+              <a:t>6 เดือน +48.3%</a:t>
             </a:r>
           </a:p>
         </p:txBody>
@@ -51317,16 +51317,16 @@
                   <a:pt x="0" y="457200"/>
                 </a:moveTo>
                 <a:lnTo>
-                  <a:pt x="412943" y="366666"/>
-                </a:lnTo>
-                <a:lnTo>
-                  <a:pt x="825886" y="253498"/>
-                </a:lnTo>
-                <a:lnTo>
-                  <a:pt x="1238829" y="217284"/>
-                </a:lnTo>
-                <a:lnTo>
-                  <a:pt x="1651772" y="49795"/>
+                  <a:pt x="412943" y="367553"/>
+                </a:lnTo>
+                <a:lnTo>
+                  <a:pt x="825886" y="255495"/>
+                </a:lnTo>
+                <a:lnTo>
+                  <a:pt x="1238829" y="210671"/>
+                </a:lnTo>
+                <a:lnTo>
+                  <a:pt x="1651772" y="49306"/>
                 </a:lnTo>
                 <a:lnTo>
                   <a:pt x="2064715" y="0"/>
@@ -51483,7 +51483,7 @@
                 </a:solidFill>
                 <a:latin typeface="Kanit"/>
               </a:rPr>
-              <a:t>฿250.00 /ร้อยผล · กลาง·ตต.</a:t>
+              <a:t>฿277.78 /ร้อยผล · กลาง·ตต.</a:t>
             </a:r>
           </a:p>
         </p:txBody>
@@ -51522,7 +51522,7 @@
                 </a:solidFill>
                 <a:latin typeface="Kanit"/>
               </a:rPr>
-              <a:t>เทียบปีก่อน +114.6%</a:t>
+              <a:t>เทียบปีก่อน +198.1%</a:t>
             </a:r>
           </a:p>
         </p:txBody>
@@ -51561,7 +51561,7 @@
                 </a:solidFill>
                 <a:latin typeface="Kanit"/>
               </a:rPr>
-              <a:t>6 เดือน −45.0%</a:t>
+              <a:t>6 เดือน −38.9%</a:t>
             </a:r>
           </a:p>
         </p:txBody>
@@ -51647,7 +51647,7 @@
                   <a:pt x="1651772" y="413314"/>
                 </a:lnTo>
                 <a:lnTo>
-                  <a:pt x="2064715" y="348309"/>
+                  <a:pt x="2064715" y="329975"/>
                 </a:lnTo>
               </a:path>
             </a:pathLst>
@@ -51690,7 +51690,7 @@
         </p:nvSpPr>
         <p:spPr>
           <a:xfrm>
-            <a:off x="4783226" y="4966028"/>
+            <a:off x="4783226" y="4947694"/>
             <a:ext cx="82296" cy="82296"/>
           </a:xfrm>
           <a:prstGeom prst="roundRect">
@@ -51886,7 +51886,7 @@
                 </a:solidFill>
                 <a:latin typeface="Kanit"/>
               </a:rPr>
-              <a:t>ราคาหน้าฟาร์ม วัดจริง — ราคารายวันของ NABC เฉลี่ยเป็นรายเดือน หน่วยเป็นบาทตามที่เผยแพร่ (ไม่มีการแปลงสกุลเงิน) ราคาล่าสุด 2026-09-09, รุ่นข้อมูลย้อนหลัง 2026-09-05 ราคาหน้าฟาร์ม (ราคาที่เกษตรกรขายได้) คือเงินที่เกษตรกรได้รับเมื่อขายครั้งแรก ก่อนพ่อค้าคนกลาง โรงสี หรือค่าขนส่งจะหักส่วนแบ่ง — ไม่ใช่ดัชนีโลก และไม่ใช่ราคาในซูเปอร์มาร์เก็ต แหล่งผลิตเป็นการอ่านแบบ ประมาณการ ว่าสินค้าแต่ละชนิดผลิตที่ไหน และทับซ้อนกันได้ น้ำตาลเป็นราคาอ้อยประกาศของ สอน. ปีละหนึ่งจุด จึงไม่มีการเปลี่ยนแปลงหกเดือนให้แสดง</a:t>
+              <a:t>ราคาหน้าฟาร์ม วัดจริง — ราคารายวันของ NABC เฉลี่ยเป็นรายเดือน หน่วยเป็นบาทตามที่เผยแพร่ (ไม่มีการแปลงสกุลเงิน) ราคาล่าสุด 2026-09-11, รุ่นข้อมูลย้อนหลัง 2026-09-11 ราคาหน้าฟาร์ม (ราคาที่เกษตรกรขายได้) คือเงินที่เกษตรกรได้รับเมื่อขายครั้งแรก ก่อนพ่อค้าคนกลาง โรงสี หรือค่าขนส่งจะหักส่วนแบ่ง — ไม่ใช่ดัชนีโลก และไม่ใช่ราคาในซูเปอร์มาร์เก็ต แหล่งผลิตเป็นการอ่านแบบ ประมาณการ ว่าสินค้าแต่ละชนิดผลิตที่ไหน และทับซ้อนกันได้ น้ำตาลเป็นราคาอ้อยประกาศของ สอน. ปีละหนึ่งจุด จึงไม่มีการเปลี่ยนแปลงหกเดือนให้แสดง</a:t>
             </a:r>
           </a:p>
         </p:txBody>

</xml_diff>

<commit_message>
deck(mcom): rebuild — the data moved past the committed figures (run 34598503032) (#921)
Co-authored-by: github-actions[bot] <41898282+github-actions[bot]@users.noreply.github.com>
</commit_message>
<xml_diff>
--- a/docs/decks/mcom-2026-08-05-macro-TH.pptx
+++ b/docs/decks/mcom-2026-08-05-macro-TH.pptx
@@ -6240,7 +6240,7 @@
                 </a:solidFill>
                 <a:latin typeface="Kanit"/>
               </a:rPr>
-              <a:t>147</a:t>
+              <a:t>144</a:t>
             </a:r>
           </a:p>
         </p:txBody>
@@ -6279,7 +6279,7 @@
                 </a:solidFill>
                 <a:latin typeface="Kanit"/>
               </a:rPr>
-              <a:t>จาก 788 (18.7%) · เรียลไทม์ · 2026-09-11</a:t>
+              <a:t>จาก 788 (18.3%) · เรียลไทม์ · 2026-09-11</a:t>
             </a:r>
           </a:p>
         </p:txBody>
@@ -6405,7 +6405,7 @@
                 </a:solidFill>
                 <a:latin typeface="Kanit"/>
               </a:rPr>
-              <a:t>61</a:t>
+              <a:t>51</a:t>
             </a:r>
           </a:p>
         </p:txBody>
@@ -7882,7 +7882,7 @@
                           </a:solidFill>
                           <a:latin typeface="Kanit"/>
                         </a:rPr>
-                        <a:t>สกลนคร</a:t>
+                        <a:t>สมุทรปราการ</a:t>
                       </a:r>
                     </a:p>
                   </a:txBody>
@@ -7905,7 +7905,7 @@
                           </a:solidFill>
                           <a:latin typeface="Kanit"/>
                         </a:rPr>
-                        <a:t>38</a:t>
+                        <a:t>16</a:t>
                       </a:r>
                     </a:p>
                   </a:txBody>
@@ -7928,7 +7928,7 @@
                           </a:solidFill>
                           <a:latin typeface="Kanit"/>
                         </a:rPr>
-                        <a:t>15</a:t>
+                        <a:t>95</a:t>
                       </a:r>
                     </a:p>
                   </a:txBody>
@@ -7947,11 +7947,11 @@
                       <a:r>
                         <a:rPr sz="900" b="1">
                           <a:solidFill>
-                            <a:srgbClr val="606060"/>
-                          </a:solidFill>
-                          <a:latin typeface="Kanit"/>
-                        </a:rPr>
-                        <a:t>0.0%</a:t>
+                            <a:srgbClr val="F5C242"/>
+                          </a:solidFill>
+                          <a:latin typeface="Kanit"/>
+                        </a:rPr>
+                        <a:t>62.5%</a:t>
                       </a:r>
                     </a:p>
                   </a:txBody>
@@ -7974,7 +7974,7 @@
                           </a:solidFill>
                           <a:latin typeface="Kanit"/>
                         </a:rPr>
-                        <a:t>7/12</a:t>
+                        <a:t>4/4</a:t>
                       </a:r>
                     </a:p>
                   </a:txBody>
@@ -8022,7 +8022,7 @@
                           </a:solidFill>
                           <a:latin typeface="Kanit"/>
                         </a:rPr>
-                        <a:t>สมุทรปราการ</a:t>
+                        <a:t>สกลนคร</a:t>
                       </a:r>
                     </a:p>
                   </a:txBody>
@@ -8045,7 +8045,7 @@
                           </a:solidFill>
                           <a:latin typeface="Kanit"/>
                         </a:rPr>
-                        <a:t>15</a:t>
+                        <a:t>38</a:t>
                       </a:r>
                     </a:p>
                   </a:txBody>
@@ -8068,7 +8068,7 @@
                           </a:solidFill>
                           <a:latin typeface="Kanit"/>
                         </a:rPr>
-                        <a:t>94</a:t>
+                        <a:t>7</a:t>
                       </a:r>
                     </a:p>
                   </a:txBody>
@@ -8087,11 +8087,11 @@
                       <a:r>
                         <a:rPr sz="900" b="1">
                           <a:solidFill>
-                            <a:srgbClr val="F5C242"/>
-                          </a:solidFill>
-                          <a:latin typeface="Kanit"/>
-                        </a:rPr>
-                        <a:t>60.0%</a:t>
+                            <a:srgbClr val="606060"/>
+                          </a:solidFill>
+                          <a:latin typeface="Kanit"/>
+                        </a:rPr>
+                        <a:t>0.0%</a:t>
                       </a:r>
                     </a:p>
                   </a:txBody>
@@ -8114,7 +8114,7 @@
                           </a:solidFill>
                           <a:latin typeface="Kanit"/>
                         </a:rPr>
-                        <a:t>4/4</a:t>
+                        <a:t>7/12</a:t>
                       </a:r>
                     </a:p>
                   </a:txBody>
@@ -8133,11 +8133,11 @@
                       <a:r>
                         <a:rPr sz="900" b="1">
                           <a:solidFill>
-                            <a:srgbClr val="F5C242"/>
-                          </a:solidFill>
-                          <a:latin typeface="Kanit"/>
-                        </a:rPr>
-                        <a:t>4</a:t>
+                            <a:srgbClr val="CC0000"/>
+                          </a:solidFill>
+                          <a:latin typeface="Kanit"/>
+                        </a:rPr>
+                        <a:t>5</a:t>
                       </a:r>
                     </a:p>
                   </a:txBody>
@@ -8162,7 +8162,7 @@
                           </a:solidFill>
                           <a:latin typeface="Kanit"/>
                         </a:rPr>
-                        <a:t>นครปฐม</a:t>
+                        <a:t>สมุทรสงคราม</a:t>
                       </a:r>
                     </a:p>
                   </a:txBody>
@@ -8185,7 +8185,7 @@
                           </a:solidFill>
                           <a:latin typeface="Kanit"/>
                         </a:rPr>
-                        <a:t>9</a:t>
+                        <a:t>6</a:t>
                       </a:r>
                     </a:p>
                   </a:txBody>
@@ -8208,7 +8208,7 @@
                           </a:solidFill>
                           <a:latin typeface="Kanit"/>
                         </a:rPr>
-                        <a:t>59</a:t>
+                        <a:t>74</a:t>
                       </a:r>
                     </a:p>
                   </a:txBody>
@@ -8231,7 +8231,7 @@
                           </a:solidFill>
                           <a:latin typeface="Kanit"/>
                         </a:rPr>
-                        <a:t>44.4%</a:t>
+                        <a:t>50.0%</a:t>
                       </a:r>
                     </a:p>
                   </a:txBody>
@@ -8254,7 +8254,7 @@
                           </a:solidFill>
                           <a:latin typeface="Kanit"/>
                         </a:rPr>
-                        <a:t>5/7</a:t>
+                        <a:t>1/2</a:t>
                       </a:r>
                     </a:p>
                   </a:txBody>
@@ -8302,7 +8302,7 @@
                           </a:solidFill>
                           <a:latin typeface="Kanit"/>
                         </a:rPr>
-                        <a:t>ตราด</a:t>
+                        <a:t>นครปฐม</a:t>
                       </a:r>
                     </a:p>
                   </a:txBody>
@@ -8325,7 +8325,7 @@
                           </a:solidFill>
                           <a:latin typeface="Kanit"/>
                         </a:rPr>
-                        <a:t>46</a:t>
+                        <a:t>9</a:t>
                       </a:r>
                     </a:p>
                   </a:txBody>
@@ -8348,7 +8348,7 @@
                           </a:solidFill>
                           <a:latin typeface="Kanit"/>
                         </a:rPr>
-                        <a:t>125</a:t>
+                        <a:t>60</a:t>
                       </a:r>
                     </a:p>
                   </a:txBody>
@@ -8371,7 +8371,7 @@
                           </a:solidFill>
                           <a:latin typeface="Kanit"/>
                         </a:rPr>
-                        <a:t>43.5%</a:t>
+                        <a:t>44.4%</a:t>
                       </a:r>
                     </a:p>
                   </a:txBody>
@@ -8394,7 +8394,7 @@
                           </a:solidFill>
                           <a:latin typeface="Kanit"/>
                         </a:rPr>
-                        <a:t>4/9</a:t>
+                        <a:t>5/7</a:t>
                       </a:r>
                     </a:p>
                   </a:txBody>
@@ -8442,7 +8442,7 @@
                           </a:solidFill>
                           <a:latin typeface="Kanit"/>
                         </a:rPr>
-                        <a:t>ศรีสะเกษ</a:t>
+                        <a:t>สตูล</a:t>
                       </a:r>
                     </a:p>
                   </a:txBody>
@@ -8465,7 +8465,7 @@
                           </a:solidFill>
                           <a:latin typeface="Kanit"/>
                         </a:rPr>
-                        <a:t>21</a:t>
+                        <a:t>37</a:t>
                       </a:r>
                     </a:p>
                   </a:txBody>
@@ -8488,7 +8488,7 @@
                           </a:solidFill>
                           <a:latin typeface="Kanit"/>
                         </a:rPr>
-                        <a:t>141</a:t>
+                        <a:t>83</a:t>
                       </a:r>
                     </a:p>
                   </a:txBody>
@@ -8511,7 +8511,7 @@
                           </a:solidFill>
                           <a:latin typeface="Kanit"/>
                         </a:rPr>
-                        <a:t>33.3%</a:t>
+                        <a:t>40.5%</a:t>
                       </a:r>
                     </a:p>
                   </a:txBody>
@@ -8534,7 +8534,7 @@
                           </a:solidFill>
                           <a:latin typeface="Kanit"/>
                         </a:rPr>
-                        <a:t>1/9</a:t>
+                        <a:t>1/8</a:t>
                       </a:r>
                     </a:p>
                   </a:txBody>
@@ -8582,7 +8582,7 @@
                           </a:solidFill>
                           <a:latin typeface="Kanit"/>
                         </a:rPr>
-                        <a:t>สมุทรสงคราม</a:t>
+                        <a:t>สมุทรสาคร</a:t>
                       </a:r>
                     </a:p>
                   </a:txBody>
@@ -8628,7 +8628,7 @@
                           </a:solidFill>
                           <a:latin typeface="Kanit"/>
                         </a:rPr>
-                        <a:t>65</a:t>
+                        <a:t>104</a:t>
                       </a:r>
                     </a:p>
                   </a:txBody>
@@ -8674,7 +8674,7 @@
                           </a:solidFill>
                           <a:latin typeface="Kanit"/>
                         </a:rPr>
-                        <a:t>1/2</a:t>
+                        <a:t>3/3</a:t>
                       </a:r>
                     </a:p>
                   </a:txBody>
@@ -31476,7 +31476,7 @@
                 </a:solidFill>
                 <a:latin typeface="Kanit"/>
               </a:rPr>
-              <a:t>รายได้จากพืชค่ากลางเพิ่มขึ้น +15.6% แต่มีสี่จังหวัดที่ลดลง — ทั้งหมดอยู่ในแหล่งปลูกมะพร้าว โดยหนักที่สุดคือสมุทรสงครามที่ −64.3%</a:t>
+              <a:t>รายได้จากพืชค่ากลางเพิ่มขึ้น +15.3% แต่มีสี่จังหวัดที่ลดลง — ทั้งหมดอยู่ในแหล่งปลูกมะพร้าว โดยหนักที่สุดคือสมุทรสงครามที่ −64.6%</a:t>
             </a:r>
           </a:p>
         </p:txBody>
@@ -32047,7 +32047,7 @@
                 </a:solidFill>
                 <a:latin typeface="Kanit"/>
               </a:rPr>
-              <a:t>รุ่นข้อมูล — ราคาโลก 2026M06 · ราคาหน้าฟาร์มไทย 2026-09-09 · ประวัติราคาไทย 2026-09-05 · ต้นทุนการผลิตพืช สศก. ไจอัป 2568 (ปีเพาะปลูก 2568/69, ประมาณการ สศก. มี.ค. 2569) · ภัยแล้ง 2026-06-21 · เงินเฟ้อ 2026-05 · GDP 2026 ไตรมาส 1 · IMF WEO 2026 · ดัชนีราคาขายต่อ 2026-05 · ยอดจดทะเบียนถึง 2026-01 · หนี้ครัวเรือน สสช. SES 2566 · ค่าจ้าง สสช. LFS 2568 · ข้อมูลตรวจวัด 2026-09-11</a:t>
+              <a:t>รุ่นข้อมูล — ราคาโลก 2026M06 · ราคาหน้าฟาร์มไทย 2026-09-11 · ประวัติราคาไทย 2026-09-11 · ต้นทุนการผลิตพืช สศก. ไจอัป 2568 (ปีเพาะปลูก 2568/69, ประมาณการ สศก. มี.ค. 2569) · ภัยแล้ง 2026-06-21 · เงินเฟ้อ 2026-05 · GDP 2026 ไตรมาส 1 · IMF WEO 2026 · ดัชนีราคาขายต่อ 2026-05 · ยอดจดทะเบียนถึง 2026-01 · หนี้ครัวเรือน สสช. SES 2566 · ค่าจ้าง สสช. LFS 2568 · ข้อมูลตรวจวัด 2026-09-11</a:t>
             </a:r>
           </a:p>
         </p:txBody>
@@ -32546,7 +32546,7 @@
               <a:t>Not on the world index — the farm gate (ราคาที่เกษตรกรขายได้) says otherwise.
 • Five of seventeen Thai farm-gate prices are falling year on year.
 • Beef: farm gate −6.1% vs world index +8.8%.
-• Margin over price: a 26% price move becomes an 82% swing in crop income.</a:t>
+• Margin over price: a 25% price move becomes an 86% swing in crop income.</a:t>
             </a:r>
           </a:p>
         </p:txBody>
@@ -33912,7 +33912,7 @@
                 </a:solidFill>
                 <a:latin typeface="Kanit"/>
               </a:rPr>
-              <a:t>32.90</a:t>
+              <a:t>32.99</a:t>
             </a:r>
           </a:p>
         </p:txBody>
@@ -33951,7 +33951,7 @@
                 </a:solidFill>
                 <a:latin typeface="Kanit"/>
               </a:rPr>
-              <a:t>อัตราอ้างอิง ECB · 2026-09-07</a:t>
+              <a:t>อัตราอ้างอิง ECB · 2026-09-10</a:t>
             </a:r>
           </a:p>
         </p:txBody>
@@ -34242,7 +34242,7 @@
                 </a:solidFill>
                 <a:latin typeface="Kanit"/>
               </a:rPr>
-              <a:t>32.2 ล้าน</a:t>
+              <a:t>32.1 ล้าน</a:t>
             </a:r>
           </a:p>
         </p:txBody>
@@ -34281,7 +34281,7 @@
                 </a:solidFill>
                 <a:latin typeface="Kanit"/>
               </a:rPr>
-              <a:t>ย้อนหลัง 12 เดือน · −6.6% เทียบปีก่อน · ธปท. 2026-06</a:t>
+              <a:t>ย้อนหลัง 12 เดือน · −5.5% เทียบปีก่อน · ธปท. 2026-07</a:t>
             </a:r>
           </a:p>
         </p:txBody>
@@ -35798,7 +35798,7 @@
                 </a:solidFill>
                 <a:latin typeface="Kanit"/>
               </a:rPr>
-              <a:t>สศช. 2026 ไตรมาส 1 · TPSO 2026-05 · ธนาคารแห่งประเทศไทย 2026-08 · BIS 2025 ไตรมาส 4 · ECB 2026-09-07, ทั้งหมดดึงจากหน่วยงานผู้เผยแพร่โดยตรง ตารางเทียบประเทศใช้ IMF World Economic Outlook 2026 (ดึงข้อมูล 2026-07-25) อัตรา NPL ที่ ธปท. เผยแพร่ — 4.48% ณ 2026 ไตรมาส 1, จาก 4.33% ไตรมาสก่อน เปลี่ยน +0.24 จุดใน 1 ปี และต่ำสุด 3.08% ณ 2021 ไตรมาส 1</a:t>
+              <a:t>สศช. 2026 ไตรมาส 1 · TPSO 2026-05 · ธนาคารแห่งประเทศไทย 2026-08 · BIS 2025 ไตรมาส 4 · ECB 2026-09-10, ทั้งหมดดึงจากหน่วยงานผู้เผยแพร่โดยตรง ตารางเทียบประเทศใช้ IMF World Economic Outlook 2026 (ดึงข้อมูล 2026-07-25) อัตรา NPL ที่ ธปท. เผยแพร่ — 4.48% ณ 2026 ไตรมาส 1, จาก 4.33% ไตรมาสก่อน เปลี่ยน +0.24 จุดใน 1 ปี และต่ำสุด 3.08% ณ 2021 ไตรมาส 1</a:t>
             </a:r>
           </a:p>
         </p:txBody>
@@ -35967,7 +35967,7 @@
               <a:t>• การเติบโต: IMF ประมาณการ 1.5% ตัวเลขจริง +2.8%
 • เงินเฟ้อ: IMF ประมาณการ 0.9% ตัวเลขจริง +2.79%
 • เราใช้ตัวเลขไทยแทนประมาณการทุกครั้งที่มีตัวเลขจริง
-• ข้อยกเว้น: ท่องเที่ยว −6.6% เทียบปีก่อน (ย้อนหลัง 12 เดือน) — หนุนรายได้นอกระบบในภาคใต้และภาคตะวันออก ซึ่งข้อมูลพืชและรถมองไม่เห็น</a:t>
+• ข้อยกเว้น: ท่องเที่ยว −5.5% เทียบปีก่อน (ย้อนหลัง 12 เดือน) — หนุนรายได้นอกระบบในภาคใต้และภาคตะวันออก ซึ่งข้อมูลพืชและรถมองไม่เห็น</a:t>
             </a:r>
           </a:p>
         </p:txBody>
@@ -37087,7 +37087,7 @@
                 </a:solidFill>
                 <a:latin typeface="Kanit"/>
               </a:rPr>
-              <a:t>338 จาก 928 อำเภอ · แม่น้ำเกินระดับ 147 จาก 788 สถานี</a:t>
+              <a:t>338 จาก 928 อำเภอ · แม่น้ำเกินระดับ 144 จาก 788 สถานี</a:t>
             </a:r>
           </a:p>
         </p:txBody>
@@ -38091,7 +38091,7 @@
                           </a:solidFill>
                           <a:latin typeface="Kanit"/>
                         </a:rPr>
-                        <a:t>19/272</a:t>
+                        <a:t>20/272</a:t>
                       </a:r>
                     </a:p>
                   </a:txBody>
@@ -38323,7 +38323,7 @@
                           </a:solidFill>
                           <a:latin typeface="Kanit"/>
                         </a:rPr>
-                        <a:t>31/167</a:t>
+                        <a:t>28/167</a:t>
                       </a:r>
                     </a:p>
                   </a:txBody>
@@ -38787,7 +38787,7 @@
                           </a:solidFill>
                           <a:latin typeface="Kanit"/>
                         </a:rPr>
-                        <a:t>44/143</a:t>
+                        <a:t>43/143</a:t>
                       </a:r>
                     </a:p>
                   </a:txBody>
@@ -39936,7 +39936,7 @@
                           </a:solidFill>
                           <a:latin typeface="Kanit"/>
                         </a:rPr>
-                        <a:t>−68.7%</a:t>
+                        <a:t>−69.0%</a:t>
                       </a:r>
                     </a:p>
                   </a:txBody>
@@ -40791,7 +40791,7 @@
                 </a:solidFill>
                 <a:latin typeface="Kanit"/>
               </a:rPr>
-              <a:t>ราคา วัดจริง — ราคาหน้าฟาร์มไทยจากราคารายวันของ NABC และราคาอ้อยประกาศของ สอน. ราคาล่าสุด 2026-09-09 การเปลี่ยนแปลงหกเดือนคำนวณจากข้อมูลรายเดือนของ NABC เอง (thai_price_history รุ่นข้อมูล 2026-09-05) พืชที่ไม่มีข้อมูลรายเดือนจะกำกับไว้ ไม่ประมาณการขึ้นมา แหล่งผลิตเป็นการอ่านแบบ ประมาณการ ว่าสินค้าแต่ละชนิดปลูกที่ไหน และแหล่งผลิตทับซ้อนกันได้ บัญชีอาชีพเกษตรเป็นข้อมูลของเราเองและ วัดจริง — บัญชีที่บันทึกอาชีพว่า เกษตร ในจังหวัดแหล่งผลิต จากฐานข้อมูล 382,735 บัญชี ณ 2026-07 ไม่เผยแพร่ช่องที่มีน้อยกว่า 30 บัญชี คนกลุ่มนี้อาศัยอยู่ในพื้นที่ที่ปลูกพืชนั้น แต่ไม่ได้ยืนยันว่าปลูกพืชนั้นเอง</a:t>
+              <a:t>ราคา วัดจริง — ราคาหน้าฟาร์มไทยจากราคารายวันของ NABC และราคาอ้อยประกาศของ สอน. ราคาล่าสุด 2026-09-11 การเปลี่ยนแปลงหกเดือนคำนวณจากข้อมูลรายเดือนของ NABC เอง (thai_price_history รุ่นข้อมูล 2026-09-11) พืชที่ไม่มีข้อมูลรายเดือนจะกำกับไว้ ไม่ประมาณการขึ้นมา แหล่งผลิตเป็นการอ่านแบบ ประมาณการ ว่าสินค้าแต่ละชนิดปลูกที่ไหน และแหล่งผลิตทับซ้อนกันได้ บัญชีอาชีพเกษตรเป็นข้อมูลของเราเองและ วัดจริง — บัญชีที่บันทึกอาชีพว่า เกษตร ในจังหวัดแหล่งผลิต จากฐานข้อมูล 382,735 บัญชี ณ 2026-07 ไม่เผยแพร่ช่องที่มีน้อยกว่า 30 บัญชี คนกลุ่มนี้อาศัยอยู่ในพื้นที่ที่ปลูกพืชนั้น แต่ไม่ได้ยืนยันว่าปลูกพืชนั้นเอง</a:t>
             </a:r>
           </a:p>
         </p:txBody>
@@ -43419,7 +43419,7 @@
                           </a:solidFill>
                           <a:latin typeface="Kanit"/>
                         </a:rPr>
-                        <a:t>91.45</a:t>
+                        <a:t>91.73</a:t>
                       </a:r>
                     </a:p>
                   </a:txBody>
@@ -43559,7 +43559,7 @@
                           </a:solidFill>
                           <a:latin typeface="Kanit"/>
                         </a:rPr>
-                        <a:t>15,362</a:t>
+                        <a:t>15,409</a:t>
                       </a:r>
                     </a:p>
                   </a:txBody>
@@ -43699,7 +43699,7 @@
                           </a:solidFill>
                           <a:latin typeface="Kanit"/>
                         </a:rPr>
-                        <a:t>36,217</a:t>
+                        <a:t>36,327</a:t>
                       </a:r>
                     </a:p>
                   </a:txBody>
@@ -43839,7 +43839,7 @@
                           </a:solidFill>
                           <a:latin typeface="Kanit"/>
                         </a:rPr>
-                        <a:t>11.18</a:t>
+                        <a:t>11.22</a:t>
                       </a:r>
                     </a:p>
                   </a:txBody>
@@ -44058,7 +44058,7 @@
                 </a:solidFill>
                 <a:latin typeface="Kanit"/>
               </a:rPr>
-              <a:t>ราคารายเดือนสกุลดอลลาร์ราคาปัจจุบันจาก World Bank Pink Sheet รุ่นข้อมูล 2026M07 (ข้อมูล 60 จุดต่อรายการ ปรับฐานเป็น 100 ณ 2021-07 เพื่อวาดกราฟ — หน่วยต่างกัน จึงใช้แกนเดียวกับระดับราคาดิบไม่ได้) แปลงเป็นบาทด้วยอัตราอ้างอิง ECB USD/THB 32.895 ณ 2026-09-07 สัดส่วนพื้นที่ปลูก วัดจริง จากสัดส่วนพืชของ สศก./กรมส่งเสริมการเกษตร (crop_mix.json) เป็นราคาปัจจุบัน ไม่ได้ปรับเงินเฟ้อ: ทุกตัวเลข ‘เทียบ 5 ปีก่อน’ มีเงินเฟ้อไทยห้าปีซ่อนอยู่ข้างใต้</a:t>
+              <a:t>ราคารายเดือนสกุลดอลลาร์ราคาปัจจุบันจาก World Bank Pink Sheet รุ่นข้อมูล 2026M07 (ข้อมูล 60 จุดต่อรายการ ปรับฐานเป็น 100 ณ 2021-07 เพื่อวาดกราฟ — หน่วยต่างกัน จึงใช้แกนเดียวกับระดับราคาดิบไม่ได้) แปลงเป็นบาทด้วยอัตราอ้างอิง ECB USD/THB 32.995 ณ 2026-09-10 สัดส่วนพื้นที่ปลูก วัดจริง จากสัดส่วนพืชของ สศก./กรมส่งเสริมการเกษตร (crop_mix.json) เป็นราคาปัจจุบัน ไม่ได้ปรับเงินเฟ้อ: ทุกตัวเลข ‘เทียบ 5 ปีก่อน’ มีเงินเฟ้อไทยห้าปีซ่อนอยู่ข้างใต้</a:t>
             </a:r>
           </a:p>
         </p:txBody>
@@ -44679,7 +44679,7 @@
                 </a:solidFill>
                 <a:latin typeface="Kanit"/>
               </a:rPr>
-              <a:t>มะพร้าว −68.7% สับปะรด −18.4% อ้อย −17.9% เทียบปีก่อน</a:t>
+              <a:t>มะพร้าว −69.0% สับปะรด −18.4% อ้อย −17.9% เทียบปีก่อน</a:t>
             </a:r>
           </a:p>
         </p:txBody>
@@ -44805,7 +44805,7 @@
                 </a:solidFill>
                 <a:latin typeface="Kanit"/>
               </a:rPr>
-              <a:t>+15.6%</a:t>
+              <a:t>+15.3%</a:t>
             </a:r>
           </a:p>
         </p:txBody>
@@ -45279,7 +45279,7 @@
                           </a:solidFill>
                           <a:latin typeface="Kanit"/>
                         </a:rPr>
-                        <a:t>+5.7%</a:t>
+                        <a:t>+5.4%</a:t>
                       </a:r>
                     </a:p>
                   </a:txBody>
@@ -45348,7 +45348,7 @@
                           </a:solidFill>
                           <a:latin typeface="Kanit"/>
                         </a:rPr>
-                        <a:t>-64.3%</a:t>
+                        <a:t>-64.6%</a:t>
                       </a:r>
                     </a:p>
                   </a:txBody>
@@ -45419,7 +45419,7 @@
                           </a:solidFill>
                           <a:latin typeface="Kanit"/>
                         </a:rPr>
-                        <a:t>+14.8%</a:t>
+                        <a:t>+14.4%</a:t>
                       </a:r>
                     </a:p>
                   </a:txBody>
@@ -45488,7 +45488,7 @@
                           </a:solidFill>
                           <a:latin typeface="Kanit"/>
                         </a:rPr>
-                        <a:t>+9.2%</a:t>
+                        <a:t>+8.8%</a:t>
                       </a:r>
                     </a:p>
                   </a:txBody>
@@ -45559,7 +45559,7 @@
                           </a:solidFill>
                           <a:latin typeface="Kanit"/>
                         </a:rPr>
-                        <a:t>+16.6%</a:t>
+                        <a:t>+16.4%</a:t>
                       </a:r>
                     </a:p>
                   </a:txBody>
@@ -45628,7 +45628,7 @@
                           </a:solidFill>
                           <a:latin typeface="Kanit"/>
                         </a:rPr>
-                        <a:t>+8.0%</a:t>
+                        <a:t>+7.7%</a:t>
                       </a:r>
                     </a:p>
                   </a:txBody>
@@ -45768,7 +45768,7 @@
                           </a:solidFill>
                           <a:latin typeface="Kanit"/>
                         </a:rPr>
-                        <a:t>+11.1%</a:t>
+                        <a:t>+10.9%</a:t>
                       </a:r>
                     </a:p>
                   </a:txBody>
@@ -45908,7 +45908,7 @@
                           </a:solidFill>
                           <a:latin typeface="Kanit"/>
                         </a:rPr>
-                        <a:t>+27.2%</a:t>
+                        <a:t>+27.3%</a:t>
                       </a:r>
                     </a:p>
                   </a:txBody>
@@ -46084,7 +46084,7 @@
                 </a:solidFill>
                 <a:latin typeface="Kanit"/>
               </a:rPr>
-              <a:t>•  ราคาหน้าฟาร์ม: ยางพารา +40% มันสำปะหลัง +76% ปาล์ม +23% ข้าว +13% รายได้จากพืชเพิ่มขึ้นทุกภาค
+              <a:t>•  ราคาหน้าฟาร์ม: ยางพารา +40% มันสำปะหลัง +77% ปาล์ม +24% ข้าว +12% รายได้จากพืชเพิ่มขึ้นทุกภาค
 •  มีสี่จังหวัดที่ลดลง — ทั้งหมดเป็นมะพร้าว และอยู่ฝั่งอ่าวไทยตะวันตก ราคามะพร้าวลดลง 69%
 •  กำไรบนกระดาษยังไม่ใช่เงินสด — ตารางถัดไปหักราคาด้วยต้นทุน</a:t>
             </a:r>
@@ -46387,7 +46387,7 @@
                           </a:solidFill>
                           <a:latin typeface="Kanit"/>
                         </a:rPr>
-                        <a:t>+17.3%</a:t>
+                        <a:t>+17.0%</a:t>
                       </a:r>
                     </a:p>
                   </a:txBody>
@@ -46550,7 +46550,7 @@
                           </a:solidFill>
                           <a:latin typeface="Kanit"/>
                         </a:rPr>
-                        <a:t>+21.0%</a:t>
+                        <a:t>+20.7%</a:t>
                       </a:r>
                     </a:p>
                   </a:txBody>
@@ -46713,7 +46713,7 @@
                           </a:solidFill>
                           <a:latin typeface="Kanit"/>
                         </a:rPr>
-                        <a:t>+10.9%</a:t>
+                        <a:t>+10.6%</a:t>
                       </a:r>
                     </a:p>
                   </a:txBody>
@@ -47039,7 +47039,7 @@
                           </a:solidFill>
                           <a:latin typeface="Kanit"/>
                         </a:rPr>
-                        <a:t>+16.3%</a:t>
+                        <a:t>+16.0%</a:t>
                       </a:r>
                     </a:p>
                   </a:txBody>
@@ -47202,7 +47202,7 @@
                           </a:solidFill>
                           <a:latin typeface="Kanit"/>
                         </a:rPr>
-                        <a:t>+14.6%</a:t>
+                        <a:t>+14.3%</a:t>
                       </a:r>
                     </a:p>
                   </a:txBody>
@@ -48024,7 +48024,7 @@
                 </a:solidFill>
                 <a:latin typeface="Kanit"/>
               </a:rPr>
-              <a:t>เทียบปีก่อน −68.7%</a:t>
+              <a:t>เทียบปีก่อน −69.0%</a:t>
             </a:r>
           </a:p>
         </p:txBody>
@@ -48134,22 +48134,22 @@
             <a:pathLst>
               <a:path w="2064715" h="457200">
                 <a:moveTo>
-                  <a:pt x="0" y="38315"/>
+                  <a:pt x="0" y="38804"/>
                 </a:moveTo>
                 <a:lnTo>
                   <a:pt x="412943" y="0"/>
                 </a:lnTo>
                 <a:lnTo>
-                  <a:pt x="825886" y="372997"/>
+                  <a:pt x="825886" y="380210"/>
                 </a:lnTo>
                 <a:lnTo>
                   <a:pt x="1238829" y="457200"/>
                 </a:lnTo>
                 <a:lnTo>
-                  <a:pt x="1651772" y="385356"/>
-                </a:lnTo>
-                <a:lnTo>
-                  <a:pt x="2064715" y="411313"/>
+                  <a:pt x="1651772" y="398914"/>
+                </a:lnTo>
+                <a:lnTo>
+                  <a:pt x="2064715" y="419093"/>
                 </a:lnTo>
               </a:path>
             </a:pathLst>
@@ -48192,7 +48192,7 @@
         </p:nvSpPr>
         <p:spPr>
           <a:xfrm>
-            <a:off x="2480767" y="2816185"/>
+            <a:off x="2480767" y="2823965"/>
             <a:ext cx="82296" cy="82296"/>
           </a:xfrm>
           <a:prstGeom prst="roundRect">
@@ -48621,7 +48621,7 @@
                 </a:solidFill>
                 <a:latin typeface="Kanit"/>
               </a:rPr>
-              <a:t>฿142.50 /กก. · ชายฝั่งใต้·ตอ.</a:t>
+              <a:t>฿141.25 /กก. · ชายฝั่งใต้·ตอ.</a:t>
             </a:r>
           </a:p>
         </p:txBody>
@@ -48660,7 +48660,7 @@
                 </a:solidFill>
                 <a:latin typeface="Kanit"/>
               </a:rPr>
-              <a:t>เทียบปีก่อน +0.4%</a:t>
+              <a:t>เทียบปีก่อน +0.3%</a:t>
             </a:r>
           </a:p>
         </p:txBody>
@@ -48699,7 +48699,7 @@
                 </a:solidFill>
                 <a:latin typeface="Kanit"/>
               </a:rPr>
-              <a:t>6 เดือน +8.0%</a:t>
+              <a:t>6 เดือน +6.7%</a:t>
             </a:r>
           </a:p>
         </p:txBody>
@@ -48776,7 +48776,7 @@
                   <a:pt x="412943" y="457200"/>
                 </a:lnTo>
                 <a:lnTo>
-                  <a:pt x="825886" y="420235"/>
+                  <a:pt x="825886" y="425604"/>
                 </a:lnTo>
                 <a:lnTo>
                   <a:pt x="1238829" y="169952"/>
@@ -48785,7 +48785,7 @@
                   <a:pt x="1651772" y="0"/>
                 </a:lnTo>
                 <a:lnTo>
-                  <a:pt x="2064715" y="12596"/>
+                  <a:pt x="2064715" y="38409"/>
                 </a:lnTo>
               </a:path>
             </a:pathLst>
@@ -48828,7 +48828,7 @@
         </p:nvSpPr>
         <p:spPr>
           <a:xfrm>
-            <a:off x="7085685" y="2417468"/>
+            <a:off x="7085685" y="2443281"/>
             <a:ext cx="82296" cy="82296"/>
           </a:xfrm>
           <a:prstGeom prst="roundRect">
@@ -48978,7 +48978,7 @@
                 </a:solidFill>
                 <a:latin typeface="Kanit"/>
               </a:rPr>
-              <a:t>เทียบปีก่อน +5.1%</a:t>
+              <a:t>เทียบปีก่อน +5.4%</a:t>
             </a:r>
           </a:p>
         </p:txBody>
@@ -49017,7 +49017,7 @@
                 </a:solidFill>
                 <a:latin typeface="Kanit"/>
               </a:rPr>
-              <a:t>6 เดือน +0.0%</a:t>
+              <a:t>6 เดือน +0.2%</a:t>
             </a:r>
           </a:p>
         </p:txBody>
@@ -49088,7 +49088,7 @@
             <a:pathLst>
               <a:path w="2064715" h="457200">
                 <a:moveTo>
-                  <a:pt x="0" y="122251"/>
+                  <a:pt x="0" y="119269"/>
                 </a:moveTo>
                 <a:lnTo>
                   <a:pt x="412943" y="309106"/>
@@ -49296,7 +49296,7 @@
                 </a:solidFill>
                 <a:latin typeface="Kanit"/>
               </a:rPr>
-              <a:t>เทียบปีก่อน +7.1%</a:t>
+              <a:t>เทียบปีก่อน +7.6%</a:t>
             </a:r>
           </a:p>
         </p:txBody>
@@ -49536,7 +49536,7 @@
                 </a:solidFill>
                 <a:latin typeface="Kanit"/>
               </a:rPr>
-              <a:t>ข้าวหอมมะลิ</a:t>
+              <a:t>ข้าวโพดเลี้ยงสัตว์</a:t>
             </a:r>
           </a:p>
         </p:txBody>
@@ -49575,7 +49575,7 @@
                 </a:solidFill>
                 <a:latin typeface="Kanit"/>
               </a:rPr>
-              <a:t>฿17,494 /ตัน · อีสาน·เหนือ·กลาง</a:t>
+              <a:t>฿8.92 /กก. · เหนือ</a:t>
             </a:r>
           </a:p>
         </p:txBody>
@@ -49614,7 +49614,7 @@
                 </a:solidFill>
                 <a:latin typeface="Kanit"/>
               </a:rPr>
-              <a:t>เทียบปีก่อน +12.8%</a:t>
+              <a:t>เทียบปีก่อน +12.1%</a:t>
             </a:r>
           </a:p>
         </p:txBody>
@@ -49628,6 +49628,285 @@
         <p:spPr>
           <a:xfrm>
             <a:off x="1489557" y="3351275"/>
+            <a:ext cx="1078077" cy="134112"/>
+          </a:xfrm>
+          <a:prstGeom prst="rect">
+            <a:avLst/>
+          </a:prstGeom>
+          <a:noFill/>
+        </p:spPr>
+        <p:txBody>
+          <a:bodyPr wrap="square" lIns="0" rIns="0" tIns="0" bIns="0" anchor="t">
+            <a:noAutofit/>
+          </a:bodyPr>
+          <a:lstStyle/>
+          <a:p>
+            <a:pPr algn="l">
+              <a:lnSpc>
+                <a:spcPts val="1056"/>
+              </a:lnSpc>
+            </a:pPr>
+            <a:r>
+              <a:rPr sz="800" b="1">
+                <a:solidFill>
+                  <a:srgbClr val="CC0000"/>
+                </a:solidFill>
+                <a:latin typeface="Kanit"/>
+              </a:rPr>
+              <a:t>6 เดือน −2.0%</a:t>
+            </a:r>
+          </a:p>
+        </p:txBody>
+      </p:sp>
+      <p:sp>
+        <p:nvSpPr>
+          <p:cNvPr id="54" name="Rectangle 53"/>
+          <p:cNvSpPr/>
+          <p:nvPr/>
+        </p:nvSpPr>
+        <p:spPr>
+          <a:xfrm>
+            <a:off x="411480" y="3506724"/>
+            <a:ext cx="2156155" cy="548640"/>
+          </a:xfrm>
+          <a:prstGeom prst="rect">
+            <a:avLst/>
+          </a:prstGeom>
+          <a:solidFill>
+            <a:srgbClr val="FBFCFE"/>
+          </a:solidFill>
+          <a:ln w="9525">
+            <a:solidFill>
+              <a:srgbClr val="D9DEE9"/>
+            </a:solidFill>
+          </a:ln>
+          <a:effectLst/>
+        </p:spPr>
+        <p:style>
+          <a:lnRef idx="1">
+            <a:schemeClr val="accent1"/>
+          </a:lnRef>
+          <a:fillRef idx="3">
+            <a:schemeClr val="accent1"/>
+          </a:fillRef>
+          <a:effectRef idx="2">
+            <a:schemeClr val="accent1"/>
+          </a:effectRef>
+          <a:fontRef idx="minor">
+            <a:schemeClr val="lt1"/>
+          </a:fontRef>
+        </p:style>
+        <p:txBody>
+          <a:bodyPr rtlCol="0" anchor="ctr" wrap="none"/>
+          <a:lstStyle/>
+          <a:p>
+            <a:pPr algn="ctr"/>
+          </a:p>
+        </p:txBody>
+      </p:sp>
+      <p:sp>
+        <p:nvSpPr>
+          <p:cNvPr id="55" name="Freeform 54"/>
+          <p:cNvSpPr/>
+          <p:nvPr/>
+        </p:nvSpPr>
+        <p:spPr>
+          <a:xfrm>
+            <a:off x="457200" y="3552444"/>
+            <a:ext cx="2064715" cy="457200"/>
+          </a:xfrm>
+          <a:custGeom>
+            <a:avLst/>
+            <a:gdLst/>
+            <a:ahLst/>
+            <a:cxnLst/>
+            <a:rect l="l" t="t" r="r" b="b"/>
+            <a:pathLst>
+              <a:path w="2064715" h="457200">
+                <a:moveTo>
+                  <a:pt x="0" y="321155"/>
+                </a:moveTo>
+                <a:lnTo>
+                  <a:pt x="412943" y="80288"/>
+                </a:lnTo>
+                <a:lnTo>
+                  <a:pt x="825886" y="0"/>
+                </a:lnTo>
+                <a:lnTo>
+                  <a:pt x="1238829" y="53525"/>
+                </a:lnTo>
+                <a:lnTo>
+                  <a:pt x="1651772" y="274319"/>
+                </a:lnTo>
+                <a:lnTo>
+                  <a:pt x="2064715" y="457200"/>
+                </a:lnTo>
+              </a:path>
+            </a:pathLst>
+          </a:custGeom>
+          <a:noFill/>
+          <a:ln w="20320">
+            <a:solidFill>
+              <a:srgbClr val="CC0000"/>
+            </a:solidFill>
+          </a:ln>
+          <a:effectLst/>
+        </p:spPr>
+        <p:style>
+          <a:lnRef idx="1">
+            <a:schemeClr val="accent1"/>
+          </a:lnRef>
+          <a:fillRef idx="3">
+            <a:schemeClr val="accent1"/>
+          </a:fillRef>
+          <a:effectRef idx="2">
+            <a:schemeClr val="accent1"/>
+          </a:effectRef>
+          <a:fontRef idx="minor">
+            <a:schemeClr val="lt1"/>
+          </a:fontRef>
+        </p:style>
+        <p:txBody>
+          <a:bodyPr rtlCol="0" anchor="ctr"/>
+          <a:lstStyle/>
+          <a:p>
+            <a:pPr algn="ctr"/>
+          </a:p>
+        </p:txBody>
+      </p:sp>
+      <p:sp>
+        <p:nvSpPr>
+          <p:cNvPr id="56" name="Rounded Rectangle 55"/>
+          <p:cNvSpPr/>
+          <p:nvPr/>
+        </p:nvSpPr>
+        <p:spPr>
+          <a:xfrm>
+            <a:off x="2480767" y="3968496"/>
+            <a:ext cx="82296" cy="82296"/>
+          </a:xfrm>
+          <a:prstGeom prst="roundRect">
+            <a:avLst>
+              <a:gd name="adj" fmla="val 50000"/>
+            </a:avLst>
+          </a:prstGeom>
+          <a:solidFill>
+            <a:srgbClr val="CC0000"/>
+          </a:solidFill>
+          <a:ln>
+            <a:noFill/>
+          </a:ln>
+          <a:effectLst/>
+        </p:spPr>
+        <p:style>
+          <a:lnRef idx="1">
+            <a:schemeClr val="accent1"/>
+          </a:lnRef>
+          <a:fillRef idx="3">
+            <a:schemeClr val="accent1"/>
+          </a:fillRef>
+          <a:effectRef idx="2">
+            <a:schemeClr val="accent1"/>
+          </a:effectRef>
+          <a:fontRef idx="minor">
+            <a:schemeClr val="lt1"/>
+          </a:fontRef>
+        </p:style>
+        <p:txBody>
+          <a:bodyPr rtlCol="0" anchor="ctr" wrap="none"/>
+          <a:lstStyle/>
+          <a:p>
+            <a:pPr algn="ctr"/>
+          </a:p>
+        </p:txBody>
+      </p:sp>
+      <p:sp>
+        <p:nvSpPr>
+          <p:cNvPr id="57" name="TextBox 56"/>
+          <p:cNvSpPr txBox="1"/>
+          <p:nvPr/>
+        </p:nvSpPr>
+        <p:spPr>
+          <a:xfrm>
+            <a:off x="2713939" y="3076956"/>
+            <a:ext cx="2156155" cy="150876"/>
+          </a:xfrm>
+          <a:prstGeom prst="rect">
+            <a:avLst/>
+          </a:prstGeom>
+          <a:noFill/>
+        </p:spPr>
+        <p:txBody>
+          <a:bodyPr wrap="square" lIns="0" rIns="0" tIns="0" bIns="0" anchor="t">
+            <a:noAutofit/>
+          </a:bodyPr>
+          <a:lstStyle/>
+          <a:p>
+            <a:pPr algn="l">
+              <a:lnSpc>
+                <a:spcPts val="1188"/>
+              </a:lnSpc>
+            </a:pPr>
+            <a:r>
+              <a:rPr sz="900" b="1">
+                <a:solidFill>
+                  <a:srgbClr val="1E2F5C"/>
+                </a:solidFill>
+                <a:latin typeface="Kanit"/>
+              </a:rPr>
+              <a:t>ข้าวหอมมะลิ</a:t>
+            </a:r>
+          </a:p>
+        </p:txBody>
+      </p:sp>
+      <p:sp>
+        <p:nvSpPr>
+          <p:cNvPr id="58" name="TextBox 57"/>
+          <p:cNvSpPr txBox="1"/>
+          <p:nvPr/>
+        </p:nvSpPr>
+        <p:spPr>
+          <a:xfrm>
+            <a:off x="2713939" y="3218687"/>
+            <a:ext cx="2156155" cy="125730"/>
+          </a:xfrm>
+          <a:prstGeom prst="rect">
+            <a:avLst/>
+          </a:prstGeom>
+          <a:noFill/>
+        </p:spPr>
+        <p:txBody>
+          <a:bodyPr wrap="square" lIns="0" rIns="0" tIns="0" bIns="0" anchor="t">
+            <a:noAutofit/>
+          </a:bodyPr>
+          <a:lstStyle/>
+          <a:p>
+            <a:pPr algn="l">
+              <a:lnSpc>
+                <a:spcPts val="990"/>
+              </a:lnSpc>
+            </a:pPr>
+            <a:r>
+              <a:rPr sz="750" b="0">
+                <a:solidFill>
+                  <a:srgbClr val="606060"/>
+                </a:solidFill>
+                <a:latin typeface="Kanit"/>
+              </a:rPr>
+              <a:t>฿17,443 /ตัน · อีสาน·เหนือ·กลาง</a:t>
+            </a:r>
+          </a:p>
+        </p:txBody>
+      </p:sp>
+      <p:sp>
+        <p:nvSpPr>
+          <p:cNvPr id="59" name="TextBox 58"/>
+          <p:cNvSpPr txBox="1"/>
+          <p:nvPr/>
+        </p:nvSpPr>
+        <p:spPr>
+          <a:xfrm>
+            <a:off x="2713939" y="3351275"/>
             <a:ext cx="1078077" cy="134112"/>
           </a:xfrm>
           <a:prstGeom prst="rect">
@@ -49653,260 +49932,20 @@
                 </a:solidFill>
                 <a:latin typeface="Kanit"/>
               </a:rPr>
-              <a:t>6 เดือน +4.3%</a:t>
+              <a:t>เทียบปีก่อน +12.4%</a:t>
             </a:r>
           </a:p>
         </p:txBody>
       </p:sp>
       <p:sp>
         <p:nvSpPr>
-          <p:cNvPr id="54" name="Rectangle 53"/>
-          <p:cNvSpPr/>
-          <p:nvPr/>
-        </p:nvSpPr>
-        <p:spPr>
-          <a:xfrm>
-            <a:off x="411480" y="3506724"/>
-            <a:ext cx="2156155" cy="548640"/>
-          </a:xfrm>
-          <a:prstGeom prst="rect">
-            <a:avLst/>
-          </a:prstGeom>
-          <a:solidFill>
-            <a:srgbClr val="FBFCFE"/>
-          </a:solidFill>
-          <a:ln w="9525">
-            <a:solidFill>
-              <a:srgbClr val="D9DEE9"/>
-            </a:solidFill>
-          </a:ln>
-          <a:effectLst/>
-        </p:spPr>
-        <p:style>
-          <a:lnRef idx="1">
-            <a:schemeClr val="accent1"/>
-          </a:lnRef>
-          <a:fillRef idx="3">
-            <a:schemeClr val="accent1"/>
-          </a:fillRef>
-          <a:effectRef idx="2">
-            <a:schemeClr val="accent1"/>
-          </a:effectRef>
-          <a:fontRef idx="minor">
-            <a:schemeClr val="lt1"/>
-          </a:fontRef>
-        </p:style>
-        <p:txBody>
-          <a:bodyPr rtlCol="0" anchor="ctr" wrap="none"/>
-          <a:lstStyle/>
-          <a:p>
-            <a:pPr algn="ctr"/>
-          </a:p>
-        </p:txBody>
-      </p:sp>
-      <p:sp>
-        <p:nvSpPr>
-          <p:cNvPr id="55" name="Freeform 54"/>
-          <p:cNvSpPr/>
-          <p:nvPr/>
-        </p:nvSpPr>
-        <p:spPr>
-          <a:xfrm>
-            <a:off x="457200" y="3552444"/>
-            <a:ext cx="2064715" cy="457200"/>
-          </a:xfrm>
-          <a:custGeom>
-            <a:avLst/>
-            <a:gdLst/>
-            <a:ahLst/>
-            <a:cxnLst/>
-            <a:rect l="l" t="t" r="r" b="b"/>
-            <a:pathLst>
-              <a:path w="2064715" h="457200">
-                <a:moveTo>
-                  <a:pt x="0" y="457200"/>
-                </a:moveTo>
-                <a:lnTo>
-                  <a:pt x="412943" y="212701"/>
-                </a:lnTo>
-                <a:lnTo>
-                  <a:pt x="825886" y="41154"/>
-                </a:lnTo>
-                <a:lnTo>
-                  <a:pt x="1238829" y="30357"/>
-                </a:lnTo>
-                <a:lnTo>
-                  <a:pt x="1651772" y="0"/>
-                </a:lnTo>
-                <a:lnTo>
-                  <a:pt x="2064715" y="163560"/>
-                </a:lnTo>
-              </a:path>
-            </a:pathLst>
-          </a:custGeom>
-          <a:noFill/>
-          <a:ln w="20320">
-            <a:solidFill>
-              <a:srgbClr val="15795F"/>
-            </a:solidFill>
-          </a:ln>
-          <a:effectLst/>
-        </p:spPr>
-        <p:style>
-          <a:lnRef idx="1">
-            <a:schemeClr val="accent1"/>
-          </a:lnRef>
-          <a:fillRef idx="3">
-            <a:schemeClr val="accent1"/>
-          </a:fillRef>
-          <a:effectRef idx="2">
-            <a:schemeClr val="accent1"/>
-          </a:effectRef>
-          <a:fontRef idx="minor">
-            <a:schemeClr val="lt1"/>
-          </a:fontRef>
-        </p:style>
-        <p:txBody>
-          <a:bodyPr rtlCol="0" anchor="ctr"/>
-          <a:lstStyle/>
-          <a:p>
-            <a:pPr algn="ctr"/>
-          </a:p>
-        </p:txBody>
-      </p:sp>
-      <p:sp>
-        <p:nvSpPr>
-          <p:cNvPr id="56" name="Rounded Rectangle 55"/>
-          <p:cNvSpPr/>
-          <p:nvPr/>
-        </p:nvSpPr>
-        <p:spPr>
-          <a:xfrm>
-            <a:off x="2480767" y="3674856"/>
-            <a:ext cx="82296" cy="82296"/>
-          </a:xfrm>
-          <a:prstGeom prst="roundRect">
-            <a:avLst>
-              <a:gd name="adj" fmla="val 50000"/>
-            </a:avLst>
-          </a:prstGeom>
-          <a:solidFill>
-            <a:srgbClr val="15795F"/>
-          </a:solidFill>
-          <a:ln>
-            <a:noFill/>
-          </a:ln>
-          <a:effectLst/>
-        </p:spPr>
-        <p:style>
-          <a:lnRef idx="1">
-            <a:schemeClr val="accent1"/>
-          </a:lnRef>
-          <a:fillRef idx="3">
-            <a:schemeClr val="accent1"/>
-          </a:fillRef>
-          <a:effectRef idx="2">
-            <a:schemeClr val="accent1"/>
-          </a:effectRef>
-          <a:fontRef idx="minor">
-            <a:schemeClr val="lt1"/>
-          </a:fontRef>
-        </p:style>
-        <p:txBody>
-          <a:bodyPr rtlCol="0" anchor="ctr" wrap="none"/>
-          <a:lstStyle/>
-          <a:p>
-            <a:pPr algn="ctr"/>
-          </a:p>
-        </p:txBody>
-      </p:sp>
-      <p:sp>
-        <p:nvSpPr>
-          <p:cNvPr id="57" name="TextBox 56"/>
+          <p:cNvPr id="60" name="TextBox 59"/>
           <p:cNvSpPr txBox="1"/>
           <p:nvPr/>
         </p:nvSpPr>
         <p:spPr>
           <a:xfrm>
-            <a:off x="2713939" y="3076956"/>
-            <a:ext cx="2156155" cy="150876"/>
-          </a:xfrm>
-          <a:prstGeom prst="rect">
-            <a:avLst/>
-          </a:prstGeom>
-          <a:noFill/>
-        </p:spPr>
-        <p:txBody>
-          <a:bodyPr wrap="square" lIns="0" rIns="0" tIns="0" bIns="0" anchor="t">
-            <a:noAutofit/>
-          </a:bodyPr>
-          <a:lstStyle/>
-          <a:p>
-            <a:pPr algn="l">
-              <a:lnSpc>
-                <a:spcPts val="1188"/>
-              </a:lnSpc>
-            </a:pPr>
-            <a:r>
-              <a:rPr sz="900" b="1">
-                <a:solidFill>
-                  <a:srgbClr val="1E2F5C"/>
-                </a:solidFill>
-                <a:latin typeface="Kanit"/>
-              </a:rPr>
-              <a:t>ข้าวโพดเลี้ยงสัตว์</a:t>
-            </a:r>
-          </a:p>
-        </p:txBody>
-      </p:sp>
-      <p:sp>
-        <p:nvSpPr>
-          <p:cNvPr id="58" name="TextBox 57"/>
-          <p:cNvSpPr txBox="1"/>
-          <p:nvPr/>
-        </p:nvSpPr>
-        <p:spPr>
-          <a:xfrm>
-            <a:off x="2713939" y="3218687"/>
-            <a:ext cx="2156155" cy="125730"/>
-          </a:xfrm>
-          <a:prstGeom prst="rect">
-            <a:avLst/>
-          </a:prstGeom>
-          <a:noFill/>
-        </p:spPr>
-        <p:txBody>
-          <a:bodyPr wrap="square" lIns="0" rIns="0" tIns="0" bIns="0" anchor="t">
-            <a:noAutofit/>
-          </a:bodyPr>
-          <a:lstStyle/>
-          <a:p>
-            <a:pPr algn="l">
-              <a:lnSpc>
-                <a:spcPts val="990"/>
-              </a:lnSpc>
-            </a:pPr>
-            <a:r>
-              <a:rPr sz="750" b="0">
-                <a:solidFill>
-                  <a:srgbClr val="606060"/>
-                </a:solidFill>
-                <a:latin typeface="Kanit"/>
-              </a:rPr>
-              <a:t>฿9.05 /กก. · เหนือ</a:t>
-            </a:r>
-          </a:p>
-        </p:txBody>
-      </p:sp>
-      <p:sp>
-        <p:nvSpPr>
-          <p:cNvPr id="59" name="TextBox 58"/>
-          <p:cNvSpPr txBox="1"/>
-          <p:nvPr/>
-        </p:nvSpPr>
-        <p:spPr>
-          <a:xfrm>
-            <a:off x="2713939" y="3351275"/>
+            <a:off x="3792016" y="3351275"/>
             <a:ext cx="1078077" cy="134112"/>
           </a:xfrm>
           <a:prstGeom prst="rect">
@@ -49932,46 +49971,7 @@
                 </a:solidFill>
                 <a:latin typeface="Kanit"/>
               </a:rPr>
-              <a:t>เทียบปีก่อน +13.6%</a:t>
-            </a:r>
-          </a:p>
-        </p:txBody>
-      </p:sp>
-      <p:sp>
-        <p:nvSpPr>
-          <p:cNvPr id="60" name="TextBox 59"/>
-          <p:cNvSpPr txBox="1"/>
-          <p:nvPr/>
-        </p:nvSpPr>
-        <p:spPr>
-          <a:xfrm>
-            <a:off x="3792016" y="3351275"/>
-            <a:ext cx="1078077" cy="134112"/>
-          </a:xfrm>
-          <a:prstGeom prst="rect">
-            <a:avLst/>
-          </a:prstGeom>
-          <a:noFill/>
-        </p:spPr>
-        <p:txBody>
-          <a:bodyPr wrap="square" lIns="0" rIns="0" tIns="0" bIns="0" anchor="t">
-            <a:noAutofit/>
-          </a:bodyPr>
-          <a:lstStyle/>
-          <a:p>
-            <a:pPr algn="l">
-              <a:lnSpc>
-                <a:spcPts val="1056"/>
-              </a:lnSpc>
-            </a:pPr>
-            <a:r>
-              <a:rPr sz="800" b="1">
-                <a:solidFill>
-                  <a:srgbClr val="CC0000"/>
-                </a:solidFill>
-                <a:latin typeface="Kanit"/>
-              </a:rPr>
-              <a:t>6 เดือน −0.3%</a:t>
+              <a:t>6 เดือน +4.0%</a:t>
             </a:r>
           </a:p>
         </p:txBody>
@@ -50042,22 +50042,22 @@
             <a:pathLst>
               <a:path w="2064715" h="457200">
                 <a:moveTo>
-                  <a:pt x="0" y="342301"/>
+                  <a:pt x="0" y="457200"/>
                 </a:moveTo>
                 <a:lnTo>
-                  <a:pt x="412943" y="83780"/>
-                </a:lnTo>
-                <a:lnTo>
-                  <a:pt x="825886" y="0"/>
-                </a:lnTo>
-                <a:lnTo>
-                  <a:pt x="1238829" y="47874"/>
-                </a:lnTo>
-                <a:lnTo>
-                  <a:pt x="1651772" y="292033"/>
-                </a:lnTo>
-                <a:lnTo>
-                  <a:pt x="2064715" y="457200"/>
+                  <a:pt x="412943" y="237319"/>
+                </a:lnTo>
+                <a:lnTo>
+                  <a:pt x="825886" y="75982"/>
+                </a:lnTo>
+                <a:lnTo>
+                  <a:pt x="1238829" y="44763"/>
+                </a:lnTo>
+                <a:lnTo>
+                  <a:pt x="1651772" y="0"/>
+                </a:lnTo>
+                <a:lnTo>
+                  <a:pt x="2064715" y="211262"/>
                 </a:lnTo>
               </a:path>
             </a:pathLst>
@@ -50065,7 +50065,7 @@
           <a:noFill/>
           <a:ln w="20320">
             <a:solidFill>
-              <a:srgbClr val="CC0000"/>
+              <a:srgbClr val="15795F"/>
             </a:solidFill>
           </a:ln>
           <a:effectLst/>
@@ -50100,7 +50100,7 @@
         </p:nvSpPr>
         <p:spPr>
           <a:xfrm>
-            <a:off x="4783226" y="3968496"/>
+            <a:off x="4783226" y="3722558"/>
             <a:ext cx="82296" cy="82296"/>
           </a:xfrm>
           <a:prstGeom prst="roundRect">
@@ -50109,7 +50109,7 @@
             </a:avLst>
           </a:prstGeom>
           <a:solidFill>
-            <a:srgbClr val="CC0000"/>
+            <a:srgbClr val="15795F"/>
           </a:solidFill>
           <a:ln>
             <a:noFill/>
@@ -50211,7 +50211,7 @@
                 </a:solidFill>
                 <a:latin typeface="Kanit"/>
               </a:rPr>
-              <a:t>฿8.38 /กก. · ใต้</a:t>
+              <a:t>฿8.41 /กก. · ใต้</a:t>
             </a:r>
           </a:p>
         </p:txBody>
@@ -50250,7 +50250,7 @@
                 </a:solidFill>
                 <a:latin typeface="Kanit"/>
               </a:rPr>
-              <a:t>เทียบปีก่อน +23.4%</a:t>
+              <a:t>เทียบปีก่อน +23.6%</a:t>
             </a:r>
           </a:p>
         </p:txBody>
@@ -50289,7 +50289,7 @@
                 </a:solidFill>
                 <a:latin typeface="Kanit"/>
               </a:rPr>
-              <a:t>6 เดือน +16.2%</a:t>
+              <a:t>6 เดือน +16.6%</a:t>
             </a:r>
           </a:p>
         </p:txBody>
@@ -50366,7 +50366,7 @@
                   <a:pt x="412943" y="457200"/>
                 </a:lnTo>
                 <a:lnTo>
-                  <a:pt x="825886" y="293166"/>
+                  <a:pt x="825886" y="296656"/>
                 </a:lnTo>
                 <a:lnTo>
                   <a:pt x="1238829" y="76781"/>
@@ -50375,7 +50375,7 @@
                   <a:pt x="1651772" y="0"/>
                 </a:lnTo>
                 <a:lnTo>
-                  <a:pt x="2064715" y="45370"/>
+                  <a:pt x="2064715" y="34900"/>
                 </a:lnTo>
               </a:path>
             </a:pathLst>
@@ -50418,7 +50418,7 @@
         </p:nvSpPr>
         <p:spPr>
           <a:xfrm>
-            <a:off x="7085685" y="3556666"/>
+            <a:off x="7085685" y="3546196"/>
             <a:ext cx="82296" cy="82296"/>
           </a:xfrm>
           <a:prstGeom prst="roundRect">
@@ -50529,7 +50529,7 @@
                 </a:solidFill>
                 <a:latin typeface="Kanit"/>
               </a:rPr>
-              <a:t>฿74.67 /กก. · กลาง·ตต.·ตอ.</a:t>
+              <a:t>฿74.74 /กก. · กลาง·ตต.·ตอ.</a:t>
             </a:r>
           </a:p>
         </p:txBody>
@@ -50568,7 +50568,7 @@
                 </a:solidFill>
                 <a:latin typeface="Kanit"/>
               </a:rPr>
-              <a:t>เทียบปีก่อน +24.2%</a:t>
+              <a:t>เทียบปีก่อน +26.9%</a:t>
             </a:r>
           </a:p>
         </p:txBody>
@@ -50607,7 +50607,7 @@
                 </a:solidFill>
                 <a:latin typeface="Kanit"/>
               </a:rPr>
-              <a:t>6 เดือน +18.4%</a:t>
+              <a:t>6 เดือน +18.5%</a:t>
             </a:r>
           </a:p>
         </p:txBody>
@@ -50678,19 +50678,19 @@
             <a:pathLst>
               <a:path w="2064715" h="457200">
                 <a:moveTo>
-                  <a:pt x="0" y="220046"/>
+                  <a:pt x="0" y="223049"/>
                 </a:moveTo>
                 <a:lnTo>
                   <a:pt x="412943" y="457200"/>
                 </a:lnTo>
                 <a:lnTo>
-                  <a:pt x="825886" y="343487"/>
-                </a:lnTo>
-                <a:lnTo>
-                  <a:pt x="1238829" y="264994"/>
-                </a:lnTo>
-                <a:lnTo>
-                  <a:pt x="1651772" y="111364"/>
+                  <a:pt x="825886" y="346852"/>
+                </a:lnTo>
+                <a:lnTo>
+                  <a:pt x="1238829" y="262074"/>
+                </a:lnTo>
+                <a:lnTo>
+                  <a:pt x="1651772" y="114047"/>
                 </a:lnTo>
                 <a:lnTo>
                   <a:pt x="2064715" y="0"/>
@@ -50847,7 +50847,7 @@
                 </a:solidFill>
                 <a:latin typeface="Kanit"/>
               </a:rPr>
-              <a:t>฿80.62 /กก. · ใต้·ตอ.</a:t>
+              <a:t>฿81.03 /กก. · ใต้·ตอ.</a:t>
             </a:r>
           </a:p>
         </p:txBody>
@@ -50925,7 +50925,7 @@
                 </a:solidFill>
                 <a:latin typeface="Kanit"/>
               </a:rPr>
-              <a:t>6 เดือน +18.5%</a:t>
+              <a:t>6 เดือน +18.9%</a:t>
             </a:r>
           </a:p>
         </p:txBody>
@@ -51005,13 +51005,13 @@
                   <a:pt x="825886" y="0"/>
                 </a:lnTo>
                 <a:lnTo>
-                  <a:pt x="1238829" y="66071"/>
+                  <a:pt x="1238829" y="62808"/>
                 </a:lnTo>
                 <a:lnTo>
                   <a:pt x="1651772" y="195360"/>
                 </a:lnTo>
                 <a:lnTo>
-                  <a:pt x="2064715" y="219831"/>
+                  <a:pt x="2064715" y="203109"/>
                 </a:lnTo>
               </a:path>
             </a:pathLst>
@@ -51054,7 +51054,7 @@
         </p:nvSpPr>
         <p:spPr>
           <a:xfrm>
-            <a:off x="11690603" y="3731127"/>
+            <a:off x="11690603" y="3714405"/>
             <a:ext cx="82296" cy="82296"/>
           </a:xfrm>
           <a:prstGeom prst="roundRect">
@@ -51165,7 +51165,7 @@
                 </a:solidFill>
                 <a:latin typeface="Kanit"/>
               </a:rPr>
-              <a:t>฿3.92 /กก. · อีสาน·เหนือ·ตอ.</a:t>
+              <a:t>฿3.93 /กก. · อีสาน·เหนือ·ตอ.</a:t>
             </a:r>
           </a:p>
         </p:txBody>
@@ -51204,7 +51204,7 @@
                 </a:solidFill>
                 <a:latin typeface="Kanit"/>
               </a:rPr>
-              <a:t>เทียบปีก่อน +76.3%</a:t>
+              <a:t>เทียบปีก่อน +77.2%</a:t>
             </a:r>
           </a:p>
         </p:txBody>
@@ -51243,7 +51243,7 @@
                 </a:solidFill>
                 <a:latin typeface="Kanit"/>
               </a:rPr>
-              <a:t>6 เดือน +47.4%</a:t>
+              <a:t>6 เดือน +48.3%</a:t>
             </a:r>
           </a:p>
         </p:txBody>
@@ -51317,16 +51317,16 @@
                   <a:pt x="0" y="457200"/>
                 </a:moveTo>
                 <a:lnTo>
-                  <a:pt x="412943" y="366666"/>
-                </a:lnTo>
-                <a:lnTo>
-                  <a:pt x="825886" y="253498"/>
-                </a:lnTo>
-                <a:lnTo>
-                  <a:pt x="1238829" y="217284"/>
-                </a:lnTo>
-                <a:lnTo>
-                  <a:pt x="1651772" y="49795"/>
+                  <a:pt x="412943" y="367553"/>
+                </a:lnTo>
+                <a:lnTo>
+                  <a:pt x="825886" y="255495"/>
+                </a:lnTo>
+                <a:lnTo>
+                  <a:pt x="1238829" y="210671"/>
+                </a:lnTo>
+                <a:lnTo>
+                  <a:pt x="1651772" y="49306"/>
                 </a:lnTo>
                 <a:lnTo>
                   <a:pt x="2064715" y="0"/>
@@ -51483,7 +51483,7 @@
                 </a:solidFill>
                 <a:latin typeface="Kanit"/>
               </a:rPr>
-              <a:t>฿250.00 /ร้อยผล · กลาง·ตต.</a:t>
+              <a:t>฿277.78 /ร้อยผล · กลาง·ตต.</a:t>
             </a:r>
           </a:p>
         </p:txBody>
@@ -51522,7 +51522,7 @@
                 </a:solidFill>
                 <a:latin typeface="Kanit"/>
               </a:rPr>
-              <a:t>เทียบปีก่อน +114.6%</a:t>
+              <a:t>เทียบปีก่อน +198.1%</a:t>
             </a:r>
           </a:p>
         </p:txBody>
@@ -51561,7 +51561,7 @@
                 </a:solidFill>
                 <a:latin typeface="Kanit"/>
               </a:rPr>
-              <a:t>6 เดือน −45.0%</a:t>
+              <a:t>6 เดือน −38.9%</a:t>
             </a:r>
           </a:p>
         </p:txBody>
@@ -51647,7 +51647,7 @@
                   <a:pt x="1651772" y="413314"/>
                 </a:lnTo>
                 <a:lnTo>
-                  <a:pt x="2064715" y="348309"/>
+                  <a:pt x="2064715" y="329975"/>
                 </a:lnTo>
               </a:path>
             </a:pathLst>
@@ -51690,7 +51690,7 @@
         </p:nvSpPr>
         <p:spPr>
           <a:xfrm>
-            <a:off x="4783226" y="4966028"/>
+            <a:off x="4783226" y="4947694"/>
             <a:ext cx="82296" cy="82296"/>
           </a:xfrm>
           <a:prstGeom prst="roundRect">
@@ -51886,7 +51886,7 @@
                 </a:solidFill>
                 <a:latin typeface="Kanit"/>
               </a:rPr>
-              <a:t>ราคาหน้าฟาร์ม วัดจริง — ราคารายวันของ NABC เฉลี่ยเป็นรายเดือน หน่วยเป็นบาทตามที่เผยแพร่ (ไม่มีการแปลงสกุลเงิน) ราคาล่าสุด 2026-09-09, รุ่นข้อมูลย้อนหลัง 2026-09-05 ราคาหน้าฟาร์ม (ราคาที่เกษตรกรขายได้) คือเงินที่เกษตรกรได้รับเมื่อขายครั้งแรก ก่อนพ่อค้าคนกลาง โรงสี หรือค่าขนส่งจะหักส่วนแบ่ง — ไม่ใช่ดัชนีโลก และไม่ใช่ราคาในซูเปอร์มาร์เก็ต แหล่งผลิตเป็นการอ่านแบบ ประมาณการ ว่าสินค้าแต่ละชนิดผลิตที่ไหน และทับซ้อนกันได้ น้ำตาลเป็นราคาอ้อยประกาศของ สอน. ปีละหนึ่งจุด จึงไม่มีการเปลี่ยนแปลงหกเดือนให้แสดง</a:t>
+              <a:t>ราคาหน้าฟาร์ม วัดจริง — ราคารายวันของ NABC เฉลี่ยเป็นรายเดือน หน่วยเป็นบาทตามที่เผยแพร่ (ไม่มีการแปลงสกุลเงิน) ราคาล่าสุด 2026-09-11, รุ่นข้อมูลย้อนหลัง 2026-09-11 ราคาหน้าฟาร์ม (ราคาที่เกษตรกรขายได้) คือเงินที่เกษตรกรได้รับเมื่อขายครั้งแรก ก่อนพ่อค้าคนกลาง โรงสี หรือค่าขนส่งจะหักส่วนแบ่ง — ไม่ใช่ดัชนีโลก และไม่ใช่ราคาในซูเปอร์มาร์เก็ต แหล่งผลิตเป็นการอ่านแบบ ประมาณการ ว่าสินค้าแต่ละชนิดผลิตที่ไหน และทับซ้อนกันได้ น้ำตาลเป็นราคาอ้อยประกาศของ สอน. ปีละหนึ่งจุด จึงไม่มีการเปลี่ยนแปลงหกเดือนให้แสดง</a:t>
             </a:r>
           </a:p>
         </p:txBody>

</xml_diff>

<commit_message>
deck(mcom): rebuild — the data moved past the committed figures (run 34620928561)
</commit_message>
<xml_diff>
--- a/docs/decks/mcom-2026-08-05-macro-TH.pptx
+++ b/docs/decks/mcom-2026-08-05-macro-TH.pptx
@@ -6240,7 +6240,7 @@
                 </a:solidFill>
                 <a:latin typeface="Kanit"/>
               </a:rPr>
-              <a:t>144</a:t>
+              <a:t>152</a:t>
             </a:r>
           </a:p>
         </p:txBody>
@@ -6279,7 +6279,7 @@
                 </a:solidFill>
                 <a:latin typeface="Kanit"/>
               </a:rPr>
-              <a:t>จาก 788 (18.3%) · เรียลไทม์ · 2026-09-11</a:t>
+              <a:t>จาก 788 (19.3%) · เรียลไทม์ · 2026-09-11</a:t>
             </a:r>
           </a:p>
         </p:txBody>
@@ -6405,7 +6405,7 @@
                 </a:solidFill>
                 <a:latin typeface="Kanit"/>
               </a:rPr>
-              <a:t>51</a:t>
+              <a:t>50</a:t>
             </a:r>
           </a:p>
         </p:txBody>
@@ -7882,7 +7882,7 @@
                           </a:solidFill>
                           <a:latin typeface="Kanit"/>
                         </a:rPr>
-                        <a:t>สมุทรปราการ</a:t>
+                        <a:t>สกลนคร</a:t>
                       </a:r>
                     </a:p>
                   </a:txBody>
@@ -7905,7 +7905,7 @@
                           </a:solidFill>
                           <a:latin typeface="Kanit"/>
                         </a:rPr>
-                        <a:t>16</a:t>
+                        <a:t>37</a:t>
                       </a:r>
                     </a:p>
                   </a:txBody>
@@ -7928,7 +7928,7 @@
                           </a:solidFill>
                           <a:latin typeface="Kanit"/>
                         </a:rPr>
-                        <a:t>95</a:t>
+                        <a:t>12</a:t>
                       </a:r>
                     </a:p>
                   </a:txBody>
@@ -7947,11 +7947,11 @@
                       <a:r>
                         <a:rPr sz="900" b="1">
                           <a:solidFill>
-                            <a:srgbClr val="F5C242"/>
-                          </a:solidFill>
-                          <a:latin typeface="Kanit"/>
-                        </a:rPr>
-                        <a:t>62.5%</a:t>
+                            <a:srgbClr val="606060"/>
+                          </a:solidFill>
+                          <a:latin typeface="Kanit"/>
+                        </a:rPr>
+                        <a:t>0.0%</a:t>
                       </a:r>
                     </a:p>
                   </a:txBody>
@@ -7974,7 +7974,7 @@
                           </a:solidFill>
                           <a:latin typeface="Kanit"/>
                         </a:rPr>
-                        <a:t>4/4</a:t>
+                        <a:t>7/12</a:t>
                       </a:r>
                     </a:p>
                   </a:txBody>
@@ -8022,7 +8022,7 @@
                           </a:solidFill>
                           <a:latin typeface="Kanit"/>
                         </a:rPr>
-                        <a:t>สกลนคร</a:t>
+                        <a:t>ปราจีนบุรี</a:t>
                       </a:r>
                     </a:p>
                   </a:txBody>
@@ -8045,7 +8045,7 @@
                           </a:solidFill>
                           <a:latin typeface="Kanit"/>
                         </a:rPr>
-                        <a:t>38</a:t>
+                        <a:t>35</a:t>
                       </a:r>
                     </a:p>
                   </a:txBody>
@@ -8068,7 +8068,7 @@
                           </a:solidFill>
                           <a:latin typeface="Kanit"/>
                         </a:rPr>
-                        <a:t>7</a:t>
+                        <a:t>98</a:t>
                       </a:r>
                     </a:p>
                   </a:txBody>
@@ -8087,11 +8087,11 @@
                       <a:r>
                         <a:rPr sz="900" b="1">
                           <a:solidFill>
-                            <a:srgbClr val="606060"/>
-                          </a:solidFill>
-                          <a:latin typeface="Kanit"/>
-                        </a:rPr>
-                        <a:t>0.0%</a:t>
+                            <a:srgbClr val="F5C242"/>
+                          </a:solidFill>
+                          <a:latin typeface="Kanit"/>
+                        </a:rPr>
+                        <a:t>54.3%</a:t>
                       </a:r>
                     </a:p>
                   </a:txBody>
@@ -8114,7 +8114,7 @@
                           </a:solidFill>
                           <a:latin typeface="Kanit"/>
                         </a:rPr>
-                        <a:t>7/12</a:t>
+                        <a:t>6/15</a:t>
                       </a:r>
                     </a:p>
                   </a:txBody>
@@ -8133,11 +8133,11 @@
                       <a:r>
                         <a:rPr sz="900" b="1">
                           <a:solidFill>
-                            <a:srgbClr val="CC0000"/>
-                          </a:solidFill>
-                          <a:latin typeface="Kanit"/>
-                        </a:rPr>
-                        <a:t>5</a:t>
+                            <a:srgbClr val="F5C242"/>
+                          </a:solidFill>
+                          <a:latin typeface="Kanit"/>
+                        </a:rPr>
+                        <a:t>4</a:t>
                       </a:r>
                     </a:p>
                   </a:txBody>
@@ -8162,7 +8162,7 @@
                           </a:solidFill>
                           <a:latin typeface="Kanit"/>
                         </a:rPr>
-                        <a:t>สมุทรสงคราม</a:t>
+                        <a:t>สตูล</a:t>
                       </a:r>
                     </a:p>
                   </a:txBody>
@@ -8185,7 +8185,7 @@
                           </a:solidFill>
                           <a:latin typeface="Kanit"/>
                         </a:rPr>
-                        <a:t>6</a:t>
+                        <a:t>37</a:t>
                       </a:r>
                     </a:p>
                   </a:txBody>
@@ -8208,7 +8208,7 @@
                           </a:solidFill>
                           <a:latin typeface="Kanit"/>
                         </a:rPr>
-                        <a:t>74</a:t>
+                        <a:t>83</a:t>
                       </a:r>
                     </a:p>
                   </a:txBody>
@@ -8231,7 +8231,7 @@
                           </a:solidFill>
                           <a:latin typeface="Kanit"/>
                         </a:rPr>
-                        <a:t>50.0%</a:t>
+                        <a:t>43.2%</a:t>
                       </a:r>
                     </a:p>
                   </a:txBody>
@@ -8254,7 +8254,7 @@
                           </a:solidFill>
                           <a:latin typeface="Kanit"/>
                         </a:rPr>
-                        <a:t>1/2</a:t>
+                        <a:t>1/8</a:t>
                       </a:r>
                     </a:p>
                   </a:txBody>
@@ -8302,7 +8302,7 @@
                           </a:solidFill>
                           <a:latin typeface="Kanit"/>
                         </a:rPr>
-                        <a:t>นครปฐม</a:t>
+                        <a:t>นครนายก</a:t>
                       </a:r>
                     </a:p>
                   </a:txBody>
@@ -8325,7 +8325,7 @@
                           </a:solidFill>
                           <a:latin typeface="Kanit"/>
                         </a:rPr>
-                        <a:t>9</a:t>
+                        <a:t>27</a:t>
                       </a:r>
                     </a:p>
                   </a:txBody>
@@ -8348,7 +8348,7 @@
                           </a:solidFill>
                           <a:latin typeface="Kanit"/>
                         </a:rPr>
-                        <a:t>60</a:t>
+                        <a:t>54</a:t>
                       </a:r>
                     </a:p>
                   </a:txBody>
@@ -8371,7 +8371,7 @@
                           </a:solidFill>
                           <a:latin typeface="Kanit"/>
                         </a:rPr>
-                        <a:t>44.4%</a:t>
+                        <a:t>37.0%</a:t>
                       </a:r>
                     </a:p>
                   </a:txBody>
@@ -8394,7 +8394,7 @@
                           </a:solidFill>
                           <a:latin typeface="Kanit"/>
                         </a:rPr>
-                        <a:t>5/7</a:t>
+                        <a:t>2/6</a:t>
                       </a:r>
                     </a:p>
                   </a:txBody>
@@ -8442,7 +8442,7 @@
                           </a:solidFill>
                           <a:latin typeface="Kanit"/>
                         </a:rPr>
-                        <a:t>สตูล</a:t>
+                        <a:t>ฉะเชิงเทรา</a:t>
                       </a:r>
                     </a:p>
                   </a:txBody>
@@ -8465,7 +8465,7 @@
                           </a:solidFill>
                           <a:latin typeface="Kanit"/>
                         </a:rPr>
-                        <a:t>37</a:t>
+                        <a:t>18</a:t>
                       </a:r>
                     </a:p>
                   </a:txBody>
@@ -8488,7 +8488,7 @@
                           </a:solidFill>
                           <a:latin typeface="Kanit"/>
                         </a:rPr>
-                        <a:t>83</a:t>
+                        <a:t>55</a:t>
                       </a:r>
                     </a:p>
                   </a:txBody>
@@ -8511,7 +8511,7 @@
                           </a:solidFill>
                           <a:latin typeface="Kanit"/>
                         </a:rPr>
-                        <a:t>40.5%</a:t>
+                        <a:t>33.3%</a:t>
                       </a:r>
                     </a:p>
                   </a:txBody>
@@ -8534,7 +8534,7 @@
                           </a:solidFill>
                           <a:latin typeface="Kanit"/>
                         </a:rPr>
-                        <a:t>1/8</a:t>
+                        <a:t>2/4</a:t>
                       </a:r>
                     </a:p>
                   </a:txBody>
@@ -8582,7 +8582,7 @@
                           </a:solidFill>
                           <a:latin typeface="Kanit"/>
                         </a:rPr>
-                        <a:t>สมุทรสาคร</a:t>
+                        <a:t>ชัยนาท</a:t>
                       </a:r>
                     </a:p>
                   </a:txBody>
@@ -8605,7 +8605,7 @@
                           </a:solidFill>
                           <a:latin typeface="Kanit"/>
                         </a:rPr>
-                        <a:t>6</a:t>
+                        <a:t>29</a:t>
                       </a:r>
                     </a:p>
                   </a:txBody>
@@ -8628,7 +8628,7 @@
                           </a:solidFill>
                           <a:latin typeface="Kanit"/>
                         </a:rPr>
-                        <a:t>104</a:t>
+                        <a:t>67</a:t>
                       </a:r>
                     </a:p>
                   </a:txBody>
@@ -8651,7 +8651,7 @@
                           </a:solidFill>
                           <a:latin typeface="Kanit"/>
                         </a:rPr>
-                        <a:t>33.3%</a:t>
+                        <a:t>31.0%</a:t>
                       </a:r>
                     </a:p>
                   </a:txBody>
@@ -8674,7 +8674,7 @@
                           </a:solidFill>
                           <a:latin typeface="Kanit"/>
                         </a:rPr>
-                        <a:t>3/3</a:t>
+                        <a:t>1/5</a:t>
                       </a:r>
                     </a:p>
                   </a:txBody>
@@ -37087,7 +37087,7 @@
                 </a:solidFill>
                 <a:latin typeface="Kanit"/>
               </a:rPr>
-              <a:t>338 จาก 928 อำเภอ · แม่น้ำเกินระดับ 144 จาก 788 สถานี</a:t>
+              <a:t>338 จาก 928 อำเภอ · แม่น้ำเกินระดับ 152 จาก 788 สถานี</a:t>
             </a:r>
           </a:p>
         </p:txBody>
@@ -37859,7 +37859,7 @@
                           </a:solidFill>
                           <a:latin typeface="Kanit"/>
                         </a:rPr>
-                        <a:t>40/155</a:t>
+                        <a:t>41/155</a:t>
                       </a:r>
                     </a:p>
                   </a:txBody>
@@ -38091,7 +38091,7 @@
                           </a:solidFill>
                           <a:latin typeface="Kanit"/>
                         </a:rPr>
-                        <a:t>20/272</a:t>
+                        <a:t>21/272</a:t>
                       </a:r>
                     </a:p>
                   </a:txBody>
@@ -38323,7 +38323,7 @@
                           </a:solidFill>
                           <a:latin typeface="Kanit"/>
                         </a:rPr>
-                        <a:t>28/167</a:t>
+                        <a:t>32/167</a:t>
                       </a:r>
                     </a:p>
                   </a:txBody>
@@ -38787,7 +38787,7 @@
                           </a:solidFill>
                           <a:latin typeface="Kanit"/>
                         </a:rPr>
-                        <a:t>43/143</a:t>
+                        <a:t>45/143</a:t>
                       </a:r>
                     </a:p>
                   </a:txBody>

</xml_diff>

<commit_message>
deck(mcom): rebuild — the data moved past the committed figures (run 34620928561) (#925)
Co-authored-by: github-actions[bot] <41898282+github-actions[bot]@users.noreply.github.com>
</commit_message>
<xml_diff>
--- a/docs/decks/mcom-2026-08-05-macro-TH.pptx
+++ b/docs/decks/mcom-2026-08-05-macro-TH.pptx
@@ -6240,7 +6240,7 @@
                 </a:solidFill>
                 <a:latin typeface="Kanit"/>
               </a:rPr>
-              <a:t>144</a:t>
+              <a:t>152</a:t>
             </a:r>
           </a:p>
         </p:txBody>
@@ -6279,7 +6279,7 @@
                 </a:solidFill>
                 <a:latin typeface="Kanit"/>
               </a:rPr>
-              <a:t>จาก 788 (18.3%) · เรียลไทม์ · 2026-09-11</a:t>
+              <a:t>จาก 788 (19.3%) · เรียลไทม์ · 2026-09-11</a:t>
             </a:r>
           </a:p>
         </p:txBody>
@@ -6405,7 +6405,7 @@
                 </a:solidFill>
                 <a:latin typeface="Kanit"/>
               </a:rPr>
-              <a:t>51</a:t>
+              <a:t>50</a:t>
             </a:r>
           </a:p>
         </p:txBody>
@@ -7882,7 +7882,7 @@
                           </a:solidFill>
                           <a:latin typeface="Kanit"/>
                         </a:rPr>
-                        <a:t>สมุทรปราการ</a:t>
+                        <a:t>สกลนคร</a:t>
                       </a:r>
                     </a:p>
                   </a:txBody>
@@ -7905,7 +7905,7 @@
                           </a:solidFill>
                           <a:latin typeface="Kanit"/>
                         </a:rPr>
-                        <a:t>16</a:t>
+                        <a:t>37</a:t>
                       </a:r>
                     </a:p>
                   </a:txBody>
@@ -7928,7 +7928,7 @@
                           </a:solidFill>
                           <a:latin typeface="Kanit"/>
                         </a:rPr>
-                        <a:t>95</a:t>
+                        <a:t>12</a:t>
                       </a:r>
                     </a:p>
                   </a:txBody>
@@ -7947,11 +7947,11 @@
                       <a:r>
                         <a:rPr sz="900" b="1">
                           <a:solidFill>
-                            <a:srgbClr val="F5C242"/>
-                          </a:solidFill>
-                          <a:latin typeface="Kanit"/>
-                        </a:rPr>
-                        <a:t>62.5%</a:t>
+                            <a:srgbClr val="606060"/>
+                          </a:solidFill>
+                          <a:latin typeface="Kanit"/>
+                        </a:rPr>
+                        <a:t>0.0%</a:t>
                       </a:r>
                     </a:p>
                   </a:txBody>
@@ -7974,7 +7974,7 @@
                           </a:solidFill>
                           <a:latin typeface="Kanit"/>
                         </a:rPr>
-                        <a:t>4/4</a:t>
+                        <a:t>7/12</a:t>
                       </a:r>
                     </a:p>
                   </a:txBody>
@@ -8022,7 +8022,7 @@
                           </a:solidFill>
                           <a:latin typeface="Kanit"/>
                         </a:rPr>
-                        <a:t>สกลนคร</a:t>
+                        <a:t>ปราจีนบุรี</a:t>
                       </a:r>
                     </a:p>
                   </a:txBody>
@@ -8045,7 +8045,7 @@
                           </a:solidFill>
                           <a:latin typeface="Kanit"/>
                         </a:rPr>
-                        <a:t>38</a:t>
+                        <a:t>35</a:t>
                       </a:r>
                     </a:p>
                   </a:txBody>
@@ -8068,7 +8068,7 @@
                           </a:solidFill>
                           <a:latin typeface="Kanit"/>
                         </a:rPr>
-                        <a:t>7</a:t>
+                        <a:t>98</a:t>
                       </a:r>
                     </a:p>
                   </a:txBody>
@@ -8087,11 +8087,11 @@
                       <a:r>
                         <a:rPr sz="900" b="1">
                           <a:solidFill>
-                            <a:srgbClr val="606060"/>
-                          </a:solidFill>
-                          <a:latin typeface="Kanit"/>
-                        </a:rPr>
-                        <a:t>0.0%</a:t>
+                            <a:srgbClr val="F5C242"/>
+                          </a:solidFill>
+                          <a:latin typeface="Kanit"/>
+                        </a:rPr>
+                        <a:t>54.3%</a:t>
                       </a:r>
                     </a:p>
                   </a:txBody>
@@ -8114,7 +8114,7 @@
                           </a:solidFill>
                           <a:latin typeface="Kanit"/>
                         </a:rPr>
-                        <a:t>7/12</a:t>
+                        <a:t>6/15</a:t>
                       </a:r>
                     </a:p>
                   </a:txBody>
@@ -8133,11 +8133,11 @@
                       <a:r>
                         <a:rPr sz="900" b="1">
                           <a:solidFill>
-                            <a:srgbClr val="CC0000"/>
-                          </a:solidFill>
-                          <a:latin typeface="Kanit"/>
-                        </a:rPr>
-                        <a:t>5</a:t>
+                            <a:srgbClr val="F5C242"/>
+                          </a:solidFill>
+                          <a:latin typeface="Kanit"/>
+                        </a:rPr>
+                        <a:t>4</a:t>
                       </a:r>
                     </a:p>
                   </a:txBody>
@@ -8162,7 +8162,7 @@
                           </a:solidFill>
                           <a:latin typeface="Kanit"/>
                         </a:rPr>
-                        <a:t>สมุทรสงคราม</a:t>
+                        <a:t>สตูล</a:t>
                       </a:r>
                     </a:p>
                   </a:txBody>
@@ -8185,7 +8185,7 @@
                           </a:solidFill>
                           <a:latin typeface="Kanit"/>
                         </a:rPr>
-                        <a:t>6</a:t>
+                        <a:t>37</a:t>
                       </a:r>
                     </a:p>
                   </a:txBody>
@@ -8208,7 +8208,7 @@
                           </a:solidFill>
                           <a:latin typeface="Kanit"/>
                         </a:rPr>
-                        <a:t>74</a:t>
+                        <a:t>83</a:t>
                       </a:r>
                     </a:p>
                   </a:txBody>
@@ -8231,7 +8231,7 @@
                           </a:solidFill>
                           <a:latin typeface="Kanit"/>
                         </a:rPr>
-                        <a:t>50.0%</a:t>
+                        <a:t>43.2%</a:t>
                       </a:r>
                     </a:p>
                   </a:txBody>
@@ -8254,7 +8254,7 @@
                           </a:solidFill>
                           <a:latin typeface="Kanit"/>
                         </a:rPr>
-                        <a:t>1/2</a:t>
+                        <a:t>1/8</a:t>
                       </a:r>
                     </a:p>
                   </a:txBody>
@@ -8302,7 +8302,7 @@
                           </a:solidFill>
                           <a:latin typeface="Kanit"/>
                         </a:rPr>
-                        <a:t>นครปฐม</a:t>
+                        <a:t>นครนายก</a:t>
                       </a:r>
                     </a:p>
                   </a:txBody>
@@ -8325,7 +8325,7 @@
                           </a:solidFill>
                           <a:latin typeface="Kanit"/>
                         </a:rPr>
-                        <a:t>9</a:t>
+                        <a:t>27</a:t>
                       </a:r>
                     </a:p>
                   </a:txBody>
@@ -8348,7 +8348,7 @@
                           </a:solidFill>
                           <a:latin typeface="Kanit"/>
                         </a:rPr>
-                        <a:t>60</a:t>
+                        <a:t>54</a:t>
                       </a:r>
                     </a:p>
                   </a:txBody>
@@ -8371,7 +8371,7 @@
                           </a:solidFill>
                           <a:latin typeface="Kanit"/>
                         </a:rPr>
-                        <a:t>44.4%</a:t>
+                        <a:t>37.0%</a:t>
                       </a:r>
                     </a:p>
                   </a:txBody>
@@ -8394,7 +8394,7 @@
                           </a:solidFill>
                           <a:latin typeface="Kanit"/>
                         </a:rPr>
-                        <a:t>5/7</a:t>
+                        <a:t>2/6</a:t>
                       </a:r>
                     </a:p>
                   </a:txBody>
@@ -8442,7 +8442,7 @@
                           </a:solidFill>
                           <a:latin typeface="Kanit"/>
                         </a:rPr>
-                        <a:t>สตูล</a:t>
+                        <a:t>ฉะเชิงเทรา</a:t>
                       </a:r>
                     </a:p>
                   </a:txBody>
@@ -8465,7 +8465,7 @@
                           </a:solidFill>
                           <a:latin typeface="Kanit"/>
                         </a:rPr>
-                        <a:t>37</a:t>
+                        <a:t>18</a:t>
                       </a:r>
                     </a:p>
                   </a:txBody>
@@ -8488,7 +8488,7 @@
                           </a:solidFill>
                           <a:latin typeface="Kanit"/>
                         </a:rPr>
-                        <a:t>83</a:t>
+                        <a:t>55</a:t>
                       </a:r>
                     </a:p>
                   </a:txBody>
@@ -8511,7 +8511,7 @@
                           </a:solidFill>
                           <a:latin typeface="Kanit"/>
                         </a:rPr>
-                        <a:t>40.5%</a:t>
+                        <a:t>33.3%</a:t>
                       </a:r>
                     </a:p>
                   </a:txBody>
@@ -8534,7 +8534,7 @@
                           </a:solidFill>
                           <a:latin typeface="Kanit"/>
                         </a:rPr>
-                        <a:t>1/8</a:t>
+                        <a:t>2/4</a:t>
                       </a:r>
                     </a:p>
                   </a:txBody>
@@ -8582,7 +8582,7 @@
                           </a:solidFill>
                           <a:latin typeface="Kanit"/>
                         </a:rPr>
-                        <a:t>สมุทรสาคร</a:t>
+                        <a:t>ชัยนาท</a:t>
                       </a:r>
                     </a:p>
                   </a:txBody>
@@ -8605,7 +8605,7 @@
                           </a:solidFill>
                           <a:latin typeface="Kanit"/>
                         </a:rPr>
-                        <a:t>6</a:t>
+                        <a:t>29</a:t>
                       </a:r>
                     </a:p>
                   </a:txBody>
@@ -8628,7 +8628,7 @@
                           </a:solidFill>
                           <a:latin typeface="Kanit"/>
                         </a:rPr>
-                        <a:t>104</a:t>
+                        <a:t>67</a:t>
                       </a:r>
                     </a:p>
                   </a:txBody>
@@ -8651,7 +8651,7 @@
                           </a:solidFill>
                           <a:latin typeface="Kanit"/>
                         </a:rPr>
-                        <a:t>33.3%</a:t>
+                        <a:t>31.0%</a:t>
                       </a:r>
                     </a:p>
                   </a:txBody>
@@ -8674,7 +8674,7 @@
                           </a:solidFill>
                           <a:latin typeface="Kanit"/>
                         </a:rPr>
-                        <a:t>3/3</a:t>
+                        <a:t>1/5</a:t>
                       </a:r>
                     </a:p>
                   </a:txBody>
@@ -37087,7 +37087,7 @@
                 </a:solidFill>
                 <a:latin typeface="Kanit"/>
               </a:rPr>
-              <a:t>338 จาก 928 อำเภอ · แม่น้ำเกินระดับ 144 จาก 788 สถานี</a:t>
+              <a:t>338 จาก 928 อำเภอ · แม่น้ำเกินระดับ 152 จาก 788 สถานี</a:t>
             </a:r>
           </a:p>
         </p:txBody>
@@ -37859,7 +37859,7 @@
                           </a:solidFill>
                           <a:latin typeface="Kanit"/>
                         </a:rPr>
-                        <a:t>40/155</a:t>
+                        <a:t>41/155</a:t>
                       </a:r>
                     </a:p>
                   </a:txBody>
@@ -38091,7 +38091,7 @@
                           </a:solidFill>
                           <a:latin typeface="Kanit"/>
                         </a:rPr>
-                        <a:t>20/272</a:t>
+                        <a:t>21/272</a:t>
                       </a:r>
                     </a:p>
                   </a:txBody>
@@ -38323,7 +38323,7 @@
                           </a:solidFill>
                           <a:latin typeface="Kanit"/>
                         </a:rPr>
-                        <a:t>28/167</a:t>
+                        <a:t>32/167</a:t>
                       </a:r>
                     </a:p>
                   </a:txBody>
@@ -38787,7 +38787,7 @@
                           </a:solidFill>
                           <a:latin typeface="Kanit"/>
                         </a:rPr>
-                        <a:t>43/143</a:t>
+                        <a:t>45/143</a:t>
                       </a:r>
                     </a:p>
                   </a:txBody>

</xml_diff>

<commit_message>
deck(mcom): rebuild — the data moved past the committed figures (run 34661997426)
</commit_message>
<xml_diff>
--- a/docs/decks/mcom-2026-08-05-macro-TH.pptx
+++ b/docs/decks/mcom-2026-08-05-macro-TH.pptx
@@ -6240,7 +6240,7 @@
                 </a:solidFill>
                 <a:latin typeface="Kanit"/>
               </a:rPr>
-              <a:t>152</a:t>
+              <a:t>151</a:t>
             </a:r>
           </a:p>
         </p:txBody>
@@ -6279,7 +6279,7 @@
                 </a:solidFill>
                 <a:latin typeface="Kanit"/>
               </a:rPr>
-              <a:t>จาก 788 (19.3%) · เรียลไทม์ · 2026-09-11</a:t>
+              <a:t>จาก 788 (19.2%) · เรียลไทม์ · 2026-09-12</a:t>
             </a:r>
           </a:p>
         </p:txBody>
@@ -6405,7 +6405,7 @@
                 </a:solidFill>
                 <a:latin typeface="Kanit"/>
               </a:rPr>
-              <a:t>50</a:t>
+              <a:t>40</a:t>
             </a:r>
           </a:p>
         </p:txBody>
@@ -6444,7 +6444,7 @@
                 </a:solidFill>
                 <a:latin typeface="Kanit"/>
               </a:rPr>
-              <a:t>ค่าล่าสุดรายวัน · 2026-09-11</a:t>
+              <a:t>ค่าล่าสุดรายวัน · 2026-09-12</a:t>
             </a:r>
           </a:p>
         </p:txBody>
@@ -7882,7 +7882,7 @@
                           </a:solidFill>
                           <a:latin typeface="Kanit"/>
                         </a:rPr>
-                        <a:t>สกลนคร</a:t>
+                        <a:t>ลำปาง</a:t>
                       </a:r>
                     </a:p>
                   </a:txBody>
@@ -7905,7 +7905,7 @@
                           </a:solidFill>
                           <a:latin typeface="Kanit"/>
                         </a:rPr>
-                        <a:t>37</a:t>
+                        <a:t>178</a:t>
                       </a:r>
                     </a:p>
                   </a:txBody>
@@ -7928,7 +7928,7 @@
                           </a:solidFill>
                           <a:latin typeface="Kanit"/>
                         </a:rPr>
-                        <a:t>12</a:t>
+                        <a:t>74</a:t>
                       </a:r>
                     </a:p>
                   </a:txBody>
@@ -7947,11 +7947,11 @@
                       <a:r>
                         <a:rPr sz="900" b="1">
                           <a:solidFill>
-                            <a:srgbClr val="606060"/>
-                          </a:solidFill>
-                          <a:latin typeface="Kanit"/>
-                        </a:rPr>
-                        <a:t>0.0%</a:t>
+                            <a:srgbClr val="F5C242"/>
+                          </a:solidFill>
+                          <a:latin typeface="Kanit"/>
+                        </a:rPr>
+                        <a:t>9.6%</a:t>
                       </a:r>
                     </a:p>
                   </a:txBody>
@@ -7974,7 +7974,7 @@
                           </a:solidFill>
                           <a:latin typeface="Kanit"/>
                         </a:rPr>
-                        <a:t>7/12</a:t>
+                        <a:t>1/25</a:t>
                       </a:r>
                     </a:p>
                   </a:txBody>
@@ -8022,7 +8022,7 @@
                           </a:solidFill>
                           <a:latin typeface="Kanit"/>
                         </a:rPr>
-                        <a:t>ปราจีนบุรี</a:t>
+                        <a:t>สกลนคร</a:t>
                       </a:r>
                     </a:p>
                   </a:txBody>
@@ -8045,7 +8045,7 @@
                           </a:solidFill>
                           <a:latin typeface="Kanit"/>
                         </a:rPr>
-                        <a:t>35</a:t>
+                        <a:t>38</a:t>
                       </a:r>
                     </a:p>
                   </a:txBody>
@@ -8068,7 +8068,7 @@
                           </a:solidFill>
                           <a:latin typeface="Kanit"/>
                         </a:rPr>
-                        <a:t>98</a:t>
+                        <a:t>13</a:t>
                       </a:r>
                     </a:p>
                   </a:txBody>
@@ -8087,11 +8087,11 @@
                       <a:r>
                         <a:rPr sz="900" b="1">
                           <a:solidFill>
-                            <a:srgbClr val="F5C242"/>
-                          </a:solidFill>
-                          <a:latin typeface="Kanit"/>
-                        </a:rPr>
-                        <a:t>54.3%</a:t>
+                            <a:srgbClr val="606060"/>
+                          </a:solidFill>
+                          <a:latin typeface="Kanit"/>
+                        </a:rPr>
+                        <a:t>0.0%</a:t>
                       </a:r>
                     </a:p>
                   </a:txBody>
@@ -8114,7 +8114,7 @@
                           </a:solidFill>
                           <a:latin typeface="Kanit"/>
                         </a:rPr>
-                        <a:t>6/15</a:t>
+                        <a:t>7/12</a:t>
                       </a:r>
                     </a:p>
                   </a:txBody>
@@ -8133,11 +8133,11 @@
                       <a:r>
                         <a:rPr sz="900" b="1">
                           <a:solidFill>
-                            <a:srgbClr val="F5C242"/>
-                          </a:solidFill>
-                          <a:latin typeface="Kanit"/>
-                        </a:rPr>
-                        <a:t>4</a:t>
+                            <a:srgbClr val="CC0000"/>
+                          </a:solidFill>
+                          <a:latin typeface="Kanit"/>
+                        </a:rPr>
+                        <a:t>5</a:t>
                       </a:r>
                     </a:p>
                   </a:txBody>
@@ -8162,7 +8162,7 @@
                           </a:solidFill>
                           <a:latin typeface="Kanit"/>
                         </a:rPr>
-                        <a:t>สตูล</a:t>
+                        <a:t>ปราจีนบุรี</a:t>
                       </a:r>
                     </a:p>
                   </a:txBody>
@@ -8185,7 +8185,7 @@
                           </a:solidFill>
                           <a:latin typeface="Kanit"/>
                         </a:rPr>
-                        <a:t>37</a:t>
+                        <a:t>35</a:t>
                       </a:r>
                     </a:p>
                   </a:txBody>
@@ -8208,7 +8208,7 @@
                           </a:solidFill>
                           <a:latin typeface="Kanit"/>
                         </a:rPr>
-                        <a:t>83</a:t>
+                        <a:t>64</a:t>
                       </a:r>
                     </a:p>
                   </a:txBody>
@@ -8231,7 +8231,7 @@
                           </a:solidFill>
                           <a:latin typeface="Kanit"/>
                         </a:rPr>
-                        <a:t>43.2%</a:t>
+                        <a:t>34.3%</a:t>
                       </a:r>
                     </a:p>
                   </a:txBody>
@@ -8254,7 +8254,7 @@
                           </a:solidFill>
                           <a:latin typeface="Kanit"/>
                         </a:rPr>
-                        <a:t>1/8</a:t>
+                        <a:t>6/15</a:t>
                       </a:r>
                     </a:p>
                   </a:txBody>
@@ -8348,7 +8348,7 @@
                           </a:solidFill>
                           <a:latin typeface="Kanit"/>
                         </a:rPr>
-                        <a:t>54</a:t>
+                        <a:t>52</a:t>
                       </a:r>
                     </a:p>
                   </a:txBody>
@@ -8371,7 +8371,7 @@
                           </a:solidFill>
                           <a:latin typeface="Kanit"/>
                         </a:rPr>
-                        <a:t>37.0%</a:t>
+                        <a:t>25.9%</a:t>
                       </a:r>
                     </a:p>
                   </a:txBody>
@@ -8488,7 +8488,7 @@
                           </a:solidFill>
                           <a:latin typeface="Kanit"/>
                         </a:rPr>
-                        <a:t>55</a:t>
+                        <a:t>52</a:t>
                       </a:r>
                     </a:p>
                   </a:txBody>
@@ -8511,7 +8511,7 @@
                           </a:solidFill>
                           <a:latin typeface="Kanit"/>
                         </a:rPr>
-                        <a:t>33.3%</a:t>
+                        <a:t>22.2%</a:t>
                       </a:r>
                     </a:p>
                   </a:txBody>
@@ -8582,7 +8582,7 @@
                           </a:solidFill>
                           <a:latin typeface="Kanit"/>
                         </a:rPr>
-                        <a:t>ชัยนาท</a:t>
+                        <a:t>สตูล</a:t>
                       </a:r>
                     </a:p>
                   </a:txBody>
@@ -8605,7 +8605,7 @@
                           </a:solidFill>
                           <a:latin typeface="Kanit"/>
                         </a:rPr>
-                        <a:t>29</a:t>
+                        <a:t>37</a:t>
                       </a:r>
                     </a:p>
                   </a:txBody>
@@ -8628,7 +8628,7 @@
                           </a:solidFill>
                           <a:latin typeface="Kanit"/>
                         </a:rPr>
-                        <a:t>67</a:t>
+                        <a:t>48</a:t>
                       </a:r>
                     </a:p>
                   </a:txBody>
@@ -8651,7 +8651,7 @@
                           </a:solidFill>
                           <a:latin typeface="Kanit"/>
                         </a:rPr>
-                        <a:t>31.0%</a:t>
+                        <a:t>18.9%</a:t>
                       </a:r>
                     </a:p>
                   </a:txBody>
@@ -8674,7 +8674,7 @@
                           </a:solidFill>
                           <a:latin typeface="Kanit"/>
                         </a:rPr>
-                        <a:t>1/5</a:t>
+                        <a:t>2/8</a:t>
                       </a:r>
                     </a:p>
                   </a:txBody>
@@ -8909,7 +8909,7 @@
                 </a:solidFill>
                 <a:latin typeface="Kanit"/>
               </a:rPr>
-              <a:t>พื้นที่ปลูก วัดจริง (สศก. — ข้อมูลอำเภอ×พืช 3,295 แถว) ภัยแล้งเป็นดัชนี SPEI จาก แบบจำลอง คำนวณจากปริมาณฝนและการคายระเหย ปรับเดือนละครั้ง ดึงข้อมูล 2026-07-20 — เป็นสัญญาณที่ครอบคลุมทั้งประเทศดีที่สุดที่มี แต่ไม่มีใครลงพื้นที่ไปเดินดูอำเภอเหล่านั้น ข้อมูลฝนและระดับน้ำ วัดจริง (ThaiWater เรียลไทม์ ดึงทุกวันและสะสมไว้ — วันที่ดึงไม่สำเร็จจะเว้นเป็นช่องว่าง ไม่ใส่ค่าสมมติ) · ฝนถึง 2026-09-11, ระดับน้ำถึง 2026-09-11 ความเสี่ยงน้ำท่วมเชิงโครงสร้าง วัดจริง (สำมะโนพื้นที่ท่วมซ้ำซาก GISTDA มาตราส่วน 1:50,000 ปี 2005-2016 — เป็นบันทึกภาคพื้นดิน 12 ปี ไม่ใช่การพยากรณ์)</a:t>
+              <a:t>พื้นที่ปลูก วัดจริง (สศก. — ข้อมูลอำเภอ×พืช 3,295 แถว) ภัยแล้งเป็นดัชนี SPEI จาก แบบจำลอง คำนวณจากปริมาณฝนและการคายระเหย ปรับเดือนละครั้ง ดึงข้อมูล 2026-07-20 — เป็นสัญญาณที่ครอบคลุมทั้งประเทศดีที่สุดที่มี แต่ไม่มีใครลงพื้นที่ไปเดินดูอำเภอเหล่านั้น ข้อมูลฝนและระดับน้ำ วัดจริง (ThaiWater เรียลไทม์ ดึงทุกวันและสะสมไว้ — วันที่ดึงไม่สำเร็จจะเว้นเป็นช่องว่าง ไม่ใส่ค่าสมมติ) · ฝนถึง 2026-09-12, ระดับน้ำถึง 2026-09-12 ความเสี่ยงน้ำท่วมเชิงโครงสร้าง วัดจริง (สำมะโนพื้นที่ท่วมซ้ำซาก GISTDA มาตราส่วน 1:50,000 ปี 2005-2016 — เป็นบันทึกภาคพื้นดิน 12 ปี ไม่ใช่การพยากรณ์)</a:t>
             </a:r>
           </a:p>
         </p:txBody>
@@ -32047,7 +32047,7 @@
                 </a:solidFill>
                 <a:latin typeface="Kanit"/>
               </a:rPr>
-              <a:t>รุ่นข้อมูล — ราคาโลก 2026M06 · ราคาหน้าฟาร์มไทย 2026-09-11 · ประวัติราคาไทย 2026-09-11 · ต้นทุนการผลิตพืช สศก. ไจอัป 2568 (ปีเพาะปลูก 2568/69, ประมาณการ สศก. มี.ค. 2569) · ภัยแล้ง 2026-06-21 · เงินเฟ้อ 2026-05 · GDP 2026 ไตรมาส 1 · IMF WEO 2026 · ดัชนีราคาขายต่อ 2026-05 · ยอดจดทะเบียนถึง 2026-01 · หนี้ครัวเรือน สสช. SES 2566 · ค่าจ้าง สสช. LFS 2568 · ข้อมูลตรวจวัด 2026-09-11</a:t>
+              <a:t>รุ่นข้อมูล — ราคาโลก 2026M06 · ราคาหน้าฟาร์มไทย 2026-09-11 · ประวัติราคาไทย 2026-09-11 · ต้นทุนการผลิตพืช สศก. ไจอัป 2568 (ปีเพาะปลูก 2568/69, ประมาณการ สศก. มี.ค. 2569) · ภัยแล้ง 2026-06-21 · เงินเฟ้อ 2026-05 · GDP 2026 ไตรมาส 1 · IMF WEO 2026 · ดัชนีราคาขายต่อ 2026-05 · ยอดจดทะเบียนถึง 2026-01 · หนี้ครัวเรือน สสช. SES 2566 · ค่าจ้าง สสช. LFS 2568 · ข้อมูลตรวจวัด 2026-09-12</a:t>
             </a:r>
           </a:p>
         </p:txBody>
@@ -37087,7 +37087,7 @@
                 </a:solidFill>
                 <a:latin typeface="Kanit"/>
               </a:rPr>
-              <a:t>338 จาก 928 อำเภอ · แม่น้ำเกินระดับ 152 จาก 788 สถานี</a:t>
+              <a:t>338 จาก 928 อำเภอ · แม่น้ำเกินระดับ 151 จาก 788 สถานี</a:t>
             </a:r>
           </a:p>
         </p:txBody>
@@ -37859,7 +37859,7 @@
                           </a:solidFill>
                           <a:latin typeface="Kanit"/>
                         </a:rPr>
-                        <a:t>41/155</a:t>
+                        <a:t>42/155</a:t>
                       </a:r>
                     </a:p>
                   </a:txBody>
@@ -38091,7 +38091,7 @@
                           </a:solidFill>
                           <a:latin typeface="Kanit"/>
                         </a:rPr>
-                        <a:t>21/272</a:t>
+                        <a:t>22/272</a:t>
                       </a:r>
                     </a:p>
                   </a:txBody>
@@ -38323,7 +38323,7 @@
                           </a:solidFill>
                           <a:latin typeface="Kanit"/>
                         </a:rPr>
-                        <a:t>32/167</a:t>
+                        <a:t>30/167</a:t>
                       </a:r>
                     </a:p>
                   </a:txBody>
@@ -38555,7 +38555,7 @@
                           </a:solidFill>
                           <a:latin typeface="Kanit"/>
                         </a:rPr>
-                        <a:t>13/51</a:t>
+                        <a:t>12/51</a:t>
                       </a:r>
                     </a:p>
                   </a:txBody>

</xml_diff>

<commit_message>
deck(mcom): rebuild — the data moved past the committed figures (run 34661997426) (#931)
Co-authored-by: github-actions[bot] <41898282+github-actions[bot]@users.noreply.github.com>
</commit_message>
<xml_diff>
--- a/docs/decks/mcom-2026-08-05-macro-TH.pptx
+++ b/docs/decks/mcom-2026-08-05-macro-TH.pptx
@@ -6240,7 +6240,7 @@
                 </a:solidFill>
                 <a:latin typeface="Kanit"/>
               </a:rPr>
-              <a:t>152</a:t>
+              <a:t>151</a:t>
             </a:r>
           </a:p>
         </p:txBody>
@@ -6279,7 +6279,7 @@
                 </a:solidFill>
                 <a:latin typeface="Kanit"/>
               </a:rPr>
-              <a:t>จาก 788 (19.3%) · เรียลไทม์ · 2026-09-11</a:t>
+              <a:t>จาก 788 (19.2%) · เรียลไทม์ · 2026-09-12</a:t>
             </a:r>
           </a:p>
         </p:txBody>
@@ -6405,7 +6405,7 @@
                 </a:solidFill>
                 <a:latin typeface="Kanit"/>
               </a:rPr>
-              <a:t>50</a:t>
+              <a:t>40</a:t>
             </a:r>
           </a:p>
         </p:txBody>
@@ -6444,7 +6444,7 @@
                 </a:solidFill>
                 <a:latin typeface="Kanit"/>
               </a:rPr>
-              <a:t>ค่าล่าสุดรายวัน · 2026-09-11</a:t>
+              <a:t>ค่าล่าสุดรายวัน · 2026-09-12</a:t>
             </a:r>
           </a:p>
         </p:txBody>
@@ -7882,7 +7882,7 @@
                           </a:solidFill>
                           <a:latin typeface="Kanit"/>
                         </a:rPr>
-                        <a:t>สกลนคร</a:t>
+                        <a:t>ลำปาง</a:t>
                       </a:r>
                     </a:p>
                   </a:txBody>
@@ -7905,7 +7905,7 @@
                           </a:solidFill>
                           <a:latin typeface="Kanit"/>
                         </a:rPr>
-                        <a:t>37</a:t>
+                        <a:t>178</a:t>
                       </a:r>
                     </a:p>
                   </a:txBody>
@@ -7928,7 +7928,7 @@
                           </a:solidFill>
                           <a:latin typeface="Kanit"/>
                         </a:rPr>
-                        <a:t>12</a:t>
+                        <a:t>74</a:t>
                       </a:r>
                     </a:p>
                   </a:txBody>
@@ -7947,11 +7947,11 @@
                       <a:r>
                         <a:rPr sz="900" b="1">
                           <a:solidFill>
-                            <a:srgbClr val="606060"/>
-                          </a:solidFill>
-                          <a:latin typeface="Kanit"/>
-                        </a:rPr>
-                        <a:t>0.0%</a:t>
+                            <a:srgbClr val="F5C242"/>
+                          </a:solidFill>
+                          <a:latin typeface="Kanit"/>
+                        </a:rPr>
+                        <a:t>9.6%</a:t>
                       </a:r>
                     </a:p>
                   </a:txBody>
@@ -7974,7 +7974,7 @@
                           </a:solidFill>
                           <a:latin typeface="Kanit"/>
                         </a:rPr>
-                        <a:t>7/12</a:t>
+                        <a:t>1/25</a:t>
                       </a:r>
                     </a:p>
                   </a:txBody>
@@ -8022,7 +8022,7 @@
                           </a:solidFill>
                           <a:latin typeface="Kanit"/>
                         </a:rPr>
-                        <a:t>ปราจีนบุรี</a:t>
+                        <a:t>สกลนคร</a:t>
                       </a:r>
                     </a:p>
                   </a:txBody>
@@ -8045,7 +8045,7 @@
                           </a:solidFill>
                           <a:latin typeface="Kanit"/>
                         </a:rPr>
-                        <a:t>35</a:t>
+                        <a:t>38</a:t>
                       </a:r>
                     </a:p>
                   </a:txBody>
@@ -8068,7 +8068,7 @@
                           </a:solidFill>
                           <a:latin typeface="Kanit"/>
                         </a:rPr>
-                        <a:t>98</a:t>
+                        <a:t>13</a:t>
                       </a:r>
                     </a:p>
                   </a:txBody>
@@ -8087,11 +8087,11 @@
                       <a:r>
                         <a:rPr sz="900" b="1">
                           <a:solidFill>
-                            <a:srgbClr val="F5C242"/>
-                          </a:solidFill>
-                          <a:latin typeface="Kanit"/>
-                        </a:rPr>
-                        <a:t>54.3%</a:t>
+                            <a:srgbClr val="606060"/>
+                          </a:solidFill>
+                          <a:latin typeface="Kanit"/>
+                        </a:rPr>
+                        <a:t>0.0%</a:t>
                       </a:r>
                     </a:p>
                   </a:txBody>
@@ -8114,7 +8114,7 @@
                           </a:solidFill>
                           <a:latin typeface="Kanit"/>
                         </a:rPr>
-                        <a:t>6/15</a:t>
+                        <a:t>7/12</a:t>
                       </a:r>
                     </a:p>
                   </a:txBody>
@@ -8133,11 +8133,11 @@
                       <a:r>
                         <a:rPr sz="900" b="1">
                           <a:solidFill>
-                            <a:srgbClr val="F5C242"/>
-                          </a:solidFill>
-                          <a:latin typeface="Kanit"/>
-                        </a:rPr>
-                        <a:t>4</a:t>
+                            <a:srgbClr val="CC0000"/>
+                          </a:solidFill>
+                          <a:latin typeface="Kanit"/>
+                        </a:rPr>
+                        <a:t>5</a:t>
                       </a:r>
                     </a:p>
                   </a:txBody>
@@ -8162,7 +8162,7 @@
                           </a:solidFill>
                           <a:latin typeface="Kanit"/>
                         </a:rPr>
-                        <a:t>สตูล</a:t>
+                        <a:t>ปราจีนบุรี</a:t>
                       </a:r>
                     </a:p>
                   </a:txBody>
@@ -8185,7 +8185,7 @@
                           </a:solidFill>
                           <a:latin typeface="Kanit"/>
                         </a:rPr>
-                        <a:t>37</a:t>
+                        <a:t>35</a:t>
                       </a:r>
                     </a:p>
                   </a:txBody>
@@ -8208,7 +8208,7 @@
                           </a:solidFill>
                           <a:latin typeface="Kanit"/>
                         </a:rPr>
-                        <a:t>83</a:t>
+                        <a:t>64</a:t>
                       </a:r>
                     </a:p>
                   </a:txBody>
@@ -8231,7 +8231,7 @@
                           </a:solidFill>
                           <a:latin typeface="Kanit"/>
                         </a:rPr>
-                        <a:t>43.2%</a:t>
+                        <a:t>34.3%</a:t>
                       </a:r>
                     </a:p>
                   </a:txBody>
@@ -8254,7 +8254,7 @@
                           </a:solidFill>
                           <a:latin typeface="Kanit"/>
                         </a:rPr>
-                        <a:t>1/8</a:t>
+                        <a:t>6/15</a:t>
                       </a:r>
                     </a:p>
                   </a:txBody>
@@ -8348,7 +8348,7 @@
                           </a:solidFill>
                           <a:latin typeface="Kanit"/>
                         </a:rPr>
-                        <a:t>54</a:t>
+                        <a:t>52</a:t>
                       </a:r>
                     </a:p>
                   </a:txBody>
@@ -8371,7 +8371,7 @@
                           </a:solidFill>
                           <a:latin typeface="Kanit"/>
                         </a:rPr>
-                        <a:t>37.0%</a:t>
+                        <a:t>25.9%</a:t>
                       </a:r>
                     </a:p>
                   </a:txBody>
@@ -8488,7 +8488,7 @@
                           </a:solidFill>
                           <a:latin typeface="Kanit"/>
                         </a:rPr>
-                        <a:t>55</a:t>
+                        <a:t>52</a:t>
                       </a:r>
                     </a:p>
                   </a:txBody>
@@ -8511,7 +8511,7 @@
                           </a:solidFill>
                           <a:latin typeface="Kanit"/>
                         </a:rPr>
-                        <a:t>33.3%</a:t>
+                        <a:t>22.2%</a:t>
                       </a:r>
                     </a:p>
                   </a:txBody>
@@ -8582,7 +8582,7 @@
                           </a:solidFill>
                           <a:latin typeface="Kanit"/>
                         </a:rPr>
-                        <a:t>ชัยนาท</a:t>
+                        <a:t>สตูล</a:t>
                       </a:r>
                     </a:p>
                   </a:txBody>
@@ -8605,7 +8605,7 @@
                           </a:solidFill>
                           <a:latin typeface="Kanit"/>
                         </a:rPr>
-                        <a:t>29</a:t>
+                        <a:t>37</a:t>
                       </a:r>
                     </a:p>
                   </a:txBody>
@@ -8628,7 +8628,7 @@
                           </a:solidFill>
                           <a:latin typeface="Kanit"/>
                         </a:rPr>
-                        <a:t>67</a:t>
+                        <a:t>48</a:t>
                       </a:r>
                     </a:p>
                   </a:txBody>
@@ -8651,7 +8651,7 @@
                           </a:solidFill>
                           <a:latin typeface="Kanit"/>
                         </a:rPr>
-                        <a:t>31.0%</a:t>
+                        <a:t>18.9%</a:t>
                       </a:r>
                     </a:p>
                   </a:txBody>
@@ -8674,7 +8674,7 @@
                           </a:solidFill>
                           <a:latin typeface="Kanit"/>
                         </a:rPr>
-                        <a:t>1/5</a:t>
+                        <a:t>2/8</a:t>
                       </a:r>
                     </a:p>
                   </a:txBody>
@@ -8909,7 +8909,7 @@
                 </a:solidFill>
                 <a:latin typeface="Kanit"/>
               </a:rPr>
-              <a:t>พื้นที่ปลูก วัดจริง (สศก. — ข้อมูลอำเภอ×พืช 3,295 แถว) ภัยแล้งเป็นดัชนี SPEI จาก แบบจำลอง คำนวณจากปริมาณฝนและการคายระเหย ปรับเดือนละครั้ง ดึงข้อมูล 2026-07-20 — เป็นสัญญาณที่ครอบคลุมทั้งประเทศดีที่สุดที่มี แต่ไม่มีใครลงพื้นที่ไปเดินดูอำเภอเหล่านั้น ข้อมูลฝนและระดับน้ำ วัดจริง (ThaiWater เรียลไทม์ ดึงทุกวันและสะสมไว้ — วันที่ดึงไม่สำเร็จจะเว้นเป็นช่องว่าง ไม่ใส่ค่าสมมติ) · ฝนถึง 2026-09-11, ระดับน้ำถึง 2026-09-11 ความเสี่ยงน้ำท่วมเชิงโครงสร้าง วัดจริง (สำมะโนพื้นที่ท่วมซ้ำซาก GISTDA มาตราส่วน 1:50,000 ปี 2005-2016 — เป็นบันทึกภาคพื้นดิน 12 ปี ไม่ใช่การพยากรณ์)</a:t>
+              <a:t>พื้นที่ปลูก วัดจริง (สศก. — ข้อมูลอำเภอ×พืช 3,295 แถว) ภัยแล้งเป็นดัชนี SPEI จาก แบบจำลอง คำนวณจากปริมาณฝนและการคายระเหย ปรับเดือนละครั้ง ดึงข้อมูล 2026-07-20 — เป็นสัญญาณที่ครอบคลุมทั้งประเทศดีที่สุดที่มี แต่ไม่มีใครลงพื้นที่ไปเดินดูอำเภอเหล่านั้น ข้อมูลฝนและระดับน้ำ วัดจริง (ThaiWater เรียลไทม์ ดึงทุกวันและสะสมไว้ — วันที่ดึงไม่สำเร็จจะเว้นเป็นช่องว่าง ไม่ใส่ค่าสมมติ) · ฝนถึง 2026-09-12, ระดับน้ำถึง 2026-09-12 ความเสี่ยงน้ำท่วมเชิงโครงสร้าง วัดจริง (สำมะโนพื้นที่ท่วมซ้ำซาก GISTDA มาตราส่วน 1:50,000 ปี 2005-2016 — เป็นบันทึกภาคพื้นดิน 12 ปี ไม่ใช่การพยากรณ์)</a:t>
             </a:r>
           </a:p>
         </p:txBody>
@@ -32047,7 +32047,7 @@
                 </a:solidFill>
                 <a:latin typeface="Kanit"/>
               </a:rPr>
-              <a:t>รุ่นข้อมูล — ราคาโลก 2026M06 · ราคาหน้าฟาร์มไทย 2026-09-11 · ประวัติราคาไทย 2026-09-11 · ต้นทุนการผลิตพืช สศก. ไจอัป 2568 (ปีเพาะปลูก 2568/69, ประมาณการ สศก. มี.ค. 2569) · ภัยแล้ง 2026-06-21 · เงินเฟ้อ 2026-05 · GDP 2026 ไตรมาส 1 · IMF WEO 2026 · ดัชนีราคาขายต่อ 2026-05 · ยอดจดทะเบียนถึง 2026-01 · หนี้ครัวเรือน สสช. SES 2566 · ค่าจ้าง สสช. LFS 2568 · ข้อมูลตรวจวัด 2026-09-11</a:t>
+              <a:t>รุ่นข้อมูล — ราคาโลก 2026M06 · ราคาหน้าฟาร์มไทย 2026-09-11 · ประวัติราคาไทย 2026-09-11 · ต้นทุนการผลิตพืช สศก. ไจอัป 2568 (ปีเพาะปลูก 2568/69, ประมาณการ สศก. มี.ค. 2569) · ภัยแล้ง 2026-06-21 · เงินเฟ้อ 2026-05 · GDP 2026 ไตรมาส 1 · IMF WEO 2026 · ดัชนีราคาขายต่อ 2026-05 · ยอดจดทะเบียนถึง 2026-01 · หนี้ครัวเรือน สสช. SES 2566 · ค่าจ้าง สสช. LFS 2568 · ข้อมูลตรวจวัด 2026-09-12</a:t>
             </a:r>
           </a:p>
         </p:txBody>
@@ -37087,7 +37087,7 @@
                 </a:solidFill>
                 <a:latin typeface="Kanit"/>
               </a:rPr>
-              <a:t>338 จาก 928 อำเภอ · แม่น้ำเกินระดับ 152 จาก 788 สถานี</a:t>
+              <a:t>338 จาก 928 อำเภอ · แม่น้ำเกินระดับ 151 จาก 788 สถานี</a:t>
             </a:r>
           </a:p>
         </p:txBody>
@@ -37859,7 +37859,7 @@
                           </a:solidFill>
                           <a:latin typeface="Kanit"/>
                         </a:rPr>
-                        <a:t>41/155</a:t>
+                        <a:t>42/155</a:t>
                       </a:r>
                     </a:p>
                   </a:txBody>
@@ -38091,7 +38091,7 @@
                           </a:solidFill>
                           <a:latin typeface="Kanit"/>
                         </a:rPr>
-                        <a:t>21/272</a:t>
+                        <a:t>22/272</a:t>
                       </a:r>
                     </a:p>
                   </a:txBody>
@@ -38323,7 +38323,7 @@
                           </a:solidFill>
                           <a:latin typeface="Kanit"/>
                         </a:rPr>
-                        <a:t>32/167</a:t>
+                        <a:t>30/167</a:t>
                       </a:r>
                     </a:p>
                   </a:txBody>
@@ -38555,7 +38555,7 @@
                           </a:solidFill>
                           <a:latin typeface="Kanit"/>
                         </a:rPr>
-                        <a:t>13/51</a:t>
+                        <a:t>12/51</a:t>
                       </a:r>
                     </a:p>
                   </a:txBody>

</xml_diff>

<commit_message>
deck(mcom): rebuild — the data moved past the committed figures (run 34681465996)
</commit_message>
<xml_diff>
--- a/docs/decks/mcom-2026-08-05-macro-TH.pptx
+++ b/docs/decks/mcom-2026-08-05-macro-TH.pptx
@@ -6240,7 +6240,7 @@
                 </a:solidFill>
                 <a:latin typeface="Kanit"/>
               </a:rPr>
-              <a:t>151</a:t>
+              <a:t>145</a:t>
             </a:r>
           </a:p>
         </p:txBody>
@@ -6279,7 +6279,7 @@
                 </a:solidFill>
                 <a:latin typeface="Kanit"/>
               </a:rPr>
-              <a:t>จาก 788 (19.2%) · เรียลไทม์ · 2026-09-12</a:t>
+              <a:t>จาก 788 (18.4%) · เรียลไทม์ · 2026-09-12</a:t>
             </a:r>
           </a:p>
         </p:txBody>
@@ -6405,7 +6405,7 @@
                 </a:solidFill>
                 <a:latin typeface="Kanit"/>
               </a:rPr>
-              <a:t>40</a:t>
+              <a:t>26</a:t>
             </a:r>
           </a:p>
         </p:txBody>
@@ -7882,7 +7882,7 @@
                           </a:solidFill>
                           <a:latin typeface="Kanit"/>
                         </a:rPr>
-                        <a:t>ลำปาง</a:t>
+                        <a:t>สกลนคร</a:t>
                       </a:r>
                     </a:p>
                   </a:txBody>
@@ -7905,7 +7905,7 @@
                           </a:solidFill>
                           <a:latin typeface="Kanit"/>
                         </a:rPr>
-                        <a:t>178</a:t>
+                        <a:t>38</a:t>
                       </a:r>
                     </a:p>
                   </a:txBody>
@@ -7928,7 +7928,7 @@
                           </a:solidFill>
                           <a:latin typeface="Kanit"/>
                         </a:rPr>
-                        <a:t>74</a:t>
+                        <a:t>14</a:t>
                       </a:r>
                     </a:p>
                   </a:txBody>
@@ -7947,11 +7947,11 @@
                       <a:r>
                         <a:rPr sz="900" b="1">
                           <a:solidFill>
-                            <a:srgbClr val="F5C242"/>
-                          </a:solidFill>
-                          <a:latin typeface="Kanit"/>
-                        </a:rPr>
-                        <a:t>9.6%</a:t>
+                            <a:srgbClr val="606060"/>
+                          </a:solidFill>
+                          <a:latin typeface="Kanit"/>
+                        </a:rPr>
+                        <a:t>0.0%</a:t>
                       </a:r>
                     </a:p>
                   </a:txBody>
@@ -7974,7 +7974,7 @@
                           </a:solidFill>
                           <a:latin typeface="Kanit"/>
                         </a:rPr>
-                        <a:t>1/25</a:t>
+                        <a:t>7/12</a:t>
                       </a:r>
                     </a:p>
                   </a:txBody>
@@ -8022,7 +8022,7 @@
                           </a:solidFill>
                           <a:latin typeface="Kanit"/>
                         </a:rPr>
-                        <a:t>สกลนคร</a:t>
+                        <a:t>กาญจนบุรี</a:t>
                       </a:r>
                     </a:p>
                   </a:txBody>
@@ -8045,7 +8045,7 @@
                           </a:solidFill>
                           <a:latin typeface="Kanit"/>
                         </a:rPr>
-                        <a:t>38</a:t>
+                        <a:t>98</a:t>
                       </a:r>
                     </a:p>
                   </a:txBody>
@@ -8068,7 +8068,7 @@
                           </a:solidFill>
                           <a:latin typeface="Kanit"/>
                         </a:rPr>
-                        <a:t>13</a:t>
+                        <a:t>69</a:t>
                       </a:r>
                     </a:p>
                   </a:txBody>
@@ -8087,11 +8087,11 @@
                       <a:r>
                         <a:rPr sz="900" b="1">
                           <a:solidFill>
-                            <a:srgbClr val="606060"/>
-                          </a:solidFill>
-                          <a:latin typeface="Kanit"/>
-                        </a:rPr>
-                        <a:t>0.0%</a:t>
+                            <a:srgbClr val="F5C242"/>
+                          </a:solidFill>
+                          <a:latin typeface="Kanit"/>
+                        </a:rPr>
+                        <a:t>17.3%</a:t>
                       </a:r>
                     </a:p>
                   </a:txBody>
@@ -8114,7 +8114,7 @@
                           </a:solidFill>
                           <a:latin typeface="Kanit"/>
                         </a:rPr>
-                        <a:t>7/12</a:t>
+                        <a:t>4/25</a:t>
                       </a:r>
                     </a:p>
                   </a:txBody>
@@ -8133,11 +8133,11 @@
                       <a:r>
                         <a:rPr sz="900" b="1">
                           <a:solidFill>
-                            <a:srgbClr val="CC0000"/>
-                          </a:solidFill>
-                          <a:latin typeface="Kanit"/>
-                        </a:rPr>
-                        <a:t>5</a:t>
+                            <a:srgbClr val="F5C242"/>
+                          </a:solidFill>
+                          <a:latin typeface="Kanit"/>
+                        </a:rPr>
+                        <a:t>4</a:t>
                       </a:r>
                     </a:p>
                   </a:txBody>
@@ -8162,7 +8162,7 @@
                           </a:solidFill>
                           <a:latin typeface="Kanit"/>
                         </a:rPr>
-                        <a:t>ปราจีนบุรี</a:t>
+                        <a:t>สมุทรสาคร</a:t>
                       </a:r>
                     </a:p>
                   </a:txBody>
@@ -8185,7 +8185,7 @@
                           </a:solidFill>
                           <a:latin typeface="Kanit"/>
                         </a:rPr>
-                        <a:t>35</a:t>
+                        <a:t>6</a:t>
                       </a:r>
                     </a:p>
                   </a:txBody>
@@ -8208,7 +8208,7 @@
                           </a:solidFill>
                           <a:latin typeface="Kanit"/>
                         </a:rPr>
-                        <a:t>64</a:t>
+                        <a:t>39</a:t>
                       </a:r>
                     </a:p>
                   </a:txBody>
@@ -8231,7 +8231,7 @@
                           </a:solidFill>
                           <a:latin typeface="Kanit"/>
                         </a:rPr>
-                        <a:t>34.3%</a:t>
+                        <a:t>16.7%</a:t>
                       </a:r>
                     </a:p>
                   </a:txBody>
@@ -8254,7 +8254,7 @@
                           </a:solidFill>
                           <a:latin typeface="Kanit"/>
                         </a:rPr>
-                        <a:t>6/15</a:t>
+                        <a:t>2/3</a:t>
                       </a:r>
                     </a:p>
                   </a:txBody>
@@ -8302,7 +8302,7 @@
                           </a:solidFill>
                           <a:latin typeface="Kanit"/>
                         </a:rPr>
-                        <a:t>นครนายก</a:t>
+                        <a:t>ลำปาง</a:t>
                       </a:r>
                     </a:p>
                   </a:txBody>
@@ -8325,7 +8325,7 @@
                           </a:solidFill>
                           <a:latin typeface="Kanit"/>
                         </a:rPr>
-                        <a:t>27</a:t>
+                        <a:t>179</a:t>
                       </a:r>
                     </a:p>
                   </a:txBody>
@@ -8348,7 +8348,7 @@
                           </a:solidFill>
                           <a:latin typeface="Kanit"/>
                         </a:rPr>
-                        <a:t>52</a:t>
+                        <a:t>74</a:t>
                       </a:r>
                     </a:p>
                   </a:txBody>
@@ -8371,7 +8371,7 @@
                           </a:solidFill>
                           <a:latin typeface="Kanit"/>
                         </a:rPr>
-                        <a:t>25.9%</a:t>
+                        <a:t>14.0%</a:t>
                       </a:r>
                     </a:p>
                   </a:txBody>
@@ -8394,7 +8394,7 @@
                           </a:solidFill>
                           <a:latin typeface="Kanit"/>
                         </a:rPr>
-                        <a:t>2/6</a:t>
+                        <a:t>1/25</a:t>
                       </a:r>
                     </a:p>
                   </a:txBody>
@@ -8442,7 +8442,7 @@
                           </a:solidFill>
                           <a:latin typeface="Kanit"/>
                         </a:rPr>
-                        <a:t>ฉะเชิงเทรา</a:t>
+                        <a:t>นครศรีธรรมราช</a:t>
                       </a:r>
                     </a:p>
                   </a:txBody>
@@ -8465,7 +8465,7 @@
                           </a:solidFill>
                           <a:latin typeface="Kanit"/>
                         </a:rPr>
-                        <a:t>18</a:t>
+                        <a:t>144</a:t>
                       </a:r>
                     </a:p>
                   </a:txBody>
@@ -8488,7 +8488,7 @@
                           </a:solidFill>
                           <a:latin typeface="Kanit"/>
                         </a:rPr>
-                        <a:t>52</a:t>
+                        <a:t>104</a:t>
                       </a:r>
                     </a:p>
                   </a:txBody>
@@ -8511,7 +8511,7 @@
                           </a:solidFill>
                           <a:latin typeface="Kanit"/>
                         </a:rPr>
-                        <a:t>22.2%</a:t>
+                        <a:t>13.9%</a:t>
                       </a:r>
                     </a:p>
                   </a:txBody>
@@ -8534,7 +8534,7 @@
                           </a:solidFill>
                           <a:latin typeface="Kanit"/>
                         </a:rPr>
-                        <a:t>2/4</a:t>
+                        <a:t>4/23</a:t>
                       </a:r>
                     </a:p>
                   </a:txBody>
@@ -8582,7 +8582,7 @@
                           </a:solidFill>
                           <a:latin typeface="Kanit"/>
                         </a:rPr>
-                        <a:t>สตูล</a:t>
+                        <a:t>ฉะเชิงเทรา</a:t>
                       </a:r>
                     </a:p>
                   </a:txBody>
@@ -8605,7 +8605,7 @@
                           </a:solidFill>
                           <a:latin typeface="Kanit"/>
                         </a:rPr>
-                        <a:t>37</a:t>
+                        <a:t>18</a:t>
                       </a:r>
                     </a:p>
                   </a:txBody>
@@ -8628,7 +8628,7 @@
                           </a:solidFill>
                           <a:latin typeface="Kanit"/>
                         </a:rPr>
-                        <a:t>48</a:t>
+                        <a:t>40</a:t>
                       </a:r>
                     </a:p>
                   </a:txBody>
@@ -8651,7 +8651,7 @@
                           </a:solidFill>
                           <a:latin typeface="Kanit"/>
                         </a:rPr>
-                        <a:t>18.9%</a:t>
+                        <a:t>11.1%</a:t>
                       </a:r>
                     </a:p>
                   </a:txBody>
@@ -8674,7 +8674,7 @@
                           </a:solidFill>
                           <a:latin typeface="Kanit"/>
                         </a:rPr>
-                        <a:t>2/8</a:t>
+                        <a:t>2/4</a:t>
                       </a:r>
                     </a:p>
                   </a:txBody>
@@ -37087,7 +37087,7 @@
                 </a:solidFill>
                 <a:latin typeface="Kanit"/>
               </a:rPr>
-              <a:t>338 จาก 928 อำเภอ · แม่น้ำเกินระดับ 151 จาก 788 สถานี</a:t>
+              <a:t>338 จาก 928 อำเภอ · แม่น้ำเกินระดับ 145 จาก 788 สถานี</a:t>
             </a:r>
           </a:p>
         </p:txBody>
@@ -37859,7 +37859,7 @@
                           </a:solidFill>
                           <a:latin typeface="Kanit"/>
                         </a:rPr>
-                        <a:t>42/155</a:t>
+                        <a:t>40/155</a:t>
                       </a:r>
                     </a:p>
                   </a:txBody>
@@ -38091,7 +38091,7 @@
                           </a:solidFill>
                           <a:latin typeface="Kanit"/>
                         </a:rPr>
-                        <a:t>22/272</a:t>
+                        <a:t>23/272</a:t>
                       </a:r>
                     </a:p>
                   </a:txBody>
@@ -38323,7 +38323,7 @@
                           </a:solidFill>
                           <a:latin typeface="Kanit"/>
                         </a:rPr>
-                        <a:t>30/167</a:t>
+                        <a:t>28/167</a:t>
                       </a:r>
                     </a:p>
                   </a:txBody>
@@ -38787,7 +38787,7 @@
                           </a:solidFill>
                           <a:latin typeface="Kanit"/>
                         </a:rPr>
-                        <a:t>45/143</a:t>
+                        <a:t>42/143</a:t>
                       </a:r>
                     </a:p>
                   </a:txBody>

</xml_diff>

<commit_message>
deck(mcom): rebuild — the data moved past the committed figures (run 34681465996) (#937)
Co-authored-by: github-actions[bot] <41898282+github-actions[bot]@users.noreply.github.com>
</commit_message>
<xml_diff>
--- a/docs/decks/mcom-2026-08-05-macro-TH.pptx
+++ b/docs/decks/mcom-2026-08-05-macro-TH.pptx
@@ -6240,7 +6240,7 @@
                 </a:solidFill>
                 <a:latin typeface="Kanit"/>
               </a:rPr>
-              <a:t>151</a:t>
+              <a:t>145</a:t>
             </a:r>
           </a:p>
         </p:txBody>
@@ -6279,7 +6279,7 @@
                 </a:solidFill>
                 <a:latin typeface="Kanit"/>
               </a:rPr>
-              <a:t>จาก 788 (19.2%) · เรียลไทม์ · 2026-09-12</a:t>
+              <a:t>จาก 788 (18.4%) · เรียลไทม์ · 2026-09-12</a:t>
             </a:r>
           </a:p>
         </p:txBody>
@@ -6405,7 +6405,7 @@
                 </a:solidFill>
                 <a:latin typeface="Kanit"/>
               </a:rPr>
-              <a:t>40</a:t>
+              <a:t>26</a:t>
             </a:r>
           </a:p>
         </p:txBody>
@@ -7882,7 +7882,7 @@
                           </a:solidFill>
                           <a:latin typeface="Kanit"/>
                         </a:rPr>
-                        <a:t>ลำปาง</a:t>
+                        <a:t>สกลนคร</a:t>
                       </a:r>
                     </a:p>
                   </a:txBody>
@@ -7905,7 +7905,7 @@
                           </a:solidFill>
                           <a:latin typeface="Kanit"/>
                         </a:rPr>
-                        <a:t>178</a:t>
+                        <a:t>38</a:t>
                       </a:r>
                     </a:p>
                   </a:txBody>
@@ -7928,7 +7928,7 @@
                           </a:solidFill>
                           <a:latin typeface="Kanit"/>
                         </a:rPr>
-                        <a:t>74</a:t>
+                        <a:t>14</a:t>
                       </a:r>
                     </a:p>
                   </a:txBody>
@@ -7947,11 +7947,11 @@
                       <a:r>
                         <a:rPr sz="900" b="1">
                           <a:solidFill>
-                            <a:srgbClr val="F5C242"/>
-                          </a:solidFill>
-                          <a:latin typeface="Kanit"/>
-                        </a:rPr>
-                        <a:t>9.6%</a:t>
+                            <a:srgbClr val="606060"/>
+                          </a:solidFill>
+                          <a:latin typeface="Kanit"/>
+                        </a:rPr>
+                        <a:t>0.0%</a:t>
                       </a:r>
                     </a:p>
                   </a:txBody>
@@ -7974,7 +7974,7 @@
                           </a:solidFill>
                           <a:latin typeface="Kanit"/>
                         </a:rPr>
-                        <a:t>1/25</a:t>
+                        <a:t>7/12</a:t>
                       </a:r>
                     </a:p>
                   </a:txBody>
@@ -8022,7 +8022,7 @@
                           </a:solidFill>
                           <a:latin typeface="Kanit"/>
                         </a:rPr>
-                        <a:t>สกลนคร</a:t>
+                        <a:t>กาญจนบุรี</a:t>
                       </a:r>
                     </a:p>
                   </a:txBody>
@@ -8045,7 +8045,7 @@
                           </a:solidFill>
                           <a:latin typeface="Kanit"/>
                         </a:rPr>
-                        <a:t>38</a:t>
+                        <a:t>98</a:t>
                       </a:r>
                     </a:p>
                   </a:txBody>
@@ -8068,7 +8068,7 @@
                           </a:solidFill>
                           <a:latin typeface="Kanit"/>
                         </a:rPr>
-                        <a:t>13</a:t>
+                        <a:t>69</a:t>
                       </a:r>
                     </a:p>
                   </a:txBody>
@@ -8087,11 +8087,11 @@
                       <a:r>
                         <a:rPr sz="900" b="1">
                           <a:solidFill>
-                            <a:srgbClr val="606060"/>
-                          </a:solidFill>
-                          <a:latin typeface="Kanit"/>
-                        </a:rPr>
-                        <a:t>0.0%</a:t>
+                            <a:srgbClr val="F5C242"/>
+                          </a:solidFill>
+                          <a:latin typeface="Kanit"/>
+                        </a:rPr>
+                        <a:t>17.3%</a:t>
                       </a:r>
                     </a:p>
                   </a:txBody>
@@ -8114,7 +8114,7 @@
                           </a:solidFill>
                           <a:latin typeface="Kanit"/>
                         </a:rPr>
-                        <a:t>7/12</a:t>
+                        <a:t>4/25</a:t>
                       </a:r>
                     </a:p>
                   </a:txBody>
@@ -8133,11 +8133,11 @@
                       <a:r>
                         <a:rPr sz="900" b="1">
                           <a:solidFill>
-                            <a:srgbClr val="CC0000"/>
-                          </a:solidFill>
-                          <a:latin typeface="Kanit"/>
-                        </a:rPr>
-                        <a:t>5</a:t>
+                            <a:srgbClr val="F5C242"/>
+                          </a:solidFill>
+                          <a:latin typeface="Kanit"/>
+                        </a:rPr>
+                        <a:t>4</a:t>
                       </a:r>
                     </a:p>
                   </a:txBody>
@@ -8162,7 +8162,7 @@
                           </a:solidFill>
                           <a:latin typeface="Kanit"/>
                         </a:rPr>
-                        <a:t>ปราจีนบุรี</a:t>
+                        <a:t>สมุทรสาคร</a:t>
                       </a:r>
                     </a:p>
                   </a:txBody>
@@ -8185,7 +8185,7 @@
                           </a:solidFill>
                           <a:latin typeface="Kanit"/>
                         </a:rPr>
-                        <a:t>35</a:t>
+                        <a:t>6</a:t>
                       </a:r>
                     </a:p>
                   </a:txBody>
@@ -8208,7 +8208,7 @@
                           </a:solidFill>
                           <a:latin typeface="Kanit"/>
                         </a:rPr>
-                        <a:t>64</a:t>
+                        <a:t>39</a:t>
                       </a:r>
                     </a:p>
                   </a:txBody>
@@ -8231,7 +8231,7 @@
                           </a:solidFill>
                           <a:latin typeface="Kanit"/>
                         </a:rPr>
-                        <a:t>34.3%</a:t>
+                        <a:t>16.7%</a:t>
                       </a:r>
                     </a:p>
                   </a:txBody>
@@ -8254,7 +8254,7 @@
                           </a:solidFill>
                           <a:latin typeface="Kanit"/>
                         </a:rPr>
-                        <a:t>6/15</a:t>
+                        <a:t>2/3</a:t>
                       </a:r>
                     </a:p>
                   </a:txBody>
@@ -8302,7 +8302,7 @@
                           </a:solidFill>
                           <a:latin typeface="Kanit"/>
                         </a:rPr>
-                        <a:t>นครนายก</a:t>
+                        <a:t>ลำปาง</a:t>
                       </a:r>
                     </a:p>
                   </a:txBody>
@@ -8325,7 +8325,7 @@
                           </a:solidFill>
                           <a:latin typeface="Kanit"/>
                         </a:rPr>
-                        <a:t>27</a:t>
+                        <a:t>179</a:t>
                       </a:r>
                     </a:p>
                   </a:txBody>
@@ -8348,7 +8348,7 @@
                           </a:solidFill>
                           <a:latin typeface="Kanit"/>
                         </a:rPr>
-                        <a:t>52</a:t>
+                        <a:t>74</a:t>
                       </a:r>
                     </a:p>
                   </a:txBody>
@@ -8371,7 +8371,7 @@
                           </a:solidFill>
                           <a:latin typeface="Kanit"/>
                         </a:rPr>
-                        <a:t>25.9%</a:t>
+                        <a:t>14.0%</a:t>
                       </a:r>
                     </a:p>
                   </a:txBody>
@@ -8394,7 +8394,7 @@
                           </a:solidFill>
                           <a:latin t